<commit_message>
chore: 매출 PPT 업로드 (best-sellers-2026-05-12.pptx)
</commit_message>
<xml_diff>
--- a/data/sales-report.pptx
+++ b/data/sales-report.pptx
@@ -1648,7 +1648,7 @@
                 <a:ea typeface="맑은 고딕" pitchFamily="34" charset="-122"/>
                 <a:cs typeface="맑은 고딕" pitchFamily="34" charset="-120"/>
               </a:rPr>
-              <a:t>2026년 5월 11일 (월)  ·  실시간 누적</a:t>
+              <a:t>2026년 05월 12일 (화)  ·  실시간 누적</a:t>
             </a:r>
             <a:endParaRPr lang="en-US" sz="2200" dirty="0"/>
           </a:p>
@@ -1726,7 +1726,7 @@
                 <a:ea typeface="맑은 고딕" pitchFamily="34" charset="-122"/>
                 <a:cs typeface="맑은 고딕" pitchFamily="34" charset="-120"/>
               </a:rPr>
-              <a:t>05.11</a:t>
+              <a:t>05.12</a:t>
             </a:r>
             <a:endParaRPr lang="en-US" sz="7200" dirty="0"/>
           </a:p>
@@ -1765,7 +1765,7 @@
                 <a:ea typeface="맑은 고딕" pitchFamily="34" charset="-122"/>
                 <a:cs typeface="맑은 고딕" pitchFamily="34" charset="-120"/>
               </a:rPr>
-              <a:t>월요일</a:t>
+              <a:t>화요일</a:t>
             </a:r>
             <a:endParaRPr lang="en-US" sz="1400" dirty="0"/>
           </a:p>
@@ -1804,7 +1804,7 @@
                 <a:ea typeface="맑은 고딕" pitchFamily="34" charset="-122"/>
                 <a:cs typeface="맑은 고딕" pitchFamily="34" charset="-120"/>
               </a:rPr>
-              <a:t>생성 2026-05-11 19:50  ·  Google Sheet 자동 동기</a:t>
+              <a:t>생성 2026-05-12 09:56  ·  Google Sheet 자동 동기</a:t>
             </a:r>
             <a:endParaRPr lang="en-US" sz="1000" dirty="0"/>
           </a:p>
@@ -1978,7 +1978,7 @@
                 <a:ea typeface="맑은 고딕" pitchFamily="34" charset="-122"/>
                 <a:cs typeface="맑은 고딕" pitchFamily="34" charset="-120"/>
               </a:rPr>
-              <a:t>2026년 5월 11일 (월)</a:t>
+              <a:t>2026년 05월 12일 (화)</a:t>
             </a:r>
             <a:endParaRPr lang="en-US" sz="1200" dirty="0"/>
           </a:p>
@@ -2145,7 +2145,7 @@
                 <a:ea typeface="맑은 고딕" pitchFamily="34" charset="-122"/>
                 <a:cs typeface="맑은 고딕" pitchFamily="34" charset="-120"/>
               </a:rPr>
-              <a:t>79 개</a:t>
+              <a:t>212 개</a:t>
             </a:r>
             <a:endParaRPr lang="en-US" sz="3600" dirty="0"/>
           </a:p>
@@ -2312,7 +2312,7 @@
                 <a:ea typeface="맑은 고딕" pitchFamily="34" charset="-122"/>
                 <a:cs typeface="맑은 고딕" pitchFamily="34" charset="-120"/>
               </a:rPr>
-              <a:t>17 건</a:t>
+              <a:t>38 건</a:t>
             </a:r>
             <a:endParaRPr lang="en-US" sz="3200" dirty="0"/>
           </a:p>
@@ -2479,7 +2479,7 @@
                 <a:ea typeface="맑은 고딕" pitchFamily="34" charset="-122"/>
                 <a:cs typeface="맑은 고딕" pitchFamily="34" charset="-120"/>
               </a:rPr>
-              <a:t>7 건</a:t>
+              <a:t>5 건</a:t>
             </a:r>
             <a:endParaRPr lang="en-US" sz="3200" dirty="0"/>
           </a:p>
@@ -2685,7 +2685,7 @@
                 <a:ea typeface="맑은 고딕" pitchFamily="34" charset="-122"/>
                 <a:cs typeface="맑은 고딕" pitchFamily="34" charset="-120"/>
               </a:rPr>
-              <a:t>82 SKU</a:t>
+              <a:t>82 SKU  ·  판매 OK</a:t>
             </a:r>
             <a:pPr indent="0" marL="0">
               <a:buNone/>
@@ -2699,7 +2699,7 @@
                 <a:ea typeface="맑은 고딕" pitchFamily="34" charset="-122"/>
                 <a:cs typeface="맑은 고딕" pitchFamily="34" charset="-120"/>
               </a:rPr>
-              <a:t>  ·  판매 OK</a:t>
+              <a:t/>
             </a:r>
             <a:endParaRPr lang="en-US" sz="1100" dirty="0"/>
           </a:p>
@@ -2827,7 +2827,7 @@
                 <a:ea typeface="맑은 고딕" pitchFamily="34" charset="-122"/>
                 <a:cs typeface="맑은 고딕" pitchFamily="34" charset="-120"/>
               </a:rPr>
-              <a:t>33 SKU</a:t>
+              <a:t>49 SKU  ·  판매 OK</a:t>
             </a:r>
             <a:pPr indent="0" marL="0">
               <a:buNone/>
@@ -2841,7 +2841,7 @@
                 <a:ea typeface="맑은 고딕" pitchFamily="34" charset="-122"/>
                 <a:cs typeface="맑은 고딕" pitchFamily="34" charset="-120"/>
               </a:rPr>
-              <a:t>  ·  판매 OK</a:t>
+              <a:t/>
             </a:r>
             <a:endParaRPr lang="en-US" sz="1100" dirty="0"/>
           </a:p>
@@ -2969,7 +2969,7 @@
                 <a:ea typeface="맑은 고딕" pitchFamily="34" charset="-122"/>
                 <a:cs typeface="맑은 고딕" pitchFamily="34" charset="-120"/>
               </a:rPr>
-              <a:t>169 SKU</a:t>
+              <a:t>192 SKU  ·  판매 데이터 있음</a:t>
             </a:r>
             <a:pPr indent="0" marL="0">
               <a:buNone/>
@@ -2983,7 +2983,7 @@
                 <a:ea typeface="맑은 고딕" pitchFamily="34" charset="-122"/>
                 <a:cs typeface="맑은 고딕" pitchFamily="34" charset="-120"/>
               </a:rPr>
-              <a:t>  ·  판매 데이터 없음</a:t>
+              <a:t/>
             </a:r>
             <a:endParaRPr lang="en-US" sz="1100" dirty="0"/>
           </a:p>
@@ -3677,7 +3677,7 @@
                           <a:ea typeface="맑은 고딕" pitchFamily="34" charset="-122"/>
                           <a:cs typeface="맑은 고딕" pitchFamily="34" charset="-120"/>
                         </a:rPr>
-                        <a:t>11 개</a:t>
+                        <a:t>27 개</a:t>
                       </a:r>
                       <a:endParaRPr lang="en-US" sz="1400" dirty="0">
                         <a:latin typeface="맑은 고딕" charset="0"/>
@@ -3874,7 +3874,7 @@
                           <a:ea typeface="맑은 고딕" pitchFamily="34" charset="-122"/>
                           <a:cs typeface="맑은 고딕" pitchFamily="34" charset="-120"/>
                         </a:rPr>
-                        <a:t>Bracelet</a:t>
+                        <a:t>Necklace</a:t>
                       </a:r>
                       <a:endParaRPr lang="en-US" sz="1000" dirty="0">
                         <a:latin typeface="맑은 고딕" charset="0"/>
@@ -3939,7 +3939,7 @@
                           <a:ea typeface="맑은 고딕" pitchFamily="34" charset="-122"/>
                           <a:cs typeface="맑은 고딕" pitchFamily="34" charset="-120"/>
                         </a:rPr>
-                        <a:t>Tanquary Bracelet</a:t>
+                        <a:t>Marquise Necklace</a:t>
                       </a:r>
                       <a:endParaRPr lang="en-US" sz="1100" dirty="0">
                         <a:latin typeface="맑은 고딕" charset="0"/>
@@ -4004,7 +4004,7 @@
                           <a:ea typeface="맑은 고딕" pitchFamily="34" charset="-122"/>
                           <a:cs typeface="맑은 고딕" pitchFamily="34" charset="-120"/>
                         </a:rPr>
-                        <a:t>6 개</a:t>
+                        <a:t>17 개</a:t>
                       </a:r>
                       <a:endParaRPr lang="en-US" sz="1400" dirty="0">
                         <a:latin typeface="맑은 고딕" charset="0"/>
@@ -4331,7 +4331,7 @@
                           <a:ea typeface="맑은 고딕" pitchFamily="34" charset="-122"/>
                           <a:cs typeface="맑은 고딕" pitchFamily="34" charset="-120"/>
                         </a:rPr>
-                        <a:t>6 개</a:t>
+                        <a:t>14 개</a:t>
                       </a:r>
                       <a:endParaRPr lang="en-US" sz="1400" dirty="0">
                         <a:latin typeface="맑은 고딕" charset="0"/>
@@ -4528,7 +4528,7 @@
                           <a:ea typeface="맑은 고딕" pitchFamily="34" charset="-122"/>
                           <a:cs typeface="맑은 고딕" pitchFamily="34" charset="-120"/>
                         </a:rPr>
-                        <a:t>Necklace</a:t>
+                        <a:t>Ring</a:t>
                       </a:r>
                       <a:endParaRPr lang="en-US" sz="1000" dirty="0">
                         <a:latin typeface="맑은 고딕" charset="0"/>
@@ -4593,7 +4593,7 @@
                           <a:ea typeface="맑은 고딕" pitchFamily="34" charset="-122"/>
                           <a:cs typeface="맑은 고딕" pitchFamily="34" charset="-120"/>
                         </a:rPr>
-                        <a:t>Marquise Necklace</a:t>
+                        <a:t>[SILVER925] Starly Open Ring</a:t>
                       </a:r>
                       <a:endParaRPr lang="en-US" sz="1100" dirty="0">
                         <a:latin typeface="맑은 고딕" charset="0"/>
@@ -4658,7 +4658,7 @@
                           <a:ea typeface="맑은 고딕" pitchFamily="34" charset="-122"/>
                           <a:cs typeface="맑은 고딕" pitchFamily="34" charset="-120"/>
                         </a:rPr>
-                        <a:t>5 개</a:t>
+                        <a:t>12 개</a:t>
                       </a:r>
                       <a:endParaRPr lang="en-US" sz="1200" dirty="0">
                         <a:latin typeface="맑은 고딕" charset="0"/>
@@ -4790,7 +4790,7 @@
                           <a:ea typeface="맑은 고딕" pitchFamily="34" charset="-122"/>
                           <a:cs typeface="맑은 고딕" pitchFamily="34" charset="-120"/>
                         </a:rPr>
-                        <a:t>Cleartype</a:t>
+                        <a:t>6A</a:t>
                       </a:r>
                       <a:endParaRPr lang="en-US" sz="1100" dirty="0">
                         <a:latin typeface="맑은 고딕" charset="0"/>
@@ -4920,7 +4920,7 @@
                           <a:ea typeface="맑은 고딕" pitchFamily="34" charset="-122"/>
                           <a:cs typeface="맑은 고딕" pitchFamily="34" charset="-120"/>
                         </a:rPr>
-                        <a:t>CandyPOP Necklace (사이즈: 2size (47~52cm))</a:t>
+                        <a:t>Tiny Cross Necklace</a:t>
                       </a:r>
                       <a:endParaRPr lang="en-US" sz="1100" dirty="0">
                         <a:latin typeface="맑은 고딕" charset="0"/>
@@ -4985,7 +4985,7 @@
                           <a:ea typeface="맑은 고딕" pitchFamily="34" charset="-122"/>
                           <a:cs typeface="맑은 고딕" pitchFamily="34" charset="-120"/>
                         </a:rPr>
-                        <a:t>5 개</a:t>
+                        <a:t>9 개</a:t>
                       </a:r>
                       <a:endParaRPr lang="en-US" sz="1200" dirty="0">
                         <a:latin typeface="맑은 고딕" charset="0"/>
@@ -5071,7 +5071,7 @@
                 <a:ea typeface="맑은 고딕" pitchFamily="34" charset="-122"/>
                 <a:cs typeface="맑은 고딕" pitchFamily="34" charset="-120"/>
               </a:rPr>
-              <a:t>베스트 상품 리포트  ·  생성 2026-05-11 19:50</a:t>
+              <a:t>베스트 상품 리포트  ·  생성 2026-05-12 09:56</a:t>
             </a:r>
             <a:endParaRPr lang="en-US" sz="900" dirty="0"/>
           </a:p>
@@ -5284,7 +5284,7 @@
                 <a:ea typeface="맑은 고딕" pitchFamily="34" charset="-122"/>
                 <a:cs typeface="맑은 고딕" pitchFamily="34" charset="-120"/>
               </a:rPr>
-              <a:t>2026년 5월 11일 (월)</a:t>
+              <a:t>2026년 05월 12일 (화)</a:t>
             </a:r>
             <a:endParaRPr lang="en-US" sz="1200" dirty="0"/>
           </a:p>
@@ -5451,7 +5451,7 @@
                 <a:ea typeface="맑은 고딕" pitchFamily="34" charset="-122"/>
                 <a:cs typeface="맑은 고딕" pitchFamily="34" charset="-120"/>
               </a:rPr>
-              <a:t>69 개</a:t>
+              <a:t>182 개</a:t>
             </a:r>
             <a:endParaRPr lang="en-US" sz="3600" dirty="0"/>
           </a:p>
@@ -5657,7 +5657,7 @@
                 <a:ea typeface="맑은 고딕" pitchFamily="34" charset="-122"/>
                 <a:cs typeface="맑은 고딕" pitchFamily="34" charset="-120"/>
               </a:rPr>
-              <a:t>11</a:t>
+              <a:t>27</a:t>
             </a:r>
             <a:endParaRPr lang="en-US" sz="4400" dirty="0"/>
           </a:p>
@@ -6256,7 +6256,7 @@
                           <a:ea typeface="맑은 고딕" pitchFamily="34" charset="-122"/>
                           <a:cs typeface="맑은 고딕" pitchFamily="34" charset="-120"/>
                         </a:rPr>
-                        <a:t>11 개</a:t>
+                        <a:t>27 개</a:t>
                       </a:r>
                       <a:endParaRPr lang="en-US" sz="1400" dirty="0">
                         <a:latin typeface="맑은 고딕" charset="0"/>
@@ -6388,7 +6388,7 @@
                           <a:ea typeface="맑은 고딕" pitchFamily="34" charset="-122"/>
                           <a:cs typeface="맑은 고딕" pitchFamily="34" charset="-120"/>
                         </a:rPr>
-                        <a:t>Bracelet</a:t>
+                        <a:t>Necklace</a:t>
                       </a:r>
                       <a:endParaRPr lang="en-US" sz="1000" dirty="0">
                         <a:latin typeface="맑은 고딕" charset="0"/>
@@ -6453,7 +6453,7 @@
                           <a:ea typeface="맑은 고딕" pitchFamily="34" charset="-122"/>
                           <a:cs typeface="맑은 고딕" pitchFamily="34" charset="-120"/>
                         </a:rPr>
-                        <a:t>Tanquary Bracelet</a:t>
+                        <a:t>Marquise Necklace</a:t>
                       </a:r>
                       <a:endParaRPr lang="en-US" sz="1100" dirty="0">
                         <a:latin typeface="맑은 고딕" charset="0"/>
@@ -6518,7 +6518,7 @@
                           <a:ea typeface="맑은 고딕" pitchFamily="34" charset="-122"/>
                           <a:cs typeface="맑은 고딕" pitchFamily="34" charset="-120"/>
                         </a:rPr>
-                        <a:t>6 개</a:t>
+                        <a:t>17 개</a:t>
                       </a:r>
                       <a:endParaRPr lang="en-US" sz="1200" dirty="0">
                         <a:latin typeface="맑은 고딕" charset="0"/>
@@ -6780,7 +6780,7 @@
                           <a:ea typeface="맑은 고딕" pitchFamily="34" charset="-122"/>
                           <a:cs typeface="맑은 고딕" pitchFamily="34" charset="-120"/>
                         </a:rPr>
-                        <a:t>6 개</a:t>
+                        <a:t>14 개</a:t>
                       </a:r>
                       <a:endParaRPr lang="en-US" sz="1200" dirty="0">
                         <a:latin typeface="맑은 고딕" charset="0"/>
@@ -6912,7 +6912,7 @@
                           <a:ea typeface="맑은 고딕" pitchFamily="34" charset="-122"/>
                           <a:cs typeface="맑은 고딕" pitchFamily="34" charset="-120"/>
                         </a:rPr>
-                        <a:t>Necklace</a:t>
+                        <a:t>Ring</a:t>
                       </a:r>
                       <a:endParaRPr lang="en-US" sz="1000" dirty="0">
                         <a:latin typeface="맑은 고딕" charset="0"/>
@@ -6977,7 +6977,7 @@
                           <a:ea typeface="맑은 고딕" pitchFamily="34" charset="-122"/>
                           <a:cs typeface="맑은 고딕" pitchFamily="34" charset="-120"/>
                         </a:rPr>
-                        <a:t>Marquise Necklace</a:t>
+                        <a:t>[SILVER925] Starly Open Ring</a:t>
                       </a:r>
                       <a:endParaRPr lang="en-US" sz="1100" dirty="0">
                         <a:latin typeface="맑은 고딕" charset="0"/>
@@ -7042,7 +7042,7 @@
                           <a:ea typeface="맑은 고딕" pitchFamily="34" charset="-122"/>
                           <a:cs typeface="맑은 고딕" pitchFamily="34" charset="-120"/>
                         </a:rPr>
-                        <a:t>5 개</a:t>
+                        <a:t>12 개</a:t>
                       </a:r>
                       <a:endParaRPr lang="en-US" sz="1200" dirty="0">
                         <a:latin typeface="맑은 고딕" charset="0"/>
@@ -7304,7 +7304,7 @@
                           <a:ea typeface="맑은 고딕" pitchFamily="34" charset="-122"/>
                           <a:cs typeface="맑은 고딕" pitchFamily="34" charset="-120"/>
                         </a:rPr>
-                        <a:t>4 개</a:t>
+                        <a:t>9 개</a:t>
                       </a:r>
                       <a:endParaRPr lang="en-US" sz="1200" dirty="0">
                         <a:latin typeface="맑은 고딕" charset="0"/>
@@ -7390,7 +7390,7 @@
                 <a:ea typeface="맑은 고딕" pitchFamily="34" charset="-122"/>
                 <a:cs typeface="맑은 고딕" pitchFamily="34" charset="-120"/>
               </a:rPr>
-              <a:t>리오더 필요  </a:t>
+              <a:t>리오더 필요  🔴 긴급 5건</a:t>
             </a:r>
             <a:pPr indent="0" marL="0">
               <a:buNone/>
@@ -7404,7 +7404,7 @@
                 <a:ea typeface="맑은 고딕" pitchFamily="34" charset="-122"/>
                 <a:cs typeface="맑은 고딕" pitchFamily="34" charset="-120"/>
               </a:rPr>
-              <a:t>🔴 긴급 5건</a:t>
+              <a:t/>
             </a:r>
             <a:endParaRPr lang="en-US" sz="1500" dirty="0"/>
           </a:p>
@@ -7557,7 +7557,7 @@
                 <a:ea typeface="맑은 고딕" pitchFamily="34" charset="-122"/>
                 <a:cs typeface="맑은 고딕" pitchFamily="34" charset="-120"/>
               </a:rPr>
-              <a:t>B-Flower Necklace (Size: 1 Size)</a:t>
+              <a:t>[SILVER925] CH.alban Open Ring</a:t>
             </a:r>
             <a:endParaRPr lang="en-US" sz="1100" dirty="0"/>
           </a:p>
@@ -7596,7 +7596,7 @@
                 <a:ea typeface="맑은 고딕" pitchFamily="34" charset="-122"/>
                 <a:cs typeface="맑은 고딕" pitchFamily="34" charset="-120"/>
               </a:rPr>
-              <a:t>Necklace  ·  재고 </a:t>
+              <a:t>Ring  ·  재고 1개</a:t>
             </a:r>
             <a:pPr indent="0" marL="0">
               <a:buNone/>
@@ -7610,7 +7610,7 @@
                 <a:ea typeface="맑은 고딕" pitchFamily="34" charset="-122"/>
                 <a:cs typeface="맑은 고딕" pitchFamily="34" charset="-120"/>
               </a:rPr>
-              <a:t>0개</a:t>
+              <a:t/>
             </a:r>
             <a:endParaRPr lang="en-US" sz="1000" dirty="0"/>
           </a:p>
@@ -7763,7 +7763,7 @@
                 <a:ea typeface="맑은 고딕" pitchFamily="34" charset="-122"/>
                 <a:cs typeface="맑은 고딕" pitchFamily="34" charset="-120"/>
               </a:rPr>
-              <a:t>[SILVER925] CH.alban Open Ring</a:t>
+              <a:t>B-Flower Necklace (Size: 2 Size)</a:t>
             </a:r>
             <a:endParaRPr lang="en-US" sz="1100" dirty="0"/>
           </a:p>
@@ -7802,7 +7802,7 @@
                 <a:ea typeface="맑은 고딕" pitchFamily="34" charset="-122"/>
                 <a:cs typeface="맑은 고딕" pitchFamily="34" charset="-120"/>
               </a:rPr>
-              <a:t>Ring  ·  재고 </a:t>
+              <a:t>Necklace  ·  재고 4개</a:t>
             </a:r>
             <a:pPr indent="0" marL="0">
               <a:buNone/>
@@ -7816,7 +7816,7 @@
                 <a:ea typeface="맑은 고딕" pitchFamily="34" charset="-122"/>
                 <a:cs typeface="맑은 고딕" pitchFamily="34" charset="-120"/>
               </a:rPr>
-              <a:t>0개</a:t>
+              <a:t/>
             </a:r>
             <a:endParaRPr lang="en-US" sz="1000" dirty="0"/>
           </a:p>
@@ -7969,7 +7969,7 @@
                 <a:ea typeface="맑은 고딕" pitchFamily="34" charset="-122"/>
                 <a:cs typeface="맑은 고딕" pitchFamily="34" charset="-120"/>
               </a:rPr>
-              <a:t>B-Flower Necklace (Size: 2 Size)</a:t>
+              <a:t>Tangle Keychain</a:t>
             </a:r>
             <a:endParaRPr lang="en-US" sz="1100" dirty="0"/>
           </a:p>
@@ -8008,7 +8008,7 @@
                 <a:ea typeface="맑은 고딕" pitchFamily="34" charset="-122"/>
                 <a:cs typeface="맑은 고딕" pitchFamily="34" charset="-120"/>
               </a:rPr>
-              <a:t>Necklace  ·  재고 </a:t>
+              <a:t>★Season off★  ·  재고 5개</a:t>
             </a:r>
             <a:pPr indent="0" marL="0">
               <a:buNone/>
@@ -8022,7 +8022,7 @@
                 <a:ea typeface="맑은 고딕" pitchFamily="34" charset="-122"/>
                 <a:cs typeface="맑은 고딕" pitchFamily="34" charset="-120"/>
               </a:rPr>
-              <a:t>5개</a:t>
+              <a:t/>
             </a:r>
             <a:endParaRPr lang="en-US" sz="1000" dirty="0"/>
           </a:p>
@@ -8175,7 +8175,7 @@
                 <a:ea typeface="맑은 고딕" pitchFamily="34" charset="-122"/>
                 <a:cs typeface="맑은 고딕" pitchFamily="34" charset="-120"/>
               </a:rPr>
-              <a:t>Tangle Keychain</a:t>
+              <a:t>8-Ball Smart Tok</a:t>
             </a:r>
             <a:endParaRPr lang="en-US" sz="1100" dirty="0"/>
           </a:p>
@@ -8214,7 +8214,7 @@
                 <a:ea typeface="맑은 고딕" pitchFamily="34" charset="-122"/>
                 <a:cs typeface="맑은 고딕" pitchFamily="34" charset="-120"/>
               </a:rPr>
-              <a:t>Season off  ·  재고 </a:t>
+              <a:t>★Season off★  ·  재고 5개</a:t>
             </a:r>
             <a:pPr indent="0" marL="0">
               <a:buNone/>
@@ -8228,7 +8228,7 @@
                 <a:ea typeface="맑은 고딕" pitchFamily="34" charset="-122"/>
                 <a:cs typeface="맑은 고딕" pitchFamily="34" charset="-120"/>
               </a:rPr>
-              <a:t>5개</a:t>
+              <a:t/>
             </a:r>
             <a:endParaRPr lang="en-US" sz="1000" dirty="0"/>
           </a:p>
@@ -8267,7 +8267,7 @@
                 <a:ea typeface="맑은 고딕" pitchFamily="34" charset="-122"/>
                 <a:cs typeface="맑은 고딕" pitchFamily="34" charset="-120"/>
               </a:rPr>
-              <a:t>베스트 상품 리포트  ·  생성 2026-05-11 19:50</a:t>
+              <a:t>베스트 상품 리포트  ·  생성 2026-05-12 09:56</a:t>
             </a:r>
             <a:endParaRPr lang="en-US" sz="900" dirty="0"/>
           </a:p>
@@ -8480,7 +8480,7 @@
                 <a:ea typeface="맑은 고딕" pitchFamily="34" charset="-122"/>
                 <a:cs typeface="맑은 고딕" pitchFamily="34" charset="-120"/>
               </a:rPr>
-              <a:t>2026년 5월 11일 (월)</a:t>
+              <a:t>2026년 05월 12일 (화)</a:t>
             </a:r>
             <a:endParaRPr lang="en-US" sz="1200" dirty="0"/>
           </a:p>
@@ -8647,7 +8647,7 @@
                 <a:ea typeface="맑은 고딕" pitchFamily="34" charset="-122"/>
                 <a:cs typeface="맑은 고딕" pitchFamily="34" charset="-120"/>
               </a:rPr>
-              <a:t>10 개</a:t>
+              <a:t>30 개</a:t>
             </a:r>
             <a:endParaRPr lang="en-US" sz="3600" dirty="0"/>
           </a:p>
@@ -8853,7 +8853,7 @@
                 <a:ea typeface="맑은 고딕" pitchFamily="34" charset="-122"/>
                 <a:cs typeface="맑은 고딕" pitchFamily="34" charset="-120"/>
               </a:rPr>
-              <a:t>5</a:t>
+              <a:t>9</a:t>
             </a:r>
             <a:endParaRPr lang="en-US" sz="4400" dirty="0"/>
           </a:p>
@@ -9452,7 +9452,7 @@
                           <a:ea typeface="맑은 고딕" pitchFamily="34" charset="-122"/>
                           <a:cs typeface="맑은 고딕" pitchFamily="34" charset="-120"/>
                         </a:rPr>
-                        <a:t>5 개</a:t>
+                        <a:t>9 개</a:t>
                       </a:r>
                       <a:endParaRPr lang="en-US" sz="1400" dirty="0">
                         <a:latin typeface="맑은 고딕" charset="0"/>
@@ -9714,7 +9714,7 @@
                           <a:ea typeface="맑은 고딕" pitchFamily="34" charset="-122"/>
                           <a:cs typeface="맑은 고딕" pitchFamily="34" charset="-120"/>
                         </a:rPr>
-                        <a:t>4 개</a:t>
+                        <a:t>7 개</a:t>
                       </a:r>
                       <a:endParaRPr lang="en-US" sz="1200" dirty="0">
                         <a:latin typeface="맑은 고딕" charset="0"/>
@@ -9911,7 +9911,7 @@
                           <a:ea typeface="맑은 고딕" pitchFamily="34" charset="-122"/>
                           <a:cs typeface="맑은 고딕" pitchFamily="34" charset="-120"/>
                         </a:rPr>
-                        <a:t>Reine 925 Open Ring</a:t>
+                        <a:t>"Reine" 925 Open Ring</a:t>
                       </a:r>
                       <a:endParaRPr lang="en-US" sz="1100" dirty="0">
                         <a:latin typeface="맑은 고딕" charset="0"/>
@@ -9976,7 +9976,7 @@
                           <a:ea typeface="맑은 고딕" pitchFamily="34" charset="-122"/>
                           <a:cs typeface="맑은 고딕" pitchFamily="34" charset="-120"/>
                         </a:rPr>
-                        <a:t>1 개</a:t>
+                        <a:t>3 개</a:t>
                       </a:r>
                       <a:endParaRPr lang="en-US" sz="1200" dirty="0">
                         <a:latin typeface="맑은 고딕" charset="0"/>
@@ -10062,7 +10062,7 @@
                 <a:ea typeface="맑은 고딕" pitchFamily="34" charset="-122"/>
                 <a:cs typeface="맑은 고딕" pitchFamily="34" charset="-120"/>
               </a:rPr>
-              <a:t>리오더 필요  </a:t>
+              <a:t>리오더 필요  🔴 긴급 8건</a:t>
             </a:r>
             <a:endParaRPr lang="en-US" sz="1500" dirty="0"/>
           </a:p>
@@ -10126,7 +10126,7 @@
                 <a:ea typeface="맑은 고딕" pitchFamily="34" charset="-122"/>
                 <a:cs typeface="맑은 고딕" pitchFamily="34" charset="-120"/>
               </a:rPr>
-              <a:t>✅  리오더 알림 없음</a:t>
+              <a:t>🔴 긴급 8건  ·  상세는 시트 확인</a:t>
             </a:r>
             <a:endParaRPr lang="en-US" sz="1400" dirty="0"/>
           </a:p>
@@ -10165,7 +10165,7 @@
                 <a:ea typeface="맑은 고딕" pitchFamily="34" charset="-122"/>
                 <a:cs typeface="맑은 고딕" pitchFamily="34" charset="-120"/>
               </a:rPr>
-              <a:t>베스트 상품 리포트  ·  생성 2026-05-11 19:50</a:t>
+              <a:t>베스트 상품 리포트  ·  생성 2026-05-12 09:56</a:t>
             </a:r>
             <a:endParaRPr lang="en-US" sz="900" dirty="0"/>
           </a:p>
@@ -10378,7 +10378,7 @@
                 <a:ea typeface="맑은 고딕" pitchFamily="34" charset="-122"/>
                 <a:cs typeface="맑은 고딕" pitchFamily="34" charset="-120"/>
               </a:rPr>
-              <a:t>2026년 5월 11일 (월)</a:t>
+              <a:t>2026년 05월 12일 (화)</a:t>
             </a:r>
             <a:endParaRPr lang="en-US" sz="1200" dirty="0"/>
           </a:p>
@@ -10545,7 +10545,7 @@
                 <a:ea typeface="맑은 고딕" pitchFamily="34" charset="-122"/>
                 <a:cs typeface="맑은 고딕" pitchFamily="34" charset="-120"/>
               </a:rPr>
-              <a:t>169</a:t>
+              <a:t>192</a:t>
             </a:r>
             <a:endParaRPr lang="en-US" sz="3000" dirty="0"/>
           </a:p>
@@ -10673,7 +10673,7 @@
                 <a:ea typeface="맑은 고딕" pitchFamily="34" charset="-122"/>
                 <a:cs typeface="맑은 고딕" pitchFamily="34" charset="-120"/>
               </a:rPr>
-              <a:t>12</a:t>
+              <a:t>16</a:t>
             </a:r>
             <a:endParaRPr lang="en-US" sz="3000" dirty="0"/>
           </a:p>
@@ -10801,7 +10801,7 @@
                 <a:ea typeface="맑은 고딕" pitchFamily="34" charset="-122"/>
                 <a:cs typeface="맑은 고딕" pitchFamily="34" charset="-120"/>
               </a:rPr>
-              <a:t>14</a:t>
+              <a:t>6</a:t>
             </a:r>
             <a:endParaRPr lang="en-US" sz="3000" dirty="0"/>
           </a:p>
@@ -10929,7 +10929,7 @@
                 <a:ea typeface="맑은 고딕" pitchFamily="34" charset="-122"/>
                 <a:cs typeface="맑은 고딕" pitchFamily="34" charset="-120"/>
               </a:rPr>
-              <a:t>26,258</a:t>
+              <a:t>43,297</a:t>
             </a:r>
             <a:endParaRPr lang="en-US" sz="3000" dirty="0"/>
           </a:p>
@@ -11489,7 +11489,7 @@
                           <a:ea typeface="맑은 고딕" pitchFamily="34" charset="-122"/>
                           <a:cs typeface="맑은 고딕" pitchFamily="34" charset="-120"/>
                         </a:rPr>
-                        <a:t>2,800</a:t>
+                        <a:t>3,939</a:t>
                       </a:r>
                       <a:endParaRPr lang="en-US" sz="1000" dirty="0">
                         <a:latin typeface="맑은 고딕" charset="0"/>
@@ -11686,7 +11686,7 @@
                           <a:ea typeface="맑은 고딕" pitchFamily="34" charset="-122"/>
                           <a:cs typeface="맑은 고딕" pitchFamily="34" charset="-120"/>
                         </a:rPr>
-                        <a:t>컬러: 피치 / 기종 옵션: C type -&gt; C type</a:t>
+                        <a:t>컬러: 퍼플 / 기종 옵션: C type -&gt; C type</a:t>
                       </a:r>
                       <a:endParaRPr lang="en-US" sz="900" dirty="0">
                         <a:latin typeface="맑은 고딕" charset="0"/>
@@ -11751,7 +11751,7 @@
                           <a:ea typeface="맑은 고딕" pitchFamily="34" charset="-122"/>
                           <a:cs typeface="맑은 고딕" pitchFamily="34" charset="-120"/>
                         </a:rPr>
-                        <a:t>1,790</a:t>
+                        <a:t>2,881</a:t>
                       </a:r>
                       <a:endParaRPr lang="en-US" sz="1000" dirty="0">
                         <a:latin typeface="맑은 고딕" charset="0"/>
@@ -12013,7 +12013,7 @@
                           <a:ea typeface="맑은 고딕" pitchFamily="34" charset="-122"/>
                           <a:cs typeface="맑은 고딕" pitchFamily="34" charset="-120"/>
                         </a:rPr>
-                        <a:t>1,740</a:t>
+                        <a:t>2,505</a:t>
                       </a:r>
                       <a:endParaRPr lang="en-US" sz="1000" dirty="0">
                         <a:latin typeface="맑은 고딕" charset="0"/>
@@ -12210,7 +12210,7 @@
                           <a:ea typeface="맑은 고딕" pitchFamily="34" charset="-122"/>
                           <a:cs typeface="맑은 고딕" pitchFamily="34" charset="-120"/>
                         </a:rPr>
-                        <a:t>컬러: 퍼플 / 기종 옵션: C type -&gt; C type</a:t>
+                        <a:t>컬러: 네온핑크 / 기종 옵션: USB -&gt; C type</a:t>
                       </a:r>
                       <a:endParaRPr lang="en-US" sz="900" dirty="0">
                         <a:latin typeface="맑은 고딕" charset="0"/>
@@ -12275,7 +12275,7 @@
                           <a:ea typeface="맑은 고딕" pitchFamily="34" charset="-122"/>
                           <a:cs typeface="맑은 고딕" pitchFamily="34" charset="-120"/>
                         </a:rPr>
-                        <a:t>1,420</a:t>
+                        <a:t>2,322</a:t>
                       </a:r>
                       <a:endParaRPr lang="en-US" sz="1000" dirty="0">
                         <a:latin typeface="맑은 고딕" charset="0"/>
@@ -12472,7 +12472,7 @@
                           <a:ea typeface="맑은 고딕" pitchFamily="34" charset="-122"/>
                           <a:cs typeface="맑은 고딕" pitchFamily="34" charset="-120"/>
                         </a:rPr>
-                        <a:t>컬러: 네온핑크 / 기종 옵션: C type -&gt; C type</a:t>
+                        <a:t>컬러: 피치 / 기종 옵션: C type -&gt; C type</a:t>
                       </a:r>
                       <a:endParaRPr lang="en-US" sz="900" dirty="0">
                         <a:latin typeface="맑은 고딕" charset="0"/>
@@ -12537,7 +12537,7 @@
                           <a:ea typeface="맑은 고딕" pitchFamily="34" charset="-122"/>
                           <a:cs typeface="맑은 고딕" pitchFamily="34" charset="-120"/>
                         </a:rPr>
-                        <a:t>920</a:t>
+                        <a:t>2,016</a:t>
                       </a:r>
                       <a:endParaRPr lang="en-US" sz="1000" dirty="0">
                         <a:latin typeface="맑은 고딕" charset="0"/>
@@ -12623,7 +12623,7 @@
                 <a:ea typeface="맑은 고딕" pitchFamily="34" charset="-122"/>
                 <a:cs typeface="맑은 고딕" pitchFamily="34" charset="-120"/>
               </a:rPr>
-              <a:t>재고 점검  </a:t>
+              <a:t>재고 점검  🔴 품절 16건</a:t>
             </a:r>
             <a:pPr indent="0" marL="0">
               <a:buNone/>
@@ -12637,7 +12637,7 @@
                 <a:ea typeface="맑은 고딕" pitchFamily="34" charset="-122"/>
                 <a:cs typeface="맑은 고딕" pitchFamily="34" charset="-120"/>
               </a:rPr>
-              <a:t>🔴 품절 12건</a:t>
+              <a:t/>
             </a:r>
             <a:endParaRPr lang="en-US" sz="1500" dirty="0"/>
           </a:p>
@@ -12790,7 +12790,7 @@
                 <a:ea typeface="맑은 고딕" pitchFamily="34" charset="-122"/>
                 <a:cs typeface="맑은 고딕" pitchFamily="34" charset="-120"/>
               </a:rPr>
-              <a:t>TRAVELER pouch bag (5color)</a:t>
+              <a:t>Food Bottle Opener</a:t>
             </a:r>
             <a:endParaRPr lang="en-US" sz="1000" dirty="0"/>
           </a:p>
@@ -12829,7 +12829,7 @@
                 <a:ea typeface="맑은 고딕" pitchFamily="34" charset="-122"/>
                 <a:cs typeface="맑은 고딕" pitchFamily="34" charset="-120"/>
               </a:rPr>
-              <a:t>컬러: 레드  ·  </a:t>
+              <a:t>종류: 당근  ·  재고 0개</a:t>
             </a:r>
             <a:pPr indent="0" marL="0">
               <a:buNone/>
@@ -12843,7 +12843,7 @@
                 <a:ea typeface="맑은 고딕" pitchFamily="34" charset="-122"/>
                 <a:cs typeface="맑은 고딕" pitchFamily="34" charset="-120"/>
               </a:rPr>
-              <a:t>재고 </a:t>
+              <a:t/>
             </a:r>
             <a:pPr indent="0" marL="0">
               <a:buNone/>
@@ -12857,7 +12857,7 @@
                 <a:ea typeface="맑은 고딕" pitchFamily="34" charset="-122"/>
                 <a:cs typeface="맑은 고딕" pitchFamily="34" charset="-120"/>
               </a:rPr>
-              <a:t>0개</a:t>
+              <a:t/>
             </a:r>
             <a:endParaRPr lang="en-US" sz="900" dirty="0"/>
           </a:p>
@@ -13010,7 +13010,7 @@
                 <a:ea typeface="맑은 고딕" pitchFamily="34" charset="-122"/>
                 <a:cs typeface="맑은 고딕" pitchFamily="34" charset="-120"/>
               </a:rPr>
-              <a:t>Miniature Refrigerator Magnet</a:t>
+              <a:t>Food Bottle Opener</a:t>
             </a:r>
             <a:endParaRPr lang="en-US" sz="1000" dirty="0"/>
           </a:p>
@@ -13049,7 +13049,7 @@
                 <a:ea typeface="맑은 고딕" pitchFamily="34" charset="-122"/>
                 <a:cs typeface="맑은 고딕" pitchFamily="34" charset="-120"/>
               </a:rPr>
-              <a:t>옵션: 엉덩이곰  ·  </a:t>
+              <a:t>종류: 치즈  ·  재고 0개</a:t>
             </a:r>
             <a:pPr indent="0" marL="0">
               <a:buNone/>
@@ -13063,7 +13063,7 @@
                 <a:ea typeface="맑은 고딕" pitchFamily="34" charset="-122"/>
                 <a:cs typeface="맑은 고딕" pitchFamily="34" charset="-120"/>
               </a:rPr>
-              <a:t>재고 </a:t>
+              <a:t/>
             </a:r>
             <a:pPr indent="0" marL="0">
               <a:buNone/>
@@ -13077,7 +13077,7 @@
                 <a:ea typeface="맑은 고딕" pitchFamily="34" charset="-122"/>
                 <a:cs typeface="맑은 고딕" pitchFamily="34" charset="-120"/>
               </a:rPr>
-              <a:t>0개</a:t>
+              <a:t/>
             </a:r>
             <a:endParaRPr lang="en-US" sz="900" dirty="0"/>
           </a:p>
@@ -13269,7 +13269,7 @@
                 <a:ea typeface="맑은 고딕" pitchFamily="34" charset="-122"/>
                 <a:cs typeface="맑은 고딕" pitchFamily="34" charset="-120"/>
               </a:rPr>
-              <a:t>컬러: 스노우화이트  ·  </a:t>
+              <a:t>컬러: 블랙  ·  재고 0개</a:t>
             </a:r>
             <a:pPr indent="0" marL="0">
               <a:buNone/>
@@ -13283,7 +13283,7 @@
                 <a:ea typeface="맑은 고딕" pitchFamily="34" charset="-122"/>
                 <a:cs typeface="맑은 고딕" pitchFamily="34" charset="-120"/>
               </a:rPr>
-              <a:t>재고 </a:t>
+              <a:t/>
             </a:r>
             <a:pPr indent="0" marL="0">
               <a:buNone/>
@@ -13297,7 +13297,7 @@
                 <a:ea typeface="맑은 고딕" pitchFamily="34" charset="-122"/>
                 <a:cs typeface="맑은 고딕" pitchFamily="34" charset="-120"/>
               </a:rPr>
-              <a:t>0개</a:t>
+              <a:t/>
             </a:r>
             <a:endParaRPr lang="en-US" sz="900" dirty="0"/>
           </a:p>
@@ -13489,7 +13489,7 @@
                 <a:ea typeface="맑은 고딕" pitchFamily="34" charset="-122"/>
                 <a:cs typeface="맑은 고딕" pitchFamily="34" charset="-120"/>
               </a:rPr>
-              <a:t>컬러: 블랙  ·  </a:t>
+              <a:t>컬러: 퍼플  ·  재고 0개</a:t>
             </a:r>
             <a:pPr indent="0" marL="0">
               <a:buNone/>
@@ -13503,7 +13503,7 @@
                 <a:ea typeface="맑은 고딕" pitchFamily="34" charset="-122"/>
                 <a:cs typeface="맑은 고딕" pitchFamily="34" charset="-120"/>
               </a:rPr>
-              <a:t>재고 </a:t>
+              <a:t/>
             </a:r>
             <a:pPr indent="0" marL="0">
               <a:buNone/>
@@ -13517,7 +13517,7 @@
                 <a:ea typeface="맑은 고딕" pitchFamily="34" charset="-122"/>
                 <a:cs typeface="맑은 고딕" pitchFamily="34" charset="-120"/>
               </a:rPr>
-              <a:t>0개</a:t>
+              <a:t/>
             </a:r>
             <a:endParaRPr lang="en-US" sz="900" dirty="0"/>
           </a:p>
@@ -13556,7 +13556,7 @@
                 <a:ea typeface="맑은 고딕" pitchFamily="34" charset="-122"/>
                 <a:cs typeface="맑은 고딕" pitchFamily="34" charset="-120"/>
               </a:rPr>
-              <a:t>베스트 상품 리포트  ·  생성 2026-05-11 19:50</a:t>
+              <a:t>베스트 상품 리포트  ·  생성 2026-05-12 09:56</a:t>
             </a:r>
             <a:endParaRPr lang="en-US" sz="900" dirty="0"/>
           </a:p>
@@ -13769,7 +13769,7 @@
                 <a:ea typeface="맑은 고딕" pitchFamily="34" charset="-122"/>
                 <a:cs typeface="맑은 고딕" pitchFamily="34" charset="-120"/>
               </a:rPr>
-              <a:t>2026년 5월 11일 (월)</a:t>
+              <a:t>2026년 05월 12일 (화)</a:t>
             </a:r>
             <a:endParaRPr lang="en-US" sz="1200" dirty="0"/>
           </a:p>
@@ -13897,7 +13897,7 @@
                 <a:ea typeface="맑은 고딕" pitchFamily="34" charset="-122"/>
                 <a:cs typeface="맑은 고딕" pitchFamily="34" charset="-120"/>
               </a:rPr>
-              <a:t>🚨  </a:t>
+              <a:t>🚨  긴급 리오더 38건    ·    주의 리오더 5건    ·    오늘 발주 검토 필수</a:t>
             </a:r>
             <a:pPr indent="0" marL="0">
               <a:buNone/>
@@ -13911,7 +13911,7 @@
                 <a:ea typeface="맑은 고딕" pitchFamily="34" charset="-122"/>
                 <a:cs typeface="맑은 고딕" pitchFamily="34" charset="-120"/>
               </a:rPr>
-              <a:t>긴급 리오더 </a:t>
+              <a:t/>
             </a:r>
             <a:pPr indent="0" marL="0">
               <a:buNone/>
@@ -13925,7 +13925,7 @@
                 <a:ea typeface="맑은 고딕" pitchFamily="34" charset="-122"/>
                 <a:cs typeface="맑은 고딕" pitchFamily="34" charset="-120"/>
               </a:rPr>
-              <a:t>17건</a:t>
+              <a:t/>
             </a:r>
             <a:pPr indent="0" marL="0">
               <a:buNone/>
@@ -13939,7 +13939,7 @@
                 <a:ea typeface="맑은 고딕" pitchFamily="34" charset="-122"/>
                 <a:cs typeface="맑은 고딕" pitchFamily="34" charset="-120"/>
               </a:rPr>
-              <a:t>    ·    </a:t>
+              <a:t/>
             </a:r>
             <a:pPr indent="0" marL="0">
               <a:buNone/>
@@ -13953,7 +13953,7 @@
                 <a:ea typeface="맑은 고딕" pitchFamily="34" charset="-122"/>
                 <a:cs typeface="맑은 고딕" pitchFamily="34" charset="-120"/>
               </a:rPr>
-              <a:t>주의 리오더 </a:t>
+              <a:t/>
             </a:r>
             <a:pPr indent="0" marL="0">
               <a:buNone/>
@@ -13967,7 +13967,7 @@
                 <a:ea typeface="맑은 고딕" pitchFamily="34" charset="-122"/>
                 <a:cs typeface="맑은 고딕" pitchFamily="34" charset="-120"/>
               </a:rPr>
-              <a:t>7건</a:t>
+              <a:t/>
             </a:r>
             <a:pPr indent="0" marL="0">
               <a:buNone/>
@@ -13981,7 +13981,7 @@
                 <a:ea typeface="맑은 고딕" pitchFamily="34" charset="-122"/>
                 <a:cs typeface="맑은 고딕" pitchFamily="34" charset="-120"/>
               </a:rPr>
-              <a:t>    ·    </a:t>
+              <a:t/>
             </a:r>
             <a:pPr indent="0" marL="0">
               <a:buNone/>
@@ -13995,7 +13995,7 @@
                 <a:ea typeface="맑은 고딕" pitchFamily="34" charset="-122"/>
                 <a:cs typeface="맑은 고딕" pitchFamily="34" charset="-120"/>
               </a:rPr>
-              <a:t>오늘 발주 검토 필수</a:t>
+              <a:t/>
             </a:r>
             <a:endParaRPr lang="en-US" sz="1800" dirty="0"/>
           </a:p>
@@ -14595,7 +14595,7 @@
                           <a:ea typeface="맑은 고딕" pitchFamily="34" charset="-122"/>
                           <a:cs typeface="맑은 고딕" pitchFamily="34" charset="-120"/>
                         </a:rPr>
-                        <a:t>Necklace</a:t>
+                        <a:t>Ring</a:t>
                       </a:r>
                       <a:endParaRPr lang="en-US" sz="1000" dirty="0">
                         <a:latin typeface="맑은 고딕" charset="0"/>
@@ -14663,7 +14663,7 @@
                           <a:ea typeface="맑은 고딕" pitchFamily="34" charset="-122"/>
                           <a:cs typeface="맑은 고딕" pitchFamily="34" charset="-120"/>
                         </a:rPr>
-                        <a:t>B-Flower Necklace (Size: 1 Size)</a:t>
+                        <a:t>[SILVER925] CH.alban Open Ring</a:t>
                       </a:r>
                       <a:endParaRPr lang="en-US" sz="1100" dirty="0">
                         <a:latin typeface="맑은 고딕" charset="0"/>
@@ -14731,7 +14731,7 @@
                           <a:ea typeface="맑은 고딕" pitchFamily="34" charset="-122"/>
                           <a:cs typeface="맑은 고딕" pitchFamily="34" charset="-120"/>
                         </a:rPr>
-                        <a:t>0</a:t>
+                        <a:t>1</a:t>
                       </a:r>
                       <a:endParaRPr lang="en-US" sz="1100" dirty="0">
                         <a:latin typeface="맑은 고딕" charset="0"/>
@@ -14799,7 +14799,7 @@
                           <a:ea typeface="맑은 고딕" pitchFamily="34" charset="-122"/>
                           <a:cs typeface="맑은 고딕" pitchFamily="34" charset="-120"/>
                         </a:rPr>
-                        <a:t>0 개</a:t>
+                        <a:t>2 개</a:t>
                       </a:r>
                       <a:endParaRPr lang="en-US" sz="1100" dirty="0">
                         <a:latin typeface="맑은 고딕" charset="0"/>
@@ -15005,7 +15005,7 @@
                           <a:ea typeface="맑은 고딕" pitchFamily="34" charset="-122"/>
                           <a:cs typeface="맑은 고딕" pitchFamily="34" charset="-120"/>
                         </a:rPr>
-                        <a:t>Ring</a:t>
+                        <a:t>Necklace</a:t>
                       </a:r>
                       <a:endParaRPr lang="en-US" sz="1000" dirty="0">
                         <a:latin typeface="맑은 고딕" charset="0"/>
@@ -15073,7 +15073,7 @@
                           <a:ea typeface="맑은 고딕" pitchFamily="34" charset="-122"/>
                           <a:cs typeface="맑은 고딕" pitchFamily="34" charset="-120"/>
                         </a:rPr>
-                        <a:t>[SILVER925] CH.alban Open Ring</a:t>
+                        <a:t>B-Flower Necklace (Size: 2 Size)</a:t>
                       </a:r>
                       <a:endParaRPr lang="en-US" sz="1100" dirty="0">
                         <a:latin typeface="맑은 고딕" charset="0"/>
@@ -15141,7 +15141,7 @@
                           <a:ea typeface="맑은 고딕" pitchFamily="34" charset="-122"/>
                           <a:cs typeface="맑은 고딕" pitchFamily="34" charset="-120"/>
                         </a:rPr>
-                        <a:t>0</a:t>
+                        <a:t>4</a:t>
                       </a:r>
                       <a:endParaRPr lang="en-US" sz="1100" dirty="0">
                         <a:latin typeface="맑은 고딕" charset="0"/>
@@ -15209,7 +15209,7 @@
                           <a:ea typeface="맑은 고딕" pitchFamily="34" charset="-122"/>
                           <a:cs typeface="맑은 고딕" pitchFamily="34" charset="-120"/>
                         </a:rPr>
-                        <a:t>2 개</a:t>
+                        <a:t>1 개</a:t>
                       </a:r>
                       <a:endParaRPr lang="en-US" sz="1100" dirty="0">
                         <a:latin typeface="맑은 고딕" charset="0"/>
@@ -15347,7 +15347,7 @@
                           <a:ea typeface="맑은 고딕" pitchFamily="34" charset="-122"/>
                           <a:cs typeface="맑은 고딕" pitchFamily="34" charset="-120"/>
                         </a:rPr>
-                        <a:t>PR</a:t>
+                        <a:t>CT</a:t>
                       </a:r>
                       <a:endParaRPr lang="en-US" sz="1100" dirty="0">
                         <a:latin typeface="맑은 고딕" charset="0"/>
@@ -15415,7 +15415,7 @@
                           <a:ea typeface="맑은 고딕" pitchFamily="34" charset="-122"/>
                           <a:cs typeface="맑은 고딕" pitchFamily="34" charset="-120"/>
                         </a:rPr>
-                        <a:t>-</a:t>
+                        <a:t>Necklace</a:t>
                       </a:r>
                       <a:endParaRPr lang="en-US" sz="1000" dirty="0">
                         <a:latin typeface="맑은 고딕" charset="0"/>
@@ -15483,7 +15483,7 @@
                           <a:ea typeface="맑은 고딕" pitchFamily="34" charset="-122"/>
                           <a:cs typeface="맑은 고딕" pitchFamily="34" charset="-120"/>
                         </a:rPr>
-                        <a:t>TRAVELER pouch bag (5color) (컬러: 레드)</a:t>
+                        <a:t>CandyPOP Necklace (사이즈: 1size (41.5~47cm))</a:t>
                       </a:r>
                       <a:endParaRPr lang="en-US" sz="1100" dirty="0">
                         <a:latin typeface="맑은 고딕" charset="0"/>
@@ -15619,7 +15619,7 @@
                           <a:ea typeface="맑은 고딕" pitchFamily="34" charset="-122"/>
                           <a:cs typeface="맑은 고딕" pitchFamily="34" charset="-120"/>
                         </a:rPr>
-                        <a:t>—</a:t>
+                        <a:t>1 개</a:t>
                       </a:r>
                       <a:endParaRPr lang="en-US" sz="1100" dirty="0">
                         <a:latin typeface="맑은 고딕" charset="0"/>
@@ -15825,7 +15825,7 @@
                           <a:ea typeface="맑은 고딕" pitchFamily="34" charset="-122"/>
                           <a:cs typeface="맑은 고딕" pitchFamily="34" charset="-120"/>
                         </a:rPr>
-                        <a:t>-</a:t>
+                        <a:t>ETC</a:t>
                       </a:r>
                       <a:endParaRPr lang="en-US" sz="1000" dirty="0">
                         <a:latin typeface="맑은 고딕" charset="0"/>
@@ -15893,7 +15893,7 @@
                           <a:ea typeface="맑은 고딕" pitchFamily="34" charset="-122"/>
                           <a:cs typeface="맑은 고딕" pitchFamily="34" charset="-120"/>
                         </a:rPr>
-                        <a:t>Miniature Refrigerator Magnet (옵션: 엉덩이곰)</a:t>
+                        <a:t>360° Rotating Phone Holder (컬러: 화이트)</a:t>
                       </a:r>
                       <a:endParaRPr lang="en-US" sz="1100" dirty="0">
                         <a:latin typeface="맑은 고딕" charset="0"/>
@@ -15961,7 +15961,7 @@
                           <a:ea typeface="맑은 고딕" pitchFamily="34" charset="-122"/>
                           <a:cs typeface="맑은 고딕" pitchFamily="34" charset="-120"/>
                         </a:rPr>
-                        <a:t>0</a:t>
+                        <a:t>17</a:t>
                       </a:r>
                       <a:endParaRPr lang="en-US" sz="1100" dirty="0">
                         <a:latin typeface="맑은 고딕" charset="0"/>
@@ -16029,7 +16029,7 @@
                           <a:ea typeface="맑은 고딕" pitchFamily="34" charset="-122"/>
                           <a:cs typeface="맑은 고딕" pitchFamily="34" charset="-120"/>
                         </a:rPr>
-                        <a:t>—</a:t>
+                        <a:t>1 개</a:t>
                       </a:r>
                       <a:endParaRPr lang="en-US" sz="1100" dirty="0">
                         <a:latin typeface="맑은 고딕" charset="0"/>
@@ -16167,7 +16167,7 @@
                           <a:ea typeface="맑은 고딕" pitchFamily="34" charset="-122"/>
                           <a:cs typeface="맑은 고딕" pitchFamily="34" charset="-120"/>
                         </a:rPr>
-                        <a:t>PR</a:t>
+                        <a:t>6A</a:t>
                       </a:r>
                       <a:endParaRPr lang="en-US" sz="1100" dirty="0">
                         <a:latin typeface="맑은 고딕" charset="0"/>
@@ -16235,7 +16235,7 @@
                           <a:ea typeface="맑은 고딕" pitchFamily="34" charset="-122"/>
                           <a:cs typeface="맑은 고딕" pitchFamily="34" charset="-120"/>
                         </a:rPr>
-                        <a:t>-</a:t>
+                        <a:t>★Season off★</a:t>
                       </a:r>
                       <a:endParaRPr lang="en-US" sz="1000" dirty="0">
                         <a:latin typeface="맑은 고딕" charset="0"/>
@@ -16303,7 +16303,7 @@
                           <a:ea typeface="맑은 고딕" pitchFamily="34" charset="-122"/>
                           <a:cs typeface="맑은 고딕" pitchFamily="34" charset="-120"/>
                         </a:rPr>
-                        <a:t>Light UV 99.9 Umbrella (7color) (컬러: 스노우화이트)</a:t>
+                        <a:t>Tangle Keychain</a:t>
                       </a:r>
                       <a:endParaRPr lang="en-US" sz="1100" dirty="0">
                         <a:latin typeface="맑은 고딕" charset="0"/>
@@ -16371,7 +16371,7 @@
                           <a:ea typeface="맑은 고딕" pitchFamily="34" charset="-122"/>
                           <a:cs typeface="맑은 고딕" pitchFamily="34" charset="-120"/>
                         </a:rPr>
-                        <a:t>0</a:t>
+                        <a:t>5</a:t>
                       </a:r>
                       <a:endParaRPr lang="en-US" sz="1100" dirty="0">
                         <a:latin typeface="맑은 고딕" charset="0"/>
@@ -16439,7 +16439,7 @@
                           <a:ea typeface="맑은 고딕" pitchFamily="34" charset="-122"/>
                           <a:cs typeface="맑은 고딕" pitchFamily="34" charset="-120"/>
                         </a:rPr>
-                        <a:t>—</a:t>
+                        <a:t>0 개</a:t>
                       </a:r>
                       <a:endParaRPr lang="en-US" sz="1100" dirty="0">
                         <a:latin typeface="맑은 고딕" charset="0"/>
@@ -16577,7 +16577,7 @@
                           <a:ea typeface="맑은 고딕" pitchFamily="34" charset="-122"/>
                           <a:cs typeface="맑은 고딕" pitchFamily="34" charset="-120"/>
                         </a:rPr>
-                        <a:t>PR</a:t>
+                        <a:t>6A</a:t>
                       </a:r>
                       <a:endParaRPr lang="en-US" sz="1100" dirty="0">
                         <a:latin typeface="맑은 고딕" charset="0"/>
@@ -16645,7 +16645,7 @@
                           <a:ea typeface="맑은 고딕" pitchFamily="34" charset="-122"/>
                           <a:cs typeface="맑은 고딕" pitchFamily="34" charset="-120"/>
                         </a:rPr>
-                        <a:t>-</a:t>
+                        <a:t>★Season off★</a:t>
                       </a:r>
                       <a:endParaRPr lang="en-US" sz="1000" dirty="0">
                         <a:latin typeface="맑은 고딕" charset="0"/>
@@ -16713,7 +16713,7 @@
                           <a:ea typeface="맑은 고딕" pitchFamily="34" charset="-122"/>
                           <a:cs typeface="맑은 고딕" pitchFamily="34" charset="-120"/>
                         </a:rPr>
-                        <a:t>Light UV 99.9 Umbrella (7color) (컬러: 블랙)</a:t>
+                        <a:t>8-Ball Smart Tok</a:t>
                       </a:r>
                       <a:endParaRPr lang="en-US" sz="1100" dirty="0">
                         <a:latin typeface="맑은 고딕" charset="0"/>
@@ -16781,7 +16781,7 @@
                           <a:ea typeface="맑은 고딕" pitchFamily="34" charset="-122"/>
                           <a:cs typeface="맑은 고딕" pitchFamily="34" charset="-120"/>
                         </a:rPr>
-                        <a:t>0</a:t>
+                        <a:t>5</a:t>
                       </a:r>
                       <a:endParaRPr lang="en-US" sz="1100" dirty="0">
                         <a:latin typeface="맑은 고딕" charset="0"/>
@@ -16849,7 +16849,7 @@
                           <a:ea typeface="맑은 고딕" pitchFamily="34" charset="-122"/>
                           <a:cs typeface="맑은 고딕" pitchFamily="34" charset="-120"/>
                         </a:rPr>
-                        <a:t>—</a:t>
+                        <a:t>0 개</a:t>
                       </a:r>
                       <a:endParaRPr lang="en-US" sz="1100" dirty="0">
                         <a:latin typeface="맑은 고딕" charset="0"/>
@@ -16987,7 +16987,7 @@
                           <a:ea typeface="맑은 고딕" pitchFamily="34" charset="-122"/>
                           <a:cs typeface="맑은 고딕" pitchFamily="34" charset="-120"/>
                         </a:rPr>
-                        <a:t>PR</a:t>
+                        <a:t>6A</a:t>
                       </a:r>
                       <a:endParaRPr lang="en-US" sz="1100" dirty="0">
                         <a:latin typeface="맑은 고딕" charset="0"/>
@@ -17055,7 +17055,7 @@
                           <a:ea typeface="맑은 고딕" pitchFamily="34" charset="-122"/>
                           <a:cs typeface="맑은 고딕" pitchFamily="34" charset="-120"/>
                         </a:rPr>
-                        <a:t>-</a:t>
+                        <a:t>Necklace</a:t>
                       </a:r>
                       <a:endParaRPr lang="en-US" sz="1000" dirty="0">
                         <a:latin typeface="맑은 고딕" charset="0"/>
@@ -17123,7 +17123,7 @@
                           <a:ea typeface="맑은 고딕" pitchFamily="34" charset="-122"/>
                           <a:cs typeface="맑은 고딕" pitchFamily="34" charset="-120"/>
                         </a:rPr>
-                        <a:t>Light UV 99.9 Umbrella (7color) (컬러: 퍼플)</a:t>
+                        <a:t>B-Flower Necklace (Size: 1 Size)</a:t>
                       </a:r>
                       <a:endParaRPr lang="en-US" sz="1100" dirty="0">
                         <a:latin typeface="맑은 고딕" charset="0"/>
@@ -17259,7 +17259,7 @@
                           <a:ea typeface="맑은 고딕" pitchFamily="34" charset="-122"/>
                           <a:cs typeface="맑은 고딕" pitchFamily="34" charset="-120"/>
                         </a:rPr>
-                        <a:t>—</a:t>
+                        <a:t>0 개</a:t>
                       </a:r>
                       <a:endParaRPr lang="en-US" sz="1100" dirty="0">
                         <a:latin typeface="맑은 고딕" charset="0"/>
@@ -17397,7 +17397,7 @@
                           <a:ea typeface="맑은 고딕" pitchFamily="34" charset="-122"/>
                           <a:cs typeface="맑은 고딕" pitchFamily="34" charset="-120"/>
                         </a:rPr>
-                        <a:t>PR</a:t>
+                        <a:t>CT</a:t>
                       </a:r>
                       <a:endParaRPr lang="en-US" sz="1100" dirty="0">
                         <a:latin typeface="맑은 고딕" charset="0"/>
@@ -17465,7 +17465,7 @@
                           <a:ea typeface="맑은 고딕" pitchFamily="34" charset="-122"/>
                           <a:cs typeface="맑은 고딕" pitchFamily="34" charset="-120"/>
                         </a:rPr>
-                        <a:t>-</a:t>
+                        <a:t>Ring</a:t>
                       </a:r>
                       <a:endParaRPr lang="en-US" sz="1000" dirty="0">
                         <a:latin typeface="맑은 고딕" charset="0"/>
@@ -17533,7 +17533,7 @@
                           <a:ea typeface="맑은 고딕" pitchFamily="34" charset="-122"/>
                           <a:cs typeface="맑은 고딕" pitchFamily="34" charset="-120"/>
                         </a:rPr>
-                        <a:t>Light UV 99.9 Umbrella (7color) (컬러: 베이지)</a:t>
+                        <a:t>"Whisow" 925 Open Ring</a:t>
                       </a:r>
                       <a:endParaRPr lang="en-US" sz="1100" dirty="0">
                         <a:latin typeface="맑은 고딕" charset="0"/>
@@ -17601,7 +17601,7 @@
                           <a:ea typeface="맑은 고딕" pitchFamily="34" charset="-122"/>
                           <a:cs typeface="맑은 고딕" pitchFamily="34" charset="-120"/>
                         </a:rPr>
-                        <a:t>0</a:t>
+                        <a:t>2</a:t>
                       </a:r>
                       <a:endParaRPr lang="en-US" sz="1100" dirty="0">
                         <a:latin typeface="맑은 고딕" charset="0"/>
@@ -17669,7 +17669,7 @@
                           <a:ea typeface="맑은 고딕" pitchFamily="34" charset="-122"/>
                           <a:cs typeface="맑은 고딕" pitchFamily="34" charset="-120"/>
                         </a:rPr>
-                        <a:t>—</a:t>
+                        <a:t>0 개</a:t>
                       </a:r>
                       <a:endParaRPr lang="en-US" sz="1100" dirty="0">
                         <a:latin typeface="맑은 고딕" charset="0"/>
@@ -17807,7 +17807,7 @@
                           <a:ea typeface="맑은 고딕" pitchFamily="34" charset="-122"/>
                           <a:cs typeface="맑은 고딕" pitchFamily="34" charset="-120"/>
                         </a:rPr>
-                        <a:t>PR</a:t>
+                        <a:t>CT</a:t>
                       </a:r>
                       <a:endParaRPr lang="en-US" sz="1100" dirty="0">
                         <a:latin typeface="맑은 고딕" charset="0"/>
@@ -17875,7 +17875,7 @@
                           <a:ea typeface="맑은 고딕" pitchFamily="34" charset="-122"/>
                           <a:cs typeface="맑은 고딕" pitchFamily="34" charset="-120"/>
                         </a:rPr>
-                        <a:t>-</a:t>
+                        <a:t>Ring</a:t>
                       </a:r>
                       <a:endParaRPr lang="en-US" sz="1000" dirty="0">
                         <a:latin typeface="맑은 고딕" charset="0"/>
@@ -17943,7 +17943,7 @@
                           <a:ea typeface="맑은 고딕" pitchFamily="34" charset="-122"/>
                           <a:cs typeface="맑은 고딕" pitchFamily="34" charset="-120"/>
                         </a:rPr>
-                        <a:t>Light UV 99.9 Umbrella (7color) (컬러: 네이비)</a:t>
+                        <a:t>"Socmall" 925 Open Ring</a:t>
                       </a:r>
                       <a:endParaRPr lang="en-US" sz="1100" dirty="0">
                         <a:latin typeface="맑은 고딕" charset="0"/>
@@ -18079,7 +18079,7 @@
                           <a:ea typeface="맑은 고딕" pitchFamily="34" charset="-122"/>
                           <a:cs typeface="맑은 고딕" pitchFamily="34" charset="-120"/>
                         </a:rPr>
-                        <a:t>—</a:t>
+                        <a:t>0 개</a:t>
                       </a:r>
                       <a:endParaRPr lang="en-US" sz="1100" dirty="0">
                         <a:latin typeface="맑은 고딕" charset="0"/>
@@ -18168,7 +18168,7 @@
                 <a:ea typeface="맑은 고딕" pitchFamily="34" charset="-122"/>
                 <a:cs typeface="맑은 고딕" pitchFamily="34" charset="-120"/>
               </a:rPr>
-              <a:t>외 15건 더 있음 — 상세는 시트에서 확인</a:t>
+              <a:t>외 29건 더 있음 — 상세는 시트에서 확인</a:t>
             </a:r>
             <a:endParaRPr lang="en-US" sz="1000" dirty="0"/>
           </a:p>
@@ -18207,7 +18207,7 @@
                 <a:ea typeface="맑은 고딕" pitchFamily="34" charset="-122"/>
                 <a:cs typeface="맑은 고딕" pitchFamily="34" charset="-120"/>
               </a:rPr>
-              <a:t>베스트 상품 리포트  ·  생성 2026-05-11 19:50</a:t>
+              <a:t>베스트 상품 리포트  ·  생성 2026-05-12 09:56</a:t>
             </a:r>
             <a:endParaRPr lang="en-US" sz="900" dirty="0"/>
           </a:p>
@@ -18420,7 +18420,7 @@
                 <a:ea typeface="맑은 고딕" pitchFamily="34" charset="-122"/>
                 <a:cs typeface="맑은 고딕" pitchFamily="34" charset="-120"/>
               </a:rPr>
-              <a:t>2026년 5월 11일 (월)</a:t>
+              <a:t>2026년 05월 12일 (화)</a:t>
             </a:r>
             <a:endParaRPr lang="en-US" sz="1200" dirty="0"/>
           </a:p>
@@ -18587,7 +18587,7 @@
                 <a:ea typeface="맑은 고딕" pitchFamily="34" charset="-122"/>
                 <a:cs typeface="맑은 고딕" pitchFamily="34" charset="-120"/>
               </a:rPr>
-              <a:t>Google Sheet '브랜드 재고현황'  ·  최신화 2026-05-11 19:50</a:t>
+              <a:t>Google Sheet '브랜드 재고현황'  ·  최신화 2026-05-12 09:56</a:t>
             </a:r>
             <a:endParaRPr lang="en-US" sz="1100" dirty="0"/>
           </a:p>
@@ -19099,7 +19099,7 @@
                 <a:ea typeface="맑은 고딕" pitchFamily="34" charset="-122"/>
                 <a:cs typeface="맑은 고딕" pitchFamily="34" charset="-120"/>
               </a:rPr>
-              <a:t>✅ 6A 82 SKU  /  ⚠ Cleartype 33 SKU (부분)  /  ⚠ Produktepr 169 SKU (재고만, 판매 미수집)</a:t>
+              <a:t>✅ 6A 82 SKU  /  ✅ Cleartype 49 SKU  /  ✅ Produktepr 192 SKU (판매 수집됨)</a:t>
             </a:r>
             <a:endParaRPr lang="en-US" sz="1100" dirty="0"/>
           </a:p>
@@ -19230,47 +19230,7 @@
                 <a:ea typeface="맑은 고딕" pitchFamily="34" charset="-122"/>
                 <a:cs typeface="맑은 고딕" pitchFamily="34" charset="-120"/>
               </a:rPr>
-              <a:t>메인 시트의 데이터량이 커서 한 번에 3개 탭 전체를 자동 추출하기 어렵습니다.</a:t>
-            </a:r>
-            <a:endParaRPr lang="en-US" sz="1000" dirty="0"/>
-          </a:p>
-          <a:p>
-            <a:pPr indent="0" marL="0">
-              <a:spcAft>
-                <a:spcPts val="200"/>
-              </a:spcAft>
-              <a:buNone/>
-            </a:pPr>
-            <a:r>
-              <a:rPr lang="en-US" sz="1000" dirty="0">
-                <a:solidFill>
-                  <a:srgbClr val="1F2937"/>
-                </a:solidFill>
-                <a:latin typeface="맑은 고딕" pitchFamily="34" charset="0"/>
-                <a:ea typeface="맑은 고딕" pitchFamily="34" charset="-122"/>
-                <a:cs typeface="맑은 고딕" pitchFamily="34" charset="-120"/>
-              </a:rPr>
-              <a:t>  → 6A: 전체 추출 OK   Cleartype: 부분 추출 (TOP 노출 위주)   Produktepr: 별도 인벤토리 파일에서 재고만</a:t>
-            </a:r>
-            <a:endParaRPr lang="en-US" sz="1000" dirty="0"/>
-          </a:p>
-          <a:p>
-            <a:pPr indent="0" marL="0">
-              <a:spcAft>
-                <a:spcPts val="200"/>
-              </a:spcAft>
-              <a:buNone/>
-            </a:pPr>
-            <a:r>
-              <a:rPr lang="en-US" sz="1000" dirty="0">
-                <a:solidFill>
-                  <a:srgbClr val="1F2937"/>
-                </a:solidFill>
-                <a:latin typeface="맑은 고딕" pitchFamily="34" charset="0"/>
-                <a:ea typeface="맑은 고딕" pitchFamily="34" charset="-122"/>
-                <a:cs typeface="맑은 고딕" pitchFamily="34" charset="-120"/>
-              </a:rPr>
-              <a:t>  매일 8시 자동 실행 시 추출 가능한 만큼 분석하고, 누락분은 시트에서 직접 확인 부탁드려요.</a:t>
+              <a:t>✅ 3개 브랜드 모두 정상 추출 — 데이터 손실 없음</a:t>
             </a:r>
             <a:endParaRPr lang="en-US" sz="1000" dirty="0"/>
           </a:p>
@@ -19309,7 +19269,7 @@
                 <a:ea typeface="맑은 고딕" pitchFamily="34" charset="-122"/>
                 <a:cs typeface="맑은 고딕" pitchFamily="34" charset="-120"/>
               </a:rPr>
-              <a:t>베스트 상품 리포트  ·  생성 2026-05-11 19:50</a:t>
+              <a:t>베스트 상품 리포트  ·  생성 2026-05-12 09:56</a:t>
             </a:r>
             <a:endParaRPr lang="en-US" sz="900" dirty="0"/>
           </a:p>

</xml_diff>

<commit_message>
chore: 매출 PPT 업로드 (best-sellers-2026-05-12.pptx) — Phase 2 테스트
</commit_message>
<xml_diff>
--- a/data/sales-report.pptx
+++ b/data/sales-report.pptx
@@ -1804,7 +1804,7 @@
                 <a:ea typeface="맑은 고딕" pitchFamily="34" charset="-122"/>
                 <a:cs typeface="맑은 고딕" pitchFamily="34" charset="-120"/>
               </a:rPr>
-              <a:t>생성 2026-05-12 09:56  ·  Google Sheet 자동 동기</a:t>
+              <a:t>생성 2026-05-12 11:12  ·  Google Sheet 자동 동기</a:t>
             </a:r>
             <a:endParaRPr lang="en-US" sz="1000" dirty="0"/>
           </a:p>
@@ -2145,7 +2145,7 @@
                 <a:ea typeface="맑은 고딕" pitchFamily="34" charset="-122"/>
                 <a:cs typeface="맑은 고딕" pitchFamily="34" charset="-120"/>
               </a:rPr>
-              <a:t>212 개</a:t>
+              <a:t>3 개</a:t>
             </a:r>
             <a:endParaRPr lang="en-US" sz="3600" dirty="0"/>
           </a:p>
@@ -2479,7 +2479,7 @@
                 <a:ea typeface="맑은 고딕" pitchFamily="34" charset="-122"/>
                 <a:cs typeface="맑은 고딕" pitchFamily="34" charset="-120"/>
               </a:rPr>
-              <a:t>5 건</a:t>
+              <a:t>4 건</a:t>
             </a:r>
             <a:endParaRPr lang="en-US" sz="3200" dirty="0"/>
           </a:p>
@@ -3612,7 +3612,7 @@
                           <a:ea typeface="맑은 고딕" pitchFamily="34" charset="-122"/>
                           <a:cs typeface="맑은 고딕" pitchFamily="34" charset="-120"/>
                         </a:rPr>
-                        <a:t>[SILVER925] Guyeong Open Ring v3.0 (silver)</a:t>
+                        <a:t>[SILVER925] Glacier Open Ring</a:t>
                       </a:r>
                       <a:endParaRPr lang="en-US" sz="1100" dirty="0">
                         <a:latin typeface="맑은 고딕" charset="0"/>
@@ -3677,7 +3677,7 @@
                           <a:ea typeface="맑은 고딕" pitchFamily="34" charset="-122"/>
                           <a:cs typeface="맑은 고딕" pitchFamily="34" charset="-120"/>
                         </a:rPr>
-                        <a:t>27 개</a:t>
+                        <a:t>1 개</a:t>
                       </a:r>
                       <a:endParaRPr lang="en-US" sz="1400" dirty="0">
                         <a:latin typeface="맑은 고딕" charset="0"/>
@@ -3939,7 +3939,7 @@
                           <a:ea typeface="맑은 고딕" pitchFamily="34" charset="-122"/>
                           <a:cs typeface="맑은 고딕" pitchFamily="34" charset="-120"/>
                         </a:rPr>
-                        <a:t>Marquise Necklace</a:t>
+                        <a:t>Polaris Necklace</a:t>
                       </a:r>
                       <a:endParaRPr lang="en-US" sz="1100" dirty="0">
                         <a:latin typeface="맑은 고딕" charset="0"/>
@@ -4004,7 +4004,7 @@
                           <a:ea typeface="맑은 고딕" pitchFamily="34" charset="-122"/>
                           <a:cs typeface="맑은 고딕" pitchFamily="34" charset="-120"/>
                         </a:rPr>
-                        <a:t>17 개</a:t>
+                        <a:t>1 개</a:t>
                       </a:r>
                       <a:endParaRPr lang="en-US" sz="1400" dirty="0">
                         <a:latin typeface="맑은 고딕" charset="0"/>
@@ -4266,7 +4266,7 @@
                           <a:ea typeface="맑은 고딕" pitchFamily="34" charset="-122"/>
                           <a:cs typeface="맑은 고딕" pitchFamily="34" charset="-120"/>
                         </a:rPr>
-                        <a:t>[SILVER925] Eramam Open Ring</a:t>
+                        <a:t>[SILVER925] CH.alban Open Ring</a:t>
                       </a:r>
                       <a:endParaRPr lang="en-US" sz="1100" dirty="0">
                         <a:latin typeface="맑은 고딕" charset="0"/>
@@ -4331,7 +4331,7 @@
                           <a:ea typeface="맑은 고딕" pitchFamily="34" charset="-122"/>
                           <a:cs typeface="맑은 고딕" pitchFamily="34" charset="-120"/>
                         </a:rPr>
-                        <a:t>14 개</a:t>
+                        <a:t>1 개</a:t>
                       </a:r>
                       <a:endParaRPr lang="en-US" sz="1400" dirty="0">
                         <a:latin typeface="맑은 고딕" charset="0"/>
@@ -4398,7 +4398,7 @@
                           <a:ea typeface="맑은 고딕" pitchFamily="34" charset="-122"/>
                           <a:cs typeface="맑은 고딕" pitchFamily="34" charset="-120"/>
                         </a:rPr>
-                        <a:t>4</a:t>
+                        <a:t/>
                       </a:r>
                       <a:endParaRPr lang="en-US" sz="1100" dirty="0">
                         <a:latin typeface="맑은 고딕" charset="0"/>
@@ -4463,7 +4463,7 @@
                           <a:ea typeface="맑은 고딕" pitchFamily="34" charset="-122"/>
                           <a:cs typeface="맑은 고딕" pitchFamily="34" charset="-120"/>
                         </a:rPr>
-                        <a:t>6A</a:t>
+                        <a:t/>
                       </a:r>
                       <a:endParaRPr lang="en-US" sz="1100" dirty="0">
                         <a:latin typeface="맑은 고딕" charset="0"/>
@@ -4528,7 +4528,7 @@
                           <a:ea typeface="맑은 고딕" pitchFamily="34" charset="-122"/>
                           <a:cs typeface="맑은 고딕" pitchFamily="34" charset="-120"/>
                         </a:rPr>
-                        <a:t>Ring</a:t>
+                        <a:t/>
                       </a:r>
                       <a:endParaRPr lang="en-US" sz="1000" dirty="0">
                         <a:latin typeface="맑은 고딕" charset="0"/>
@@ -4593,7 +4593,7 @@
                           <a:ea typeface="맑은 고딕" pitchFamily="34" charset="-122"/>
                           <a:cs typeface="맑은 고딕" pitchFamily="34" charset="-120"/>
                         </a:rPr>
-                        <a:t>[SILVER925] Starly Open Ring</a:t>
+                        <a:t/>
                       </a:r>
                       <a:endParaRPr lang="en-US" sz="1100" dirty="0">
                         <a:latin typeface="맑은 고딕" charset="0"/>
@@ -4658,7 +4658,7 @@
                           <a:ea typeface="맑은 고딕" pitchFamily="34" charset="-122"/>
                           <a:cs typeface="맑은 고딕" pitchFamily="34" charset="-120"/>
                         </a:rPr>
-                        <a:t>12 개</a:t>
+                        <a:t/>
                       </a:r>
                       <a:endParaRPr lang="en-US" sz="1200" dirty="0">
                         <a:latin typeface="맑은 고딕" charset="0"/>
@@ -4725,7 +4725,7 @@
                           <a:ea typeface="맑은 고딕" pitchFamily="34" charset="-122"/>
                           <a:cs typeface="맑은 고딕" pitchFamily="34" charset="-120"/>
                         </a:rPr>
-                        <a:t>5</a:t>
+                        <a:t/>
                       </a:r>
                       <a:endParaRPr lang="en-US" sz="1100" dirty="0">
                         <a:latin typeface="맑은 고딕" charset="0"/>
@@ -4790,7 +4790,7 @@
                           <a:ea typeface="맑은 고딕" pitchFamily="34" charset="-122"/>
                           <a:cs typeface="맑은 고딕" pitchFamily="34" charset="-120"/>
                         </a:rPr>
-                        <a:t>6A</a:t>
+                        <a:t/>
                       </a:r>
                       <a:endParaRPr lang="en-US" sz="1100" dirty="0">
                         <a:latin typeface="맑은 고딕" charset="0"/>
@@ -4855,7 +4855,7 @@
                           <a:ea typeface="맑은 고딕" pitchFamily="34" charset="-122"/>
                           <a:cs typeface="맑은 고딕" pitchFamily="34" charset="-120"/>
                         </a:rPr>
-                        <a:t>Necklace</a:t>
+                        <a:t/>
                       </a:r>
                       <a:endParaRPr lang="en-US" sz="1000" dirty="0">
                         <a:latin typeface="맑은 고딕" charset="0"/>
@@ -4920,7 +4920,7 @@
                           <a:ea typeface="맑은 고딕" pitchFamily="34" charset="-122"/>
                           <a:cs typeface="맑은 고딕" pitchFamily="34" charset="-120"/>
                         </a:rPr>
-                        <a:t>Tiny Cross Necklace</a:t>
+                        <a:t/>
                       </a:r>
                       <a:endParaRPr lang="en-US" sz="1100" dirty="0">
                         <a:latin typeface="맑은 고딕" charset="0"/>
@@ -4985,7 +4985,7 @@
                           <a:ea typeface="맑은 고딕" pitchFamily="34" charset="-122"/>
                           <a:cs typeface="맑은 고딕" pitchFamily="34" charset="-120"/>
                         </a:rPr>
-                        <a:t>9 개</a:t>
+                        <a:t/>
                       </a:r>
                       <a:endParaRPr lang="en-US" sz="1200" dirty="0">
                         <a:latin typeface="맑은 고딕" charset="0"/>
@@ -5071,7 +5071,7 @@
                 <a:ea typeface="맑은 고딕" pitchFamily="34" charset="-122"/>
                 <a:cs typeface="맑은 고딕" pitchFamily="34" charset="-120"/>
               </a:rPr>
-              <a:t>베스트 상품 리포트  ·  생성 2026-05-12 09:56</a:t>
+              <a:t>베스트 상품 리포트  ·  생성 2026-05-12 11:12</a:t>
             </a:r>
             <a:endParaRPr lang="en-US" sz="900" dirty="0"/>
           </a:p>
@@ -5451,7 +5451,7 @@
                 <a:ea typeface="맑은 고딕" pitchFamily="34" charset="-122"/>
                 <a:cs typeface="맑은 고딕" pitchFamily="34" charset="-120"/>
               </a:rPr>
-              <a:t>182 개</a:t>
+              <a:t>3 개</a:t>
             </a:r>
             <a:endParaRPr lang="en-US" sz="3600" dirty="0"/>
           </a:p>
@@ -5579,7 +5579,7 @@
                 <a:ea typeface="맑은 고딕" pitchFamily="34" charset="-122"/>
                 <a:cs typeface="맑은 고딕" pitchFamily="34" charset="-120"/>
               </a:rPr>
-              <a:t>[SILVER925] Guyeong Open Ring v3.0 (silver)</a:t>
+              <a:t>[SILVER925] Glacier Open Ring</a:t>
             </a:r>
             <a:endParaRPr lang="en-US" sz="1800" dirty="0"/>
           </a:p>
@@ -5657,7 +5657,7 @@
                 <a:ea typeface="맑은 고딕" pitchFamily="34" charset="-122"/>
                 <a:cs typeface="맑은 고딕" pitchFamily="34" charset="-120"/>
               </a:rPr>
-              <a:t>27</a:t>
+              <a:t>1</a:t>
             </a:r>
             <a:endParaRPr lang="en-US" sz="4400" dirty="0"/>
           </a:p>
@@ -6191,7 +6191,7 @@
                           <a:ea typeface="맑은 고딕" pitchFamily="34" charset="-122"/>
                           <a:cs typeface="맑은 고딕" pitchFamily="34" charset="-120"/>
                         </a:rPr>
-                        <a:t>[SILVER925] Guyeong Open Ring v3.0 (silver)</a:t>
+                        <a:t>[SILVER925] Glacier Open Ring</a:t>
                       </a:r>
                       <a:endParaRPr lang="en-US" sz="1100" dirty="0">
                         <a:latin typeface="맑은 고딕" charset="0"/>
@@ -6256,7 +6256,7 @@
                           <a:ea typeface="맑은 고딕" pitchFamily="34" charset="-122"/>
                           <a:cs typeface="맑은 고딕" pitchFamily="34" charset="-120"/>
                         </a:rPr>
-                        <a:t>27 개</a:t>
+                        <a:t>1 개</a:t>
                       </a:r>
                       <a:endParaRPr lang="en-US" sz="1400" dirty="0">
                         <a:latin typeface="맑은 고딕" charset="0"/>
@@ -6453,7 +6453,7 @@
                           <a:ea typeface="맑은 고딕" pitchFamily="34" charset="-122"/>
                           <a:cs typeface="맑은 고딕" pitchFamily="34" charset="-120"/>
                         </a:rPr>
-                        <a:t>Marquise Necklace</a:t>
+                        <a:t>Polaris Necklace</a:t>
                       </a:r>
                       <a:endParaRPr lang="en-US" sz="1100" dirty="0">
                         <a:latin typeface="맑은 고딕" charset="0"/>
@@ -6518,7 +6518,7 @@
                           <a:ea typeface="맑은 고딕" pitchFamily="34" charset="-122"/>
                           <a:cs typeface="맑은 고딕" pitchFamily="34" charset="-120"/>
                         </a:rPr>
-                        <a:t>17 개</a:t>
+                        <a:t>1 개</a:t>
                       </a:r>
                       <a:endParaRPr lang="en-US" sz="1200" dirty="0">
                         <a:latin typeface="맑은 고딕" charset="0"/>
@@ -6715,7 +6715,7 @@
                           <a:ea typeface="맑은 고딕" pitchFamily="34" charset="-122"/>
                           <a:cs typeface="맑은 고딕" pitchFamily="34" charset="-120"/>
                         </a:rPr>
-                        <a:t>[SILVER925] Eramam Open Ring</a:t>
+                        <a:t>[SILVER925] CH.alban Open Ring</a:t>
                       </a:r>
                       <a:endParaRPr lang="en-US" sz="1100" dirty="0">
                         <a:latin typeface="맑은 고딕" charset="0"/>
@@ -6780,7 +6780,7 @@
                           <a:ea typeface="맑은 고딕" pitchFamily="34" charset="-122"/>
                           <a:cs typeface="맑은 고딕" pitchFamily="34" charset="-120"/>
                         </a:rPr>
-                        <a:t>14 개</a:t>
+                        <a:t>1 개</a:t>
                       </a:r>
                       <a:endParaRPr lang="en-US" sz="1200" dirty="0">
                         <a:latin typeface="맑은 고딕" charset="0"/>
@@ -6847,7 +6847,7 @@
                           <a:ea typeface="맑은 고딕" pitchFamily="34" charset="-122"/>
                           <a:cs typeface="맑은 고딕" pitchFamily="34" charset="-120"/>
                         </a:rPr>
-                        <a:t>4</a:t>
+                        <a:t/>
                       </a:r>
                       <a:endParaRPr lang="en-US" sz="1100" dirty="0">
                         <a:latin typeface="맑은 고딕" charset="0"/>
@@ -6912,7 +6912,7 @@
                           <a:ea typeface="맑은 고딕" pitchFamily="34" charset="-122"/>
                           <a:cs typeface="맑은 고딕" pitchFamily="34" charset="-120"/>
                         </a:rPr>
-                        <a:t>Ring</a:t>
+                        <a:t/>
                       </a:r>
                       <a:endParaRPr lang="en-US" sz="1000" dirty="0">
                         <a:latin typeface="맑은 고딕" charset="0"/>
@@ -6977,7 +6977,7 @@
                           <a:ea typeface="맑은 고딕" pitchFamily="34" charset="-122"/>
                           <a:cs typeface="맑은 고딕" pitchFamily="34" charset="-120"/>
                         </a:rPr>
-                        <a:t>[SILVER925] Starly Open Ring</a:t>
+                        <a:t/>
                       </a:r>
                       <a:endParaRPr lang="en-US" sz="1100" dirty="0">
                         <a:latin typeface="맑은 고딕" charset="0"/>
@@ -7042,7 +7042,7 @@
                           <a:ea typeface="맑은 고딕" pitchFamily="34" charset="-122"/>
                           <a:cs typeface="맑은 고딕" pitchFamily="34" charset="-120"/>
                         </a:rPr>
-                        <a:t>12 개</a:t>
+                        <a:t/>
                       </a:r>
                       <a:endParaRPr lang="en-US" sz="1200" dirty="0">
                         <a:latin typeface="맑은 고딕" charset="0"/>
@@ -7109,7 +7109,7 @@
                           <a:ea typeface="맑은 고딕" pitchFamily="34" charset="-122"/>
                           <a:cs typeface="맑은 고딕" pitchFamily="34" charset="-120"/>
                         </a:rPr>
-                        <a:t>5</a:t>
+                        <a:t/>
                       </a:r>
                       <a:endParaRPr lang="en-US" sz="1100" dirty="0">
                         <a:latin typeface="맑은 고딕" charset="0"/>
@@ -7174,7 +7174,7 @@
                           <a:ea typeface="맑은 고딕" pitchFamily="34" charset="-122"/>
                           <a:cs typeface="맑은 고딕" pitchFamily="34" charset="-120"/>
                         </a:rPr>
-                        <a:t>Necklace</a:t>
+                        <a:t/>
                       </a:r>
                       <a:endParaRPr lang="en-US" sz="1000" dirty="0">
                         <a:latin typeface="맑은 고딕" charset="0"/>
@@ -7239,7 +7239,7 @@
                           <a:ea typeface="맑은 고딕" pitchFamily="34" charset="-122"/>
                           <a:cs typeface="맑은 고딕" pitchFamily="34" charset="-120"/>
                         </a:rPr>
-                        <a:t>Tiny Cross Necklace</a:t>
+                        <a:t/>
                       </a:r>
                       <a:endParaRPr lang="en-US" sz="1100" dirty="0">
                         <a:latin typeface="맑은 고딕" charset="0"/>
@@ -7304,7 +7304,7 @@
                           <a:ea typeface="맑은 고딕" pitchFamily="34" charset="-122"/>
                           <a:cs typeface="맑은 고딕" pitchFamily="34" charset="-120"/>
                         </a:rPr>
-                        <a:t>9 개</a:t>
+                        <a:t/>
                       </a:r>
                       <a:endParaRPr lang="en-US" sz="1200" dirty="0">
                         <a:latin typeface="맑은 고딕" charset="0"/>
@@ -7596,7 +7596,7 @@
                 <a:ea typeface="맑은 고딕" pitchFamily="34" charset="-122"/>
                 <a:cs typeface="맑은 고딕" pitchFamily="34" charset="-120"/>
               </a:rPr>
-              <a:t>Ring  ·  재고 1개</a:t>
+              <a:t>Ring  ·  재고 0개</a:t>
             </a:r>
             <a:pPr indent="0" marL="0">
               <a:buNone/>
@@ -7763,6 +7763,418 @@
                 <a:ea typeface="맑은 고딕" pitchFamily="34" charset="-122"/>
                 <a:cs typeface="맑은 고딕" pitchFamily="34" charset="-120"/>
               </a:rPr>
+              <a:t>Tangle Keychain</a:t>
+            </a:r>
+            <a:endParaRPr lang="en-US" sz="1100" dirty="0"/>
+          </a:p>
+        </p:txBody>
+      </p:sp>
+      <p:sp>
+        <p:nvSpPr>
+          <p:cNvPr id="32" name="Text 29"/>
+          <p:cNvSpPr/>
+          <p:nvPr/>
+        </p:nvSpPr>
+        <p:spPr>
+          <a:xfrm>
+            <a:off x="8211312" y="4425696"/>
+            <a:ext cx="3291840" cy="256032"/>
+          </a:xfrm>
+          <a:prstGeom prst="rect">
+            <a:avLst/>
+          </a:prstGeom>
+          <a:noFill/>
+          <a:ln/>
+        </p:spPr>
+        <p:txBody>
+          <a:bodyPr wrap="square" lIns="0" tIns="0" rIns="0" bIns="0" rtlCol="0" anchor="ctr"/>
+          <a:lstStyle/>
+          <a:p>
+            <a:pPr indent="0" marL="0">
+              <a:buNone/>
+            </a:pPr>
+            <a:r>
+              <a:rPr lang="en-US" sz="1000" dirty="0">
+                <a:solidFill>
+                  <a:srgbClr val="6B7280"/>
+                </a:solidFill>
+                <a:latin typeface="맑은 고딕" pitchFamily="34" charset="0"/>
+                <a:ea typeface="맑은 고딕" pitchFamily="34" charset="-122"/>
+                <a:cs typeface="맑은 고딕" pitchFamily="34" charset="-120"/>
+              </a:rPr>
+              <a:t>★Season off★  ·  재고 5개</a:t>
+            </a:r>
+            <a:pPr indent="0" marL="0">
+              <a:buNone/>
+            </a:pPr>
+            <a:r>
+              <a:rPr lang="en-US" sz="1000" b="1" dirty="0">
+                <a:solidFill>
+                  <a:srgbClr val="D72638"/>
+                </a:solidFill>
+                <a:latin typeface="맑은 고딕" pitchFamily="34" charset="0"/>
+                <a:ea typeface="맑은 고딕" pitchFamily="34" charset="-122"/>
+                <a:cs typeface="맑은 고딕" pitchFamily="34" charset="-120"/>
+              </a:rPr>
+              <a:t/>
+            </a:r>
+            <a:endParaRPr lang="en-US" sz="1000" dirty="0"/>
+          </a:p>
+        </p:txBody>
+      </p:sp>
+      <p:sp>
+        <p:nvSpPr>
+          <p:cNvPr id="33" name="Shape 30"/>
+          <p:cNvSpPr/>
+          <p:nvPr/>
+        </p:nvSpPr>
+        <p:spPr>
+          <a:xfrm>
+            <a:off x="7406640" y="4809744"/>
+            <a:ext cx="4206240" cy="640080"/>
+          </a:xfrm>
+          <a:prstGeom prst="rect">
+            <a:avLst/>
+          </a:prstGeom>
+          <a:solidFill>
+            <a:srgbClr val="FFF5F5"/>
+          </a:solidFill>
+          <a:ln w="6350">
+            <a:solidFill>
+              <a:srgbClr val="E5E7EB"/>
+            </a:solidFill>
+            <a:prstDash val="solid"/>
+          </a:ln>
+        </p:spPr>
+      </p:sp>
+      <p:sp>
+        <p:nvSpPr>
+          <p:cNvPr id="34" name="Shape 31"/>
+          <p:cNvSpPr/>
+          <p:nvPr/>
+        </p:nvSpPr>
+        <p:spPr>
+          <a:xfrm>
+            <a:off x="7406640" y="4809744"/>
+            <a:ext cx="109728" cy="640080"/>
+          </a:xfrm>
+          <a:prstGeom prst="rect">
+            <a:avLst/>
+          </a:prstGeom>
+          <a:solidFill>
+            <a:srgbClr val="D72638"/>
+          </a:solidFill>
+          <a:ln w="12700">
+            <a:solidFill>
+              <a:srgbClr val="D72638"/>
+            </a:solidFill>
+            <a:prstDash val="solid"/>
+          </a:ln>
+        </p:spPr>
+      </p:sp>
+      <p:sp>
+        <p:nvSpPr>
+          <p:cNvPr id="35" name="Shape 32"/>
+          <p:cNvSpPr/>
+          <p:nvPr/>
+        </p:nvSpPr>
+        <p:spPr>
+          <a:xfrm>
+            <a:off x="7571232" y="4901184"/>
+            <a:ext cx="548640" cy="256032"/>
+          </a:xfrm>
+          <a:prstGeom prst="rect">
+            <a:avLst/>
+          </a:prstGeom>
+          <a:solidFill>
+            <a:srgbClr val="D72638"/>
+          </a:solidFill>
+          <a:ln w="12700">
+            <a:solidFill>
+              <a:srgbClr val="D72638"/>
+            </a:solidFill>
+            <a:prstDash val="solid"/>
+          </a:ln>
+        </p:spPr>
+      </p:sp>
+      <p:sp>
+        <p:nvSpPr>
+          <p:cNvPr id="36" name="Text 33"/>
+          <p:cNvSpPr/>
+          <p:nvPr/>
+        </p:nvSpPr>
+        <p:spPr>
+          <a:xfrm>
+            <a:off x="7571232" y="4901184"/>
+            <a:ext cx="548640" cy="256032"/>
+          </a:xfrm>
+          <a:prstGeom prst="rect">
+            <a:avLst/>
+          </a:prstGeom>
+          <a:noFill/>
+          <a:ln/>
+        </p:spPr>
+        <p:txBody>
+          <a:bodyPr wrap="square" lIns="0" tIns="0" rIns="0" bIns="0" rtlCol="0" anchor="ctr"/>
+          <a:lstStyle/>
+          <a:p>
+            <a:pPr algn="ctr" indent="0" marL="0">
+              <a:buNone/>
+            </a:pPr>
+            <a:r>
+              <a:rPr lang="en-US" sz="900" b="1" dirty="0">
+                <a:solidFill>
+                  <a:srgbClr val="FFFFFF"/>
+                </a:solidFill>
+                <a:latin typeface="맑은 고딕" pitchFamily="34" charset="0"/>
+                <a:ea typeface="맑은 고딕" pitchFamily="34" charset="-122"/>
+                <a:cs typeface="맑은 고딕" pitchFamily="34" charset="-120"/>
+              </a:rPr>
+              <a:t>긴급</a:t>
+            </a:r>
+            <a:endParaRPr lang="en-US" sz="900" dirty="0"/>
+          </a:p>
+        </p:txBody>
+      </p:sp>
+      <p:sp>
+        <p:nvSpPr>
+          <p:cNvPr id="37" name="Text 34"/>
+          <p:cNvSpPr/>
+          <p:nvPr/>
+        </p:nvSpPr>
+        <p:spPr>
+          <a:xfrm>
+            <a:off x="8211312" y="4864608"/>
+            <a:ext cx="3291840" cy="274320"/>
+          </a:xfrm>
+          <a:prstGeom prst="rect">
+            <a:avLst/>
+          </a:prstGeom>
+          <a:noFill/>
+          <a:ln/>
+        </p:spPr>
+        <p:txBody>
+          <a:bodyPr wrap="square" lIns="0" tIns="0" rIns="0" bIns="0" rtlCol="0" anchor="ctr"/>
+          <a:lstStyle/>
+          <a:p>
+            <a:pPr indent="0" marL="0">
+              <a:buNone/>
+            </a:pPr>
+            <a:r>
+              <a:rPr lang="en-US" sz="1100" b="1" dirty="0">
+                <a:solidFill>
+                  <a:srgbClr val="0B1220"/>
+                </a:solidFill>
+                <a:latin typeface="맑은 고딕" pitchFamily="34" charset="0"/>
+                <a:ea typeface="맑은 고딕" pitchFamily="34" charset="-122"/>
+                <a:cs typeface="맑은 고딕" pitchFamily="34" charset="-120"/>
+              </a:rPr>
+              <a:t>8-Ball Smart Tok</a:t>
+            </a:r>
+            <a:endParaRPr lang="en-US" sz="1100" dirty="0"/>
+          </a:p>
+        </p:txBody>
+      </p:sp>
+      <p:sp>
+        <p:nvSpPr>
+          <p:cNvPr id="38" name="Text 35"/>
+          <p:cNvSpPr/>
+          <p:nvPr/>
+        </p:nvSpPr>
+        <p:spPr>
+          <a:xfrm>
+            <a:off x="8211312" y="5138928"/>
+            <a:ext cx="3291840" cy="256032"/>
+          </a:xfrm>
+          <a:prstGeom prst="rect">
+            <a:avLst/>
+          </a:prstGeom>
+          <a:noFill/>
+          <a:ln/>
+        </p:spPr>
+        <p:txBody>
+          <a:bodyPr wrap="square" lIns="0" tIns="0" rIns="0" bIns="0" rtlCol="0" anchor="ctr"/>
+          <a:lstStyle/>
+          <a:p>
+            <a:pPr indent="0" marL="0">
+              <a:buNone/>
+            </a:pPr>
+            <a:r>
+              <a:rPr lang="en-US" sz="1000" dirty="0">
+                <a:solidFill>
+                  <a:srgbClr val="6B7280"/>
+                </a:solidFill>
+                <a:latin typeface="맑은 고딕" pitchFamily="34" charset="0"/>
+                <a:ea typeface="맑은 고딕" pitchFamily="34" charset="-122"/>
+                <a:cs typeface="맑은 고딕" pitchFamily="34" charset="-120"/>
+              </a:rPr>
+              <a:t>★Season off★  ·  재고 5개</a:t>
+            </a:r>
+            <a:pPr indent="0" marL="0">
+              <a:buNone/>
+            </a:pPr>
+            <a:r>
+              <a:rPr lang="en-US" sz="1000" b="1" dirty="0">
+                <a:solidFill>
+                  <a:srgbClr val="D72638"/>
+                </a:solidFill>
+                <a:latin typeface="맑은 고딕" pitchFamily="34" charset="0"/>
+                <a:ea typeface="맑은 고딕" pitchFamily="34" charset="-122"/>
+                <a:cs typeface="맑은 고딕" pitchFamily="34" charset="-120"/>
+              </a:rPr>
+              <a:t/>
+            </a:r>
+            <a:endParaRPr lang="en-US" sz="1000" dirty="0"/>
+          </a:p>
+        </p:txBody>
+      </p:sp>
+      <p:sp>
+        <p:nvSpPr>
+          <p:cNvPr id="39" name="Shape 36"/>
+          <p:cNvSpPr/>
+          <p:nvPr/>
+        </p:nvSpPr>
+        <p:spPr>
+          <a:xfrm>
+            <a:off x="7406640" y="5522976"/>
+            <a:ext cx="4206240" cy="640080"/>
+          </a:xfrm>
+          <a:prstGeom prst="rect">
+            <a:avLst/>
+          </a:prstGeom>
+          <a:solidFill>
+            <a:srgbClr val="FFF5F5"/>
+          </a:solidFill>
+          <a:ln w="6350">
+            <a:solidFill>
+              <a:srgbClr val="E5E7EB"/>
+            </a:solidFill>
+            <a:prstDash val="solid"/>
+          </a:ln>
+        </p:spPr>
+      </p:sp>
+      <p:sp>
+        <p:nvSpPr>
+          <p:cNvPr id="40" name="Shape 37"/>
+          <p:cNvSpPr/>
+          <p:nvPr/>
+        </p:nvSpPr>
+        <p:spPr>
+          <a:xfrm>
+            <a:off x="7406640" y="5522976"/>
+            <a:ext cx="109728" cy="640080"/>
+          </a:xfrm>
+          <a:prstGeom prst="rect">
+            <a:avLst/>
+          </a:prstGeom>
+          <a:solidFill>
+            <a:srgbClr val="D72638"/>
+          </a:solidFill>
+          <a:ln w="12700">
+            <a:solidFill>
+              <a:srgbClr val="D72638"/>
+            </a:solidFill>
+            <a:prstDash val="solid"/>
+          </a:ln>
+        </p:spPr>
+      </p:sp>
+      <p:sp>
+        <p:nvSpPr>
+          <p:cNvPr id="41" name="Shape 38"/>
+          <p:cNvSpPr/>
+          <p:nvPr/>
+        </p:nvSpPr>
+        <p:spPr>
+          <a:xfrm>
+            <a:off x="7571232" y="5614416"/>
+            <a:ext cx="548640" cy="256032"/>
+          </a:xfrm>
+          <a:prstGeom prst="rect">
+            <a:avLst/>
+          </a:prstGeom>
+          <a:solidFill>
+            <a:srgbClr val="D72638"/>
+          </a:solidFill>
+          <a:ln w="12700">
+            <a:solidFill>
+              <a:srgbClr val="D72638"/>
+            </a:solidFill>
+            <a:prstDash val="solid"/>
+          </a:ln>
+        </p:spPr>
+      </p:sp>
+      <p:sp>
+        <p:nvSpPr>
+          <p:cNvPr id="42" name="Text 39"/>
+          <p:cNvSpPr/>
+          <p:nvPr/>
+        </p:nvSpPr>
+        <p:spPr>
+          <a:xfrm>
+            <a:off x="7571232" y="5614416"/>
+            <a:ext cx="548640" cy="256032"/>
+          </a:xfrm>
+          <a:prstGeom prst="rect">
+            <a:avLst/>
+          </a:prstGeom>
+          <a:noFill/>
+          <a:ln/>
+        </p:spPr>
+        <p:txBody>
+          <a:bodyPr wrap="square" lIns="0" tIns="0" rIns="0" bIns="0" rtlCol="0" anchor="ctr"/>
+          <a:lstStyle/>
+          <a:p>
+            <a:pPr algn="ctr" indent="0" marL="0">
+              <a:buNone/>
+            </a:pPr>
+            <a:r>
+              <a:rPr lang="en-US" sz="900" b="1" dirty="0">
+                <a:solidFill>
+                  <a:srgbClr val="FFFFFF"/>
+                </a:solidFill>
+                <a:latin typeface="맑은 고딕" pitchFamily="34" charset="0"/>
+                <a:ea typeface="맑은 고딕" pitchFamily="34" charset="-122"/>
+                <a:cs typeface="맑은 고딕" pitchFamily="34" charset="-120"/>
+              </a:rPr>
+              <a:t>긴급</a:t>
+            </a:r>
+            <a:endParaRPr lang="en-US" sz="900" dirty="0"/>
+          </a:p>
+        </p:txBody>
+      </p:sp>
+      <p:sp>
+        <p:nvSpPr>
+          <p:cNvPr id="43" name="Text 40"/>
+          <p:cNvSpPr/>
+          <p:nvPr/>
+        </p:nvSpPr>
+        <p:spPr>
+          <a:xfrm>
+            <a:off x="8211312" y="5577840"/>
+            <a:ext cx="3291840" cy="274320"/>
+          </a:xfrm>
+          <a:prstGeom prst="rect">
+            <a:avLst/>
+          </a:prstGeom>
+          <a:noFill/>
+          <a:ln/>
+        </p:spPr>
+        <p:txBody>
+          <a:bodyPr wrap="square" lIns="0" tIns="0" rIns="0" bIns="0" rtlCol="0" anchor="ctr"/>
+          <a:lstStyle/>
+          <a:p>
+            <a:pPr indent="0" marL="0">
+              <a:buNone/>
+            </a:pPr>
+            <a:r>
+              <a:rPr lang="en-US" sz="1100" b="1" dirty="0">
+                <a:solidFill>
+                  <a:srgbClr val="0B1220"/>
+                </a:solidFill>
+                <a:latin typeface="맑은 고딕" pitchFamily="34" charset="0"/>
+                <a:ea typeface="맑은 고딕" pitchFamily="34" charset="-122"/>
+                <a:cs typeface="맑은 고딕" pitchFamily="34" charset="-120"/>
+              </a:rPr>
               <a:t>B-Flower Necklace (Size: 2 Size)</a:t>
             </a:r>
             <a:endParaRPr lang="en-US" sz="1100" dirty="0"/>
@@ -7771,13 +8183,13 @@
       </p:sp>
       <p:sp>
         <p:nvSpPr>
-          <p:cNvPr id="32" name="Text 29"/>
-          <p:cNvSpPr/>
-          <p:nvPr/>
-        </p:nvSpPr>
-        <p:spPr>
-          <a:xfrm>
-            <a:off x="8211312" y="4425696"/>
+          <p:cNvPr id="44" name="Text 41"/>
+          <p:cNvSpPr/>
+          <p:nvPr/>
+        </p:nvSpPr>
+        <p:spPr>
+          <a:xfrm>
+            <a:off x="8211312" y="5852160"/>
             <a:ext cx="3291840" cy="256032"/>
           </a:xfrm>
           <a:prstGeom prst="rect">
@@ -7824,418 +8236,6 @@
       </p:sp>
       <p:sp>
         <p:nvSpPr>
-          <p:cNvPr id="33" name="Shape 30"/>
-          <p:cNvSpPr/>
-          <p:nvPr/>
-        </p:nvSpPr>
-        <p:spPr>
-          <a:xfrm>
-            <a:off x="7406640" y="4809744"/>
-            <a:ext cx="4206240" cy="640080"/>
-          </a:xfrm>
-          <a:prstGeom prst="rect">
-            <a:avLst/>
-          </a:prstGeom>
-          <a:solidFill>
-            <a:srgbClr val="FFF5F5"/>
-          </a:solidFill>
-          <a:ln w="6350">
-            <a:solidFill>
-              <a:srgbClr val="E5E7EB"/>
-            </a:solidFill>
-            <a:prstDash val="solid"/>
-          </a:ln>
-        </p:spPr>
-      </p:sp>
-      <p:sp>
-        <p:nvSpPr>
-          <p:cNvPr id="34" name="Shape 31"/>
-          <p:cNvSpPr/>
-          <p:nvPr/>
-        </p:nvSpPr>
-        <p:spPr>
-          <a:xfrm>
-            <a:off x="7406640" y="4809744"/>
-            <a:ext cx="109728" cy="640080"/>
-          </a:xfrm>
-          <a:prstGeom prst="rect">
-            <a:avLst/>
-          </a:prstGeom>
-          <a:solidFill>
-            <a:srgbClr val="D72638"/>
-          </a:solidFill>
-          <a:ln w="12700">
-            <a:solidFill>
-              <a:srgbClr val="D72638"/>
-            </a:solidFill>
-            <a:prstDash val="solid"/>
-          </a:ln>
-        </p:spPr>
-      </p:sp>
-      <p:sp>
-        <p:nvSpPr>
-          <p:cNvPr id="35" name="Shape 32"/>
-          <p:cNvSpPr/>
-          <p:nvPr/>
-        </p:nvSpPr>
-        <p:spPr>
-          <a:xfrm>
-            <a:off x="7571232" y="4901184"/>
-            <a:ext cx="548640" cy="256032"/>
-          </a:xfrm>
-          <a:prstGeom prst="rect">
-            <a:avLst/>
-          </a:prstGeom>
-          <a:solidFill>
-            <a:srgbClr val="D72638"/>
-          </a:solidFill>
-          <a:ln w="12700">
-            <a:solidFill>
-              <a:srgbClr val="D72638"/>
-            </a:solidFill>
-            <a:prstDash val="solid"/>
-          </a:ln>
-        </p:spPr>
-      </p:sp>
-      <p:sp>
-        <p:nvSpPr>
-          <p:cNvPr id="36" name="Text 33"/>
-          <p:cNvSpPr/>
-          <p:nvPr/>
-        </p:nvSpPr>
-        <p:spPr>
-          <a:xfrm>
-            <a:off x="7571232" y="4901184"/>
-            <a:ext cx="548640" cy="256032"/>
-          </a:xfrm>
-          <a:prstGeom prst="rect">
-            <a:avLst/>
-          </a:prstGeom>
-          <a:noFill/>
-          <a:ln/>
-        </p:spPr>
-        <p:txBody>
-          <a:bodyPr wrap="square" lIns="0" tIns="0" rIns="0" bIns="0" rtlCol="0" anchor="ctr"/>
-          <a:lstStyle/>
-          <a:p>
-            <a:pPr algn="ctr" indent="0" marL="0">
-              <a:buNone/>
-            </a:pPr>
-            <a:r>
-              <a:rPr lang="en-US" sz="900" b="1" dirty="0">
-                <a:solidFill>
-                  <a:srgbClr val="FFFFFF"/>
-                </a:solidFill>
-                <a:latin typeface="맑은 고딕" pitchFamily="34" charset="0"/>
-                <a:ea typeface="맑은 고딕" pitchFamily="34" charset="-122"/>
-                <a:cs typeface="맑은 고딕" pitchFamily="34" charset="-120"/>
-              </a:rPr>
-              <a:t>긴급</a:t>
-            </a:r>
-            <a:endParaRPr lang="en-US" sz="900" dirty="0"/>
-          </a:p>
-        </p:txBody>
-      </p:sp>
-      <p:sp>
-        <p:nvSpPr>
-          <p:cNvPr id="37" name="Text 34"/>
-          <p:cNvSpPr/>
-          <p:nvPr/>
-        </p:nvSpPr>
-        <p:spPr>
-          <a:xfrm>
-            <a:off x="8211312" y="4864608"/>
-            <a:ext cx="3291840" cy="274320"/>
-          </a:xfrm>
-          <a:prstGeom prst="rect">
-            <a:avLst/>
-          </a:prstGeom>
-          <a:noFill/>
-          <a:ln/>
-        </p:spPr>
-        <p:txBody>
-          <a:bodyPr wrap="square" lIns="0" tIns="0" rIns="0" bIns="0" rtlCol="0" anchor="ctr"/>
-          <a:lstStyle/>
-          <a:p>
-            <a:pPr indent="0" marL="0">
-              <a:buNone/>
-            </a:pPr>
-            <a:r>
-              <a:rPr lang="en-US" sz="1100" b="1" dirty="0">
-                <a:solidFill>
-                  <a:srgbClr val="0B1220"/>
-                </a:solidFill>
-                <a:latin typeface="맑은 고딕" pitchFamily="34" charset="0"/>
-                <a:ea typeface="맑은 고딕" pitchFamily="34" charset="-122"/>
-                <a:cs typeface="맑은 고딕" pitchFamily="34" charset="-120"/>
-              </a:rPr>
-              <a:t>Tangle Keychain</a:t>
-            </a:r>
-            <a:endParaRPr lang="en-US" sz="1100" dirty="0"/>
-          </a:p>
-        </p:txBody>
-      </p:sp>
-      <p:sp>
-        <p:nvSpPr>
-          <p:cNvPr id="38" name="Text 35"/>
-          <p:cNvSpPr/>
-          <p:nvPr/>
-        </p:nvSpPr>
-        <p:spPr>
-          <a:xfrm>
-            <a:off x="8211312" y="5138928"/>
-            <a:ext cx="3291840" cy="256032"/>
-          </a:xfrm>
-          <a:prstGeom prst="rect">
-            <a:avLst/>
-          </a:prstGeom>
-          <a:noFill/>
-          <a:ln/>
-        </p:spPr>
-        <p:txBody>
-          <a:bodyPr wrap="square" lIns="0" tIns="0" rIns="0" bIns="0" rtlCol="0" anchor="ctr"/>
-          <a:lstStyle/>
-          <a:p>
-            <a:pPr indent="0" marL="0">
-              <a:buNone/>
-            </a:pPr>
-            <a:r>
-              <a:rPr lang="en-US" sz="1000" dirty="0">
-                <a:solidFill>
-                  <a:srgbClr val="6B7280"/>
-                </a:solidFill>
-                <a:latin typeface="맑은 고딕" pitchFamily="34" charset="0"/>
-                <a:ea typeface="맑은 고딕" pitchFamily="34" charset="-122"/>
-                <a:cs typeface="맑은 고딕" pitchFamily="34" charset="-120"/>
-              </a:rPr>
-              <a:t>★Season off★  ·  재고 5개</a:t>
-            </a:r>
-            <a:pPr indent="0" marL="0">
-              <a:buNone/>
-            </a:pPr>
-            <a:r>
-              <a:rPr lang="en-US" sz="1000" b="1" dirty="0">
-                <a:solidFill>
-                  <a:srgbClr val="D72638"/>
-                </a:solidFill>
-                <a:latin typeface="맑은 고딕" pitchFamily="34" charset="0"/>
-                <a:ea typeface="맑은 고딕" pitchFamily="34" charset="-122"/>
-                <a:cs typeface="맑은 고딕" pitchFamily="34" charset="-120"/>
-              </a:rPr>
-              <a:t/>
-            </a:r>
-            <a:endParaRPr lang="en-US" sz="1000" dirty="0"/>
-          </a:p>
-        </p:txBody>
-      </p:sp>
-      <p:sp>
-        <p:nvSpPr>
-          <p:cNvPr id="39" name="Shape 36"/>
-          <p:cNvSpPr/>
-          <p:nvPr/>
-        </p:nvSpPr>
-        <p:spPr>
-          <a:xfrm>
-            <a:off x="7406640" y="5522976"/>
-            <a:ext cx="4206240" cy="640080"/>
-          </a:xfrm>
-          <a:prstGeom prst="rect">
-            <a:avLst/>
-          </a:prstGeom>
-          <a:solidFill>
-            <a:srgbClr val="FFF5F5"/>
-          </a:solidFill>
-          <a:ln w="6350">
-            <a:solidFill>
-              <a:srgbClr val="E5E7EB"/>
-            </a:solidFill>
-            <a:prstDash val="solid"/>
-          </a:ln>
-        </p:spPr>
-      </p:sp>
-      <p:sp>
-        <p:nvSpPr>
-          <p:cNvPr id="40" name="Shape 37"/>
-          <p:cNvSpPr/>
-          <p:nvPr/>
-        </p:nvSpPr>
-        <p:spPr>
-          <a:xfrm>
-            <a:off x="7406640" y="5522976"/>
-            <a:ext cx="109728" cy="640080"/>
-          </a:xfrm>
-          <a:prstGeom prst="rect">
-            <a:avLst/>
-          </a:prstGeom>
-          <a:solidFill>
-            <a:srgbClr val="D72638"/>
-          </a:solidFill>
-          <a:ln w="12700">
-            <a:solidFill>
-              <a:srgbClr val="D72638"/>
-            </a:solidFill>
-            <a:prstDash val="solid"/>
-          </a:ln>
-        </p:spPr>
-      </p:sp>
-      <p:sp>
-        <p:nvSpPr>
-          <p:cNvPr id="41" name="Shape 38"/>
-          <p:cNvSpPr/>
-          <p:nvPr/>
-        </p:nvSpPr>
-        <p:spPr>
-          <a:xfrm>
-            <a:off x="7571232" y="5614416"/>
-            <a:ext cx="548640" cy="256032"/>
-          </a:xfrm>
-          <a:prstGeom prst="rect">
-            <a:avLst/>
-          </a:prstGeom>
-          <a:solidFill>
-            <a:srgbClr val="D72638"/>
-          </a:solidFill>
-          <a:ln w="12700">
-            <a:solidFill>
-              <a:srgbClr val="D72638"/>
-            </a:solidFill>
-            <a:prstDash val="solid"/>
-          </a:ln>
-        </p:spPr>
-      </p:sp>
-      <p:sp>
-        <p:nvSpPr>
-          <p:cNvPr id="42" name="Text 39"/>
-          <p:cNvSpPr/>
-          <p:nvPr/>
-        </p:nvSpPr>
-        <p:spPr>
-          <a:xfrm>
-            <a:off x="7571232" y="5614416"/>
-            <a:ext cx="548640" cy="256032"/>
-          </a:xfrm>
-          <a:prstGeom prst="rect">
-            <a:avLst/>
-          </a:prstGeom>
-          <a:noFill/>
-          <a:ln/>
-        </p:spPr>
-        <p:txBody>
-          <a:bodyPr wrap="square" lIns="0" tIns="0" rIns="0" bIns="0" rtlCol="0" anchor="ctr"/>
-          <a:lstStyle/>
-          <a:p>
-            <a:pPr algn="ctr" indent="0" marL="0">
-              <a:buNone/>
-            </a:pPr>
-            <a:r>
-              <a:rPr lang="en-US" sz="900" b="1" dirty="0">
-                <a:solidFill>
-                  <a:srgbClr val="FFFFFF"/>
-                </a:solidFill>
-                <a:latin typeface="맑은 고딕" pitchFamily="34" charset="0"/>
-                <a:ea typeface="맑은 고딕" pitchFamily="34" charset="-122"/>
-                <a:cs typeface="맑은 고딕" pitchFamily="34" charset="-120"/>
-              </a:rPr>
-              <a:t>긴급</a:t>
-            </a:r>
-            <a:endParaRPr lang="en-US" sz="900" dirty="0"/>
-          </a:p>
-        </p:txBody>
-      </p:sp>
-      <p:sp>
-        <p:nvSpPr>
-          <p:cNvPr id="43" name="Text 40"/>
-          <p:cNvSpPr/>
-          <p:nvPr/>
-        </p:nvSpPr>
-        <p:spPr>
-          <a:xfrm>
-            <a:off x="8211312" y="5577840"/>
-            <a:ext cx="3291840" cy="274320"/>
-          </a:xfrm>
-          <a:prstGeom prst="rect">
-            <a:avLst/>
-          </a:prstGeom>
-          <a:noFill/>
-          <a:ln/>
-        </p:spPr>
-        <p:txBody>
-          <a:bodyPr wrap="square" lIns="0" tIns="0" rIns="0" bIns="0" rtlCol="0" anchor="ctr"/>
-          <a:lstStyle/>
-          <a:p>
-            <a:pPr indent="0" marL="0">
-              <a:buNone/>
-            </a:pPr>
-            <a:r>
-              <a:rPr lang="en-US" sz="1100" b="1" dirty="0">
-                <a:solidFill>
-                  <a:srgbClr val="0B1220"/>
-                </a:solidFill>
-                <a:latin typeface="맑은 고딕" pitchFamily="34" charset="0"/>
-                <a:ea typeface="맑은 고딕" pitchFamily="34" charset="-122"/>
-                <a:cs typeface="맑은 고딕" pitchFamily="34" charset="-120"/>
-              </a:rPr>
-              <a:t>8-Ball Smart Tok</a:t>
-            </a:r>
-            <a:endParaRPr lang="en-US" sz="1100" dirty="0"/>
-          </a:p>
-        </p:txBody>
-      </p:sp>
-      <p:sp>
-        <p:nvSpPr>
-          <p:cNvPr id="44" name="Text 41"/>
-          <p:cNvSpPr/>
-          <p:nvPr/>
-        </p:nvSpPr>
-        <p:spPr>
-          <a:xfrm>
-            <a:off x="8211312" y="5852160"/>
-            <a:ext cx="3291840" cy="256032"/>
-          </a:xfrm>
-          <a:prstGeom prst="rect">
-            <a:avLst/>
-          </a:prstGeom>
-          <a:noFill/>
-          <a:ln/>
-        </p:spPr>
-        <p:txBody>
-          <a:bodyPr wrap="square" lIns="0" tIns="0" rIns="0" bIns="0" rtlCol="0" anchor="ctr"/>
-          <a:lstStyle/>
-          <a:p>
-            <a:pPr indent="0" marL="0">
-              <a:buNone/>
-            </a:pPr>
-            <a:r>
-              <a:rPr lang="en-US" sz="1000" dirty="0">
-                <a:solidFill>
-                  <a:srgbClr val="6B7280"/>
-                </a:solidFill>
-                <a:latin typeface="맑은 고딕" pitchFamily="34" charset="0"/>
-                <a:ea typeface="맑은 고딕" pitchFamily="34" charset="-122"/>
-                <a:cs typeface="맑은 고딕" pitchFamily="34" charset="-120"/>
-              </a:rPr>
-              <a:t>★Season off★  ·  재고 5개</a:t>
-            </a:r>
-            <a:pPr indent="0" marL="0">
-              <a:buNone/>
-            </a:pPr>
-            <a:r>
-              <a:rPr lang="en-US" sz="1000" b="1" dirty="0">
-                <a:solidFill>
-                  <a:srgbClr val="D72638"/>
-                </a:solidFill>
-                <a:latin typeface="맑은 고딕" pitchFamily="34" charset="0"/>
-                <a:ea typeface="맑은 고딕" pitchFamily="34" charset="-122"/>
-                <a:cs typeface="맑은 고딕" pitchFamily="34" charset="-120"/>
-              </a:rPr>
-              <a:t/>
-            </a:r>
-            <a:endParaRPr lang="en-US" sz="1000" dirty="0"/>
-          </a:p>
-        </p:txBody>
-      </p:sp>
-      <p:sp>
-        <p:nvSpPr>
           <p:cNvPr id="45" name="Text 42"/>
           <p:cNvSpPr/>
           <p:nvPr/>
@@ -8267,7 +8267,7 @@
                 <a:ea typeface="맑은 고딕" pitchFamily="34" charset="-122"/>
                 <a:cs typeface="맑은 고딕" pitchFamily="34" charset="-120"/>
               </a:rPr>
-              <a:t>베스트 상품 리포트  ·  생성 2026-05-12 09:56</a:t>
+              <a:t>베스트 상품 리포트  ·  생성 2026-05-12 11:12</a:t>
             </a:r>
             <a:endParaRPr lang="en-US" sz="900" dirty="0"/>
           </a:p>
@@ -8647,7 +8647,7 @@
                 <a:ea typeface="맑은 고딕" pitchFamily="34" charset="-122"/>
                 <a:cs typeface="맑은 고딕" pitchFamily="34" charset="-120"/>
               </a:rPr>
-              <a:t>30 개</a:t>
+              <a:t>0 개</a:t>
             </a:r>
             <a:endParaRPr lang="en-US" sz="3600" dirty="0"/>
           </a:p>
@@ -8853,7 +8853,7 @@
                 <a:ea typeface="맑은 고딕" pitchFamily="34" charset="-122"/>
                 <a:cs typeface="맑은 고딕" pitchFamily="34" charset="-120"/>
               </a:rPr>
-              <a:t>9</a:t>
+              <a:t>5</a:t>
             </a:r>
             <a:endParaRPr lang="en-US" sz="4400" dirty="0"/>
           </a:p>
@@ -9257,7 +9257,7 @@
                           <a:ea typeface="맑은 고딕" pitchFamily="34" charset="-122"/>
                           <a:cs typeface="맑은 고딕" pitchFamily="34" charset="-120"/>
                         </a:rPr>
-                        <a:t>1</a:t>
+                        <a:t/>
                       </a:r>
                       <a:endParaRPr lang="en-US" sz="1100" dirty="0">
                         <a:latin typeface="맑은 고딕" charset="0"/>
@@ -9322,7 +9322,7 @@
                           <a:ea typeface="맑은 고딕" pitchFamily="34" charset="-122"/>
                           <a:cs typeface="맑은 고딕" pitchFamily="34" charset="-120"/>
                         </a:rPr>
-                        <a:t>Necklace</a:t>
+                        <a:t/>
                       </a:r>
                       <a:endParaRPr lang="en-US" sz="1000" dirty="0">
                         <a:latin typeface="맑은 고딕" charset="0"/>
@@ -9387,7 +9387,7 @@
                           <a:ea typeface="맑은 고딕" pitchFamily="34" charset="-122"/>
                           <a:cs typeface="맑은 고딕" pitchFamily="34" charset="-120"/>
                         </a:rPr>
-                        <a:t>CandyPOP Necklace (사이즈: 2size (47~52cm))</a:t>
+                        <a:t/>
                       </a:r>
                       <a:endParaRPr lang="en-US" sz="1100" dirty="0">
                         <a:latin typeface="맑은 고딕" charset="0"/>
@@ -9452,7 +9452,7 @@
                           <a:ea typeface="맑은 고딕" pitchFamily="34" charset="-122"/>
                           <a:cs typeface="맑은 고딕" pitchFamily="34" charset="-120"/>
                         </a:rPr>
-                        <a:t>9 개</a:t>
+                        <a:t/>
                       </a:r>
                       <a:endParaRPr lang="en-US" sz="1400" dirty="0">
                         <a:latin typeface="맑은 고딕" charset="0"/>
@@ -9519,7 +9519,7 @@
                           <a:ea typeface="맑은 고딕" pitchFamily="34" charset="-122"/>
                           <a:cs typeface="맑은 고딕" pitchFamily="34" charset="-120"/>
                         </a:rPr>
-                        <a:t>2</a:t>
+                        <a:t/>
                       </a:r>
                       <a:endParaRPr lang="en-US" sz="1100" dirty="0">
                         <a:latin typeface="맑은 고딕" charset="0"/>
@@ -9584,7 +9584,7 @@
                           <a:ea typeface="맑은 고딕" pitchFamily="34" charset="-122"/>
                           <a:cs typeface="맑은 고딕" pitchFamily="34" charset="-120"/>
                         </a:rPr>
-                        <a:t>Necklace</a:t>
+                        <a:t/>
                       </a:r>
                       <a:endParaRPr lang="en-US" sz="1000" dirty="0">
                         <a:latin typeface="맑은 고딕" charset="0"/>
@@ -9649,7 +9649,7 @@
                           <a:ea typeface="맑은 고딕" pitchFamily="34" charset="-122"/>
                           <a:cs typeface="맑은 고딕" pitchFamily="34" charset="-120"/>
                         </a:rPr>
-                        <a:t>ThreadDuo Necklace</a:t>
+                        <a:t/>
                       </a:r>
                       <a:endParaRPr lang="en-US" sz="1100" dirty="0">
                         <a:latin typeface="맑은 고딕" charset="0"/>
@@ -9714,7 +9714,7 @@
                           <a:ea typeface="맑은 고딕" pitchFamily="34" charset="-122"/>
                           <a:cs typeface="맑은 고딕" pitchFamily="34" charset="-120"/>
                         </a:rPr>
-                        <a:t>7 개</a:t>
+                        <a:t/>
                       </a:r>
                       <a:endParaRPr lang="en-US" sz="1200" dirty="0">
                         <a:latin typeface="맑은 고딕" charset="0"/>
@@ -9781,7 +9781,7 @@
                           <a:ea typeface="맑은 고딕" pitchFamily="34" charset="-122"/>
                           <a:cs typeface="맑은 고딕" pitchFamily="34" charset="-120"/>
                         </a:rPr>
-                        <a:t>3</a:t>
+                        <a:t/>
                       </a:r>
                       <a:endParaRPr lang="en-US" sz="1100" dirty="0">
                         <a:latin typeface="맑은 고딕" charset="0"/>
@@ -9846,7 +9846,7 @@
                           <a:ea typeface="맑은 고딕" pitchFamily="34" charset="-122"/>
                           <a:cs typeface="맑은 고딕" pitchFamily="34" charset="-120"/>
                         </a:rPr>
-                        <a:t>Ring</a:t>
+                        <a:t/>
                       </a:r>
                       <a:endParaRPr lang="en-US" sz="1000" dirty="0">
                         <a:latin typeface="맑은 고딕" charset="0"/>
@@ -9911,7 +9911,7 @@
                           <a:ea typeface="맑은 고딕" pitchFamily="34" charset="-122"/>
                           <a:cs typeface="맑은 고딕" pitchFamily="34" charset="-120"/>
                         </a:rPr>
-                        <a:t>"Reine" 925 Open Ring</a:t>
+                        <a:t/>
                       </a:r>
                       <a:endParaRPr lang="en-US" sz="1100" dirty="0">
                         <a:latin typeface="맑은 고딕" charset="0"/>
@@ -9976,7 +9976,7 @@
                           <a:ea typeface="맑은 고딕" pitchFamily="34" charset="-122"/>
                           <a:cs typeface="맑은 고딕" pitchFamily="34" charset="-120"/>
                         </a:rPr>
-                        <a:t>3 개</a:t>
+                        <a:t/>
                       </a:r>
                       <a:endParaRPr lang="en-US" sz="1200" dirty="0">
                         <a:latin typeface="맑은 고딕" charset="0"/>
@@ -10165,7 +10165,7 @@
                 <a:ea typeface="맑은 고딕" pitchFamily="34" charset="-122"/>
                 <a:cs typeface="맑은 고딕" pitchFamily="34" charset="-120"/>
               </a:rPr>
-              <a:t>베스트 상품 리포트  ·  생성 2026-05-12 09:56</a:t>
+              <a:t>베스트 상품 리포트  ·  생성 2026-05-12 11:12</a:t>
             </a:r>
             <a:endParaRPr lang="en-US" sz="900" dirty="0"/>
           </a:p>
@@ -10929,7 +10929,7 @@
                 <a:ea typeface="맑은 고딕" pitchFamily="34" charset="-122"/>
                 <a:cs typeface="맑은 고딕" pitchFamily="34" charset="-120"/>
               </a:rPr>
-              <a:t>43,297</a:t>
+              <a:t>43,250</a:t>
             </a:r>
             <a:endParaRPr lang="en-US" sz="3000" dirty="0"/>
           </a:p>
@@ -11751,7 +11751,7 @@
                           <a:ea typeface="맑은 고딕" pitchFamily="34" charset="-122"/>
                           <a:cs typeface="맑은 고딕" pitchFamily="34" charset="-120"/>
                         </a:rPr>
-                        <a:t>2,881</a:t>
+                        <a:t>2,874</a:t>
                       </a:r>
                       <a:endParaRPr lang="en-US" sz="1000" dirty="0">
                         <a:latin typeface="맑은 고딕" charset="0"/>
@@ -12013,7 +12013,7 @@
                           <a:ea typeface="맑은 고딕" pitchFamily="34" charset="-122"/>
                           <a:cs typeface="맑은 고딕" pitchFamily="34" charset="-120"/>
                         </a:rPr>
-                        <a:t>2,505</a:t>
+                        <a:t>2,504</a:t>
                       </a:r>
                       <a:endParaRPr lang="en-US" sz="1000" dirty="0">
                         <a:latin typeface="맑은 고딕" charset="0"/>
@@ -12275,7 +12275,7 @@
                           <a:ea typeface="맑은 고딕" pitchFamily="34" charset="-122"/>
                           <a:cs typeface="맑은 고딕" pitchFamily="34" charset="-120"/>
                         </a:rPr>
-                        <a:t>2,322</a:t>
+                        <a:t>2,321</a:t>
                       </a:r>
                       <a:endParaRPr lang="en-US" sz="1000" dirty="0">
                         <a:latin typeface="맑은 고딕" charset="0"/>
@@ -12537,7 +12537,7 @@
                           <a:ea typeface="맑은 고딕" pitchFamily="34" charset="-122"/>
                           <a:cs typeface="맑은 고딕" pitchFamily="34" charset="-120"/>
                         </a:rPr>
-                        <a:t>2,016</a:t>
+                        <a:t>2,012</a:t>
                       </a:r>
                       <a:endParaRPr lang="en-US" sz="1000" dirty="0">
                         <a:latin typeface="맑은 고딕" charset="0"/>
@@ -13556,7 +13556,7 @@
                 <a:ea typeface="맑은 고딕" pitchFamily="34" charset="-122"/>
                 <a:cs typeface="맑은 고딕" pitchFamily="34" charset="-120"/>
               </a:rPr>
-              <a:t>베스트 상품 리포트  ·  생성 2026-05-12 09:56</a:t>
+              <a:t>베스트 상품 리포트  ·  생성 2026-05-12 11:12</a:t>
             </a:r>
             <a:endParaRPr lang="en-US" sz="900" dirty="0"/>
           </a:p>
@@ -13897,7 +13897,7 @@
                 <a:ea typeface="맑은 고딕" pitchFamily="34" charset="-122"/>
                 <a:cs typeface="맑은 고딕" pitchFamily="34" charset="-120"/>
               </a:rPr>
-              <a:t>🚨  긴급 리오더 38건    ·    주의 리오더 5건    ·    오늘 발주 검토 필수</a:t>
+              <a:t>🚨  긴급 리오더 38건    ·    주의 리오더 4건    ·    오늘 발주 검토 필수</a:t>
             </a:r>
             <a:pPr indent="0" marL="0">
               <a:buNone/>
@@ -14731,7 +14731,7 @@
                           <a:ea typeface="맑은 고딕" pitchFamily="34" charset="-122"/>
                           <a:cs typeface="맑은 고딕" pitchFamily="34" charset="-120"/>
                         </a:rPr>
-                        <a:t>1</a:t>
+                        <a:t>0</a:t>
                       </a:r>
                       <a:endParaRPr lang="en-US" sz="1100" dirty="0">
                         <a:latin typeface="맑은 고딕" charset="0"/>
@@ -14799,7 +14799,7 @@
                           <a:ea typeface="맑은 고딕" pitchFamily="34" charset="-122"/>
                           <a:cs typeface="맑은 고딕" pitchFamily="34" charset="-120"/>
                         </a:rPr>
-                        <a:t>2 개</a:t>
+                        <a:t>1 개</a:t>
                       </a:r>
                       <a:endParaRPr lang="en-US" sz="1100" dirty="0">
                         <a:latin typeface="맑은 고딕" charset="0"/>
@@ -15005,7 +15005,7 @@
                           <a:ea typeface="맑은 고딕" pitchFamily="34" charset="-122"/>
                           <a:cs typeface="맑은 고딕" pitchFamily="34" charset="-120"/>
                         </a:rPr>
-                        <a:t>Necklace</a:t>
+                        <a:t>★Season off★</a:t>
                       </a:r>
                       <a:endParaRPr lang="en-US" sz="1000" dirty="0">
                         <a:latin typeface="맑은 고딕" charset="0"/>
@@ -15073,7 +15073,7 @@
                           <a:ea typeface="맑은 고딕" pitchFamily="34" charset="-122"/>
                           <a:cs typeface="맑은 고딕" pitchFamily="34" charset="-120"/>
                         </a:rPr>
-                        <a:t>B-Flower Necklace (Size: 2 Size)</a:t>
+                        <a:t>Tangle Keychain</a:t>
                       </a:r>
                       <a:endParaRPr lang="en-US" sz="1100" dirty="0">
                         <a:latin typeface="맑은 고딕" charset="0"/>
@@ -15141,7 +15141,7 @@
                           <a:ea typeface="맑은 고딕" pitchFamily="34" charset="-122"/>
                           <a:cs typeface="맑은 고딕" pitchFamily="34" charset="-120"/>
                         </a:rPr>
-                        <a:t>4</a:t>
+                        <a:t>5</a:t>
                       </a:r>
                       <a:endParaRPr lang="en-US" sz="1100" dirty="0">
                         <a:latin typeface="맑은 고딕" charset="0"/>
@@ -15209,7 +15209,7 @@
                           <a:ea typeface="맑은 고딕" pitchFamily="34" charset="-122"/>
                           <a:cs typeface="맑은 고딕" pitchFamily="34" charset="-120"/>
                         </a:rPr>
-                        <a:t>1 개</a:t>
+                        <a:t>0 개</a:t>
                       </a:r>
                       <a:endParaRPr lang="en-US" sz="1100" dirty="0">
                         <a:latin typeface="맑은 고딕" charset="0"/>
@@ -15347,7 +15347,7 @@
                           <a:ea typeface="맑은 고딕" pitchFamily="34" charset="-122"/>
                           <a:cs typeface="맑은 고딕" pitchFamily="34" charset="-120"/>
                         </a:rPr>
-                        <a:t>CT</a:t>
+                        <a:t>6A</a:t>
                       </a:r>
                       <a:endParaRPr lang="en-US" sz="1100" dirty="0">
                         <a:latin typeface="맑은 고딕" charset="0"/>
@@ -15415,7 +15415,7 @@
                           <a:ea typeface="맑은 고딕" pitchFamily="34" charset="-122"/>
                           <a:cs typeface="맑은 고딕" pitchFamily="34" charset="-120"/>
                         </a:rPr>
-                        <a:t>Necklace</a:t>
+                        <a:t>★Season off★</a:t>
                       </a:r>
                       <a:endParaRPr lang="en-US" sz="1000" dirty="0">
                         <a:latin typeface="맑은 고딕" charset="0"/>
@@ -15483,7 +15483,7 @@
                           <a:ea typeface="맑은 고딕" pitchFamily="34" charset="-122"/>
                           <a:cs typeface="맑은 고딕" pitchFamily="34" charset="-120"/>
                         </a:rPr>
-                        <a:t>CandyPOP Necklace (사이즈: 1size (41.5~47cm))</a:t>
+                        <a:t>8-Ball Smart Tok</a:t>
                       </a:r>
                       <a:endParaRPr lang="en-US" sz="1100" dirty="0">
                         <a:latin typeface="맑은 고딕" charset="0"/>
@@ -15551,7 +15551,7 @@
                           <a:ea typeface="맑은 고딕" pitchFamily="34" charset="-122"/>
                           <a:cs typeface="맑은 고딕" pitchFamily="34" charset="-120"/>
                         </a:rPr>
-                        <a:t>0</a:t>
+                        <a:t>5</a:t>
                       </a:r>
                       <a:endParaRPr lang="en-US" sz="1100" dirty="0">
                         <a:latin typeface="맑은 고딕" charset="0"/>
@@ -15619,7 +15619,7 @@
                           <a:ea typeface="맑은 고딕" pitchFamily="34" charset="-122"/>
                           <a:cs typeface="맑은 고딕" pitchFamily="34" charset="-120"/>
                         </a:rPr>
-                        <a:t>1 개</a:t>
+                        <a:t>0 개</a:t>
                       </a:r>
                       <a:endParaRPr lang="en-US" sz="1100" dirty="0">
                         <a:latin typeface="맑은 고딕" charset="0"/>
@@ -15757,7 +15757,7 @@
                           <a:ea typeface="맑은 고딕" pitchFamily="34" charset="-122"/>
                           <a:cs typeface="맑은 고딕" pitchFamily="34" charset="-120"/>
                         </a:rPr>
-                        <a:t>PR</a:t>
+                        <a:t>6A</a:t>
                       </a:r>
                       <a:endParaRPr lang="en-US" sz="1100" dirty="0">
                         <a:latin typeface="맑은 고딕" charset="0"/>
@@ -15825,7 +15825,7 @@
                           <a:ea typeface="맑은 고딕" pitchFamily="34" charset="-122"/>
                           <a:cs typeface="맑은 고딕" pitchFamily="34" charset="-120"/>
                         </a:rPr>
-                        <a:t>ETC</a:t>
+                        <a:t>Necklace</a:t>
                       </a:r>
                       <a:endParaRPr lang="en-US" sz="1000" dirty="0">
                         <a:latin typeface="맑은 고딕" charset="0"/>
@@ -15893,7 +15893,7 @@
                           <a:ea typeface="맑은 고딕" pitchFamily="34" charset="-122"/>
                           <a:cs typeface="맑은 고딕" pitchFamily="34" charset="-120"/>
                         </a:rPr>
-                        <a:t>360° Rotating Phone Holder (컬러: 화이트)</a:t>
+                        <a:t>B-Flower Necklace (Size: 2 Size)</a:t>
                       </a:r>
                       <a:endParaRPr lang="en-US" sz="1100" dirty="0">
                         <a:latin typeface="맑은 고딕" charset="0"/>
@@ -15961,7 +15961,7 @@
                           <a:ea typeface="맑은 고딕" pitchFamily="34" charset="-122"/>
                           <a:cs typeface="맑은 고딕" pitchFamily="34" charset="-120"/>
                         </a:rPr>
-                        <a:t>17</a:t>
+                        <a:t>4</a:t>
                       </a:r>
                       <a:endParaRPr lang="en-US" sz="1100" dirty="0">
                         <a:latin typeface="맑은 고딕" charset="0"/>
@@ -16029,7 +16029,7 @@
                           <a:ea typeface="맑은 고딕" pitchFamily="34" charset="-122"/>
                           <a:cs typeface="맑은 고딕" pitchFamily="34" charset="-120"/>
                         </a:rPr>
-                        <a:t>1 개</a:t>
+                        <a:t>0 개</a:t>
                       </a:r>
                       <a:endParaRPr lang="en-US" sz="1100" dirty="0">
                         <a:latin typeface="맑은 고딕" charset="0"/>
@@ -16235,7 +16235,7 @@
                           <a:ea typeface="맑은 고딕" pitchFamily="34" charset="-122"/>
                           <a:cs typeface="맑은 고딕" pitchFamily="34" charset="-120"/>
                         </a:rPr>
-                        <a:t>★Season off★</a:t>
+                        <a:t>Necklace</a:t>
                       </a:r>
                       <a:endParaRPr lang="en-US" sz="1000" dirty="0">
                         <a:latin typeface="맑은 고딕" charset="0"/>
@@ -16303,7 +16303,7 @@
                           <a:ea typeface="맑은 고딕" pitchFamily="34" charset="-122"/>
                           <a:cs typeface="맑은 고딕" pitchFamily="34" charset="-120"/>
                         </a:rPr>
-                        <a:t>Tangle Keychain</a:t>
+                        <a:t>B-Flower Necklace (Size: 1 Size)</a:t>
                       </a:r>
                       <a:endParaRPr lang="en-US" sz="1100" dirty="0">
                         <a:latin typeface="맑은 고딕" charset="0"/>
@@ -16371,7 +16371,7 @@
                           <a:ea typeface="맑은 고딕" pitchFamily="34" charset="-122"/>
                           <a:cs typeface="맑은 고딕" pitchFamily="34" charset="-120"/>
                         </a:rPr>
-                        <a:t>5</a:t>
+                        <a:t>0</a:t>
                       </a:r>
                       <a:endParaRPr lang="en-US" sz="1100" dirty="0">
                         <a:latin typeface="맑은 고딕" charset="0"/>
@@ -16577,7 +16577,7 @@
                           <a:ea typeface="맑은 고딕" pitchFamily="34" charset="-122"/>
                           <a:cs typeface="맑은 고딕" pitchFamily="34" charset="-120"/>
                         </a:rPr>
-                        <a:t>6A</a:t>
+                        <a:t>CT</a:t>
                       </a:r>
                       <a:endParaRPr lang="en-US" sz="1100" dirty="0">
                         <a:latin typeface="맑은 고딕" charset="0"/>
@@ -16645,7 +16645,7 @@
                           <a:ea typeface="맑은 고딕" pitchFamily="34" charset="-122"/>
                           <a:cs typeface="맑은 고딕" pitchFamily="34" charset="-120"/>
                         </a:rPr>
-                        <a:t>★Season off★</a:t>
+                        <a:t>Ring</a:t>
                       </a:r>
                       <a:endParaRPr lang="en-US" sz="1000" dirty="0">
                         <a:latin typeface="맑은 고딕" charset="0"/>
@@ -16713,7 +16713,7 @@
                           <a:ea typeface="맑은 고딕" pitchFamily="34" charset="-122"/>
                           <a:cs typeface="맑은 고딕" pitchFamily="34" charset="-120"/>
                         </a:rPr>
-                        <a:t>8-Ball Smart Tok</a:t>
+                        <a:t>"Whisow" 925 Open Ring</a:t>
                       </a:r>
                       <a:endParaRPr lang="en-US" sz="1100" dirty="0">
                         <a:latin typeface="맑은 고딕" charset="0"/>
@@ -16781,7 +16781,7 @@
                           <a:ea typeface="맑은 고딕" pitchFamily="34" charset="-122"/>
                           <a:cs typeface="맑은 고딕" pitchFamily="34" charset="-120"/>
                         </a:rPr>
-                        <a:t>5</a:t>
+                        <a:t>2</a:t>
                       </a:r>
                       <a:endParaRPr lang="en-US" sz="1100" dirty="0">
                         <a:latin typeface="맑은 고딕" charset="0"/>
@@ -16987,7 +16987,7 @@
                           <a:ea typeface="맑은 고딕" pitchFamily="34" charset="-122"/>
                           <a:cs typeface="맑은 고딕" pitchFamily="34" charset="-120"/>
                         </a:rPr>
-                        <a:t>6A</a:t>
+                        <a:t>CT</a:t>
                       </a:r>
                       <a:endParaRPr lang="en-US" sz="1100" dirty="0">
                         <a:latin typeface="맑은 고딕" charset="0"/>
@@ -17055,7 +17055,7 @@
                           <a:ea typeface="맑은 고딕" pitchFamily="34" charset="-122"/>
                           <a:cs typeface="맑은 고딕" pitchFamily="34" charset="-120"/>
                         </a:rPr>
-                        <a:t>Necklace</a:t>
+                        <a:t>Ring</a:t>
                       </a:r>
                       <a:endParaRPr lang="en-US" sz="1000" dirty="0">
                         <a:latin typeface="맑은 고딕" charset="0"/>
@@ -17123,7 +17123,7 @@
                           <a:ea typeface="맑은 고딕" pitchFamily="34" charset="-122"/>
                           <a:cs typeface="맑은 고딕" pitchFamily="34" charset="-120"/>
                         </a:rPr>
-                        <a:t>B-Flower Necklace (Size: 1 Size)</a:t>
+                        <a:t>"Socmall" 925 Open Ring</a:t>
                       </a:r>
                       <a:endParaRPr lang="en-US" sz="1100" dirty="0">
                         <a:latin typeface="맑은 고딕" charset="0"/>
@@ -17533,7 +17533,7 @@
                           <a:ea typeface="맑은 고딕" pitchFamily="34" charset="-122"/>
                           <a:cs typeface="맑은 고딕" pitchFamily="34" charset="-120"/>
                         </a:rPr>
-                        <a:t>"Whisow" 925 Open Ring</a:t>
+                        <a:t>"Serendlory" 925 Open Ring</a:t>
                       </a:r>
                       <a:endParaRPr lang="en-US" sz="1100" dirty="0">
                         <a:latin typeface="맑은 고딕" charset="0"/>
@@ -17601,7 +17601,7 @@
                           <a:ea typeface="맑은 고딕" pitchFamily="34" charset="-122"/>
                           <a:cs typeface="맑은 고딕" pitchFamily="34" charset="-120"/>
                         </a:rPr>
-                        <a:t>2</a:t>
+                        <a:t>0</a:t>
                       </a:r>
                       <a:endParaRPr lang="en-US" sz="1100" dirty="0">
                         <a:latin typeface="맑은 고딕" charset="0"/>
@@ -17943,7 +17943,7 @@
                           <a:ea typeface="맑은 고딕" pitchFamily="34" charset="-122"/>
                           <a:cs typeface="맑은 고딕" pitchFamily="34" charset="-120"/>
                         </a:rPr>
-                        <a:t>"Socmall" 925 Open Ring</a:t>
+                        <a:t>"Usongtar" 925 Open Ring</a:t>
                       </a:r>
                       <a:endParaRPr lang="en-US" sz="1100" dirty="0">
                         <a:latin typeface="맑은 고딕" charset="0"/>
@@ -18207,7 +18207,7 @@
                 <a:ea typeface="맑은 고딕" pitchFamily="34" charset="-122"/>
                 <a:cs typeface="맑은 고딕" pitchFamily="34" charset="-120"/>
               </a:rPr>
-              <a:t>베스트 상품 리포트  ·  생성 2026-05-12 09:56</a:t>
+              <a:t>베스트 상품 리포트  ·  생성 2026-05-12 11:12</a:t>
             </a:r>
             <a:endParaRPr lang="en-US" sz="900" dirty="0"/>
           </a:p>
@@ -18587,7 +18587,7 @@
                 <a:ea typeface="맑은 고딕" pitchFamily="34" charset="-122"/>
                 <a:cs typeface="맑은 고딕" pitchFamily="34" charset="-120"/>
               </a:rPr>
-              <a:t>Google Sheet '브랜드 재고현황'  ·  최신화 2026-05-12 09:56</a:t>
+              <a:t>Google Sheet '브랜드 재고현황'  ·  최신화 2026-05-12 11:12</a:t>
             </a:r>
             <a:endParaRPr lang="en-US" sz="1100" dirty="0"/>
           </a:p>
@@ -19269,7 +19269,7 @@
                 <a:ea typeface="맑은 고딕" pitchFamily="34" charset="-122"/>
                 <a:cs typeface="맑은 고딕" pitchFamily="34" charset="-120"/>
               </a:rPr>
-              <a:t>베스트 상품 리포트  ·  생성 2026-05-12 09:56</a:t>
+              <a:t>베스트 상품 리포트  ·  생성 2026-05-12 11:12</a:t>
             </a:r>
             <a:endParaRPr lang="en-US" sz="900" dirty="0"/>
           </a:p>

</xml_diff>

<commit_message>
chore: 매출 PPT 업로드 (best-sellers-2026-05-13.pptx)
</commit_message>
<xml_diff>
--- a/data/sales-report.pptx
+++ b/data/sales-report.pptx
@@ -1648,7 +1648,7 @@
                 <a:ea typeface="맑은 고딕" pitchFamily="34" charset="-122"/>
                 <a:cs typeface="맑은 고딕" pitchFamily="34" charset="-120"/>
               </a:rPr>
-              <a:t>2026년 05월 12일 (화)  ·  실시간 누적</a:t>
+              <a:t>2026년 05월 13일 (수)  ·  실시간 누적</a:t>
             </a:r>
             <a:endParaRPr lang="en-US" sz="2200" dirty="0"/>
           </a:p>
@@ -1726,7 +1726,7 @@
                 <a:ea typeface="맑은 고딕" pitchFamily="34" charset="-122"/>
                 <a:cs typeface="맑은 고딕" pitchFamily="34" charset="-120"/>
               </a:rPr>
-              <a:t>05.12</a:t>
+              <a:t>05.13</a:t>
             </a:r>
             <a:endParaRPr lang="en-US" sz="7200" dirty="0"/>
           </a:p>
@@ -1765,7 +1765,7 @@
                 <a:ea typeface="맑은 고딕" pitchFamily="34" charset="-122"/>
                 <a:cs typeface="맑은 고딕" pitchFamily="34" charset="-120"/>
               </a:rPr>
-              <a:t>화요일</a:t>
+              <a:t>수요일</a:t>
             </a:r>
             <a:endParaRPr lang="en-US" sz="1400" dirty="0"/>
           </a:p>
@@ -1804,7 +1804,7 @@
                 <a:ea typeface="맑은 고딕" pitchFamily="34" charset="-122"/>
                 <a:cs typeface="맑은 고딕" pitchFamily="34" charset="-120"/>
               </a:rPr>
-              <a:t>생성 2026-05-12 11:12  ·  Google Sheet 자동 동기</a:t>
+              <a:t>생성 2026-05-13 12:17  ·  Google Sheet 자동 동기</a:t>
             </a:r>
             <a:endParaRPr lang="en-US" sz="1000" dirty="0"/>
           </a:p>
@@ -1978,7 +1978,7 @@
                 <a:ea typeface="맑은 고딕" pitchFamily="34" charset="-122"/>
                 <a:cs typeface="맑은 고딕" pitchFamily="34" charset="-120"/>
               </a:rPr>
-              <a:t>2026년 05월 12일 (화)</a:t>
+              <a:t>2026년 05월 13일 (수)</a:t>
             </a:r>
             <a:endParaRPr lang="en-US" sz="1200" dirty="0"/>
           </a:p>
@@ -2145,7 +2145,7 @@
                 <a:ea typeface="맑은 고딕" pitchFamily="34" charset="-122"/>
                 <a:cs typeface="맑은 고딕" pitchFamily="34" charset="-120"/>
               </a:rPr>
-              <a:t>3 개</a:t>
+              <a:t>5 개</a:t>
             </a:r>
             <a:endParaRPr lang="en-US" sz="3600" dirty="0"/>
           </a:p>
@@ -2312,7 +2312,7 @@
                 <a:ea typeface="맑은 고딕" pitchFamily="34" charset="-122"/>
                 <a:cs typeface="맑은 고딕" pitchFamily="34" charset="-120"/>
               </a:rPr>
-              <a:t>38 건</a:t>
+              <a:t>45 건</a:t>
             </a:r>
             <a:endParaRPr lang="en-US" sz="3200" dirty="0"/>
           </a:p>
@@ -2479,7 +2479,7 @@
                 <a:ea typeface="맑은 고딕" pitchFamily="34" charset="-122"/>
                 <a:cs typeface="맑은 고딕" pitchFamily="34" charset="-120"/>
               </a:rPr>
-              <a:t>4 건</a:t>
+              <a:t>9 건</a:t>
             </a:r>
             <a:endParaRPr lang="en-US" sz="3200" dirty="0"/>
           </a:p>
@@ -2685,7 +2685,7 @@
                 <a:ea typeface="맑은 고딕" pitchFamily="34" charset="-122"/>
                 <a:cs typeface="맑은 고딕" pitchFamily="34" charset="-120"/>
               </a:rPr>
-              <a:t>82 SKU  ·  판매 OK</a:t>
+              <a:t>84 SKU  ·  판매 OK</a:t>
             </a:r>
             <a:pPr indent="0" marL="0">
               <a:buNone/>
@@ -2827,7 +2827,7 @@
                 <a:ea typeface="맑은 고딕" pitchFamily="34" charset="-122"/>
                 <a:cs typeface="맑은 고딕" pitchFamily="34" charset="-120"/>
               </a:rPr>
-              <a:t>49 SKU  ·  판매 OK</a:t>
+              <a:t>57 SKU  ·  판매 OK</a:t>
             </a:r>
             <a:pPr indent="0" marL="0">
               <a:buNone/>
@@ -3612,7 +3612,7 @@
                           <a:ea typeface="맑은 고딕" pitchFamily="34" charset="-122"/>
                           <a:cs typeface="맑은 고딕" pitchFamily="34" charset="-120"/>
                         </a:rPr>
-                        <a:t>[SILVER925] Glacier Open Ring</a:t>
+                        <a:t>[SILVER925] Crown Open Ring</a:t>
                       </a:r>
                       <a:endParaRPr lang="en-US" sz="1100" dirty="0">
                         <a:latin typeface="맑은 고딕" charset="0"/>
@@ -3939,7 +3939,7 @@
                           <a:ea typeface="맑은 고딕" pitchFamily="34" charset="-122"/>
                           <a:cs typeface="맑은 고딕" pitchFamily="34" charset="-120"/>
                         </a:rPr>
-                        <a:t>Polaris Necklace</a:t>
+                        <a:t>Guapi Necklace</a:t>
                       </a:r>
                       <a:endParaRPr lang="en-US" sz="1100" dirty="0">
                         <a:latin typeface="맑은 고딕" charset="0"/>
@@ -4266,7 +4266,7 @@
                           <a:ea typeface="맑은 고딕" pitchFamily="34" charset="-122"/>
                           <a:cs typeface="맑은 고딕" pitchFamily="34" charset="-120"/>
                         </a:rPr>
-                        <a:t>[SILVER925] CH.alban Open Ring</a:t>
+                        <a:t>[SILVER925] Dotty Open Ring</a:t>
                       </a:r>
                       <a:endParaRPr lang="en-US" sz="1100" dirty="0">
                         <a:latin typeface="맑은 고딕" charset="0"/>
@@ -4398,7 +4398,7 @@
                           <a:ea typeface="맑은 고딕" pitchFamily="34" charset="-122"/>
                           <a:cs typeface="맑은 고딕" pitchFamily="34" charset="-120"/>
                         </a:rPr>
-                        <a:t/>
+                        <a:t>4</a:t>
                       </a:r>
                       <a:endParaRPr lang="en-US" sz="1100" dirty="0">
                         <a:latin typeface="맑은 고딕" charset="0"/>
@@ -4463,7 +4463,7 @@
                           <a:ea typeface="맑은 고딕" pitchFamily="34" charset="-122"/>
                           <a:cs typeface="맑은 고딕" pitchFamily="34" charset="-120"/>
                         </a:rPr>
-                        <a:t/>
+                        <a:t>6A</a:t>
                       </a:r>
                       <a:endParaRPr lang="en-US" sz="1100" dirty="0">
                         <a:latin typeface="맑은 고딕" charset="0"/>
@@ -4528,7 +4528,7 @@
                           <a:ea typeface="맑은 고딕" pitchFamily="34" charset="-122"/>
                           <a:cs typeface="맑은 고딕" pitchFamily="34" charset="-120"/>
                         </a:rPr>
-                        <a:t/>
+                        <a:t>Ring</a:t>
                       </a:r>
                       <a:endParaRPr lang="en-US" sz="1000" dirty="0">
                         <a:latin typeface="맑은 고딕" charset="0"/>
@@ -4593,7 +4593,7 @@
                           <a:ea typeface="맑은 고딕" pitchFamily="34" charset="-122"/>
                           <a:cs typeface="맑은 고딕" pitchFamily="34" charset="-120"/>
                         </a:rPr>
-                        <a:t/>
+                        <a:t>[SILVER925] Azure Open Ring</a:t>
                       </a:r>
                       <a:endParaRPr lang="en-US" sz="1100" dirty="0">
                         <a:latin typeface="맑은 고딕" charset="0"/>
@@ -4658,7 +4658,7 @@
                           <a:ea typeface="맑은 고딕" pitchFamily="34" charset="-122"/>
                           <a:cs typeface="맑은 고딕" pitchFamily="34" charset="-120"/>
                         </a:rPr>
-                        <a:t/>
+                        <a:t>1 개</a:t>
                       </a:r>
                       <a:endParaRPr lang="en-US" sz="1200" dirty="0">
                         <a:latin typeface="맑은 고딕" charset="0"/>
@@ -4725,7 +4725,7 @@
                           <a:ea typeface="맑은 고딕" pitchFamily="34" charset="-122"/>
                           <a:cs typeface="맑은 고딕" pitchFamily="34" charset="-120"/>
                         </a:rPr>
-                        <a:t/>
+                        <a:t>5</a:t>
                       </a:r>
                       <a:endParaRPr lang="en-US" sz="1100" dirty="0">
                         <a:latin typeface="맑은 고딕" charset="0"/>
@@ -4790,7 +4790,7 @@
                           <a:ea typeface="맑은 고딕" pitchFamily="34" charset="-122"/>
                           <a:cs typeface="맑은 고딕" pitchFamily="34" charset="-120"/>
                         </a:rPr>
-                        <a:t/>
+                        <a:t>CT</a:t>
                       </a:r>
                       <a:endParaRPr lang="en-US" sz="1100" dirty="0">
                         <a:latin typeface="맑은 고딕" charset="0"/>
@@ -4855,7 +4855,7 @@
                           <a:ea typeface="맑은 고딕" pitchFamily="34" charset="-122"/>
                           <a:cs typeface="맑은 고딕" pitchFamily="34" charset="-120"/>
                         </a:rPr>
-                        <a:t/>
+                        <a:t>Necklace</a:t>
                       </a:r>
                       <a:endParaRPr lang="en-US" sz="1000" dirty="0">
                         <a:latin typeface="맑은 고딕" charset="0"/>
@@ -4920,7 +4920,7 @@
                           <a:ea typeface="맑은 고딕" pitchFamily="34" charset="-122"/>
                           <a:cs typeface="맑은 고딕" pitchFamily="34" charset="-120"/>
                         </a:rPr>
-                        <a:t/>
+                        <a:t>CandyPOP Necklace (사이즈: 1size (41.5~47cm))</a:t>
                       </a:r>
                       <a:endParaRPr lang="en-US" sz="1100" dirty="0">
                         <a:latin typeface="맑은 고딕" charset="0"/>
@@ -4985,7 +4985,7 @@
                           <a:ea typeface="맑은 고딕" pitchFamily="34" charset="-122"/>
                           <a:cs typeface="맑은 고딕" pitchFamily="34" charset="-120"/>
                         </a:rPr>
-                        <a:t/>
+                        <a:t>1 개</a:t>
                       </a:r>
                       <a:endParaRPr lang="en-US" sz="1200" dirty="0">
                         <a:latin typeface="맑은 고딕" charset="0"/>
@@ -5071,7 +5071,7 @@
                 <a:ea typeface="맑은 고딕" pitchFamily="34" charset="-122"/>
                 <a:cs typeface="맑은 고딕" pitchFamily="34" charset="-120"/>
               </a:rPr>
-              <a:t>베스트 상품 리포트  ·  생성 2026-05-12 11:12</a:t>
+              <a:t>베스트 상품 리포트  ·  생성 2026-05-13 12:17</a:t>
             </a:r>
             <a:endParaRPr lang="en-US" sz="900" dirty="0"/>
           </a:p>
@@ -5284,7 +5284,7 @@
                 <a:ea typeface="맑은 고딕" pitchFamily="34" charset="-122"/>
                 <a:cs typeface="맑은 고딕" pitchFamily="34" charset="-120"/>
               </a:rPr>
-              <a:t>2026년 05월 12일 (화)</a:t>
+              <a:t>2026년 05월 13일 (수)</a:t>
             </a:r>
             <a:endParaRPr lang="en-US" sz="1200" dirty="0"/>
           </a:p>
@@ -5451,7 +5451,7 @@
                 <a:ea typeface="맑은 고딕" pitchFamily="34" charset="-122"/>
                 <a:cs typeface="맑은 고딕" pitchFamily="34" charset="-120"/>
               </a:rPr>
-              <a:t>3 개</a:t>
+              <a:t>4 개</a:t>
             </a:r>
             <a:endParaRPr lang="en-US" sz="3600" dirty="0"/>
           </a:p>
@@ -5579,7 +5579,7 @@
                 <a:ea typeface="맑은 고딕" pitchFamily="34" charset="-122"/>
                 <a:cs typeface="맑은 고딕" pitchFamily="34" charset="-120"/>
               </a:rPr>
-              <a:t>[SILVER925] Glacier Open Ring</a:t>
+              <a:t>[SILVER925] Crown Open Ring</a:t>
             </a:r>
             <a:endParaRPr lang="en-US" sz="1800" dirty="0"/>
           </a:p>
@@ -6191,7 +6191,7 @@
                           <a:ea typeface="맑은 고딕" pitchFamily="34" charset="-122"/>
                           <a:cs typeface="맑은 고딕" pitchFamily="34" charset="-120"/>
                         </a:rPr>
-                        <a:t>[SILVER925] Glacier Open Ring</a:t>
+                        <a:t>[SILVER925] Crown Open Ring</a:t>
                       </a:r>
                       <a:endParaRPr lang="en-US" sz="1100" dirty="0">
                         <a:latin typeface="맑은 고딕" charset="0"/>
@@ -6453,7 +6453,7 @@
                           <a:ea typeface="맑은 고딕" pitchFamily="34" charset="-122"/>
                           <a:cs typeface="맑은 고딕" pitchFamily="34" charset="-120"/>
                         </a:rPr>
-                        <a:t>Polaris Necklace</a:t>
+                        <a:t>Guapi Necklace</a:t>
                       </a:r>
                       <a:endParaRPr lang="en-US" sz="1100" dirty="0">
                         <a:latin typeface="맑은 고딕" charset="0"/>
@@ -6715,7 +6715,7 @@
                           <a:ea typeface="맑은 고딕" pitchFamily="34" charset="-122"/>
                           <a:cs typeface="맑은 고딕" pitchFamily="34" charset="-120"/>
                         </a:rPr>
-                        <a:t>[SILVER925] CH.alban Open Ring</a:t>
+                        <a:t>[SILVER925] Dotty Open Ring</a:t>
                       </a:r>
                       <a:endParaRPr lang="en-US" sz="1100" dirty="0">
                         <a:latin typeface="맑은 고딕" charset="0"/>
@@ -6847,7 +6847,7 @@
                           <a:ea typeface="맑은 고딕" pitchFamily="34" charset="-122"/>
                           <a:cs typeface="맑은 고딕" pitchFamily="34" charset="-120"/>
                         </a:rPr>
-                        <a:t/>
+                        <a:t>4</a:t>
                       </a:r>
                       <a:endParaRPr lang="en-US" sz="1100" dirty="0">
                         <a:latin typeface="맑은 고딕" charset="0"/>
@@ -6912,7 +6912,7 @@
                           <a:ea typeface="맑은 고딕" pitchFamily="34" charset="-122"/>
                           <a:cs typeface="맑은 고딕" pitchFamily="34" charset="-120"/>
                         </a:rPr>
-                        <a:t/>
+                        <a:t>Ring</a:t>
                       </a:r>
                       <a:endParaRPr lang="en-US" sz="1000" dirty="0">
                         <a:latin typeface="맑은 고딕" charset="0"/>
@@ -6977,7 +6977,7 @@
                           <a:ea typeface="맑은 고딕" pitchFamily="34" charset="-122"/>
                           <a:cs typeface="맑은 고딕" pitchFamily="34" charset="-120"/>
                         </a:rPr>
-                        <a:t/>
+                        <a:t>[SILVER925] Azure Open Ring</a:t>
                       </a:r>
                       <a:endParaRPr lang="en-US" sz="1100" dirty="0">
                         <a:latin typeface="맑은 고딕" charset="0"/>
@@ -7042,7 +7042,7 @@
                           <a:ea typeface="맑은 고딕" pitchFamily="34" charset="-122"/>
                           <a:cs typeface="맑은 고딕" pitchFamily="34" charset="-120"/>
                         </a:rPr>
-                        <a:t/>
+                        <a:t>1 개</a:t>
                       </a:r>
                       <a:endParaRPr lang="en-US" sz="1200" dirty="0">
                         <a:latin typeface="맑은 고딕" charset="0"/>
@@ -7557,212 +7557,6 @@
                 <a:ea typeface="맑은 고딕" pitchFamily="34" charset="-122"/>
                 <a:cs typeface="맑은 고딕" pitchFamily="34" charset="-120"/>
               </a:rPr>
-              <a:t>[SILVER925] CH.alban Open Ring</a:t>
-            </a:r>
-            <a:endParaRPr lang="en-US" sz="1100" dirty="0"/>
-          </a:p>
-        </p:txBody>
-      </p:sp>
-      <p:sp>
-        <p:nvSpPr>
-          <p:cNvPr id="26" name="Text 23"/>
-          <p:cNvSpPr/>
-          <p:nvPr/>
-        </p:nvSpPr>
-        <p:spPr>
-          <a:xfrm>
-            <a:off x="8211312" y="3712464"/>
-            <a:ext cx="3291840" cy="256032"/>
-          </a:xfrm>
-          <a:prstGeom prst="rect">
-            <a:avLst/>
-          </a:prstGeom>
-          <a:noFill/>
-          <a:ln/>
-        </p:spPr>
-        <p:txBody>
-          <a:bodyPr wrap="square" lIns="0" tIns="0" rIns="0" bIns="0" rtlCol="0" anchor="ctr"/>
-          <a:lstStyle/>
-          <a:p>
-            <a:pPr indent="0" marL="0">
-              <a:buNone/>
-            </a:pPr>
-            <a:r>
-              <a:rPr lang="en-US" sz="1000" dirty="0">
-                <a:solidFill>
-                  <a:srgbClr val="6B7280"/>
-                </a:solidFill>
-                <a:latin typeface="맑은 고딕" pitchFamily="34" charset="0"/>
-                <a:ea typeface="맑은 고딕" pitchFamily="34" charset="-122"/>
-                <a:cs typeface="맑은 고딕" pitchFamily="34" charset="-120"/>
-              </a:rPr>
-              <a:t>Ring  ·  재고 0개</a:t>
-            </a:r>
-            <a:pPr indent="0" marL="0">
-              <a:buNone/>
-            </a:pPr>
-            <a:r>
-              <a:rPr lang="en-US" sz="1000" b="1" dirty="0">
-                <a:solidFill>
-                  <a:srgbClr val="D72638"/>
-                </a:solidFill>
-                <a:latin typeface="맑은 고딕" pitchFamily="34" charset="0"/>
-                <a:ea typeface="맑은 고딕" pitchFamily="34" charset="-122"/>
-                <a:cs typeface="맑은 고딕" pitchFamily="34" charset="-120"/>
-              </a:rPr>
-              <a:t/>
-            </a:r>
-            <a:endParaRPr lang="en-US" sz="1000" dirty="0"/>
-          </a:p>
-        </p:txBody>
-      </p:sp>
-      <p:sp>
-        <p:nvSpPr>
-          <p:cNvPr id="27" name="Shape 24"/>
-          <p:cNvSpPr/>
-          <p:nvPr/>
-        </p:nvSpPr>
-        <p:spPr>
-          <a:xfrm>
-            <a:off x="7406640" y="4096512"/>
-            <a:ext cx="4206240" cy="640080"/>
-          </a:xfrm>
-          <a:prstGeom prst="rect">
-            <a:avLst/>
-          </a:prstGeom>
-          <a:solidFill>
-            <a:srgbClr val="FFF5F5"/>
-          </a:solidFill>
-          <a:ln w="6350">
-            <a:solidFill>
-              <a:srgbClr val="E5E7EB"/>
-            </a:solidFill>
-            <a:prstDash val="solid"/>
-          </a:ln>
-        </p:spPr>
-      </p:sp>
-      <p:sp>
-        <p:nvSpPr>
-          <p:cNvPr id="28" name="Shape 25"/>
-          <p:cNvSpPr/>
-          <p:nvPr/>
-        </p:nvSpPr>
-        <p:spPr>
-          <a:xfrm>
-            <a:off x="7406640" y="4096512"/>
-            <a:ext cx="109728" cy="640080"/>
-          </a:xfrm>
-          <a:prstGeom prst="rect">
-            <a:avLst/>
-          </a:prstGeom>
-          <a:solidFill>
-            <a:srgbClr val="D72638"/>
-          </a:solidFill>
-          <a:ln w="12700">
-            <a:solidFill>
-              <a:srgbClr val="D72638"/>
-            </a:solidFill>
-            <a:prstDash val="solid"/>
-          </a:ln>
-        </p:spPr>
-      </p:sp>
-      <p:sp>
-        <p:nvSpPr>
-          <p:cNvPr id="29" name="Shape 26"/>
-          <p:cNvSpPr/>
-          <p:nvPr/>
-        </p:nvSpPr>
-        <p:spPr>
-          <a:xfrm>
-            <a:off x="7571232" y="4187952"/>
-            <a:ext cx="548640" cy="256032"/>
-          </a:xfrm>
-          <a:prstGeom prst="rect">
-            <a:avLst/>
-          </a:prstGeom>
-          <a:solidFill>
-            <a:srgbClr val="D72638"/>
-          </a:solidFill>
-          <a:ln w="12700">
-            <a:solidFill>
-              <a:srgbClr val="D72638"/>
-            </a:solidFill>
-            <a:prstDash val="solid"/>
-          </a:ln>
-        </p:spPr>
-      </p:sp>
-      <p:sp>
-        <p:nvSpPr>
-          <p:cNvPr id="30" name="Text 27"/>
-          <p:cNvSpPr/>
-          <p:nvPr/>
-        </p:nvSpPr>
-        <p:spPr>
-          <a:xfrm>
-            <a:off x="7571232" y="4187952"/>
-            <a:ext cx="548640" cy="256032"/>
-          </a:xfrm>
-          <a:prstGeom prst="rect">
-            <a:avLst/>
-          </a:prstGeom>
-          <a:noFill/>
-          <a:ln/>
-        </p:spPr>
-        <p:txBody>
-          <a:bodyPr wrap="square" lIns="0" tIns="0" rIns="0" bIns="0" rtlCol="0" anchor="ctr"/>
-          <a:lstStyle/>
-          <a:p>
-            <a:pPr algn="ctr" indent="0" marL="0">
-              <a:buNone/>
-            </a:pPr>
-            <a:r>
-              <a:rPr lang="en-US" sz="900" b="1" dirty="0">
-                <a:solidFill>
-                  <a:srgbClr val="FFFFFF"/>
-                </a:solidFill>
-                <a:latin typeface="맑은 고딕" pitchFamily="34" charset="0"/>
-                <a:ea typeface="맑은 고딕" pitchFamily="34" charset="-122"/>
-                <a:cs typeface="맑은 고딕" pitchFamily="34" charset="-120"/>
-              </a:rPr>
-              <a:t>긴급</a:t>
-            </a:r>
-            <a:endParaRPr lang="en-US" sz="900" dirty="0"/>
-          </a:p>
-        </p:txBody>
-      </p:sp>
-      <p:sp>
-        <p:nvSpPr>
-          <p:cNvPr id="31" name="Text 28"/>
-          <p:cNvSpPr/>
-          <p:nvPr/>
-        </p:nvSpPr>
-        <p:spPr>
-          <a:xfrm>
-            <a:off x="8211312" y="4151376"/>
-            <a:ext cx="3291840" cy="274320"/>
-          </a:xfrm>
-          <a:prstGeom prst="rect">
-            <a:avLst/>
-          </a:prstGeom>
-          <a:noFill/>
-          <a:ln/>
-        </p:spPr>
-        <p:txBody>
-          <a:bodyPr wrap="square" lIns="0" tIns="0" rIns="0" bIns="0" rtlCol="0" anchor="ctr"/>
-          <a:lstStyle/>
-          <a:p>
-            <a:pPr indent="0" marL="0">
-              <a:buNone/>
-            </a:pPr>
-            <a:r>
-              <a:rPr lang="en-US" sz="1100" b="1" dirty="0">
-                <a:solidFill>
-                  <a:srgbClr val="0B1220"/>
-                </a:solidFill>
-                <a:latin typeface="맑은 고딕" pitchFamily="34" charset="0"/>
-                <a:ea typeface="맑은 고딕" pitchFamily="34" charset="-122"/>
-                <a:cs typeface="맑은 고딕" pitchFamily="34" charset="-120"/>
-              </a:rPr>
               <a:t>Tangle Keychain</a:t>
             </a:r>
             <a:endParaRPr lang="en-US" sz="1100" dirty="0"/>
@@ -7771,13 +7565,13 @@
       </p:sp>
       <p:sp>
         <p:nvSpPr>
-          <p:cNvPr id="32" name="Text 29"/>
-          <p:cNvSpPr/>
-          <p:nvPr/>
-        </p:nvSpPr>
-        <p:spPr>
-          <a:xfrm>
-            <a:off x="8211312" y="4425696"/>
+          <p:cNvPr id="26" name="Text 23"/>
+          <p:cNvSpPr/>
+          <p:nvPr/>
+        </p:nvSpPr>
+        <p:spPr>
+          <a:xfrm>
+            <a:off x="8211312" y="3712464"/>
             <a:ext cx="3291840" cy="256032"/>
           </a:xfrm>
           <a:prstGeom prst="rect">
@@ -7824,13 +7618,13 @@
       </p:sp>
       <p:sp>
         <p:nvSpPr>
-          <p:cNvPr id="33" name="Shape 30"/>
-          <p:cNvSpPr/>
-          <p:nvPr/>
-        </p:nvSpPr>
-        <p:spPr>
-          <a:xfrm>
-            <a:off x="7406640" y="4809744"/>
+          <p:cNvPr id="27" name="Shape 24"/>
+          <p:cNvSpPr/>
+          <p:nvPr/>
+        </p:nvSpPr>
+        <p:spPr>
+          <a:xfrm>
+            <a:off x="7406640" y="4096512"/>
             <a:ext cx="4206240" cy="640080"/>
           </a:xfrm>
           <a:prstGeom prst="rect">
@@ -7849,13 +7643,13 @@
       </p:sp>
       <p:sp>
         <p:nvSpPr>
-          <p:cNvPr id="34" name="Shape 31"/>
-          <p:cNvSpPr/>
-          <p:nvPr/>
-        </p:nvSpPr>
-        <p:spPr>
-          <a:xfrm>
-            <a:off x="7406640" y="4809744"/>
+          <p:cNvPr id="28" name="Shape 25"/>
+          <p:cNvSpPr/>
+          <p:nvPr/>
+        </p:nvSpPr>
+        <p:spPr>
+          <a:xfrm>
+            <a:off x="7406640" y="4096512"/>
             <a:ext cx="109728" cy="640080"/>
           </a:xfrm>
           <a:prstGeom prst="rect">
@@ -7874,13 +7668,13 @@
       </p:sp>
       <p:sp>
         <p:nvSpPr>
-          <p:cNvPr id="35" name="Shape 32"/>
-          <p:cNvSpPr/>
-          <p:nvPr/>
-        </p:nvSpPr>
-        <p:spPr>
-          <a:xfrm>
-            <a:off x="7571232" y="4901184"/>
+          <p:cNvPr id="29" name="Shape 26"/>
+          <p:cNvSpPr/>
+          <p:nvPr/>
+        </p:nvSpPr>
+        <p:spPr>
+          <a:xfrm>
+            <a:off x="7571232" y="4187952"/>
             <a:ext cx="548640" cy="256032"/>
           </a:xfrm>
           <a:prstGeom prst="rect">
@@ -7899,13 +7693,13 @@
       </p:sp>
       <p:sp>
         <p:nvSpPr>
-          <p:cNvPr id="36" name="Text 33"/>
-          <p:cNvSpPr/>
-          <p:nvPr/>
-        </p:nvSpPr>
-        <p:spPr>
-          <a:xfrm>
-            <a:off x="7571232" y="4901184"/>
+          <p:cNvPr id="30" name="Text 27"/>
+          <p:cNvSpPr/>
+          <p:nvPr/>
+        </p:nvSpPr>
+        <p:spPr>
+          <a:xfrm>
+            <a:off x="7571232" y="4187952"/>
             <a:ext cx="548640" cy="256032"/>
           </a:xfrm>
           <a:prstGeom prst="rect">
@@ -7938,13 +7732,13 @@
       </p:sp>
       <p:sp>
         <p:nvSpPr>
-          <p:cNvPr id="37" name="Text 34"/>
-          <p:cNvSpPr/>
-          <p:nvPr/>
-        </p:nvSpPr>
-        <p:spPr>
-          <a:xfrm>
-            <a:off x="8211312" y="4864608"/>
+          <p:cNvPr id="31" name="Text 28"/>
+          <p:cNvSpPr/>
+          <p:nvPr/>
+        </p:nvSpPr>
+        <p:spPr>
+          <a:xfrm>
+            <a:off x="8211312" y="4151376"/>
             <a:ext cx="3291840" cy="274320"/>
           </a:xfrm>
           <a:prstGeom prst="rect">
@@ -7977,13 +7771,13 @@
       </p:sp>
       <p:sp>
         <p:nvSpPr>
-          <p:cNvPr id="38" name="Text 35"/>
-          <p:cNvSpPr/>
-          <p:nvPr/>
-        </p:nvSpPr>
-        <p:spPr>
-          <a:xfrm>
-            <a:off x="8211312" y="5138928"/>
+          <p:cNvPr id="32" name="Text 29"/>
+          <p:cNvSpPr/>
+          <p:nvPr/>
+        </p:nvSpPr>
+        <p:spPr>
+          <a:xfrm>
+            <a:off x="8211312" y="4425696"/>
             <a:ext cx="3291840" cy="256032"/>
           </a:xfrm>
           <a:prstGeom prst="rect">
@@ -8030,13 +7824,13 @@
       </p:sp>
       <p:sp>
         <p:nvSpPr>
-          <p:cNvPr id="39" name="Shape 36"/>
-          <p:cNvSpPr/>
-          <p:nvPr/>
-        </p:nvSpPr>
-        <p:spPr>
-          <a:xfrm>
-            <a:off x="7406640" y="5522976"/>
+          <p:cNvPr id="33" name="Shape 30"/>
+          <p:cNvSpPr/>
+          <p:nvPr/>
+        </p:nvSpPr>
+        <p:spPr>
+          <a:xfrm>
+            <a:off x="7406640" y="4809744"/>
             <a:ext cx="4206240" cy="640080"/>
           </a:xfrm>
           <a:prstGeom prst="rect">
@@ -8055,13 +7849,13 @@
       </p:sp>
       <p:sp>
         <p:nvSpPr>
-          <p:cNvPr id="40" name="Shape 37"/>
-          <p:cNvSpPr/>
-          <p:nvPr/>
-        </p:nvSpPr>
-        <p:spPr>
-          <a:xfrm>
-            <a:off x="7406640" y="5522976"/>
+          <p:cNvPr id="34" name="Shape 31"/>
+          <p:cNvSpPr/>
+          <p:nvPr/>
+        </p:nvSpPr>
+        <p:spPr>
+          <a:xfrm>
+            <a:off x="7406640" y="4809744"/>
             <a:ext cx="109728" cy="640080"/>
           </a:xfrm>
           <a:prstGeom prst="rect">
@@ -8080,13 +7874,13 @@
       </p:sp>
       <p:sp>
         <p:nvSpPr>
-          <p:cNvPr id="41" name="Shape 38"/>
-          <p:cNvSpPr/>
-          <p:nvPr/>
-        </p:nvSpPr>
-        <p:spPr>
-          <a:xfrm>
-            <a:off x="7571232" y="5614416"/>
+          <p:cNvPr id="35" name="Shape 32"/>
+          <p:cNvSpPr/>
+          <p:nvPr/>
+        </p:nvSpPr>
+        <p:spPr>
+          <a:xfrm>
+            <a:off x="7571232" y="4901184"/>
             <a:ext cx="548640" cy="256032"/>
           </a:xfrm>
           <a:prstGeom prst="rect">
@@ -8105,13 +7899,13 @@
       </p:sp>
       <p:sp>
         <p:nvSpPr>
-          <p:cNvPr id="42" name="Text 39"/>
-          <p:cNvSpPr/>
-          <p:nvPr/>
-        </p:nvSpPr>
-        <p:spPr>
-          <a:xfrm>
-            <a:off x="7571232" y="5614416"/>
+          <p:cNvPr id="36" name="Text 33"/>
+          <p:cNvSpPr/>
+          <p:nvPr/>
+        </p:nvSpPr>
+        <p:spPr>
+          <a:xfrm>
+            <a:off x="7571232" y="4901184"/>
             <a:ext cx="548640" cy="256032"/>
           </a:xfrm>
           <a:prstGeom prst="rect">
@@ -8144,13 +7938,13 @@
       </p:sp>
       <p:sp>
         <p:nvSpPr>
-          <p:cNvPr id="43" name="Text 40"/>
-          <p:cNvSpPr/>
-          <p:nvPr/>
-        </p:nvSpPr>
-        <p:spPr>
-          <a:xfrm>
-            <a:off x="8211312" y="5577840"/>
+          <p:cNvPr id="37" name="Text 34"/>
+          <p:cNvSpPr/>
+          <p:nvPr/>
+        </p:nvSpPr>
+        <p:spPr>
+          <a:xfrm>
+            <a:off x="8211312" y="4864608"/>
             <a:ext cx="3291840" cy="274320"/>
           </a:xfrm>
           <a:prstGeom prst="rect">
@@ -8183,13 +7977,13 @@
       </p:sp>
       <p:sp>
         <p:nvSpPr>
-          <p:cNvPr id="44" name="Text 41"/>
-          <p:cNvSpPr/>
-          <p:nvPr/>
-        </p:nvSpPr>
-        <p:spPr>
-          <a:xfrm>
-            <a:off x="8211312" y="5852160"/>
+          <p:cNvPr id="38" name="Text 35"/>
+          <p:cNvSpPr/>
+          <p:nvPr/>
+        </p:nvSpPr>
+        <p:spPr>
+          <a:xfrm>
+            <a:off x="8211312" y="5138928"/>
             <a:ext cx="3291840" cy="256032"/>
           </a:xfrm>
           <a:prstGeom prst="rect">
@@ -8236,6 +8030,212 @@
       </p:sp>
       <p:sp>
         <p:nvSpPr>
+          <p:cNvPr id="39" name="Shape 36"/>
+          <p:cNvSpPr/>
+          <p:nvPr/>
+        </p:nvSpPr>
+        <p:spPr>
+          <a:xfrm>
+            <a:off x="7406640" y="5522976"/>
+            <a:ext cx="4206240" cy="640080"/>
+          </a:xfrm>
+          <a:prstGeom prst="rect">
+            <a:avLst/>
+          </a:prstGeom>
+          <a:solidFill>
+            <a:srgbClr val="FFF5F5"/>
+          </a:solidFill>
+          <a:ln w="6350">
+            <a:solidFill>
+              <a:srgbClr val="E5E7EB"/>
+            </a:solidFill>
+            <a:prstDash val="solid"/>
+          </a:ln>
+        </p:spPr>
+      </p:sp>
+      <p:sp>
+        <p:nvSpPr>
+          <p:cNvPr id="40" name="Shape 37"/>
+          <p:cNvSpPr/>
+          <p:nvPr/>
+        </p:nvSpPr>
+        <p:spPr>
+          <a:xfrm>
+            <a:off x="7406640" y="5522976"/>
+            <a:ext cx="109728" cy="640080"/>
+          </a:xfrm>
+          <a:prstGeom prst="rect">
+            <a:avLst/>
+          </a:prstGeom>
+          <a:solidFill>
+            <a:srgbClr val="D72638"/>
+          </a:solidFill>
+          <a:ln w="12700">
+            <a:solidFill>
+              <a:srgbClr val="D72638"/>
+            </a:solidFill>
+            <a:prstDash val="solid"/>
+          </a:ln>
+        </p:spPr>
+      </p:sp>
+      <p:sp>
+        <p:nvSpPr>
+          <p:cNvPr id="41" name="Shape 38"/>
+          <p:cNvSpPr/>
+          <p:nvPr/>
+        </p:nvSpPr>
+        <p:spPr>
+          <a:xfrm>
+            <a:off x="7571232" y="5614416"/>
+            <a:ext cx="548640" cy="256032"/>
+          </a:xfrm>
+          <a:prstGeom prst="rect">
+            <a:avLst/>
+          </a:prstGeom>
+          <a:solidFill>
+            <a:srgbClr val="D72638"/>
+          </a:solidFill>
+          <a:ln w="12700">
+            <a:solidFill>
+              <a:srgbClr val="D72638"/>
+            </a:solidFill>
+            <a:prstDash val="solid"/>
+          </a:ln>
+        </p:spPr>
+      </p:sp>
+      <p:sp>
+        <p:nvSpPr>
+          <p:cNvPr id="42" name="Text 39"/>
+          <p:cNvSpPr/>
+          <p:nvPr/>
+        </p:nvSpPr>
+        <p:spPr>
+          <a:xfrm>
+            <a:off x="7571232" y="5614416"/>
+            <a:ext cx="548640" cy="256032"/>
+          </a:xfrm>
+          <a:prstGeom prst="rect">
+            <a:avLst/>
+          </a:prstGeom>
+          <a:noFill/>
+          <a:ln/>
+        </p:spPr>
+        <p:txBody>
+          <a:bodyPr wrap="square" lIns="0" tIns="0" rIns="0" bIns="0" rtlCol="0" anchor="ctr"/>
+          <a:lstStyle/>
+          <a:p>
+            <a:pPr algn="ctr" indent="0" marL="0">
+              <a:buNone/>
+            </a:pPr>
+            <a:r>
+              <a:rPr lang="en-US" sz="900" b="1" dirty="0">
+                <a:solidFill>
+                  <a:srgbClr val="FFFFFF"/>
+                </a:solidFill>
+                <a:latin typeface="맑은 고딕" pitchFamily="34" charset="0"/>
+                <a:ea typeface="맑은 고딕" pitchFamily="34" charset="-122"/>
+                <a:cs typeface="맑은 고딕" pitchFamily="34" charset="-120"/>
+              </a:rPr>
+              <a:t>긴급</a:t>
+            </a:r>
+            <a:endParaRPr lang="en-US" sz="900" dirty="0"/>
+          </a:p>
+        </p:txBody>
+      </p:sp>
+      <p:sp>
+        <p:nvSpPr>
+          <p:cNvPr id="43" name="Text 40"/>
+          <p:cNvSpPr/>
+          <p:nvPr/>
+        </p:nvSpPr>
+        <p:spPr>
+          <a:xfrm>
+            <a:off x="8211312" y="5577840"/>
+            <a:ext cx="3291840" cy="274320"/>
+          </a:xfrm>
+          <a:prstGeom prst="rect">
+            <a:avLst/>
+          </a:prstGeom>
+          <a:noFill/>
+          <a:ln/>
+        </p:spPr>
+        <p:txBody>
+          <a:bodyPr wrap="square" lIns="0" tIns="0" rIns="0" bIns="0" rtlCol="0" anchor="ctr"/>
+          <a:lstStyle/>
+          <a:p>
+            <a:pPr indent="0" marL="0">
+              <a:buNone/>
+            </a:pPr>
+            <a:r>
+              <a:rPr lang="en-US" sz="1100" b="1" dirty="0">
+                <a:solidFill>
+                  <a:srgbClr val="0B1220"/>
+                </a:solidFill>
+                <a:latin typeface="맑은 고딕" pitchFamily="34" charset="0"/>
+                <a:ea typeface="맑은 고딕" pitchFamily="34" charset="-122"/>
+                <a:cs typeface="맑은 고딕" pitchFamily="34" charset="-120"/>
+              </a:rPr>
+              <a:t>[SILVER925] CH.alban Open Ring</a:t>
+            </a:r>
+            <a:endParaRPr lang="en-US" sz="1100" dirty="0"/>
+          </a:p>
+        </p:txBody>
+      </p:sp>
+      <p:sp>
+        <p:nvSpPr>
+          <p:cNvPr id="44" name="Text 41"/>
+          <p:cNvSpPr/>
+          <p:nvPr/>
+        </p:nvSpPr>
+        <p:spPr>
+          <a:xfrm>
+            <a:off x="8211312" y="5852160"/>
+            <a:ext cx="3291840" cy="256032"/>
+          </a:xfrm>
+          <a:prstGeom prst="rect">
+            <a:avLst/>
+          </a:prstGeom>
+          <a:noFill/>
+          <a:ln/>
+        </p:spPr>
+        <p:txBody>
+          <a:bodyPr wrap="square" lIns="0" tIns="0" rIns="0" bIns="0" rtlCol="0" anchor="ctr"/>
+          <a:lstStyle/>
+          <a:p>
+            <a:pPr indent="0" marL="0">
+              <a:buNone/>
+            </a:pPr>
+            <a:r>
+              <a:rPr lang="en-US" sz="1000" dirty="0">
+                <a:solidFill>
+                  <a:srgbClr val="6B7280"/>
+                </a:solidFill>
+                <a:latin typeface="맑은 고딕" pitchFamily="34" charset="0"/>
+                <a:ea typeface="맑은 고딕" pitchFamily="34" charset="-122"/>
+                <a:cs typeface="맑은 고딕" pitchFamily="34" charset="-120"/>
+              </a:rPr>
+              <a:t>Ring  ·  재고 1개</a:t>
+            </a:r>
+            <a:pPr indent="0" marL="0">
+              <a:buNone/>
+            </a:pPr>
+            <a:r>
+              <a:rPr lang="en-US" sz="1000" b="1" dirty="0">
+                <a:solidFill>
+                  <a:srgbClr val="D72638"/>
+                </a:solidFill>
+                <a:latin typeface="맑은 고딕" pitchFamily="34" charset="0"/>
+                <a:ea typeface="맑은 고딕" pitchFamily="34" charset="-122"/>
+                <a:cs typeface="맑은 고딕" pitchFamily="34" charset="-120"/>
+              </a:rPr>
+              <a:t/>
+            </a:r>
+            <a:endParaRPr lang="en-US" sz="1000" dirty="0"/>
+          </a:p>
+        </p:txBody>
+      </p:sp>
+      <p:sp>
+        <p:nvSpPr>
           <p:cNvPr id="45" name="Text 42"/>
           <p:cNvSpPr/>
           <p:nvPr/>
@@ -8267,7 +8267,7 @@
                 <a:ea typeface="맑은 고딕" pitchFamily="34" charset="-122"/>
                 <a:cs typeface="맑은 고딕" pitchFamily="34" charset="-120"/>
               </a:rPr>
-              <a:t>베스트 상품 리포트  ·  생성 2026-05-12 11:12</a:t>
+              <a:t>베스트 상품 리포트  ·  생성 2026-05-13 12:17</a:t>
             </a:r>
             <a:endParaRPr lang="en-US" sz="900" dirty="0"/>
           </a:p>
@@ -8480,7 +8480,7 @@
                 <a:ea typeface="맑은 고딕" pitchFamily="34" charset="-122"/>
                 <a:cs typeface="맑은 고딕" pitchFamily="34" charset="-120"/>
               </a:rPr>
-              <a:t>2026년 05월 12일 (화)</a:t>
+              <a:t>2026년 05월 13일 (수)</a:t>
             </a:r>
             <a:endParaRPr lang="en-US" sz="1200" dirty="0"/>
           </a:p>
@@ -8647,7 +8647,7 @@
                 <a:ea typeface="맑은 고딕" pitchFamily="34" charset="-122"/>
                 <a:cs typeface="맑은 고딕" pitchFamily="34" charset="-120"/>
               </a:rPr>
-              <a:t>0 개</a:t>
+              <a:t>1 개</a:t>
             </a:r>
             <a:endParaRPr lang="en-US" sz="3600" dirty="0"/>
           </a:p>
@@ -8775,7 +8775,7 @@
                 <a:ea typeface="맑은 고딕" pitchFamily="34" charset="-122"/>
                 <a:cs typeface="맑은 고딕" pitchFamily="34" charset="-120"/>
               </a:rPr>
-              <a:t>CandyPOP Necklace (사이즈: 2size (47~52cm))</a:t>
+              <a:t>CandyPOP Necklace (사이즈: 1size (41.5~47cm))</a:t>
             </a:r>
             <a:endParaRPr lang="en-US" sz="1800" dirty="0"/>
           </a:p>
@@ -8853,7 +8853,7 @@
                 <a:ea typeface="맑은 고딕" pitchFamily="34" charset="-122"/>
                 <a:cs typeface="맑은 고딕" pitchFamily="34" charset="-120"/>
               </a:rPr>
-              <a:t>5</a:t>
+              <a:t>1</a:t>
             </a:r>
             <a:endParaRPr lang="en-US" sz="4400" dirty="0"/>
           </a:p>
@@ -9257,7 +9257,7 @@
                           <a:ea typeface="맑은 고딕" pitchFamily="34" charset="-122"/>
                           <a:cs typeface="맑은 고딕" pitchFamily="34" charset="-120"/>
                         </a:rPr>
-                        <a:t/>
+                        <a:t>1</a:t>
                       </a:r>
                       <a:endParaRPr lang="en-US" sz="1100" dirty="0">
                         <a:latin typeface="맑은 고딕" charset="0"/>
@@ -9322,7 +9322,7 @@
                           <a:ea typeface="맑은 고딕" pitchFamily="34" charset="-122"/>
                           <a:cs typeface="맑은 고딕" pitchFamily="34" charset="-120"/>
                         </a:rPr>
-                        <a:t/>
+                        <a:t>Necklace</a:t>
                       </a:r>
                       <a:endParaRPr lang="en-US" sz="1000" dirty="0">
                         <a:latin typeface="맑은 고딕" charset="0"/>
@@ -9387,7 +9387,7 @@
                           <a:ea typeface="맑은 고딕" pitchFamily="34" charset="-122"/>
                           <a:cs typeface="맑은 고딕" pitchFamily="34" charset="-120"/>
                         </a:rPr>
-                        <a:t/>
+                        <a:t>CandyPOP Necklace (사이즈: 1size (41.5~47cm))</a:t>
                       </a:r>
                       <a:endParaRPr lang="en-US" sz="1100" dirty="0">
                         <a:latin typeface="맑은 고딕" charset="0"/>
@@ -9452,7 +9452,7 @@
                           <a:ea typeface="맑은 고딕" pitchFamily="34" charset="-122"/>
                           <a:cs typeface="맑은 고딕" pitchFamily="34" charset="-120"/>
                         </a:rPr>
-                        <a:t/>
+                        <a:t>1 개</a:t>
                       </a:r>
                       <a:endParaRPr lang="en-US" sz="1400" dirty="0">
                         <a:latin typeface="맑은 고딕" charset="0"/>
@@ -10062,7 +10062,7 @@
                 <a:ea typeface="맑은 고딕" pitchFamily="34" charset="-122"/>
                 <a:cs typeface="맑은 고딕" pitchFamily="34" charset="-120"/>
               </a:rPr>
-              <a:t>리오더 필요  🔴 긴급 8건</a:t>
+              <a:t>리오더 필요  🔴 긴급 15건</a:t>
             </a:r>
             <a:endParaRPr lang="en-US" sz="1500" dirty="0"/>
           </a:p>
@@ -10126,7 +10126,7 @@
                 <a:ea typeface="맑은 고딕" pitchFamily="34" charset="-122"/>
                 <a:cs typeface="맑은 고딕" pitchFamily="34" charset="-120"/>
               </a:rPr>
-              <a:t>🔴 긴급 8건  ·  상세는 시트 확인</a:t>
+              <a:t>🔴 긴급 15건  ·  상세는 시트 확인</a:t>
             </a:r>
             <a:endParaRPr lang="en-US" sz="1400" dirty="0"/>
           </a:p>
@@ -10165,7 +10165,7 @@
                 <a:ea typeface="맑은 고딕" pitchFamily="34" charset="-122"/>
                 <a:cs typeface="맑은 고딕" pitchFamily="34" charset="-120"/>
               </a:rPr>
-              <a:t>베스트 상품 리포트  ·  생성 2026-05-12 11:12</a:t>
+              <a:t>베스트 상품 리포트  ·  생성 2026-05-13 12:17</a:t>
             </a:r>
             <a:endParaRPr lang="en-US" sz="900" dirty="0"/>
           </a:p>
@@ -10378,7 +10378,7 @@
                 <a:ea typeface="맑은 고딕" pitchFamily="34" charset="-122"/>
                 <a:cs typeface="맑은 고딕" pitchFamily="34" charset="-120"/>
               </a:rPr>
-              <a:t>2026년 05월 12일 (화)</a:t>
+              <a:t>2026년 05월 13일 (수)</a:t>
             </a:r>
             <a:endParaRPr lang="en-US" sz="1200" dirty="0"/>
           </a:p>
@@ -10929,7 +10929,7 @@
                 <a:ea typeface="맑은 고딕" pitchFamily="34" charset="-122"/>
                 <a:cs typeface="맑은 고딕" pitchFamily="34" charset="-120"/>
               </a:rPr>
-              <a:t>43,250</a:t>
+              <a:t>42,578</a:t>
             </a:r>
             <a:endParaRPr lang="en-US" sz="3000" dirty="0"/>
           </a:p>
@@ -11489,7 +11489,7 @@
                           <a:ea typeface="맑은 고딕" pitchFamily="34" charset="-122"/>
                           <a:cs typeface="맑은 고딕" pitchFamily="34" charset="-120"/>
                         </a:rPr>
-                        <a:t>3,939</a:t>
+                        <a:t>3,936</a:t>
                       </a:r>
                       <a:endParaRPr lang="en-US" sz="1000" dirty="0">
                         <a:latin typeface="맑은 고딕" charset="0"/>
@@ -11751,7 +11751,7 @@
                           <a:ea typeface="맑은 고딕" pitchFamily="34" charset="-122"/>
                           <a:cs typeface="맑은 고딕" pitchFamily="34" charset="-120"/>
                         </a:rPr>
-                        <a:t>2,874</a:t>
+                        <a:t>2,791</a:t>
                       </a:r>
                       <a:endParaRPr lang="en-US" sz="1000" dirty="0">
                         <a:latin typeface="맑은 고딕" charset="0"/>
@@ -12013,7 +12013,7 @@
                           <a:ea typeface="맑은 고딕" pitchFamily="34" charset="-122"/>
                           <a:cs typeface="맑은 고딕" pitchFamily="34" charset="-120"/>
                         </a:rPr>
-                        <a:t>2,504</a:t>
+                        <a:t>2,500</a:t>
                       </a:r>
                       <a:endParaRPr lang="en-US" sz="1000" dirty="0">
                         <a:latin typeface="맑은 고딕" charset="0"/>
@@ -12275,7 +12275,7 @@
                           <a:ea typeface="맑은 고딕" pitchFamily="34" charset="-122"/>
                           <a:cs typeface="맑은 고딕" pitchFamily="34" charset="-120"/>
                         </a:rPr>
-                        <a:t>2,321</a:t>
+                        <a:t>2,281</a:t>
                       </a:r>
                       <a:endParaRPr lang="en-US" sz="1000" dirty="0">
                         <a:latin typeface="맑은 고딕" charset="0"/>
@@ -12537,7 +12537,7 @@
                           <a:ea typeface="맑은 고딕" pitchFamily="34" charset="-122"/>
                           <a:cs typeface="맑은 고딕" pitchFamily="34" charset="-120"/>
                         </a:rPr>
-                        <a:t>2,012</a:t>
+                        <a:t>1,937</a:t>
                       </a:r>
                       <a:endParaRPr lang="en-US" sz="1000" dirty="0">
                         <a:latin typeface="맑은 고딕" charset="0"/>
@@ -13556,7 +13556,7 @@
                 <a:ea typeface="맑은 고딕" pitchFamily="34" charset="-122"/>
                 <a:cs typeface="맑은 고딕" pitchFamily="34" charset="-120"/>
               </a:rPr>
-              <a:t>베스트 상품 리포트  ·  생성 2026-05-12 11:12</a:t>
+              <a:t>베스트 상품 리포트  ·  생성 2026-05-13 12:17</a:t>
             </a:r>
             <a:endParaRPr lang="en-US" sz="900" dirty="0"/>
           </a:p>
@@ -13769,7 +13769,7 @@
                 <a:ea typeface="맑은 고딕" pitchFamily="34" charset="-122"/>
                 <a:cs typeface="맑은 고딕" pitchFamily="34" charset="-120"/>
               </a:rPr>
-              <a:t>2026년 05월 12일 (화)</a:t>
+              <a:t>2026년 05월 13일 (수)</a:t>
             </a:r>
             <a:endParaRPr lang="en-US" sz="1200" dirty="0"/>
           </a:p>
@@ -13897,7 +13897,7 @@
                 <a:ea typeface="맑은 고딕" pitchFamily="34" charset="-122"/>
                 <a:cs typeface="맑은 고딕" pitchFamily="34" charset="-120"/>
               </a:rPr>
-              <a:t>🚨  긴급 리오더 38건    ·    주의 리오더 4건    ·    오늘 발주 검토 필수</a:t>
+              <a:t>🚨  긴급 리오더 45건    ·    주의 리오더 9건    ·    오늘 발주 검토 필수</a:t>
             </a:r>
             <a:pPr indent="0" marL="0">
               <a:buNone/>
@@ -14595,7 +14595,7 @@
                           <a:ea typeface="맑은 고딕" pitchFamily="34" charset="-122"/>
                           <a:cs typeface="맑은 고딕" pitchFamily="34" charset="-120"/>
                         </a:rPr>
-                        <a:t>Ring</a:t>
+                        <a:t>★Season off★</a:t>
                       </a:r>
                       <a:endParaRPr lang="en-US" sz="1000" dirty="0">
                         <a:latin typeface="맑은 고딕" charset="0"/>
@@ -14663,7 +14663,7 @@
                           <a:ea typeface="맑은 고딕" pitchFamily="34" charset="-122"/>
                           <a:cs typeface="맑은 고딕" pitchFamily="34" charset="-120"/>
                         </a:rPr>
-                        <a:t>[SILVER925] CH.alban Open Ring</a:t>
+                        <a:t>Tangle Keychain</a:t>
                       </a:r>
                       <a:endParaRPr lang="en-US" sz="1100" dirty="0">
                         <a:latin typeface="맑은 고딕" charset="0"/>
@@ -14731,7 +14731,7 @@
                           <a:ea typeface="맑은 고딕" pitchFamily="34" charset="-122"/>
                           <a:cs typeface="맑은 고딕" pitchFamily="34" charset="-120"/>
                         </a:rPr>
-                        <a:t>0</a:t>
+                        <a:t>5</a:t>
                       </a:r>
                       <a:endParaRPr lang="en-US" sz="1100" dirty="0">
                         <a:latin typeface="맑은 고딕" charset="0"/>
@@ -14799,7 +14799,7 @@
                           <a:ea typeface="맑은 고딕" pitchFamily="34" charset="-122"/>
                           <a:cs typeface="맑은 고딕" pitchFamily="34" charset="-120"/>
                         </a:rPr>
-                        <a:t>1 개</a:t>
+                        <a:t>0 개</a:t>
                       </a:r>
                       <a:endParaRPr lang="en-US" sz="1100" dirty="0">
                         <a:latin typeface="맑은 고딕" charset="0"/>
@@ -15073,7 +15073,7 @@
                           <a:ea typeface="맑은 고딕" pitchFamily="34" charset="-122"/>
                           <a:cs typeface="맑은 고딕" pitchFamily="34" charset="-120"/>
                         </a:rPr>
-                        <a:t>Tangle Keychain</a:t>
+                        <a:t>8-Ball Smart Tok</a:t>
                       </a:r>
                       <a:endParaRPr lang="en-US" sz="1100" dirty="0">
                         <a:latin typeface="맑은 고딕" charset="0"/>
@@ -15415,7 +15415,7 @@
                           <a:ea typeface="맑은 고딕" pitchFamily="34" charset="-122"/>
                           <a:cs typeface="맑은 고딕" pitchFamily="34" charset="-120"/>
                         </a:rPr>
-                        <a:t>★Season off★</a:t>
+                        <a:t>Necklace</a:t>
                       </a:r>
                       <a:endParaRPr lang="en-US" sz="1000" dirty="0">
                         <a:latin typeface="맑은 고딕" charset="0"/>
@@ -15483,7 +15483,7 @@
                           <a:ea typeface="맑은 고딕" pitchFamily="34" charset="-122"/>
                           <a:cs typeface="맑은 고딕" pitchFamily="34" charset="-120"/>
                         </a:rPr>
-                        <a:t>8-Ball Smart Tok</a:t>
+                        <a:t>B-Flower Necklace (Size: 2 Size)</a:t>
                       </a:r>
                       <a:endParaRPr lang="en-US" sz="1100" dirty="0">
                         <a:latin typeface="맑은 고딕" charset="0"/>
@@ -15551,7 +15551,7 @@
                           <a:ea typeface="맑은 고딕" pitchFamily="34" charset="-122"/>
                           <a:cs typeface="맑은 고딕" pitchFamily="34" charset="-120"/>
                         </a:rPr>
-                        <a:t>5</a:t>
+                        <a:t>4</a:t>
                       </a:r>
                       <a:endParaRPr lang="en-US" sz="1100" dirty="0">
                         <a:latin typeface="맑은 고딕" charset="0"/>
@@ -15825,7 +15825,7 @@
                           <a:ea typeface="맑은 고딕" pitchFamily="34" charset="-122"/>
                           <a:cs typeface="맑은 고딕" pitchFamily="34" charset="-120"/>
                         </a:rPr>
-                        <a:t>Necklace</a:t>
+                        <a:t>Ring</a:t>
                       </a:r>
                       <a:endParaRPr lang="en-US" sz="1000" dirty="0">
                         <a:latin typeface="맑은 고딕" charset="0"/>
@@ -15893,7 +15893,7 @@
                           <a:ea typeface="맑은 고딕" pitchFamily="34" charset="-122"/>
                           <a:cs typeface="맑은 고딕" pitchFamily="34" charset="-120"/>
                         </a:rPr>
-                        <a:t>B-Flower Necklace (Size: 2 Size)</a:t>
+                        <a:t>[SILVER925] CH.alban Open Ring</a:t>
                       </a:r>
                       <a:endParaRPr lang="en-US" sz="1100" dirty="0">
                         <a:latin typeface="맑은 고딕" charset="0"/>
@@ -15961,7 +15961,7 @@
                           <a:ea typeface="맑은 고딕" pitchFamily="34" charset="-122"/>
                           <a:cs typeface="맑은 고딕" pitchFamily="34" charset="-120"/>
                         </a:rPr>
-                        <a:t>4</a:t>
+                        <a:t>1</a:t>
                       </a:r>
                       <a:endParaRPr lang="en-US" sz="1100" dirty="0">
                         <a:latin typeface="맑은 고딕" charset="0"/>
@@ -17123,7 +17123,7 @@
                           <a:ea typeface="맑은 고딕" pitchFamily="34" charset="-122"/>
                           <a:cs typeface="맑은 고딕" pitchFamily="34" charset="-120"/>
                         </a:rPr>
-                        <a:t>"Socmall" 925 Open Ring</a:t>
+                        <a:t>"Mobiuss" 925 Open Ring</a:t>
                       </a:r>
                       <a:endParaRPr lang="en-US" sz="1100" dirty="0">
                         <a:latin typeface="맑은 고딕" charset="0"/>
@@ -17191,7 +17191,7 @@
                           <a:ea typeface="맑은 고딕" pitchFamily="34" charset="-122"/>
                           <a:cs typeface="맑은 고딕" pitchFamily="34" charset="-120"/>
                         </a:rPr>
-                        <a:t>0</a:t>
+                        <a:t>2</a:t>
                       </a:r>
                       <a:endParaRPr lang="en-US" sz="1100" dirty="0">
                         <a:latin typeface="맑은 고딕" charset="0"/>
@@ -17533,7 +17533,7 @@
                           <a:ea typeface="맑은 고딕" pitchFamily="34" charset="-122"/>
                           <a:cs typeface="맑은 고딕" pitchFamily="34" charset="-120"/>
                         </a:rPr>
-                        <a:t>"Serendlory" 925 Open Ring</a:t>
+                        <a:t>"Primošten" 925 Open Ring</a:t>
                       </a:r>
                       <a:endParaRPr lang="en-US" sz="1100" dirty="0">
                         <a:latin typeface="맑은 고딕" charset="0"/>
@@ -17601,7 +17601,7 @@
                           <a:ea typeface="맑은 고딕" pitchFamily="34" charset="-122"/>
                           <a:cs typeface="맑은 고딕" pitchFamily="34" charset="-120"/>
                         </a:rPr>
-                        <a:t>0</a:t>
+                        <a:t>2</a:t>
                       </a:r>
                       <a:endParaRPr lang="en-US" sz="1100" dirty="0">
                         <a:latin typeface="맑은 고딕" charset="0"/>
@@ -17943,7 +17943,7 @@
                           <a:ea typeface="맑은 고딕" pitchFamily="34" charset="-122"/>
                           <a:cs typeface="맑은 고딕" pitchFamily="34" charset="-120"/>
                         </a:rPr>
-                        <a:t>"Usongtar" 925 Open Ring</a:t>
+                        <a:t>"Shirakawago" 925 Open Ring</a:t>
                       </a:r>
                       <a:endParaRPr lang="en-US" sz="1100" dirty="0">
                         <a:latin typeface="맑은 고딕" charset="0"/>
@@ -18011,7 +18011,7 @@
                           <a:ea typeface="맑은 고딕" pitchFamily="34" charset="-122"/>
                           <a:cs typeface="맑은 고딕" pitchFamily="34" charset="-120"/>
                         </a:rPr>
-                        <a:t>0</a:t>
+                        <a:t>2</a:t>
                       </a:r>
                       <a:endParaRPr lang="en-US" sz="1100" dirty="0">
                         <a:latin typeface="맑은 고딕" charset="0"/>
@@ -18168,7 +18168,7 @@
                 <a:ea typeface="맑은 고딕" pitchFamily="34" charset="-122"/>
                 <a:cs typeface="맑은 고딕" pitchFamily="34" charset="-120"/>
               </a:rPr>
-              <a:t>외 29건 더 있음 — 상세는 시트에서 확인</a:t>
+              <a:t>외 36건 더 있음 — 상세는 시트에서 확인</a:t>
             </a:r>
             <a:endParaRPr lang="en-US" sz="1000" dirty="0"/>
           </a:p>
@@ -18207,7 +18207,7 @@
                 <a:ea typeface="맑은 고딕" pitchFamily="34" charset="-122"/>
                 <a:cs typeface="맑은 고딕" pitchFamily="34" charset="-120"/>
               </a:rPr>
-              <a:t>베스트 상품 리포트  ·  생성 2026-05-12 11:12</a:t>
+              <a:t>베스트 상품 리포트  ·  생성 2026-05-13 12:17</a:t>
             </a:r>
             <a:endParaRPr lang="en-US" sz="900" dirty="0"/>
           </a:p>
@@ -18420,7 +18420,7 @@
                 <a:ea typeface="맑은 고딕" pitchFamily="34" charset="-122"/>
                 <a:cs typeface="맑은 고딕" pitchFamily="34" charset="-120"/>
               </a:rPr>
-              <a:t>2026년 05월 12일 (화)</a:t>
+              <a:t>2026년 05월 13일 (수)</a:t>
             </a:r>
             <a:endParaRPr lang="en-US" sz="1200" dirty="0"/>
           </a:p>
@@ -18587,7 +18587,7 @@
                 <a:ea typeface="맑은 고딕" pitchFamily="34" charset="-122"/>
                 <a:cs typeface="맑은 고딕" pitchFamily="34" charset="-120"/>
               </a:rPr>
-              <a:t>Google Sheet '브랜드 재고현황'  ·  최신화 2026-05-12 11:12</a:t>
+              <a:t>Google Sheet '브랜드 재고현황'  ·  최신화 2026-05-13 12:17</a:t>
             </a:r>
             <a:endParaRPr lang="en-US" sz="1100" dirty="0"/>
           </a:p>
@@ -19099,7 +19099,7 @@
                 <a:ea typeface="맑은 고딕" pitchFamily="34" charset="-122"/>
                 <a:cs typeface="맑은 고딕" pitchFamily="34" charset="-120"/>
               </a:rPr>
-              <a:t>✅ 6A 82 SKU  /  ✅ Cleartype 49 SKU  /  ✅ Produktepr 192 SKU (판매 수집됨)</a:t>
+              <a:t>✅ 6A 84 SKU  /  ✅ Cleartype 57 SKU  /  ✅ Produktepr 192 SKU (판매 수집됨)</a:t>
             </a:r>
             <a:endParaRPr lang="en-US" sz="1100" dirty="0"/>
           </a:p>
@@ -19269,7 +19269,7 @@
                 <a:ea typeface="맑은 고딕" pitchFamily="34" charset="-122"/>
                 <a:cs typeface="맑은 고딕" pitchFamily="34" charset="-120"/>
               </a:rPr>
-              <a:t>베스트 상품 리포트  ·  생성 2026-05-12 11:12</a:t>
+              <a:t>베스트 상품 리포트  ·  생성 2026-05-13 12:17</a:t>
             </a:r>
             <a:endParaRPr lang="en-US" sz="900" dirty="0"/>
           </a:p>

</xml_diff>

<commit_message>
chore: 매출 PPT 업로드 (best-sellers-2026-05-13.pptx) [auto]
</commit_message>
<xml_diff>
--- a/data/sales-report.pptx
+++ b/data/sales-report.pptx
@@ -1804,7 +1804,7 @@
                 <a:ea typeface="맑은 고딕" pitchFamily="34" charset="-122"/>
                 <a:cs typeface="맑은 고딕" pitchFamily="34" charset="-120"/>
               </a:rPr>
-              <a:t>생성 2026-05-13 12:17  ·  Google Sheet 자동 동기</a:t>
+              <a:t>생성 2026-05-13 13:47  ·  Google Sheet 자동 동기</a:t>
             </a:r>
             <a:endParaRPr lang="en-US" sz="1000" dirty="0"/>
           </a:p>
@@ -5071,7 +5071,7 @@
                 <a:ea typeface="맑은 고딕" pitchFamily="34" charset="-122"/>
                 <a:cs typeface="맑은 고딕" pitchFamily="34" charset="-120"/>
               </a:rPr>
-              <a:t>베스트 상품 리포트  ·  생성 2026-05-13 12:17</a:t>
+              <a:t>베스트 상품 리포트  ·  생성 2026-05-13 13:47</a:t>
             </a:r>
             <a:endParaRPr lang="en-US" sz="900" dirty="0"/>
           </a:p>
@@ -8267,7 +8267,7 @@
                 <a:ea typeface="맑은 고딕" pitchFamily="34" charset="-122"/>
                 <a:cs typeface="맑은 고딕" pitchFamily="34" charset="-120"/>
               </a:rPr>
-              <a:t>베스트 상품 리포트  ·  생성 2026-05-13 12:17</a:t>
+              <a:t>베스트 상품 리포트  ·  생성 2026-05-13 13:47</a:t>
             </a:r>
             <a:endParaRPr lang="en-US" sz="900" dirty="0"/>
           </a:p>
@@ -10165,7 +10165,7 @@
                 <a:ea typeface="맑은 고딕" pitchFamily="34" charset="-122"/>
                 <a:cs typeface="맑은 고딕" pitchFamily="34" charset="-120"/>
               </a:rPr>
-              <a:t>베스트 상품 리포트  ·  생성 2026-05-13 12:17</a:t>
+              <a:t>베스트 상품 리포트  ·  생성 2026-05-13 13:47</a:t>
             </a:r>
             <a:endParaRPr lang="en-US" sz="900" dirty="0"/>
           </a:p>
@@ -13556,7 +13556,7 @@
                 <a:ea typeface="맑은 고딕" pitchFamily="34" charset="-122"/>
                 <a:cs typeface="맑은 고딕" pitchFamily="34" charset="-120"/>
               </a:rPr>
-              <a:t>베스트 상품 리포트  ·  생성 2026-05-13 12:17</a:t>
+              <a:t>베스트 상품 리포트  ·  생성 2026-05-13 13:47</a:t>
             </a:r>
             <a:endParaRPr lang="en-US" sz="900" dirty="0"/>
           </a:p>
@@ -18207,7 +18207,7 @@
                 <a:ea typeface="맑은 고딕" pitchFamily="34" charset="-122"/>
                 <a:cs typeface="맑은 고딕" pitchFamily="34" charset="-120"/>
               </a:rPr>
-              <a:t>베스트 상품 리포트  ·  생성 2026-05-13 12:17</a:t>
+              <a:t>베스트 상품 리포트  ·  생성 2026-05-13 13:47</a:t>
             </a:r>
             <a:endParaRPr lang="en-US" sz="900" dirty="0"/>
           </a:p>
@@ -18587,7 +18587,7 @@
                 <a:ea typeface="맑은 고딕" pitchFamily="34" charset="-122"/>
                 <a:cs typeface="맑은 고딕" pitchFamily="34" charset="-120"/>
               </a:rPr>
-              <a:t>Google Sheet '브랜드 재고현황'  ·  최신화 2026-05-13 12:17</a:t>
+              <a:t>Google Sheet '브랜드 재고현황'  ·  최신화 2026-05-13 13:47</a:t>
             </a:r>
             <a:endParaRPr lang="en-US" sz="1100" dirty="0"/>
           </a:p>
@@ -19269,7 +19269,7 @@
                 <a:ea typeface="맑은 고딕" pitchFamily="34" charset="-122"/>
                 <a:cs typeface="맑은 고딕" pitchFamily="34" charset="-120"/>
               </a:rPr>
-              <a:t>베스트 상품 리포트  ·  생성 2026-05-13 12:17</a:t>
+              <a:t>베스트 상품 리포트  ·  생성 2026-05-13 13:47</a:t>
             </a:r>
             <a:endParaRPr lang="en-US" sz="900" dirty="0"/>
           </a:p>

</xml_diff>

<commit_message>
chore: 매출 PPT 업로드 (best-sellers-2026-05-14.pptx) [auto]
</commit_message>
<xml_diff>
--- a/data/sales-report.pptx
+++ b/data/sales-report.pptx
@@ -1648,7 +1648,7 @@
                 <a:ea typeface="맑은 고딕" pitchFamily="34" charset="-122"/>
                 <a:cs typeface="맑은 고딕" pitchFamily="34" charset="-120"/>
               </a:rPr>
-              <a:t>2026년 05월 13일 (수)  ·  실시간 누적</a:t>
+              <a:t>2026년 05월 14일 (목)  ·  24h 출고 기준</a:t>
             </a:r>
             <a:endParaRPr lang="en-US" sz="2200" dirty="0"/>
           </a:p>
@@ -1726,7 +1726,7 @@
                 <a:ea typeface="맑은 고딕" pitchFamily="34" charset="-122"/>
                 <a:cs typeface="맑은 고딕" pitchFamily="34" charset="-120"/>
               </a:rPr>
-              <a:t>05.13</a:t>
+              <a:t>05.14</a:t>
             </a:r>
             <a:endParaRPr lang="en-US" sz="7200" dirty="0"/>
           </a:p>
@@ -1765,7 +1765,7 @@
                 <a:ea typeface="맑은 고딕" pitchFamily="34" charset="-122"/>
                 <a:cs typeface="맑은 고딕" pitchFamily="34" charset="-120"/>
               </a:rPr>
-              <a:t>수요일</a:t>
+              <a:t>목요일</a:t>
             </a:r>
             <a:endParaRPr lang="en-US" sz="1400" dirty="0"/>
           </a:p>
@@ -1804,7 +1804,7 @@
                 <a:ea typeface="맑은 고딕" pitchFamily="34" charset="-122"/>
                 <a:cs typeface="맑은 고딕" pitchFamily="34" charset="-120"/>
               </a:rPr>
-              <a:t>생성 2026-05-13 14:10  ·  Google Sheet 자동 동기</a:t>
+              <a:t>생성 2026-05-14 08:00  ·  Google Sheet 자동 동기</a:t>
             </a:r>
             <a:endParaRPr lang="en-US" sz="1000" dirty="0"/>
           </a:p>
@@ -1978,7 +1978,7 @@
                 <a:ea typeface="맑은 고딕" pitchFamily="34" charset="-122"/>
                 <a:cs typeface="맑은 고딕" pitchFamily="34" charset="-120"/>
               </a:rPr>
-              <a:t>2026년 05월 13일 (수)</a:t>
+              <a:t>2026년 05월 14일 (목)</a:t>
             </a:r>
             <a:endParaRPr lang="en-US" sz="1200" dirty="0"/>
           </a:p>
@@ -2145,7 +2145,7 @@
                 <a:ea typeface="맑은 고딕" pitchFamily="34" charset="-122"/>
                 <a:cs typeface="맑은 고딕" pitchFamily="34" charset="-120"/>
               </a:rPr>
-              <a:t>5 개</a:t>
+              <a:t>301 개</a:t>
             </a:r>
             <a:endParaRPr lang="en-US" sz="3600" dirty="0"/>
           </a:p>
@@ -2312,7 +2312,7 @@
                 <a:ea typeface="맑은 고딕" pitchFamily="34" charset="-122"/>
                 <a:cs typeface="맑은 고딕" pitchFamily="34" charset="-120"/>
               </a:rPr>
-              <a:t>45 건</a:t>
+              <a:t>50 건</a:t>
             </a:r>
             <a:endParaRPr lang="en-US" sz="3200" dirty="0"/>
           </a:p>
@@ -2479,7 +2479,7 @@
                 <a:ea typeface="맑은 고딕" pitchFamily="34" charset="-122"/>
                 <a:cs typeface="맑은 고딕" pitchFamily="34" charset="-120"/>
               </a:rPr>
-              <a:t>9 건</a:t>
+              <a:t>8 건</a:t>
             </a:r>
             <a:endParaRPr lang="en-US" sz="3200" dirty="0"/>
           </a:p>
@@ -3482,7 +3482,7 @@
                           <a:ea typeface="맑은 고딕" pitchFamily="34" charset="-122"/>
                           <a:cs typeface="맑은 고딕" pitchFamily="34" charset="-120"/>
                         </a:rPr>
-                        <a:t>6A</a:t>
+                        <a:t>CT</a:t>
                       </a:r>
                       <a:endParaRPr lang="en-US" sz="1100" dirty="0">
                         <a:latin typeface="맑은 고딕" charset="0"/>
@@ -3547,7 +3547,7 @@
                           <a:ea typeface="맑은 고딕" pitchFamily="34" charset="-122"/>
                           <a:cs typeface="맑은 고딕" pitchFamily="34" charset="-120"/>
                         </a:rPr>
-                        <a:t>Ring</a:t>
+                        <a:t>Necklace</a:t>
                       </a:r>
                       <a:endParaRPr lang="en-US" sz="1000" dirty="0">
                         <a:latin typeface="맑은 고딕" charset="0"/>
@@ -3612,7 +3612,7 @@
                           <a:ea typeface="맑은 고딕" pitchFamily="34" charset="-122"/>
                           <a:cs typeface="맑은 고딕" pitchFamily="34" charset="-120"/>
                         </a:rPr>
-                        <a:t>[SILVER925] Crown Open Ring</a:t>
+                        <a:t>CandyPOP Necklace (사이즈: 1size (41.5~47cm))</a:t>
                       </a:r>
                       <a:endParaRPr lang="en-US" sz="1100" dirty="0">
                         <a:latin typeface="맑은 고딕" charset="0"/>
@@ -3677,7 +3677,7 @@
                           <a:ea typeface="맑은 고딕" pitchFamily="34" charset="-122"/>
                           <a:cs typeface="맑은 고딕" pitchFamily="34" charset="-120"/>
                         </a:rPr>
-                        <a:t>1 개</a:t>
+                        <a:t>53 개</a:t>
                       </a:r>
                       <a:endParaRPr lang="en-US" sz="1400" dirty="0">
                         <a:latin typeface="맑은 고딕" charset="0"/>
@@ -3809,7 +3809,7 @@
                           <a:ea typeface="맑은 고딕" pitchFamily="34" charset="-122"/>
                           <a:cs typeface="맑은 고딕" pitchFamily="34" charset="-120"/>
                         </a:rPr>
-                        <a:t>6A</a:t>
+                        <a:t>CT</a:t>
                       </a:r>
                       <a:endParaRPr lang="en-US" sz="1100" dirty="0">
                         <a:latin typeface="맑은 고딕" charset="0"/>
@@ -3939,7 +3939,7 @@
                           <a:ea typeface="맑은 고딕" pitchFamily="34" charset="-122"/>
                           <a:cs typeface="맑은 고딕" pitchFamily="34" charset="-120"/>
                         </a:rPr>
-                        <a:t>Guapi Necklace</a:t>
+                        <a:t>CandyPOP Necklace (사이즈: 2size (47~52cm))</a:t>
                       </a:r>
                       <a:endParaRPr lang="en-US" sz="1100" dirty="0">
                         <a:latin typeface="맑은 고딕" charset="0"/>
@@ -4004,7 +4004,7 @@
                           <a:ea typeface="맑은 고딕" pitchFamily="34" charset="-122"/>
                           <a:cs typeface="맑은 고딕" pitchFamily="34" charset="-120"/>
                         </a:rPr>
-                        <a:t>1 개</a:t>
+                        <a:t>40 개</a:t>
                       </a:r>
                       <a:endParaRPr lang="en-US" sz="1400" dirty="0">
                         <a:latin typeface="맑은 고딕" charset="0"/>
@@ -4266,7 +4266,7 @@
                           <a:ea typeface="맑은 고딕" pitchFamily="34" charset="-122"/>
                           <a:cs typeface="맑은 고딕" pitchFamily="34" charset="-120"/>
                         </a:rPr>
-                        <a:t>[SILVER925] Dotty Open Ring</a:t>
+                        <a:t>[SILVER925] Guyeong Open Ring v3.0 (silver)</a:t>
                       </a:r>
                       <a:endParaRPr lang="en-US" sz="1100" dirty="0">
                         <a:latin typeface="맑은 고딕" charset="0"/>
@@ -4331,7 +4331,7 @@
                           <a:ea typeface="맑은 고딕" pitchFamily="34" charset="-122"/>
                           <a:cs typeface="맑은 고딕" pitchFamily="34" charset="-120"/>
                         </a:rPr>
-                        <a:t>1 개</a:t>
+                        <a:t>26 개</a:t>
                       </a:r>
                       <a:endParaRPr lang="en-US" sz="1400" dirty="0">
                         <a:latin typeface="맑은 고딕" charset="0"/>
@@ -4463,7 +4463,7 @@
                           <a:ea typeface="맑은 고딕" pitchFamily="34" charset="-122"/>
                           <a:cs typeface="맑은 고딕" pitchFamily="34" charset="-120"/>
                         </a:rPr>
-                        <a:t>6A</a:t>
+                        <a:t>CT</a:t>
                       </a:r>
                       <a:endParaRPr lang="en-US" sz="1100" dirty="0">
                         <a:latin typeface="맑은 고딕" charset="0"/>
@@ -4528,7 +4528,7 @@
                           <a:ea typeface="맑은 고딕" pitchFamily="34" charset="-122"/>
                           <a:cs typeface="맑은 고딕" pitchFamily="34" charset="-120"/>
                         </a:rPr>
-                        <a:t>Ring</a:t>
+                        <a:t>Necklace</a:t>
                       </a:r>
                       <a:endParaRPr lang="en-US" sz="1000" dirty="0">
                         <a:latin typeface="맑은 고딕" charset="0"/>
@@ -4593,7 +4593,7 @@
                           <a:ea typeface="맑은 고딕" pitchFamily="34" charset="-122"/>
                           <a:cs typeface="맑은 고딕" pitchFamily="34" charset="-120"/>
                         </a:rPr>
-                        <a:t>[SILVER925] Azure Open Ring</a:t>
+                        <a:t>ThreadDuo Necklace</a:t>
                       </a:r>
                       <a:endParaRPr lang="en-US" sz="1100" dirty="0">
                         <a:latin typeface="맑은 고딕" charset="0"/>
@@ -4658,7 +4658,7 @@
                           <a:ea typeface="맑은 고딕" pitchFamily="34" charset="-122"/>
                           <a:cs typeface="맑은 고딕" pitchFamily="34" charset="-120"/>
                         </a:rPr>
-                        <a:t>1 개</a:t>
+                        <a:t>16 개</a:t>
                       </a:r>
                       <a:endParaRPr lang="en-US" sz="1200" dirty="0">
                         <a:latin typeface="맑은 고딕" charset="0"/>
@@ -4790,7 +4790,7 @@
                           <a:ea typeface="맑은 고딕" pitchFamily="34" charset="-122"/>
                           <a:cs typeface="맑은 고딕" pitchFamily="34" charset="-120"/>
                         </a:rPr>
-                        <a:t>CT</a:t>
+                        <a:t>6A</a:t>
                       </a:r>
                       <a:endParaRPr lang="en-US" sz="1100" dirty="0">
                         <a:latin typeface="맑은 고딕" charset="0"/>
@@ -4920,7 +4920,7 @@
                           <a:ea typeface="맑은 고딕" pitchFamily="34" charset="-122"/>
                           <a:cs typeface="맑은 고딕" pitchFamily="34" charset="-120"/>
                         </a:rPr>
-                        <a:t>CandyPOP Necklace (사이즈: 1size (41.5~47cm))</a:t>
+                        <a:t>Tiny Cross Necklace</a:t>
                       </a:r>
                       <a:endParaRPr lang="en-US" sz="1100" dirty="0">
                         <a:latin typeface="맑은 고딕" charset="0"/>
@@ -4985,7 +4985,7 @@
                           <a:ea typeface="맑은 고딕" pitchFamily="34" charset="-122"/>
                           <a:cs typeface="맑은 고딕" pitchFamily="34" charset="-120"/>
                         </a:rPr>
-                        <a:t>1 개</a:t>
+                        <a:t>14 개</a:t>
                       </a:r>
                       <a:endParaRPr lang="en-US" sz="1200" dirty="0">
                         <a:latin typeface="맑은 고딕" charset="0"/>
@@ -5071,7 +5071,7 @@
                 <a:ea typeface="맑은 고딕" pitchFamily="34" charset="-122"/>
                 <a:cs typeface="맑은 고딕" pitchFamily="34" charset="-120"/>
               </a:rPr>
-              <a:t>베스트 상품 리포트  ·  생성 2026-05-13 14:10</a:t>
+              <a:t>베스트 상품 리포트  ·  생성 2026-05-14 08:00</a:t>
             </a:r>
             <a:endParaRPr lang="en-US" sz="900" dirty="0"/>
           </a:p>
@@ -5284,7 +5284,7 @@
                 <a:ea typeface="맑은 고딕" pitchFamily="34" charset="-122"/>
                 <a:cs typeface="맑은 고딕" pitchFamily="34" charset="-120"/>
               </a:rPr>
-              <a:t>2026년 05월 13일 (수)</a:t>
+              <a:t>2026년 05월 14일 (목)</a:t>
             </a:r>
             <a:endParaRPr lang="en-US" sz="1200" dirty="0"/>
           </a:p>
@@ -5451,7 +5451,7 @@
                 <a:ea typeface="맑은 고딕" pitchFamily="34" charset="-122"/>
                 <a:cs typeface="맑은 고딕" pitchFamily="34" charset="-120"/>
               </a:rPr>
-              <a:t>4 개</a:t>
+              <a:t>166 개</a:t>
             </a:r>
             <a:endParaRPr lang="en-US" sz="3600" dirty="0"/>
           </a:p>
@@ -5579,7 +5579,7 @@
                 <a:ea typeface="맑은 고딕" pitchFamily="34" charset="-122"/>
                 <a:cs typeface="맑은 고딕" pitchFamily="34" charset="-120"/>
               </a:rPr>
-              <a:t>[SILVER925] Crown Open Ring</a:t>
+              <a:t>[SILVER925] Guyeong Open Ring v3.0 (silver)</a:t>
             </a:r>
             <a:endParaRPr lang="en-US" sz="1800" dirty="0"/>
           </a:p>
@@ -5657,7 +5657,7 @@
                 <a:ea typeface="맑은 고딕" pitchFamily="34" charset="-122"/>
                 <a:cs typeface="맑은 고딕" pitchFamily="34" charset="-120"/>
               </a:rPr>
-              <a:t>1</a:t>
+              <a:t>26</a:t>
             </a:r>
             <a:endParaRPr lang="en-US" sz="4400" dirty="0"/>
           </a:p>
@@ -6191,7 +6191,7 @@
                           <a:ea typeface="맑은 고딕" pitchFamily="34" charset="-122"/>
                           <a:cs typeface="맑은 고딕" pitchFamily="34" charset="-120"/>
                         </a:rPr>
-                        <a:t>[SILVER925] Crown Open Ring</a:t>
+                        <a:t>[SILVER925] Guyeong Open Ring v3.0 (silver)</a:t>
                       </a:r>
                       <a:endParaRPr lang="en-US" sz="1100" dirty="0">
                         <a:latin typeface="맑은 고딕" charset="0"/>
@@ -6256,7 +6256,7 @@
                           <a:ea typeface="맑은 고딕" pitchFamily="34" charset="-122"/>
                           <a:cs typeface="맑은 고딕" pitchFamily="34" charset="-120"/>
                         </a:rPr>
-                        <a:t>1 개</a:t>
+                        <a:t>26 개</a:t>
                       </a:r>
                       <a:endParaRPr lang="en-US" sz="1400" dirty="0">
                         <a:latin typeface="맑은 고딕" charset="0"/>
@@ -6453,7 +6453,7 @@
                           <a:ea typeface="맑은 고딕" pitchFamily="34" charset="-122"/>
                           <a:cs typeface="맑은 고딕" pitchFamily="34" charset="-120"/>
                         </a:rPr>
-                        <a:t>Guapi Necklace</a:t>
+                        <a:t>Tiny Cross Necklace</a:t>
                       </a:r>
                       <a:endParaRPr lang="en-US" sz="1100" dirty="0">
                         <a:latin typeface="맑은 고딕" charset="0"/>
@@ -6518,7 +6518,7 @@
                           <a:ea typeface="맑은 고딕" pitchFamily="34" charset="-122"/>
                           <a:cs typeface="맑은 고딕" pitchFamily="34" charset="-120"/>
                         </a:rPr>
-                        <a:t>1 개</a:t>
+                        <a:t>14 개</a:t>
                       </a:r>
                       <a:endParaRPr lang="en-US" sz="1200" dirty="0">
                         <a:latin typeface="맑은 고딕" charset="0"/>
@@ -6650,7 +6650,7 @@
                           <a:ea typeface="맑은 고딕" pitchFamily="34" charset="-122"/>
                           <a:cs typeface="맑은 고딕" pitchFamily="34" charset="-120"/>
                         </a:rPr>
-                        <a:t>Ring</a:t>
+                        <a:t>Necklace</a:t>
                       </a:r>
                       <a:endParaRPr lang="en-US" sz="1000" dirty="0">
                         <a:latin typeface="맑은 고딕" charset="0"/>
@@ -6715,7 +6715,7 @@
                           <a:ea typeface="맑은 고딕" pitchFamily="34" charset="-122"/>
                           <a:cs typeface="맑은 고딕" pitchFamily="34" charset="-120"/>
                         </a:rPr>
-                        <a:t>[SILVER925] Dotty Open Ring</a:t>
+                        <a:t>Marquise Necklace</a:t>
                       </a:r>
                       <a:endParaRPr lang="en-US" sz="1100" dirty="0">
                         <a:latin typeface="맑은 고딕" charset="0"/>
@@ -6780,7 +6780,7 @@
                           <a:ea typeface="맑은 고딕" pitchFamily="34" charset="-122"/>
                           <a:cs typeface="맑은 고딕" pitchFamily="34" charset="-120"/>
                         </a:rPr>
-                        <a:t>1 개</a:t>
+                        <a:t>12 개</a:t>
                       </a:r>
                       <a:endParaRPr lang="en-US" sz="1200" dirty="0">
                         <a:latin typeface="맑은 고딕" charset="0"/>
@@ -6977,7 +6977,7 @@
                           <a:ea typeface="맑은 고딕" pitchFamily="34" charset="-122"/>
                           <a:cs typeface="맑은 고딕" pitchFamily="34" charset="-120"/>
                         </a:rPr>
-                        <a:t>[SILVER925] Azure Open Ring</a:t>
+                        <a:t>[SILVER925] Eramam Open Ring</a:t>
                       </a:r>
                       <a:endParaRPr lang="en-US" sz="1100" dirty="0">
                         <a:latin typeface="맑은 고딕" charset="0"/>
@@ -7042,7 +7042,7 @@
                           <a:ea typeface="맑은 고딕" pitchFamily="34" charset="-122"/>
                           <a:cs typeface="맑은 고딕" pitchFamily="34" charset="-120"/>
                         </a:rPr>
-                        <a:t>1 개</a:t>
+                        <a:t>10 개</a:t>
                       </a:r>
                       <a:endParaRPr lang="en-US" sz="1200" dirty="0">
                         <a:latin typeface="맑은 고딕" charset="0"/>
@@ -7109,7 +7109,7 @@
                           <a:ea typeface="맑은 고딕" pitchFamily="34" charset="-122"/>
                           <a:cs typeface="맑은 고딕" pitchFamily="34" charset="-120"/>
                         </a:rPr>
-                        <a:t/>
+                        <a:t>5</a:t>
                       </a:r>
                       <a:endParaRPr lang="en-US" sz="1100" dirty="0">
                         <a:latin typeface="맑은 고딕" charset="0"/>
@@ -7174,7 +7174,7 @@
                           <a:ea typeface="맑은 고딕" pitchFamily="34" charset="-122"/>
                           <a:cs typeface="맑은 고딕" pitchFamily="34" charset="-120"/>
                         </a:rPr>
-                        <a:t/>
+                        <a:t>Necklace</a:t>
                       </a:r>
                       <a:endParaRPr lang="en-US" sz="1000" dirty="0">
                         <a:latin typeface="맑은 고딕" charset="0"/>
@@ -7239,7 +7239,7 @@
                           <a:ea typeface="맑은 고딕" pitchFamily="34" charset="-122"/>
                           <a:cs typeface="맑은 고딕" pitchFamily="34" charset="-120"/>
                         </a:rPr>
-                        <a:t/>
+                        <a:t>YOKNIS 9921 Necklace</a:t>
                       </a:r>
                       <a:endParaRPr lang="en-US" sz="1100" dirty="0">
                         <a:latin typeface="맑은 고딕" charset="0"/>
@@ -7304,7 +7304,7 @@
                           <a:ea typeface="맑은 고딕" pitchFamily="34" charset="-122"/>
                           <a:cs typeface="맑은 고딕" pitchFamily="34" charset="-120"/>
                         </a:rPr>
-                        <a:t/>
+                        <a:t>6 개</a:t>
                       </a:r>
                       <a:endParaRPr lang="en-US" sz="1200" dirty="0">
                         <a:latin typeface="맑은 고딕" charset="0"/>
@@ -7596,7 +7596,7 @@
                 <a:ea typeface="맑은 고딕" pitchFamily="34" charset="-122"/>
                 <a:cs typeface="맑은 고딕" pitchFamily="34" charset="-120"/>
               </a:rPr>
-              <a:t>★Season off★  ·  재고 5개</a:t>
+              <a:t>★Season off★  ·  재고 4개</a:t>
             </a:r>
             <a:pPr indent="0" marL="0">
               <a:buNone/>
@@ -7763,6 +7763,212 @@
                 <a:ea typeface="맑은 고딕" pitchFamily="34" charset="-122"/>
                 <a:cs typeface="맑은 고딕" pitchFamily="34" charset="-120"/>
               </a:rPr>
+              <a:t>[SILVER925] CH.alban Open Ring</a:t>
+            </a:r>
+            <a:endParaRPr lang="en-US" sz="1100" dirty="0"/>
+          </a:p>
+        </p:txBody>
+      </p:sp>
+      <p:sp>
+        <p:nvSpPr>
+          <p:cNvPr id="32" name="Text 29"/>
+          <p:cNvSpPr/>
+          <p:nvPr/>
+        </p:nvSpPr>
+        <p:spPr>
+          <a:xfrm>
+            <a:off x="8211312" y="4425696"/>
+            <a:ext cx="3291840" cy="256032"/>
+          </a:xfrm>
+          <a:prstGeom prst="rect">
+            <a:avLst/>
+          </a:prstGeom>
+          <a:noFill/>
+          <a:ln/>
+        </p:spPr>
+        <p:txBody>
+          <a:bodyPr wrap="square" lIns="0" tIns="0" rIns="0" bIns="0" rtlCol="0" anchor="ctr"/>
+          <a:lstStyle/>
+          <a:p>
+            <a:pPr indent="0" marL="0">
+              <a:buNone/>
+            </a:pPr>
+            <a:r>
+              <a:rPr lang="en-US" sz="1000" dirty="0">
+                <a:solidFill>
+                  <a:srgbClr val="6B7280"/>
+                </a:solidFill>
+                <a:latin typeface="맑은 고딕" pitchFamily="34" charset="0"/>
+                <a:ea typeface="맑은 고딕" pitchFamily="34" charset="-122"/>
+                <a:cs typeface="맑은 고딕" pitchFamily="34" charset="-120"/>
+              </a:rPr>
+              <a:t>Ring  ·  재고 0개</a:t>
+            </a:r>
+            <a:pPr indent="0" marL="0">
+              <a:buNone/>
+            </a:pPr>
+            <a:r>
+              <a:rPr lang="en-US" sz="1000" b="1" dirty="0">
+                <a:solidFill>
+                  <a:srgbClr val="D72638"/>
+                </a:solidFill>
+                <a:latin typeface="맑은 고딕" pitchFamily="34" charset="0"/>
+                <a:ea typeface="맑은 고딕" pitchFamily="34" charset="-122"/>
+                <a:cs typeface="맑은 고딕" pitchFamily="34" charset="-120"/>
+              </a:rPr>
+              <a:t/>
+            </a:r>
+            <a:endParaRPr lang="en-US" sz="1000" dirty="0"/>
+          </a:p>
+        </p:txBody>
+      </p:sp>
+      <p:sp>
+        <p:nvSpPr>
+          <p:cNvPr id="33" name="Shape 30"/>
+          <p:cNvSpPr/>
+          <p:nvPr/>
+        </p:nvSpPr>
+        <p:spPr>
+          <a:xfrm>
+            <a:off x="7406640" y="4809744"/>
+            <a:ext cx="4206240" cy="640080"/>
+          </a:xfrm>
+          <a:prstGeom prst="rect">
+            <a:avLst/>
+          </a:prstGeom>
+          <a:solidFill>
+            <a:srgbClr val="FFF5F5"/>
+          </a:solidFill>
+          <a:ln w="6350">
+            <a:solidFill>
+              <a:srgbClr val="E5E7EB"/>
+            </a:solidFill>
+            <a:prstDash val="solid"/>
+          </a:ln>
+        </p:spPr>
+      </p:sp>
+      <p:sp>
+        <p:nvSpPr>
+          <p:cNvPr id="34" name="Shape 31"/>
+          <p:cNvSpPr/>
+          <p:nvPr/>
+        </p:nvSpPr>
+        <p:spPr>
+          <a:xfrm>
+            <a:off x="7406640" y="4809744"/>
+            <a:ext cx="109728" cy="640080"/>
+          </a:xfrm>
+          <a:prstGeom prst="rect">
+            <a:avLst/>
+          </a:prstGeom>
+          <a:solidFill>
+            <a:srgbClr val="D72638"/>
+          </a:solidFill>
+          <a:ln w="12700">
+            <a:solidFill>
+              <a:srgbClr val="D72638"/>
+            </a:solidFill>
+            <a:prstDash val="solid"/>
+          </a:ln>
+        </p:spPr>
+      </p:sp>
+      <p:sp>
+        <p:nvSpPr>
+          <p:cNvPr id="35" name="Shape 32"/>
+          <p:cNvSpPr/>
+          <p:nvPr/>
+        </p:nvSpPr>
+        <p:spPr>
+          <a:xfrm>
+            <a:off x="7571232" y="4901184"/>
+            <a:ext cx="548640" cy="256032"/>
+          </a:xfrm>
+          <a:prstGeom prst="rect">
+            <a:avLst/>
+          </a:prstGeom>
+          <a:solidFill>
+            <a:srgbClr val="D72638"/>
+          </a:solidFill>
+          <a:ln w="12700">
+            <a:solidFill>
+              <a:srgbClr val="D72638"/>
+            </a:solidFill>
+            <a:prstDash val="solid"/>
+          </a:ln>
+        </p:spPr>
+      </p:sp>
+      <p:sp>
+        <p:nvSpPr>
+          <p:cNvPr id="36" name="Text 33"/>
+          <p:cNvSpPr/>
+          <p:nvPr/>
+        </p:nvSpPr>
+        <p:spPr>
+          <a:xfrm>
+            <a:off x="7571232" y="4901184"/>
+            <a:ext cx="548640" cy="256032"/>
+          </a:xfrm>
+          <a:prstGeom prst="rect">
+            <a:avLst/>
+          </a:prstGeom>
+          <a:noFill/>
+          <a:ln/>
+        </p:spPr>
+        <p:txBody>
+          <a:bodyPr wrap="square" lIns="0" tIns="0" rIns="0" bIns="0" rtlCol="0" anchor="ctr"/>
+          <a:lstStyle/>
+          <a:p>
+            <a:pPr algn="ctr" indent="0" marL="0">
+              <a:buNone/>
+            </a:pPr>
+            <a:r>
+              <a:rPr lang="en-US" sz="900" b="1" dirty="0">
+                <a:solidFill>
+                  <a:srgbClr val="FFFFFF"/>
+                </a:solidFill>
+                <a:latin typeface="맑은 고딕" pitchFamily="34" charset="0"/>
+                <a:ea typeface="맑은 고딕" pitchFamily="34" charset="-122"/>
+                <a:cs typeface="맑은 고딕" pitchFamily="34" charset="-120"/>
+              </a:rPr>
+              <a:t>긴급</a:t>
+            </a:r>
+            <a:endParaRPr lang="en-US" sz="900" dirty="0"/>
+          </a:p>
+        </p:txBody>
+      </p:sp>
+      <p:sp>
+        <p:nvSpPr>
+          <p:cNvPr id="37" name="Text 34"/>
+          <p:cNvSpPr/>
+          <p:nvPr/>
+        </p:nvSpPr>
+        <p:spPr>
+          <a:xfrm>
+            <a:off x="8211312" y="4864608"/>
+            <a:ext cx="3291840" cy="274320"/>
+          </a:xfrm>
+          <a:prstGeom prst="rect">
+            <a:avLst/>
+          </a:prstGeom>
+          <a:noFill/>
+          <a:ln/>
+        </p:spPr>
+        <p:txBody>
+          <a:bodyPr wrap="square" lIns="0" tIns="0" rIns="0" bIns="0" rtlCol="0" anchor="ctr"/>
+          <a:lstStyle/>
+          <a:p>
+            <a:pPr indent="0" marL="0">
+              <a:buNone/>
+            </a:pPr>
+            <a:r>
+              <a:rPr lang="en-US" sz="1100" b="1" dirty="0">
+                <a:solidFill>
+                  <a:srgbClr val="0B1220"/>
+                </a:solidFill>
+                <a:latin typeface="맑은 고딕" pitchFamily="34" charset="0"/>
+                <a:ea typeface="맑은 고딕" pitchFamily="34" charset="-122"/>
+                <a:cs typeface="맑은 고딕" pitchFamily="34" charset="-120"/>
+              </a:rPr>
               <a:t>8-Ball Smart Tok</a:t>
             </a:r>
             <a:endParaRPr lang="en-US" sz="1100" dirty="0"/>
@@ -7771,13 +7977,13 @@
       </p:sp>
       <p:sp>
         <p:nvSpPr>
-          <p:cNvPr id="32" name="Text 29"/>
-          <p:cNvSpPr/>
-          <p:nvPr/>
-        </p:nvSpPr>
-        <p:spPr>
-          <a:xfrm>
-            <a:off x="8211312" y="4425696"/>
+          <p:cNvPr id="38" name="Text 35"/>
+          <p:cNvSpPr/>
+          <p:nvPr/>
+        </p:nvSpPr>
+        <p:spPr>
+          <a:xfrm>
+            <a:off x="8211312" y="5138928"/>
             <a:ext cx="3291840" cy="256032"/>
           </a:xfrm>
           <a:prstGeom prst="rect">
@@ -7824,13 +8030,13 @@
       </p:sp>
       <p:sp>
         <p:nvSpPr>
-          <p:cNvPr id="33" name="Shape 30"/>
-          <p:cNvSpPr/>
-          <p:nvPr/>
-        </p:nvSpPr>
-        <p:spPr>
-          <a:xfrm>
-            <a:off x="7406640" y="4809744"/>
+          <p:cNvPr id="39" name="Shape 36"/>
+          <p:cNvSpPr/>
+          <p:nvPr/>
+        </p:nvSpPr>
+        <p:spPr>
+          <a:xfrm>
+            <a:off x="7406640" y="5522976"/>
             <a:ext cx="4206240" cy="640080"/>
           </a:xfrm>
           <a:prstGeom prst="rect">
@@ -7849,13 +8055,13 @@
       </p:sp>
       <p:sp>
         <p:nvSpPr>
-          <p:cNvPr id="34" name="Shape 31"/>
-          <p:cNvSpPr/>
-          <p:nvPr/>
-        </p:nvSpPr>
-        <p:spPr>
-          <a:xfrm>
-            <a:off x="7406640" y="4809744"/>
+          <p:cNvPr id="40" name="Shape 37"/>
+          <p:cNvSpPr/>
+          <p:nvPr/>
+        </p:nvSpPr>
+        <p:spPr>
+          <a:xfrm>
+            <a:off x="7406640" y="5522976"/>
             <a:ext cx="109728" cy="640080"/>
           </a:xfrm>
           <a:prstGeom prst="rect">
@@ -7874,13 +8080,13 @@
       </p:sp>
       <p:sp>
         <p:nvSpPr>
-          <p:cNvPr id="35" name="Shape 32"/>
-          <p:cNvSpPr/>
-          <p:nvPr/>
-        </p:nvSpPr>
-        <p:spPr>
-          <a:xfrm>
-            <a:off x="7571232" y="4901184"/>
+          <p:cNvPr id="41" name="Shape 38"/>
+          <p:cNvSpPr/>
+          <p:nvPr/>
+        </p:nvSpPr>
+        <p:spPr>
+          <a:xfrm>
+            <a:off x="7571232" y="5614416"/>
             <a:ext cx="548640" cy="256032"/>
           </a:xfrm>
           <a:prstGeom prst="rect">
@@ -7899,13 +8105,13 @@
       </p:sp>
       <p:sp>
         <p:nvSpPr>
-          <p:cNvPr id="36" name="Text 33"/>
-          <p:cNvSpPr/>
-          <p:nvPr/>
-        </p:nvSpPr>
-        <p:spPr>
-          <a:xfrm>
-            <a:off x="7571232" y="4901184"/>
+          <p:cNvPr id="42" name="Text 39"/>
+          <p:cNvSpPr/>
+          <p:nvPr/>
+        </p:nvSpPr>
+        <p:spPr>
+          <a:xfrm>
+            <a:off x="7571232" y="5614416"/>
             <a:ext cx="548640" cy="256032"/>
           </a:xfrm>
           <a:prstGeom prst="rect">
@@ -7938,13 +8144,13 @@
       </p:sp>
       <p:sp>
         <p:nvSpPr>
-          <p:cNvPr id="37" name="Text 34"/>
-          <p:cNvSpPr/>
-          <p:nvPr/>
-        </p:nvSpPr>
-        <p:spPr>
-          <a:xfrm>
-            <a:off x="8211312" y="4864608"/>
+          <p:cNvPr id="43" name="Text 40"/>
+          <p:cNvSpPr/>
+          <p:nvPr/>
+        </p:nvSpPr>
+        <p:spPr>
+          <a:xfrm>
+            <a:off x="8211312" y="5577840"/>
             <a:ext cx="3291840" cy="274320"/>
           </a:xfrm>
           <a:prstGeom prst="rect">
@@ -7977,13 +8183,13 @@
       </p:sp>
       <p:sp>
         <p:nvSpPr>
-          <p:cNvPr id="38" name="Text 35"/>
-          <p:cNvSpPr/>
-          <p:nvPr/>
-        </p:nvSpPr>
-        <p:spPr>
-          <a:xfrm>
-            <a:off x="8211312" y="5138928"/>
+          <p:cNvPr id="44" name="Text 41"/>
+          <p:cNvSpPr/>
+          <p:nvPr/>
+        </p:nvSpPr>
+        <p:spPr>
+          <a:xfrm>
+            <a:off x="8211312" y="5852160"/>
             <a:ext cx="3291840" cy="256032"/>
           </a:xfrm>
           <a:prstGeom prst="rect">
@@ -8030,212 +8236,6 @@
       </p:sp>
       <p:sp>
         <p:nvSpPr>
-          <p:cNvPr id="39" name="Shape 36"/>
-          <p:cNvSpPr/>
-          <p:nvPr/>
-        </p:nvSpPr>
-        <p:spPr>
-          <a:xfrm>
-            <a:off x="7406640" y="5522976"/>
-            <a:ext cx="4206240" cy="640080"/>
-          </a:xfrm>
-          <a:prstGeom prst="rect">
-            <a:avLst/>
-          </a:prstGeom>
-          <a:solidFill>
-            <a:srgbClr val="FFF5F5"/>
-          </a:solidFill>
-          <a:ln w="6350">
-            <a:solidFill>
-              <a:srgbClr val="E5E7EB"/>
-            </a:solidFill>
-            <a:prstDash val="solid"/>
-          </a:ln>
-        </p:spPr>
-      </p:sp>
-      <p:sp>
-        <p:nvSpPr>
-          <p:cNvPr id="40" name="Shape 37"/>
-          <p:cNvSpPr/>
-          <p:nvPr/>
-        </p:nvSpPr>
-        <p:spPr>
-          <a:xfrm>
-            <a:off x="7406640" y="5522976"/>
-            <a:ext cx="109728" cy="640080"/>
-          </a:xfrm>
-          <a:prstGeom prst="rect">
-            <a:avLst/>
-          </a:prstGeom>
-          <a:solidFill>
-            <a:srgbClr val="D72638"/>
-          </a:solidFill>
-          <a:ln w="12700">
-            <a:solidFill>
-              <a:srgbClr val="D72638"/>
-            </a:solidFill>
-            <a:prstDash val="solid"/>
-          </a:ln>
-        </p:spPr>
-      </p:sp>
-      <p:sp>
-        <p:nvSpPr>
-          <p:cNvPr id="41" name="Shape 38"/>
-          <p:cNvSpPr/>
-          <p:nvPr/>
-        </p:nvSpPr>
-        <p:spPr>
-          <a:xfrm>
-            <a:off x="7571232" y="5614416"/>
-            <a:ext cx="548640" cy="256032"/>
-          </a:xfrm>
-          <a:prstGeom prst="rect">
-            <a:avLst/>
-          </a:prstGeom>
-          <a:solidFill>
-            <a:srgbClr val="D72638"/>
-          </a:solidFill>
-          <a:ln w="12700">
-            <a:solidFill>
-              <a:srgbClr val="D72638"/>
-            </a:solidFill>
-            <a:prstDash val="solid"/>
-          </a:ln>
-        </p:spPr>
-      </p:sp>
-      <p:sp>
-        <p:nvSpPr>
-          <p:cNvPr id="42" name="Text 39"/>
-          <p:cNvSpPr/>
-          <p:nvPr/>
-        </p:nvSpPr>
-        <p:spPr>
-          <a:xfrm>
-            <a:off x="7571232" y="5614416"/>
-            <a:ext cx="548640" cy="256032"/>
-          </a:xfrm>
-          <a:prstGeom prst="rect">
-            <a:avLst/>
-          </a:prstGeom>
-          <a:noFill/>
-          <a:ln/>
-        </p:spPr>
-        <p:txBody>
-          <a:bodyPr wrap="square" lIns="0" tIns="0" rIns="0" bIns="0" rtlCol="0" anchor="ctr"/>
-          <a:lstStyle/>
-          <a:p>
-            <a:pPr algn="ctr" indent="0" marL="0">
-              <a:buNone/>
-            </a:pPr>
-            <a:r>
-              <a:rPr lang="en-US" sz="900" b="1" dirty="0">
-                <a:solidFill>
-                  <a:srgbClr val="FFFFFF"/>
-                </a:solidFill>
-                <a:latin typeface="맑은 고딕" pitchFamily="34" charset="0"/>
-                <a:ea typeface="맑은 고딕" pitchFamily="34" charset="-122"/>
-                <a:cs typeface="맑은 고딕" pitchFamily="34" charset="-120"/>
-              </a:rPr>
-              <a:t>긴급</a:t>
-            </a:r>
-            <a:endParaRPr lang="en-US" sz="900" dirty="0"/>
-          </a:p>
-        </p:txBody>
-      </p:sp>
-      <p:sp>
-        <p:nvSpPr>
-          <p:cNvPr id="43" name="Text 40"/>
-          <p:cNvSpPr/>
-          <p:nvPr/>
-        </p:nvSpPr>
-        <p:spPr>
-          <a:xfrm>
-            <a:off x="8211312" y="5577840"/>
-            <a:ext cx="3291840" cy="274320"/>
-          </a:xfrm>
-          <a:prstGeom prst="rect">
-            <a:avLst/>
-          </a:prstGeom>
-          <a:noFill/>
-          <a:ln/>
-        </p:spPr>
-        <p:txBody>
-          <a:bodyPr wrap="square" lIns="0" tIns="0" rIns="0" bIns="0" rtlCol="0" anchor="ctr"/>
-          <a:lstStyle/>
-          <a:p>
-            <a:pPr indent="0" marL="0">
-              <a:buNone/>
-            </a:pPr>
-            <a:r>
-              <a:rPr lang="en-US" sz="1100" b="1" dirty="0">
-                <a:solidFill>
-                  <a:srgbClr val="0B1220"/>
-                </a:solidFill>
-                <a:latin typeface="맑은 고딕" pitchFamily="34" charset="0"/>
-                <a:ea typeface="맑은 고딕" pitchFamily="34" charset="-122"/>
-                <a:cs typeface="맑은 고딕" pitchFamily="34" charset="-120"/>
-              </a:rPr>
-              <a:t>[SILVER925] CH.alban Open Ring</a:t>
-            </a:r>
-            <a:endParaRPr lang="en-US" sz="1100" dirty="0"/>
-          </a:p>
-        </p:txBody>
-      </p:sp>
-      <p:sp>
-        <p:nvSpPr>
-          <p:cNvPr id="44" name="Text 41"/>
-          <p:cNvSpPr/>
-          <p:nvPr/>
-        </p:nvSpPr>
-        <p:spPr>
-          <a:xfrm>
-            <a:off x="8211312" y="5852160"/>
-            <a:ext cx="3291840" cy="256032"/>
-          </a:xfrm>
-          <a:prstGeom prst="rect">
-            <a:avLst/>
-          </a:prstGeom>
-          <a:noFill/>
-          <a:ln/>
-        </p:spPr>
-        <p:txBody>
-          <a:bodyPr wrap="square" lIns="0" tIns="0" rIns="0" bIns="0" rtlCol="0" anchor="ctr"/>
-          <a:lstStyle/>
-          <a:p>
-            <a:pPr indent="0" marL="0">
-              <a:buNone/>
-            </a:pPr>
-            <a:r>
-              <a:rPr lang="en-US" sz="1000" dirty="0">
-                <a:solidFill>
-                  <a:srgbClr val="6B7280"/>
-                </a:solidFill>
-                <a:latin typeface="맑은 고딕" pitchFamily="34" charset="0"/>
-                <a:ea typeface="맑은 고딕" pitchFamily="34" charset="-122"/>
-                <a:cs typeface="맑은 고딕" pitchFamily="34" charset="-120"/>
-              </a:rPr>
-              <a:t>Ring  ·  재고 1개</a:t>
-            </a:r>
-            <a:pPr indent="0" marL="0">
-              <a:buNone/>
-            </a:pPr>
-            <a:r>
-              <a:rPr lang="en-US" sz="1000" b="1" dirty="0">
-                <a:solidFill>
-                  <a:srgbClr val="D72638"/>
-                </a:solidFill>
-                <a:latin typeface="맑은 고딕" pitchFamily="34" charset="0"/>
-                <a:ea typeface="맑은 고딕" pitchFamily="34" charset="-122"/>
-                <a:cs typeface="맑은 고딕" pitchFamily="34" charset="-120"/>
-              </a:rPr>
-              <a:t/>
-            </a:r>
-            <a:endParaRPr lang="en-US" sz="1000" dirty="0"/>
-          </a:p>
-        </p:txBody>
-      </p:sp>
-      <p:sp>
-        <p:nvSpPr>
           <p:cNvPr id="45" name="Text 42"/>
           <p:cNvSpPr/>
           <p:nvPr/>
@@ -8267,7 +8267,7 @@
                 <a:ea typeface="맑은 고딕" pitchFamily="34" charset="-122"/>
                 <a:cs typeface="맑은 고딕" pitchFamily="34" charset="-120"/>
               </a:rPr>
-              <a:t>베스트 상품 리포트  ·  생성 2026-05-13 14:10</a:t>
+              <a:t>베스트 상품 리포트  ·  생성 2026-05-14 08:00</a:t>
             </a:r>
             <a:endParaRPr lang="en-US" sz="900" dirty="0"/>
           </a:p>
@@ -8480,7 +8480,7 @@
                 <a:ea typeface="맑은 고딕" pitchFamily="34" charset="-122"/>
                 <a:cs typeface="맑은 고딕" pitchFamily="34" charset="-120"/>
               </a:rPr>
-              <a:t>2026년 05월 13일 (수)</a:t>
+              <a:t>2026년 05월 14일 (목)</a:t>
             </a:r>
             <a:endParaRPr lang="en-US" sz="1200" dirty="0"/>
           </a:p>
@@ -8647,7 +8647,7 @@
                 <a:ea typeface="맑은 고딕" pitchFamily="34" charset="-122"/>
                 <a:cs typeface="맑은 고딕" pitchFamily="34" charset="-120"/>
               </a:rPr>
-              <a:t>1 개</a:t>
+              <a:t>135 개</a:t>
             </a:r>
             <a:endParaRPr lang="en-US" sz="3600" dirty="0"/>
           </a:p>
@@ -8853,7 +8853,7 @@
                 <a:ea typeface="맑은 고딕" pitchFamily="34" charset="-122"/>
                 <a:cs typeface="맑은 고딕" pitchFamily="34" charset="-120"/>
               </a:rPr>
-              <a:t>1</a:t>
+              <a:t>53</a:t>
             </a:r>
             <a:endParaRPr lang="en-US" sz="4400" dirty="0"/>
           </a:p>
@@ -9452,7 +9452,7 @@
                           <a:ea typeface="맑은 고딕" pitchFamily="34" charset="-122"/>
                           <a:cs typeface="맑은 고딕" pitchFamily="34" charset="-120"/>
                         </a:rPr>
-                        <a:t>1 개</a:t>
+                        <a:t>53 개</a:t>
                       </a:r>
                       <a:endParaRPr lang="en-US" sz="1400" dirty="0">
                         <a:latin typeface="맑은 고딕" charset="0"/>
@@ -9519,7 +9519,7 @@
                           <a:ea typeface="맑은 고딕" pitchFamily="34" charset="-122"/>
                           <a:cs typeface="맑은 고딕" pitchFamily="34" charset="-120"/>
                         </a:rPr>
-                        <a:t/>
+                        <a:t>2</a:t>
                       </a:r>
                       <a:endParaRPr lang="en-US" sz="1100" dirty="0">
                         <a:latin typeface="맑은 고딕" charset="0"/>
@@ -9584,7 +9584,7 @@
                           <a:ea typeface="맑은 고딕" pitchFamily="34" charset="-122"/>
                           <a:cs typeface="맑은 고딕" pitchFamily="34" charset="-120"/>
                         </a:rPr>
-                        <a:t/>
+                        <a:t>Necklace</a:t>
                       </a:r>
                       <a:endParaRPr lang="en-US" sz="1000" dirty="0">
                         <a:latin typeface="맑은 고딕" charset="0"/>
@@ -9649,7 +9649,7 @@
                           <a:ea typeface="맑은 고딕" pitchFamily="34" charset="-122"/>
                           <a:cs typeface="맑은 고딕" pitchFamily="34" charset="-120"/>
                         </a:rPr>
-                        <a:t/>
+                        <a:t>CandyPOP Necklace (사이즈: 2size (47~52cm))</a:t>
                       </a:r>
                       <a:endParaRPr lang="en-US" sz="1100" dirty="0">
                         <a:latin typeface="맑은 고딕" charset="0"/>
@@ -9714,7 +9714,7 @@
                           <a:ea typeface="맑은 고딕" pitchFamily="34" charset="-122"/>
                           <a:cs typeface="맑은 고딕" pitchFamily="34" charset="-120"/>
                         </a:rPr>
-                        <a:t/>
+                        <a:t>40 개</a:t>
                       </a:r>
                       <a:endParaRPr lang="en-US" sz="1200" dirty="0">
                         <a:latin typeface="맑은 고딕" charset="0"/>
@@ -9781,7 +9781,7 @@
                           <a:ea typeface="맑은 고딕" pitchFamily="34" charset="-122"/>
                           <a:cs typeface="맑은 고딕" pitchFamily="34" charset="-120"/>
                         </a:rPr>
-                        <a:t/>
+                        <a:t>3</a:t>
                       </a:r>
                       <a:endParaRPr lang="en-US" sz="1100" dirty="0">
                         <a:latin typeface="맑은 고딕" charset="0"/>
@@ -9846,7 +9846,7 @@
                           <a:ea typeface="맑은 고딕" pitchFamily="34" charset="-122"/>
                           <a:cs typeface="맑은 고딕" pitchFamily="34" charset="-120"/>
                         </a:rPr>
-                        <a:t/>
+                        <a:t>Necklace</a:t>
                       </a:r>
                       <a:endParaRPr lang="en-US" sz="1000" dirty="0">
                         <a:latin typeface="맑은 고딕" charset="0"/>
@@ -9911,7 +9911,7 @@
                           <a:ea typeface="맑은 고딕" pitchFamily="34" charset="-122"/>
                           <a:cs typeface="맑은 고딕" pitchFamily="34" charset="-120"/>
                         </a:rPr>
-                        <a:t/>
+                        <a:t>ThreadDuo Necklace</a:t>
                       </a:r>
                       <a:endParaRPr lang="en-US" sz="1100" dirty="0">
                         <a:latin typeface="맑은 고딕" charset="0"/>
@@ -9976,7 +9976,7 @@
                           <a:ea typeface="맑은 고딕" pitchFamily="34" charset="-122"/>
                           <a:cs typeface="맑은 고딕" pitchFamily="34" charset="-120"/>
                         </a:rPr>
-                        <a:t/>
+                        <a:t>16 개</a:t>
                       </a:r>
                       <a:endParaRPr lang="en-US" sz="1200" dirty="0">
                         <a:latin typeface="맑은 고딕" charset="0"/>
@@ -10165,7 +10165,7 @@
                 <a:ea typeface="맑은 고딕" pitchFamily="34" charset="-122"/>
                 <a:cs typeface="맑은 고딕" pitchFamily="34" charset="-120"/>
               </a:rPr>
-              <a:t>베스트 상품 리포트  ·  생성 2026-05-13 14:10</a:t>
+              <a:t>베스트 상품 리포트  ·  생성 2026-05-14 08:00</a:t>
             </a:r>
             <a:endParaRPr lang="en-US" sz="900" dirty="0"/>
           </a:p>
@@ -10378,7 +10378,7 @@
                 <a:ea typeface="맑은 고딕" pitchFamily="34" charset="-122"/>
                 <a:cs typeface="맑은 고딕" pitchFamily="34" charset="-120"/>
               </a:rPr>
-              <a:t>2026년 05월 13일 (수)</a:t>
+              <a:t>2026년 05월 14일 (목)</a:t>
             </a:r>
             <a:endParaRPr lang="en-US" sz="1200" dirty="0"/>
           </a:p>
@@ -10673,7 +10673,7 @@
                 <a:ea typeface="맑은 고딕" pitchFamily="34" charset="-122"/>
                 <a:cs typeface="맑은 고딕" pitchFamily="34" charset="-120"/>
               </a:rPr>
-              <a:t>16</a:t>
+              <a:t>19</a:t>
             </a:r>
             <a:endParaRPr lang="en-US" sz="3000" dirty="0"/>
           </a:p>
@@ -10801,7 +10801,7 @@
                 <a:ea typeface="맑은 고딕" pitchFamily="34" charset="-122"/>
                 <a:cs typeface="맑은 고딕" pitchFamily="34" charset="-120"/>
               </a:rPr>
-              <a:t>6</a:t>
+              <a:t>7</a:t>
             </a:r>
             <a:endParaRPr lang="en-US" sz="3000" dirty="0"/>
           </a:p>
@@ -10929,7 +10929,7 @@
                 <a:ea typeface="맑은 고딕" pitchFamily="34" charset="-122"/>
                 <a:cs typeface="맑은 고딕" pitchFamily="34" charset="-120"/>
               </a:rPr>
-              <a:t>42,578</a:t>
+              <a:t>37,350</a:t>
             </a:r>
             <a:endParaRPr lang="en-US" sz="3000" dirty="0"/>
           </a:p>
@@ -11424,7 +11424,7 @@
                           <a:ea typeface="맑은 고딕" pitchFamily="34" charset="-122"/>
                           <a:cs typeface="맑은 고딕" pitchFamily="34" charset="-120"/>
                         </a:rPr>
-                        <a:t>컬러: 옐로우 / 기종 옵션: USB -&gt; Apple 8pin</a:t>
+                        <a:t>컬러: 퍼플 / 기종 옵션: C type -&gt; C type</a:t>
                       </a:r>
                       <a:endParaRPr lang="en-US" sz="900" dirty="0">
                         <a:latin typeface="맑은 고딕" charset="0"/>
@@ -11489,7 +11489,7 @@
                           <a:ea typeface="맑은 고딕" pitchFamily="34" charset="-122"/>
                           <a:cs typeface="맑은 고딕" pitchFamily="34" charset="-120"/>
                         </a:rPr>
-                        <a:t>3,936</a:t>
+                        <a:t>2,408</a:t>
                       </a:r>
                       <a:endParaRPr lang="en-US" sz="1000" dirty="0">
                         <a:latin typeface="맑은 고딕" charset="0"/>
@@ -11686,7 +11686,7 @@
                           <a:ea typeface="맑은 고딕" pitchFamily="34" charset="-122"/>
                           <a:cs typeface="맑은 고딕" pitchFamily="34" charset="-120"/>
                         </a:rPr>
-                        <a:t>컬러: 퍼플 / 기종 옵션: C type -&gt; C type</a:t>
+                        <a:t>컬러: 옐로우 / 기종 옵션: USB -&gt; Apple 8pin</a:t>
                       </a:r>
                       <a:endParaRPr lang="en-US" sz="900" dirty="0">
                         <a:latin typeface="맑은 고딕" charset="0"/>
@@ -11751,7 +11751,7 @@
                           <a:ea typeface="맑은 고딕" pitchFamily="34" charset="-122"/>
                           <a:cs typeface="맑은 고딕" pitchFamily="34" charset="-120"/>
                         </a:rPr>
-                        <a:t>2,791</a:t>
+                        <a:t>2,166</a:t>
                       </a:r>
                       <a:endParaRPr lang="en-US" sz="1000" dirty="0">
                         <a:latin typeface="맑은 고딕" charset="0"/>
@@ -11948,7 +11948,7 @@
                           <a:ea typeface="맑은 고딕" pitchFamily="34" charset="-122"/>
                           <a:cs typeface="맑은 고딕" pitchFamily="34" charset="-120"/>
                         </a:rPr>
-                        <a:t>컬러: 오렌지 / 기종 옵션: USB -&gt; Apple 8pin</a:t>
+                        <a:t>컬러: 네온핑크 / 기종 옵션: USB -&gt; C type</a:t>
                       </a:r>
                       <a:endParaRPr lang="en-US" sz="900" dirty="0">
                         <a:latin typeface="맑은 고딕" charset="0"/>
@@ -12013,7 +12013,7 @@
                           <a:ea typeface="맑은 고딕" pitchFamily="34" charset="-122"/>
                           <a:cs typeface="맑은 고딕" pitchFamily="34" charset="-120"/>
                         </a:rPr>
-                        <a:t>2,500</a:t>
+                        <a:t>2,042</a:t>
                       </a:r>
                       <a:endParaRPr lang="en-US" sz="1000" dirty="0">
                         <a:latin typeface="맑은 고딕" charset="0"/>
@@ -12210,7 +12210,7 @@
                           <a:ea typeface="맑은 고딕" pitchFamily="34" charset="-122"/>
                           <a:cs typeface="맑은 고딕" pitchFamily="34" charset="-120"/>
                         </a:rPr>
-                        <a:t>컬러: 네온핑크 / 기종 옵션: USB -&gt; C type</a:t>
+                        <a:t>컬러: 피치 / 기종 옵션: C type -&gt; C type</a:t>
                       </a:r>
                       <a:endParaRPr lang="en-US" sz="900" dirty="0">
                         <a:latin typeface="맑은 고딕" charset="0"/>
@@ -12275,7 +12275,7 @@
                           <a:ea typeface="맑은 고딕" pitchFamily="34" charset="-122"/>
                           <a:cs typeface="맑은 고딕" pitchFamily="34" charset="-120"/>
                         </a:rPr>
-                        <a:t>2,281</a:t>
+                        <a:t>1,746</a:t>
                       </a:r>
                       <a:endParaRPr lang="en-US" sz="1000" dirty="0">
                         <a:latin typeface="맑은 고딕" charset="0"/>
@@ -12472,7 +12472,7 @@
                           <a:ea typeface="맑은 고딕" pitchFamily="34" charset="-122"/>
                           <a:cs typeface="맑은 고딕" pitchFamily="34" charset="-120"/>
                         </a:rPr>
-                        <a:t>컬러: 피치 / 기종 옵션: C type -&gt; C type</a:t>
+                        <a:t>컬러: 오렌지 / 기종 옵션: USB -&gt; Apple 8pin</a:t>
                       </a:r>
                       <a:endParaRPr lang="en-US" sz="900" dirty="0">
                         <a:latin typeface="맑은 고딕" charset="0"/>
@@ -12537,7 +12537,7 @@
                           <a:ea typeface="맑은 고딕" pitchFamily="34" charset="-122"/>
                           <a:cs typeface="맑은 고딕" pitchFamily="34" charset="-120"/>
                         </a:rPr>
-                        <a:t>1,937</a:t>
+                        <a:t>1,714</a:t>
                       </a:r>
                       <a:endParaRPr lang="en-US" sz="1000" dirty="0">
                         <a:latin typeface="맑은 고딕" charset="0"/>
@@ -12623,7 +12623,7 @@
                 <a:ea typeface="맑은 고딕" pitchFamily="34" charset="-122"/>
                 <a:cs typeface="맑은 고딕" pitchFamily="34" charset="-120"/>
               </a:rPr>
-              <a:t>재고 점검  🔴 품절 16건</a:t>
+              <a:t>재고 점검  🔴 품절 19건</a:t>
             </a:r>
             <a:pPr indent="0" marL="0">
               <a:buNone/>
@@ -13556,7 +13556,7 @@
                 <a:ea typeface="맑은 고딕" pitchFamily="34" charset="-122"/>
                 <a:cs typeface="맑은 고딕" pitchFamily="34" charset="-120"/>
               </a:rPr>
-              <a:t>베스트 상품 리포트  ·  생성 2026-05-13 14:10</a:t>
+              <a:t>베스트 상품 리포트  ·  생성 2026-05-14 08:00</a:t>
             </a:r>
             <a:endParaRPr lang="en-US" sz="900" dirty="0"/>
           </a:p>
@@ -13769,7 +13769,7 @@
                 <a:ea typeface="맑은 고딕" pitchFamily="34" charset="-122"/>
                 <a:cs typeface="맑은 고딕" pitchFamily="34" charset="-120"/>
               </a:rPr>
-              <a:t>2026년 05월 13일 (수)</a:t>
+              <a:t>2026년 05월 14일 (목)</a:t>
             </a:r>
             <a:endParaRPr lang="en-US" sz="1200" dirty="0"/>
           </a:p>
@@ -13897,7 +13897,7 @@
                 <a:ea typeface="맑은 고딕" pitchFamily="34" charset="-122"/>
                 <a:cs typeface="맑은 고딕" pitchFamily="34" charset="-120"/>
               </a:rPr>
-              <a:t>🚨  긴급 리오더 45건    ·    주의 리오더 9건    ·    오늘 발주 검토 필수</a:t>
+              <a:t>🚨  긴급 리오더 50건    ·    주의 리오더 8건    ·    오늘 발주 검토 필수</a:t>
             </a:r>
             <a:pPr indent="0" marL="0">
               <a:buNone/>
@@ -14527,7 +14527,7 @@
                           <a:ea typeface="맑은 고딕" pitchFamily="34" charset="-122"/>
                           <a:cs typeface="맑은 고딕" pitchFamily="34" charset="-120"/>
                         </a:rPr>
-                        <a:t>6A</a:t>
+                        <a:t>PR</a:t>
                       </a:r>
                       <a:endParaRPr lang="en-US" sz="1100" dirty="0">
                         <a:latin typeface="맑은 고딕" charset="0"/>
@@ -14595,7 +14595,7 @@
                           <a:ea typeface="맑은 고딕" pitchFamily="34" charset="-122"/>
                           <a:cs typeface="맑은 고딕" pitchFamily="34" charset="-120"/>
                         </a:rPr>
-                        <a:t>★Season off★</a:t>
+                        <a:t>ELECTRONIC</a:t>
                       </a:r>
                       <a:endParaRPr lang="en-US" sz="1000" dirty="0">
                         <a:latin typeface="맑은 고딕" charset="0"/>
@@ -14663,7 +14663,7 @@
                           <a:ea typeface="맑은 고딕" pitchFamily="34" charset="-122"/>
                           <a:cs typeface="맑은 고딕" pitchFamily="34" charset="-120"/>
                         </a:rPr>
-                        <a:t>Tangle Keychain</a:t>
+                        <a:t>180° Fast Charging Cable (8color) (컬러: 퍼플 / 기종 옵션: USB -&gt; C type)</a:t>
                       </a:r>
                       <a:endParaRPr lang="en-US" sz="1100" dirty="0">
                         <a:latin typeface="맑은 고딕" charset="0"/>
@@ -14731,7 +14731,7 @@
                           <a:ea typeface="맑은 고딕" pitchFamily="34" charset="-122"/>
                           <a:cs typeface="맑은 고딕" pitchFamily="34" charset="-120"/>
                         </a:rPr>
-                        <a:t>5</a:t>
+                        <a:t>0</a:t>
                       </a:r>
                       <a:endParaRPr lang="en-US" sz="1100" dirty="0">
                         <a:latin typeface="맑은 고딕" charset="0"/>
@@ -14799,7 +14799,7 @@
                           <a:ea typeface="맑은 고딕" pitchFamily="34" charset="-122"/>
                           <a:cs typeface="맑은 고딕" pitchFamily="34" charset="-120"/>
                         </a:rPr>
-                        <a:t>0 개</a:t>
+                        <a:t>240 개</a:t>
                       </a:r>
                       <a:endParaRPr lang="en-US" sz="1100" dirty="0">
                         <a:latin typeface="맑은 고딕" charset="0"/>
@@ -14937,7 +14937,7 @@
                           <a:ea typeface="맑은 고딕" pitchFamily="34" charset="-122"/>
                           <a:cs typeface="맑은 고딕" pitchFamily="34" charset="-120"/>
                         </a:rPr>
-                        <a:t>6A</a:t>
+                        <a:t>PR</a:t>
                       </a:r>
                       <a:endParaRPr lang="en-US" sz="1100" dirty="0">
                         <a:latin typeface="맑은 고딕" charset="0"/>
@@ -15005,7 +15005,7 @@
                           <a:ea typeface="맑은 고딕" pitchFamily="34" charset="-122"/>
                           <a:cs typeface="맑은 고딕" pitchFamily="34" charset="-120"/>
                         </a:rPr>
-                        <a:t>★Season off★</a:t>
+                        <a:t>ELECTRONIC</a:t>
                       </a:r>
                       <a:endParaRPr lang="en-US" sz="1000" dirty="0">
                         <a:latin typeface="맑은 고딕" charset="0"/>
@@ -15073,7 +15073,7 @@
                           <a:ea typeface="맑은 고딕" pitchFamily="34" charset="-122"/>
                           <a:cs typeface="맑은 고딕" pitchFamily="34" charset="-120"/>
                         </a:rPr>
-                        <a:t>8-Ball Smart Tok</a:t>
+                        <a:t>180° Fast Charging Cable (8color) (컬러: 오렌지 / 기종 옵션: C type -&gt; C type)</a:t>
                       </a:r>
                       <a:endParaRPr lang="en-US" sz="1100" dirty="0">
                         <a:latin typeface="맑은 고딕" charset="0"/>
@@ -15141,7 +15141,7 @@
                           <a:ea typeface="맑은 고딕" pitchFamily="34" charset="-122"/>
                           <a:cs typeface="맑은 고딕" pitchFamily="34" charset="-120"/>
                         </a:rPr>
-                        <a:t>5</a:t>
+                        <a:t>0</a:t>
                       </a:r>
                       <a:endParaRPr lang="en-US" sz="1100" dirty="0">
                         <a:latin typeface="맑은 고딕" charset="0"/>
@@ -15209,7 +15209,7 @@
                           <a:ea typeface="맑은 고딕" pitchFamily="34" charset="-122"/>
                           <a:cs typeface="맑은 고딕" pitchFamily="34" charset="-120"/>
                         </a:rPr>
-                        <a:t>0 개</a:t>
+                        <a:t>202 개</a:t>
                       </a:r>
                       <a:endParaRPr lang="en-US" sz="1100" dirty="0">
                         <a:latin typeface="맑은 고딕" charset="0"/>
@@ -15347,7 +15347,7 @@
                           <a:ea typeface="맑은 고딕" pitchFamily="34" charset="-122"/>
                           <a:cs typeface="맑은 고딕" pitchFamily="34" charset="-120"/>
                         </a:rPr>
-                        <a:t>6A</a:t>
+                        <a:t>PR</a:t>
                       </a:r>
                       <a:endParaRPr lang="en-US" sz="1100" dirty="0">
                         <a:latin typeface="맑은 고딕" charset="0"/>
@@ -15415,7 +15415,7 @@
                           <a:ea typeface="맑은 고딕" pitchFamily="34" charset="-122"/>
                           <a:cs typeface="맑은 고딕" pitchFamily="34" charset="-120"/>
                         </a:rPr>
-                        <a:t>Necklace</a:t>
+                        <a:t>ELECTRONIC</a:t>
                       </a:r>
                       <a:endParaRPr lang="en-US" sz="1000" dirty="0">
                         <a:latin typeface="맑은 고딕" charset="0"/>
@@ -15483,7 +15483,7 @@
                           <a:ea typeface="맑은 고딕" pitchFamily="34" charset="-122"/>
                           <a:cs typeface="맑은 고딕" pitchFamily="34" charset="-120"/>
                         </a:rPr>
-                        <a:t>B-Flower Necklace (Size: 2 Size)</a:t>
+                        <a:t>180° Fast Charging Cable (8color) (컬러: 피치 / 기종 옵션: USB -&gt; C type)</a:t>
                       </a:r>
                       <a:endParaRPr lang="en-US" sz="1100" dirty="0">
                         <a:latin typeface="맑은 고딕" charset="0"/>
@@ -15551,7 +15551,7 @@
                           <a:ea typeface="맑은 고딕" pitchFamily="34" charset="-122"/>
                           <a:cs typeface="맑은 고딕" pitchFamily="34" charset="-120"/>
                         </a:rPr>
-                        <a:t>4</a:t>
+                        <a:t>0</a:t>
                       </a:r>
                       <a:endParaRPr lang="en-US" sz="1100" dirty="0">
                         <a:latin typeface="맑은 고딕" charset="0"/>
@@ -15619,7 +15619,7 @@
                           <a:ea typeface="맑은 고딕" pitchFamily="34" charset="-122"/>
                           <a:cs typeface="맑은 고딕" pitchFamily="34" charset="-120"/>
                         </a:rPr>
-                        <a:t>0 개</a:t>
+                        <a:t>182 개</a:t>
                       </a:r>
                       <a:endParaRPr lang="en-US" sz="1100" dirty="0">
                         <a:latin typeface="맑은 고딕" charset="0"/>
@@ -15757,7 +15757,7 @@
                           <a:ea typeface="맑은 고딕" pitchFamily="34" charset="-122"/>
                           <a:cs typeface="맑은 고딕" pitchFamily="34" charset="-120"/>
                         </a:rPr>
-                        <a:t>6A</a:t>
+                        <a:t>PR</a:t>
                       </a:r>
                       <a:endParaRPr lang="en-US" sz="1100" dirty="0">
                         <a:latin typeface="맑은 고딕" charset="0"/>
@@ -15825,7 +15825,7 @@
                           <a:ea typeface="맑은 고딕" pitchFamily="34" charset="-122"/>
                           <a:cs typeface="맑은 고딕" pitchFamily="34" charset="-120"/>
                         </a:rPr>
-                        <a:t>Ring</a:t>
+                        <a:t>ETC</a:t>
                       </a:r>
                       <a:endParaRPr lang="en-US" sz="1000" dirty="0">
                         <a:latin typeface="맑은 고딕" charset="0"/>
@@ -15893,7 +15893,7 @@
                           <a:ea typeface="맑은 고딕" pitchFamily="34" charset="-122"/>
                           <a:cs typeface="맑은 고딕" pitchFamily="34" charset="-120"/>
                         </a:rPr>
-                        <a:t>[SILVER925] CH.alban Open Ring</a:t>
+                        <a:t>Ball hanger (6color) (컬러: 아이보리)</a:t>
                       </a:r>
                       <a:endParaRPr lang="en-US" sz="1100" dirty="0">
                         <a:latin typeface="맑은 고딕" charset="0"/>
@@ -15961,7 +15961,7 @@
                           <a:ea typeface="맑은 고딕" pitchFamily="34" charset="-122"/>
                           <a:cs typeface="맑은 고딕" pitchFamily="34" charset="-120"/>
                         </a:rPr>
-                        <a:t>1</a:t>
+                        <a:t>10</a:t>
                       </a:r>
                       <a:endParaRPr lang="en-US" sz="1100" dirty="0">
                         <a:latin typeface="맑은 고딕" charset="0"/>
@@ -16029,7 +16029,7 @@
                           <a:ea typeface="맑은 고딕" pitchFamily="34" charset="-122"/>
                           <a:cs typeface="맑은 고딕" pitchFamily="34" charset="-120"/>
                         </a:rPr>
-                        <a:t>0 개</a:t>
+                        <a:t>139 개</a:t>
                       </a:r>
                       <a:endParaRPr lang="en-US" sz="1100" dirty="0">
                         <a:latin typeface="맑은 고딕" charset="0"/>
@@ -16167,7 +16167,7 @@
                           <a:ea typeface="맑은 고딕" pitchFamily="34" charset="-122"/>
                           <a:cs typeface="맑은 고딕" pitchFamily="34" charset="-120"/>
                         </a:rPr>
-                        <a:t>6A</a:t>
+                        <a:t>PR</a:t>
                       </a:r>
                       <a:endParaRPr lang="en-US" sz="1100" dirty="0">
                         <a:latin typeface="맑은 고딕" charset="0"/>
@@ -16235,7 +16235,7 @@
                           <a:ea typeface="맑은 고딕" pitchFamily="34" charset="-122"/>
                           <a:cs typeface="맑은 고딕" pitchFamily="34" charset="-120"/>
                         </a:rPr>
-                        <a:t>Necklace</a:t>
+                        <a:t>ELECTRONIC</a:t>
                       </a:r>
                       <a:endParaRPr lang="en-US" sz="1000" dirty="0">
                         <a:latin typeface="맑은 고딕" charset="0"/>
@@ -16303,7 +16303,7 @@
                           <a:ea typeface="맑은 고딕" pitchFamily="34" charset="-122"/>
                           <a:cs typeface="맑은 고딕" pitchFamily="34" charset="-120"/>
                         </a:rPr>
-                        <a:t>B-Flower Necklace (Size: 1 Size)</a:t>
+                        <a:t>180° Fast Charging Cable (8color) (컬러: 블루 / 기종 옵션: C type -&gt; C type)</a:t>
                       </a:r>
                       <a:endParaRPr lang="en-US" sz="1100" dirty="0">
                         <a:latin typeface="맑은 고딕" charset="0"/>
@@ -16439,7 +16439,7 @@
                           <a:ea typeface="맑은 고딕" pitchFamily="34" charset="-122"/>
                           <a:cs typeface="맑은 고딕" pitchFamily="34" charset="-120"/>
                         </a:rPr>
-                        <a:t>0 개</a:t>
+                        <a:t>133 개</a:t>
                       </a:r>
                       <a:endParaRPr lang="en-US" sz="1100" dirty="0">
                         <a:latin typeface="맑은 고딕" charset="0"/>
@@ -16577,7 +16577,7 @@
                           <a:ea typeface="맑은 고딕" pitchFamily="34" charset="-122"/>
                           <a:cs typeface="맑은 고딕" pitchFamily="34" charset="-120"/>
                         </a:rPr>
-                        <a:t>CT</a:t>
+                        <a:t>PR</a:t>
                       </a:r>
                       <a:endParaRPr lang="en-US" sz="1100" dirty="0">
                         <a:latin typeface="맑은 고딕" charset="0"/>
@@ -16645,7 +16645,7 @@
                           <a:ea typeface="맑은 고딕" pitchFamily="34" charset="-122"/>
                           <a:cs typeface="맑은 고딕" pitchFamily="34" charset="-120"/>
                         </a:rPr>
-                        <a:t>Ring</a:t>
+                        <a:t>ELECTRONIC</a:t>
                       </a:r>
                       <a:endParaRPr lang="en-US" sz="1000" dirty="0">
                         <a:latin typeface="맑은 고딕" charset="0"/>
@@ -16713,7 +16713,7 @@
                           <a:ea typeface="맑은 고딕" pitchFamily="34" charset="-122"/>
                           <a:cs typeface="맑은 고딕" pitchFamily="34" charset="-120"/>
                         </a:rPr>
-                        <a:t>"Whisow" 925 Open Ring</a:t>
+                        <a:t>180° Fast Charging Cable (8color) (컬러: 옐로우 / 기종 옵션: USB -&gt; C type)</a:t>
                       </a:r>
                       <a:endParaRPr lang="en-US" sz="1100" dirty="0">
                         <a:latin typeface="맑은 고딕" charset="0"/>
@@ -16781,7 +16781,7 @@
                           <a:ea typeface="맑은 고딕" pitchFamily="34" charset="-122"/>
                           <a:cs typeface="맑은 고딕" pitchFamily="34" charset="-120"/>
                         </a:rPr>
-                        <a:t>2</a:t>
+                        <a:t>0</a:t>
                       </a:r>
                       <a:endParaRPr lang="en-US" sz="1100" dirty="0">
                         <a:latin typeface="맑은 고딕" charset="0"/>
@@ -16849,7 +16849,7 @@
                           <a:ea typeface="맑은 고딕" pitchFamily="34" charset="-122"/>
                           <a:cs typeface="맑은 고딕" pitchFamily="34" charset="-120"/>
                         </a:rPr>
-                        <a:t>0 개</a:t>
+                        <a:t>28 개</a:t>
                       </a:r>
                       <a:endParaRPr lang="en-US" sz="1100" dirty="0">
                         <a:latin typeface="맑은 고딕" charset="0"/>
@@ -16987,7 +16987,7 @@
                           <a:ea typeface="맑은 고딕" pitchFamily="34" charset="-122"/>
                           <a:cs typeface="맑은 고딕" pitchFamily="34" charset="-120"/>
                         </a:rPr>
-                        <a:t>CT</a:t>
+                        <a:t>PR</a:t>
                       </a:r>
                       <a:endParaRPr lang="en-US" sz="1100" dirty="0">
                         <a:latin typeface="맑은 고딕" charset="0"/>
@@ -17055,7 +17055,7 @@
                           <a:ea typeface="맑은 고딕" pitchFamily="34" charset="-122"/>
                           <a:cs typeface="맑은 고딕" pitchFamily="34" charset="-120"/>
                         </a:rPr>
-                        <a:t>Ring</a:t>
+                        <a:t>ELECTRONIC</a:t>
                       </a:r>
                       <a:endParaRPr lang="en-US" sz="1000" dirty="0">
                         <a:latin typeface="맑은 고딕" charset="0"/>
@@ -17123,7 +17123,7 @@
                           <a:ea typeface="맑은 고딕" pitchFamily="34" charset="-122"/>
                           <a:cs typeface="맑은 고딕" pitchFamily="34" charset="-120"/>
                         </a:rPr>
-                        <a:t>"Mobiuss" 925 Open Ring</a:t>
+                        <a:t>Jacquard Fast Charging Cable (7color) (컬러: 퍼플 / 기종옵션: C-Apple 8pin / 길이: 2m)</a:t>
                       </a:r>
                       <a:endParaRPr lang="en-US" sz="1100" dirty="0">
                         <a:latin typeface="맑은 고딕" charset="0"/>
@@ -17191,7 +17191,7 @@
                           <a:ea typeface="맑은 고딕" pitchFamily="34" charset="-122"/>
                           <a:cs typeface="맑은 고딕" pitchFamily="34" charset="-120"/>
                         </a:rPr>
-                        <a:t>2</a:t>
+                        <a:t>20</a:t>
                       </a:r>
                       <a:endParaRPr lang="en-US" sz="1100" dirty="0">
                         <a:latin typeface="맑은 고딕" charset="0"/>
@@ -17259,7 +17259,7 @@
                           <a:ea typeface="맑은 고딕" pitchFamily="34" charset="-122"/>
                           <a:cs typeface="맑은 고딕" pitchFamily="34" charset="-120"/>
                         </a:rPr>
-                        <a:t>0 개</a:t>
+                        <a:t>5 개</a:t>
                       </a:r>
                       <a:endParaRPr lang="en-US" sz="1100" dirty="0">
                         <a:latin typeface="맑은 고딕" charset="0"/>
@@ -17397,7 +17397,7 @@
                           <a:ea typeface="맑은 고딕" pitchFamily="34" charset="-122"/>
                           <a:cs typeface="맑은 고딕" pitchFamily="34" charset="-120"/>
                         </a:rPr>
-                        <a:t>CT</a:t>
+                        <a:t>6A</a:t>
                       </a:r>
                       <a:endParaRPr lang="en-US" sz="1100" dirty="0">
                         <a:latin typeface="맑은 고딕" charset="0"/>
@@ -17465,7 +17465,7 @@
                           <a:ea typeface="맑은 고딕" pitchFamily="34" charset="-122"/>
                           <a:cs typeface="맑은 고딕" pitchFamily="34" charset="-120"/>
                         </a:rPr>
-                        <a:t>Ring</a:t>
+                        <a:t>★Season off★</a:t>
                       </a:r>
                       <a:endParaRPr lang="en-US" sz="1000" dirty="0">
                         <a:latin typeface="맑은 고딕" charset="0"/>
@@ -17533,7 +17533,7 @@
                           <a:ea typeface="맑은 고딕" pitchFamily="34" charset="-122"/>
                           <a:cs typeface="맑은 고딕" pitchFamily="34" charset="-120"/>
                         </a:rPr>
-                        <a:t>"Primošten" 925 Open Ring</a:t>
+                        <a:t>Tangle Keychain</a:t>
                       </a:r>
                       <a:endParaRPr lang="en-US" sz="1100" dirty="0">
                         <a:latin typeface="맑은 고딕" charset="0"/>
@@ -17601,7 +17601,7 @@
                           <a:ea typeface="맑은 고딕" pitchFamily="34" charset="-122"/>
                           <a:cs typeface="맑은 고딕" pitchFamily="34" charset="-120"/>
                         </a:rPr>
-                        <a:t>2</a:t>
+                        <a:t>4</a:t>
                       </a:r>
                       <a:endParaRPr lang="en-US" sz="1100" dirty="0">
                         <a:latin typeface="맑은 고딕" charset="0"/>
@@ -17669,7 +17669,7 @@
                           <a:ea typeface="맑은 고딕" pitchFamily="34" charset="-122"/>
                           <a:cs typeface="맑은 고딕" pitchFamily="34" charset="-120"/>
                         </a:rPr>
-                        <a:t>0 개</a:t>
+                        <a:t>1 개</a:t>
                       </a:r>
                       <a:endParaRPr lang="en-US" sz="1100" dirty="0">
                         <a:latin typeface="맑은 고딕" charset="0"/>
@@ -17807,7 +17807,7 @@
                           <a:ea typeface="맑은 고딕" pitchFamily="34" charset="-122"/>
                           <a:cs typeface="맑은 고딕" pitchFamily="34" charset="-120"/>
                         </a:rPr>
-                        <a:t>CT</a:t>
+                        <a:t>6A</a:t>
                       </a:r>
                       <a:endParaRPr lang="en-US" sz="1100" dirty="0">
                         <a:latin typeface="맑은 고딕" charset="0"/>
@@ -17943,7 +17943,7 @@
                           <a:ea typeface="맑은 고딕" pitchFamily="34" charset="-122"/>
                           <a:cs typeface="맑은 고딕" pitchFamily="34" charset="-120"/>
                         </a:rPr>
-                        <a:t>"Shirakawago" 925 Open Ring</a:t>
+                        <a:t>[SILVER925] CH.alban Open Ring</a:t>
                       </a:r>
                       <a:endParaRPr lang="en-US" sz="1100" dirty="0">
                         <a:latin typeface="맑은 고딕" charset="0"/>
@@ -18011,7 +18011,7 @@
                           <a:ea typeface="맑은 고딕" pitchFamily="34" charset="-122"/>
                           <a:cs typeface="맑은 고딕" pitchFamily="34" charset="-120"/>
                         </a:rPr>
-                        <a:t>2</a:t>
+                        <a:t>0</a:t>
                       </a:r>
                       <a:endParaRPr lang="en-US" sz="1100" dirty="0">
                         <a:latin typeface="맑은 고딕" charset="0"/>
@@ -18079,7 +18079,7 @@
                           <a:ea typeface="맑은 고딕" pitchFamily="34" charset="-122"/>
                           <a:cs typeface="맑은 고딕" pitchFamily="34" charset="-120"/>
                         </a:rPr>
-                        <a:t>0 개</a:t>
+                        <a:t>1 개</a:t>
                       </a:r>
                       <a:endParaRPr lang="en-US" sz="1100" dirty="0">
                         <a:latin typeface="맑은 고딕" charset="0"/>
@@ -18168,7 +18168,7 @@
                 <a:ea typeface="맑은 고딕" pitchFamily="34" charset="-122"/>
                 <a:cs typeface="맑은 고딕" pitchFamily="34" charset="-120"/>
               </a:rPr>
-              <a:t>외 36건 더 있음 — 상세는 시트에서 확인</a:t>
+              <a:t>외 41건 더 있음 — 상세는 시트에서 확인</a:t>
             </a:r>
             <a:endParaRPr lang="en-US" sz="1000" dirty="0"/>
           </a:p>
@@ -18207,7 +18207,7 @@
                 <a:ea typeface="맑은 고딕" pitchFamily="34" charset="-122"/>
                 <a:cs typeface="맑은 고딕" pitchFamily="34" charset="-120"/>
               </a:rPr>
-              <a:t>베스트 상품 리포트  ·  생성 2026-05-13 14:10</a:t>
+              <a:t>베스트 상품 리포트  ·  생성 2026-05-14 08:00</a:t>
             </a:r>
             <a:endParaRPr lang="en-US" sz="900" dirty="0"/>
           </a:p>
@@ -18420,7 +18420,7 @@
                 <a:ea typeface="맑은 고딕" pitchFamily="34" charset="-122"/>
                 <a:cs typeface="맑은 고딕" pitchFamily="34" charset="-120"/>
               </a:rPr>
-              <a:t>2026년 05월 13일 (수)</a:t>
+              <a:t>2026년 05월 14일 (목)</a:t>
             </a:r>
             <a:endParaRPr lang="en-US" sz="1200" dirty="0"/>
           </a:p>
@@ -18587,7 +18587,7 @@
                 <a:ea typeface="맑은 고딕" pitchFamily="34" charset="-122"/>
                 <a:cs typeface="맑은 고딕" pitchFamily="34" charset="-120"/>
               </a:rPr>
-              <a:t>Google Sheet '브랜드 재고현황'  ·  최신화 2026-05-13 14:10</a:t>
+              <a:t>Google Sheet '브랜드 재고현황'  ·  최신화 2026-05-14 08:00</a:t>
             </a:r>
             <a:endParaRPr lang="en-US" sz="1100" dirty="0"/>
           </a:p>
@@ -19230,7 +19230,7 @@
                 <a:ea typeface="맑은 고딕" pitchFamily="34" charset="-122"/>
                 <a:cs typeface="맑은 고딕" pitchFamily="34" charset="-120"/>
               </a:rPr>
-              <a:t>✅ 3개 브랜드 모두 정상 추출  ·  ⚠ 첫 실행 — 24h 비교 데이터 없음 (실시간 결제완료 기준). 내일부터 24h 출고 기준 적용</a:t>
+              <a:t>✅ 3개 브랜드 모두 정상 추출  ·  24h 출고 기준 (2026-05-13 08:00 → 2026-05-14 08:00) · 신규 SKU 12건은 결제완료 기준</a:t>
             </a:r>
             <a:endParaRPr lang="en-US" sz="1000" dirty="0"/>
           </a:p>
@@ -19269,7 +19269,7 @@
                 <a:ea typeface="맑은 고딕" pitchFamily="34" charset="-122"/>
                 <a:cs typeface="맑은 고딕" pitchFamily="34" charset="-120"/>
               </a:rPr>
-              <a:t>베스트 상품 리포트  ·  생성 2026-05-13 14:10</a:t>
+              <a:t>베스트 상품 리포트  ·  생성 2026-05-14 08:00</a:t>
             </a:r>
             <a:endParaRPr lang="en-US" sz="900" dirty="0"/>
           </a:p>

</xml_diff>

<commit_message>
chore: 매출 PPT 업로드 (best-sellers-2026-05-15.pptx) [auto]
</commit_message>
<xml_diff>
--- a/data/sales-report.pptx
+++ b/data/sales-report.pptx
@@ -1648,7 +1648,7 @@
                 <a:ea typeface="맑은 고딕" pitchFamily="34" charset="-122"/>
                 <a:cs typeface="맑은 고딕" pitchFamily="34" charset="-120"/>
               </a:rPr>
-              <a:t>2026년 05월 14일 (목)  ·  24h 출고 기준</a:t>
+              <a:t>2026년 05월 15일 (금)  ·  24h 출고 기준</a:t>
             </a:r>
             <a:endParaRPr lang="en-US" sz="2200" dirty="0"/>
           </a:p>
@@ -1726,7 +1726,7 @@
                 <a:ea typeface="맑은 고딕" pitchFamily="34" charset="-122"/>
                 <a:cs typeface="맑은 고딕" pitchFamily="34" charset="-120"/>
               </a:rPr>
-              <a:t>05.14</a:t>
+              <a:t>05.15</a:t>
             </a:r>
             <a:endParaRPr lang="en-US" sz="7200" dirty="0"/>
           </a:p>
@@ -1765,7 +1765,7 @@
                 <a:ea typeface="맑은 고딕" pitchFamily="34" charset="-122"/>
                 <a:cs typeface="맑은 고딕" pitchFamily="34" charset="-120"/>
               </a:rPr>
-              <a:t>목요일</a:t>
+              <a:t>금요일</a:t>
             </a:r>
             <a:endParaRPr lang="en-US" sz="1400" dirty="0"/>
           </a:p>
@@ -1804,7 +1804,7 @@
                 <a:ea typeface="맑은 고딕" pitchFamily="34" charset="-122"/>
                 <a:cs typeface="맑은 고딕" pitchFamily="34" charset="-120"/>
               </a:rPr>
-              <a:t>생성 2026-05-14 08:00  ·  Google Sheet 자동 동기</a:t>
+              <a:t>생성 2026-05-15 08:00  ·  Google Sheet 자동 동기</a:t>
             </a:r>
             <a:endParaRPr lang="en-US" sz="1000" dirty="0"/>
           </a:p>
@@ -1978,7 +1978,7 @@
                 <a:ea typeface="맑은 고딕" pitchFamily="34" charset="-122"/>
                 <a:cs typeface="맑은 고딕" pitchFamily="34" charset="-120"/>
               </a:rPr>
-              <a:t>2026년 05월 14일 (목)</a:t>
+              <a:t>2026년 05월 15일 (금)</a:t>
             </a:r>
             <a:endParaRPr lang="en-US" sz="1200" dirty="0"/>
           </a:p>
@@ -2145,7 +2145,7 @@
                 <a:ea typeface="맑은 고딕" pitchFamily="34" charset="-122"/>
                 <a:cs typeface="맑은 고딕" pitchFamily="34" charset="-120"/>
               </a:rPr>
-              <a:t>301 개</a:t>
+              <a:t>343 개</a:t>
             </a:r>
             <a:endParaRPr lang="en-US" sz="3600" dirty="0"/>
           </a:p>
@@ -2312,7 +2312,7 @@
                 <a:ea typeface="맑은 고딕" pitchFamily="34" charset="-122"/>
                 <a:cs typeface="맑은 고딕" pitchFamily="34" charset="-120"/>
               </a:rPr>
-              <a:t>50 건</a:t>
+              <a:t>53 건</a:t>
             </a:r>
             <a:endParaRPr lang="en-US" sz="3200" dirty="0"/>
           </a:p>
@@ -2685,7 +2685,7 @@
                 <a:ea typeface="맑은 고딕" pitchFamily="34" charset="-122"/>
                 <a:cs typeface="맑은 고딕" pitchFamily="34" charset="-120"/>
               </a:rPr>
-              <a:t>84 SKU  ·  판매 OK</a:t>
+              <a:t>86 SKU  ·  판매 OK</a:t>
             </a:r>
             <a:pPr indent="0" marL="0">
               <a:buNone/>
@@ -2827,7 +2827,7 @@
                 <a:ea typeface="맑은 고딕" pitchFamily="34" charset="-122"/>
                 <a:cs typeface="맑은 고딕" pitchFamily="34" charset="-120"/>
               </a:rPr>
-              <a:t>57 SKU  ·  판매 OK</a:t>
+              <a:t>59 SKU  ·  판매 OK</a:t>
             </a:r>
             <a:pPr indent="0" marL="0">
               <a:buNone/>
@@ -3677,7 +3677,7 @@
                           <a:ea typeface="맑은 고딕" pitchFamily="34" charset="-122"/>
                           <a:cs typeface="맑은 고딕" pitchFamily="34" charset="-120"/>
                         </a:rPr>
-                        <a:t>53 개</a:t>
+                        <a:t>44 개</a:t>
                       </a:r>
                       <a:endParaRPr lang="en-US" sz="1400" dirty="0">
                         <a:latin typeface="맑은 고딕" charset="0"/>
@@ -3809,7 +3809,7 @@
                           <a:ea typeface="맑은 고딕" pitchFamily="34" charset="-122"/>
                           <a:cs typeface="맑은 고딕" pitchFamily="34" charset="-120"/>
                         </a:rPr>
-                        <a:t>CT</a:t>
+                        <a:t>6A</a:t>
                       </a:r>
                       <a:endParaRPr lang="en-US" sz="1100" dirty="0">
                         <a:latin typeface="맑은 고딕" charset="0"/>
@@ -3874,7 +3874,7 @@
                           <a:ea typeface="맑은 고딕" pitchFamily="34" charset="-122"/>
                           <a:cs typeface="맑은 고딕" pitchFamily="34" charset="-120"/>
                         </a:rPr>
-                        <a:t>Necklace</a:t>
+                        <a:t>Ring</a:t>
                       </a:r>
                       <a:endParaRPr lang="en-US" sz="1000" dirty="0">
                         <a:latin typeface="맑은 고딕" charset="0"/>
@@ -3939,7 +3939,7 @@
                           <a:ea typeface="맑은 고딕" pitchFamily="34" charset="-122"/>
                           <a:cs typeface="맑은 고딕" pitchFamily="34" charset="-120"/>
                         </a:rPr>
-                        <a:t>CandyPOP Necklace (사이즈: 2size (47~52cm))</a:t>
+                        <a:t>[SILVER925] Guyeong Open Ring v3.0 (silver)</a:t>
                       </a:r>
                       <a:endParaRPr lang="en-US" sz="1100" dirty="0">
                         <a:latin typeface="맑은 고딕" charset="0"/>
@@ -4004,7 +4004,7 @@
                           <a:ea typeface="맑은 고딕" pitchFamily="34" charset="-122"/>
                           <a:cs typeface="맑은 고딕" pitchFamily="34" charset="-120"/>
                         </a:rPr>
-                        <a:t>40 개</a:t>
+                        <a:t>37 개</a:t>
                       </a:r>
                       <a:endParaRPr lang="en-US" sz="1400" dirty="0">
                         <a:latin typeface="맑은 고딕" charset="0"/>
@@ -4136,7 +4136,7 @@
                           <a:ea typeface="맑은 고딕" pitchFamily="34" charset="-122"/>
                           <a:cs typeface="맑은 고딕" pitchFamily="34" charset="-120"/>
                         </a:rPr>
-                        <a:t>6A</a:t>
+                        <a:t>CT</a:t>
                       </a:r>
                       <a:endParaRPr lang="en-US" sz="1100" dirty="0">
                         <a:latin typeface="맑은 고딕" charset="0"/>
@@ -4201,7 +4201,7 @@
                           <a:ea typeface="맑은 고딕" pitchFamily="34" charset="-122"/>
                           <a:cs typeface="맑은 고딕" pitchFamily="34" charset="-120"/>
                         </a:rPr>
-                        <a:t>Ring</a:t>
+                        <a:t>Necklace</a:t>
                       </a:r>
                       <a:endParaRPr lang="en-US" sz="1000" dirty="0">
                         <a:latin typeface="맑은 고딕" charset="0"/>
@@ -4266,7 +4266,7 @@
                           <a:ea typeface="맑은 고딕" pitchFamily="34" charset="-122"/>
                           <a:cs typeface="맑은 고딕" pitchFamily="34" charset="-120"/>
                         </a:rPr>
-                        <a:t>[SILVER925] Guyeong Open Ring v3.0 (silver)</a:t>
+                        <a:t>CandyPOP Necklace (사이즈: 2size (47~52cm))</a:t>
                       </a:r>
                       <a:endParaRPr lang="en-US" sz="1100" dirty="0">
                         <a:latin typeface="맑은 고딕" charset="0"/>
@@ -4331,7 +4331,7 @@
                           <a:ea typeface="맑은 고딕" pitchFamily="34" charset="-122"/>
                           <a:cs typeface="맑은 고딕" pitchFamily="34" charset="-120"/>
                         </a:rPr>
-                        <a:t>26 개</a:t>
+                        <a:t>22 개</a:t>
                       </a:r>
                       <a:endParaRPr lang="en-US" sz="1400" dirty="0">
                         <a:latin typeface="맑은 고딕" charset="0"/>
@@ -4528,7 +4528,7 @@
                           <a:ea typeface="맑은 고딕" pitchFamily="34" charset="-122"/>
                           <a:cs typeface="맑은 고딕" pitchFamily="34" charset="-120"/>
                         </a:rPr>
-                        <a:t>Necklace</a:t>
+                        <a:t>Ring</a:t>
                       </a:r>
                       <a:endParaRPr lang="en-US" sz="1000" dirty="0">
                         <a:latin typeface="맑은 고딕" charset="0"/>
@@ -4593,7 +4593,7 @@
                           <a:ea typeface="맑은 고딕" pitchFamily="34" charset="-122"/>
                           <a:cs typeface="맑은 고딕" pitchFamily="34" charset="-120"/>
                         </a:rPr>
-                        <a:t>ThreadDuo Necklace</a:t>
+                        <a:t>"Reine" 925 Open Ring</a:t>
                       </a:r>
                       <a:endParaRPr lang="en-US" sz="1100" dirty="0">
                         <a:latin typeface="맑은 고딕" charset="0"/>
@@ -4658,7 +4658,7 @@
                           <a:ea typeface="맑은 고딕" pitchFamily="34" charset="-122"/>
                           <a:cs typeface="맑은 고딕" pitchFamily="34" charset="-120"/>
                         </a:rPr>
-                        <a:t>16 개</a:t>
+                        <a:t>14 개</a:t>
                       </a:r>
                       <a:endParaRPr lang="en-US" sz="1200" dirty="0">
                         <a:latin typeface="맑은 고딕" charset="0"/>
@@ -4790,7 +4790,7 @@
                           <a:ea typeface="맑은 고딕" pitchFamily="34" charset="-122"/>
                           <a:cs typeface="맑은 고딕" pitchFamily="34" charset="-120"/>
                         </a:rPr>
-                        <a:t>6A</a:t>
+                        <a:t>CT</a:t>
                       </a:r>
                       <a:endParaRPr lang="en-US" sz="1100" dirty="0">
                         <a:latin typeface="맑은 고딕" charset="0"/>
@@ -4920,7 +4920,7 @@
                           <a:ea typeface="맑은 고딕" pitchFamily="34" charset="-122"/>
                           <a:cs typeface="맑은 고딕" pitchFamily="34" charset="-120"/>
                         </a:rPr>
-                        <a:t>Tiny Cross Necklace</a:t>
+                        <a:t>ThreadDuo Necklace</a:t>
                       </a:r>
                       <a:endParaRPr lang="en-US" sz="1100" dirty="0">
                         <a:latin typeface="맑은 고딕" charset="0"/>
@@ -4985,7 +4985,7 @@
                           <a:ea typeface="맑은 고딕" pitchFamily="34" charset="-122"/>
                           <a:cs typeface="맑은 고딕" pitchFamily="34" charset="-120"/>
                         </a:rPr>
-                        <a:t>14 개</a:t>
+                        <a:t>13 개</a:t>
                       </a:r>
                       <a:endParaRPr lang="en-US" sz="1200" dirty="0">
                         <a:latin typeface="맑은 고딕" charset="0"/>
@@ -5071,7 +5071,7 @@
                 <a:ea typeface="맑은 고딕" pitchFamily="34" charset="-122"/>
                 <a:cs typeface="맑은 고딕" pitchFamily="34" charset="-120"/>
               </a:rPr>
-              <a:t>베스트 상품 리포트  ·  생성 2026-05-14 08:00</a:t>
+              <a:t>베스트 상품 리포트  ·  생성 2026-05-15 08:00</a:t>
             </a:r>
             <a:endParaRPr lang="en-US" sz="900" dirty="0"/>
           </a:p>
@@ -5284,7 +5284,7 @@
                 <a:ea typeface="맑은 고딕" pitchFamily="34" charset="-122"/>
                 <a:cs typeface="맑은 고딕" pitchFamily="34" charset="-120"/>
               </a:rPr>
-              <a:t>2026년 05월 14일 (목)</a:t>
+              <a:t>2026년 05월 15일 (금)</a:t>
             </a:r>
             <a:endParaRPr lang="en-US" sz="1200" dirty="0"/>
           </a:p>
@@ -5451,7 +5451,7 @@
                 <a:ea typeface="맑은 고딕" pitchFamily="34" charset="-122"/>
                 <a:cs typeface="맑은 고딕" pitchFamily="34" charset="-120"/>
               </a:rPr>
-              <a:t>166 개</a:t>
+              <a:t>206 개</a:t>
             </a:r>
             <a:endParaRPr lang="en-US" sz="3600" dirty="0"/>
           </a:p>
@@ -5657,7 +5657,7 @@
                 <a:ea typeface="맑은 고딕" pitchFamily="34" charset="-122"/>
                 <a:cs typeface="맑은 고딕" pitchFamily="34" charset="-120"/>
               </a:rPr>
-              <a:t>26</a:t>
+              <a:t>37</a:t>
             </a:r>
             <a:endParaRPr lang="en-US" sz="4400" dirty="0"/>
           </a:p>
@@ -6256,7 +6256,7 @@
                           <a:ea typeface="맑은 고딕" pitchFamily="34" charset="-122"/>
                           <a:cs typeface="맑은 고딕" pitchFamily="34" charset="-120"/>
                         </a:rPr>
-                        <a:t>26 개</a:t>
+                        <a:t>37 개</a:t>
                       </a:r>
                       <a:endParaRPr lang="en-US" sz="1400" dirty="0">
                         <a:latin typeface="맑은 고딕" charset="0"/>
@@ -6453,7 +6453,7 @@
                           <a:ea typeface="맑은 고딕" pitchFamily="34" charset="-122"/>
                           <a:cs typeface="맑은 고딕" pitchFamily="34" charset="-120"/>
                         </a:rPr>
-                        <a:t>Tiny Cross Necklace</a:t>
+                        <a:t>RichardKokser Necklace</a:t>
                       </a:r>
                       <a:endParaRPr lang="en-US" sz="1100" dirty="0">
                         <a:latin typeface="맑은 고딕" charset="0"/>
@@ -6518,7 +6518,7 @@
                           <a:ea typeface="맑은 고딕" pitchFamily="34" charset="-122"/>
                           <a:cs typeface="맑은 고딕" pitchFamily="34" charset="-120"/>
                         </a:rPr>
-                        <a:t>14 개</a:t>
+                        <a:t>11 개</a:t>
                       </a:r>
                       <a:endParaRPr lang="en-US" sz="1200" dirty="0">
                         <a:latin typeface="맑은 고딕" charset="0"/>
@@ -6715,7 +6715,7 @@
                           <a:ea typeface="맑은 고딕" pitchFamily="34" charset="-122"/>
                           <a:cs typeface="맑은 고딕" pitchFamily="34" charset="-120"/>
                         </a:rPr>
-                        <a:t>Marquise Necklace</a:t>
+                        <a:t>YOKNIS 9921 Necklace</a:t>
                       </a:r>
                       <a:endParaRPr lang="en-US" sz="1100" dirty="0">
                         <a:latin typeface="맑은 고딕" charset="0"/>
@@ -6780,7 +6780,7 @@
                           <a:ea typeface="맑은 고딕" pitchFamily="34" charset="-122"/>
                           <a:cs typeface="맑은 고딕" pitchFamily="34" charset="-120"/>
                         </a:rPr>
-                        <a:t>12 개</a:t>
+                        <a:t>10 개</a:t>
                       </a:r>
                       <a:endParaRPr lang="en-US" sz="1200" dirty="0">
                         <a:latin typeface="맑은 고딕" charset="0"/>
@@ -6977,7 +6977,7 @@
                           <a:ea typeface="맑은 고딕" pitchFamily="34" charset="-122"/>
                           <a:cs typeface="맑은 고딕" pitchFamily="34" charset="-120"/>
                         </a:rPr>
-                        <a:t>[SILVER925] Eramam Open Ring</a:t>
+                        <a:t>[SILVER925] A Rua Open Ring</a:t>
                       </a:r>
                       <a:endParaRPr lang="en-US" sz="1100" dirty="0">
                         <a:latin typeface="맑은 고딕" charset="0"/>
@@ -7174,7 +7174,7 @@
                           <a:ea typeface="맑은 고딕" pitchFamily="34" charset="-122"/>
                           <a:cs typeface="맑은 고딕" pitchFamily="34" charset="-120"/>
                         </a:rPr>
-                        <a:t>Necklace</a:t>
+                        <a:t>Ring</a:t>
                       </a:r>
                       <a:endParaRPr lang="en-US" sz="1000" dirty="0">
                         <a:latin typeface="맑은 고딕" charset="0"/>
@@ -7239,7 +7239,7 @@
                           <a:ea typeface="맑은 고딕" pitchFamily="34" charset="-122"/>
                           <a:cs typeface="맑은 고딕" pitchFamily="34" charset="-120"/>
                         </a:rPr>
-                        <a:t>YOKNIS 9921 Necklace</a:t>
+                        <a:t>[SILVER925] Starly Open Ring</a:t>
                       </a:r>
                       <a:endParaRPr lang="en-US" sz="1100" dirty="0">
                         <a:latin typeface="맑은 고딕" charset="0"/>
@@ -7304,7 +7304,7 @@
                           <a:ea typeface="맑은 고딕" pitchFamily="34" charset="-122"/>
                           <a:cs typeface="맑은 고딕" pitchFamily="34" charset="-120"/>
                         </a:rPr>
-                        <a:t>6 개</a:t>
+                        <a:t>9 개</a:t>
                       </a:r>
                       <a:endParaRPr lang="en-US" sz="1200" dirty="0">
                         <a:latin typeface="맑은 고딕" charset="0"/>
@@ -7557,6 +7557,418 @@
                 <a:ea typeface="맑은 고딕" pitchFamily="34" charset="-122"/>
                 <a:cs typeface="맑은 고딕" pitchFamily="34" charset="-120"/>
               </a:rPr>
+              <a:t>8-Ball Smart Tok</a:t>
+            </a:r>
+            <a:endParaRPr lang="en-US" sz="1100" dirty="0"/>
+          </a:p>
+        </p:txBody>
+      </p:sp>
+      <p:sp>
+        <p:nvSpPr>
+          <p:cNvPr id="26" name="Text 23"/>
+          <p:cNvSpPr/>
+          <p:nvPr/>
+        </p:nvSpPr>
+        <p:spPr>
+          <a:xfrm>
+            <a:off x="8211312" y="3712464"/>
+            <a:ext cx="3291840" cy="256032"/>
+          </a:xfrm>
+          <a:prstGeom prst="rect">
+            <a:avLst/>
+          </a:prstGeom>
+          <a:noFill/>
+          <a:ln/>
+        </p:spPr>
+        <p:txBody>
+          <a:bodyPr wrap="square" lIns="0" tIns="0" rIns="0" bIns="0" rtlCol="0" anchor="ctr"/>
+          <a:lstStyle/>
+          <a:p>
+            <a:pPr indent="0" marL="0">
+              <a:buNone/>
+            </a:pPr>
+            <a:r>
+              <a:rPr lang="en-US" sz="1000" dirty="0">
+                <a:solidFill>
+                  <a:srgbClr val="6B7280"/>
+                </a:solidFill>
+                <a:latin typeface="맑은 고딕" pitchFamily="34" charset="0"/>
+                <a:ea typeface="맑은 고딕" pitchFamily="34" charset="-122"/>
+                <a:cs typeface="맑은 고딕" pitchFamily="34" charset="-120"/>
+              </a:rPr>
+              <a:t>★Season off★  ·  재고 5개</a:t>
+            </a:r>
+            <a:pPr indent="0" marL="0">
+              <a:buNone/>
+            </a:pPr>
+            <a:r>
+              <a:rPr lang="en-US" sz="1000" b="1" dirty="0">
+                <a:solidFill>
+                  <a:srgbClr val="D72638"/>
+                </a:solidFill>
+                <a:latin typeface="맑은 고딕" pitchFamily="34" charset="0"/>
+                <a:ea typeface="맑은 고딕" pitchFamily="34" charset="-122"/>
+                <a:cs typeface="맑은 고딕" pitchFamily="34" charset="-120"/>
+              </a:rPr>
+              <a:t/>
+            </a:r>
+            <a:endParaRPr lang="en-US" sz="1000" dirty="0"/>
+          </a:p>
+        </p:txBody>
+      </p:sp>
+      <p:sp>
+        <p:nvSpPr>
+          <p:cNvPr id="27" name="Shape 24"/>
+          <p:cNvSpPr/>
+          <p:nvPr/>
+        </p:nvSpPr>
+        <p:spPr>
+          <a:xfrm>
+            <a:off x="7406640" y="4096512"/>
+            <a:ext cx="4206240" cy="640080"/>
+          </a:xfrm>
+          <a:prstGeom prst="rect">
+            <a:avLst/>
+          </a:prstGeom>
+          <a:solidFill>
+            <a:srgbClr val="FFF5F5"/>
+          </a:solidFill>
+          <a:ln w="6350">
+            <a:solidFill>
+              <a:srgbClr val="E5E7EB"/>
+            </a:solidFill>
+            <a:prstDash val="solid"/>
+          </a:ln>
+        </p:spPr>
+      </p:sp>
+      <p:sp>
+        <p:nvSpPr>
+          <p:cNvPr id="28" name="Shape 25"/>
+          <p:cNvSpPr/>
+          <p:nvPr/>
+        </p:nvSpPr>
+        <p:spPr>
+          <a:xfrm>
+            <a:off x="7406640" y="4096512"/>
+            <a:ext cx="109728" cy="640080"/>
+          </a:xfrm>
+          <a:prstGeom prst="rect">
+            <a:avLst/>
+          </a:prstGeom>
+          <a:solidFill>
+            <a:srgbClr val="D72638"/>
+          </a:solidFill>
+          <a:ln w="12700">
+            <a:solidFill>
+              <a:srgbClr val="D72638"/>
+            </a:solidFill>
+            <a:prstDash val="solid"/>
+          </a:ln>
+        </p:spPr>
+      </p:sp>
+      <p:sp>
+        <p:nvSpPr>
+          <p:cNvPr id="29" name="Shape 26"/>
+          <p:cNvSpPr/>
+          <p:nvPr/>
+        </p:nvSpPr>
+        <p:spPr>
+          <a:xfrm>
+            <a:off x="7571232" y="4187952"/>
+            <a:ext cx="548640" cy="256032"/>
+          </a:xfrm>
+          <a:prstGeom prst="rect">
+            <a:avLst/>
+          </a:prstGeom>
+          <a:solidFill>
+            <a:srgbClr val="D72638"/>
+          </a:solidFill>
+          <a:ln w="12700">
+            <a:solidFill>
+              <a:srgbClr val="D72638"/>
+            </a:solidFill>
+            <a:prstDash val="solid"/>
+          </a:ln>
+        </p:spPr>
+      </p:sp>
+      <p:sp>
+        <p:nvSpPr>
+          <p:cNvPr id="30" name="Text 27"/>
+          <p:cNvSpPr/>
+          <p:nvPr/>
+        </p:nvSpPr>
+        <p:spPr>
+          <a:xfrm>
+            <a:off x="7571232" y="4187952"/>
+            <a:ext cx="548640" cy="256032"/>
+          </a:xfrm>
+          <a:prstGeom prst="rect">
+            <a:avLst/>
+          </a:prstGeom>
+          <a:noFill/>
+          <a:ln/>
+        </p:spPr>
+        <p:txBody>
+          <a:bodyPr wrap="square" lIns="0" tIns="0" rIns="0" bIns="0" rtlCol="0" anchor="ctr"/>
+          <a:lstStyle/>
+          <a:p>
+            <a:pPr algn="ctr" indent="0" marL="0">
+              <a:buNone/>
+            </a:pPr>
+            <a:r>
+              <a:rPr lang="en-US" sz="900" b="1" dirty="0">
+                <a:solidFill>
+                  <a:srgbClr val="FFFFFF"/>
+                </a:solidFill>
+                <a:latin typeface="맑은 고딕" pitchFamily="34" charset="0"/>
+                <a:ea typeface="맑은 고딕" pitchFamily="34" charset="-122"/>
+                <a:cs typeface="맑은 고딕" pitchFamily="34" charset="-120"/>
+              </a:rPr>
+              <a:t>긴급</a:t>
+            </a:r>
+            <a:endParaRPr lang="en-US" sz="900" dirty="0"/>
+          </a:p>
+        </p:txBody>
+      </p:sp>
+      <p:sp>
+        <p:nvSpPr>
+          <p:cNvPr id="31" name="Text 28"/>
+          <p:cNvSpPr/>
+          <p:nvPr/>
+        </p:nvSpPr>
+        <p:spPr>
+          <a:xfrm>
+            <a:off x="8211312" y="4151376"/>
+            <a:ext cx="3291840" cy="274320"/>
+          </a:xfrm>
+          <a:prstGeom prst="rect">
+            <a:avLst/>
+          </a:prstGeom>
+          <a:noFill/>
+          <a:ln/>
+        </p:spPr>
+        <p:txBody>
+          <a:bodyPr wrap="square" lIns="0" tIns="0" rIns="0" bIns="0" rtlCol="0" anchor="ctr"/>
+          <a:lstStyle/>
+          <a:p>
+            <a:pPr indent="0" marL="0">
+              <a:buNone/>
+            </a:pPr>
+            <a:r>
+              <a:rPr lang="en-US" sz="1100" b="1" dirty="0">
+                <a:solidFill>
+                  <a:srgbClr val="0B1220"/>
+                </a:solidFill>
+                <a:latin typeface="맑은 고딕" pitchFamily="34" charset="0"/>
+                <a:ea typeface="맑은 고딕" pitchFamily="34" charset="-122"/>
+                <a:cs typeface="맑은 고딕" pitchFamily="34" charset="-120"/>
+              </a:rPr>
+              <a:t>B-Flower Necklace (Size: 2 Size)</a:t>
+            </a:r>
+            <a:endParaRPr lang="en-US" sz="1100" dirty="0"/>
+          </a:p>
+        </p:txBody>
+      </p:sp>
+      <p:sp>
+        <p:nvSpPr>
+          <p:cNvPr id="32" name="Text 29"/>
+          <p:cNvSpPr/>
+          <p:nvPr/>
+        </p:nvSpPr>
+        <p:spPr>
+          <a:xfrm>
+            <a:off x="8211312" y="4425696"/>
+            <a:ext cx="3291840" cy="256032"/>
+          </a:xfrm>
+          <a:prstGeom prst="rect">
+            <a:avLst/>
+          </a:prstGeom>
+          <a:noFill/>
+          <a:ln/>
+        </p:spPr>
+        <p:txBody>
+          <a:bodyPr wrap="square" lIns="0" tIns="0" rIns="0" bIns="0" rtlCol="0" anchor="ctr"/>
+          <a:lstStyle/>
+          <a:p>
+            <a:pPr indent="0" marL="0">
+              <a:buNone/>
+            </a:pPr>
+            <a:r>
+              <a:rPr lang="en-US" sz="1000" dirty="0">
+                <a:solidFill>
+                  <a:srgbClr val="6B7280"/>
+                </a:solidFill>
+                <a:latin typeface="맑은 고딕" pitchFamily="34" charset="0"/>
+                <a:ea typeface="맑은 고딕" pitchFamily="34" charset="-122"/>
+                <a:cs typeface="맑은 고딕" pitchFamily="34" charset="-120"/>
+              </a:rPr>
+              <a:t>Necklace  ·  재고 4개</a:t>
+            </a:r>
+            <a:pPr indent="0" marL="0">
+              <a:buNone/>
+            </a:pPr>
+            <a:r>
+              <a:rPr lang="en-US" sz="1000" b="1" dirty="0">
+                <a:solidFill>
+                  <a:srgbClr val="D72638"/>
+                </a:solidFill>
+                <a:latin typeface="맑은 고딕" pitchFamily="34" charset="0"/>
+                <a:ea typeface="맑은 고딕" pitchFamily="34" charset="-122"/>
+                <a:cs typeface="맑은 고딕" pitchFamily="34" charset="-120"/>
+              </a:rPr>
+              <a:t/>
+            </a:r>
+            <a:endParaRPr lang="en-US" sz="1000" dirty="0"/>
+          </a:p>
+        </p:txBody>
+      </p:sp>
+      <p:sp>
+        <p:nvSpPr>
+          <p:cNvPr id="33" name="Shape 30"/>
+          <p:cNvSpPr/>
+          <p:nvPr/>
+        </p:nvSpPr>
+        <p:spPr>
+          <a:xfrm>
+            <a:off x="7406640" y="4809744"/>
+            <a:ext cx="4206240" cy="640080"/>
+          </a:xfrm>
+          <a:prstGeom prst="rect">
+            <a:avLst/>
+          </a:prstGeom>
+          <a:solidFill>
+            <a:srgbClr val="FFF5F5"/>
+          </a:solidFill>
+          <a:ln w="6350">
+            <a:solidFill>
+              <a:srgbClr val="E5E7EB"/>
+            </a:solidFill>
+            <a:prstDash val="solid"/>
+          </a:ln>
+        </p:spPr>
+      </p:sp>
+      <p:sp>
+        <p:nvSpPr>
+          <p:cNvPr id="34" name="Shape 31"/>
+          <p:cNvSpPr/>
+          <p:nvPr/>
+        </p:nvSpPr>
+        <p:spPr>
+          <a:xfrm>
+            <a:off x="7406640" y="4809744"/>
+            <a:ext cx="109728" cy="640080"/>
+          </a:xfrm>
+          <a:prstGeom prst="rect">
+            <a:avLst/>
+          </a:prstGeom>
+          <a:solidFill>
+            <a:srgbClr val="D72638"/>
+          </a:solidFill>
+          <a:ln w="12700">
+            <a:solidFill>
+              <a:srgbClr val="D72638"/>
+            </a:solidFill>
+            <a:prstDash val="solid"/>
+          </a:ln>
+        </p:spPr>
+      </p:sp>
+      <p:sp>
+        <p:nvSpPr>
+          <p:cNvPr id="35" name="Shape 32"/>
+          <p:cNvSpPr/>
+          <p:nvPr/>
+        </p:nvSpPr>
+        <p:spPr>
+          <a:xfrm>
+            <a:off x="7571232" y="4901184"/>
+            <a:ext cx="548640" cy="256032"/>
+          </a:xfrm>
+          <a:prstGeom prst="rect">
+            <a:avLst/>
+          </a:prstGeom>
+          <a:solidFill>
+            <a:srgbClr val="D72638"/>
+          </a:solidFill>
+          <a:ln w="12700">
+            <a:solidFill>
+              <a:srgbClr val="D72638"/>
+            </a:solidFill>
+            <a:prstDash val="solid"/>
+          </a:ln>
+        </p:spPr>
+      </p:sp>
+      <p:sp>
+        <p:nvSpPr>
+          <p:cNvPr id="36" name="Text 33"/>
+          <p:cNvSpPr/>
+          <p:nvPr/>
+        </p:nvSpPr>
+        <p:spPr>
+          <a:xfrm>
+            <a:off x="7571232" y="4901184"/>
+            <a:ext cx="548640" cy="256032"/>
+          </a:xfrm>
+          <a:prstGeom prst="rect">
+            <a:avLst/>
+          </a:prstGeom>
+          <a:noFill/>
+          <a:ln/>
+        </p:spPr>
+        <p:txBody>
+          <a:bodyPr wrap="square" lIns="0" tIns="0" rIns="0" bIns="0" rtlCol="0" anchor="ctr"/>
+          <a:lstStyle/>
+          <a:p>
+            <a:pPr algn="ctr" indent="0" marL="0">
+              <a:buNone/>
+            </a:pPr>
+            <a:r>
+              <a:rPr lang="en-US" sz="900" b="1" dirty="0">
+                <a:solidFill>
+                  <a:srgbClr val="FFFFFF"/>
+                </a:solidFill>
+                <a:latin typeface="맑은 고딕" pitchFamily="34" charset="0"/>
+                <a:ea typeface="맑은 고딕" pitchFamily="34" charset="-122"/>
+                <a:cs typeface="맑은 고딕" pitchFamily="34" charset="-120"/>
+              </a:rPr>
+              <a:t>긴급</a:t>
+            </a:r>
+            <a:endParaRPr lang="en-US" sz="900" dirty="0"/>
+          </a:p>
+        </p:txBody>
+      </p:sp>
+      <p:sp>
+        <p:nvSpPr>
+          <p:cNvPr id="37" name="Text 34"/>
+          <p:cNvSpPr/>
+          <p:nvPr/>
+        </p:nvSpPr>
+        <p:spPr>
+          <a:xfrm>
+            <a:off x="8211312" y="4864608"/>
+            <a:ext cx="3291840" cy="274320"/>
+          </a:xfrm>
+          <a:prstGeom prst="rect">
+            <a:avLst/>
+          </a:prstGeom>
+          <a:noFill/>
+          <a:ln/>
+        </p:spPr>
+        <p:txBody>
+          <a:bodyPr wrap="square" lIns="0" tIns="0" rIns="0" bIns="0" rtlCol="0" anchor="ctr"/>
+          <a:lstStyle/>
+          <a:p>
+            <a:pPr indent="0" marL="0">
+              <a:buNone/>
+            </a:pPr>
+            <a:r>
+              <a:rPr lang="en-US" sz="1100" b="1" dirty="0">
+                <a:solidFill>
+                  <a:srgbClr val="0B1220"/>
+                </a:solidFill>
+                <a:latin typeface="맑은 고딕" pitchFamily="34" charset="0"/>
+                <a:ea typeface="맑은 고딕" pitchFamily="34" charset="-122"/>
+                <a:cs typeface="맑은 고딕" pitchFamily="34" charset="-120"/>
+              </a:rPr>
               <a:t>Tangle Keychain</a:t>
             </a:r>
             <a:endParaRPr lang="en-US" sz="1100" dirty="0"/>
@@ -7565,13 +7977,13 @@
       </p:sp>
       <p:sp>
         <p:nvSpPr>
-          <p:cNvPr id="26" name="Text 23"/>
-          <p:cNvSpPr/>
-          <p:nvPr/>
-        </p:nvSpPr>
-        <p:spPr>
-          <a:xfrm>
-            <a:off x="8211312" y="3712464"/>
+          <p:cNvPr id="38" name="Text 35"/>
+          <p:cNvSpPr/>
+          <p:nvPr/>
+        </p:nvSpPr>
+        <p:spPr>
+          <a:xfrm>
+            <a:off x="8211312" y="5138928"/>
             <a:ext cx="3291840" cy="256032"/>
           </a:xfrm>
           <a:prstGeom prst="rect">
@@ -7618,13 +8030,13 @@
       </p:sp>
       <p:sp>
         <p:nvSpPr>
-          <p:cNvPr id="27" name="Shape 24"/>
-          <p:cNvSpPr/>
-          <p:nvPr/>
-        </p:nvSpPr>
-        <p:spPr>
-          <a:xfrm>
-            <a:off x="7406640" y="4096512"/>
+          <p:cNvPr id="39" name="Shape 36"/>
+          <p:cNvSpPr/>
+          <p:nvPr/>
+        </p:nvSpPr>
+        <p:spPr>
+          <a:xfrm>
+            <a:off x="7406640" y="5522976"/>
             <a:ext cx="4206240" cy="640080"/>
           </a:xfrm>
           <a:prstGeom prst="rect">
@@ -7643,13 +8055,13 @@
       </p:sp>
       <p:sp>
         <p:nvSpPr>
-          <p:cNvPr id="28" name="Shape 25"/>
-          <p:cNvSpPr/>
-          <p:nvPr/>
-        </p:nvSpPr>
-        <p:spPr>
-          <a:xfrm>
-            <a:off x="7406640" y="4096512"/>
+          <p:cNvPr id="40" name="Shape 37"/>
+          <p:cNvSpPr/>
+          <p:nvPr/>
+        </p:nvSpPr>
+        <p:spPr>
+          <a:xfrm>
+            <a:off x="7406640" y="5522976"/>
             <a:ext cx="109728" cy="640080"/>
           </a:xfrm>
           <a:prstGeom prst="rect">
@@ -7668,13 +8080,13 @@
       </p:sp>
       <p:sp>
         <p:nvSpPr>
-          <p:cNvPr id="29" name="Shape 26"/>
-          <p:cNvSpPr/>
-          <p:nvPr/>
-        </p:nvSpPr>
-        <p:spPr>
-          <a:xfrm>
-            <a:off x="7571232" y="4187952"/>
+          <p:cNvPr id="41" name="Shape 38"/>
+          <p:cNvSpPr/>
+          <p:nvPr/>
+        </p:nvSpPr>
+        <p:spPr>
+          <a:xfrm>
+            <a:off x="7571232" y="5614416"/>
             <a:ext cx="548640" cy="256032"/>
           </a:xfrm>
           <a:prstGeom prst="rect">
@@ -7693,13 +8105,13 @@
       </p:sp>
       <p:sp>
         <p:nvSpPr>
-          <p:cNvPr id="30" name="Text 27"/>
-          <p:cNvSpPr/>
-          <p:nvPr/>
-        </p:nvSpPr>
-        <p:spPr>
-          <a:xfrm>
-            <a:off x="7571232" y="4187952"/>
+          <p:cNvPr id="42" name="Text 39"/>
+          <p:cNvSpPr/>
+          <p:nvPr/>
+        </p:nvSpPr>
+        <p:spPr>
+          <a:xfrm>
+            <a:off x="7571232" y="5614416"/>
             <a:ext cx="548640" cy="256032"/>
           </a:xfrm>
           <a:prstGeom prst="rect">
@@ -7732,13 +8144,13 @@
       </p:sp>
       <p:sp>
         <p:nvSpPr>
-          <p:cNvPr id="31" name="Text 28"/>
-          <p:cNvSpPr/>
-          <p:nvPr/>
-        </p:nvSpPr>
-        <p:spPr>
-          <a:xfrm>
-            <a:off x="8211312" y="4151376"/>
+          <p:cNvPr id="43" name="Text 40"/>
+          <p:cNvSpPr/>
+          <p:nvPr/>
+        </p:nvSpPr>
+        <p:spPr>
+          <a:xfrm>
+            <a:off x="8211312" y="5577840"/>
             <a:ext cx="3291840" cy="274320"/>
           </a:xfrm>
           <a:prstGeom prst="rect">
@@ -7763,7 +8175,7 @@
                 <a:ea typeface="맑은 고딕" pitchFamily="34" charset="-122"/>
                 <a:cs typeface="맑은 고딕" pitchFamily="34" charset="-120"/>
               </a:rPr>
-              <a:t>[SILVER925] CH.alban Open Ring</a:t>
+              <a:t>B-Flower Necklace (Size: 1 Size)</a:t>
             </a:r>
             <a:endParaRPr lang="en-US" sz="1100" dirty="0"/>
           </a:p>
@@ -7771,13 +8183,13 @@
       </p:sp>
       <p:sp>
         <p:nvSpPr>
-          <p:cNvPr id="32" name="Text 29"/>
-          <p:cNvSpPr/>
-          <p:nvPr/>
-        </p:nvSpPr>
-        <p:spPr>
-          <a:xfrm>
-            <a:off x="8211312" y="4425696"/>
+          <p:cNvPr id="44" name="Text 41"/>
+          <p:cNvSpPr/>
+          <p:nvPr/>
+        </p:nvSpPr>
+        <p:spPr>
+          <a:xfrm>
+            <a:off x="8211312" y="5852160"/>
             <a:ext cx="3291840" cy="256032"/>
           </a:xfrm>
           <a:prstGeom prst="rect">
@@ -7802,7 +8214,7 @@
                 <a:ea typeface="맑은 고딕" pitchFamily="34" charset="-122"/>
                 <a:cs typeface="맑은 고딕" pitchFamily="34" charset="-120"/>
               </a:rPr>
-              <a:t>Ring  ·  재고 0개</a:t>
+              <a:t>Necklace  ·  재고 0개</a:t>
             </a:r>
             <a:pPr indent="0" marL="0">
               <a:buNone/>
@@ -7824,418 +8236,6 @@
       </p:sp>
       <p:sp>
         <p:nvSpPr>
-          <p:cNvPr id="33" name="Shape 30"/>
-          <p:cNvSpPr/>
-          <p:nvPr/>
-        </p:nvSpPr>
-        <p:spPr>
-          <a:xfrm>
-            <a:off x="7406640" y="4809744"/>
-            <a:ext cx="4206240" cy="640080"/>
-          </a:xfrm>
-          <a:prstGeom prst="rect">
-            <a:avLst/>
-          </a:prstGeom>
-          <a:solidFill>
-            <a:srgbClr val="FFF5F5"/>
-          </a:solidFill>
-          <a:ln w="6350">
-            <a:solidFill>
-              <a:srgbClr val="E5E7EB"/>
-            </a:solidFill>
-            <a:prstDash val="solid"/>
-          </a:ln>
-        </p:spPr>
-      </p:sp>
-      <p:sp>
-        <p:nvSpPr>
-          <p:cNvPr id="34" name="Shape 31"/>
-          <p:cNvSpPr/>
-          <p:nvPr/>
-        </p:nvSpPr>
-        <p:spPr>
-          <a:xfrm>
-            <a:off x="7406640" y="4809744"/>
-            <a:ext cx="109728" cy="640080"/>
-          </a:xfrm>
-          <a:prstGeom prst="rect">
-            <a:avLst/>
-          </a:prstGeom>
-          <a:solidFill>
-            <a:srgbClr val="D72638"/>
-          </a:solidFill>
-          <a:ln w="12700">
-            <a:solidFill>
-              <a:srgbClr val="D72638"/>
-            </a:solidFill>
-            <a:prstDash val="solid"/>
-          </a:ln>
-        </p:spPr>
-      </p:sp>
-      <p:sp>
-        <p:nvSpPr>
-          <p:cNvPr id="35" name="Shape 32"/>
-          <p:cNvSpPr/>
-          <p:nvPr/>
-        </p:nvSpPr>
-        <p:spPr>
-          <a:xfrm>
-            <a:off x="7571232" y="4901184"/>
-            <a:ext cx="548640" cy="256032"/>
-          </a:xfrm>
-          <a:prstGeom prst="rect">
-            <a:avLst/>
-          </a:prstGeom>
-          <a:solidFill>
-            <a:srgbClr val="D72638"/>
-          </a:solidFill>
-          <a:ln w="12700">
-            <a:solidFill>
-              <a:srgbClr val="D72638"/>
-            </a:solidFill>
-            <a:prstDash val="solid"/>
-          </a:ln>
-        </p:spPr>
-      </p:sp>
-      <p:sp>
-        <p:nvSpPr>
-          <p:cNvPr id="36" name="Text 33"/>
-          <p:cNvSpPr/>
-          <p:nvPr/>
-        </p:nvSpPr>
-        <p:spPr>
-          <a:xfrm>
-            <a:off x="7571232" y="4901184"/>
-            <a:ext cx="548640" cy="256032"/>
-          </a:xfrm>
-          <a:prstGeom prst="rect">
-            <a:avLst/>
-          </a:prstGeom>
-          <a:noFill/>
-          <a:ln/>
-        </p:spPr>
-        <p:txBody>
-          <a:bodyPr wrap="square" lIns="0" tIns="0" rIns="0" bIns="0" rtlCol="0" anchor="ctr"/>
-          <a:lstStyle/>
-          <a:p>
-            <a:pPr algn="ctr" indent="0" marL="0">
-              <a:buNone/>
-            </a:pPr>
-            <a:r>
-              <a:rPr lang="en-US" sz="900" b="1" dirty="0">
-                <a:solidFill>
-                  <a:srgbClr val="FFFFFF"/>
-                </a:solidFill>
-                <a:latin typeface="맑은 고딕" pitchFamily="34" charset="0"/>
-                <a:ea typeface="맑은 고딕" pitchFamily="34" charset="-122"/>
-                <a:cs typeface="맑은 고딕" pitchFamily="34" charset="-120"/>
-              </a:rPr>
-              <a:t>긴급</a:t>
-            </a:r>
-            <a:endParaRPr lang="en-US" sz="900" dirty="0"/>
-          </a:p>
-        </p:txBody>
-      </p:sp>
-      <p:sp>
-        <p:nvSpPr>
-          <p:cNvPr id="37" name="Text 34"/>
-          <p:cNvSpPr/>
-          <p:nvPr/>
-        </p:nvSpPr>
-        <p:spPr>
-          <a:xfrm>
-            <a:off x="8211312" y="4864608"/>
-            <a:ext cx="3291840" cy="274320"/>
-          </a:xfrm>
-          <a:prstGeom prst="rect">
-            <a:avLst/>
-          </a:prstGeom>
-          <a:noFill/>
-          <a:ln/>
-        </p:spPr>
-        <p:txBody>
-          <a:bodyPr wrap="square" lIns="0" tIns="0" rIns="0" bIns="0" rtlCol="0" anchor="ctr"/>
-          <a:lstStyle/>
-          <a:p>
-            <a:pPr indent="0" marL="0">
-              <a:buNone/>
-            </a:pPr>
-            <a:r>
-              <a:rPr lang="en-US" sz="1100" b="1" dirty="0">
-                <a:solidFill>
-                  <a:srgbClr val="0B1220"/>
-                </a:solidFill>
-                <a:latin typeface="맑은 고딕" pitchFamily="34" charset="0"/>
-                <a:ea typeface="맑은 고딕" pitchFamily="34" charset="-122"/>
-                <a:cs typeface="맑은 고딕" pitchFamily="34" charset="-120"/>
-              </a:rPr>
-              <a:t>8-Ball Smart Tok</a:t>
-            </a:r>
-            <a:endParaRPr lang="en-US" sz="1100" dirty="0"/>
-          </a:p>
-        </p:txBody>
-      </p:sp>
-      <p:sp>
-        <p:nvSpPr>
-          <p:cNvPr id="38" name="Text 35"/>
-          <p:cNvSpPr/>
-          <p:nvPr/>
-        </p:nvSpPr>
-        <p:spPr>
-          <a:xfrm>
-            <a:off x="8211312" y="5138928"/>
-            <a:ext cx="3291840" cy="256032"/>
-          </a:xfrm>
-          <a:prstGeom prst="rect">
-            <a:avLst/>
-          </a:prstGeom>
-          <a:noFill/>
-          <a:ln/>
-        </p:spPr>
-        <p:txBody>
-          <a:bodyPr wrap="square" lIns="0" tIns="0" rIns="0" bIns="0" rtlCol="0" anchor="ctr"/>
-          <a:lstStyle/>
-          <a:p>
-            <a:pPr indent="0" marL="0">
-              <a:buNone/>
-            </a:pPr>
-            <a:r>
-              <a:rPr lang="en-US" sz="1000" dirty="0">
-                <a:solidFill>
-                  <a:srgbClr val="6B7280"/>
-                </a:solidFill>
-                <a:latin typeface="맑은 고딕" pitchFamily="34" charset="0"/>
-                <a:ea typeface="맑은 고딕" pitchFamily="34" charset="-122"/>
-                <a:cs typeface="맑은 고딕" pitchFamily="34" charset="-120"/>
-              </a:rPr>
-              <a:t>★Season off★  ·  재고 5개</a:t>
-            </a:r>
-            <a:pPr indent="0" marL="0">
-              <a:buNone/>
-            </a:pPr>
-            <a:r>
-              <a:rPr lang="en-US" sz="1000" b="1" dirty="0">
-                <a:solidFill>
-                  <a:srgbClr val="D72638"/>
-                </a:solidFill>
-                <a:latin typeface="맑은 고딕" pitchFamily="34" charset="0"/>
-                <a:ea typeface="맑은 고딕" pitchFamily="34" charset="-122"/>
-                <a:cs typeface="맑은 고딕" pitchFamily="34" charset="-120"/>
-              </a:rPr>
-              <a:t/>
-            </a:r>
-            <a:endParaRPr lang="en-US" sz="1000" dirty="0"/>
-          </a:p>
-        </p:txBody>
-      </p:sp>
-      <p:sp>
-        <p:nvSpPr>
-          <p:cNvPr id="39" name="Shape 36"/>
-          <p:cNvSpPr/>
-          <p:nvPr/>
-        </p:nvSpPr>
-        <p:spPr>
-          <a:xfrm>
-            <a:off x="7406640" y="5522976"/>
-            <a:ext cx="4206240" cy="640080"/>
-          </a:xfrm>
-          <a:prstGeom prst="rect">
-            <a:avLst/>
-          </a:prstGeom>
-          <a:solidFill>
-            <a:srgbClr val="FFF5F5"/>
-          </a:solidFill>
-          <a:ln w="6350">
-            <a:solidFill>
-              <a:srgbClr val="E5E7EB"/>
-            </a:solidFill>
-            <a:prstDash val="solid"/>
-          </a:ln>
-        </p:spPr>
-      </p:sp>
-      <p:sp>
-        <p:nvSpPr>
-          <p:cNvPr id="40" name="Shape 37"/>
-          <p:cNvSpPr/>
-          <p:nvPr/>
-        </p:nvSpPr>
-        <p:spPr>
-          <a:xfrm>
-            <a:off x="7406640" y="5522976"/>
-            <a:ext cx="109728" cy="640080"/>
-          </a:xfrm>
-          <a:prstGeom prst="rect">
-            <a:avLst/>
-          </a:prstGeom>
-          <a:solidFill>
-            <a:srgbClr val="D72638"/>
-          </a:solidFill>
-          <a:ln w="12700">
-            <a:solidFill>
-              <a:srgbClr val="D72638"/>
-            </a:solidFill>
-            <a:prstDash val="solid"/>
-          </a:ln>
-        </p:spPr>
-      </p:sp>
-      <p:sp>
-        <p:nvSpPr>
-          <p:cNvPr id="41" name="Shape 38"/>
-          <p:cNvSpPr/>
-          <p:nvPr/>
-        </p:nvSpPr>
-        <p:spPr>
-          <a:xfrm>
-            <a:off x="7571232" y="5614416"/>
-            <a:ext cx="548640" cy="256032"/>
-          </a:xfrm>
-          <a:prstGeom prst="rect">
-            <a:avLst/>
-          </a:prstGeom>
-          <a:solidFill>
-            <a:srgbClr val="D72638"/>
-          </a:solidFill>
-          <a:ln w="12700">
-            <a:solidFill>
-              <a:srgbClr val="D72638"/>
-            </a:solidFill>
-            <a:prstDash val="solid"/>
-          </a:ln>
-        </p:spPr>
-      </p:sp>
-      <p:sp>
-        <p:nvSpPr>
-          <p:cNvPr id="42" name="Text 39"/>
-          <p:cNvSpPr/>
-          <p:nvPr/>
-        </p:nvSpPr>
-        <p:spPr>
-          <a:xfrm>
-            <a:off x="7571232" y="5614416"/>
-            <a:ext cx="548640" cy="256032"/>
-          </a:xfrm>
-          <a:prstGeom prst="rect">
-            <a:avLst/>
-          </a:prstGeom>
-          <a:noFill/>
-          <a:ln/>
-        </p:spPr>
-        <p:txBody>
-          <a:bodyPr wrap="square" lIns="0" tIns="0" rIns="0" bIns="0" rtlCol="0" anchor="ctr"/>
-          <a:lstStyle/>
-          <a:p>
-            <a:pPr algn="ctr" indent="0" marL="0">
-              <a:buNone/>
-            </a:pPr>
-            <a:r>
-              <a:rPr lang="en-US" sz="900" b="1" dirty="0">
-                <a:solidFill>
-                  <a:srgbClr val="FFFFFF"/>
-                </a:solidFill>
-                <a:latin typeface="맑은 고딕" pitchFamily="34" charset="0"/>
-                <a:ea typeface="맑은 고딕" pitchFamily="34" charset="-122"/>
-                <a:cs typeface="맑은 고딕" pitchFamily="34" charset="-120"/>
-              </a:rPr>
-              <a:t>긴급</a:t>
-            </a:r>
-            <a:endParaRPr lang="en-US" sz="900" dirty="0"/>
-          </a:p>
-        </p:txBody>
-      </p:sp>
-      <p:sp>
-        <p:nvSpPr>
-          <p:cNvPr id="43" name="Text 40"/>
-          <p:cNvSpPr/>
-          <p:nvPr/>
-        </p:nvSpPr>
-        <p:spPr>
-          <a:xfrm>
-            <a:off x="8211312" y="5577840"/>
-            <a:ext cx="3291840" cy="274320"/>
-          </a:xfrm>
-          <a:prstGeom prst="rect">
-            <a:avLst/>
-          </a:prstGeom>
-          <a:noFill/>
-          <a:ln/>
-        </p:spPr>
-        <p:txBody>
-          <a:bodyPr wrap="square" lIns="0" tIns="0" rIns="0" bIns="0" rtlCol="0" anchor="ctr"/>
-          <a:lstStyle/>
-          <a:p>
-            <a:pPr indent="0" marL="0">
-              <a:buNone/>
-            </a:pPr>
-            <a:r>
-              <a:rPr lang="en-US" sz="1100" b="1" dirty="0">
-                <a:solidFill>
-                  <a:srgbClr val="0B1220"/>
-                </a:solidFill>
-                <a:latin typeface="맑은 고딕" pitchFamily="34" charset="0"/>
-                <a:ea typeface="맑은 고딕" pitchFamily="34" charset="-122"/>
-                <a:cs typeface="맑은 고딕" pitchFamily="34" charset="-120"/>
-              </a:rPr>
-              <a:t>B-Flower Necklace (Size: 2 Size)</a:t>
-            </a:r>
-            <a:endParaRPr lang="en-US" sz="1100" dirty="0"/>
-          </a:p>
-        </p:txBody>
-      </p:sp>
-      <p:sp>
-        <p:nvSpPr>
-          <p:cNvPr id="44" name="Text 41"/>
-          <p:cNvSpPr/>
-          <p:nvPr/>
-        </p:nvSpPr>
-        <p:spPr>
-          <a:xfrm>
-            <a:off x="8211312" y="5852160"/>
-            <a:ext cx="3291840" cy="256032"/>
-          </a:xfrm>
-          <a:prstGeom prst="rect">
-            <a:avLst/>
-          </a:prstGeom>
-          <a:noFill/>
-          <a:ln/>
-        </p:spPr>
-        <p:txBody>
-          <a:bodyPr wrap="square" lIns="0" tIns="0" rIns="0" bIns="0" rtlCol="0" anchor="ctr"/>
-          <a:lstStyle/>
-          <a:p>
-            <a:pPr indent="0" marL="0">
-              <a:buNone/>
-            </a:pPr>
-            <a:r>
-              <a:rPr lang="en-US" sz="1000" dirty="0">
-                <a:solidFill>
-                  <a:srgbClr val="6B7280"/>
-                </a:solidFill>
-                <a:latin typeface="맑은 고딕" pitchFamily="34" charset="0"/>
-                <a:ea typeface="맑은 고딕" pitchFamily="34" charset="-122"/>
-                <a:cs typeface="맑은 고딕" pitchFamily="34" charset="-120"/>
-              </a:rPr>
-              <a:t>Necklace  ·  재고 4개</a:t>
-            </a:r>
-            <a:pPr indent="0" marL="0">
-              <a:buNone/>
-            </a:pPr>
-            <a:r>
-              <a:rPr lang="en-US" sz="1000" b="1" dirty="0">
-                <a:solidFill>
-                  <a:srgbClr val="D72638"/>
-                </a:solidFill>
-                <a:latin typeface="맑은 고딕" pitchFamily="34" charset="0"/>
-                <a:ea typeface="맑은 고딕" pitchFamily="34" charset="-122"/>
-                <a:cs typeface="맑은 고딕" pitchFamily="34" charset="-120"/>
-              </a:rPr>
-              <a:t/>
-            </a:r>
-            <a:endParaRPr lang="en-US" sz="1000" dirty="0"/>
-          </a:p>
-        </p:txBody>
-      </p:sp>
-      <p:sp>
-        <p:nvSpPr>
           <p:cNvPr id="45" name="Text 42"/>
           <p:cNvSpPr/>
           <p:nvPr/>
@@ -8267,7 +8267,7 @@
                 <a:ea typeface="맑은 고딕" pitchFamily="34" charset="-122"/>
                 <a:cs typeface="맑은 고딕" pitchFamily="34" charset="-120"/>
               </a:rPr>
-              <a:t>베스트 상품 리포트  ·  생성 2026-05-14 08:00</a:t>
+              <a:t>베스트 상품 리포트  ·  생성 2026-05-15 08:00</a:t>
             </a:r>
             <a:endParaRPr lang="en-US" sz="900" dirty="0"/>
           </a:p>
@@ -8480,7 +8480,7 @@
                 <a:ea typeface="맑은 고딕" pitchFamily="34" charset="-122"/>
                 <a:cs typeface="맑은 고딕" pitchFamily="34" charset="-120"/>
               </a:rPr>
-              <a:t>2026년 05월 14일 (목)</a:t>
+              <a:t>2026년 05월 15일 (금)</a:t>
             </a:r>
             <a:endParaRPr lang="en-US" sz="1200" dirty="0"/>
           </a:p>
@@ -8647,7 +8647,7 @@
                 <a:ea typeface="맑은 고딕" pitchFamily="34" charset="-122"/>
                 <a:cs typeface="맑은 고딕" pitchFamily="34" charset="-120"/>
               </a:rPr>
-              <a:t>135 개</a:t>
+              <a:t>137 개</a:t>
             </a:r>
             <a:endParaRPr lang="en-US" sz="3600" dirty="0"/>
           </a:p>
@@ -8853,7 +8853,7 @@
                 <a:ea typeface="맑은 고딕" pitchFamily="34" charset="-122"/>
                 <a:cs typeface="맑은 고딕" pitchFamily="34" charset="-120"/>
               </a:rPr>
-              <a:t>53</a:t>
+              <a:t>44</a:t>
             </a:r>
             <a:endParaRPr lang="en-US" sz="4400" dirty="0"/>
           </a:p>
@@ -9452,7 +9452,7 @@
                           <a:ea typeface="맑은 고딕" pitchFamily="34" charset="-122"/>
                           <a:cs typeface="맑은 고딕" pitchFamily="34" charset="-120"/>
                         </a:rPr>
-                        <a:t>53 개</a:t>
+                        <a:t>44 개</a:t>
                       </a:r>
                       <a:endParaRPr lang="en-US" sz="1400" dirty="0">
                         <a:latin typeface="맑은 고딕" charset="0"/>
@@ -9714,7 +9714,7 @@
                           <a:ea typeface="맑은 고딕" pitchFamily="34" charset="-122"/>
                           <a:cs typeface="맑은 고딕" pitchFamily="34" charset="-120"/>
                         </a:rPr>
-                        <a:t>40 개</a:t>
+                        <a:t>22 개</a:t>
                       </a:r>
                       <a:endParaRPr lang="en-US" sz="1200" dirty="0">
                         <a:latin typeface="맑은 고딕" charset="0"/>
@@ -9846,7 +9846,7 @@
                           <a:ea typeface="맑은 고딕" pitchFamily="34" charset="-122"/>
                           <a:cs typeface="맑은 고딕" pitchFamily="34" charset="-120"/>
                         </a:rPr>
-                        <a:t>Necklace</a:t>
+                        <a:t>Ring</a:t>
                       </a:r>
                       <a:endParaRPr lang="en-US" sz="1000" dirty="0">
                         <a:latin typeface="맑은 고딕" charset="0"/>
@@ -9911,7 +9911,7 @@
                           <a:ea typeface="맑은 고딕" pitchFamily="34" charset="-122"/>
                           <a:cs typeface="맑은 고딕" pitchFamily="34" charset="-120"/>
                         </a:rPr>
-                        <a:t>ThreadDuo Necklace</a:t>
+                        <a:t>"Reine" 925 Open Ring</a:t>
                       </a:r>
                       <a:endParaRPr lang="en-US" sz="1100" dirty="0">
                         <a:latin typeface="맑은 고딕" charset="0"/>
@@ -9976,7 +9976,7 @@
                           <a:ea typeface="맑은 고딕" pitchFamily="34" charset="-122"/>
                           <a:cs typeface="맑은 고딕" pitchFamily="34" charset="-120"/>
                         </a:rPr>
-                        <a:t>16 개</a:t>
+                        <a:t>14 개</a:t>
                       </a:r>
                       <a:endParaRPr lang="en-US" sz="1200" dirty="0">
                         <a:latin typeface="맑은 고딕" charset="0"/>
@@ -10062,7 +10062,7 @@
                 <a:ea typeface="맑은 고딕" pitchFamily="34" charset="-122"/>
                 <a:cs typeface="맑은 고딕" pitchFamily="34" charset="-120"/>
               </a:rPr>
-              <a:t>리오더 필요  🔴 긴급 15건</a:t>
+              <a:t>리오더 필요  🔴 긴급 16건</a:t>
             </a:r>
             <a:endParaRPr lang="en-US" sz="1500" dirty="0"/>
           </a:p>
@@ -10126,7 +10126,7 @@
                 <a:ea typeface="맑은 고딕" pitchFamily="34" charset="-122"/>
                 <a:cs typeface="맑은 고딕" pitchFamily="34" charset="-120"/>
               </a:rPr>
-              <a:t>🔴 긴급 15건  ·  상세는 시트 확인</a:t>
+              <a:t>🔴 긴급 16건  ·  상세는 시트 확인</a:t>
             </a:r>
             <a:endParaRPr lang="en-US" sz="1400" dirty="0"/>
           </a:p>
@@ -10165,7 +10165,7 @@
                 <a:ea typeface="맑은 고딕" pitchFamily="34" charset="-122"/>
                 <a:cs typeface="맑은 고딕" pitchFamily="34" charset="-120"/>
               </a:rPr>
-              <a:t>베스트 상품 리포트  ·  생성 2026-05-14 08:00</a:t>
+              <a:t>베스트 상품 리포트  ·  생성 2026-05-15 08:00</a:t>
             </a:r>
             <a:endParaRPr lang="en-US" sz="900" dirty="0"/>
           </a:p>
@@ -10378,7 +10378,7 @@
                 <a:ea typeface="맑은 고딕" pitchFamily="34" charset="-122"/>
                 <a:cs typeface="맑은 고딕" pitchFamily="34" charset="-120"/>
               </a:rPr>
-              <a:t>2026년 05월 14일 (목)</a:t>
+              <a:t>2026년 05월 15일 (금)</a:t>
             </a:r>
             <a:endParaRPr lang="en-US" sz="1200" dirty="0"/>
           </a:p>
@@ -10673,7 +10673,7 @@
                 <a:ea typeface="맑은 고딕" pitchFamily="34" charset="-122"/>
                 <a:cs typeface="맑은 고딕" pitchFamily="34" charset="-120"/>
               </a:rPr>
-              <a:t>19</a:t>
+              <a:t>21</a:t>
             </a:r>
             <a:endParaRPr lang="en-US" sz="3000" dirty="0"/>
           </a:p>
@@ -10929,7 +10929,7 @@
                 <a:ea typeface="맑은 고딕" pitchFamily="34" charset="-122"/>
                 <a:cs typeface="맑은 고딕" pitchFamily="34" charset="-120"/>
               </a:rPr>
-              <a:t>37,350</a:t>
+              <a:t>36,490</a:t>
             </a:r>
             <a:endParaRPr lang="en-US" sz="3000" dirty="0"/>
           </a:p>
@@ -11489,7 +11489,7 @@
                           <a:ea typeface="맑은 고딕" pitchFamily="34" charset="-122"/>
                           <a:cs typeface="맑은 고딕" pitchFamily="34" charset="-120"/>
                         </a:rPr>
-                        <a:t>2,408</a:t>
+                        <a:t>2,303</a:t>
                       </a:r>
                       <a:endParaRPr lang="en-US" sz="1000" dirty="0">
                         <a:latin typeface="맑은 고딕" charset="0"/>
@@ -11751,7 +11751,7 @@
                           <a:ea typeface="맑은 고딕" pitchFamily="34" charset="-122"/>
                           <a:cs typeface="맑은 고딕" pitchFamily="34" charset="-120"/>
                         </a:rPr>
-                        <a:t>2,166</a:t>
+                        <a:t>2,158</a:t>
                       </a:r>
                       <a:endParaRPr lang="en-US" sz="1000" dirty="0">
                         <a:latin typeface="맑은 고딕" charset="0"/>
@@ -12013,7 +12013,7 @@
                           <a:ea typeface="맑은 고딕" pitchFamily="34" charset="-122"/>
                           <a:cs typeface="맑은 고딕" pitchFamily="34" charset="-120"/>
                         </a:rPr>
-                        <a:t>2,042</a:t>
+                        <a:t>1,981</a:t>
                       </a:r>
                       <a:endParaRPr lang="en-US" sz="1000" dirty="0">
                         <a:latin typeface="맑은 고딕" charset="0"/>
@@ -12210,7 +12210,7 @@
                           <a:ea typeface="맑은 고딕" pitchFamily="34" charset="-122"/>
                           <a:cs typeface="맑은 고딕" pitchFamily="34" charset="-120"/>
                         </a:rPr>
-                        <a:t>컬러: 피치 / 기종 옵션: C type -&gt; C type</a:t>
+                        <a:t>컬러: 오렌지 / 기종 옵션: USB -&gt; Apple 8pin</a:t>
                       </a:r>
                       <a:endParaRPr lang="en-US" sz="900" dirty="0">
                         <a:latin typeface="맑은 고딕" charset="0"/>
@@ -12275,7 +12275,7 @@
                           <a:ea typeface="맑은 고딕" pitchFamily="34" charset="-122"/>
                           <a:cs typeface="맑은 고딕" pitchFamily="34" charset="-120"/>
                         </a:rPr>
-                        <a:t>1,746</a:t>
+                        <a:t>1,708</a:t>
                       </a:r>
                       <a:endParaRPr lang="en-US" sz="1000" dirty="0">
                         <a:latin typeface="맑은 고딕" charset="0"/>
@@ -12472,7 +12472,7 @@
                           <a:ea typeface="맑은 고딕" pitchFamily="34" charset="-122"/>
                           <a:cs typeface="맑은 고딕" pitchFamily="34" charset="-120"/>
                         </a:rPr>
-                        <a:t>컬러: 오렌지 / 기종 옵션: USB -&gt; Apple 8pin</a:t>
+                        <a:t>컬러: 피치 / 기종 옵션: C type -&gt; C type</a:t>
                       </a:r>
                       <a:endParaRPr lang="en-US" sz="900" dirty="0">
                         <a:latin typeface="맑은 고딕" charset="0"/>
@@ -12537,7 +12537,7 @@
                           <a:ea typeface="맑은 고딕" pitchFamily="34" charset="-122"/>
                           <a:cs typeface="맑은 고딕" pitchFamily="34" charset="-120"/>
                         </a:rPr>
-                        <a:t>1,714</a:t>
+                        <a:t>1,660</a:t>
                       </a:r>
                       <a:endParaRPr lang="en-US" sz="1000" dirty="0">
                         <a:latin typeface="맑은 고딕" charset="0"/>
@@ -12623,7 +12623,7 @@
                 <a:ea typeface="맑은 고딕" pitchFamily="34" charset="-122"/>
                 <a:cs typeface="맑은 고딕" pitchFamily="34" charset="-120"/>
               </a:rPr>
-              <a:t>재고 점검  🔴 품절 19건</a:t>
+              <a:t>재고 점검  🔴 품절 21건</a:t>
             </a:r>
             <a:pPr indent="0" marL="0">
               <a:buNone/>
@@ -13556,7 +13556,7 @@
                 <a:ea typeface="맑은 고딕" pitchFamily="34" charset="-122"/>
                 <a:cs typeface="맑은 고딕" pitchFamily="34" charset="-120"/>
               </a:rPr>
-              <a:t>베스트 상품 리포트  ·  생성 2026-05-14 08:00</a:t>
+              <a:t>베스트 상품 리포트  ·  생성 2026-05-15 08:00</a:t>
             </a:r>
             <a:endParaRPr lang="en-US" sz="900" dirty="0"/>
           </a:p>
@@ -13769,7 +13769,7 @@
                 <a:ea typeface="맑은 고딕" pitchFamily="34" charset="-122"/>
                 <a:cs typeface="맑은 고딕" pitchFamily="34" charset="-120"/>
               </a:rPr>
-              <a:t>2026년 05월 14일 (목)</a:t>
+              <a:t>2026년 05월 15일 (금)</a:t>
             </a:r>
             <a:endParaRPr lang="en-US" sz="1200" dirty="0"/>
           </a:p>
@@ -13897,7 +13897,7 @@
                 <a:ea typeface="맑은 고딕" pitchFamily="34" charset="-122"/>
                 <a:cs typeface="맑은 고딕" pitchFamily="34" charset="-120"/>
               </a:rPr>
-              <a:t>🚨  긴급 리오더 50건    ·    주의 리오더 8건    ·    오늘 발주 검토 필수</a:t>
+              <a:t>🚨  긴급 리오더 53건    ·    주의 리오더 8건    ·    오늘 발주 검토 필수</a:t>
             </a:r>
             <a:pPr indent="0" marL="0">
               <a:buNone/>
@@ -14663,7 +14663,7 @@
                           <a:ea typeface="맑은 고딕" pitchFamily="34" charset="-122"/>
                           <a:cs typeface="맑은 고딕" pitchFamily="34" charset="-120"/>
                         </a:rPr>
-                        <a:t>180° Fast Charging Cable (8color) (컬러: 퍼플 / 기종 옵션: USB -&gt; C type)</a:t>
+                        <a:t>180° Fast Charging Cable (8color) (컬러: 오렌지 / 기종 옵션: USB -&gt; C type)</a:t>
                       </a:r>
                       <a:endParaRPr lang="en-US" sz="1100" dirty="0">
                         <a:latin typeface="맑은 고딕" charset="0"/>
@@ -14799,7 +14799,7 @@
                           <a:ea typeface="맑은 고딕" pitchFamily="34" charset="-122"/>
                           <a:cs typeface="맑은 고딕" pitchFamily="34" charset="-120"/>
                         </a:rPr>
-                        <a:t>240 개</a:t>
+                        <a:t>105 개</a:t>
                       </a:r>
                       <a:endParaRPr lang="en-US" sz="1100" dirty="0">
                         <a:latin typeface="맑은 고딕" charset="0"/>
@@ -15073,7 +15073,7 @@
                           <a:ea typeface="맑은 고딕" pitchFamily="34" charset="-122"/>
                           <a:cs typeface="맑은 고딕" pitchFamily="34" charset="-120"/>
                         </a:rPr>
-                        <a:t>180° Fast Charging Cable (8color) (컬러: 오렌지 / 기종 옵션: C type -&gt; C type)</a:t>
+                        <a:t>180° Fast Charging Cable (8color) (컬러: 민트 / 기종 옵션: C type -&gt; C type)</a:t>
                       </a:r>
                       <a:endParaRPr lang="en-US" sz="1100" dirty="0">
                         <a:latin typeface="맑은 고딕" charset="0"/>
@@ -15209,7 +15209,7 @@
                           <a:ea typeface="맑은 고딕" pitchFamily="34" charset="-122"/>
                           <a:cs typeface="맑은 고딕" pitchFamily="34" charset="-120"/>
                         </a:rPr>
-                        <a:t>202 개</a:t>
+                        <a:t>42 개</a:t>
                       </a:r>
                       <a:endParaRPr lang="en-US" sz="1100" dirty="0">
                         <a:latin typeface="맑은 고딕" charset="0"/>
@@ -15483,7 +15483,7 @@
                           <a:ea typeface="맑은 고딕" pitchFamily="34" charset="-122"/>
                           <a:cs typeface="맑은 고딕" pitchFamily="34" charset="-120"/>
                         </a:rPr>
-                        <a:t>180° Fast Charging Cable (8color) (컬러: 피치 / 기종 옵션: USB -&gt; C type)</a:t>
+                        <a:t>Jacquard Fast Charging Cable (7color) (컬러: 퍼플 / 기종옵션: C-Apple 8pin / 길이: 2m)</a:t>
                       </a:r>
                       <a:endParaRPr lang="en-US" sz="1100" dirty="0">
                         <a:latin typeface="맑은 고딕" charset="0"/>
@@ -15551,7 +15551,7 @@
                           <a:ea typeface="맑은 고딕" pitchFamily="34" charset="-122"/>
                           <a:cs typeface="맑은 고딕" pitchFamily="34" charset="-120"/>
                         </a:rPr>
-                        <a:t>0</a:t>
+                        <a:t>17</a:t>
                       </a:r>
                       <a:endParaRPr lang="en-US" sz="1100" dirty="0">
                         <a:latin typeface="맑은 고딕" charset="0"/>
@@ -15619,7 +15619,7 @@
                           <a:ea typeface="맑은 고딕" pitchFamily="34" charset="-122"/>
                           <a:cs typeface="맑은 고딕" pitchFamily="34" charset="-120"/>
                         </a:rPr>
-                        <a:t>182 개</a:t>
+                        <a:t>3 개</a:t>
                       </a:r>
                       <a:endParaRPr lang="en-US" sz="1100" dirty="0">
                         <a:latin typeface="맑은 고딕" charset="0"/>
@@ -15757,7 +15757,7 @@
                           <a:ea typeface="맑은 고딕" pitchFamily="34" charset="-122"/>
                           <a:cs typeface="맑은 고딕" pitchFamily="34" charset="-120"/>
                         </a:rPr>
-                        <a:t>PR</a:t>
+                        <a:t>CT</a:t>
                       </a:r>
                       <a:endParaRPr lang="en-US" sz="1100" dirty="0">
                         <a:latin typeface="맑은 고딕" charset="0"/>
@@ -15825,7 +15825,7 @@
                           <a:ea typeface="맑은 고딕" pitchFamily="34" charset="-122"/>
                           <a:cs typeface="맑은 고딕" pitchFamily="34" charset="-120"/>
                         </a:rPr>
-                        <a:t>ETC</a:t>
+                        <a:t>Ring</a:t>
                       </a:r>
                       <a:endParaRPr lang="en-US" sz="1000" dirty="0">
                         <a:latin typeface="맑은 고딕" charset="0"/>
@@ -15893,7 +15893,7 @@
                           <a:ea typeface="맑은 고딕" pitchFamily="34" charset="-122"/>
                           <a:cs typeface="맑은 고딕" pitchFamily="34" charset="-120"/>
                         </a:rPr>
-                        <a:t>Ball hanger (6color) (컬러: 아이보리)</a:t>
+                        <a:t>"Whisow" 925 Open Ring</a:t>
                       </a:r>
                       <a:endParaRPr lang="en-US" sz="1100" dirty="0">
                         <a:latin typeface="맑은 고딕" charset="0"/>
@@ -15961,7 +15961,7 @@
                           <a:ea typeface="맑은 고딕" pitchFamily="34" charset="-122"/>
                           <a:cs typeface="맑은 고딕" pitchFamily="34" charset="-120"/>
                         </a:rPr>
-                        <a:t>10</a:t>
+                        <a:t>1</a:t>
                       </a:r>
                       <a:endParaRPr lang="en-US" sz="1100" dirty="0">
                         <a:latin typeface="맑은 고딕" charset="0"/>
@@ -16029,7 +16029,7 @@
                           <a:ea typeface="맑은 고딕" pitchFamily="34" charset="-122"/>
                           <a:cs typeface="맑은 고딕" pitchFamily="34" charset="-120"/>
                         </a:rPr>
-                        <a:t>139 개</a:t>
+                        <a:t>1 개</a:t>
                       </a:r>
                       <a:endParaRPr lang="en-US" sz="1100" dirty="0">
                         <a:latin typeface="맑은 고딕" charset="0"/>
@@ -16167,7 +16167,7 @@
                           <a:ea typeface="맑은 고딕" pitchFamily="34" charset="-122"/>
                           <a:cs typeface="맑은 고딕" pitchFamily="34" charset="-120"/>
                         </a:rPr>
-                        <a:t>PR</a:t>
+                        <a:t>6A</a:t>
                       </a:r>
                       <a:endParaRPr lang="en-US" sz="1100" dirty="0">
                         <a:latin typeface="맑은 고딕" charset="0"/>
@@ -16235,7 +16235,7 @@
                           <a:ea typeface="맑은 고딕" pitchFamily="34" charset="-122"/>
                           <a:cs typeface="맑은 고딕" pitchFamily="34" charset="-120"/>
                         </a:rPr>
-                        <a:t>ELECTRONIC</a:t>
+                        <a:t>★Season off★</a:t>
                       </a:r>
                       <a:endParaRPr lang="en-US" sz="1000" dirty="0">
                         <a:latin typeface="맑은 고딕" charset="0"/>
@@ -16303,7 +16303,7 @@
                           <a:ea typeface="맑은 고딕" pitchFamily="34" charset="-122"/>
                           <a:cs typeface="맑은 고딕" pitchFamily="34" charset="-120"/>
                         </a:rPr>
-                        <a:t>180° Fast Charging Cable (8color) (컬러: 블루 / 기종 옵션: C type -&gt; C type)</a:t>
+                        <a:t>8-Ball Smart Tok</a:t>
                       </a:r>
                       <a:endParaRPr lang="en-US" sz="1100" dirty="0">
                         <a:latin typeface="맑은 고딕" charset="0"/>
@@ -16371,7 +16371,7 @@
                           <a:ea typeface="맑은 고딕" pitchFamily="34" charset="-122"/>
                           <a:cs typeface="맑은 고딕" pitchFamily="34" charset="-120"/>
                         </a:rPr>
-                        <a:t>0</a:t>
+                        <a:t>5</a:t>
                       </a:r>
                       <a:endParaRPr lang="en-US" sz="1100" dirty="0">
                         <a:latin typeface="맑은 고딕" charset="0"/>
@@ -16439,7 +16439,7 @@
                           <a:ea typeface="맑은 고딕" pitchFamily="34" charset="-122"/>
                           <a:cs typeface="맑은 고딕" pitchFamily="34" charset="-120"/>
                         </a:rPr>
-                        <a:t>133 개</a:t>
+                        <a:t>0 개</a:t>
                       </a:r>
                       <a:endParaRPr lang="en-US" sz="1100" dirty="0">
                         <a:latin typeface="맑은 고딕" charset="0"/>
@@ -16577,7 +16577,7 @@
                           <a:ea typeface="맑은 고딕" pitchFamily="34" charset="-122"/>
                           <a:cs typeface="맑은 고딕" pitchFamily="34" charset="-120"/>
                         </a:rPr>
-                        <a:t>PR</a:t>
+                        <a:t>6A</a:t>
                       </a:r>
                       <a:endParaRPr lang="en-US" sz="1100" dirty="0">
                         <a:latin typeface="맑은 고딕" charset="0"/>
@@ -16645,7 +16645,7 @@
                           <a:ea typeface="맑은 고딕" pitchFamily="34" charset="-122"/>
                           <a:cs typeface="맑은 고딕" pitchFamily="34" charset="-120"/>
                         </a:rPr>
-                        <a:t>ELECTRONIC</a:t>
+                        <a:t>Necklace</a:t>
                       </a:r>
                       <a:endParaRPr lang="en-US" sz="1000" dirty="0">
                         <a:latin typeface="맑은 고딕" charset="0"/>
@@ -16713,7 +16713,7 @@
                           <a:ea typeface="맑은 고딕" pitchFamily="34" charset="-122"/>
                           <a:cs typeface="맑은 고딕" pitchFamily="34" charset="-120"/>
                         </a:rPr>
-                        <a:t>180° Fast Charging Cable (8color) (컬러: 옐로우 / 기종 옵션: USB -&gt; C type)</a:t>
+                        <a:t>B-Flower Necklace (Size: 2 Size)</a:t>
                       </a:r>
                       <a:endParaRPr lang="en-US" sz="1100" dirty="0">
                         <a:latin typeface="맑은 고딕" charset="0"/>
@@ -16781,7 +16781,7 @@
                           <a:ea typeface="맑은 고딕" pitchFamily="34" charset="-122"/>
                           <a:cs typeface="맑은 고딕" pitchFamily="34" charset="-120"/>
                         </a:rPr>
-                        <a:t>0</a:t>
+                        <a:t>4</a:t>
                       </a:r>
                       <a:endParaRPr lang="en-US" sz="1100" dirty="0">
                         <a:latin typeface="맑은 고딕" charset="0"/>
@@ -16849,7 +16849,7 @@
                           <a:ea typeface="맑은 고딕" pitchFamily="34" charset="-122"/>
                           <a:cs typeface="맑은 고딕" pitchFamily="34" charset="-120"/>
                         </a:rPr>
-                        <a:t>28 개</a:t>
+                        <a:t>0 개</a:t>
                       </a:r>
                       <a:endParaRPr lang="en-US" sz="1100" dirty="0">
                         <a:latin typeface="맑은 고딕" charset="0"/>
@@ -16987,7 +16987,7 @@
                           <a:ea typeface="맑은 고딕" pitchFamily="34" charset="-122"/>
                           <a:cs typeface="맑은 고딕" pitchFamily="34" charset="-120"/>
                         </a:rPr>
-                        <a:t>PR</a:t>
+                        <a:t>6A</a:t>
                       </a:r>
                       <a:endParaRPr lang="en-US" sz="1100" dirty="0">
                         <a:latin typeface="맑은 고딕" charset="0"/>
@@ -17055,7 +17055,7 @@
                           <a:ea typeface="맑은 고딕" pitchFamily="34" charset="-122"/>
                           <a:cs typeface="맑은 고딕" pitchFamily="34" charset="-120"/>
                         </a:rPr>
-                        <a:t>ELECTRONIC</a:t>
+                        <a:t>★Season off★</a:t>
                       </a:r>
                       <a:endParaRPr lang="en-US" sz="1000" dirty="0">
                         <a:latin typeface="맑은 고딕" charset="0"/>
@@ -17123,7 +17123,7 @@
                           <a:ea typeface="맑은 고딕" pitchFamily="34" charset="-122"/>
                           <a:cs typeface="맑은 고딕" pitchFamily="34" charset="-120"/>
                         </a:rPr>
-                        <a:t>Jacquard Fast Charging Cable (7color) (컬러: 퍼플 / 기종옵션: C-Apple 8pin / 길이: 2m)</a:t>
+                        <a:t>Tangle Keychain</a:t>
                       </a:r>
                       <a:endParaRPr lang="en-US" sz="1100" dirty="0">
                         <a:latin typeface="맑은 고딕" charset="0"/>
@@ -17191,7 +17191,7 @@
                           <a:ea typeface="맑은 고딕" pitchFamily="34" charset="-122"/>
                           <a:cs typeface="맑은 고딕" pitchFamily="34" charset="-120"/>
                         </a:rPr>
-                        <a:t>20</a:t>
+                        <a:t>4</a:t>
                       </a:r>
                       <a:endParaRPr lang="en-US" sz="1100" dirty="0">
                         <a:latin typeface="맑은 고딕" charset="0"/>
@@ -17259,7 +17259,7 @@
                           <a:ea typeface="맑은 고딕" pitchFamily="34" charset="-122"/>
                           <a:cs typeface="맑은 고딕" pitchFamily="34" charset="-120"/>
                         </a:rPr>
-                        <a:t>5 개</a:t>
+                        <a:t>0 개</a:t>
                       </a:r>
                       <a:endParaRPr lang="en-US" sz="1100" dirty="0">
                         <a:latin typeface="맑은 고딕" charset="0"/>
@@ -17465,7 +17465,7 @@
                           <a:ea typeface="맑은 고딕" pitchFamily="34" charset="-122"/>
                           <a:cs typeface="맑은 고딕" pitchFamily="34" charset="-120"/>
                         </a:rPr>
-                        <a:t>★Season off★</a:t>
+                        <a:t>Necklace</a:t>
                       </a:r>
                       <a:endParaRPr lang="en-US" sz="1000" dirty="0">
                         <a:latin typeface="맑은 고딕" charset="0"/>
@@ -17533,7 +17533,7 @@
                           <a:ea typeface="맑은 고딕" pitchFamily="34" charset="-122"/>
                           <a:cs typeface="맑은 고딕" pitchFamily="34" charset="-120"/>
                         </a:rPr>
-                        <a:t>Tangle Keychain</a:t>
+                        <a:t>B-Flower Necklace (Size: 1 Size)</a:t>
                       </a:r>
                       <a:endParaRPr lang="en-US" sz="1100" dirty="0">
                         <a:latin typeface="맑은 고딕" charset="0"/>
@@ -17601,7 +17601,7 @@
                           <a:ea typeface="맑은 고딕" pitchFamily="34" charset="-122"/>
                           <a:cs typeface="맑은 고딕" pitchFamily="34" charset="-120"/>
                         </a:rPr>
-                        <a:t>4</a:t>
+                        <a:t>0</a:t>
                       </a:r>
                       <a:endParaRPr lang="en-US" sz="1100" dirty="0">
                         <a:latin typeface="맑은 고딕" charset="0"/>
@@ -17669,7 +17669,7 @@
                           <a:ea typeface="맑은 고딕" pitchFamily="34" charset="-122"/>
                           <a:cs typeface="맑은 고딕" pitchFamily="34" charset="-120"/>
                         </a:rPr>
-                        <a:t>1 개</a:t>
+                        <a:t>0 개</a:t>
                       </a:r>
                       <a:endParaRPr lang="en-US" sz="1100" dirty="0">
                         <a:latin typeface="맑은 고딕" charset="0"/>
@@ -18079,7 +18079,7 @@
                           <a:ea typeface="맑은 고딕" pitchFamily="34" charset="-122"/>
                           <a:cs typeface="맑은 고딕" pitchFamily="34" charset="-120"/>
                         </a:rPr>
-                        <a:t>1 개</a:t>
+                        <a:t>0 개</a:t>
                       </a:r>
                       <a:endParaRPr lang="en-US" sz="1100" dirty="0">
                         <a:latin typeface="맑은 고딕" charset="0"/>
@@ -18168,7 +18168,7 @@
                 <a:ea typeface="맑은 고딕" pitchFamily="34" charset="-122"/>
                 <a:cs typeface="맑은 고딕" pitchFamily="34" charset="-120"/>
               </a:rPr>
-              <a:t>외 41건 더 있음 — 상세는 시트에서 확인</a:t>
+              <a:t>외 44건 더 있음 — 상세는 시트에서 확인</a:t>
             </a:r>
             <a:endParaRPr lang="en-US" sz="1000" dirty="0"/>
           </a:p>
@@ -18207,7 +18207,7 @@
                 <a:ea typeface="맑은 고딕" pitchFamily="34" charset="-122"/>
                 <a:cs typeface="맑은 고딕" pitchFamily="34" charset="-120"/>
               </a:rPr>
-              <a:t>베스트 상품 리포트  ·  생성 2026-05-14 08:00</a:t>
+              <a:t>베스트 상품 리포트  ·  생성 2026-05-15 08:00</a:t>
             </a:r>
             <a:endParaRPr lang="en-US" sz="900" dirty="0"/>
           </a:p>
@@ -18420,7 +18420,7 @@
                 <a:ea typeface="맑은 고딕" pitchFamily="34" charset="-122"/>
                 <a:cs typeface="맑은 고딕" pitchFamily="34" charset="-120"/>
               </a:rPr>
-              <a:t>2026년 05월 14일 (목)</a:t>
+              <a:t>2026년 05월 15일 (금)</a:t>
             </a:r>
             <a:endParaRPr lang="en-US" sz="1200" dirty="0"/>
           </a:p>
@@ -18587,7 +18587,7 @@
                 <a:ea typeface="맑은 고딕" pitchFamily="34" charset="-122"/>
                 <a:cs typeface="맑은 고딕" pitchFamily="34" charset="-120"/>
               </a:rPr>
-              <a:t>Google Sheet '브랜드 재고현황'  ·  최신화 2026-05-14 08:00</a:t>
+              <a:t>Google Sheet '브랜드 재고현황'  ·  최신화 2026-05-15 08:00</a:t>
             </a:r>
             <a:endParaRPr lang="en-US" sz="1100" dirty="0"/>
           </a:p>
@@ -19099,7 +19099,7 @@
                 <a:ea typeface="맑은 고딕" pitchFamily="34" charset="-122"/>
                 <a:cs typeface="맑은 고딕" pitchFamily="34" charset="-120"/>
               </a:rPr>
-              <a:t>✅ 6A 84 SKU  /  ✅ Cleartype 57 SKU  /  ✅ Produktepr 192 SKU (판매 수집됨)</a:t>
+              <a:t>✅ 6A 86 SKU  /  ✅ Cleartype 59 SKU  /  ✅ Produktepr 192 SKU (판매 수집됨)</a:t>
             </a:r>
             <a:endParaRPr lang="en-US" sz="1100" dirty="0"/>
           </a:p>
@@ -19230,7 +19230,7 @@
                 <a:ea typeface="맑은 고딕" pitchFamily="34" charset="-122"/>
                 <a:cs typeface="맑은 고딕" pitchFamily="34" charset="-120"/>
               </a:rPr>
-              <a:t>✅ 3개 브랜드 모두 정상 추출  ·  24h 출고 기준 (2026-05-13 08:00 → 2026-05-14 08:00) · 신규 SKU 12건은 결제완료 기준</a:t>
+              <a:t>✅ 3개 브랜드 모두 정상 추출  ·  24h 출고 기준 (2026-05-14 08:00 → 2026-05-15 08:00) · 신규 SKU 16건은 결제완료 기준</a:t>
             </a:r>
             <a:endParaRPr lang="en-US" sz="1000" dirty="0"/>
           </a:p>
@@ -19269,7 +19269,7 @@
                 <a:ea typeface="맑은 고딕" pitchFamily="34" charset="-122"/>
                 <a:cs typeface="맑은 고딕" pitchFamily="34" charset="-120"/>
               </a:rPr>
-              <a:t>베스트 상품 리포트  ·  생성 2026-05-14 08:00</a:t>
+              <a:t>베스트 상품 리포트  ·  생성 2026-05-15 08:00</a:t>
             </a:r>
             <a:endParaRPr lang="en-US" sz="900" dirty="0"/>
           </a:p>

</xml_diff>

<commit_message>
chore: 매출 PPT 업로드 (best-sellers-2026-05-16.pptx) [auto]
</commit_message>
<xml_diff>
--- a/data/sales-report.pptx
+++ b/data/sales-report.pptx
@@ -1648,7 +1648,7 @@
                 <a:ea typeface="맑은 고딕" pitchFamily="34" charset="-122"/>
                 <a:cs typeface="맑은 고딕" pitchFamily="34" charset="-120"/>
               </a:rPr>
-              <a:t>2026년 05월 15일 (금)  ·  24h 출고 기준</a:t>
+              <a:t>2026년 05월 16일 (토)  ·  24h 출고 기준</a:t>
             </a:r>
             <a:endParaRPr lang="en-US" sz="2200" dirty="0"/>
           </a:p>
@@ -1726,7 +1726,7 @@
                 <a:ea typeface="맑은 고딕" pitchFamily="34" charset="-122"/>
                 <a:cs typeface="맑은 고딕" pitchFamily="34" charset="-120"/>
               </a:rPr>
-              <a:t>05.15</a:t>
+              <a:t>05.16</a:t>
             </a:r>
             <a:endParaRPr lang="en-US" sz="7200" dirty="0"/>
           </a:p>
@@ -1765,7 +1765,7 @@
                 <a:ea typeface="맑은 고딕" pitchFamily="34" charset="-122"/>
                 <a:cs typeface="맑은 고딕" pitchFamily="34" charset="-120"/>
               </a:rPr>
-              <a:t>금요일</a:t>
+              <a:t>토요일</a:t>
             </a:r>
             <a:endParaRPr lang="en-US" sz="1400" dirty="0"/>
           </a:p>
@@ -1804,7 +1804,7 @@
                 <a:ea typeface="맑은 고딕" pitchFamily="34" charset="-122"/>
                 <a:cs typeface="맑은 고딕" pitchFamily="34" charset="-120"/>
               </a:rPr>
-              <a:t>생성 2026-05-15 08:00  ·  Google Sheet 자동 동기</a:t>
+              <a:t>생성 2026-05-16 08:00  ·  Google Sheet 자동 동기</a:t>
             </a:r>
             <a:endParaRPr lang="en-US" sz="1000" dirty="0"/>
           </a:p>
@@ -1978,7 +1978,7 @@
                 <a:ea typeface="맑은 고딕" pitchFamily="34" charset="-122"/>
                 <a:cs typeface="맑은 고딕" pitchFamily="34" charset="-120"/>
               </a:rPr>
-              <a:t>2026년 05월 15일 (금)</a:t>
+              <a:t>2026년 05월 16일 (토)</a:t>
             </a:r>
             <a:endParaRPr lang="en-US" sz="1200" dirty="0"/>
           </a:p>
@@ -2145,7 +2145,7 @@
                 <a:ea typeface="맑은 고딕" pitchFamily="34" charset="-122"/>
                 <a:cs typeface="맑은 고딕" pitchFamily="34" charset="-120"/>
               </a:rPr>
-              <a:t>343 개</a:t>
+              <a:t>346 개</a:t>
             </a:r>
             <a:endParaRPr lang="en-US" sz="3600" dirty="0"/>
           </a:p>
@@ -2312,7 +2312,7 @@
                 <a:ea typeface="맑은 고딕" pitchFamily="34" charset="-122"/>
                 <a:cs typeface="맑은 고딕" pitchFamily="34" charset="-120"/>
               </a:rPr>
-              <a:t>53 건</a:t>
+              <a:t>57 건</a:t>
             </a:r>
             <a:endParaRPr lang="en-US" sz="3200" dirty="0"/>
           </a:p>
@@ -3677,7 +3677,7 @@
                           <a:ea typeface="맑은 고딕" pitchFamily="34" charset="-122"/>
                           <a:cs typeface="맑은 고딕" pitchFamily="34" charset="-120"/>
                         </a:rPr>
-                        <a:t>44 개</a:t>
+                        <a:t>45 개</a:t>
                       </a:r>
                       <a:endParaRPr lang="en-US" sz="1400" dirty="0">
                         <a:latin typeface="맑은 고딕" charset="0"/>
@@ -3809,7 +3809,7 @@
                           <a:ea typeface="맑은 고딕" pitchFamily="34" charset="-122"/>
                           <a:cs typeface="맑은 고딕" pitchFamily="34" charset="-120"/>
                         </a:rPr>
-                        <a:t>6A</a:t>
+                        <a:t>CT</a:t>
                       </a:r>
                       <a:endParaRPr lang="en-US" sz="1100" dirty="0">
                         <a:latin typeface="맑은 고딕" charset="0"/>
@@ -3874,7 +3874,7 @@
                           <a:ea typeface="맑은 고딕" pitchFamily="34" charset="-122"/>
                           <a:cs typeface="맑은 고딕" pitchFamily="34" charset="-120"/>
                         </a:rPr>
-                        <a:t>Ring</a:t>
+                        <a:t>Necklace</a:t>
                       </a:r>
                       <a:endParaRPr lang="en-US" sz="1000" dirty="0">
                         <a:latin typeface="맑은 고딕" charset="0"/>
@@ -3939,7 +3939,7 @@
                           <a:ea typeface="맑은 고딕" pitchFamily="34" charset="-122"/>
                           <a:cs typeface="맑은 고딕" pitchFamily="34" charset="-120"/>
                         </a:rPr>
-                        <a:t>[SILVER925] Guyeong Open Ring v3.0 (silver)</a:t>
+                        <a:t>CandyPOP Necklace (사이즈: 2size (47~52cm))</a:t>
                       </a:r>
                       <a:endParaRPr lang="en-US" sz="1100" dirty="0">
                         <a:latin typeface="맑은 고딕" charset="0"/>
@@ -4004,7 +4004,7 @@
                           <a:ea typeface="맑은 고딕" pitchFamily="34" charset="-122"/>
                           <a:cs typeface="맑은 고딕" pitchFamily="34" charset="-120"/>
                         </a:rPr>
-                        <a:t>37 개</a:t>
+                        <a:t>40 개</a:t>
                       </a:r>
                       <a:endParaRPr lang="en-US" sz="1400" dirty="0">
                         <a:latin typeface="맑은 고딕" charset="0"/>
@@ -4136,7 +4136,7 @@
                           <a:ea typeface="맑은 고딕" pitchFamily="34" charset="-122"/>
                           <a:cs typeface="맑은 고딕" pitchFamily="34" charset="-120"/>
                         </a:rPr>
-                        <a:t>CT</a:t>
+                        <a:t>6A</a:t>
                       </a:r>
                       <a:endParaRPr lang="en-US" sz="1100" dirty="0">
                         <a:latin typeface="맑은 고딕" charset="0"/>
@@ -4201,7 +4201,7 @@
                           <a:ea typeface="맑은 고딕" pitchFamily="34" charset="-122"/>
                           <a:cs typeface="맑은 고딕" pitchFamily="34" charset="-120"/>
                         </a:rPr>
-                        <a:t>Necklace</a:t>
+                        <a:t>Ring</a:t>
                       </a:r>
                       <a:endParaRPr lang="en-US" sz="1000" dirty="0">
                         <a:latin typeface="맑은 고딕" charset="0"/>
@@ -4266,7 +4266,7 @@
                           <a:ea typeface="맑은 고딕" pitchFamily="34" charset="-122"/>
                           <a:cs typeface="맑은 고딕" pitchFamily="34" charset="-120"/>
                         </a:rPr>
-                        <a:t>CandyPOP Necklace (사이즈: 2size (47~52cm))</a:t>
+                        <a:t>[SILVER925] Guyeong Open Ring v3.0 (silver)</a:t>
                       </a:r>
                       <a:endParaRPr lang="en-US" sz="1100" dirty="0">
                         <a:latin typeface="맑은 고딕" charset="0"/>
@@ -4331,7 +4331,7 @@
                           <a:ea typeface="맑은 고딕" pitchFamily="34" charset="-122"/>
                           <a:cs typeface="맑은 고딕" pitchFamily="34" charset="-120"/>
                         </a:rPr>
-                        <a:t>22 개</a:t>
+                        <a:t>21 개</a:t>
                       </a:r>
                       <a:endParaRPr lang="en-US" sz="1400" dirty="0">
                         <a:latin typeface="맑은 고딕" charset="0"/>
@@ -4528,7 +4528,7 @@
                           <a:ea typeface="맑은 고딕" pitchFamily="34" charset="-122"/>
                           <a:cs typeface="맑은 고딕" pitchFamily="34" charset="-120"/>
                         </a:rPr>
-                        <a:t>Ring</a:t>
+                        <a:t>Necklace</a:t>
                       </a:r>
                       <a:endParaRPr lang="en-US" sz="1000" dirty="0">
                         <a:latin typeface="맑은 고딕" charset="0"/>
@@ -4593,7 +4593,7 @@
                           <a:ea typeface="맑은 고딕" pitchFamily="34" charset="-122"/>
                           <a:cs typeface="맑은 고딕" pitchFamily="34" charset="-120"/>
                         </a:rPr>
-                        <a:t>"Reine" 925 Open Ring</a:t>
+                        <a:t>ThreadDuo Necklace</a:t>
                       </a:r>
                       <a:endParaRPr lang="en-US" sz="1100" dirty="0">
                         <a:latin typeface="맑은 고딕" charset="0"/>
@@ -4658,7 +4658,7 @@
                           <a:ea typeface="맑은 고딕" pitchFamily="34" charset="-122"/>
                           <a:cs typeface="맑은 고딕" pitchFamily="34" charset="-120"/>
                         </a:rPr>
-                        <a:t>14 개</a:t>
+                        <a:t>18 개</a:t>
                       </a:r>
                       <a:endParaRPr lang="en-US" sz="1200" dirty="0">
                         <a:latin typeface="맑은 고딕" charset="0"/>
@@ -4790,7 +4790,7 @@
                           <a:ea typeface="맑은 고딕" pitchFamily="34" charset="-122"/>
                           <a:cs typeface="맑은 고딕" pitchFamily="34" charset="-120"/>
                         </a:rPr>
-                        <a:t>CT</a:t>
+                        <a:t>6A</a:t>
                       </a:r>
                       <a:endParaRPr lang="en-US" sz="1100" dirty="0">
                         <a:latin typeface="맑은 고딕" charset="0"/>
@@ -4920,7 +4920,7 @@
                           <a:ea typeface="맑은 고딕" pitchFamily="34" charset="-122"/>
                           <a:cs typeface="맑은 고딕" pitchFamily="34" charset="-120"/>
                         </a:rPr>
-                        <a:t>ThreadDuo Necklace</a:t>
+                        <a:t>RichardKokser Necklace</a:t>
                       </a:r>
                       <a:endParaRPr lang="en-US" sz="1100" dirty="0">
                         <a:latin typeface="맑은 고딕" charset="0"/>
@@ -4985,7 +4985,7 @@
                           <a:ea typeface="맑은 고딕" pitchFamily="34" charset="-122"/>
                           <a:cs typeface="맑은 고딕" pitchFamily="34" charset="-120"/>
                         </a:rPr>
-                        <a:t>13 개</a:t>
+                        <a:t>11 개</a:t>
                       </a:r>
                       <a:endParaRPr lang="en-US" sz="1200" dirty="0">
                         <a:latin typeface="맑은 고딕" charset="0"/>
@@ -5071,7 +5071,7 @@
                 <a:ea typeface="맑은 고딕" pitchFamily="34" charset="-122"/>
                 <a:cs typeface="맑은 고딕" pitchFamily="34" charset="-120"/>
               </a:rPr>
-              <a:t>베스트 상품 리포트  ·  생성 2026-05-15 08:00</a:t>
+              <a:t>베스트 상품 리포트  ·  생성 2026-05-16 08:00</a:t>
             </a:r>
             <a:endParaRPr lang="en-US" sz="900" dirty="0"/>
           </a:p>
@@ -5284,7 +5284,7 @@
                 <a:ea typeface="맑은 고딕" pitchFamily="34" charset="-122"/>
                 <a:cs typeface="맑은 고딕" pitchFamily="34" charset="-120"/>
               </a:rPr>
-              <a:t>2026년 05월 15일 (금)</a:t>
+              <a:t>2026년 05월 16일 (토)</a:t>
             </a:r>
             <a:endParaRPr lang="en-US" sz="1200" dirty="0"/>
           </a:p>
@@ -5451,7 +5451,7 @@
                 <a:ea typeface="맑은 고딕" pitchFamily="34" charset="-122"/>
                 <a:cs typeface="맑은 고딕" pitchFamily="34" charset="-120"/>
               </a:rPr>
-              <a:t>206 개</a:t>
+              <a:t>202 개</a:t>
             </a:r>
             <a:endParaRPr lang="en-US" sz="3600" dirty="0"/>
           </a:p>
@@ -5657,7 +5657,7 @@
                 <a:ea typeface="맑은 고딕" pitchFamily="34" charset="-122"/>
                 <a:cs typeface="맑은 고딕" pitchFamily="34" charset="-120"/>
               </a:rPr>
-              <a:t>37</a:t>
+              <a:t>21</a:t>
             </a:r>
             <a:endParaRPr lang="en-US" sz="4400" dirty="0"/>
           </a:p>
@@ -6256,7 +6256,7 @@
                           <a:ea typeface="맑은 고딕" pitchFamily="34" charset="-122"/>
                           <a:cs typeface="맑은 고딕" pitchFamily="34" charset="-120"/>
                         </a:rPr>
-                        <a:t>37 개</a:t>
+                        <a:t>21 개</a:t>
                       </a:r>
                       <a:endParaRPr lang="en-US" sz="1400" dirty="0">
                         <a:latin typeface="맑은 고딕" charset="0"/>
@@ -6650,7 +6650,7 @@
                           <a:ea typeface="맑은 고딕" pitchFamily="34" charset="-122"/>
                           <a:cs typeface="맑은 고딕" pitchFamily="34" charset="-120"/>
                         </a:rPr>
-                        <a:t>Necklace</a:t>
+                        <a:t>Ring</a:t>
                       </a:r>
                       <a:endParaRPr lang="en-US" sz="1000" dirty="0">
                         <a:latin typeface="맑은 고딕" charset="0"/>
@@ -6715,7 +6715,7 @@
                           <a:ea typeface="맑은 고딕" pitchFamily="34" charset="-122"/>
                           <a:cs typeface="맑은 고딕" pitchFamily="34" charset="-120"/>
                         </a:rPr>
-                        <a:t>YOKNIS 9921 Necklace</a:t>
+                        <a:t>[SILVER925] Eramam Open Ring</a:t>
                       </a:r>
                       <a:endParaRPr lang="en-US" sz="1100" dirty="0">
                         <a:latin typeface="맑은 고딕" charset="0"/>
@@ -6912,7 +6912,7 @@
                           <a:ea typeface="맑은 고딕" pitchFamily="34" charset="-122"/>
                           <a:cs typeface="맑은 고딕" pitchFamily="34" charset="-120"/>
                         </a:rPr>
-                        <a:t>Ring</a:t>
+                        <a:t>Necklace</a:t>
                       </a:r>
                       <a:endParaRPr lang="en-US" sz="1000" dirty="0">
                         <a:latin typeface="맑은 고딕" charset="0"/>
@@ -6977,7 +6977,7 @@
                           <a:ea typeface="맑은 고딕" pitchFamily="34" charset="-122"/>
                           <a:cs typeface="맑은 고딕" pitchFamily="34" charset="-120"/>
                         </a:rPr>
-                        <a:t>[SILVER925] A Rua Open Ring</a:t>
+                        <a:t>Tiny Cross Necklace</a:t>
                       </a:r>
                       <a:endParaRPr lang="en-US" sz="1100" dirty="0">
                         <a:latin typeface="맑은 고딕" charset="0"/>
@@ -7042,7 +7042,7 @@
                           <a:ea typeface="맑은 고딕" pitchFamily="34" charset="-122"/>
                           <a:cs typeface="맑은 고딕" pitchFamily="34" charset="-120"/>
                         </a:rPr>
-                        <a:t>10 개</a:t>
+                        <a:t>9 개</a:t>
                       </a:r>
                       <a:endParaRPr lang="en-US" sz="1200" dirty="0">
                         <a:latin typeface="맑은 고딕" charset="0"/>
@@ -7557,6 +7557,418 @@
                 <a:ea typeface="맑은 고딕" pitchFamily="34" charset="-122"/>
                 <a:cs typeface="맑은 고딕" pitchFamily="34" charset="-120"/>
               </a:rPr>
+              <a:t>Marquise Necklace</a:t>
+            </a:r>
+            <a:endParaRPr lang="en-US" sz="1100" dirty="0"/>
+          </a:p>
+        </p:txBody>
+      </p:sp>
+      <p:sp>
+        <p:nvSpPr>
+          <p:cNvPr id="26" name="Text 23"/>
+          <p:cNvSpPr/>
+          <p:nvPr/>
+        </p:nvSpPr>
+        <p:spPr>
+          <a:xfrm>
+            <a:off x="8211312" y="3712464"/>
+            <a:ext cx="3291840" cy="256032"/>
+          </a:xfrm>
+          <a:prstGeom prst="rect">
+            <a:avLst/>
+          </a:prstGeom>
+          <a:noFill/>
+          <a:ln/>
+        </p:spPr>
+        <p:txBody>
+          <a:bodyPr wrap="square" lIns="0" tIns="0" rIns="0" bIns="0" rtlCol="0" anchor="ctr"/>
+          <a:lstStyle/>
+          <a:p>
+            <a:pPr indent="0" marL="0">
+              <a:buNone/>
+            </a:pPr>
+            <a:r>
+              <a:rPr lang="en-US" sz="1000" dirty="0">
+                <a:solidFill>
+                  <a:srgbClr val="6B7280"/>
+                </a:solidFill>
+                <a:latin typeface="맑은 고딕" pitchFamily="34" charset="0"/>
+                <a:ea typeface="맑은 고딕" pitchFamily="34" charset="-122"/>
+                <a:cs typeface="맑은 고딕" pitchFamily="34" charset="-120"/>
+              </a:rPr>
+              <a:t>Necklace  ·  재고 0개</a:t>
+            </a:r>
+            <a:pPr indent="0" marL="0">
+              <a:buNone/>
+            </a:pPr>
+            <a:r>
+              <a:rPr lang="en-US" sz="1000" b="1" dirty="0">
+                <a:solidFill>
+                  <a:srgbClr val="D72638"/>
+                </a:solidFill>
+                <a:latin typeface="맑은 고딕" pitchFamily="34" charset="0"/>
+                <a:ea typeface="맑은 고딕" pitchFamily="34" charset="-122"/>
+                <a:cs typeface="맑은 고딕" pitchFamily="34" charset="-120"/>
+              </a:rPr>
+              <a:t/>
+            </a:r>
+            <a:endParaRPr lang="en-US" sz="1000" dirty="0"/>
+          </a:p>
+        </p:txBody>
+      </p:sp>
+      <p:sp>
+        <p:nvSpPr>
+          <p:cNvPr id="27" name="Shape 24"/>
+          <p:cNvSpPr/>
+          <p:nvPr/>
+        </p:nvSpPr>
+        <p:spPr>
+          <a:xfrm>
+            <a:off x="7406640" y="4096512"/>
+            <a:ext cx="4206240" cy="640080"/>
+          </a:xfrm>
+          <a:prstGeom prst="rect">
+            <a:avLst/>
+          </a:prstGeom>
+          <a:solidFill>
+            <a:srgbClr val="FFF5F5"/>
+          </a:solidFill>
+          <a:ln w="6350">
+            <a:solidFill>
+              <a:srgbClr val="E5E7EB"/>
+            </a:solidFill>
+            <a:prstDash val="solid"/>
+          </a:ln>
+        </p:spPr>
+      </p:sp>
+      <p:sp>
+        <p:nvSpPr>
+          <p:cNvPr id="28" name="Shape 25"/>
+          <p:cNvSpPr/>
+          <p:nvPr/>
+        </p:nvSpPr>
+        <p:spPr>
+          <a:xfrm>
+            <a:off x="7406640" y="4096512"/>
+            <a:ext cx="109728" cy="640080"/>
+          </a:xfrm>
+          <a:prstGeom prst="rect">
+            <a:avLst/>
+          </a:prstGeom>
+          <a:solidFill>
+            <a:srgbClr val="D72638"/>
+          </a:solidFill>
+          <a:ln w="12700">
+            <a:solidFill>
+              <a:srgbClr val="D72638"/>
+            </a:solidFill>
+            <a:prstDash val="solid"/>
+          </a:ln>
+        </p:spPr>
+      </p:sp>
+      <p:sp>
+        <p:nvSpPr>
+          <p:cNvPr id="29" name="Shape 26"/>
+          <p:cNvSpPr/>
+          <p:nvPr/>
+        </p:nvSpPr>
+        <p:spPr>
+          <a:xfrm>
+            <a:off x="7571232" y="4187952"/>
+            <a:ext cx="548640" cy="256032"/>
+          </a:xfrm>
+          <a:prstGeom prst="rect">
+            <a:avLst/>
+          </a:prstGeom>
+          <a:solidFill>
+            <a:srgbClr val="D72638"/>
+          </a:solidFill>
+          <a:ln w="12700">
+            <a:solidFill>
+              <a:srgbClr val="D72638"/>
+            </a:solidFill>
+            <a:prstDash val="solid"/>
+          </a:ln>
+        </p:spPr>
+      </p:sp>
+      <p:sp>
+        <p:nvSpPr>
+          <p:cNvPr id="30" name="Text 27"/>
+          <p:cNvSpPr/>
+          <p:nvPr/>
+        </p:nvSpPr>
+        <p:spPr>
+          <a:xfrm>
+            <a:off x="7571232" y="4187952"/>
+            <a:ext cx="548640" cy="256032"/>
+          </a:xfrm>
+          <a:prstGeom prst="rect">
+            <a:avLst/>
+          </a:prstGeom>
+          <a:noFill/>
+          <a:ln/>
+        </p:spPr>
+        <p:txBody>
+          <a:bodyPr wrap="square" lIns="0" tIns="0" rIns="0" bIns="0" rtlCol="0" anchor="ctr"/>
+          <a:lstStyle/>
+          <a:p>
+            <a:pPr algn="ctr" indent="0" marL="0">
+              <a:buNone/>
+            </a:pPr>
+            <a:r>
+              <a:rPr lang="en-US" sz="900" b="1" dirty="0">
+                <a:solidFill>
+                  <a:srgbClr val="FFFFFF"/>
+                </a:solidFill>
+                <a:latin typeface="맑은 고딕" pitchFamily="34" charset="0"/>
+                <a:ea typeface="맑은 고딕" pitchFamily="34" charset="-122"/>
+                <a:cs typeface="맑은 고딕" pitchFamily="34" charset="-120"/>
+              </a:rPr>
+              <a:t>긴급</a:t>
+            </a:r>
+            <a:endParaRPr lang="en-US" sz="900" dirty="0"/>
+          </a:p>
+        </p:txBody>
+      </p:sp>
+      <p:sp>
+        <p:nvSpPr>
+          <p:cNvPr id="31" name="Text 28"/>
+          <p:cNvSpPr/>
+          <p:nvPr/>
+        </p:nvSpPr>
+        <p:spPr>
+          <a:xfrm>
+            <a:off x="8211312" y="4151376"/>
+            <a:ext cx="3291840" cy="274320"/>
+          </a:xfrm>
+          <a:prstGeom prst="rect">
+            <a:avLst/>
+          </a:prstGeom>
+          <a:noFill/>
+          <a:ln/>
+        </p:spPr>
+        <p:txBody>
+          <a:bodyPr wrap="square" lIns="0" tIns="0" rIns="0" bIns="0" rtlCol="0" anchor="ctr"/>
+          <a:lstStyle/>
+          <a:p>
+            <a:pPr indent="0" marL="0">
+              <a:buNone/>
+            </a:pPr>
+            <a:r>
+              <a:rPr lang="en-US" sz="1100" b="1" dirty="0">
+                <a:solidFill>
+                  <a:srgbClr val="0B1220"/>
+                </a:solidFill>
+                <a:latin typeface="맑은 고딕" pitchFamily="34" charset="0"/>
+                <a:ea typeface="맑은 고딕" pitchFamily="34" charset="-122"/>
+                <a:cs typeface="맑은 고딕" pitchFamily="34" charset="-120"/>
+              </a:rPr>
+              <a:t>Tangle Keychain</a:t>
+            </a:r>
+            <a:endParaRPr lang="en-US" sz="1100" dirty="0"/>
+          </a:p>
+        </p:txBody>
+      </p:sp>
+      <p:sp>
+        <p:nvSpPr>
+          <p:cNvPr id="32" name="Text 29"/>
+          <p:cNvSpPr/>
+          <p:nvPr/>
+        </p:nvSpPr>
+        <p:spPr>
+          <a:xfrm>
+            <a:off x="8211312" y="4425696"/>
+            <a:ext cx="3291840" cy="256032"/>
+          </a:xfrm>
+          <a:prstGeom prst="rect">
+            <a:avLst/>
+          </a:prstGeom>
+          <a:noFill/>
+          <a:ln/>
+        </p:spPr>
+        <p:txBody>
+          <a:bodyPr wrap="square" lIns="0" tIns="0" rIns="0" bIns="0" rtlCol="0" anchor="ctr"/>
+          <a:lstStyle/>
+          <a:p>
+            <a:pPr indent="0" marL="0">
+              <a:buNone/>
+            </a:pPr>
+            <a:r>
+              <a:rPr lang="en-US" sz="1000" dirty="0">
+                <a:solidFill>
+                  <a:srgbClr val="6B7280"/>
+                </a:solidFill>
+                <a:latin typeface="맑은 고딕" pitchFamily="34" charset="0"/>
+                <a:ea typeface="맑은 고딕" pitchFamily="34" charset="-122"/>
+                <a:cs typeface="맑은 고딕" pitchFamily="34" charset="-120"/>
+              </a:rPr>
+              <a:t>★Season off★  ·  재고 3개</a:t>
+            </a:r>
+            <a:pPr indent="0" marL="0">
+              <a:buNone/>
+            </a:pPr>
+            <a:r>
+              <a:rPr lang="en-US" sz="1000" b="1" dirty="0">
+                <a:solidFill>
+                  <a:srgbClr val="D72638"/>
+                </a:solidFill>
+                <a:latin typeface="맑은 고딕" pitchFamily="34" charset="0"/>
+                <a:ea typeface="맑은 고딕" pitchFamily="34" charset="-122"/>
+                <a:cs typeface="맑은 고딕" pitchFamily="34" charset="-120"/>
+              </a:rPr>
+              <a:t/>
+            </a:r>
+            <a:endParaRPr lang="en-US" sz="1000" dirty="0"/>
+          </a:p>
+        </p:txBody>
+      </p:sp>
+      <p:sp>
+        <p:nvSpPr>
+          <p:cNvPr id="33" name="Shape 30"/>
+          <p:cNvSpPr/>
+          <p:nvPr/>
+        </p:nvSpPr>
+        <p:spPr>
+          <a:xfrm>
+            <a:off x="7406640" y="4809744"/>
+            <a:ext cx="4206240" cy="640080"/>
+          </a:xfrm>
+          <a:prstGeom prst="rect">
+            <a:avLst/>
+          </a:prstGeom>
+          <a:solidFill>
+            <a:srgbClr val="FFF5F5"/>
+          </a:solidFill>
+          <a:ln w="6350">
+            <a:solidFill>
+              <a:srgbClr val="E5E7EB"/>
+            </a:solidFill>
+            <a:prstDash val="solid"/>
+          </a:ln>
+        </p:spPr>
+      </p:sp>
+      <p:sp>
+        <p:nvSpPr>
+          <p:cNvPr id="34" name="Shape 31"/>
+          <p:cNvSpPr/>
+          <p:nvPr/>
+        </p:nvSpPr>
+        <p:spPr>
+          <a:xfrm>
+            <a:off x="7406640" y="4809744"/>
+            <a:ext cx="109728" cy="640080"/>
+          </a:xfrm>
+          <a:prstGeom prst="rect">
+            <a:avLst/>
+          </a:prstGeom>
+          <a:solidFill>
+            <a:srgbClr val="D72638"/>
+          </a:solidFill>
+          <a:ln w="12700">
+            <a:solidFill>
+              <a:srgbClr val="D72638"/>
+            </a:solidFill>
+            <a:prstDash val="solid"/>
+          </a:ln>
+        </p:spPr>
+      </p:sp>
+      <p:sp>
+        <p:nvSpPr>
+          <p:cNvPr id="35" name="Shape 32"/>
+          <p:cNvSpPr/>
+          <p:nvPr/>
+        </p:nvSpPr>
+        <p:spPr>
+          <a:xfrm>
+            <a:off x="7571232" y="4901184"/>
+            <a:ext cx="548640" cy="256032"/>
+          </a:xfrm>
+          <a:prstGeom prst="rect">
+            <a:avLst/>
+          </a:prstGeom>
+          <a:solidFill>
+            <a:srgbClr val="D72638"/>
+          </a:solidFill>
+          <a:ln w="12700">
+            <a:solidFill>
+              <a:srgbClr val="D72638"/>
+            </a:solidFill>
+            <a:prstDash val="solid"/>
+          </a:ln>
+        </p:spPr>
+      </p:sp>
+      <p:sp>
+        <p:nvSpPr>
+          <p:cNvPr id="36" name="Text 33"/>
+          <p:cNvSpPr/>
+          <p:nvPr/>
+        </p:nvSpPr>
+        <p:spPr>
+          <a:xfrm>
+            <a:off x="7571232" y="4901184"/>
+            <a:ext cx="548640" cy="256032"/>
+          </a:xfrm>
+          <a:prstGeom prst="rect">
+            <a:avLst/>
+          </a:prstGeom>
+          <a:noFill/>
+          <a:ln/>
+        </p:spPr>
+        <p:txBody>
+          <a:bodyPr wrap="square" lIns="0" tIns="0" rIns="0" bIns="0" rtlCol="0" anchor="ctr"/>
+          <a:lstStyle/>
+          <a:p>
+            <a:pPr algn="ctr" indent="0" marL="0">
+              <a:buNone/>
+            </a:pPr>
+            <a:r>
+              <a:rPr lang="en-US" sz="900" b="1" dirty="0">
+                <a:solidFill>
+                  <a:srgbClr val="FFFFFF"/>
+                </a:solidFill>
+                <a:latin typeface="맑은 고딕" pitchFamily="34" charset="0"/>
+                <a:ea typeface="맑은 고딕" pitchFamily="34" charset="-122"/>
+                <a:cs typeface="맑은 고딕" pitchFamily="34" charset="-120"/>
+              </a:rPr>
+              <a:t>긴급</a:t>
+            </a:r>
+            <a:endParaRPr lang="en-US" sz="900" dirty="0"/>
+          </a:p>
+        </p:txBody>
+      </p:sp>
+      <p:sp>
+        <p:nvSpPr>
+          <p:cNvPr id="37" name="Text 34"/>
+          <p:cNvSpPr/>
+          <p:nvPr/>
+        </p:nvSpPr>
+        <p:spPr>
+          <a:xfrm>
+            <a:off x="8211312" y="4864608"/>
+            <a:ext cx="3291840" cy="274320"/>
+          </a:xfrm>
+          <a:prstGeom prst="rect">
+            <a:avLst/>
+          </a:prstGeom>
+          <a:noFill/>
+          <a:ln/>
+        </p:spPr>
+        <p:txBody>
+          <a:bodyPr wrap="square" lIns="0" tIns="0" rIns="0" bIns="0" rtlCol="0" anchor="ctr"/>
+          <a:lstStyle/>
+          <a:p>
+            <a:pPr indent="0" marL="0">
+              <a:buNone/>
+            </a:pPr>
+            <a:r>
+              <a:rPr lang="en-US" sz="1100" b="1" dirty="0">
+                <a:solidFill>
+                  <a:srgbClr val="0B1220"/>
+                </a:solidFill>
+                <a:latin typeface="맑은 고딕" pitchFamily="34" charset="0"/>
+                <a:ea typeface="맑은 고딕" pitchFamily="34" charset="-122"/>
+                <a:cs typeface="맑은 고딕" pitchFamily="34" charset="-120"/>
+              </a:rPr>
               <a:t>8-Ball Smart Tok</a:t>
             </a:r>
             <a:endParaRPr lang="en-US" sz="1100" dirty="0"/>
@@ -7565,13 +7977,13 @@
       </p:sp>
       <p:sp>
         <p:nvSpPr>
-          <p:cNvPr id="26" name="Text 23"/>
-          <p:cNvSpPr/>
-          <p:nvPr/>
-        </p:nvSpPr>
-        <p:spPr>
-          <a:xfrm>
-            <a:off x="8211312" y="3712464"/>
+          <p:cNvPr id="38" name="Text 35"/>
+          <p:cNvSpPr/>
+          <p:nvPr/>
+        </p:nvSpPr>
+        <p:spPr>
+          <a:xfrm>
+            <a:off x="8211312" y="5138928"/>
             <a:ext cx="3291840" cy="256032"/>
           </a:xfrm>
           <a:prstGeom prst="rect">
@@ -7618,13 +8030,13 @@
       </p:sp>
       <p:sp>
         <p:nvSpPr>
-          <p:cNvPr id="27" name="Shape 24"/>
-          <p:cNvSpPr/>
-          <p:nvPr/>
-        </p:nvSpPr>
-        <p:spPr>
-          <a:xfrm>
-            <a:off x="7406640" y="4096512"/>
+          <p:cNvPr id="39" name="Shape 36"/>
+          <p:cNvSpPr/>
+          <p:nvPr/>
+        </p:nvSpPr>
+        <p:spPr>
+          <a:xfrm>
+            <a:off x="7406640" y="5522976"/>
             <a:ext cx="4206240" cy="640080"/>
           </a:xfrm>
           <a:prstGeom prst="rect">
@@ -7643,13 +8055,13 @@
       </p:sp>
       <p:sp>
         <p:nvSpPr>
-          <p:cNvPr id="28" name="Shape 25"/>
-          <p:cNvSpPr/>
-          <p:nvPr/>
-        </p:nvSpPr>
-        <p:spPr>
-          <a:xfrm>
-            <a:off x="7406640" y="4096512"/>
+          <p:cNvPr id="40" name="Shape 37"/>
+          <p:cNvSpPr/>
+          <p:nvPr/>
+        </p:nvSpPr>
+        <p:spPr>
+          <a:xfrm>
+            <a:off x="7406640" y="5522976"/>
             <a:ext cx="109728" cy="640080"/>
           </a:xfrm>
           <a:prstGeom prst="rect">
@@ -7668,13 +8080,13 @@
       </p:sp>
       <p:sp>
         <p:nvSpPr>
-          <p:cNvPr id="29" name="Shape 26"/>
-          <p:cNvSpPr/>
-          <p:nvPr/>
-        </p:nvSpPr>
-        <p:spPr>
-          <a:xfrm>
-            <a:off x="7571232" y="4187952"/>
+          <p:cNvPr id="41" name="Shape 38"/>
+          <p:cNvSpPr/>
+          <p:nvPr/>
+        </p:nvSpPr>
+        <p:spPr>
+          <a:xfrm>
+            <a:off x="7571232" y="5614416"/>
             <a:ext cx="548640" cy="256032"/>
           </a:xfrm>
           <a:prstGeom prst="rect">
@@ -7693,13 +8105,13 @@
       </p:sp>
       <p:sp>
         <p:nvSpPr>
-          <p:cNvPr id="30" name="Text 27"/>
-          <p:cNvSpPr/>
-          <p:nvPr/>
-        </p:nvSpPr>
-        <p:spPr>
-          <a:xfrm>
-            <a:off x="7571232" y="4187952"/>
+          <p:cNvPr id="42" name="Text 39"/>
+          <p:cNvSpPr/>
+          <p:nvPr/>
+        </p:nvSpPr>
+        <p:spPr>
+          <a:xfrm>
+            <a:off x="7571232" y="5614416"/>
             <a:ext cx="548640" cy="256032"/>
           </a:xfrm>
           <a:prstGeom prst="rect">
@@ -7732,13 +8144,13 @@
       </p:sp>
       <p:sp>
         <p:nvSpPr>
-          <p:cNvPr id="31" name="Text 28"/>
-          <p:cNvSpPr/>
-          <p:nvPr/>
-        </p:nvSpPr>
-        <p:spPr>
-          <a:xfrm>
-            <a:off x="8211312" y="4151376"/>
+          <p:cNvPr id="43" name="Text 40"/>
+          <p:cNvSpPr/>
+          <p:nvPr/>
+        </p:nvSpPr>
+        <p:spPr>
+          <a:xfrm>
+            <a:off x="8211312" y="5577840"/>
             <a:ext cx="3291840" cy="274320"/>
           </a:xfrm>
           <a:prstGeom prst="rect">
@@ -7771,13 +8183,13 @@
       </p:sp>
       <p:sp>
         <p:nvSpPr>
-          <p:cNvPr id="32" name="Text 29"/>
-          <p:cNvSpPr/>
-          <p:nvPr/>
-        </p:nvSpPr>
-        <p:spPr>
-          <a:xfrm>
-            <a:off x="8211312" y="4425696"/>
+          <p:cNvPr id="44" name="Text 41"/>
+          <p:cNvSpPr/>
+          <p:nvPr/>
+        </p:nvSpPr>
+        <p:spPr>
+          <a:xfrm>
+            <a:off x="8211312" y="5852160"/>
             <a:ext cx="3291840" cy="256032"/>
           </a:xfrm>
           <a:prstGeom prst="rect">
@@ -7824,418 +8236,6 @@
       </p:sp>
       <p:sp>
         <p:nvSpPr>
-          <p:cNvPr id="33" name="Shape 30"/>
-          <p:cNvSpPr/>
-          <p:nvPr/>
-        </p:nvSpPr>
-        <p:spPr>
-          <a:xfrm>
-            <a:off x="7406640" y="4809744"/>
-            <a:ext cx="4206240" cy="640080"/>
-          </a:xfrm>
-          <a:prstGeom prst="rect">
-            <a:avLst/>
-          </a:prstGeom>
-          <a:solidFill>
-            <a:srgbClr val="FFF5F5"/>
-          </a:solidFill>
-          <a:ln w="6350">
-            <a:solidFill>
-              <a:srgbClr val="E5E7EB"/>
-            </a:solidFill>
-            <a:prstDash val="solid"/>
-          </a:ln>
-        </p:spPr>
-      </p:sp>
-      <p:sp>
-        <p:nvSpPr>
-          <p:cNvPr id="34" name="Shape 31"/>
-          <p:cNvSpPr/>
-          <p:nvPr/>
-        </p:nvSpPr>
-        <p:spPr>
-          <a:xfrm>
-            <a:off x="7406640" y="4809744"/>
-            <a:ext cx="109728" cy="640080"/>
-          </a:xfrm>
-          <a:prstGeom prst="rect">
-            <a:avLst/>
-          </a:prstGeom>
-          <a:solidFill>
-            <a:srgbClr val="D72638"/>
-          </a:solidFill>
-          <a:ln w="12700">
-            <a:solidFill>
-              <a:srgbClr val="D72638"/>
-            </a:solidFill>
-            <a:prstDash val="solid"/>
-          </a:ln>
-        </p:spPr>
-      </p:sp>
-      <p:sp>
-        <p:nvSpPr>
-          <p:cNvPr id="35" name="Shape 32"/>
-          <p:cNvSpPr/>
-          <p:nvPr/>
-        </p:nvSpPr>
-        <p:spPr>
-          <a:xfrm>
-            <a:off x="7571232" y="4901184"/>
-            <a:ext cx="548640" cy="256032"/>
-          </a:xfrm>
-          <a:prstGeom prst="rect">
-            <a:avLst/>
-          </a:prstGeom>
-          <a:solidFill>
-            <a:srgbClr val="D72638"/>
-          </a:solidFill>
-          <a:ln w="12700">
-            <a:solidFill>
-              <a:srgbClr val="D72638"/>
-            </a:solidFill>
-            <a:prstDash val="solid"/>
-          </a:ln>
-        </p:spPr>
-      </p:sp>
-      <p:sp>
-        <p:nvSpPr>
-          <p:cNvPr id="36" name="Text 33"/>
-          <p:cNvSpPr/>
-          <p:nvPr/>
-        </p:nvSpPr>
-        <p:spPr>
-          <a:xfrm>
-            <a:off x="7571232" y="4901184"/>
-            <a:ext cx="548640" cy="256032"/>
-          </a:xfrm>
-          <a:prstGeom prst="rect">
-            <a:avLst/>
-          </a:prstGeom>
-          <a:noFill/>
-          <a:ln/>
-        </p:spPr>
-        <p:txBody>
-          <a:bodyPr wrap="square" lIns="0" tIns="0" rIns="0" bIns="0" rtlCol="0" anchor="ctr"/>
-          <a:lstStyle/>
-          <a:p>
-            <a:pPr algn="ctr" indent="0" marL="0">
-              <a:buNone/>
-            </a:pPr>
-            <a:r>
-              <a:rPr lang="en-US" sz="900" b="1" dirty="0">
-                <a:solidFill>
-                  <a:srgbClr val="FFFFFF"/>
-                </a:solidFill>
-                <a:latin typeface="맑은 고딕" pitchFamily="34" charset="0"/>
-                <a:ea typeface="맑은 고딕" pitchFamily="34" charset="-122"/>
-                <a:cs typeface="맑은 고딕" pitchFamily="34" charset="-120"/>
-              </a:rPr>
-              <a:t>긴급</a:t>
-            </a:r>
-            <a:endParaRPr lang="en-US" sz="900" dirty="0"/>
-          </a:p>
-        </p:txBody>
-      </p:sp>
-      <p:sp>
-        <p:nvSpPr>
-          <p:cNvPr id="37" name="Text 34"/>
-          <p:cNvSpPr/>
-          <p:nvPr/>
-        </p:nvSpPr>
-        <p:spPr>
-          <a:xfrm>
-            <a:off x="8211312" y="4864608"/>
-            <a:ext cx="3291840" cy="274320"/>
-          </a:xfrm>
-          <a:prstGeom prst="rect">
-            <a:avLst/>
-          </a:prstGeom>
-          <a:noFill/>
-          <a:ln/>
-        </p:spPr>
-        <p:txBody>
-          <a:bodyPr wrap="square" lIns="0" tIns="0" rIns="0" bIns="0" rtlCol="0" anchor="ctr"/>
-          <a:lstStyle/>
-          <a:p>
-            <a:pPr indent="0" marL="0">
-              <a:buNone/>
-            </a:pPr>
-            <a:r>
-              <a:rPr lang="en-US" sz="1100" b="1" dirty="0">
-                <a:solidFill>
-                  <a:srgbClr val="0B1220"/>
-                </a:solidFill>
-                <a:latin typeface="맑은 고딕" pitchFamily="34" charset="0"/>
-                <a:ea typeface="맑은 고딕" pitchFamily="34" charset="-122"/>
-                <a:cs typeface="맑은 고딕" pitchFamily="34" charset="-120"/>
-              </a:rPr>
-              <a:t>Tangle Keychain</a:t>
-            </a:r>
-            <a:endParaRPr lang="en-US" sz="1100" dirty="0"/>
-          </a:p>
-        </p:txBody>
-      </p:sp>
-      <p:sp>
-        <p:nvSpPr>
-          <p:cNvPr id="38" name="Text 35"/>
-          <p:cNvSpPr/>
-          <p:nvPr/>
-        </p:nvSpPr>
-        <p:spPr>
-          <a:xfrm>
-            <a:off x="8211312" y="5138928"/>
-            <a:ext cx="3291840" cy="256032"/>
-          </a:xfrm>
-          <a:prstGeom prst="rect">
-            <a:avLst/>
-          </a:prstGeom>
-          <a:noFill/>
-          <a:ln/>
-        </p:spPr>
-        <p:txBody>
-          <a:bodyPr wrap="square" lIns="0" tIns="0" rIns="0" bIns="0" rtlCol="0" anchor="ctr"/>
-          <a:lstStyle/>
-          <a:p>
-            <a:pPr indent="0" marL="0">
-              <a:buNone/>
-            </a:pPr>
-            <a:r>
-              <a:rPr lang="en-US" sz="1000" dirty="0">
-                <a:solidFill>
-                  <a:srgbClr val="6B7280"/>
-                </a:solidFill>
-                <a:latin typeface="맑은 고딕" pitchFamily="34" charset="0"/>
-                <a:ea typeface="맑은 고딕" pitchFamily="34" charset="-122"/>
-                <a:cs typeface="맑은 고딕" pitchFamily="34" charset="-120"/>
-              </a:rPr>
-              <a:t>★Season off★  ·  재고 4개</a:t>
-            </a:r>
-            <a:pPr indent="0" marL="0">
-              <a:buNone/>
-            </a:pPr>
-            <a:r>
-              <a:rPr lang="en-US" sz="1000" b="1" dirty="0">
-                <a:solidFill>
-                  <a:srgbClr val="D72638"/>
-                </a:solidFill>
-                <a:latin typeface="맑은 고딕" pitchFamily="34" charset="0"/>
-                <a:ea typeface="맑은 고딕" pitchFamily="34" charset="-122"/>
-                <a:cs typeface="맑은 고딕" pitchFamily="34" charset="-120"/>
-              </a:rPr>
-              <a:t/>
-            </a:r>
-            <a:endParaRPr lang="en-US" sz="1000" dirty="0"/>
-          </a:p>
-        </p:txBody>
-      </p:sp>
-      <p:sp>
-        <p:nvSpPr>
-          <p:cNvPr id="39" name="Shape 36"/>
-          <p:cNvSpPr/>
-          <p:nvPr/>
-        </p:nvSpPr>
-        <p:spPr>
-          <a:xfrm>
-            <a:off x="7406640" y="5522976"/>
-            <a:ext cx="4206240" cy="640080"/>
-          </a:xfrm>
-          <a:prstGeom prst="rect">
-            <a:avLst/>
-          </a:prstGeom>
-          <a:solidFill>
-            <a:srgbClr val="FFF5F5"/>
-          </a:solidFill>
-          <a:ln w="6350">
-            <a:solidFill>
-              <a:srgbClr val="E5E7EB"/>
-            </a:solidFill>
-            <a:prstDash val="solid"/>
-          </a:ln>
-        </p:spPr>
-      </p:sp>
-      <p:sp>
-        <p:nvSpPr>
-          <p:cNvPr id="40" name="Shape 37"/>
-          <p:cNvSpPr/>
-          <p:nvPr/>
-        </p:nvSpPr>
-        <p:spPr>
-          <a:xfrm>
-            <a:off x="7406640" y="5522976"/>
-            <a:ext cx="109728" cy="640080"/>
-          </a:xfrm>
-          <a:prstGeom prst="rect">
-            <a:avLst/>
-          </a:prstGeom>
-          <a:solidFill>
-            <a:srgbClr val="D72638"/>
-          </a:solidFill>
-          <a:ln w="12700">
-            <a:solidFill>
-              <a:srgbClr val="D72638"/>
-            </a:solidFill>
-            <a:prstDash val="solid"/>
-          </a:ln>
-        </p:spPr>
-      </p:sp>
-      <p:sp>
-        <p:nvSpPr>
-          <p:cNvPr id="41" name="Shape 38"/>
-          <p:cNvSpPr/>
-          <p:nvPr/>
-        </p:nvSpPr>
-        <p:spPr>
-          <a:xfrm>
-            <a:off x="7571232" y="5614416"/>
-            <a:ext cx="548640" cy="256032"/>
-          </a:xfrm>
-          <a:prstGeom prst="rect">
-            <a:avLst/>
-          </a:prstGeom>
-          <a:solidFill>
-            <a:srgbClr val="D72638"/>
-          </a:solidFill>
-          <a:ln w="12700">
-            <a:solidFill>
-              <a:srgbClr val="D72638"/>
-            </a:solidFill>
-            <a:prstDash val="solid"/>
-          </a:ln>
-        </p:spPr>
-      </p:sp>
-      <p:sp>
-        <p:nvSpPr>
-          <p:cNvPr id="42" name="Text 39"/>
-          <p:cNvSpPr/>
-          <p:nvPr/>
-        </p:nvSpPr>
-        <p:spPr>
-          <a:xfrm>
-            <a:off x="7571232" y="5614416"/>
-            <a:ext cx="548640" cy="256032"/>
-          </a:xfrm>
-          <a:prstGeom prst="rect">
-            <a:avLst/>
-          </a:prstGeom>
-          <a:noFill/>
-          <a:ln/>
-        </p:spPr>
-        <p:txBody>
-          <a:bodyPr wrap="square" lIns="0" tIns="0" rIns="0" bIns="0" rtlCol="0" anchor="ctr"/>
-          <a:lstStyle/>
-          <a:p>
-            <a:pPr algn="ctr" indent="0" marL="0">
-              <a:buNone/>
-            </a:pPr>
-            <a:r>
-              <a:rPr lang="en-US" sz="900" b="1" dirty="0">
-                <a:solidFill>
-                  <a:srgbClr val="FFFFFF"/>
-                </a:solidFill>
-                <a:latin typeface="맑은 고딕" pitchFamily="34" charset="0"/>
-                <a:ea typeface="맑은 고딕" pitchFamily="34" charset="-122"/>
-                <a:cs typeface="맑은 고딕" pitchFamily="34" charset="-120"/>
-              </a:rPr>
-              <a:t>긴급</a:t>
-            </a:r>
-            <a:endParaRPr lang="en-US" sz="900" dirty="0"/>
-          </a:p>
-        </p:txBody>
-      </p:sp>
-      <p:sp>
-        <p:nvSpPr>
-          <p:cNvPr id="43" name="Text 40"/>
-          <p:cNvSpPr/>
-          <p:nvPr/>
-        </p:nvSpPr>
-        <p:spPr>
-          <a:xfrm>
-            <a:off x="8211312" y="5577840"/>
-            <a:ext cx="3291840" cy="274320"/>
-          </a:xfrm>
-          <a:prstGeom prst="rect">
-            <a:avLst/>
-          </a:prstGeom>
-          <a:noFill/>
-          <a:ln/>
-        </p:spPr>
-        <p:txBody>
-          <a:bodyPr wrap="square" lIns="0" tIns="0" rIns="0" bIns="0" rtlCol="0" anchor="ctr"/>
-          <a:lstStyle/>
-          <a:p>
-            <a:pPr indent="0" marL="0">
-              <a:buNone/>
-            </a:pPr>
-            <a:r>
-              <a:rPr lang="en-US" sz="1100" b="1" dirty="0">
-                <a:solidFill>
-                  <a:srgbClr val="0B1220"/>
-                </a:solidFill>
-                <a:latin typeface="맑은 고딕" pitchFamily="34" charset="0"/>
-                <a:ea typeface="맑은 고딕" pitchFamily="34" charset="-122"/>
-                <a:cs typeface="맑은 고딕" pitchFamily="34" charset="-120"/>
-              </a:rPr>
-              <a:t>B-Flower Necklace (Size: 1 Size)</a:t>
-            </a:r>
-            <a:endParaRPr lang="en-US" sz="1100" dirty="0"/>
-          </a:p>
-        </p:txBody>
-      </p:sp>
-      <p:sp>
-        <p:nvSpPr>
-          <p:cNvPr id="44" name="Text 41"/>
-          <p:cNvSpPr/>
-          <p:nvPr/>
-        </p:nvSpPr>
-        <p:spPr>
-          <a:xfrm>
-            <a:off x="8211312" y="5852160"/>
-            <a:ext cx="3291840" cy="256032"/>
-          </a:xfrm>
-          <a:prstGeom prst="rect">
-            <a:avLst/>
-          </a:prstGeom>
-          <a:noFill/>
-          <a:ln/>
-        </p:spPr>
-        <p:txBody>
-          <a:bodyPr wrap="square" lIns="0" tIns="0" rIns="0" bIns="0" rtlCol="0" anchor="ctr"/>
-          <a:lstStyle/>
-          <a:p>
-            <a:pPr indent="0" marL="0">
-              <a:buNone/>
-            </a:pPr>
-            <a:r>
-              <a:rPr lang="en-US" sz="1000" dirty="0">
-                <a:solidFill>
-                  <a:srgbClr val="6B7280"/>
-                </a:solidFill>
-                <a:latin typeface="맑은 고딕" pitchFamily="34" charset="0"/>
-                <a:ea typeface="맑은 고딕" pitchFamily="34" charset="-122"/>
-                <a:cs typeface="맑은 고딕" pitchFamily="34" charset="-120"/>
-              </a:rPr>
-              <a:t>Necklace  ·  재고 0개</a:t>
-            </a:r>
-            <a:pPr indent="0" marL="0">
-              <a:buNone/>
-            </a:pPr>
-            <a:r>
-              <a:rPr lang="en-US" sz="1000" b="1" dirty="0">
-                <a:solidFill>
-                  <a:srgbClr val="D72638"/>
-                </a:solidFill>
-                <a:latin typeface="맑은 고딕" pitchFamily="34" charset="0"/>
-                <a:ea typeface="맑은 고딕" pitchFamily="34" charset="-122"/>
-                <a:cs typeface="맑은 고딕" pitchFamily="34" charset="-120"/>
-              </a:rPr>
-              <a:t/>
-            </a:r>
-            <a:endParaRPr lang="en-US" sz="1000" dirty="0"/>
-          </a:p>
-        </p:txBody>
-      </p:sp>
-      <p:sp>
-        <p:nvSpPr>
           <p:cNvPr id="45" name="Text 42"/>
           <p:cNvSpPr/>
           <p:nvPr/>
@@ -8267,7 +8267,7 @@
                 <a:ea typeface="맑은 고딕" pitchFamily="34" charset="-122"/>
                 <a:cs typeface="맑은 고딕" pitchFamily="34" charset="-120"/>
               </a:rPr>
-              <a:t>베스트 상품 리포트  ·  생성 2026-05-15 08:00</a:t>
+              <a:t>베스트 상품 리포트  ·  생성 2026-05-16 08:00</a:t>
             </a:r>
             <a:endParaRPr lang="en-US" sz="900" dirty="0"/>
           </a:p>
@@ -8480,7 +8480,7 @@
                 <a:ea typeface="맑은 고딕" pitchFamily="34" charset="-122"/>
                 <a:cs typeface="맑은 고딕" pitchFamily="34" charset="-120"/>
               </a:rPr>
-              <a:t>2026년 05월 15일 (금)</a:t>
+              <a:t>2026년 05월 16일 (토)</a:t>
             </a:r>
             <a:endParaRPr lang="en-US" sz="1200" dirty="0"/>
           </a:p>
@@ -8647,7 +8647,7 @@
                 <a:ea typeface="맑은 고딕" pitchFamily="34" charset="-122"/>
                 <a:cs typeface="맑은 고딕" pitchFamily="34" charset="-120"/>
               </a:rPr>
-              <a:t>137 개</a:t>
+              <a:t>144 개</a:t>
             </a:r>
             <a:endParaRPr lang="en-US" sz="3600" dirty="0"/>
           </a:p>
@@ -8853,7 +8853,7 @@
                 <a:ea typeface="맑은 고딕" pitchFamily="34" charset="-122"/>
                 <a:cs typeface="맑은 고딕" pitchFamily="34" charset="-120"/>
               </a:rPr>
-              <a:t>44</a:t>
+              <a:t>45</a:t>
             </a:r>
             <a:endParaRPr lang="en-US" sz="4400" dirty="0"/>
           </a:p>
@@ -9452,7 +9452,7 @@
                           <a:ea typeface="맑은 고딕" pitchFamily="34" charset="-122"/>
                           <a:cs typeface="맑은 고딕" pitchFamily="34" charset="-120"/>
                         </a:rPr>
-                        <a:t>44 개</a:t>
+                        <a:t>45 개</a:t>
                       </a:r>
                       <a:endParaRPr lang="en-US" sz="1400" dirty="0">
                         <a:latin typeface="맑은 고딕" charset="0"/>
@@ -9714,7 +9714,7 @@
                           <a:ea typeface="맑은 고딕" pitchFamily="34" charset="-122"/>
                           <a:cs typeface="맑은 고딕" pitchFamily="34" charset="-120"/>
                         </a:rPr>
-                        <a:t>22 개</a:t>
+                        <a:t>40 개</a:t>
                       </a:r>
                       <a:endParaRPr lang="en-US" sz="1200" dirty="0">
                         <a:latin typeface="맑은 고딕" charset="0"/>
@@ -9846,7 +9846,7 @@
                           <a:ea typeface="맑은 고딕" pitchFamily="34" charset="-122"/>
                           <a:cs typeface="맑은 고딕" pitchFamily="34" charset="-120"/>
                         </a:rPr>
-                        <a:t>Ring</a:t>
+                        <a:t>Necklace</a:t>
                       </a:r>
                       <a:endParaRPr lang="en-US" sz="1000" dirty="0">
                         <a:latin typeface="맑은 고딕" charset="0"/>
@@ -9911,7 +9911,7 @@
                           <a:ea typeface="맑은 고딕" pitchFamily="34" charset="-122"/>
                           <a:cs typeface="맑은 고딕" pitchFamily="34" charset="-120"/>
                         </a:rPr>
-                        <a:t>"Reine" 925 Open Ring</a:t>
+                        <a:t>ThreadDuo Necklace</a:t>
                       </a:r>
                       <a:endParaRPr lang="en-US" sz="1100" dirty="0">
                         <a:latin typeface="맑은 고딕" charset="0"/>
@@ -9976,7 +9976,7 @@
                           <a:ea typeface="맑은 고딕" pitchFamily="34" charset="-122"/>
                           <a:cs typeface="맑은 고딕" pitchFamily="34" charset="-120"/>
                         </a:rPr>
-                        <a:t>14 개</a:t>
+                        <a:t>18 개</a:t>
                       </a:r>
                       <a:endParaRPr lang="en-US" sz="1200" dirty="0">
                         <a:latin typeface="맑은 고딕" charset="0"/>
@@ -10165,7 +10165,7 @@
                 <a:ea typeface="맑은 고딕" pitchFamily="34" charset="-122"/>
                 <a:cs typeface="맑은 고딕" pitchFamily="34" charset="-120"/>
               </a:rPr>
-              <a:t>베스트 상품 리포트  ·  생성 2026-05-15 08:00</a:t>
+              <a:t>베스트 상품 리포트  ·  생성 2026-05-16 08:00</a:t>
             </a:r>
             <a:endParaRPr lang="en-US" sz="900" dirty="0"/>
           </a:p>
@@ -10378,7 +10378,7 @@
                 <a:ea typeface="맑은 고딕" pitchFamily="34" charset="-122"/>
                 <a:cs typeface="맑은 고딕" pitchFamily="34" charset="-120"/>
               </a:rPr>
-              <a:t>2026년 05월 15일 (금)</a:t>
+              <a:t>2026년 05월 16일 (토)</a:t>
             </a:r>
             <a:endParaRPr lang="en-US" sz="1200" dirty="0"/>
           </a:p>
@@ -10673,7 +10673,7 @@
                 <a:ea typeface="맑은 고딕" pitchFamily="34" charset="-122"/>
                 <a:cs typeface="맑은 고딕" pitchFamily="34" charset="-120"/>
               </a:rPr>
-              <a:t>21</a:t>
+              <a:t>24</a:t>
             </a:r>
             <a:endParaRPr lang="en-US" sz="3000" dirty="0"/>
           </a:p>
@@ -10801,7 +10801,7 @@
                 <a:ea typeface="맑은 고딕" pitchFamily="34" charset="-122"/>
                 <a:cs typeface="맑은 고딕" pitchFamily="34" charset="-120"/>
               </a:rPr>
-              <a:t>7</a:t>
+              <a:t>8</a:t>
             </a:r>
             <a:endParaRPr lang="en-US" sz="3000" dirty="0"/>
           </a:p>
@@ -10929,7 +10929,7 @@
                 <a:ea typeface="맑은 고딕" pitchFamily="34" charset="-122"/>
                 <a:cs typeface="맑은 고딕" pitchFamily="34" charset="-120"/>
               </a:rPr>
-              <a:t>36,490</a:t>
+              <a:t>35,672</a:t>
             </a:r>
             <a:endParaRPr lang="en-US" sz="3000" dirty="0"/>
           </a:p>
@@ -11489,7 +11489,7 @@
                           <a:ea typeface="맑은 고딕" pitchFamily="34" charset="-122"/>
                           <a:cs typeface="맑은 고딕" pitchFamily="34" charset="-120"/>
                         </a:rPr>
-                        <a:t>2,303</a:t>
+                        <a:t>2,207</a:t>
                       </a:r>
                       <a:endParaRPr lang="en-US" sz="1000" dirty="0">
                         <a:latin typeface="맑은 고딕" charset="0"/>
@@ -11751,7 +11751,7 @@
                           <a:ea typeface="맑은 고딕" pitchFamily="34" charset="-122"/>
                           <a:cs typeface="맑은 고딕" pitchFamily="34" charset="-120"/>
                         </a:rPr>
-                        <a:t>2,158</a:t>
+                        <a:t>2,153</a:t>
                       </a:r>
                       <a:endParaRPr lang="en-US" sz="1000" dirty="0">
                         <a:latin typeface="맑은 고딕" charset="0"/>
@@ -12013,7 +12013,7 @@
                           <a:ea typeface="맑은 고딕" pitchFamily="34" charset="-122"/>
                           <a:cs typeface="맑은 고딕" pitchFamily="34" charset="-120"/>
                         </a:rPr>
-                        <a:t>1,981</a:t>
+                        <a:t>1,942</a:t>
                       </a:r>
                       <a:endParaRPr lang="en-US" sz="1000" dirty="0">
                         <a:latin typeface="맑은 고딕" charset="0"/>
@@ -12275,7 +12275,7 @@
                           <a:ea typeface="맑은 고딕" pitchFamily="34" charset="-122"/>
                           <a:cs typeface="맑은 고딕" pitchFamily="34" charset="-120"/>
                         </a:rPr>
-                        <a:t>1,708</a:t>
+                        <a:t>1,695</a:t>
                       </a:r>
                       <a:endParaRPr lang="en-US" sz="1000" dirty="0">
                         <a:latin typeface="맑은 고딕" charset="0"/>
@@ -12537,7 +12537,7 @@
                           <a:ea typeface="맑은 고딕" pitchFamily="34" charset="-122"/>
                           <a:cs typeface="맑은 고딕" pitchFamily="34" charset="-120"/>
                         </a:rPr>
-                        <a:t>1,660</a:t>
+                        <a:t>1,573</a:t>
                       </a:r>
                       <a:endParaRPr lang="en-US" sz="1000" dirty="0">
                         <a:latin typeface="맑은 고딕" charset="0"/>
@@ -12623,7 +12623,7 @@
                 <a:ea typeface="맑은 고딕" pitchFamily="34" charset="-122"/>
                 <a:cs typeface="맑은 고딕" pitchFamily="34" charset="-120"/>
               </a:rPr>
-              <a:t>재고 점검  🔴 품절 21건</a:t>
+              <a:t>재고 점검  🔴 품절 24건</a:t>
             </a:r>
             <a:pPr indent="0" marL="0">
               <a:buNone/>
@@ -12790,6 +12790,226 @@
                 <a:ea typeface="맑은 고딕" pitchFamily="34" charset="-122"/>
                 <a:cs typeface="맑은 고딕" pitchFamily="34" charset="-120"/>
               </a:rPr>
+              <a:t>Compact Phone Stand (6color)</a:t>
+            </a:r>
+            <a:endParaRPr lang="en-US" sz="1000" dirty="0"/>
+          </a:p>
+        </p:txBody>
+      </p:sp>
+      <p:sp>
+        <p:nvSpPr>
+          <p:cNvPr id="31" name="Text 28"/>
+          <p:cNvSpPr/>
+          <p:nvPr/>
+        </p:nvSpPr>
+        <p:spPr>
+          <a:xfrm>
+            <a:off x="8211312" y="3712464"/>
+            <a:ext cx="3291840" cy="256032"/>
+          </a:xfrm>
+          <a:prstGeom prst="rect">
+            <a:avLst/>
+          </a:prstGeom>
+          <a:noFill/>
+          <a:ln/>
+        </p:spPr>
+        <p:txBody>
+          <a:bodyPr wrap="square" lIns="0" tIns="0" rIns="0" bIns="0" rtlCol="0" anchor="ctr"/>
+          <a:lstStyle/>
+          <a:p>
+            <a:pPr indent="0" marL="0">
+              <a:buNone/>
+            </a:pPr>
+            <a:r>
+              <a:rPr lang="en-US" sz="900" dirty="0">
+                <a:solidFill>
+                  <a:srgbClr val="6B7280"/>
+                </a:solidFill>
+                <a:latin typeface="맑은 고딕" pitchFamily="34" charset="0"/>
+                <a:ea typeface="맑은 고딕" pitchFamily="34" charset="-122"/>
+                <a:cs typeface="맑은 고딕" pitchFamily="34" charset="-120"/>
+              </a:rPr>
+              <a:t>컬러: 화이트  ·  재고 0개</a:t>
+            </a:r>
+            <a:pPr indent="0" marL="0">
+              <a:buNone/>
+            </a:pPr>
+            <a:r>
+              <a:rPr lang="en-US" sz="1000" dirty="0">
+                <a:solidFill>
+                  <a:srgbClr val="6B7280"/>
+                </a:solidFill>
+                <a:latin typeface="맑은 고딕" pitchFamily="34" charset="0"/>
+                <a:ea typeface="맑은 고딕" pitchFamily="34" charset="-122"/>
+                <a:cs typeface="맑은 고딕" pitchFamily="34" charset="-120"/>
+              </a:rPr>
+              <a:t/>
+            </a:r>
+            <a:pPr indent="0" marL="0">
+              <a:buNone/>
+            </a:pPr>
+            <a:r>
+              <a:rPr lang="en-US" sz="1000" b="1" dirty="0">
+                <a:solidFill>
+                  <a:srgbClr val="D72638"/>
+                </a:solidFill>
+                <a:latin typeface="맑은 고딕" pitchFamily="34" charset="0"/>
+                <a:ea typeface="맑은 고딕" pitchFamily="34" charset="-122"/>
+                <a:cs typeface="맑은 고딕" pitchFamily="34" charset="-120"/>
+              </a:rPr>
+              <a:t/>
+            </a:r>
+            <a:endParaRPr lang="en-US" sz="900" dirty="0"/>
+          </a:p>
+        </p:txBody>
+      </p:sp>
+      <p:sp>
+        <p:nvSpPr>
+          <p:cNvPr id="32" name="Shape 29"/>
+          <p:cNvSpPr/>
+          <p:nvPr/>
+        </p:nvSpPr>
+        <p:spPr>
+          <a:xfrm>
+            <a:off x="7406640" y="4096512"/>
+            <a:ext cx="4206240" cy="640080"/>
+          </a:xfrm>
+          <a:prstGeom prst="rect">
+            <a:avLst/>
+          </a:prstGeom>
+          <a:solidFill>
+            <a:srgbClr val="FFF5F5"/>
+          </a:solidFill>
+          <a:ln w="6350">
+            <a:solidFill>
+              <a:srgbClr val="E5E7EB"/>
+            </a:solidFill>
+            <a:prstDash val="solid"/>
+          </a:ln>
+        </p:spPr>
+      </p:sp>
+      <p:sp>
+        <p:nvSpPr>
+          <p:cNvPr id="33" name="Shape 30"/>
+          <p:cNvSpPr/>
+          <p:nvPr/>
+        </p:nvSpPr>
+        <p:spPr>
+          <a:xfrm>
+            <a:off x="7406640" y="4096512"/>
+            <a:ext cx="109728" cy="640080"/>
+          </a:xfrm>
+          <a:prstGeom prst="rect">
+            <a:avLst/>
+          </a:prstGeom>
+          <a:solidFill>
+            <a:srgbClr val="D72638"/>
+          </a:solidFill>
+          <a:ln w="12700">
+            <a:solidFill>
+              <a:srgbClr val="D72638"/>
+            </a:solidFill>
+            <a:prstDash val="solid"/>
+          </a:ln>
+        </p:spPr>
+      </p:sp>
+      <p:sp>
+        <p:nvSpPr>
+          <p:cNvPr id="34" name="Shape 31"/>
+          <p:cNvSpPr/>
+          <p:nvPr/>
+        </p:nvSpPr>
+        <p:spPr>
+          <a:xfrm>
+            <a:off x="7571232" y="4187952"/>
+            <a:ext cx="548640" cy="256032"/>
+          </a:xfrm>
+          <a:prstGeom prst="rect">
+            <a:avLst/>
+          </a:prstGeom>
+          <a:solidFill>
+            <a:srgbClr val="D72638"/>
+          </a:solidFill>
+          <a:ln w="12700">
+            <a:solidFill>
+              <a:srgbClr val="D72638"/>
+            </a:solidFill>
+            <a:prstDash val="solid"/>
+          </a:ln>
+        </p:spPr>
+      </p:sp>
+      <p:sp>
+        <p:nvSpPr>
+          <p:cNvPr id="35" name="Text 32"/>
+          <p:cNvSpPr/>
+          <p:nvPr/>
+        </p:nvSpPr>
+        <p:spPr>
+          <a:xfrm>
+            <a:off x="7571232" y="4187952"/>
+            <a:ext cx="548640" cy="256032"/>
+          </a:xfrm>
+          <a:prstGeom prst="rect">
+            <a:avLst/>
+          </a:prstGeom>
+          <a:noFill/>
+          <a:ln/>
+        </p:spPr>
+        <p:txBody>
+          <a:bodyPr wrap="square" lIns="0" tIns="0" rIns="0" bIns="0" rtlCol="0" anchor="ctr"/>
+          <a:lstStyle/>
+          <a:p>
+            <a:pPr algn="ctr" indent="0" marL="0">
+              <a:buNone/>
+            </a:pPr>
+            <a:r>
+              <a:rPr lang="en-US" sz="900" b="1" dirty="0">
+                <a:solidFill>
+                  <a:srgbClr val="FFFFFF"/>
+                </a:solidFill>
+                <a:latin typeface="맑은 고딕" pitchFamily="34" charset="0"/>
+                <a:ea typeface="맑은 고딕" pitchFamily="34" charset="-122"/>
+                <a:cs typeface="맑은 고딕" pitchFamily="34" charset="-120"/>
+              </a:rPr>
+              <a:t>긴급</a:t>
+            </a:r>
+            <a:endParaRPr lang="en-US" sz="900" dirty="0"/>
+          </a:p>
+        </p:txBody>
+      </p:sp>
+      <p:sp>
+        <p:nvSpPr>
+          <p:cNvPr id="36" name="Text 33"/>
+          <p:cNvSpPr/>
+          <p:nvPr/>
+        </p:nvSpPr>
+        <p:spPr>
+          <a:xfrm>
+            <a:off x="8211312" y="4151376"/>
+            <a:ext cx="3291840" cy="274320"/>
+          </a:xfrm>
+          <a:prstGeom prst="rect">
+            <a:avLst/>
+          </a:prstGeom>
+          <a:noFill/>
+          <a:ln/>
+        </p:spPr>
+        <p:txBody>
+          <a:bodyPr wrap="square" lIns="0" tIns="0" rIns="0" bIns="0" rtlCol="0" anchor="ctr"/>
+          <a:lstStyle/>
+          <a:p>
+            <a:pPr indent="0" marL="0">
+              <a:buNone/>
+            </a:pPr>
+            <a:r>
+              <a:rPr lang="en-US" sz="1000" b="1" dirty="0">
+                <a:solidFill>
+                  <a:srgbClr val="0B1220"/>
+                </a:solidFill>
+                <a:latin typeface="맑은 고딕" pitchFamily="34" charset="0"/>
+                <a:ea typeface="맑은 고딕" pitchFamily="34" charset="-122"/>
+                <a:cs typeface="맑은 고딕" pitchFamily="34" charset="-120"/>
+              </a:rPr>
               <a:t>Food Bottle Opener</a:t>
             </a:r>
             <a:endParaRPr lang="en-US" sz="1000" dirty="0"/>
@@ -12798,13 +13018,13 @@
       </p:sp>
       <p:sp>
         <p:nvSpPr>
-          <p:cNvPr id="31" name="Text 28"/>
-          <p:cNvSpPr/>
-          <p:nvPr/>
-        </p:nvSpPr>
-        <p:spPr>
-          <a:xfrm>
-            <a:off x="8211312" y="3712464"/>
+          <p:cNvPr id="37" name="Text 34"/>
+          <p:cNvSpPr/>
+          <p:nvPr/>
+        </p:nvSpPr>
+        <p:spPr>
+          <a:xfrm>
+            <a:off x="8211312" y="4425696"/>
             <a:ext cx="3291840" cy="256032"/>
           </a:xfrm>
           <a:prstGeom prst="rect">
@@ -12865,13 +13085,13 @@
       </p:sp>
       <p:sp>
         <p:nvSpPr>
-          <p:cNvPr id="32" name="Shape 29"/>
-          <p:cNvSpPr/>
-          <p:nvPr/>
-        </p:nvSpPr>
-        <p:spPr>
-          <a:xfrm>
-            <a:off x="7406640" y="4096512"/>
+          <p:cNvPr id="38" name="Shape 35"/>
+          <p:cNvSpPr/>
+          <p:nvPr/>
+        </p:nvSpPr>
+        <p:spPr>
+          <a:xfrm>
+            <a:off x="7406640" y="4809744"/>
             <a:ext cx="4206240" cy="640080"/>
           </a:xfrm>
           <a:prstGeom prst="rect">
@@ -12890,13 +13110,13 @@
       </p:sp>
       <p:sp>
         <p:nvSpPr>
-          <p:cNvPr id="33" name="Shape 30"/>
-          <p:cNvSpPr/>
-          <p:nvPr/>
-        </p:nvSpPr>
-        <p:spPr>
-          <a:xfrm>
-            <a:off x="7406640" y="4096512"/>
+          <p:cNvPr id="39" name="Shape 36"/>
+          <p:cNvSpPr/>
+          <p:nvPr/>
+        </p:nvSpPr>
+        <p:spPr>
+          <a:xfrm>
+            <a:off x="7406640" y="4809744"/>
             <a:ext cx="109728" cy="640080"/>
           </a:xfrm>
           <a:prstGeom prst="rect">
@@ -12915,13 +13135,13 @@
       </p:sp>
       <p:sp>
         <p:nvSpPr>
-          <p:cNvPr id="34" name="Shape 31"/>
-          <p:cNvSpPr/>
-          <p:nvPr/>
-        </p:nvSpPr>
-        <p:spPr>
-          <a:xfrm>
-            <a:off x="7571232" y="4187952"/>
+          <p:cNvPr id="40" name="Shape 37"/>
+          <p:cNvSpPr/>
+          <p:nvPr/>
+        </p:nvSpPr>
+        <p:spPr>
+          <a:xfrm>
+            <a:off x="7571232" y="4901184"/>
             <a:ext cx="548640" cy="256032"/>
           </a:xfrm>
           <a:prstGeom prst="rect">
@@ -12940,13 +13160,13 @@
       </p:sp>
       <p:sp>
         <p:nvSpPr>
-          <p:cNvPr id="35" name="Text 32"/>
-          <p:cNvSpPr/>
-          <p:nvPr/>
-        </p:nvSpPr>
-        <p:spPr>
-          <a:xfrm>
-            <a:off x="7571232" y="4187952"/>
+          <p:cNvPr id="41" name="Text 38"/>
+          <p:cNvSpPr/>
+          <p:nvPr/>
+        </p:nvSpPr>
+        <p:spPr>
+          <a:xfrm>
+            <a:off x="7571232" y="4901184"/>
             <a:ext cx="548640" cy="256032"/>
           </a:xfrm>
           <a:prstGeom prst="rect">
@@ -12979,13 +13199,13 @@
       </p:sp>
       <p:sp>
         <p:nvSpPr>
-          <p:cNvPr id="36" name="Text 33"/>
-          <p:cNvSpPr/>
-          <p:nvPr/>
-        </p:nvSpPr>
-        <p:spPr>
-          <a:xfrm>
-            <a:off x="8211312" y="4151376"/>
+          <p:cNvPr id="42" name="Text 39"/>
+          <p:cNvSpPr/>
+          <p:nvPr/>
+        </p:nvSpPr>
+        <p:spPr>
+          <a:xfrm>
+            <a:off x="8211312" y="4864608"/>
             <a:ext cx="3291840" cy="274320"/>
           </a:xfrm>
           <a:prstGeom prst="rect">
@@ -13018,13 +13238,13 @@
       </p:sp>
       <p:sp>
         <p:nvSpPr>
-          <p:cNvPr id="37" name="Text 34"/>
-          <p:cNvSpPr/>
-          <p:nvPr/>
-        </p:nvSpPr>
-        <p:spPr>
-          <a:xfrm>
-            <a:off x="8211312" y="4425696"/>
+          <p:cNvPr id="43" name="Text 40"/>
+          <p:cNvSpPr/>
+          <p:nvPr/>
+        </p:nvSpPr>
+        <p:spPr>
+          <a:xfrm>
+            <a:off x="8211312" y="5138928"/>
             <a:ext cx="3291840" cy="256032"/>
           </a:xfrm>
           <a:prstGeom prst="rect">
@@ -13085,13 +13305,13 @@
       </p:sp>
       <p:sp>
         <p:nvSpPr>
-          <p:cNvPr id="38" name="Shape 35"/>
-          <p:cNvSpPr/>
-          <p:nvPr/>
-        </p:nvSpPr>
-        <p:spPr>
-          <a:xfrm>
-            <a:off x="7406640" y="4809744"/>
+          <p:cNvPr id="44" name="Shape 41"/>
+          <p:cNvSpPr/>
+          <p:nvPr/>
+        </p:nvSpPr>
+        <p:spPr>
+          <a:xfrm>
+            <a:off x="7406640" y="5522976"/>
             <a:ext cx="4206240" cy="640080"/>
           </a:xfrm>
           <a:prstGeom prst="rect">
@@ -13110,13 +13330,13 @@
       </p:sp>
       <p:sp>
         <p:nvSpPr>
-          <p:cNvPr id="39" name="Shape 36"/>
-          <p:cNvSpPr/>
-          <p:nvPr/>
-        </p:nvSpPr>
-        <p:spPr>
-          <a:xfrm>
-            <a:off x="7406640" y="4809744"/>
+          <p:cNvPr id="45" name="Shape 42"/>
+          <p:cNvSpPr/>
+          <p:nvPr/>
+        </p:nvSpPr>
+        <p:spPr>
+          <a:xfrm>
+            <a:off x="7406640" y="5522976"/>
             <a:ext cx="109728" cy="640080"/>
           </a:xfrm>
           <a:prstGeom prst="rect">
@@ -13135,13 +13355,13 @@
       </p:sp>
       <p:sp>
         <p:nvSpPr>
-          <p:cNvPr id="40" name="Shape 37"/>
-          <p:cNvSpPr/>
-          <p:nvPr/>
-        </p:nvSpPr>
-        <p:spPr>
-          <a:xfrm>
-            <a:off x="7571232" y="4901184"/>
+          <p:cNvPr id="46" name="Shape 43"/>
+          <p:cNvSpPr/>
+          <p:nvPr/>
+        </p:nvSpPr>
+        <p:spPr>
+          <a:xfrm>
+            <a:off x="7571232" y="5614416"/>
             <a:ext cx="548640" cy="256032"/>
           </a:xfrm>
           <a:prstGeom prst="rect">
@@ -13160,13 +13380,13 @@
       </p:sp>
       <p:sp>
         <p:nvSpPr>
-          <p:cNvPr id="41" name="Text 38"/>
-          <p:cNvSpPr/>
-          <p:nvPr/>
-        </p:nvSpPr>
-        <p:spPr>
-          <a:xfrm>
-            <a:off x="7571232" y="4901184"/>
+          <p:cNvPr id="47" name="Text 44"/>
+          <p:cNvSpPr/>
+          <p:nvPr/>
+        </p:nvSpPr>
+        <p:spPr>
+          <a:xfrm>
+            <a:off x="7571232" y="5614416"/>
             <a:ext cx="548640" cy="256032"/>
           </a:xfrm>
           <a:prstGeom prst="rect">
@@ -13199,13 +13419,13 @@
       </p:sp>
       <p:sp>
         <p:nvSpPr>
-          <p:cNvPr id="42" name="Text 39"/>
-          <p:cNvSpPr/>
-          <p:nvPr/>
-        </p:nvSpPr>
-        <p:spPr>
-          <a:xfrm>
-            <a:off x="8211312" y="4864608"/>
+          <p:cNvPr id="48" name="Text 45"/>
+          <p:cNvSpPr/>
+          <p:nvPr/>
+        </p:nvSpPr>
+        <p:spPr>
+          <a:xfrm>
+            <a:off x="8211312" y="5577840"/>
             <a:ext cx="3291840" cy="274320"/>
           </a:xfrm>
           <a:prstGeom prst="rect">
@@ -13238,13 +13458,13 @@
       </p:sp>
       <p:sp>
         <p:nvSpPr>
-          <p:cNvPr id="43" name="Text 40"/>
-          <p:cNvSpPr/>
-          <p:nvPr/>
-        </p:nvSpPr>
-        <p:spPr>
-          <a:xfrm>
-            <a:off x="8211312" y="5138928"/>
+          <p:cNvPr id="49" name="Text 46"/>
+          <p:cNvSpPr/>
+          <p:nvPr/>
+        </p:nvSpPr>
+        <p:spPr>
+          <a:xfrm>
+            <a:off x="8211312" y="5852160"/>
             <a:ext cx="3291840" cy="256032"/>
           </a:xfrm>
           <a:prstGeom prst="rect">
@@ -13305,167 +13525,14 @@
       </p:sp>
       <p:sp>
         <p:nvSpPr>
-          <p:cNvPr id="44" name="Shape 41"/>
-          <p:cNvSpPr/>
-          <p:nvPr/>
-        </p:nvSpPr>
-        <p:spPr>
-          <a:xfrm>
-            <a:off x="7406640" y="5522976"/>
-            <a:ext cx="4206240" cy="640080"/>
-          </a:xfrm>
-          <a:prstGeom prst="rect">
-            <a:avLst/>
-          </a:prstGeom>
-          <a:solidFill>
-            <a:srgbClr val="FFF5F5"/>
-          </a:solidFill>
-          <a:ln w="6350">
-            <a:solidFill>
-              <a:srgbClr val="E5E7EB"/>
-            </a:solidFill>
-            <a:prstDash val="solid"/>
-          </a:ln>
-        </p:spPr>
-      </p:sp>
-      <p:sp>
-        <p:nvSpPr>
-          <p:cNvPr id="45" name="Shape 42"/>
-          <p:cNvSpPr/>
-          <p:nvPr/>
-        </p:nvSpPr>
-        <p:spPr>
-          <a:xfrm>
-            <a:off x="7406640" y="5522976"/>
-            <a:ext cx="109728" cy="640080"/>
-          </a:xfrm>
-          <a:prstGeom prst="rect">
-            <a:avLst/>
-          </a:prstGeom>
-          <a:solidFill>
-            <a:srgbClr val="D72638"/>
-          </a:solidFill>
-          <a:ln w="12700">
-            <a:solidFill>
-              <a:srgbClr val="D72638"/>
-            </a:solidFill>
-            <a:prstDash val="solid"/>
-          </a:ln>
-        </p:spPr>
-      </p:sp>
-      <p:sp>
-        <p:nvSpPr>
-          <p:cNvPr id="46" name="Shape 43"/>
-          <p:cNvSpPr/>
-          <p:nvPr/>
-        </p:nvSpPr>
-        <p:spPr>
-          <a:xfrm>
-            <a:off x="7571232" y="5614416"/>
-            <a:ext cx="548640" cy="256032"/>
-          </a:xfrm>
-          <a:prstGeom prst="rect">
-            <a:avLst/>
-          </a:prstGeom>
-          <a:solidFill>
-            <a:srgbClr val="D72638"/>
-          </a:solidFill>
-          <a:ln w="12700">
-            <a:solidFill>
-              <a:srgbClr val="D72638"/>
-            </a:solidFill>
-            <a:prstDash val="solid"/>
-          </a:ln>
-        </p:spPr>
-      </p:sp>
-      <p:sp>
-        <p:nvSpPr>
-          <p:cNvPr id="47" name="Text 44"/>
-          <p:cNvSpPr/>
-          <p:nvPr/>
-        </p:nvSpPr>
-        <p:spPr>
-          <a:xfrm>
-            <a:off x="7571232" y="5614416"/>
-            <a:ext cx="548640" cy="256032"/>
-          </a:xfrm>
-          <a:prstGeom prst="rect">
-            <a:avLst/>
-          </a:prstGeom>
-          <a:noFill/>
-          <a:ln/>
-        </p:spPr>
-        <p:txBody>
-          <a:bodyPr wrap="square" lIns="0" tIns="0" rIns="0" bIns="0" rtlCol="0" anchor="ctr"/>
-          <a:lstStyle/>
-          <a:p>
-            <a:pPr algn="ctr" indent="0" marL="0">
-              <a:buNone/>
-            </a:pPr>
-            <a:r>
-              <a:rPr lang="en-US" sz="900" b="1" dirty="0">
-                <a:solidFill>
-                  <a:srgbClr val="FFFFFF"/>
-                </a:solidFill>
-                <a:latin typeface="맑은 고딕" pitchFamily="34" charset="0"/>
-                <a:ea typeface="맑은 고딕" pitchFamily="34" charset="-122"/>
-                <a:cs typeface="맑은 고딕" pitchFamily="34" charset="-120"/>
-              </a:rPr>
-              <a:t>긴급</a:t>
-            </a:r>
-            <a:endParaRPr lang="en-US" sz="900" dirty="0"/>
-          </a:p>
-        </p:txBody>
-      </p:sp>
-      <p:sp>
-        <p:nvSpPr>
-          <p:cNvPr id="48" name="Text 45"/>
-          <p:cNvSpPr/>
-          <p:nvPr/>
-        </p:nvSpPr>
-        <p:spPr>
-          <a:xfrm>
-            <a:off x="8211312" y="5577840"/>
-            <a:ext cx="3291840" cy="274320"/>
-          </a:xfrm>
-          <a:prstGeom prst="rect">
-            <a:avLst/>
-          </a:prstGeom>
-          <a:noFill/>
-          <a:ln/>
-        </p:spPr>
-        <p:txBody>
-          <a:bodyPr wrap="square" lIns="0" tIns="0" rIns="0" bIns="0" rtlCol="0" anchor="ctr"/>
-          <a:lstStyle/>
-          <a:p>
-            <a:pPr indent="0" marL="0">
-              <a:buNone/>
-            </a:pPr>
-            <a:r>
-              <a:rPr lang="en-US" sz="1000" b="1" dirty="0">
-                <a:solidFill>
-                  <a:srgbClr val="0B1220"/>
-                </a:solidFill>
-                <a:latin typeface="맑은 고딕" pitchFamily="34" charset="0"/>
-                <a:ea typeface="맑은 고딕" pitchFamily="34" charset="-122"/>
-                <a:cs typeface="맑은 고딕" pitchFamily="34" charset="-120"/>
-              </a:rPr>
-              <a:t>Light UV 99.9 Umbrella (7color)</a:t>
-            </a:r>
-            <a:endParaRPr lang="en-US" sz="1000" dirty="0"/>
-          </a:p>
-        </p:txBody>
-      </p:sp>
-      <p:sp>
-        <p:nvSpPr>
-          <p:cNvPr id="49" name="Text 46"/>
-          <p:cNvSpPr/>
-          <p:nvPr/>
-        </p:nvSpPr>
-        <p:spPr>
-          <a:xfrm>
-            <a:off x="8211312" y="5852160"/>
-            <a:ext cx="3291840" cy="256032"/>
+          <p:cNvPr id="50" name="Text 47"/>
+          <p:cNvSpPr/>
+          <p:nvPr/>
+        </p:nvSpPr>
+        <p:spPr>
+          <a:xfrm>
+            <a:off x="548640" y="6492240"/>
+            <a:ext cx="7315200" cy="274320"/>
           </a:xfrm>
           <a:prstGeom prst="rect">
             <a:avLst/>
@@ -13489,74 +13556,7 @@
                 <a:ea typeface="맑은 고딕" pitchFamily="34" charset="-122"/>
                 <a:cs typeface="맑은 고딕" pitchFamily="34" charset="-120"/>
               </a:rPr>
-              <a:t>컬러: 퍼플  ·  재고 0개</a:t>
-            </a:r>
-            <a:pPr indent="0" marL="0">
-              <a:buNone/>
-            </a:pPr>
-            <a:r>
-              <a:rPr lang="en-US" sz="1000" dirty="0">
-                <a:solidFill>
-                  <a:srgbClr val="6B7280"/>
-                </a:solidFill>
-                <a:latin typeface="맑은 고딕" pitchFamily="34" charset="0"/>
-                <a:ea typeface="맑은 고딕" pitchFamily="34" charset="-122"/>
-                <a:cs typeface="맑은 고딕" pitchFamily="34" charset="-120"/>
-              </a:rPr>
-              <a:t/>
-            </a:r>
-            <a:pPr indent="0" marL="0">
-              <a:buNone/>
-            </a:pPr>
-            <a:r>
-              <a:rPr lang="en-US" sz="1000" b="1" dirty="0">
-                <a:solidFill>
-                  <a:srgbClr val="D72638"/>
-                </a:solidFill>
-                <a:latin typeface="맑은 고딕" pitchFamily="34" charset="0"/>
-                <a:ea typeface="맑은 고딕" pitchFamily="34" charset="-122"/>
-                <a:cs typeface="맑은 고딕" pitchFamily="34" charset="-120"/>
-              </a:rPr>
-              <a:t/>
-            </a:r>
-            <a:endParaRPr lang="en-US" sz="900" dirty="0"/>
-          </a:p>
-        </p:txBody>
-      </p:sp>
-      <p:sp>
-        <p:nvSpPr>
-          <p:cNvPr id="50" name="Text 47"/>
-          <p:cNvSpPr/>
-          <p:nvPr/>
-        </p:nvSpPr>
-        <p:spPr>
-          <a:xfrm>
-            <a:off x="548640" y="6492240"/>
-            <a:ext cx="7315200" cy="274320"/>
-          </a:xfrm>
-          <a:prstGeom prst="rect">
-            <a:avLst/>
-          </a:prstGeom>
-          <a:noFill/>
-          <a:ln/>
-        </p:spPr>
-        <p:txBody>
-          <a:bodyPr wrap="square" lIns="0" tIns="0" rIns="0" bIns="0" rtlCol="0" anchor="ctr"/>
-          <a:lstStyle/>
-          <a:p>
-            <a:pPr indent="0" marL="0">
-              <a:buNone/>
-            </a:pPr>
-            <a:r>
-              <a:rPr lang="en-US" sz="900" dirty="0">
-                <a:solidFill>
-                  <a:srgbClr val="6B7280"/>
-                </a:solidFill>
-                <a:latin typeface="맑은 고딕" pitchFamily="34" charset="0"/>
-                <a:ea typeface="맑은 고딕" pitchFamily="34" charset="-122"/>
-                <a:cs typeface="맑은 고딕" pitchFamily="34" charset="-120"/>
-              </a:rPr>
-              <a:t>베스트 상품 리포트  ·  생성 2026-05-15 08:00</a:t>
+              <a:t>베스트 상품 리포트  ·  생성 2026-05-16 08:00</a:t>
             </a:r>
             <a:endParaRPr lang="en-US" sz="900" dirty="0"/>
           </a:p>
@@ -13769,7 +13769,7 @@
                 <a:ea typeface="맑은 고딕" pitchFamily="34" charset="-122"/>
                 <a:cs typeface="맑은 고딕" pitchFamily="34" charset="-120"/>
               </a:rPr>
-              <a:t>2026년 05월 15일 (금)</a:t>
+              <a:t>2026년 05월 16일 (토)</a:t>
             </a:r>
             <a:endParaRPr lang="en-US" sz="1200" dirty="0"/>
           </a:p>
@@ -13897,7 +13897,7 @@
                 <a:ea typeface="맑은 고딕" pitchFamily="34" charset="-122"/>
                 <a:cs typeface="맑은 고딕" pitchFamily="34" charset="-120"/>
               </a:rPr>
-              <a:t>🚨  긴급 리오더 53건    ·    주의 리오더 8건    ·    오늘 발주 검토 필수</a:t>
+              <a:t>🚨  긴급 리오더 57건    ·    주의 리오더 8건    ·    오늘 발주 검토 필수</a:t>
             </a:r>
             <a:pPr indent="0" marL="0">
               <a:buNone/>
@@ -14663,7 +14663,7 @@
                           <a:ea typeface="맑은 고딕" pitchFamily="34" charset="-122"/>
                           <a:cs typeface="맑은 고딕" pitchFamily="34" charset="-120"/>
                         </a:rPr>
-                        <a:t>180° Fast Charging Cable (8color) (컬러: 오렌지 / 기종 옵션: USB -&gt; C type)</a:t>
+                        <a:t>180° Fast Charging Cable (8color) (컬러: 네온그린 / 기종 옵션: C type -&gt; C type)</a:t>
                       </a:r>
                       <a:endParaRPr lang="en-US" sz="1100" dirty="0">
                         <a:latin typeface="맑은 고딕" charset="0"/>
@@ -14799,7 +14799,7 @@
                           <a:ea typeface="맑은 고딕" pitchFamily="34" charset="-122"/>
                           <a:cs typeface="맑은 고딕" pitchFamily="34" charset="-120"/>
                         </a:rPr>
-                        <a:t>105 개</a:t>
+                        <a:t>216 개</a:t>
                       </a:r>
                       <a:endParaRPr lang="en-US" sz="1100" dirty="0">
                         <a:latin typeface="맑은 고딕" charset="0"/>
@@ -15005,7 +15005,7 @@
                           <a:ea typeface="맑은 고딕" pitchFamily="34" charset="-122"/>
                           <a:cs typeface="맑은 고딕" pitchFamily="34" charset="-120"/>
                         </a:rPr>
-                        <a:t>ELECTRONIC</a:t>
+                        <a:t>ETC</a:t>
                       </a:r>
                       <a:endParaRPr lang="en-US" sz="1000" dirty="0">
                         <a:latin typeface="맑은 고딕" charset="0"/>
@@ -15073,7 +15073,7 @@
                           <a:ea typeface="맑은 고딕" pitchFamily="34" charset="-122"/>
                           <a:cs typeface="맑은 고딕" pitchFamily="34" charset="-120"/>
                         </a:rPr>
-                        <a:t>180° Fast Charging Cable (8color) (컬러: 민트 / 기종 옵션: C type -&gt; C type)</a:t>
+                        <a:t>Compact Phone Stand (6color) (컬러: 화이트)</a:t>
                       </a:r>
                       <a:endParaRPr lang="en-US" sz="1100" dirty="0">
                         <a:latin typeface="맑은 고딕" charset="0"/>
@@ -15209,7 +15209,7 @@
                           <a:ea typeface="맑은 고딕" pitchFamily="34" charset="-122"/>
                           <a:cs typeface="맑은 고딕" pitchFamily="34" charset="-120"/>
                         </a:rPr>
-                        <a:t>42 개</a:t>
+                        <a:t>35 개</a:t>
                       </a:r>
                       <a:endParaRPr lang="en-US" sz="1100" dirty="0">
                         <a:latin typeface="맑은 고딕" charset="0"/>
@@ -15483,7 +15483,7 @@
                           <a:ea typeface="맑은 고딕" pitchFamily="34" charset="-122"/>
                           <a:cs typeface="맑은 고딕" pitchFamily="34" charset="-120"/>
                         </a:rPr>
-                        <a:t>Jacquard Fast Charging Cable (7color) (컬러: 퍼플 / 기종옵션: C-Apple 8pin / 길이: 2m)</a:t>
+                        <a:t>180° Fast Charging Cable (8color) (컬러: 네온그린 / 기종 옵션: USB -&gt; Apple 8pin)</a:t>
                       </a:r>
                       <a:endParaRPr lang="en-US" sz="1100" dirty="0">
                         <a:latin typeface="맑은 고딕" charset="0"/>
@@ -15551,7 +15551,7 @@
                           <a:ea typeface="맑은 고딕" pitchFamily="34" charset="-122"/>
                           <a:cs typeface="맑은 고딕" pitchFamily="34" charset="-120"/>
                         </a:rPr>
-                        <a:t>17</a:t>
+                        <a:t>0</a:t>
                       </a:r>
                       <a:endParaRPr lang="en-US" sz="1100" dirty="0">
                         <a:latin typeface="맑은 고딕" charset="0"/>
@@ -15619,7 +15619,7 @@
                           <a:ea typeface="맑은 고딕" pitchFamily="34" charset="-122"/>
                           <a:cs typeface="맑은 고딕" pitchFamily="34" charset="-120"/>
                         </a:rPr>
-                        <a:t>3 개</a:t>
+                        <a:t>29 개</a:t>
                       </a:r>
                       <a:endParaRPr lang="en-US" sz="1100" dirty="0">
                         <a:latin typeface="맑은 고딕" charset="0"/>
@@ -15757,7 +15757,7 @@
                           <a:ea typeface="맑은 고딕" pitchFamily="34" charset="-122"/>
                           <a:cs typeface="맑은 고딕" pitchFamily="34" charset="-120"/>
                         </a:rPr>
-                        <a:t>CT</a:t>
+                        <a:t>PR</a:t>
                       </a:r>
                       <a:endParaRPr lang="en-US" sz="1100" dirty="0">
                         <a:latin typeface="맑은 고딕" charset="0"/>
@@ -15825,7 +15825,7 @@
                           <a:ea typeface="맑은 고딕" pitchFamily="34" charset="-122"/>
                           <a:cs typeface="맑은 고딕" pitchFamily="34" charset="-120"/>
                         </a:rPr>
-                        <a:t>Ring</a:t>
+                        <a:t>ELECTRONIC</a:t>
                       </a:r>
                       <a:endParaRPr lang="en-US" sz="1000" dirty="0">
                         <a:latin typeface="맑은 고딕" charset="0"/>
@@ -15893,7 +15893,7 @@
                           <a:ea typeface="맑은 고딕" pitchFamily="34" charset="-122"/>
                           <a:cs typeface="맑은 고딕" pitchFamily="34" charset="-120"/>
                         </a:rPr>
-                        <a:t>"Whisow" 925 Open Ring</a:t>
+                        <a:t>180° Fast Charging Cable (8color) (컬러: 민트 / 기종 옵션: USB -&gt; Apple 8pin)</a:t>
                       </a:r>
                       <a:endParaRPr lang="en-US" sz="1100" dirty="0">
                         <a:latin typeface="맑은 고딕" charset="0"/>
@@ -15961,7 +15961,7 @@
                           <a:ea typeface="맑은 고딕" pitchFamily="34" charset="-122"/>
                           <a:cs typeface="맑은 고딕" pitchFamily="34" charset="-120"/>
                         </a:rPr>
-                        <a:t>1</a:t>
+                        <a:t>0</a:t>
                       </a:r>
                       <a:endParaRPr lang="en-US" sz="1100" dirty="0">
                         <a:latin typeface="맑은 고딕" charset="0"/>
@@ -16029,7 +16029,7 @@
                           <a:ea typeface="맑은 고딕" pitchFamily="34" charset="-122"/>
                           <a:cs typeface="맑은 고딕" pitchFamily="34" charset="-120"/>
                         </a:rPr>
-                        <a:t>1 개</a:t>
+                        <a:t>28 개</a:t>
                       </a:r>
                       <a:endParaRPr lang="en-US" sz="1100" dirty="0">
                         <a:latin typeface="맑은 고딕" charset="0"/>
@@ -16235,7 +16235,7 @@
                           <a:ea typeface="맑은 고딕" pitchFamily="34" charset="-122"/>
                           <a:cs typeface="맑은 고딕" pitchFamily="34" charset="-120"/>
                         </a:rPr>
-                        <a:t>★Season off★</a:t>
+                        <a:t>Necklace</a:t>
                       </a:r>
                       <a:endParaRPr lang="en-US" sz="1000" dirty="0">
                         <a:latin typeface="맑은 고딕" charset="0"/>
@@ -16303,7 +16303,7 @@
                           <a:ea typeface="맑은 고딕" pitchFamily="34" charset="-122"/>
                           <a:cs typeface="맑은 고딕" pitchFamily="34" charset="-120"/>
                         </a:rPr>
-                        <a:t>8-Ball Smart Tok</a:t>
+                        <a:t>Marquise Necklace</a:t>
                       </a:r>
                       <a:endParaRPr lang="en-US" sz="1100" dirty="0">
                         <a:latin typeface="맑은 고딕" charset="0"/>
@@ -16371,7 +16371,7 @@
                           <a:ea typeface="맑은 고딕" pitchFamily="34" charset="-122"/>
                           <a:cs typeface="맑은 고딕" pitchFamily="34" charset="-120"/>
                         </a:rPr>
-                        <a:t>5</a:t>
+                        <a:t>0</a:t>
                       </a:r>
                       <a:endParaRPr lang="en-US" sz="1100" dirty="0">
                         <a:latin typeface="맑은 고딕" charset="0"/>
@@ -16439,7 +16439,7 @@
                           <a:ea typeface="맑은 고딕" pitchFamily="34" charset="-122"/>
                           <a:cs typeface="맑은 고딕" pitchFamily="34" charset="-120"/>
                         </a:rPr>
-                        <a:t>0 개</a:t>
+                        <a:t>8 개</a:t>
                       </a:r>
                       <a:endParaRPr lang="en-US" sz="1100" dirty="0">
                         <a:latin typeface="맑은 고딕" charset="0"/>
@@ -16645,7 +16645,7 @@
                           <a:ea typeface="맑은 고딕" pitchFamily="34" charset="-122"/>
                           <a:cs typeface="맑은 고딕" pitchFamily="34" charset="-120"/>
                         </a:rPr>
-                        <a:t>Necklace</a:t>
+                        <a:t>★Season off★</a:t>
                       </a:r>
                       <a:endParaRPr lang="en-US" sz="1000" dirty="0">
                         <a:latin typeface="맑은 고딕" charset="0"/>
@@ -16713,7 +16713,7 @@
                           <a:ea typeface="맑은 고딕" pitchFamily="34" charset="-122"/>
                           <a:cs typeface="맑은 고딕" pitchFamily="34" charset="-120"/>
                         </a:rPr>
-                        <a:t>B-Flower Necklace (Size: 2 Size)</a:t>
+                        <a:t>Tangle Keychain</a:t>
                       </a:r>
                       <a:endParaRPr lang="en-US" sz="1100" dirty="0">
                         <a:latin typeface="맑은 고딕" charset="0"/>
@@ -16781,7 +16781,7 @@
                           <a:ea typeface="맑은 고딕" pitchFamily="34" charset="-122"/>
                           <a:cs typeface="맑은 고딕" pitchFamily="34" charset="-120"/>
                         </a:rPr>
-                        <a:t>4</a:t>
+                        <a:t>3</a:t>
                       </a:r>
                       <a:endParaRPr lang="en-US" sz="1100" dirty="0">
                         <a:latin typeface="맑은 고딕" charset="0"/>
@@ -16849,7 +16849,7 @@
                           <a:ea typeface="맑은 고딕" pitchFamily="34" charset="-122"/>
                           <a:cs typeface="맑은 고딕" pitchFamily="34" charset="-120"/>
                         </a:rPr>
-                        <a:t>0 개</a:t>
+                        <a:t>1 개</a:t>
                       </a:r>
                       <a:endParaRPr lang="en-US" sz="1100" dirty="0">
                         <a:latin typeface="맑은 고딕" charset="0"/>
@@ -17123,7 +17123,7 @@
                           <a:ea typeface="맑은 고딕" pitchFamily="34" charset="-122"/>
                           <a:cs typeface="맑은 고딕" pitchFamily="34" charset="-120"/>
                         </a:rPr>
-                        <a:t>Tangle Keychain</a:t>
+                        <a:t>8-Ball Smart Tok</a:t>
                       </a:r>
                       <a:endParaRPr lang="en-US" sz="1100" dirty="0">
                         <a:latin typeface="맑은 고딕" charset="0"/>
@@ -17191,7 +17191,7 @@
                           <a:ea typeface="맑은 고딕" pitchFamily="34" charset="-122"/>
                           <a:cs typeface="맑은 고딕" pitchFamily="34" charset="-120"/>
                         </a:rPr>
-                        <a:t>4</a:t>
+                        <a:t>5</a:t>
                       </a:r>
                       <a:endParaRPr lang="en-US" sz="1100" dirty="0">
                         <a:latin typeface="맑은 고딕" charset="0"/>
@@ -17533,7 +17533,7 @@
                           <a:ea typeface="맑은 고딕" pitchFamily="34" charset="-122"/>
                           <a:cs typeface="맑은 고딕" pitchFamily="34" charset="-120"/>
                         </a:rPr>
-                        <a:t>B-Flower Necklace (Size: 1 Size)</a:t>
+                        <a:t>B-Flower Necklace (Size: 2 Size)</a:t>
                       </a:r>
                       <a:endParaRPr lang="en-US" sz="1100" dirty="0">
                         <a:latin typeface="맑은 고딕" charset="0"/>
@@ -17601,7 +17601,7 @@
                           <a:ea typeface="맑은 고딕" pitchFamily="34" charset="-122"/>
                           <a:cs typeface="맑은 고딕" pitchFamily="34" charset="-120"/>
                         </a:rPr>
-                        <a:t>0</a:t>
+                        <a:t>4</a:t>
                       </a:r>
                       <a:endParaRPr lang="en-US" sz="1100" dirty="0">
                         <a:latin typeface="맑은 고딕" charset="0"/>
@@ -17875,7 +17875,7 @@
                           <a:ea typeface="맑은 고딕" pitchFamily="34" charset="-122"/>
                           <a:cs typeface="맑은 고딕" pitchFamily="34" charset="-120"/>
                         </a:rPr>
-                        <a:t>Ring</a:t>
+                        <a:t>Necklace</a:t>
                       </a:r>
                       <a:endParaRPr lang="en-US" sz="1000" dirty="0">
                         <a:latin typeface="맑은 고딕" charset="0"/>
@@ -17943,7 +17943,7 @@
                           <a:ea typeface="맑은 고딕" pitchFamily="34" charset="-122"/>
                           <a:cs typeface="맑은 고딕" pitchFamily="34" charset="-120"/>
                         </a:rPr>
-                        <a:t>[SILVER925] CH.alban Open Ring</a:t>
+                        <a:t>B-Flower Necklace (Size: 1 Size)</a:t>
                       </a:r>
                       <a:endParaRPr lang="en-US" sz="1100" dirty="0">
                         <a:latin typeface="맑은 고딕" charset="0"/>
@@ -18168,7 +18168,7 @@
                 <a:ea typeface="맑은 고딕" pitchFamily="34" charset="-122"/>
                 <a:cs typeface="맑은 고딕" pitchFamily="34" charset="-120"/>
               </a:rPr>
-              <a:t>외 44건 더 있음 — 상세는 시트에서 확인</a:t>
+              <a:t>외 48건 더 있음 — 상세는 시트에서 확인</a:t>
             </a:r>
             <a:endParaRPr lang="en-US" sz="1000" dirty="0"/>
           </a:p>
@@ -18207,7 +18207,7 @@
                 <a:ea typeface="맑은 고딕" pitchFamily="34" charset="-122"/>
                 <a:cs typeface="맑은 고딕" pitchFamily="34" charset="-120"/>
               </a:rPr>
-              <a:t>베스트 상품 리포트  ·  생성 2026-05-15 08:00</a:t>
+              <a:t>베스트 상품 리포트  ·  생성 2026-05-16 08:00</a:t>
             </a:r>
             <a:endParaRPr lang="en-US" sz="900" dirty="0"/>
           </a:p>
@@ -18420,7 +18420,7 @@
                 <a:ea typeface="맑은 고딕" pitchFamily="34" charset="-122"/>
                 <a:cs typeface="맑은 고딕" pitchFamily="34" charset="-120"/>
               </a:rPr>
-              <a:t>2026년 05월 15일 (금)</a:t>
+              <a:t>2026년 05월 16일 (토)</a:t>
             </a:r>
             <a:endParaRPr lang="en-US" sz="1200" dirty="0"/>
           </a:p>
@@ -18587,7 +18587,7 @@
                 <a:ea typeface="맑은 고딕" pitchFamily="34" charset="-122"/>
                 <a:cs typeface="맑은 고딕" pitchFamily="34" charset="-120"/>
               </a:rPr>
-              <a:t>Google Sheet '브랜드 재고현황'  ·  최신화 2026-05-15 08:00</a:t>
+              <a:t>Google Sheet '브랜드 재고현황'  ·  최신화 2026-05-16 08:00</a:t>
             </a:r>
             <a:endParaRPr lang="en-US" sz="1100" dirty="0"/>
           </a:p>
@@ -19230,7 +19230,7 @@
                 <a:ea typeface="맑은 고딕" pitchFamily="34" charset="-122"/>
                 <a:cs typeface="맑은 고딕" pitchFamily="34" charset="-120"/>
               </a:rPr>
-              <a:t>✅ 3개 브랜드 모두 정상 추출  ·  24h 출고 기준 (2026-05-14 08:00 → 2026-05-15 08:00) · 신규 SKU 16건은 결제완료 기준</a:t>
+              <a:t>✅ 3개 브랜드 모두 정상 추출  ·  24h 출고 기준 (2026-05-15 08:00 → 2026-05-16 08:00) · 신규 SKU 12건은 결제완료 기준</a:t>
             </a:r>
             <a:endParaRPr lang="en-US" sz="1000" dirty="0"/>
           </a:p>
@@ -19269,7 +19269,7 @@
                 <a:ea typeface="맑은 고딕" pitchFamily="34" charset="-122"/>
                 <a:cs typeface="맑은 고딕" pitchFamily="34" charset="-120"/>
               </a:rPr>
-              <a:t>베스트 상품 리포트  ·  생성 2026-05-15 08:00</a:t>
+              <a:t>베스트 상품 리포트  ·  생성 2026-05-16 08:00</a:t>
             </a:r>
             <a:endParaRPr lang="en-US" sz="900" dirty="0"/>
           </a:p>

</xml_diff>

<commit_message>
chore: 매출 PPT 업로드 (best-sellers-2026-05-17.pptx) [auto]
</commit_message>
<xml_diff>
--- a/data/sales-report.pptx
+++ b/data/sales-report.pptx
@@ -1648,7 +1648,7 @@
                 <a:ea typeface="맑은 고딕" pitchFamily="34" charset="-122"/>
                 <a:cs typeface="맑은 고딕" pitchFamily="34" charset="-120"/>
               </a:rPr>
-              <a:t>2026년 05월 16일 (토)  ·  24h 출고 기준</a:t>
+              <a:t>2026년 05월 17일 (일)  ·  24h 출고 기준</a:t>
             </a:r>
             <a:endParaRPr lang="en-US" sz="2200" dirty="0"/>
           </a:p>
@@ -1726,7 +1726,7 @@
                 <a:ea typeface="맑은 고딕" pitchFamily="34" charset="-122"/>
                 <a:cs typeface="맑은 고딕" pitchFamily="34" charset="-120"/>
               </a:rPr>
-              <a:t>05.16</a:t>
+              <a:t>05.17</a:t>
             </a:r>
             <a:endParaRPr lang="en-US" sz="7200" dirty="0"/>
           </a:p>
@@ -1765,7 +1765,7 @@
                 <a:ea typeface="맑은 고딕" pitchFamily="34" charset="-122"/>
                 <a:cs typeface="맑은 고딕" pitchFamily="34" charset="-120"/>
               </a:rPr>
-              <a:t>토요일</a:t>
+              <a:t>일요일</a:t>
             </a:r>
             <a:endParaRPr lang="en-US" sz="1400" dirty="0"/>
           </a:p>
@@ -1804,7 +1804,7 @@
                 <a:ea typeface="맑은 고딕" pitchFamily="34" charset="-122"/>
                 <a:cs typeface="맑은 고딕" pitchFamily="34" charset="-120"/>
               </a:rPr>
-              <a:t>생성 2026-05-16 08:00  ·  Google Sheet 자동 동기</a:t>
+              <a:t>생성 2026-05-17 08:00  ·  Google Sheet 자동 동기</a:t>
             </a:r>
             <a:endParaRPr lang="en-US" sz="1000" dirty="0"/>
           </a:p>
@@ -1978,7 +1978,7 @@
                 <a:ea typeface="맑은 고딕" pitchFamily="34" charset="-122"/>
                 <a:cs typeface="맑은 고딕" pitchFamily="34" charset="-120"/>
               </a:rPr>
-              <a:t>2026년 05월 16일 (토)</a:t>
+              <a:t>2026년 05월 17일 (일)</a:t>
             </a:r>
             <a:endParaRPr lang="en-US" sz="1200" dirty="0"/>
           </a:p>
@@ -2145,7 +2145,7 @@
                 <a:ea typeface="맑은 고딕" pitchFamily="34" charset="-122"/>
                 <a:cs typeface="맑은 고딕" pitchFamily="34" charset="-120"/>
               </a:rPr>
-              <a:t>346 개</a:t>
+              <a:t>652 개</a:t>
             </a:r>
             <a:endParaRPr lang="en-US" sz="3600" dirty="0"/>
           </a:p>
@@ -2312,7 +2312,7 @@
                 <a:ea typeface="맑은 고딕" pitchFamily="34" charset="-122"/>
                 <a:cs typeface="맑은 고딕" pitchFamily="34" charset="-120"/>
               </a:rPr>
-              <a:t>57 건</a:t>
+              <a:t>59 건</a:t>
             </a:r>
             <a:endParaRPr lang="en-US" sz="3200" dirty="0"/>
           </a:p>
@@ -2479,7 +2479,7 @@
                 <a:ea typeface="맑은 고딕" pitchFamily="34" charset="-122"/>
                 <a:cs typeface="맑은 고딕" pitchFamily="34" charset="-120"/>
               </a:rPr>
-              <a:t>8 건</a:t>
+              <a:t>9 건</a:t>
             </a:r>
             <a:endParaRPr lang="en-US" sz="3200" dirty="0"/>
           </a:p>
@@ -3482,7 +3482,7 @@
                           <a:ea typeface="맑은 고딕" pitchFamily="34" charset="-122"/>
                           <a:cs typeface="맑은 고딕" pitchFamily="34" charset="-120"/>
                         </a:rPr>
-                        <a:t>CT</a:t>
+                        <a:t>6A</a:t>
                       </a:r>
                       <a:endParaRPr lang="en-US" sz="1100" dirty="0">
                         <a:latin typeface="맑은 고딕" charset="0"/>
@@ -3547,7 +3547,7 @@
                           <a:ea typeface="맑은 고딕" pitchFamily="34" charset="-122"/>
                           <a:cs typeface="맑은 고딕" pitchFamily="34" charset="-120"/>
                         </a:rPr>
-                        <a:t>Necklace</a:t>
+                        <a:t>Ring</a:t>
                       </a:r>
                       <a:endParaRPr lang="en-US" sz="1000" dirty="0">
                         <a:latin typeface="맑은 고딕" charset="0"/>
@@ -3612,7 +3612,7 @@
                           <a:ea typeface="맑은 고딕" pitchFamily="34" charset="-122"/>
                           <a:cs typeface="맑은 고딕" pitchFamily="34" charset="-120"/>
                         </a:rPr>
-                        <a:t>CandyPOP Necklace (사이즈: 1size (41.5~47cm))</a:t>
+                        <a:t>[SILVER925] CH.alban Open Ring</a:t>
                       </a:r>
                       <a:endParaRPr lang="en-US" sz="1100" dirty="0">
                         <a:latin typeface="맑은 고딕" charset="0"/>
@@ -3677,7 +3677,7 @@
                           <a:ea typeface="맑은 고딕" pitchFamily="34" charset="-122"/>
                           <a:cs typeface="맑은 고딕" pitchFamily="34" charset="-120"/>
                         </a:rPr>
-                        <a:t>45 개</a:t>
+                        <a:t>68 개</a:t>
                       </a:r>
                       <a:endParaRPr lang="en-US" sz="1400" dirty="0">
                         <a:latin typeface="맑은 고딕" charset="0"/>
@@ -3809,7 +3809,7 @@
                           <a:ea typeface="맑은 고딕" pitchFamily="34" charset="-122"/>
                           <a:cs typeface="맑은 고딕" pitchFamily="34" charset="-120"/>
                         </a:rPr>
-                        <a:t>CT</a:t>
+                        <a:t>6A</a:t>
                       </a:r>
                       <a:endParaRPr lang="en-US" sz="1100" dirty="0">
                         <a:latin typeface="맑은 고딕" charset="0"/>
@@ -3874,7 +3874,7 @@
                           <a:ea typeface="맑은 고딕" pitchFamily="34" charset="-122"/>
                           <a:cs typeface="맑은 고딕" pitchFamily="34" charset="-120"/>
                         </a:rPr>
-                        <a:t>Necklace</a:t>
+                        <a:t>Ring</a:t>
                       </a:r>
                       <a:endParaRPr lang="en-US" sz="1000" dirty="0">
                         <a:latin typeface="맑은 고딕" charset="0"/>
@@ -3939,7 +3939,7 @@
                           <a:ea typeface="맑은 고딕" pitchFamily="34" charset="-122"/>
                           <a:cs typeface="맑은 고딕" pitchFamily="34" charset="-120"/>
                         </a:rPr>
-                        <a:t>CandyPOP Necklace (사이즈: 2size (47~52cm))</a:t>
+                        <a:t>[SILVER925] Guyeong Open Ring v3.0 (silver)</a:t>
                       </a:r>
                       <a:endParaRPr lang="en-US" sz="1100" dirty="0">
                         <a:latin typeface="맑은 고딕" charset="0"/>
@@ -4004,7 +4004,7 @@
                           <a:ea typeface="맑은 고딕" pitchFamily="34" charset="-122"/>
                           <a:cs typeface="맑은 고딕" pitchFamily="34" charset="-120"/>
                         </a:rPr>
-                        <a:t>40 개</a:t>
+                        <a:t>62 개</a:t>
                       </a:r>
                       <a:endParaRPr lang="en-US" sz="1400" dirty="0">
                         <a:latin typeface="맑은 고딕" charset="0"/>
@@ -4136,7 +4136,7 @@
                           <a:ea typeface="맑은 고딕" pitchFamily="34" charset="-122"/>
                           <a:cs typeface="맑은 고딕" pitchFamily="34" charset="-120"/>
                         </a:rPr>
-                        <a:t>6A</a:t>
+                        <a:t>CT</a:t>
                       </a:r>
                       <a:endParaRPr lang="en-US" sz="1100" dirty="0">
                         <a:latin typeface="맑은 고딕" charset="0"/>
@@ -4201,7 +4201,7 @@
                           <a:ea typeface="맑은 고딕" pitchFamily="34" charset="-122"/>
                           <a:cs typeface="맑은 고딕" pitchFamily="34" charset="-120"/>
                         </a:rPr>
-                        <a:t>Ring</a:t>
+                        <a:t>Necklace</a:t>
                       </a:r>
                       <a:endParaRPr lang="en-US" sz="1000" dirty="0">
                         <a:latin typeface="맑은 고딕" charset="0"/>
@@ -4266,7 +4266,7 @@
                           <a:ea typeface="맑은 고딕" pitchFamily="34" charset="-122"/>
                           <a:cs typeface="맑은 고딕" pitchFamily="34" charset="-120"/>
                         </a:rPr>
-                        <a:t>[SILVER925] Guyeong Open Ring v3.0 (silver)</a:t>
+                        <a:t>CandyPOP Necklace (사이즈: 1size (41.5~47cm))</a:t>
                       </a:r>
                       <a:endParaRPr lang="en-US" sz="1100" dirty="0">
                         <a:latin typeface="맑은 고딕" charset="0"/>
@@ -4331,7 +4331,7 @@
                           <a:ea typeface="맑은 고딕" pitchFamily="34" charset="-122"/>
                           <a:cs typeface="맑은 고딕" pitchFamily="34" charset="-120"/>
                         </a:rPr>
-                        <a:t>21 개</a:t>
+                        <a:t>51 개</a:t>
                       </a:r>
                       <a:endParaRPr lang="en-US" sz="1400" dirty="0">
                         <a:latin typeface="맑은 고딕" charset="0"/>
@@ -4593,7 +4593,7 @@
                           <a:ea typeface="맑은 고딕" pitchFamily="34" charset="-122"/>
                           <a:cs typeface="맑은 고딕" pitchFamily="34" charset="-120"/>
                         </a:rPr>
-                        <a:t>ThreadDuo Necklace</a:t>
+                        <a:t>CandyPOP Necklace (사이즈: 2size (47~52cm))</a:t>
                       </a:r>
                       <a:endParaRPr lang="en-US" sz="1100" dirty="0">
                         <a:latin typeface="맑은 고딕" charset="0"/>
@@ -4658,7 +4658,7 @@
                           <a:ea typeface="맑은 고딕" pitchFamily="34" charset="-122"/>
                           <a:cs typeface="맑은 고딕" pitchFamily="34" charset="-120"/>
                         </a:rPr>
-                        <a:t>18 개</a:t>
+                        <a:t>48 개</a:t>
                       </a:r>
                       <a:endParaRPr lang="en-US" sz="1200" dirty="0">
                         <a:latin typeface="맑은 고딕" charset="0"/>
@@ -4920,7 +4920,7 @@
                           <a:ea typeface="맑은 고딕" pitchFamily="34" charset="-122"/>
                           <a:cs typeface="맑은 고딕" pitchFamily="34" charset="-120"/>
                         </a:rPr>
-                        <a:t>RichardKokser Necklace</a:t>
+                        <a:t>Tiny Cross Necklace</a:t>
                       </a:r>
                       <a:endParaRPr lang="en-US" sz="1100" dirty="0">
                         <a:latin typeface="맑은 고딕" charset="0"/>
@@ -4985,7 +4985,7 @@
                           <a:ea typeface="맑은 고딕" pitchFamily="34" charset="-122"/>
                           <a:cs typeface="맑은 고딕" pitchFamily="34" charset="-120"/>
                         </a:rPr>
-                        <a:t>11 개</a:t>
+                        <a:t>29 개</a:t>
                       </a:r>
                       <a:endParaRPr lang="en-US" sz="1200" dirty="0">
                         <a:latin typeface="맑은 고딕" charset="0"/>
@@ -5071,7 +5071,7 @@
                 <a:ea typeface="맑은 고딕" pitchFamily="34" charset="-122"/>
                 <a:cs typeface="맑은 고딕" pitchFamily="34" charset="-120"/>
               </a:rPr>
-              <a:t>베스트 상품 리포트  ·  생성 2026-05-16 08:00</a:t>
+              <a:t>베스트 상품 리포트  ·  생성 2026-05-17 08:00</a:t>
             </a:r>
             <a:endParaRPr lang="en-US" sz="900" dirty="0"/>
           </a:p>
@@ -5284,7 +5284,7 @@
                 <a:ea typeface="맑은 고딕" pitchFamily="34" charset="-122"/>
                 <a:cs typeface="맑은 고딕" pitchFamily="34" charset="-120"/>
               </a:rPr>
-              <a:t>2026년 05월 16일 (토)</a:t>
+              <a:t>2026년 05월 17일 (일)</a:t>
             </a:r>
             <a:endParaRPr lang="en-US" sz="1200" dirty="0"/>
           </a:p>
@@ -5451,7 +5451,7 @@
                 <a:ea typeface="맑은 고딕" pitchFamily="34" charset="-122"/>
                 <a:cs typeface="맑은 고딕" pitchFamily="34" charset="-120"/>
               </a:rPr>
-              <a:t>202 개</a:t>
+              <a:t>499 개</a:t>
             </a:r>
             <a:endParaRPr lang="en-US" sz="3600" dirty="0"/>
           </a:p>
@@ -5579,7 +5579,7 @@
                 <a:ea typeface="맑은 고딕" pitchFamily="34" charset="-122"/>
                 <a:cs typeface="맑은 고딕" pitchFamily="34" charset="-120"/>
               </a:rPr>
-              <a:t>[SILVER925] Guyeong Open Ring v3.0 (silver)</a:t>
+              <a:t>[SILVER925] CH.alban Open Ring</a:t>
             </a:r>
             <a:endParaRPr lang="en-US" sz="1800" dirty="0"/>
           </a:p>
@@ -5657,7 +5657,7 @@
                 <a:ea typeface="맑은 고딕" pitchFamily="34" charset="-122"/>
                 <a:cs typeface="맑은 고딕" pitchFamily="34" charset="-120"/>
               </a:rPr>
-              <a:t>21</a:t>
+              <a:t>68</a:t>
             </a:r>
             <a:endParaRPr lang="en-US" sz="4400" dirty="0"/>
           </a:p>
@@ -6191,7 +6191,7 @@
                           <a:ea typeface="맑은 고딕" pitchFamily="34" charset="-122"/>
                           <a:cs typeface="맑은 고딕" pitchFamily="34" charset="-120"/>
                         </a:rPr>
-                        <a:t>[SILVER925] Guyeong Open Ring v3.0 (silver)</a:t>
+                        <a:t>[SILVER925] CH.alban Open Ring</a:t>
                       </a:r>
                       <a:endParaRPr lang="en-US" sz="1100" dirty="0">
                         <a:latin typeface="맑은 고딕" charset="0"/>
@@ -6256,7 +6256,7 @@
                           <a:ea typeface="맑은 고딕" pitchFamily="34" charset="-122"/>
                           <a:cs typeface="맑은 고딕" pitchFamily="34" charset="-120"/>
                         </a:rPr>
-                        <a:t>21 개</a:t>
+                        <a:t>68 개</a:t>
                       </a:r>
                       <a:endParaRPr lang="en-US" sz="1400" dirty="0">
                         <a:latin typeface="맑은 고딕" charset="0"/>
@@ -6388,7 +6388,7 @@
                           <a:ea typeface="맑은 고딕" pitchFamily="34" charset="-122"/>
                           <a:cs typeface="맑은 고딕" pitchFamily="34" charset="-120"/>
                         </a:rPr>
-                        <a:t>Necklace</a:t>
+                        <a:t>Ring</a:t>
                       </a:r>
                       <a:endParaRPr lang="en-US" sz="1000" dirty="0">
                         <a:latin typeface="맑은 고딕" charset="0"/>
@@ -6453,7 +6453,7 @@
                           <a:ea typeface="맑은 고딕" pitchFamily="34" charset="-122"/>
                           <a:cs typeface="맑은 고딕" pitchFamily="34" charset="-120"/>
                         </a:rPr>
-                        <a:t>RichardKokser Necklace</a:t>
+                        <a:t>[SILVER925] Guyeong Open Ring v3.0 (silver)</a:t>
                       </a:r>
                       <a:endParaRPr lang="en-US" sz="1100" dirty="0">
                         <a:latin typeface="맑은 고딕" charset="0"/>
@@ -6518,7 +6518,7 @@
                           <a:ea typeface="맑은 고딕" pitchFamily="34" charset="-122"/>
                           <a:cs typeface="맑은 고딕" pitchFamily="34" charset="-120"/>
                         </a:rPr>
-                        <a:t>11 개</a:t>
+                        <a:t>62 개</a:t>
                       </a:r>
                       <a:endParaRPr lang="en-US" sz="1200" dirty="0">
                         <a:latin typeface="맑은 고딕" charset="0"/>
@@ -6650,7 +6650,7 @@
                           <a:ea typeface="맑은 고딕" pitchFamily="34" charset="-122"/>
                           <a:cs typeface="맑은 고딕" pitchFamily="34" charset="-120"/>
                         </a:rPr>
-                        <a:t>Ring</a:t>
+                        <a:t>Necklace</a:t>
                       </a:r>
                       <a:endParaRPr lang="en-US" sz="1000" dirty="0">
                         <a:latin typeface="맑은 고딕" charset="0"/>
@@ -6715,7 +6715,7 @@
                           <a:ea typeface="맑은 고딕" pitchFamily="34" charset="-122"/>
                           <a:cs typeface="맑은 고딕" pitchFamily="34" charset="-120"/>
                         </a:rPr>
-                        <a:t>[SILVER925] Eramam Open Ring</a:t>
+                        <a:t>Tiny Cross Necklace</a:t>
                       </a:r>
                       <a:endParaRPr lang="en-US" sz="1100" dirty="0">
                         <a:latin typeface="맑은 고딕" charset="0"/>
@@ -6780,7 +6780,7 @@
                           <a:ea typeface="맑은 고딕" pitchFamily="34" charset="-122"/>
                           <a:cs typeface="맑은 고딕" pitchFamily="34" charset="-120"/>
                         </a:rPr>
-                        <a:t>10 개</a:t>
+                        <a:t>29 개</a:t>
                       </a:r>
                       <a:endParaRPr lang="en-US" sz="1200" dirty="0">
                         <a:latin typeface="맑은 고딕" charset="0"/>
@@ -6912,7 +6912,7 @@
                           <a:ea typeface="맑은 고딕" pitchFamily="34" charset="-122"/>
                           <a:cs typeface="맑은 고딕" pitchFamily="34" charset="-120"/>
                         </a:rPr>
-                        <a:t>Necklace</a:t>
+                        <a:t>Ring</a:t>
                       </a:r>
                       <a:endParaRPr lang="en-US" sz="1000" dirty="0">
                         <a:latin typeface="맑은 고딕" charset="0"/>
@@ -6977,7 +6977,7 @@
                           <a:ea typeface="맑은 고딕" pitchFamily="34" charset="-122"/>
                           <a:cs typeface="맑은 고딕" pitchFamily="34" charset="-120"/>
                         </a:rPr>
-                        <a:t>Tiny Cross Necklace</a:t>
+                        <a:t>[SILVER925] Starly Open Ring</a:t>
                       </a:r>
                       <a:endParaRPr lang="en-US" sz="1100" dirty="0">
                         <a:latin typeface="맑은 고딕" charset="0"/>
@@ -7042,7 +7042,7 @@
                           <a:ea typeface="맑은 고딕" pitchFamily="34" charset="-122"/>
                           <a:cs typeface="맑은 고딕" pitchFamily="34" charset="-120"/>
                         </a:rPr>
-                        <a:t>9 개</a:t>
+                        <a:t>26 개</a:t>
                       </a:r>
                       <a:endParaRPr lang="en-US" sz="1200" dirty="0">
                         <a:latin typeface="맑은 고딕" charset="0"/>
@@ -7239,7 +7239,7 @@
                           <a:ea typeface="맑은 고딕" pitchFamily="34" charset="-122"/>
                           <a:cs typeface="맑은 고딕" pitchFamily="34" charset="-120"/>
                         </a:rPr>
-                        <a:t>[SILVER925] Starly Open Ring</a:t>
+                        <a:t>[SILVER925] Eramam Open Ring</a:t>
                       </a:r>
                       <a:endParaRPr lang="en-US" sz="1100" dirty="0">
                         <a:latin typeface="맑은 고딕" charset="0"/>
@@ -7304,7 +7304,7 @@
                           <a:ea typeface="맑은 고딕" pitchFamily="34" charset="-122"/>
                           <a:cs typeface="맑은 고딕" pitchFamily="34" charset="-120"/>
                         </a:rPr>
-                        <a:t>9 개</a:t>
+                        <a:t>24 개</a:t>
                       </a:r>
                       <a:endParaRPr lang="en-US" sz="1200" dirty="0">
                         <a:latin typeface="맑은 고딕" charset="0"/>
@@ -7390,7 +7390,7 @@
                 <a:ea typeface="맑은 고딕" pitchFamily="34" charset="-122"/>
                 <a:cs typeface="맑은 고딕" pitchFamily="34" charset="-120"/>
               </a:rPr>
-              <a:t>리오더 필요  🔴 긴급 5건</a:t>
+              <a:t>리오더 필요  🔴 긴급 6건</a:t>
             </a:r>
             <a:pPr indent="0" marL="0">
               <a:buNone/>
@@ -7557,7 +7557,7 @@
                 <a:ea typeface="맑은 고딕" pitchFamily="34" charset="-122"/>
                 <a:cs typeface="맑은 고딕" pitchFamily="34" charset="-120"/>
               </a:rPr>
-              <a:t>Marquise Necklace</a:t>
+              <a:t>[SILVER925] Geos Open Ring</a:t>
             </a:r>
             <a:endParaRPr lang="en-US" sz="1100" dirty="0"/>
           </a:p>
@@ -7596,7 +7596,7 @@
                 <a:ea typeface="맑은 고딕" pitchFamily="34" charset="-122"/>
                 <a:cs typeface="맑은 고딕" pitchFamily="34" charset="-120"/>
               </a:rPr>
-              <a:t>Necklace  ·  재고 0개</a:t>
+              <a:t>Ring  ·  재고 0개</a:t>
             </a:r>
             <a:pPr indent="0" marL="0">
               <a:buNone/>
@@ -7763,6 +7763,418 @@
                 <a:ea typeface="맑은 고딕" pitchFamily="34" charset="-122"/>
                 <a:cs typeface="맑은 고딕" pitchFamily="34" charset="-120"/>
               </a:rPr>
+              <a:t>8-Ball Smart Tok</a:t>
+            </a:r>
+            <a:endParaRPr lang="en-US" sz="1100" dirty="0"/>
+          </a:p>
+        </p:txBody>
+      </p:sp>
+      <p:sp>
+        <p:nvSpPr>
+          <p:cNvPr id="32" name="Text 29"/>
+          <p:cNvSpPr/>
+          <p:nvPr/>
+        </p:nvSpPr>
+        <p:spPr>
+          <a:xfrm>
+            <a:off x="8211312" y="4425696"/>
+            <a:ext cx="3291840" cy="256032"/>
+          </a:xfrm>
+          <a:prstGeom prst="rect">
+            <a:avLst/>
+          </a:prstGeom>
+          <a:noFill/>
+          <a:ln/>
+        </p:spPr>
+        <p:txBody>
+          <a:bodyPr wrap="square" lIns="0" tIns="0" rIns="0" bIns="0" rtlCol="0" anchor="ctr"/>
+          <a:lstStyle/>
+          <a:p>
+            <a:pPr indent="0" marL="0">
+              <a:buNone/>
+            </a:pPr>
+            <a:r>
+              <a:rPr lang="en-US" sz="1000" dirty="0">
+                <a:solidFill>
+                  <a:srgbClr val="6B7280"/>
+                </a:solidFill>
+                <a:latin typeface="맑은 고딕" pitchFamily="34" charset="0"/>
+                <a:ea typeface="맑은 고딕" pitchFamily="34" charset="-122"/>
+                <a:cs typeface="맑은 고딕" pitchFamily="34" charset="-120"/>
+              </a:rPr>
+              <a:t>★Season off★  ·  재고 5개</a:t>
+            </a:r>
+            <a:pPr indent="0" marL="0">
+              <a:buNone/>
+            </a:pPr>
+            <a:r>
+              <a:rPr lang="en-US" sz="1000" b="1" dirty="0">
+                <a:solidFill>
+                  <a:srgbClr val="D72638"/>
+                </a:solidFill>
+                <a:latin typeface="맑은 고딕" pitchFamily="34" charset="0"/>
+                <a:ea typeface="맑은 고딕" pitchFamily="34" charset="-122"/>
+                <a:cs typeface="맑은 고딕" pitchFamily="34" charset="-120"/>
+              </a:rPr>
+              <a:t/>
+            </a:r>
+            <a:endParaRPr lang="en-US" sz="1000" dirty="0"/>
+          </a:p>
+        </p:txBody>
+      </p:sp>
+      <p:sp>
+        <p:nvSpPr>
+          <p:cNvPr id="33" name="Shape 30"/>
+          <p:cNvSpPr/>
+          <p:nvPr/>
+        </p:nvSpPr>
+        <p:spPr>
+          <a:xfrm>
+            <a:off x="7406640" y="4809744"/>
+            <a:ext cx="4206240" cy="640080"/>
+          </a:xfrm>
+          <a:prstGeom prst="rect">
+            <a:avLst/>
+          </a:prstGeom>
+          <a:solidFill>
+            <a:srgbClr val="FFF5F5"/>
+          </a:solidFill>
+          <a:ln w="6350">
+            <a:solidFill>
+              <a:srgbClr val="E5E7EB"/>
+            </a:solidFill>
+            <a:prstDash val="solid"/>
+          </a:ln>
+        </p:spPr>
+      </p:sp>
+      <p:sp>
+        <p:nvSpPr>
+          <p:cNvPr id="34" name="Shape 31"/>
+          <p:cNvSpPr/>
+          <p:nvPr/>
+        </p:nvSpPr>
+        <p:spPr>
+          <a:xfrm>
+            <a:off x="7406640" y="4809744"/>
+            <a:ext cx="109728" cy="640080"/>
+          </a:xfrm>
+          <a:prstGeom prst="rect">
+            <a:avLst/>
+          </a:prstGeom>
+          <a:solidFill>
+            <a:srgbClr val="D72638"/>
+          </a:solidFill>
+          <a:ln w="12700">
+            <a:solidFill>
+              <a:srgbClr val="D72638"/>
+            </a:solidFill>
+            <a:prstDash val="solid"/>
+          </a:ln>
+        </p:spPr>
+      </p:sp>
+      <p:sp>
+        <p:nvSpPr>
+          <p:cNvPr id="35" name="Shape 32"/>
+          <p:cNvSpPr/>
+          <p:nvPr/>
+        </p:nvSpPr>
+        <p:spPr>
+          <a:xfrm>
+            <a:off x="7571232" y="4901184"/>
+            <a:ext cx="548640" cy="256032"/>
+          </a:xfrm>
+          <a:prstGeom prst="rect">
+            <a:avLst/>
+          </a:prstGeom>
+          <a:solidFill>
+            <a:srgbClr val="D72638"/>
+          </a:solidFill>
+          <a:ln w="12700">
+            <a:solidFill>
+              <a:srgbClr val="D72638"/>
+            </a:solidFill>
+            <a:prstDash val="solid"/>
+          </a:ln>
+        </p:spPr>
+      </p:sp>
+      <p:sp>
+        <p:nvSpPr>
+          <p:cNvPr id="36" name="Text 33"/>
+          <p:cNvSpPr/>
+          <p:nvPr/>
+        </p:nvSpPr>
+        <p:spPr>
+          <a:xfrm>
+            <a:off x="7571232" y="4901184"/>
+            <a:ext cx="548640" cy="256032"/>
+          </a:xfrm>
+          <a:prstGeom prst="rect">
+            <a:avLst/>
+          </a:prstGeom>
+          <a:noFill/>
+          <a:ln/>
+        </p:spPr>
+        <p:txBody>
+          <a:bodyPr wrap="square" lIns="0" tIns="0" rIns="0" bIns="0" rtlCol="0" anchor="ctr"/>
+          <a:lstStyle/>
+          <a:p>
+            <a:pPr algn="ctr" indent="0" marL="0">
+              <a:buNone/>
+            </a:pPr>
+            <a:r>
+              <a:rPr lang="en-US" sz="900" b="1" dirty="0">
+                <a:solidFill>
+                  <a:srgbClr val="FFFFFF"/>
+                </a:solidFill>
+                <a:latin typeface="맑은 고딕" pitchFamily="34" charset="0"/>
+                <a:ea typeface="맑은 고딕" pitchFamily="34" charset="-122"/>
+                <a:cs typeface="맑은 고딕" pitchFamily="34" charset="-120"/>
+              </a:rPr>
+              <a:t>긴급</a:t>
+            </a:r>
+            <a:endParaRPr lang="en-US" sz="900" dirty="0"/>
+          </a:p>
+        </p:txBody>
+      </p:sp>
+      <p:sp>
+        <p:nvSpPr>
+          <p:cNvPr id="37" name="Text 34"/>
+          <p:cNvSpPr/>
+          <p:nvPr/>
+        </p:nvSpPr>
+        <p:spPr>
+          <a:xfrm>
+            <a:off x="8211312" y="4864608"/>
+            <a:ext cx="3291840" cy="274320"/>
+          </a:xfrm>
+          <a:prstGeom prst="rect">
+            <a:avLst/>
+          </a:prstGeom>
+          <a:noFill/>
+          <a:ln/>
+        </p:spPr>
+        <p:txBody>
+          <a:bodyPr wrap="square" lIns="0" tIns="0" rIns="0" bIns="0" rtlCol="0" anchor="ctr"/>
+          <a:lstStyle/>
+          <a:p>
+            <a:pPr indent="0" marL="0">
+              <a:buNone/>
+            </a:pPr>
+            <a:r>
+              <a:rPr lang="en-US" sz="1100" b="1" dirty="0">
+                <a:solidFill>
+                  <a:srgbClr val="0B1220"/>
+                </a:solidFill>
+                <a:latin typeface="맑은 고딕" pitchFamily="34" charset="0"/>
+                <a:ea typeface="맑은 고딕" pitchFamily="34" charset="-122"/>
+                <a:cs typeface="맑은 고딕" pitchFamily="34" charset="-120"/>
+              </a:rPr>
+              <a:t>B-Flower Necklace (Size: 2 Size)</a:t>
+            </a:r>
+            <a:endParaRPr lang="en-US" sz="1100" dirty="0"/>
+          </a:p>
+        </p:txBody>
+      </p:sp>
+      <p:sp>
+        <p:nvSpPr>
+          <p:cNvPr id="38" name="Text 35"/>
+          <p:cNvSpPr/>
+          <p:nvPr/>
+        </p:nvSpPr>
+        <p:spPr>
+          <a:xfrm>
+            <a:off x="8211312" y="5138928"/>
+            <a:ext cx="3291840" cy="256032"/>
+          </a:xfrm>
+          <a:prstGeom prst="rect">
+            <a:avLst/>
+          </a:prstGeom>
+          <a:noFill/>
+          <a:ln/>
+        </p:spPr>
+        <p:txBody>
+          <a:bodyPr wrap="square" lIns="0" tIns="0" rIns="0" bIns="0" rtlCol="0" anchor="ctr"/>
+          <a:lstStyle/>
+          <a:p>
+            <a:pPr indent="0" marL="0">
+              <a:buNone/>
+            </a:pPr>
+            <a:r>
+              <a:rPr lang="en-US" sz="1000" dirty="0">
+                <a:solidFill>
+                  <a:srgbClr val="6B7280"/>
+                </a:solidFill>
+                <a:latin typeface="맑은 고딕" pitchFamily="34" charset="0"/>
+                <a:ea typeface="맑은 고딕" pitchFamily="34" charset="-122"/>
+                <a:cs typeface="맑은 고딕" pitchFamily="34" charset="-120"/>
+              </a:rPr>
+              <a:t>Necklace  ·  재고 4개</a:t>
+            </a:r>
+            <a:pPr indent="0" marL="0">
+              <a:buNone/>
+            </a:pPr>
+            <a:r>
+              <a:rPr lang="en-US" sz="1000" b="1" dirty="0">
+                <a:solidFill>
+                  <a:srgbClr val="D72638"/>
+                </a:solidFill>
+                <a:latin typeface="맑은 고딕" pitchFamily="34" charset="0"/>
+                <a:ea typeface="맑은 고딕" pitchFamily="34" charset="-122"/>
+                <a:cs typeface="맑은 고딕" pitchFamily="34" charset="-120"/>
+              </a:rPr>
+              <a:t/>
+            </a:r>
+            <a:endParaRPr lang="en-US" sz="1000" dirty="0"/>
+          </a:p>
+        </p:txBody>
+      </p:sp>
+      <p:sp>
+        <p:nvSpPr>
+          <p:cNvPr id="39" name="Shape 36"/>
+          <p:cNvSpPr/>
+          <p:nvPr/>
+        </p:nvSpPr>
+        <p:spPr>
+          <a:xfrm>
+            <a:off x="7406640" y="5522976"/>
+            <a:ext cx="4206240" cy="640080"/>
+          </a:xfrm>
+          <a:prstGeom prst="rect">
+            <a:avLst/>
+          </a:prstGeom>
+          <a:solidFill>
+            <a:srgbClr val="FFF5F5"/>
+          </a:solidFill>
+          <a:ln w="6350">
+            <a:solidFill>
+              <a:srgbClr val="E5E7EB"/>
+            </a:solidFill>
+            <a:prstDash val="solid"/>
+          </a:ln>
+        </p:spPr>
+      </p:sp>
+      <p:sp>
+        <p:nvSpPr>
+          <p:cNvPr id="40" name="Shape 37"/>
+          <p:cNvSpPr/>
+          <p:nvPr/>
+        </p:nvSpPr>
+        <p:spPr>
+          <a:xfrm>
+            <a:off x="7406640" y="5522976"/>
+            <a:ext cx="109728" cy="640080"/>
+          </a:xfrm>
+          <a:prstGeom prst="rect">
+            <a:avLst/>
+          </a:prstGeom>
+          <a:solidFill>
+            <a:srgbClr val="D72638"/>
+          </a:solidFill>
+          <a:ln w="12700">
+            <a:solidFill>
+              <a:srgbClr val="D72638"/>
+            </a:solidFill>
+            <a:prstDash val="solid"/>
+          </a:ln>
+        </p:spPr>
+      </p:sp>
+      <p:sp>
+        <p:nvSpPr>
+          <p:cNvPr id="41" name="Shape 38"/>
+          <p:cNvSpPr/>
+          <p:nvPr/>
+        </p:nvSpPr>
+        <p:spPr>
+          <a:xfrm>
+            <a:off x="7571232" y="5614416"/>
+            <a:ext cx="548640" cy="256032"/>
+          </a:xfrm>
+          <a:prstGeom prst="rect">
+            <a:avLst/>
+          </a:prstGeom>
+          <a:solidFill>
+            <a:srgbClr val="D72638"/>
+          </a:solidFill>
+          <a:ln w="12700">
+            <a:solidFill>
+              <a:srgbClr val="D72638"/>
+            </a:solidFill>
+            <a:prstDash val="solid"/>
+          </a:ln>
+        </p:spPr>
+      </p:sp>
+      <p:sp>
+        <p:nvSpPr>
+          <p:cNvPr id="42" name="Text 39"/>
+          <p:cNvSpPr/>
+          <p:nvPr/>
+        </p:nvSpPr>
+        <p:spPr>
+          <a:xfrm>
+            <a:off x="7571232" y="5614416"/>
+            <a:ext cx="548640" cy="256032"/>
+          </a:xfrm>
+          <a:prstGeom prst="rect">
+            <a:avLst/>
+          </a:prstGeom>
+          <a:noFill/>
+          <a:ln/>
+        </p:spPr>
+        <p:txBody>
+          <a:bodyPr wrap="square" lIns="0" tIns="0" rIns="0" bIns="0" rtlCol="0" anchor="ctr"/>
+          <a:lstStyle/>
+          <a:p>
+            <a:pPr algn="ctr" indent="0" marL="0">
+              <a:buNone/>
+            </a:pPr>
+            <a:r>
+              <a:rPr lang="en-US" sz="900" b="1" dirty="0">
+                <a:solidFill>
+                  <a:srgbClr val="FFFFFF"/>
+                </a:solidFill>
+                <a:latin typeface="맑은 고딕" pitchFamily="34" charset="0"/>
+                <a:ea typeface="맑은 고딕" pitchFamily="34" charset="-122"/>
+                <a:cs typeface="맑은 고딕" pitchFamily="34" charset="-120"/>
+              </a:rPr>
+              <a:t>긴급</a:t>
+            </a:r>
+            <a:endParaRPr lang="en-US" sz="900" dirty="0"/>
+          </a:p>
+        </p:txBody>
+      </p:sp>
+      <p:sp>
+        <p:nvSpPr>
+          <p:cNvPr id="43" name="Text 40"/>
+          <p:cNvSpPr/>
+          <p:nvPr/>
+        </p:nvSpPr>
+        <p:spPr>
+          <a:xfrm>
+            <a:off x="8211312" y="5577840"/>
+            <a:ext cx="3291840" cy="274320"/>
+          </a:xfrm>
+          <a:prstGeom prst="rect">
+            <a:avLst/>
+          </a:prstGeom>
+          <a:noFill/>
+          <a:ln/>
+        </p:spPr>
+        <p:txBody>
+          <a:bodyPr wrap="square" lIns="0" tIns="0" rIns="0" bIns="0" rtlCol="0" anchor="ctr"/>
+          <a:lstStyle/>
+          <a:p>
+            <a:pPr indent="0" marL="0">
+              <a:buNone/>
+            </a:pPr>
+            <a:r>
+              <a:rPr lang="en-US" sz="1100" b="1" dirty="0">
+                <a:solidFill>
+                  <a:srgbClr val="0B1220"/>
+                </a:solidFill>
+                <a:latin typeface="맑은 고딕" pitchFamily="34" charset="0"/>
+                <a:ea typeface="맑은 고딕" pitchFamily="34" charset="-122"/>
+                <a:cs typeface="맑은 고딕" pitchFamily="34" charset="-120"/>
+              </a:rPr>
               <a:t>Tangle Keychain</a:t>
             </a:r>
             <a:endParaRPr lang="en-US" sz="1100" dirty="0"/>
@@ -7771,13 +8183,13 @@
       </p:sp>
       <p:sp>
         <p:nvSpPr>
-          <p:cNvPr id="32" name="Text 29"/>
-          <p:cNvSpPr/>
-          <p:nvPr/>
-        </p:nvSpPr>
-        <p:spPr>
-          <a:xfrm>
-            <a:off x="8211312" y="4425696"/>
+          <p:cNvPr id="44" name="Text 41"/>
+          <p:cNvSpPr/>
+          <p:nvPr/>
+        </p:nvSpPr>
+        <p:spPr>
+          <a:xfrm>
+            <a:off x="8211312" y="5852160"/>
             <a:ext cx="3291840" cy="256032"/>
           </a:xfrm>
           <a:prstGeom prst="rect">
@@ -7824,418 +8236,6 @@
       </p:sp>
       <p:sp>
         <p:nvSpPr>
-          <p:cNvPr id="33" name="Shape 30"/>
-          <p:cNvSpPr/>
-          <p:nvPr/>
-        </p:nvSpPr>
-        <p:spPr>
-          <a:xfrm>
-            <a:off x="7406640" y="4809744"/>
-            <a:ext cx="4206240" cy="640080"/>
-          </a:xfrm>
-          <a:prstGeom prst="rect">
-            <a:avLst/>
-          </a:prstGeom>
-          <a:solidFill>
-            <a:srgbClr val="FFF5F5"/>
-          </a:solidFill>
-          <a:ln w="6350">
-            <a:solidFill>
-              <a:srgbClr val="E5E7EB"/>
-            </a:solidFill>
-            <a:prstDash val="solid"/>
-          </a:ln>
-        </p:spPr>
-      </p:sp>
-      <p:sp>
-        <p:nvSpPr>
-          <p:cNvPr id="34" name="Shape 31"/>
-          <p:cNvSpPr/>
-          <p:nvPr/>
-        </p:nvSpPr>
-        <p:spPr>
-          <a:xfrm>
-            <a:off x="7406640" y="4809744"/>
-            <a:ext cx="109728" cy="640080"/>
-          </a:xfrm>
-          <a:prstGeom prst="rect">
-            <a:avLst/>
-          </a:prstGeom>
-          <a:solidFill>
-            <a:srgbClr val="D72638"/>
-          </a:solidFill>
-          <a:ln w="12700">
-            <a:solidFill>
-              <a:srgbClr val="D72638"/>
-            </a:solidFill>
-            <a:prstDash val="solid"/>
-          </a:ln>
-        </p:spPr>
-      </p:sp>
-      <p:sp>
-        <p:nvSpPr>
-          <p:cNvPr id="35" name="Shape 32"/>
-          <p:cNvSpPr/>
-          <p:nvPr/>
-        </p:nvSpPr>
-        <p:spPr>
-          <a:xfrm>
-            <a:off x="7571232" y="4901184"/>
-            <a:ext cx="548640" cy="256032"/>
-          </a:xfrm>
-          <a:prstGeom prst="rect">
-            <a:avLst/>
-          </a:prstGeom>
-          <a:solidFill>
-            <a:srgbClr val="D72638"/>
-          </a:solidFill>
-          <a:ln w="12700">
-            <a:solidFill>
-              <a:srgbClr val="D72638"/>
-            </a:solidFill>
-            <a:prstDash val="solid"/>
-          </a:ln>
-        </p:spPr>
-      </p:sp>
-      <p:sp>
-        <p:nvSpPr>
-          <p:cNvPr id="36" name="Text 33"/>
-          <p:cNvSpPr/>
-          <p:nvPr/>
-        </p:nvSpPr>
-        <p:spPr>
-          <a:xfrm>
-            <a:off x="7571232" y="4901184"/>
-            <a:ext cx="548640" cy="256032"/>
-          </a:xfrm>
-          <a:prstGeom prst="rect">
-            <a:avLst/>
-          </a:prstGeom>
-          <a:noFill/>
-          <a:ln/>
-        </p:spPr>
-        <p:txBody>
-          <a:bodyPr wrap="square" lIns="0" tIns="0" rIns="0" bIns="0" rtlCol="0" anchor="ctr"/>
-          <a:lstStyle/>
-          <a:p>
-            <a:pPr algn="ctr" indent="0" marL="0">
-              <a:buNone/>
-            </a:pPr>
-            <a:r>
-              <a:rPr lang="en-US" sz="900" b="1" dirty="0">
-                <a:solidFill>
-                  <a:srgbClr val="FFFFFF"/>
-                </a:solidFill>
-                <a:latin typeface="맑은 고딕" pitchFamily="34" charset="0"/>
-                <a:ea typeface="맑은 고딕" pitchFamily="34" charset="-122"/>
-                <a:cs typeface="맑은 고딕" pitchFamily="34" charset="-120"/>
-              </a:rPr>
-              <a:t>긴급</a:t>
-            </a:r>
-            <a:endParaRPr lang="en-US" sz="900" dirty="0"/>
-          </a:p>
-        </p:txBody>
-      </p:sp>
-      <p:sp>
-        <p:nvSpPr>
-          <p:cNvPr id="37" name="Text 34"/>
-          <p:cNvSpPr/>
-          <p:nvPr/>
-        </p:nvSpPr>
-        <p:spPr>
-          <a:xfrm>
-            <a:off x="8211312" y="4864608"/>
-            <a:ext cx="3291840" cy="274320"/>
-          </a:xfrm>
-          <a:prstGeom prst="rect">
-            <a:avLst/>
-          </a:prstGeom>
-          <a:noFill/>
-          <a:ln/>
-        </p:spPr>
-        <p:txBody>
-          <a:bodyPr wrap="square" lIns="0" tIns="0" rIns="0" bIns="0" rtlCol="0" anchor="ctr"/>
-          <a:lstStyle/>
-          <a:p>
-            <a:pPr indent="0" marL="0">
-              <a:buNone/>
-            </a:pPr>
-            <a:r>
-              <a:rPr lang="en-US" sz="1100" b="1" dirty="0">
-                <a:solidFill>
-                  <a:srgbClr val="0B1220"/>
-                </a:solidFill>
-                <a:latin typeface="맑은 고딕" pitchFamily="34" charset="0"/>
-                <a:ea typeface="맑은 고딕" pitchFamily="34" charset="-122"/>
-                <a:cs typeface="맑은 고딕" pitchFamily="34" charset="-120"/>
-              </a:rPr>
-              <a:t>8-Ball Smart Tok</a:t>
-            </a:r>
-            <a:endParaRPr lang="en-US" sz="1100" dirty="0"/>
-          </a:p>
-        </p:txBody>
-      </p:sp>
-      <p:sp>
-        <p:nvSpPr>
-          <p:cNvPr id="38" name="Text 35"/>
-          <p:cNvSpPr/>
-          <p:nvPr/>
-        </p:nvSpPr>
-        <p:spPr>
-          <a:xfrm>
-            <a:off x="8211312" y="5138928"/>
-            <a:ext cx="3291840" cy="256032"/>
-          </a:xfrm>
-          <a:prstGeom prst="rect">
-            <a:avLst/>
-          </a:prstGeom>
-          <a:noFill/>
-          <a:ln/>
-        </p:spPr>
-        <p:txBody>
-          <a:bodyPr wrap="square" lIns="0" tIns="0" rIns="0" bIns="0" rtlCol="0" anchor="ctr"/>
-          <a:lstStyle/>
-          <a:p>
-            <a:pPr indent="0" marL="0">
-              <a:buNone/>
-            </a:pPr>
-            <a:r>
-              <a:rPr lang="en-US" sz="1000" dirty="0">
-                <a:solidFill>
-                  <a:srgbClr val="6B7280"/>
-                </a:solidFill>
-                <a:latin typeface="맑은 고딕" pitchFamily="34" charset="0"/>
-                <a:ea typeface="맑은 고딕" pitchFamily="34" charset="-122"/>
-                <a:cs typeface="맑은 고딕" pitchFamily="34" charset="-120"/>
-              </a:rPr>
-              <a:t>★Season off★  ·  재고 5개</a:t>
-            </a:r>
-            <a:pPr indent="0" marL="0">
-              <a:buNone/>
-            </a:pPr>
-            <a:r>
-              <a:rPr lang="en-US" sz="1000" b="1" dirty="0">
-                <a:solidFill>
-                  <a:srgbClr val="D72638"/>
-                </a:solidFill>
-                <a:latin typeface="맑은 고딕" pitchFamily="34" charset="0"/>
-                <a:ea typeface="맑은 고딕" pitchFamily="34" charset="-122"/>
-                <a:cs typeface="맑은 고딕" pitchFamily="34" charset="-120"/>
-              </a:rPr>
-              <a:t/>
-            </a:r>
-            <a:endParaRPr lang="en-US" sz="1000" dirty="0"/>
-          </a:p>
-        </p:txBody>
-      </p:sp>
-      <p:sp>
-        <p:nvSpPr>
-          <p:cNvPr id="39" name="Shape 36"/>
-          <p:cNvSpPr/>
-          <p:nvPr/>
-        </p:nvSpPr>
-        <p:spPr>
-          <a:xfrm>
-            <a:off x="7406640" y="5522976"/>
-            <a:ext cx="4206240" cy="640080"/>
-          </a:xfrm>
-          <a:prstGeom prst="rect">
-            <a:avLst/>
-          </a:prstGeom>
-          <a:solidFill>
-            <a:srgbClr val="FFF5F5"/>
-          </a:solidFill>
-          <a:ln w="6350">
-            <a:solidFill>
-              <a:srgbClr val="E5E7EB"/>
-            </a:solidFill>
-            <a:prstDash val="solid"/>
-          </a:ln>
-        </p:spPr>
-      </p:sp>
-      <p:sp>
-        <p:nvSpPr>
-          <p:cNvPr id="40" name="Shape 37"/>
-          <p:cNvSpPr/>
-          <p:nvPr/>
-        </p:nvSpPr>
-        <p:spPr>
-          <a:xfrm>
-            <a:off x="7406640" y="5522976"/>
-            <a:ext cx="109728" cy="640080"/>
-          </a:xfrm>
-          <a:prstGeom prst="rect">
-            <a:avLst/>
-          </a:prstGeom>
-          <a:solidFill>
-            <a:srgbClr val="D72638"/>
-          </a:solidFill>
-          <a:ln w="12700">
-            <a:solidFill>
-              <a:srgbClr val="D72638"/>
-            </a:solidFill>
-            <a:prstDash val="solid"/>
-          </a:ln>
-        </p:spPr>
-      </p:sp>
-      <p:sp>
-        <p:nvSpPr>
-          <p:cNvPr id="41" name="Shape 38"/>
-          <p:cNvSpPr/>
-          <p:nvPr/>
-        </p:nvSpPr>
-        <p:spPr>
-          <a:xfrm>
-            <a:off x="7571232" y="5614416"/>
-            <a:ext cx="548640" cy="256032"/>
-          </a:xfrm>
-          <a:prstGeom prst="rect">
-            <a:avLst/>
-          </a:prstGeom>
-          <a:solidFill>
-            <a:srgbClr val="D72638"/>
-          </a:solidFill>
-          <a:ln w="12700">
-            <a:solidFill>
-              <a:srgbClr val="D72638"/>
-            </a:solidFill>
-            <a:prstDash val="solid"/>
-          </a:ln>
-        </p:spPr>
-      </p:sp>
-      <p:sp>
-        <p:nvSpPr>
-          <p:cNvPr id="42" name="Text 39"/>
-          <p:cNvSpPr/>
-          <p:nvPr/>
-        </p:nvSpPr>
-        <p:spPr>
-          <a:xfrm>
-            <a:off x="7571232" y="5614416"/>
-            <a:ext cx="548640" cy="256032"/>
-          </a:xfrm>
-          <a:prstGeom prst="rect">
-            <a:avLst/>
-          </a:prstGeom>
-          <a:noFill/>
-          <a:ln/>
-        </p:spPr>
-        <p:txBody>
-          <a:bodyPr wrap="square" lIns="0" tIns="0" rIns="0" bIns="0" rtlCol="0" anchor="ctr"/>
-          <a:lstStyle/>
-          <a:p>
-            <a:pPr algn="ctr" indent="0" marL="0">
-              <a:buNone/>
-            </a:pPr>
-            <a:r>
-              <a:rPr lang="en-US" sz="900" b="1" dirty="0">
-                <a:solidFill>
-                  <a:srgbClr val="FFFFFF"/>
-                </a:solidFill>
-                <a:latin typeface="맑은 고딕" pitchFamily="34" charset="0"/>
-                <a:ea typeface="맑은 고딕" pitchFamily="34" charset="-122"/>
-                <a:cs typeface="맑은 고딕" pitchFamily="34" charset="-120"/>
-              </a:rPr>
-              <a:t>긴급</a:t>
-            </a:r>
-            <a:endParaRPr lang="en-US" sz="900" dirty="0"/>
-          </a:p>
-        </p:txBody>
-      </p:sp>
-      <p:sp>
-        <p:nvSpPr>
-          <p:cNvPr id="43" name="Text 40"/>
-          <p:cNvSpPr/>
-          <p:nvPr/>
-        </p:nvSpPr>
-        <p:spPr>
-          <a:xfrm>
-            <a:off x="8211312" y="5577840"/>
-            <a:ext cx="3291840" cy="274320"/>
-          </a:xfrm>
-          <a:prstGeom prst="rect">
-            <a:avLst/>
-          </a:prstGeom>
-          <a:noFill/>
-          <a:ln/>
-        </p:spPr>
-        <p:txBody>
-          <a:bodyPr wrap="square" lIns="0" tIns="0" rIns="0" bIns="0" rtlCol="0" anchor="ctr"/>
-          <a:lstStyle/>
-          <a:p>
-            <a:pPr indent="0" marL="0">
-              <a:buNone/>
-            </a:pPr>
-            <a:r>
-              <a:rPr lang="en-US" sz="1100" b="1" dirty="0">
-                <a:solidFill>
-                  <a:srgbClr val="0B1220"/>
-                </a:solidFill>
-                <a:latin typeface="맑은 고딕" pitchFamily="34" charset="0"/>
-                <a:ea typeface="맑은 고딕" pitchFamily="34" charset="-122"/>
-                <a:cs typeface="맑은 고딕" pitchFamily="34" charset="-120"/>
-              </a:rPr>
-              <a:t>B-Flower Necklace (Size: 2 Size)</a:t>
-            </a:r>
-            <a:endParaRPr lang="en-US" sz="1100" dirty="0"/>
-          </a:p>
-        </p:txBody>
-      </p:sp>
-      <p:sp>
-        <p:nvSpPr>
-          <p:cNvPr id="44" name="Text 41"/>
-          <p:cNvSpPr/>
-          <p:nvPr/>
-        </p:nvSpPr>
-        <p:spPr>
-          <a:xfrm>
-            <a:off x="8211312" y="5852160"/>
-            <a:ext cx="3291840" cy="256032"/>
-          </a:xfrm>
-          <a:prstGeom prst="rect">
-            <a:avLst/>
-          </a:prstGeom>
-          <a:noFill/>
-          <a:ln/>
-        </p:spPr>
-        <p:txBody>
-          <a:bodyPr wrap="square" lIns="0" tIns="0" rIns="0" bIns="0" rtlCol="0" anchor="ctr"/>
-          <a:lstStyle/>
-          <a:p>
-            <a:pPr indent="0" marL="0">
-              <a:buNone/>
-            </a:pPr>
-            <a:r>
-              <a:rPr lang="en-US" sz="1000" dirty="0">
-                <a:solidFill>
-                  <a:srgbClr val="6B7280"/>
-                </a:solidFill>
-                <a:latin typeface="맑은 고딕" pitchFamily="34" charset="0"/>
-                <a:ea typeface="맑은 고딕" pitchFamily="34" charset="-122"/>
-                <a:cs typeface="맑은 고딕" pitchFamily="34" charset="-120"/>
-              </a:rPr>
-              <a:t>Necklace  ·  재고 4개</a:t>
-            </a:r>
-            <a:pPr indent="0" marL="0">
-              <a:buNone/>
-            </a:pPr>
-            <a:r>
-              <a:rPr lang="en-US" sz="1000" b="1" dirty="0">
-                <a:solidFill>
-                  <a:srgbClr val="D72638"/>
-                </a:solidFill>
-                <a:latin typeface="맑은 고딕" pitchFamily="34" charset="0"/>
-                <a:ea typeface="맑은 고딕" pitchFamily="34" charset="-122"/>
-                <a:cs typeface="맑은 고딕" pitchFamily="34" charset="-120"/>
-              </a:rPr>
-              <a:t/>
-            </a:r>
-            <a:endParaRPr lang="en-US" sz="1000" dirty="0"/>
-          </a:p>
-        </p:txBody>
-      </p:sp>
-      <p:sp>
-        <p:nvSpPr>
           <p:cNvPr id="45" name="Text 42"/>
           <p:cNvSpPr/>
           <p:nvPr/>
@@ -8267,7 +8267,7 @@
                 <a:ea typeface="맑은 고딕" pitchFamily="34" charset="-122"/>
                 <a:cs typeface="맑은 고딕" pitchFamily="34" charset="-120"/>
               </a:rPr>
-              <a:t>베스트 상품 리포트  ·  생성 2026-05-16 08:00</a:t>
+              <a:t>베스트 상품 리포트  ·  생성 2026-05-17 08:00</a:t>
             </a:r>
             <a:endParaRPr lang="en-US" sz="900" dirty="0"/>
           </a:p>
@@ -8480,7 +8480,7 @@
                 <a:ea typeface="맑은 고딕" pitchFamily="34" charset="-122"/>
                 <a:cs typeface="맑은 고딕" pitchFamily="34" charset="-120"/>
               </a:rPr>
-              <a:t>2026년 05월 16일 (토)</a:t>
+              <a:t>2026년 05월 17일 (일)</a:t>
             </a:r>
             <a:endParaRPr lang="en-US" sz="1200" dirty="0"/>
           </a:p>
@@ -8647,7 +8647,7 @@
                 <a:ea typeface="맑은 고딕" pitchFamily="34" charset="-122"/>
                 <a:cs typeface="맑은 고딕" pitchFamily="34" charset="-120"/>
               </a:rPr>
-              <a:t>144 개</a:t>
+              <a:t>153 개</a:t>
             </a:r>
             <a:endParaRPr lang="en-US" sz="3600" dirty="0"/>
           </a:p>
@@ -8853,7 +8853,7 @@
                 <a:ea typeface="맑은 고딕" pitchFamily="34" charset="-122"/>
                 <a:cs typeface="맑은 고딕" pitchFamily="34" charset="-120"/>
               </a:rPr>
-              <a:t>45</a:t>
+              <a:t>51</a:t>
             </a:r>
             <a:endParaRPr lang="en-US" sz="4400" dirty="0"/>
           </a:p>
@@ -9452,7 +9452,7 @@
                           <a:ea typeface="맑은 고딕" pitchFamily="34" charset="-122"/>
                           <a:cs typeface="맑은 고딕" pitchFamily="34" charset="-120"/>
                         </a:rPr>
-                        <a:t>45 개</a:t>
+                        <a:t>51 개</a:t>
                       </a:r>
                       <a:endParaRPr lang="en-US" sz="1400" dirty="0">
                         <a:latin typeface="맑은 고딕" charset="0"/>
@@ -9714,7 +9714,7 @@
                           <a:ea typeface="맑은 고딕" pitchFamily="34" charset="-122"/>
                           <a:cs typeface="맑은 고딕" pitchFamily="34" charset="-120"/>
                         </a:rPr>
-                        <a:t>40 개</a:t>
+                        <a:t>48 개</a:t>
                       </a:r>
                       <a:endParaRPr lang="en-US" sz="1200" dirty="0">
                         <a:latin typeface="맑은 고딕" charset="0"/>
@@ -9976,7 +9976,7 @@
                           <a:ea typeface="맑은 고딕" pitchFamily="34" charset="-122"/>
                           <a:cs typeface="맑은 고딕" pitchFamily="34" charset="-120"/>
                         </a:rPr>
-                        <a:t>18 개</a:t>
+                        <a:t>19 개</a:t>
                       </a:r>
                       <a:endParaRPr lang="en-US" sz="1200" dirty="0">
                         <a:latin typeface="맑은 고딕" charset="0"/>
@@ -10062,7 +10062,7 @@
                 <a:ea typeface="맑은 고딕" pitchFamily="34" charset="-122"/>
                 <a:cs typeface="맑은 고딕" pitchFamily="34" charset="-120"/>
               </a:rPr>
-              <a:t>리오더 필요  🔴 긴급 16건</a:t>
+              <a:t>리오더 필요  🔴 긴급 17건</a:t>
             </a:r>
             <a:endParaRPr lang="en-US" sz="1500" dirty="0"/>
           </a:p>
@@ -10126,7 +10126,7 @@
                 <a:ea typeface="맑은 고딕" pitchFamily="34" charset="-122"/>
                 <a:cs typeface="맑은 고딕" pitchFamily="34" charset="-120"/>
               </a:rPr>
-              <a:t>🔴 긴급 16건  ·  상세는 시트 확인</a:t>
+              <a:t>🔴 긴급 17건  ·  상세는 시트 확인</a:t>
             </a:r>
             <a:endParaRPr lang="en-US" sz="1400" dirty="0"/>
           </a:p>
@@ -10165,7 +10165,7 @@
                 <a:ea typeface="맑은 고딕" pitchFamily="34" charset="-122"/>
                 <a:cs typeface="맑은 고딕" pitchFamily="34" charset="-120"/>
               </a:rPr>
-              <a:t>베스트 상품 리포트  ·  생성 2026-05-16 08:00</a:t>
+              <a:t>베스트 상품 리포트  ·  생성 2026-05-17 08:00</a:t>
             </a:r>
             <a:endParaRPr lang="en-US" sz="900" dirty="0"/>
           </a:p>
@@ -10378,7 +10378,7 @@
                 <a:ea typeface="맑은 고딕" pitchFamily="34" charset="-122"/>
                 <a:cs typeface="맑은 고딕" pitchFamily="34" charset="-120"/>
               </a:rPr>
-              <a:t>2026년 05월 16일 (토)</a:t>
+              <a:t>2026년 05월 17일 (일)</a:t>
             </a:r>
             <a:endParaRPr lang="en-US" sz="1200" dirty="0"/>
           </a:p>
@@ -10673,7 +10673,7 @@
                 <a:ea typeface="맑은 고딕" pitchFamily="34" charset="-122"/>
                 <a:cs typeface="맑은 고딕" pitchFamily="34" charset="-120"/>
               </a:rPr>
-              <a:t>24</a:t>
+              <a:t>25</a:t>
             </a:r>
             <a:endParaRPr lang="en-US" sz="3000" dirty="0"/>
           </a:p>
@@ -10801,7 +10801,7 @@
                 <a:ea typeface="맑은 고딕" pitchFamily="34" charset="-122"/>
                 <a:cs typeface="맑은 고딕" pitchFamily="34" charset="-120"/>
               </a:rPr>
-              <a:t>8</a:t>
+              <a:t>7</a:t>
             </a:r>
             <a:endParaRPr lang="en-US" sz="3000" dirty="0"/>
           </a:p>
@@ -10929,7 +10929,7 @@
                 <a:ea typeface="맑은 고딕" pitchFamily="34" charset="-122"/>
                 <a:cs typeface="맑은 고딕" pitchFamily="34" charset="-120"/>
               </a:rPr>
-              <a:t>35,672</a:t>
+              <a:t>35,053</a:t>
             </a:r>
             <a:endParaRPr lang="en-US" sz="3000" dirty="0"/>
           </a:p>
@@ -11424,7 +11424,7 @@
                           <a:ea typeface="맑은 고딕" pitchFamily="34" charset="-122"/>
                           <a:cs typeface="맑은 고딕" pitchFamily="34" charset="-120"/>
                         </a:rPr>
-                        <a:t>컬러: 퍼플 / 기종 옵션: C type -&gt; C type</a:t>
+                        <a:t>컬러: 옐로우 / 기종 옵션: USB -&gt; Apple 8pin</a:t>
                       </a:r>
                       <a:endParaRPr lang="en-US" sz="900" dirty="0">
                         <a:latin typeface="맑은 고딕" charset="0"/>
@@ -11489,7 +11489,7 @@
                           <a:ea typeface="맑은 고딕" pitchFamily="34" charset="-122"/>
                           <a:cs typeface="맑은 고딕" pitchFamily="34" charset="-120"/>
                         </a:rPr>
-                        <a:t>2,207</a:t>
+                        <a:t>2,140</a:t>
                       </a:r>
                       <a:endParaRPr lang="en-US" sz="1000" dirty="0">
                         <a:latin typeface="맑은 고딕" charset="0"/>
@@ -11686,7 +11686,7 @@
                           <a:ea typeface="맑은 고딕" pitchFamily="34" charset="-122"/>
                           <a:cs typeface="맑은 고딕" pitchFamily="34" charset="-120"/>
                         </a:rPr>
-                        <a:t>컬러: 옐로우 / 기종 옵션: USB -&gt; Apple 8pin</a:t>
+                        <a:t>컬러: 퍼플 / 기종 옵션: C type -&gt; C type</a:t>
                       </a:r>
                       <a:endParaRPr lang="en-US" sz="900" dirty="0">
                         <a:latin typeface="맑은 고딕" charset="0"/>
@@ -11751,7 +11751,7 @@
                           <a:ea typeface="맑은 고딕" pitchFamily="34" charset="-122"/>
                           <a:cs typeface="맑은 고딕" pitchFamily="34" charset="-120"/>
                         </a:rPr>
-                        <a:t>2,153</a:t>
+                        <a:t>2,093</a:t>
                       </a:r>
                       <a:endParaRPr lang="en-US" sz="1000" dirty="0">
                         <a:latin typeface="맑은 고딕" charset="0"/>
@@ -12013,7 +12013,7 @@
                           <a:ea typeface="맑은 고딕" pitchFamily="34" charset="-122"/>
                           <a:cs typeface="맑은 고딕" pitchFamily="34" charset="-120"/>
                         </a:rPr>
-                        <a:t>1,942</a:t>
+                        <a:t>1,893</a:t>
                       </a:r>
                       <a:endParaRPr lang="en-US" sz="1000" dirty="0">
                         <a:latin typeface="맑은 고딕" charset="0"/>
@@ -12275,7 +12275,7 @@
                           <a:ea typeface="맑은 고딕" pitchFamily="34" charset="-122"/>
                           <a:cs typeface="맑은 고딕" pitchFamily="34" charset="-120"/>
                         </a:rPr>
-                        <a:t>1,695</a:t>
+                        <a:t>1,676</a:t>
                       </a:r>
                       <a:endParaRPr lang="en-US" sz="1000" dirty="0">
                         <a:latin typeface="맑은 고딕" charset="0"/>
@@ -12537,7 +12537,7 @@
                           <a:ea typeface="맑은 고딕" pitchFamily="34" charset="-122"/>
                           <a:cs typeface="맑은 고딕" pitchFamily="34" charset="-120"/>
                         </a:rPr>
-                        <a:t>1,573</a:t>
+                        <a:t>1,506</a:t>
                       </a:r>
                       <a:endParaRPr lang="en-US" sz="1000" dirty="0">
                         <a:latin typeface="맑은 고딕" charset="0"/>
@@ -12623,7 +12623,7 @@
                 <a:ea typeface="맑은 고딕" pitchFamily="34" charset="-122"/>
                 <a:cs typeface="맑은 고딕" pitchFamily="34" charset="-120"/>
               </a:rPr>
-              <a:t>재고 점검  🔴 품절 24건</a:t>
+              <a:t>재고 점검  🔴 품절 25건</a:t>
             </a:r>
             <a:pPr indent="0" marL="0">
               <a:buNone/>
@@ -13556,7 +13556,7 @@
                 <a:ea typeface="맑은 고딕" pitchFamily="34" charset="-122"/>
                 <a:cs typeface="맑은 고딕" pitchFamily="34" charset="-120"/>
               </a:rPr>
-              <a:t>베스트 상품 리포트  ·  생성 2026-05-16 08:00</a:t>
+              <a:t>베스트 상품 리포트  ·  생성 2026-05-17 08:00</a:t>
             </a:r>
             <a:endParaRPr lang="en-US" sz="900" dirty="0"/>
           </a:p>
@@ -13769,7 +13769,7 @@
                 <a:ea typeface="맑은 고딕" pitchFamily="34" charset="-122"/>
                 <a:cs typeface="맑은 고딕" pitchFamily="34" charset="-120"/>
               </a:rPr>
-              <a:t>2026년 05월 16일 (토)</a:t>
+              <a:t>2026년 05월 17일 (일)</a:t>
             </a:r>
             <a:endParaRPr lang="en-US" sz="1200" dirty="0"/>
           </a:p>
@@ -13897,7 +13897,7 @@
                 <a:ea typeface="맑은 고딕" pitchFamily="34" charset="-122"/>
                 <a:cs typeface="맑은 고딕" pitchFamily="34" charset="-120"/>
               </a:rPr>
-              <a:t>🚨  긴급 리오더 57건    ·    주의 리오더 8건    ·    오늘 발주 검토 필수</a:t>
+              <a:t>🚨  긴급 리오더 59건    ·    주의 리오더 9건    ·    오늘 발주 검토 필수</a:t>
             </a:r>
             <a:pPr indent="0" marL="0">
               <a:buNone/>
@@ -14527,7 +14527,7 @@
                           <a:ea typeface="맑은 고딕" pitchFamily="34" charset="-122"/>
                           <a:cs typeface="맑은 고딕" pitchFamily="34" charset="-120"/>
                         </a:rPr>
-                        <a:t>PR</a:t>
+                        <a:t>6A</a:t>
                       </a:r>
                       <a:endParaRPr lang="en-US" sz="1100" dirty="0">
                         <a:latin typeface="맑은 고딕" charset="0"/>
@@ -14595,7 +14595,7 @@
                           <a:ea typeface="맑은 고딕" pitchFamily="34" charset="-122"/>
                           <a:cs typeface="맑은 고딕" pitchFamily="34" charset="-120"/>
                         </a:rPr>
-                        <a:t>ELECTRONIC</a:t>
+                        <a:t>Ring</a:t>
                       </a:r>
                       <a:endParaRPr lang="en-US" sz="1000" dirty="0">
                         <a:latin typeface="맑은 고딕" charset="0"/>
@@ -14663,7 +14663,7 @@
                           <a:ea typeface="맑은 고딕" pitchFamily="34" charset="-122"/>
                           <a:cs typeface="맑은 고딕" pitchFamily="34" charset="-120"/>
                         </a:rPr>
-                        <a:t>180° Fast Charging Cable (8color) (컬러: 네온그린 / 기종 옵션: C type -&gt; C type)</a:t>
+                        <a:t>[SILVER925] Geos Open Ring</a:t>
                       </a:r>
                       <a:endParaRPr lang="en-US" sz="1100" dirty="0">
                         <a:latin typeface="맑은 고딕" charset="0"/>
@@ -14799,7 +14799,7 @@
                           <a:ea typeface="맑은 고딕" pitchFamily="34" charset="-122"/>
                           <a:cs typeface="맑은 고딕" pitchFamily="34" charset="-120"/>
                         </a:rPr>
-                        <a:t>216 개</a:t>
+                        <a:t>17 개</a:t>
                       </a:r>
                       <a:endParaRPr lang="en-US" sz="1100" dirty="0">
                         <a:latin typeface="맑은 고딕" charset="0"/>
@@ -15005,7 +15005,7 @@
                           <a:ea typeface="맑은 고딕" pitchFamily="34" charset="-122"/>
                           <a:cs typeface="맑은 고딕" pitchFamily="34" charset="-120"/>
                         </a:rPr>
-                        <a:t>ETC</a:t>
+                        <a:t>ELECTRONIC</a:t>
                       </a:r>
                       <a:endParaRPr lang="en-US" sz="1000" dirty="0">
                         <a:latin typeface="맑은 고딕" charset="0"/>
@@ -15073,7 +15073,7 @@
                           <a:ea typeface="맑은 고딕" pitchFamily="34" charset="-122"/>
                           <a:cs typeface="맑은 고딕" pitchFamily="34" charset="-120"/>
                         </a:rPr>
-                        <a:t>Compact Phone Stand (6color) (컬러: 화이트)</a:t>
+                        <a:t>Jacquard Fast Charging Cable (7color) (컬러: 퍼플 / 기종옵션: C-Apple 8pin / 길이: 2m)</a:t>
                       </a:r>
                       <a:endParaRPr lang="en-US" sz="1100" dirty="0">
                         <a:latin typeface="맑은 고딕" charset="0"/>
@@ -15141,7 +15141,7 @@
                           <a:ea typeface="맑은 고딕" pitchFamily="34" charset="-122"/>
                           <a:cs typeface="맑은 고딕" pitchFamily="34" charset="-120"/>
                         </a:rPr>
-                        <a:t>0</a:t>
+                        <a:t>14</a:t>
                       </a:r>
                       <a:endParaRPr lang="en-US" sz="1100" dirty="0">
                         <a:latin typeface="맑은 고딕" charset="0"/>
@@ -15209,7 +15209,7 @@
                           <a:ea typeface="맑은 고딕" pitchFamily="34" charset="-122"/>
                           <a:cs typeface="맑은 고딕" pitchFamily="34" charset="-120"/>
                         </a:rPr>
-                        <a:t>35 개</a:t>
+                        <a:t>3 개</a:t>
                       </a:r>
                       <a:endParaRPr lang="en-US" sz="1100" dirty="0">
                         <a:latin typeface="맑은 고딕" charset="0"/>
@@ -15347,7 +15347,7 @@
                           <a:ea typeface="맑은 고딕" pitchFamily="34" charset="-122"/>
                           <a:cs typeface="맑은 고딕" pitchFamily="34" charset="-120"/>
                         </a:rPr>
-                        <a:t>PR</a:t>
+                        <a:t>CT</a:t>
                       </a:r>
                       <a:endParaRPr lang="en-US" sz="1100" dirty="0">
                         <a:latin typeface="맑은 고딕" charset="0"/>
@@ -15415,7 +15415,7 @@
                           <a:ea typeface="맑은 고딕" pitchFamily="34" charset="-122"/>
                           <a:cs typeface="맑은 고딕" pitchFamily="34" charset="-120"/>
                         </a:rPr>
-                        <a:t>ELECTRONIC</a:t>
+                        <a:t>Ring</a:t>
                       </a:r>
                       <a:endParaRPr lang="en-US" sz="1000" dirty="0">
                         <a:latin typeface="맑은 고딕" charset="0"/>
@@ -15483,7 +15483,7 @@
                           <a:ea typeface="맑은 고딕" pitchFamily="34" charset="-122"/>
                           <a:cs typeface="맑은 고딕" pitchFamily="34" charset="-120"/>
                         </a:rPr>
-                        <a:t>180° Fast Charging Cable (8color) (컬러: 네온그린 / 기종 옵션: USB -&gt; Apple 8pin)</a:t>
+                        <a:t>"Bloometal" 925 Open Ring</a:t>
                       </a:r>
                       <a:endParaRPr lang="en-US" sz="1100" dirty="0">
                         <a:latin typeface="맑은 고딕" charset="0"/>
@@ -15551,7 +15551,7 @@
                           <a:ea typeface="맑은 고딕" pitchFamily="34" charset="-122"/>
                           <a:cs typeface="맑은 고딕" pitchFamily="34" charset="-120"/>
                         </a:rPr>
-                        <a:t>0</a:t>
+                        <a:t>5</a:t>
                       </a:r>
                       <a:endParaRPr lang="en-US" sz="1100" dirty="0">
                         <a:latin typeface="맑은 고딕" charset="0"/>
@@ -15619,7 +15619,7 @@
                           <a:ea typeface="맑은 고딕" pitchFamily="34" charset="-122"/>
                           <a:cs typeface="맑은 고딕" pitchFamily="34" charset="-120"/>
                         </a:rPr>
-                        <a:t>29 개</a:t>
+                        <a:t>1 개</a:t>
                       </a:r>
                       <a:endParaRPr lang="en-US" sz="1100" dirty="0">
                         <a:latin typeface="맑은 고딕" charset="0"/>
@@ -15825,7 +15825,7 @@
                           <a:ea typeface="맑은 고딕" pitchFamily="34" charset="-122"/>
                           <a:cs typeface="맑은 고딕" pitchFamily="34" charset="-120"/>
                         </a:rPr>
-                        <a:t>ELECTRONIC</a:t>
+                        <a:t>ETC</a:t>
                       </a:r>
                       <a:endParaRPr lang="en-US" sz="1000" dirty="0">
                         <a:latin typeface="맑은 고딕" charset="0"/>
@@ -15893,7 +15893,7 @@
                           <a:ea typeface="맑은 고딕" pitchFamily="34" charset="-122"/>
                           <a:cs typeface="맑은 고딕" pitchFamily="34" charset="-120"/>
                         </a:rPr>
-                        <a:t>180° Fast Charging Cable (8color) (컬러: 민트 / 기종 옵션: USB -&gt; Apple 8pin)</a:t>
+                        <a:t>Fuzzy Stripe Slippers (3color) (컬러: 그린 / 사이즈: 240~250(여성))</a:t>
                       </a:r>
                       <a:endParaRPr lang="en-US" sz="1100" dirty="0">
                         <a:latin typeface="맑은 고딕" charset="0"/>
@@ -15961,7 +15961,7 @@
                           <a:ea typeface="맑은 고딕" pitchFamily="34" charset="-122"/>
                           <a:cs typeface="맑은 고딕" pitchFamily="34" charset="-120"/>
                         </a:rPr>
-                        <a:t>0</a:t>
+                        <a:t>6</a:t>
                       </a:r>
                       <a:endParaRPr lang="en-US" sz="1100" dirty="0">
                         <a:latin typeface="맑은 고딕" charset="0"/>
@@ -16029,7 +16029,7 @@
                           <a:ea typeface="맑은 고딕" pitchFamily="34" charset="-122"/>
                           <a:cs typeface="맑은 고딕" pitchFamily="34" charset="-120"/>
                         </a:rPr>
-                        <a:t>28 개</a:t>
+                        <a:t>1 개</a:t>
                       </a:r>
                       <a:endParaRPr lang="en-US" sz="1100" dirty="0">
                         <a:latin typeface="맑은 고딕" charset="0"/>
@@ -16167,7 +16167,7 @@
                           <a:ea typeface="맑은 고딕" pitchFamily="34" charset="-122"/>
                           <a:cs typeface="맑은 고딕" pitchFamily="34" charset="-120"/>
                         </a:rPr>
-                        <a:t>6A</a:t>
+                        <a:t>PR</a:t>
                       </a:r>
                       <a:endParaRPr lang="en-US" sz="1100" dirty="0">
                         <a:latin typeface="맑은 고딕" charset="0"/>
@@ -16235,7 +16235,7 @@
                           <a:ea typeface="맑은 고딕" pitchFamily="34" charset="-122"/>
                           <a:cs typeface="맑은 고딕" pitchFamily="34" charset="-120"/>
                         </a:rPr>
-                        <a:t>Necklace</a:t>
+                        <a:t>ETC</a:t>
                       </a:r>
                       <a:endParaRPr lang="en-US" sz="1000" dirty="0">
                         <a:latin typeface="맑은 고딕" charset="0"/>
@@ -16303,7 +16303,7 @@
                           <a:ea typeface="맑은 고딕" pitchFamily="34" charset="-122"/>
                           <a:cs typeface="맑은 고딕" pitchFamily="34" charset="-120"/>
                         </a:rPr>
-                        <a:t>Marquise Necklace</a:t>
+                        <a:t>Cotton Lunch Mini Bag (5color) (색상: 레드)</a:t>
                       </a:r>
                       <a:endParaRPr lang="en-US" sz="1100" dirty="0">
                         <a:latin typeface="맑은 고딕" charset="0"/>
@@ -16371,7 +16371,7 @@
                           <a:ea typeface="맑은 고딕" pitchFamily="34" charset="-122"/>
                           <a:cs typeface="맑은 고딕" pitchFamily="34" charset="-120"/>
                         </a:rPr>
-                        <a:t>0</a:t>
+                        <a:t>8</a:t>
                       </a:r>
                       <a:endParaRPr lang="en-US" sz="1100" dirty="0">
                         <a:latin typeface="맑은 고딕" charset="0"/>
@@ -16439,7 +16439,7 @@
                           <a:ea typeface="맑은 고딕" pitchFamily="34" charset="-122"/>
                           <a:cs typeface="맑은 고딕" pitchFamily="34" charset="-120"/>
                         </a:rPr>
-                        <a:t>8 개</a:t>
+                        <a:t>1 개</a:t>
                       </a:r>
                       <a:endParaRPr lang="en-US" sz="1100" dirty="0">
                         <a:latin typeface="맑은 고딕" charset="0"/>
@@ -16577,7 +16577,7 @@
                           <a:ea typeface="맑은 고딕" pitchFamily="34" charset="-122"/>
                           <a:cs typeface="맑은 고딕" pitchFamily="34" charset="-120"/>
                         </a:rPr>
-                        <a:t>6A</a:t>
+                        <a:t>PR</a:t>
                       </a:r>
                       <a:endParaRPr lang="en-US" sz="1100" dirty="0">
                         <a:latin typeface="맑은 고딕" charset="0"/>
@@ -16645,7 +16645,7 @@
                           <a:ea typeface="맑은 고딕" pitchFamily="34" charset="-122"/>
                           <a:cs typeface="맑은 고딕" pitchFamily="34" charset="-120"/>
                         </a:rPr>
-                        <a:t>★Season off★</a:t>
+                        <a:t>ELECTRONIC</a:t>
                       </a:r>
                       <a:endParaRPr lang="en-US" sz="1000" dirty="0">
                         <a:latin typeface="맑은 고딕" charset="0"/>
@@ -16713,7 +16713,7 @@
                           <a:ea typeface="맑은 고딕" pitchFamily="34" charset="-122"/>
                           <a:cs typeface="맑은 고딕" pitchFamily="34" charset="-120"/>
                         </a:rPr>
-                        <a:t>Tangle Keychain</a:t>
+                        <a:t>180° Fast Charging Cable (8color) (컬러: 오렌지 / 기종 옵션: C type -&gt; C type)</a:t>
                       </a:r>
                       <a:endParaRPr lang="en-US" sz="1100" dirty="0">
                         <a:latin typeface="맑은 고딕" charset="0"/>
@@ -16781,7 +16781,7 @@
                           <a:ea typeface="맑은 고딕" pitchFamily="34" charset="-122"/>
                           <a:cs typeface="맑은 고딕" pitchFamily="34" charset="-120"/>
                         </a:rPr>
-                        <a:t>3</a:t>
+                        <a:t>0</a:t>
                       </a:r>
                       <a:endParaRPr lang="en-US" sz="1100" dirty="0">
                         <a:latin typeface="맑은 고딕" charset="0"/>
@@ -17875,7 +17875,7 @@
                           <a:ea typeface="맑은 고딕" pitchFamily="34" charset="-122"/>
                           <a:cs typeface="맑은 고딕" pitchFamily="34" charset="-120"/>
                         </a:rPr>
-                        <a:t>Necklace</a:t>
+                        <a:t>★Season off★</a:t>
                       </a:r>
                       <a:endParaRPr lang="en-US" sz="1000" dirty="0">
                         <a:latin typeface="맑은 고딕" charset="0"/>
@@ -17943,7 +17943,7 @@
                           <a:ea typeface="맑은 고딕" pitchFamily="34" charset="-122"/>
                           <a:cs typeface="맑은 고딕" pitchFamily="34" charset="-120"/>
                         </a:rPr>
-                        <a:t>B-Flower Necklace (Size: 1 Size)</a:t>
+                        <a:t>Tangle Keychain</a:t>
                       </a:r>
                       <a:endParaRPr lang="en-US" sz="1100" dirty="0">
                         <a:latin typeface="맑은 고딕" charset="0"/>
@@ -18011,7 +18011,7 @@
                           <a:ea typeface="맑은 고딕" pitchFamily="34" charset="-122"/>
                           <a:cs typeface="맑은 고딕" pitchFamily="34" charset="-120"/>
                         </a:rPr>
-                        <a:t>0</a:t>
+                        <a:t>3</a:t>
                       </a:r>
                       <a:endParaRPr lang="en-US" sz="1100" dirty="0">
                         <a:latin typeface="맑은 고딕" charset="0"/>
@@ -18168,7 +18168,7 @@
                 <a:ea typeface="맑은 고딕" pitchFamily="34" charset="-122"/>
                 <a:cs typeface="맑은 고딕" pitchFamily="34" charset="-120"/>
               </a:rPr>
-              <a:t>외 48건 더 있음 — 상세는 시트에서 확인</a:t>
+              <a:t>외 50건 더 있음 — 상세는 시트에서 확인</a:t>
             </a:r>
             <a:endParaRPr lang="en-US" sz="1000" dirty="0"/>
           </a:p>
@@ -18207,7 +18207,7 @@
                 <a:ea typeface="맑은 고딕" pitchFamily="34" charset="-122"/>
                 <a:cs typeface="맑은 고딕" pitchFamily="34" charset="-120"/>
               </a:rPr>
-              <a:t>베스트 상품 리포트  ·  생성 2026-05-16 08:00</a:t>
+              <a:t>베스트 상품 리포트  ·  생성 2026-05-17 08:00</a:t>
             </a:r>
             <a:endParaRPr lang="en-US" sz="900" dirty="0"/>
           </a:p>
@@ -18420,7 +18420,7 @@
                 <a:ea typeface="맑은 고딕" pitchFamily="34" charset="-122"/>
                 <a:cs typeface="맑은 고딕" pitchFamily="34" charset="-120"/>
               </a:rPr>
-              <a:t>2026년 05월 16일 (토)</a:t>
+              <a:t>2026년 05월 17일 (일)</a:t>
             </a:r>
             <a:endParaRPr lang="en-US" sz="1200" dirty="0"/>
           </a:p>
@@ -18587,7 +18587,7 @@
                 <a:ea typeface="맑은 고딕" pitchFamily="34" charset="-122"/>
                 <a:cs typeface="맑은 고딕" pitchFamily="34" charset="-120"/>
               </a:rPr>
-              <a:t>Google Sheet '브랜드 재고현황'  ·  최신화 2026-05-16 08:00</a:t>
+              <a:t>Google Sheet '브랜드 재고현황'  ·  최신화 2026-05-17 08:00</a:t>
             </a:r>
             <a:endParaRPr lang="en-US" sz="1100" dirty="0"/>
           </a:p>
@@ -19230,7 +19230,7 @@
                 <a:ea typeface="맑은 고딕" pitchFamily="34" charset="-122"/>
                 <a:cs typeface="맑은 고딕" pitchFamily="34" charset="-120"/>
               </a:rPr>
-              <a:t>✅ 3개 브랜드 모두 정상 추출  ·  24h 출고 기준 (2026-05-15 08:00 → 2026-05-16 08:00) · 신규 SKU 12건은 결제완료 기준</a:t>
+              <a:t>✅ 3개 브랜드 모두 정상 추출  ·  24h 출고 기준 (2026-05-16 08:00 → 2026-05-17 08:00) · 신규 SKU 12건은 결제완료 기준</a:t>
             </a:r>
             <a:endParaRPr lang="en-US" sz="1000" dirty="0"/>
           </a:p>
@@ -19269,7 +19269,7 @@
                 <a:ea typeface="맑은 고딕" pitchFamily="34" charset="-122"/>
                 <a:cs typeface="맑은 고딕" pitchFamily="34" charset="-120"/>
               </a:rPr>
-              <a:t>베스트 상품 리포트  ·  생성 2026-05-16 08:00</a:t>
+              <a:t>베스트 상품 리포트  ·  생성 2026-05-17 08:00</a:t>
             </a:r>
             <a:endParaRPr lang="en-US" sz="900" dirty="0"/>
           </a:p>

</xml_diff>

<commit_message>
chore: 매출 PPT 업로드 (best-sellers-2026-05-18.pptx) [auto]
</commit_message>
<xml_diff>
--- a/data/sales-report.pptx
+++ b/data/sales-report.pptx
@@ -1648,7 +1648,7 @@
                 <a:ea typeface="맑은 고딕" pitchFamily="34" charset="-122"/>
                 <a:cs typeface="맑은 고딕" pitchFamily="34" charset="-120"/>
               </a:rPr>
-              <a:t>2026년 05월 17일 (일)  ·  24h 출고 기준</a:t>
+              <a:t>2026년 05월 18일 (월)  ·  24h 출고 기준</a:t>
             </a:r>
             <a:endParaRPr lang="en-US" sz="2200" dirty="0"/>
           </a:p>
@@ -1726,7 +1726,7 @@
                 <a:ea typeface="맑은 고딕" pitchFamily="34" charset="-122"/>
                 <a:cs typeface="맑은 고딕" pitchFamily="34" charset="-120"/>
               </a:rPr>
-              <a:t>05.17</a:t>
+              <a:t>05.18</a:t>
             </a:r>
             <a:endParaRPr lang="en-US" sz="7200" dirty="0"/>
           </a:p>
@@ -1765,7 +1765,7 @@
                 <a:ea typeface="맑은 고딕" pitchFamily="34" charset="-122"/>
                 <a:cs typeface="맑은 고딕" pitchFamily="34" charset="-120"/>
               </a:rPr>
-              <a:t>일요일</a:t>
+              <a:t>월요일</a:t>
             </a:r>
             <a:endParaRPr lang="en-US" sz="1400" dirty="0"/>
           </a:p>
@@ -1804,7 +1804,7 @@
                 <a:ea typeface="맑은 고딕" pitchFamily="34" charset="-122"/>
                 <a:cs typeface="맑은 고딕" pitchFamily="34" charset="-120"/>
               </a:rPr>
-              <a:t>생성 2026-05-17 08:00  ·  Google Sheet 자동 동기</a:t>
+              <a:t>생성 2026-05-18 08:00  ·  Google Sheet 자동 동기</a:t>
             </a:r>
             <a:endParaRPr lang="en-US" sz="1000" dirty="0"/>
           </a:p>
@@ -1978,7 +1978,7 @@
                 <a:ea typeface="맑은 고딕" pitchFamily="34" charset="-122"/>
                 <a:cs typeface="맑은 고딕" pitchFamily="34" charset="-120"/>
               </a:rPr>
-              <a:t>2026년 05월 17일 (일)</a:t>
+              <a:t>2026년 05월 18일 (월)</a:t>
             </a:r>
             <a:endParaRPr lang="en-US" sz="1200" dirty="0"/>
           </a:p>
@@ -2145,7 +2145,7 @@
                 <a:ea typeface="맑은 고딕" pitchFamily="34" charset="-122"/>
                 <a:cs typeface="맑은 고딕" pitchFamily="34" charset="-120"/>
               </a:rPr>
-              <a:t>652 개</a:t>
+              <a:t>808 개</a:t>
             </a:r>
             <a:endParaRPr lang="en-US" sz="3600" dirty="0"/>
           </a:p>
@@ -2312,7 +2312,7 @@
                 <a:ea typeface="맑은 고딕" pitchFamily="34" charset="-122"/>
                 <a:cs typeface="맑은 고딕" pitchFamily="34" charset="-120"/>
               </a:rPr>
-              <a:t>59 건</a:t>
+              <a:t>64 건</a:t>
             </a:r>
             <a:endParaRPr lang="en-US" sz="3200" dirty="0"/>
           </a:p>
@@ -2479,7 +2479,7 @@
                 <a:ea typeface="맑은 고딕" pitchFamily="34" charset="-122"/>
                 <a:cs typeface="맑은 고딕" pitchFamily="34" charset="-120"/>
               </a:rPr>
-              <a:t>9 건</a:t>
+              <a:t>12 건</a:t>
             </a:r>
             <a:endParaRPr lang="en-US" sz="3200" dirty="0"/>
           </a:p>
@@ -3612,7 +3612,7 @@
                           <a:ea typeface="맑은 고딕" pitchFamily="34" charset="-122"/>
                           <a:cs typeface="맑은 고딕" pitchFamily="34" charset="-120"/>
                         </a:rPr>
-                        <a:t>[SILVER925] CH.alban Open Ring</a:t>
+                        <a:t>[SILVER925] Guyeong Open Ring v3.0 (silver)</a:t>
                       </a:r>
                       <a:endParaRPr lang="en-US" sz="1100" dirty="0">
                         <a:latin typeface="맑은 고딕" charset="0"/>
@@ -3677,7 +3677,7 @@
                           <a:ea typeface="맑은 고딕" pitchFamily="34" charset="-122"/>
                           <a:cs typeface="맑은 고딕" pitchFamily="34" charset="-120"/>
                         </a:rPr>
-                        <a:t>68 개</a:t>
+                        <a:t>113 개</a:t>
                       </a:r>
                       <a:endParaRPr lang="en-US" sz="1400" dirty="0">
                         <a:latin typeface="맑은 고딕" charset="0"/>
@@ -3809,7 +3809,7 @@
                           <a:ea typeface="맑은 고딕" pitchFamily="34" charset="-122"/>
                           <a:cs typeface="맑은 고딕" pitchFamily="34" charset="-120"/>
                         </a:rPr>
-                        <a:t>6A</a:t>
+                        <a:t>CT</a:t>
                       </a:r>
                       <a:endParaRPr lang="en-US" sz="1100" dirty="0">
                         <a:latin typeface="맑은 고딕" charset="0"/>
@@ -3874,7 +3874,7 @@
                           <a:ea typeface="맑은 고딕" pitchFamily="34" charset="-122"/>
                           <a:cs typeface="맑은 고딕" pitchFamily="34" charset="-120"/>
                         </a:rPr>
-                        <a:t>Ring</a:t>
+                        <a:t>Necklace</a:t>
                       </a:r>
                       <a:endParaRPr lang="en-US" sz="1000" dirty="0">
                         <a:latin typeface="맑은 고딕" charset="0"/>
@@ -3939,7 +3939,7 @@
                           <a:ea typeface="맑은 고딕" pitchFamily="34" charset="-122"/>
                           <a:cs typeface="맑은 고딕" pitchFamily="34" charset="-120"/>
                         </a:rPr>
-                        <a:t>[SILVER925] Guyeong Open Ring v3.0 (silver)</a:t>
+                        <a:t>CandyPOP Necklace (사이즈: 2size (47~52cm))</a:t>
                       </a:r>
                       <a:endParaRPr lang="en-US" sz="1100" dirty="0">
                         <a:latin typeface="맑은 고딕" charset="0"/>
@@ -4004,7 +4004,7 @@
                           <a:ea typeface="맑은 고딕" pitchFamily="34" charset="-122"/>
                           <a:cs typeface="맑은 고딕" pitchFamily="34" charset="-120"/>
                         </a:rPr>
-                        <a:t>62 개</a:t>
+                        <a:t>57 개</a:t>
                       </a:r>
                       <a:endParaRPr lang="en-US" sz="1400" dirty="0">
                         <a:latin typeface="맑은 고딕" charset="0"/>
@@ -4331,7 +4331,7 @@
                           <a:ea typeface="맑은 고딕" pitchFamily="34" charset="-122"/>
                           <a:cs typeface="맑은 고딕" pitchFamily="34" charset="-120"/>
                         </a:rPr>
-                        <a:t>51 개</a:t>
+                        <a:t>57 개</a:t>
                       </a:r>
                       <a:endParaRPr lang="en-US" sz="1400" dirty="0">
                         <a:latin typeface="맑은 고딕" charset="0"/>
@@ -4463,7 +4463,7 @@
                           <a:ea typeface="맑은 고딕" pitchFamily="34" charset="-122"/>
                           <a:cs typeface="맑은 고딕" pitchFamily="34" charset="-120"/>
                         </a:rPr>
-                        <a:t>CT</a:t>
+                        <a:t>6A</a:t>
                       </a:r>
                       <a:endParaRPr lang="en-US" sz="1100" dirty="0">
                         <a:latin typeface="맑은 고딕" charset="0"/>
@@ -4528,7 +4528,7 @@
                           <a:ea typeface="맑은 고딕" pitchFamily="34" charset="-122"/>
                           <a:cs typeface="맑은 고딕" pitchFamily="34" charset="-120"/>
                         </a:rPr>
-                        <a:t>Necklace</a:t>
+                        <a:t>Ring</a:t>
                       </a:r>
                       <a:endParaRPr lang="en-US" sz="1000" dirty="0">
                         <a:latin typeface="맑은 고딕" charset="0"/>
@@ -4593,7 +4593,7 @@
                           <a:ea typeface="맑은 고딕" pitchFamily="34" charset="-122"/>
                           <a:cs typeface="맑은 고딕" pitchFamily="34" charset="-120"/>
                         </a:rPr>
-                        <a:t>CandyPOP Necklace (사이즈: 2size (47~52cm))</a:t>
+                        <a:t>[SILVER925] CH.alban Open Ring</a:t>
                       </a:r>
                       <a:endParaRPr lang="en-US" sz="1100" dirty="0">
                         <a:latin typeface="맑은 고딕" charset="0"/>
@@ -4658,7 +4658,7 @@
                           <a:ea typeface="맑은 고딕" pitchFamily="34" charset="-122"/>
                           <a:cs typeface="맑은 고딕" pitchFamily="34" charset="-120"/>
                         </a:rPr>
-                        <a:t>48 개</a:t>
+                        <a:t>46 개</a:t>
                       </a:r>
                       <a:endParaRPr lang="en-US" sz="1200" dirty="0">
                         <a:latin typeface="맑은 고딕" charset="0"/>
@@ -4985,7 +4985,7 @@
                           <a:ea typeface="맑은 고딕" pitchFamily="34" charset="-122"/>
                           <a:cs typeface="맑은 고딕" pitchFamily="34" charset="-120"/>
                         </a:rPr>
-                        <a:t>29 개</a:t>
+                        <a:t>43 개</a:t>
                       </a:r>
                       <a:endParaRPr lang="en-US" sz="1200" dirty="0">
                         <a:latin typeface="맑은 고딕" charset="0"/>
@@ -5071,7 +5071,7 @@
                 <a:ea typeface="맑은 고딕" pitchFamily="34" charset="-122"/>
                 <a:cs typeface="맑은 고딕" pitchFamily="34" charset="-120"/>
               </a:rPr>
-              <a:t>베스트 상품 리포트  ·  생성 2026-05-17 08:00</a:t>
+              <a:t>베스트 상품 리포트  ·  생성 2026-05-18 08:00</a:t>
             </a:r>
             <a:endParaRPr lang="en-US" sz="900" dirty="0"/>
           </a:p>
@@ -5284,7 +5284,7 @@
                 <a:ea typeface="맑은 고딕" pitchFamily="34" charset="-122"/>
                 <a:cs typeface="맑은 고딕" pitchFamily="34" charset="-120"/>
               </a:rPr>
-              <a:t>2026년 05월 17일 (일)</a:t>
+              <a:t>2026년 05월 18일 (월)</a:t>
             </a:r>
             <a:endParaRPr lang="en-US" sz="1200" dirty="0"/>
           </a:p>
@@ -5451,7 +5451,7 @@
                 <a:ea typeface="맑은 고딕" pitchFamily="34" charset="-122"/>
                 <a:cs typeface="맑은 고딕" pitchFamily="34" charset="-120"/>
               </a:rPr>
-              <a:t>499 개</a:t>
+              <a:t>605 개</a:t>
             </a:r>
             <a:endParaRPr lang="en-US" sz="3600" dirty="0"/>
           </a:p>
@@ -5579,7 +5579,7 @@
                 <a:ea typeface="맑은 고딕" pitchFamily="34" charset="-122"/>
                 <a:cs typeface="맑은 고딕" pitchFamily="34" charset="-120"/>
               </a:rPr>
-              <a:t>[SILVER925] CH.alban Open Ring</a:t>
+              <a:t>[SILVER925] Guyeong Open Ring v3.0 (silver)</a:t>
             </a:r>
             <a:endParaRPr lang="en-US" sz="1800" dirty="0"/>
           </a:p>
@@ -5657,7 +5657,7 @@
                 <a:ea typeface="맑은 고딕" pitchFamily="34" charset="-122"/>
                 <a:cs typeface="맑은 고딕" pitchFamily="34" charset="-120"/>
               </a:rPr>
-              <a:t>68</a:t>
+              <a:t>113</a:t>
             </a:r>
             <a:endParaRPr lang="en-US" sz="4400" dirty="0"/>
           </a:p>
@@ -6191,7 +6191,7 @@
                           <a:ea typeface="맑은 고딕" pitchFamily="34" charset="-122"/>
                           <a:cs typeface="맑은 고딕" pitchFamily="34" charset="-120"/>
                         </a:rPr>
-                        <a:t>[SILVER925] CH.alban Open Ring</a:t>
+                        <a:t>[SILVER925] Guyeong Open Ring v3.0 (silver)</a:t>
                       </a:r>
                       <a:endParaRPr lang="en-US" sz="1100" dirty="0">
                         <a:latin typeface="맑은 고딕" charset="0"/>
@@ -6256,7 +6256,7 @@
                           <a:ea typeface="맑은 고딕" pitchFamily="34" charset="-122"/>
                           <a:cs typeface="맑은 고딕" pitchFamily="34" charset="-120"/>
                         </a:rPr>
-                        <a:t>68 개</a:t>
+                        <a:t>113 개</a:t>
                       </a:r>
                       <a:endParaRPr lang="en-US" sz="1400" dirty="0">
                         <a:latin typeface="맑은 고딕" charset="0"/>
@@ -6453,7 +6453,7 @@
                           <a:ea typeface="맑은 고딕" pitchFamily="34" charset="-122"/>
                           <a:cs typeface="맑은 고딕" pitchFamily="34" charset="-120"/>
                         </a:rPr>
-                        <a:t>[SILVER925] Guyeong Open Ring v3.0 (silver)</a:t>
+                        <a:t>[SILVER925] CH.alban Open Ring</a:t>
                       </a:r>
                       <a:endParaRPr lang="en-US" sz="1100" dirty="0">
                         <a:latin typeface="맑은 고딕" charset="0"/>
@@ -6518,7 +6518,7 @@
                           <a:ea typeface="맑은 고딕" pitchFamily="34" charset="-122"/>
                           <a:cs typeface="맑은 고딕" pitchFamily="34" charset="-120"/>
                         </a:rPr>
-                        <a:t>62 개</a:t>
+                        <a:t>46 개</a:t>
                       </a:r>
                       <a:endParaRPr lang="en-US" sz="1200" dirty="0">
                         <a:latin typeface="맑은 고딕" charset="0"/>
@@ -6780,7 +6780,7 @@
                           <a:ea typeface="맑은 고딕" pitchFamily="34" charset="-122"/>
                           <a:cs typeface="맑은 고딕" pitchFamily="34" charset="-120"/>
                         </a:rPr>
-                        <a:t>29 개</a:t>
+                        <a:t>43 개</a:t>
                       </a:r>
                       <a:endParaRPr lang="en-US" sz="1200" dirty="0">
                         <a:latin typeface="맑은 고딕" charset="0"/>
@@ -7042,7 +7042,7 @@
                           <a:ea typeface="맑은 고딕" pitchFamily="34" charset="-122"/>
                           <a:cs typeface="맑은 고딕" pitchFamily="34" charset="-120"/>
                         </a:rPr>
-                        <a:t>26 개</a:t>
+                        <a:t>42 개</a:t>
                       </a:r>
                       <a:endParaRPr lang="en-US" sz="1200" dirty="0">
                         <a:latin typeface="맑은 고딕" charset="0"/>
@@ -7304,7 +7304,7 @@
                           <a:ea typeface="맑은 고딕" pitchFamily="34" charset="-122"/>
                           <a:cs typeface="맑은 고딕" pitchFamily="34" charset="-120"/>
                         </a:rPr>
-                        <a:t>24 개</a:t>
+                        <a:t>42 개</a:t>
                       </a:r>
                       <a:endParaRPr lang="en-US" sz="1200" dirty="0">
                         <a:latin typeface="맑은 고딕" charset="0"/>
@@ -7390,7 +7390,7 @@
                 <a:ea typeface="맑은 고딕" pitchFamily="34" charset="-122"/>
                 <a:cs typeface="맑은 고딕" pitchFamily="34" charset="-120"/>
               </a:rPr>
-              <a:t>리오더 필요  🔴 긴급 6건</a:t>
+              <a:t>리오더 필요  🔴 긴급 9건</a:t>
             </a:r>
             <a:pPr indent="0" marL="0">
               <a:buNone/>
@@ -7557,7 +7557,7 @@
                 <a:ea typeface="맑은 고딕" pitchFamily="34" charset="-122"/>
                 <a:cs typeface="맑은 고딕" pitchFamily="34" charset="-120"/>
               </a:rPr>
-              <a:t>[SILVER925] Geos Open Ring</a:t>
+              <a:t>[SILVER925] Azure Open Ring</a:t>
             </a:r>
             <a:endParaRPr lang="en-US" sz="1100" dirty="0"/>
           </a:p>
@@ -7596,7 +7596,7 @@
                 <a:ea typeface="맑은 고딕" pitchFamily="34" charset="-122"/>
                 <a:cs typeface="맑은 고딕" pitchFamily="34" charset="-120"/>
               </a:rPr>
-              <a:t>Ring  ·  재고 0개</a:t>
+              <a:t>Ring  ·  재고 2개</a:t>
             </a:r>
             <a:pPr indent="0" marL="0">
               <a:buNone/>
@@ -7763,6 +7763,418 @@
                 <a:ea typeface="맑은 고딕" pitchFamily="34" charset="-122"/>
                 <a:cs typeface="맑은 고딕" pitchFamily="34" charset="-120"/>
               </a:rPr>
+              <a:t>RichardKokser Necklace</a:t>
+            </a:r>
+            <a:endParaRPr lang="en-US" sz="1100" dirty="0"/>
+          </a:p>
+        </p:txBody>
+      </p:sp>
+      <p:sp>
+        <p:nvSpPr>
+          <p:cNvPr id="32" name="Text 29"/>
+          <p:cNvSpPr/>
+          <p:nvPr/>
+        </p:nvSpPr>
+        <p:spPr>
+          <a:xfrm>
+            <a:off x="8211312" y="4425696"/>
+            <a:ext cx="3291840" cy="256032"/>
+          </a:xfrm>
+          <a:prstGeom prst="rect">
+            <a:avLst/>
+          </a:prstGeom>
+          <a:noFill/>
+          <a:ln/>
+        </p:spPr>
+        <p:txBody>
+          <a:bodyPr wrap="square" lIns="0" tIns="0" rIns="0" bIns="0" rtlCol="0" anchor="ctr"/>
+          <a:lstStyle/>
+          <a:p>
+            <a:pPr indent="0" marL="0">
+              <a:buNone/>
+            </a:pPr>
+            <a:r>
+              <a:rPr lang="en-US" sz="1000" dirty="0">
+                <a:solidFill>
+                  <a:srgbClr val="6B7280"/>
+                </a:solidFill>
+                <a:latin typeface="맑은 고딕" pitchFamily="34" charset="0"/>
+                <a:ea typeface="맑은 고딕" pitchFamily="34" charset="-122"/>
+                <a:cs typeface="맑은 고딕" pitchFamily="34" charset="-120"/>
+              </a:rPr>
+              <a:t>Necklace  ·  재고 5개</a:t>
+            </a:r>
+            <a:pPr indent="0" marL="0">
+              <a:buNone/>
+            </a:pPr>
+            <a:r>
+              <a:rPr lang="en-US" sz="1000" b="1" dirty="0">
+                <a:solidFill>
+                  <a:srgbClr val="D72638"/>
+                </a:solidFill>
+                <a:latin typeface="맑은 고딕" pitchFamily="34" charset="0"/>
+                <a:ea typeface="맑은 고딕" pitchFamily="34" charset="-122"/>
+                <a:cs typeface="맑은 고딕" pitchFamily="34" charset="-120"/>
+              </a:rPr>
+              <a:t/>
+            </a:r>
+            <a:endParaRPr lang="en-US" sz="1000" dirty="0"/>
+          </a:p>
+        </p:txBody>
+      </p:sp>
+      <p:sp>
+        <p:nvSpPr>
+          <p:cNvPr id="33" name="Shape 30"/>
+          <p:cNvSpPr/>
+          <p:nvPr/>
+        </p:nvSpPr>
+        <p:spPr>
+          <a:xfrm>
+            <a:off x="7406640" y="4809744"/>
+            <a:ext cx="4206240" cy="640080"/>
+          </a:xfrm>
+          <a:prstGeom prst="rect">
+            <a:avLst/>
+          </a:prstGeom>
+          <a:solidFill>
+            <a:srgbClr val="FFF5F5"/>
+          </a:solidFill>
+          <a:ln w="6350">
+            <a:solidFill>
+              <a:srgbClr val="E5E7EB"/>
+            </a:solidFill>
+            <a:prstDash val="solid"/>
+          </a:ln>
+        </p:spPr>
+      </p:sp>
+      <p:sp>
+        <p:nvSpPr>
+          <p:cNvPr id="34" name="Shape 31"/>
+          <p:cNvSpPr/>
+          <p:nvPr/>
+        </p:nvSpPr>
+        <p:spPr>
+          <a:xfrm>
+            <a:off x="7406640" y="4809744"/>
+            <a:ext cx="109728" cy="640080"/>
+          </a:xfrm>
+          <a:prstGeom prst="rect">
+            <a:avLst/>
+          </a:prstGeom>
+          <a:solidFill>
+            <a:srgbClr val="D72638"/>
+          </a:solidFill>
+          <a:ln w="12700">
+            <a:solidFill>
+              <a:srgbClr val="D72638"/>
+            </a:solidFill>
+            <a:prstDash val="solid"/>
+          </a:ln>
+        </p:spPr>
+      </p:sp>
+      <p:sp>
+        <p:nvSpPr>
+          <p:cNvPr id="35" name="Shape 32"/>
+          <p:cNvSpPr/>
+          <p:nvPr/>
+        </p:nvSpPr>
+        <p:spPr>
+          <a:xfrm>
+            <a:off x="7571232" y="4901184"/>
+            <a:ext cx="548640" cy="256032"/>
+          </a:xfrm>
+          <a:prstGeom prst="rect">
+            <a:avLst/>
+          </a:prstGeom>
+          <a:solidFill>
+            <a:srgbClr val="D72638"/>
+          </a:solidFill>
+          <a:ln w="12700">
+            <a:solidFill>
+              <a:srgbClr val="D72638"/>
+            </a:solidFill>
+            <a:prstDash val="solid"/>
+          </a:ln>
+        </p:spPr>
+      </p:sp>
+      <p:sp>
+        <p:nvSpPr>
+          <p:cNvPr id="36" name="Text 33"/>
+          <p:cNvSpPr/>
+          <p:nvPr/>
+        </p:nvSpPr>
+        <p:spPr>
+          <a:xfrm>
+            <a:off x="7571232" y="4901184"/>
+            <a:ext cx="548640" cy="256032"/>
+          </a:xfrm>
+          <a:prstGeom prst="rect">
+            <a:avLst/>
+          </a:prstGeom>
+          <a:noFill/>
+          <a:ln/>
+        </p:spPr>
+        <p:txBody>
+          <a:bodyPr wrap="square" lIns="0" tIns="0" rIns="0" bIns="0" rtlCol="0" anchor="ctr"/>
+          <a:lstStyle/>
+          <a:p>
+            <a:pPr algn="ctr" indent="0" marL="0">
+              <a:buNone/>
+            </a:pPr>
+            <a:r>
+              <a:rPr lang="en-US" sz="900" b="1" dirty="0">
+                <a:solidFill>
+                  <a:srgbClr val="FFFFFF"/>
+                </a:solidFill>
+                <a:latin typeface="맑은 고딕" pitchFamily="34" charset="0"/>
+                <a:ea typeface="맑은 고딕" pitchFamily="34" charset="-122"/>
+                <a:cs typeface="맑은 고딕" pitchFamily="34" charset="-120"/>
+              </a:rPr>
+              <a:t>긴급</a:t>
+            </a:r>
+            <a:endParaRPr lang="en-US" sz="900" dirty="0"/>
+          </a:p>
+        </p:txBody>
+      </p:sp>
+      <p:sp>
+        <p:nvSpPr>
+          <p:cNvPr id="37" name="Text 34"/>
+          <p:cNvSpPr/>
+          <p:nvPr/>
+        </p:nvSpPr>
+        <p:spPr>
+          <a:xfrm>
+            <a:off x="8211312" y="4864608"/>
+            <a:ext cx="3291840" cy="274320"/>
+          </a:xfrm>
+          <a:prstGeom prst="rect">
+            <a:avLst/>
+          </a:prstGeom>
+          <a:noFill/>
+          <a:ln/>
+        </p:spPr>
+        <p:txBody>
+          <a:bodyPr wrap="square" lIns="0" tIns="0" rIns="0" bIns="0" rtlCol="0" anchor="ctr"/>
+          <a:lstStyle/>
+          <a:p>
+            <a:pPr indent="0" marL="0">
+              <a:buNone/>
+            </a:pPr>
+            <a:r>
+              <a:rPr lang="en-US" sz="1100" b="1" dirty="0">
+                <a:solidFill>
+                  <a:srgbClr val="0B1220"/>
+                </a:solidFill>
+                <a:latin typeface="맑은 고딕" pitchFamily="34" charset="0"/>
+                <a:ea typeface="맑은 고딕" pitchFamily="34" charset="-122"/>
+                <a:cs typeface="맑은 고딕" pitchFamily="34" charset="-120"/>
+              </a:rPr>
+              <a:t>Two-ball Bangle</a:t>
+            </a:r>
+            <a:endParaRPr lang="en-US" sz="1100" dirty="0"/>
+          </a:p>
+        </p:txBody>
+      </p:sp>
+      <p:sp>
+        <p:nvSpPr>
+          <p:cNvPr id="38" name="Text 35"/>
+          <p:cNvSpPr/>
+          <p:nvPr/>
+        </p:nvSpPr>
+        <p:spPr>
+          <a:xfrm>
+            <a:off x="8211312" y="5138928"/>
+            <a:ext cx="3291840" cy="256032"/>
+          </a:xfrm>
+          <a:prstGeom prst="rect">
+            <a:avLst/>
+          </a:prstGeom>
+          <a:noFill/>
+          <a:ln/>
+        </p:spPr>
+        <p:txBody>
+          <a:bodyPr wrap="square" lIns="0" tIns="0" rIns="0" bIns="0" rtlCol="0" anchor="ctr"/>
+          <a:lstStyle/>
+          <a:p>
+            <a:pPr indent="0" marL="0">
+              <a:buNone/>
+            </a:pPr>
+            <a:r>
+              <a:rPr lang="en-US" sz="1000" dirty="0">
+                <a:solidFill>
+                  <a:srgbClr val="6B7280"/>
+                </a:solidFill>
+                <a:latin typeface="맑은 고딕" pitchFamily="34" charset="0"/>
+                <a:ea typeface="맑은 고딕" pitchFamily="34" charset="-122"/>
+                <a:cs typeface="맑은 고딕" pitchFamily="34" charset="-120"/>
+              </a:rPr>
+              <a:t>Bracelet  ·  재고 5개</a:t>
+            </a:r>
+            <a:pPr indent="0" marL="0">
+              <a:buNone/>
+            </a:pPr>
+            <a:r>
+              <a:rPr lang="en-US" sz="1000" b="1" dirty="0">
+                <a:solidFill>
+                  <a:srgbClr val="D72638"/>
+                </a:solidFill>
+                <a:latin typeface="맑은 고딕" pitchFamily="34" charset="0"/>
+                <a:ea typeface="맑은 고딕" pitchFamily="34" charset="-122"/>
+                <a:cs typeface="맑은 고딕" pitchFamily="34" charset="-120"/>
+              </a:rPr>
+              <a:t/>
+            </a:r>
+            <a:endParaRPr lang="en-US" sz="1000" dirty="0"/>
+          </a:p>
+        </p:txBody>
+      </p:sp>
+      <p:sp>
+        <p:nvSpPr>
+          <p:cNvPr id="39" name="Shape 36"/>
+          <p:cNvSpPr/>
+          <p:nvPr/>
+        </p:nvSpPr>
+        <p:spPr>
+          <a:xfrm>
+            <a:off x="7406640" y="5522976"/>
+            <a:ext cx="4206240" cy="640080"/>
+          </a:xfrm>
+          <a:prstGeom prst="rect">
+            <a:avLst/>
+          </a:prstGeom>
+          <a:solidFill>
+            <a:srgbClr val="FFF5F5"/>
+          </a:solidFill>
+          <a:ln w="6350">
+            <a:solidFill>
+              <a:srgbClr val="E5E7EB"/>
+            </a:solidFill>
+            <a:prstDash val="solid"/>
+          </a:ln>
+        </p:spPr>
+      </p:sp>
+      <p:sp>
+        <p:nvSpPr>
+          <p:cNvPr id="40" name="Shape 37"/>
+          <p:cNvSpPr/>
+          <p:nvPr/>
+        </p:nvSpPr>
+        <p:spPr>
+          <a:xfrm>
+            <a:off x="7406640" y="5522976"/>
+            <a:ext cx="109728" cy="640080"/>
+          </a:xfrm>
+          <a:prstGeom prst="rect">
+            <a:avLst/>
+          </a:prstGeom>
+          <a:solidFill>
+            <a:srgbClr val="D72638"/>
+          </a:solidFill>
+          <a:ln w="12700">
+            <a:solidFill>
+              <a:srgbClr val="D72638"/>
+            </a:solidFill>
+            <a:prstDash val="solid"/>
+          </a:ln>
+        </p:spPr>
+      </p:sp>
+      <p:sp>
+        <p:nvSpPr>
+          <p:cNvPr id="41" name="Shape 38"/>
+          <p:cNvSpPr/>
+          <p:nvPr/>
+        </p:nvSpPr>
+        <p:spPr>
+          <a:xfrm>
+            <a:off x="7571232" y="5614416"/>
+            <a:ext cx="548640" cy="256032"/>
+          </a:xfrm>
+          <a:prstGeom prst="rect">
+            <a:avLst/>
+          </a:prstGeom>
+          <a:solidFill>
+            <a:srgbClr val="D72638"/>
+          </a:solidFill>
+          <a:ln w="12700">
+            <a:solidFill>
+              <a:srgbClr val="D72638"/>
+            </a:solidFill>
+            <a:prstDash val="solid"/>
+          </a:ln>
+        </p:spPr>
+      </p:sp>
+      <p:sp>
+        <p:nvSpPr>
+          <p:cNvPr id="42" name="Text 39"/>
+          <p:cNvSpPr/>
+          <p:nvPr/>
+        </p:nvSpPr>
+        <p:spPr>
+          <a:xfrm>
+            <a:off x="7571232" y="5614416"/>
+            <a:ext cx="548640" cy="256032"/>
+          </a:xfrm>
+          <a:prstGeom prst="rect">
+            <a:avLst/>
+          </a:prstGeom>
+          <a:noFill/>
+          <a:ln/>
+        </p:spPr>
+        <p:txBody>
+          <a:bodyPr wrap="square" lIns="0" tIns="0" rIns="0" bIns="0" rtlCol="0" anchor="ctr"/>
+          <a:lstStyle/>
+          <a:p>
+            <a:pPr algn="ctr" indent="0" marL="0">
+              <a:buNone/>
+            </a:pPr>
+            <a:r>
+              <a:rPr lang="en-US" sz="900" b="1" dirty="0">
+                <a:solidFill>
+                  <a:srgbClr val="FFFFFF"/>
+                </a:solidFill>
+                <a:latin typeface="맑은 고딕" pitchFamily="34" charset="0"/>
+                <a:ea typeface="맑은 고딕" pitchFamily="34" charset="-122"/>
+                <a:cs typeface="맑은 고딕" pitchFamily="34" charset="-120"/>
+              </a:rPr>
+              <a:t>긴급</a:t>
+            </a:r>
+            <a:endParaRPr lang="en-US" sz="900" dirty="0"/>
+          </a:p>
+        </p:txBody>
+      </p:sp>
+      <p:sp>
+        <p:nvSpPr>
+          <p:cNvPr id="43" name="Text 40"/>
+          <p:cNvSpPr/>
+          <p:nvPr/>
+        </p:nvSpPr>
+        <p:spPr>
+          <a:xfrm>
+            <a:off x="8211312" y="5577840"/>
+            <a:ext cx="3291840" cy="274320"/>
+          </a:xfrm>
+          <a:prstGeom prst="rect">
+            <a:avLst/>
+          </a:prstGeom>
+          <a:noFill/>
+          <a:ln/>
+        </p:spPr>
+        <p:txBody>
+          <a:bodyPr wrap="square" lIns="0" tIns="0" rIns="0" bIns="0" rtlCol="0" anchor="ctr"/>
+          <a:lstStyle/>
+          <a:p>
+            <a:pPr indent="0" marL="0">
+              <a:buNone/>
+            </a:pPr>
+            <a:r>
+              <a:rPr lang="en-US" sz="1100" b="1" dirty="0">
+                <a:solidFill>
+                  <a:srgbClr val="0B1220"/>
+                </a:solidFill>
+                <a:latin typeface="맑은 고딕" pitchFamily="34" charset="0"/>
+                <a:ea typeface="맑은 고딕" pitchFamily="34" charset="-122"/>
+                <a:cs typeface="맑은 고딕" pitchFamily="34" charset="-120"/>
+              </a:rPr>
               <a:t>8-Ball Smart Tok</a:t>
             </a:r>
             <a:endParaRPr lang="en-US" sz="1100" dirty="0"/>
@@ -7771,13 +8183,13 @@
       </p:sp>
       <p:sp>
         <p:nvSpPr>
-          <p:cNvPr id="32" name="Text 29"/>
-          <p:cNvSpPr/>
-          <p:nvPr/>
-        </p:nvSpPr>
-        <p:spPr>
-          <a:xfrm>
-            <a:off x="8211312" y="4425696"/>
+          <p:cNvPr id="44" name="Text 41"/>
+          <p:cNvSpPr/>
+          <p:nvPr/>
+        </p:nvSpPr>
+        <p:spPr>
+          <a:xfrm>
+            <a:off x="8211312" y="5852160"/>
             <a:ext cx="3291840" cy="256032"/>
           </a:xfrm>
           <a:prstGeom prst="rect">
@@ -7824,418 +8236,6 @@
       </p:sp>
       <p:sp>
         <p:nvSpPr>
-          <p:cNvPr id="33" name="Shape 30"/>
-          <p:cNvSpPr/>
-          <p:nvPr/>
-        </p:nvSpPr>
-        <p:spPr>
-          <a:xfrm>
-            <a:off x="7406640" y="4809744"/>
-            <a:ext cx="4206240" cy="640080"/>
-          </a:xfrm>
-          <a:prstGeom prst="rect">
-            <a:avLst/>
-          </a:prstGeom>
-          <a:solidFill>
-            <a:srgbClr val="FFF5F5"/>
-          </a:solidFill>
-          <a:ln w="6350">
-            <a:solidFill>
-              <a:srgbClr val="E5E7EB"/>
-            </a:solidFill>
-            <a:prstDash val="solid"/>
-          </a:ln>
-        </p:spPr>
-      </p:sp>
-      <p:sp>
-        <p:nvSpPr>
-          <p:cNvPr id="34" name="Shape 31"/>
-          <p:cNvSpPr/>
-          <p:nvPr/>
-        </p:nvSpPr>
-        <p:spPr>
-          <a:xfrm>
-            <a:off x="7406640" y="4809744"/>
-            <a:ext cx="109728" cy="640080"/>
-          </a:xfrm>
-          <a:prstGeom prst="rect">
-            <a:avLst/>
-          </a:prstGeom>
-          <a:solidFill>
-            <a:srgbClr val="D72638"/>
-          </a:solidFill>
-          <a:ln w="12700">
-            <a:solidFill>
-              <a:srgbClr val="D72638"/>
-            </a:solidFill>
-            <a:prstDash val="solid"/>
-          </a:ln>
-        </p:spPr>
-      </p:sp>
-      <p:sp>
-        <p:nvSpPr>
-          <p:cNvPr id="35" name="Shape 32"/>
-          <p:cNvSpPr/>
-          <p:nvPr/>
-        </p:nvSpPr>
-        <p:spPr>
-          <a:xfrm>
-            <a:off x="7571232" y="4901184"/>
-            <a:ext cx="548640" cy="256032"/>
-          </a:xfrm>
-          <a:prstGeom prst="rect">
-            <a:avLst/>
-          </a:prstGeom>
-          <a:solidFill>
-            <a:srgbClr val="D72638"/>
-          </a:solidFill>
-          <a:ln w="12700">
-            <a:solidFill>
-              <a:srgbClr val="D72638"/>
-            </a:solidFill>
-            <a:prstDash val="solid"/>
-          </a:ln>
-        </p:spPr>
-      </p:sp>
-      <p:sp>
-        <p:nvSpPr>
-          <p:cNvPr id="36" name="Text 33"/>
-          <p:cNvSpPr/>
-          <p:nvPr/>
-        </p:nvSpPr>
-        <p:spPr>
-          <a:xfrm>
-            <a:off x="7571232" y="4901184"/>
-            <a:ext cx="548640" cy="256032"/>
-          </a:xfrm>
-          <a:prstGeom prst="rect">
-            <a:avLst/>
-          </a:prstGeom>
-          <a:noFill/>
-          <a:ln/>
-        </p:spPr>
-        <p:txBody>
-          <a:bodyPr wrap="square" lIns="0" tIns="0" rIns="0" bIns="0" rtlCol="0" anchor="ctr"/>
-          <a:lstStyle/>
-          <a:p>
-            <a:pPr algn="ctr" indent="0" marL="0">
-              <a:buNone/>
-            </a:pPr>
-            <a:r>
-              <a:rPr lang="en-US" sz="900" b="1" dirty="0">
-                <a:solidFill>
-                  <a:srgbClr val="FFFFFF"/>
-                </a:solidFill>
-                <a:latin typeface="맑은 고딕" pitchFamily="34" charset="0"/>
-                <a:ea typeface="맑은 고딕" pitchFamily="34" charset="-122"/>
-                <a:cs typeface="맑은 고딕" pitchFamily="34" charset="-120"/>
-              </a:rPr>
-              <a:t>긴급</a:t>
-            </a:r>
-            <a:endParaRPr lang="en-US" sz="900" dirty="0"/>
-          </a:p>
-        </p:txBody>
-      </p:sp>
-      <p:sp>
-        <p:nvSpPr>
-          <p:cNvPr id="37" name="Text 34"/>
-          <p:cNvSpPr/>
-          <p:nvPr/>
-        </p:nvSpPr>
-        <p:spPr>
-          <a:xfrm>
-            <a:off x="8211312" y="4864608"/>
-            <a:ext cx="3291840" cy="274320"/>
-          </a:xfrm>
-          <a:prstGeom prst="rect">
-            <a:avLst/>
-          </a:prstGeom>
-          <a:noFill/>
-          <a:ln/>
-        </p:spPr>
-        <p:txBody>
-          <a:bodyPr wrap="square" lIns="0" tIns="0" rIns="0" bIns="0" rtlCol="0" anchor="ctr"/>
-          <a:lstStyle/>
-          <a:p>
-            <a:pPr indent="0" marL="0">
-              <a:buNone/>
-            </a:pPr>
-            <a:r>
-              <a:rPr lang="en-US" sz="1100" b="1" dirty="0">
-                <a:solidFill>
-                  <a:srgbClr val="0B1220"/>
-                </a:solidFill>
-                <a:latin typeface="맑은 고딕" pitchFamily="34" charset="0"/>
-                <a:ea typeface="맑은 고딕" pitchFamily="34" charset="-122"/>
-                <a:cs typeface="맑은 고딕" pitchFamily="34" charset="-120"/>
-              </a:rPr>
-              <a:t>B-Flower Necklace (Size: 2 Size)</a:t>
-            </a:r>
-            <a:endParaRPr lang="en-US" sz="1100" dirty="0"/>
-          </a:p>
-        </p:txBody>
-      </p:sp>
-      <p:sp>
-        <p:nvSpPr>
-          <p:cNvPr id="38" name="Text 35"/>
-          <p:cNvSpPr/>
-          <p:nvPr/>
-        </p:nvSpPr>
-        <p:spPr>
-          <a:xfrm>
-            <a:off x="8211312" y="5138928"/>
-            <a:ext cx="3291840" cy="256032"/>
-          </a:xfrm>
-          <a:prstGeom prst="rect">
-            <a:avLst/>
-          </a:prstGeom>
-          <a:noFill/>
-          <a:ln/>
-        </p:spPr>
-        <p:txBody>
-          <a:bodyPr wrap="square" lIns="0" tIns="0" rIns="0" bIns="0" rtlCol="0" anchor="ctr"/>
-          <a:lstStyle/>
-          <a:p>
-            <a:pPr indent="0" marL="0">
-              <a:buNone/>
-            </a:pPr>
-            <a:r>
-              <a:rPr lang="en-US" sz="1000" dirty="0">
-                <a:solidFill>
-                  <a:srgbClr val="6B7280"/>
-                </a:solidFill>
-                <a:latin typeface="맑은 고딕" pitchFamily="34" charset="0"/>
-                <a:ea typeface="맑은 고딕" pitchFamily="34" charset="-122"/>
-                <a:cs typeface="맑은 고딕" pitchFamily="34" charset="-120"/>
-              </a:rPr>
-              <a:t>Necklace  ·  재고 4개</a:t>
-            </a:r>
-            <a:pPr indent="0" marL="0">
-              <a:buNone/>
-            </a:pPr>
-            <a:r>
-              <a:rPr lang="en-US" sz="1000" b="1" dirty="0">
-                <a:solidFill>
-                  <a:srgbClr val="D72638"/>
-                </a:solidFill>
-                <a:latin typeface="맑은 고딕" pitchFamily="34" charset="0"/>
-                <a:ea typeface="맑은 고딕" pitchFamily="34" charset="-122"/>
-                <a:cs typeface="맑은 고딕" pitchFamily="34" charset="-120"/>
-              </a:rPr>
-              <a:t/>
-            </a:r>
-            <a:endParaRPr lang="en-US" sz="1000" dirty="0"/>
-          </a:p>
-        </p:txBody>
-      </p:sp>
-      <p:sp>
-        <p:nvSpPr>
-          <p:cNvPr id="39" name="Shape 36"/>
-          <p:cNvSpPr/>
-          <p:nvPr/>
-        </p:nvSpPr>
-        <p:spPr>
-          <a:xfrm>
-            <a:off x="7406640" y="5522976"/>
-            <a:ext cx="4206240" cy="640080"/>
-          </a:xfrm>
-          <a:prstGeom prst="rect">
-            <a:avLst/>
-          </a:prstGeom>
-          <a:solidFill>
-            <a:srgbClr val="FFF5F5"/>
-          </a:solidFill>
-          <a:ln w="6350">
-            <a:solidFill>
-              <a:srgbClr val="E5E7EB"/>
-            </a:solidFill>
-            <a:prstDash val="solid"/>
-          </a:ln>
-        </p:spPr>
-      </p:sp>
-      <p:sp>
-        <p:nvSpPr>
-          <p:cNvPr id="40" name="Shape 37"/>
-          <p:cNvSpPr/>
-          <p:nvPr/>
-        </p:nvSpPr>
-        <p:spPr>
-          <a:xfrm>
-            <a:off x="7406640" y="5522976"/>
-            <a:ext cx="109728" cy="640080"/>
-          </a:xfrm>
-          <a:prstGeom prst="rect">
-            <a:avLst/>
-          </a:prstGeom>
-          <a:solidFill>
-            <a:srgbClr val="D72638"/>
-          </a:solidFill>
-          <a:ln w="12700">
-            <a:solidFill>
-              <a:srgbClr val="D72638"/>
-            </a:solidFill>
-            <a:prstDash val="solid"/>
-          </a:ln>
-        </p:spPr>
-      </p:sp>
-      <p:sp>
-        <p:nvSpPr>
-          <p:cNvPr id="41" name="Shape 38"/>
-          <p:cNvSpPr/>
-          <p:nvPr/>
-        </p:nvSpPr>
-        <p:spPr>
-          <a:xfrm>
-            <a:off x="7571232" y="5614416"/>
-            <a:ext cx="548640" cy="256032"/>
-          </a:xfrm>
-          <a:prstGeom prst="rect">
-            <a:avLst/>
-          </a:prstGeom>
-          <a:solidFill>
-            <a:srgbClr val="D72638"/>
-          </a:solidFill>
-          <a:ln w="12700">
-            <a:solidFill>
-              <a:srgbClr val="D72638"/>
-            </a:solidFill>
-            <a:prstDash val="solid"/>
-          </a:ln>
-        </p:spPr>
-      </p:sp>
-      <p:sp>
-        <p:nvSpPr>
-          <p:cNvPr id="42" name="Text 39"/>
-          <p:cNvSpPr/>
-          <p:nvPr/>
-        </p:nvSpPr>
-        <p:spPr>
-          <a:xfrm>
-            <a:off x="7571232" y="5614416"/>
-            <a:ext cx="548640" cy="256032"/>
-          </a:xfrm>
-          <a:prstGeom prst="rect">
-            <a:avLst/>
-          </a:prstGeom>
-          <a:noFill/>
-          <a:ln/>
-        </p:spPr>
-        <p:txBody>
-          <a:bodyPr wrap="square" lIns="0" tIns="0" rIns="0" bIns="0" rtlCol="0" anchor="ctr"/>
-          <a:lstStyle/>
-          <a:p>
-            <a:pPr algn="ctr" indent="0" marL="0">
-              <a:buNone/>
-            </a:pPr>
-            <a:r>
-              <a:rPr lang="en-US" sz="900" b="1" dirty="0">
-                <a:solidFill>
-                  <a:srgbClr val="FFFFFF"/>
-                </a:solidFill>
-                <a:latin typeface="맑은 고딕" pitchFamily="34" charset="0"/>
-                <a:ea typeface="맑은 고딕" pitchFamily="34" charset="-122"/>
-                <a:cs typeface="맑은 고딕" pitchFamily="34" charset="-120"/>
-              </a:rPr>
-              <a:t>긴급</a:t>
-            </a:r>
-            <a:endParaRPr lang="en-US" sz="900" dirty="0"/>
-          </a:p>
-        </p:txBody>
-      </p:sp>
-      <p:sp>
-        <p:nvSpPr>
-          <p:cNvPr id="43" name="Text 40"/>
-          <p:cNvSpPr/>
-          <p:nvPr/>
-        </p:nvSpPr>
-        <p:spPr>
-          <a:xfrm>
-            <a:off x="8211312" y="5577840"/>
-            <a:ext cx="3291840" cy="274320"/>
-          </a:xfrm>
-          <a:prstGeom prst="rect">
-            <a:avLst/>
-          </a:prstGeom>
-          <a:noFill/>
-          <a:ln/>
-        </p:spPr>
-        <p:txBody>
-          <a:bodyPr wrap="square" lIns="0" tIns="0" rIns="0" bIns="0" rtlCol="0" anchor="ctr"/>
-          <a:lstStyle/>
-          <a:p>
-            <a:pPr indent="0" marL="0">
-              <a:buNone/>
-            </a:pPr>
-            <a:r>
-              <a:rPr lang="en-US" sz="1100" b="1" dirty="0">
-                <a:solidFill>
-                  <a:srgbClr val="0B1220"/>
-                </a:solidFill>
-                <a:latin typeface="맑은 고딕" pitchFamily="34" charset="0"/>
-                <a:ea typeface="맑은 고딕" pitchFamily="34" charset="-122"/>
-                <a:cs typeface="맑은 고딕" pitchFamily="34" charset="-120"/>
-              </a:rPr>
-              <a:t>Tangle Keychain</a:t>
-            </a:r>
-            <a:endParaRPr lang="en-US" sz="1100" dirty="0"/>
-          </a:p>
-        </p:txBody>
-      </p:sp>
-      <p:sp>
-        <p:nvSpPr>
-          <p:cNvPr id="44" name="Text 41"/>
-          <p:cNvSpPr/>
-          <p:nvPr/>
-        </p:nvSpPr>
-        <p:spPr>
-          <a:xfrm>
-            <a:off x="8211312" y="5852160"/>
-            <a:ext cx="3291840" cy="256032"/>
-          </a:xfrm>
-          <a:prstGeom prst="rect">
-            <a:avLst/>
-          </a:prstGeom>
-          <a:noFill/>
-          <a:ln/>
-        </p:spPr>
-        <p:txBody>
-          <a:bodyPr wrap="square" lIns="0" tIns="0" rIns="0" bIns="0" rtlCol="0" anchor="ctr"/>
-          <a:lstStyle/>
-          <a:p>
-            <a:pPr indent="0" marL="0">
-              <a:buNone/>
-            </a:pPr>
-            <a:r>
-              <a:rPr lang="en-US" sz="1000" dirty="0">
-                <a:solidFill>
-                  <a:srgbClr val="6B7280"/>
-                </a:solidFill>
-                <a:latin typeface="맑은 고딕" pitchFamily="34" charset="0"/>
-                <a:ea typeface="맑은 고딕" pitchFamily="34" charset="-122"/>
-                <a:cs typeface="맑은 고딕" pitchFamily="34" charset="-120"/>
-              </a:rPr>
-              <a:t>★Season off★  ·  재고 3개</a:t>
-            </a:r>
-            <a:pPr indent="0" marL="0">
-              <a:buNone/>
-            </a:pPr>
-            <a:r>
-              <a:rPr lang="en-US" sz="1000" b="1" dirty="0">
-                <a:solidFill>
-                  <a:srgbClr val="D72638"/>
-                </a:solidFill>
-                <a:latin typeface="맑은 고딕" pitchFamily="34" charset="0"/>
-                <a:ea typeface="맑은 고딕" pitchFamily="34" charset="-122"/>
-                <a:cs typeface="맑은 고딕" pitchFamily="34" charset="-120"/>
-              </a:rPr>
-              <a:t/>
-            </a:r>
-            <a:endParaRPr lang="en-US" sz="1000" dirty="0"/>
-          </a:p>
-        </p:txBody>
-      </p:sp>
-      <p:sp>
-        <p:nvSpPr>
           <p:cNvPr id="45" name="Text 42"/>
           <p:cNvSpPr/>
           <p:nvPr/>
@@ -8267,7 +8267,7 @@
                 <a:ea typeface="맑은 고딕" pitchFamily="34" charset="-122"/>
                 <a:cs typeface="맑은 고딕" pitchFamily="34" charset="-120"/>
               </a:rPr>
-              <a:t>베스트 상품 리포트  ·  생성 2026-05-17 08:00</a:t>
+              <a:t>베스트 상품 리포트  ·  생성 2026-05-18 08:00</a:t>
             </a:r>
             <a:endParaRPr lang="en-US" sz="900" dirty="0"/>
           </a:p>
@@ -8480,7 +8480,7 @@
                 <a:ea typeface="맑은 고딕" pitchFamily="34" charset="-122"/>
                 <a:cs typeface="맑은 고딕" pitchFamily="34" charset="-120"/>
               </a:rPr>
-              <a:t>2026년 05월 17일 (일)</a:t>
+              <a:t>2026년 05월 18일 (월)</a:t>
             </a:r>
             <a:endParaRPr lang="en-US" sz="1200" dirty="0"/>
           </a:p>
@@ -8647,7 +8647,7 @@
                 <a:ea typeface="맑은 고딕" pitchFamily="34" charset="-122"/>
                 <a:cs typeface="맑은 고딕" pitchFamily="34" charset="-120"/>
               </a:rPr>
-              <a:t>153 개</a:t>
+              <a:t>203 개</a:t>
             </a:r>
             <a:endParaRPr lang="en-US" sz="3600" dirty="0"/>
           </a:p>
@@ -8775,7 +8775,7 @@
                 <a:ea typeface="맑은 고딕" pitchFamily="34" charset="-122"/>
                 <a:cs typeface="맑은 고딕" pitchFamily="34" charset="-120"/>
               </a:rPr>
-              <a:t>CandyPOP Necklace (사이즈: 1size (41.5~47cm))</a:t>
+              <a:t>CandyPOP Necklace (사이즈: 2size (47~52cm))</a:t>
             </a:r>
             <a:endParaRPr lang="en-US" sz="1800" dirty="0"/>
           </a:p>
@@ -8853,7 +8853,7 @@
                 <a:ea typeface="맑은 고딕" pitchFamily="34" charset="-122"/>
                 <a:cs typeface="맑은 고딕" pitchFamily="34" charset="-120"/>
               </a:rPr>
-              <a:t>51</a:t>
+              <a:t>57</a:t>
             </a:r>
             <a:endParaRPr lang="en-US" sz="4400" dirty="0"/>
           </a:p>
@@ -9387,7 +9387,7 @@
                           <a:ea typeface="맑은 고딕" pitchFamily="34" charset="-122"/>
                           <a:cs typeface="맑은 고딕" pitchFamily="34" charset="-120"/>
                         </a:rPr>
-                        <a:t>CandyPOP Necklace (사이즈: 1size (41.5~47cm))</a:t>
+                        <a:t>CandyPOP Necklace (사이즈: 2size (47~52cm))</a:t>
                       </a:r>
                       <a:endParaRPr lang="en-US" sz="1100" dirty="0">
                         <a:latin typeface="맑은 고딕" charset="0"/>
@@ -9452,7 +9452,7 @@
                           <a:ea typeface="맑은 고딕" pitchFamily="34" charset="-122"/>
                           <a:cs typeface="맑은 고딕" pitchFamily="34" charset="-120"/>
                         </a:rPr>
-                        <a:t>51 개</a:t>
+                        <a:t>57 개</a:t>
                       </a:r>
                       <a:endParaRPr lang="en-US" sz="1400" dirty="0">
                         <a:latin typeface="맑은 고딕" charset="0"/>
@@ -9649,7 +9649,7 @@
                           <a:ea typeface="맑은 고딕" pitchFamily="34" charset="-122"/>
                           <a:cs typeface="맑은 고딕" pitchFamily="34" charset="-120"/>
                         </a:rPr>
-                        <a:t>CandyPOP Necklace (사이즈: 2size (47~52cm))</a:t>
+                        <a:t>CandyPOP Necklace (사이즈: 1size (41.5~47cm))</a:t>
                       </a:r>
                       <a:endParaRPr lang="en-US" sz="1100" dirty="0">
                         <a:latin typeface="맑은 고딕" charset="0"/>
@@ -9714,7 +9714,7 @@
                           <a:ea typeface="맑은 고딕" pitchFamily="34" charset="-122"/>
                           <a:cs typeface="맑은 고딕" pitchFamily="34" charset="-120"/>
                         </a:rPr>
-                        <a:t>48 개</a:t>
+                        <a:t>57 개</a:t>
                       </a:r>
                       <a:endParaRPr lang="en-US" sz="1200" dirty="0">
                         <a:latin typeface="맑은 고딕" charset="0"/>
@@ -9846,7 +9846,7 @@
                           <a:ea typeface="맑은 고딕" pitchFamily="34" charset="-122"/>
                           <a:cs typeface="맑은 고딕" pitchFamily="34" charset="-120"/>
                         </a:rPr>
-                        <a:t>Necklace</a:t>
+                        <a:t>Ring</a:t>
                       </a:r>
                       <a:endParaRPr lang="en-US" sz="1000" dirty="0">
                         <a:latin typeface="맑은 고딕" charset="0"/>
@@ -9911,7 +9911,7 @@
                           <a:ea typeface="맑은 고딕" pitchFamily="34" charset="-122"/>
                           <a:cs typeface="맑은 고딕" pitchFamily="34" charset="-120"/>
                         </a:rPr>
-                        <a:t>ThreadDuo Necklace</a:t>
+                        <a:t>"4s" 925 Open Ring (사이즈: 남성)</a:t>
                       </a:r>
                       <a:endParaRPr lang="en-US" sz="1100" dirty="0">
                         <a:latin typeface="맑은 고딕" charset="0"/>
@@ -9976,7 +9976,7 @@
                           <a:ea typeface="맑은 고딕" pitchFamily="34" charset="-122"/>
                           <a:cs typeface="맑은 고딕" pitchFamily="34" charset="-120"/>
                         </a:rPr>
-                        <a:t>19 개</a:t>
+                        <a:t>28 개</a:t>
                       </a:r>
                       <a:endParaRPr lang="en-US" sz="1200" dirty="0">
                         <a:latin typeface="맑은 고딕" charset="0"/>
@@ -10062,7 +10062,7 @@
                 <a:ea typeface="맑은 고딕" pitchFamily="34" charset="-122"/>
                 <a:cs typeface="맑은 고딕" pitchFamily="34" charset="-120"/>
               </a:rPr>
-              <a:t>리오더 필요  🔴 긴급 17건</a:t>
+              <a:t>리오더 필요  🔴 긴급 18건</a:t>
             </a:r>
             <a:endParaRPr lang="en-US" sz="1500" dirty="0"/>
           </a:p>
@@ -10126,7 +10126,7 @@
                 <a:ea typeface="맑은 고딕" pitchFamily="34" charset="-122"/>
                 <a:cs typeface="맑은 고딕" pitchFamily="34" charset="-120"/>
               </a:rPr>
-              <a:t>🔴 긴급 17건  ·  상세는 시트 확인</a:t>
+              <a:t>🔴 긴급 18건  ·  상세는 시트 확인</a:t>
             </a:r>
             <a:endParaRPr lang="en-US" sz="1400" dirty="0"/>
           </a:p>
@@ -10165,7 +10165,7 @@
                 <a:ea typeface="맑은 고딕" pitchFamily="34" charset="-122"/>
                 <a:cs typeface="맑은 고딕" pitchFamily="34" charset="-120"/>
               </a:rPr>
-              <a:t>베스트 상품 리포트  ·  생성 2026-05-17 08:00</a:t>
+              <a:t>베스트 상품 리포트  ·  생성 2026-05-18 08:00</a:t>
             </a:r>
             <a:endParaRPr lang="en-US" sz="900" dirty="0"/>
           </a:p>
@@ -10378,7 +10378,7 @@
                 <a:ea typeface="맑은 고딕" pitchFamily="34" charset="-122"/>
                 <a:cs typeface="맑은 고딕" pitchFamily="34" charset="-120"/>
               </a:rPr>
-              <a:t>2026년 05월 17일 (일)</a:t>
+              <a:t>2026년 05월 18일 (월)</a:t>
             </a:r>
             <a:endParaRPr lang="en-US" sz="1200" dirty="0"/>
           </a:p>
@@ -10673,7 +10673,7 @@
                 <a:ea typeface="맑은 고딕" pitchFamily="34" charset="-122"/>
                 <a:cs typeface="맑은 고딕" pitchFamily="34" charset="-120"/>
               </a:rPr>
-              <a:t>25</a:t>
+              <a:t>26</a:t>
             </a:r>
             <a:endParaRPr lang="en-US" sz="3000" dirty="0"/>
           </a:p>
@@ -10801,7 +10801,7 @@
                 <a:ea typeface="맑은 고딕" pitchFamily="34" charset="-122"/>
                 <a:cs typeface="맑은 고딕" pitchFamily="34" charset="-120"/>
               </a:rPr>
-              <a:t>7</a:t>
+              <a:t>6</a:t>
             </a:r>
             <a:endParaRPr lang="en-US" sz="3000" dirty="0"/>
           </a:p>
@@ -10929,7 +10929,7 @@
                 <a:ea typeface="맑은 고딕" pitchFamily="34" charset="-122"/>
                 <a:cs typeface="맑은 고딕" pitchFamily="34" charset="-120"/>
               </a:rPr>
-              <a:t>35,053</a:t>
+              <a:t>34,441</a:t>
             </a:r>
             <a:endParaRPr lang="en-US" sz="3000" dirty="0"/>
           </a:p>
@@ -11489,7 +11489,7 @@
                           <a:ea typeface="맑은 고딕" pitchFamily="34" charset="-122"/>
                           <a:cs typeface="맑은 고딕" pitchFamily="34" charset="-120"/>
                         </a:rPr>
-                        <a:t>2,140</a:t>
+                        <a:t>2,132</a:t>
                       </a:r>
                       <a:endParaRPr lang="en-US" sz="1000" dirty="0">
                         <a:latin typeface="맑은 고딕" charset="0"/>
@@ -11751,7 +11751,7 @@
                           <a:ea typeface="맑은 고딕" pitchFamily="34" charset="-122"/>
                           <a:cs typeface="맑은 고딕" pitchFamily="34" charset="-120"/>
                         </a:rPr>
-                        <a:t>2,093</a:t>
+                        <a:t>1,980</a:t>
                       </a:r>
                       <a:endParaRPr lang="en-US" sz="1000" dirty="0">
                         <a:latin typeface="맑은 고딕" charset="0"/>
@@ -12013,7 +12013,7 @@
                           <a:ea typeface="맑은 고딕" pitchFamily="34" charset="-122"/>
                           <a:cs typeface="맑은 고딕" pitchFamily="34" charset="-120"/>
                         </a:rPr>
-                        <a:t>1,893</a:t>
+                        <a:t>1,822</a:t>
                       </a:r>
                       <a:endParaRPr lang="en-US" sz="1000" dirty="0">
                         <a:latin typeface="맑은 고딕" charset="0"/>
@@ -12275,7 +12275,7 @@
                           <a:ea typeface="맑은 고딕" pitchFamily="34" charset="-122"/>
                           <a:cs typeface="맑은 고딕" pitchFamily="34" charset="-120"/>
                         </a:rPr>
-                        <a:t>1,676</a:t>
+                        <a:t>1,667</a:t>
                       </a:r>
                       <a:endParaRPr lang="en-US" sz="1000" dirty="0">
                         <a:latin typeface="맑은 고딕" charset="0"/>
@@ -12537,7 +12537,7 @@
                           <a:ea typeface="맑은 고딕" pitchFamily="34" charset="-122"/>
                           <a:cs typeface="맑은 고딕" pitchFamily="34" charset="-120"/>
                         </a:rPr>
-                        <a:t>1,506</a:t>
+                        <a:t>1,435</a:t>
                       </a:r>
                       <a:endParaRPr lang="en-US" sz="1000" dirty="0">
                         <a:latin typeface="맑은 고딕" charset="0"/>
@@ -12623,7 +12623,7 @@
                 <a:ea typeface="맑은 고딕" pitchFamily="34" charset="-122"/>
                 <a:cs typeface="맑은 고딕" pitchFamily="34" charset="-120"/>
               </a:rPr>
-              <a:t>재고 점검  🔴 품절 25건</a:t>
+              <a:t>재고 점검  🔴 품절 26건</a:t>
             </a:r>
             <a:pPr indent="0" marL="0">
               <a:buNone/>
@@ -13010,6 +13010,226 @@
                 <a:ea typeface="맑은 고딕" pitchFamily="34" charset="-122"/>
                 <a:cs typeface="맑은 고딕" pitchFamily="34" charset="-120"/>
               </a:rPr>
+              <a:t>Cotton Lunch Mini Bag (5color)</a:t>
+            </a:r>
+            <a:endParaRPr lang="en-US" sz="1000" dirty="0"/>
+          </a:p>
+        </p:txBody>
+      </p:sp>
+      <p:sp>
+        <p:nvSpPr>
+          <p:cNvPr id="37" name="Text 34"/>
+          <p:cNvSpPr/>
+          <p:nvPr/>
+        </p:nvSpPr>
+        <p:spPr>
+          <a:xfrm>
+            <a:off x="8211312" y="4425696"/>
+            <a:ext cx="3291840" cy="256032"/>
+          </a:xfrm>
+          <a:prstGeom prst="rect">
+            <a:avLst/>
+          </a:prstGeom>
+          <a:noFill/>
+          <a:ln/>
+        </p:spPr>
+        <p:txBody>
+          <a:bodyPr wrap="square" lIns="0" tIns="0" rIns="0" bIns="0" rtlCol="0" anchor="ctr"/>
+          <a:lstStyle/>
+          <a:p>
+            <a:pPr indent="0" marL="0">
+              <a:buNone/>
+            </a:pPr>
+            <a:r>
+              <a:rPr lang="en-US" sz="900" dirty="0">
+                <a:solidFill>
+                  <a:srgbClr val="6B7280"/>
+                </a:solidFill>
+                <a:latin typeface="맑은 고딕" pitchFamily="34" charset="0"/>
+                <a:ea typeface="맑은 고딕" pitchFamily="34" charset="-122"/>
+                <a:cs typeface="맑은 고딕" pitchFamily="34" charset="-120"/>
+              </a:rPr>
+              <a:t>색상: 블랙  ·  재고 0개</a:t>
+            </a:r>
+            <a:pPr indent="0" marL="0">
+              <a:buNone/>
+            </a:pPr>
+            <a:r>
+              <a:rPr lang="en-US" sz="1000" dirty="0">
+                <a:solidFill>
+                  <a:srgbClr val="6B7280"/>
+                </a:solidFill>
+                <a:latin typeface="맑은 고딕" pitchFamily="34" charset="0"/>
+                <a:ea typeface="맑은 고딕" pitchFamily="34" charset="-122"/>
+                <a:cs typeface="맑은 고딕" pitchFamily="34" charset="-120"/>
+              </a:rPr>
+              <a:t/>
+            </a:r>
+            <a:pPr indent="0" marL="0">
+              <a:buNone/>
+            </a:pPr>
+            <a:r>
+              <a:rPr lang="en-US" sz="1000" b="1" dirty="0">
+                <a:solidFill>
+                  <a:srgbClr val="D72638"/>
+                </a:solidFill>
+                <a:latin typeface="맑은 고딕" pitchFamily="34" charset="0"/>
+                <a:ea typeface="맑은 고딕" pitchFamily="34" charset="-122"/>
+                <a:cs typeface="맑은 고딕" pitchFamily="34" charset="-120"/>
+              </a:rPr>
+              <a:t/>
+            </a:r>
+            <a:endParaRPr lang="en-US" sz="900" dirty="0"/>
+          </a:p>
+        </p:txBody>
+      </p:sp>
+      <p:sp>
+        <p:nvSpPr>
+          <p:cNvPr id="38" name="Shape 35"/>
+          <p:cNvSpPr/>
+          <p:nvPr/>
+        </p:nvSpPr>
+        <p:spPr>
+          <a:xfrm>
+            <a:off x="7406640" y="4809744"/>
+            <a:ext cx="4206240" cy="640080"/>
+          </a:xfrm>
+          <a:prstGeom prst="rect">
+            <a:avLst/>
+          </a:prstGeom>
+          <a:solidFill>
+            <a:srgbClr val="FFF5F5"/>
+          </a:solidFill>
+          <a:ln w="6350">
+            <a:solidFill>
+              <a:srgbClr val="E5E7EB"/>
+            </a:solidFill>
+            <a:prstDash val="solid"/>
+          </a:ln>
+        </p:spPr>
+      </p:sp>
+      <p:sp>
+        <p:nvSpPr>
+          <p:cNvPr id="39" name="Shape 36"/>
+          <p:cNvSpPr/>
+          <p:nvPr/>
+        </p:nvSpPr>
+        <p:spPr>
+          <a:xfrm>
+            <a:off x="7406640" y="4809744"/>
+            <a:ext cx="109728" cy="640080"/>
+          </a:xfrm>
+          <a:prstGeom prst="rect">
+            <a:avLst/>
+          </a:prstGeom>
+          <a:solidFill>
+            <a:srgbClr val="D72638"/>
+          </a:solidFill>
+          <a:ln w="12700">
+            <a:solidFill>
+              <a:srgbClr val="D72638"/>
+            </a:solidFill>
+            <a:prstDash val="solid"/>
+          </a:ln>
+        </p:spPr>
+      </p:sp>
+      <p:sp>
+        <p:nvSpPr>
+          <p:cNvPr id="40" name="Shape 37"/>
+          <p:cNvSpPr/>
+          <p:nvPr/>
+        </p:nvSpPr>
+        <p:spPr>
+          <a:xfrm>
+            <a:off x="7571232" y="4901184"/>
+            <a:ext cx="548640" cy="256032"/>
+          </a:xfrm>
+          <a:prstGeom prst="rect">
+            <a:avLst/>
+          </a:prstGeom>
+          <a:solidFill>
+            <a:srgbClr val="D72638"/>
+          </a:solidFill>
+          <a:ln w="12700">
+            <a:solidFill>
+              <a:srgbClr val="D72638"/>
+            </a:solidFill>
+            <a:prstDash val="solid"/>
+          </a:ln>
+        </p:spPr>
+      </p:sp>
+      <p:sp>
+        <p:nvSpPr>
+          <p:cNvPr id="41" name="Text 38"/>
+          <p:cNvSpPr/>
+          <p:nvPr/>
+        </p:nvSpPr>
+        <p:spPr>
+          <a:xfrm>
+            <a:off x="7571232" y="4901184"/>
+            <a:ext cx="548640" cy="256032"/>
+          </a:xfrm>
+          <a:prstGeom prst="rect">
+            <a:avLst/>
+          </a:prstGeom>
+          <a:noFill/>
+          <a:ln/>
+        </p:spPr>
+        <p:txBody>
+          <a:bodyPr wrap="square" lIns="0" tIns="0" rIns="0" bIns="0" rtlCol="0" anchor="ctr"/>
+          <a:lstStyle/>
+          <a:p>
+            <a:pPr algn="ctr" indent="0" marL="0">
+              <a:buNone/>
+            </a:pPr>
+            <a:r>
+              <a:rPr lang="en-US" sz="900" b="1" dirty="0">
+                <a:solidFill>
+                  <a:srgbClr val="FFFFFF"/>
+                </a:solidFill>
+                <a:latin typeface="맑은 고딕" pitchFamily="34" charset="0"/>
+                <a:ea typeface="맑은 고딕" pitchFamily="34" charset="-122"/>
+                <a:cs typeface="맑은 고딕" pitchFamily="34" charset="-120"/>
+              </a:rPr>
+              <a:t>긴급</a:t>
+            </a:r>
+            <a:endParaRPr lang="en-US" sz="900" dirty="0"/>
+          </a:p>
+        </p:txBody>
+      </p:sp>
+      <p:sp>
+        <p:nvSpPr>
+          <p:cNvPr id="42" name="Text 39"/>
+          <p:cNvSpPr/>
+          <p:nvPr/>
+        </p:nvSpPr>
+        <p:spPr>
+          <a:xfrm>
+            <a:off x="8211312" y="4864608"/>
+            <a:ext cx="3291840" cy="274320"/>
+          </a:xfrm>
+          <a:prstGeom prst="rect">
+            <a:avLst/>
+          </a:prstGeom>
+          <a:noFill/>
+          <a:ln/>
+        </p:spPr>
+        <p:txBody>
+          <a:bodyPr wrap="square" lIns="0" tIns="0" rIns="0" bIns="0" rtlCol="0" anchor="ctr"/>
+          <a:lstStyle/>
+          <a:p>
+            <a:pPr indent="0" marL="0">
+              <a:buNone/>
+            </a:pPr>
+            <a:r>
+              <a:rPr lang="en-US" sz="1000" b="1" dirty="0">
+                <a:solidFill>
+                  <a:srgbClr val="0B1220"/>
+                </a:solidFill>
+                <a:latin typeface="맑은 고딕" pitchFamily="34" charset="0"/>
+                <a:ea typeface="맑은 고딕" pitchFamily="34" charset="-122"/>
+                <a:cs typeface="맑은 고딕" pitchFamily="34" charset="-120"/>
+              </a:rPr>
               <a:t>Food Bottle Opener</a:t>
             </a:r>
             <a:endParaRPr lang="en-US" sz="1000" dirty="0"/>
@@ -13018,13 +13238,13 @@
       </p:sp>
       <p:sp>
         <p:nvSpPr>
-          <p:cNvPr id="37" name="Text 34"/>
-          <p:cNvSpPr/>
-          <p:nvPr/>
-        </p:nvSpPr>
-        <p:spPr>
-          <a:xfrm>
-            <a:off x="8211312" y="4425696"/>
+          <p:cNvPr id="43" name="Text 40"/>
+          <p:cNvSpPr/>
+          <p:nvPr/>
+        </p:nvSpPr>
+        <p:spPr>
+          <a:xfrm>
+            <a:off x="8211312" y="5138928"/>
             <a:ext cx="3291840" cy="256032"/>
           </a:xfrm>
           <a:prstGeom prst="rect">
@@ -13085,13 +13305,13 @@
       </p:sp>
       <p:sp>
         <p:nvSpPr>
-          <p:cNvPr id="38" name="Shape 35"/>
-          <p:cNvSpPr/>
-          <p:nvPr/>
-        </p:nvSpPr>
-        <p:spPr>
-          <a:xfrm>
-            <a:off x="7406640" y="4809744"/>
+          <p:cNvPr id="44" name="Shape 41"/>
+          <p:cNvSpPr/>
+          <p:nvPr/>
+        </p:nvSpPr>
+        <p:spPr>
+          <a:xfrm>
+            <a:off x="7406640" y="5522976"/>
             <a:ext cx="4206240" cy="640080"/>
           </a:xfrm>
           <a:prstGeom prst="rect">
@@ -13110,13 +13330,13 @@
       </p:sp>
       <p:sp>
         <p:nvSpPr>
-          <p:cNvPr id="39" name="Shape 36"/>
-          <p:cNvSpPr/>
-          <p:nvPr/>
-        </p:nvSpPr>
-        <p:spPr>
-          <a:xfrm>
-            <a:off x="7406640" y="4809744"/>
+          <p:cNvPr id="45" name="Shape 42"/>
+          <p:cNvSpPr/>
+          <p:nvPr/>
+        </p:nvSpPr>
+        <p:spPr>
+          <a:xfrm>
+            <a:off x="7406640" y="5522976"/>
             <a:ext cx="109728" cy="640080"/>
           </a:xfrm>
           <a:prstGeom prst="rect">
@@ -13135,13 +13355,13 @@
       </p:sp>
       <p:sp>
         <p:nvSpPr>
-          <p:cNvPr id="40" name="Shape 37"/>
-          <p:cNvSpPr/>
-          <p:nvPr/>
-        </p:nvSpPr>
-        <p:spPr>
-          <a:xfrm>
-            <a:off x="7571232" y="4901184"/>
+          <p:cNvPr id="46" name="Shape 43"/>
+          <p:cNvSpPr/>
+          <p:nvPr/>
+        </p:nvSpPr>
+        <p:spPr>
+          <a:xfrm>
+            <a:off x="7571232" y="5614416"/>
             <a:ext cx="548640" cy="256032"/>
           </a:xfrm>
           <a:prstGeom prst="rect">
@@ -13160,13 +13380,13 @@
       </p:sp>
       <p:sp>
         <p:nvSpPr>
-          <p:cNvPr id="41" name="Text 38"/>
-          <p:cNvSpPr/>
-          <p:nvPr/>
-        </p:nvSpPr>
-        <p:spPr>
-          <a:xfrm>
-            <a:off x="7571232" y="4901184"/>
+          <p:cNvPr id="47" name="Text 44"/>
+          <p:cNvSpPr/>
+          <p:nvPr/>
+        </p:nvSpPr>
+        <p:spPr>
+          <a:xfrm>
+            <a:off x="7571232" y="5614416"/>
             <a:ext cx="548640" cy="256032"/>
           </a:xfrm>
           <a:prstGeom prst="rect">
@@ -13199,13 +13419,13 @@
       </p:sp>
       <p:sp>
         <p:nvSpPr>
-          <p:cNvPr id="42" name="Text 39"/>
-          <p:cNvSpPr/>
-          <p:nvPr/>
-        </p:nvSpPr>
-        <p:spPr>
-          <a:xfrm>
-            <a:off x="8211312" y="4864608"/>
+          <p:cNvPr id="48" name="Text 45"/>
+          <p:cNvSpPr/>
+          <p:nvPr/>
+        </p:nvSpPr>
+        <p:spPr>
+          <a:xfrm>
+            <a:off x="8211312" y="5577840"/>
             <a:ext cx="3291840" cy="274320"/>
           </a:xfrm>
           <a:prstGeom prst="rect">
@@ -13238,13 +13458,13 @@
       </p:sp>
       <p:sp>
         <p:nvSpPr>
-          <p:cNvPr id="43" name="Text 40"/>
-          <p:cNvSpPr/>
-          <p:nvPr/>
-        </p:nvSpPr>
-        <p:spPr>
-          <a:xfrm>
-            <a:off x="8211312" y="5138928"/>
+          <p:cNvPr id="49" name="Text 46"/>
+          <p:cNvSpPr/>
+          <p:nvPr/>
+        </p:nvSpPr>
+        <p:spPr>
+          <a:xfrm>
+            <a:off x="8211312" y="5852160"/>
             <a:ext cx="3291840" cy="256032"/>
           </a:xfrm>
           <a:prstGeom prst="rect">
@@ -13305,167 +13525,14 @@
       </p:sp>
       <p:sp>
         <p:nvSpPr>
-          <p:cNvPr id="44" name="Shape 41"/>
-          <p:cNvSpPr/>
-          <p:nvPr/>
-        </p:nvSpPr>
-        <p:spPr>
-          <a:xfrm>
-            <a:off x="7406640" y="5522976"/>
-            <a:ext cx="4206240" cy="640080"/>
-          </a:xfrm>
-          <a:prstGeom prst="rect">
-            <a:avLst/>
-          </a:prstGeom>
-          <a:solidFill>
-            <a:srgbClr val="FFF5F5"/>
-          </a:solidFill>
-          <a:ln w="6350">
-            <a:solidFill>
-              <a:srgbClr val="E5E7EB"/>
-            </a:solidFill>
-            <a:prstDash val="solid"/>
-          </a:ln>
-        </p:spPr>
-      </p:sp>
-      <p:sp>
-        <p:nvSpPr>
-          <p:cNvPr id="45" name="Shape 42"/>
-          <p:cNvSpPr/>
-          <p:nvPr/>
-        </p:nvSpPr>
-        <p:spPr>
-          <a:xfrm>
-            <a:off x="7406640" y="5522976"/>
-            <a:ext cx="109728" cy="640080"/>
-          </a:xfrm>
-          <a:prstGeom prst="rect">
-            <a:avLst/>
-          </a:prstGeom>
-          <a:solidFill>
-            <a:srgbClr val="D72638"/>
-          </a:solidFill>
-          <a:ln w="12700">
-            <a:solidFill>
-              <a:srgbClr val="D72638"/>
-            </a:solidFill>
-            <a:prstDash val="solid"/>
-          </a:ln>
-        </p:spPr>
-      </p:sp>
-      <p:sp>
-        <p:nvSpPr>
-          <p:cNvPr id="46" name="Shape 43"/>
-          <p:cNvSpPr/>
-          <p:nvPr/>
-        </p:nvSpPr>
-        <p:spPr>
-          <a:xfrm>
-            <a:off x="7571232" y="5614416"/>
-            <a:ext cx="548640" cy="256032"/>
-          </a:xfrm>
-          <a:prstGeom prst="rect">
-            <a:avLst/>
-          </a:prstGeom>
-          <a:solidFill>
-            <a:srgbClr val="D72638"/>
-          </a:solidFill>
-          <a:ln w="12700">
-            <a:solidFill>
-              <a:srgbClr val="D72638"/>
-            </a:solidFill>
-            <a:prstDash val="solid"/>
-          </a:ln>
-        </p:spPr>
-      </p:sp>
-      <p:sp>
-        <p:nvSpPr>
-          <p:cNvPr id="47" name="Text 44"/>
-          <p:cNvSpPr/>
-          <p:nvPr/>
-        </p:nvSpPr>
-        <p:spPr>
-          <a:xfrm>
-            <a:off x="7571232" y="5614416"/>
-            <a:ext cx="548640" cy="256032"/>
-          </a:xfrm>
-          <a:prstGeom prst="rect">
-            <a:avLst/>
-          </a:prstGeom>
-          <a:noFill/>
-          <a:ln/>
-        </p:spPr>
-        <p:txBody>
-          <a:bodyPr wrap="square" lIns="0" tIns="0" rIns="0" bIns="0" rtlCol="0" anchor="ctr"/>
-          <a:lstStyle/>
-          <a:p>
-            <a:pPr algn="ctr" indent="0" marL="0">
-              <a:buNone/>
-            </a:pPr>
-            <a:r>
-              <a:rPr lang="en-US" sz="900" b="1" dirty="0">
-                <a:solidFill>
-                  <a:srgbClr val="FFFFFF"/>
-                </a:solidFill>
-                <a:latin typeface="맑은 고딕" pitchFamily="34" charset="0"/>
-                <a:ea typeface="맑은 고딕" pitchFamily="34" charset="-122"/>
-                <a:cs typeface="맑은 고딕" pitchFamily="34" charset="-120"/>
-              </a:rPr>
-              <a:t>긴급</a:t>
-            </a:r>
-            <a:endParaRPr lang="en-US" sz="900" dirty="0"/>
-          </a:p>
-        </p:txBody>
-      </p:sp>
-      <p:sp>
-        <p:nvSpPr>
-          <p:cNvPr id="48" name="Text 45"/>
-          <p:cNvSpPr/>
-          <p:nvPr/>
-        </p:nvSpPr>
-        <p:spPr>
-          <a:xfrm>
-            <a:off x="8211312" y="5577840"/>
-            <a:ext cx="3291840" cy="274320"/>
-          </a:xfrm>
-          <a:prstGeom prst="rect">
-            <a:avLst/>
-          </a:prstGeom>
-          <a:noFill/>
-          <a:ln/>
-        </p:spPr>
-        <p:txBody>
-          <a:bodyPr wrap="square" lIns="0" tIns="0" rIns="0" bIns="0" rtlCol="0" anchor="ctr"/>
-          <a:lstStyle/>
-          <a:p>
-            <a:pPr indent="0" marL="0">
-              <a:buNone/>
-            </a:pPr>
-            <a:r>
-              <a:rPr lang="en-US" sz="1000" b="1" dirty="0">
-                <a:solidFill>
-                  <a:srgbClr val="0B1220"/>
-                </a:solidFill>
-                <a:latin typeface="맑은 고딕" pitchFamily="34" charset="0"/>
-                <a:ea typeface="맑은 고딕" pitchFamily="34" charset="-122"/>
-                <a:cs typeface="맑은 고딕" pitchFamily="34" charset="-120"/>
-              </a:rPr>
-              <a:t>Light UV 99.9 Umbrella (7color)</a:t>
-            </a:r>
-            <a:endParaRPr lang="en-US" sz="1000" dirty="0"/>
-          </a:p>
-        </p:txBody>
-      </p:sp>
-      <p:sp>
-        <p:nvSpPr>
-          <p:cNvPr id="49" name="Text 46"/>
-          <p:cNvSpPr/>
-          <p:nvPr/>
-        </p:nvSpPr>
-        <p:spPr>
-          <a:xfrm>
-            <a:off x="8211312" y="5852160"/>
-            <a:ext cx="3291840" cy="256032"/>
+          <p:cNvPr id="50" name="Text 47"/>
+          <p:cNvSpPr/>
+          <p:nvPr/>
+        </p:nvSpPr>
+        <p:spPr>
+          <a:xfrm>
+            <a:off x="548640" y="6492240"/>
+            <a:ext cx="7315200" cy="274320"/>
           </a:xfrm>
           <a:prstGeom prst="rect">
             <a:avLst/>
@@ -13489,74 +13556,7 @@
                 <a:ea typeface="맑은 고딕" pitchFamily="34" charset="-122"/>
                 <a:cs typeface="맑은 고딕" pitchFamily="34" charset="-120"/>
               </a:rPr>
-              <a:t>컬러: 블랙  ·  재고 0개</a:t>
-            </a:r>
-            <a:pPr indent="0" marL="0">
-              <a:buNone/>
-            </a:pPr>
-            <a:r>
-              <a:rPr lang="en-US" sz="1000" dirty="0">
-                <a:solidFill>
-                  <a:srgbClr val="6B7280"/>
-                </a:solidFill>
-                <a:latin typeface="맑은 고딕" pitchFamily="34" charset="0"/>
-                <a:ea typeface="맑은 고딕" pitchFamily="34" charset="-122"/>
-                <a:cs typeface="맑은 고딕" pitchFamily="34" charset="-120"/>
-              </a:rPr>
-              <a:t/>
-            </a:r>
-            <a:pPr indent="0" marL="0">
-              <a:buNone/>
-            </a:pPr>
-            <a:r>
-              <a:rPr lang="en-US" sz="1000" b="1" dirty="0">
-                <a:solidFill>
-                  <a:srgbClr val="D72638"/>
-                </a:solidFill>
-                <a:latin typeface="맑은 고딕" pitchFamily="34" charset="0"/>
-                <a:ea typeface="맑은 고딕" pitchFamily="34" charset="-122"/>
-                <a:cs typeface="맑은 고딕" pitchFamily="34" charset="-120"/>
-              </a:rPr>
-              <a:t/>
-            </a:r>
-            <a:endParaRPr lang="en-US" sz="900" dirty="0"/>
-          </a:p>
-        </p:txBody>
-      </p:sp>
-      <p:sp>
-        <p:nvSpPr>
-          <p:cNvPr id="50" name="Text 47"/>
-          <p:cNvSpPr/>
-          <p:nvPr/>
-        </p:nvSpPr>
-        <p:spPr>
-          <a:xfrm>
-            <a:off x="548640" y="6492240"/>
-            <a:ext cx="7315200" cy="274320"/>
-          </a:xfrm>
-          <a:prstGeom prst="rect">
-            <a:avLst/>
-          </a:prstGeom>
-          <a:noFill/>
-          <a:ln/>
-        </p:spPr>
-        <p:txBody>
-          <a:bodyPr wrap="square" lIns="0" tIns="0" rIns="0" bIns="0" rtlCol="0" anchor="ctr"/>
-          <a:lstStyle/>
-          <a:p>
-            <a:pPr indent="0" marL="0">
-              <a:buNone/>
-            </a:pPr>
-            <a:r>
-              <a:rPr lang="en-US" sz="900" dirty="0">
-                <a:solidFill>
-                  <a:srgbClr val="6B7280"/>
-                </a:solidFill>
-                <a:latin typeface="맑은 고딕" pitchFamily="34" charset="0"/>
-                <a:ea typeface="맑은 고딕" pitchFamily="34" charset="-122"/>
-                <a:cs typeface="맑은 고딕" pitchFamily="34" charset="-120"/>
-              </a:rPr>
-              <a:t>베스트 상품 리포트  ·  생성 2026-05-17 08:00</a:t>
+              <a:t>베스트 상품 리포트  ·  생성 2026-05-18 08:00</a:t>
             </a:r>
             <a:endParaRPr lang="en-US" sz="900" dirty="0"/>
           </a:p>
@@ -13769,7 +13769,7 @@
                 <a:ea typeface="맑은 고딕" pitchFamily="34" charset="-122"/>
                 <a:cs typeface="맑은 고딕" pitchFamily="34" charset="-120"/>
               </a:rPr>
-              <a:t>2026년 05월 17일 (일)</a:t>
+              <a:t>2026년 05월 18일 (월)</a:t>
             </a:r>
             <a:endParaRPr lang="en-US" sz="1200" dirty="0"/>
           </a:p>
@@ -13897,7 +13897,7 @@
                 <a:ea typeface="맑은 고딕" pitchFamily="34" charset="-122"/>
                 <a:cs typeface="맑은 고딕" pitchFamily="34" charset="-120"/>
               </a:rPr>
-              <a:t>🚨  긴급 리오더 59건    ·    주의 리오더 9건    ·    오늘 발주 검토 필수</a:t>
+              <a:t>🚨  긴급 리오더 64건    ·    주의 리오더 12건    ·    오늘 발주 검토 필수</a:t>
             </a:r>
             <a:pPr indent="0" marL="0">
               <a:buNone/>
@@ -14663,7 +14663,7 @@
                           <a:ea typeface="맑은 고딕" pitchFamily="34" charset="-122"/>
                           <a:cs typeface="맑은 고딕" pitchFamily="34" charset="-120"/>
                         </a:rPr>
-                        <a:t>[SILVER925] Geos Open Ring</a:t>
+                        <a:t>[SILVER925] Azure Open Ring</a:t>
                       </a:r>
                       <a:endParaRPr lang="en-US" sz="1100" dirty="0">
                         <a:latin typeface="맑은 고딕" charset="0"/>
@@ -14731,7 +14731,7 @@
                           <a:ea typeface="맑은 고딕" pitchFamily="34" charset="-122"/>
                           <a:cs typeface="맑은 고딕" pitchFamily="34" charset="-120"/>
                         </a:rPr>
-                        <a:t>0</a:t>
+                        <a:t>2</a:t>
                       </a:r>
                       <a:endParaRPr lang="en-US" sz="1100" dirty="0">
                         <a:latin typeface="맑은 고딕" charset="0"/>
@@ -14799,7 +14799,7 @@
                           <a:ea typeface="맑은 고딕" pitchFamily="34" charset="-122"/>
                           <a:cs typeface="맑은 고딕" pitchFamily="34" charset="-120"/>
                         </a:rPr>
-                        <a:t>17 개</a:t>
+                        <a:t>6 개</a:t>
                       </a:r>
                       <a:endParaRPr lang="en-US" sz="1100" dirty="0">
                         <a:latin typeface="맑은 고딕" charset="0"/>
@@ -14937,7 +14937,7 @@
                           <a:ea typeface="맑은 고딕" pitchFamily="34" charset="-122"/>
                           <a:cs typeface="맑은 고딕" pitchFamily="34" charset="-120"/>
                         </a:rPr>
-                        <a:t>PR</a:t>
+                        <a:t>6A</a:t>
                       </a:r>
                       <a:endParaRPr lang="en-US" sz="1100" dirty="0">
                         <a:latin typeface="맑은 고딕" charset="0"/>
@@ -15005,7 +15005,7 @@
                           <a:ea typeface="맑은 고딕" pitchFamily="34" charset="-122"/>
                           <a:cs typeface="맑은 고딕" pitchFamily="34" charset="-120"/>
                         </a:rPr>
-                        <a:t>ELECTRONIC</a:t>
+                        <a:t>Necklace</a:t>
                       </a:r>
                       <a:endParaRPr lang="en-US" sz="1000" dirty="0">
                         <a:latin typeface="맑은 고딕" charset="0"/>
@@ -15073,7 +15073,7 @@
                           <a:ea typeface="맑은 고딕" pitchFamily="34" charset="-122"/>
                           <a:cs typeface="맑은 고딕" pitchFamily="34" charset="-120"/>
                         </a:rPr>
-                        <a:t>Jacquard Fast Charging Cable (7color) (컬러: 퍼플 / 기종옵션: C-Apple 8pin / 길이: 2m)</a:t>
+                        <a:t>RichardKokser Necklace</a:t>
                       </a:r>
                       <a:endParaRPr lang="en-US" sz="1100" dirty="0">
                         <a:latin typeface="맑은 고딕" charset="0"/>
@@ -15141,7 +15141,7 @@
                           <a:ea typeface="맑은 고딕" pitchFamily="34" charset="-122"/>
                           <a:cs typeface="맑은 고딕" pitchFamily="34" charset="-120"/>
                         </a:rPr>
-                        <a:t>14</a:t>
+                        <a:t>5</a:t>
                       </a:r>
                       <a:endParaRPr lang="en-US" sz="1100" dirty="0">
                         <a:latin typeface="맑은 고딕" charset="0"/>
@@ -15209,7 +15209,7 @@
                           <a:ea typeface="맑은 고딕" pitchFamily="34" charset="-122"/>
                           <a:cs typeface="맑은 고딕" pitchFamily="34" charset="-120"/>
                         </a:rPr>
-                        <a:t>3 개</a:t>
+                        <a:t>5 개</a:t>
                       </a:r>
                       <a:endParaRPr lang="en-US" sz="1100" dirty="0">
                         <a:latin typeface="맑은 고딕" charset="0"/>
@@ -15551,7 +15551,7 @@
                           <a:ea typeface="맑은 고딕" pitchFamily="34" charset="-122"/>
                           <a:cs typeface="맑은 고딕" pitchFamily="34" charset="-120"/>
                         </a:rPr>
-                        <a:t>5</a:t>
+                        <a:t>3</a:t>
                       </a:r>
                       <a:endParaRPr lang="en-US" sz="1100" dirty="0">
                         <a:latin typeface="맑은 고딕" charset="0"/>
@@ -15619,7 +15619,7 @@
                           <a:ea typeface="맑은 고딕" pitchFamily="34" charset="-122"/>
                           <a:cs typeface="맑은 고딕" pitchFamily="34" charset="-120"/>
                         </a:rPr>
-                        <a:t>1 개</a:t>
+                        <a:t>2 개</a:t>
                       </a:r>
                       <a:endParaRPr lang="en-US" sz="1100" dirty="0">
                         <a:latin typeface="맑은 고딕" charset="0"/>
@@ -15893,7 +15893,7 @@
                           <a:ea typeface="맑은 고딕" pitchFamily="34" charset="-122"/>
                           <a:cs typeface="맑은 고딕" pitchFamily="34" charset="-120"/>
                         </a:rPr>
-                        <a:t>Fuzzy Stripe Slippers (3color) (컬러: 그린 / 사이즈: 240~250(여성))</a:t>
+                        <a:t>360° Rotating Phone Holder (컬러: 블랙)</a:t>
                       </a:r>
                       <a:endParaRPr lang="en-US" sz="1100" dirty="0">
                         <a:latin typeface="맑은 고딕" charset="0"/>
@@ -15961,7 +15961,7 @@
                           <a:ea typeface="맑은 고딕" pitchFamily="34" charset="-122"/>
                           <a:cs typeface="맑은 고딕" pitchFamily="34" charset="-120"/>
                         </a:rPr>
-                        <a:t>6</a:t>
+                        <a:t>17</a:t>
                       </a:r>
                       <a:endParaRPr lang="en-US" sz="1100" dirty="0">
                         <a:latin typeface="맑은 고딕" charset="0"/>
@@ -16029,7 +16029,7 @@
                           <a:ea typeface="맑은 고딕" pitchFamily="34" charset="-122"/>
                           <a:cs typeface="맑은 고딕" pitchFamily="34" charset="-120"/>
                         </a:rPr>
-                        <a:t>1 개</a:t>
+                        <a:t>2 개</a:t>
                       </a:r>
                       <a:endParaRPr lang="en-US" sz="1100" dirty="0">
                         <a:latin typeface="맑은 고딕" charset="0"/>
@@ -16167,7 +16167,7 @@
                           <a:ea typeface="맑은 고딕" pitchFamily="34" charset="-122"/>
                           <a:cs typeface="맑은 고딕" pitchFamily="34" charset="-120"/>
                         </a:rPr>
-                        <a:t>PR</a:t>
+                        <a:t>6A</a:t>
                       </a:r>
                       <a:endParaRPr lang="en-US" sz="1100" dirty="0">
                         <a:latin typeface="맑은 고딕" charset="0"/>
@@ -16235,7 +16235,7 @@
                           <a:ea typeface="맑은 고딕" pitchFamily="34" charset="-122"/>
                           <a:cs typeface="맑은 고딕" pitchFamily="34" charset="-120"/>
                         </a:rPr>
-                        <a:t>ETC</a:t>
+                        <a:t>Bracelet</a:t>
                       </a:r>
                       <a:endParaRPr lang="en-US" sz="1000" dirty="0">
                         <a:latin typeface="맑은 고딕" charset="0"/>
@@ -16303,7 +16303,7 @@
                           <a:ea typeface="맑은 고딕" pitchFamily="34" charset="-122"/>
                           <a:cs typeface="맑은 고딕" pitchFamily="34" charset="-120"/>
                         </a:rPr>
-                        <a:t>Cotton Lunch Mini Bag (5color) (색상: 레드)</a:t>
+                        <a:t>Two-ball Bangle</a:t>
                       </a:r>
                       <a:endParaRPr lang="en-US" sz="1100" dirty="0">
                         <a:latin typeface="맑은 고딕" charset="0"/>
@@ -16371,7 +16371,7 @@
                           <a:ea typeface="맑은 고딕" pitchFamily="34" charset="-122"/>
                           <a:cs typeface="맑은 고딕" pitchFamily="34" charset="-120"/>
                         </a:rPr>
-                        <a:t>8</a:t>
+                        <a:t>5</a:t>
                       </a:r>
                       <a:endParaRPr lang="en-US" sz="1100" dirty="0">
                         <a:latin typeface="맑은 고딕" charset="0"/>
@@ -16577,7 +16577,7 @@
                           <a:ea typeface="맑은 고딕" pitchFamily="34" charset="-122"/>
                           <a:cs typeface="맑은 고딕" pitchFamily="34" charset="-120"/>
                         </a:rPr>
-                        <a:t>PR</a:t>
+                        <a:t>CT</a:t>
                       </a:r>
                       <a:endParaRPr lang="en-US" sz="1100" dirty="0">
                         <a:latin typeface="맑은 고딕" charset="0"/>
@@ -16645,7 +16645,7 @@
                           <a:ea typeface="맑은 고딕" pitchFamily="34" charset="-122"/>
                           <a:cs typeface="맑은 고딕" pitchFamily="34" charset="-120"/>
                         </a:rPr>
-                        <a:t>ELECTRONIC</a:t>
+                        <a:t>Ring</a:t>
                       </a:r>
                       <a:endParaRPr lang="en-US" sz="1000" dirty="0">
                         <a:latin typeface="맑은 고딕" charset="0"/>
@@ -16713,7 +16713,7 @@
                           <a:ea typeface="맑은 고딕" pitchFamily="34" charset="-122"/>
                           <a:cs typeface="맑은 고딕" pitchFamily="34" charset="-120"/>
                         </a:rPr>
-                        <a:t>180° Fast Charging Cable (8color) (컬러: 오렌지 / 기종 옵션: C type -&gt; C type)</a:t>
+                        <a:t>"Giethoorn" 925 Open Ring</a:t>
                       </a:r>
                       <a:endParaRPr lang="en-US" sz="1100" dirty="0">
                         <a:latin typeface="맑은 고딕" charset="0"/>
@@ -16781,7 +16781,7 @@
                           <a:ea typeface="맑은 고딕" pitchFamily="34" charset="-122"/>
                           <a:cs typeface="맑은 고딕" pitchFamily="34" charset="-120"/>
                         </a:rPr>
-                        <a:t>0</a:t>
+                        <a:t>5</a:t>
                       </a:r>
                       <a:endParaRPr lang="en-US" sz="1100" dirty="0">
                         <a:latin typeface="맑은 고딕" charset="0"/>
@@ -16987,7 +16987,7 @@
                           <a:ea typeface="맑은 고딕" pitchFamily="34" charset="-122"/>
                           <a:cs typeface="맑은 고딕" pitchFamily="34" charset="-120"/>
                         </a:rPr>
-                        <a:t>6A</a:t>
+                        <a:t>CT</a:t>
                       </a:r>
                       <a:endParaRPr lang="en-US" sz="1100" dirty="0">
                         <a:latin typeface="맑은 고딕" charset="0"/>
@@ -17055,7 +17055,7 @@
                           <a:ea typeface="맑은 고딕" pitchFamily="34" charset="-122"/>
                           <a:cs typeface="맑은 고딕" pitchFamily="34" charset="-120"/>
                         </a:rPr>
-                        <a:t>★Season off★</a:t>
+                        <a:t>Ring</a:t>
                       </a:r>
                       <a:endParaRPr lang="en-US" sz="1000" dirty="0">
                         <a:latin typeface="맑은 고딕" charset="0"/>
@@ -17123,7 +17123,7 @@
                           <a:ea typeface="맑은 고딕" pitchFamily="34" charset="-122"/>
                           <a:cs typeface="맑은 고딕" pitchFamily="34" charset="-120"/>
                         </a:rPr>
-                        <a:t>8-Ball Smart Tok</a:t>
+                        <a:t>"Whisow" 925 Open Ring</a:t>
                       </a:r>
                       <a:endParaRPr lang="en-US" sz="1100" dirty="0">
                         <a:latin typeface="맑은 고딕" charset="0"/>
@@ -17191,7 +17191,7 @@
                           <a:ea typeface="맑은 고딕" pitchFamily="34" charset="-122"/>
                           <a:cs typeface="맑은 고딕" pitchFamily="34" charset="-120"/>
                         </a:rPr>
-                        <a:t>5</a:t>
+                        <a:t>0</a:t>
                       </a:r>
                       <a:endParaRPr lang="en-US" sz="1100" dirty="0">
                         <a:latin typeface="맑은 고딕" charset="0"/>
@@ -17259,7 +17259,7 @@
                           <a:ea typeface="맑은 고딕" pitchFamily="34" charset="-122"/>
                           <a:cs typeface="맑은 고딕" pitchFamily="34" charset="-120"/>
                         </a:rPr>
-                        <a:t>0 개</a:t>
+                        <a:t>1 개</a:t>
                       </a:r>
                       <a:endParaRPr lang="en-US" sz="1100" dirty="0">
                         <a:latin typeface="맑은 고딕" charset="0"/>
@@ -17397,7 +17397,7 @@
                           <a:ea typeface="맑은 고딕" pitchFamily="34" charset="-122"/>
                           <a:cs typeface="맑은 고딕" pitchFamily="34" charset="-120"/>
                         </a:rPr>
-                        <a:t>6A</a:t>
+                        <a:t>PR</a:t>
                       </a:r>
                       <a:endParaRPr lang="en-US" sz="1100" dirty="0">
                         <a:latin typeface="맑은 고딕" charset="0"/>
@@ -17465,7 +17465,7 @@
                           <a:ea typeface="맑은 고딕" pitchFamily="34" charset="-122"/>
                           <a:cs typeface="맑은 고딕" pitchFamily="34" charset="-120"/>
                         </a:rPr>
-                        <a:t>Necklace</a:t>
+                        <a:t>★ Last Sale ★</a:t>
                       </a:r>
                       <a:endParaRPr lang="en-US" sz="1000" dirty="0">
                         <a:latin typeface="맑은 고딕" charset="0"/>
@@ -17533,7 +17533,7 @@
                           <a:ea typeface="맑은 고딕" pitchFamily="34" charset="-122"/>
                           <a:cs typeface="맑은 고딕" pitchFamily="34" charset="-120"/>
                         </a:rPr>
-                        <a:t>B-Flower Necklace (Size: 2 Size)</a:t>
+                        <a:t>Cloud Grip Glass Mini Brush (3color) (컬러: 스카이블루)</a:t>
                       </a:r>
                       <a:endParaRPr lang="en-US" sz="1100" dirty="0">
                         <a:latin typeface="맑은 고딕" charset="0"/>
@@ -17601,7 +17601,7 @@
                           <a:ea typeface="맑은 고딕" pitchFamily="34" charset="-122"/>
                           <a:cs typeface="맑은 고딕" pitchFamily="34" charset="-120"/>
                         </a:rPr>
-                        <a:t>4</a:t>
+                        <a:t>20</a:t>
                       </a:r>
                       <a:endParaRPr lang="en-US" sz="1100" dirty="0">
                         <a:latin typeface="맑은 고딕" charset="0"/>
@@ -17669,7 +17669,7 @@
                           <a:ea typeface="맑은 고딕" pitchFamily="34" charset="-122"/>
                           <a:cs typeface="맑은 고딕" pitchFamily="34" charset="-120"/>
                         </a:rPr>
-                        <a:t>0 개</a:t>
+                        <a:t>1 개</a:t>
                       </a:r>
                       <a:endParaRPr lang="en-US" sz="1100" dirty="0">
                         <a:latin typeface="맑은 고딕" charset="0"/>
@@ -17807,7 +17807,7 @@
                           <a:ea typeface="맑은 고딕" pitchFamily="34" charset="-122"/>
                           <a:cs typeface="맑은 고딕" pitchFamily="34" charset="-120"/>
                         </a:rPr>
-                        <a:t>6A</a:t>
+                        <a:t>PR</a:t>
                       </a:r>
                       <a:endParaRPr lang="en-US" sz="1100" dirty="0">
                         <a:latin typeface="맑은 고딕" charset="0"/>
@@ -17875,7 +17875,7 @@
                           <a:ea typeface="맑은 고딕" pitchFamily="34" charset="-122"/>
                           <a:cs typeface="맑은 고딕" pitchFamily="34" charset="-120"/>
                         </a:rPr>
-                        <a:t>★Season off★</a:t>
+                        <a:t>ETC</a:t>
                       </a:r>
                       <a:endParaRPr lang="en-US" sz="1000" dirty="0">
                         <a:latin typeface="맑은 고딕" charset="0"/>
@@ -17943,7 +17943,7 @@
                           <a:ea typeface="맑은 고딕" pitchFamily="34" charset="-122"/>
                           <a:cs typeface="맑은 고딕" pitchFamily="34" charset="-120"/>
                         </a:rPr>
-                        <a:t>Tangle Keychain</a:t>
+                        <a:t>Fuzzy Stripe Slippers (3color) (컬러: 핑크 / 사이즈: 240~250(여성))</a:t>
                       </a:r>
                       <a:endParaRPr lang="en-US" sz="1100" dirty="0">
                         <a:latin typeface="맑은 고딕" charset="0"/>
@@ -18011,7 +18011,7 @@
                           <a:ea typeface="맑은 고딕" pitchFamily="34" charset="-122"/>
                           <a:cs typeface="맑은 고딕" pitchFamily="34" charset="-120"/>
                         </a:rPr>
-                        <a:t>3</a:t>
+                        <a:t>2</a:t>
                       </a:r>
                       <a:endParaRPr lang="en-US" sz="1100" dirty="0">
                         <a:latin typeface="맑은 고딕" charset="0"/>
@@ -18079,7 +18079,7 @@
                           <a:ea typeface="맑은 고딕" pitchFamily="34" charset="-122"/>
                           <a:cs typeface="맑은 고딕" pitchFamily="34" charset="-120"/>
                         </a:rPr>
-                        <a:t>0 개</a:t>
+                        <a:t>1 개</a:t>
                       </a:r>
                       <a:endParaRPr lang="en-US" sz="1100" dirty="0">
                         <a:latin typeface="맑은 고딕" charset="0"/>
@@ -18168,7 +18168,7 @@
                 <a:ea typeface="맑은 고딕" pitchFamily="34" charset="-122"/>
                 <a:cs typeface="맑은 고딕" pitchFamily="34" charset="-120"/>
               </a:rPr>
-              <a:t>외 50건 더 있음 — 상세는 시트에서 확인</a:t>
+              <a:t>외 55건 더 있음 — 상세는 시트에서 확인</a:t>
             </a:r>
             <a:endParaRPr lang="en-US" sz="1000" dirty="0"/>
           </a:p>
@@ -18207,7 +18207,7 @@
                 <a:ea typeface="맑은 고딕" pitchFamily="34" charset="-122"/>
                 <a:cs typeface="맑은 고딕" pitchFamily="34" charset="-120"/>
               </a:rPr>
-              <a:t>베스트 상품 리포트  ·  생성 2026-05-17 08:00</a:t>
+              <a:t>베스트 상품 리포트  ·  생성 2026-05-18 08:00</a:t>
             </a:r>
             <a:endParaRPr lang="en-US" sz="900" dirty="0"/>
           </a:p>
@@ -18420,7 +18420,7 @@
                 <a:ea typeface="맑은 고딕" pitchFamily="34" charset="-122"/>
                 <a:cs typeface="맑은 고딕" pitchFamily="34" charset="-120"/>
               </a:rPr>
-              <a:t>2026년 05월 17일 (일)</a:t>
+              <a:t>2026년 05월 18일 (월)</a:t>
             </a:r>
             <a:endParaRPr lang="en-US" sz="1200" dirty="0"/>
           </a:p>
@@ -18587,7 +18587,7 @@
                 <a:ea typeface="맑은 고딕" pitchFamily="34" charset="-122"/>
                 <a:cs typeface="맑은 고딕" pitchFamily="34" charset="-120"/>
               </a:rPr>
-              <a:t>Google Sheet '브랜드 재고현황'  ·  최신화 2026-05-17 08:00</a:t>
+              <a:t>Google Sheet '브랜드 재고현황'  ·  최신화 2026-05-18 08:00</a:t>
             </a:r>
             <a:endParaRPr lang="en-US" sz="1100" dirty="0"/>
           </a:p>
@@ -19230,7 +19230,7 @@
                 <a:ea typeface="맑은 고딕" pitchFamily="34" charset="-122"/>
                 <a:cs typeface="맑은 고딕" pitchFamily="34" charset="-120"/>
               </a:rPr>
-              <a:t>✅ 3개 브랜드 모두 정상 추출  ·  24h 출고 기준 (2026-05-16 08:00 → 2026-05-17 08:00) · 신규 SKU 12건은 결제완료 기준</a:t>
+              <a:t>✅ 3개 브랜드 모두 정상 추출  ·  24h 출고 기준 (2026-05-17 08:00 → 2026-05-18 08:00) · 신규 SKU 12건은 결제완료 기준</a:t>
             </a:r>
             <a:endParaRPr lang="en-US" sz="1000" dirty="0"/>
           </a:p>
@@ -19269,7 +19269,7 @@
                 <a:ea typeface="맑은 고딕" pitchFamily="34" charset="-122"/>
                 <a:cs typeface="맑은 고딕" pitchFamily="34" charset="-120"/>
               </a:rPr>
-              <a:t>베스트 상품 리포트  ·  생성 2026-05-17 08:00</a:t>
+              <a:t>베스트 상품 리포트  ·  생성 2026-05-18 08:00</a:t>
             </a:r>
             <a:endParaRPr lang="en-US" sz="900" dirty="0"/>
           </a:p>

</xml_diff>

<commit_message>
chore: 매출 PPT 업로드 (best-sellers-2026-05-19.pptx) [auto]
</commit_message>
<xml_diff>
--- a/data/sales-report.pptx
+++ b/data/sales-report.pptx
@@ -1648,7 +1648,7 @@
                 <a:ea typeface="맑은 고딕" pitchFamily="34" charset="-122"/>
                 <a:cs typeface="맑은 고딕" pitchFamily="34" charset="-120"/>
               </a:rPr>
-              <a:t>2026년 05월 18일 (월)  ·  24h 출고 기준</a:t>
+              <a:t>2026년 05월 19일 (화)  ·  24h 출고 기준</a:t>
             </a:r>
             <a:endParaRPr lang="en-US" sz="2200" dirty="0"/>
           </a:p>
@@ -1726,7 +1726,7 @@
                 <a:ea typeface="맑은 고딕" pitchFamily="34" charset="-122"/>
                 <a:cs typeface="맑은 고딕" pitchFamily="34" charset="-120"/>
               </a:rPr>
-              <a:t>05.18</a:t>
+              <a:t>05.19</a:t>
             </a:r>
             <a:endParaRPr lang="en-US" sz="7200" dirty="0"/>
           </a:p>
@@ -1765,7 +1765,7 @@
                 <a:ea typeface="맑은 고딕" pitchFamily="34" charset="-122"/>
                 <a:cs typeface="맑은 고딕" pitchFamily="34" charset="-120"/>
               </a:rPr>
-              <a:t>월요일</a:t>
+              <a:t>화요일</a:t>
             </a:r>
             <a:endParaRPr lang="en-US" sz="1400" dirty="0"/>
           </a:p>
@@ -1804,7 +1804,7 @@
                 <a:ea typeface="맑은 고딕" pitchFamily="34" charset="-122"/>
                 <a:cs typeface="맑은 고딕" pitchFamily="34" charset="-120"/>
               </a:rPr>
-              <a:t>생성 2026-05-18 08:00  ·  Google Sheet 자동 동기</a:t>
+              <a:t>생성 2026-05-19 08:00  ·  Google Sheet 자동 동기</a:t>
             </a:r>
             <a:endParaRPr lang="en-US" sz="1000" dirty="0"/>
           </a:p>
@@ -1978,7 +1978,7 @@
                 <a:ea typeface="맑은 고딕" pitchFamily="34" charset="-122"/>
                 <a:cs typeface="맑은 고딕" pitchFamily="34" charset="-120"/>
               </a:rPr>
-              <a:t>2026년 05월 18일 (월)</a:t>
+              <a:t>2026년 05월 19일 (화)</a:t>
             </a:r>
             <a:endParaRPr lang="en-US" sz="1200" dirty="0"/>
           </a:p>
@@ -2145,7 +2145,7 @@
                 <a:ea typeface="맑은 고딕" pitchFamily="34" charset="-122"/>
                 <a:cs typeface="맑은 고딕" pitchFamily="34" charset="-120"/>
               </a:rPr>
-              <a:t>808 개</a:t>
+              <a:t>348 개</a:t>
             </a:r>
             <a:endParaRPr lang="en-US" sz="3600" dirty="0"/>
           </a:p>
@@ -2312,7 +2312,7 @@
                 <a:ea typeface="맑은 고딕" pitchFamily="34" charset="-122"/>
                 <a:cs typeface="맑은 고딕" pitchFamily="34" charset="-120"/>
               </a:rPr>
-              <a:t>64 건</a:t>
+              <a:t>65 건</a:t>
             </a:r>
             <a:endParaRPr lang="en-US" sz="3200" dirty="0"/>
           </a:p>
@@ -2479,7 +2479,7 @@
                 <a:ea typeface="맑은 고딕" pitchFamily="34" charset="-122"/>
                 <a:cs typeface="맑은 고딕" pitchFamily="34" charset="-120"/>
               </a:rPr>
-              <a:t>12 건</a:t>
+              <a:t>10 건</a:t>
             </a:r>
             <a:endParaRPr lang="en-US" sz="3200" dirty="0"/>
           </a:p>
@@ -2685,7 +2685,7 @@
                 <a:ea typeface="맑은 고딕" pitchFamily="34" charset="-122"/>
                 <a:cs typeface="맑은 고딕" pitchFamily="34" charset="-120"/>
               </a:rPr>
-              <a:t>86 SKU  ·  판매 OK</a:t>
+              <a:t>87 SKU  ·  판매 OK</a:t>
             </a:r>
             <a:pPr indent="0" marL="0">
               <a:buNone/>
@@ -3612,7 +3612,7 @@
                           <a:ea typeface="맑은 고딕" pitchFamily="34" charset="-122"/>
                           <a:cs typeface="맑은 고딕" pitchFamily="34" charset="-120"/>
                         </a:rPr>
-                        <a:t>[SILVER925] Guyeong Open Ring v3.0 (silver)</a:t>
+                        <a:t>[SILVER925] CH.alban Open Ring</a:t>
                       </a:r>
                       <a:endParaRPr lang="en-US" sz="1100" dirty="0">
                         <a:latin typeface="맑은 고딕" charset="0"/>
@@ -3677,7 +3677,7 @@
                           <a:ea typeface="맑은 고딕" pitchFamily="34" charset="-122"/>
                           <a:cs typeface="맑은 고딕" pitchFamily="34" charset="-120"/>
                         </a:rPr>
-                        <a:t>113 개</a:t>
+                        <a:t>47 개</a:t>
                       </a:r>
                       <a:endParaRPr lang="en-US" sz="1400" dirty="0">
                         <a:latin typeface="맑은 고딕" charset="0"/>
@@ -3939,7 +3939,7 @@
                           <a:ea typeface="맑은 고딕" pitchFamily="34" charset="-122"/>
                           <a:cs typeface="맑은 고딕" pitchFamily="34" charset="-120"/>
                         </a:rPr>
-                        <a:t>CandyPOP Necklace (사이즈: 2size (47~52cm))</a:t>
+                        <a:t>CandyPOP Necklace (사이즈: 1size (41.5~47cm))</a:t>
                       </a:r>
                       <a:endParaRPr lang="en-US" sz="1100" dirty="0">
                         <a:latin typeface="맑은 고딕" charset="0"/>
@@ -4004,7 +4004,7 @@
                           <a:ea typeface="맑은 고딕" pitchFamily="34" charset="-122"/>
                           <a:cs typeface="맑은 고딕" pitchFamily="34" charset="-120"/>
                         </a:rPr>
-                        <a:t>57 개</a:t>
+                        <a:t>46 개</a:t>
                       </a:r>
                       <a:endParaRPr lang="en-US" sz="1400" dirty="0">
                         <a:latin typeface="맑은 고딕" charset="0"/>
@@ -4136,7 +4136,7 @@
                           <a:ea typeface="맑은 고딕" pitchFamily="34" charset="-122"/>
                           <a:cs typeface="맑은 고딕" pitchFamily="34" charset="-120"/>
                         </a:rPr>
-                        <a:t>CT</a:t>
+                        <a:t>6A</a:t>
                       </a:r>
                       <a:endParaRPr lang="en-US" sz="1100" dirty="0">
                         <a:latin typeface="맑은 고딕" charset="0"/>
@@ -4201,7 +4201,7 @@
                           <a:ea typeface="맑은 고딕" pitchFamily="34" charset="-122"/>
                           <a:cs typeface="맑은 고딕" pitchFamily="34" charset="-120"/>
                         </a:rPr>
-                        <a:t>Necklace</a:t>
+                        <a:t>Ring</a:t>
                       </a:r>
                       <a:endParaRPr lang="en-US" sz="1000" dirty="0">
                         <a:latin typeface="맑은 고딕" charset="0"/>
@@ -4266,7 +4266,7 @@
                           <a:ea typeface="맑은 고딕" pitchFamily="34" charset="-122"/>
                           <a:cs typeface="맑은 고딕" pitchFamily="34" charset="-120"/>
                         </a:rPr>
-                        <a:t>CandyPOP Necklace (사이즈: 1size (41.5~47cm))</a:t>
+                        <a:t>[SILVER925] Guyeong Open Ring v3.0 (silver)</a:t>
                       </a:r>
                       <a:endParaRPr lang="en-US" sz="1100" dirty="0">
                         <a:latin typeface="맑은 고딕" charset="0"/>
@@ -4331,7 +4331,7 @@
                           <a:ea typeface="맑은 고딕" pitchFamily="34" charset="-122"/>
                           <a:cs typeface="맑은 고딕" pitchFamily="34" charset="-120"/>
                         </a:rPr>
-                        <a:t>57 개</a:t>
+                        <a:t>30 개</a:t>
                       </a:r>
                       <a:endParaRPr lang="en-US" sz="1400" dirty="0">
                         <a:latin typeface="맑은 고딕" charset="0"/>
@@ -4463,7 +4463,7 @@
                           <a:ea typeface="맑은 고딕" pitchFamily="34" charset="-122"/>
                           <a:cs typeface="맑은 고딕" pitchFamily="34" charset="-120"/>
                         </a:rPr>
-                        <a:t>6A</a:t>
+                        <a:t>CT</a:t>
                       </a:r>
                       <a:endParaRPr lang="en-US" sz="1100" dirty="0">
                         <a:latin typeface="맑은 고딕" charset="0"/>
@@ -4528,7 +4528,7 @@
                           <a:ea typeface="맑은 고딕" pitchFamily="34" charset="-122"/>
                           <a:cs typeface="맑은 고딕" pitchFamily="34" charset="-120"/>
                         </a:rPr>
-                        <a:t>Ring</a:t>
+                        <a:t>Necklace</a:t>
                       </a:r>
                       <a:endParaRPr lang="en-US" sz="1000" dirty="0">
                         <a:latin typeface="맑은 고딕" charset="0"/>
@@ -4593,7 +4593,7 @@
                           <a:ea typeface="맑은 고딕" pitchFamily="34" charset="-122"/>
                           <a:cs typeface="맑은 고딕" pitchFamily="34" charset="-120"/>
                         </a:rPr>
-                        <a:t>[SILVER925] CH.alban Open Ring</a:t>
+                        <a:t>CandyPOP Necklace (사이즈: 2size (47~52cm))</a:t>
                       </a:r>
                       <a:endParaRPr lang="en-US" sz="1100" dirty="0">
                         <a:latin typeface="맑은 고딕" charset="0"/>
@@ -4658,7 +4658,7 @@
                           <a:ea typeface="맑은 고딕" pitchFamily="34" charset="-122"/>
                           <a:cs typeface="맑은 고딕" pitchFamily="34" charset="-120"/>
                         </a:rPr>
-                        <a:t>46 개</a:t>
+                        <a:t>23 개</a:t>
                       </a:r>
                       <a:endParaRPr lang="en-US" sz="1200" dirty="0">
                         <a:latin typeface="맑은 고딕" charset="0"/>
@@ -4790,7 +4790,7 @@
                           <a:ea typeface="맑은 고딕" pitchFamily="34" charset="-122"/>
                           <a:cs typeface="맑은 고딕" pitchFamily="34" charset="-120"/>
                         </a:rPr>
-                        <a:t>6A</a:t>
+                        <a:t>CT</a:t>
                       </a:r>
                       <a:endParaRPr lang="en-US" sz="1100" dirty="0">
                         <a:latin typeface="맑은 고딕" charset="0"/>
@@ -4920,7 +4920,7 @@
                           <a:ea typeface="맑은 고딕" pitchFamily="34" charset="-122"/>
                           <a:cs typeface="맑은 고딕" pitchFamily="34" charset="-120"/>
                         </a:rPr>
-                        <a:t>Tiny Cross Necklace</a:t>
+                        <a:t>ThreadDuo Necklace</a:t>
                       </a:r>
                       <a:endParaRPr lang="en-US" sz="1100" dirty="0">
                         <a:latin typeface="맑은 고딕" charset="0"/>
@@ -4985,7 +4985,7 @@
                           <a:ea typeface="맑은 고딕" pitchFamily="34" charset="-122"/>
                           <a:cs typeface="맑은 고딕" pitchFamily="34" charset="-120"/>
                         </a:rPr>
-                        <a:t>43 개</a:t>
+                        <a:t>17 개</a:t>
                       </a:r>
                       <a:endParaRPr lang="en-US" sz="1200" dirty="0">
                         <a:latin typeface="맑은 고딕" charset="0"/>
@@ -5071,7 +5071,7 @@
                 <a:ea typeface="맑은 고딕" pitchFamily="34" charset="-122"/>
                 <a:cs typeface="맑은 고딕" pitchFamily="34" charset="-120"/>
               </a:rPr>
-              <a:t>베스트 상품 리포트  ·  생성 2026-05-18 08:00</a:t>
+              <a:t>베스트 상품 리포트  ·  생성 2026-05-19 08:00</a:t>
             </a:r>
             <a:endParaRPr lang="en-US" sz="900" dirty="0"/>
           </a:p>
@@ -5284,7 +5284,7 @@
                 <a:ea typeface="맑은 고딕" pitchFamily="34" charset="-122"/>
                 <a:cs typeface="맑은 고딕" pitchFamily="34" charset="-120"/>
               </a:rPr>
-              <a:t>2026년 05월 18일 (월)</a:t>
+              <a:t>2026년 05월 19일 (화)</a:t>
             </a:r>
             <a:endParaRPr lang="en-US" sz="1200" dirty="0"/>
           </a:p>
@@ -5451,7 +5451,7 @@
                 <a:ea typeface="맑은 고딕" pitchFamily="34" charset="-122"/>
                 <a:cs typeface="맑은 고딕" pitchFamily="34" charset="-120"/>
               </a:rPr>
-              <a:t>605 개</a:t>
+              <a:t>225 개</a:t>
             </a:r>
             <a:endParaRPr lang="en-US" sz="3600" dirty="0"/>
           </a:p>
@@ -5579,7 +5579,7 @@
                 <a:ea typeface="맑은 고딕" pitchFamily="34" charset="-122"/>
                 <a:cs typeface="맑은 고딕" pitchFamily="34" charset="-120"/>
               </a:rPr>
-              <a:t>[SILVER925] Guyeong Open Ring v3.0 (silver)</a:t>
+              <a:t>[SILVER925] CH.alban Open Ring</a:t>
             </a:r>
             <a:endParaRPr lang="en-US" sz="1800" dirty="0"/>
           </a:p>
@@ -5657,7 +5657,7 @@
                 <a:ea typeface="맑은 고딕" pitchFamily="34" charset="-122"/>
                 <a:cs typeface="맑은 고딕" pitchFamily="34" charset="-120"/>
               </a:rPr>
-              <a:t>113</a:t>
+              <a:t>47</a:t>
             </a:r>
             <a:endParaRPr lang="en-US" sz="4400" dirty="0"/>
           </a:p>
@@ -6191,7 +6191,7 @@
                           <a:ea typeface="맑은 고딕" pitchFamily="34" charset="-122"/>
                           <a:cs typeface="맑은 고딕" pitchFamily="34" charset="-120"/>
                         </a:rPr>
-                        <a:t>[SILVER925] Guyeong Open Ring v3.0 (silver)</a:t>
+                        <a:t>[SILVER925] CH.alban Open Ring</a:t>
                       </a:r>
                       <a:endParaRPr lang="en-US" sz="1100" dirty="0">
                         <a:latin typeface="맑은 고딕" charset="0"/>
@@ -6256,7 +6256,7 @@
                           <a:ea typeface="맑은 고딕" pitchFamily="34" charset="-122"/>
                           <a:cs typeface="맑은 고딕" pitchFamily="34" charset="-120"/>
                         </a:rPr>
-                        <a:t>113 개</a:t>
+                        <a:t>47 개</a:t>
                       </a:r>
                       <a:endParaRPr lang="en-US" sz="1400" dirty="0">
                         <a:latin typeface="맑은 고딕" charset="0"/>
@@ -6453,7 +6453,7 @@
                           <a:ea typeface="맑은 고딕" pitchFamily="34" charset="-122"/>
                           <a:cs typeface="맑은 고딕" pitchFamily="34" charset="-120"/>
                         </a:rPr>
-                        <a:t>[SILVER925] CH.alban Open Ring</a:t>
+                        <a:t>[SILVER925] Guyeong Open Ring v3.0 (silver)</a:t>
                       </a:r>
                       <a:endParaRPr lang="en-US" sz="1100" dirty="0">
                         <a:latin typeface="맑은 고딕" charset="0"/>
@@ -6518,7 +6518,7 @@
                           <a:ea typeface="맑은 고딕" pitchFamily="34" charset="-122"/>
                           <a:cs typeface="맑은 고딕" pitchFamily="34" charset="-120"/>
                         </a:rPr>
-                        <a:t>46 개</a:t>
+                        <a:t>30 개</a:t>
                       </a:r>
                       <a:endParaRPr lang="en-US" sz="1200" dirty="0">
                         <a:latin typeface="맑은 고딕" charset="0"/>
@@ -6650,7 +6650,7 @@
                           <a:ea typeface="맑은 고딕" pitchFamily="34" charset="-122"/>
                           <a:cs typeface="맑은 고딕" pitchFamily="34" charset="-120"/>
                         </a:rPr>
-                        <a:t>Necklace</a:t>
+                        <a:t>Ring</a:t>
                       </a:r>
                       <a:endParaRPr lang="en-US" sz="1000" dirty="0">
                         <a:latin typeface="맑은 고딕" charset="0"/>
@@ -6715,7 +6715,7 @@
                           <a:ea typeface="맑은 고딕" pitchFamily="34" charset="-122"/>
                           <a:cs typeface="맑은 고딕" pitchFamily="34" charset="-120"/>
                         </a:rPr>
-                        <a:t>Tiny Cross Necklace</a:t>
+                        <a:t>[SILVER925] Starly Open Ring</a:t>
                       </a:r>
                       <a:endParaRPr lang="en-US" sz="1100" dirty="0">
                         <a:latin typeface="맑은 고딕" charset="0"/>
@@ -6780,7 +6780,7 @@
                           <a:ea typeface="맑은 고딕" pitchFamily="34" charset="-122"/>
                           <a:cs typeface="맑은 고딕" pitchFamily="34" charset="-120"/>
                         </a:rPr>
-                        <a:t>43 개</a:t>
+                        <a:t>14 개</a:t>
                       </a:r>
                       <a:endParaRPr lang="en-US" sz="1200" dirty="0">
                         <a:latin typeface="맑은 고딕" charset="0"/>
@@ -6977,7 +6977,7 @@
                           <a:ea typeface="맑은 고딕" pitchFamily="34" charset="-122"/>
                           <a:cs typeface="맑은 고딕" pitchFamily="34" charset="-120"/>
                         </a:rPr>
-                        <a:t>[SILVER925] Starly Open Ring</a:t>
+                        <a:t>[SILVER925] Eramam Open Ring</a:t>
                       </a:r>
                       <a:endParaRPr lang="en-US" sz="1100" dirty="0">
                         <a:latin typeface="맑은 고딕" charset="0"/>
@@ -7042,7 +7042,7 @@
                           <a:ea typeface="맑은 고딕" pitchFamily="34" charset="-122"/>
                           <a:cs typeface="맑은 고딕" pitchFamily="34" charset="-120"/>
                         </a:rPr>
-                        <a:t>42 개</a:t>
+                        <a:t>10 개</a:t>
                       </a:r>
                       <a:endParaRPr lang="en-US" sz="1200" dirty="0">
                         <a:latin typeface="맑은 고딕" charset="0"/>
@@ -7239,7 +7239,7 @@
                           <a:ea typeface="맑은 고딕" pitchFamily="34" charset="-122"/>
                           <a:cs typeface="맑은 고딕" pitchFamily="34" charset="-120"/>
                         </a:rPr>
-                        <a:t>[SILVER925] Eramam Open Ring</a:t>
+                        <a:t>[SILVER925] Cstic Open Ring</a:t>
                       </a:r>
                       <a:endParaRPr lang="en-US" sz="1100" dirty="0">
                         <a:latin typeface="맑은 고딕" charset="0"/>
@@ -7304,7 +7304,7 @@
                           <a:ea typeface="맑은 고딕" pitchFamily="34" charset="-122"/>
                           <a:cs typeface="맑은 고딕" pitchFamily="34" charset="-120"/>
                         </a:rPr>
-                        <a:t>42 개</a:t>
+                        <a:t>9 개</a:t>
                       </a:r>
                       <a:endParaRPr lang="en-US" sz="1200" dirty="0">
                         <a:latin typeface="맑은 고딕" charset="0"/>
@@ -7557,7 +7557,7 @@
                 <a:ea typeface="맑은 고딕" pitchFamily="34" charset="-122"/>
                 <a:cs typeface="맑은 고딕" pitchFamily="34" charset="-120"/>
               </a:rPr>
-              <a:t>[SILVER925] Azure Open Ring</a:t>
+              <a:t>Two-ball Bangle</a:t>
             </a:r>
             <a:endParaRPr lang="en-US" sz="1100" dirty="0"/>
           </a:p>
@@ -7596,7 +7596,7 @@
                 <a:ea typeface="맑은 고딕" pitchFamily="34" charset="-122"/>
                 <a:cs typeface="맑은 고딕" pitchFamily="34" charset="-120"/>
               </a:rPr>
-              <a:t>Ring  ·  재고 2개</a:t>
+              <a:t>Bracelet  ·  재고 0개</a:t>
             </a:r>
             <a:pPr indent="0" marL="0">
               <a:buNone/>
@@ -7778,6 +7778,418 @@
         <p:spPr>
           <a:xfrm>
             <a:off x="8211312" y="4425696"/>
+            <a:ext cx="3291840" cy="256032"/>
+          </a:xfrm>
+          <a:prstGeom prst="rect">
+            <a:avLst/>
+          </a:prstGeom>
+          <a:noFill/>
+          <a:ln/>
+        </p:spPr>
+        <p:txBody>
+          <a:bodyPr wrap="square" lIns="0" tIns="0" rIns="0" bIns="0" rtlCol="0" anchor="ctr"/>
+          <a:lstStyle/>
+          <a:p>
+            <a:pPr indent="0" marL="0">
+              <a:buNone/>
+            </a:pPr>
+            <a:r>
+              <a:rPr lang="en-US" sz="1000" dirty="0">
+                <a:solidFill>
+                  <a:srgbClr val="6B7280"/>
+                </a:solidFill>
+                <a:latin typeface="맑은 고딕" pitchFamily="34" charset="0"/>
+                <a:ea typeface="맑은 고딕" pitchFamily="34" charset="-122"/>
+                <a:cs typeface="맑은 고딕" pitchFamily="34" charset="-120"/>
+              </a:rPr>
+              <a:t>Necklace  ·  재고 0개</a:t>
+            </a:r>
+            <a:pPr indent="0" marL="0">
+              <a:buNone/>
+            </a:pPr>
+            <a:r>
+              <a:rPr lang="en-US" sz="1000" b="1" dirty="0">
+                <a:solidFill>
+                  <a:srgbClr val="D72638"/>
+                </a:solidFill>
+                <a:latin typeface="맑은 고딕" pitchFamily="34" charset="0"/>
+                <a:ea typeface="맑은 고딕" pitchFamily="34" charset="-122"/>
+                <a:cs typeface="맑은 고딕" pitchFamily="34" charset="-120"/>
+              </a:rPr>
+              <a:t/>
+            </a:r>
+            <a:endParaRPr lang="en-US" sz="1000" dirty="0"/>
+          </a:p>
+        </p:txBody>
+      </p:sp>
+      <p:sp>
+        <p:nvSpPr>
+          <p:cNvPr id="33" name="Shape 30"/>
+          <p:cNvSpPr/>
+          <p:nvPr/>
+        </p:nvSpPr>
+        <p:spPr>
+          <a:xfrm>
+            <a:off x="7406640" y="4809744"/>
+            <a:ext cx="4206240" cy="640080"/>
+          </a:xfrm>
+          <a:prstGeom prst="rect">
+            <a:avLst/>
+          </a:prstGeom>
+          <a:solidFill>
+            <a:srgbClr val="FFF5F5"/>
+          </a:solidFill>
+          <a:ln w="6350">
+            <a:solidFill>
+              <a:srgbClr val="E5E7EB"/>
+            </a:solidFill>
+            <a:prstDash val="solid"/>
+          </a:ln>
+        </p:spPr>
+      </p:sp>
+      <p:sp>
+        <p:nvSpPr>
+          <p:cNvPr id="34" name="Shape 31"/>
+          <p:cNvSpPr/>
+          <p:nvPr/>
+        </p:nvSpPr>
+        <p:spPr>
+          <a:xfrm>
+            <a:off x="7406640" y="4809744"/>
+            <a:ext cx="109728" cy="640080"/>
+          </a:xfrm>
+          <a:prstGeom prst="rect">
+            <a:avLst/>
+          </a:prstGeom>
+          <a:solidFill>
+            <a:srgbClr val="D72638"/>
+          </a:solidFill>
+          <a:ln w="12700">
+            <a:solidFill>
+              <a:srgbClr val="D72638"/>
+            </a:solidFill>
+            <a:prstDash val="solid"/>
+          </a:ln>
+        </p:spPr>
+      </p:sp>
+      <p:sp>
+        <p:nvSpPr>
+          <p:cNvPr id="35" name="Shape 32"/>
+          <p:cNvSpPr/>
+          <p:nvPr/>
+        </p:nvSpPr>
+        <p:spPr>
+          <a:xfrm>
+            <a:off x="7571232" y="4901184"/>
+            <a:ext cx="548640" cy="256032"/>
+          </a:xfrm>
+          <a:prstGeom prst="rect">
+            <a:avLst/>
+          </a:prstGeom>
+          <a:solidFill>
+            <a:srgbClr val="D72638"/>
+          </a:solidFill>
+          <a:ln w="12700">
+            <a:solidFill>
+              <a:srgbClr val="D72638"/>
+            </a:solidFill>
+            <a:prstDash val="solid"/>
+          </a:ln>
+        </p:spPr>
+      </p:sp>
+      <p:sp>
+        <p:nvSpPr>
+          <p:cNvPr id="36" name="Text 33"/>
+          <p:cNvSpPr/>
+          <p:nvPr/>
+        </p:nvSpPr>
+        <p:spPr>
+          <a:xfrm>
+            <a:off x="7571232" y="4901184"/>
+            <a:ext cx="548640" cy="256032"/>
+          </a:xfrm>
+          <a:prstGeom prst="rect">
+            <a:avLst/>
+          </a:prstGeom>
+          <a:noFill/>
+          <a:ln/>
+        </p:spPr>
+        <p:txBody>
+          <a:bodyPr wrap="square" lIns="0" tIns="0" rIns="0" bIns="0" rtlCol="0" anchor="ctr"/>
+          <a:lstStyle/>
+          <a:p>
+            <a:pPr algn="ctr" indent="0" marL="0">
+              <a:buNone/>
+            </a:pPr>
+            <a:r>
+              <a:rPr lang="en-US" sz="900" b="1" dirty="0">
+                <a:solidFill>
+                  <a:srgbClr val="FFFFFF"/>
+                </a:solidFill>
+                <a:latin typeface="맑은 고딕" pitchFamily="34" charset="0"/>
+                <a:ea typeface="맑은 고딕" pitchFamily="34" charset="-122"/>
+                <a:cs typeface="맑은 고딕" pitchFamily="34" charset="-120"/>
+              </a:rPr>
+              <a:t>긴급</a:t>
+            </a:r>
+            <a:endParaRPr lang="en-US" sz="900" dirty="0"/>
+          </a:p>
+        </p:txBody>
+      </p:sp>
+      <p:sp>
+        <p:nvSpPr>
+          <p:cNvPr id="37" name="Text 34"/>
+          <p:cNvSpPr/>
+          <p:nvPr/>
+        </p:nvSpPr>
+        <p:spPr>
+          <a:xfrm>
+            <a:off x="8211312" y="4864608"/>
+            <a:ext cx="3291840" cy="274320"/>
+          </a:xfrm>
+          <a:prstGeom prst="rect">
+            <a:avLst/>
+          </a:prstGeom>
+          <a:noFill/>
+          <a:ln/>
+        </p:spPr>
+        <p:txBody>
+          <a:bodyPr wrap="square" lIns="0" tIns="0" rIns="0" bIns="0" rtlCol="0" anchor="ctr"/>
+          <a:lstStyle/>
+          <a:p>
+            <a:pPr indent="0" marL="0">
+              <a:buNone/>
+            </a:pPr>
+            <a:r>
+              <a:rPr lang="en-US" sz="1100" b="1" dirty="0">
+                <a:solidFill>
+                  <a:srgbClr val="0B1220"/>
+                </a:solidFill>
+                <a:latin typeface="맑은 고딕" pitchFamily="34" charset="0"/>
+                <a:ea typeface="맑은 고딕" pitchFamily="34" charset="-122"/>
+                <a:cs typeface="맑은 고딕" pitchFamily="34" charset="-120"/>
+              </a:rPr>
+              <a:t>[SILVER925] Azure Open Ring</a:t>
+            </a:r>
+            <a:endParaRPr lang="en-US" sz="1100" dirty="0"/>
+          </a:p>
+        </p:txBody>
+      </p:sp>
+      <p:sp>
+        <p:nvSpPr>
+          <p:cNvPr id="38" name="Text 35"/>
+          <p:cNvSpPr/>
+          <p:nvPr/>
+        </p:nvSpPr>
+        <p:spPr>
+          <a:xfrm>
+            <a:off x="8211312" y="5138928"/>
+            <a:ext cx="3291840" cy="256032"/>
+          </a:xfrm>
+          <a:prstGeom prst="rect">
+            <a:avLst/>
+          </a:prstGeom>
+          <a:noFill/>
+          <a:ln/>
+        </p:spPr>
+        <p:txBody>
+          <a:bodyPr wrap="square" lIns="0" tIns="0" rIns="0" bIns="0" rtlCol="0" anchor="ctr"/>
+          <a:lstStyle/>
+          <a:p>
+            <a:pPr indent="0" marL="0">
+              <a:buNone/>
+            </a:pPr>
+            <a:r>
+              <a:rPr lang="en-US" sz="1000" dirty="0">
+                <a:solidFill>
+                  <a:srgbClr val="6B7280"/>
+                </a:solidFill>
+                <a:latin typeface="맑은 고딕" pitchFamily="34" charset="0"/>
+                <a:ea typeface="맑은 고딕" pitchFamily="34" charset="-122"/>
+                <a:cs typeface="맑은 고딕" pitchFamily="34" charset="-120"/>
+              </a:rPr>
+              <a:t>Ring  ·  재고 1개</a:t>
+            </a:r>
+            <a:pPr indent="0" marL="0">
+              <a:buNone/>
+            </a:pPr>
+            <a:r>
+              <a:rPr lang="en-US" sz="1000" b="1" dirty="0">
+                <a:solidFill>
+                  <a:srgbClr val="D72638"/>
+                </a:solidFill>
+                <a:latin typeface="맑은 고딕" pitchFamily="34" charset="0"/>
+                <a:ea typeface="맑은 고딕" pitchFamily="34" charset="-122"/>
+                <a:cs typeface="맑은 고딕" pitchFamily="34" charset="-120"/>
+              </a:rPr>
+              <a:t/>
+            </a:r>
+            <a:endParaRPr lang="en-US" sz="1000" dirty="0"/>
+          </a:p>
+        </p:txBody>
+      </p:sp>
+      <p:sp>
+        <p:nvSpPr>
+          <p:cNvPr id="39" name="Shape 36"/>
+          <p:cNvSpPr/>
+          <p:nvPr/>
+        </p:nvSpPr>
+        <p:spPr>
+          <a:xfrm>
+            <a:off x="7406640" y="5522976"/>
+            <a:ext cx="4206240" cy="640080"/>
+          </a:xfrm>
+          <a:prstGeom prst="rect">
+            <a:avLst/>
+          </a:prstGeom>
+          <a:solidFill>
+            <a:srgbClr val="FFF5F5"/>
+          </a:solidFill>
+          <a:ln w="6350">
+            <a:solidFill>
+              <a:srgbClr val="E5E7EB"/>
+            </a:solidFill>
+            <a:prstDash val="solid"/>
+          </a:ln>
+        </p:spPr>
+      </p:sp>
+      <p:sp>
+        <p:nvSpPr>
+          <p:cNvPr id="40" name="Shape 37"/>
+          <p:cNvSpPr/>
+          <p:nvPr/>
+        </p:nvSpPr>
+        <p:spPr>
+          <a:xfrm>
+            <a:off x="7406640" y="5522976"/>
+            <a:ext cx="109728" cy="640080"/>
+          </a:xfrm>
+          <a:prstGeom prst="rect">
+            <a:avLst/>
+          </a:prstGeom>
+          <a:solidFill>
+            <a:srgbClr val="D72638"/>
+          </a:solidFill>
+          <a:ln w="12700">
+            <a:solidFill>
+              <a:srgbClr val="D72638"/>
+            </a:solidFill>
+            <a:prstDash val="solid"/>
+          </a:ln>
+        </p:spPr>
+      </p:sp>
+      <p:sp>
+        <p:nvSpPr>
+          <p:cNvPr id="41" name="Shape 38"/>
+          <p:cNvSpPr/>
+          <p:nvPr/>
+        </p:nvSpPr>
+        <p:spPr>
+          <a:xfrm>
+            <a:off x="7571232" y="5614416"/>
+            <a:ext cx="548640" cy="256032"/>
+          </a:xfrm>
+          <a:prstGeom prst="rect">
+            <a:avLst/>
+          </a:prstGeom>
+          <a:solidFill>
+            <a:srgbClr val="D72638"/>
+          </a:solidFill>
+          <a:ln w="12700">
+            <a:solidFill>
+              <a:srgbClr val="D72638"/>
+            </a:solidFill>
+            <a:prstDash val="solid"/>
+          </a:ln>
+        </p:spPr>
+      </p:sp>
+      <p:sp>
+        <p:nvSpPr>
+          <p:cNvPr id="42" name="Text 39"/>
+          <p:cNvSpPr/>
+          <p:nvPr/>
+        </p:nvSpPr>
+        <p:spPr>
+          <a:xfrm>
+            <a:off x="7571232" y="5614416"/>
+            <a:ext cx="548640" cy="256032"/>
+          </a:xfrm>
+          <a:prstGeom prst="rect">
+            <a:avLst/>
+          </a:prstGeom>
+          <a:noFill/>
+          <a:ln/>
+        </p:spPr>
+        <p:txBody>
+          <a:bodyPr wrap="square" lIns="0" tIns="0" rIns="0" bIns="0" rtlCol="0" anchor="ctr"/>
+          <a:lstStyle/>
+          <a:p>
+            <a:pPr algn="ctr" indent="0" marL="0">
+              <a:buNone/>
+            </a:pPr>
+            <a:r>
+              <a:rPr lang="en-US" sz="900" b="1" dirty="0">
+                <a:solidFill>
+                  <a:srgbClr val="FFFFFF"/>
+                </a:solidFill>
+                <a:latin typeface="맑은 고딕" pitchFamily="34" charset="0"/>
+                <a:ea typeface="맑은 고딕" pitchFamily="34" charset="-122"/>
+                <a:cs typeface="맑은 고딕" pitchFamily="34" charset="-120"/>
+              </a:rPr>
+              <a:t>긴급</a:t>
+            </a:r>
+            <a:endParaRPr lang="en-US" sz="900" dirty="0"/>
+          </a:p>
+        </p:txBody>
+      </p:sp>
+      <p:sp>
+        <p:nvSpPr>
+          <p:cNvPr id="43" name="Text 40"/>
+          <p:cNvSpPr/>
+          <p:nvPr/>
+        </p:nvSpPr>
+        <p:spPr>
+          <a:xfrm>
+            <a:off x="8211312" y="5577840"/>
+            <a:ext cx="3291840" cy="274320"/>
+          </a:xfrm>
+          <a:prstGeom prst="rect">
+            <a:avLst/>
+          </a:prstGeom>
+          <a:noFill/>
+          <a:ln/>
+        </p:spPr>
+        <p:txBody>
+          <a:bodyPr wrap="square" lIns="0" tIns="0" rIns="0" bIns="0" rtlCol="0" anchor="ctr"/>
+          <a:lstStyle/>
+          <a:p>
+            <a:pPr indent="0" marL="0">
+              <a:buNone/>
+            </a:pPr>
+            <a:r>
+              <a:rPr lang="en-US" sz="1100" b="1" dirty="0">
+                <a:solidFill>
+                  <a:srgbClr val="0B1220"/>
+                </a:solidFill>
+                <a:latin typeface="맑은 고딕" pitchFamily="34" charset="0"/>
+                <a:ea typeface="맑은 고딕" pitchFamily="34" charset="-122"/>
+                <a:cs typeface="맑은 고딕" pitchFamily="34" charset="-120"/>
+              </a:rPr>
+              <a:t>B-Flower Necklace (Size: 2 Size)</a:t>
+            </a:r>
+            <a:endParaRPr lang="en-US" sz="1100" dirty="0"/>
+          </a:p>
+        </p:txBody>
+      </p:sp>
+      <p:sp>
+        <p:nvSpPr>
+          <p:cNvPr id="44" name="Text 41"/>
+          <p:cNvSpPr/>
+          <p:nvPr/>
+        </p:nvSpPr>
+        <p:spPr>
+          <a:xfrm>
+            <a:off x="8211312" y="5852160"/>
             <a:ext cx="3291840" cy="256032"/>
           </a:xfrm>
           <a:prstGeom prst="rect">
@@ -7824,418 +8236,6 @@
       </p:sp>
       <p:sp>
         <p:nvSpPr>
-          <p:cNvPr id="33" name="Shape 30"/>
-          <p:cNvSpPr/>
-          <p:nvPr/>
-        </p:nvSpPr>
-        <p:spPr>
-          <a:xfrm>
-            <a:off x="7406640" y="4809744"/>
-            <a:ext cx="4206240" cy="640080"/>
-          </a:xfrm>
-          <a:prstGeom prst="rect">
-            <a:avLst/>
-          </a:prstGeom>
-          <a:solidFill>
-            <a:srgbClr val="FFF5F5"/>
-          </a:solidFill>
-          <a:ln w="6350">
-            <a:solidFill>
-              <a:srgbClr val="E5E7EB"/>
-            </a:solidFill>
-            <a:prstDash val="solid"/>
-          </a:ln>
-        </p:spPr>
-      </p:sp>
-      <p:sp>
-        <p:nvSpPr>
-          <p:cNvPr id="34" name="Shape 31"/>
-          <p:cNvSpPr/>
-          <p:nvPr/>
-        </p:nvSpPr>
-        <p:spPr>
-          <a:xfrm>
-            <a:off x="7406640" y="4809744"/>
-            <a:ext cx="109728" cy="640080"/>
-          </a:xfrm>
-          <a:prstGeom prst="rect">
-            <a:avLst/>
-          </a:prstGeom>
-          <a:solidFill>
-            <a:srgbClr val="D72638"/>
-          </a:solidFill>
-          <a:ln w="12700">
-            <a:solidFill>
-              <a:srgbClr val="D72638"/>
-            </a:solidFill>
-            <a:prstDash val="solid"/>
-          </a:ln>
-        </p:spPr>
-      </p:sp>
-      <p:sp>
-        <p:nvSpPr>
-          <p:cNvPr id="35" name="Shape 32"/>
-          <p:cNvSpPr/>
-          <p:nvPr/>
-        </p:nvSpPr>
-        <p:spPr>
-          <a:xfrm>
-            <a:off x="7571232" y="4901184"/>
-            <a:ext cx="548640" cy="256032"/>
-          </a:xfrm>
-          <a:prstGeom prst="rect">
-            <a:avLst/>
-          </a:prstGeom>
-          <a:solidFill>
-            <a:srgbClr val="D72638"/>
-          </a:solidFill>
-          <a:ln w="12700">
-            <a:solidFill>
-              <a:srgbClr val="D72638"/>
-            </a:solidFill>
-            <a:prstDash val="solid"/>
-          </a:ln>
-        </p:spPr>
-      </p:sp>
-      <p:sp>
-        <p:nvSpPr>
-          <p:cNvPr id="36" name="Text 33"/>
-          <p:cNvSpPr/>
-          <p:nvPr/>
-        </p:nvSpPr>
-        <p:spPr>
-          <a:xfrm>
-            <a:off x="7571232" y="4901184"/>
-            <a:ext cx="548640" cy="256032"/>
-          </a:xfrm>
-          <a:prstGeom prst="rect">
-            <a:avLst/>
-          </a:prstGeom>
-          <a:noFill/>
-          <a:ln/>
-        </p:spPr>
-        <p:txBody>
-          <a:bodyPr wrap="square" lIns="0" tIns="0" rIns="0" bIns="0" rtlCol="0" anchor="ctr"/>
-          <a:lstStyle/>
-          <a:p>
-            <a:pPr algn="ctr" indent="0" marL="0">
-              <a:buNone/>
-            </a:pPr>
-            <a:r>
-              <a:rPr lang="en-US" sz="900" b="1" dirty="0">
-                <a:solidFill>
-                  <a:srgbClr val="FFFFFF"/>
-                </a:solidFill>
-                <a:latin typeface="맑은 고딕" pitchFamily="34" charset="0"/>
-                <a:ea typeface="맑은 고딕" pitchFamily="34" charset="-122"/>
-                <a:cs typeface="맑은 고딕" pitchFamily="34" charset="-120"/>
-              </a:rPr>
-              <a:t>긴급</a:t>
-            </a:r>
-            <a:endParaRPr lang="en-US" sz="900" dirty="0"/>
-          </a:p>
-        </p:txBody>
-      </p:sp>
-      <p:sp>
-        <p:nvSpPr>
-          <p:cNvPr id="37" name="Text 34"/>
-          <p:cNvSpPr/>
-          <p:nvPr/>
-        </p:nvSpPr>
-        <p:spPr>
-          <a:xfrm>
-            <a:off x="8211312" y="4864608"/>
-            <a:ext cx="3291840" cy="274320"/>
-          </a:xfrm>
-          <a:prstGeom prst="rect">
-            <a:avLst/>
-          </a:prstGeom>
-          <a:noFill/>
-          <a:ln/>
-        </p:spPr>
-        <p:txBody>
-          <a:bodyPr wrap="square" lIns="0" tIns="0" rIns="0" bIns="0" rtlCol="0" anchor="ctr"/>
-          <a:lstStyle/>
-          <a:p>
-            <a:pPr indent="0" marL="0">
-              <a:buNone/>
-            </a:pPr>
-            <a:r>
-              <a:rPr lang="en-US" sz="1100" b="1" dirty="0">
-                <a:solidFill>
-                  <a:srgbClr val="0B1220"/>
-                </a:solidFill>
-                <a:latin typeface="맑은 고딕" pitchFamily="34" charset="0"/>
-                <a:ea typeface="맑은 고딕" pitchFamily="34" charset="-122"/>
-                <a:cs typeface="맑은 고딕" pitchFamily="34" charset="-120"/>
-              </a:rPr>
-              <a:t>Two-ball Bangle</a:t>
-            </a:r>
-            <a:endParaRPr lang="en-US" sz="1100" dirty="0"/>
-          </a:p>
-        </p:txBody>
-      </p:sp>
-      <p:sp>
-        <p:nvSpPr>
-          <p:cNvPr id="38" name="Text 35"/>
-          <p:cNvSpPr/>
-          <p:nvPr/>
-        </p:nvSpPr>
-        <p:spPr>
-          <a:xfrm>
-            <a:off x="8211312" y="5138928"/>
-            <a:ext cx="3291840" cy="256032"/>
-          </a:xfrm>
-          <a:prstGeom prst="rect">
-            <a:avLst/>
-          </a:prstGeom>
-          <a:noFill/>
-          <a:ln/>
-        </p:spPr>
-        <p:txBody>
-          <a:bodyPr wrap="square" lIns="0" tIns="0" rIns="0" bIns="0" rtlCol="0" anchor="ctr"/>
-          <a:lstStyle/>
-          <a:p>
-            <a:pPr indent="0" marL="0">
-              <a:buNone/>
-            </a:pPr>
-            <a:r>
-              <a:rPr lang="en-US" sz="1000" dirty="0">
-                <a:solidFill>
-                  <a:srgbClr val="6B7280"/>
-                </a:solidFill>
-                <a:latin typeface="맑은 고딕" pitchFamily="34" charset="0"/>
-                <a:ea typeface="맑은 고딕" pitchFamily="34" charset="-122"/>
-                <a:cs typeface="맑은 고딕" pitchFamily="34" charset="-120"/>
-              </a:rPr>
-              <a:t>Bracelet  ·  재고 5개</a:t>
-            </a:r>
-            <a:pPr indent="0" marL="0">
-              <a:buNone/>
-            </a:pPr>
-            <a:r>
-              <a:rPr lang="en-US" sz="1000" b="1" dirty="0">
-                <a:solidFill>
-                  <a:srgbClr val="D72638"/>
-                </a:solidFill>
-                <a:latin typeface="맑은 고딕" pitchFamily="34" charset="0"/>
-                <a:ea typeface="맑은 고딕" pitchFamily="34" charset="-122"/>
-                <a:cs typeface="맑은 고딕" pitchFamily="34" charset="-120"/>
-              </a:rPr>
-              <a:t/>
-            </a:r>
-            <a:endParaRPr lang="en-US" sz="1000" dirty="0"/>
-          </a:p>
-        </p:txBody>
-      </p:sp>
-      <p:sp>
-        <p:nvSpPr>
-          <p:cNvPr id="39" name="Shape 36"/>
-          <p:cNvSpPr/>
-          <p:nvPr/>
-        </p:nvSpPr>
-        <p:spPr>
-          <a:xfrm>
-            <a:off x="7406640" y="5522976"/>
-            <a:ext cx="4206240" cy="640080"/>
-          </a:xfrm>
-          <a:prstGeom prst="rect">
-            <a:avLst/>
-          </a:prstGeom>
-          <a:solidFill>
-            <a:srgbClr val="FFF5F5"/>
-          </a:solidFill>
-          <a:ln w="6350">
-            <a:solidFill>
-              <a:srgbClr val="E5E7EB"/>
-            </a:solidFill>
-            <a:prstDash val="solid"/>
-          </a:ln>
-        </p:spPr>
-      </p:sp>
-      <p:sp>
-        <p:nvSpPr>
-          <p:cNvPr id="40" name="Shape 37"/>
-          <p:cNvSpPr/>
-          <p:nvPr/>
-        </p:nvSpPr>
-        <p:spPr>
-          <a:xfrm>
-            <a:off x="7406640" y="5522976"/>
-            <a:ext cx="109728" cy="640080"/>
-          </a:xfrm>
-          <a:prstGeom prst="rect">
-            <a:avLst/>
-          </a:prstGeom>
-          <a:solidFill>
-            <a:srgbClr val="D72638"/>
-          </a:solidFill>
-          <a:ln w="12700">
-            <a:solidFill>
-              <a:srgbClr val="D72638"/>
-            </a:solidFill>
-            <a:prstDash val="solid"/>
-          </a:ln>
-        </p:spPr>
-      </p:sp>
-      <p:sp>
-        <p:nvSpPr>
-          <p:cNvPr id="41" name="Shape 38"/>
-          <p:cNvSpPr/>
-          <p:nvPr/>
-        </p:nvSpPr>
-        <p:spPr>
-          <a:xfrm>
-            <a:off x="7571232" y="5614416"/>
-            <a:ext cx="548640" cy="256032"/>
-          </a:xfrm>
-          <a:prstGeom prst="rect">
-            <a:avLst/>
-          </a:prstGeom>
-          <a:solidFill>
-            <a:srgbClr val="D72638"/>
-          </a:solidFill>
-          <a:ln w="12700">
-            <a:solidFill>
-              <a:srgbClr val="D72638"/>
-            </a:solidFill>
-            <a:prstDash val="solid"/>
-          </a:ln>
-        </p:spPr>
-      </p:sp>
-      <p:sp>
-        <p:nvSpPr>
-          <p:cNvPr id="42" name="Text 39"/>
-          <p:cNvSpPr/>
-          <p:nvPr/>
-        </p:nvSpPr>
-        <p:spPr>
-          <a:xfrm>
-            <a:off x="7571232" y="5614416"/>
-            <a:ext cx="548640" cy="256032"/>
-          </a:xfrm>
-          <a:prstGeom prst="rect">
-            <a:avLst/>
-          </a:prstGeom>
-          <a:noFill/>
-          <a:ln/>
-        </p:spPr>
-        <p:txBody>
-          <a:bodyPr wrap="square" lIns="0" tIns="0" rIns="0" bIns="0" rtlCol="0" anchor="ctr"/>
-          <a:lstStyle/>
-          <a:p>
-            <a:pPr algn="ctr" indent="0" marL="0">
-              <a:buNone/>
-            </a:pPr>
-            <a:r>
-              <a:rPr lang="en-US" sz="900" b="1" dirty="0">
-                <a:solidFill>
-                  <a:srgbClr val="FFFFFF"/>
-                </a:solidFill>
-                <a:latin typeface="맑은 고딕" pitchFamily="34" charset="0"/>
-                <a:ea typeface="맑은 고딕" pitchFamily="34" charset="-122"/>
-                <a:cs typeface="맑은 고딕" pitchFamily="34" charset="-120"/>
-              </a:rPr>
-              <a:t>긴급</a:t>
-            </a:r>
-            <a:endParaRPr lang="en-US" sz="900" dirty="0"/>
-          </a:p>
-        </p:txBody>
-      </p:sp>
-      <p:sp>
-        <p:nvSpPr>
-          <p:cNvPr id="43" name="Text 40"/>
-          <p:cNvSpPr/>
-          <p:nvPr/>
-        </p:nvSpPr>
-        <p:spPr>
-          <a:xfrm>
-            <a:off x="8211312" y="5577840"/>
-            <a:ext cx="3291840" cy="274320"/>
-          </a:xfrm>
-          <a:prstGeom prst="rect">
-            <a:avLst/>
-          </a:prstGeom>
-          <a:noFill/>
-          <a:ln/>
-        </p:spPr>
-        <p:txBody>
-          <a:bodyPr wrap="square" lIns="0" tIns="0" rIns="0" bIns="0" rtlCol="0" anchor="ctr"/>
-          <a:lstStyle/>
-          <a:p>
-            <a:pPr indent="0" marL="0">
-              <a:buNone/>
-            </a:pPr>
-            <a:r>
-              <a:rPr lang="en-US" sz="1100" b="1" dirty="0">
-                <a:solidFill>
-                  <a:srgbClr val="0B1220"/>
-                </a:solidFill>
-                <a:latin typeface="맑은 고딕" pitchFamily="34" charset="0"/>
-                <a:ea typeface="맑은 고딕" pitchFamily="34" charset="-122"/>
-                <a:cs typeface="맑은 고딕" pitchFamily="34" charset="-120"/>
-              </a:rPr>
-              <a:t>8-Ball Smart Tok</a:t>
-            </a:r>
-            <a:endParaRPr lang="en-US" sz="1100" dirty="0"/>
-          </a:p>
-        </p:txBody>
-      </p:sp>
-      <p:sp>
-        <p:nvSpPr>
-          <p:cNvPr id="44" name="Text 41"/>
-          <p:cNvSpPr/>
-          <p:nvPr/>
-        </p:nvSpPr>
-        <p:spPr>
-          <a:xfrm>
-            <a:off x="8211312" y="5852160"/>
-            <a:ext cx="3291840" cy="256032"/>
-          </a:xfrm>
-          <a:prstGeom prst="rect">
-            <a:avLst/>
-          </a:prstGeom>
-          <a:noFill/>
-          <a:ln/>
-        </p:spPr>
-        <p:txBody>
-          <a:bodyPr wrap="square" lIns="0" tIns="0" rIns="0" bIns="0" rtlCol="0" anchor="ctr"/>
-          <a:lstStyle/>
-          <a:p>
-            <a:pPr indent="0" marL="0">
-              <a:buNone/>
-            </a:pPr>
-            <a:r>
-              <a:rPr lang="en-US" sz="1000" dirty="0">
-                <a:solidFill>
-                  <a:srgbClr val="6B7280"/>
-                </a:solidFill>
-                <a:latin typeface="맑은 고딕" pitchFamily="34" charset="0"/>
-                <a:ea typeface="맑은 고딕" pitchFamily="34" charset="-122"/>
-                <a:cs typeface="맑은 고딕" pitchFamily="34" charset="-120"/>
-              </a:rPr>
-              <a:t>★Season off★  ·  재고 5개</a:t>
-            </a:r>
-            <a:pPr indent="0" marL="0">
-              <a:buNone/>
-            </a:pPr>
-            <a:r>
-              <a:rPr lang="en-US" sz="1000" b="1" dirty="0">
-                <a:solidFill>
-                  <a:srgbClr val="D72638"/>
-                </a:solidFill>
-                <a:latin typeface="맑은 고딕" pitchFamily="34" charset="0"/>
-                <a:ea typeface="맑은 고딕" pitchFamily="34" charset="-122"/>
-                <a:cs typeface="맑은 고딕" pitchFamily="34" charset="-120"/>
-              </a:rPr>
-              <a:t/>
-            </a:r>
-            <a:endParaRPr lang="en-US" sz="1000" dirty="0"/>
-          </a:p>
-        </p:txBody>
-      </p:sp>
-      <p:sp>
-        <p:nvSpPr>
           <p:cNvPr id="45" name="Text 42"/>
           <p:cNvSpPr/>
           <p:nvPr/>
@@ -8267,7 +8267,7 @@
                 <a:ea typeface="맑은 고딕" pitchFamily="34" charset="-122"/>
                 <a:cs typeface="맑은 고딕" pitchFamily="34" charset="-120"/>
               </a:rPr>
-              <a:t>베스트 상품 리포트  ·  생성 2026-05-18 08:00</a:t>
+              <a:t>베스트 상품 리포트  ·  생성 2026-05-19 08:00</a:t>
             </a:r>
             <a:endParaRPr lang="en-US" sz="900" dirty="0"/>
           </a:p>
@@ -8480,7 +8480,7 @@
                 <a:ea typeface="맑은 고딕" pitchFamily="34" charset="-122"/>
                 <a:cs typeface="맑은 고딕" pitchFamily="34" charset="-120"/>
               </a:rPr>
-              <a:t>2026년 05월 18일 (월)</a:t>
+              <a:t>2026년 05월 19일 (화)</a:t>
             </a:r>
             <a:endParaRPr lang="en-US" sz="1200" dirty="0"/>
           </a:p>
@@ -8647,7 +8647,7 @@
                 <a:ea typeface="맑은 고딕" pitchFamily="34" charset="-122"/>
                 <a:cs typeface="맑은 고딕" pitchFamily="34" charset="-120"/>
               </a:rPr>
-              <a:t>203 개</a:t>
+              <a:t>123 개</a:t>
             </a:r>
             <a:endParaRPr lang="en-US" sz="3600" dirty="0"/>
           </a:p>
@@ -8775,7 +8775,7 @@
                 <a:ea typeface="맑은 고딕" pitchFamily="34" charset="-122"/>
                 <a:cs typeface="맑은 고딕" pitchFamily="34" charset="-120"/>
               </a:rPr>
-              <a:t>CandyPOP Necklace (사이즈: 2size (47~52cm))</a:t>
+              <a:t>CandyPOP Necklace (사이즈: 1size (41.5~47cm))</a:t>
             </a:r>
             <a:endParaRPr lang="en-US" sz="1800" dirty="0"/>
           </a:p>
@@ -8853,7 +8853,7 @@
                 <a:ea typeface="맑은 고딕" pitchFamily="34" charset="-122"/>
                 <a:cs typeface="맑은 고딕" pitchFamily="34" charset="-120"/>
               </a:rPr>
-              <a:t>57</a:t>
+              <a:t>46</a:t>
             </a:r>
             <a:endParaRPr lang="en-US" sz="4400" dirty="0"/>
           </a:p>
@@ -9387,7 +9387,7 @@
                           <a:ea typeface="맑은 고딕" pitchFamily="34" charset="-122"/>
                           <a:cs typeface="맑은 고딕" pitchFamily="34" charset="-120"/>
                         </a:rPr>
-                        <a:t>CandyPOP Necklace (사이즈: 2size (47~52cm))</a:t>
+                        <a:t>CandyPOP Necklace (사이즈: 1size (41.5~47cm))</a:t>
                       </a:r>
                       <a:endParaRPr lang="en-US" sz="1100" dirty="0">
                         <a:latin typeface="맑은 고딕" charset="0"/>
@@ -9452,7 +9452,7 @@
                           <a:ea typeface="맑은 고딕" pitchFamily="34" charset="-122"/>
                           <a:cs typeface="맑은 고딕" pitchFamily="34" charset="-120"/>
                         </a:rPr>
-                        <a:t>57 개</a:t>
+                        <a:t>46 개</a:t>
                       </a:r>
                       <a:endParaRPr lang="en-US" sz="1400" dirty="0">
                         <a:latin typeface="맑은 고딕" charset="0"/>
@@ -9649,7 +9649,7 @@
                           <a:ea typeface="맑은 고딕" pitchFamily="34" charset="-122"/>
                           <a:cs typeface="맑은 고딕" pitchFamily="34" charset="-120"/>
                         </a:rPr>
-                        <a:t>CandyPOP Necklace (사이즈: 1size (41.5~47cm))</a:t>
+                        <a:t>CandyPOP Necklace (사이즈: 2size (47~52cm))</a:t>
                       </a:r>
                       <a:endParaRPr lang="en-US" sz="1100" dirty="0">
                         <a:latin typeface="맑은 고딕" charset="0"/>
@@ -9714,7 +9714,7 @@
                           <a:ea typeface="맑은 고딕" pitchFamily="34" charset="-122"/>
                           <a:cs typeface="맑은 고딕" pitchFamily="34" charset="-120"/>
                         </a:rPr>
-                        <a:t>57 개</a:t>
+                        <a:t>23 개</a:t>
                       </a:r>
                       <a:endParaRPr lang="en-US" sz="1200" dirty="0">
                         <a:latin typeface="맑은 고딕" charset="0"/>
@@ -9846,7 +9846,7 @@
                           <a:ea typeface="맑은 고딕" pitchFamily="34" charset="-122"/>
                           <a:cs typeface="맑은 고딕" pitchFamily="34" charset="-120"/>
                         </a:rPr>
-                        <a:t>Ring</a:t>
+                        <a:t>Necklace</a:t>
                       </a:r>
                       <a:endParaRPr lang="en-US" sz="1000" dirty="0">
                         <a:latin typeface="맑은 고딕" charset="0"/>
@@ -9911,7 +9911,7 @@
                           <a:ea typeface="맑은 고딕" pitchFamily="34" charset="-122"/>
                           <a:cs typeface="맑은 고딕" pitchFamily="34" charset="-120"/>
                         </a:rPr>
-                        <a:t>"4s" 925 Open Ring (사이즈: 남성)</a:t>
+                        <a:t>ThreadDuo Necklace</a:t>
                       </a:r>
                       <a:endParaRPr lang="en-US" sz="1100" dirty="0">
                         <a:latin typeface="맑은 고딕" charset="0"/>
@@ -9976,7 +9976,7 @@
                           <a:ea typeface="맑은 고딕" pitchFamily="34" charset="-122"/>
                           <a:cs typeface="맑은 고딕" pitchFamily="34" charset="-120"/>
                         </a:rPr>
-                        <a:t>28 개</a:t>
+                        <a:t>17 개</a:t>
                       </a:r>
                       <a:endParaRPr lang="en-US" sz="1200" dirty="0">
                         <a:latin typeface="맑은 고딕" charset="0"/>
@@ -10165,7 +10165,7 @@
                 <a:ea typeface="맑은 고딕" pitchFamily="34" charset="-122"/>
                 <a:cs typeface="맑은 고딕" pitchFamily="34" charset="-120"/>
               </a:rPr>
-              <a:t>베스트 상품 리포트  ·  생성 2026-05-18 08:00</a:t>
+              <a:t>베스트 상품 리포트  ·  생성 2026-05-19 08:00</a:t>
             </a:r>
             <a:endParaRPr lang="en-US" sz="900" dirty="0"/>
           </a:p>
@@ -10378,7 +10378,7 @@
                 <a:ea typeface="맑은 고딕" pitchFamily="34" charset="-122"/>
                 <a:cs typeface="맑은 고딕" pitchFamily="34" charset="-120"/>
               </a:rPr>
-              <a:t>2026년 05월 18일 (월)</a:t>
+              <a:t>2026년 05월 19일 (화)</a:t>
             </a:r>
             <a:endParaRPr lang="en-US" sz="1200" dirty="0"/>
           </a:p>
@@ -10673,7 +10673,7 @@
                 <a:ea typeface="맑은 고딕" pitchFamily="34" charset="-122"/>
                 <a:cs typeface="맑은 고딕" pitchFamily="34" charset="-120"/>
               </a:rPr>
-              <a:t>26</a:t>
+              <a:t>25</a:t>
             </a:r>
             <a:endParaRPr lang="en-US" sz="3000" dirty="0"/>
           </a:p>
@@ -10801,7 +10801,7 @@
                 <a:ea typeface="맑은 고딕" pitchFamily="34" charset="-122"/>
                 <a:cs typeface="맑은 고딕" pitchFamily="34" charset="-120"/>
               </a:rPr>
-              <a:t>6</a:t>
+              <a:t>7</a:t>
             </a:r>
             <a:endParaRPr lang="en-US" sz="3000" dirty="0"/>
           </a:p>
@@ -10929,7 +10929,7 @@
                 <a:ea typeface="맑은 고딕" pitchFamily="34" charset="-122"/>
                 <a:cs typeface="맑은 고딕" pitchFamily="34" charset="-120"/>
               </a:rPr>
-              <a:t>34,441</a:t>
+              <a:t>33,910</a:t>
             </a:r>
             <a:endParaRPr lang="en-US" sz="3000" dirty="0"/>
           </a:p>
@@ -11489,7 +11489,7 @@
                           <a:ea typeface="맑은 고딕" pitchFamily="34" charset="-122"/>
                           <a:cs typeface="맑은 고딕" pitchFamily="34" charset="-120"/>
                         </a:rPr>
-                        <a:t>2,132</a:t>
+                        <a:t>2,123</a:t>
                       </a:r>
                       <a:endParaRPr lang="en-US" sz="1000" dirty="0">
                         <a:latin typeface="맑은 고딕" charset="0"/>
@@ -11751,7 +11751,7 @@
                           <a:ea typeface="맑은 고딕" pitchFamily="34" charset="-122"/>
                           <a:cs typeface="맑은 고딕" pitchFamily="34" charset="-120"/>
                         </a:rPr>
-                        <a:t>1,980</a:t>
+                        <a:t>1,875</a:t>
                       </a:r>
                       <a:endParaRPr lang="en-US" sz="1000" dirty="0">
                         <a:latin typeface="맑은 고딕" charset="0"/>
@@ -12013,7 +12013,7 @@
                           <a:ea typeface="맑은 고딕" pitchFamily="34" charset="-122"/>
                           <a:cs typeface="맑은 고딕" pitchFamily="34" charset="-120"/>
                         </a:rPr>
-                        <a:t>1,822</a:t>
+                        <a:t>1,749</a:t>
                       </a:r>
                       <a:endParaRPr lang="en-US" sz="1000" dirty="0">
                         <a:latin typeface="맑은 고딕" charset="0"/>
@@ -12275,7 +12275,7 @@
                           <a:ea typeface="맑은 고딕" pitchFamily="34" charset="-122"/>
                           <a:cs typeface="맑은 고딕" pitchFamily="34" charset="-120"/>
                         </a:rPr>
-                        <a:t>1,667</a:t>
+                        <a:t>1,655</a:t>
                       </a:r>
                       <a:endParaRPr lang="en-US" sz="1000" dirty="0">
                         <a:latin typeface="맑은 고딕" charset="0"/>
@@ -12537,7 +12537,7 @@
                           <a:ea typeface="맑은 고딕" pitchFamily="34" charset="-122"/>
                           <a:cs typeface="맑은 고딕" pitchFamily="34" charset="-120"/>
                         </a:rPr>
-                        <a:t>1,435</a:t>
+                        <a:t>1,358</a:t>
                       </a:r>
                       <a:endParaRPr lang="en-US" sz="1000" dirty="0">
                         <a:latin typeface="맑은 고딕" charset="0"/>
@@ -12623,7 +12623,7 @@
                 <a:ea typeface="맑은 고딕" pitchFamily="34" charset="-122"/>
                 <a:cs typeface="맑은 고딕" pitchFamily="34" charset="-120"/>
               </a:rPr>
-              <a:t>재고 점검  🔴 품절 26건</a:t>
+              <a:t>재고 점검  🔴 품절 25건</a:t>
             </a:r>
             <a:pPr indent="0" marL="0">
               <a:buNone/>
@@ -12790,226 +12790,6 @@
                 <a:ea typeface="맑은 고딕" pitchFamily="34" charset="-122"/>
                 <a:cs typeface="맑은 고딕" pitchFamily="34" charset="-120"/>
               </a:rPr>
-              <a:t>Compact Phone Stand (6color)</a:t>
-            </a:r>
-            <a:endParaRPr lang="en-US" sz="1000" dirty="0"/>
-          </a:p>
-        </p:txBody>
-      </p:sp>
-      <p:sp>
-        <p:nvSpPr>
-          <p:cNvPr id="31" name="Text 28"/>
-          <p:cNvSpPr/>
-          <p:nvPr/>
-        </p:nvSpPr>
-        <p:spPr>
-          <a:xfrm>
-            <a:off x="8211312" y="3712464"/>
-            <a:ext cx="3291840" cy="256032"/>
-          </a:xfrm>
-          <a:prstGeom prst="rect">
-            <a:avLst/>
-          </a:prstGeom>
-          <a:noFill/>
-          <a:ln/>
-        </p:spPr>
-        <p:txBody>
-          <a:bodyPr wrap="square" lIns="0" tIns="0" rIns="0" bIns="0" rtlCol="0" anchor="ctr"/>
-          <a:lstStyle/>
-          <a:p>
-            <a:pPr indent="0" marL="0">
-              <a:buNone/>
-            </a:pPr>
-            <a:r>
-              <a:rPr lang="en-US" sz="900" dirty="0">
-                <a:solidFill>
-                  <a:srgbClr val="6B7280"/>
-                </a:solidFill>
-                <a:latin typeface="맑은 고딕" pitchFamily="34" charset="0"/>
-                <a:ea typeface="맑은 고딕" pitchFamily="34" charset="-122"/>
-                <a:cs typeface="맑은 고딕" pitchFamily="34" charset="-120"/>
-              </a:rPr>
-              <a:t>컬러: 화이트  ·  재고 0개</a:t>
-            </a:r>
-            <a:pPr indent="0" marL="0">
-              <a:buNone/>
-            </a:pPr>
-            <a:r>
-              <a:rPr lang="en-US" sz="1000" dirty="0">
-                <a:solidFill>
-                  <a:srgbClr val="6B7280"/>
-                </a:solidFill>
-                <a:latin typeface="맑은 고딕" pitchFamily="34" charset="0"/>
-                <a:ea typeface="맑은 고딕" pitchFamily="34" charset="-122"/>
-                <a:cs typeface="맑은 고딕" pitchFamily="34" charset="-120"/>
-              </a:rPr>
-              <a:t/>
-            </a:r>
-            <a:pPr indent="0" marL="0">
-              <a:buNone/>
-            </a:pPr>
-            <a:r>
-              <a:rPr lang="en-US" sz="1000" b="1" dirty="0">
-                <a:solidFill>
-                  <a:srgbClr val="D72638"/>
-                </a:solidFill>
-                <a:latin typeface="맑은 고딕" pitchFamily="34" charset="0"/>
-                <a:ea typeface="맑은 고딕" pitchFamily="34" charset="-122"/>
-                <a:cs typeface="맑은 고딕" pitchFamily="34" charset="-120"/>
-              </a:rPr>
-              <a:t/>
-            </a:r>
-            <a:endParaRPr lang="en-US" sz="900" dirty="0"/>
-          </a:p>
-        </p:txBody>
-      </p:sp>
-      <p:sp>
-        <p:nvSpPr>
-          <p:cNvPr id="32" name="Shape 29"/>
-          <p:cNvSpPr/>
-          <p:nvPr/>
-        </p:nvSpPr>
-        <p:spPr>
-          <a:xfrm>
-            <a:off x="7406640" y="4096512"/>
-            <a:ext cx="4206240" cy="640080"/>
-          </a:xfrm>
-          <a:prstGeom prst="rect">
-            <a:avLst/>
-          </a:prstGeom>
-          <a:solidFill>
-            <a:srgbClr val="FFF5F5"/>
-          </a:solidFill>
-          <a:ln w="6350">
-            <a:solidFill>
-              <a:srgbClr val="E5E7EB"/>
-            </a:solidFill>
-            <a:prstDash val="solid"/>
-          </a:ln>
-        </p:spPr>
-      </p:sp>
-      <p:sp>
-        <p:nvSpPr>
-          <p:cNvPr id="33" name="Shape 30"/>
-          <p:cNvSpPr/>
-          <p:nvPr/>
-        </p:nvSpPr>
-        <p:spPr>
-          <a:xfrm>
-            <a:off x="7406640" y="4096512"/>
-            <a:ext cx="109728" cy="640080"/>
-          </a:xfrm>
-          <a:prstGeom prst="rect">
-            <a:avLst/>
-          </a:prstGeom>
-          <a:solidFill>
-            <a:srgbClr val="D72638"/>
-          </a:solidFill>
-          <a:ln w="12700">
-            <a:solidFill>
-              <a:srgbClr val="D72638"/>
-            </a:solidFill>
-            <a:prstDash val="solid"/>
-          </a:ln>
-        </p:spPr>
-      </p:sp>
-      <p:sp>
-        <p:nvSpPr>
-          <p:cNvPr id="34" name="Shape 31"/>
-          <p:cNvSpPr/>
-          <p:nvPr/>
-        </p:nvSpPr>
-        <p:spPr>
-          <a:xfrm>
-            <a:off x="7571232" y="4187952"/>
-            <a:ext cx="548640" cy="256032"/>
-          </a:xfrm>
-          <a:prstGeom prst="rect">
-            <a:avLst/>
-          </a:prstGeom>
-          <a:solidFill>
-            <a:srgbClr val="D72638"/>
-          </a:solidFill>
-          <a:ln w="12700">
-            <a:solidFill>
-              <a:srgbClr val="D72638"/>
-            </a:solidFill>
-            <a:prstDash val="solid"/>
-          </a:ln>
-        </p:spPr>
-      </p:sp>
-      <p:sp>
-        <p:nvSpPr>
-          <p:cNvPr id="35" name="Text 32"/>
-          <p:cNvSpPr/>
-          <p:nvPr/>
-        </p:nvSpPr>
-        <p:spPr>
-          <a:xfrm>
-            <a:off x="7571232" y="4187952"/>
-            <a:ext cx="548640" cy="256032"/>
-          </a:xfrm>
-          <a:prstGeom prst="rect">
-            <a:avLst/>
-          </a:prstGeom>
-          <a:noFill/>
-          <a:ln/>
-        </p:spPr>
-        <p:txBody>
-          <a:bodyPr wrap="square" lIns="0" tIns="0" rIns="0" bIns="0" rtlCol="0" anchor="ctr"/>
-          <a:lstStyle/>
-          <a:p>
-            <a:pPr algn="ctr" indent="0" marL="0">
-              <a:buNone/>
-            </a:pPr>
-            <a:r>
-              <a:rPr lang="en-US" sz="900" b="1" dirty="0">
-                <a:solidFill>
-                  <a:srgbClr val="FFFFFF"/>
-                </a:solidFill>
-                <a:latin typeface="맑은 고딕" pitchFamily="34" charset="0"/>
-                <a:ea typeface="맑은 고딕" pitchFamily="34" charset="-122"/>
-                <a:cs typeface="맑은 고딕" pitchFamily="34" charset="-120"/>
-              </a:rPr>
-              <a:t>긴급</a:t>
-            </a:r>
-            <a:endParaRPr lang="en-US" sz="900" dirty="0"/>
-          </a:p>
-        </p:txBody>
-      </p:sp>
-      <p:sp>
-        <p:nvSpPr>
-          <p:cNvPr id="36" name="Text 33"/>
-          <p:cNvSpPr/>
-          <p:nvPr/>
-        </p:nvSpPr>
-        <p:spPr>
-          <a:xfrm>
-            <a:off x="8211312" y="4151376"/>
-            <a:ext cx="3291840" cy="274320"/>
-          </a:xfrm>
-          <a:prstGeom prst="rect">
-            <a:avLst/>
-          </a:prstGeom>
-          <a:noFill/>
-          <a:ln/>
-        </p:spPr>
-        <p:txBody>
-          <a:bodyPr wrap="square" lIns="0" tIns="0" rIns="0" bIns="0" rtlCol="0" anchor="ctr"/>
-          <a:lstStyle/>
-          <a:p>
-            <a:pPr indent="0" marL="0">
-              <a:buNone/>
-            </a:pPr>
-            <a:r>
-              <a:rPr lang="en-US" sz="1000" b="1" dirty="0">
-                <a:solidFill>
-                  <a:srgbClr val="0B1220"/>
-                </a:solidFill>
-                <a:latin typeface="맑은 고딕" pitchFamily="34" charset="0"/>
-                <a:ea typeface="맑은 고딕" pitchFamily="34" charset="-122"/>
-                <a:cs typeface="맑은 고딕" pitchFamily="34" charset="-120"/>
-              </a:rPr>
               <a:t>Cotton Lunch Mini Bag (5color)</a:t>
             </a:r>
             <a:endParaRPr lang="en-US" sz="1000" dirty="0"/>
@@ -13018,13 +12798,13 @@
       </p:sp>
       <p:sp>
         <p:nvSpPr>
-          <p:cNvPr id="37" name="Text 34"/>
-          <p:cNvSpPr/>
-          <p:nvPr/>
-        </p:nvSpPr>
-        <p:spPr>
-          <a:xfrm>
-            <a:off x="8211312" y="4425696"/>
+          <p:cNvPr id="31" name="Text 28"/>
+          <p:cNvSpPr/>
+          <p:nvPr/>
+        </p:nvSpPr>
+        <p:spPr>
+          <a:xfrm>
+            <a:off x="8211312" y="3712464"/>
             <a:ext cx="3291840" cy="256032"/>
           </a:xfrm>
           <a:prstGeom prst="rect">
@@ -13085,13 +12865,13 @@
       </p:sp>
       <p:sp>
         <p:nvSpPr>
-          <p:cNvPr id="38" name="Shape 35"/>
-          <p:cNvSpPr/>
-          <p:nvPr/>
-        </p:nvSpPr>
-        <p:spPr>
-          <a:xfrm>
-            <a:off x="7406640" y="4809744"/>
+          <p:cNvPr id="32" name="Shape 29"/>
+          <p:cNvSpPr/>
+          <p:nvPr/>
+        </p:nvSpPr>
+        <p:spPr>
+          <a:xfrm>
+            <a:off x="7406640" y="4096512"/>
             <a:ext cx="4206240" cy="640080"/>
           </a:xfrm>
           <a:prstGeom prst="rect">
@@ -13110,13 +12890,13 @@
       </p:sp>
       <p:sp>
         <p:nvSpPr>
-          <p:cNvPr id="39" name="Shape 36"/>
-          <p:cNvSpPr/>
-          <p:nvPr/>
-        </p:nvSpPr>
-        <p:spPr>
-          <a:xfrm>
-            <a:off x="7406640" y="4809744"/>
+          <p:cNvPr id="33" name="Shape 30"/>
+          <p:cNvSpPr/>
+          <p:nvPr/>
+        </p:nvSpPr>
+        <p:spPr>
+          <a:xfrm>
+            <a:off x="7406640" y="4096512"/>
             <a:ext cx="109728" cy="640080"/>
           </a:xfrm>
           <a:prstGeom prst="rect">
@@ -13135,13 +12915,13 @@
       </p:sp>
       <p:sp>
         <p:nvSpPr>
-          <p:cNvPr id="40" name="Shape 37"/>
-          <p:cNvSpPr/>
-          <p:nvPr/>
-        </p:nvSpPr>
-        <p:spPr>
-          <a:xfrm>
-            <a:off x="7571232" y="4901184"/>
+          <p:cNvPr id="34" name="Shape 31"/>
+          <p:cNvSpPr/>
+          <p:nvPr/>
+        </p:nvSpPr>
+        <p:spPr>
+          <a:xfrm>
+            <a:off x="7571232" y="4187952"/>
             <a:ext cx="548640" cy="256032"/>
           </a:xfrm>
           <a:prstGeom prst="rect">
@@ -13160,13 +12940,13 @@
       </p:sp>
       <p:sp>
         <p:nvSpPr>
-          <p:cNvPr id="41" name="Text 38"/>
-          <p:cNvSpPr/>
-          <p:nvPr/>
-        </p:nvSpPr>
-        <p:spPr>
-          <a:xfrm>
-            <a:off x="7571232" y="4901184"/>
+          <p:cNvPr id="35" name="Text 32"/>
+          <p:cNvSpPr/>
+          <p:nvPr/>
+        </p:nvSpPr>
+        <p:spPr>
+          <a:xfrm>
+            <a:off x="7571232" y="4187952"/>
             <a:ext cx="548640" cy="256032"/>
           </a:xfrm>
           <a:prstGeom prst="rect">
@@ -13199,13 +12979,13 @@
       </p:sp>
       <p:sp>
         <p:nvSpPr>
-          <p:cNvPr id="42" name="Text 39"/>
-          <p:cNvSpPr/>
-          <p:nvPr/>
-        </p:nvSpPr>
-        <p:spPr>
-          <a:xfrm>
-            <a:off x="8211312" y="4864608"/>
+          <p:cNvPr id="36" name="Text 33"/>
+          <p:cNvSpPr/>
+          <p:nvPr/>
+        </p:nvSpPr>
+        <p:spPr>
+          <a:xfrm>
+            <a:off x="8211312" y="4151376"/>
             <a:ext cx="3291840" cy="274320"/>
           </a:xfrm>
           <a:prstGeom prst="rect">
@@ -13238,13 +13018,13 @@
       </p:sp>
       <p:sp>
         <p:nvSpPr>
-          <p:cNvPr id="43" name="Text 40"/>
-          <p:cNvSpPr/>
-          <p:nvPr/>
-        </p:nvSpPr>
-        <p:spPr>
-          <a:xfrm>
-            <a:off x="8211312" y="5138928"/>
+          <p:cNvPr id="37" name="Text 34"/>
+          <p:cNvSpPr/>
+          <p:nvPr/>
+        </p:nvSpPr>
+        <p:spPr>
+          <a:xfrm>
+            <a:off x="8211312" y="4425696"/>
             <a:ext cx="3291840" cy="256032"/>
           </a:xfrm>
           <a:prstGeom prst="rect">
@@ -13305,13 +13085,13 @@
       </p:sp>
       <p:sp>
         <p:nvSpPr>
-          <p:cNvPr id="44" name="Shape 41"/>
-          <p:cNvSpPr/>
-          <p:nvPr/>
-        </p:nvSpPr>
-        <p:spPr>
-          <a:xfrm>
-            <a:off x="7406640" y="5522976"/>
+          <p:cNvPr id="38" name="Shape 35"/>
+          <p:cNvSpPr/>
+          <p:nvPr/>
+        </p:nvSpPr>
+        <p:spPr>
+          <a:xfrm>
+            <a:off x="7406640" y="4809744"/>
             <a:ext cx="4206240" cy="640080"/>
           </a:xfrm>
           <a:prstGeom prst="rect">
@@ -13330,13 +13110,13 @@
       </p:sp>
       <p:sp>
         <p:nvSpPr>
-          <p:cNvPr id="45" name="Shape 42"/>
-          <p:cNvSpPr/>
-          <p:nvPr/>
-        </p:nvSpPr>
-        <p:spPr>
-          <a:xfrm>
-            <a:off x="7406640" y="5522976"/>
+          <p:cNvPr id="39" name="Shape 36"/>
+          <p:cNvSpPr/>
+          <p:nvPr/>
+        </p:nvSpPr>
+        <p:spPr>
+          <a:xfrm>
+            <a:off x="7406640" y="4809744"/>
             <a:ext cx="109728" cy="640080"/>
           </a:xfrm>
           <a:prstGeom prst="rect">
@@ -13355,13 +13135,13 @@
       </p:sp>
       <p:sp>
         <p:nvSpPr>
-          <p:cNvPr id="46" name="Shape 43"/>
-          <p:cNvSpPr/>
-          <p:nvPr/>
-        </p:nvSpPr>
-        <p:spPr>
-          <a:xfrm>
-            <a:off x="7571232" y="5614416"/>
+          <p:cNvPr id="40" name="Shape 37"/>
+          <p:cNvSpPr/>
+          <p:nvPr/>
+        </p:nvSpPr>
+        <p:spPr>
+          <a:xfrm>
+            <a:off x="7571232" y="4901184"/>
             <a:ext cx="548640" cy="256032"/>
           </a:xfrm>
           <a:prstGeom prst="rect">
@@ -13380,13 +13160,13 @@
       </p:sp>
       <p:sp>
         <p:nvSpPr>
-          <p:cNvPr id="47" name="Text 44"/>
-          <p:cNvSpPr/>
-          <p:nvPr/>
-        </p:nvSpPr>
-        <p:spPr>
-          <a:xfrm>
-            <a:off x="7571232" y="5614416"/>
+          <p:cNvPr id="41" name="Text 38"/>
+          <p:cNvSpPr/>
+          <p:nvPr/>
+        </p:nvSpPr>
+        <p:spPr>
+          <a:xfrm>
+            <a:off x="7571232" y="4901184"/>
             <a:ext cx="548640" cy="256032"/>
           </a:xfrm>
           <a:prstGeom prst="rect">
@@ -13419,13 +13199,13 @@
       </p:sp>
       <p:sp>
         <p:nvSpPr>
-          <p:cNvPr id="48" name="Text 45"/>
-          <p:cNvSpPr/>
-          <p:nvPr/>
-        </p:nvSpPr>
-        <p:spPr>
-          <a:xfrm>
-            <a:off x="8211312" y="5577840"/>
+          <p:cNvPr id="42" name="Text 39"/>
+          <p:cNvSpPr/>
+          <p:nvPr/>
+        </p:nvSpPr>
+        <p:spPr>
+          <a:xfrm>
+            <a:off x="8211312" y="4864608"/>
             <a:ext cx="3291840" cy="274320"/>
           </a:xfrm>
           <a:prstGeom prst="rect">
@@ -13458,13 +13238,13 @@
       </p:sp>
       <p:sp>
         <p:nvSpPr>
-          <p:cNvPr id="49" name="Text 46"/>
-          <p:cNvSpPr/>
-          <p:nvPr/>
-        </p:nvSpPr>
-        <p:spPr>
-          <a:xfrm>
-            <a:off x="8211312" y="5852160"/>
+          <p:cNvPr id="43" name="Text 40"/>
+          <p:cNvSpPr/>
+          <p:nvPr/>
+        </p:nvSpPr>
+        <p:spPr>
+          <a:xfrm>
+            <a:off x="8211312" y="5138928"/>
             <a:ext cx="3291840" cy="256032"/>
           </a:xfrm>
           <a:prstGeom prst="rect">
@@ -13525,14 +13305,167 @@
       </p:sp>
       <p:sp>
         <p:nvSpPr>
-          <p:cNvPr id="50" name="Text 47"/>
-          <p:cNvSpPr/>
-          <p:nvPr/>
-        </p:nvSpPr>
-        <p:spPr>
-          <a:xfrm>
-            <a:off x="548640" y="6492240"/>
-            <a:ext cx="7315200" cy="274320"/>
+          <p:cNvPr id="44" name="Shape 41"/>
+          <p:cNvSpPr/>
+          <p:nvPr/>
+        </p:nvSpPr>
+        <p:spPr>
+          <a:xfrm>
+            <a:off x="7406640" y="5522976"/>
+            <a:ext cx="4206240" cy="640080"/>
+          </a:xfrm>
+          <a:prstGeom prst="rect">
+            <a:avLst/>
+          </a:prstGeom>
+          <a:solidFill>
+            <a:srgbClr val="FFF5F5"/>
+          </a:solidFill>
+          <a:ln w="6350">
+            <a:solidFill>
+              <a:srgbClr val="E5E7EB"/>
+            </a:solidFill>
+            <a:prstDash val="solid"/>
+          </a:ln>
+        </p:spPr>
+      </p:sp>
+      <p:sp>
+        <p:nvSpPr>
+          <p:cNvPr id="45" name="Shape 42"/>
+          <p:cNvSpPr/>
+          <p:nvPr/>
+        </p:nvSpPr>
+        <p:spPr>
+          <a:xfrm>
+            <a:off x="7406640" y="5522976"/>
+            <a:ext cx="109728" cy="640080"/>
+          </a:xfrm>
+          <a:prstGeom prst="rect">
+            <a:avLst/>
+          </a:prstGeom>
+          <a:solidFill>
+            <a:srgbClr val="D72638"/>
+          </a:solidFill>
+          <a:ln w="12700">
+            <a:solidFill>
+              <a:srgbClr val="D72638"/>
+            </a:solidFill>
+            <a:prstDash val="solid"/>
+          </a:ln>
+        </p:spPr>
+      </p:sp>
+      <p:sp>
+        <p:nvSpPr>
+          <p:cNvPr id="46" name="Shape 43"/>
+          <p:cNvSpPr/>
+          <p:nvPr/>
+        </p:nvSpPr>
+        <p:spPr>
+          <a:xfrm>
+            <a:off x="7571232" y="5614416"/>
+            <a:ext cx="548640" cy="256032"/>
+          </a:xfrm>
+          <a:prstGeom prst="rect">
+            <a:avLst/>
+          </a:prstGeom>
+          <a:solidFill>
+            <a:srgbClr val="D72638"/>
+          </a:solidFill>
+          <a:ln w="12700">
+            <a:solidFill>
+              <a:srgbClr val="D72638"/>
+            </a:solidFill>
+            <a:prstDash val="solid"/>
+          </a:ln>
+        </p:spPr>
+      </p:sp>
+      <p:sp>
+        <p:nvSpPr>
+          <p:cNvPr id="47" name="Text 44"/>
+          <p:cNvSpPr/>
+          <p:nvPr/>
+        </p:nvSpPr>
+        <p:spPr>
+          <a:xfrm>
+            <a:off x="7571232" y="5614416"/>
+            <a:ext cx="548640" cy="256032"/>
+          </a:xfrm>
+          <a:prstGeom prst="rect">
+            <a:avLst/>
+          </a:prstGeom>
+          <a:noFill/>
+          <a:ln/>
+        </p:spPr>
+        <p:txBody>
+          <a:bodyPr wrap="square" lIns="0" tIns="0" rIns="0" bIns="0" rtlCol="0" anchor="ctr"/>
+          <a:lstStyle/>
+          <a:p>
+            <a:pPr algn="ctr" indent="0" marL="0">
+              <a:buNone/>
+            </a:pPr>
+            <a:r>
+              <a:rPr lang="en-US" sz="900" b="1" dirty="0">
+                <a:solidFill>
+                  <a:srgbClr val="FFFFFF"/>
+                </a:solidFill>
+                <a:latin typeface="맑은 고딕" pitchFamily="34" charset="0"/>
+                <a:ea typeface="맑은 고딕" pitchFamily="34" charset="-122"/>
+                <a:cs typeface="맑은 고딕" pitchFamily="34" charset="-120"/>
+              </a:rPr>
+              <a:t>긴급</a:t>
+            </a:r>
+            <a:endParaRPr lang="en-US" sz="900" dirty="0"/>
+          </a:p>
+        </p:txBody>
+      </p:sp>
+      <p:sp>
+        <p:nvSpPr>
+          <p:cNvPr id="48" name="Text 45"/>
+          <p:cNvSpPr/>
+          <p:nvPr/>
+        </p:nvSpPr>
+        <p:spPr>
+          <a:xfrm>
+            <a:off x="8211312" y="5577840"/>
+            <a:ext cx="3291840" cy="274320"/>
+          </a:xfrm>
+          <a:prstGeom prst="rect">
+            <a:avLst/>
+          </a:prstGeom>
+          <a:noFill/>
+          <a:ln/>
+        </p:spPr>
+        <p:txBody>
+          <a:bodyPr wrap="square" lIns="0" tIns="0" rIns="0" bIns="0" rtlCol="0" anchor="ctr"/>
+          <a:lstStyle/>
+          <a:p>
+            <a:pPr indent="0" marL="0">
+              <a:buNone/>
+            </a:pPr>
+            <a:r>
+              <a:rPr lang="en-US" sz="1000" b="1" dirty="0">
+                <a:solidFill>
+                  <a:srgbClr val="0B1220"/>
+                </a:solidFill>
+                <a:latin typeface="맑은 고딕" pitchFamily="34" charset="0"/>
+                <a:ea typeface="맑은 고딕" pitchFamily="34" charset="-122"/>
+                <a:cs typeface="맑은 고딕" pitchFamily="34" charset="-120"/>
+              </a:rPr>
+              <a:t>Light UV 99.9 Umbrella (7color)</a:t>
+            </a:r>
+            <a:endParaRPr lang="en-US" sz="1000" dirty="0"/>
+          </a:p>
+        </p:txBody>
+      </p:sp>
+      <p:sp>
+        <p:nvSpPr>
+          <p:cNvPr id="49" name="Text 46"/>
+          <p:cNvSpPr/>
+          <p:nvPr/>
+        </p:nvSpPr>
+        <p:spPr>
+          <a:xfrm>
+            <a:off x="8211312" y="5852160"/>
+            <a:ext cx="3291840" cy="256032"/>
           </a:xfrm>
           <a:prstGeom prst="rect">
             <a:avLst/>
@@ -13556,7 +13489,74 @@
                 <a:ea typeface="맑은 고딕" pitchFamily="34" charset="-122"/>
                 <a:cs typeface="맑은 고딕" pitchFamily="34" charset="-120"/>
               </a:rPr>
-              <a:t>베스트 상품 리포트  ·  생성 2026-05-18 08:00</a:t>
+              <a:t>컬러: 블랙  ·  재고 0개</a:t>
+            </a:r>
+            <a:pPr indent="0" marL="0">
+              <a:buNone/>
+            </a:pPr>
+            <a:r>
+              <a:rPr lang="en-US" sz="1000" dirty="0">
+                <a:solidFill>
+                  <a:srgbClr val="6B7280"/>
+                </a:solidFill>
+                <a:latin typeface="맑은 고딕" pitchFamily="34" charset="0"/>
+                <a:ea typeface="맑은 고딕" pitchFamily="34" charset="-122"/>
+                <a:cs typeface="맑은 고딕" pitchFamily="34" charset="-120"/>
+              </a:rPr>
+              <a:t/>
+            </a:r>
+            <a:pPr indent="0" marL="0">
+              <a:buNone/>
+            </a:pPr>
+            <a:r>
+              <a:rPr lang="en-US" sz="1000" b="1" dirty="0">
+                <a:solidFill>
+                  <a:srgbClr val="D72638"/>
+                </a:solidFill>
+                <a:latin typeface="맑은 고딕" pitchFamily="34" charset="0"/>
+                <a:ea typeface="맑은 고딕" pitchFamily="34" charset="-122"/>
+                <a:cs typeface="맑은 고딕" pitchFamily="34" charset="-120"/>
+              </a:rPr>
+              <a:t/>
+            </a:r>
+            <a:endParaRPr lang="en-US" sz="900" dirty="0"/>
+          </a:p>
+        </p:txBody>
+      </p:sp>
+      <p:sp>
+        <p:nvSpPr>
+          <p:cNvPr id="50" name="Text 47"/>
+          <p:cNvSpPr/>
+          <p:nvPr/>
+        </p:nvSpPr>
+        <p:spPr>
+          <a:xfrm>
+            <a:off x="548640" y="6492240"/>
+            <a:ext cx="7315200" cy="274320"/>
+          </a:xfrm>
+          <a:prstGeom prst="rect">
+            <a:avLst/>
+          </a:prstGeom>
+          <a:noFill/>
+          <a:ln/>
+        </p:spPr>
+        <p:txBody>
+          <a:bodyPr wrap="square" lIns="0" tIns="0" rIns="0" bIns="0" rtlCol="0" anchor="ctr"/>
+          <a:lstStyle/>
+          <a:p>
+            <a:pPr indent="0" marL="0">
+              <a:buNone/>
+            </a:pPr>
+            <a:r>
+              <a:rPr lang="en-US" sz="900" dirty="0">
+                <a:solidFill>
+                  <a:srgbClr val="6B7280"/>
+                </a:solidFill>
+                <a:latin typeface="맑은 고딕" pitchFamily="34" charset="0"/>
+                <a:ea typeface="맑은 고딕" pitchFamily="34" charset="-122"/>
+                <a:cs typeface="맑은 고딕" pitchFamily="34" charset="-120"/>
+              </a:rPr>
+              <a:t>베스트 상품 리포트  ·  생성 2026-05-19 08:00</a:t>
             </a:r>
             <a:endParaRPr lang="en-US" sz="900" dirty="0"/>
           </a:p>
@@ -13769,7 +13769,7 @@
                 <a:ea typeface="맑은 고딕" pitchFamily="34" charset="-122"/>
                 <a:cs typeface="맑은 고딕" pitchFamily="34" charset="-120"/>
               </a:rPr>
-              <a:t>2026년 05월 18일 (월)</a:t>
+              <a:t>2026년 05월 19일 (화)</a:t>
             </a:r>
             <a:endParaRPr lang="en-US" sz="1200" dirty="0"/>
           </a:p>
@@ -13897,7 +13897,7 @@
                 <a:ea typeface="맑은 고딕" pitchFamily="34" charset="-122"/>
                 <a:cs typeface="맑은 고딕" pitchFamily="34" charset="-120"/>
               </a:rPr>
-              <a:t>🚨  긴급 리오더 64건    ·    주의 리오더 12건    ·    오늘 발주 검토 필수</a:t>
+              <a:t>🚨  긴급 리오더 65건    ·    주의 리오더 10건    ·    오늘 발주 검토 필수</a:t>
             </a:r>
             <a:pPr indent="0" marL="0">
               <a:buNone/>
@@ -14595,7 +14595,7 @@
                           <a:ea typeface="맑은 고딕" pitchFamily="34" charset="-122"/>
                           <a:cs typeface="맑은 고딕" pitchFamily="34" charset="-120"/>
                         </a:rPr>
-                        <a:t>Ring</a:t>
+                        <a:t>Bracelet</a:t>
                       </a:r>
                       <a:endParaRPr lang="en-US" sz="1000" dirty="0">
                         <a:latin typeface="맑은 고딕" charset="0"/>
@@ -14663,7 +14663,7 @@
                           <a:ea typeface="맑은 고딕" pitchFamily="34" charset="-122"/>
                           <a:cs typeface="맑은 고딕" pitchFamily="34" charset="-120"/>
                         </a:rPr>
-                        <a:t>[SILVER925] Azure Open Ring</a:t>
+                        <a:t>Two-ball Bangle</a:t>
                       </a:r>
                       <a:endParaRPr lang="en-US" sz="1100" dirty="0">
                         <a:latin typeface="맑은 고딕" charset="0"/>
@@ -14731,7 +14731,7 @@
                           <a:ea typeface="맑은 고딕" pitchFamily="34" charset="-122"/>
                           <a:cs typeface="맑은 고딕" pitchFamily="34" charset="-120"/>
                         </a:rPr>
-                        <a:t>2</a:t>
+                        <a:t>0</a:t>
                       </a:r>
                       <a:endParaRPr lang="en-US" sz="1100" dirty="0">
                         <a:latin typeface="맑은 고딕" charset="0"/>
@@ -14799,7 +14799,7 @@
                           <a:ea typeface="맑은 고딕" pitchFamily="34" charset="-122"/>
                           <a:cs typeface="맑은 고딕" pitchFamily="34" charset="-120"/>
                         </a:rPr>
-                        <a:t>6 개</a:t>
+                        <a:t>5 개</a:t>
                       </a:r>
                       <a:endParaRPr lang="en-US" sz="1100" dirty="0">
                         <a:latin typeface="맑은 고딕" charset="0"/>
@@ -15141,7 +15141,7 @@
                           <a:ea typeface="맑은 고딕" pitchFamily="34" charset="-122"/>
                           <a:cs typeface="맑은 고딕" pitchFamily="34" charset="-120"/>
                         </a:rPr>
-                        <a:t>5</a:t>
+                        <a:t>0</a:t>
                       </a:r>
                       <a:endParaRPr lang="en-US" sz="1100" dirty="0">
                         <a:latin typeface="맑은 고딕" charset="0"/>
@@ -15483,7 +15483,7 @@
                           <a:ea typeface="맑은 고딕" pitchFamily="34" charset="-122"/>
                           <a:cs typeface="맑은 고딕" pitchFamily="34" charset="-120"/>
                         </a:rPr>
-                        <a:t>"Bloometal" 925 Open Ring</a:t>
+                        <a:t>"Giethoorn" 925 Open Ring</a:t>
                       </a:r>
                       <a:endParaRPr lang="en-US" sz="1100" dirty="0">
                         <a:latin typeface="맑은 고딕" charset="0"/>
@@ -15551,7 +15551,7 @@
                           <a:ea typeface="맑은 고딕" pitchFamily="34" charset="-122"/>
                           <a:cs typeface="맑은 고딕" pitchFamily="34" charset="-120"/>
                         </a:rPr>
-                        <a:t>3</a:t>
+                        <a:t>2</a:t>
                       </a:r>
                       <a:endParaRPr lang="en-US" sz="1100" dirty="0">
                         <a:latin typeface="맑은 고딕" charset="0"/>
@@ -15619,7 +15619,7 @@
                           <a:ea typeface="맑은 고딕" pitchFamily="34" charset="-122"/>
                           <a:cs typeface="맑은 고딕" pitchFamily="34" charset="-120"/>
                         </a:rPr>
-                        <a:t>2 개</a:t>
+                        <a:t>3 개</a:t>
                       </a:r>
                       <a:endParaRPr lang="en-US" sz="1100" dirty="0">
                         <a:latin typeface="맑은 고딕" charset="0"/>
@@ -15757,7 +15757,7 @@
                           <a:ea typeface="맑은 고딕" pitchFamily="34" charset="-122"/>
                           <a:cs typeface="맑은 고딕" pitchFamily="34" charset="-120"/>
                         </a:rPr>
-                        <a:t>PR</a:t>
+                        <a:t>6A</a:t>
                       </a:r>
                       <a:endParaRPr lang="en-US" sz="1100" dirty="0">
                         <a:latin typeface="맑은 고딕" charset="0"/>
@@ -15825,7 +15825,7 @@
                           <a:ea typeface="맑은 고딕" pitchFamily="34" charset="-122"/>
                           <a:cs typeface="맑은 고딕" pitchFamily="34" charset="-120"/>
                         </a:rPr>
-                        <a:t>ETC</a:t>
+                        <a:t>Ring</a:t>
                       </a:r>
                       <a:endParaRPr lang="en-US" sz="1000" dirty="0">
                         <a:latin typeface="맑은 고딕" charset="0"/>
@@ -15893,7 +15893,7 @@
                           <a:ea typeface="맑은 고딕" pitchFamily="34" charset="-122"/>
                           <a:cs typeface="맑은 고딕" pitchFamily="34" charset="-120"/>
                         </a:rPr>
-                        <a:t>360° Rotating Phone Holder (컬러: 블랙)</a:t>
+                        <a:t>[SILVER925] Azure Open Ring</a:t>
                       </a:r>
                       <a:endParaRPr lang="en-US" sz="1100" dirty="0">
                         <a:latin typeface="맑은 고딕" charset="0"/>
@@ -15961,7 +15961,7 @@
                           <a:ea typeface="맑은 고딕" pitchFamily="34" charset="-122"/>
                           <a:cs typeface="맑은 고딕" pitchFamily="34" charset="-120"/>
                         </a:rPr>
-                        <a:t>17</a:t>
+                        <a:t>1</a:t>
                       </a:r>
                       <a:endParaRPr lang="en-US" sz="1100" dirty="0">
                         <a:latin typeface="맑은 고딕" charset="0"/>
@@ -16029,7 +16029,7 @@
                           <a:ea typeface="맑은 고딕" pitchFamily="34" charset="-122"/>
                           <a:cs typeface="맑은 고딕" pitchFamily="34" charset="-120"/>
                         </a:rPr>
-                        <a:t>2 개</a:t>
+                        <a:t>1 개</a:t>
                       </a:r>
                       <a:endParaRPr lang="en-US" sz="1100" dirty="0">
                         <a:latin typeface="맑은 고딕" charset="0"/>
@@ -16167,7 +16167,7 @@
                           <a:ea typeface="맑은 고딕" pitchFamily="34" charset="-122"/>
                           <a:cs typeface="맑은 고딕" pitchFamily="34" charset="-120"/>
                         </a:rPr>
-                        <a:t>6A</a:t>
+                        <a:t>PR</a:t>
                       </a:r>
                       <a:endParaRPr lang="en-US" sz="1100" dirty="0">
                         <a:latin typeface="맑은 고딕" charset="0"/>
@@ -16235,7 +16235,7 @@
                           <a:ea typeface="맑은 고딕" pitchFamily="34" charset="-122"/>
                           <a:cs typeface="맑은 고딕" pitchFamily="34" charset="-120"/>
                         </a:rPr>
-                        <a:t>Bracelet</a:t>
+                        <a:t>★ Last Sale ★</a:t>
                       </a:r>
                       <a:endParaRPr lang="en-US" sz="1000" dirty="0">
                         <a:latin typeface="맑은 고딕" charset="0"/>
@@ -16303,7 +16303,7 @@
                           <a:ea typeface="맑은 고딕" pitchFamily="34" charset="-122"/>
                           <a:cs typeface="맑은 고딕" pitchFamily="34" charset="-120"/>
                         </a:rPr>
-                        <a:t>Two-ball Bangle</a:t>
+                        <a:t>Cloud Grip Glass Mini Brush (3color) (컬러: 스카이블루)</a:t>
                       </a:r>
                       <a:endParaRPr lang="en-US" sz="1100" dirty="0">
                         <a:latin typeface="맑은 고딕" charset="0"/>
@@ -16371,7 +16371,7 @@
                           <a:ea typeface="맑은 고딕" pitchFamily="34" charset="-122"/>
                           <a:cs typeface="맑은 고딕" pitchFamily="34" charset="-120"/>
                         </a:rPr>
-                        <a:t>5</a:t>
+                        <a:t>19</a:t>
                       </a:r>
                       <a:endParaRPr lang="en-US" sz="1100" dirty="0">
                         <a:latin typeface="맑은 고딕" charset="0"/>
@@ -16577,7 +16577,7 @@
                           <a:ea typeface="맑은 고딕" pitchFamily="34" charset="-122"/>
                           <a:cs typeface="맑은 고딕" pitchFamily="34" charset="-120"/>
                         </a:rPr>
-                        <a:t>CT</a:t>
+                        <a:t>PR</a:t>
                       </a:r>
                       <a:endParaRPr lang="en-US" sz="1100" dirty="0">
                         <a:latin typeface="맑은 고딕" charset="0"/>
@@ -16645,7 +16645,7 @@
                           <a:ea typeface="맑은 고딕" pitchFamily="34" charset="-122"/>
                           <a:cs typeface="맑은 고딕" pitchFamily="34" charset="-120"/>
                         </a:rPr>
-                        <a:t>Ring</a:t>
+                        <a:t>ETC</a:t>
                       </a:r>
                       <a:endParaRPr lang="en-US" sz="1000" dirty="0">
                         <a:latin typeface="맑은 고딕" charset="0"/>
@@ -16713,7 +16713,7 @@
                           <a:ea typeface="맑은 고딕" pitchFamily="34" charset="-122"/>
                           <a:cs typeface="맑은 고딕" pitchFamily="34" charset="-120"/>
                         </a:rPr>
-                        <a:t>"Giethoorn" 925 Open Ring</a:t>
+                        <a:t>Padded Color Pouch (4color) (컬러: 오렌지)</a:t>
                       </a:r>
                       <a:endParaRPr lang="en-US" sz="1100" dirty="0">
                         <a:latin typeface="맑은 고딕" charset="0"/>
@@ -16781,7 +16781,7 @@
                           <a:ea typeface="맑은 고딕" pitchFamily="34" charset="-122"/>
                           <a:cs typeface="맑은 고딕" pitchFamily="34" charset="-120"/>
                         </a:rPr>
-                        <a:t>5</a:t>
+                        <a:t>20</a:t>
                       </a:r>
                       <a:endParaRPr lang="en-US" sz="1100" dirty="0">
                         <a:latin typeface="맑은 고딕" charset="0"/>
@@ -16987,7 +16987,7 @@
                           <a:ea typeface="맑은 고딕" pitchFamily="34" charset="-122"/>
                           <a:cs typeface="맑은 고딕" pitchFamily="34" charset="-120"/>
                         </a:rPr>
-                        <a:t>CT</a:t>
+                        <a:t>PR</a:t>
                       </a:r>
                       <a:endParaRPr lang="en-US" sz="1100" dirty="0">
                         <a:latin typeface="맑은 고딕" charset="0"/>
@@ -17055,7 +17055,7 @@
                           <a:ea typeface="맑은 고딕" pitchFamily="34" charset="-122"/>
                           <a:cs typeface="맑은 고딕" pitchFamily="34" charset="-120"/>
                         </a:rPr>
-                        <a:t>Ring</a:t>
+                        <a:t>ELECTRONIC</a:t>
                       </a:r>
                       <a:endParaRPr lang="en-US" sz="1000" dirty="0">
                         <a:latin typeface="맑은 고딕" charset="0"/>
@@ -17123,7 +17123,7 @@
                           <a:ea typeface="맑은 고딕" pitchFamily="34" charset="-122"/>
                           <a:cs typeface="맑은 고딕" pitchFamily="34" charset="-120"/>
                         </a:rPr>
-                        <a:t>"Whisow" 925 Open Ring</a:t>
+                        <a:t>Jacquard Fast Charging Cable (7color) (컬러: 퍼플 / 기종옵션: C-Apple 8pin / 길이: 2m)</a:t>
                       </a:r>
                       <a:endParaRPr lang="en-US" sz="1100" dirty="0">
                         <a:latin typeface="맑은 고딕" charset="0"/>
@@ -17191,7 +17191,7 @@
                           <a:ea typeface="맑은 고딕" pitchFamily="34" charset="-122"/>
                           <a:cs typeface="맑은 고딕" pitchFamily="34" charset="-120"/>
                         </a:rPr>
-                        <a:t>0</a:t>
+                        <a:t>13</a:t>
                       </a:r>
                       <a:endParaRPr lang="en-US" sz="1100" dirty="0">
                         <a:latin typeface="맑은 고딕" charset="0"/>
@@ -17397,7 +17397,7 @@
                           <a:ea typeface="맑은 고딕" pitchFamily="34" charset="-122"/>
                           <a:cs typeface="맑은 고딕" pitchFamily="34" charset="-120"/>
                         </a:rPr>
-                        <a:t>PR</a:t>
+                        <a:t>6A</a:t>
                       </a:r>
                       <a:endParaRPr lang="en-US" sz="1100" dirty="0">
                         <a:latin typeface="맑은 고딕" charset="0"/>
@@ -17465,7 +17465,7 @@
                           <a:ea typeface="맑은 고딕" pitchFamily="34" charset="-122"/>
                           <a:cs typeface="맑은 고딕" pitchFamily="34" charset="-120"/>
                         </a:rPr>
-                        <a:t>★ Last Sale ★</a:t>
+                        <a:t>Necklace</a:t>
                       </a:r>
                       <a:endParaRPr lang="en-US" sz="1000" dirty="0">
                         <a:latin typeface="맑은 고딕" charset="0"/>
@@ -17533,7 +17533,7 @@
                           <a:ea typeface="맑은 고딕" pitchFamily="34" charset="-122"/>
                           <a:cs typeface="맑은 고딕" pitchFamily="34" charset="-120"/>
                         </a:rPr>
-                        <a:t>Cloud Grip Glass Mini Brush (3color) (컬러: 스카이블루)</a:t>
+                        <a:t>B-Flower Necklace (Size: 2 Size)</a:t>
                       </a:r>
                       <a:endParaRPr lang="en-US" sz="1100" dirty="0">
                         <a:latin typeface="맑은 고딕" charset="0"/>
@@ -17601,7 +17601,7 @@
                           <a:ea typeface="맑은 고딕" pitchFamily="34" charset="-122"/>
                           <a:cs typeface="맑은 고딕" pitchFamily="34" charset="-120"/>
                         </a:rPr>
-                        <a:t>20</a:t>
+                        <a:t>5</a:t>
                       </a:r>
                       <a:endParaRPr lang="en-US" sz="1100" dirty="0">
                         <a:latin typeface="맑은 고딕" charset="0"/>
@@ -17669,7 +17669,7 @@
                           <a:ea typeface="맑은 고딕" pitchFamily="34" charset="-122"/>
                           <a:cs typeface="맑은 고딕" pitchFamily="34" charset="-120"/>
                         </a:rPr>
-                        <a:t>1 개</a:t>
+                        <a:t>0 개</a:t>
                       </a:r>
                       <a:endParaRPr lang="en-US" sz="1100" dirty="0">
                         <a:latin typeface="맑은 고딕" charset="0"/>
@@ -17807,7 +17807,7 @@
                           <a:ea typeface="맑은 고딕" pitchFamily="34" charset="-122"/>
                           <a:cs typeface="맑은 고딕" pitchFamily="34" charset="-120"/>
                         </a:rPr>
-                        <a:t>PR</a:t>
+                        <a:t>6A</a:t>
                       </a:r>
                       <a:endParaRPr lang="en-US" sz="1100" dirty="0">
                         <a:latin typeface="맑은 고딕" charset="0"/>
@@ -17875,7 +17875,7 @@
                           <a:ea typeface="맑은 고딕" pitchFamily="34" charset="-122"/>
                           <a:cs typeface="맑은 고딕" pitchFamily="34" charset="-120"/>
                         </a:rPr>
-                        <a:t>ETC</a:t>
+                        <a:t>★Season off★</a:t>
                       </a:r>
                       <a:endParaRPr lang="en-US" sz="1000" dirty="0">
                         <a:latin typeface="맑은 고딕" charset="0"/>
@@ -17943,7 +17943,7 @@
                           <a:ea typeface="맑은 고딕" pitchFamily="34" charset="-122"/>
                           <a:cs typeface="맑은 고딕" pitchFamily="34" charset="-120"/>
                         </a:rPr>
-                        <a:t>Fuzzy Stripe Slippers (3color) (컬러: 핑크 / 사이즈: 240~250(여성))</a:t>
+                        <a:t>8-Ball Smart Tok</a:t>
                       </a:r>
                       <a:endParaRPr lang="en-US" sz="1100" dirty="0">
                         <a:latin typeface="맑은 고딕" charset="0"/>
@@ -18011,7 +18011,7 @@
                           <a:ea typeface="맑은 고딕" pitchFamily="34" charset="-122"/>
                           <a:cs typeface="맑은 고딕" pitchFamily="34" charset="-120"/>
                         </a:rPr>
-                        <a:t>2</a:t>
+                        <a:t>5</a:t>
                       </a:r>
                       <a:endParaRPr lang="en-US" sz="1100" dirty="0">
                         <a:latin typeface="맑은 고딕" charset="0"/>
@@ -18079,7 +18079,7 @@
                           <a:ea typeface="맑은 고딕" pitchFamily="34" charset="-122"/>
                           <a:cs typeface="맑은 고딕" pitchFamily="34" charset="-120"/>
                         </a:rPr>
-                        <a:t>1 개</a:t>
+                        <a:t>0 개</a:t>
                       </a:r>
                       <a:endParaRPr lang="en-US" sz="1100" dirty="0">
                         <a:latin typeface="맑은 고딕" charset="0"/>
@@ -18168,7 +18168,7 @@
                 <a:ea typeface="맑은 고딕" pitchFamily="34" charset="-122"/>
                 <a:cs typeface="맑은 고딕" pitchFamily="34" charset="-120"/>
               </a:rPr>
-              <a:t>외 55건 더 있음 — 상세는 시트에서 확인</a:t>
+              <a:t>외 56건 더 있음 — 상세는 시트에서 확인</a:t>
             </a:r>
             <a:endParaRPr lang="en-US" sz="1000" dirty="0"/>
           </a:p>
@@ -18207,7 +18207,7 @@
                 <a:ea typeface="맑은 고딕" pitchFamily="34" charset="-122"/>
                 <a:cs typeface="맑은 고딕" pitchFamily="34" charset="-120"/>
               </a:rPr>
-              <a:t>베스트 상품 리포트  ·  생성 2026-05-18 08:00</a:t>
+              <a:t>베스트 상품 리포트  ·  생성 2026-05-19 08:00</a:t>
             </a:r>
             <a:endParaRPr lang="en-US" sz="900" dirty="0"/>
           </a:p>
@@ -18420,7 +18420,7 @@
                 <a:ea typeface="맑은 고딕" pitchFamily="34" charset="-122"/>
                 <a:cs typeface="맑은 고딕" pitchFamily="34" charset="-120"/>
               </a:rPr>
-              <a:t>2026년 05월 18일 (월)</a:t>
+              <a:t>2026년 05월 19일 (화)</a:t>
             </a:r>
             <a:endParaRPr lang="en-US" sz="1200" dirty="0"/>
           </a:p>
@@ -18587,7 +18587,7 @@
                 <a:ea typeface="맑은 고딕" pitchFamily="34" charset="-122"/>
                 <a:cs typeface="맑은 고딕" pitchFamily="34" charset="-120"/>
               </a:rPr>
-              <a:t>Google Sheet '브랜드 재고현황'  ·  최신화 2026-05-18 08:00</a:t>
+              <a:t>Google Sheet '브랜드 재고현황'  ·  최신화 2026-05-19 08:00</a:t>
             </a:r>
             <a:endParaRPr lang="en-US" sz="1100" dirty="0"/>
           </a:p>
@@ -19099,7 +19099,7 @@
                 <a:ea typeface="맑은 고딕" pitchFamily="34" charset="-122"/>
                 <a:cs typeface="맑은 고딕" pitchFamily="34" charset="-120"/>
               </a:rPr>
-              <a:t>✅ 6A 86 SKU  /  ✅ Cleartype 59 SKU  /  ✅ Produktepr 192 SKU (판매 수집됨)</a:t>
+              <a:t>✅ 6A 87 SKU  /  ✅ Cleartype 59 SKU  /  ✅ Produktepr 192 SKU (판매 수집됨)</a:t>
             </a:r>
             <a:endParaRPr lang="en-US" sz="1100" dirty="0"/>
           </a:p>
@@ -19230,7 +19230,7 @@
                 <a:ea typeface="맑은 고딕" pitchFamily="34" charset="-122"/>
                 <a:cs typeface="맑은 고딕" pitchFamily="34" charset="-120"/>
               </a:rPr>
-              <a:t>✅ 3개 브랜드 모두 정상 추출  ·  24h 출고 기준 (2026-05-17 08:00 → 2026-05-18 08:00) · 신규 SKU 12건은 결제완료 기준</a:t>
+              <a:t>✅ 3개 브랜드 모두 정상 추출  ·  24h 출고 기준 (2026-05-18 08:00 → 2026-05-19 08:00) · 신규 SKU 13건은 결제완료 기준</a:t>
             </a:r>
             <a:endParaRPr lang="en-US" sz="1000" dirty="0"/>
           </a:p>
@@ -19269,7 +19269,7 @@
                 <a:ea typeface="맑은 고딕" pitchFamily="34" charset="-122"/>
                 <a:cs typeface="맑은 고딕" pitchFamily="34" charset="-120"/>
               </a:rPr>
-              <a:t>베스트 상품 리포트  ·  생성 2026-05-18 08:00</a:t>
+              <a:t>베스트 상품 리포트  ·  생성 2026-05-19 08:00</a:t>
             </a:r>
             <a:endParaRPr lang="en-US" sz="900" dirty="0"/>
           </a:p>

</xml_diff>

<commit_message>
chore: 매출 PPT 업로드 (best-sellers-2026-05-19.pptx)
</commit_message>
<xml_diff>
--- a/data/sales-report.pptx
+++ b/data/sales-report.pptx
@@ -1648,7 +1648,7 @@
                 <a:ea typeface="맑은 고딕" pitchFamily="34" charset="-122"/>
                 <a:cs typeface="맑은 고딕" pitchFamily="34" charset="-120"/>
               </a:rPr>
-              <a:t>2026년 05월 19일 (화)  ·  24h 출고 기준</a:t>
+              <a:t>2026년 5월 19일 (화)  ·  실시간 누적</a:t>
             </a:r>
             <a:endParaRPr lang="en-US" sz="2200" dirty="0"/>
           </a:p>
@@ -1804,7 +1804,7 @@
                 <a:ea typeface="맑은 고딕" pitchFamily="34" charset="-122"/>
                 <a:cs typeface="맑은 고딕" pitchFamily="34" charset="-120"/>
               </a:rPr>
-              <a:t>생성 2026-05-19 08:00  ·  Google Sheet 자동 동기</a:t>
+              <a:t>생성 2026-05-19 12:14  ·  Google Sheet 자동 동기</a:t>
             </a:r>
             <a:endParaRPr lang="en-US" sz="1000" dirty="0"/>
           </a:p>
@@ -1978,7 +1978,7 @@
                 <a:ea typeface="맑은 고딕" pitchFamily="34" charset="-122"/>
                 <a:cs typeface="맑은 고딕" pitchFamily="34" charset="-120"/>
               </a:rPr>
-              <a:t>2026년 05월 19일 (화)</a:t>
+              <a:t>2026년 5월 19일 (화)</a:t>
             </a:r>
             <a:endParaRPr lang="en-US" sz="1200" dirty="0"/>
           </a:p>
@@ -2145,7 +2145,7 @@
                 <a:ea typeface="맑은 고딕" pitchFamily="34" charset="-122"/>
                 <a:cs typeface="맑은 고딕" pitchFamily="34" charset="-120"/>
               </a:rPr>
-              <a:t>348 개</a:t>
+              <a:t>333 개</a:t>
             </a:r>
             <a:endParaRPr lang="en-US" sz="3600" dirty="0"/>
           </a:p>
@@ -2479,7 +2479,7 @@
                 <a:ea typeface="맑은 고딕" pitchFamily="34" charset="-122"/>
                 <a:cs typeface="맑은 고딕" pitchFamily="34" charset="-120"/>
               </a:rPr>
-              <a:t>10 건</a:t>
+              <a:t>0 건</a:t>
             </a:r>
             <a:endParaRPr lang="en-US" sz="3200" dirty="0"/>
           </a:p>
@@ -2969,7 +2969,7 @@
                 <a:ea typeface="맑은 고딕" pitchFamily="34" charset="-122"/>
                 <a:cs typeface="맑은 고딕" pitchFamily="34" charset="-120"/>
               </a:rPr>
-              <a:t>192 SKU  ·  판매 데이터 있음</a:t>
+              <a:t>192 SKU  ·  판매 OK</a:t>
             </a:r>
             <a:pPr indent="0" marL="0">
               <a:buNone/>
@@ -3482,7 +3482,7 @@
                           <a:ea typeface="맑은 고딕" pitchFamily="34" charset="-122"/>
                           <a:cs typeface="맑은 고딕" pitchFamily="34" charset="-120"/>
                         </a:rPr>
-                        <a:t>6A</a:t>
+                        <a:t>[SILVER925] CH.alban Open Ring</a:t>
                       </a:r>
                       <a:endParaRPr lang="en-US" sz="1100" dirty="0">
                         <a:latin typeface="맑은 고딕" charset="0"/>
@@ -3547,7 +3547,7 @@
                           <a:ea typeface="맑은 고딕" pitchFamily="34" charset="-122"/>
                           <a:cs typeface="맑은 고딕" pitchFamily="34" charset="-120"/>
                         </a:rPr>
-                        <a:t>Ring</a:t>
+                        <a:t>6A</a:t>
                       </a:r>
                       <a:endParaRPr lang="en-US" sz="1000" dirty="0">
                         <a:latin typeface="맑은 고딕" charset="0"/>
@@ -3612,7 +3612,7 @@
                           <a:ea typeface="맑은 고딕" pitchFamily="34" charset="-122"/>
                           <a:cs typeface="맑은 고딕" pitchFamily="34" charset="-120"/>
                         </a:rPr>
-                        <a:t>[SILVER925] CH.alban Open Ring</a:t>
+                        <a:t>Ring</a:t>
                       </a:r>
                       <a:endParaRPr lang="en-US" sz="1100" dirty="0">
                         <a:latin typeface="맑은 고딕" charset="0"/>
@@ -3677,7 +3677,7 @@
                           <a:ea typeface="맑은 고딕" pitchFamily="34" charset="-122"/>
                           <a:cs typeface="맑은 고딕" pitchFamily="34" charset="-120"/>
                         </a:rPr>
-                        <a:t>47 개</a:t>
+                        <a:t>42 개</a:t>
                       </a:r>
                       <a:endParaRPr lang="en-US" sz="1400" dirty="0">
                         <a:latin typeface="맑은 고딕" charset="0"/>
@@ -3809,7 +3809,7 @@
                           <a:ea typeface="맑은 고딕" pitchFamily="34" charset="-122"/>
                           <a:cs typeface="맑은 고딕" pitchFamily="34" charset="-120"/>
                         </a:rPr>
-                        <a:t>CT</a:t>
+                        <a:t>CandyPOP Necklace (사이즈: 1size (41.5~47cm))</a:t>
                       </a:r>
                       <a:endParaRPr lang="en-US" sz="1100" dirty="0">
                         <a:latin typeface="맑은 고딕" charset="0"/>
@@ -3874,7 +3874,7 @@
                           <a:ea typeface="맑은 고딕" pitchFamily="34" charset="-122"/>
                           <a:cs typeface="맑은 고딕" pitchFamily="34" charset="-120"/>
                         </a:rPr>
-                        <a:t>Necklace</a:t>
+                        <a:t>CT</a:t>
                       </a:r>
                       <a:endParaRPr lang="en-US" sz="1000" dirty="0">
                         <a:latin typeface="맑은 고딕" charset="0"/>
@@ -3939,7 +3939,7 @@
                           <a:ea typeface="맑은 고딕" pitchFamily="34" charset="-122"/>
                           <a:cs typeface="맑은 고딕" pitchFamily="34" charset="-120"/>
                         </a:rPr>
-                        <a:t>CandyPOP Necklace (사이즈: 1size (41.5~47cm))</a:t>
+                        <a:t>Necklace</a:t>
                       </a:r>
                       <a:endParaRPr lang="en-US" sz="1100" dirty="0">
                         <a:latin typeface="맑은 고딕" charset="0"/>
@@ -4004,7 +4004,7 @@
                           <a:ea typeface="맑은 고딕" pitchFamily="34" charset="-122"/>
                           <a:cs typeface="맑은 고딕" pitchFamily="34" charset="-120"/>
                         </a:rPr>
-                        <a:t>46 개</a:t>
+                        <a:t>42 개</a:t>
                       </a:r>
                       <a:endParaRPr lang="en-US" sz="1400" dirty="0">
                         <a:latin typeface="맑은 고딕" charset="0"/>
@@ -4136,7 +4136,7 @@
                           <a:ea typeface="맑은 고딕" pitchFamily="34" charset="-122"/>
                           <a:cs typeface="맑은 고딕" pitchFamily="34" charset="-120"/>
                         </a:rPr>
-                        <a:t>6A</a:t>
+                        <a:t>[SILVER925] Guyeong Open Ring v3.0 (silver)</a:t>
                       </a:r>
                       <a:endParaRPr lang="en-US" sz="1100" dirty="0">
                         <a:latin typeface="맑은 고딕" charset="0"/>
@@ -4201,7 +4201,7 @@
                           <a:ea typeface="맑은 고딕" pitchFamily="34" charset="-122"/>
                           <a:cs typeface="맑은 고딕" pitchFamily="34" charset="-120"/>
                         </a:rPr>
-                        <a:t>Ring</a:t>
+                        <a:t>6A</a:t>
                       </a:r>
                       <a:endParaRPr lang="en-US" sz="1000" dirty="0">
                         <a:latin typeface="맑은 고딕" charset="0"/>
@@ -4266,7 +4266,7 @@
                           <a:ea typeface="맑은 고딕" pitchFamily="34" charset="-122"/>
                           <a:cs typeface="맑은 고딕" pitchFamily="34" charset="-120"/>
                         </a:rPr>
-                        <a:t>[SILVER925] Guyeong Open Ring v3.0 (silver)</a:t>
+                        <a:t>Ring</a:t>
                       </a:r>
                       <a:endParaRPr lang="en-US" sz="1100" dirty="0">
                         <a:latin typeface="맑은 고딕" charset="0"/>
@@ -4331,7 +4331,7 @@
                           <a:ea typeface="맑은 고딕" pitchFamily="34" charset="-122"/>
                           <a:cs typeface="맑은 고딕" pitchFamily="34" charset="-120"/>
                         </a:rPr>
-                        <a:t>30 개</a:t>
+                        <a:t>31 개</a:t>
                       </a:r>
                       <a:endParaRPr lang="en-US" sz="1400" dirty="0">
                         <a:latin typeface="맑은 고딕" charset="0"/>
@@ -4463,7 +4463,7 @@
                           <a:ea typeface="맑은 고딕" pitchFamily="34" charset="-122"/>
                           <a:cs typeface="맑은 고딕" pitchFamily="34" charset="-120"/>
                         </a:rPr>
-                        <a:t>CT</a:t>
+                        <a:t>CandyPOP Necklace (사이즈: 2size (47~52cm))</a:t>
                       </a:r>
                       <a:endParaRPr lang="en-US" sz="1100" dirty="0">
                         <a:latin typeface="맑은 고딕" charset="0"/>
@@ -4528,7 +4528,7 @@
                           <a:ea typeface="맑은 고딕" pitchFamily="34" charset="-122"/>
                           <a:cs typeface="맑은 고딕" pitchFamily="34" charset="-120"/>
                         </a:rPr>
-                        <a:t>Necklace</a:t>
+                        <a:t>CT</a:t>
                       </a:r>
                       <a:endParaRPr lang="en-US" sz="1000" dirty="0">
                         <a:latin typeface="맑은 고딕" charset="0"/>
@@ -4593,7 +4593,7 @@
                           <a:ea typeface="맑은 고딕" pitchFamily="34" charset="-122"/>
                           <a:cs typeface="맑은 고딕" pitchFamily="34" charset="-120"/>
                         </a:rPr>
-                        <a:t>CandyPOP Necklace (사이즈: 2size (47~52cm))</a:t>
+                        <a:t>Necklace</a:t>
                       </a:r>
                       <a:endParaRPr lang="en-US" sz="1100" dirty="0">
                         <a:latin typeface="맑은 고딕" charset="0"/>
@@ -4658,7 +4658,7 @@
                           <a:ea typeface="맑은 고딕" pitchFamily="34" charset="-122"/>
                           <a:cs typeface="맑은 고딕" pitchFamily="34" charset="-120"/>
                         </a:rPr>
-                        <a:t>23 개</a:t>
+                        <a:t>19 개</a:t>
                       </a:r>
                       <a:endParaRPr lang="en-US" sz="1200" dirty="0">
                         <a:latin typeface="맑은 고딕" charset="0"/>
@@ -4790,7 +4790,7 @@
                           <a:ea typeface="맑은 고딕" pitchFamily="34" charset="-122"/>
                           <a:cs typeface="맑은 고딕" pitchFamily="34" charset="-120"/>
                         </a:rPr>
-                        <a:t>CT</a:t>
+                        <a:t>ThreadDuo Necklace</a:t>
                       </a:r>
                       <a:endParaRPr lang="en-US" sz="1100" dirty="0">
                         <a:latin typeface="맑은 고딕" charset="0"/>
@@ -4855,7 +4855,7 @@
                           <a:ea typeface="맑은 고딕" pitchFamily="34" charset="-122"/>
                           <a:cs typeface="맑은 고딕" pitchFamily="34" charset="-120"/>
                         </a:rPr>
-                        <a:t>Necklace</a:t>
+                        <a:t>CT</a:t>
                       </a:r>
                       <a:endParaRPr lang="en-US" sz="1000" dirty="0">
                         <a:latin typeface="맑은 고딕" charset="0"/>
@@ -4920,7 +4920,7 @@
                           <a:ea typeface="맑은 고딕" pitchFamily="34" charset="-122"/>
                           <a:cs typeface="맑은 고딕" pitchFamily="34" charset="-120"/>
                         </a:rPr>
-                        <a:t>ThreadDuo Necklace</a:t>
+                        <a:t>Necklace</a:t>
                       </a:r>
                       <a:endParaRPr lang="en-US" sz="1100" dirty="0">
                         <a:latin typeface="맑은 고딕" charset="0"/>
@@ -4985,7 +4985,7 @@
                           <a:ea typeface="맑은 고딕" pitchFamily="34" charset="-122"/>
                           <a:cs typeface="맑은 고딕" pitchFamily="34" charset="-120"/>
                         </a:rPr>
-                        <a:t>17 개</a:t>
+                        <a:t>19 개</a:t>
                       </a:r>
                       <a:endParaRPr lang="en-US" sz="1200" dirty="0">
                         <a:latin typeface="맑은 고딕" charset="0"/>
@@ -5071,7 +5071,7 @@
                 <a:ea typeface="맑은 고딕" pitchFamily="34" charset="-122"/>
                 <a:cs typeface="맑은 고딕" pitchFamily="34" charset="-120"/>
               </a:rPr>
-              <a:t>베스트 상품 리포트  ·  생성 2026-05-19 08:00</a:t>
+              <a:t>베스트 상품 리포트  ·  생성 2026-05-19 12:14</a:t>
             </a:r>
             <a:endParaRPr lang="en-US" sz="900" dirty="0"/>
           </a:p>
@@ -5284,7 +5284,7 @@
                 <a:ea typeface="맑은 고딕" pitchFamily="34" charset="-122"/>
                 <a:cs typeface="맑은 고딕" pitchFamily="34" charset="-120"/>
               </a:rPr>
-              <a:t>2026년 05월 19일 (화)</a:t>
+              <a:t>2026년 5월 19일 (화)</a:t>
             </a:r>
             <a:endParaRPr lang="en-US" sz="1200" dirty="0"/>
           </a:p>
@@ -5451,7 +5451,7 @@
                 <a:ea typeface="맑은 고딕" pitchFamily="34" charset="-122"/>
                 <a:cs typeface="맑은 고딕" pitchFamily="34" charset="-120"/>
               </a:rPr>
-              <a:t>225 개</a:t>
+              <a:t>213 개</a:t>
             </a:r>
             <a:endParaRPr lang="en-US" sz="3600" dirty="0"/>
           </a:p>
@@ -5657,7 +5657,7 @@
                 <a:ea typeface="맑은 고딕" pitchFamily="34" charset="-122"/>
                 <a:cs typeface="맑은 고딕" pitchFamily="34" charset="-120"/>
               </a:rPr>
-              <a:t>47</a:t>
+              <a:t>42</a:t>
             </a:r>
             <a:endParaRPr lang="en-US" sz="4400" dirty="0"/>
           </a:p>
@@ -6126,7 +6126,7 @@
                           <a:ea typeface="맑은 고딕" pitchFamily="34" charset="-122"/>
                           <a:cs typeface="맑은 고딕" pitchFamily="34" charset="-120"/>
                         </a:rPr>
-                        <a:t>Ring</a:t>
+                        <a:t>[SILVER925] CH.alban Open Ring</a:t>
                       </a:r>
                       <a:endParaRPr lang="en-US" sz="1000" dirty="0">
                         <a:latin typeface="맑은 고딕" charset="0"/>
@@ -6191,7 +6191,7 @@
                           <a:ea typeface="맑은 고딕" pitchFamily="34" charset="-122"/>
                           <a:cs typeface="맑은 고딕" pitchFamily="34" charset="-120"/>
                         </a:rPr>
-                        <a:t>[SILVER925] CH.alban Open Ring</a:t>
+                        <a:t>Ring</a:t>
                       </a:r>
                       <a:endParaRPr lang="en-US" sz="1100" dirty="0">
                         <a:latin typeface="맑은 고딕" charset="0"/>
@@ -6256,7 +6256,7 @@
                           <a:ea typeface="맑은 고딕" pitchFamily="34" charset="-122"/>
                           <a:cs typeface="맑은 고딕" pitchFamily="34" charset="-120"/>
                         </a:rPr>
-                        <a:t>47 개</a:t>
+                        <a:t>42 개</a:t>
                       </a:r>
                       <a:endParaRPr lang="en-US" sz="1400" dirty="0">
                         <a:latin typeface="맑은 고딕" charset="0"/>
@@ -6388,7 +6388,7 @@
                           <a:ea typeface="맑은 고딕" pitchFamily="34" charset="-122"/>
                           <a:cs typeface="맑은 고딕" pitchFamily="34" charset="-120"/>
                         </a:rPr>
-                        <a:t>Ring</a:t>
+                        <a:t>[SILVER925] Guyeong Open Ring v3.0 (silver)</a:t>
                       </a:r>
                       <a:endParaRPr lang="en-US" sz="1000" dirty="0">
                         <a:latin typeface="맑은 고딕" charset="0"/>
@@ -6453,7 +6453,7 @@
                           <a:ea typeface="맑은 고딕" pitchFamily="34" charset="-122"/>
                           <a:cs typeface="맑은 고딕" pitchFamily="34" charset="-120"/>
                         </a:rPr>
-                        <a:t>[SILVER925] Guyeong Open Ring v3.0 (silver)</a:t>
+                        <a:t>Ring</a:t>
                       </a:r>
                       <a:endParaRPr lang="en-US" sz="1100" dirty="0">
                         <a:latin typeface="맑은 고딕" charset="0"/>
@@ -6518,7 +6518,7 @@
                           <a:ea typeface="맑은 고딕" pitchFamily="34" charset="-122"/>
                           <a:cs typeface="맑은 고딕" pitchFamily="34" charset="-120"/>
                         </a:rPr>
-                        <a:t>30 개</a:t>
+                        <a:t>31 개</a:t>
                       </a:r>
                       <a:endParaRPr lang="en-US" sz="1200" dirty="0">
                         <a:latin typeface="맑은 고딕" charset="0"/>
@@ -6650,7 +6650,7 @@
                           <a:ea typeface="맑은 고딕" pitchFamily="34" charset="-122"/>
                           <a:cs typeface="맑은 고딕" pitchFamily="34" charset="-120"/>
                         </a:rPr>
-                        <a:t>Ring</a:t>
+                        <a:t>[SILVER925] Starly Open Ring</a:t>
                       </a:r>
                       <a:endParaRPr lang="en-US" sz="1000" dirty="0">
                         <a:latin typeface="맑은 고딕" charset="0"/>
@@ -6715,7 +6715,7 @@
                           <a:ea typeface="맑은 고딕" pitchFamily="34" charset="-122"/>
                           <a:cs typeface="맑은 고딕" pitchFamily="34" charset="-120"/>
                         </a:rPr>
-                        <a:t>[SILVER925] Starly Open Ring</a:t>
+                        <a:t>Ring</a:t>
                       </a:r>
                       <a:endParaRPr lang="en-US" sz="1100" dirty="0">
                         <a:latin typeface="맑은 고딕" charset="0"/>
@@ -6780,7 +6780,7 @@
                           <a:ea typeface="맑은 고딕" pitchFamily="34" charset="-122"/>
                           <a:cs typeface="맑은 고딕" pitchFamily="34" charset="-120"/>
                         </a:rPr>
-                        <a:t>14 개</a:t>
+                        <a:t>15 개</a:t>
                       </a:r>
                       <a:endParaRPr lang="en-US" sz="1200" dirty="0">
                         <a:latin typeface="맑은 고딕" charset="0"/>
@@ -6912,7 +6912,7 @@
                           <a:ea typeface="맑은 고딕" pitchFamily="34" charset="-122"/>
                           <a:cs typeface="맑은 고딕" pitchFamily="34" charset="-120"/>
                         </a:rPr>
-                        <a:t>Ring</a:t>
+                        <a:t>[SILVER925] Eramam Open Ring</a:t>
                       </a:r>
                       <a:endParaRPr lang="en-US" sz="1000" dirty="0">
                         <a:latin typeface="맑은 고딕" charset="0"/>
@@ -6977,7 +6977,7 @@
                           <a:ea typeface="맑은 고딕" pitchFamily="34" charset="-122"/>
                           <a:cs typeface="맑은 고딕" pitchFamily="34" charset="-120"/>
                         </a:rPr>
-                        <a:t>[SILVER925] Eramam Open Ring</a:t>
+                        <a:t>Ring</a:t>
                       </a:r>
                       <a:endParaRPr lang="en-US" sz="1100" dirty="0">
                         <a:latin typeface="맑은 고딕" charset="0"/>
@@ -7042,7 +7042,7 @@
                           <a:ea typeface="맑은 고딕" pitchFamily="34" charset="-122"/>
                           <a:cs typeface="맑은 고딕" pitchFamily="34" charset="-120"/>
                         </a:rPr>
-                        <a:t>10 개</a:t>
+                        <a:t>11 개</a:t>
                       </a:r>
                       <a:endParaRPr lang="en-US" sz="1200" dirty="0">
                         <a:latin typeface="맑은 고딕" charset="0"/>
@@ -7174,7 +7174,7 @@
                           <a:ea typeface="맑은 고딕" pitchFamily="34" charset="-122"/>
                           <a:cs typeface="맑은 고딕" pitchFamily="34" charset="-120"/>
                         </a:rPr>
-                        <a:t>Ring</a:t>
+                        <a:t>Tiny Cross Necklace</a:t>
                       </a:r>
                       <a:endParaRPr lang="en-US" sz="1000" dirty="0">
                         <a:latin typeface="맑은 고딕" charset="0"/>
@@ -7239,7 +7239,7 @@
                           <a:ea typeface="맑은 고딕" pitchFamily="34" charset="-122"/>
                           <a:cs typeface="맑은 고딕" pitchFamily="34" charset="-120"/>
                         </a:rPr>
-                        <a:t>[SILVER925] Cstic Open Ring</a:t>
+                        <a:t>Necklace</a:t>
                       </a:r>
                       <a:endParaRPr lang="en-US" sz="1100" dirty="0">
                         <a:latin typeface="맑은 고딕" charset="0"/>
@@ -7557,212 +7557,6 @@
                 <a:ea typeface="맑은 고딕" pitchFamily="34" charset="-122"/>
                 <a:cs typeface="맑은 고딕" pitchFamily="34" charset="-120"/>
               </a:rPr>
-              <a:t>Two-ball Bangle</a:t>
-            </a:r>
-            <a:endParaRPr lang="en-US" sz="1100" dirty="0"/>
-          </a:p>
-        </p:txBody>
-      </p:sp>
-      <p:sp>
-        <p:nvSpPr>
-          <p:cNvPr id="26" name="Text 23"/>
-          <p:cNvSpPr/>
-          <p:nvPr/>
-        </p:nvSpPr>
-        <p:spPr>
-          <a:xfrm>
-            <a:off x="8211312" y="3712464"/>
-            <a:ext cx="3291840" cy="256032"/>
-          </a:xfrm>
-          <a:prstGeom prst="rect">
-            <a:avLst/>
-          </a:prstGeom>
-          <a:noFill/>
-          <a:ln/>
-        </p:spPr>
-        <p:txBody>
-          <a:bodyPr wrap="square" lIns="0" tIns="0" rIns="0" bIns="0" rtlCol="0" anchor="ctr"/>
-          <a:lstStyle/>
-          <a:p>
-            <a:pPr indent="0" marL="0">
-              <a:buNone/>
-            </a:pPr>
-            <a:r>
-              <a:rPr lang="en-US" sz="1000" dirty="0">
-                <a:solidFill>
-                  <a:srgbClr val="6B7280"/>
-                </a:solidFill>
-                <a:latin typeface="맑은 고딕" pitchFamily="34" charset="0"/>
-                <a:ea typeface="맑은 고딕" pitchFamily="34" charset="-122"/>
-                <a:cs typeface="맑은 고딕" pitchFamily="34" charset="-120"/>
-              </a:rPr>
-              <a:t>Bracelet  ·  재고 0개</a:t>
-            </a:r>
-            <a:pPr indent="0" marL="0">
-              <a:buNone/>
-            </a:pPr>
-            <a:r>
-              <a:rPr lang="en-US" sz="1000" b="1" dirty="0">
-                <a:solidFill>
-                  <a:srgbClr val="D72638"/>
-                </a:solidFill>
-                <a:latin typeface="맑은 고딕" pitchFamily="34" charset="0"/>
-                <a:ea typeface="맑은 고딕" pitchFamily="34" charset="-122"/>
-                <a:cs typeface="맑은 고딕" pitchFamily="34" charset="-120"/>
-              </a:rPr>
-              <a:t/>
-            </a:r>
-            <a:endParaRPr lang="en-US" sz="1000" dirty="0"/>
-          </a:p>
-        </p:txBody>
-      </p:sp>
-      <p:sp>
-        <p:nvSpPr>
-          <p:cNvPr id="27" name="Shape 24"/>
-          <p:cNvSpPr/>
-          <p:nvPr/>
-        </p:nvSpPr>
-        <p:spPr>
-          <a:xfrm>
-            <a:off x="7406640" y="4096512"/>
-            <a:ext cx="4206240" cy="640080"/>
-          </a:xfrm>
-          <a:prstGeom prst="rect">
-            <a:avLst/>
-          </a:prstGeom>
-          <a:solidFill>
-            <a:srgbClr val="FFF5F5"/>
-          </a:solidFill>
-          <a:ln w="6350">
-            <a:solidFill>
-              <a:srgbClr val="E5E7EB"/>
-            </a:solidFill>
-            <a:prstDash val="solid"/>
-          </a:ln>
-        </p:spPr>
-      </p:sp>
-      <p:sp>
-        <p:nvSpPr>
-          <p:cNvPr id="28" name="Shape 25"/>
-          <p:cNvSpPr/>
-          <p:nvPr/>
-        </p:nvSpPr>
-        <p:spPr>
-          <a:xfrm>
-            <a:off x="7406640" y="4096512"/>
-            <a:ext cx="109728" cy="640080"/>
-          </a:xfrm>
-          <a:prstGeom prst="rect">
-            <a:avLst/>
-          </a:prstGeom>
-          <a:solidFill>
-            <a:srgbClr val="D72638"/>
-          </a:solidFill>
-          <a:ln w="12700">
-            <a:solidFill>
-              <a:srgbClr val="D72638"/>
-            </a:solidFill>
-            <a:prstDash val="solid"/>
-          </a:ln>
-        </p:spPr>
-      </p:sp>
-      <p:sp>
-        <p:nvSpPr>
-          <p:cNvPr id="29" name="Shape 26"/>
-          <p:cNvSpPr/>
-          <p:nvPr/>
-        </p:nvSpPr>
-        <p:spPr>
-          <a:xfrm>
-            <a:off x="7571232" y="4187952"/>
-            <a:ext cx="548640" cy="256032"/>
-          </a:xfrm>
-          <a:prstGeom prst="rect">
-            <a:avLst/>
-          </a:prstGeom>
-          <a:solidFill>
-            <a:srgbClr val="D72638"/>
-          </a:solidFill>
-          <a:ln w="12700">
-            <a:solidFill>
-              <a:srgbClr val="D72638"/>
-            </a:solidFill>
-            <a:prstDash val="solid"/>
-          </a:ln>
-        </p:spPr>
-      </p:sp>
-      <p:sp>
-        <p:nvSpPr>
-          <p:cNvPr id="30" name="Text 27"/>
-          <p:cNvSpPr/>
-          <p:nvPr/>
-        </p:nvSpPr>
-        <p:spPr>
-          <a:xfrm>
-            <a:off x="7571232" y="4187952"/>
-            <a:ext cx="548640" cy="256032"/>
-          </a:xfrm>
-          <a:prstGeom prst="rect">
-            <a:avLst/>
-          </a:prstGeom>
-          <a:noFill/>
-          <a:ln/>
-        </p:spPr>
-        <p:txBody>
-          <a:bodyPr wrap="square" lIns="0" tIns="0" rIns="0" bIns="0" rtlCol="0" anchor="ctr"/>
-          <a:lstStyle/>
-          <a:p>
-            <a:pPr algn="ctr" indent="0" marL="0">
-              <a:buNone/>
-            </a:pPr>
-            <a:r>
-              <a:rPr lang="en-US" sz="900" b="1" dirty="0">
-                <a:solidFill>
-                  <a:srgbClr val="FFFFFF"/>
-                </a:solidFill>
-                <a:latin typeface="맑은 고딕" pitchFamily="34" charset="0"/>
-                <a:ea typeface="맑은 고딕" pitchFamily="34" charset="-122"/>
-                <a:cs typeface="맑은 고딕" pitchFamily="34" charset="-120"/>
-              </a:rPr>
-              <a:t>긴급</a:t>
-            </a:r>
-            <a:endParaRPr lang="en-US" sz="900" dirty="0"/>
-          </a:p>
-        </p:txBody>
-      </p:sp>
-      <p:sp>
-        <p:nvSpPr>
-          <p:cNvPr id="31" name="Text 28"/>
-          <p:cNvSpPr/>
-          <p:nvPr/>
-        </p:nvSpPr>
-        <p:spPr>
-          <a:xfrm>
-            <a:off x="8211312" y="4151376"/>
-            <a:ext cx="3291840" cy="274320"/>
-          </a:xfrm>
-          <a:prstGeom prst="rect">
-            <a:avLst/>
-          </a:prstGeom>
-          <a:noFill/>
-          <a:ln/>
-        </p:spPr>
-        <p:txBody>
-          <a:bodyPr wrap="square" lIns="0" tIns="0" rIns="0" bIns="0" rtlCol="0" anchor="ctr"/>
-          <a:lstStyle/>
-          <a:p>
-            <a:pPr indent="0" marL="0">
-              <a:buNone/>
-            </a:pPr>
-            <a:r>
-              <a:rPr lang="en-US" sz="1100" b="1" dirty="0">
-                <a:solidFill>
-                  <a:srgbClr val="0B1220"/>
-                </a:solidFill>
-                <a:latin typeface="맑은 고딕" pitchFamily="34" charset="0"/>
-                <a:ea typeface="맑은 고딕" pitchFamily="34" charset="-122"/>
-                <a:cs typeface="맑은 고딕" pitchFamily="34" charset="-120"/>
-              </a:rPr>
               <a:t>RichardKokser Necklace</a:t>
             </a:r>
             <a:endParaRPr lang="en-US" sz="1100" dirty="0"/>
@@ -7771,13 +7565,13 @@
       </p:sp>
       <p:sp>
         <p:nvSpPr>
-          <p:cNvPr id="32" name="Text 29"/>
-          <p:cNvSpPr/>
-          <p:nvPr/>
-        </p:nvSpPr>
-        <p:spPr>
-          <a:xfrm>
-            <a:off x="8211312" y="4425696"/>
+          <p:cNvPr id="26" name="Text 23"/>
+          <p:cNvSpPr/>
+          <p:nvPr/>
+        </p:nvSpPr>
+        <p:spPr>
+          <a:xfrm>
+            <a:off x="8211312" y="3712464"/>
             <a:ext cx="3291840" cy="256032"/>
           </a:xfrm>
           <a:prstGeom prst="rect">
@@ -7824,13 +7618,13 @@
       </p:sp>
       <p:sp>
         <p:nvSpPr>
-          <p:cNvPr id="33" name="Shape 30"/>
-          <p:cNvSpPr/>
-          <p:nvPr/>
-        </p:nvSpPr>
-        <p:spPr>
-          <a:xfrm>
-            <a:off x="7406640" y="4809744"/>
+          <p:cNvPr id="27" name="Shape 24"/>
+          <p:cNvSpPr/>
+          <p:nvPr/>
+        </p:nvSpPr>
+        <p:spPr>
+          <a:xfrm>
+            <a:off x="7406640" y="4096512"/>
             <a:ext cx="4206240" cy="640080"/>
           </a:xfrm>
           <a:prstGeom prst="rect">
@@ -7849,13 +7643,13 @@
       </p:sp>
       <p:sp>
         <p:nvSpPr>
-          <p:cNvPr id="34" name="Shape 31"/>
-          <p:cNvSpPr/>
-          <p:nvPr/>
-        </p:nvSpPr>
-        <p:spPr>
-          <a:xfrm>
-            <a:off x="7406640" y="4809744"/>
+          <p:cNvPr id="28" name="Shape 25"/>
+          <p:cNvSpPr/>
+          <p:nvPr/>
+        </p:nvSpPr>
+        <p:spPr>
+          <a:xfrm>
+            <a:off x="7406640" y="4096512"/>
             <a:ext cx="109728" cy="640080"/>
           </a:xfrm>
           <a:prstGeom prst="rect">
@@ -7874,13 +7668,13 @@
       </p:sp>
       <p:sp>
         <p:nvSpPr>
-          <p:cNvPr id="35" name="Shape 32"/>
-          <p:cNvSpPr/>
-          <p:nvPr/>
-        </p:nvSpPr>
-        <p:spPr>
-          <a:xfrm>
-            <a:off x="7571232" y="4901184"/>
+          <p:cNvPr id="29" name="Shape 26"/>
+          <p:cNvSpPr/>
+          <p:nvPr/>
+        </p:nvSpPr>
+        <p:spPr>
+          <a:xfrm>
+            <a:off x="7571232" y="4187952"/>
             <a:ext cx="548640" cy="256032"/>
           </a:xfrm>
           <a:prstGeom prst="rect">
@@ -7899,13 +7693,13 @@
       </p:sp>
       <p:sp>
         <p:nvSpPr>
-          <p:cNvPr id="36" name="Text 33"/>
-          <p:cNvSpPr/>
-          <p:nvPr/>
-        </p:nvSpPr>
-        <p:spPr>
-          <a:xfrm>
-            <a:off x="7571232" y="4901184"/>
+          <p:cNvPr id="30" name="Text 27"/>
+          <p:cNvSpPr/>
+          <p:nvPr/>
+        </p:nvSpPr>
+        <p:spPr>
+          <a:xfrm>
+            <a:off x="7571232" y="4187952"/>
             <a:ext cx="548640" cy="256032"/>
           </a:xfrm>
           <a:prstGeom prst="rect">
@@ -7938,13 +7732,13 @@
       </p:sp>
       <p:sp>
         <p:nvSpPr>
-          <p:cNvPr id="37" name="Text 34"/>
-          <p:cNvSpPr/>
-          <p:nvPr/>
-        </p:nvSpPr>
-        <p:spPr>
-          <a:xfrm>
-            <a:off x="8211312" y="4864608"/>
+          <p:cNvPr id="31" name="Text 28"/>
+          <p:cNvSpPr/>
+          <p:nvPr/>
+        </p:nvSpPr>
+        <p:spPr>
+          <a:xfrm>
+            <a:off x="8211312" y="4151376"/>
             <a:ext cx="3291840" cy="274320"/>
           </a:xfrm>
           <a:prstGeom prst="rect">
@@ -7977,13 +7771,13 @@
       </p:sp>
       <p:sp>
         <p:nvSpPr>
-          <p:cNvPr id="38" name="Text 35"/>
-          <p:cNvSpPr/>
-          <p:nvPr/>
-        </p:nvSpPr>
-        <p:spPr>
-          <a:xfrm>
-            <a:off x="8211312" y="5138928"/>
+          <p:cNvPr id="32" name="Text 29"/>
+          <p:cNvSpPr/>
+          <p:nvPr/>
+        </p:nvSpPr>
+        <p:spPr>
+          <a:xfrm>
+            <a:off x="8211312" y="4425696"/>
             <a:ext cx="3291840" cy="256032"/>
           </a:xfrm>
           <a:prstGeom prst="rect">
@@ -8030,6 +7824,212 @@
       </p:sp>
       <p:sp>
         <p:nvSpPr>
+          <p:cNvPr id="33" name="Shape 30"/>
+          <p:cNvSpPr/>
+          <p:nvPr/>
+        </p:nvSpPr>
+        <p:spPr>
+          <a:xfrm>
+            <a:off x="7406640" y="4809744"/>
+            <a:ext cx="4206240" cy="640080"/>
+          </a:xfrm>
+          <a:prstGeom prst="rect">
+            <a:avLst/>
+          </a:prstGeom>
+          <a:solidFill>
+            <a:srgbClr val="FFF5F5"/>
+          </a:solidFill>
+          <a:ln w="6350">
+            <a:solidFill>
+              <a:srgbClr val="E5E7EB"/>
+            </a:solidFill>
+            <a:prstDash val="solid"/>
+          </a:ln>
+        </p:spPr>
+      </p:sp>
+      <p:sp>
+        <p:nvSpPr>
+          <p:cNvPr id="34" name="Shape 31"/>
+          <p:cNvSpPr/>
+          <p:nvPr/>
+        </p:nvSpPr>
+        <p:spPr>
+          <a:xfrm>
+            <a:off x="7406640" y="4809744"/>
+            <a:ext cx="109728" cy="640080"/>
+          </a:xfrm>
+          <a:prstGeom prst="rect">
+            <a:avLst/>
+          </a:prstGeom>
+          <a:solidFill>
+            <a:srgbClr val="D72638"/>
+          </a:solidFill>
+          <a:ln w="12700">
+            <a:solidFill>
+              <a:srgbClr val="D72638"/>
+            </a:solidFill>
+            <a:prstDash val="solid"/>
+          </a:ln>
+        </p:spPr>
+      </p:sp>
+      <p:sp>
+        <p:nvSpPr>
+          <p:cNvPr id="35" name="Shape 32"/>
+          <p:cNvSpPr/>
+          <p:nvPr/>
+        </p:nvSpPr>
+        <p:spPr>
+          <a:xfrm>
+            <a:off x="7571232" y="4901184"/>
+            <a:ext cx="548640" cy="256032"/>
+          </a:xfrm>
+          <a:prstGeom prst="rect">
+            <a:avLst/>
+          </a:prstGeom>
+          <a:solidFill>
+            <a:srgbClr val="D72638"/>
+          </a:solidFill>
+          <a:ln w="12700">
+            <a:solidFill>
+              <a:srgbClr val="D72638"/>
+            </a:solidFill>
+            <a:prstDash val="solid"/>
+          </a:ln>
+        </p:spPr>
+      </p:sp>
+      <p:sp>
+        <p:nvSpPr>
+          <p:cNvPr id="36" name="Text 33"/>
+          <p:cNvSpPr/>
+          <p:nvPr/>
+        </p:nvSpPr>
+        <p:spPr>
+          <a:xfrm>
+            <a:off x="7571232" y="4901184"/>
+            <a:ext cx="548640" cy="256032"/>
+          </a:xfrm>
+          <a:prstGeom prst="rect">
+            <a:avLst/>
+          </a:prstGeom>
+          <a:noFill/>
+          <a:ln/>
+        </p:spPr>
+        <p:txBody>
+          <a:bodyPr wrap="square" lIns="0" tIns="0" rIns="0" bIns="0" rtlCol="0" anchor="ctr"/>
+          <a:lstStyle/>
+          <a:p>
+            <a:pPr algn="ctr" indent="0" marL="0">
+              <a:buNone/>
+            </a:pPr>
+            <a:r>
+              <a:rPr lang="en-US" sz="900" b="1" dirty="0">
+                <a:solidFill>
+                  <a:srgbClr val="FFFFFF"/>
+                </a:solidFill>
+                <a:latin typeface="맑은 고딕" pitchFamily="34" charset="0"/>
+                <a:ea typeface="맑은 고딕" pitchFamily="34" charset="-122"/>
+                <a:cs typeface="맑은 고딕" pitchFamily="34" charset="-120"/>
+              </a:rPr>
+              <a:t>긴급</a:t>
+            </a:r>
+            <a:endParaRPr lang="en-US" sz="900" dirty="0"/>
+          </a:p>
+        </p:txBody>
+      </p:sp>
+      <p:sp>
+        <p:nvSpPr>
+          <p:cNvPr id="37" name="Text 34"/>
+          <p:cNvSpPr/>
+          <p:nvPr/>
+        </p:nvSpPr>
+        <p:spPr>
+          <a:xfrm>
+            <a:off x="8211312" y="4864608"/>
+            <a:ext cx="3291840" cy="274320"/>
+          </a:xfrm>
+          <a:prstGeom prst="rect">
+            <a:avLst/>
+          </a:prstGeom>
+          <a:noFill/>
+          <a:ln/>
+        </p:spPr>
+        <p:txBody>
+          <a:bodyPr wrap="square" lIns="0" tIns="0" rIns="0" bIns="0" rtlCol="0" anchor="ctr"/>
+          <a:lstStyle/>
+          <a:p>
+            <a:pPr indent="0" marL="0">
+              <a:buNone/>
+            </a:pPr>
+            <a:r>
+              <a:rPr lang="en-US" sz="1100" b="1" dirty="0">
+                <a:solidFill>
+                  <a:srgbClr val="0B1220"/>
+                </a:solidFill>
+                <a:latin typeface="맑은 고딕" pitchFamily="34" charset="0"/>
+                <a:ea typeface="맑은 고딕" pitchFamily="34" charset="-122"/>
+                <a:cs typeface="맑은 고딕" pitchFamily="34" charset="-120"/>
+              </a:rPr>
+              <a:t>Marquise Necklace</a:t>
+            </a:r>
+            <a:endParaRPr lang="en-US" sz="1100" dirty="0"/>
+          </a:p>
+        </p:txBody>
+      </p:sp>
+      <p:sp>
+        <p:nvSpPr>
+          <p:cNvPr id="38" name="Text 35"/>
+          <p:cNvSpPr/>
+          <p:nvPr/>
+        </p:nvSpPr>
+        <p:spPr>
+          <a:xfrm>
+            <a:off x="8211312" y="5138928"/>
+            <a:ext cx="3291840" cy="256032"/>
+          </a:xfrm>
+          <a:prstGeom prst="rect">
+            <a:avLst/>
+          </a:prstGeom>
+          <a:noFill/>
+          <a:ln/>
+        </p:spPr>
+        <p:txBody>
+          <a:bodyPr wrap="square" lIns="0" tIns="0" rIns="0" bIns="0" rtlCol="0" anchor="ctr"/>
+          <a:lstStyle/>
+          <a:p>
+            <a:pPr indent="0" marL="0">
+              <a:buNone/>
+            </a:pPr>
+            <a:r>
+              <a:rPr lang="en-US" sz="1000" dirty="0">
+                <a:solidFill>
+                  <a:srgbClr val="6B7280"/>
+                </a:solidFill>
+                <a:latin typeface="맑은 고딕" pitchFamily="34" charset="0"/>
+                <a:ea typeface="맑은 고딕" pitchFamily="34" charset="-122"/>
+                <a:cs typeface="맑은 고딕" pitchFamily="34" charset="-120"/>
+              </a:rPr>
+              <a:t>Necklace  ·  재고 0개</a:t>
+            </a:r>
+            <a:pPr indent="0" marL="0">
+              <a:buNone/>
+            </a:pPr>
+            <a:r>
+              <a:rPr lang="en-US" sz="1000" b="1" dirty="0">
+                <a:solidFill>
+                  <a:srgbClr val="D72638"/>
+                </a:solidFill>
+                <a:latin typeface="맑은 고딕" pitchFamily="34" charset="0"/>
+                <a:ea typeface="맑은 고딕" pitchFamily="34" charset="-122"/>
+                <a:cs typeface="맑은 고딕" pitchFamily="34" charset="-120"/>
+              </a:rPr>
+              <a:t/>
+            </a:r>
+            <a:endParaRPr lang="en-US" sz="1000" dirty="0"/>
+          </a:p>
+        </p:txBody>
+      </p:sp>
+      <p:sp>
+        <p:nvSpPr>
           <p:cNvPr id="39" name="Shape 36"/>
           <p:cNvSpPr/>
           <p:nvPr/>
@@ -8267,7 +8267,7 @@
                 <a:ea typeface="맑은 고딕" pitchFamily="34" charset="-122"/>
                 <a:cs typeface="맑은 고딕" pitchFamily="34" charset="-120"/>
               </a:rPr>
-              <a:t>베스트 상품 리포트  ·  생성 2026-05-19 08:00</a:t>
+              <a:t>베스트 상품 리포트  ·  생성 2026-05-19 12:14</a:t>
             </a:r>
             <a:endParaRPr lang="en-US" sz="900" dirty="0"/>
           </a:p>
@@ -8480,7 +8480,7 @@
                 <a:ea typeface="맑은 고딕" pitchFamily="34" charset="-122"/>
                 <a:cs typeface="맑은 고딕" pitchFamily="34" charset="-120"/>
               </a:rPr>
-              <a:t>2026년 05월 19일 (화)</a:t>
+              <a:t>2026년 5월 19일 (화)</a:t>
             </a:r>
             <a:endParaRPr lang="en-US" sz="1200" dirty="0"/>
           </a:p>
@@ -8647,7 +8647,7 @@
                 <a:ea typeface="맑은 고딕" pitchFamily="34" charset="-122"/>
                 <a:cs typeface="맑은 고딕" pitchFamily="34" charset="-120"/>
               </a:rPr>
-              <a:t>123 개</a:t>
+              <a:t>120 개</a:t>
             </a:r>
             <a:endParaRPr lang="en-US" sz="3600" dirty="0"/>
           </a:p>
@@ -8853,7 +8853,7 @@
                 <a:ea typeface="맑은 고딕" pitchFamily="34" charset="-122"/>
                 <a:cs typeface="맑은 고딕" pitchFamily="34" charset="-120"/>
               </a:rPr>
-              <a:t>46</a:t>
+              <a:t>42</a:t>
             </a:r>
             <a:endParaRPr lang="en-US" sz="4400" dirty="0"/>
           </a:p>
@@ -9322,7 +9322,7 @@
                           <a:ea typeface="맑은 고딕" pitchFamily="34" charset="-122"/>
                           <a:cs typeface="맑은 고딕" pitchFamily="34" charset="-120"/>
                         </a:rPr>
-                        <a:t>Necklace</a:t>
+                        <a:t>CandyPOP Necklace (사이즈: 1size (41.5~47cm))</a:t>
                       </a:r>
                       <a:endParaRPr lang="en-US" sz="1000" dirty="0">
                         <a:latin typeface="맑은 고딕" charset="0"/>
@@ -9387,7 +9387,7 @@
                           <a:ea typeface="맑은 고딕" pitchFamily="34" charset="-122"/>
                           <a:cs typeface="맑은 고딕" pitchFamily="34" charset="-120"/>
                         </a:rPr>
-                        <a:t>CandyPOP Necklace (사이즈: 1size (41.5~47cm))</a:t>
+                        <a:t>Necklace</a:t>
                       </a:r>
                       <a:endParaRPr lang="en-US" sz="1100" dirty="0">
                         <a:latin typeface="맑은 고딕" charset="0"/>
@@ -9452,7 +9452,7 @@
                           <a:ea typeface="맑은 고딕" pitchFamily="34" charset="-122"/>
                           <a:cs typeface="맑은 고딕" pitchFamily="34" charset="-120"/>
                         </a:rPr>
-                        <a:t>46 개</a:t>
+                        <a:t>42 개</a:t>
                       </a:r>
                       <a:endParaRPr lang="en-US" sz="1400" dirty="0">
                         <a:latin typeface="맑은 고딕" charset="0"/>
@@ -9584,7 +9584,7 @@
                           <a:ea typeface="맑은 고딕" pitchFamily="34" charset="-122"/>
                           <a:cs typeface="맑은 고딕" pitchFamily="34" charset="-120"/>
                         </a:rPr>
-                        <a:t>Necklace</a:t>
+                        <a:t>CandyPOP Necklace (사이즈: 2size (47~52cm))</a:t>
                       </a:r>
                       <a:endParaRPr lang="en-US" sz="1000" dirty="0">
                         <a:latin typeface="맑은 고딕" charset="0"/>
@@ -9649,7 +9649,7 @@
                           <a:ea typeface="맑은 고딕" pitchFamily="34" charset="-122"/>
                           <a:cs typeface="맑은 고딕" pitchFamily="34" charset="-120"/>
                         </a:rPr>
-                        <a:t>CandyPOP Necklace (사이즈: 2size (47~52cm))</a:t>
+                        <a:t>Necklace</a:t>
                       </a:r>
                       <a:endParaRPr lang="en-US" sz="1100" dirty="0">
                         <a:latin typeface="맑은 고딕" charset="0"/>
@@ -9714,7 +9714,7 @@
                           <a:ea typeface="맑은 고딕" pitchFamily="34" charset="-122"/>
                           <a:cs typeface="맑은 고딕" pitchFamily="34" charset="-120"/>
                         </a:rPr>
-                        <a:t>23 개</a:t>
+                        <a:t>19 개</a:t>
                       </a:r>
                       <a:endParaRPr lang="en-US" sz="1200" dirty="0">
                         <a:latin typeface="맑은 고딕" charset="0"/>
@@ -9846,7 +9846,7 @@
                           <a:ea typeface="맑은 고딕" pitchFamily="34" charset="-122"/>
                           <a:cs typeface="맑은 고딕" pitchFamily="34" charset="-120"/>
                         </a:rPr>
-                        <a:t>Necklace</a:t>
+                        <a:t>ThreadDuo Necklace</a:t>
                       </a:r>
                       <a:endParaRPr lang="en-US" sz="1000" dirty="0">
                         <a:latin typeface="맑은 고딕" charset="0"/>
@@ -9911,7 +9911,7 @@
                           <a:ea typeface="맑은 고딕" pitchFamily="34" charset="-122"/>
                           <a:cs typeface="맑은 고딕" pitchFamily="34" charset="-120"/>
                         </a:rPr>
-                        <a:t>ThreadDuo Necklace</a:t>
+                        <a:t>Necklace</a:t>
                       </a:r>
                       <a:endParaRPr lang="en-US" sz="1100" dirty="0">
                         <a:latin typeface="맑은 고딕" charset="0"/>
@@ -9976,7 +9976,7 @@
                           <a:ea typeface="맑은 고딕" pitchFamily="34" charset="-122"/>
                           <a:cs typeface="맑은 고딕" pitchFamily="34" charset="-120"/>
                         </a:rPr>
-                        <a:t>17 개</a:t>
+                        <a:t>19 개</a:t>
                       </a:r>
                       <a:endParaRPr lang="en-US" sz="1200" dirty="0">
                         <a:latin typeface="맑은 고딕" charset="0"/>
@@ -10062,7 +10062,7 @@
                 <a:ea typeface="맑은 고딕" pitchFamily="34" charset="-122"/>
                 <a:cs typeface="맑은 고딕" pitchFamily="34" charset="-120"/>
               </a:rPr>
-              <a:t>리오더 필요  🔴 긴급 18건</a:t>
+              <a:t>리오더 필요  🔴 긴급 18건 · 상세는 시트 확인</a:t>
             </a:r>
             <a:endParaRPr lang="en-US" sz="1500" dirty="0"/>
           </a:p>
@@ -10126,7 +10126,7 @@
                 <a:ea typeface="맑은 고딕" pitchFamily="34" charset="-122"/>
                 <a:cs typeface="맑은 고딕" pitchFamily="34" charset="-120"/>
               </a:rPr>
-              <a:t>🔴 긴급 18건  ·  상세는 시트 확인</a:t>
+              <a:t>🔴 긴급 18건 · 상세는 시트 확인</a:t>
             </a:r>
             <a:endParaRPr lang="en-US" sz="1400" dirty="0"/>
           </a:p>
@@ -10165,7 +10165,7 @@
                 <a:ea typeface="맑은 고딕" pitchFamily="34" charset="-122"/>
                 <a:cs typeface="맑은 고딕" pitchFamily="34" charset="-120"/>
               </a:rPr>
-              <a:t>베스트 상품 리포트  ·  생성 2026-05-19 08:00</a:t>
+              <a:t>베스트 상품 리포트  ·  생성 2026-05-19 12:14</a:t>
             </a:r>
             <a:endParaRPr lang="en-US" sz="900" dirty="0"/>
           </a:p>
@@ -10378,7 +10378,7 @@
                 <a:ea typeface="맑은 고딕" pitchFamily="34" charset="-122"/>
                 <a:cs typeface="맑은 고딕" pitchFamily="34" charset="-120"/>
               </a:rPr>
-              <a:t>2026년 05월 19일 (화)</a:t>
+              <a:t>2026년 5월 19일 (화)</a:t>
             </a:r>
             <a:endParaRPr lang="en-US" sz="1200" dirty="0"/>
           </a:p>
@@ -10929,7 +10929,7 @@
                 <a:ea typeface="맑은 고딕" pitchFamily="34" charset="-122"/>
                 <a:cs typeface="맑은 고딕" pitchFamily="34" charset="-120"/>
               </a:rPr>
-              <a:t>33,910</a:t>
+              <a:t>33,859</a:t>
             </a:r>
             <a:endParaRPr lang="en-US" sz="3000" dirty="0"/>
           </a:p>
@@ -11359,7 +11359,7 @@
                           <a:ea typeface="맑은 고딕" pitchFamily="34" charset="-122"/>
                           <a:cs typeface="맑은 고딕" pitchFamily="34" charset="-120"/>
                         </a:rPr>
-                        <a:t>180° Fast Charging Cable (8color)</a:t>
+                        <a:t>180° Fast Charging Cable (8color) (컬러: 옐로우 / 기종 옵션: USB -&gt; Apple 8pin)</a:t>
                       </a:r>
                       <a:endParaRPr lang="en-US" sz="1000" dirty="0">
                         <a:latin typeface="맑은 고딕" charset="0"/>
@@ -11424,7 +11424,7 @@
                           <a:ea typeface="맑은 고딕" pitchFamily="34" charset="-122"/>
                           <a:cs typeface="맑은 고딕" pitchFamily="34" charset="-120"/>
                         </a:rPr>
-                        <a:t>컬러: 옐로우 / 기종 옵션: USB -&gt; Apple 8pin</a:t>
+                        <a:t>ELECTRONIC</a:t>
                       </a:r>
                       <a:endParaRPr lang="en-US" sz="900" dirty="0">
                         <a:latin typeface="맑은 고딕" charset="0"/>
@@ -11621,7 +11621,7 @@
                           <a:ea typeface="맑은 고딕" pitchFamily="34" charset="-122"/>
                           <a:cs typeface="맑은 고딕" pitchFamily="34" charset="-120"/>
                         </a:rPr>
-                        <a:t>180° Fast Charging Cable (8color)</a:t>
+                        <a:t>180° Fast Charging Cable (8color) (컬러: 퍼플 / 기종 옵션: C type -&gt; C type)</a:t>
                       </a:r>
                       <a:endParaRPr lang="en-US" sz="1000" dirty="0">
                         <a:latin typeface="맑은 고딕" charset="0"/>
@@ -11686,7 +11686,7 @@
                           <a:ea typeface="맑은 고딕" pitchFamily="34" charset="-122"/>
                           <a:cs typeface="맑은 고딕" pitchFamily="34" charset="-120"/>
                         </a:rPr>
-                        <a:t>컬러: 퍼플 / 기종 옵션: C type -&gt; C type</a:t>
+                        <a:t>ELECTRONIC</a:t>
                       </a:r>
                       <a:endParaRPr lang="en-US" sz="900" dirty="0">
                         <a:latin typeface="맑은 고딕" charset="0"/>
@@ -11751,7 +11751,7 @@
                           <a:ea typeface="맑은 고딕" pitchFamily="34" charset="-122"/>
                           <a:cs typeface="맑은 고딕" pitchFamily="34" charset="-120"/>
                         </a:rPr>
-                        <a:t>1,875</a:t>
+                        <a:t>1,865</a:t>
                       </a:r>
                       <a:endParaRPr lang="en-US" sz="1000" dirty="0">
                         <a:latin typeface="맑은 고딕" charset="0"/>
@@ -11883,7 +11883,7 @@
                           <a:ea typeface="맑은 고딕" pitchFamily="34" charset="-122"/>
                           <a:cs typeface="맑은 고딕" pitchFamily="34" charset="-120"/>
                         </a:rPr>
-                        <a:t>180° Fast Charging Cable (8color)</a:t>
+                        <a:t>180° Fast Charging Cable (8color) (컬러: 네온핑크 / 기종 옵션: USB -&gt; C type)</a:t>
                       </a:r>
                       <a:endParaRPr lang="en-US" sz="1000" dirty="0">
                         <a:latin typeface="맑은 고딕" charset="0"/>
@@ -11948,7 +11948,7 @@
                           <a:ea typeface="맑은 고딕" pitchFamily="34" charset="-122"/>
                           <a:cs typeface="맑은 고딕" pitchFamily="34" charset="-120"/>
                         </a:rPr>
-                        <a:t>컬러: 네온핑크 / 기종 옵션: USB -&gt; C type</a:t>
+                        <a:t>ELECTRONIC</a:t>
                       </a:r>
                       <a:endParaRPr lang="en-US" sz="900" dirty="0">
                         <a:latin typeface="맑은 고딕" charset="0"/>
@@ -12013,7 +12013,7 @@
                           <a:ea typeface="맑은 고딕" pitchFamily="34" charset="-122"/>
                           <a:cs typeface="맑은 고딕" pitchFamily="34" charset="-120"/>
                         </a:rPr>
-                        <a:t>1,749</a:t>
+                        <a:t>1,743</a:t>
                       </a:r>
                       <a:endParaRPr lang="en-US" sz="1000" dirty="0">
                         <a:latin typeface="맑은 고딕" charset="0"/>
@@ -12145,7 +12145,7 @@
                           <a:ea typeface="맑은 고딕" pitchFamily="34" charset="-122"/>
                           <a:cs typeface="맑은 고딕" pitchFamily="34" charset="-120"/>
                         </a:rPr>
-                        <a:t>180° Fast Charging Cable (8color)</a:t>
+                        <a:t>180° Fast Charging Cable (8color) (컬러: 오렌지 / 기종 옵션: USB -&gt; Apple 8pin)</a:t>
                       </a:r>
                       <a:endParaRPr lang="en-US" sz="1000" dirty="0">
                         <a:latin typeface="맑은 고딕" charset="0"/>
@@ -12210,7 +12210,7 @@
                           <a:ea typeface="맑은 고딕" pitchFamily="34" charset="-122"/>
                           <a:cs typeface="맑은 고딕" pitchFamily="34" charset="-120"/>
                         </a:rPr>
-                        <a:t>컬러: 오렌지 / 기종 옵션: USB -&gt; Apple 8pin</a:t>
+                        <a:t>ELECTRONIC</a:t>
                       </a:r>
                       <a:endParaRPr lang="en-US" sz="900" dirty="0">
                         <a:latin typeface="맑은 고딕" charset="0"/>
@@ -12275,7 +12275,7 @@
                           <a:ea typeface="맑은 고딕" pitchFamily="34" charset="-122"/>
                           <a:cs typeface="맑은 고딕" pitchFamily="34" charset="-120"/>
                         </a:rPr>
-                        <a:t>1,655</a:t>
+                        <a:t>1,654</a:t>
                       </a:r>
                       <a:endParaRPr lang="en-US" sz="1000" dirty="0">
                         <a:latin typeface="맑은 고딕" charset="0"/>
@@ -12407,7 +12407,7 @@
                           <a:ea typeface="맑은 고딕" pitchFamily="34" charset="-122"/>
                           <a:cs typeface="맑은 고딕" pitchFamily="34" charset="-120"/>
                         </a:rPr>
-                        <a:t>180° Fast Charging Cable (8color)</a:t>
+                        <a:t>180° Fast Charging Cable (8color) (컬러: 피치 / 기종 옵션: C type -&gt; C type)</a:t>
                       </a:r>
                       <a:endParaRPr lang="en-US" sz="1000" dirty="0">
                         <a:latin typeface="맑은 고딕" charset="0"/>
@@ -12472,7 +12472,7 @@
                           <a:ea typeface="맑은 고딕" pitchFamily="34" charset="-122"/>
                           <a:cs typeface="맑은 고딕" pitchFamily="34" charset="-120"/>
                         </a:rPr>
-                        <a:t>컬러: 피치 / 기종 옵션: C type -&gt; C type</a:t>
+                        <a:t>ELECTRONIC</a:t>
                       </a:r>
                       <a:endParaRPr lang="en-US" sz="900" dirty="0">
                         <a:latin typeface="맑은 고딕" charset="0"/>
@@ -12537,7 +12537,7 @@
                           <a:ea typeface="맑은 고딕" pitchFamily="34" charset="-122"/>
                           <a:cs typeface="맑은 고딕" pitchFamily="34" charset="-120"/>
                         </a:rPr>
-                        <a:t>1,358</a:t>
+                        <a:t>1,349</a:t>
                       </a:r>
                       <a:endParaRPr lang="en-US" sz="1000" dirty="0">
                         <a:latin typeface="맑은 고딕" charset="0"/>
@@ -13556,7 +13556,7 @@
                 <a:ea typeface="맑은 고딕" pitchFamily="34" charset="-122"/>
                 <a:cs typeface="맑은 고딕" pitchFamily="34" charset="-120"/>
               </a:rPr>
-              <a:t>베스트 상품 리포트  ·  생성 2026-05-19 08:00</a:t>
+              <a:t>베스트 상품 리포트  ·  생성 2026-05-19 12:14</a:t>
             </a:r>
             <a:endParaRPr lang="en-US" sz="900" dirty="0"/>
           </a:p>
@@ -13769,7 +13769,7 @@
                 <a:ea typeface="맑은 고딕" pitchFamily="34" charset="-122"/>
                 <a:cs typeface="맑은 고딕" pitchFamily="34" charset="-120"/>
               </a:rPr>
-              <a:t>2026년 05월 19일 (화)</a:t>
+              <a:t>2026년 5월 19일 (화)</a:t>
             </a:r>
             <a:endParaRPr lang="en-US" sz="1200" dirty="0"/>
           </a:p>
@@ -13897,7 +13897,7 @@
                 <a:ea typeface="맑은 고딕" pitchFamily="34" charset="-122"/>
                 <a:cs typeface="맑은 고딕" pitchFamily="34" charset="-120"/>
               </a:rPr>
-              <a:t>🚨  긴급 리오더 65건    ·    주의 리오더 10건    ·    오늘 발주 검토 필수</a:t>
+              <a:t>🚨  긴급 리오더 65건    ·    주의 리오더 0건    ·    오늘 발주 검토 필수</a:t>
             </a:r>
             <a:pPr indent="0" marL="0">
               <a:buNone/>
@@ -14459,7 +14459,827 @@
                           <a:ea typeface="맑은 고딕" pitchFamily="34" charset="-122"/>
                           <a:cs typeface="맑은 고딕" pitchFamily="34" charset="-120"/>
                         </a:rPr>
-                        <a:t>긴급</a:t>
+                        <a:t>1</a:t>
+                      </a:r>
+                      <a:endParaRPr lang="en-US" sz="1100" dirty="0">
+                        <a:latin typeface="맑은 고딕" charset="0"/>
+                        <a:ea typeface="맑은 고딕" charset="0"/>
+                        <a:cs typeface="맑은 고딕" charset="0"/>
+                      </a:endParaRPr>
+                    </a:p>
+                  </a:txBody>
+                  <a:tcPr marL="91440" marR="91440" marT="45720" marB="45720" anchor="ctr">
+                    <a:lnL w="6350" cap="flat" cmpd="sng" algn="ctr">
+                      <a:solidFill>
+                        <a:srgbClr val="E5E7EB"/>
+                      </a:solidFill>
+                      <a:prstDash val="solid"/>
+                      <a:round/>
+                      <a:headEnd type="none" w="med" len="med"/>
+                      <a:tailEnd type="none" w="med" len="med"/>
+                    </a:lnL>
+                    <a:lnR w="6350" cap="flat" cmpd="sng" algn="ctr">
+                      <a:solidFill>
+                        <a:srgbClr val="E5E7EB"/>
+                      </a:solidFill>
+                      <a:prstDash val="solid"/>
+                      <a:round/>
+                      <a:headEnd type="none" w="med" len="med"/>
+                      <a:tailEnd type="none" w="med" len="med"/>
+                    </a:lnR>
+                    <a:lnT w="6350" cap="flat" cmpd="sng" algn="ctr">
+                      <a:solidFill>
+                        <a:srgbClr val="E5E7EB"/>
+                      </a:solidFill>
+                      <a:prstDash val="solid"/>
+                      <a:round/>
+                      <a:headEnd type="none" w="med" len="med"/>
+                      <a:tailEnd type="none" w="med" len="med"/>
+                    </a:lnT>
+                    <a:lnB w="6350" cap="flat" cmpd="sng" algn="ctr">
+                      <a:solidFill>
+                        <a:srgbClr val="E5E7EB"/>
+                      </a:solidFill>
+                      <a:prstDash val="solid"/>
+                      <a:round/>
+                      <a:headEnd type="none" w="med" len="med"/>
+                      <a:tailEnd type="none" w="med" len="med"/>
+                    </a:lnB>
+                    <a:solidFill>
+                      <a:srgbClr val="D72638"/>
+                    </a:solidFill>
+                  </a:tcPr>
+                </a:tc>
+                <a:tc>
+                  <a:txBody>
+                    <a:bodyPr/>
+                    <a:lstStyle/>
+                    <a:p>
+                      <a:pPr algn="ctr" indent="0" marL="0">
+                        <a:buNone/>
+                      </a:pPr>
+                      <a:r>
+                        <a:rPr lang="en-US" sz="1100" b="1" dirty="0">
+                          <a:solidFill>
+                            <a:srgbClr val="1F2937"/>
+                          </a:solidFill>
+                          <a:latin typeface="맑은 고딕" pitchFamily="34" charset="0"/>
+                          <a:ea typeface="맑은 고딕" pitchFamily="34" charset="-122"/>
+                          <a:cs typeface="맑은 고딕" pitchFamily="34" charset="-120"/>
+                        </a:rPr>
+                        <a:t>CT</a:t>
+                      </a:r>
+                      <a:endParaRPr lang="en-US" sz="1100" dirty="0">
+                        <a:latin typeface="맑은 고딕" charset="0"/>
+                        <a:ea typeface="맑은 고딕" charset="0"/>
+                        <a:cs typeface="맑은 고딕" charset="0"/>
+                      </a:endParaRPr>
+                    </a:p>
+                  </a:txBody>
+                  <a:tcPr marL="91440" marR="91440" marT="45720" marB="45720" anchor="ctr">
+                    <a:lnL w="6350" cap="flat" cmpd="sng" algn="ctr">
+                      <a:solidFill>
+                        <a:srgbClr val="E5E7EB"/>
+                      </a:solidFill>
+                      <a:prstDash val="solid"/>
+                      <a:round/>
+                      <a:headEnd type="none" w="med" len="med"/>
+                      <a:tailEnd type="none" w="med" len="med"/>
+                    </a:lnL>
+                    <a:lnR w="6350" cap="flat" cmpd="sng" algn="ctr">
+                      <a:solidFill>
+                        <a:srgbClr val="E5E7EB"/>
+                      </a:solidFill>
+                      <a:prstDash val="solid"/>
+                      <a:round/>
+                      <a:headEnd type="none" w="med" len="med"/>
+                      <a:tailEnd type="none" w="med" len="med"/>
+                    </a:lnR>
+                    <a:lnT w="6350" cap="flat" cmpd="sng" algn="ctr">
+                      <a:solidFill>
+                        <a:srgbClr val="E5E7EB"/>
+                      </a:solidFill>
+                      <a:prstDash val="solid"/>
+                      <a:round/>
+                      <a:headEnd type="none" w="med" len="med"/>
+                      <a:tailEnd type="none" w="med" len="med"/>
+                    </a:lnT>
+                    <a:lnB w="6350" cap="flat" cmpd="sng" algn="ctr">
+                      <a:solidFill>
+                        <a:srgbClr val="E5E7EB"/>
+                      </a:solidFill>
+                      <a:prstDash val="solid"/>
+                      <a:round/>
+                      <a:headEnd type="none" w="med" len="med"/>
+                      <a:tailEnd type="none" w="med" len="med"/>
+                    </a:lnB>
+                    <a:solidFill>
+                      <a:srgbClr val="FFF5F5"/>
+                    </a:solidFill>
+                  </a:tcPr>
+                </a:tc>
+                <a:tc>
+                  <a:txBody>
+                    <a:bodyPr/>
+                    <a:lstStyle/>
+                    <a:p>
+                      <a:pPr indent="0" marL="0">
+                        <a:buNone/>
+                      </a:pPr>
+                      <a:r>
+                        <a:rPr lang="en-US" sz="1000" dirty="0">
+                          <a:solidFill>
+                            <a:srgbClr val="6B7280"/>
+                          </a:solidFill>
+                          <a:latin typeface="맑은 고딕" pitchFamily="34" charset="0"/>
+                          <a:ea typeface="맑은 고딕" pitchFamily="34" charset="-122"/>
+                          <a:cs typeface="맑은 고딕" pitchFamily="34" charset="-120"/>
+                        </a:rPr>
+                        <a:t>Ring</a:t>
+                      </a:r>
+                      <a:endParaRPr lang="en-US" sz="1000" dirty="0">
+                        <a:latin typeface="맑은 고딕" charset="0"/>
+                        <a:ea typeface="맑은 고딕" charset="0"/>
+                        <a:cs typeface="맑은 고딕" charset="0"/>
+                      </a:endParaRPr>
+                    </a:p>
+                  </a:txBody>
+                  <a:tcPr marL="91440" marR="91440" marT="45720" marB="45720" anchor="ctr">
+                    <a:lnL w="6350" cap="flat" cmpd="sng" algn="ctr">
+                      <a:solidFill>
+                        <a:srgbClr val="E5E7EB"/>
+                      </a:solidFill>
+                      <a:prstDash val="solid"/>
+                      <a:round/>
+                      <a:headEnd type="none" w="med" len="med"/>
+                      <a:tailEnd type="none" w="med" len="med"/>
+                    </a:lnL>
+                    <a:lnR w="6350" cap="flat" cmpd="sng" algn="ctr">
+                      <a:solidFill>
+                        <a:srgbClr val="E5E7EB"/>
+                      </a:solidFill>
+                      <a:prstDash val="solid"/>
+                      <a:round/>
+                      <a:headEnd type="none" w="med" len="med"/>
+                      <a:tailEnd type="none" w="med" len="med"/>
+                    </a:lnR>
+                    <a:lnT w="6350" cap="flat" cmpd="sng" algn="ctr">
+                      <a:solidFill>
+                        <a:srgbClr val="E5E7EB"/>
+                      </a:solidFill>
+                      <a:prstDash val="solid"/>
+                      <a:round/>
+                      <a:headEnd type="none" w="med" len="med"/>
+                      <a:tailEnd type="none" w="med" len="med"/>
+                    </a:lnT>
+                    <a:lnB w="6350" cap="flat" cmpd="sng" algn="ctr">
+                      <a:solidFill>
+                        <a:srgbClr val="E5E7EB"/>
+                      </a:solidFill>
+                      <a:prstDash val="solid"/>
+                      <a:round/>
+                      <a:headEnd type="none" w="med" len="med"/>
+                      <a:tailEnd type="none" w="med" len="med"/>
+                    </a:lnB>
+                    <a:solidFill>
+                      <a:srgbClr val="FFF5F5"/>
+                    </a:solidFill>
+                  </a:tcPr>
+                </a:tc>
+                <a:tc>
+                  <a:txBody>
+                    <a:bodyPr/>
+                    <a:lstStyle/>
+                    <a:p>
+                      <a:pPr indent="0" marL="0">
+                        <a:buNone/>
+                      </a:pPr>
+                      <a:r>
+                        <a:rPr lang="en-US" sz="1100" b="1" dirty="0">
+                          <a:solidFill>
+                            <a:srgbClr val="0B1220"/>
+                          </a:solidFill>
+                          <a:latin typeface="맑은 고딕" pitchFamily="34" charset="0"/>
+                          <a:ea typeface="맑은 고딕" pitchFamily="34" charset="-122"/>
+                          <a:cs typeface="맑은 고딕" pitchFamily="34" charset="-120"/>
+                        </a:rPr>
+                        <a:t>"Giethoorn" 925 Open Ring</a:t>
+                      </a:r>
+                      <a:endParaRPr lang="en-US" sz="1100" dirty="0">
+                        <a:latin typeface="맑은 고딕" charset="0"/>
+                        <a:ea typeface="맑은 고딕" charset="0"/>
+                        <a:cs typeface="맑은 고딕" charset="0"/>
+                      </a:endParaRPr>
+                    </a:p>
+                  </a:txBody>
+                  <a:tcPr marL="91440" marR="91440" marT="45720" marB="45720" anchor="ctr">
+                    <a:lnL w="6350" cap="flat" cmpd="sng" algn="ctr">
+                      <a:solidFill>
+                        <a:srgbClr val="E5E7EB"/>
+                      </a:solidFill>
+                      <a:prstDash val="solid"/>
+                      <a:round/>
+                      <a:headEnd type="none" w="med" len="med"/>
+                      <a:tailEnd type="none" w="med" len="med"/>
+                    </a:lnL>
+                    <a:lnR w="6350" cap="flat" cmpd="sng" algn="ctr">
+                      <a:solidFill>
+                        <a:srgbClr val="E5E7EB"/>
+                      </a:solidFill>
+                      <a:prstDash val="solid"/>
+                      <a:round/>
+                      <a:headEnd type="none" w="med" len="med"/>
+                      <a:tailEnd type="none" w="med" len="med"/>
+                    </a:lnR>
+                    <a:lnT w="6350" cap="flat" cmpd="sng" algn="ctr">
+                      <a:solidFill>
+                        <a:srgbClr val="E5E7EB"/>
+                      </a:solidFill>
+                      <a:prstDash val="solid"/>
+                      <a:round/>
+                      <a:headEnd type="none" w="med" len="med"/>
+                      <a:tailEnd type="none" w="med" len="med"/>
+                    </a:lnT>
+                    <a:lnB w="6350" cap="flat" cmpd="sng" algn="ctr">
+                      <a:solidFill>
+                        <a:srgbClr val="E5E7EB"/>
+                      </a:solidFill>
+                      <a:prstDash val="solid"/>
+                      <a:round/>
+                      <a:headEnd type="none" w="med" len="med"/>
+                      <a:tailEnd type="none" w="med" len="med"/>
+                    </a:lnB>
+                    <a:solidFill>
+                      <a:srgbClr val="FFF5F5"/>
+                    </a:solidFill>
+                  </a:tcPr>
+                </a:tc>
+                <a:tc>
+                  <a:txBody>
+                    <a:bodyPr/>
+                    <a:lstStyle/>
+                    <a:p>
+                      <a:pPr algn="r" indent="0" marL="0">
+                        <a:buNone/>
+                      </a:pPr>
+                      <a:r>
+                        <a:rPr lang="en-US" sz="1100" b="1" dirty="0">
+                          <a:solidFill>
+                            <a:srgbClr val="D72638"/>
+                          </a:solidFill>
+                          <a:latin typeface="맑은 고딕" pitchFamily="34" charset="0"/>
+                          <a:ea typeface="맑은 고딕" pitchFamily="34" charset="-122"/>
+                          <a:cs typeface="맑은 고딕" pitchFamily="34" charset="-120"/>
+                        </a:rPr>
+                        <a:t>3</a:t>
+                      </a:r>
+                      <a:endParaRPr lang="en-US" sz="1100" dirty="0">
+                        <a:latin typeface="맑은 고딕" charset="0"/>
+                        <a:ea typeface="맑은 고딕" charset="0"/>
+                        <a:cs typeface="맑은 고딕" charset="0"/>
+                      </a:endParaRPr>
+                    </a:p>
+                  </a:txBody>
+                  <a:tcPr marL="91440" marR="91440" marT="45720" marB="45720" anchor="ctr">
+                    <a:lnL w="6350" cap="flat" cmpd="sng" algn="ctr">
+                      <a:solidFill>
+                        <a:srgbClr val="E5E7EB"/>
+                      </a:solidFill>
+                      <a:prstDash val="solid"/>
+                      <a:round/>
+                      <a:headEnd type="none" w="med" len="med"/>
+                      <a:tailEnd type="none" w="med" len="med"/>
+                    </a:lnL>
+                    <a:lnR w="6350" cap="flat" cmpd="sng" algn="ctr">
+                      <a:solidFill>
+                        <a:srgbClr val="E5E7EB"/>
+                      </a:solidFill>
+                      <a:prstDash val="solid"/>
+                      <a:round/>
+                      <a:headEnd type="none" w="med" len="med"/>
+                      <a:tailEnd type="none" w="med" len="med"/>
+                    </a:lnR>
+                    <a:lnT w="6350" cap="flat" cmpd="sng" algn="ctr">
+                      <a:solidFill>
+                        <a:srgbClr val="E5E7EB"/>
+                      </a:solidFill>
+                      <a:prstDash val="solid"/>
+                      <a:round/>
+                      <a:headEnd type="none" w="med" len="med"/>
+                      <a:tailEnd type="none" w="med" len="med"/>
+                    </a:lnT>
+                    <a:lnB w="6350" cap="flat" cmpd="sng" algn="ctr">
+                      <a:solidFill>
+                        <a:srgbClr val="E5E7EB"/>
+                      </a:solidFill>
+                      <a:prstDash val="solid"/>
+                      <a:round/>
+                      <a:headEnd type="none" w="med" len="med"/>
+                      <a:tailEnd type="none" w="med" len="med"/>
+                    </a:lnB>
+                    <a:solidFill>
+                      <a:srgbClr val="FFF5F5"/>
+                    </a:solidFill>
+                  </a:tcPr>
+                </a:tc>
+                <a:tc>
+                  <a:txBody>
+                    <a:bodyPr/>
+                    <a:lstStyle/>
+                    <a:p>
+                      <a:pPr algn="r" indent="0" marL="0">
+                        <a:buNone/>
+                      </a:pPr>
+                      <a:r>
+                        <a:rPr lang="en-US" sz="1100" dirty="0">
+                          <a:solidFill>
+                            <a:srgbClr val="1F2937"/>
+                          </a:solidFill>
+                          <a:latin typeface="맑은 고딕" pitchFamily="34" charset="0"/>
+                          <a:ea typeface="맑은 고딕" pitchFamily="34" charset="-122"/>
+                          <a:cs typeface="맑은 고딕" pitchFamily="34" charset="-120"/>
+                        </a:rPr>
+                        <a:t>2</a:t>
+                      </a:r>
+                      <a:endParaRPr lang="en-US" sz="1100" dirty="0">
+                        <a:latin typeface="맑은 고딕" charset="0"/>
+                        <a:ea typeface="맑은 고딕" charset="0"/>
+                        <a:cs typeface="맑은 고딕" charset="0"/>
+                      </a:endParaRPr>
+                    </a:p>
+                  </a:txBody>
+                  <a:tcPr marL="91440" marR="91440" marT="45720" marB="45720" anchor="ctr">
+                    <a:lnL w="6350" cap="flat" cmpd="sng" algn="ctr">
+                      <a:solidFill>
+                        <a:srgbClr val="E5E7EB"/>
+                      </a:solidFill>
+                      <a:prstDash val="solid"/>
+                      <a:round/>
+                      <a:headEnd type="none" w="med" len="med"/>
+                      <a:tailEnd type="none" w="med" len="med"/>
+                    </a:lnL>
+                    <a:lnR w="6350" cap="flat" cmpd="sng" algn="ctr">
+                      <a:solidFill>
+                        <a:srgbClr val="E5E7EB"/>
+                      </a:solidFill>
+                      <a:prstDash val="solid"/>
+                      <a:round/>
+                      <a:headEnd type="none" w="med" len="med"/>
+                      <a:tailEnd type="none" w="med" len="med"/>
+                    </a:lnR>
+                    <a:lnT w="6350" cap="flat" cmpd="sng" algn="ctr">
+                      <a:solidFill>
+                        <a:srgbClr val="E5E7EB"/>
+                      </a:solidFill>
+                      <a:prstDash val="solid"/>
+                      <a:round/>
+                      <a:headEnd type="none" w="med" len="med"/>
+                      <a:tailEnd type="none" w="med" len="med"/>
+                    </a:lnT>
+                    <a:lnB w="6350" cap="flat" cmpd="sng" algn="ctr">
+                      <a:solidFill>
+                        <a:srgbClr val="E5E7EB"/>
+                      </a:solidFill>
+                      <a:prstDash val="solid"/>
+                      <a:round/>
+                      <a:headEnd type="none" w="med" len="med"/>
+                      <a:tailEnd type="none" w="med" len="med"/>
+                    </a:lnB>
+                    <a:solidFill>
+                      <a:srgbClr val="FFF5F5"/>
+                    </a:solidFill>
+                  </a:tcPr>
+                </a:tc>
+              </a:tr>
+              <a:tr h="384048">
+                <a:tc>
+                  <a:txBody>
+                    <a:bodyPr/>
+                    <a:lstStyle/>
+                    <a:p>
+                      <a:pPr algn="ctr" indent="0" marL="0">
+                        <a:buNone/>
+                      </a:pPr>
+                      <a:r>
+                        <a:rPr lang="en-US" sz="1100" b="1" dirty="0">
+                          <a:solidFill>
+                            <a:srgbClr val="FFFFFF"/>
+                          </a:solidFill>
+                          <a:latin typeface="맑은 고딕" pitchFamily="34" charset="0"/>
+                          <a:ea typeface="맑은 고딕" pitchFamily="34" charset="-122"/>
+                          <a:cs typeface="맑은 고딕" pitchFamily="34" charset="-120"/>
+                        </a:rPr>
+                        <a:t>2</a:t>
+                      </a:r>
+                      <a:endParaRPr lang="en-US" sz="1100" dirty="0">
+                        <a:latin typeface="맑은 고딕" charset="0"/>
+                        <a:ea typeface="맑은 고딕" charset="0"/>
+                        <a:cs typeface="맑은 고딕" charset="0"/>
+                      </a:endParaRPr>
+                    </a:p>
+                  </a:txBody>
+                  <a:tcPr marL="91440" marR="91440" marT="45720" marB="45720" anchor="ctr">
+                    <a:lnL w="6350" cap="flat" cmpd="sng" algn="ctr">
+                      <a:solidFill>
+                        <a:srgbClr val="E5E7EB"/>
+                      </a:solidFill>
+                      <a:prstDash val="solid"/>
+                      <a:round/>
+                      <a:headEnd type="none" w="med" len="med"/>
+                      <a:tailEnd type="none" w="med" len="med"/>
+                    </a:lnL>
+                    <a:lnR w="6350" cap="flat" cmpd="sng" algn="ctr">
+                      <a:solidFill>
+                        <a:srgbClr val="E5E7EB"/>
+                      </a:solidFill>
+                      <a:prstDash val="solid"/>
+                      <a:round/>
+                      <a:headEnd type="none" w="med" len="med"/>
+                      <a:tailEnd type="none" w="med" len="med"/>
+                    </a:lnR>
+                    <a:lnT w="6350" cap="flat" cmpd="sng" algn="ctr">
+                      <a:solidFill>
+                        <a:srgbClr val="E5E7EB"/>
+                      </a:solidFill>
+                      <a:prstDash val="solid"/>
+                      <a:round/>
+                      <a:headEnd type="none" w="med" len="med"/>
+                      <a:tailEnd type="none" w="med" len="med"/>
+                    </a:lnT>
+                    <a:lnB w="6350" cap="flat" cmpd="sng" algn="ctr">
+                      <a:solidFill>
+                        <a:srgbClr val="E5E7EB"/>
+                      </a:solidFill>
+                      <a:prstDash val="solid"/>
+                      <a:round/>
+                      <a:headEnd type="none" w="med" len="med"/>
+                      <a:tailEnd type="none" w="med" len="med"/>
+                    </a:lnB>
+                    <a:solidFill>
+                      <a:srgbClr val="D72638"/>
+                    </a:solidFill>
+                  </a:tcPr>
+                </a:tc>
+                <a:tc>
+                  <a:txBody>
+                    <a:bodyPr/>
+                    <a:lstStyle/>
+                    <a:p>
+                      <a:pPr algn="ctr" indent="0" marL="0">
+                        <a:buNone/>
+                      </a:pPr>
+                      <a:r>
+                        <a:rPr lang="en-US" sz="1100" b="1" dirty="0">
+                          <a:solidFill>
+                            <a:srgbClr val="1F2937"/>
+                          </a:solidFill>
+                          <a:latin typeface="맑은 고딕" pitchFamily="34" charset="0"/>
+                          <a:ea typeface="맑은 고딕" pitchFamily="34" charset="-122"/>
+                          <a:cs typeface="맑은 고딕" pitchFamily="34" charset="-120"/>
+                        </a:rPr>
+                        <a:t>PP</a:t>
+                      </a:r>
+                      <a:endParaRPr lang="en-US" sz="1100" dirty="0">
+                        <a:latin typeface="맑은 고딕" charset="0"/>
+                        <a:ea typeface="맑은 고딕" charset="0"/>
+                        <a:cs typeface="맑은 고딕" charset="0"/>
+                      </a:endParaRPr>
+                    </a:p>
+                  </a:txBody>
+                  <a:tcPr marL="91440" marR="91440" marT="45720" marB="45720" anchor="ctr">
+                    <a:lnL w="6350" cap="flat" cmpd="sng" algn="ctr">
+                      <a:solidFill>
+                        <a:srgbClr val="E5E7EB"/>
+                      </a:solidFill>
+                      <a:prstDash val="solid"/>
+                      <a:round/>
+                      <a:headEnd type="none" w="med" len="med"/>
+                      <a:tailEnd type="none" w="med" len="med"/>
+                    </a:lnL>
+                    <a:lnR w="6350" cap="flat" cmpd="sng" algn="ctr">
+                      <a:solidFill>
+                        <a:srgbClr val="E5E7EB"/>
+                      </a:solidFill>
+                      <a:prstDash val="solid"/>
+                      <a:round/>
+                      <a:headEnd type="none" w="med" len="med"/>
+                      <a:tailEnd type="none" w="med" len="med"/>
+                    </a:lnR>
+                    <a:lnT w="6350" cap="flat" cmpd="sng" algn="ctr">
+                      <a:solidFill>
+                        <a:srgbClr val="E5E7EB"/>
+                      </a:solidFill>
+                      <a:prstDash val="solid"/>
+                      <a:round/>
+                      <a:headEnd type="none" w="med" len="med"/>
+                      <a:tailEnd type="none" w="med" len="med"/>
+                    </a:lnT>
+                    <a:lnB w="6350" cap="flat" cmpd="sng" algn="ctr">
+                      <a:solidFill>
+                        <a:srgbClr val="E5E7EB"/>
+                      </a:solidFill>
+                      <a:prstDash val="solid"/>
+                      <a:round/>
+                      <a:headEnd type="none" w="med" len="med"/>
+                      <a:tailEnd type="none" w="med" len="med"/>
+                    </a:lnB>
+                    <a:solidFill>
+                      <a:srgbClr val="FFF5F5"/>
+                    </a:solidFill>
+                  </a:tcPr>
+                </a:tc>
+                <a:tc>
+                  <a:txBody>
+                    <a:bodyPr/>
+                    <a:lstStyle/>
+                    <a:p>
+                      <a:pPr indent="0" marL="0">
+                        <a:buNone/>
+                      </a:pPr>
+                      <a:r>
+                        <a:rPr lang="en-US" sz="1000" dirty="0">
+                          <a:solidFill>
+                            <a:srgbClr val="6B7280"/>
+                          </a:solidFill>
+                          <a:latin typeface="맑은 고딕" pitchFamily="34" charset="0"/>
+                          <a:ea typeface="맑은 고딕" pitchFamily="34" charset="-122"/>
+                          <a:cs typeface="맑은 고딕" pitchFamily="34" charset="-120"/>
+                        </a:rPr>
+                        <a:t>ELECTRONIC</a:t>
+                      </a:r>
+                      <a:endParaRPr lang="en-US" sz="1000" dirty="0">
+                        <a:latin typeface="맑은 고딕" charset="0"/>
+                        <a:ea typeface="맑은 고딕" charset="0"/>
+                        <a:cs typeface="맑은 고딕" charset="0"/>
+                      </a:endParaRPr>
+                    </a:p>
+                  </a:txBody>
+                  <a:tcPr marL="91440" marR="91440" marT="45720" marB="45720" anchor="ctr">
+                    <a:lnL w="6350" cap="flat" cmpd="sng" algn="ctr">
+                      <a:solidFill>
+                        <a:srgbClr val="E5E7EB"/>
+                      </a:solidFill>
+                      <a:prstDash val="solid"/>
+                      <a:round/>
+                      <a:headEnd type="none" w="med" len="med"/>
+                      <a:tailEnd type="none" w="med" len="med"/>
+                    </a:lnL>
+                    <a:lnR w="6350" cap="flat" cmpd="sng" algn="ctr">
+                      <a:solidFill>
+                        <a:srgbClr val="E5E7EB"/>
+                      </a:solidFill>
+                      <a:prstDash val="solid"/>
+                      <a:round/>
+                      <a:headEnd type="none" w="med" len="med"/>
+                      <a:tailEnd type="none" w="med" len="med"/>
+                    </a:lnR>
+                    <a:lnT w="6350" cap="flat" cmpd="sng" algn="ctr">
+                      <a:solidFill>
+                        <a:srgbClr val="E5E7EB"/>
+                      </a:solidFill>
+                      <a:prstDash val="solid"/>
+                      <a:round/>
+                      <a:headEnd type="none" w="med" len="med"/>
+                      <a:tailEnd type="none" w="med" len="med"/>
+                    </a:lnT>
+                    <a:lnB w="6350" cap="flat" cmpd="sng" algn="ctr">
+                      <a:solidFill>
+                        <a:srgbClr val="E5E7EB"/>
+                      </a:solidFill>
+                      <a:prstDash val="solid"/>
+                      <a:round/>
+                      <a:headEnd type="none" w="med" len="med"/>
+                      <a:tailEnd type="none" w="med" len="med"/>
+                    </a:lnB>
+                    <a:solidFill>
+                      <a:srgbClr val="FFF5F5"/>
+                    </a:solidFill>
+                  </a:tcPr>
+                </a:tc>
+                <a:tc>
+                  <a:txBody>
+                    <a:bodyPr/>
+                    <a:lstStyle/>
+                    <a:p>
+                      <a:pPr indent="0" marL="0">
+                        <a:buNone/>
+                      </a:pPr>
+                      <a:r>
+                        <a:rPr lang="en-US" sz="1100" b="1" dirty="0">
+                          <a:solidFill>
+                            <a:srgbClr val="0B1220"/>
+                          </a:solidFill>
+                          <a:latin typeface="맑은 고딕" pitchFamily="34" charset="0"/>
+                          <a:ea typeface="맑은 고딕" pitchFamily="34" charset="-122"/>
+                          <a:cs typeface="맑은 고딕" pitchFamily="34" charset="-120"/>
+                        </a:rPr>
+                        <a:t>180° Fast Charging Cable (8color) (컬러: 블루 / 기종 옵션: C type -&gt; C type)</a:t>
+                      </a:r>
+                      <a:endParaRPr lang="en-US" sz="1100" dirty="0">
+                        <a:latin typeface="맑은 고딕" charset="0"/>
+                        <a:ea typeface="맑은 고딕" charset="0"/>
+                        <a:cs typeface="맑은 고딕" charset="0"/>
+                      </a:endParaRPr>
+                    </a:p>
+                  </a:txBody>
+                  <a:tcPr marL="91440" marR="91440" marT="45720" marB="45720" anchor="ctr">
+                    <a:lnL w="6350" cap="flat" cmpd="sng" algn="ctr">
+                      <a:solidFill>
+                        <a:srgbClr val="E5E7EB"/>
+                      </a:solidFill>
+                      <a:prstDash val="solid"/>
+                      <a:round/>
+                      <a:headEnd type="none" w="med" len="med"/>
+                      <a:tailEnd type="none" w="med" len="med"/>
+                    </a:lnL>
+                    <a:lnR w="6350" cap="flat" cmpd="sng" algn="ctr">
+                      <a:solidFill>
+                        <a:srgbClr val="E5E7EB"/>
+                      </a:solidFill>
+                      <a:prstDash val="solid"/>
+                      <a:round/>
+                      <a:headEnd type="none" w="med" len="med"/>
+                      <a:tailEnd type="none" w="med" len="med"/>
+                    </a:lnR>
+                    <a:lnT w="6350" cap="flat" cmpd="sng" algn="ctr">
+                      <a:solidFill>
+                        <a:srgbClr val="E5E7EB"/>
+                      </a:solidFill>
+                      <a:prstDash val="solid"/>
+                      <a:round/>
+                      <a:headEnd type="none" w="med" len="med"/>
+                      <a:tailEnd type="none" w="med" len="med"/>
+                    </a:lnT>
+                    <a:lnB w="6350" cap="flat" cmpd="sng" algn="ctr">
+                      <a:solidFill>
+                        <a:srgbClr val="E5E7EB"/>
+                      </a:solidFill>
+                      <a:prstDash val="solid"/>
+                      <a:round/>
+                      <a:headEnd type="none" w="med" len="med"/>
+                      <a:tailEnd type="none" w="med" len="med"/>
+                    </a:lnB>
+                    <a:solidFill>
+                      <a:srgbClr val="FFF5F5"/>
+                    </a:solidFill>
+                  </a:tcPr>
+                </a:tc>
+                <a:tc>
+                  <a:txBody>
+                    <a:bodyPr/>
+                    <a:lstStyle/>
+                    <a:p>
+                      <a:pPr algn="r" indent="0" marL="0">
+                        <a:buNone/>
+                      </a:pPr>
+                      <a:r>
+                        <a:rPr lang="en-US" sz="1100" b="1" dirty="0">
+                          <a:solidFill>
+                            <a:srgbClr val="D72638"/>
+                          </a:solidFill>
+                          <a:latin typeface="맑은 고딕" pitchFamily="34" charset="0"/>
+                          <a:ea typeface="맑은 고딕" pitchFamily="34" charset="-122"/>
+                          <a:cs typeface="맑은 고딕" pitchFamily="34" charset="-120"/>
+                        </a:rPr>
+                        <a:t>3</a:t>
+                      </a:r>
+                      <a:endParaRPr lang="en-US" sz="1100" dirty="0">
+                        <a:latin typeface="맑은 고딕" charset="0"/>
+                        <a:ea typeface="맑은 고딕" charset="0"/>
+                        <a:cs typeface="맑은 고딕" charset="0"/>
+                      </a:endParaRPr>
+                    </a:p>
+                  </a:txBody>
+                  <a:tcPr marL="91440" marR="91440" marT="45720" marB="45720" anchor="ctr">
+                    <a:lnL w="6350" cap="flat" cmpd="sng" algn="ctr">
+                      <a:solidFill>
+                        <a:srgbClr val="E5E7EB"/>
+                      </a:solidFill>
+                      <a:prstDash val="solid"/>
+                      <a:round/>
+                      <a:headEnd type="none" w="med" len="med"/>
+                      <a:tailEnd type="none" w="med" len="med"/>
+                    </a:lnL>
+                    <a:lnR w="6350" cap="flat" cmpd="sng" algn="ctr">
+                      <a:solidFill>
+                        <a:srgbClr val="E5E7EB"/>
+                      </a:solidFill>
+                      <a:prstDash val="solid"/>
+                      <a:round/>
+                      <a:headEnd type="none" w="med" len="med"/>
+                      <a:tailEnd type="none" w="med" len="med"/>
+                    </a:lnR>
+                    <a:lnT w="6350" cap="flat" cmpd="sng" algn="ctr">
+                      <a:solidFill>
+                        <a:srgbClr val="E5E7EB"/>
+                      </a:solidFill>
+                      <a:prstDash val="solid"/>
+                      <a:round/>
+                      <a:headEnd type="none" w="med" len="med"/>
+                      <a:tailEnd type="none" w="med" len="med"/>
+                    </a:lnT>
+                    <a:lnB w="6350" cap="flat" cmpd="sng" algn="ctr">
+                      <a:solidFill>
+                        <a:srgbClr val="E5E7EB"/>
+                      </a:solidFill>
+                      <a:prstDash val="solid"/>
+                      <a:round/>
+                      <a:headEnd type="none" w="med" len="med"/>
+                      <a:tailEnd type="none" w="med" len="med"/>
+                    </a:lnB>
+                    <a:solidFill>
+                      <a:srgbClr val="FFF5F5"/>
+                    </a:solidFill>
+                  </a:tcPr>
+                </a:tc>
+                <a:tc>
+                  <a:txBody>
+                    <a:bodyPr/>
+                    <a:lstStyle/>
+                    <a:p>
+                      <a:pPr algn="r" indent="0" marL="0">
+                        <a:buNone/>
+                      </a:pPr>
+                      <a:r>
+                        <a:rPr lang="en-US" sz="1100" dirty="0">
+                          <a:solidFill>
+                            <a:srgbClr val="1F2937"/>
+                          </a:solidFill>
+                          <a:latin typeface="맑은 고딕" pitchFamily="34" charset="0"/>
+                          <a:ea typeface="맑은 고딕" pitchFamily="34" charset="-122"/>
+                          <a:cs typeface="맑은 고딕" pitchFamily="34" charset="-120"/>
+                        </a:rPr>
+                        <a:t>0</a:t>
+                      </a:r>
+                      <a:endParaRPr lang="en-US" sz="1100" dirty="0">
+                        <a:latin typeface="맑은 고딕" charset="0"/>
+                        <a:ea typeface="맑은 고딕" charset="0"/>
+                        <a:cs typeface="맑은 고딕" charset="0"/>
+                      </a:endParaRPr>
+                    </a:p>
+                  </a:txBody>
+                  <a:tcPr marL="91440" marR="91440" marT="45720" marB="45720" anchor="ctr">
+                    <a:lnL w="6350" cap="flat" cmpd="sng" algn="ctr">
+                      <a:solidFill>
+                        <a:srgbClr val="E5E7EB"/>
+                      </a:solidFill>
+                      <a:prstDash val="solid"/>
+                      <a:round/>
+                      <a:headEnd type="none" w="med" len="med"/>
+                      <a:tailEnd type="none" w="med" len="med"/>
+                    </a:lnL>
+                    <a:lnR w="6350" cap="flat" cmpd="sng" algn="ctr">
+                      <a:solidFill>
+                        <a:srgbClr val="E5E7EB"/>
+                      </a:solidFill>
+                      <a:prstDash val="solid"/>
+                      <a:round/>
+                      <a:headEnd type="none" w="med" len="med"/>
+                      <a:tailEnd type="none" w="med" len="med"/>
+                    </a:lnR>
+                    <a:lnT w="6350" cap="flat" cmpd="sng" algn="ctr">
+                      <a:solidFill>
+                        <a:srgbClr val="E5E7EB"/>
+                      </a:solidFill>
+                      <a:prstDash val="solid"/>
+                      <a:round/>
+                      <a:headEnd type="none" w="med" len="med"/>
+                      <a:tailEnd type="none" w="med" len="med"/>
+                    </a:lnT>
+                    <a:lnB w="6350" cap="flat" cmpd="sng" algn="ctr">
+                      <a:solidFill>
+                        <a:srgbClr val="E5E7EB"/>
+                      </a:solidFill>
+                      <a:prstDash val="solid"/>
+                      <a:round/>
+                      <a:headEnd type="none" w="med" len="med"/>
+                      <a:tailEnd type="none" w="med" len="med"/>
+                    </a:lnB>
+                    <a:solidFill>
+                      <a:srgbClr val="FFF5F5"/>
+                    </a:solidFill>
+                  </a:tcPr>
+                </a:tc>
+              </a:tr>
+              <a:tr h="384048">
+                <a:tc>
+                  <a:txBody>
+                    <a:bodyPr/>
+                    <a:lstStyle/>
+                    <a:p>
+                      <a:pPr algn="ctr" indent="0" marL="0">
+                        <a:buNone/>
+                      </a:pPr>
+                      <a:r>
+                        <a:rPr lang="en-US" sz="1100" b="1" dirty="0">
+                          <a:solidFill>
+                            <a:srgbClr val="FFFFFF"/>
+                          </a:solidFill>
+                          <a:latin typeface="맑은 고딕" pitchFamily="34" charset="0"/>
+                          <a:ea typeface="맑은 고딕" pitchFamily="34" charset="-122"/>
+                          <a:cs typeface="맑은 고딕" pitchFamily="34" charset="-120"/>
+                        </a:rPr>
+                        <a:t>3</a:t>
                       </a:r>
                       <a:endParaRPr lang="en-US" sz="1100" dirty="0">
                         <a:latin typeface="맑은 고딕" charset="0"/>
@@ -14595,7 +15415,7 @@
                           <a:ea typeface="맑은 고딕" pitchFamily="34" charset="-122"/>
                           <a:cs typeface="맑은 고딕" pitchFamily="34" charset="-120"/>
                         </a:rPr>
-                        <a:t>Bracelet</a:t>
+                        <a:t>Necklace</a:t>
                       </a:r>
                       <a:endParaRPr lang="en-US" sz="1000" dirty="0">
                         <a:latin typeface="맑은 고딕" charset="0"/>
@@ -14663,7 +15483,7 @@
                           <a:ea typeface="맑은 고딕" pitchFamily="34" charset="-122"/>
                           <a:cs typeface="맑은 고딕" pitchFamily="34" charset="-120"/>
                         </a:rPr>
-                        <a:t>Two-ball Bangle</a:t>
+                        <a:t>RichardKokser Necklace</a:t>
                       </a:r>
                       <a:endParaRPr lang="en-US" sz="1100" dirty="0">
                         <a:latin typeface="맑은 고딕" charset="0"/>
@@ -14731,7 +15551,7 @@
                           <a:ea typeface="맑은 고딕" pitchFamily="34" charset="-122"/>
                           <a:cs typeface="맑은 고딕" pitchFamily="34" charset="-120"/>
                         </a:rPr>
-                        <a:t>0</a:t>
+                        <a:t>2</a:t>
                       </a:r>
                       <a:endParaRPr lang="en-US" sz="1100" dirty="0">
                         <a:latin typeface="맑은 고딕" charset="0"/>
@@ -14799,7 +15619,7 @@
                           <a:ea typeface="맑은 고딕" pitchFamily="34" charset="-122"/>
                           <a:cs typeface="맑은 고딕" pitchFamily="34" charset="-120"/>
                         </a:rPr>
-                        <a:t>5 개</a:t>
+                        <a:t>0</a:t>
                       </a:r>
                       <a:endParaRPr lang="en-US" sz="1100" dirty="0">
                         <a:latin typeface="맑은 고딕" charset="0"/>
@@ -14869,7 +15689,417 @@
                           <a:ea typeface="맑은 고딕" pitchFamily="34" charset="-122"/>
                           <a:cs typeface="맑은 고딕" pitchFamily="34" charset="-120"/>
                         </a:rPr>
-                        <a:t>긴급</a:t>
+                        <a:t>4</a:t>
+                      </a:r>
+                      <a:endParaRPr lang="en-US" sz="1100" dirty="0">
+                        <a:latin typeface="맑은 고딕" charset="0"/>
+                        <a:ea typeface="맑은 고딕" charset="0"/>
+                        <a:cs typeface="맑은 고딕" charset="0"/>
+                      </a:endParaRPr>
+                    </a:p>
+                  </a:txBody>
+                  <a:tcPr marL="91440" marR="91440" marT="45720" marB="45720" anchor="ctr">
+                    <a:lnL w="6350" cap="flat" cmpd="sng" algn="ctr">
+                      <a:solidFill>
+                        <a:srgbClr val="E5E7EB"/>
+                      </a:solidFill>
+                      <a:prstDash val="solid"/>
+                      <a:round/>
+                      <a:headEnd type="none" w="med" len="med"/>
+                      <a:tailEnd type="none" w="med" len="med"/>
+                    </a:lnL>
+                    <a:lnR w="6350" cap="flat" cmpd="sng" algn="ctr">
+                      <a:solidFill>
+                        <a:srgbClr val="E5E7EB"/>
+                      </a:solidFill>
+                      <a:prstDash val="solid"/>
+                      <a:round/>
+                      <a:headEnd type="none" w="med" len="med"/>
+                      <a:tailEnd type="none" w="med" len="med"/>
+                    </a:lnR>
+                    <a:lnT w="6350" cap="flat" cmpd="sng" algn="ctr">
+                      <a:solidFill>
+                        <a:srgbClr val="E5E7EB"/>
+                      </a:solidFill>
+                      <a:prstDash val="solid"/>
+                      <a:round/>
+                      <a:headEnd type="none" w="med" len="med"/>
+                      <a:tailEnd type="none" w="med" len="med"/>
+                    </a:lnT>
+                    <a:lnB w="6350" cap="flat" cmpd="sng" algn="ctr">
+                      <a:solidFill>
+                        <a:srgbClr val="E5E7EB"/>
+                      </a:solidFill>
+                      <a:prstDash val="solid"/>
+                      <a:round/>
+                      <a:headEnd type="none" w="med" len="med"/>
+                      <a:tailEnd type="none" w="med" len="med"/>
+                    </a:lnB>
+                    <a:solidFill>
+                      <a:srgbClr val="D72638"/>
+                    </a:solidFill>
+                  </a:tcPr>
+                </a:tc>
+                <a:tc>
+                  <a:txBody>
+                    <a:bodyPr/>
+                    <a:lstStyle/>
+                    <a:p>
+                      <a:pPr algn="ctr" indent="0" marL="0">
+                        <a:buNone/>
+                      </a:pPr>
+                      <a:r>
+                        <a:rPr lang="en-US" sz="1100" b="1" dirty="0">
+                          <a:solidFill>
+                            <a:srgbClr val="1F2937"/>
+                          </a:solidFill>
+                          <a:latin typeface="맑은 고딕" pitchFamily="34" charset="0"/>
+                          <a:ea typeface="맑은 고딕" pitchFamily="34" charset="-122"/>
+                          <a:cs typeface="맑은 고딕" pitchFamily="34" charset="-120"/>
+                        </a:rPr>
+                        <a:t>PP</a:t>
+                      </a:r>
+                      <a:endParaRPr lang="en-US" sz="1100" dirty="0">
+                        <a:latin typeface="맑은 고딕" charset="0"/>
+                        <a:ea typeface="맑은 고딕" charset="0"/>
+                        <a:cs typeface="맑은 고딕" charset="0"/>
+                      </a:endParaRPr>
+                    </a:p>
+                  </a:txBody>
+                  <a:tcPr marL="91440" marR="91440" marT="45720" marB="45720" anchor="ctr">
+                    <a:lnL w="6350" cap="flat" cmpd="sng" algn="ctr">
+                      <a:solidFill>
+                        <a:srgbClr val="E5E7EB"/>
+                      </a:solidFill>
+                      <a:prstDash val="solid"/>
+                      <a:round/>
+                      <a:headEnd type="none" w="med" len="med"/>
+                      <a:tailEnd type="none" w="med" len="med"/>
+                    </a:lnL>
+                    <a:lnR w="6350" cap="flat" cmpd="sng" algn="ctr">
+                      <a:solidFill>
+                        <a:srgbClr val="E5E7EB"/>
+                      </a:solidFill>
+                      <a:prstDash val="solid"/>
+                      <a:round/>
+                      <a:headEnd type="none" w="med" len="med"/>
+                      <a:tailEnd type="none" w="med" len="med"/>
+                    </a:lnR>
+                    <a:lnT w="6350" cap="flat" cmpd="sng" algn="ctr">
+                      <a:solidFill>
+                        <a:srgbClr val="E5E7EB"/>
+                      </a:solidFill>
+                      <a:prstDash val="solid"/>
+                      <a:round/>
+                      <a:headEnd type="none" w="med" len="med"/>
+                      <a:tailEnd type="none" w="med" len="med"/>
+                    </a:lnT>
+                    <a:lnB w="6350" cap="flat" cmpd="sng" algn="ctr">
+                      <a:solidFill>
+                        <a:srgbClr val="E5E7EB"/>
+                      </a:solidFill>
+                      <a:prstDash val="solid"/>
+                      <a:round/>
+                      <a:headEnd type="none" w="med" len="med"/>
+                      <a:tailEnd type="none" w="med" len="med"/>
+                    </a:lnB>
+                    <a:solidFill>
+                      <a:srgbClr val="FFF5F5"/>
+                    </a:solidFill>
+                  </a:tcPr>
+                </a:tc>
+                <a:tc>
+                  <a:txBody>
+                    <a:bodyPr/>
+                    <a:lstStyle/>
+                    <a:p>
+                      <a:pPr indent="0" marL="0">
+                        <a:buNone/>
+                      </a:pPr>
+                      <a:r>
+                        <a:rPr lang="en-US" sz="1000" dirty="0">
+                          <a:solidFill>
+                            <a:srgbClr val="6B7280"/>
+                          </a:solidFill>
+                          <a:latin typeface="맑은 고딕" pitchFamily="34" charset="0"/>
+                          <a:ea typeface="맑은 고딕" pitchFamily="34" charset="-122"/>
+                          <a:cs typeface="맑은 고딕" pitchFamily="34" charset="-120"/>
+                        </a:rPr>
+                        <a:t>ELECTRONIC</a:t>
+                      </a:r>
+                      <a:endParaRPr lang="en-US" sz="1000" dirty="0">
+                        <a:latin typeface="맑은 고딕" charset="0"/>
+                        <a:ea typeface="맑은 고딕" charset="0"/>
+                        <a:cs typeface="맑은 고딕" charset="0"/>
+                      </a:endParaRPr>
+                    </a:p>
+                  </a:txBody>
+                  <a:tcPr marL="91440" marR="91440" marT="45720" marB="45720" anchor="ctr">
+                    <a:lnL w="6350" cap="flat" cmpd="sng" algn="ctr">
+                      <a:solidFill>
+                        <a:srgbClr val="E5E7EB"/>
+                      </a:solidFill>
+                      <a:prstDash val="solid"/>
+                      <a:round/>
+                      <a:headEnd type="none" w="med" len="med"/>
+                      <a:tailEnd type="none" w="med" len="med"/>
+                    </a:lnL>
+                    <a:lnR w="6350" cap="flat" cmpd="sng" algn="ctr">
+                      <a:solidFill>
+                        <a:srgbClr val="E5E7EB"/>
+                      </a:solidFill>
+                      <a:prstDash val="solid"/>
+                      <a:round/>
+                      <a:headEnd type="none" w="med" len="med"/>
+                      <a:tailEnd type="none" w="med" len="med"/>
+                    </a:lnR>
+                    <a:lnT w="6350" cap="flat" cmpd="sng" algn="ctr">
+                      <a:solidFill>
+                        <a:srgbClr val="E5E7EB"/>
+                      </a:solidFill>
+                      <a:prstDash val="solid"/>
+                      <a:round/>
+                      <a:headEnd type="none" w="med" len="med"/>
+                      <a:tailEnd type="none" w="med" len="med"/>
+                    </a:lnT>
+                    <a:lnB w="6350" cap="flat" cmpd="sng" algn="ctr">
+                      <a:solidFill>
+                        <a:srgbClr val="E5E7EB"/>
+                      </a:solidFill>
+                      <a:prstDash val="solid"/>
+                      <a:round/>
+                      <a:headEnd type="none" w="med" len="med"/>
+                      <a:tailEnd type="none" w="med" len="med"/>
+                    </a:lnB>
+                    <a:solidFill>
+                      <a:srgbClr val="FFF5F5"/>
+                    </a:solidFill>
+                  </a:tcPr>
+                </a:tc>
+                <a:tc>
+                  <a:txBody>
+                    <a:bodyPr/>
+                    <a:lstStyle/>
+                    <a:p>
+                      <a:pPr indent="0" marL="0">
+                        <a:buNone/>
+                      </a:pPr>
+                      <a:r>
+                        <a:rPr lang="en-US" sz="1100" b="1" dirty="0">
+                          <a:solidFill>
+                            <a:srgbClr val="0B1220"/>
+                          </a:solidFill>
+                          <a:latin typeface="맑은 고딕" pitchFamily="34" charset="0"/>
+                          <a:ea typeface="맑은 고딕" pitchFamily="34" charset="-122"/>
+                          <a:cs typeface="맑은 고딕" pitchFamily="34" charset="-120"/>
+                        </a:rPr>
+                        <a:t>180° Fast Charging Cable (8color) (컬러: 네온그린 / 기종 옵션: C type -&gt; C type)</a:t>
+                      </a:r>
+                      <a:endParaRPr lang="en-US" sz="1100" dirty="0">
+                        <a:latin typeface="맑은 고딕" charset="0"/>
+                        <a:ea typeface="맑은 고딕" charset="0"/>
+                        <a:cs typeface="맑은 고딕" charset="0"/>
+                      </a:endParaRPr>
+                    </a:p>
+                  </a:txBody>
+                  <a:tcPr marL="91440" marR="91440" marT="45720" marB="45720" anchor="ctr">
+                    <a:lnL w="6350" cap="flat" cmpd="sng" algn="ctr">
+                      <a:solidFill>
+                        <a:srgbClr val="E5E7EB"/>
+                      </a:solidFill>
+                      <a:prstDash val="solid"/>
+                      <a:round/>
+                      <a:headEnd type="none" w="med" len="med"/>
+                      <a:tailEnd type="none" w="med" len="med"/>
+                    </a:lnL>
+                    <a:lnR w="6350" cap="flat" cmpd="sng" algn="ctr">
+                      <a:solidFill>
+                        <a:srgbClr val="E5E7EB"/>
+                      </a:solidFill>
+                      <a:prstDash val="solid"/>
+                      <a:round/>
+                      <a:headEnd type="none" w="med" len="med"/>
+                      <a:tailEnd type="none" w="med" len="med"/>
+                    </a:lnR>
+                    <a:lnT w="6350" cap="flat" cmpd="sng" algn="ctr">
+                      <a:solidFill>
+                        <a:srgbClr val="E5E7EB"/>
+                      </a:solidFill>
+                      <a:prstDash val="solid"/>
+                      <a:round/>
+                      <a:headEnd type="none" w="med" len="med"/>
+                      <a:tailEnd type="none" w="med" len="med"/>
+                    </a:lnT>
+                    <a:lnB w="6350" cap="flat" cmpd="sng" algn="ctr">
+                      <a:solidFill>
+                        <a:srgbClr val="E5E7EB"/>
+                      </a:solidFill>
+                      <a:prstDash val="solid"/>
+                      <a:round/>
+                      <a:headEnd type="none" w="med" len="med"/>
+                      <a:tailEnd type="none" w="med" len="med"/>
+                    </a:lnB>
+                    <a:solidFill>
+                      <a:srgbClr val="FFF5F5"/>
+                    </a:solidFill>
+                  </a:tcPr>
+                </a:tc>
+                <a:tc>
+                  <a:txBody>
+                    <a:bodyPr/>
+                    <a:lstStyle/>
+                    <a:p>
+                      <a:pPr algn="r" indent="0" marL="0">
+                        <a:buNone/>
+                      </a:pPr>
+                      <a:r>
+                        <a:rPr lang="en-US" sz="1100" b="1" dirty="0">
+                          <a:solidFill>
+                            <a:srgbClr val="D72638"/>
+                          </a:solidFill>
+                          <a:latin typeface="맑은 고딕" pitchFamily="34" charset="0"/>
+                          <a:ea typeface="맑은 고딕" pitchFamily="34" charset="-122"/>
+                          <a:cs typeface="맑은 고딕" pitchFamily="34" charset="-120"/>
+                        </a:rPr>
+                        <a:t>2</a:t>
+                      </a:r>
+                      <a:endParaRPr lang="en-US" sz="1100" dirty="0">
+                        <a:latin typeface="맑은 고딕" charset="0"/>
+                        <a:ea typeface="맑은 고딕" charset="0"/>
+                        <a:cs typeface="맑은 고딕" charset="0"/>
+                      </a:endParaRPr>
+                    </a:p>
+                  </a:txBody>
+                  <a:tcPr marL="91440" marR="91440" marT="45720" marB="45720" anchor="ctr">
+                    <a:lnL w="6350" cap="flat" cmpd="sng" algn="ctr">
+                      <a:solidFill>
+                        <a:srgbClr val="E5E7EB"/>
+                      </a:solidFill>
+                      <a:prstDash val="solid"/>
+                      <a:round/>
+                      <a:headEnd type="none" w="med" len="med"/>
+                      <a:tailEnd type="none" w="med" len="med"/>
+                    </a:lnL>
+                    <a:lnR w="6350" cap="flat" cmpd="sng" algn="ctr">
+                      <a:solidFill>
+                        <a:srgbClr val="E5E7EB"/>
+                      </a:solidFill>
+                      <a:prstDash val="solid"/>
+                      <a:round/>
+                      <a:headEnd type="none" w="med" len="med"/>
+                      <a:tailEnd type="none" w="med" len="med"/>
+                    </a:lnR>
+                    <a:lnT w="6350" cap="flat" cmpd="sng" algn="ctr">
+                      <a:solidFill>
+                        <a:srgbClr val="E5E7EB"/>
+                      </a:solidFill>
+                      <a:prstDash val="solid"/>
+                      <a:round/>
+                      <a:headEnd type="none" w="med" len="med"/>
+                      <a:tailEnd type="none" w="med" len="med"/>
+                    </a:lnT>
+                    <a:lnB w="6350" cap="flat" cmpd="sng" algn="ctr">
+                      <a:solidFill>
+                        <a:srgbClr val="E5E7EB"/>
+                      </a:solidFill>
+                      <a:prstDash val="solid"/>
+                      <a:round/>
+                      <a:headEnd type="none" w="med" len="med"/>
+                      <a:tailEnd type="none" w="med" len="med"/>
+                    </a:lnB>
+                    <a:solidFill>
+                      <a:srgbClr val="FFF5F5"/>
+                    </a:solidFill>
+                  </a:tcPr>
+                </a:tc>
+                <a:tc>
+                  <a:txBody>
+                    <a:bodyPr/>
+                    <a:lstStyle/>
+                    <a:p>
+                      <a:pPr algn="r" indent="0" marL="0">
+                        <a:buNone/>
+                      </a:pPr>
+                      <a:r>
+                        <a:rPr lang="en-US" sz="1100" dirty="0">
+                          <a:solidFill>
+                            <a:srgbClr val="1F2937"/>
+                          </a:solidFill>
+                          <a:latin typeface="맑은 고딕" pitchFamily="34" charset="0"/>
+                          <a:ea typeface="맑은 고딕" pitchFamily="34" charset="-122"/>
+                          <a:cs typeface="맑은 고딕" pitchFamily="34" charset="-120"/>
+                        </a:rPr>
+                        <a:t>0</a:t>
+                      </a:r>
+                      <a:endParaRPr lang="en-US" sz="1100" dirty="0">
+                        <a:latin typeface="맑은 고딕" charset="0"/>
+                        <a:ea typeface="맑은 고딕" charset="0"/>
+                        <a:cs typeface="맑은 고딕" charset="0"/>
+                      </a:endParaRPr>
+                    </a:p>
+                  </a:txBody>
+                  <a:tcPr marL="91440" marR="91440" marT="45720" marB="45720" anchor="ctr">
+                    <a:lnL w="6350" cap="flat" cmpd="sng" algn="ctr">
+                      <a:solidFill>
+                        <a:srgbClr val="E5E7EB"/>
+                      </a:solidFill>
+                      <a:prstDash val="solid"/>
+                      <a:round/>
+                      <a:headEnd type="none" w="med" len="med"/>
+                      <a:tailEnd type="none" w="med" len="med"/>
+                    </a:lnL>
+                    <a:lnR w="6350" cap="flat" cmpd="sng" algn="ctr">
+                      <a:solidFill>
+                        <a:srgbClr val="E5E7EB"/>
+                      </a:solidFill>
+                      <a:prstDash val="solid"/>
+                      <a:round/>
+                      <a:headEnd type="none" w="med" len="med"/>
+                      <a:tailEnd type="none" w="med" len="med"/>
+                    </a:lnR>
+                    <a:lnT w="6350" cap="flat" cmpd="sng" algn="ctr">
+                      <a:solidFill>
+                        <a:srgbClr val="E5E7EB"/>
+                      </a:solidFill>
+                      <a:prstDash val="solid"/>
+                      <a:round/>
+                      <a:headEnd type="none" w="med" len="med"/>
+                      <a:tailEnd type="none" w="med" len="med"/>
+                    </a:lnT>
+                    <a:lnB w="6350" cap="flat" cmpd="sng" algn="ctr">
+                      <a:solidFill>
+                        <a:srgbClr val="E5E7EB"/>
+                      </a:solidFill>
+                      <a:prstDash val="solid"/>
+                      <a:round/>
+                      <a:headEnd type="none" w="med" len="med"/>
+                      <a:tailEnd type="none" w="med" len="med"/>
+                    </a:lnB>
+                    <a:solidFill>
+                      <a:srgbClr val="FFF5F5"/>
+                    </a:solidFill>
+                  </a:tcPr>
+                </a:tc>
+              </a:tr>
+              <a:tr h="384048">
+                <a:tc>
+                  <a:txBody>
+                    <a:bodyPr/>
+                    <a:lstStyle/>
+                    <a:p>
+                      <a:pPr algn="ctr" indent="0" marL="0">
+                        <a:buNone/>
+                      </a:pPr>
+                      <a:r>
+                        <a:rPr lang="en-US" sz="1100" b="1" dirty="0">
+                          <a:solidFill>
+                            <a:srgbClr val="FFFFFF"/>
+                          </a:solidFill>
+                          <a:latin typeface="맑은 고딕" pitchFamily="34" charset="0"/>
+                          <a:ea typeface="맑은 고딕" pitchFamily="34" charset="-122"/>
+                          <a:cs typeface="맑은 고딕" pitchFamily="34" charset="-120"/>
+                        </a:rPr>
+                        <a:t>5</a:t>
                       </a:r>
                       <a:endParaRPr lang="en-US" sz="1100" dirty="0">
                         <a:latin typeface="맑은 고딕" charset="0"/>
@@ -15005,7 +16235,7 @@
                           <a:ea typeface="맑은 고딕" pitchFamily="34" charset="-122"/>
                           <a:cs typeface="맑은 고딕" pitchFamily="34" charset="-120"/>
                         </a:rPr>
-                        <a:t>Necklace</a:t>
+                        <a:t>Ring</a:t>
                       </a:r>
                       <a:endParaRPr lang="en-US" sz="1000" dirty="0">
                         <a:latin typeface="맑은 고딕" charset="0"/>
@@ -15073,7 +16303,7 @@
                           <a:ea typeface="맑은 고딕" pitchFamily="34" charset="-122"/>
                           <a:cs typeface="맑은 고딕" pitchFamily="34" charset="-120"/>
                         </a:rPr>
-                        <a:t>RichardKokser Necklace</a:t>
+                        <a:t>[SILVER925] Azure Open Ring</a:t>
                       </a:r>
                       <a:endParaRPr lang="en-US" sz="1100" dirty="0">
                         <a:latin typeface="맑은 고딕" charset="0"/>
@@ -15141,7 +16371,7 @@
                           <a:ea typeface="맑은 고딕" pitchFamily="34" charset="-122"/>
                           <a:cs typeface="맑은 고딕" pitchFamily="34" charset="-120"/>
                         </a:rPr>
-                        <a:t>0</a:t>
+                        <a:t>1</a:t>
                       </a:r>
                       <a:endParaRPr lang="en-US" sz="1100" dirty="0">
                         <a:latin typeface="맑은 고딕" charset="0"/>
@@ -15209,7 +16439,7 @@
                           <a:ea typeface="맑은 고딕" pitchFamily="34" charset="-122"/>
                           <a:cs typeface="맑은 고딕" pitchFamily="34" charset="-120"/>
                         </a:rPr>
-                        <a:t>5 개</a:t>
+                        <a:t>1</a:t>
                       </a:r>
                       <a:endParaRPr lang="en-US" sz="1100" dirty="0">
                         <a:latin typeface="맑은 고딕" charset="0"/>
@@ -15279,417 +16509,7 @@
                           <a:ea typeface="맑은 고딕" pitchFamily="34" charset="-122"/>
                           <a:cs typeface="맑은 고딕" pitchFamily="34" charset="-120"/>
                         </a:rPr>
-                        <a:t>긴급</a:t>
-                      </a:r>
-                      <a:endParaRPr lang="en-US" sz="1100" dirty="0">
-                        <a:latin typeface="맑은 고딕" charset="0"/>
-                        <a:ea typeface="맑은 고딕" charset="0"/>
-                        <a:cs typeface="맑은 고딕" charset="0"/>
-                      </a:endParaRPr>
-                    </a:p>
-                  </a:txBody>
-                  <a:tcPr marL="91440" marR="91440" marT="45720" marB="45720" anchor="ctr">
-                    <a:lnL w="6350" cap="flat" cmpd="sng" algn="ctr">
-                      <a:solidFill>
-                        <a:srgbClr val="E5E7EB"/>
-                      </a:solidFill>
-                      <a:prstDash val="solid"/>
-                      <a:round/>
-                      <a:headEnd type="none" w="med" len="med"/>
-                      <a:tailEnd type="none" w="med" len="med"/>
-                    </a:lnL>
-                    <a:lnR w="6350" cap="flat" cmpd="sng" algn="ctr">
-                      <a:solidFill>
-                        <a:srgbClr val="E5E7EB"/>
-                      </a:solidFill>
-                      <a:prstDash val="solid"/>
-                      <a:round/>
-                      <a:headEnd type="none" w="med" len="med"/>
-                      <a:tailEnd type="none" w="med" len="med"/>
-                    </a:lnR>
-                    <a:lnT w="6350" cap="flat" cmpd="sng" algn="ctr">
-                      <a:solidFill>
-                        <a:srgbClr val="E5E7EB"/>
-                      </a:solidFill>
-                      <a:prstDash val="solid"/>
-                      <a:round/>
-                      <a:headEnd type="none" w="med" len="med"/>
-                      <a:tailEnd type="none" w="med" len="med"/>
-                    </a:lnT>
-                    <a:lnB w="6350" cap="flat" cmpd="sng" algn="ctr">
-                      <a:solidFill>
-                        <a:srgbClr val="E5E7EB"/>
-                      </a:solidFill>
-                      <a:prstDash val="solid"/>
-                      <a:round/>
-                      <a:headEnd type="none" w="med" len="med"/>
-                      <a:tailEnd type="none" w="med" len="med"/>
-                    </a:lnB>
-                    <a:solidFill>
-                      <a:srgbClr val="D72638"/>
-                    </a:solidFill>
-                  </a:tcPr>
-                </a:tc>
-                <a:tc>
-                  <a:txBody>
-                    <a:bodyPr/>
-                    <a:lstStyle/>
-                    <a:p>
-                      <a:pPr algn="ctr" indent="0" marL="0">
-                        <a:buNone/>
-                      </a:pPr>
-                      <a:r>
-                        <a:rPr lang="en-US" sz="1100" b="1" dirty="0">
-                          <a:solidFill>
-                            <a:srgbClr val="1F2937"/>
-                          </a:solidFill>
-                          <a:latin typeface="맑은 고딕" pitchFamily="34" charset="0"/>
-                          <a:ea typeface="맑은 고딕" pitchFamily="34" charset="-122"/>
-                          <a:cs typeface="맑은 고딕" pitchFamily="34" charset="-120"/>
-                        </a:rPr>
-                        <a:t>CT</a:t>
-                      </a:r>
-                      <a:endParaRPr lang="en-US" sz="1100" dirty="0">
-                        <a:latin typeface="맑은 고딕" charset="0"/>
-                        <a:ea typeface="맑은 고딕" charset="0"/>
-                        <a:cs typeface="맑은 고딕" charset="0"/>
-                      </a:endParaRPr>
-                    </a:p>
-                  </a:txBody>
-                  <a:tcPr marL="91440" marR="91440" marT="45720" marB="45720" anchor="ctr">
-                    <a:lnL w="6350" cap="flat" cmpd="sng" algn="ctr">
-                      <a:solidFill>
-                        <a:srgbClr val="E5E7EB"/>
-                      </a:solidFill>
-                      <a:prstDash val="solid"/>
-                      <a:round/>
-                      <a:headEnd type="none" w="med" len="med"/>
-                      <a:tailEnd type="none" w="med" len="med"/>
-                    </a:lnL>
-                    <a:lnR w="6350" cap="flat" cmpd="sng" algn="ctr">
-                      <a:solidFill>
-                        <a:srgbClr val="E5E7EB"/>
-                      </a:solidFill>
-                      <a:prstDash val="solid"/>
-                      <a:round/>
-                      <a:headEnd type="none" w="med" len="med"/>
-                      <a:tailEnd type="none" w="med" len="med"/>
-                    </a:lnR>
-                    <a:lnT w="6350" cap="flat" cmpd="sng" algn="ctr">
-                      <a:solidFill>
-                        <a:srgbClr val="E5E7EB"/>
-                      </a:solidFill>
-                      <a:prstDash val="solid"/>
-                      <a:round/>
-                      <a:headEnd type="none" w="med" len="med"/>
-                      <a:tailEnd type="none" w="med" len="med"/>
-                    </a:lnT>
-                    <a:lnB w="6350" cap="flat" cmpd="sng" algn="ctr">
-                      <a:solidFill>
-                        <a:srgbClr val="E5E7EB"/>
-                      </a:solidFill>
-                      <a:prstDash val="solid"/>
-                      <a:round/>
-                      <a:headEnd type="none" w="med" len="med"/>
-                      <a:tailEnd type="none" w="med" len="med"/>
-                    </a:lnB>
-                    <a:solidFill>
-                      <a:srgbClr val="FFF5F5"/>
-                    </a:solidFill>
-                  </a:tcPr>
-                </a:tc>
-                <a:tc>
-                  <a:txBody>
-                    <a:bodyPr/>
-                    <a:lstStyle/>
-                    <a:p>
-                      <a:pPr indent="0" marL="0">
-                        <a:buNone/>
-                      </a:pPr>
-                      <a:r>
-                        <a:rPr lang="en-US" sz="1000" dirty="0">
-                          <a:solidFill>
-                            <a:srgbClr val="6B7280"/>
-                          </a:solidFill>
-                          <a:latin typeface="맑은 고딕" pitchFamily="34" charset="0"/>
-                          <a:ea typeface="맑은 고딕" pitchFamily="34" charset="-122"/>
-                          <a:cs typeface="맑은 고딕" pitchFamily="34" charset="-120"/>
-                        </a:rPr>
-                        <a:t>Ring</a:t>
-                      </a:r>
-                      <a:endParaRPr lang="en-US" sz="1000" dirty="0">
-                        <a:latin typeface="맑은 고딕" charset="0"/>
-                        <a:ea typeface="맑은 고딕" charset="0"/>
-                        <a:cs typeface="맑은 고딕" charset="0"/>
-                      </a:endParaRPr>
-                    </a:p>
-                  </a:txBody>
-                  <a:tcPr marL="91440" marR="91440" marT="45720" marB="45720" anchor="ctr">
-                    <a:lnL w="6350" cap="flat" cmpd="sng" algn="ctr">
-                      <a:solidFill>
-                        <a:srgbClr val="E5E7EB"/>
-                      </a:solidFill>
-                      <a:prstDash val="solid"/>
-                      <a:round/>
-                      <a:headEnd type="none" w="med" len="med"/>
-                      <a:tailEnd type="none" w="med" len="med"/>
-                    </a:lnL>
-                    <a:lnR w="6350" cap="flat" cmpd="sng" algn="ctr">
-                      <a:solidFill>
-                        <a:srgbClr val="E5E7EB"/>
-                      </a:solidFill>
-                      <a:prstDash val="solid"/>
-                      <a:round/>
-                      <a:headEnd type="none" w="med" len="med"/>
-                      <a:tailEnd type="none" w="med" len="med"/>
-                    </a:lnR>
-                    <a:lnT w="6350" cap="flat" cmpd="sng" algn="ctr">
-                      <a:solidFill>
-                        <a:srgbClr val="E5E7EB"/>
-                      </a:solidFill>
-                      <a:prstDash val="solid"/>
-                      <a:round/>
-                      <a:headEnd type="none" w="med" len="med"/>
-                      <a:tailEnd type="none" w="med" len="med"/>
-                    </a:lnT>
-                    <a:lnB w="6350" cap="flat" cmpd="sng" algn="ctr">
-                      <a:solidFill>
-                        <a:srgbClr val="E5E7EB"/>
-                      </a:solidFill>
-                      <a:prstDash val="solid"/>
-                      <a:round/>
-                      <a:headEnd type="none" w="med" len="med"/>
-                      <a:tailEnd type="none" w="med" len="med"/>
-                    </a:lnB>
-                    <a:solidFill>
-                      <a:srgbClr val="FFF5F5"/>
-                    </a:solidFill>
-                  </a:tcPr>
-                </a:tc>
-                <a:tc>
-                  <a:txBody>
-                    <a:bodyPr/>
-                    <a:lstStyle/>
-                    <a:p>
-                      <a:pPr indent="0" marL="0">
-                        <a:buNone/>
-                      </a:pPr>
-                      <a:r>
-                        <a:rPr lang="en-US" sz="1100" b="1" dirty="0">
-                          <a:solidFill>
-                            <a:srgbClr val="0B1220"/>
-                          </a:solidFill>
-                          <a:latin typeface="맑은 고딕" pitchFamily="34" charset="0"/>
-                          <a:ea typeface="맑은 고딕" pitchFamily="34" charset="-122"/>
-                          <a:cs typeface="맑은 고딕" pitchFamily="34" charset="-120"/>
-                        </a:rPr>
-                        <a:t>"Giethoorn" 925 Open Ring</a:t>
-                      </a:r>
-                      <a:endParaRPr lang="en-US" sz="1100" dirty="0">
-                        <a:latin typeface="맑은 고딕" charset="0"/>
-                        <a:ea typeface="맑은 고딕" charset="0"/>
-                        <a:cs typeface="맑은 고딕" charset="0"/>
-                      </a:endParaRPr>
-                    </a:p>
-                  </a:txBody>
-                  <a:tcPr marL="91440" marR="91440" marT="45720" marB="45720" anchor="ctr">
-                    <a:lnL w="6350" cap="flat" cmpd="sng" algn="ctr">
-                      <a:solidFill>
-                        <a:srgbClr val="E5E7EB"/>
-                      </a:solidFill>
-                      <a:prstDash val="solid"/>
-                      <a:round/>
-                      <a:headEnd type="none" w="med" len="med"/>
-                      <a:tailEnd type="none" w="med" len="med"/>
-                    </a:lnL>
-                    <a:lnR w="6350" cap="flat" cmpd="sng" algn="ctr">
-                      <a:solidFill>
-                        <a:srgbClr val="E5E7EB"/>
-                      </a:solidFill>
-                      <a:prstDash val="solid"/>
-                      <a:round/>
-                      <a:headEnd type="none" w="med" len="med"/>
-                      <a:tailEnd type="none" w="med" len="med"/>
-                    </a:lnR>
-                    <a:lnT w="6350" cap="flat" cmpd="sng" algn="ctr">
-                      <a:solidFill>
-                        <a:srgbClr val="E5E7EB"/>
-                      </a:solidFill>
-                      <a:prstDash val="solid"/>
-                      <a:round/>
-                      <a:headEnd type="none" w="med" len="med"/>
-                      <a:tailEnd type="none" w="med" len="med"/>
-                    </a:lnT>
-                    <a:lnB w="6350" cap="flat" cmpd="sng" algn="ctr">
-                      <a:solidFill>
-                        <a:srgbClr val="E5E7EB"/>
-                      </a:solidFill>
-                      <a:prstDash val="solid"/>
-                      <a:round/>
-                      <a:headEnd type="none" w="med" len="med"/>
-                      <a:tailEnd type="none" w="med" len="med"/>
-                    </a:lnB>
-                    <a:solidFill>
-                      <a:srgbClr val="FFF5F5"/>
-                    </a:solidFill>
-                  </a:tcPr>
-                </a:tc>
-                <a:tc>
-                  <a:txBody>
-                    <a:bodyPr/>
-                    <a:lstStyle/>
-                    <a:p>
-                      <a:pPr algn="r" indent="0" marL="0">
-                        <a:buNone/>
-                      </a:pPr>
-                      <a:r>
-                        <a:rPr lang="en-US" sz="1100" b="1" dirty="0">
-                          <a:solidFill>
-                            <a:srgbClr val="D72638"/>
-                          </a:solidFill>
-                          <a:latin typeface="맑은 고딕" pitchFamily="34" charset="0"/>
-                          <a:ea typeface="맑은 고딕" pitchFamily="34" charset="-122"/>
-                          <a:cs typeface="맑은 고딕" pitchFamily="34" charset="-120"/>
-                        </a:rPr>
-                        <a:t>2</a:t>
-                      </a:r>
-                      <a:endParaRPr lang="en-US" sz="1100" dirty="0">
-                        <a:latin typeface="맑은 고딕" charset="0"/>
-                        <a:ea typeface="맑은 고딕" charset="0"/>
-                        <a:cs typeface="맑은 고딕" charset="0"/>
-                      </a:endParaRPr>
-                    </a:p>
-                  </a:txBody>
-                  <a:tcPr marL="91440" marR="91440" marT="45720" marB="45720" anchor="ctr">
-                    <a:lnL w="6350" cap="flat" cmpd="sng" algn="ctr">
-                      <a:solidFill>
-                        <a:srgbClr val="E5E7EB"/>
-                      </a:solidFill>
-                      <a:prstDash val="solid"/>
-                      <a:round/>
-                      <a:headEnd type="none" w="med" len="med"/>
-                      <a:tailEnd type="none" w="med" len="med"/>
-                    </a:lnL>
-                    <a:lnR w="6350" cap="flat" cmpd="sng" algn="ctr">
-                      <a:solidFill>
-                        <a:srgbClr val="E5E7EB"/>
-                      </a:solidFill>
-                      <a:prstDash val="solid"/>
-                      <a:round/>
-                      <a:headEnd type="none" w="med" len="med"/>
-                      <a:tailEnd type="none" w="med" len="med"/>
-                    </a:lnR>
-                    <a:lnT w="6350" cap="flat" cmpd="sng" algn="ctr">
-                      <a:solidFill>
-                        <a:srgbClr val="E5E7EB"/>
-                      </a:solidFill>
-                      <a:prstDash val="solid"/>
-                      <a:round/>
-                      <a:headEnd type="none" w="med" len="med"/>
-                      <a:tailEnd type="none" w="med" len="med"/>
-                    </a:lnT>
-                    <a:lnB w="6350" cap="flat" cmpd="sng" algn="ctr">
-                      <a:solidFill>
-                        <a:srgbClr val="E5E7EB"/>
-                      </a:solidFill>
-                      <a:prstDash val="solid"/>
-                      <a:round/>
-                      <a:headEnd type="none" w="med" len="med"/>
-                      <a:tailEnd type="none" w="med" len="med"/>
-                    </a:lnB>
-                    <a:solidFill>
-                      <a:srgbClr val="FFF5F5"/>
-                    </a:solidFill>
-                  </a:tcPr>
-                </a:tc>
-                <a:tc>
-                  <a:txBody>
-                    <a:bodyPr/>
-                    <a:lstStyle/>
-                    <a:p>
-                      <a:pPr algn="r" indent="0" marL="0">
-                        <a:buNone/>
-                      </a:pPr>
-                      <a:r>
-                        <a:rPr lang="en-US" sz="1100" dirty="0">
-                          <a:solidFill>
-                            <a:srgbClr val="1F2937"/>
-                          </a:solidFill>
-                          <a:latin typeface="맑은 고딕" pitchFamily="34" charset="0"/>
-                          <a:ea typeface="맑은 고딕" pitchFamily="34" charset="-122"/>
-                          <a:cs typeface="맑은 고딕" pitchFamily="34" charset="-120"/>
-                        </a:rPr>
-                        <a:t>3 개</a:t>
-                      </a:r>
-                      <a:endParaRPr lang="en-US" sz="1100" dirty="0">
-                        <a:latin typeface="맑은 고딕" charset="0"/>
-                        <a:ea typeface="맑은 고딕" charset="0"/>
-                        <a:cs typeface="맑은 고딕" charset="0"/>
-                      </a:endParaRPr>
-                    </a:p>
-                  </a:txBody>
-                  <a:tcPr marL="91440" marR="91440" marT="45720" marB="45720" anchor="ctr">
-                    <a:lnL w="6350" cap="flat" cmpd="sng" algn="ctr">
-                      <a:solidFill>
-                        <a:srgbClr val="E5E7EB"/>
-                      </a:solidFill>
-                      <a:prstDash val="solid"/>
-                      <a:round/>
-                      <a:headEnd type="none" w="med" len="med"/>
-                      <a:tailEnd type="none" w="med" len="med"/>
-                    </a:lnL>
-                    <a:lnR w="6350" cap="flat" cmpd="sng" algn="ctr">
-                      <a:solidFill>
-                        <a:srgbClr val="E5E7EB"/>
-                      </a:solidFill>
-                      <a:prstDash val="solid"/>
-                      <a:round/>
-                      <a:headEnd type="none" w="med" len="med"/>
-                      <a:tailEnd type="none" w="med" len="med"/>
-                    </a:lnR>
-                    <a:lnT w="6350" cap="flat" cmpd="sng" algn="ctr">
-                      <a:solidFill>
-                        <a:srgbClr val="E5E7EB"/>
-                      </a:solidFill>
-                      <a:prstDash val="solid"/>
-                      <a:round/>
-                      <a:headEnd type="none" w="med" len="med"/>
-                      <a:tailEnd type="none" w="med" len="med"/>
-                    </a:lnT>
-                    <a:lnB w="6350" cap="flat" cmpd="sng" algn="ctr">
-                      <a:solidFill>
-                        <a:srgbClr val="E5E7EB"/>
-                      </a:solidFill>
-                      <a:prstDash val="solid"/>
-                      <a:round/>
-                      <a:headEnd type="none" w="med" len="med"/>
-                      <a:tailEnd type="none" w="med" len="med"/>
-                    </a:lnB>
-                    <a:solidFill>
-                      <a:srgbClr val="FFF5F5"/>
-                    </a:solidFill>
-                  </a:tcPr>
-                </a:tc>
-              </a:tr>
-              <a:tr h="384048">
-                <a:tc>
-                  <a:txBody>
-                    <a:bodyPr/>
-                    <a:lstStyle/>
-                    <a:p>
-                      <a:pPr algn="ctr" indent="0" marL="0">
-                        <a:buNone/>
-                      </a:pPr>
-                      <a:r>
-                        <a:rPr lang="en-US" sz="1100" b="1" dirty="0">
-                          <a:solidFill>
-                            <a:srgbClr val="FFFFFF"/>
-                          </a:solidFill>
-                          <a:latin typeface="맑은 고딕" pitchFamily="34" charset="0"/>
-                          <a:ea typeface="맑은 고딕" pitchFamily="34" charset="-122"/>
-                          <a:cs typeface="맑은 고딕" pitchFamily="34" charset="-120"/>
-                        </a:rPr>
-                        <a:t>긴급</a:t>
+                        <a:t>6</a:t>
                       </a:r>
                       <a:endParaRPr lang="en-US" sz="1100" dirty="0">
                         <a:latin typeface="맑은 고딕" charset="0"/>
@@ -15825,7 +16645,7 @@
                           <a:ea typeface="맑은 고딕" pitchFamily="34" charset="-122"/>
                           <a:cs typeface="맑은 고딕" pitchFamily="34" charset="-120"/>
                         </a:rPr>
-                        <a:t>Ring</a:t>
+                        <a:t>Necklace</a:t>
                       </a:r>
                       <a:endParaRPr lang="en-US" sz="1000" dirty="0">
                         <a:latin typeface="맑은 고딕" charset="0"/>
@@ -15893,7 +16713,7 @@
                           <a:ea typeface="맑은 고딕" pitchFamily="34" charset="-122"/>
                           <a:cs typeface="맑은 고딕" pitchFamily="34" charset="-120"/>
                         </a:rPr>
-                        <a:t>[SILVER925] Azure Open Ring</a:t>
+                        <a:t>Marquise Necklace</a:t>
                       </a:r>
                       <a:endParaRPr lang="en-US" sz="1100" dirty="0">
                         <a:latin typeface="맑은 고딕" charset="0"/>
@@ -16029,7 +16849,7 @@
                           <a:ea typeface="맑은 고딕" pitchFamily="34" charset="-122"/>
                           <a:cs typeface="맑은 고딕" pitchFamily="34" charset="-120"/>
                         </a:rPr>
-                        <a:t>1 개</a:t>
+                        <a:t>0</a:t>
                       </a:r>
                       <a:endParaRPr lang="en-US" sz="1100" dirty="0">
                         <a:latin typeface="맑은 고딕" charset="0"/>
@@ -16099,7 +16919,7 @@
                           <a:ea typeface="맑은 고딕" pitchFamily="34" charset="-122"/>
                           <a:cs typeface="맑은 고딕" pitchFamily="34" charset="-120"/>
                         </a:rPr>
-                        <a:t>긴급</a:t>
+                        <a:t>7</a:t>
                       </a:r>
                       <a:endParaRPr lang="en-US" sz="1100" dirty="0">
                         <a:latin typeface="맑은 고딕" charset="0"/>
@@ -16167,417 +16987,7 @@
                           <a:ea typeface="맑은 고딕" pitchFamily="34" charset="-122"/>
                           <a:cs typeface="맑은 고딕" pitchFamily="34" charset="-120"/>
                         </a:rPr>
-                        <a:t>PR</a:t>
-                      </a:r>
-                      <a:endParaRPr lang="en-US" sz="1100" dirty="0">
-                        <a:latin typeface="맑은 고딕" charset="0"/>
-                        <a:ea typeface="맑은 고딕" charset="0"/>
-                        <a:cs typeface="맑은 고딕" charset="0"/>
-                      </a:endParaRPr>
-                    </a:p>
-                  </a:txBody>
-                  <a:tcPr marL="91440" marR="91440" marT="45720" marB="45720" anchor="ctr">
-                    <a:lnL w="6350" cap="flat" cmpd="sng" algn="ctr">
-                      <a:solidFill>
-                        <a:srgbClr val="E5E7EB"/>
-                      </a:solidFill>
-                      <a:prstDash val="solid"/>
-                      <a:round/>
-                      <a:headEnd type="none" w="med" len="med"/>
-                      <a:tailEnd type="none" w="med" len="med"/>
-                    </a:lnL>
-                    <a:lnR w="6350" cap="flat" cmpd="sng" algn="ctr">
-                      <a:solidFill>
-                        <a:srgbClr val="E5E7EB"/>
-                      </a:solidFill>
-                      <a:prstDash val="solid"/>
-                      <a:round/>
-                      <a:headEnd type="none" w="med" len="med"/>
-                      <a:tailEnd type="none" w="med" len="med"/>
-                    </a:lnR>
-                    <a:lnT w="6350" cap="flat" cmpd="sng" algn="ctr">
-                      <a:solidFill>
-                        <a:srgbClr val="E5E7EB"/>
-                      </a:solidFill>
-                      <a:prstDash val="solid"/>
-                      <a:round/>
-                      <a:headEnd type="none" w="med" len="med"/>
-                      <a:tailEnd type="none" w="med" len="med"/>
-                    </a:lnT>
-                    <a:lnB w="6350" cap="flat" cmpd="sng" algn="ctr">
-                      <a:solidFill>
-                        <a:srgbClr val="E5E7EB"/>
-                      </a:solidFill>
-                      <a:prstDash val="solid"/>
-                      <a:round/>
-                      <a:headEnd type="none" w="med" len="med"/>
-                      <a:tailEnd type="none" w="med" len="med"/>
-                    </a:lnB>
-                    <a:solidFill>
-                      <a:srgbClr val="FFF5F5"/>
-                    </a:solidFill>
-                  </a:tcPr>
-                </a:tc>
-                <a:tc>
-                  <a:txBody>
-                    <a:bodyPr/>
-                    <a:lstStyle/>
-                    <a:p>
-                      <a:pPr indent="0" marL="0">
-                        <a:buNone/>
-                      </a:pPr>
-                      <a:r>
-                        <a:rPr lang="en-US" sz="1000" dirty="0">
-                          <a:solidFill>
-                            <a:srgbClr val="6B7280"/>
-                          </a:solidFill>
-                          <a:latin typeface="맑은 고딕" pitchFamily="34" charset="0"/>
-                          <a:ea typeface="맑은 고딕" pitchFamily="34" charset="-122"/>
-                          <a:cs typeface="맑은 고딕" pitchFamily="34" charset="-120"/>
-                        </a:rPr>
-                        <a:t>★ Last Sale ★</a:t>
-                      </a:r>
-                      <a:endParaRPr lang="en-US" sz="1000" dirty="0">
-                        <a:latin typeface="맑은 고딕" charset="0"/>
-                        <a:ea typeface="맑은 고딕" charset="0"/>
-                        <a:cs typeface="맑은 고딕" charset="0"/>
-                      </a:endParaRPr>
-                    </a:p>
-                  </a:txBody>
-                  <a:tcPr marL="91440" marR="91440" marT="45720" marB="45720" anchor="ctr">
-                    <a:lnL w="6350" cap="flat" cmpd="sng" algn="ctr">
-                      <a:solidFill>
-                        <a:srgbClr val="E5E7EB"/>
-                      </a:solidFill>
-                      <a:prstDash val="solid"/>
-                      <a:round/>
-                      <a:headEnd type="none" w="med" len="med"/>
-                      <a:tailEnd type="none" w="med" len="med"/>
-                    </a:lnL>
-                    <a:lnR w="6350" cap="flat" cmpd="sng" algn="ctr">
-                      <a:solidFill>
-                        <a:srgbClr val="E5E7EB"/>
-                      </a:solidFill>
-                      <a:prstDash val="solid"/>
-                      <a:round/>
-                      <a:headEnd type="none" w="med" len="med"/>
-                      <a:tailEnd type="none" w="med" len="med"/>
-                    </a:lnR>
-                    <a:lnT w="6350" cap="flat" cmpd="sng" algn="ctr">
-                      <a:solidFill>
-                        <a:srgbClr val="E5E7EB"/>
-                      </a:solidFill>
-                      <a:prstDash val="solid"/>
-                      <a:round/>
-                      <a:headEnd type="none" w="med" len="med"/>
-                      <a:tailEnd type="none" w="med" len="med"/>
-                    </a:lnT>
-                    <a:lnB w="6350" cap="flat" cmpd="sng" algn="ctr">
-                      <a:solidFill>
-                        <a:srgbClr val="E5E7EB"/>
-                      </a:solidFill>
-                      <a:prstDash val="solid"/>
-                      <a:round/>
-                      <a:headEnd type="none" w="med" len="med"/>
-                      <a:tailEnd type="none" w="med" len="med"/>
-                    </a:lnB>
-                    <a:solidFill>
-                      <a:srgbClr val="FFF5F5"/>
-                    </a:solidFill>
-                  </a:tcPr>
-                </a:tc>
-                <a:tc>
-                  <a:txBody>
-                    <a:bodyPr/>
-                    <a:lstStyle/>
-                    <a:p>
-                      <a:pPr indent="0" marL="0">
-                        <a:buNone/>
-                      </a:pPr>
-                      <a:r>
-                        <a:rPr lang="en-US" sz="1100" b="1" dirty="0">
-                          <a:solidFill>
-                            <a:srgbClr val="0B1220"/>
-                          </a:solidFill>
-                          <a:latin typeface="맑은 고딕" pitchFamily="34" charset="0"/>
-                          <a:ea typeface="맑은 고딕" pitchFamily="34" charset="-122"/>
-                          <a:cs typeface="맑은 고딕" pitchFamily="34" charset="-120"/>
-                        </a:rPr>
-                        <a:t>Cloud Grip Glass Mini Brush (3color) (컬러: 스카이블루)</a:t>
-                      </a:r>
-                      <a:endParaRPr lang="en-US" sz="1100" dirty="0">
-                        <a:latin typeface="맑은 고딕" charset="0"/>
-                        <a:ea typeface="맑은 고딕" charset="0"/>
-                        <a:cs typeface="맑은 고딕" charset="0"/>
-                      </a:endParaRPr>
-                    </a:p>
-                  </a:txBody>
-                  <a:tcPr marL="91440" marR="91440" marT="45720" marB="45720" anchor="ctr">
-                    <a:lnL w="6350" cap="flat" cmpd="sng" algn="ctr">
-                      <a:solidFill>
-                        <a:srgbClr val="E5E7EB"/>
-                      </a:solidFill>
-                      <a:prstDash val="solid"/>
-                      <a:round/>
-                      <a:headEnd type="none" w="med" len="med"/>
-                      <a:tailEnd type="none" w="med" len="med"/>
-                    </a:lnL>
-                    <a:lnR w="6350" cap="flat" cmpd="sng" algn="ctr">
-                      <a:solidFill>
-                        <a:srgbClr val="E5E7EB"/>
-                      </a:solidFill>
-                      <a:prstDash val="solid"/>
-                      <a:round/>
-                      <a:headEnd type="none" w="med" len="med"/>
-                      <a:tailEnd type="none" w="med" len="med"/>
-                    </a:lnR>
-                    <a:lnT w="6350" cap="flat" cmpd="sng" algn="ctr">
-                      <a:solidFill>
-                        <a:srgbClr val="E5E7EB"/>
-                      </a:solidFill>
-                      <a:prstDash val="solid"/>
-                      <a:round/>
-                      <a:headEnd type="none" w="med" len="med"/>
-                      <a:tailEnd type="none" w="med" len="med"/>
-                    </a:lnT>
-                    <a:lnB w="6350" cap="flat" cmpd="sng" algn="ctr">
-                      <a:solidFill>
-                        <a:srgbClr val="E5E7EB"/>
-                      </a:solidFill>
-                      <a:prstDash val="solid"/>
-                      <a:round/>
-                      <a:headEnd type="none" w="med" len="med"/>
-                      <a:tailEnd type="none" w="med" len="med"/>
-                    </a:lnB>
-                    <a:solidFill>
-                      <a:srgbClr val="FFF5F5"/>
-                    </a:solidFill>
-                  </a:tcPr>
-                </a:tc>
-                <a:tc>
-                  <a:txBody>
-                    <a:bodyPr/>
-                    <a:lstStyle/>
-                    <a:p>
-                      <a:pPr algn="r" indent="0" marL="0">
-                        <a:buNone/>
-                      </a:pPr>
-                      <a:r>
-                        <a:rPr lang="en-US" sz="1100" b="1" dirty="0">
-                          <a:solidFill>
-                            <a:srgbClr val="D72638"/>
-                          </a:solidFill>
-                          <a:latin typeface="맑은 고딕" pitchFamily="34" charset="0"/>
-                          <a:ea typeface="맑은 고딕" pitchFamily="34" charset="-122"/>
-                          <a:cs typeface="맑은 고딕" pitchFamily="34" charset="-120"/>
-                        </a:rPr>
-                        <a:t>19</a:t>
-                      </a:r>
-                      <a:endParaRPr lang="en-US" sz="1100" dirty="0">
-                        <a:latin typeface="맑은 고딕" charset="0"/>
-                        <a:ea typeface="맑은 고딕" charset="0"/>
-                        <a:cs typeface="맑은 고딕" charset="0"/>
-                      </a:endParaRPr>
-                    </a:p>
-                  </a:txBody>
-                  <a:tcPr marL="91440" marR="91440" marT="45720" marB="45720" anchor="ctr">
-                    <a:lnL w="6350" cap="flat" cmpd="sng" algn="ctr">
-                      <a:solidFill>
-                        <a:srgbClr val="E5E7EB"/>
-                      </a:solidFill>
-                      <a:prstDash val="solid"/>
-                      <a:round/>
-                      <a:headEnd type="none" w="med" len="med"/>
-                      <a:tailEnd type="none" w="med" len="med"/>
-                    </a:lnL>
-                    <a:lnR w="6350" cap="flat" cmpd="sng" algn="ctr">
-                      <a:solidFill>
-                        <a:srgbClr val="E5E7EB"/>
-                      </a:solidFill>
-                      <a:prstDash val="solid"/>
-                      <a:round/>
-                      <a:headEnd type="none" w="med" len="med"/>
-                      <a:tailEnd type="none" w="med" len="med"/>
-                    </a:lnR>
-                    <a:lnT w="6350" cap="flat" cmpd="sng" algn="ctr">
-                      <a:solidFill>
-                        <a:srgbClr val="E5E7EB"/>
-                      </a:solidFill>
-                      <a:prstDash val="solid"/>
-                      <a:round/>
-                      <a:headEnd type="none" w="med" len="med"/>
-                      <a:tailEnd type="none" w="med" len="med"/>
-                    </a:lnT>
-                    <a:lnB w="6350" cap="flat" cmpd="sng" algn="ctr">
-                      <a:solidFill>
-                        <a:srgbClr val="E5E7EB"/>
-                      </a:solidFill>
-                      <a:prstDash val="solid"/>
-                      <a:round/>
-                      <a:headEnd type="none" w="med" len="med"/>
-                      <a:tailEnd type="none" w="med" len="med"/>
-                    </a:lnB>
-                    <a:solidFill>
-                      <a:srgbClr val="FFF5F5"/>
-                    </a:solidFill>
-                  </a:tcPr>
-                </a:tc>
-                <a:tc>
-                  <a:txBody>
-                    <a:bodyPr/>
-                    <a:lstStyle/>
-                    <a:p>
-                      <a:pPr algn="r" indent="0" marL="0">
-                        <a:buNone/>
-                      </a:pPr>
-                      <a:r>
-                        <a:rPr lang="en-US" sz="1100" dirty="0">
-                          <a:solidFill>
-                            <a:srgbClr val="1F2937"/>
-                          </a:solidFill>
-                          <a:latin typeface="맑은 고딕" pitchFamily="34" charset="0"/>
-                          <a:ea typeface="맑은 고딕" pitchFamily="34" charset="-122"/>
-                          <a:cs typeface="맑은 고딕" pitchFamily="34" charset="-120"/>
-                        </a:rPr>
-                        <a:t>1 개</a:t>
-                      </a:r>
-                      <a:endParaRPr lang="en-US" sz="1100" dirty="0">
-                        <a:latin typeface="맑은 고딕" charset="0"/>
-                        <a:ea typeface="맑은 고딕" charset="0"/>
-                        <a:cs typeface="맑은 고딕" charset="0"/>
-                      </a:endParaRPr>
-                    </a:p>
-                  </a:txBody>
-                  <a:tcPr marL="91440" marR="91440" marT="45720" marB="45720" anchor="ctr">
-                    <a:lnL w="6350" cap="flat" cmpd="sng" algn="ctr">
-                      <a:solidFill>
-                        <a:srgbClr val="E5E7EB"/>
-                      </a:solidFill>
-                      <a:prstDash val="solid"/>
-                      <a:round/>
-                      <a:headEnd type="none" w="med" len="med"/>
-                      <a:tailEnd type="none" w="med" len="med"/>
-                    </a:lnL>
-                    <a:lnR w="6350" cap="flat" cmpd="sng" algn="ctr">
-                      <a:solidFill>
-                        <a:srgbClr val="E5E7EB"/>
-                      </a:solidFill>
-                      <a:prstDash val="solid"/>
-                      <a:round/>
-                      <a:headEnd type="none" w="med" len="med"/>
-                      <a:tailEnd type="none" w="med" len="med"/>
-                    </a:lnR>
-                    <a:lnT w="6350" cap="flat" cmpd="sng" algn="ctr">
-                      <a:solidFill>
-                        <a:srgbClr val="E5E7EB"/>
-                      </a:solidFill>
-                      <a:prstDash val="solid"/>
-                      <a:round/>
-                      <a:headEnd type="none" w="med" len="med"/>
-                      <a:tailEnd type="none" w="med" len="med"/>
-                    </a:lnT>
-                    <a:lnB w="6350" cap="flat" cmpd="sng" algn="ctr">
-                      <a:solidFill>
-                        <a:srgbClr val="E5E7EB"/>
-                      </a:solidFill>
-                      <a:prstDash val="solid"/>
-                      <a:round/>
-                      <a:headEnd type="none" w="med" len="med"/>
-                      <a:tailEnd type="none" w="med" len="med"/>
-                    </a:lnB>
-                    <a:solidFill>
-                      <a:srgbClr val="FFF5F5"/>
-                    </a:solidFill>
-                  </a:tcPr>
-                </a:tc>
-              </a:tr>
-              <a:tr h="384048">
-                <a:tc>
-                  <a:txBody>
-                    <a:bodyPr/>
-                    <a:lstStyle/>
-                    <a:p>
-                      <a:pPr algn="ctr" indent="0" marL="0">
-                        <a:buNone/>
-                      </a:pPr>
-                      <a:r>
-                        <a:rPr lang="en-US" sz="1100" b="1" dirty="0">
-                          <a:solidFill>
-                            <a:srgbClr val="FFFFFF"/>
-                          </a:solidFill>
-                          <a:latin typeface="맑은 고딕" pitchFamily="34" charset="0"/>
-                          <a:ea typeface="맑은 고딕" pitchFamily="34" charset="-122"/>
-                          <a:cs typeface="맑은 고딕" pitchFamily="34" charset="-120"/>
-                        </a:rPr>
-                        <a:t>긴급</a:t>
-                      </a:r>
-                      <a:endParaRPr lang="en-US" sz="1100" dirty="0">
-                        <a:latin typeface="맑은 고딕" charset="0"/>
-                        <a:ea typeface="맑은 고딕" charset="0"/>
-                        <a:cs typeface="맑은 고딕" charset="0"/>
-                      </a:endParaRPr>
-                    </a:p>
-                  </a:txBody>
-                  <a:tcPr marL="91440" marR="91440" marT="45720" marB="45720" anchor="ctr">
-                    <a:lnL w="6350" cap="flat" cmpd="sng" algn="ctr">
-                      <a:solidFill>
-                        <a:srgbClr val="E5E7EB"/>
-                      </a:solidFill>
-                      <a:prstDash val="solid"/>
-                      <a:round/>
-                      <a:headEnd type="none" w="med" len="med"/>
-                      <a:tailEnd type="none" w="med" len="med"/>
-                    </a:lnL>
-                    <a:lnR w="6350" cap="flat" cmpd="sng" algn="ctr">
-                      <a:solidFill>
-                        <a:srgbClr val="E5E7EB"/>
-                      </a:solidFill>
-                      <a:prstDash val="solid"/>
-                      <a:round/>
-                      <a:headEnd type="none" w="med" len="med"/>
-                      <a:tailEnd type="none" w="med" len="med"/>
-                    </a:lnR>
-                    <a:lnT w="6350" cap="flat" cmpd="sng" algn="ctr">
-                      <a:solidFill>
-                        <a:srgbClr val="E5E7EB"/>
-                      </a:solidFill>
-                      <a:prstDash val="solid"/>
-                      <a:round/>
-                      <a:headEnd type="none" w="med" len="med"/>
-                      <a:tailEnd type="none" w="med" len="med"/>
-                    </a:lnT>
-                    <a:lnB w="6350" cap="flat" cmpd="sng" algn="ctr">
-                      <a:solidFill>
-                        <a:srgbClr val="E5E7EB"/>
-                      </a:solidFill>
-                      <a:prstDash val="solid"/>
-                      <a:round/>
-                      <a:headEnd type="none" w="med" len="med"/>
-                      <a:tailEnd type="none" w="med" len="med"/>
-                    </a:lnB>
-                    <a:solidFill>
-                      <a:srgbClr val="D72638"/>
-                    </a:solidFill>
-                  </a:tcPr>
-                </a:tc>
-                <a:tc>
-                  <a:txBody>
-                    <a:bodyPr/>
-                    <a:lstStyle/>
-                    <a:p>
-                      <a:pPr algn="ctr" indent="0" marL="0">
-                        <a:buNone/>
-                      </a:pPr>
-                      <a:r>
-                        <a:rPr lang="en-US" sz="1100" b="1" dirty="0">
-                          <a:solidFill>
-                            <a:srgbClr val="1F2937"/>
-                          </a:solidFill>
-                          <a:latin typeface="맑은 고딕" pitchFamily="34" charset="0"/>
-                          <a:ea typeface="맑은 고딕" pitchFamily="34" charset="-122"/>
-                          <a:cs typeface="맑은 고딕" pitchFamily="34" charset="-120"/>
-                        </a:rPr>
-                        <a:t>PR</a:t>
+                        <a:t>PP</a:t>
                       </a:r>
                       <a:endParaRPr lang="en-US" sz="1100" dirty="0">
                         <a:latin typeface="맑은 고딕" charset="0"/>
@@ -16781,7 +17191,7 @@
                           <a:ea typeface="맑은 고딕" pitchFamily="34" charset="-122"/>
                           <a:cs typeface="맑은 고딕" pitchFamily="34" charset="-120"/>
                         </a:rPr>
-                        <a:t>20</a:t>
+                        <a:t>1</a:t>
                       </a:r>
                       <a:endParaRPr lang="en-US" sz="1100" dirty="0">
                         <a:latin typeface="맑은 고딕" charset="0"/>
@@ -16849,7 +17259,7 @@
                           <a:ea typeface="맑은 고딕" pitchFamily="34" charset="-122"/>
                           <a:cs typeface="맑은 고딕" pitchFamily="34" charset="-120"/>
                         </a:rPr>
-                        <a:t>1 개</a:t>
+                        <a:t>20</a:t>
                       </a:r>
                       <a:endParaRPr lang="en-US" sz="1100" dirty="0">
                         <a:latin typeface="맑은 고딕" charset="0"/>
@@ -16919,7 +17329,7 @@
                           <a:ea typeface="맑은 고딕" pitchFamily="34" charset="-122"/>
                           <a:cs typeface="맑은 고딕" pitchFamily="34" charset="-120"/>
                         </a:rPr>
-                        <a:t>긴급</a:t>
+                        <a:t>8</a:t>
                       </a:r>
                       <a:endParaRPr lang="en-US" sz="1100" dirty="0">
                         <a:latin typeface="맑은 고딕" charset="0"/>
@@ -16987,7 +17397,7 @@
                           <a:ea typeface="맑은 고딕" pitchFamily="34" charset="-122"/>
                           <a:cs typeface="맑은 고딕" pitchFamily="34" charset="-120"/>
                         </a:rPr>
-                        <a:t>PR</a:t>
+                        <a:t>PP</a:t>
                       </a:r>
                       <a:endParaRPr lang="en-US" sz="1100" dirty="0">
                         <a:latin typeface="맑은 고딕" charset="0"/>
@@ -17191,7 +17601,7 @@
                           <a:ea typeface="맑은 고딕" pitchFamily="34" charset="-122"/>
                           <a:cs typeface="맑은 고딕" pitchFamily="34" charset="-120"/>
                         </a:rPr>
-                        <a:t>13</a:t>
+                        <a:t>1</a:t>
                       </a:r>
                       <a:endParaRPr lang="en-US" sz="1100" dirty="0">
                         <a:latin typeface="맑은 고딕" charset="0"/>
@@ -17259,7 +17669,7 @@
                           <a:ea typeface="맑은 고딕" pitchFamily="34" charset="-122"/>
                           <a:cs typeface="맑은 고딕" pitchFamily="34" charset="-120"/>
                         </a:rPr>
-                        <a:t>1 개</a:t>
+                        <a:t>13</a:t>
                       </a:r>
                       <a:endParaRPr lang="en-US" sz="1100" dirty="0">
                         <a:latin typeface="맑은 고딕" charset="0"/>
@@ -17329,7 +17739,7 @@
                           <a:ea typeface="맑은 고딕" pitchFamily="34" charset="-122"/>
                           <a:cs typeface="맑은 고딕" pitchFamily="34" charset="-120"/>
                         </a:rPr>
-                        <a:t>긴급</a:t>
+                        <a:t>9</a:t>
                       </a:r>
                       <a:endParaRPr lang="en-US" sz="1100" dirty="0">
                         <a:latin typeface="맑은 고딕" charset="0"/>
@@ -17397,7 +17807,7 @@
                           <a:ea typeface="맑은 고딕" pitchFamily="34" charset="-122"/>
                           <a:cs typeface="맑은 고딕" pitchFamily="34" charset="-120"/>
                         </a:rPr>
-                        <a:t>6A</a:t>
+                        <a:t>PP</a:t>
                       </a:r>
                       <a:endParaRPr lang="en-US" sz="1100" dirty="0">
                         <a:latin typeface="맑은 고딕" charset="0"/>
@@ -17465,7 +17875,7 @@
                           <a:ea typeface="맑은 고딕" pitchFamily="34" charset="-122"/>
                           <a:cs typeface="맑은 고딕" pitchFamily="34" charset="-120"/>
                         </a:rPr>
-                        <a:t>Necklace</a:t>
+                        <a:t>ELECTRONIC</a:t>
                       </a:r>
                       <a:endParaRPr lang="en-US" sz="1000" dirty="0">
                         <a:latin typeface="맑은 고딕" charset="0"/>
@@ -17533,7 +17943,7 @@
                           <a:ea typeface="맑은 고딕" pitchFamily="34" charset="-122"/>
                           <a:cs typeface="맑은 고딕" pitchFamily="34" charset="-120"/>
                         </a:rPr>
-                        <a:t>B-Flower Necklace (Size: 2 Size)</a:t>
+                        <a:t>180° Fast Charging Cable (8color) (컬러: 오렌지 / 기종 옵션: USB -&gt; C type)</a:t>
                       </a:r>
                       <a:endParaRPr lang="en-US" sz="1100" dirty="0">
                         <a:latin typeface="맑은 고딕" charset="0"/>
@@ -17601,7 +18011,7 @@
                           <a:ea typeface="맑은 고딕" pitchFamily="34" charset="-122"/>
                           <a:cs typeface="맑은 고딕" pitchFamily="34" charset="-120"/>
                         </a:rPr>
-                        <a:t>5</a:t>
+                        <a:t>1</a:t>
                       </a:r>
                       <a:endParaRPr lang="en-US" sz="1100" dirty="0">
                         <a:latin typeface="맑은 고딕" charset="0"/>
@@ -17669,417 +18079,7 @@
                           <a:ea typeface="맑은 고딕" pitchFamily="34" charset="-122"/>
                           <a:cs typeface="맑은 고딕" pitchFamily="34" charset="-120"/>
                         </a:rPr>
-                        <a:t>0 개</a:t>
-                      </a:r>
-                      <a:endParaRPr lang="en-US" sz="1100" dirty="0">
-                        <a:latin typeface="맑은 고딕" charset="0"/>
-                        <a:ea typeface="맑은 고딕" charset="0"/>
-                        <a:cs typeface="맑은 고딕" charset="0"/>
-                      </a:endParaRPr>
-                    </a:p>
-                  </a:txBody>
-                  <a:tcPr marL="91440" marR="91440" marT="45720" marB="45720" anchor="ctr">
-                    <a:lnL w="6350" cap="flat" cmpd="sng" algn="ctr">
-                      <a:solidFill>
-                        <a:srgbClr val="E5E7EB"/>
-                      </a:solidFill>
-                      <a:prstDash val="solid"/>
-                      <a:round/>
-                      <a:headEnd type="none" w="med" len="med"/>
-                      <a:tailEnd type="none" w="med" len="med"/>
-                    </a:lnL>
-                    <a:lnR w="6350" cap="flat" cmpd="sng" algn="ctr">
-                      <a:solidFill>
-                        <a:srgbClr val="E5E7EB"/>
-                      </a:solidFill>
-                      <a:prstDash val="solid"/>
-                      <a:round/>
-                      <a:headEnd type="none" w="med" len="med"/>
-                      <a:tailEnd type="none" w="med" len="med"/>
-                    </a:lnR>
-                    <a:lnT w="6350" cap="flat" cmpd="sng" algn="ctr">
-                      <a:solidFill>
-                        <a:srgbClr val="E5E7EB"/>
-                      </a:solidFill>
-                      <a:prstDash val="solid"/>
-                      <a:round/>
-                      <a:headEnd type="none" w="med" len="med"/>
-                      <a:tailEnd type="none" w="med" len="med"/>
-                    </a:lnT>
-                    <a:lnB w="6350" cap="flat" cmpd="sng" algn="ctr">
-                      <a:solidFill>
-                        <a:srgbClr val="E5E7EB"/>
-                      </a:solidFill>
-                      <a:prstDash val="solid"/>
-                      <a:round/>
-                      <a:headEnd type="none" w="med" len="med"/>
-                      <a:tailEnd type="none" w="med" len="med"/>
-                    </a:lnB>
-                    <a:solidFill>
-                      <a:srgbClr val="FFF5F5"/>
-                    </a:solidFill>
-                  </a:tcPr>
-                </a:tc>
-              </a:tr>
-              <a:tr h="384048">
-                <a:tc>
-                  <a:txBody>
-                    <a:bodyPr/>
-                    <a:lstStyle/>
-                    <a:p>
-                      <a:pPr algn="ctr" indent="0" marL="0">
-                        <a:buNone/>
-                      </a:pPr>
-                      <a:r>
-                        <a:rPr lang="en-US" sz="1100" b="1" dirty="0">
-                          <a:solidFill>
-                            <a:srgbClr val="FFFFFF"/>
-                          </a:solidFill>
-                          <a:latin typeface="맑은 고딕" pitchFamily="34" charset="0"/>
-                          <a:ea typeface="맑은 고딕" pitchFamily="34" charset="-122"/>
-                          <a:cs typeface="맑은 고딕" pitchFamily="34" charset="-120"/>
-                        </a:rPr>
-                        <a:t>긴급</a:t>
-                      </a:r>
-                      <a:endParaRPr lang="en-US" sz="1100" dirty="0">
-                        <a:latin typeface="맑은 고딕" charset="0"/>
-                        <a:ea typeface="맑은 고딕" charset="0"/>
-                        <a:cs typeface="맑은 고딕" charset="0"/>
-                      </a:endParaRPr>
-                    </a:p>
-                  </a:txBody>
-                  <a:tcPr marL="91440" marR="91440" marT="45720" marB="45720" anchor="ctr">
-                    <a:lnL w="6350" cap="flat" cmpd="sng" algn="ctr">
-                      <a:solidFill>
-                        <a:srgbClr val="E5E7EB"/>
-                      </a:solidFill>
-                      <a:prstDash val="solid"/>
-                      <a:round/>
-                      <a:headEnd type="none" w="med" len="med"/>
-                      <a:tailEnd type="none" w="med" len="med"/>
-                    </a:lnL>
-                    <a:lnR w="6350" cap="flat" cmpd="sng" algn="ctr">
-                      <a:solidFill>
-                        <a:srgbClr val="E5E7EB"/>
-                      </a:solidFill>
-                      <a:prstDash val="solid"/>
-                      <a:round/>
-                      <a:headEnd type="none" w="med" len="med"/>
-                      <a:tailEnd type="none" w="med" len="med"/>
-                    </a:lnR>
-                    <a:lnT w="6350" cap="flat" cmpd="sng" algn="ctr">
-                      <a:solidFill>
-                        <a:srgbClr val="E5E7EB"/>
-                      </a:solidFill>
-                      <a:prstDash val="solid"/>
-                      <a:round/>
-                      <a:headEnd type="none" w="med" len="med"/>
-                      <a:tailEnd type="none" w="med" len="med"/>
-                    </a:lnT>
-                    <a:lnB w="6350" cap="flat" cmpd="sng" algn="ctr">
-                      <a:solidFill>
-                        <a:srgbClr val="E5E7EB"/>
-                      </a:solidFill>
-                      <a:prstDash val="solid"/>
-                      <a:round/>
-                      <a:headEnd type="none" w="med" len="med"/>
-                      <a:tailEnd type="none" w="med" len="med"/>
-                    </a:lnB>
-                    <a:solidFill>
-                      <a:srgbClr val="D72638"/>
-                    </a:solidFill>
-                  </a:tcPr>
-                </a:tc>
-                <a:tc>
-                  <a:txBody>
-                    <a:bodyPr/>
-                    <a:lstStyle/>
-                    <a:p>
-                      <a:pPr algn="ctr" indent="0" marL="0">
-                        <a:buNone/>
-                      </a:pPr>
-                      <a:r>
-                        <a:rPr lang="en-US" sz="1100" b="1" dirty="0">
-                          <a:solidFill>
-                            <a:srgbClr val="1F2937"/>
-                          </a:solidFill>
-                          <a:latin typeface="맑은 고딕" pitchFamily="34" charset="0"/>
-                          <a:ea typeface="맑은 고딕" pitchFamily="34" charset="-122"/>
-                          <a:cs typeface="맑은 고딕" pitchFamily="34" charset="-120"/>
-                        </a:rPr>
-                        <a:t>6A</a:t>
-                      </a:r>
-                      <a:endParaRPr lang="en-US" sz="1100" dirty="0">
-                        <a:latin typeface="맑은 고딕" charset="0"/>
-                        <a:ea typeface="맑은 고딕" charset="0"/>
-                        <a:cs typeface="맑은 고딕" charset="0"/>
-                      </a:endParaRPr>
-                    </a:p>
-                  </a:txBody>
-                  <a:tcPr marL="91440" marR="91440" marT="45720" marB="45720" anchor="ctr">
-                    <a:lnL w="6350" cap="flat" cmpd="sng" algn="ctr">
-                      <a:solidFill>
-                        <a:srgbClr val="E5E7EB"/>
-                      </a:solidFill>
-                      <a:prstDash val="solid"/>
-                      <a:round/>
-                      <a:headEnd type="none" w="med" len="med"/>
-                      <a:tailEnd type="none" w="med" len="med"/>
-                    </a:lnL>
-                    <a:lnR w="6350" cap="flat" cmpd="sng" algn="ctr">
-                      <a:solidFill>
-                        <a:srgbClr val="E5E7EB"/>
-                      </a:solidFill>
-                      <a:prstDash val="solid"/>
-                      <a:round/>
-                      <a:headEnd type="none" w="med" len="med"/>
-                      <a:tailEnd type="none" w="med" len="med"/>
-                    </a:lnR>
-                    <a:lnT w="6350" cap="flat" cmpd="sng" algn="ctr">
-                      <a:solidFill>
-                        <a:srgbClr val="E5E7EB"/>
-                      </a:solidFill>
-                      <a:prstDash val="solid"/>
-                      <a:round/>
-                      <a:headEnd type="none" w="med" len="med"/>
-                      <a:tailEnd type="none" w="med" len="med"/>
-                    </a:lnT>
-                    <a:lnB w="6350" cap="flat" cmpd="sng" algn="ctr">
-                      <a:solidFill>
-                        <a:srgbClr val="E5E7EB"/>
-                      </a:solidFill>
-                      <a:prstDash val="solid"/>
-                      <a:round/>
-                      <a:headEnd type="none" w="med" len="med"/>
-                      <a:tailEnd type="none" w="med" len="med"/>
-                    </a:lnB>
-                    <a:solidFill>
-                      <a:srgbClr val="FFF5F5"/>
-                    </a:solidFill>
-                  </a:tcPr>
-                </a:tc>
-                <a:tc>
-                  <a:txBody>
-                    <a:bodyPr/>
-                    <a:lstStyle/>
-                    <a:p>
-                      <a:pPr indent="0" marL="0">
-                        <a:buNone/>
-                      </a:pPr>
-                      <a:r>
-                        <a:rPr lang="en-US" sz="1000" dirty="0">
-                          <a:solidFill>
-                            <a:srgbClr val="6B7280"/>
-                          </a:solidFill>
-                          <a:latin typeface="맑은 고딕" pitchFamily="34" charset="0"/>
-                          <a:ea typeface="맑은 고딕" pitchFamily="34" charset="-122"/>
-                          <a:cs typeface="맑은 고딕" pitchFamily="34" charset="-120"/>
-                        </a:rPr>
-                        <a:t>★Season off★</a:t>
-                      </a:r>
-                      <a:endParaRPr lang="en-US" sz="1000" dirty="0">
-                        <a:latin typeface="맑은 고딕" charset="0"/>
-                        <a:ea typeface="맑은 고딕" charset="0"/>
-                        <a:cs typeface="맑은 고딕" charset="0"/>
-                      </a:endParaRPr>
-                    </a:p>
-                  </a:txBody>
-                  <a:tcPr marL="91440" marR="91440" marT="45720" marB="45720" anchor="ctr">
-                    <a:lnL w="6350" cap="flat" cmpd="sng" algn="ctr">
-                      <a:solidFill>
-                        <a:srgbClr val="E5E7EB"/>
-                      </a:solidFill>
-                      <a:prstDash val="solid"/>
-                      <a:round/>
-                      <a:headEnd type="none" w="med" len="med"/>
-                      <a:tailEnd type="none" w="med" len="med"/>
-                    </a:lnL>
-                    <a:lnR w="6350" cap="flat" cmpd="sng" algn="ctr">
-                      <a:solidFill>
-                        <a:srgbClr val="E5E7EB"/>
-                      </a:solidFill>
-                      <a:prstDash val="solid"/>
-                      <a:round/>
-                      <a:headEnd type="none" w="med" len="med"/>
-                      <a:tailEnd type="none" w="med" len="med"/>
-                    </a:lnR>
-                    <a:lnT w="6350" cap="flat" cmpd="sng" algn="ctr">
-                      <a:solidFill>
-                        <a:srgbClr val="E5E7EB"/>
-                      </a:solidFill>
-                      <a:prstDash val="solid"/>
-                      <a:round/>
-                      <a:headEnd type="none" w="med" len="med"/>
-                      <a:tailEnd type="none" w="med" len="med"/>
-                    </a:lnT>
-                    <a:lnB w="6350" cap="flat" cmpd="sng" algn="ctr">
-                      <a:solidFill>
-                        <a:srgbClr val="E5E7EB"/>
-                      </a:solidFill>
-                      <a:prstDash val="solid"/>
-                      <a:round/>
-                      <a:headEnd type="none" w="med" len="med"/>
-                      <a:tailEnd type="none" w="med" len="med"/>
-                    </a:lnB>
-                    <a:solidFill>
-                      <a:srgbClr val="FFF5F5"/>
-                    </a:solidFill>
-                  </a:tcPr>
-                </a:tc>
-                <a:tc>
-                  <a:txBody>
-                    <a:bodyPr/>
-                    <a:lstStyle/>
-                    <a:p>
-                      <a:pPr indent="0" marL="0">
-                        <a:buNone/>
-                      </a:pPr>
-                      <a:r>
-                        <a:rPr lang="en-US" sz="1100" b="1" dirty="0">
-                          <a:solidFill>
-                            <a:srgbClr val="0B1220"/>
-                          </a:solidFill>
-                          <a:latin typeface="맑은 고딕" pitchFamily="34" charset="0"/>
-                          <a:ea typeface="맑은 고딕" pitchFamily="34" charset="-122"/>
-                          <a:cs typeface="맑은 고딕" pitchFamily="34" charset="-120"/>
-                        </a:rPr>
-                        <a:t>8-Ball Smart Tok</a:t>
-                      </a:r>
-                      <a:endParaRPr lang="en-US" sz="1100" dirty="0">
-                        <a:latin typeface="맑은 고딕" charset="0"/>
-                        <a:ea typeface="맑은 고딕" charset="0"/>
-                        <a:cs typeface="맑은 고딕" charset="0"/>
-                      </a:endParaRPr>
-                    </a:p>
-                  </a:txBody>
-                  <a:tcPr marL="91440" marR="91440" marT="45720" marB="45720" anchor="ctr">
-                    <a:lnL w="6350" cap="flat" cmpd="sng" algn="ctr">
-                      <a:solidFill>
-                        <a:srgbClr val="E5E7EB"/>
-                      </a:solidFill>
-                      <a:prstDash val="solid"/>
-                      <a:round/>
-                      <a:headEnd type="none" w="med" len="med"/>
-                      <a:tailEnd type="none" w="med" len="med"/>
-                    </a:lnL>
-                    <a:lnR w="6350" cap="flat" cmpd="sng" algn="ctr">
-                      <a:solidFill>
-                        <a:srgbClr val="E5E7EB"/>
-                      </a:solidFill>
-                      <a:prstDash val="solid"/>
-                      <a:round/>
-                      <a:headEnd type="none" w="med" len="med"/>
-                      <a:tailEnd type="none" w="med" len="med"/>
-                    </a:lnR>
-                    <a:lnT w="6350" cap="flat" cmpd="sng" algn="ctr">
-                      <a:solidFill>
-                        <a:srgbClr val="E5E7EB"/>
-                      </a:solidFill>
-                      <a:prstDash val="solid"/>
-                      <a:round/>
-                      <a:headEnd type="none" w="med" len="med"/>
-                      <a:tailEnd type="none" w="med" len="med"/>
-                    </a:lnT>
-                    <a:lnB w="6350" cap="flat" cmpd="sng" algn="ctr">
-                      <a:solidFill>
-                        <a:srgbClr val="E5E7EB"/>
-                      </a:solidFill>
-                      <a:prstDash val="solid"/>
-                      <a:round/>
-                      <a:headEnd type="none" w="med" len="med"/>
-                      <a:tailEnd type="none" w="med" len="med"/>
-                    </a:lnB>
-                    <a:solidFill>
-                      <a:srgbClr val="FFF5F5"/>
-                    </a:solidFill>
-                  </a:tcPr>
-                </a:tc>
-                <a:tc>
-                  <a:txBody>
-                    <a:bodyPr/>
-                    <a:lstStyle/>
-                    <a:p>
-                      <a:pPr algn="r" indent="0" marL="0">
-                        <a:buNone/>
-                      </a:pPr>
-                      <a:r>
-                        <a:rPr lang="en-US" sz="1100" b="1" dirty="0">
-                          <a:solidFill>
-                            <a:srgbClr val="D72638"/>
-                          </a:solidFill>
-                          <a:latin typeface="맑은 고딕" pitchFamily="34" charset="0"/>
-                          <a:ea typeface="맑은 고딕" pitchFamily="34" charset="-122"/>
-                          <a:cs typeface="맑은 고딕" pitchFamily="34" charset="-120"/>
-                        </a:rPr>
-                        <a:t>5</a:t>
-                      </a:r>
-                      <a:endParaRPr lang="en-US" sz="1100" dirty="0">
-                        <a:latin typeface="맑은 고딕" charset="0"/>
-                        <a:ea typeface="맑은 고딕" charset="0"/>
-                        <a:cs typeface="맑은 고딕" charset="0"/>
-                      </a:endParaRPr>
-                    </a:p>
-                  </a:txBody>
-                  <a:tcPr marL="91440" marR="91440" marT="45720" marB="45720" anchor="ctr">
-                    <a:lnL w="6350" cap="flat" cmpd="sng" algn="ctr">
-                      <a:solidFill>
-                        <a:srgbClr val="E5E7EB"/>
-                      </a:solidFill>
-                      <a:prstDash val="solid"/>
-                      <a:round/>
-                      <a:headEnd type="none" w="med" len="med"/>
-                      <a:tailEnd type="none" w="med" len="med"/>
-                    </a:lnL>
-                    <a:lnR w="6350" cap="flat" cmpd="sng" algn="ctr">
-                      <a:solidFill>
-                        <a:srgbClr val="E5E7EB"/>
-                      </a:solidFill>
-                      <a:prstDash val="solid"/>
-                      <a:round/>
-                      <a:headEnd type="none" w="med" len="med"/>
-                      <a:tailEnd type="none" w="med" len="med"/>
-                    </a:lnR>
-                    <a:lnT w="6350" cap="flat" cmpd="sng" algn="ctr">
-                      <a:solidFill>
-                        <a:srgbClr val="E5E7EB"/>
-                      </a:solidFill>
-                      <a:prstDash val="solid"/>
-                      <a:round/>
-                      <a:headEnd type="none" w="med" len="med"/>
-                      <a:tailEnd type="none" w="med" len="med"/>
-                    </a:lnT>
-                    <a:lnB w="6350" cap="flat" cmpd="sng" algn="ctr">
-                      <a:solidFill>
-                        <a:srgbClr val="E5E7EB"/>
-                      </a:solidFill>
-                      <a:prstDash val="solid"/>
-                      <a:round/>
-                      <a:headEnd type="none" w="med" len="med"/>
-                      <a:tailEnd type="none" w="med" len="med"/>
-                    </a:lnB>
-                    <a:solidFill>
-                      <a:srgbClr val="FFF5F5"/>
-                    </a:solidFill>
-                  </a:tcPr>
-                </a:tc>
-                <a:tc>
-                  <a:txBody>
-                    <a:bodyPr/>
-                    <a:lstStyle/>
-                    <a:p>
-                      <a:pPr algn="r" indent="0" marL="0">
-                        <a:buNone/>
-                      </a:pPr>
-                      <a:r>
-                        <a:rPr lang="en-US" sz="1100" dirty="0">
-                          <a:solidFill>
-                            <a:srgbClr val="1F2937"/>
-                          </a:solidFill>
-                          <a:latin typeface="맑은 고딕" pitchFamily="34" charset="0"/>
-                          <a:ea typeface="맑은 고딕" pitchFamily="34" charset="-122"/>
-                          <a:cs typeface="맑은 고딕" pitchFamily="34" charset="-120"/>
-                        </a:rPr>
-                        <a:t>0 개</a:t>
+                        <a:t>0</a:t>
                       </a:r>
                       <a:endParaRPr lang="en-US" sz="1100" dirty="0">
                         <a:latin typeface="맑은 고딕" charset="0"/>
@@ -18168,7 +18168,7 @@
                 <a:ea typeface="맑은 고딕" pitchFamily="34" charset="-122"/>
                 <a:cs typeface="맑은 고딕" pitchFamily="34" charset="-120"/>
               </a:rPr>
-              <a:t>외 56건 더 있음 — 상세는 시트에서 확인</a:t>
+              <a:t>외 21건 더 있음 — 상세는 시트에서 확인</a:t>
             </a:r>
             <a:endParaRPr lang="en-US" sz="1000" dirty="0"/>
           </a:p>
@@ -18207,7 +18207,7 @@
                 <a:ea typeface="맑은 고딕" pitchFamily="34" charset="-122"/>
                 <a:cs typeface="맑은 고딕" pitchFamily="34" charset="-120"/>
               </a:rPr>
-              <a:t>베스트 상품 리포트  ·  생성 2026-05-19 08:00</a:t>
+              <a:t>베스트 상품 리포트  ·  생성 2026-05-19 12:14</a:t>
             </a:r>
             <a:endParaRPr lang="en-US" sz="900" dirty="0"/>
           </a:p>
@@ -18420,7 +18420,7 @@
                 <a:ea typeface="맑은 고딕" pitchFamily="34" charset="-122"/>
                 <a:cs typeface="맑은 고딕" pitchFamily="34" charset="-120"/>
               </a:rPr>
-              <a:t>2026년 05월 19일 (화)</a:t>
+              <a:t>2026년 5월 19일 (화)</a:t>
             </a:r>
             <a:endParaRPr lang="en-US" sz="1200" dirty="0"/>
           </a:p>
@@ -18587,7 +18587,7 @@
                 <a:ea typeface="맑은 고딕" pitchFamily="34" charset="-122"/>
                 <a:cs typeface="맑은 고딕" pitchFamily="34" charset="-120"/>
               </a:rPr>
-              <a:t>Google Sheet '브랜드 재고현황'  ·  최신화 2026-05-19 08:00</a:t>
+              <a:t>Google Sheet '브랜드 재고현황'  ·  최신화 2026-05-19 08:00 KST</a:t>
             </a:r>
             <a:endParaRPr lang="en-US" sz="1100" dirty="0"/>
           </a:p>
@@ -19099,7 +19099,7 @@
                 <a:ea typeface="맑은 고딕" pitchFamily="34" charset="-122"/>
                 <a:cs typeface="맑은 고딕" pitchFamily="34" charset="-120"/>
               </a:rPr>
-              <a:t>✅ 6A 87 SKU  /  ✅ Cleartype 59 SKU  /  ✅ Produktepr 192 SKU (판매 수집됨)</a:t>
+              <a:t>✅ 6A 87 SKU  /  ✅ Cleartype 59 SKU  /  ✅ Produktepr 192 SKU</a:t>
             </a:r>
             <a:endParaRPr lang="en-US" sz="1100" dirty="0"/>
           </a:p>
@@ -19230,7 +19230,7 @@
                 <a:ea typeface="맑은 고딕" pitchFamily="34" charset="-122"/>
                 <a:cs typeface="맑은 고딕" pitchFamily="34" charset="-120"/>
               </a:rPr>
-              <a:t>✅ 3개 브랜드 모두 정상 추출  ·  24h 출고 기준 (2026-05-18 08:00 → 2026-05-19 08:00) · 신규 SKU 13건은 결제완료 기준</a:t>
+              <a:t>✅ 3개 브랜드 모두 정상 추출 — 데이터 손실 없음</a:t>
             </a:r>
             <a:endParaRPr lang="en-US" sz="1000" dirty="0"/>
           </a:p>
@@ -19269,7 +19269,7 @@
                 <a:ea typeface="맑은 고딕" pitchFamily="34" charset="-122"/>
                 <a:cs typeface="맑은 고딕" pitchFamily="34" charset="-120"/>
               </a:rPr>
-              <a:t>베스트 상품 리포트  ·  생성 2026-05-19 08:00</a:t>
+              <a:t>베스트 상품 리포트  ·  생성 2026-05-19 12:14</a:t>
             </a:r>
             <a:endParaRPr lang="en-US" sz="900" dirty="0"/>
           </a:p>

</xml_diff>

<commit_message>
chore: 매출 PPT 업로드 (best-sellers-2026-05-21.pptx) [auto]
</commit_message>
<xml_diff>
--- a/data/sales-report.pptx
+++ b/data/sales-report.pptx
@@ -1648,7 +1648,7 @@
                 <a:ea typeface="맑은 고딕" pitchFamily="34" charset="-122"/>
                 <a:cs typeface="맑은 고딕" pitchFamily="34" charset="-120"/>
               </a:rPr>
-              <a:t>2026년 05월 20일 (수)  ·  24h 출고 기준</a:t>
+              <a:t>2026년 05월 21일 (목)  ·  24h 출고 기준</a:t>
             </a:r>
             <a:endParaRPr lang="en-US" sz="2200" dirty="0"/>
           </a:p>
@@ -1726,7 +1726,7 @@
                 <a:ea typeface="맑은 고딕" pitchFamily="34" charset="-122"/>
                 <a:cs typeface="맑은 고딕" pitchFamily="34" charset="-120"/>
               </a:rPr>
-              <a:t>05.20</a:t>
+              <a:t>05.21</a:t>
             </a:r>
             <a:endParaRPr lang="en-US" sz="7200" dirty="0"/>
           </a:p>
@@ -1765,7 +1765,7 @@
                 <a:ea typeface="맑은 고딕" pitchFamily="34" charset="-122"/>
                 <a:cs typeface="맑은 고딕" pitchFamily="34" charset="-120"/>
               </a:rPr>
-              <a:t>수요일</a:t>
+              <a:t>목요일</a:t>
             </a:r>
             <a:endParaRPr lang="en-US" sz="1400" dirty="0"/>
           </a:p>
@@ -1804,7 +1804,7 @@
                 <a:ea typeface="맑은 고딕" pitchFamily="34" charset="-122"/>
                 <a:cs typeface="맑은 고딕" pitchFamily="34" charset="-120"/>
               </a:rPr>
-              <a:t>생성 2026-05-20 08:00  ·  Google Sheet 자동 동기</a:t>
+              <a:t>생성 2026-05-21 08:00  ·  Google Sheet 자동 동기</a:t>
             </a:r>
             <a:endParaRPr lang="en-US" sz="1000" dirty="0"/>
           </a:p>
@@ -1978,7 +1978,7 @@
                 <a:ea typeface="맑은 고딕" pitchFamily="34" charset="-122"/>
                 <a:cs typeface="맑은 고딕" pitchFamily="34" charset="-120"/>
               </a:rPr>
-              <a:t>2026년 05월 20일 (수)</a:t>
+              <a:t>2026년 05월 21일 (목)</a:t>
             </a:r>
             <a:endParaRPr lang="en-US" sz="1200" dirty="0"/>
           </a:p>
@@ -2145,7 +2145,7 @@
                 <a:ea typeface="맑은 고딕" pitchFamily="34" charset="-122"/>
                 <a:cs typeface="맑은 고딕" pitchFamily="34" charset="-120"/>
               </a:rPr>
-              <a:t>341 개</a:t>
+              <a:t>428 개</a:t>
             </a:r>
             <a:endParaRPr lang="en-US" sz="3600" dirty="0"/>
           </a:p>
@@ -2312,7 +2312,7 @@
                 <a:ea typeface="맑은 고딕" pitchFamily="34" charset="-122"/>
                 <a:cs typeface="맑은 고딕" pitchFamily="34" charset="-120"/>
               </a:rPr>
-              <a:t>66 건</a:t>
+              <a:t>70 건</a:t>
             </a:r>
             <a:endParaRPr lang="en-US" sz="3200" dirty="0"/>
           </a:p>
@@ -2479,7 +2479,7 @@
                 <a:ea typeface="맑은 고딕" pitchFamily="34" charset="-122"/>
                 <a:cs typeface="맑은 고딕" pitchFamily="34" charset="-120"/>
               </a:rPr>
-              <a:t>10 건</a:t>
+              <a:t>13 건</a:t>
             </a:r>
             <a:endParaRPr lang="en-US" sz="3200" dirty="0"/>
           </a:p>
@@ -3482,7 +3482,7 @@
                           <a:ea typeface="맑은 고딕" pitchFamily="34" charset="-122"/>
                           <a:cs typeface="맑은 고딕" pitchFamily="34" charset="-120"/>
                         </a:rPr>
-                        <a:t>CT</a:t>
+                        <a:t>6A</a:t>
                       </a:r>
                       <a:endParaRPr lang="en-US" sz="1100" dirty="0">
                         <a:latin typeface="맑은 고딕" charset="0"/>
@@ -3547,7 +3547,7 @@
                           <a:ea typeface="맑은 고딕" pitchFamily="34" charset="-122"/>
                           <a:cs typeface="맑은 고딕" pitchFamily="34" charset="-120"/>
                         </a:rPr>
-                        <a:t>Necklace</a:t>
+                        <a:t>Ring</a:t>
                       </a:r>
                       <a:endParaRPr lang="en-US" sz="1000" dirty="0">
                         <a:latin typeface="맑은 고딕" charset="0"/>
@@ -3612,7 +3612,7 @@
                           <a:ea typeface="맑은 고딕" pitchFamily="34" charset="-122"/>
                           <a:cs typeface="맑은 고딕" pitchFamily="34" charset="-120"/>
                         </a:rPr>
-                        <a:t>CandyPOP Necklace (사이즈: 2size (47~52cm))</a:t>
+                        <a:t>[SILVER925] CH.alban Open Ring</a:t>
                       </a:r>
                       <a:endParaRPr lang="en-US" sz="1100" dirty="0">
                         <a:latin typeface="맑은 고딕" charset="0"/>
@@ -3677,7 +3677,7 @@
                           <a:ea typeface="맑은 고딕" pitchFamily="34" charset="-122"/>
                           <a:cs typeface="맑은 고딕" pitchFamily="34" charset="-120"/>
                         </a:rPr>
-                        <a:t>37 개</a:t>
+                        <a:t>43 개</a:t>
                       </a:r>
                       <a:endParaRPr lang="en-US" sz="1400" dirty="0">
                         <a:latin typeface="맑은 고딕" charset="0"/>
@@ -3809,7 +3809,7 @@
                           <a:ea typeface="맑은 고딕" pitchFamily="34" charset="-122"/>
                           <a:cs typeface="맑은 고딕" pitchFamily="34" charset="-120"/>
                         </a:rPr>
-                        <a:t>6A</a:t>
+                        <a:t>CT</a:t>
                       </a:r>
                       <a:endParaRPr lang="en-US" sz="1100" dirty="0">
                         <a:latin typeface="맑은 고딕" charset="0"/>
@@ -3874,7 +3874,7 @@
                           <a:ea typeface="맑은 고딕" pitchFamily="34" charset="-122"/>
                           <a:cs typeface="맑은 고딕" pitchFamily="34" charset="-120"/>
                         </a:rPr>
-                        <a:t>Ring</a:t>
+                        <a:t>Necklace</a:t>
                       </a:r>
                       <a:endParaRPr lang="en-US" sz="1000" dirty="0">
                         <a:latin typeface="맑은 고딕" charset="0"/>
@@ -3939,7 +3939,7 @@
                           <a:ea typeface="맑은 고딕" pitchFamily="34" charset="-122"/>
                           <a:cs typeface="맑은 고딕" pitchFamily="34" charset="-120"/>
                         </a:rPr>
-                        <a:t>[SILVER925] CH.alban Open Ring</a:t>
+                        <a:t>CandyPOP Necklace (사이즈: 1size (37~43cm))</a:t>
                       </a:r>
                       <a:endParaRPr lang="en-US" sz="1100" dirty="0">
                         <a:latin typeface="맑은 고딕" charset="0"/>
@@ -4004,7 +4004,7 @@
                           <a:ea typeface="맑은 고딕" pitchFamily="34" charset="-122"/>
                           <a:cs typeface="맑은 고딕" pitchFamily="34" charset="-120"/>
                         </a:rPr>
-                        <a:t>23 개</a:t>
+                        <a:t>33 개</a:t>
                       </a:r>
                       <a:endParaRPr lang="en-US" sz="1400" dirty="0">
                         <a:latin typeface="맑은 고딕" charset="0"/>
@@ -4331,7 +4331,7 @@
                           <a:ea typeface="맑은 고딕" pitchFamily="34" charset="-122"/>
                           <a:cs typeface="맑은 고딕" pitchFamily="34" charset="-120"/>
                         </a:rPr>
-                        <a:t>22 개</a:t>
+                        <a:t>28 개</a:t>
                       </a:r>
                       <a:endParaRPr lang="en-US" sz="1400" dirty="0">
                         <a:latin typeface="맑은 고딕" charset="0"/>
@@ -4463,7 +4463,7 @@
                           <a:ea typeface="맑은 고딕" pitchFamily="34" charset="-122"/>
                           <a:cs typeface="맑은 고딕" pitchFamily="34" charset="-120"/>
                         </a:rPr>
-                        <a:t>CT</a:t>
+                        <a:t>6A</a:t>
                       </a:r>
                       <a:endParaRPr lang="en-US" sz="1100" dirty="0">
                         <a:latin typeface="맑은 고딕" charset="0"/>
@@ -4528,7 +4528,7 @@
                           <a:ea typeface="맑은 고딕" pitchFamily="34" charset="-122"/>
                           <a:cs typeface="맑은 고딕" pitchFamily="34" charset="-120"/>
                         </a:rPr>
-                        <a:t>Necklace</a:t>
+                        <a:t>Ring</a:t>
                       </a:r>
                       <a:endParaRPr lang="en-US" sz="1000" dirty="0">
                         <a:latin typeface="맑은 고딕" charset="0"/>
@@ -4593,7 +4593,7 @@
                           <a:ea typeface="맑은 고딕" pitchFamily="34" charset="-122"/>
                           <a:cs typeface="맑은 고딕" pitchFamily="34" charset="-120"/>
                         </a:rPr>
-                        <a:t>ThreadDuo Necklace</a:t>
+                        <a:t>[SILVER925] Guyeong Open Ring v3.0 (silver)</a:t>
                       </a:r>
                       <a:endParaRPr lang="en-US" sz="1100" dirty="0">
                         <a:latin typeface="맑은 고딕" charset="0"/>
@@ -4658,7 +4658,7 @@
                           <a:ea typeface="맑은 고딕" pitchFamily="34" charset="-122"/>
                           <a:cs typeface="맑은 고딕" pitchFamily="34" charset="-120"/>
                         </a:rPr>
-                        <a:t>22 개</a:t>
+                        <a:t>25 개</a:t>
                       </a:r>
                       <a:endParaRPr lang="en-US" sz="1200" dirty="0">
                         <a:latin typeface="맑은 고딕" charset="0"/>
@@ -4790,7 +4790,7 @@
                           <a:ea typeface="맑은 고딕" pitchFamily="34" charset="-122"/>
                           <a:cs typeface="맑은 고딕" pitchFamily="34" charset="-120"/>
                         </a:rPr>
-                        <a:t>6A</a:t>
+                        <a:t>CT</a:t>
                       </a:r>
                       <a:endParaRPr lang="en-US" sz="1100" dirty="0">
                         <a:latin typeface="맑은 고딕" charset="0"/>
@@ -4855,7 +4855,7 @@
                           <a:ea typeface="맑은 고딕" pitchFamily="34" charset="-122"/>
                           <a:cs typeface="맑은 고딕" pitchFamily="34" charset="-120"/>
                         </a:rPr>
-                        <a:t>Ring</a:t>
+                        <a:t>Necklace</a:t>
                       </a:r>
                       <a:endParaRPr lang="en-US" sz="1000" dirty="0">
                         <a:latin typeface="맑은 고딕" charset="0"/>
@@ -4920,7 +4920,7 @@
                           <a:ea typeface="맑은 고딕" pitchFamily="34" charset="-122"/>
                           <a:cs typeface="맑은 고딕" pitchFamily="34" charset="-120"/>
                         </a:rPr>
-                        <a:t>[SILVER925] Guyeong Open Ring v3.0 (silver)</a:t>
+                        <a:t>CandyPOP Necklace (사이즈: 2size (47~52cm))</a:t>
                       </a:r>
                       <a:endParaRPr lang="en-US" sz="1100" dirty="0">
                         <a:latin typeface="맑은 고딕" charset="0"/>
@@ -4985,7 +4985,7 @@
                           <a:ea typeface="맑은 고딕" pitchFamily="34" charset="-122"/>
                           <a:cs typeface="맑은 고딕" pitchFamily="34" charset="-120"/>
                         </a:rPr>
-                        <a:t>20 개</a:t>
+                        <a:t>23 개</a:t>
                       </a:r>
                       <a:endParaRPr lang="en-US" sz="1200" dirty="0">
                         <a:latin typeface="맑은 고딕" charset="0"/>
@@ -5071,7 +5071,7 @@
                 <a:ea typeface="맑은 고딕" pitchFamily="34" charset="-122"/>
                 <a:cs typeface="맑은 고딕" pitchFamily="34" charset="-120"/>
               </a:rPr>
-              <a:t>베스트 상품 리포트  ·  생성 2026-05-20 08:00</a:t>
+              <a:t>베스트 상품 리포트  ·  생성 2026-05-21 08:00</a:t>
             </a:r>
             <a:endParaRPr lang="en-US" sz="900" dirty="0"/>
           </a:p>
@@ -5284,7 +5284,7 @@
                 <a:ea typeface="맑은 고딕" pitchFamily="34" charset="-122"/>
                 <a:cs typeface="맑은 고딕" pitchFamily="34" charset="-120"/>
               </a:rPr>
-              <a:t>2026년 05월 20일 (수)</a:t>
+              <a:t>2026년 05월 21일 (목)</a:t>
             </a:r>
             <a:endParaRPr lang="en-US" sz="1200" dirty="0"/>
           </a:p>
@@ -5451,7 +5451,7 @@
                 <a:ea typeface="맑은 고딕" pitchFamily="34" charset="-122"/>
                 <a:cs typeface="맑은 고딕" pitchFamily="34" charset="-120"/>
               </a:rPr>
-              <a:t>211 개</a:t>
+              <a:t>295 개</a:t>
             </a:r>
             <a:endParaRPr lang="en-US" sz="3600" dirty="0"/>
           </a:p>
@@ -5657,7 +5657,7 @@
                 <a:ea typeface="맑은 고딕" pitchFamily="34" charset="-122"/>
                 <a:cs typeface="맑은 고딕" pitchFamily="34" charset="-120"/>
               </a:rPr>
-              <a:t>23</a:t>
+              <a:t>43</a:t>
             </a:r>
             <a:endParaRPr lang="en-US" sz="4400" dirty="0"/>
           </a:p>
@@ -6256,7 +6256,7 @@
                           <a:ea typeface="맑은 고딕" pitchFamily="34" charset="-122"/>
                           <a:cs typeface="맑은 고딕" pitchFamily="34" charset="-120"/>
                         </a:rPr>
-                        <a:t>23 개</a:t>
+                        <a:t>43 개</a:t>
                       </a:r>
                       <a:endParaRPr lang="en-US" sz="1400" dirty="0">
                         <a:latin typeface="맑은 고딕" charset="0"/>
@@ -6518,7 +6518,7 @@
                           <a:ea typeface="맑은 고딕" pitchFamily="34" charset="-122"/>
                           <a:cs typeface="맑은 고딕" pitchFamily="34" charset="-120"/>
                         </a:rPr>
-                        <a:t>20 개</a:t>
+                        <a:t>25 개</a:t>
                       </a:r>
                       <a:endParaRPr lang="en-US" sz="1200" dirty="0">
                         <a:latin typeface="맑은 고딕" charset="0"/>
@@ -6780,7 +6780,7 @@
                           <a:ea typeface="맑은 고딕" pitchFamily="34" charset="-122"/>
                           <a:cs typeface="맑은 고딕" pitchFamily="34" charset="-120"/>
                         </a:rPr>
-                        <a:t>15 개</a:t>
+                        <a:t>16 개</a:t>
                       </a:r>
                       <a:endParaRPr lang="en-US" sz="1200" dirty="0">
                         <a:latin typeface="맑은 고딕" charset="0"/>
@@ -6977,7 +6977,7 @@
                           <a:ea typeface="맑은 고딕" pitchFamily="34" charset="-122"/>
                           <a:cs typeface="맑은 고딕" pitchFamily="34" charset="-120"/>
                         </a:rPr>
-                        <a:t>[SILVER925] A Rua Open Ring</a:t>
+                        <a:t>[SILVER925] Starly Open Ring</a:t>
                       </a:r>
                       <a:endParaRPr lang="en-US" sz="1100" dirty="0">
                         <a:latin typeface="맑은 고딕" charset="0"/>
@@ -7042,7 +7042,7 @@
                           <a:ea typeface="맑은 고딕" pitchFamily="34" charset="-122"/>
                           <a:cs typeface="맑은 고딕" pitchFamily="34" charset="-120"/>
                         </a:rPr>
-                        <a:t>13 개</a:t>
+                        <a:t>16 개</a:t>
                       </a:r>
                       <a:endParaRPr lang="en-US" sz="1200" dirty="0">
                         <a:latin typeface="맑은 고딕" charset="0"/>
@@ -7239,7 +7239,7 @@
                           <a:ea typeface="맑은 고딕" pitchFamily="34" charset="-122"/>
                           <a:cs typeface="맑은 고딕" pitchFamily="34" charset="-120"/>
                         </a:rPr>
-                        <a:t>[SILVER925] Starly Open Ring</a:t>
+                        <a:t>[SILVER925] A Rua Open Ring</a:t>
                       </a:r>
                       <a:endParaRPr lang="en-US" sz="1100" dirty="0">
                         <a:latin typeface="맑은 고딕" charset="0"/>
@@ -7304,7 +7304,7 @@
                           <a:ea typeface="맑은 고딕" pitchFamily="34" charset="-122"/>
                           <a:cs typeface="맑은 고딕" pitchFamily="34" charset="-120"/>
                         </a:rPr>
-                        <a:t>12 개</a:t>
+                        <a:t>16 개</a:t>
                       </a:r>
                       <a:endParaRPr lang="en-US" sz="1200" dirty="0">
                         <a:latin typeface="맑은 고딕" charset="0"/>
@@ -7390,7 +7390,7 @@
                 <a:ea typeface="맑은 고딕" pitchFamily="34" charset="-122"/>
                 <a:cs typeface="맑은 고딕" pitchFamily="34" charset="-120"/>
               </a:rPr>
-              <a:t>리오더 필요  🔴 긴급 9건</a:t>
+              <a:t>리오더 필요  🔴 긴급 10건</a:t>
             </a:r>
             <a:pPr indent="0" marL="0">
               <a:buNone/>
@@ -7557,7 +7557,7 @@
                 <a:ea typeface="맑은 고딕" pitchFamily="34" charset="-122"/>
                 <a:cs typeface="맑은 고딕" pitchFamily="34" charset="-120"/>
               </a:rPr>
-              <a:t>Chainlink Necklace</a:t>
+              <a:t>Safety Pin Necklace</a:t>
             </a:r>
             <a:endParaRPr lang="en-US" sz="1100" dirty="0"/>
           </a:p>
@@ -7572,6 +7572,212 @@
         <p:spPr>
           <a:xfrm>
             <a:off x="8211312" y="3712464"/>
+            <a:ext cx="3291840" cy="256032"/>
+          </a:xfrm>
+          <a:prstGeom prst="rect">
+            <a:avLst/>
+          </a:prstGeom>
+          <a:noFill/>
+          <a:ln/>
+        </p:spPr>
+        <p:txBody>
+          <a:bodyPr wrap="square" lIns="0" tIns="0" rIns="0" bIns="0" rtlCol="0" anchor="ctr"/>
+          <a:lstStyle/>
+          <a:p>
+            <a:pPr indent="0" marL="0">
+              <a:buNone/>
+            </a:pPr>
+            <a:r>
+              <a:rPr lang="en-US" sz="1000" dirty="0">
+                <a:solidFill>
+                  <a:srgbClr val="6B7280"/>
+                </a:solidFill>
+                <a:latin typeface="맑은 고딕" pitchFamily="34" charset="0"/>
+                <a:ea typeface="맑은 고딕" pitchFamily="34" charset="-122"/>
+                <a:cs typeface="맑은 고딕" pitchFamily="34" charset="-120"/>
+              </a:rPr>
+              <a:t>Necklace  ·  재고 2개</a:t>
+            </a:r>
+            <a:pPr indent="0" marL="0">
+              <a:buNone/>
+            </a:pPr>
+            <a:r>
+              <a:rPr lang="en-US" sz="1000" b="1" dirty="0">
+                <a:solidFill>
+                  <a:srgbClr val="D72638"/>
+                </a:solidFill>
+                <a:latin typeface="맑은 고딕" pitchFamily="34" charset="0"/>
+                <a:ea typeface="맑은 고딕" pitchFamily="34" charset="-122"/>
+                <a:cs typeface="맑은 고딕" pitchFamily="34" charset="-120"/>
+              </a:rPr>
+              <a:t/>
+            </a:r>
+            <a:endParaRPr lang="en-US" sz="1000" dirty="0"/>
+          </a:p>
+        </p:txBody>
+      </p:sp>
+      <p:sp>
+        <p:nvSpPr>
+          <p:cNvPr id="27" name="Shape 24"/>
+          <p:cNvSpPr/>
+          <p:nvPr/>
+        </p:nvSpPr>
+        <p:spPr>
+          <a:xfrm>
+            <a:off x="7406640" y="4096512"/>
+            <a:ext cx="4206240" cy="640080"/>
+          </a:xfrm>
+          <a:prstGeom prst="rect">
+            <a:avLst/>
+          </a:prstGeom>
+          <a:solidFill>
+            <a:srgbClr val="FFF5F5"/>
+          </a:solidFill>
+          <a:ln w="6350">
+            <a:solidFill>
+              <a:srgbClr val="E5E7EB"/>
+            </a:solidFill>
+            <a:prstDash val="solid"/>
+          </a:ln>
+        </p:spPr>
+      </p:sp>
+      <p:sp>
+        <p:nvSpPr>
+          <p:cNvPr id="28" name="Shape 25"/>
+          <p:cNvSpPr/>
+          <p:nvPr/>
+        </p:nvSpPr>
+        <p:spPr>
+          <a:xfrm>
+            <a:off x="7406640" y="4096512"/>
+            <a:ext cx="109728" cy="640080"/>
+          </a:xfrm>
+          <a:prstGeom prst="rect">
+            <a:avLst/>
+          </a:prstGeom>
+          <a:solidFill>
+            <a:srgbClr val="D72638"/>
+          </a:solidFill>
+          <a:ln w="12700">
+            <a:solidFill>
+              <a:srgbClr val="D72638"/>
+            </a:solidFill>
+            <a:prstDash val="solid"/>
+          </a:ln>
+        </p:spPr>
+      </p:sp>
+      <p:sp>
+        <p:nvSpPr>
+          <p:cNvPr id="29" name="Shape 26"/>
+          <p:cNvSpPr/>
+          <p:nvPr/>
+        </p:nvSpPr>
+        <p:spPr>
+          <a:xfrm>
+            <a:off x="7571232" y="4187952"/>
+            <a:ext cx="548640" cy="256032"/>
+          </a:xfrm>
+          <a:prstGeom prst="rect">
+            <a:avLst/>
+          </a:prstGeom>
+          <a:solidFill>
+            <a:srgbClr val="D72638"/>
+          </a:solidFill>
+          <a:ln w="12700">
+            <a:solidFill>
+              <a:srgbClr val="D72638"/>
+            </a:solidFill>
+            <a:prstDash val="solid"/>
+          </a:ln>
+        </p:spPr>
+      </p:sp>
+      <p:sp>
+        <p:nvSpPr>
+          <p:cNvPr id="30" name="Text 27"/>
+          <p:cNvSpPr/>
+          <p:nvPr/>
+        </p:nvSpPr>
+        <p:spPr>
+          <a:xfrm>
+            <a:off x="7571232" y="4187952"/>
+            <a:ext cx="548640" cy="256032"/>
+          </a:xfrm>
+          <a:prstGeom prst="rect">
+            <a:avLst/>
+          </a:prstGeom>
+          <a:noFill/>
+          <a:ln/>
+        </p:spPr>
+        <p:txBody>
+          <a:bodyPr wrap="square" lIns="0" tIns="0" rIns="0" bIns="0" rtlCol="0" anchor="ctr"/>
+          <a:lstStyle/>
+          <a:p>
+            <a:pPr algn="ctr" indent="0" marL="0">
+              <a:buNone/>
+            </a:pPr>
+            <a:r>
+              <a:rPr lang="en-US" sz="900" b="1" dirty="0">
+                <a:solidFill>
+                  <a:srgbClr val="FFFFFF"/>
+                </a:solidFill>
+                <a:latin typeface="맑은 고딕" pitchFamily="34" charset="0"/>
+                <a:ea typeface="맑은 고딕" pitchFamily="34" charset="-122"/>
+                <a:cs typeface="맑은 고딕" pitchFamily="34" charset="-120"/>
+              </a:rPr>
+              <a:t>긴급</a:t>
+            </a:r>
+            <a:endParaRPr lang="en-US" sz="900" dirty="0"/>
+          </a:p>
+        </p:txBody>
+      </p:sp>
+      <p:sp>
+        <p:nvSpPr>
+          <p:cNvPr id="31" name="Text 28"/>
+          <p:cNvSpPr/>
+          <p:nvPr/>
+        </p:nvSpPr>
+        <p:spPr>
+          <a:xfrm>
+            <a:off x="8211312" y="4151376"/>
+            <a:ext cx="3291840" cy="274320"/>
+          </a:xfrm>
+          <a:prstGeom prst="rect">
+            <a:avLst/>
+          </a:prstGeom>
+          <a:noFill/>
+          <a:ln/>
+        </p:spPr>
+        <p:txBody>
+          <a:bodyPr wrap="square" lIns="0" tIns="0" rIns="0" bIns="0" rtlCol="0" anchor="ctr"/>
+          <a:lstStyle/>
+          <a:p>
+            <a:pPr indent="0" marL="0">
+              <a:buNone/>
+            </a:pPr>
+            <a:r>
+              <a:rPr lang="en-US" sz="1100" b="1" dirty="0">
+                <a:solidFill>
+                  <a:srgbClr val="0B1220"/>
+                </a:solidFill>
+                <a:latin typeface="맑은 고딕" pitchFamily="34" charset="0"/>
+                <a:ea typeface="맑은 고딕" pitchFamily="34" charset="-122"/>
+                <a:cs typeface="맑은 고딕" pitchFamily="34" charset="-120"/>
+              </a:rPr>
+              <a:t>B-Flower Necklace (Size: 2 Size)</a:t>
+            </a:r>
+            <a:endParaRPr lang="en-US" sz="1100" dirty="0"/>
+          </a:p>
+        </p:txBody>
+      </p:sp>
+      <p:sp>
+        <p:nvSpPr>
+          <p:cNvPr id="32" name="Text 29"/>
+          <p:cNvSpPr/>
+          <p:nvPr/>
+        </p:nvSpPr>
+        <p:spPr>
+          <a:xfrm>
+            <a:off x="8211312" y="4425696"/>
             <a:ext cx="3291840" cy="256032"/>
           </a:xfrm>
           <a:prstGeom prst="rect">
@@ -7618,13 +7824,13 @@
       </p:sp>
       <p:sp>
         <p:nvSpPr>
-          <p:cNvPr id="27" name="Shape 24"/>
-          <p:cNvSpPr/>
-          <p:nvPr/>
-        </p:nvSpPr>
-        <p:spPr>
-          <a:xfrm>
-            <a:off x="7406640" y="4096512"/>
+          <p:cNvPr id="33" name="Shape 30"/>
+          <p:cNvSpPr/>
+          <p:nvPr/>
+        </p:nvSpPr>
+        <p:spPr>
+          <a:xfrm>
+            <a:off x="7406640" y="4809744"/>
             <a:ext cx="4206240" cy="640080"/>
           </a:xfrm>
           <a:prstGeom prst="rect">
@@ -7643,13 +7849,13 @@
       </p:sp>
       <p:sp>
         <p:nvSpPr>
-          <p:cNvPr id="28" name="Shape 25"/>
-          <p:cNvSpPr/>
-          <p:nvPr/>
-        </p:nvSpPr>
-        <p:spPr>
-          <a:xfrm>
-            <a:off x="7406640" y="4096512"/>
+          <p:cNvPr id="34" name="Shape 31"/>
+          <p:cNvSpPr/>
+          <p:nvPr/>
+        </p:nvSpPr>
+        <p:spPr>
+          <a:xfrm>
+            <a:off x="7406640" y="4809744"/>
             <a:ext cx="109728" cy="640080"/>
           </a:xfrm>
           <a:prstGeom prst="rect">
@@ -7668,13 +7874,13 @@
       </p:sp>
       <p:sp>
         <p:nvSpPr>
-          <p:cNvPr id="29" name="Shape 26"/>
-          <p:cNvSpPr/>
-          <p:nvPr/>
-        </p:nvSpPr>
-        <p:spPr>
-          <a:xfrm>
-            <a:off x="7571232" y="4187952"/>
+          <p:cNvPr id="35" name="Shape 32"/>
+          <p:cNvSpPr/>
+          <p:nvPr/>
+        </p:nvSpPr>
+        <p:spPr>
+          <a:xfrm>
+            <a:off x="7571232" y="4901184"/>
             <a:ext cx="548640" cy="256032"/>
           </a:xfrm>
           <a:prstGeom prst="rect">
@@ -7693,13 +7899,13 @@
       </p:sp>
       <p:sp>
         <p:nvSpPr>
-          <p:cNvPr id="30" name="Text 27"/>
-          <p:cNvSpPr/>
-          <p:nvPr/>
-        </p:nvSpPr>
-        <p:spPr>
-          <a:xfrm>
-            <a:off x="7571232" y="4187952"/>
+          <p:cNvPr id="36" name="Text 33"/>
+          <p:cNvSpPr/>
+          <p:nvPr/>
+        </p:nvSpPr>
+        <p:spPr>
+          <a:xfrm>
+            <a:off x="7571232" y="4901184"/>
             <a:ext cx="548640" cy="256032"/>
           </a:xfrm>
           <a:prstGeom prst="rect">
@@ -7732,13 +7938,13 @@
       </p:sp>
       <p:sp>
         <p:nvSpPr>
-          <p:cNvPr id="31" name="Text 28"/>
-          <p:cNvSpPr/>
-          <p:nvPr/>
-        </p:nvSpPr>
-        <p:spPr>
-          <a:xfrm>
-            <a:off x="8211312" y="4151376"/>
+          <p:cNvPr id="37" name="Text 34"/>
+          <p:cNvSpPr/>
+          <p:nvPr/>
+        </p:nvSpPr>
+        <p:spPr>
+          <a:xfrm>
+            <a:off x="8211312" y="4864608"/>
             <a:ext cx="3291840" cy="274320"/>
           </a:xfrm>
           <a:prstGeom prst="rect">
@@ -7763,7 +7969,7 @@
                 <a:ea typeface="맑은 고딕" pitchFamily="34" charset="-122"/>
                 <a:cs typeface="맑은 고딕" pitchFamily="34" charset="-120"/>
               </a:rPr>
-              <a:t>Tangle Keychain</a:t>
+              <a:t>Chainlink Necklace</a:t>
             </a:r>
             <a:endParaRPr lang="en-US" sz="1100" dirty="0"/>
           </a:p>
@@ -7771,13 +7977,13 @@
       </p:sp>
       <p:sp>
         <p:nvSpPr>
-          <p:cNvPr id="32" name="Text 29"/>
-          <p:cNvSpPr/>
-          <p:nvPr/>
-        </p:nvSpPr>
-        <p:spPr>
-          <a:xfrm>
-            <a:off x="8211312" y="4425696"/>
+          <p:cNvPr id="38" name="Text 35"/>
+          <p:cNvSpPr/>
+          <p:nvPr/>
+        </p:nvSpPr>
+        <p:spPr>
+          <a:xfrm>
+            <a:off x="8211312" y="5138928"/>
             <a:ext cx="3291840" cy="256032"/>
           </a:xfrm>
           <a:prstGeom prst="rect">
@@ -7802,213 +8008,7 @@
                 <a:ea typeface="맑은 고딕" pitchFamily="34" charset="-122"/>
                 <a:cs typeface="맑은 고딕" pitchFamily="34" charset="-120"/>
               </a:rPr>
-              <a:t>★Season off★  ·  재고 2개</a:t>
-            </a:r>
-            <a:pPr indent="0" marL="0">
-              <a:buNone/>
-            </a:pPr>
-            <a:r>
-              <a:rPr lang="en-US" sz="1000" b="1" dirty="0">
-                <a:solidFill>
-                  <a:srgbClr val="D72638"/>
-                </a:solidFill>
-                <a:latin typeface="맑은 고딕" pitchFamily="34" charset="0"/>
-                <a:ea typeface="맑은 고딕" pitchFamily="34" charset="-122"/>
-                <a:cs typeface="맑은 고딕" pitchFamily="34" charset="-120"/>
-              </a:rPr>
-              <a:t/>
-            </a:r>
-            <a:endParaRPr lang="en-US" sz="1000" dirty="0"/>
-          </a:p>
-        </p:txBody>
-      </p:sp>
-      <p:sp>
-        <p:nvSpPr>
-          <p:cNvPr id="33" name="Shape 30"/>
-          <p:cNvSpPr/>
-          <p:nvPr/>
-        </p:nvSpPr>
-        <p:spPr>
-          <a:xfrm>
-            <a:off x="7406640" y="4809744"/>
-            <a:ext cx="4206240" cy="640080"/>
-          </a:xfrm>
-          <a:prstGeom prst="rect">
-            <a:avLst/>
-          </a:prstGeom>
-          <a:solidFill>
-            <a:srgbClr val="FFF5F5"/>
-          </a:solidFill>
-          <a:ln w="6350">
-            <a:solidFill>
-              <a:srgbClr val="E5E7EB"/>
-            </a:solidFill>
-            <a:prstDash val="solid"/>
-          </a:ln>
-        </p:spPr>
-      </p:sp>
-      <p:sp>
-        <p:nvSpPr>
-          <p:cNvPr id="34" name="Shape 31"/>
-          <p:cNvSpPr/>
-          <p:nvPr/>
-        </p:nvSpPr>
-        <p:spPr>
-          <a:xfrm>
-            <a:off x="7406640" y="4809744"/>
-            <a:ext cx="109728" cy="640080"/>
-          </a:xfrm>
-          <a:prstGeom prst="rect">
-            <a:avLst/>
-          </a:prstGeom>
-          <a:solidFill>
-            <a:srgbClr val="D72638"/>
-          </a:solidFill>
-          <a:ln w="12700">
-            <a:solidFill>
-              <a:srgbClr val="D72638"/>
-            </a:solidFill>
-            <a:prstDash val="solid"/>
-          </a:ln>
-        </p:spPr>
-      </p:sp>
-      <p:sp>
-        <p:nvSpPr>
-          <p:cNvPr id="35" name="Shape 32"/>
-          <p:cNvSpPr/>
-          <p:nvPr/>
-        </p:nvSpPr>
-        <p:spPr>
-          <a:xfrm>
-            <a:off x="7571232" y="4901184"/>
-            <a:ext cx="548640" cy="256032"/>
-          </a:xfrm>
-          <a:prstGeom prst="rect">
-            <a:avLst/>
-          </a:prstGeom>
-          <a:solidFill>
-            <a:srgbClr val="D72638"/>
-          </a:solidFill>
-          <a:ln w="12700">
-            <a:solidFill>
-              <a:srgbClr val="D72638"/>
-            </a:solidFill>
-            <a:prstDash val="solid"/>
-          </a:ln>
-        </p:spPr>
-      </p:sp>
-      <p:sp>
-        <p:nvSpPr>
-          <p:cNvPr id="36" name="Text 33"/>
-          <p:cNvSpPr/>
-          <p:nvPr/>
-        </p:nvSpPr>
-        <p:spPr>
-          <a:xfrm>
-            <a:off x="7571232" y="4901184"/>
-            <a:ext cx="548640" cy="256032"/>
-          </a:xfrm>
-          <a:prstGeom prst="rect">
-            <a:avLst/>
-          </a:prstGeom>
-          <a:noFill/>
-          <a:ln/>
-        </p:spPr>
-        <p:txBody>
-          <a:bodyPr wrap="square" lIns="0" tIns="0" rIns="0" bIns="0" rtlCol="0" anchor="ctr"/>
-          <a:lstStyle/>
-          <a:p>
-            <a:pPr algn="ctr" indent="0" marL="0">
-              <a:buNone/>
-            </a:pPr>
-            <a:r>
-              <a:rPr lang="en-US" sz="900" b="1" dirty="0">
-                <a:solidFill>
-                  <a:srgbClr val="FFFFFF"/>
-                </a:solidFill>
-                <a:latin typeface="맑은 고딕" pitchFamily="34" charset="0"/>
-                <a:ea typeface="맑은 고딕" pitchFamily="34" charset="-122"/>
-                <a:cs typeface="맑은 고딕" pitchFamily="34" charset="-120"/>
-              </a:rPr>
-              <a:t>긴급</a:t>
-            </a:r>
-            <a:endParaRPr lang="en-US" sz="900" dirty="0"/>
-          </a:p>
-        </p:txBody>
-      </p:sp>
-      <p:sp>
-        <p:nvSpPr>
-          <p:cNvPr id="37" name="Text 34"/>
-          <p:cNvSpPr/>
-          <p:nvPr/>
-        </p:nvSpPr>
-        <p:spPr>
-          <a:xfrm>
-            <a:off x="8211312" y="4864608"/>
-            <a:ext cx="3291840" cy="274320"/>
-          </a:xfrm>
-          <a:prstGeom prst="rect">
-            <a:avLst/>
-          </a:prstGeom>
-          <a:noFill/>
-          <a:ln/>
-        </p:spPr>
-        <p:txBody>
-          <a:bodyPr wrap="square" lIns="0" tIns="0" rIns="0" bIns="0" rtlCol="0" anchor="ctr"/>
-          <a:lstStyle/>
-          <a:p>
-            <a:pPr indent="0" marL="0">
-              <a:buNone/>
-            </a:pPr>
-            <a:r>
-              <a:rPr lang="en-US" sz="1100" b="1" dirty="0">
-                <a:solidFill>
-                  <a:srgbClr val="0B1220"/>
-                </a:solidFill>
-                <a:latin typeface="맑은 고딕" pitchFamily="34" charset="0"/>
-                <a:ea typeface="맑은 고딕" pitchFamily="34" charset="-122"/>
-                <a:cs typeface="맑은 고딕" pitchFamily="34" charset="-120"/>
-              </a:rPr>
-              <a:t>B-Flower Necklace (Size: 2 Size)</a:t>
-            </a:r>
-            <a:endParaRPr lang="en-US" sz="1100" dirty="0"/>
-          </a:p>
-        </p:txBody>
-      </p:sp>
-      <p:sp>
-        <p:nvSpPr>
-          <p:cNvPr id="38" name="Text 35"/>
-          <p:cNvSpPr/>
-          <p:nvPr/>
-        </p:nvSpPr>
-        <p:spPr>
-          <a:xfrm>
-            <a:off x="8211312" y="5138928"/>
-            <a:ext cx="3291840" cy="256032"/>
-          </a:xfrm>
-          <a:prstGeom prst="rect">
-            <a:avLst/>
-          </a:prstGeom>
-          <a:noFill/>
-          <a:ln/>
-        </p:spPr>
-        <p:txBody>
-          <a:bodyPr wrap="square" lIns="0" tIns="0" rIns="0" bIns="0" rtlCol="0" anchor="ctr"/>
-          <a:lstStyle/>
-          <a:p>
-            <a:pPr indent="0" marL="0">
-              <a:buNone/>
-            </a:pPr>
-            <a:r>
-              <a:rPr lang="en-US" sz="1000" dirty="0">
-                <a:solidFill>
-                  <a:srgbClr val="6B7280"/>
-                </a:solidFill>
-                <a:latin typeface="맑은 고딕" pitchFamily="34" charset="0"/>
-                <a:ea typeface="맑은 고딕" pitchFamily="34" charset="-122"/>
-                <a:cs typeface="맑은 고딕" pitchFamily="34" charset="-120"/>
-              </a:rPr>
-              <a:t>Necklace  ·  재고 5개</a:t>
+              <a:t>Necklace  ·  재고 2개</a:t>
             </a:r>
             <a:pPr indent="0" marL="0">
               <a:buNone/>
@@ -8267,7 +8267,7 @@
                 <a:ea typeface="맑은 고딕" pitchFamily="34" charset="-122"/>
                 <a:cs typeface="맑은 고딕" pitchFamily="34" charset="-120"/>
               </a:rPr>
-              <a:t>베스트 상품 리포트  ·  생성 2026-05-20 08:00</a:t>
+              <a:t>베스트 상품 리포트  ·  생성 2026-05-21 08:00</a:t>
             </a:r>
             <a:endParaRPr lang="en-US" sz="900" dirty="0"/>
           </a:p>
@@ -8480,7 +8480,7 @@
                 <a:ea typeface="맑은 고딕" pitchFamily="34" charset="-122"/>
                 <a:cs typeface="맑은 고딕" pitchFamily="34" charset="-120"/>
               </a:rPr>
-              <a:t>2026년 05월 20일 (수)</a:t>
+              <a:t>2026년 05월 21일 (목)</a:t>
             </a:r>
             <a:endParaRPr lang="en-US" sz="1200" dirty="0"/>
           </a:p>
@@ -8647,7 +8647,7 @@
                 <a:ea typeface="맑은 고딕" pitchFamily="34" charset="-122"/>
                 <a:cs typeface="맑은 고딕" pitchFamily="34" charset="-120"/>
               </a:rPr>
-              <a:t>130 개</a:t>
+              <a:t>133 개</a:t>
             </a:r>
             <a:endParaRPr lang="en-US" sz="3600" dirty="0"/>
           </a:p>
@@ -8775,7 +8775,7 @@
                 <a:ea typeface="맑은 고딕" pitchFamily="34" charset="-122"/>
                 <a:cs typeface="맑은 고딕" pitchFamily="34" charset="-120"/>
               </a:rPr>
-              <a:t>CandyPOP Necklace (사이즈: 2size (47~52cm))</a:t>
+              <a:t>CandyPOP Necklace (사이즈: 1size (37~43cm))</a:t>
             </a:r>
             <a:endParaRPr lang="en-US" sz="1800" dirty="0"/>
           </a:p>
@@ -8853,7 +8853,7 @@
                 <a:ea typeface="맑은 고딕" pitchFamily="34" charset="-122"/>
                 <a:cs typeface="맑은 고딕" pitchFamily="34" charset="-120"/>
               </a:rPr>
-              <a:t>37</a:t>
+              <a:t>33</a:t>
             </a:r>
             <a:endParaRPr lang="en-US" sz="4400" dirty="0"/>
           </a:p>
@@ -9387,7 +9387,7 @@
                           <a:ea typeface="맑은 고딕" pitchFamily="34" charset="-122"/>
                           <a:cs typeface="맑은 고딕" pitchFamily="34" charset="-120"/>
                         </a:rPr>
-                        <a:t>CandyPOP Necklace (사이즈: 2size (47~52cm))</a:t>
+                        <a:t>CandyPOP Necklace (사이즈: 1size (37~43cm))</a:t>
                       </a:r>
                       <a:endParaRPr lang="en-US" sz="1100" dirty="0">
                         <a:latin typeface="맑은 고딕" charset="0"/>
@@ -9452,7 +9452,7 @@
                           <a:ea typeface="맑은 고딕" pitchFamily="34" charset="-122"/>
                           <a:cs typeface="맑은 고딕" pitchFamily="34" charset="-120"/>
                         </a:rPr>
-                        <a:t>37 개</a:t>
+                        <a:t>33 개</a:t>
                       </a:r>
                       <a:endParaRPr lang="en-US" sz="1400" dirty="0">
                         <a:latin typeface="맑은 고딕" charset="0"/>
@@ -9714,7 +9714,7 @@
                           <a:ea typeface="맑은 고딕" pitchFamily="34" charset="-122"/>
                           <a:cs typeface="맑은 고딕" pitchFamily="34" charset="-120"/>
                         </a:rPr>
-                        <a:t>22 개</a:t>
+                        <a:t>28 개</a:t>
                       </a:r>
                       <a:endParaRPr lang="en-US" sz="1200" dirty="0">
                         <a:latin typeface="맑은 고딕" charset="0"/>
@@ -9911,7 +9911,7 @@
                           <a:ea typeface="맑은 고딕" pitchFamily="34" charset="-122"/>
                           <a:cs typeface="맑은 고딕" pitchFamily="34" charset="-120"/>
                         </a:rPr>
-                        <a:t>ThreadDuo Necklace</a:t>
+                        <a:t>CandyPOP Necklace (사이즈: 2size (47~52cm))</a:t>
                       </a:r>
                       <a:endParaRPr lang="en-US" sz="1100" dirty="0">
                         <a:latin typeface="맑은 고딕" charset="0"/>
@@ -9976,7 +9976,7 @@
                           <a:ea typeface="맑은 고딕" pitchFamily="34" charset="-122"/>
                           <a:cs typeface="맑은 고딕" pitchFamily="34" charset="-120"/>
                         </a:rPr>
-                        <a:t>22 개</a:t>
+                        <a:t>23 개</a:t>
                       </a:r>
                       <a:endParaRPr lang="en-US" sz="1200" dirty="0">
                         <a:latin typeface="맑은 고딕" charset="0"/>
@@ -10062,7 +10062,7 @@
                 <a:ea typeface="맑은 고딕" pitchFamily="34" charset="-122"/>
                 <a:cs typeface="맑은 고딕" pitchFamily="34" charset="-120"/>
               </a:rPr>
-              <a:t>리오더 필요  🔴 긴급 18건</a:t>
+              <a:t>리오더 필요  🔴 긴급 20건</a:t>
             </a:r>
             <a:endParaRPr lang="en-US" sz="1500" dirty="0"/>
           </a:p>
@@ -10126,7 +10126,7 @@
                 <a:ea typeface="맑은 고딕" pitchFamily="34" charset="-122"/>
                 <a:cs typeface="맑은 고딕" pitchFamily="34" charset="-120"/>
               </a:rPr>
-              <a:t>🔴 긴급 18건  ·  상세는 시트 확인</a:t>
+              <a:t>🔴 긴급 20건  ·  상세는 시트 확인</a:t>
             </a:r>
             <a:endParaRPr lang="en-US" sz="1400" dirty="0"/>
           </a:p>
@@ -10165,7 +10165,7 @@
                 <a:ea typeface="맑은 고딕" pitchFamily="34" charset="-122"/>
                 <a:cs typeface="맑은 고딕" pitchFamily="34" charset="-120"/>
               </a:rPr>
-              <a:t>베스트 상품 리포트  ·  생성 2026-05-20 08:00</a:t>
+              <a:t>베스트 상품 리포트  ·  생성 2026-05-21 08:00</a:t>
             </a:r>
             <a:endParaRPr lang="en-US" sz="900" dirty="0"/>
           </a:p>
@@ -10378,7 +10378,7 @@
                 <a:ea typeface="맑은 고딕" pitchFamily="34" charset="-122"/>
                 <a:cs typeface="맑은 고딕" pitchFamily="34" charset="-120"/>
               </a:rPr>
-              <a:t>2026년 05월 20일 (수)</a:t>
+              <a:t>2026년 05월 21일 (목)</a:t>
             </a:r>
             <a:endParaRPr lang="en-US" sz="1200" dirty="0"/>
           </a:p>
@@ -10673,7 +10673,7 @@
                 <a:ea typeface="맑은 고딕" pitchFamily="34" charset="-122"/>
                 <a:cs typeface="맑은 고딕" pitchFamily="34" charset="-120"/>
               </a:rPr>
-              <a:t>26</a:t>
+              <a:t>27</a:t>
             </a:r>
             <a:endParaRPr lang="en-US" sz="3000" dirty="0"/>
           </a:p>
@@ -10929,7 +10929,7 @@
                 <a:ea typeface="맑은 고딕" pitchFamily="34" charset="-122"/>
                 <a:cs typeface="맑은 고딕" pitchFamily="34" charset="-120"/>
               </a:rPr>
-              <a:t>33,251</a:t>
+              <a:t>32,526</a:t>
             </a:r>
             <a:endParaRPr lang="en-US" sz="3000" dirty="0"/>
           </a:p>
@@ -11489,7 +11489,7 @@
                           <a:ea typeface="맑은 고딕" pitchFamily="34" charset="-122"/>
                           <a:cs typeface="맑은 고딕" pitchFamily="34" charset="-120"/>
                         </a:rPr>
-                        <a:t>2,106</a:t>
+                        <a:t>2,101</a:t>
                       </a:r>
                       <a:endParaRPr lang="en-US" sz="1000" dirty="0">
                         <a:latin typeface="맑은 고딕" charset="0"/>
@@ -11686,7 +11686,7 @@
                           <a:ea typeface="맑은 고딕" pitchFamily="34" charset="-122"/>
                           <a:cs typeface="맑은 고딕" pitchFamily="34" charset="-120"/>
                         </a:rPr>
-                        <a:t>컬러: 퍼플 / 기종 옵션: C type -&gt; C type</a:t>
+                        <a:t>컬러: 오렌지 / 기종 옵션: USB -&gt; Apple 8pin</a:t>
                       </a:r>
                       <a:endParaRPr lang="en-US" sz="900" dirty="0">
                         <a:latin typeface="맑은 고딕" charset="0"/>
@@ -11751,7 +11751,7 @@
                           <a:ea typeface="맑은 고딕" pitchFamily="34" charset="-122"/>
                           <a:cs typeface="맑은 고딕" pitchFamily="34" charset="-120"/>
                         </a:rPr>
-                        <a:t>1,727</a:t>
+                        <a:t>1,640</a:t>
                       </a:r>
                       <a:endParaRPr lang="en-US" sz="1000" dirty="0">
                         <a:latin typeface="맑은 고딕" charset="0"/>
@@ -12013,7 +12013,7 @@
                           <a:ea typeface="맑은 고딕" pitchFamily="34" charset="-122"/>
                           <a:cs typeface="맑은 고딕" pitchFamily="34" charset="-120"/>
                         </a:rPr>
-                        <a:t>1,674</a:t>
+                        <a:t>1,616</a:t>
                       </a:r>
                       <a:endParaRPr lang="en-US" sz="1000" dirty="0">
                         <a:latin typeface="맑은 고딕" charset="0"/>
@@ -12210,7 +12210,7 @@
                           <a:ea typeface="맑은 고딕" pitchFamily="34" charset="-122"/>
                           <a:cs typeface="맑은 고딕" pitchFamily="34" charset="-120"/>
                         </a:rPr>
-                        <a:t>컬러: 오렌지 / 기종 옵션: USB -&gt; Apple 8pin</a:t>
+                        <a:t>컬러: 퍼플 / 기종 옵션: C type -&gt; C type</a:t>
                       </a:r>
                       <a:endParaRPr lang="en-US" sz="900" dirty="0">
                         <a:latin typeface="맑은 고딕" charset="0"/>
@@ -12275,7 +12275,7 @@
                           <a:ea typeface="맑은 고딕" pitchFamily="34" charset="-122"/>
                           <a:cs typeface="맑은 고딕" pitchFamily="34" charset="-120"/>
                         </a:rPr>
-                        <a:t>1,647</a:t>
+                        <a:t>1,610</a:t>
                       </a:r>
                       <a:endParaRPr lang="en-US" sz="1000" dirty="0">
                         <a:latin typeface="맑은 고딕" charset="0"/>
@@ -12537,7 +12537,7 @@
                           <a:ea typeface="맑은 고딕" pitchFamily="34" charset="-122"/>
                           <a:cs typeface="맑은 고딕" pitchFamily="34" charset="-120"/>
                         </a:rPr>
-                        <a:t>1,267</a:t>
+                        <a:t>1,153</a:t>
                       </a:r>
                       <a:endParaRPr lang="en-US" sz="1000" dirty="0">
                         <a:latin typeface="맑은 고딕" charset="0"/>
@@ -12623,7 +12623,7 @@
                 <a:ea typeface="맑은 고딕" pitchFamily="34" charset="-122"/>
                 <a:cs typeface="맑은 고딕" pitchFamily="34" charset="-120"/>
               </a:rPr>
-              <a:t>재고 점검  🔴 품절 26건</a:t>
+              <a:t>재고 점검  🔴 품절 27건</a:t>
             </a:r>
             <a:pPr indent="0" marL="0">
               <a:buNone/>
@@ -13556,7 +13556,7 @@
                 <a:ea typeface="맑은 고딕" pitchFamily="34" charset="-122"/>
                 <a:cs typeface="맑은 고딕" pitchFamily="34" charset="-120"/>
               </a:rPr>
-              <a:t>베스트 상품 리포트  ·  생성 2026-05-20 08:00</a:t>
+              <a:t>베스트 상품 리포트  ·  생성 2026-05-21 08:00</a:t>
             </a:r>
             <a:endParaRPr lang="en-US" sz="900" dirty="0"/>
           </a:p>
@@ -13769,7 +13769,7 @@
                 <a:ea typeface="맑은 고딕" pitchFamily="34" charset="-122"/>
                 <a:cs typeface="맑은 고딕" pitchFamily="34" charset="-120"/>
               </a:rPr>
-              <a:t>2026년 05월 20일 (수)</a:t>
+              <a:t>2026년 05월 21일 (목)</a:t>
             </a:r>
             <a:endParaRPr lang="en-US" sz="1200" dirty="0"/>
           </a:p>
@@ -13897,7 +13897,7 @@
                 <a:ea typeface="맑은 고딕" pitchFamily="34" charset="-122"/>
                 <a:cs typeface="맑은 고딕" pitchFamily="34" charset="-120"/>
               </a:rPr>
-              <a:t>🚨  긴급 리오더 66건    ·    주의 리오더 10건    ·    오늘 발주 검토 필수</a:t>
+              <a:t>🚨  긴급 리오더 70건    ·    주의 리오더 13건    ·    오늘 발주 검토 필수</a:t>
             </a:r>
             <a:pPr indent="0" marL="0">
               <a:buNone/>
@@ -14663,7 +14663,7 @@
                           <a:ea typeface="맑은 고딕" pitchFamily="34" charset="-122"/>
                           <a:cs typeface="맑은 고딕" pitchFamily="34" charset="-120"/>
                         </a:rPr>
-                        <a:t>180° Fast Charging Cable (8color) (컬러: 블루 / 기종 옵션: USB -&gt; C type)</a:t>
+                        <a:t>180° Fast Charging Cable (8color) (컬러: 네온핑크 / 기종 옵션: C type -&gt; C type)</a:t>
                       </a:r>
                       <a:endParaRPr lang="en-US" sz="1100" dirty="0">
                         <a:latin typeface="맑은 고딕" charset="0"/>
@@ -14799,7 +14799,7 @@
                           <a:ea typeface="맑은 고딕" pitchFamily="34" charset="-122"/>
                           <a:cs typeface="맑은 고딕" pitchFamily="34" charset="-120"/>
                         </a:rPr>
-                        <a:t>29 개</a:t>
+                        <a:t>244 개</a:t>
                       </a:r>
                       <a:endParaRPr lang="en-US" sz="1100" dirty="0">
                         <a:latin typeface="맑은 고딕" charset="0"/>
@@ -15073,7 +15073,7 @@
                           <a:ea typeface="맑은 고딕" pitchFamily="34" charset="-122"/>
                           <a:cs typeface="맑은 고딕" pitchFamily="34" charset="-120"/>
                         </a:rPr>
-                        <a:t>Chainlink Necklace</a:t>
+                        <a:t>Safety Pin Necklace</a:t>
                       </a:r>
                       <a:endParaRPr lang="en-US" sz="1100" dirty="0">
                         <a:latin typeface="맑은 고딕" charset="0"/>
@@ -15141,7 +15141,7 @@
                           <a:ea typeface="맑은 고딕" pitchFamily="34" charset="-122"/>
                           <a:cs typeface="맑은 고딕" pitchFamily="34" charset="-120"/>
                         </a:rPr>
-                        <a:t>3</a:t>
+                        <a:t>2</a:t>
                       </a:r>
                       <a:endParaRPr lang="en-US" sz="1100" dirty="0">
                         <a:latin typeface="맑은 고딕" charset="0"/>
@@ -15209,7 +15209,7 @@
                           <a:ea typeface="맑은 고딕" pitchFamily="34" charset="-122"/>
                           <a:cs typeface="맑은 고딕" pitchFamily="34" charset="-120"/>
                         </a:rPr>
-                        <a:t>3 개</a:t>
+                        <a:t>4 개</a:t>
                       </a:r>
                       <a:endParaRPr lang="en-US" sz="1100" dirty="0">
                         <a:latin typeface="맑은 고딕" charset="0"/>
@@ -15347,7 +15347,7 @@
                           <a:ea typeface="맑은 고딕" pitchFamily="34" charset="-122"/>
                           <a:cs typeface="맑은 고딕" pitchFamily="34" charset="-120"/>
                         </a:rPr>
-                        <a:t>6A</a:t>
+                        <a:t>CT</a:t>
                       </a:r>
                       <a:endParaRPr lang="en-US" sz="1100" dirty="0">
                         <a:latin typeface="맑은 고딕" charset="0"/>
@@ -15415,7 +15415,7 @@
                           <a:ea typeface="맑은 고딕" pitchFamily="34" charset="-122"/>
                           <a:cs typeface="맑은 고딕" pitchFamily="34" charset="-120"/>
                         </a:rPr>
-                        <a:t>★Season off★</a:t>
+                        <a:t>Ring</a:t>
                       </a:r>
                       <a:endParaRPr lang="en-US" sz="1000" dirty="0">
                         <a:latin typeface="맑은 고딕" charset="0"/>
@@ -15483,7 +15483,7 @@
                           <a:ea typeface="맑은 고딕" pitchFamily="34" charset="-122"/>
                           <a:cs typeface="맑은 고딕" pitchFamily="34" charset="-120"/>
                         </a:rPr>
-                        <a:t>Tangle Keychain</a:t>
+                        <a:t>"Crackave" 925 Open Ring</a:t>
                       </a:r>
                       <a:endParaRPr lang="en-US" sz="1100" dirty="0">
                         <a:latin typeface="맑은 고딕" charset="0"/>
@@ -15551,7 +15551,7 @@
                           <a:ea typeface="맑은 고딕" pitchFamily="34" charset="-122"/>
                           <a:cs typeface="맑은 고딕" pitchFamily="34" charset="-120"/>
                         </a:rPr>
-                        <a:t>2</a:t>
+                        <a:t>5</a:t>
                       </a:r>
                       <a:endParaRPr lang="en-US" sz="1100" dirty="0">
                         <a:latin typeface="맑은 고딕" charset="0"/>
@@ -15619,7 +15619,7 @@
                           <a:ea typeface="맑은 고딕" pitchFamily="34" charset="-122"/>
                           <a:cs typeface="맑은 고딕" pitchFamily="34" charset="-120"/>
                         </a:rPr>
-                        <a:t>1 개</a:t>
+                        <a:t>3 개</a:t>
                       </a:r>
                       <a:endParaRPr lang="en-US" sz="1100" dirty="0">
                         <a:latin typeface="맑은 고딕" charset="0"/>
@@ -15757,7 +15757,7 @@
                           <a:ea typeface="맑은 고딕" pitchFamily="34" charset="-122"/>
                           <a:cs typeface="맑은 고딕" pitchFamily="34" charset="-120"/>
                         </a:rPr>
-                        <a:t>CT</a:t>
+                        <a:t>PR</a:t>
                       </a:r>
                       <a:endParaRPr lang="en-US" sz="1100" dirty="0">
                         <a:latin typeface="맑은 고딕" charset="0"/>
@@ -15825,7 +15825,7 @@
                           <a:ea typeface="맑은 고딕" pitchFamily="34" charset="-122"/>
                           <a:cs typeface="맑은 고딕" pitchFamily="34" charset="-120"/>
                         </a:rPr>
-                        <a:t>Ring</a:t>
+                        <a:t>★ Last Sale ★</a:t>
                       </a:r>
                       <a:endParaRPr lang="en-US" sz="1000" dirty="0">
                         <a:latin typeface="맑은 고딕" charset="0"/>
@@ -15893,7 +15893,7 @@
                           <a:ea typeface="맑은 고딕" pitchFamily="34" charset="-122"/>
                           <a:cs typeface="맑은 고딕" pitchFamily="34" charset="-120"/>
                         </a:rPr>
-                        <a:t>"Giethoorn" 925 Open Ring</a:t>
+                        <a:t>Cloud Grip Glass Mini Brush (3color) (컬러: 스카이블루)</a:t>
                       </a:r>
                       <a:endParaRPr lang="en-US" sz="1100" dirty="0">
                         <a:latin typeface="맑은 고딕" charset="0"/>
@@ -15961,7 +15961,7 @@
                           <a:ea typeface="맑은 고딕" pitchFamily="34" charset="-122"/>
                           <a:cs typeface="맑은 고딕" pitchFamily="34" charset="-120"/>
                         </a:rPr>
-                        <a:t>1</a:t>
+                        <a:t>16</a:t>
                       </a:r>
                       <a:endParaRPr lang="en-US" sz="1100" dirty="0">
                         <a:latin typeface="맑은 고딕" charset="0"/>
@@ -16029,7 +16029,7 @@
                           <a:ea typeface="맑은 고딕" pitchFamily="34" charset="-122"/>
                           <a:cs typeface="맑은 고딕" pitchFamily="34" charset="-120"/>
                         </a:rPr>
-                        <a:t>1 개</a:t>
+                        <a:t>3 개</a:t>
                       </a:r>
                       <a:endParaRPr lang="en-US" sz="1100" dirty="0">
                         <a:latin typeface="맑은 고딕" charset="0"/>
@@ -16167,7 +16167,7 @@
                           <a:ea typeface="맑은 고딕" pitchFamily="34" charset="-122"/>
                           <a:cs typeface="맑은 고딕" pitchFamily="34" charset="-120"/>
                         </a:rPr>
-                        <a:t>PR</a:t>
+                        <a:t>6A</a:t>
                       </a:r>
                       <a:endParaRPr lang="en-US" sz="1100" dirty="0">
                         <a:latin typeface="맑은 고딕" charset="0"/>
@@ -16235,7 +16235,7 @@
                           <a:ea typeface="맑은 고딕" pitchFamily="34" charset="-122"/>
                           <a:cs typeface="맑은 고딕" pitchFamily="34" charset="-120"/>
                         </a:rPr>
-                        <a:t>ETC</a:t>
+                        <a:t>Necklace</a:t>
                       </a:r>
                       <a:endParaRPr lang="en-US" sz="1000" dirty="0">
                         <a:latin typeface="맑은 고딕" charset="0"/>
@@ -16303,7 +16303,7 @@
                           <a:ea typeface="맑은 고딕" pitchFamily="34" charset="-122"/>
                           <a:cs typeface="맑은 고딕" pitchFamily="34" charset="-120"/>
                         </a:rPr>
-                        <a:t>Fuzzy Stripe Slippers (3color) (컬러: 그린 / 사이즈: 240~250(여성))</a:t>
+                        <a:t>B-Flower Necklace (Size: 2 Size)</a:t>
                       </a:r>
                       <a:endParaRPr lang="en-US" sz="1100" dirty="0">
                         <a:latin typeface="맑은 고딕" charset="0"/>
@@ -16371,7 +16371,7 @@
                           <a:ea typeface="맑은 고딕" pitchFamily="34" charset="-122"/>
                           <a:cs typeface="맑은 고딕" pitchFamily="34" charset="-120"/>
                         </a:rPr>
-                        <a:t>5</a:t>
+                        <a:t>3</a:t>
                       </a:r>
                       <a:endParaRPr lang="en-US" sz="1100" dirty="0">
                         <a:latin typeface="맑은 고딕" charset="0"/>
@@ -16439,7 +16439,7 @@
                           <a:ea typeface="맑은 고딕" pitchFamily="34" charset="-122"/>
                           <a:cs typeface="맑은 고딕" pitchFamily="34" charset="-120"/>
                         </a:rPr>
-                        <a:t>1 개</a:t>
+                        <a:t>2 개</a:t>
                       </a:r>
                       <a:endParaRPr lang="en-US" sz="1100" dirty="0">
                         <a:latin typeface="맑은 고딕" charset="0"/>
@@ -16577,7 +16577,7 @@
                           <a:ea typeface="맑은 고딕" pitchFamily="34" charset="-122"/>
                           <a:cs typeface="맑은 고딕" pitchFamily="34" charset="-120"/>
                         </a:rPr>
-                        <a:t>6A</a:t>
+                        <a:t>PR</a:t>
                       </a:r>
                       <a:endParaRPr lang="en-US" sz="1100" dirty="0">
                         <a:latin typeface="맑은 고딕" charset="0"/>
@@ -16645,7 +16645,7 @@
                           <a:ea typeface="맑은 고딕" pitchFamily="34" charset="-122"/>
                           <a:cs typeface="맑은 고딕" pitchFamily="34" charset="-120"/>
                         </a:rPr>
-                        <a:t>Necklace</a:t>
+                        <a:t>ETC</a:t>
                       </a:r>
                       <a:endParaRPr lang="en-US" sz="1000" dirty="0">
                         <a:latin typeface="맑은 고딕" charset="0"/>
@@ -16713,7 +16713,7 @@
                           <a:ea typeface="맑은 고딕" pitchFamily="34" charset="-122"/>
                           <a:cs typeface="맑은 고딕" pitchFamily="34" charset="-120"/>
                         </a:rPr>
-                        <a:t>B-Flower Necklace (Size: 2 Size)</a:t>
+                        <a:t>Ball hanger (6color) (컬러: 아이보리)</a:t>
                       </a:r>
                       <a:endParaRPr lang="en-US" sz="1100" dirty="0">
                         <a:latin typeface="맑은 고딕" charset="0"/>
@@ -16781,7 +16781,7 @@
                           <a:ea typeface="맑은 고딕" pitchFamily="34" charset="-122"/>
                           <a:cs typeface="맑은 고딕" pitchFamily="34" charset="-120"/>
                         </a:rPr>
-                        <a:t>5</a:t>
+                        <a:t>8</a:t>
                       </a:r>
                       <a:endParaRPr lang="en-US" sz="1100" dirty="0">
                         <a:latin typeface="맑은 고딕" charset="0"/>
@@ -16849,7 +16849,7 @@
                           <a:ea typeface="맑은 고딕" pitchFamily="34" charset="-122"/>
                           <a:cs typeface="맑은 고딕" pitchFamily="34" charset="-120"/>
                         </a:rPr>
-                        <a:t>0 개</a:t>
+                        <a:t>2 개</a:t>
                       </a:r>
                       <a:endParaRPr lang="en-US" sz="1100" dirty="0">
                         <a:latin typeface="맑은 고딕" charset="0"/>
@@ -17055,7 +17055,7 @@
                           <a:ea typeface="맑은 고딕" pitchFamily="34" charset="-122"/>
                           <a:cs typeface="맑은 고딕" pitchFamily="34" charset="-120"/>
                         </a:rPr>
-                        <a:t>★Season off★</a:t>
+                        <a:t>Necklace</a:t>
                       </a:r>
                       <a:endParaRPr lang="en-US" sz="1000" dirty="0">
                         <a:latin typeface="맑은 고딕" charset="0"/>
@@ -17123,7 +17123,7 @@
                           <a:ea typeface="맑은 고딕" pitchFamily="34" charset="-122"/>
                           <a:cs typeface="맑은 고딕" pitchFamily="34" charset="-120"/>
                         </a:rPr>
-                        <a:t>8-Ball Smart Tok</a:t>
+                        <a:t>Chainlink Necklace</a:t>
                       </a:r>
                       <a:endParaRPr lang="en-US" sz="1100" dirty="0">
                         <a:latin typeface="맑은 고딕" charset="0"/>
@@ -17191,7 +17191,7 @@
                           <a:ea typeface="맑은 고딕" pitchFamily="34" charset="-122"/>
                           <a:cs typeface="맑은 고딕" pitchFamily="34" charset="-120"/>
                         </a:rPr>
-                        <a:t>5</a:t>
+                        <a:t>2</a:t>
                       </a:r>
                       <a:endParaRPr lang="en-US" sz="1100" dirty="0">
                         <a:latin typeface="맑은 고딕" charset="0"/>
@@ -17259,7 +17259,7 @@
                           <a:ea typeface="맑은 고딕" pitchFamily="34" charset="-122"/>
                           <a:cs typeface="맑은 고딕" pitchFamily="34" charset="-120"/>
                         </a:rPr>
-                        <a:t>0 개</a:t>
+                        <a:t>1 개</a:t>
                       </a:r>
                       <a:endParaRPr lang="en-US" sz="1100" dirty="0">
                         <a:latin typeface="맑은 고딕" charset="0"/>
@@ -17397,7 +17397,7 @@
                           <a:ea typeface="맑은 고딕" pitchFamily="34" charset="-122"/>
                           <a:cs typeface="맑은 고딕" pitchFamily="34" charset="-120"/>
                         </a:rPr>
-                        <a:t>6A</a:t>
+                        <a:t>CT</a:t>
                       </a:r>
                       <a:endParaRPr lang="en-US" sz="1100" dirty="0">
                         <a:latin typeface="맑은 고딕" charset="0"/>
@@ -17465,7 +17465,7 @@
                           <a:ea typeface="맑은 고딕" pitchFamily="34" charset="-122"/>
                           <a:cs typeface="맑은 고딕" pitchFamily="34" charset="-120"/>
                         </a:rPr>
-                        <a:t>Bracelet</a:t>
+                        <a:t>Ring</a:t>
                       </a:r>
                       <a:endParaRPr lang="en-US" sz="1000" dirty="0">
                         <a:latin typeface="맑은 고딕" charset="0"/>
@@ -17533,7 +17533,7 @@
                           <a:ea typeface="맑은 고딕" pitchFamily="34" charset="-122"/>
                           <a:cs typeface="맑은 고딕" pitchFamily="34" charset="-120"/>
                         </a:rPr>
-                        <a:t>Two-ball Bangle</a:t>
+                        <a:t>"Mlayer" 925 Open Ring</a:t>
                       </a:r>
                       <a:endParaRPr lang="en-US" sz="1100" dirty="0">
                         <a:latin typeface="맑은 고딕" charset="0"/>
@@ -17601,7 +17601,7 @@
                           <a:ea typeface="맑은 고딕" pitchFamily="34" charset="-122"/>
                           <a:cs typeface="맑은 고딕" pitchFamily="34" charset="-120"/>
                         </a:rPr>
-                        <a:t>0</a:t>
+                        <a:t>5</a:t>
                       </a:r>
                       <a:endParaRPr lang="en-US" sz="1100" dirty="0">
                         <a:latin typeface="맑은 고딕" charset="0"/>
@@ -17669,7 +17669,7 @@
                           <a:ea typeface="맑은 고딕" pitchFamily="34" charset="-122"/>
                           <a:cs typeface="맑은 고딕" pitchFamily="34" charset="-120"/>
                         </a:rPr>
-                        <a:t>0 개</a:t>
+                        <a:t>1 개</a:t>
                       </a:r>
                       <a:endParaRPr lang="en-US" sz="1100" dirty="0">
                         <a:latin typeface="맑은 고딕" charset="0"/>
@@ -17807,7 +17807,7 @@
                           <a:ea typeface="맑은 고딕" pitchFamily="34" charset="-122"/>
                           <a:cs typeface="맑은 고딕" pitchFamily="34" charset="-120"/>
                         </a:rPr>
-                        <a:t>6A</a:t>
+                        <a:t>PR</a:t>
                       </a:r>
                       <a:endParaRPr lang="en-US" sz="1100" dirty="0">
                         <a:latin typeface="맑은 고딕" charset="0"/>
@@ -17875,7 +17875,7 @@
                           <a:ea typeface="맑은 고딕" pitchFamily="34" charset="-122"/>
                           <a:cs typeface="맑은 고딕" pitchFamily="34" charset="-120"/>
                         </a:rPr>
-                        <a:t>★Best★</a:t>
+                        <a:t>ELECTRONIC</a:t>
                       </a:r>
                       <a:endParaRPr lang="en-US" sz="1000" dirty="0">
                         <a:latin typeface="맑은 고딕" charset="0"/>
@@ -17943,7 +17943,7 @@
                           <a:ea typeface="맑은 고딕" pitchFamily="34" charset="-122"/>
                           <a:cs typeface="맑은 고딕" pitchFamily="34" charset="-120"/>
                         </a:rPr>
-                        <a:t>Marquise Necklace</a:t>
+                        <a:t>Jacquard Fast Charging Cable (7color) (컬러: 퍼플 / 기종옵션: C-Apple 8pin / 길이: 2m)</a:t>
                       </a:r>
                       <a:endParaRPr lang="en-US" sz="1100" dirty="0">
                         <a:latin typeface="맑은 고딕" charset="0"/>
@@ -18011,7 +18011,7 @@
                           <a:ea typeface="맑은 고딕" pitchFamily="34" charset="-122"/>
                           <a:cs typeface="맑은 고딕" pitchFamily="34" charset="-120"/>
                         </a:rPr>
-                        <a:t>0</a:t>
+                        <a:t>12</a:t>
                       </a:r>
                       <a:endParaRPr lang="en-US" sz="1100" dirty="0">
                         <a:latin typeface="맑은 고딕" charset="0"/>
@@ -18079,7 +18079,7 @@
                           <a:ea typeface="맑은 고딕" pitchFamily="34" charset="-122"/>
                           <a:cs typeface="맑은 고딕" pitchFamily="34" charset="-120"/>
                         </a:rPr>
-                        <a:t>0 개</a:t>
+                        <a:t>1 개</a:t>
                       </a:r>
                       <a:endParaRPr lang="en-US" sz="1100" dirty="0">
                         <a:latin typeface="맑은 고딕" charset="0"/>
@@ -18168,7 +18168,7 @@
                 <a:ea typeface="맑은 고딕" pitchFamily="34" charset="-122"/>
                 <a:cs typeface="맑은 고딕" pitchFamily="34" charset="-120"/>
               </a:rPr>
-              <a:t>외 57건 더 있음 — 상세는 시트에서 확인</a:t>
+              <a:t>외 61건 더 있음 — 상세는 시트에서 확인</a:t>
             </a:r>
             <a:endParaRPr lang="en-US" sz="1000" dirty="0"/>
           </a:p>
@@ -18207,7 +18207,7 @@
                 <a:ea typeface="맑은 고딕" pitchFamily="34" charset="-122"/>
                 <a:cs typeface="맑은 고딕" pitchFamily="34" charset="-120"/>
               </a:rPr>
-              <a:t>베스트 상품 리포트  ·  생성 2026-05-20 08:00</a:t>
+              <a:t>베스트 상품 리포트  ·  생성 2026-05-21 08:00</a:t>
             </a:r>
             <a:endParaRPr lang="en-US" sz="900" dirty="0"/>
           </a:p>
@@ -18420,7 +18420,7 @@
                 <a:ea typeface="맑은 고딕" pitchFamily="34" charset="-122"/>
                 <a:cs typeface="맑은 고딕" pitchFamily="34" charset="-120"/>
               </a:rPr>
-              <a:t>2026년 05월 20일 (수)</a:t>
+              <a:t>2026년 05월 21일 (목)</a:t>
             </a:r>
             <a:endParaRPr lang="en-US" sz="1200" dirty="0"/>
           </a:p>
@@ -18587,7 +18587,7 @@
                 <a:ea typeface="맑은 고딕" pitchFamily="34" charset="-122"/>
                 <a:cs typeface="맑은 고딕" pitchFamily="34" charset="-120"/>
               </a:rPr>
-              <a:t>Google Sheet '브랜드 재고현황'  ·  최신화 2026-05-20 08:00</a:t>
+              <a:t>Google Sheet '브랜드 재고현황'  ·  최신화 2026-05-21 08:00</a:t>
             </a:r>
             <a:endParaRPr lang="en-US" sz="1100" dirty="0"/>
           </a:p>
@@ -19230,7 +19230,7 @@
                 <a:ea typeface="맑은 고딕" pitchFamily="34" charset="-122"/>
                 <a:cs typeface="맑은 고딕" pitchFamily="34" charset="-120"/>
               </a:rPr>
-              <a:t>✅ 3개 브랜드 모두 정상 추출  ·  24h 출고 기준 (2026-05-19 08:00 → 2026-05-20 08:00) · 신규 SKU 13건은 결제완료 기준</a:t>
+              <a:t>✅ 3개 브랜드 모두 정상 추출  ·  24h 출고 기준 (2026-05-20 08:00 → 2026-05-21 08:00) · 신규 SKU 12건은 결제완료 기준</a:t>
             </a:r>
             <a:endParaRPr lang="en-US" sz="1000" dirty="0"/>
           </a:p>
@@ -19269,7 +19269,7 @@
                 <a:ea typeface="맑은 고딕" pitchFamily="34" charset="-122"/>
                 <a:cs typeface="맑은 고딕" pitchFamily="34" charset="-120"/>
               </a:rPr>
-              <a:t>베스트 상품 리포트  ·  생성 2026-05-20 08:00</a:t>
+              <a:t>베스트 상품 리포트  ·  생성 2026-05-21 08:00</a:t>
             </a:r>
             <a:endParaRPr lang="en-US" sz="900" dirty="0"/>
           </a:p>

</xml_diff>

<commit_message>
chore: 매출 PPT 업로드 (best-sellers-2026-05-22.pptx) [auto]
</commit_message>
<xml_diff>
--- a/data/sales-report.pptx
+++ b/data/sales-report.pptx
@@ -1648,7 +1648,7 @@
                 <a:ea typeface="맑은 고딕" pitchFamily="34" charset="-122"/>
                 <a:cs typeface="맑은 고딕" pitchFamily="34" charset="-120"/>
               </a:rPr>
-              <a:t>2026년 05월 21일 (목)  ·  24h 출고 기준</a:t>
+              <a:t>2026년 05월 22일 (금)  ·  24h 출고 기준</a:t>
             </a:r>
             <a:endParaRPr lang="en-US" sz="2200" dirty="0"/>
           </a:p>
@@ -1726,7 +1726,7 @@
                 <a:ea typeface="맑은 고딕" pitchFamily="34" charset="-122"/>
                 <a:cs typeface="맑은 고딕" pitchFamily="34" charset="-120"/>
               </a:rPr>
-              <a:t>05.21</a:t>
+              <a:t>05.22</a:t>
             </a:r>
             <a:endParaRPr lang="en-US" sz="7200" dirty="0"/>
           </a:p>
@@ -1765,7 +1765,7 @@
                 <a:ea typeface="맑은 고딕" pitchFamily="34" charset="-122"/>
                 <a:cs typeface="맑은 고딕" pitchFamily="34" charset="-120"/>
               </a:rPr>
-              <a:t>목요일</a:t>
+              <a:t>금요일</a:t>
             </a:r>
             <a:endParaRPr lang="en-US" sz="1400" dirty="0"/>
           </a:p>
@@ -1804,7 +1804,7 @@
                 <a:ea typeface="맑은 고딕" pitchFamily="34" charset="-122"/>
                 <a:cs typeface="맑은 고딕" pitchFamily="34" charset="-120"/>
               </a:rPr>
-              <a:t>생성 2026-05-21 08:00  ·  Google Sheet 자동 동기</a:t>
+              <a:t>생성 2026-05-22 08:00  ·  Google Sheet 자동 동기</a:t>
             </a:r>
             <a:endParaRPr lang="en-US" sz="1000" dirty="0"/>
           </a:p>
@@ -1978,7 +1978,7 @@
                 <a:ea typeface="맑은 고딕" pitchFamily="34" charset="-122"/>
                 <a:cs typeface="맑은 고딕" pitchFamily="34" charset="-120"/>
               </a:rPr>
-              <a:t>2026년 05월 21일 (목)</a:t>
+              <a:t>2026년 05월 22일 (금)</a:t>
             </a:r>
             <a:endParaRPr lang="en-US" sz="1200" dirty="0"/>
           </a:p>
@@ -2145,7 +2145,7 @@
                 <a:ea typeface="맑은 고딕" pitchFamily="34" charset="-122"/>
                 <a:cs typeface="맑은 고딕" pitchFamily="34" charset="-120"/>
               </a:rPr>
-              <a:t>428 개</a:t>
+              <a:t>372 개</a:t>
             </a:r>
             <a:endParaRPr lang="en-US" sz="3600" dirty="0"/>
           </a:p>
@@ -2312,7 +2312,7 @@
                 <a:ea typeface="맑은 고딕" pitchFamily="34" charset="-122"/>
                 <a:cs typeface="맑은 고딕" pitchFamily="34" charset="-120"/>
               </a:rPr>
-              <a:t>70 건</a:t>
+              <a:t>68 건</a:t>
             </a:r>
             <a:endParaRPr lang="en-US" sz="3200" dirty="0"/>
           </a:p>
@@ -2479,7 +2479,7 @@
                 <a:ea typeface="맑은 고딕" pitchFamily="34" charset="-122"/>
                 <a:cs typeface="맑은 고딕" pitchFamily="34" charset="-120"/>
               </a:rPr>
-              <a:t>13 건</a:t>
+              <a:t>11 건</a:t>
             </a:r>
             <a:endParaRPr lang="en-US" sz="3200" dirty="0"/>
           </a:p>
@@ -2685,7 +2685,7 @@
                 <a:ea typeface="맑은 고딕" pitchFamily="34" charset="-122"/>
                 <a:cs typeface="맑은 고딕" pitchFamily="34" charset="-120"/>
               </a:rPr>
-              <a:t>86 SKU  ·  판매 OK</a:t>
+              <a:t>84 SKU  ·  판매 OK</a:t>
             </a:r>
             <a:pPr indent="0" marL="0">
               <a:buNone/>
@@ -3677,7 +3677,7 @@
                           <a:ea typeface="맑은 고딕" pitchFamily="34" charset="-122"/>
                           <a:cs typeface="맑은 고딕" pitchFamily="34" charset="-120"/>
                         </a:rPr>
-                        <a:t>43 개</a:t>
+                        <a:t>48 개</a:t>
                       </a:r>
                       <a:endParaRPr lang="en-US" sz="1400" dirty="0">
                         <a:latin typeface="맑은 고딕" charset="0"/>
@@ -3809,7 +3809,7 @@
                           <a:ea typeface="맑은 고딕" pitchFamily="34" charset="-122"/>
                           <a:cs typeface="맑은 고딕" pitchFamily="34" charset="-120"/>
                         </a:rPr>
-                        <a:t>CT</a:t>
+                        <a:t>6A</a:t>
                       </a:r>
                       <a:endParaRPr lang="en-US" sz="1100" dirty="0">
                         <a:latin typeface="맑은 고딕" charset="0"/>
@@ -3874,7 +3874,7 @@
                           <a:ea typeface="맑은 고딕" pitchFamily="34" charset="-122"/>
                           <a:cs typeface="맑은 고딕" pitchFamily="34" charset="-120"/>
                         </a:rPr>
-                        <a:t>Necklace</a:t>
+                        <a:t>Ring</a:t>
                       </a:r>
                       <a:endParaRPr lang="en-US" sz="1000" dirty="0">
                         <a:latin typeface="맑은 고딕" charset="0"/>
@@ -3939,7 +3939,7 @@
                           <a:ea typeface="맑은 고딕" pitchFamily="34" charset="-122"/>
                           <a:cs typeface="맑은 고딕" pitchFamily="34" charset="-120"/>
                         </a:rPr>
-                        <a:t>CandyPOP Necklace (사이즈: 1size (37~43cm))</a:t>
+                        <a:t>[SILVER925] Guyeong Open Ring v3.0 (silver)</a:t>
                       </a:r>
                       <a:endParaRPr lang="en-US" sz="1100" dirty="0">
                         <a:latin typeface="맑은 고딕" charset="0"/>
@@ -4004,7 +4004,7 @@
                           <a:ea typeface="맑은 고딕" pitchFamily="34" charset="-122"/>
                           <a:cs typeface="맑은 고딕" pitchFamily="34" charset="-120"/>
                         </a:rPr>
-                        <a:t>33 개</a:t>
+                        <a:t>40 개</a:t>
                       </a:r>
                       <a:endParaRPr lang="en-US" sz="1400" dirty="0">
                         <a:latin typeface="맑은 고딕" charset="0"/>
@@ -4201,7 +4201,7 @@
                           <a:ea typeface="맑은 고딕" pitchFamily="34" charset="-122"/>
                           <a:cs typeface="맑은 고딕" pitchFamily="34" charset="-120"/>
                         </a:rPr>
-                        <a:t>Ring</a:t>
+                        <a:t>Necklace</a:t>
                       </a:r>
                       <a:endParaRPr lang="en-US" sz="1000" dirty="0">
                         <a:latin typeface="맑은 고딕" charset="0"/>
@@ -4266,7 +4266,7 @@
                           <a:ea typeface="맑은 고딕" pitchFamily="34" charset="-122"/>
                           <a:cs typeface="맑은 고딕" pitchFamily="34" charset="-120"/>
                         </a:rPr>
-                        <a:t>"4s" 925 Open Ring (사이즈: 남성)</a:t>
+                        <a:t>CandyPOP Necklace (사이즈: 1size (37~43cm))</a:t>
                       </a:r>
                       <a:endParaRPr lang="en-US" sz="1100" dirty="0">
                         <a:latin typeface="맑은 고딕" charset="0"/>
@@ -4331,7 +4331,7 @@
                           <a:ea typeface="맑은 고딕" pitchFamily="34" charset="-122"/>
                           <a:cs typeface="맑은 고딕" pitchFamily="34" charset="-120"/>
                         </a:rPr>
-                        <a:t>28 개</a:t>
+                        <a:t>29 개</a:t>
                       </a:r>
                       <a:endParaRPr lang="en-US" sz="1400" dirty="0">
                         <a:latin typeface="맑은 고딕" charset="0"/>
@@ -4463,7 +4463,7 @@
                           <a:ea typeface="맑은 고딕" pitchFamily="34" charset="-122"/>
                           <a:cs typeface="맑은 고딕" pitchFamily="34" charset="-120"/>
                         </a:rPr>
-                        <a:t>6A</a:t>
+                        <a:t>CT</a:t>
                       </a:r>
                       <a:endParaRPr lang="en-US" sz="1100" dirty="0">
                         <a:latin typeface="맑은 고딕" charset="0"/>
@@ -4528,7 +4528,7 @@
                           <a:ea typeface="맑은 고딕" pitchFamily="34" charset="-122"/>
                           <a:cs typeface="맑은 고딕" pitchFamily="34" charset="-120"/>
                         </a:rPr>
-                        <a:t>Ring</a:t>
+                        <a:t>Necklace</a:t>
                       </a:r>
                       <a:endParaRPr lang="en-US" sz="1000" dirty="0">
                         <a:latin typeface="맑은 고딕" charset="0"/>
@@ -4593,7 +4593,7 @@
                           <a:ea typeface="맑은 고딕" pitchFamily="34" charset="-122"/>
                           <a:cs typeface="맑은 고딕" pitchFamily="34" charset="-120"/>
                         </a:rPr>
-                        <a:t>[SILVER925] Guyeong Open Ring v3.0 (silver)</a:t>
+                        <a:t>CandyPOP Necklace (사이즈: 2size (47~52cm))</a:t>
                       </a:r>
                       <a:endParaRPr lang="en-US" sz="1100" dirty="0">
                         <a:latin typeface="맑은 고딕" charset="0"/>
@@ -4658,7 +4658,7 @@
                           <a:ea typeface="맑은 고딕" pitchFamily="34" charset="-122"/>
                           <a:cs typeface="맑은 고딕" pitchFamily="34" charset="-120"/>
                         </a:rPr>
-                        <a:t>25 개</a:t>
+                        <a:t>24 개</a:t>
                       </a:r>
                       <a:endParaRPr lang="en-US" sz="1200" dirty="0">
                         <a:latin typeface="맑은 고딕" charset="0"/>
@@ -4790,7 +4790,7 @@
                           <a:ea typeface="맑은 고딕" pitchFamily="34" charset="-122"/>
                           <a:cs typeface="맑은 고딕" pitchFamily="34" charset="-120"/>
                         </a:rPr>
-                        <a:t>CT</a:t>
+                        <a:t>6A</a:t>
                       </a:r>
                       <a:endParaRPr lang="en-US" sz="1100" dirty="0">
                         <a:latin typeface="맑은 고딕" charset="0"/>
@@ -4855,7 +4855,7 @@
                           <a:ea typeface="맑은 고딕" pitchFamily="34" charset="-122"/>
                           <a:cs typeface="맑은 고딕" pitchFamily="34" charset="-120"/>
                         </a:rPr>
-                        <a:t>Necklace</a:t>
+                        <a:t>Ring</a:t>
                       </a:r>
                       <a:endParaRPr lang="en-US" sz="1000" dirty="0">
                         <a:latin typeface="맑은 고딕" charset="0"/>
@@ -4920,7 +4920,7 @@
                           <a:ea typeface="맑은 고딕" pitchFamily="34" charset="-122"/>
                           <a:cs typeface="맑은 고딕" pitchFamily="34" charset="-120"/>
                         </a:rPr>
-                        <a:t>CandyPOP Necklace (사이즈: 2size (47~52cm))</a:t>
+                        <a:t>[SILVER925] Eramam Open Ring</a:t>
                       </a:r>
                       <a:endParaRPr lang="en-US" sz="1100" dirty="0">
                         <a:latin typeface="맑은 고딕" charset="0"/>
@@ -4985,7 +4985,7 @@
                           <a:ea typeface="맑은 고딕" pitchFamily="34" charset="-122"/>
                           <a:cs typeface="맑은 고딕" pitchFamily="34" charset="-120"/>
                         </a:rPr>
-                        <a:t>23 개</a:t>
+                        <a:t>13 개</a:t>
                       </a:r>
                       <a:endParaRPr lang="en-US" sz="1200" dirty="0">
                         <a:latin typeface="맑은 고딕" charset="0"/>
@@ -5071,7 +5071,7 @@
                 <a:ea typeface="맑은 고딕" pitchFamily="34" charset="-122"/>
                 <a:cs typeface="맑은 고딕" pitchFamily="34" charset="-120"/>
               </a:rPr>
-              <a:t>베스트 상품 리포트  ·  생성 2026-05-21 08:00</a:t>
+              <a:t>베스트 상품 리포트  ·  생성 2026-05-22 08:00</a:t>
             </a:r>
             <a:endParaRPr lang="en-US" sz="900" dirty="0"/>
           </a:p>
@@ -5284,7 +5284,7 @@
                 <a:ea typeface="맑은 고딕" pitchFamily="34" charset="-122"/>
                 <a:cs typeface="맑은 고딕" pitchFamily="34" charset="-120"/>
               </a:rPr>
-              <a:t>2026년 05월 21일 (목)</a:t>
+              <a:t>2026년 05월 22일 (금)</a:t>
             </a:r>
             <a:endParaRPr lang="en-US" sz="1200" dirty="0"/>
           </a:p>
@@ -5451,7 +5451,7 @@
                 <a:ea typeface="맑은 고딕" pitchFamily="34" charset="-122"/>
                 <a:cs typeface="맑은 고딕" pitchFamily="34" charset="-120"/>
               </a:rPr>
-              <a:t>295 개</a:t>
+              <a:t>267 개</a:t>
             </a:r>
             <a:endParaRPr lang="en-US" sz="3600" dirty="0"/>
           </a:p>
@@ -5657,7 +5657,7 @@
                 <a:ea typeface="맑은 고딕" pitchFamily="34" charset="-122"/>
                 <a:cs typeface="맑은 고딕" pitchFamily="34" charset="-120"/>
               </a:rPr>
-              <a:t>43</a:t>
+              <a:t>48</a:t>
             </a:r>
             <a:endParaRPr lang="en-US" sz="4400" dirty="0"/>
           </a:p>
@@ -6256,7 +6256,7 @@
                           <a:ea typeface="맑은 고딕" pitchFamily="34" charset="-122"/>
                           <a:cs typeface="맑은 고딕" pitchFamily="34" charset="-120"/>
                         </a:rPr>
-                        <a:t>43 개</a:t>
+                        <a:t>48 개</a:t>
                       </a:r>
                       <a:endParaRPr lang="en-US" sz="1400" dirty="0">
                         <a:latin typeface="맑은 고딕" charset="0"/>
@@ -6518,7 +6518,7 @@
                           <a:ea typeface="맑은 고딕" pitchFamily="34" charset="-122"/>
                           <a:cs typeface="맑은 고딕" pitchFamily="34" charset="-120"/>
                         </a:rPr>
-                        <a:t>25 개</a:t>
+                        <a:t>40 개</a:t>
                       </a:r>
                       <a:endParaRPr lang="en-US" sz="1200" dirty="0">
                         <a:latin typeface="맑은 고딕" charset="0"/>
@@ -6650,7 +6650,7 @@
                           <a:ea typeface="맑은 고딕" pitchFamily="34" charset="-122"/>
                           <a:cs typeface="맑은 고딕" pitchFamily="34" charset="-120"/>
                         </a:rPr>
-                        <a:t>Necklace</a:t>
+                        <a:t>Ring</a:t>
                       </a:r>
                       <a:endParaRPr lang="en-US" sz="1000" dirty="0">
                         <a:latin typeface="맑은 고딕" charset="0"/>
@@ -6715,7 +6715,7 @@
                           <a:ea typeface="맑은 고딕" pitchFamily="34" charset="-122"/>
                           <a:cs typeface="맑은 고딕" pitchFamily="34" charset="-120"/>
                         </a:rPr>
-                        <a:t>Tiny Cross Necklace</a:t>
+                        <a:t>[SILVER925] Eramam Open Ring</a:t>
                       </a:r>
                       <a:endParaRPr lang="en-US" sz="1100" dirty="0">
                         <a:latin typeface="맑은 고딕" charset="0"/>
@@ -6780,7 +6780,7 @@
                           <a:ea typeface="맑은 고딕" pitchFamily="34" charset="-122"/>
                           <a:cs typeface="맑은 고딕" pitchFamily="34" charset="-120"/>
                         </a:rPr>
-                        <a:t>16 개</a:t>
+                        <a:t>13 개</a:t>
                       </a:r>
                       <a:endParaRPr lang="en-US" sz="1200" dirty="0">
                         <a:latin typeface="맑은 고딕" charset="0"/>
@@ -7042,7 +7042,7 @@
                           <a:ea typeface="맑은 고딕" pitchFamily="34" charset="-122"/>
                           <a:cs typeface="맑은 고딕" pitchFamily="34" charset="-120"/>
                         </a:rPr>
-                        <a:t>16 개</a:t>
+                        <a:t>12 개</a:t>
                       </a:r>
                       <a:endParaRPr lang="en-US" sz="1200" dirty="0">
                         <a:latin typeface="맑은 고딕" charset="0"/>
@@ -7174,7 +7174,7 @@
                           <a:ea typeface="맑은 고딕" pitchFamily="34" charset="-122"/>
                           <a:cs typeface="맑은 고딕" pitchFamily="34" charset="-120"/>
                         </a:rPr>
-                        <a:t>Ring</a:t>
+                        <a:t>Necklace</a:t>
                       </a:r>
                       <a:endParaRPr lang="en-US" sz="1000" dirty="0">
                         <a:latin typeface="맑은 고딕" charset="0"/>
@@ -7239,7 +7239,7 @@
                           <a:ea typeface="맑은 고딕" pitchFamily="34" charset="-122"/>
                           <a:cs typeface="맑은 고딕" pitchFamily="34" charset="-120"/>
                         </a:rPr>
-                        <a:t>[SILVER925] A Rua Open Ring</a:t>
+                        <a:t>Tiny Cross Necklace</a:t>
                       </a:r>
                       <a:endParaRPr lang="en-US" sz="1100" dirty="0">
                         <a:latin typeface="맑은 고딕" charset="0"/>
@@ -7304,7 +7304,7 @@
                           <a:ea typeface="맑은 고딕" pitchFamily="34" charset="-122"/>
                           <a:cs typeface="맑은 고딕" pitchFamily="34" charset="-120"/>
                         </a:rPr>
-                        <a:t>16 개</a:t>
+                        <a:t>11 개</a:t>
                       </a:r>
                       <a:endParaRPr lang="en-US" sz="1200" dirty="0">
                         <a:latin typeface="맑은 고딕" charset="0"/>
@@ -7390,7 +7390,7 @@
                 <a:ea typeface="맑은 고딕" pitchFamily="34" charset="-122"/>
                 <a:cs typeface="맑은 고딕" pitchFamily="34" charset="-120"/>
               </a:rPr>
-              <a:t>리오더 필요  🔴 긴급 10건</a:t>
+              <a:t>리오더 필요  🔴 긴급 8건</a:t>
             </a:r>
             <a:pPr indent="0" marL="0">
               <a:buNone/>
@@ -7557,7 +7557,7 @@
                 <a:ea typeface="맑은 고딕" pitchFamily="34" charset="-122"/>
                 <a:cs typeface="맑은 고딕" pitchFamily="34" charset="-120"/>
               </a:rPr>
-              <a:t>Safety Pin Necklace</a:t>
+              <a:t>8-Ball Smart Tok</a:t>
             </a:r>
             <a:endParaRPr lang="en-US" sz="1100" dirty="0"/>
           </a:p>
@@ -7572,6 +7572,212 @@
         <p:spPr>
           <a:xfrm>
             <a:off x="8211312" y="3712464"/>
+            <a:ext cx="3291840" cy="256032"/>
+          </a:xfrm>
+          <a:prstGeom prst="rect">
+            <a:avLst/>
+          </a:prstGeom>
+          <a:noFill/>
+          <a:ln/>
+        </p:spPr>
+        <p:txBody>
+          <a:bodyPr wrap="square" lIns="0" tIns="0" rIns="0" bIns="0" rtlCol="0" anchor="ctr"/>
+          <a:lstStyle/>
+          <a:p>
+            <a:pPr indent="0" marL="0">
+              <a:buNone/>
+            </a:pPr>
+            <a:r>
+              <a:rPr lang="en-US" sz="1000" dirty="0">
+                <a:solidFill>
+                  <a:srgbClr val="6B7280"/>
+                </a:solidFill>
+                <a:latin typeface="맑은 고딕" pitchFamily="34" charset="0"/>
+                <a:ea typeface="맑은 고딕" pitchFamily="34" charset="-122"/>
+                <a:cs typeface="맑은 고딕" pitchFamily="34" charset="-120"/>
+              </a:rPr>
+              <a:t>★Season off★  ·  재고 4개</a:t>
+            </a:r>
+            <a:pPr indent="0" marL="0">
+              <a:buNone/>
+            </a:pPr>
+            <a:r>
+              <a:rPr lang="en-US" sz="1000" b="1" dirty="0">
+                <a:solidFill>
+                  <a:srgbClr val="D72638"/>
+                </a:solidFill>
+                <a:latin typeface="맑은 고딕" pitchFamily="34" charset="0"/>
+                <a:ea typeface="맑은 고딕" pitchFamily="34" charset="-122"/>
+                <a:cs typeface="맑은 고딕" pitchFamily="34" charset="-120"/>
+              </a:rPr>
+              <a:t/>
+            </a:r>
+            <a:endParaRPr lang="en-US" sz="1000" dirty="0"/>
+          </a:p>
+        </p:txBody>
+      </p:sp>
+      <p:sp>
+        <p:nvSpPr>
+          <p:cNvPr id="27" name="Shape 24"/>
+          <p:cNvSpPr/>
+          <p:nvPr/>
+        </p:nvSpPr>
+        <p:spPr>
+          <a:xfrm>
+            <a:off x="7406640" y="4096512"/>
+            <a:ext cx="4206240" cy="640080"/>
+          </a:xfrm>
+          <a:prstGeom prst="rect">
+            <a:avLst/>
+          </a:prstGeom>
+          <a:solidFill>
+            <a:srgbClr val="FFF5F5"/>
+          </a:solidFill>
+          <a:ln w="6350">
+            <a:solidFill>
+              <a:srgbClr val="E5E7EB"/>
+            </a:solidFill>
+            <a:prstDash val="solid"/>
+          </a:ln>
+        </p:spPr>
+      </p:sp>
+      <p:sp>
+        <p:nvSpPr>
+          <p:cNvPr id="28" name="Shape 25"/>
+          <p:cNvSpPr/>
+          <p:nvPr/>
+        </p:nvSpPr>
+        <p:spPr>
+          <a:xfrm>
+            <a:off x="7406640" y="4096512"/>
+            <a:ext cx="109728" cy="640080"/>
+          </a:xfrm>
+          <a:prstGeom prst="rect">
+            <a:avLst/>
+          </a:prstGeom>
+          <a:solidFill>
+            <a:srgbClr val="D72638"/>
+          </a:solidFill>
+          <a:ln w="12700">
+            <a:solidFill>
+              <a:srgbClr val="D72638"/>
+            </a:solidFill>
+            <a:prstDash val="solid"/>
+          </a:ln>
+        </p:spPr>
+      </p:sp>
+      <p:sp>
+        <p:nvSpPr>
+          <p:cNvPr id="29" name="Shape 26"/>
+          <p:cNvSpPr/>
+          <p:nvPr/>
+        </p:nvSpPr>
+        <p:spPr>
+          <a:xfrm>
+            <a:off x="7571232" y="4187952"/>
+            <a:ext cx="548640" cy="256032"/>
+          </a:xfrm>
+          <a:prstGeom prst="rect">
+            <a:avLst/>
+          </a:prstGeom>
+          <a:solidFill>
+            <a:srgbClr val="D72638"/>
+          </a:solidFill>
+          <a:ln w="12700">
+            <a:solidFill>
+              <a:srgbClr val="D72638"/>
+            </a:solidFill>
+            <a:prstDash val="solid"/>
+          </a:ln>
+        </p:spPr>
+      </p:sp>
+      <p:sp>
+        <p:nvSpPr>
+          <p:cNvPr id="30" name="Text 27"/>
+          <p:cNvSpPr/>
+          <p:nvPr/>
+        </p:nvSpPr>
+        <p:spPr>
+          <a:xfrm>
+            <a:off x="7571232" y="4187952"/>
+            <a:ext cx="548640" cy="256032"/>
+          </a:xfrm>
+          <a:prstGeom prst="rect">
+            <a:avLst/>
+          </a:prstGeom>
+          <a:noFill/>
+          <a:ln/>
+        </p:spPr>
+        <p:txBody>
+          <a:bodyPr wrap="square" lIns="0" tIns="0" rIns="0" bIns="0" rtlCol="0" anchor="ctr"/>
+          <a:lstStyle/>
+          <a:p>
+            <a:pPr algn="ctr" indent="0" marL="0">
+              <a:buNone/>
+            </a:pPr>
+            <a:r>
+              <a:rPr lang="en-US" sz="900" b="1" dirty="0">
+                <a:solidFill>
+                  <a:srgbClr val="FFFFFF"/>
+                </a:solidFill>
+                <a:latin typeface="맑은 고딕" pitchFamily="34" charset="0"/>
+                <a:ea typeface="맑은 고딕" pitchFamily="34" charset="-122"/>
+                <a:cs typeface="맑은 고딕" pitchFamily="34" charset="-120"/>
+              </a:rPr>
+              <a:t>긴급</a:t>
+            </a:r>
+            <a:endParaRPr lang="en-US" sz="900" dirty="0"/>
+          </a:p>
+        </p:txBody>
+      </p:sp>
+      <p:sp>
+        <p:nvSpPr>
+          <p:cNvPr id="31" name="Text 28"/>
+          <p:cNvSpPr/>
+          <p:nvPr/>
+        </p:nvSpPr>
+        <p:spPr>
+          <a:xfrm>
+            <a:off x="8211312" y="4151376"/>
+            <a:ext cx="3291840" cy="274320"/>
+          </a:xfrm>
+          <a:prstGeom prst="rect">
+            <a:avLst/>
+          </a:prstGeom>
+          <a:noFill/>
+          <a:ln/>
+        </p:spPr>
+        <p:txBody>
+          <a:bodyPr wrap="square" lIns="0" tIns="0" rIns="0" bIns="0" rtlCol="0" anchor="ctr"/>
+          <a:lstStyle/>
+          <a:p>
+            <a:pPr indent="0" marL="0">
+              <a:buNone/>
+            </a:pPr>
+            <a:r>
+              <a:rPr lang="en-US" sz="1100" b="1" dirty="0">
+                <a:solidFill>
+                  <a:srgbClr val="0B1220"/>
+                </a:solidFill>
+                <a:latin typeface="맑은 고딕" pitchFamily="34" charset="0"/>
+                <a:ea typeface="맑은 고딕" pitchFamily="34" charset="-122"/>
+                <a:cs typeface="맑은 고딕" pitchFamily="34" charset="-120"/>
+              </a:rPr>
+              <a:t>B-Flower Necklace (Size: 2 Size)</a:t>
+            </a:r>
+            <a:endParaRPr lang="en-US" sz="1100" dirty="0"/>
+          </a:p>
+        </p:txBody>
+      </p:sp>
+      <p:sp>
+        <p:nvSpPr>
+          <p:cNvPr id="32" name="Text 29"/>
+          <p:cNvSpPr/>
+          <p:nvPr/>
+        </p:nvSpPr>
+        <p:spPr>
+          <a:xfrm>
+            <a:off x="8211312" y="4425696"/>
             <a:ext cx="3291840" cy="256032"/>
           </a:xfrm>
           <a:prstGeom prst="rect">
@@ -7618,212 +7824,6 @@
       </p:sp>
       <p:sp>
         <p:nvSpPr>
-          <p:cNvPr id="27" name="Shape 24"/>
-          <p:cNvSpPr/>
-          <p:nvPr/>
-        </p:nvSpPr>
-        <p:spPr>
-          <a:xfrm>
-            <a:off x="7406640" y="4096512"/>
-            <a:ext cx="4206240" cy="640080"/>
-          </a:xfrm>
-          <a:prstGeom prst="rect">
-            <a:avLst/>
-          </a:prstGeom>
-          <a:solidFill>
-            <a:srgbClr val="FFF5F5"/>
-          </a:solidFill>
-          <a:ln w="6350">
-            <a:solidFill>
-              <a:srgbClr val="E5E7EB"/>
-            </a:solidFill>
-            <a:prstDash val="solid"/>
-          </a:ln>
-        </p:spPr>
-      </p:sp>
-      <p:sp>
-        <p:nvSpPr>
-          <p:cNvPr id="28" name="Shape 25"/>
-          <p:cNvSpPr/>
-          <p:nvPr/>
-        </p:nvSpPr>
-        <p:spPr>
-          <a:xfrm>
-            <a:off x="7406640" y="4096512"/>
-            <a:ext cx="109728" cy="640080"/>
-          </a:xfrm>
-          <a:prstGeom prst="rect">
-            <a:avLst/>
-          </a:prstGeom>
-          <a:solidFill>
-            <a:srgbClr val="D72638"/>
-          </a:solidFill>
-          <a:ln w="12700">
-            <a:solidFill>
-              <a:srgbClr val="D72638"/>
-            </a:solidFill>
-            <a:prstDash val="solid"/>
-          </a:ln>
-        </p:spPr>
-      </p:sp>
-      <p:sp>
-        <p:nvSpPr>
-          <p:cNvPr id="29" name="Shape 26"/>
-          <p:cNvSpPr/>
-          <p:nvPr/>
-        </p:nvSpPr>
-        <p:spPr>
-          <a:xfrm>
-            <a:off x="7571232" y="4187952"/>
-            <a:ext cx="548640" cy="256032"/>
-          </a:xfrm>
-          <a:prstGeom prst="rect">
-            <a:avLst/>
-          </a:prstGeom>
-          <a:solidFill>
-            <a:srgbClr val="D72638"/>
-          </a:solidFill>
-          <a:ln w="12700">
-            <a:solidFill>
-              <a:srgbClr val="D72638"/>
-            </a:solidFill>
-            <a:prstDash val="solid"/>
-          </a:ln>
-        </p:spPr>
-      </p:sp>
-      <p:sp>
-        <p:nvSpPr>
-          <p:cNvPr id="30" name="Text 27"/>
-          <p:cNvSpPr/>
-          <p:nvPr/>
-        </p:nvSpPr>
-        <p:spPr>
-          <a:xfrm>
-            <a:off x="7571232" y="4187952"/>
-            <a:ext cx="548640" cy="256032"/>
-          </a:xfrm>
-          <a:prstGeom prst="rect">
-            <a:avLst/>
-          </a:prstGeom>
-          <a:noFill/>
-          <a:ln/>
-        </p:spPr>
-        <p:txBody>
-          <a:bodyPr wrap="square" lIns="0" tIns="0" rIns="0" bIns="0" rtlCol="0" anchor="ctr"/>
-          <a:lstStyle/>
-          <a:p>
-            <a:pPr algn="ctr" indent="0" marL="0">
-              <a:buNone/>
-            </a:pPr>
-            <a:r>
-              <a:rPr lang="en-US" sz="900" b="1" dirty="0">
-                <a:solidFill>
-                  <a:srgbClr val="FFFFFF"/>
-                </a:solidFill>
-                <a:latin typeface="맑은 고딕" pitchFamily="34" charset="0"/>
-                <a:ea typeface="맑은 고딕" pitchFamily="34" charset="-122"/>
-                <a:cs typeface="맑은 고딕" pitchFamily="34" charset="-120"/>
-              </a:rPr>
-              <a:t>긴급</a:t>
-            </a:r>
-            <a:endParaRPr lang="en-US" sz="900" dirty="0"/>
-          </a:p>
-        </p:txBody>
-      </p:sp>
-      <p:sp>
-        <p:nvSpPr>
-          <p:cNvPr id="31" name="Text 28"/>
-          <p:cNvSpPr/>
-          <p:nvPr/>
-        </p:nvSpPr>
-        <p:spPr>
-          <a:xfrm>
-            <a:off x="8211312" y="4151376"/>
-            <a:ext cx="3291840" cy="274320"/>
-          </a:xfrm>
-          <a:prstGeom prst="rect">
-            <a:avLst/>
-          </a:prstGeom>
-          <a:noFill/>
-          <a:ln/>
-        </p:spPr>
-        <p:txBody>
-          <a:bodyPr wrap="square" lIns="0" tIns="0" rIns="0" bIns="0" rtlCol="0" anchor="ctr"/>
-          <a:lstStyle/>
-          <a:p>
-            <a:pPr indent="0" marL="0">
-              <a:buNone/>
-            </a:pPr>
-            <a:r>
-              <a:rPr lang="en-US" sz="1100" b="1" dirty="0">
-                <a:solidFill>
-                  <a:srgbClr val="0B1220"/>
-                </a:solidFill>
-                <a:latin typeface="맑은 고딕" pitchFamily="34" charset="0"/>
-                <a:ea typeface="맑은 고딕" pitchFamily="34" charset="-122"/>
-                <a:cs typeface="맑은 고딕" pitchFamily="34" charset="-120"/>
-              </a:rPr>
-              <a:t>B-Flower Necklace (Size: 2 Size)</a:t>
-            </a:r>
-            <a:endParaRPr lang="en-US" sz="1100" dirty="0"/>
-          </a:p>
-        </p:txBody>
-      </p:sp>
-      <p:sp>
-        <p:nvSpPr>
-          <p:cNvPr id="32" name="Text 29"/>
-          <p:cNvSpPr/>
-          <p:nvPr/>
-        </p:nvSpPr>
-        <p:spPr>
-          <a:xfrm>
-            <a:off x="8211312" y="4425696"/>
-            <a:ext cx="3291840" cy="256032"/>
-          </a:xfrm>
-          <a:prstGeom prst="rect">
-            <a:avLst/>
-          </a:prstGeom>
-          <a:noFill/>
-          <a:ln/>
-        </p:spPr>
-        <p:txBody>
-          <a:bodyPr wrap="square" lIns="0" tIns="0" rIns="0" bIns="0" rtlCol="0" anchor="ctr"/>
-          <a:lstStyle/>
-          <a:p>
-            <a:pPr indent="0" marL="0">
-              <a:buNone/>
-            </a:pPr>
-            <a:r>
-              <a:rPr lang="en-US" sz="1000" dirty="0">
-                <a:solidFill>
-                  <a:srgbClr val="6B7280"/>
-                </a:solidFill>
-                <a:latin typeface="맑은 고딕" pitchFamily="34" charset="0"/>
-                <a:ea typeface="맑은 고딕" pitchFamily="34" charset="-122"/>
-                <a:cs typeface="맑은 고딕" pitchFamily="34" charset="-120"/>
-              </a:rPr>
-              <a:t>Necklace  ·  재고 3개</a:t>
-            </a:r>
-            <a:pPr indent="0" marL="0">
-              <a:buNone/>
-            </a:pPr>
-            <a:r>
-              <a:rPr lang="en-US" sz="1000" b="1" dirty="0">
-                <a:solidFill>
-                  <a:srgbClr val="D72638"/>
-                </a:solidFill>
-                <a:latin typeface="맑은 고딕" pitchFamily="34" charset="0"/>
-                <a:ea typeface="맑은 고딕" pitchFamily="34" charset="-122"/>
-                <a:cs typeface="맑은 고딕" pitchFamily="34" charset="-120"/>
-              </a:rPr>
-              <a:t/>
-            </a:r>
-            <a:endParaRPr lang="en-US" sz="1000" dirty="0"/>
-          </a:p>
-        </p:txBody>
-      </p:sp>
-      <p:sp>
-        <p:nvSpPr>
           <p:cNvPr id="33" name="Shape 30"/>
           <p:cNvSpPr/>
           <p:nvPr/>
@@ -8175,7 +8175,7 @@
                 <a:ea typeface="맑은 고딕" pitchFamily="34" charset="-122"/>
                 <a:cs typeface="맑은 고딕" pitchFamily="34" charset="-120"/>
               </a:rPr>
-              <a:t>8-Ball Smart Tok</a:t>
+              <a:t>Two-ball Bangle</a:t>
             </a:r>
             <a:endParaRPr lang="en-US" sz="1100" dirty="0"/>
           </a:p>
@@ -8214,7 +8214,7 @@
                 <a:ea typeface="맑은 고딕" pitchFamily="34" charset="-122"/>
                 <a:cs typeface="맑은 고딕" pitchFamily="34" charset="-120"/>
               </a:rPr>
-              <a:t>★Season off★  ·  재고 5개</a:t>
+              <a:t>Bracelet  ·  재고 0개</a:t>
             </a:r>
             <a:pPr indent="0" marL="0">
               <a:buNone/>
@@ -8267,7 +8267,7 @@
                 <a:ea typeface="맑은 고딕" pitchFamily="34" charset="-122"/>
                 <a:cs typeface="맑은 고딕" pitchFamily="34" charset="-120"/>
               </a:rPr>
-              <a:t>베스트 상품 리포트  ·  생성 2026-05-21 08:00</a:t>
+              <a:t>베스트 상품 리포트  ·  생성 2026-05-22 08:00</a:t>
             </a:r>
             <a:endParaRPr lang="en-US" sz="900" dirty="0"/>
           </a:p>
@@ -8480,7 +8480,7 @@
                 <a:ea typeface="맑은 고딕" pitchFamily="34" charset="-122"/>
                 <a:cs typeface="맑은 고딕" pitchFamily="34" charset="-120"/>
               </a:rPr>
-              <a:t>2026년 05월 21일 (목)</a:t>
+              <a:t>2026년 05월 22일 (금)</a:t>
             </a:r>
             <a:endParaRPr lang="en-US" sz="1200" dirty="0"/>
           </a:p>
@@ -8647,7 +8647,7 @@
                 <a:ea typeface="맑은 고딕" pitchFamily="34" charset="-122"/>
                 <a:cs typeface="맑은 고딕" pitchFamily="34" charset="-120"/>
               </a:rPr>
-              <a:t>133 개</a:t>
+              <a:t>105 개</a:t>
             </a:r>
             <a:endParaRPr lang="en-US" sz="3600" dirty="0"/>
           </a:p>
@@ -8853,7 +8853,7 @@
                 <a:ea typeface="맑은 고딕" pitchFamily="34" charset="-122"/>
                 <a:cs typeface="맑은 고딕" pitchFamily="34" charset="-120"/>
               </a:rPr>
-              <a:t>33</a:t>
+              <a:t>29</a:t>
             </a:r>
             <a:endParaRPr lang="en-US" sz="4400" dirty="0"/>
           </a:p>
@@ -9452,7 +9452,7 @@
                           <a:ea typeface="맑은 고딕" pitchFamily="34" charset="-122"/>
                           <a:cs typeface="맑은 고딕" pitchFamily="34" charset="-120"/>
                         </a:rPr>
-                        <a:t>33 개</a:t>
+                        <a:t>29 개</a:t>
                       </a:r>
                       <a:endParaRPr lang="en-US" sz="1400" dirty="0">
                         <a:latin typeface="맑은 고딕" charset="0"/>
@@ -9584,7 +9584,7 @@
                           <a:ea typeface="맑은 고딕" pitchFamily="34" charset="-122"/>
                           <a:cs typeface="맑은 고딕" pitchFamily="34" charset="-120"/>
                         </a:rPr>
-                        <a:t>Ring</a:t>
+                        <a:t>Necklace</a:t>
                       </a:r>
                       <a:endParaRPr lang="en-US" sz="1000" dirty="0">
                         <a:latin typeface="맑은 고딕" charset="0"/>
@@ -9649,7 +9649,7 @@
                           <a:ea typeface="맑은 고딕" pitchFamily="34" charset="-122"/>
                           <a:cs typeface="맑은 고딕" pitchFamily="34" charset="-120"/>
                         </a:rPr>
-                        <a:t>"4s" 925 Open Ring (사이즈: 남성)</a:t>
+                        <a:t>CandyPOP Necklace (사이즈: 2size (47~52cm))</a:t>
                       </a:r>
                       <a:endParaRPr lang="en-US" sz="1100" dirty="0">
                         <a:latin typeface="맑은 고딕" charset="0"/>
@@ -9714,7 +9714,7 @@
                           <a:ea typeface="맑은 고딕" pitchFamily="34" charset="-122"/>
                           <a:cs typeface="맑은 고딕" pitchFamily="34" charset="-120"/>
                         </a:rPr>
-                        <a:t>28 개</a:t>
+                        <a:t>24 개</a:t>
                       </a:r>
                       <a:endParaRPr lang="en-US" sz="1200" dirty="0">
                         <a:latin typeface="맑은 고딕" charset="0"/>
@@ -9911,7 +9911,7 @@
                           <a:ea typeface="맑은 고딕" pitchFamily="34" charset="-122"/>
                           <a:cs typeface="맑은 고딕" pitchFamily="34" charset="-120"/>
                         </a:rPr>
-                        <a:t>CandyPOP Necklace (사이즈: 2size (47~52cm))</a:t>
+                        <a:t>ThreadDuo Necklace</a:t>
                       </a:r>
                       <a:endParaRPr lang="en-US" sz="1100" dirty="0">
                         <a:latin typeface="맑은 고딕" charset="0"/>
@@ -9976,7 +9976,7 @@
                           <a:ea typeface="맑은 고딕" pitchFamily="34" charset="-122"/>
                           <a:cs typeface="맑은 고딕" pitchFamily="34" charset="-120"/>
                         </a:rPr>
-                        <a:t>23 개</a:t>
+                        <a:t>10 개</a:t>
                       </a:r>
                       <a:endParaRPr lang="en-US" sz="1200" dirty="0">
                         <a:latin typeface="맑은 고딕" charset="0"/>
@@ -10062,7 +10062,7 @@
                 <a:ea typeface="맑은 고딕" pitchFamily="34" charset="-122"/>
                 <a:cs typeface="맑은 고딕" pitchFamily="34" charset="-120"/>
               </a:rPr>
-              <a:t>리오더 필요  🔴 긴급 20건</a:t>
+              <a:t>리오더 필요  🔴 긴급 19건</a:t>
             </a:r>
             <a:endParaRPr lang="en-US" sz="1500" dirty="0"/>
           </a:p>
@@ -10126,7 +10126,7 @@
                 <a:ea typeface="맑은 고딕" pitchFamily="34" charset="-122"/>
                 <a:cs typeface="맑은 고딕" pitchFamily="34" charset="-120"/>
               </a:rPr>
-              <a:t>🔴 긴급 20건  ·  상세는 시트 확인</a:t>
+              <a:t>🔴 긴급 19건  ·  상세는 시트 확인</a:t>
             </a:r>
             <a:endParaRPr lang="en-US" sz="1400" dirty="0"/>
           </a:p>
@@ -10165,7 +10165,7 @@
                 <a:ea typeface="맑은 고딕" pitchFamily="34" charset="-122"/>
                 <a:cs typeface="맑은 고딕" pitchFamily="34" charset="-120"/>
               </a:rPr>
-              <a:t>베스트 상품 리포트  ·  생성 2026-05-21 08:00</a:t>
+              <a:t>베스트 상품 리포트  ·  생성 2026-05-22 08:00</a:t>
             </a:r>
             <a:endParaRPr lang="en-US" sz="900" dirty="0"/>
           </a:p>
@@ -10378,7 +10378,7 @@
                 <a:ea typeface="맑은 고딕" pitchFamily="34" charset="-122"/>
                 <a:cs typeface="맑은 고딕" pitchFamily="34" charset="-120"/>
               </a:rPr>
-              <a:t>2026년 05월 21일 (목)</a:t>
+              <a:t>2026년 05월 22일 (금)</a:t>
             </a:r>
             <a:endParaRPr lang="en-US" sz="1200" dirty="0"/>
           </a:p>
@@ -10929,7 +10929,7 @@
                 <a:ea typeface="맑은 고딕" pitchFamily="34" charset="-122"/>
                 <a:cs typeface="맑은 고딕" pitchFamily="34" charset="-120"/>
               </a:rPr>
-              <a:t>32,526</a:t>
+              <a:t>31,973</a:t>
             </a:r>
             <a:endParaRPr lang="en-US" sz="3000" dirty="0"/>
           </a:p>
@@ -11489,7 +11489,7 @@
                           <a:ea typeface="맑은 고딕" pitchFamily="34" charset="-122"/>
                           <a:cs typeface="맑은 고딕" pitchFamily="34" charset="-120"/>
                         </a:rPr>
-                        <a:t>2,101</a:t>
+                        <a:t>2,097</a:t>
                       </a:r>
                       <a:endParaRPr lang="en-US" sz="1000" dirty="0">
                         <a:latin typeface="맑은 고딕" charset="0"/>
@@ -11751,7 +11751,7 @@
                           <a:ea typeface="맑은 고딕" pitchFamily="34" charset="-122"/>
                           <a:cs typeface="맑은 고딕" pitchFamily="34" charset="-120"/>
                         </a:rPr>
-                        <a:t>1,640</a:t>
+                        <a:t>1,632</a:t>
                       </a:r>
                       <a:endParaRPr lang="en-US" sz="1000" dirty="0">
                         <a:latin typeface="맑은 고딕" charset="0"/>
@@ -12013,7 +12013,7 @@
                           <a:ea typeface="맑은 고딕" pitchFamily="34" charset="-122"/>
                           <a:cs typeface="맑은 고딕" pitchFamily="34" charset="-120"/>
                         </a:rPr>
-                        <a:t>1,616</a:t>
+                        <a:t>1,539</a:t>
                       </a:r>
                       <a:endParaRPr lang="en-US" sz="1000" dirty="0">
                         <a:latin typeface="맑은 고딕" charset="0"/>
@@ -12275,7 +12275,7 @@
                           <a:ea typeface="맑은 고딕" pitchFamily="34" charset="-122"/>
                           <a:cs typeface="맑은 고딕" pitchFamily="34" charset="-120"/>
                         </a:rPr>
-                        <a:t>1,610</a:t>
+                        <a:t>1,458</a:t>
                       </a:r>
                       <a:endParaRPr lang="en-US" sz="1000" dirty="0">
                         <a:latin typeface="맑은 고딕" charset="0"/>
@@ -12537,7 +12537,7 @@
                           <a:ea typeface="맑은 고딕" pitchFamily="34" charset="-122"/>
                           <a:cs typeface="맑은 고딕" pitchFamily="34" charset="-120"/>
                         </a:rPr>
-                        <a:t>1,153</a:t>
+                        <a:t>1,031</a:t>
                       </a:r>
                       <a:endParaRPr lang="en-US" sz="1000" dirty="0">
                         <a:latin typeface="맑은 고딕" charset="0"/>
@@ -13556,7 +13556,7 @@
                 <a:ea typeface="맑은 고딕" pitchFamily="34" charset="-122"/>
                 <a:cs typeface="맑은 고딕" pitchFamily="34" charset="-120"/>
               </a:rPr>
-              <a:t>베스트 상품 리포트  ·  생성 2026-05-21 08:00</a:t>
+              <a:t>베스트 상품 리포트  ·  생성 2026-05-22 08:00</a:t>
             </a:r>
             <a:endParaRPr lang="en-US" sz="900" dirty="0"/>
           </a:p>
@@ -13769,7 +13769,7 @@
                 <a:ea typeface="맑은 고딕" pitchFamily="34" charset="-122"/>
                 <a:cs typeface="맑은 고딕" pitchFamily="34" charset="-120"/>
               </a:rPr>
-              <a:t>2026년 05월 21일 (목)</a:t>
+              <a:t>2026년 05월 22일 (금)</a:t>
             </a:r>
             <a:endParaRPr lang="en-US" sz="1200" dirty="0"/>
           </a:p>
@@ -13897,7 +13897,7 @@
                 <a:ea typeface="맑은 고딕" pitchFamily="34" charset="-122"/>
                 <a:cs typeface="맑은 고딕" pitchFamily="34" charset="-120"/>
               </a:rPr>
-              <a:t>🚨  긴급 리오더 70건    ·    주의 리오더 13건    ·    오늘 발주 검토 필수</a:t>
+              <a:t>🚨  긴급 리오더 68건    ·    주의 리오더 11건    ·    오늘 발주 검토 필수</a:t>
             </a:r>
             <a:pPr indent="0" marL="0">
               <a:buNone/>
@@ -14663,7 +14663,7 @@
                           <a:ea typeface="맑은 고딕" pitchFamily="34" charset="-122"/>
                           <a:cs typeface="맑은 고딕" pitchFamily="34" charset="-120"/>
                         </a:rPr>
-                        <a:t>180° Fast Charging Cable (8color) (컬러: 네온핑크 / 기종 옵션: C type -&gt; C type)</a:t>
+                        <a:t>Jacquard Fast Charging Cable (7color) (컬러: 블루 / 기종옵션: C-Apple 8pin / 길이: 2m)</a:t>
                       </a:r>
                       <a:endParaRPr lang="en-US" sz="1100" dirty="0">
                         <a:latin typeface="맑은 고딕" charset="0"/>
@@ -14731,7 +14731,7 @@
                           <a:ea typeface="맑은 고딕" pitchFamily="34" charset="-122"/>
                           <a:cs typeface="맑은 고딕" pitchFamily="34" charset="-120"/>
                         </a:rPr>
-                        <a:t>0</a:t>
+                        <a:t>20</a:t>
                       </a:r>
                       <a:endParaRPr lang="en-US" sz="1100" dirty="0">
                         <a:latin typeface="맑은 고딕" charset="0"/>
@@ -14799,7 +14799,7 @@
                           <a:ea typeface="맑은 고딕" pitchFamily="34" charset="-122"/>
                           <a:cs typeface="맑은 고딕" pitchFamily="34" charset="-120"/>
                         </a:rPr>
-                        <a:t>244 개</a:t>
+                        <a:t>4 개</a:t>
                       </a:r>
                       <a:endParaRPr lang="en-US" sz="1100" dirty="0">
                         <a:latin typeface="맑은 고딕" charset="0"/>
@@ -14937,7 +14937,7 @@
                           <a:ea typeface="맑은 고딕" pitchFamily="34" charset="-122"/>
                           <a:cs typeface="맑은 고딕" pitchFamily="34" charset="-120"/>
                         </a:rPr>
-                        <a:t>6A</a:t>
+                        <a:t>PR</a:t>
                       </a:r>
                       <a:endParaRPr lang="en-US" sz="1100" dirty="0">
                         <a:latin typeface="맑은 고딕" charset="0"/>
@@ -15005,7 +15005,7 @@
                           <a:ea typeface="맑은 고딕" pitchFamily="34" charset="-122"/>
                           <a:cs typeface="맑은 고딕" pitchFamily="34" charset="-120"/>
                         </a:rPr>
-                        <a:t>Necklace</a:t>
+                        <a:t>ETC</a:t>
                       </a:r>
                       <a:endParaRPr lang="en-US" sz="1000" dirty="0">
                         <a:latin typeface="맑은 고딕" charset="0"/>
@@ -15073,7 +15073,7 @@
                           <a:ea typeface="맑은 고딕" pitchFamily="34" charset="-122"/>
                           <a:cs typeface="맑은 고딕" pitchFamily="34" charset="-120"/>
                         </a:rPr>
-                        <a:t>Safety Pin Necklace</a:t>
+                        <a:t>Padded Color Pouch (4color) (컬러: 오렌지)</a:t>
                       </a:r>
                       <a:endParaRPr lang="en-US" sz="1100" dirty="0">
                         <a:latin typeface="맑은 고딕" charset="0"/>
@@ -15141,7 +15141,7 @@
                           <a:ea typeface="맑은 고딕" pitchFamily="34" charset="-122"/>
                           <a:cs typeface="맑은 고딕" pitchFamily="34" charset="-120"/>
                         </a:rPr>
-                        <a:t>2</a:t>
+                        <a:t>16</a:t>
                       </a:r>
                       <a:endParaRPr lang="en-US" sz="1100" dirty="0">
                         <a:latin typeface="맑은 고딕" charset="0"/>
@@ -15483,7 +15483,7 @@
                           <a:ea typeface="맑은 고딕" pitchFamily="34" charset="-122"/>
                           <a:cs typeface="맑은 고딕" pitchFamily="34" charset="-120"/>
                         </a:rPr>
-                        <a:t>"Crackave" 925 Open Ring</a:t>
+                        <a:t>"Linkrace" 925 Open Ring</a:t>
                       </a:r>
                       <a:endParaRPr lang="en-US" sz="1100" dirty="0">
                         <a:latin typeface="맑은 고딕" charset="0"/>
@@ -15551,7 +15551,7 @@
                           <a:ea typeface="맑은 고딕" pitchFamily="34" charset="-122"/>
                           <a:cs typeface="맑은 고딕" pitchFamily="34" charset="-120"/>
                         </a:rPr>
-                        <a:t>5</a:t>
+                        <a:t>4</a:t>
                       </a:r>
                       <a:endParaRPr lang="en-US" sz="1100" dirty="0">
                         <a:latin typeface="맑은 고딕" charset="0"/>
@@ -15619,7 +15619,7 @@
                           <a:ea typeface="맑은 고딕" pitchFamily="34" charset="-122"/>
                           <a:cs typeface="맑은 고딕" pitchFamily="34" charset="-120"/>
                         </a:rPr>
-                        <a:t>3 개</a:t>
+                        <a:t>2 개</a:t>
                       </a:r>
                       <a:endParaRPr lang="en-US" sz="1100" dirty="0">
                         <a:latin typeface="맑은 고딕" charset="0"/>
@@ -15757,7 +15757,7 @@
                           <a:ea typeface="맑은 고딕" pitchFamily="34" charset="-122"/>
                           <a:cs typeface="맑은 고딕" pitchFamily="34" charset="-120"/>
                         </a:rPr>
-                        <a:t>PR</a:t>
+                        <a:t>6A</a:t>
                       </a:r>
                       <a:endParaRPr lang="en-US" sz="1100" dirty="0">
                         <a:latin typeface="맑은 고딕" charset="0"/>
@@ -15825,7 +15825,7 @@
                           <a:ea typeface="맑은 고딕" pitchFamily="34" charset="-122"/>
                           <a:cs typeface="맑은 고딕" pitchFamily="34" charset="-120"/>
                         </a:rPr>
-                        <a:t>★ Last Sale ★</a:t>
+                        <a:t>★Season off★</a:t>
                       </a:r>
                       <a:endParaRPr lang="en-US" sz="1000" dirty="0">
                         <a:latin typeface="맑은 고딕" charset="0"/>
@@ -15893,7 +15893,7 @@
                           <a:ea typeface="맑은 고딕" pitchFamily="34" charset="-122"/>
                           <a:cs typeface="맑은 고딕" pitchFamily="34" charset="-120"/>
                         </a:rPr>
-                        <a:t>Cloud Grip Glass Mini Brush (3color) (컬러: 스카이블루)</a:t>
+                        <a:t>8-Ball Smart Tok</a:t>
                       </a:r>
                       <a:endParaRPr lang="en-US" sz="1100" dirty="0">
                         <a:latin typeface="맑은 고딕" charset="0"/>
@@ -15961,7 +15961,7 @@
                           <a:ea typeface="맑은 고딕" pitchFamily="34" charset="-122"/>
                           <a:cs typeface="맑은 고딕" pitchFamily="34" charset="-120"/>
                         </a:rPr>
-                        <a:t>16</a:t>
+                        <a:t>4</a:t>
                       </a:r>
                       <a:endParaRPr lang="en-US" sz="1100" dirty="0">
                         <a:latin typeface="맑은 고딕" charset="0"/>
@@ -16029,7 +16029,7 @@
                           <a:ea typeface="맑은 고딕" pitchFamily="34" charset="-122"/>
                           <a:cs typeface="맑은 고딕" pitchFamily="34" charset="-120"/>
                         </a:rPr>
-                        <a:t>3 개</a:t>
+                        <a:t>1 개</a:t>
                       </a:r>
                       <a:endParaRPr lang="en-US" sz="1100" dirty="0">
                         <a:latin typeface="맑은 고딕" charset="0"/>
@@ -16371,7 +16371,7 @@
                           <a:ea typeface="맑은 고딕" pitchFamily="34" charset="-122"/>
                           <a:cs typeface="맑은 고딕" pitchFamily="34" charset="-120"/>
                         </a:rPr>
-                        <a:t>3</a:t>
+                        <a:t>2</a:t>
                       </a:r>
                       <a:endParaRPr lang="en-US" sz="1100" dirty="0">
                         <a:latin typeface="맑은 고딕" charset="0"/>
@@ -16439,7 +16439,7 @@
                           <a:ea typeface="맑은 고딕" pitchFamily="34" charset="-122"/>
                           <a:cs typeface="맑은 고딕" pitchFamily="34" charset="-120"/>
                         </a:rPr>
-                        <a:t>2 개</a:t>
+                        <a:t>1 개</a:t>
                       </a:r>
                       <a:endParaRPr lang="en-US" sz="1100" dirty="0">
                         <a:latin typeface="맑은 고딕" charset="0"/>
@@ -16577,7 +16577,7 @@
                           <a:ea typeface="맑은 고딕" pitchFamily="34" charset="-122"/>
                           <a:cs typeface="맑은 고딕" pitchFamily="34" charset="-120"/>
                         </a:rPr>
-                        <a:t>PR</a:t>
+                        <a:t>CT</a:t>
                       </a:r>
                       <a:endParaRPr lang="en-US" sz="1100" dirty="0">
                         <a:latin typeface="맑은 고딕" charset="0"/>
@@ -16645,7 +16645,7 @@
                           <a:ea typeface="맑은 고딕" pitchFamily="34" charset="-122"/>
                           <a:cs typeface="맑은 고딕" pitchFamily="34" charset="-120"/>
                         </a:rPr>
-                        <a:t>ETC</a:t>
+                        <a:t>Ring</a:t>
                       </a:r>
                       <a:endParaRPr lang="en-US" sz="1000" dirty="0">
                         <a:latin typeface="맑은 고딕" charset="0"/>
@@ -16713,7 +16713,7 @@
                           <a:ea typeface="맑은 고딕" pitchFamily="34" charset="-122"/>
                           <a:cs typeface="맑은 고딕" pitchFamily="34" charset="-120"/>
                         </a:rPr>
-                        <a:t>Ball hanger (6color) (컬러: 아이보리)</a:t>
+                        <a:t>"Mlayer" 925 Open Ring</a:t>
                       </a:r>
                       <a:endParaRPr lang="en-US" sz="1100" dirty="0">
                         <a:latin typeface="맑은 고딕" charset="0"/>
@@ -16781,7 +16781,7 @@
                           <a:ea typeface="맑은 고딕" pitchFamily="34" charset="-122"/>
                           <a:cs typeface="맑은 고딕" pitchFamily="34" charset="-120"/>
                         </a:rPr>
-                        <a:t>8</a:t>
+                        <a:t>4</a:t>
                       </a:r>
                       <a:endParaRPr lang="en-US" sz="1100" dirty="0">
                         <a:latin typeface="맑은 고딕" charset="0"/>
@@ -16849,7 +16849,7 @@
                           <a:ea typeface="맑은 고딕" pitchFamily="34" charset="-122"/>
                           <a:cs typeface="맑은 고딕" pitchFamily="34" charset="-120"/>
                         </a:rPr>
-                        <a:t>2 개</a:t>
+                        <a:t>1 개</a:t>
                       </a:r>
                       <a:endParaRPr lang="en-US" sz="1100" dirty="0">
                         <a:latin typeface="맑은 고딕" charset="0"/>
@@ -16987,7 +16987,7 @@
                           <a:ea typeface="맑은 고딕" pitchFamily="34" charset="-122"/>
                           <a:cs typeface="맑은 고딕" pitchFamily="34" charset="-120"/>
                         </a:rPr>
-                        <a:t>6A</a:t>
+                        <a:t>CT</a:t>
                       </a:r>
                       <a:endParaRPr lang="en-US" sz="1100" dirty="0">
                         <a:latin typeface="맑은 고딕" charset="0"/>
@@ -17055,7 +17055,7 @@
                           <a:ea typeface="맑은 고딕" pitchFamily="34" charset="-122"/>
                           <a:cs typeface="맑은 고딕" pitchFamily="34" charset="-120"/>
                         </a:rPr>
-                        <a:t>Necklace</a:t>
+                        <a:t>Ring</a:t>
                       </a:r>
                       <a:endParaRPr lang="en-US" sz="1000" dirty="0">
                         <a:latin typeface="맑은 고딕" charset="0"/>
@@ -17123,7 +17123,7 @@
                           <a:ea typeface="맑은 고딕" pitchFamily="34" charset="-122"/>
                           <a:cs typeface="맑은 고딕" pitchFamily="34" charset="-120"/>
                         </a:rPr>
-                        <a:t>Chainlink Necklace</a:t>
+                        <a:t>"Giethoorn" 925 Open Ring</a:t>
                       </a:r>
                       <a:endParaRPr lang="en-US" sz="1100" dirty="0">
                         <a:latin typeface="맑은 고딕" charset="0"/>
@@ -17191,7 +17191,7 @@
                           <a:ea typeface="맑은 고딕" pitchFamily="34" charset="-122"/>
                           <a:cs typeface="맑은 고딕" pitchFamily="34" charset="-120"/>
                         </a:rPr>
-                        <a:t>2</a:t>
+                        <a:t>0</a:t>
                       </a:r>
                       <a:endParaRPr lang="en-US" sz="1100" dirty="0">
                         <a:latin typeface="맑은 고딕" charset="0"/>
@@ -17397,7 +17397,7 @@
                           <a:ea typeface="맑은 고딕" pitchFamily="34" charset="-122"/>
                           <a:cs typeface="맑은 고딕" pitchFamily="34" charset="-120"/>
                         </a:rPr>
-                        <a:t>CT</a:t>
+                        <a:t>PR</a:t>
                       </a:r>
                       <a:endParaRPr lang="en-US" sz="1100" dirty="0">
                         <a:latin typeface="맑은 고딕" charset="0"/>
@@ -17465,7 +17465,7 @@
                           <a:ea typeface="맑은 고딕" pitchFamily="34" charset="-122"/>
                           <a:cs typeface="맑은 고딕" pitchFamily="34" charset="-120"/>
                         </a:rPr>
-                        <a:t>Ring</a:t>
+                        <a:t>ETC</a:t>
                       </a:r>
                       <a:endParaRPr lang="en-US" sz="1000" dirty="0">
                         <a:latin typeface="맑은 고딕" charset="0"/>
@@ -17533,7 +17533,7 @@
                           <a:ea typeface="맑은 고딕" pitchFamily="34" charset="-122"/>
                           <a:cs typeface="맑은 고딕" pitchFamily="34" charset="-120"/>
                         </a:rPr>
-                        <a:t>"Mlayer" 925 Open Ring</a:t>
+                        <a:t>360° Rotating Phone Holder (컬러: 화이트)</a:t>
                       </a:r>
                       <a:endParaRPr lang="en-US" sz="1100" dirty="0">
                         <a:latin typeface="맑은 고딕" charset="0"/>
@@ -17601,7 +17601,7 @@
                           <a:ea typeface="맑은 고딕" pitchFamily="34" charset="-122"/>
                           <a:cs typeface="맑은 고딕" pitchFamily="34" charset="-120"/>
                         </a:rPr>
-                        <a:t>5</a:t>
+                        <a:t>14</a:t>
                       </a:r>
                       <a:endParaRPr lang="en-US" sz="1100" dirty="0">
                         <a:latin typeface="맑은 고딕" charset="0"/>
@@ -18011,7 +18011,7 @@
                           <a:ea typeface="맑은 고딕" pitchFamily="34" charset="-122"/>
                           <a:cs typeface="맑은 고딕" pitchFamily="34" charset="-120"/>
                         </a:rPr>
-                        <a:t>12</a:t>
+                        <a:t>11</a:t>
                       </a:r>
                       <a:endParaRPr lang="en-US" sz="1100" dirty="0">
                         <a:latin typeface="맑은 고딕" charset="0"/>
@@ -18168,7 +18168,7 @@
                 <a:ea typeface="맑은 고딕" pitchFamily="34" charset="-122"/>
                 <a:cs typeface="맑은 고딕" pitchFamily="34" charset="-120"/>
               </a:rPr>
-              <a:t>외 61건 더 있음 — 상세는 시트에서 확인</a:t>
+              <a:t>외 59건 더 있음 — 상세는 시트에서 확인</a:t>
             </a:r>
             <a:endParaRPr lang="en-US" sz="1000" dirty="0"/>
           </a:p>
@@ -18207,7 +18207,7 @@
                 <a:ea typeface="맑은 고딕" pitchFamily="34" charset="-122"/>
                 <a:cs typeface="맑은 고딕" pitchFamily="34" charset="-120"/>
               </a:rPr>
-              <a:t>베스트 상품 리포트  ·  생성 2026-05-21 08:00</a:t>
+              <a:t>베스트 상품 리포트  ·  생성 2026-05-22 08:00</a:t>
             </a:r>
             <a:endParaRPr lang="en-US" sz="900" dirty="0"/>
           </a:p>
@@ -18420,7 +18420,7 @@
                 <a:ea typeface="맑은 고딕" pitchFamily="34" charset="-122"/>
                 <a:cs typeface="맑은 고딕" pitchFamily="34" charset="-120"/>
               </a:rPr>
-              <a:t>2026년 05월 21일 (목)</a:t>
+              <a:t>2026년 05월 22일 (금)</a:t>
             </a:r>
             <a:endParaRPr lang="en-US" sz="1200" dirty="0"/>
           </a:p>
@@ -18587,7 +18587,7 @@
                 <a:ea typeface="맑은 고딕" pitchFamily="34" charset="-122"/>
                 <a:cs typeface="맑은 고딕" pitchFamily="34" charset="-120"/>
               </a:rPr>
-              <a:t>Google Sheet '브랜드 재고현황'  ·  최신화 2026-05-21 08:00</a:t>
+              <a:t>Google Sheet '브랜드 재고현황'  ·  최신화 2026-05-22 08:00</a:t>
             </a:r>
             <a:endParaRPr lang="en-US" sz="1100" dirty="0"/>
           </a:p>
@@ -19099,7 +19099,7 @@
                 <a:ea typeface="맑은 고딕" pitchFamily="34" charset="-122"/>
                 <a:cs typeface="맑은 고딕" pitchFamily="34" charset="-120"/>
               </a:rPr>
-              <a:t>✅ 6A 86 SKU  /  ✅ Cleartype 59 SKU  /  ✅ Produktepr 192 SKU (판매 수집됨)</a:t>
+              <a:t>✅ 6A 84 SKU  /  ✅ Cleartype 59 SKU  /  ✅ Produktepr 192 SKU (판매 수집됨)</a:t>
             </a:r>
             <a:endParaRPr lang="en-US" sz="1100" dirty="0"/>
           </a:p>
@@ -19230,7 +19230,7 @@
                 <a:ea typeface="맑은 고딕" pitchFamily="34" charset="-122"/>
                 <a:cs typeface="맑은 고딕" pitchFamily="34" charset="-120"/>
               </a:rPr>
-              <a:t>✅ 3개 브랜드 모두 정상 추출  ·  24h 출고 기준 (2026-05-20 08:00 → 2026-05-21 08:00) · 신규 SKU 12건은 결제완료 기준</a:t>
+              <a:t>✅ 3개 브랜드 모두 정상 추출  ·  24h 출고 기준 (2026-05-21 08:00 → 2026-05-22 08:00) · 신규 SKU 12건은 결제완료 기준</a:t>
             </a:r>
             <a:endParaRPr lang="en-US" sz="1000" dirty="0"/>
           </a:p>
@@ -19269,7 +19269,7 @@
                 <a:ea typeface="맑은 고딕" pitchFamily="34" charset="-122"/>
                 <a:cs typeface="맑은 고딕" pitchFamily="34" charset="-120"/>
               </a:rPr>
-              <a:t>베스트 상품 리포트  ·  생성 2026-05-21 08:00</a:t>
+              <a:t>베스트 상품 리포트  ·  생성 2026-05-22 08:00</a:t>
             </a:r>
             <a:endParaRPr lang="en-US" sz="900" dirty="0"/>
           </a:p>

</xml_diff>

<commit_message>
chore: 매출 PPT 업로드 (best-sellers-2026-05-23.pptx) [auto]
</commit_message>
<xml_diff>
--- a/data/sales-report.pptx
+++ b/data/sales-report.pptx
@@ -1648,7 +1648,7 @@
                 <a:ea typeface="맑은 고딕" pitchFamily="34" charset="-122"/>
                 <a:cs typeface="맑은 고딕" pitchFamily="34" charset="-120"/>
               </a:rPr>
-              <a:t>2026년 05월 22일 (금)  ·  24h 출고 기준</a:t>
+              <a:t>2026년 05월 23일 (토)  ·  24h 출고 기준</a:t>
             </a:r>
             <a:endParaRPr lang="en-US" sz="2200" dirty="0"/>
           </a:p>
@@ -1726,7 +1726,7 @@
                 <a:ea typeface="맑은 고딕" pitchFamily="34" charset="-122"/>
                 <a:cs typeface="맑은 고딕" pitchFamily="34" charset="-120"/>
               </a:rPr>
-              <a:t>05.22</a:t>
+              <a:t>05.23</a:t>
             </a:r>
             <a:endParaRPr lang="en-US" sz="7200" dirty="0"/>
           </a:p>
@@ -1765,7 +1765,7 @@
                 <a:ea typeface="맑은 고딕" pitchFamily="34" charset="-122"/>
                 <a:cs typeface="맑은 고딕" pitchFamily="34" charset="-120"/>
               </a:rPr>
-              <a:t>금요일</a:t>
+              <a:t>토요일</a:t>
             </a:r>
             <a:endParaRPr lang="en-US" sz="1400" dirty="0"/>
           </a:p>
@@ -1804,7 +1804,7 @@
                 <a:ea typeface="맑은 고딕" pitchFamily="34" charset="-122"/>
                 <a:cs typeface="맑은 고딕" pitchFamily="34" charset="-120"/>
               </a:rPr>
-              <a:t>생성 2026-05-22 08:00  ·  Google Sheet 자동 동기</a:t>
+              <a:t>생성 2026-05-23 08:00  ·  Google Sheet 자동 동기</a:t>
             </a:r>
             <a:endParaRPr lang="en-US" sz="1000" dirty="0"/>
           </a:p>
@@ -1978,7 +1978,7 @@
                 <a:ea typeface="맑은 고딕" pitchFamily="34" charset="-122"/>
                 <a:cs typeface="맑은 고딕" pitchFamily="34" charset="-120"/>
               </a:rPr>
-              <a:t>2026년 05월 22일 (금)</a:t>
+              <a:t>2026년 05월 23일 (토)</a:t>
             </a:r>
             <a:endParaRPr lang="en-US" sz="1200" dirty="0"/>
           </a:p>
@@ -2145,7 +2145,7 @@
                 <a:ea typeface="맑은 고딕" pitchFamily="34" charset="-122"/>
                 <a:cs typeface="맑은 고딕" pitchFamily="34" charset="-120"/>
               </a:rPr>
-              <a:t>372 개</a:t>
+              <a:t>294 개</a:t>
             </a:r>
             <a:endParaRPr lang="en-US" sz="3600" dirty="0"/>
           </a:p>
@@ -2312,7 +2312,7 @@
                 <a:ea typeface="맑은 고딕" pitchFamily="34" charset="-122"/>
                 <a:cs typeface="맑은 고딕" pitchFamily="34" charset="-120"/>
               </a:rPr>
-              <a:t>68 건</a:t>
+              <a:t>67 건</a:t>
             </a:r>
             <a:endParaRPr lang="en-US" sz="3200" dirty="0"/>
           </a:p>
@@ -2479,7 +2479,7 @@
                 <a:ea typeface="맑은 고딕" pitchFamily="34" charset="-122"/>
                 <a:cs typeface="맑은 고딕" pitchFamily="34" charset="-120"/>
               </a:rPr>
-              <a:t>11 건</a:t>
+              <a:t>9 건</a:t>
             </a:r>
             <a:endParaRPr lang="en-US" sz="3200" dirty="0"/>
           </a:p>
@@ -2685,7 +2685,7 @@
                 <a:ea typeface="맑은 고딕" pitchFamily="34" charset="-122"/>
                 <a:cs typeface="맑은 고딕" pitchFamily="34" charset="-120"/>
               </a:rPr>
-              <a:t>84 SKU  ·  판매 OK</a:t>
+              <a:t>86 SKU  ·  판매 OK</a:t>
             </a:r>
             <a:pPr indent="0" marL="0">
               <a:buNone/>
@@ -3677,7 +3677,7 @@
                           <a:ea typeface="맑은 고딕" pitchFamily="34" charset="-122"/>
                           <a:cs typeface="맑은 고딕" pitchFamily="34" charset="-120"/>
                         </a:rPr>
-                        <a:t>48 개</a:t>
+                        <a:t>36 개</a:t>
                       </a:r>
                       <a:endParaRPr lang="en-US" sz="1400" dirty="0">
                         <a:latin typeface="맑은 고딕" charset="0"/>
@@ -3809,7 +3809,7 @@
                           <a:ea typeface="맑은 고딕" pitchFamily="34" charset="-122"/>
                           <a:cs typeface="맑은 고딕" pitchFamily="34" charset="-120"/>
                         </a:rPr>
-                        <a:t>6A</a:t>
+                        <a:t>CT</a:t>
                       </a:r>
                       <a:endParaRPr lang="en-US" sz="1100" dirty="0">
                         <a:latin typeface="맑은 고딕" charset="0"/>
@@ -3874,7 +3874,7 @@
                           <a:ea typeface="맑은 고딕" pitchFamily="34" charset="-122"/>
                           <a:cs typeface="맑은 고딕" pitchFamily="34" charset="-120"/>
                         </a:rPr>
-                        <a:t>Ring</a:t>
+                        <a:t>Necklace</a:t>
                       </a:r>
                       <a:endParaRPr lang="en-US" sz="1000" dirty="0">
                         <a:latin typeface="맑은 고딕" charset="0"/>
@@ -3939,7 +3939,7 @@
                           <a:ea typeface="맑은 고딕" pitchFamily="34" charset="-122"/>
                           <a:cs typeface="맑은 고딕" pitchFamily="34" charset="-120"/>
                         </a:rPr>
-                        <a:t>[SILVER925] Guyeong Open Ring v3.0 (silver)</a:t>
+                        <a:t>CandyPOP Necklace (사이즈: 1size (37~43cm))</a:t>
                       </a:r>
                       <a:endParaRPr lang="en-US" sz="1100" dirty="0">
                         <a:latin typeface="맑은 고딕" charset="0"/>
@@ -4004,7 +4004,7 @@
                           <a:ea typeface="맑은 고딕" pitchFamily="34" charset="-122"/>
                           <a:cs typeface="맑은 고딕" pitchFamily="34" charset="-120"/>
                         </a:rPr>
-                        <a:t>40 개</a:t>
+                        <a:t>24 개</a:t>
                       </a:r>
                       <a:endParaRPr lang="en-US" sz="1400" dirty="0">
                         <a:latin typeface="맑은 고딕" charset="0"/>
@@ -4266,7 +4266,7 @@
                           <a:ea typeface="맑은 고딕" pitchFamily="34" charset="-122"/>
                           <a:cs typeface="맑은 고딕" pitchFamily="34" charset="-120"/>
                         </a:rPr>
-                        <a:t>CandyPOP Necklace (사이즈: 1size (37~43cm))</a:t>
+                        <a:t>CandyPOP Necklace (사이즈: 2size (47~52cm))</a:t>
                       </a:r>
                       <a:endParaRPr lang="en-US" sz="1100" dirty="0">
                         <a:latin typeface="맑은 고딕" charset="0"/>
@@ -4331,7 +4331,7 @@
                           <a:ea typeface="맑은 고딕" pitchFamily="34" charset="-122"/>
                           <a:cs typeface="맑은 고딕" pitchFamily="34" charset="-120"/>
                         </a:rPr>
-                        <a:t>29 개</a:t>
+                        <a:t>23 개</a:t>
                       </a:r>
                       <a:endParaRPr lang="en-US" sz="1400" dirty="0">
                         <a:latin typeface="맑은 고딕" charset="0"/>
@@ -4463,7 +4463,7 @@
                           <a:ea typeface="맑은 고딕" pitchFamily="34" charset="-122"/>
                           <a:cs typeface="맑은 고딕" pitchFamily="34" charset="-120"/>
                         </a:rPr>
-                        <a:t>CT</a:t>
+                        <a:t>6A</a:t>
                       </a:r>
                       <a:endParaRPr lang="en-US" sz="1100" dirty="0">
                         <a:latin typeface="맑은 고딕" charset="0"/>
@@ -4528,7 +4528,7 @@
                           <a:ea typeface="맑은 고딕" pitchFamily="34" charset="-122"/>
                           <a:cs typeface="맑은 고딕" pitchFamily="34" charset="-120"/>
                         </a:rPr>
-                        <a:t>Necklace</a:t>
+                        <a:t>Ring</a:t>
                       </a:r>
                       <a:endParaRPr lang="en-US" sz="1000" dirty="0">
                         <a:latin typeface="맑은 고딕" charset="0"/>
@@ -4593,7 +4593,7 @@
                           <a:ea typeface="맑은 고딕" pitchFamily="34" charset="-122"/>
                           <a:cs typeface="맑은 고딕" pitchFamily="34" charset="-120"/>
                         </a:rPr>
-                        <a:t>CandyPOP Necklace (사이즈: 2size (47~52cm))</a:t>
+                        <a:t>[SILVER925] Guyeong Open Ring v3.0 (silver)</a:t>
                       </a:r>
                       <a:endParaRPr lang="en-US" sz="1100" dirty="0">
                         <a:latin typeface="맑은 고딕" charset="0"/>
@@ -4658,7 +4658,7 @@
                           <a:ea typeface="맑은 고딕" pitchFamily="34" charset="-122"/>
                           <a:cs typeface="맑은 고딕" pitchFamily="34" charset="-120"/>
                         </a:rPr>
-                        <a:t>24 개</a:t>
+                        <a:t>22 개</a:t>
                       </a:r>
                       <a:endParaRPr lang="en-US" sz="1200" dirty="0">
                         <a:latin typeface="맑은 고딕" charset="0"/>
@@ -4920,7 +4920,7 @@
                           <a:ea typeface="맑은 고딕" pitchFamily="34" charset="-122"/>
                           <a:cs typeface="맑은 고딕" pitchFamily="34" charset="-120"/>
                         </a:rPr>
-                        <a:t>[SILVER925] Eramam Open Ring</a:t>
+                        <a:t>[SILVER925] Mustafakemalpaşa Ring (사이즈: 12호)</a:t>
                       </a:r>
                       <a:endParaRPr lang="en-US" sz="1100" dirty="0">
                         <a:latin typeface="맑은 고딕" charset="0"/>
@@ -4985,7 +4985,7 @@
                           <a:ea typeface="맑은 고딕" pitchFamily="34" charset="-122"/>
                           <a:cs typeface="맑은 고딕" pitchFamily="34" charset="-120"/>
                         </a:rPr>
-                        <a:t>13 개</a:t>
+                        <a:t>14 개</a:t>
                       </a:r>
                       <a:endParaRPr lang="en-US" sz="1200" dirty="0">
                         <a:latin typeface="맑은 고딕" charset="0"/>
@@ -5071,7 +5071,7 @@
                 <a:ea typeface="맑은 고딕" pitchFamily="34" charset="-122"/>
                 <a:cs typeface="맑은 고딕" pitchFamily="34" charset="-120"/>
               </a:rPr>
-              <a:t>베스트 상품 리포트  ·  생성 2026-05-22 08:00</a:t>
+              <a:t>베스트 상품 리포트  ·  생성 2026-05-23 08:00</a:t>
             </a:r>
             <a:endParaRPr lang="en-US" sz="900" dirty="0"/>
           </a:p>
@@ -5284,7 +5284,7 @@
                 <a:ea typeface="맑은 고딕" pitchFamily="34" charset="-122"/>
                 <a:cs typeface="맑은 고딕" pitchFamily="34" charset="-120"/>
               </a:rPr>
-              <a:t>2026년 05월 22일 (금)</a:t>
+              <a:t>2026년 05월 23일 (토)</a:t>
             </a:r>
             <a:endParaRPr lang="en-US" sz="1200" dirty="0"/>
           </a:p>
@@ -5451,7 +5451,7 @@
                 <a:ea typeface="맑은 고딕" pitchFamily="34" charset="-122"/>
                 <a:cs typeface="맑은 고딕" pitchFamily="34" charset="-120"/>
               </a:rPr>
-              <a:t>267 개</a:t>
+              <a:t>215 개</a:t>
             </a:r>
             <a:endParaRPr lang="en-US" sz="3600" dirty="0"/>
           </a:p>
@@ -5657,7 +5657,7 @@
                 <a:ea typeface="맑은 고딕" pitchFamily="34" charset="-122"/>
                 <a:cs typeface="맑은 고딕" pitchFamily="34" charset="-120"/>
               </a:rPr>
-              <a:t>48</a:t>
+              <a:t>36</a:t>
             </a:r>
             <a:endParaRPr lang="en-US" sz="4400" dirty="0"/>
           </a:p>
@@ -6256,7 +6256,7 @@
                           <a:ea typeface="맑은 고딕" pitchFamily="34" charset="-122"/>
                           <a:cs typeface="맑은 고딕" pitchFamily="34" charset="-120"/>
                         </a:rPr>
-                        <a:t>48 개</a:t>
+                        <a:t>36 개</a:t>
                       </a:r>
                       <a:endParaRPr lang="en-US" sz="1400" dirty="0">
                         <a:latin typeface="맑은 고딕" charset="0"/>
@@ -6518,7 +6518,7 @@
                           <a:ea typeface="맑은 고딕" pitchFamily="34" charset="-122"/>
                           <a:cs typeface="맑은 고딕" pitchFamily="34" charset="-120"/>
                         </a:rPr>
-                        <a:t>40 개</a:t>
+                        <a:t>22 개</a:t>
                       </a:r>
                       <a:endParaRPr lang="en-US" sz="1200" dirty="0">
                         <a:latin typeface="맑은 고딕" charset="0"/>
@@ -6715,7 +6715,7 @@
                           <a:ea typeface="맑은 고딕" pitchFamily="34" charset="-122"/>
                           <a:cs typeface="맑은 고딕" pitchFamily="34" charset="-120"/>
                         </a:rPr>
-                        <a:t>[SILVER925] Eramam Open Ring</a:t>
+                        <a:t>[SILVER925] Mustafakemalpaşa Ring (사이즈: 12호)</a:t>
                       </a:r>
                       <a:endParaRPr lang="en-US" sz="1100" dirty="0">
                         <a:latin typeface="맑은 고딕" charset="0"/>
@@ -6780,7 +6780,7 @@
                           <a:ea typeface="맑은 고딕" pitchFamily="34" charset="-122"/>
                           <a:cs typeface="맑은 고딕" pitchFamily="34" charset="-120"/>
                         </a:rPr>
-                        <a:t>13 개</a:t>
+                        <a:t>14 개</a:t>
                       </a:r>
                       <a:endParaRPr lang="en-US" sz="1200" dirty="0">
                         <a:latin typeface="맑은 고딕" charset="0"/>
@@ -6977,7 +6977,7 @@
                           <a:ea typeface="맑은 고딕" pitchFamily="34" charset="-122"/>
                           <a:cs typeface="맑은 고딕" pitchFamily="34" charset="-120"/>
                         </a:rPr>
-                        <a:t>[SILVER925] Starly Open Ring</a:t>
+                        <a:t>[SILVER925] Kouro Open Ring</a:t>
                       </a:r>
                       <a:endParaRPr lang="en-US" sz="1100" dirty="0">
                         <a:latin typeface="맑은 고딕" charset="0"/>
@@ -7042,7 +7042,7 @@
                           <a:ea typeface="맑은 고딕" pitchFamily="34" charset="-122"/>
                           <a:cs typeface="맑은 고딕" pitchFamily="34" charset="-120"/>
                         </a:rPr>
-                        <a:t>12 개</a:t>
+                        <a:t>10 개</a:t>
                       </a:r>
                       <a:endParaRPr lang="en-US" sz="1200" dirty="0">
                         <a:latin typeface="맑은 고딕" charset="0"/>
@@ -7174,7 +7174,7 @@
                           <a:ea typeface="맑은 고딕" pitchFamily="34" charset="-122"/>
                           <a:cs typeface="맑은 고딕" pitchFamily="34" charset="-120"/>
                         </a:rPr>
-                        <a:t>Necklace</a:t>
+                        <a:t>Ring</a:t>
                       </a:r>
                       <a:endParaRPr lang="en-US" sz="1000" dirty="0">
                         <a:latin typeface="맑은 고딕" charset="0"/>
@@ -7239,7 +7239,7 @@
                           <a:ea typeface="맑은 고딕" pitchFamily="34" charset="-122"/>
                           <a:cs typeface="맑은 고딕" pitchFamily="34" charset="-120"/>
                         </a:rPr>
-                        <a:t>Tiny Cross Necklace</a:t>
+                        <a:t>[SILVER925] Crown Open Ring</a:t>
                       </a:r>
                       <a:endParaRPr lang="en-US" sz="1100" dirty="0">
                         <a:latin typeface="맑은 고딕" charset="0"/>
@@ -7304,7 +7304,7 @@
                           <a:ea typeface="맑은 고딕" pitchFamily="34" charset="-122"/>
                           <a:cs typeface="맑은 고딕" pitchFamily="34" charset="-120"/>
                         </a:rPr>
-                        <a:t>11 개</a:t>
+                        <a:t>9 개</a:t>
                       </a:r>
                       <a:endParaRPr lang="en-US" sz="1200" dirty="0">
                         <a:latin typeface="맑은 고딕" charset="0"/>
@@ -7390,7 +7390,7 @@
                 <a:ea typeface="맑은 고딕" pitchFamily="34" charset="-122"/>
                 <a:cs typeface="맑은 고딕" pitchFamily="34" charset="-120"/>
               </a:rPr>
-              <a:t>리오더 필요  🔴 긴급 8건</a:t>
+              <a:t>리오더 필요  🔴 긴급 7건</a:t>
             </a:r>
             <a:pPr indent="0" marL="0">
               <a:buNone/>
@@ -7557,6 +7557,418 @@
                 <a:ea typeface="맑은 고딕" pitchFamily="34" charset="-122"/>
                 <a:cs typeface="맑은 고딕" pitchFamily="34" charset="-120"/>
               </a:rPr>
+              <a:t>B-Flower Necklace (Size: 2 Size)</a:t>
+            </a:r>
+            <a:endParaRPr lang="en-US" sz="1100" dirty="0"/>
+          </a:p>
+        </p:txBody>
+      </p:sp>
+      <p:sp>
+        <p:nvSpPr>
+          <p:cNvPr id="26" name="Text 23"/>
+          <p:cNvSpPr/>
+          <p:nvPr/>
+        </p:nvSpPr>
+        <p:spPr>
+          <a:xfrm>
+            <a:off x="8211312" y="3712464"/>
+            <a:ext cx="3291840" cy="256032"/>
+          </a:xfrm>
+          <a:prstGeom prst="rect">
+            <a:avLst/>
+          </a:prstGeom>
+          <a:noFill/>
+          <a:ln/>
+        </p:spPr>
+        <p:txBody>
+          <a:bodyPr wrap="square" lIns="0" tIns="0" rIns="0" bIns="0" rtlCol="0" anchor="ctr"/>
+          <a:lstStyle/>
+          <a:p>
+            <a:pPr indent="0" marL="0">
+              <a:buNone/>
+            </a:pPr>
+            <a:r>
+              <a:rPr lang="en-US" sz="1000" dirty="0">
+                <a:solidFill>
+                  <a:srgbClr val="6B7280"/>
+                </a:solidFill>
+                <a:latin typeface="맑은 고딕" pitchFamily="34" charset="0"/>
+                <a:ea typeface="맑은 고딕" pitchFamily="34" charset="-122"/>
+                <a:cs typeface="맑은 고딕" pitchFamily="34" charset="-120"/>
+              </a:rPr>
+              <a:t>Necklace  ·  재고 0개</a:t>
+            </a:r>
+            <a:pPr indent="0" marL="0">
+              <a:buNone/>
+            </a:pPr>
+            <a:r>
+              <a:rPr lang="en-US" sz="1000" b="1" dirty="0">
+                <a:solidFill>
+                  <a:srgbClr val="D72638"/>
+                </a:solidFill>
+                <a:latin typeface="맑은 고딕" pitchFamily="34" charset="0"/>
+                <a:ea typeface="맑은 고딕" pitchFamily="34" charset="-122"/>
+                <a:cs typeface="맑은 고딕" pitchFamily="34" charset="-120"/>
+              </a:rPr>
+              <a:t/>
+            </a:r>
+            <a:endParaRPr lang="en-US" sz="1000" dirty="0"/>
+          </a:p>
+        </p:txBody>
+      </p:sp>
+      <p:sp>
+        <p:nvSpPr>
+          <p:cNvPr id="27" name="Shape 24"/>
+          <p:cNvSpPr/>
+          <p:nvPr/>
+        </p:nvSpPr>
+        <p:spPr>
+          <a:xfrm>
+            <a:off x="7406640" y="4096512"/>
+            <a:ext cx="4206240" cy="640080"/>
+          </a:xfrm>
+          <a:prstGeom prst="rect">
+            <a:avLst/>
+          </a:prstGeom>
+          <a:solidFill>
+            <a:srgbClr val="FFF5F5"/>
+          </a:solidFill>
+          <a:ln w="6350">
+            <a:solidFill>
+              <a:srgbClr val="E5E7EB"/>
+            </a:solidFill>
+            <a:prstDash val="solid"/>
+          </a:ln>
+        </p:spPr>
+      </p:sp>
+      <p:sp>
+        <p:nvSpPr>
+          <p:cNvPr id="28" name="Shape 25"/>
+          <p:cNvSpPr/>
+          <p:nvPr/>
+        </p:nvSpPr>
+        <p:spPr>
+          <a:xfrm>
+            <a:off x="7406640" y="4096512"/>
+            <a:ext cx="109728" cy="640080"/>
+          </a:xfrm>
+          <a:prstGeom prst="rect">
+            <a:avLst/>
+          </a:prstGeom>
+          <a:solidFill>
+            <a:srgbClr val="D72638"/>
+          </a:solidFill>
+          <a:ln w="12700">
+            <a:solidFill>
+              <a:srgbClr val="D72638"/>
+            </a:solidFill>
+            <a:prstDash val="solid"/>
+          </a:ln>
+        </p:spPr>
+      </p:sp>
+      <p:sp>
+        <p:nvSpPr>
+          <p:cNvPr id="29" name="Shape 26"/>
+          <p:cNvSpPr/>
+          <p:nvPr/>
+        </p:nvSpPr>
+        <p:spPr>
+          <a:xfrm>
+            <a:off x="7571232" y="4187952"/>
+            <a:ext cx="548640" cy="256032"/>
+          </a:xfrm>
+          <a:prstGeom prst="rect">
+            <a:avLst/>
+          </a:prstGeom>
+          <a:solidFill>
+            <a:srgbClr val="D72638"/>
+          </a:solidFill>
+          <a:ln w="12700">
+            <a:solidFill>
+              <a:srgbClr val="D72638"/>
+            </a:solidFill>
+            <a:prstDash val="solid"/>
+          </a:ln>
+        </p:spPr>
+      </p:sp>
+      <p:sp>
+        <p:nvSpPr>
+          <p:cNvPr id="30" name="Text 27"/>
+          <p:cNvSpPr/>
+          <p:nvPr/>
+        </p:nvSpPr>
+        <p:spPr>
+          <a:xfrm>
+            <a:off x="7571232" y="4187952"/>
+            <a:ext cx="548640" cy="256032"/>
+          </a:xfrm>
+          <a:prstGeom prst="rect">
+            <a:avLst/>
+          </a:prstGeom>
+          <a:noFill/>
+          <a:ln/>
+        </p:spPr>
+        <p:txBody>
+          <a:bodyPr wrap="square" lIns="0" tIns="0" rIns="0" bIns="0" rtlCol="0" anchor="ctr"/>
+          <a:lstStyle/>
+          <a:p>
+            <a:pPr algn="ctr" indent="0" marL="0">
+              <a:buNone/>
+            </a:pPr>
+            <a:r>
+              <a:rPr lang="en-US" sz="900" b="1" dirty="0">
+                <a:solidFill>
+                  <a:srgbClr val="FFFFFF"/>
+                </a:solidFill>
+                <a:latin typeface="맑은 고딕" pitchFamily="34" charset="0"/>
+                <a:ea typeface="맑은 고딕" pitchFamily="34" charset="-122"/>
+                <a:cs typeface="맑은 고딕" pitchFamily="34" charset="-120"/>
+              </a:rPr>
+              <a:t>긴급</a:t>
+            </a:r>
+            <a:endParaRPr lang="en-US" sz="900" dirty="0"/>
+          </a:p>
+        </p:txBody>
+      </p:sp>
+      <p:sp>
+        <p:nvSpPr>
+          <p:cNvPr id="31" name="Text 28"/>
+          <p:cNvSpPr/>
+          <p:nvPr/>
+        </p:nvSpPr>
+        <p:spPr>
+          <a:xfrm>
+            <a:off x="8211312" y="4151376"/>
+            <a:ext cx="3291840" cy="274320"/>
+          </a:xfrm>
+          <a:prstGeom prst="rect">
+            <a:avLst/>
+          </a:prstGeom>
+          <a:noFill/>
+          <a:ln/>
+        </p:spPr>
+        <p:txBody>
+          <a:bodyPr wrap="square" lIns="0" tIns="0" rIns="0" bIns="0" rtlCol="0" anchor="ctr"/>
+          <a:lstStyle/>
+          <a:p>
+            <a:pPr indent="0" marL="0">
+              <a:buNone/>
+            </a:pPr>
+            <a:r>
+              <a:rPr lang="en-US" sz="1100" b="1" dirty="0">
+                <a:solidFill>
+                  <a:srgbClr val="0B1220"/>
+                </a:solidFill>
+                <a:latin typeface="맑은 고딕" pitchFamily="34" charset="0"/>
+                <a:ea typeface="맑은 고딕" pitchFamily="34" charset="-122"/>
+                <a:cs typeface="맑은 고딕" pitchFamily="34" charset="-120"/>
+              </a:rPr>
+              <a:t>Chainlink Necklace</a:t>
+            </a:r>
+            <a:endParaRPr lang="en-US" sz="1100" dirty="0"/>
+          </a:p>
+        </p:txBody>
+      </p:sp>
+      <p:sp>
+        <p:nvSpPr>
+          <p:cNvPr id="32" name="Text 29"/>
+          <p:cNvSpPr/>
+          <p:nvPr/>
+        </p:nvSpPr>
+        <p:spPr>
+          <a:xfrm>
+            <a:off x="8211312" y="4425696"/>
+            <a:ext cx="3291840" cy="256032"/>
+          </a:xfrm>
+          <a:prstGeom prst="rect">
+            <a:avLst/>
+          </a:prstGeom>
+          <a:noFill/>
+          <a:ln/>
+        </p:spPr>
+        <p:txBody>
+          <a:bodyPr wrap="square" lIns="0" tIns="0" rIns="0" bIns="0" rtlCol="0" anchor="ctr"/>
+          <a:lstStyle/>
+          <a:p>
+            <a:pPr indent="0" marL="0">
+              <a:buNone/>
+            </a:pPr>
+            <a:r>
+              <a:rPr lang="en-US" sz="1000" dirty="0">
+                <a:solidFill>
+                  <a:srgbClr val="6B7280"/>
+                </a:solidFill>
+                <a:latin typeface="맑은 고딕" pitchFamily="34" charset="0"/>
+                <a:ea typeface="맑은 고딕" pitchFamily="34" charset="-122"/>
+                <a:cs typeface="맑은 고딕" pitchFamily="34" charset="-120"/>
+              </a:rPr>
+              <a:t>Necklace  ·  재고 1개</a:t>
+            </a:r>
+            <a:pPr indent="0" marL="0">
+              <a:buNone/>
+            </a:pPr>
+            <a:r>
+              <a:rPr lang="en-US" sz="1000" b="1" dirty="0">
+                <a:solidFill>
+                  <a:srgbClr val="D72638"/>
+                </a:solidFill>
+                <a:latin typeface="맑은 고딕" pitchFamily="34" charset="0"/>
+                <a:ea typeface="맑은 고딕" pitchFamily="34" charset="-122"/>
+                <a:cs typeface="맑은 고딕" pitchFamily="34" charset="-120"/>
+              </a:rPr>
+              <a:t/>
+            </a:r>
+            <a:endParaRPr lang="en-US" sz="1000" dirty="0"/>
+          </a:p>
+        </p:txBody>
+      </p:sp>
+      <p:sp>
+        <p:nvSpPr>
+          <p:cNvPr id="33" name="Shape 30"/>
+          <p:cNvSpPr/>
+          <p:nvPr/>
+        </p:nvSpPr>
+        <p:spPr>
+          <a:xfrm>
+            <a:off x="7406640" y="4809744"/>
+            <a:ext cx="4206240" cy="640080"/>
+          </a:xfrm>
+          <a:prstGeom prst="rect">
+            <a:avLst/>
+          </a:prstGeom>
+          <a:solidFill>
+            <a:srgbClr val="FFF5F5"/>
+          </a:solidFill>
+          <a:ln w="6350">
+            <a:solidFill>
+              <a:srgbClr val="E5E7EB"/>
+            </a:solidFill>
+            <a:prstDash val="solid"/>
+          </a:ln>
+        </p:spPr>
+      </p:sp>
+      <p:sp>
+        <p:nvSpPr>
+          <p:cNvPr id="34" name="Shape 31"/>
+          <p:cNvSpPr/>
+          <p:nvPr/>
+        </p:nvSpPr>
+        <p:spPr>
+          <a:xfrm>
+            <a:off x="7406640" y="4809744"/>
+            <a:ext cx="109728" cy="640080"/>
+          </a:xfrm>
+          <a:prstGeom prst="rect">
+            <a:avLst/>
+          </a:prstGeom>
+          <a:solidFill>
+            <a:srgbClr val="D72638"/>
+          </a:solidFill>
+          <a:ln w="12700">
+            <a:solidFill>
+              <a:srgbClr val="D72638"/>
+            </a:solidFill>
+            <a:prstDash val="solid"/>
+          </a:ln>
+        </p:spPr>
+      </p:sp>
+      <p:sp>
+        <p:nvSpPr>
+          <p:cNvPr id="35" name="Shape 32"/>
+          <p:cNvSpPr/>
+          <p:nvPr/>
+        </p:nvSpPr>
+        <p:spPr>
+          <a:xfrm>
+            <a:off x="7571232" y="4901184"/>
+            <a:ext cx="548640" cy="256032"/>
+          </a:xfrm>
+          <a:prstGeom prst="rect">
+            <a:avLst/>
+          </a:prstGeom>
+          <a:solidFill>
+            <a:srgbClr val="D72638"/>
+          </a:solidFill>
+          <a:ln w="12700">
+            <a:solidFill>
+              <a:srgbClr val="D72638"/>
+            </a:solidFill>
+            <a:prstDash val="solid"/>
+          </a:ln>
+        </p:spPr>
+      </p:sp>
+      <p:sp>
+        <p:nvSpPr>
+          <p:cNvPr id="36" name="Text 33"/>
+          <p:cNvSpPr/>
+          <p:nvPr/>
+        </p:nvSpPr>
+        <p:spPr>
+          <a:xfrm>
+            <a:off x="7571232" y="4901184"/>
+            <a:ext cx="548640" cy="256032"/>
+          </a:xfrm>
+          <a:prstGeom prst="rect">
+            <a:avLst/>
+          </a:prstGeom>
+          <a:noFill/>
+          <a:ln/>
+        </p:spPr>
+        <p:txBody>
+          <a:bodyPr wrap="square" lIns="0" tIns="0" rIns="0" bIns="0" rtlCol="0" anchor="ctr"/>
+          <a:lstStyle/>
+          <a:p>
+            <a:pPr algn="ctr" indent="0" marL="0">
+              <a:buNone/>
+            </a:pPr>
+            <a:r>
+              <a:rPr lang="en-US" sz="900" b="1" dirty="0">
+                <a:solidFill>
+                  <a:srgbClr val="FFFFFF"/>
+                </a:solidFill>
+                <a:latin typeface="맑은 고딕" pitchFamily="34" charset="0"/>
+                <a:ea typeface="맑은 고딕" pitchFamily="34" charset="-122"/>
+                <a:cs typeface="맑은 고딕" pitchFamily="34" charset="-120"/>
+              </a:rPr>
+              <a:t>긴급</a:t>
+            </a:r>
+            <a:endParaRPr lang="en-US" sz="900" dirty="0"/>
+          </a:p>
+        </p:txBody>
+      </p:sp>
+      <p:sp>
+        <p:nvSpPr>
+          <p:cNvPr id="37" name="Text 34"/>
+          <p:cNvSpPr/>
+          <p:nvPr/>
+        </p:nvSpPr>
+        <p:spPr>
+          <a:xfrm>
+            <a:off x="8211312" y="4864608"/>
+            <a:ext cx="3291840" cy="274320"/>
+          </a:xfrm>
+          <a:prstGeom prst="rect">
+            <a:avLst/>
+          </a:prstGeom>
+          <a:noFill/>
+          <a:ln/>
+        </p:spPr>
+        <p:txBody>
+          <a:bodyPr wrap="square" lIns="0" tIns="0" rIns="0" bIns="0" rtlCol="0" anchor="ctr"/>
+          <a:lstStyle/>
+          <a:p>
+            <a:pPr indent="0" marL="0">
+              <a:buNone/>
+            </a:pPr>
+            <a:r>
+              <a:rPr lang="en-US" sz="1100" b="1" dirty="0">
+                <a:solidFill>
+                  <a:srgbClr val="0B1220"/>
+                </a:solidFill>
+                <a:latin typeface="맑은 고딕" pitchFamily="34" charset="0"/>
+                <a:ea typeface="맑은 고딕" pitchFamily="34" charset="-122"/>
+                <a:cs typeface="맑은 고딕" pitchFamily="34" charset="-120"/>
+              </a:rPr>
               <a:t>8-Ball Smart Tok</a:t>
             </a:r>
             <a:endParaRPr lang="en-US" sz="1100" dirty="0"/>
@@ -7565,13 +7977,13 @@
       </p:sp>
       <p:sp>
         <p:nvSpPr>
-          <p:cNvPr id="26" name="Text 23"/>
-          <p:cNvSpPr/>
-          <p:nvPr/>
-        </p:nvSpPr>
-        <p:spPr>
-          <a:xfrm>
-            <a:off x="8211312" y="3712464"/>
+          <p:cNvPr id="38" name="Text 35"/>
+          <p:cNvSpPr/>
+          <p:nvPr/>
+        </p:nvSpPr>
+        <p:spPr>
+          <a:xfrm>
+            <a:off x="8211312" y="5138928"/>
             <a:ext cx="3291840" cy="256032"/>
           </a:xfrm>
           <a:prstGeom prst="rect">
@@ -7618,418 +8030,6 @@
       </p:sp>
       <p:sp>
         <p:nvSpPr>
-          <p:cNvPr id="27" name="Shape 24"/>
-          <p:cNvSpPr/>
-          <p:nvPr/>
-        </p:nvSpPr>
-        <p:spPr>
-          <a:xfrm>
-            <a:off x="7406640" y="4096512"/>
-            <a:ext cx="4206240" cy="640080"/>
-          </a:xfrm>
-          <a:prstGeom prst="rect">
-            <a:avLst/>
-          </a:prstGeom>
-          <a:solidFill>
-            <a:srgbClr val="FFF5F5"/>
-          </a:solidFill>
-          <a:ln w="6350">
-            <a:solidFill>
-              <a:srgbClr val="E5E7EB"/>
-            </a:solidFill>
-            <a:prstDash val="solid"/>
-          </a:ln>
-        </p:spPr>
-      </p:sp>
-      <p:sp>
-        <p:nvSpPr>
-          <p:cNvPr id="28" name="Shape 25"/>
-          <p:cNvSpPr/>
-          <p:nvPr/>
-        </p:nvSpPr>
-        <p:spPr>
-          <a:xfrm>
-            <a:off x="7406640" y="4096512"/>
-            <a:ext cx="109728" cy="640080"/>
-          </a:xfrm>
-          <a:prstGeom prst="rect">
-            <a:avLst/>
-          </a:prstGeom>
-          <a:solidFill>
-            <a:srgbClr val="D72638"/>
-          </a:solidFill>
-          <a:ln w="12700">
-            <a:solidFill>
-              <a:srgbClr val="D72638"/>
-            </a:solidFill>
-            <a:prstDash val="solid"/>
-          </a:ln>
-        </p:spPr>
-      </p:sp>
-      <p:sp>
-        <p:nvSpPr>
-          <p:cNvPr id="29" name="Shape 26"/>
-          <p:cNvSpPr/>
-          <p:nvPr/>
-        </p:nvSpPr>
-        <p:spPr>
-          <a:xfrm>
-            <a:off x="7571232" y="4187952"/>
-            <a:ext cx="548640" cy="256032"/>
-          </a:xfrm>
-          <a:prstGeom prst="rect">
-            <a:avLst/>
-          </a:prstGeom>
-          <a:solidFill>
-            <a:srgbClr val="D72638"/>
-          </a:solidFill>
-          <a:ln w="12700">
-            <a:solidFill>
-              <a:srgbClr val="D72638"/>
-            </a:solidFill>
-            <a:prstDash val="solid"/>
-          </a:ln>
-        </p:spPr>
-      </p:sp>
-      <p:sp>
-        <p:nvSpPr>
-          <p:cNvPr id="30" name="Text 27"/>
-          <p:cNvSpPr/>
-          <p:nvPr/>
-        </p:nvSpPr>
-        <p:spPr>
-          <a:xfrm>
-            <a:off x="7571232" y="4187952"/>
-            <a:ext cx="548640" cy="256032"/>
-          </a:xfrm>
-          <a:prstGeom prst="rect">
-            <a:avLst/>
-          </a:prstGeom>
-          <a:noFill/>
-          <a:ln/>
-        </p:spPr>
-        <p:txBody>
-          <a:bodyPr wrap="square" lIns="0" tIns="0" rIns="0" bIns="0" rtlCol="0" anchor="ctr"/>
-          <a:lstStyle/>
-          <a:p>
-            <a:pPr algn="ctr" indent="0" marL="0">
-              <a:buNone/>
-            </a:pPr>
-            <a:r>
-              <a:rPr lang="en-US" sz="900" b="1" dirty="0">
-                <a:solidFill>
-                  <a:srgbClr val="FFFFFF"/>
-                </a:solidFill>
-                <a:latin typeface="맑은 고딕" pitchFamily="34" charset="0"/>
-                <a:ea typeface="맑은 고딕" pitchFamily="34" charset="-122"/>
-                <a:cs typeface="맑은 고딕" pitchFamily="34" charset="-120"/>
-              </a:rPr>
-              <a:t>긴급</a:t>
-            </a:r>
-            <a:endParaRPr lang="en-US" sz="900" dirty="0"/>
-          </a:p>
-        </p:txBody>
-      </p:sp>
-      <p:sp>
-        <p:nvSpPr>
-          <p:cNvPr id="31" name="Text 28"/>
-          <p:cNvSpPr/>
-          <p:nvPr/>
-        </p:nvSpPr>
-        <p:spPr>
-          <a:xfrm>
-            <a:off x="8211312" y="4151376"/>
-            <a:ext cx="3291840" cy="274320"/>
-          </a:xfrm>
-          <a:prstGeom prst="rect">
-            <a:avLst/>
-          </a:prstGeom>
-          <a:noFill/>
-          <a:ln/>
-        </p:spPr>
-        <p:txBody>
-          <a:bodyPr wrap="square" lIns="0" tIns="0" rIns="0" bIns="0" rtlCol="0" anchor="ctr"/>
-          <a:lstStyle/>
-          <a:p>
-            <a:pPr indent="0" marL="0">
-              <a:buNone/>
-            </a:pPr>
-            <a:r>
-              <a:rPr lang="en-US" sz="1100" b="1" dirty="0">
-                <a:solidFill>
-                  <a:srgbClr val="0B1220"/>
-                </a:solidFill>
-                <a:latin typeface="맑은 고딕" pitchFamily="34" charset="0"/>
-                <a:ea typeface="맑은 고딕" pitchFamily="34" charset="-122"/>
-                <a:cs typeface="맑은 고딕" pitchFamily="34" charset="-120"/>
-              </a:rPr>
-              <a:t>B-Flower Necklace (Size: 2 Size)</a:t>
-            </a:r>
-            <a:endParaRPr lang="en-US" sz="1100" dirty="0"/>
-          </a:p>
-        </p:txBody>
-      </p:sp>
-      <p:sp>
-        <p:nvSpPr>
-          <p:cNvPr id="32" name="Text 29"/>
-          <p:cNvSpPr/>
-          <p:nvPr/>
-        </p:nvSpPr>
-        <p:spPr>
-          <a:xfrm>
-            <a:off x="8211312" y="4425696"/>
-            <a:ext cx="3291840" cy="256032"/>
-          </a:xfrm>
-          <a:prstGeom prst="rect">
-            <a:avLst/>
-          </a:prstGeom>
-          <a:noFill/>
-          <a:ln/>
-        </p:spPr>
-        <p:txBody>
-          <a:bodyPr wrap="square" lIns="0" tIns="0" rIns="0" bIns="0" rtlCol="0" anchor="ctr"/>
-          <a:lstStyle/>
-          <a:p>
-            <a:pPr indent="0" marL="0">
-              <a:buNone/>
-            </a:pPr>
-            <a:r>
-              <a:rPr lang="en-US" sz="1000" dirty="0">
-                <a:solidFill>
-                  <a:srgbClr val="6B7280"/>
-                </a:solidFill>
-                <a:latin typeface="맑은 고딕" pitchFamily="34" charset="0"/>
-                <a:ea typeface="맑은 고딕" pitchFamily="34" charset="-122"/>
-                <a:cs typeface="맑은 고딕" pitchFamily="34" charset="-120"/>
-              </a:rPr>
-              <a:t>Necklace  ·  재고 2개</a:t>
-            </a:r>
-            <a:pPr indent="0" marL="0">
-              <a:buNone/>
-            </a:pPr>
-            <a:r>
-              <a:rPr lang="en-US" sz="1000" b="1" dirty="0">
-                <a:solidFill>
-                  <a:srgbClr val="D72638"/>
-                </a:solidFill>
-                <a:latin typeface="맑은 고딕" pitchFamily="34" charset="0"/>
-                <a:ea typeface="맑은 고딕" pitchFamily="34" charset="-122"/>
-                <a:cs typeface="맑은 고딕" pitchFamily="34" charset="-120"/>
-              </a:rPr>
-              <a:t/>
-            </a:r>
-            <a:endParaRPr lang="en-US" sz="1000" dirty="0"/>
-          </a:p>
-        </p:txBody>
-      </p:sp>
-      <p:sp>
-        <p:nvSpPr>
-          <p:cNvPr id="33" name="Shape 30"/>
-          <p:cNvSpPr/>
-          <p:nvPr/>
-        </p:nvSpPr>
-        <p:spPr>
-          <a:xfrm>
-            <a:off x="7406640" y="4809744"/>
-            <a:ext cx="4206240" cy="640080"/>
-          </a:xfrm>
-          <a:prstGeom prst="rect">
-            <a:avLst/>
-          </a:prstGeom>
-          <a:solidFill>
-            <a:srgbClr val="FFF5F5"/>
-          </a:solidFill>
-          <a:ln w="6350">
-            <a:solidFill>
-              <a:srgbClr val="E5E7EB"/>
-            </a:solidFill>
-            <a:prstDash val="solid"/>
-          </a:ln>
-        </p:spPr>
-      </p:sp>
-      <p:sp>
-        <p:nvSpPr>
-          <p:cNvPr id="34" name="Shape 31"/>
-          <p:cNvSpPr/>
-          <p:nvPr/>
-        </p:nvSpPr>
-        <p:spPr>
-          <a:xfrm>
-            <a:off x="7406640" y="4809744"/>
-            <a:ext cx="109728" cy="640080"/>
-          </a:xfrm>
-          <a:prstGeom prst="rect">
-            <a:avLst/>
-          </a:prstGeom>
-          <a:solidFill>
-            <a:srgbClr val="D72638"/>
-          </a:solidFill>
-          <a:ln w="12700">
-            <a:solidFill>
-              <a:srgbClr val="D72638"/>
-            </a:solidFill>
-            <a:prstDash val="solid"/>
-          </a:ln>
-        </p:spPr>
-      </p:sp>
-      <p:sp>
-        <p:nvSpPr>
-          <p:cNvPr id="35" name="Shape 32"/>
-          <p:cNvSpPr/>
-          <p:nvPr/>
-        </p:nvSpPr>
-        <p:spPr>
-          <a:xfrm>
-            <a:off x="7571232" y="4901184"/>
-            <a:ext cx="548640" cy="256032"/>
-          </a:xfrm>
-          <a:prstGeom prst="rect">
-            <a:avLst/>
-          </a:prstGeom>
-          <a:solidFill>
-            <a:srgbClr val="D72638"/>
-          </a:solidFill>
-          <a:ln w="12700">
-            <a:solidFill>
-              <a:srgbClr val="D72638"/>
-            </a:solidFill>
-            <a:prstDash val="solid"/>
-          </a:ln>
-        </p:spPr>
-      </p:sp>
-      <p:sp>
-        <p:nvSpPr>
-          <p:cNvPr id="36" name="Text 33"/>
-          <p:cNvSpPr/>
-          <p:nvPr/>
-        </p:nvSpPr>
-        <p:spPr>
-          <a:xfrm>
-            <a:off x="7571232" y="4901184"/>
-            <a:ext cx="548640" cy="256032"/>
-          </a:xfrm>
-          <a:prstGeom prst="rect">
-            <a:avLst/>
-          </a:prstGeom>
-          <a:noFill/>
-          <a:ln/>
-        </p:spPr>
-        <p:txBody>
-          <a:bodyPr wrap="square" lIns="0" tIns="0" rIns="0" bIns="0" rtlCol="0" anchor="ctr"/>
-          <a:lstStyle/>
-          <a:p>
-            <a:pPr algn="ctr" indent="0" marL="0">
-              <a:buNone/>
-            </a:pPr>
-            <a:r>
-              <a:rPr lang="en-US" sz="900" b="1" dirty="0">
-                <a:solidFill>
-                  <a:srgbClr val="FFFFFF"/>
-                </a:solidFill>
-                <a:latin typeface="맑은 고딕" pitchFamily="34" charset="0"/>
-                <a:ea typeface="맑은 고딕" pitchFamily="34" charset="-122"/>
-                <a:cs typeface="맑은 고딕" pitchFamily="34" charset="-120"/>
-              </a:rPr>
-              <a:t>긴급</a:t>
-            </a:r>
-            <a:endParaRPr lang="en-US" sz="900" dirty="0"/>
-          </a:p>
-        </p:txBody>
-      </p:sp>
-      <p:sp>
-        <p:nvSpPr>
-          <p:cNvPr id="37" name="Text 34"/>
-          <p:cNvSpPr/>
-          <p:nvPr/>
-        </p:nvSpPr>
-        <p:spPr>
-          <a:xfrm>
-            <a:off x="8211312" y="4864608"/>
-            <a:ext cx="3291840" cy="274320"/>
-          </a:xfrm>
-          <a:prstGeom prst="rect">
-            <a:avLst/>
-          </a:prstGeom>
-          <a:noFill/>
-          <a:ln/>
-        </p:spPr>
-        <p:txBody>
-          <a:bodyPr wrap="square" lIns="0" tIns="0" rIns="0" bIns="0" rtlCol="0" anchor="ctr"/>
-          <a:lstStyle/>
-          <a:p>
-            <a:pPr indent="0" marL="0">
-              <a:buNone/>
-            </a:pPr>
-            <a:r>
-              <a:rPr lang="en-US" sz="1100" b="1" dirty="0">
-                <a:solidFill>
-                  <a:srgbClr val="0B1220"/>
-                </a:solidFill>
-                <a:latin typeface="맑은 고딕" pitchFamily="34" charset="0"/>
-                <a:ea typeface="맑은 고딕" pitchFamily="34" charset="-122"/>
-                <a:cs typeface="맑은 고딕" pitchFamily="34" charset="-120"/>
-              </a:rPr>
-              <a:t>Chainlink Necklace</a:t>
-            </a:r>
-            <a:endParaRPr lang="en-US" sz="1100" dirty="0"/>
-          </a:p>
-        </p:txBody>
-      </p:sp>
-      <p:sp>
-        <p:nvSpPr>
-          <p:cNvPr id="38" name="Text 35"/>
-          <p:cNvSpPr/>
-          <p:nvPr/>
-        </p:nvSpPr>
-        <p:spPr>
-          <a:xfrm>
-            <a:off x="8211312" y="5138928"/>
-            <a:ext cx="3291840" cy="256032"/>
-          </a:xfrm>
-          <a:prstGeom prst="rect">
-            <a:avLst/>
-          </a:prstGeom>
-          <a:noFill/>
-          <a:ln/>
-        </p:spPr>
-        <p:txBody>
-          <a:bodyPr wrap="square" lIns="0" tIns="0" rIns="0" bIns="0" rtlCol="0" anchor="ctr"/>
-          <a:lstStyle/>
-          <a:p>
-            <a:pPr indent="0" marL="0">
-              <a:buNone/>
-            </a:pPr>
-            <a:r>
-              <a:rPr lang="en-US" sz="1000" dirty="0">
-                <a:solidFill>
-                  <a:srgbClr val="6B7280"/>
-                </a:solidFill>
-                <a:latin typeface="맑은 고딕" pitchFamily="34" charset="0"/>
-                <a:ea typeface="맑은 고딕" pitchFamily="34" charset="-122"/>
-                <a:cs typeface="맑은 고딕" pitchFamily="34" charset="-120"/>
-              </a:rPr>
-              <a:t>Necklace  ·  재고 2개</a:t>
-            </a:r>
-            <a:pPr indent="0" marL="0">
-              <a:buNone/>
-            </a:pPr>
-            <a:r>
-              <a:rPr lang="en-US" sz="1000" b="1" dirty="0">
-                <a:solidFill>
-                  <a:srgbClr val="D72638"/>
-                </a:solidFill>
-                <a:latin typeface="맑은 고딕" pitchFamily="34" charset="0"/>
-                <a:ea typeface="맑은 고딕" pitchFamily="34" charset="-122"/>
-                <a:cs typeface="맑은 고딕" pitchFamily="34" charset="-120"/>
-              </a:rPr>
-              <a:t/>
-            </a:r>
-            <a:endParaRPr lang="en-US" sz="1000" dirty="0"/>
-          </a:p>
-        </p:txBody>
-      </p:sp>
-      <p:sp>
-        <p:nvSpPr>
           <p:cNvPr id="39" name="Shape 36"/>
           <p:cNvSpPr/>
           <p:nvPr/>
@@ -8267,7 +8267,7 @@
                 <a:ea typeface="맑은 고딕" pitchFamily="34" charset="-122"/>
                 <a:cs typeface="맑은 고딕" pitchFamily="34" charset="-120"/>
               </a:rPr>
-              <a:t>베스트 상품 리포트  ·  생성 2026-05-22 08:00</a:t>
+              <a:t>베스트 상품 리포트  ·  생성 2026-05-23 08:00</a:t>
             </a:r>
             <a:endParaRPr lang="en-US" sz="900" dirty="0"/>
           </a:p>
@@ -8480,7 +8480,7 @@
                 <a:ea typeface="맑은 고딕" pitchFamily="34" charset="-122"/>
                 <a:cs typeface="맑은 고딕" pitchFamily="34" charset="-120"/>
               </a:rPr>
-              <a:t>2026년 05월 22일 (금)</a:t>
+              <a:t>2026년 05월 23일 (토)</a:t>
             </a:r>
             <a:endParaRPr lang="en-US" sz="1200" dirty="0"/>
           </a:p>
@@ -8647,7 +8647,7 @@
                 <a:ea typeface="맑은 고딕" pitchFamily="34" charset="-122"/>
                 <a:cs typeface="맑은 고딕" pitchFamily="34" charset="-120"/>
               </a:rPr>
-              <a:t>105 개</a:t>
+              <a:t>79 개</a:t>
             </a:r>
             <a:endParaRPr lang="en-US" sz="3600" dirty="0"/>
           </a:p>
@@ -8853,7 +8853,7 @@
                 <a:ea typeface="맑은 고딕" pitchFamily="34" charset="-122"/>
                 <a:cs typeface="맑은 고딕" pitchFamily="34" charset="-120"/>
               </a:rPr>
-              <a:t>29</a:t>
+              <a:t>24</a:t>
             </a:r>
             <a:endParaRPr lang="en-US" sz="4400" dirty="0"/>
           </a:p>
@@ -9452,7 +9452,7 @@
                           <a:ea typeface="맑은 고딕" pitchFamily="34" charset="-122"/>
                           <a:cs typeface="맑은 고딕" pitchFamily="34" charset="-120"/>
                         </a:rPr>
-                        <a:t>29 개</a:t>
+                        <a:t>24 개</a:t>
                       </a:r>
                       <a:endParaRPr lang="en-US" sz="1400" dirty="0">
                         <a:latin typeface="맑은 고딕" charset="0"/>
@@ -9714,7 +9714,7 @@
                           <a:ea typeface="맑은 고딕" pitchFamily="34" charset="-122"/>
                           <a:cs typeface="맑은 고딕" pitchFamily="34" charset="-120"/>
                         </a:rPr>
-                        <a:t>24 개</a:t>
+                        <a:t>23 개</a:t>
                       </a:r>
                       <a:endParaRPr lang="en-US" sz="1200" dirty="0">
                         <a:latin typeface="맑은 고딕" charset="0"/>
@@ -10165,7 +10165,7 @@
                 <a:ea typeface="맑은 고딕" pitchFamily="34" charset="-122"/>
                 <a:cs typeface="맑은 고딕" pitchFamily="34" charset="-120"/>
               </a:rPr>
-              <a:t>베스트 상품 리포트  ·  생성 2026-05-22 08:00</a:t>
+              <a:t>베스트 상품 리포트  ·  생성 2026-05-23 08:00</a:t>
             </a:r>
             <a:endParaRPr lang="en-US" sz="900" dirty="0"/>
           </a:p>
@@ -10378,7 +10378,7 @@
                 <a:ea typeface="맑은 고딕" pitchFamily="34" charset="-122"/>
                 <a:cs typeface="맑은 고딕" pitchFamily="34" charset="-120"/>
               </a:rPr>
-              <a:t>2026년 05월 22일 (금)</a:t>
+              <a:t>2026년 05월 23일 (토)</a:t>
             </a:r>
             <a:endParaRPr lang="en-US" sz="1200" dirty="0"/>
           </a:p>
@@ -10673,7 +10673,7 @@
                 <a:ea typeface="맑은 고딕" pitchFamily="34" charset="-122"/>
                 <a:cs typeface="맑은 고딕" pitchFamily="34" charset="-120"/>
               </a:rPr>
-              <a:t>27</a:t>
+              <a:t>28</a:t>
             </a:r>
             <a:endParaRPr lang="en-US" sz="3000" dirty="0"/>
           </a:p>
@@ -10929,7 +10929,7 @@
                 <a:ea typeface="맑은 고딕" pitchFamily="34" charset="-122"/>
                 <a:cs typeface="맑은 고딕" pitchFamily="34" charset="-120"/>
               </a:rPr>
-              <a:t>31,973</a:t>
+              <a:t>31,412</a:t>
             </a:r>
             <a:endParaRPr lang="en-US" sz="3000" dirty="0"/>
           </a:p>
@@ -11489,7 +11489,7 @@
                           <a:ea typeface="맑은 고딕" pitchFamily="34" charset="-122"/>
                           <a:cs typeface="맑은 고딕" pitchFamily="34" charset="-120"/>
                         </a:rPr>
-                        <a:t>2,097</a:t>
+                        <a:t>2,093</a:t>
                       </a:r>
                       <a:endParaRPr lang="en-US" sz="1000" dirty="0">
                         <a:latin typeface="맑은 고딕" charset="0"/>
@@ -11751,7 +11751,7 @@
                           <a:ea typeface="맑은 고딕" pitchFamily="34" charset="-122"/>
                           <a:cs typeface="맑은 고딕" pitchFamily="34" charset="-120"/>
                         </a:rPr>
-                        <a:t>1,632</a:t>
+                        <a:t>1,620</a:t>
                       </a:r>
                       <a:endParaRPr lang="en-US" sz="1000" dirty="0">
                         <a:latin typeface="맑은 고딕" charset="0"/>
@@ -12013,7 +12013,7 @@
                           <a:ea typeface="맑은 고딕" pitchFamily="34" charset="-122"/>
                           <a:cs typeface="맑은 고딕" pitchFamily="34" charset="-120"/>
                         </a:rPr>
-                        <a:t>1,539</a:t>
+                        <a:t>1,436</a:t>
                       </a:r>
                       <a:endParaRPr lang="en-US" sz="1000" dirty="0">
                         <a:latin typeface="맑은 고딕" charset="0"/>
@@ -12275,7 +12275,7 @@
                           <a:ea typeface="맑은 고딕" pitchFamily="34" charset="-122"/>
                           <a:cs typeface="맑은 고딕" pitchFamily="34" charset="-120"/>
                         </a:rPr>
-                        <a:t>1,458</a:t>
+                        <a:t>1,324</a:t>
                       </a:r>
                       <a:endParaRPr lang="en-US" sz="1000" dirty="0">
                         <a:latin typeface="맑은 고딕" charset="0"/>
@@ -12537,7 +12537,7 @@
                           <a:ea typeface="맑은 고딕" pitchFamily="34" charset="-122"/>
                           <a:cs typeface="맑은 고딕" pitchFamily="34" charset="-120"/>
                         </a:rPr>
-                        <a:t>1,031</a:t>
+                        <a:t>928</a:t>
                       </a:r>
                       <a:endParaRPr lang="en-US" sz="1000" dirty="0">
                         <a:latin typeface="맑은 고딕" charset="0"/>
@@ -12623,7 +12623,7 @@
                 <a:ea typeface="맑은 고딕" pitchFamily="34" charset="-122"/>
                 <a:cs typeface="맑은 고딕" pitchFamily="34" charset="-120"/>
               </a:rPr>
-              <a:t>재고 점검  🔴 품절 27건</a:t>
+              <a:t>재고 점검  🔴 품절 28건</a:t>
             </a:r>
             <a:pPr indent="0" marL="0">
               <a:buNone/>
@@ -12805,6 +12805,226 @@
         <p:spPr>
           <a:xfrm>
             <a:off x="8211312" y="3712464"/>
+            <a:ext cx="3291840" cy="256032"/>
+          </a:xfrm>
+          <a:prstGeom prst="rect">
+            <a:avLst/>
+          </a:prstGeom>
+          <a:noFill/>
+          <a:ln/>
+        </p:spPr>
+        <p:txBody>
+          <a:bodyPr wrap="square" lIns="0" tIns="0" rIns="0" bIns="0" rtlCol="0" anchor="ctr"/>
+          <a:lstStyle/>
+          <a:p>
+            <a:pPr indent="0" marL="0">
+              <a:buNone/>
+            </a:pPr>
+            <a:r>
+              <a:rPr lang="en-US" sz="900" dirty="0">
+                <a:solidFill>
+                  <a:srgbClr val="6B7280"/>
+                </a:solidFill>
+                <a:latin typeface="맑은 고딕" pitchFamily="34" charset="0"/>
+                <a:ea typeface="맑은 고딕" pitchFamily="34" charset="-122"/>
+                <a:cs typeface="맑은 고딕" pitchFamily="34" charset="-120"/>
+              </a:rPr>
+              <a:t>색상: 레드  ·  재고 0개</a:t>
+            </a:r>
+            <a:pPr indent="0" marL="0">
+              <a:buNone/>
+            </a:pPr>
+            <a:r>
+              <a:rPr lang="en-US" sz="1000" dirty="0">
+                <a:solidFill>
+                  <a:srgbClr val="6B7280"/>
+                </a:solidFill>
+                <a:latin typeface="맑은 고딕" pitchFamily="34" charset="0"/>
+                <a:ea typeface="맑은 고딕" pitchFamily="34" charset="-122"/>
+                <a:cs typeface="맑은 고딕" pitchFamily="34" charset="-120"/>
+              </a:rPr>
+              <a:t/>
+            </a:r>
+            <a:pPr indent="0" marL="0">
+              <a:buNone/>
+            </a:pPr>
+            <a:r>
+              <a:rPr lang="en-US" sz="1000" b="1" dirty="0">
+                <a:solidFill>
+                  <a:srgbClr val="D72638"/>
+                </a:solidFill>
+                <a:latin typeface="맑은 고딕" pitchFamily="34" charset="0"/>
+                <a:ea typeface="맑은 고딕" pitchFamily="34" charset="-122"/>
+                <a:cs typeface="맑은 고딕" pitchFamily="34" charset="-120"/>
+              </a:rPr>
+              <a:t/>
+            </a:r>
+            <a:endParaRPr lang="en-US" sz="900" dirty="0"/>
+          </a:p>
+        </p:txBody>
+      </p:sp>
+      <p:sp>
+        <p:nvSpPr>
+          <p:cNvPr id="32" name="Shape 29"/>
+          <p:cNvSpPr/>
+          <p:nvPr/>
+        </p:nvSpPr>
+        <p:spPr>
+          <a:xfrm>
+            <a:off x="7406640" y="4096512"/>
+            <a:ext cx="4206240" cy="640080"/>
+          </a:xfrm>
+          <a:prstGeom prst="rect">
+            <a:avLst/>
+          </a:prstGeom>
+          <a:solidFill>
+            <a:srgbClr val="FFF5F5"/>
+          </a:solidFill>
+          <a:ln w="6350">
+            <a:solidFill>
+              <a:srgbClr val="E5E7EB"/>
+            </a:solidFill>
+            <a:prstDash val="solid"/>
+          </a:ln>
+        </p:spPr>
+      </p:sp>
+      <p:sp>
+        <p:nvSpPr>
+          <p:cNvPr id="33" name="Shape 30"/>
+          <p:cNvSpPr/>
+          <p:nvPr/>
+        </p:nvSpPr>
+        <p:spPr>
+          <a:xfrm>
+            <a:off x="7406640" y="4096512"/>
+            <a:ext cx="109728" cy="640080"/>
+          </a:xfrm>
+          <a:prstGeom prst="rect">
+            <a:avLst/>
+          </a:prstGeom>
+          <a:solidFill>
+            <a:srgbClr val="D72638"/>
+          </a:solidFill>
+          <a:ln w="12700">
+            <a:solidFill>
+              <a:srgbClr val="D72638"/>
+            </a:solidFill>
+            <a:prstDash val="solid"/>
+          </a:ln>
+        </p:spPr>
+      </p:sp>
+      <p:sp>
+        <p:nvSpPr>
+          <p:cNvPr id="34" name="Shape 31"/>
+          <p:cNvSpPr/>
+          <p:nvPr/>
+        </p:nvSpPr>
+        <p:spPr>
+          <a:xfrm>
+            <a:off x="7571232" y="4187952"/>
+            <a:ext cx="548640" cy="256032"/>
+          </a:xfrm>
+          <a:prstGeom prst="rect">
+            <a:avLst/>
+          </a:prstGeom>
+          <a:solidFill>
+            <a:srgbClr val="D72638"/>
+          </a:solidFill>
+          <a:ln w="12700">
+            <a:solidFill>
+              <a:srgbClr val="D72638"/>
+            </a:solidFill>
+            <a:prstDash val="solid"/>
+          </a:ln>
+        </p:spPr>
+      </p:sp>
+      <p:sp>
+        <p:nvSpPr>
+          <p:cNvPr id="35" name="Text 32"/>
+          <p:cNvSpPr/>
+          <p:nvPr/>
+        </p:nvSpPr>
+        <p:spPr>
+          <a:xfrm>
+            <a:off x="7571232" y="4187952"/>
+            <a:ext cx="548640" cy="256032"/>
+          </a:xfrm>
+          <a:prstGeom prst="rect">
+            <a:avLst/>
+          </a:prstGeom>
+          <a:noFill/>
+          <a:ln/>
+        </p:spPr>
+        <p:txBody>
+          <a:bodyPr wrap="square" lIns="0" tIns="0" rIns="0" bIns="0" rtlCol="0" anchor="ctr"/>
+          <a:lstStyle/>
+          <a:p>
+            <a:pPr algn="ctr" indent="0" marL="0">
+              <a:buNone/>
+            </a:pPr>
+            <a:r>
+              <a:rPr lang="en-US" sz="900" b="1" dirty="0">
+                <a:solidFill>
+                  <a:srgbClr val="FFFFFF"/>
+                </a:solidFill>
+                <a:latin typeface="맑은 고딕" pitchFamily="34" charset="0"/>
+                <a:ea typeface="맑은 고딕" pitchFamily="34" charset="-122"/>
+                <a:cs typeface="맑은 고딕" pitchFamily="34" charset="-120"/>
+              </a:rPr>
+              <a:t>긴급</a:t>
+            </a:r>
+            <a:endParaRPr lang="en-US" sz="900" dirty="0"/>
+          </a:p>
+        </p:txBody>
+      </p:sp>
+      <p:sp>
+        <p:nvSpPr>
+          <p:cNvPr id="36" name="Text 33"/>
+          <p:cNvSpPr/>
+          <p:nvPr/>
+        </p:nvSpPr>
+        <p:spPr>
+          <a:xfrm>
+            <a:off x="8211312" y="4151376"/>
+            <a:ext cx="3291840" cy="274320"/>
+          </a:xfrm>
+          <a:prstGeom prst="rect">
+            <a:avLst/>
+          </a:prstGeom>
+          <a:noFill/>
+          <a:ln/>
+        </p:spPr>
+        <p:txBody>
+          <a:bodyPr wrap="square" lIns="0" tIns="0" rIns="0" bIns="0" rtlCol="0" anchor="ctr"/>
+          <a:lstStyle/>
+          <a:p>
+            <a:pPr indent="0" marL="0">
+              <a:buNone/>
+            </a:pPr>
+            <a:r>
+              <a:rPr lang="en-US" sz="1000" b="1" dirty="0">
+                <a:solidFill>
+                  <a:srgbClr val="0B1220"/>
+                </a:solidFill>
+                <a:latin typeface="맑은 고딕" pitchFamily="34" charset="0"/>
+                <a:ea typeface="맑은 고딕" pitchFamily="34" charset="-122"/>
+                <a:cs typeface="맑은 고딕" pitchFamily="34" charset="-120"/>
+              </a:rPr>
+              <a:t>Cotton Lunch Mini Bag (5color)</a:t>
+            </a:r>
+            <a:endParaRPr lang="en-US" sz="1000" dirty="0"/>
+          </a:p>
+        </p:txBody>
+      </p:sp>
+      <p:sp>
+        <p:nvSpPr>
+          <p:cNvPr id="37" name="Text 34"/>
+          <p:cNvSpPr/>
+          <p:nvPr/>
+        </p:nvSpPr>
+        <p:spPr>
+          <a:xfrm>
+            <a:off x="8211312" y="4425696"/>
             <a:ext cx="3291840" cy="256032"/>
           </a:xfrm>
           <a:prstGeom prst="rect">
@@ -12865,13 +13085,13 @@
       </p:sp>
       <p:sp>
         <p:nvSpPr>
-          <p:cNvPr id="32" name="Shape 29"/>
-          <p:cNvSpPr/>
-          <p:nvPr/>
-        </p:nvSpPr>
-        <p:spPr>
-          <a:xfrm>
-            <a:off x="7406640" y="4096512"/>
+          <p:cNvPr id="38" name="Shape 35"/>
+          <p:cNvSpPr/>
+          <p:nvPr/>
+        </p:nvSpPr>
+        <p:spPr>
+          <a:xfrm>
+            <a:off x="7406640" y="4809744"/>
             <a:ext cx="4206240" cy="640080"/>
           </a:xfrm>
           <a:prstGeom prst="rect">
@@ -12890,13 +13110,13 @@
       </p:sp>
       <p:sp>
         <p:nvSpPr>
-          <p:cNvPr id="33" name="Shape 30"/>
-          <p:cNvSpPr/>
-          <p:nvPr/>
-        </p:nvSpPr>
-        <p:spPr>
-          <a:xfrm>
-            <a:off x="7406640" y="4096512"/>
+          <p:cNvPr id="39" name="Shape 36"/>
+          <p:cNvSpPr/>
+          <p:nvPr/>
+        </p:nvSpPr>
+        <p:spPr>
+          <a:xfrm>
+            <a:off x="7406640" y="4809744"/>
             <a:ext cx="109728" cy="640080"/>
           </a:xfrm>
           <a:prstGeom prst="rect">
@@ -12915,13 +13135,13 @@
       </p:sp>
       <p:sp>
         <p:nvSpPr>
-          <p:cNvPr id="34" name="Shape 31"/>
-          <p:cNvSpPr/>
-          <p:nvPr/>
-        </p:nvSpPr>
-        <p:spPr>
-          <a:xfrm>
-            <a:off x="7571232" y="4187952"/>
+          <p:cNvPr id="40" name="Shape 37"/>
+          <p:cNvSpPr/>
+          <p:nvPr/>
+        </p:nvSpPr>
+        <p:spPr>
+          <a:xfrm>
+            <a:off x="7571232" y="4901184"/>
             <a:ext cx="548640" cy="256032"/>
           </a:xfrm>
           <a:prstGeom prst="rect">
@@ -12940,13 +13160,13 @@
       </p:sp>
       <p:sp>
         <p:nvSpPr>
-          <p:cNvPr id="35" name="Text 32"/>
-          <p:cNvSpPr/>
-          <p:nvPr/>
-        </p:nvSpPr>
-        <p:spPr>
-          <a:xfrm>
-            <a:off x="7571232" y="4187952"/>
+          <p:cNvPr id="41" name="Text 38"/>
+          <p:cNvSpPr/>
+          <p:nvPr/>
+        </p:nvSpPr>
+        <p:spPr>
+          <a:xfrm>
+            <a:off x="7571232" y="4901184"/>
             <a:ext cx="548640" cy="256032"/>
           </a:xfrm>
           <a:prstGeom prst="rect">
@@ -12979,13 +13199,13 @@
       </p:sp>
       <p:sp>
         <p:nvSpPr>
-          <p:cNvPr id="36" name="Text 33"/>
-          <p:cNvSpPr/>
-          <p:nvPr/>
-        </p:nvSpPr>
-        <p:spPr>
-          <a:xfrm>
-            <a:off x="8211312" y="4151376"/>
+          <p:cNvPr id="42" name="Text 39"/>
+          <p:cNvSpPr/>
+          <p:nvPr/>
+        </p:nvSpPr>
+        <p:spPr>
+          <a:xfrm>
+            <a:off x="8211312" y="4864608"/>
             <a:ext cx="3291840" cy="274320"/>
           </a:xfrm>
           <a:prstGeom prst="rect">
@@ -13018,13 +13238,13 @@
       </p:sp>
       <p:sp>
         <p:nvSpPr>
-          <p:cNvPr id="37" name="Text 34"/>
-          <p:cNvSpPr/>
-          <p:nvPr/>
-        </p:nvSpPr>
-        <p:spPr>
-          <a:xfrm>
-            <a:off x="8211312" y="4425696"/>
+          <p:cNvPr id="43" name="Text 40"/>
+          <p:cNvSpPr/>
+          <p:nvPr/>
+        </p:nvSpPr>
+        <p:spPr>
+          <a:xfrm>
+            <a:off x="8211312" y="5138928"/>
             <a:ext cx="3291840" cy="256032"/>
           </a:xfrm>
           <a:prstGeom prst="rect">
@@ -13085,13 +13305,13 @@
       </p:sp>
       <p:sp>
         <p:nvSpPr>
-          <p:cNvPr id="38" name="Shape 35"/>
-          <p:cNvSpPr/>
-          <p:nvPr/>
-        </p:nvSpPr>
-        <p:spPr>
-          <a:xfrm>
-            <a:off x="7406640" y="4809744"/>
+          <p:cNvPr id="44" name="Shape 41"/>
+          <p:cNvSpPr/>
+          <p:nvPr/>
+        </p:nvSpPr>
+        <p:spPr>
+          <a:xfrm>
+            <a:off x="7406640" y="5522976"/>
             <a:ext cx="4206240" cy="640080"/>
           </a:xfrm>
           <a:prstGeom prst="rect">
@@ -13110,13 +13330,13 @@
       </p:sp>
       <p:sp>
         <p:nvSpPr>
-          <p:cNvPr id="39" name="Shape 36"/>
-          <p:cNvSpPr/>
-          <p:nvPr/>
-        </p:nvSpPr>
-        <p:spPr>
-          <a:xfrm>
-            <a:off x="7406640" y="4809744"/>
+          <p:cNvPr id="45" name="Shape 42"/>
+          <p:cNvSpPr/>
+          <p:nvPr/>
+        </p:nvSpPr>
+        <p:spPr>
+          <a:xfrm>
+            <a:off x="7406640" y="5522976"/>
             <a:ext cx="109728" cy="640080"/>
           </a:xfrm>
           <a:prstGeom prst="rect">
@@ -13135,13 +13355,13 @@
       </p:sp>
       <p:sp>
         <p:nvSpPr>
-          <p:cNvPr id="40" name="Shape 37"/>
-          <p:cNvSpPr/>
-          <p:nvPr/>
-        </p:nvSpPr>
-        <p:spPr>
-          <a:xfrm>
-            <a:off x="7571232" y="4901184"/>
+          <p:cNvPr id="46" name="Shape 43"/>
+          <p:cNvSpPr/>
+          <p:nvPr/>
+        </p:nvSpPr>
+        <p:spPr>
+          <a:xfrm>
+            <a:off x="7571232" y="5614416"/>
             <a:ext cx="548640" cy="256032"/>
           </a:xfrm>
           <a:prstGeom prst="rect">
@@ -13160,13 +13380,13 @@
       </p:sp>
       <p:sp>
         <p:nvSpPr>
-          <p:cNvPr id="41" name="Text 38"/>
-          <p:cNvSpPr/>
-          <p:nvPr/>
-        </p:nvSpPr>
-        <p:spPr>
-          <a:xfrm>
-            <a:off x="7571232" y="4901184"/>
+          <p:cNvPr id="47" name="Text 44"/>
+          <p:cNvSpPr/>
+          <p:nvPr/>
+        </p:nvSpPr>
+        <p:spPr>
+          <a:xfrm>
+            <a:off x="7571232" y="5614416"/>
             <a:ext cx="548640" cy="256032"/>
           </a:xfrm>
           <a:prstGeom prst="rect">
@@ -13199,13 +13419,13 @@
       </p:sp>
       <p:sp>
         <p:nvSpPr>
-          <p:cNvPr id="42" name="Text 39"/>
-          <p:cNvSpPr/>
-          <p:nvPr/>
-        </p:nvSpPr>
-        <p:spPr>
-          <a:xfrm>
-            <a:off x="8211312" y="4864608"/>
+          <p:cNvPr id="48" name="Text 45"/>
+          <p:cNvSpPr/>
+          <p:nvPr/>
+        </p:nvSpPr>
+        <p:spPr>
+          <a:xfrm>
+            <a:off x="8211312" y="5577840"/>
             <a:ext cx="3291840" cy="274320"/>
           </a:xfrm>
           <a:prstGeom prst="rect">
@@ -13238,13 +13458,13 @@
       </p:sp>
       <p:sp>
         <p:nvSpPr>
-          <p:cNvPr id="43" name="Text 40"/>
-          <p:cNvSpPr/>
-          <p:nvPr/>
-        </p:nvSpPr>
-        <p:spPr>
-          <a:xfrm>
-            <a:off x="8211312" y="5138928"/>
+          <p:cNvPr id="49" name="Text 46"/>
+          <p:cNvSpPr/>
+          <p:nvPr/>
+        </p:nvSpPr>
+        <p:spPr>
+          <a:xfrm>
+            <a:off x="8211312" y="5852160"/>
             <a:ext cx="3291840" cy="256032"/>
           </a:xfrm>
           <a:prstGeom prst="rect">
@@ -13305,167 +13525,14 @@
       </p:sp>
       <p:sp>
         <p:nvSpPr>
-          <p:cNvPr id="44" name="Shape 41"/>
-          <p:cNvSpPr/>
-          <p:nvPr/>
-        </p:nvSpPr>
-        <p:spPr>
-          <a:xfrm>
-            <a:off x="7406640" y="5522976"/>
-            <a:ext cx="4206240" cy="640080"/>
-          </a:xfrm>
-          <a:prstGeom prst="rect">
-            <a:avLst/>
-          </a:prstGeom>
-          <a:solidFill>
-            <a:srgbClr val="FFF5F5"/>
-          </a:solidFill>
-          <a:ln w="6350">
-            <a:solidFill>
-              <a:srgbClr val="E5E7EB"/>
-            </a:solidFill>
-            <a:prstDash val="solid"/>
-          </a:ln>
-        </p:spPr>
-      </p:sp>
-      <p:sp>
-        <p:nvSpPr>
-          <p:cNvPr id="45" name="Shape 42"/>
-          <p:cNvSpPr/>
-          <p:nvPr/>
-        </p:nvSpPr>
-        <p:spPr>
-          <a:xfrm>
-            <a:off x="7406640" y="5522976"/>
-            <a:ext cx="109728" cy="640080"/>
-          </a:xfrm>
-          <a:prstGeom prst="rect">
-            <a:avLst/>
-          </a:prstGeom>
-          <a:solidFill>
-            <a:srgbClr val="D72638"/>
-          </a:solidFill>
-          <a:ln w="12700">
-            <a:solidFill>
-              <a:srgbClr val="D72638"/>
-            </a:solidFill>
-            <a:prstDash val="solid"/>
-          </a:ln>
-        </p:spPr>
-      </p:sp>
-      <p:sp>
-        <p:nvSpPr>
-          <p:cNvPr id="46" name="Shape 43"/>
-          <p:cNvSpPr/>
-          <p:nvPr/>
-        </p:nvSpPr>
-        <p:spPr>
-          <a:xfrm>
-            <a:off x="7571232" y="5614416"/>
-            <a:ext cx="548640" cy="256032"/>
-          </a:xfrm>
-          <a:prstGeom prst="rect">
-            <a:avLst/>
-          </a:prstGeom>
-          <a:solidFill>
-            <a:srgbClr val="D72638"/>
-          </a:solidFill>
-          <a:ln w="12700">
-            <a:solidFill>
-              <a:srgbClr val="D72638"/>
-            </a:solidFill>
-            <a:prstDash val="solid"/>
-          </a:ln>
-        </p:spPr>
-      </p:sp>
-      <p:sp>
-        <p:nvSpPr>
-          <p:cNvPr id="47" name="Text 44"/>
-          <p:cNvSpPr/>
-          <p:nvPr/>
-        </p:nvSpPr>
-        <p:spPr>
-          <a:xfrm>
-            <a:off x="7571232" y="5614416"/>
-            <a:ext cx="548640" cy="256032"/>
-          </a:xfrm>
-          <a:prstGeom prst="rect">
-            <a:avLst/>
-          </a:prstGeom>
-          <a:noFill/>
-          <a:ln/>
-        </p:spPr>
-        <p:txBody>
-          <a:bodyPr wrap="square" lIns="0" tIns="0" rIns="0" bIns="0" rtlCol="0" anchor="ctr"/>
-          <a:lstStyle/>
-          <a:p>
-            <a:pPr algn="ctr" indent="0" marL="0">
-              <a:buNone/>
-            </a:pPr>
-            <a:r>
-              <a:rPr lang="en-US" sz="900" b="1" dirty="0">
-                <a:solidFill>
-                  <a:srgbClr val="FFFFFF"/>
-                </a:solidFill>
-                <a:latin typeface="맑은 고딕" pitchFamily="34" charset="0"/>
-                <a:ea typeface="맑은 고딕" pitchFamily="34" charset="-122"/>
-                <a:cs typeface="맑은 고딕" pitchFamily="34" charset="-120"/>
-              </a:rPr>
-              <a:t>긴급</a:t>
-            </a:r>
-            <a:endParaRPr lang="en-US" sz="900" dirty="0"/>
-          </a:p>
-        </p:txBody>
-      </p:sp>
-      <p:sp>
-        <p:nvSpPr>
-          <p:cNvPr id="48" name="Text 45"/>
-          <p:cNvSpPr/>
-          <p:nvPr/>
-        </p:nvSpPr>
-        <p:spPr>
-          <a:xfrm>
-            <a:off x="8211312" y="5577840"/>
-            <a:ext cx="3291840" cy="274320"/>
-          </a:xfrm>
-          <a:prstGeom prst="rect">
-            <a:avLst/>
-          </a:prstGeom>
-          <a:noFill/>
-          <a:ln/>
-        </p:spPr>
-        <p:txBody>
-          <a:bodyPr wrap="square" lIns="0" tIns="0" rIns="0" bIns="0" rtlCol="0" anchor="ctr"/>
-          <a:lstStyle/>
-          <a:p>
-            <a:pPr indent="0" marL="0">
-              <a:buNone/>
-            </a:pPr>
-            <a:r>
-              <a:rPr lang="en-US" sz="1000" b="1" dirty="0">
-                <a:solidFill>
-                  <a:srgbClr val="0B1220"/>
-                </a:solidFill>
-                <a:latin typeface="맑은 고딕" pitchFamily="34" charset="0"/>
-                <a:ea typeface="맑은 고딕" pitchFamily="34" charset="-122"/>
-                <a:cs typeface="맑은 고딕" pitchFamily="34" charset="-120"/>
-              </a:rPr>
-              <a:t>Light UV 99.9 Umbrella (7color)</a:t>
-            </a:r>
-            <a:endParaRPr lang="en-US" sz="1000" dirty="0"/>
-          </a:p>
-        </p:txBody>
-      </p:sp>
-      <p:sp>
-        <p:nvSpPr>
-          <p:cNvPr id="49" name="Text 46"/>
-          <p:cNvSpPr/>
-          <p:nvPr/>
-        </p:nvSpPr>
-        <p:spPr>
-          <a:xfrm>
-            <a:off x="8211312" y="5852160"/>
-            <a:ext cx="3291840" cy="256032"/>
+          <p:cNvPr id="50" name="Text 47"/>
+          <p:cNvSpPr/>
+          <p:nvPr/>
+        </p:nvSpPr>
+        <p:spPr>
+          <a:xfrm>
+            <a:off x="548640" y="6492240"/>
+            <a:ext cx="7315200" cy="274320"/>
           </a:xfrm>
           <a:prstGeom prst="rect">
             <a:avLst/>
@@ -13489,74 +13556,7 @@
                 <a:ea typeface="맑은 고딕" pitchFamily="34" charset="-122"/>
                 <a:cs typeface="맑은 고딕" pitchFamily="34" charset="-120"/>
               </a:rPr>
-              <a:t>컬러: 블랙  ·  재고 0개</a:t>
-            </a:r>
-            <a:pPr indent="0" marL="0">
-              <a:buNone/>
-            </a:pPr>
-            <a:r>
-              <a:rPr lang="en-US" sz="1000" dirty="0">
-                <a:solidFill>
-                  <a:srgbClr val="6B7280"/>
-                </a:solidFill>
-                <a:latin typeface="맑은 고딕" pitchFamily="34" charset="0"/>
-                <a:ea typeface="맑은 고딕" pitchFamily="34" charset="-122"/>
-                <a:cs typeface="맑은 고딕" pitchFamily="34" charset="-120"/>
-              </a:rPr>
-              <a:t/>
-            </a:r>
-            <a:pPr indent="0" marL="0">
-              <a:buNone/>
-            </a:pPr>
-            <a:r>
-              <a:rPr lang="en-US" sz="1000" b="1" dirty="0">
-                <a:solidFill>
-                  <a:srgbClr val="D72638"/>
-                </a:solidFill>
-                <a:latin typeface="맑은 고딕" pitchFamily="34" charset="0"/>
-                <a:ea typeface="맑은 고딕" pitchFamily="34" charset="-122"/>
-                <a:cs typeface="맑은 고딕" pitchFamily="34" charset="-120"/>
-              </a:rPr>
-              <a:t/>
-            </a:r>
-            <a:endParaRPr lang="en-US" sz="900" dirty="0"/>
-          </a:p>
-        </p:txBody>
-      </p:sp>
-      <p:sp>
-        <p:nvSpPr>
-          <p:cNvPr id="50" name="Text 47"/>
-          <p:cNvSpPr/>
-          <p:nvPr/>
-        </p:nvSpPr>
-        <p:spPr>
-          <a:xfrm>
-            <a:off x="548640" y="6492240"/>
-            <a:ext cx="7315200" cy="274320"/>
-          </a:xfrm>
-          <a:prstGeom prst="rect">
-            <a:avLst/>
-          </a:prstGeom>
-          <a:noFill/>
-          <a:ln/>
-        </p:spPr>
-        <p:txBody>
-          <a:bodyPr wrap="square" lIns="0" tIns="0" rIns="0" bIns="0" rtlCol="0" anchor="ctr"/>
-          <a:lstStyle/>
-          <a:p>
-            <a:pPr indent="0" marL="0">
-              <a:buNone/>
-            </a:pPr>
-            <a:r>
-              <a:rPr lang="en-US" sz="900" dirty="0">
-                <a:solidFill>
-                  <a:srgbClr val="6B7280"/>
-                </a:solidFill>
-                <a:latin typeface="맑은 고딕" pitchFamily="34" charset="0"/>
-                <a:ea typeface="맑은 고딕" pitchFamily="34" charset="-122"/>
-                <a:cs typeface="맑은 고딕" pitchFamily="34" charset="-120"/>
-              </a:rPr>
-              <a:t>베스트 상품 리포트  ·  생성 2026-05-22 08:00</a:t>
+              <a:t>베스트 상품 리포트  ·  생성 2026-05-23 08:00</a:t>
             </a:r>
             <a:endParaRPr lang="en-US" sz="900" dirty="0"/>
           </a:p>
@@ -13769,7 +13769,7 @@
                 <a:ea typeface="맑은 고딕" pitchFamily="34" charset="-122"/>
                 <a:cs typeface="맑은 고딕" pitchFamily="34" charset="-120"/>
               </a:rPr>
-              <a:t>2026년 05월 22일 (금)</a:t>
+              <a:t>2026년 05월 23일 (토)</a:t>
             </a:r>
             <a:endParaRPr lang="en-US" sz="1200" dirty="0"/>
           </a:p>
@@ -13897,7 +13897,7 @@
                 <a:ea typeface="맑은 고딕" pitchFamily="34" charset="-122"/>
                 <a:cs typeface="맑은 고딕" pitchFamily="34" charset="-120"/>
               </a:rPr>
-              <a:t>🚨  긴급 리오더 68건    ·    주의 리오더 11건    ·    오늘 발주 검토 필수</a:t>
+              <a:t>🚨  긴급 리오더 67건    ·    주의 리오더 9건    ·    오늘 발주 검토 필수</a:t>
             </a:r>
             <a:pPr indent="0" marL="0">
               <a:buNone/>
@@ -14595,7 +14595,7 @@
                           <a:ea typeface="맑은 고딕" pitchFamily="34" charset="-122"/>
                           <a:cs typeface="맑은 고딕" pitchFamily="34" charset="-120"/>
                         </a:rPr>
-                        <a:t>ELECTRONIC</a:t>
+                        <a:t>ETC</a:t>
                       </a:r>
                       <a:endParaRPr lang="en-US" sz="1000" dirty="0">
                         <a:latin typeface="맑은 고딕" charset="0"/>
@@ -14663,7 +14663,7 @@
                           <a:ea typeface="맑은 고딕" pitchFamily="34" charset="-122"/>
                           <a:cs typeface="맑은 고딕" pitchFamily="34" charset="-120"/>
                         </a:rPr>
-                        <a:t>Jacquard Fast Charging Cable (7color) (컬러: 블루 / 기종옵션: C-Apple 8pin / 길이: 2m)</a:t>
+                        <a:t>Cotton Lunch Mini Bag (5color) (색상: 레드)</a:t>
                       </a:r>
                       <a:endParaRPr lang="en-US" sz="1100" dirty="0">
                         <a:latin typeface="맑은 고딕" charset="0"/>
@@ -14731,7 +14731,7 @@
                           <a:ea typeface="맑은 고딕" pitchFamily="34" charset="-122"/>
                           <a:cs typeface="맑은 고딕" pitchFamily="34" charset="-120"/>
                         </a:rPr>
-                        <a:t>20</a:t>
+                        <a:t>0</a:t>
                       </a:r>
                       <a:endParaRPr lang="en-US" sz="1100" dirty="0">
                         <a:latin typeface="맑은 고딕" charset="0"/>
@@ -14799,7 +14799,7 @@
                           <a:ea typeface="맑은 고딕" pitchFamily="34" charset="-122"/>
                           <a:cs typeface="맑은 고딕" pitchFamily="34" charset="-120"/>
                         </a:rPr>
-                        <a:t>4 개</a:t>
+                        <a:t>8 개</a:t>
                       </a:r>
                       <a:endParaRPr lang="en-US" sz="1100" dirty="0">
                         <a:latin typeface="맑은 고딕" charset="0"/>
@@ -14937,7 +14937,7 @@
                           <a:ea typeface="맑은 고딕" pitchFamily="34" charset="-122"/>
                           <a:cs typeface="맑은 고딕" pitchFamily="34" charset="-120"/>
                         </a:rPr>
-                        <a:t>PR</a:t>
+                        <a:t>CT</a:t>
                       </a:r>
                       <a:endParaRPr lang="en-US" sz="1100" dirty="0">
                         <a:latin typeface="맑은 고딕" charset="0"/>
@@ -15005,7 +15005,7 @@
                           <a:ea typeface="맑은 고딕" pitchFamily="34" charset="-122"/>
                           <a:cs typeface="맑은 고딕" pitchFamily="34" charset="-120"/>
                         </a:rPr>
-                        <a:t>ETC</a:t>
+                        <a:t>Ring</a:t>
                       </a:r>
                       <a:endParaRPr lang="en-US" sz="1000" dirty="0">
                         <a:latin typeface="맑은 고딕" charset="0"/>
@@ -15073,7 +15073,7 @@
                           <a:ea typeface="맑은 고딕" pitchFamily="34" charset="-122"/>
                           <a:cs typeface="맑은 고딕" pitchFamily="34" charset="-120"/>
                         </a:rPr>
-                        <a:t>Padded Color Pouch (4color) (컬러: 오렌지)</a:t>
+                        <a:t>"Linkrace" 925 Open Ring</a:t>
                       </a:r>
                       <a:endParaRPr lang="en-US" sz="1100" dirty="0">
                         <a:latin typeface="맑은 고딕" charset="0"/>
@@ -15141,7 +15141,7 @@
                           <a:ea typeface="맑은 고딕" pitchFamily="34" charset="-122"/>
                           <a:cs typeface="맑은 고딕" pitchFamily="34" charset="-120"/>
                         </a:rPr>
-                        <a:t>16</a:t>
+                        <a:t>0</a:t>
                       </a:r>
                       <a:endParaRPr lang="en-US" sz="1100" dirty="0">
                         <a:latin typeface="맑은 고딕" charset="0"/>
@@ -15347,7 +15347,7 @@
                           <a:ea typeface="맑은 고딕" pitchFamily="34" charset="-122"/>
                           <a:cs typeface="맑은 고딕" pitchFamily="34" charset="-120"/>
                         </a:rPr>
-                        <a:t>CT</a:t>
+                        <a:t>6A</a:t>
                       </a:r>
                       <a:endParaRPr lang="en-US" sz="1100" dirty="0">
                         <a:latin typeface="맑은 고딕" charset="0"/>
@@ -15415,7 +15415,7 @@
                           <a:ea typeface="맑은 고딕" pitchFamily="34" charset="-122"/>
                           <a:cs typeface="맑은 고딕" pitchFamily="34" charset="-120"/>
                         </a:rPr>
-                        <a:t>Ring</a:t>
+                        <a:t>Necklace</a:t>
                       </a:r>
                       <a:endParaRPr lang="en-US" sz="1000" dirty="0">
                         <a:latin typeface="맑은 고딕" charset="0"/>
@@ -15483,7 +15483,7 @@
                           <a:ea typeface="맑은 고딕" pitchFamily="34" charset="-122"/>
                           <a:cs typeface="맑은 고딕" pitchFamily="34" charset="-120"/>
                         </a:rPr>
-                        <a:t>"Linkrace" 925 Open Ring</a:t>
+                        <a:t>B-Flower Necklace (Size: 2 Size)</a:t>
                       </a:r>
                       <a:endParaRPr lang="en-US" sz="1100" dirty="0">
                         <a:latin typeface="맑은 고딕" charset="0"/>
@@ -15551,7 +15551,7 @@
                           <a:ea typeface="맑은 고딕" pitchFamily="34" charset="-122"/>
                           <a:cs typeface="맑은 고딕" pitchFamily="34" charset="-120"/>
                         </a:rPr>
-                        <a:t>4</a:t>
+                        <a:t>0</a:t>
                       </a:r>
                       <a:endParaRPr lang="en-US" sz="1100" dirty="0">
                         <a:latin typeface="맑은 고딕" charset="0"/>
@@ -15757,7 +15757,7 @@
                           <a:ea typeface="맑은 고딕" pitchFamily="34" charset="-122"/>
                           <a:cs typeface="맑은 고딕" pitchFamily="34" charset="-120"/>
                         </a:rPr>
-                        <a:t>6A</a:t>
+                        <a:t>PR</a:t>
                       </a:r>
                       <a:endParaRPr lang="en-US" sz="1100" dirty="0">
                         <a:latin typeface="맑은 고딕" charset="0"/>
@@ -15825,7 +15825,7 @@
                           <a:ea typeface="맑은 고딕" pitchFamily="34" charset="-122"/>
                           <a:cs typeface="맑은 고딕" pitchFamily="34" charset="-120"/>
                         </a:rPr>
-                        <a:t>★Season off★</a:t>
+                        <a:t>ELECTRONIC</a:t>
                       </a:r>
                       <a:endParaRPr lang="en-US" sz="1000" dirty="0">
                         <a:latin typeface="맑은 고딕" charset="0"/>
@@ -15893,7 +15893,7 @@
                           <a:ea typeface="맑은 고딕" pitchFamily="34" charset="-122"/>
                           <a:cs typeface="맑은 고딕" pitchFamily="34" charset="-120"/>
                         </a:rPr>
-                        <a:t>8-Ball Smart Tok</a:t>
+                        <a:t>Jacquard Fast Charging Cable (7color) (컬러: 블루 / 기종옵션: C-Apple 8pin / 길이: 2m)</a:t>
                       </a:r>
                       <a:endParaRPr lang="en-US" sz="1100" dirty="0">
                         <a:latin typeface="맑은 고딕" charset="0"/>
@@ -15961,7 +15961,7 @@
                           <a:ea typeface="맑은 고딕" pitchFamily="34" charset="-122"/>
                           <a:cs typeface="맑은 고딕" pitchFamily="34" charset="-120"/>
                         </a:rPr>
-                        <a:t>4</a:t>
+                        <a:t>18</a:t>
                       </a:r>
                       <a:endParaRPr lang="en-US" sz="1100" dirty="0">
                         <a:latin typeface="맑은 고딕" charset="0"/>
@@ -16029,7 +16029,7 @@
                           <a:ea typeface="맑은 고딕" pitchFamily="34" charset="-122"/>
                           <a:cs typeface="맑은 고딕" pitchFamily="34" charset="-120"/>
                         </a:rPr>
-                        <a:t>1 개</a:t>
+                        <a:t>2 개</a:t>
                       </a:r>
                       <a:endParaRPr lang="en-US" sz="1100" dirty="0">
                         <a:latin typeface="맑은 고딕" charset="0"/>
@@ -16303,7 +16303,7 @@
                           <a:ea typeface="맑은 고딕" pitchFamily="34" charset="-122"/>
                           <a:cs typeface="맑은 고딕" pitchFamily="34" charset="-120"/>
                         </a:rPr>
-                        <a:t>B-Flower Necklace (Size: 2 Size)</a:t>
+                        <a:t>Chainlink Necklace</a:t>
                       </a:r>
                       <a:endParaRPr lang="en-US" sz="1100" dirty="0">
                         <a:latin typeface="맑은 고딕" charset="0"/>
@@ -16371,7 +16371,7 @@
                           <a:ea typeface="맑은 고딕" pitchFamily="34" charset="-122"/>
                           <a:cs typeface="맑은 고딕" pitchFamily="34" charset="-120"/>
                         </a:rPr>
-                        <a:t>2</a:t>
+                        <a:t>1</a:t>
                       </a:r>
                       <a:endParaRPr lang="en-US" sz="1100" dirty="0">
                         <a:latin typeface="맑은 고딕" charset="0"/>
@@ -16713,7 +16713,7 @@
                           <a:ea typeface="맑은 고딕" pitchFamily="34" charset="-122"/>
                           <a:cs typeface="맑은 고딕" pitchFamily="34" charset="-120"/>
                         </a:rPr>
-                        <a:t>"Mlayer" 925 Open Ring</a:t>
+                        <a:t>"Crackave" 925 Open Ring</a:t>
                       </a:r>
                       <a:endParaRPr lang="en-US" sz="1100" dirty="0">
                         <a:latin typeface="맑은 고딕" charset="0"/>
@@ -16987,7 +16987,7 @@
                           <a:ea typeface="맑은 고딕" pitchFamily="34" charset="-122"/>
                           <a:cs typeface="맑은 고딕" pitchFamily="34" charset="-120"/>
                         </a:rPr>
-                        <a:t>CT</a:t>
+                        <a:t>PR</a:t>
                       </a:r>
                       <a:endParaRPr lang="en-US" sz="1100" dirty="0">
                         <a:latin typeface="맑은 고딕" charset="0"/>
@@ -17055,7 +17055,7 @@
                           <a:ea typeface="맑은 고딕" pitchFamily="34" charset="-122"/>
                           <a:cs typeface="맑은 고딕" pitchFamily="34" charset="-120"/>
                         </a:rPr>
-                        <a:t>Ring</a:t>
+                        <a:t>ELECTRONIC</a:t>
                       </a:r>
                       <a:endParaRPr lang="en-US" sz="1000" dirty="0">
                         <a:latin typeface="맑은 고딕" charset="0"/>
@@ -17123,7 +17123,7 @@
                           <a:ea typeface="맑은 고딕" pitchFamily="34" charset="-122"/>
                           <a:cs typeface="맑은 고딕" pitchFamily="34" charset="-120"/>
                         </a:rPr>
-                        <a:t>"Giethoorn" 925 Open Ring</a:t>
+                        <a:t>Jacquard Fast Charging Cable (7color) (컬러: 퍼플 / 기종옵션: C-Apple 8pin / 길이: 2m)</a:t>
                       </a:r>
                       <a:endParaRPr lang="en-US" sz="1100" dirty="0">
                         <a:latin typeface="맑은 고딕" charset="0"/>
@@ -17191,7 +17191,7 @@
                           <a:ea typeface="맑은 고딕" pitchFamily="34" charset="-122"/>
                           <a:cs typeface="맑은 고딕" pitchFamily="34" charset="-120"/>
                         </a:rPr>
-                        <a:t>0</a:t>
+                        <a:t>10</a:t>
                       </a:r>
                       <a:endParaRPr lang="en-US" sz="1100" dirty="0">
                         <a:latin typeface="맑은 고딕" charset="0"/>
@@ -17397,7 +17397,7 @@
                           <a:ea typeface="맑은 고딕" pitchFamily="34" charset="-122"/>
                           <a:cs typeface="맑은 고딕" pitchFamily="34" charset="-120"/>
                         </a:rPr>
-                        <a:t>PR</a:t>
+                        <a:t>6A</a:t>
                       </a:r>
                       <a:endParaRPr lang="en-US" sz="1100" dirty="0">
                         <a:latin typeface="맑은 고딕" charset="0"/>
@@ -17465,7 +17465,7 @@
                           <a:ea typeface="맑은 고딕" pitchFamily="34" charset="-122"/>
                           <a:cs typeface="맑은 고딕" pitchFamily="34" charset="-120"/>
                         </a:rPr>
-                        <a:t>ETC</a:t>
+                        <a:t>★Season off★</a:t>
                       </a:r>
                       <a:endParaRPr lang="en-US" sz="1000" dirty="0">
                         <a:latin typeface="맑은 고딕" charset="0"/>
@@ -17533,7 +17533,7 @@
                           <a:ea typeface="맑은 고딕" pitchFamily="34" charset="-122"/>
                           <a:cs typeface="맑은 고딕" pitchFamily="34" charset="-120"/>
                         </a:rPr>
-                        <a:t>360° Rotating Phone Holder (컬러: 화이트)</a:t>
+                        <a:t>8-Ball Smart Tok</a:t>
                       </a:r>
                       <a:endParaRPr lang="en-US" sz="1100" dirty="0">
                         <a:latin typeface="맑은 고딕" charset="0"/>
@@ -17601,7 +17601,7 @@
                           <a:ea typeface="맑은 고딕" pitchFamily="34" charset="-122"/>
                           <a:cs typeface="맑은 고딕" pitchFamily="34" charset="-120"/>
                         </a:rPr>
-                        <a:t>14</a:t>
+                        <a:t>4</a:t>
                       </a:r>
                       <a:endParaRPr lang="en-US" sz="1100" dirty="0">
                         <a:latin typeface="맑은 고딕" charset="0"/>
@@ -17669,7 +17669,7 @@
                           <a:ea typeface="맑은 고딕" pitchFamily="34" charset="-122"/>
                           <a:cs typeface="맑은 고딕" pitchFamily="34" charset="-120"/>
                         </a:rPr>
-                        <a:t>1 개</a:t>
+                        <a:t>0 개</a:t>
                       </a:r>
                       <a:endParaRPr lang="en-US" sz="1100" dirty="0">
                         <a:latin typeface="맑은 고딕" charset="0"/>
@@ -17807,7 +17807,7 @@
                           <a:ea typeface="맑은 고딕" pitchFamily="34" charset="-122"/>
                           <a:cs typeface="맑은 고딕" pitchFamily="34" charset="-120"/>
                         </a:rPr>
-                        <a:t>PR</a:t>
+                        <a:t>6A</a:t>
                       </a:r>
                       <a:endParaRPr lang="en-US" sz="1100" dirty="0">
                         <a:latin typeface="맑은 고딕" charset="0"/>
@@ -17875,7 +17875,7 @@
                           <a:ea typeface="맑은 고딕" pitchFamily="34" charset="-122"/>
                           <a:cs typeface="맑은 고딕" pitchFamily="34" charset="-120"/>
                         </a:rPr>
-                        <a:t>ELECTRONIC</a:t>
+                        <a:t>Bracelet</a:t>
                       </a:r>
                       <a:endParaRPr lang="en-US" sz="1000" dirty="0">
                         <a:latin typeface="맑은 고딕" charset="0"/>
@@ -17943,7 +17943,7 @@
                           <a:ea typeface="맑은 고딕" pitchFamily="34" charset="-122"/>
                           <a:cs typeface="맑은 고딕" pitchFamily="34" charset="-120"/>
                         </a:rPr>
-                        <a:t>Jacquard Fast Charging Cable (7color) (컬러: 퍼플 / 기종옵션: C-Apple 8pin / 길이: 2m)</a:t>
+                        <a:t>Two-ball Bangle</a:t>
                       </a:r>
                       <a:endParaRPr lang="en-US" sz="1100" dirty="0">
                         <a:latin typeface="맑은 고딕" charset="0"/>
@@ -18011,7 +18011,7 @@
                           <a:ea typeface="맑은 고딕" pitchFamily="34" charset="-122"/>
                           <a:cs typeface="맑은 고딕" pitchFamily="34" charset="-120"/>
                         </a:rPr>
-                        <a:t>11</a:t>
+                        <a:t>0</a:t>
                       </a:r>
                       <a:endParaRPr lang="en-US" sz="1100" dirty="0">
                         <a:latin typeface="맑은 고딕" charset="0"/>
@@ -18079,7 +18079,7 @@
                           <a:ea typeface="맑은 고딕" pitchFamily="34" charset="-122"/>
                           <a:cs typeface="맑은 고딕" pitchFamily="34" charset="-120"/>
                         </a:rPr>
-                        <a:t>1 개</a:t>
+                        <a:t>0 개</a:t>
                       </a:r>
                       <a:endParaRPr lang="en-US" sz="1100" dirty="0">
                         <a:latin typeface="맑은 고딕" charset="0"/>
@@ -18168,7 +18168,7 @@
                 <a:ea typeface="맑은 고딕" pitchFamily="34" charset="-122"/>
                 <a:cs typeface="맑은 고딕" pitchFamily="34" charset="-120"/>
               </a:rPr>
-              <a:t>외 59건 더 있음 — 상세는 시트에서 확인</a:t>
+              <a:t>외 58건 더 있음 — 상세는 시트에서 확인</a:t>
             </a:r>
             <a:endParaRPr lang="en-US" sz="1000" dirty="0"/>
           </a:p>
@@ -18207,7 +18207,7 @@
                 <a:ea typeface="맑은 고딕" pitchFamily="34" charset="-122"/>
                 <a:cs typeface="맑은 고딕" pitchFamily="34" charset="-120"/>
               </a:rPr>
-              <a:t>베스트 상품 리포트  ·  생성 2026-05-22 08:00</a:t>
+              <a:t>베스트 상품 리포트  ·  생성 2026-05-23 08:00</a:t>
             </a:r>
             <a:endParaRPr lang="en-US" sz="900" dirty="0"/>
           </a:p>
@@ -18420,7 +18420,7 @@
                 <a:ea typeface="맑은 고딕" pitchFamily="34" charset="-122"/>
                 <a:cs typeface="맑은 고딕" pitchFamily="34" charset="-120"/>
               </a:rPr>
-              <a:t>2026년 05월 22일 (금)</a:t>
+              <a:t>2026년 05월 23일 (토)</a:t>
             </a:r>
             <a:endParaRPr lang="en-US" sz="1200" dirty="0"/>
           </a:p>
@@ -18587,7 +18587,7 @@
                 <a:ea typeface="맑은 고딕" pitchFamily="34" charset="-122"/>
                 <a:cs typeface="맑은 고딕" pitchFamily="34" charset="-120"/>
               </a:rPr>
-              <a:t>Google Sheet '브랜드 재고현황'  ·  최신화 2026-05-22 08:00</a:t>
+              <a:t>Google Sheet '브랜드 재고현황'  ·  최신화 2026-05-23 08:00</a:t>
             </a:r>
             <a:endParaRPr lang="en-US" sz="1100" dirty="0"/>
           </a:p>
@@ -19099,7 +19099,7 @@
                 <a:ea typeface="맑은 고딕" pitchFamily="34" charset="-122"/>
                 <a:cs typeface="맑은 고딕" pitchFamily="34" charset="-120"/>
               </a:rPr>
-              <a:t>✅ 6A 84 SKU  /  ✅ Cleartype 59 SKU  /  ✅ Produktepr 192 SKU (판매 수집됨)</a:t>
+              <a:t>✅ 6A 86 SKU  /  ✅ Cleartype 59 SKU  /  ✅ Produktepr 192 SKU (판매 수집됨)</a:t>
             </a:r>
             <a:endParaRPr lang="en-US" sz="1100" dirty="0"/>
           </a:p>
@@ -19230,7 +19230,7 @@
                 <a:ea typeface="맑은 고딕" pitchFamily="34" charset="-122"/>
                 <a:cs typeface="맑은 고딕" pitchFamily="34" charset="-120"/>
               </a:rPr>
-              <a:t>✅ 3개 브랜드 모두 정상 추출  ·  24h 출고 기준 (2026-05-21 08:00 → 2026-05-22 08:00) · 신규 SKU 12건은 결제완료 기준</a:t>
+              <a:t>✅ 3개 브랜드 모두 정상 추출  ·  24h 출고 기준 (2026-05-22 08:00 → 2026-05-23 08:00) · 신규 SKU 14건은 결제완료 기준</a:t>
             </a:r>
             <a:endParaRPr lang="en-US" sz="1000" dirty="0"/>
           </a:p>
@@ -19269,7 +19269,7 @@
                 <a:ea typeface="맑은 고딕" pitchFamily="34" charset="-122"/>
                 <a:cs typeface="맑은 고딕" pitchFamily="34" charset="-120"/>
               </a:rPr>
-              <a:t>베스트 상품 리포트  ·  생성 2026-05-22 08:00</a:t>
+              <a:t>베스트 상품 리포트  ·  생성 2026-05-23 08:00</a:t>
             </a:r>
             <a:endParaRPr lang="en-US" sz="900" dirty="0"/>
           </a:p>

</xml_diff>

<commit_message>
chore: 매출 PPT 업로드 (best-sellers-2026-05-24.pptx) [auto]
</commit_message>
<xml_diff>
--- a/data/sales-report.pptx
+++ b/data/sales-report.pptx
@@ -1648,7 +1648,7 @@
                 <a:ea typeface="맑은 고딕" pitchFamily="34" charset="-122"/>
                 <a:cs typeface="맑은 고딕" pitchFamily="34" charset="-120"/>
               </a:rPr>
-              <a:t>2026년 05월 23일 (토)  ·  24h 출고 기준</a:t>
+              <a:t>2026년 05월 24일 (일)  ·  24h 출고 기준</a:t>
             </a:r>
             <a:endParaRPr lang="en-US" sz="2200" dirty="0"/>
           </a:p>
@@ -1726,7 +1726,7 @@
                 <a:ea typeface="맑은 고딕" pitchFamily="34" charset="-122"/>
                 <a:cs typeface="맑은 고딕" pitchFamily="34" charset="-120"/>
               </a:rPr>
-              <a:t>05.23</a:t>
+              <a:t>05.24</a:t>
             </a:r>
             <a:endParaRPr lang="en-US" sz="7200" dirty="0"/>
           </a:p>
@@ -1765,7 +1765,7 @@
                 <a:ea typeface="맑은 고딕" pitchFamily="34" charset="-122"/>
                 <a:cs typeface="맑은 고딕" pitchFamily="34" charset="-120"/>
               </a:rPr>
-              <a:t>토요일</a:t>
+              <a:t>일요일</a:t>
             </a:r>
             <a:endParaRPr lang="en-US" sz="1400" dirty="0"/>
           </a:p>
@@ -1804,7 +1804,7 @@
                 <a:ea typeface="맑은 고딕" pitchFamily="34" charset="-122"/>
                 <a:cs typeface="맑은 고딕" pitchFamily="34" charset="-120"/>
               </a:rPr>
-              <a:t>생성 2026-05-23 08:00  ·  Google Sheet 자동 동기</a:t>
+              <a:t>생성 2026-05-24 08:00  ·  Google Sheet 자동 동기</a:t>
             </a:r>
             <a:endParaRPr lang="en-US" sz="1000" dirty="0"/>
           </a:p>
@@ -1978,7 +1978,7 @@
                 <a:ea typeface="맑은 고딕" pitchFamily="34" charset="-122"/>
                 <a:cs typeface="맑은 고딕" pitchFamily="34" charset="-120"/>
               </a:rPr>
-              <a:t>2026년 05월 23일 (토)</a:t>
+              <a:t>2026년 05월 24일 (일)</a:t>
             </a:r>
             <a:endParaRPr lang="en-US" sz="1200" dirty="0"/>
           </a:p>
@@ -2145,7 +2145,7 @@
                 <a:ea typeface="맑은 고딕" pitchFamily="34" charset="-122"/>
                 <a:cs typeface="맑은 고딕" pitchFamily="34" charset="-120"/>
               </a:rPr>
-              <a:t>294 개</a:t>
+              <a:t>497 개</a:t>
             </a:r>
             <a:endParaRPr lang="en-US" sz="3600" dirty="0"/>
           </a:p>
@@ -2312,7 +2312,7 @@
                 <a:ea typeface="맑은 고딕" pitchFamily="34" charset="-122"/>
                 <a:cs typeface="맑은 고딕" pitchFamily="34" charset="-120"/>
               </a:rPr>
-              <a:t>67 건</a:t>
+              <a:t>70 건</a:t>
             </a:r>
             <a:endParaRPr lang="en-US" sz="3200" dirty="0"/>
           </a:p>
@@ -2479,7 +2479,7 @@
                 <a:ea typeface="맑은 고딕" pitchFamily="34" charset="-122"/>
                 <a:cs typeface="맑은 고딕" pitchFamily="34" charset="-120"/>
               </a:rPr>
-              <a:t>9 건</a:t>
+              <a:t>10 건</a:t>
             </a:r>
             <a:endParaRPr lang="en-US" sz="3200" dirty="0"/>
           </a:p>
@@ -3612,7 +3612,7 @@
                           <a:ea typeface="맑은 고딕" pitchFamily="34" charset="-122"/>
                           <a:cs typeface="맑은 고딕" pitchFamily="34" charset="-120"/>
                         </a:rPr>
-                        <a:t>[SILVER925] CH.alban Open Ring</a:t>
+                        <a:t>[SILVER925] Guyeong Open Ring v3.0 (silver)</a:t>
                       </a:r>
                       <a:endParaRPr lang="en-US" sz="1100" dirty="0">
                         <a:latin typeface="맑은 고딕" charset="0"/>
@@ -3677,7 +3677,7 @@
                           <a:ea typeface="맑은 고딕" pitchFamily="34" charset="-122"/>
                           <a:cs typeface="맑은 고딕" pitchFamily="34" charset="-120"/>
                         </a:rPr>
-                        <a:t>36 개</a:t>
+                        <a:t>46 개</a:t>
                       </a:r>
                       <a:endParaRPr lang="en-US" sz="1400" dirty="0">
                         <a:latin typeface="맑은 고딕" charset="0"/>
@@ -4004,7 +4004,7 @@
                           <a:ea typeface="맑은 고딕" pitchFamily="34" charset="-122"/>
                           <a:cs typeface="맑은 고딕" pitchFamily="34" charset="-120"/>
                         </a:rPr>
-                        <a:t>24 개</a:t>
+                        <a:t>46 개</a:t>
                       </a:r>
                       <a:endParaRPr lang="en-US" sz="1400" dirty="0">
                         <a:latin typeface="맑은 고딕" charset="0"/>
@@ -4331,7 +4331,7 @@
                           <a:ea typeface="맑은 고딕" pitchFamily="34" charset="-122"/>
                           <a:cs typeface="맑은 고딕" pitchFamily="34" charset="-120"/>
                         </a:rPr>
-                        <a:t>23 개</a:t>
+                        <a:t>44 개</a:t>
                       </a:r>
                       <a:endParaRPr lang="en-US" sz="1400" dirty="0">
                         <a:latin typeface="맑은 고딕" charset="0"/>
@@ -4593,7 +4593,7 @@
                           <a:ea typeface="맑은 고딕" pitchFamily="34" charset="-122"/>
                           <a:cs typeface="맑은 고딕" pitchFamily="34" charset="-120"/>
                         </a:rPr>
-                        <a:t>[SILVER925] Guyeong Open Ring v3.0 (silver)</a:t>
+                        <a:t>[SILVER925] CH.alban Open Ring</a:t>
                       </a:r>
                       <a:endParaRPr lang="en-US" sz="1100" dirty="0">
                         <a:latin typeface="맑은 고딕" charset="0"/>
@@ -4658,7 +4658,7 @@
                           <a:ea typeface="맑은 고딕" pitchFamily="34" charset="-122"/>
                           <a:cs typeface="맑은 고딕" pitchFamily="34" charset="-120"/>
                         </a:rPr>
-                        <a:t>22 개</a:t>
+                        <a:t>42 개</a:t>
                       </a:r>
                       <a:endParaRPr lang="en-US" sz="1200" dirty="0">
                         <a:latin typeface="맑은 고딕" charset="0"/>
@@ -4790,7 +4790,7 @@
                           <a:ea typeface="맑은 고딕" pitchFamily="34" charset="-122"/>
                           <a:cs typeface="맑은 고딕" pitchFamily="34" charset="-120"/>
                         </a:rPr>
-                        <a:t>6A</a:t>
+                        <a:t>CT</a:t>
                       </a:r>
                       <a:endParaRPr lang="en-US" sz="1100" dirty="0">
                         <a:latin typeface="맑은 고딕" charset="0"/>
@@ -4855,7 +4855,7 @@
                           <a:ea typeface="맑은 고딕" pitchFamily="34" charset="-122"/>
                           <a:cs typeface="맑은 고딕" pitchFamily="34" charset="-120"/>
                         </a:rPr>
-                        <a:t>Ring</a:t>
+                        <a:t>Necklace</a:t>
                       </a:r>
                       <a:endParaRPr lang="en-US" sz="1000" dirty="0">
                         <a:latin typeface="맑은 고딕" charset="0"/>
@@ -4920,7 +4920,7 @@
                           <a:ea typeface="맑은 고딕" pitchFamily="34" charset="-122"/>
                           <a:cs typeface="맑은 고딕" pitchFamily="34" charset="-120"/>
                         </a:rPr>
-                        <a:t>[SILVER925] Mustafakemalpaşa Ring (사이즈: 12호)</a:t>
+                        <a:t>ThreadDuo Necklace</a:t>
                       </a:r>
                       <a:endParaRPr lang="en-US" sz="1100" dirty="0">
                         <a:latin typeface="맑은 고딕" charset="0"/>
@@ -4985,7 +4985,7 @@
                           <a:ea typeface="맑은 고딕" pitchFamily="34" charset="-122"/>
                           <a:cs typeface="맑은 고딕" pitchFamily="34" charset="-120"/>
                         </a:rPr>
-                        <a:t>14 개</a:t>
+                        <a:t>29 개</a:t>
                       </a:r>
                       <a:endParaRPr lang="en-US" sz="1200" dirty="0">
                         <a:latin typeface="맑은 고딕" charset="0"/>
@@ -5071,7 +5071,7 @@
                 <a:ea typeface="맑은 고딕" pitchFamily="34" charset="-122"/>
                 <a:cs typeface="맑은 고딕" pitchFamily="34" charset="-120"/>
               </a:rPr>
-              <a:t>베스트 상품 리포트  ·  생성 2026-05-23 08:00</a:t>
+              <a:t>베스트 상품 리포트  ·  생성 2026-05-24 08:00</a:t>
             </a:r>
             <a:endParaRPr lang="en-US" sz="900" dirty="0"/>
           </a:p>
@@ -5284,7 +5284,7 @@
                 <a:ea typeface="맑은 고딕" pitchFamily="34" charset="-122"/>
                 <a:cs typeface="맑은 고딕" pitchFamily="34" charset="-120"/>
               </a:rPr>
-              <a:t>2026년 05월 23일 (토)</a:t>
+              <a:t>2026년 05월 24일 (일)</a:t>
             </a:r>
             <a:endParaRPr lang="en-US" sz="1200" dirty="0"/>
           </a:p>
@@ -5451,7 +5451,7 @@
                 <a:ea typeface="맑은 고딕" pitchFamily="34" charset="-122"/>
                 <a:cs typeface="맑은 고딕" pitchFamily="34" charset="-120"/>
               </a:rPr>
-              <a:t>215 개</a:t>
+              <a:t>303 개</a:t>
             </a:r>
             <a:endParaRPr lang="en-US" sz="3600" dirty="0"/>
           </a:p>
@@ -5579,7 +5579,7 @@
                 <a:ea typeface="맑은 고딕" pitchFamily="34" charset="-122"/>
                 <a:cs typeface="맑은 고딕" pitchFamily="34" charset="-120"/>
               </a:rPr>
-              <a:t>[SILVER925] CH.alban Open Ring</a:t>
+              <a:t>[SILVER925] Guyeong Open Ring v3.0 (silver)</a:t>
             </a:r>
             <a:endParaRPr lang="en-US" sz="1800" dirty="0"/>
           </a:p>
@@ -5657,7 +5657,7 @@
                 <a:ea typeface="맑은 고딕" pitchFamily="34" charset="-122"/>
                 <a:cs typeface="맑은 고딕" pitchFamily="34" charset="-120"/>
               </a:rPr>
-              <a:t>36</a:t>
+              <a:t>46</a:t>
             </a:r>
             <a:endParaRPr lang="en-US" sz="4400" dirty="0"/>
           </a:p>
@@ -6191,7 +6191,7 @@
                           <a:ea typeface="맑은 고딕" pitchFamily="34" charset="-122"/>
                           <a:cs typeface="맑은 고딕" pitchFamily="34" charset="-120"/>
                         </a:rPr>
-                        <a:t>[SILVER925] CH.alban Open Ring</a:t>
+                        <a:t>[SILVER925] Guyeong Open Ring v3.0 (silver)</a:t>
                       </a:r>
                       <a:endParaRPr lang="en-US" sz="1100" dirty="0">
                         <a:latin typeface="맑은 고딕" charset="0"/>
@@ -6256,7 +6256,7 @@
                           <a:ea typeface="맑은 고딕" pitchFamily="34" charset="-122"/>
                           <a:cs typeface="맑은 고딕" pitchFamily="34" charset="-120"/>
                         </a:rPr>
-                        <a:t>36 개</a:t>
+                        <a:t>46 개</a:t>
                       </a:r>
                       <a:endParaRPr lang="en-US" sz="1400" dirty="0">
                         <a:latin typeface="맑은 고딕" charset="0"/>
@@ -6453,7 +6453,7 @@
                           <a:ea typeface="맑은 고딕" pitchFamily="34" charset="-122"/>
                           <a:cs typeface="맑은 고딕" pitchFamily="34" charset="-120"/>
                         </a:rPr>
-                        <a:t>[SILVER925] Guyeong Open Ring v3.0 (silver)</a:t>
+                        <a:t>[SILVER925] CH.alban Open Ring</a:t>
                       </a:r>
                       <a:endParaRPr lang="en-US" sz="1100" dirty="0">
                         <a:latin typeface="맑은 고딕" charset="0"/>
@@ -6518,7 +6518,7 @@
                           <a:ea typeface="맑은 고딕" pitchFamily="34" charset="-122"/>
                           <a:cs typeface="맑은 고딕" pitchFamily="34" charset="-120"/>
                         </a:rPr>
-                        <a:t>22 개</a:t>
+                        <a:t>42 개</a:t>
                       </a:r>
                       <a:endParaRPr lang="en-US" sz="1200" dirty="0">
                         <a:latin typeface="맑은 고딕" charset="0"/>
@@ -6715,7 +6715,7 @@
                           <a:ea typeface="맑은 고딕" pitchFamily="34" charset="-122"/>
                           <a:cs typeface="맑은 고딕" pitchFamily="34" charset="-120"/>
                         </a:rPr>
-                        <a:t>[SILVER925] Mustafakemalpaşa Ring (사이즈: 12호)</a:t>
+                        <a:t>[SILVER925] Starly Open Ring</a:t>
                       </a:r>
                       <a:endParaRPr lang="en-US" sz="1100" dirty="0">
                         <a:latin typeface="맑은 고딕" charset="0"/>
@@ -6780,7 +6780,7 @@
                           <a:ea typeface="맑은 고딕" pitchFamily="34" charset="-122"/>
                           <a:cs typeface="맑은 고딕" pitchFamily="34" charset="-120"/>
                         </a:rPr>
-                        <a:t>14 개</a:t>
+                        <a:t>19 개</a:t>
                       </a:r>
                       <a:endParaRPr lang="en-US" sz="1200" dirty="0">
                         <a:latin typeface="맑은 고딕" charset="0"/>
@@ -6912,7 +6912,7 @@
                           <a:ea typeface="맑은 고딕" pitchFamily="34" charset="-122"/>
                           <a:cs typeface="맑은 고딕" pitchFamily="34" charset="-120"/>
                         </a:rPr>
-                        <a:t>Ring</a:t>
+                        <a:t>Necklace</a:t>
                       </a:r>
                       <a:endParaRPr lang="en-US" sz="1000" dirty="0">
                         <a:latin typeface="맑은 고딕" charset="0"/>
@@ -6977,7 +6977,7 @@
                           <a:ea typeface="맑은 고딕" pitchFamily="34" charset="-122"/>
                           <a:cs typeface="맑은 고딕" pitchFamily="34" charset="-120"/>
                         </a:rPr>
-                        <a:t>[SILVER925] Kouro Open Ring</a:t>
+                        <a:t>Tiny Cross Necklace</a:t>
                       </a:r>
                       <a:endParaRPr lang="en-US" sz="1100" dirty="0">
                         <a:latin typeface="맑은 고딕" charset="0"/>
@@ -7042,7 +7042,7 @@
                           <a:ea typeface="맑은 고딕" pitchFamily="34" charset="-122"/>
                           <a:cs typeface="맑은 고딕" pitchFamily="34" charset="-120"/>
                         </a:rPr>
-                        <a:t>10 개</a:t>
+                        <a:t>17 개</a:t>
                       </a:r>
                       <a:endParaRPr lang="en-US" sz="1200" dirty="0">
                         <a:latin typeface="맑은 고딕" charset="0"/>
@@ -7239,7 +7239,7 @@
                           <a:ea typeface="맑은 고딕" pitchFamily="34" charset="-122"/>
                           <a:cs typeface="맑은 고딕" pitchFamily="34" charset="-120"/>
                         </a:rPr>
-                        <a:t>[SILVER925] Crown Open Ring</a:t>
+                        <a:t>[SILVER925] A Rua Open Ring</a:t>
                       </a:r>
                       <a:endParaRPr lang="en-US" sz="1100" dirty="0">
                         <a:latin typeface="맑은 고딕" charset="0"/>
@@ -7304,7 +7304,7 @@
                           <a:ea typeface="맑은 고딕" pitchFamily="34" charset="-122"/>
                           <a:cs typeface="맑은 고딕" pitchFamily="34" charset="-120"/>
                         </a:rPr>
-                        <a:t>9 개</a:t>
+                        <a:t>17 개</a:t>
                       </a:r>
                       <a:endParaRPr lang="en-US" sz="1200" dirty="0">
                         <a:latin typeface="맑은 고딕" charset="0"/>
@@ -7390,7 +7390,7 @@
                 <a:ea typeface="맑은 고딕" pitchFamily="34" charset="-122"/>
                 <a:cs typeface="맑은 고딕" pitchFamily="34" charset="-120"/>
               </a:rPr>
-              <a:t>리오더 필요  🔴 긴급 7건</a:t>
+              <a:t>리오더 필요  🔴 긴급 9건</a:t>
             </a:r>
             <a:pPr indent="0" marL="0">
               <a:buNone/>
@@ -7557,7 +7557,7 @@
                 <a:ea typeface="맑은 고딕" pitchFamily="34" charset="-122"/>
                 <a:cs typeface="맑은 고딕" pitchFamily="34" charset="-120"/>
               </a:rPr>
-              <a:t>B-Flower Necklace (Size: 2 Size)</a:t>
+              <a:t>2PT Bracelet</a:t>
             </a:r>
             <a:endParaRPr lang="en-US" sz="1100" dirty="0"/>
           </a:p>
@@ -7572,6 +7572,418 @@
         <p:spPr>
           <a:xfrm>
             <a:off x="8211312" y="3712464"/>
+            <a:ext cx="3291840" cy="256032"/>
+          </a:xfrm>
+          <a:prstGeom prst="rect">
+            <a:avLst/>
+          </a:prstGeom>
+          <a:noFill/>
+          <a:ln/>
+        </p:spPr>
+        <p:txBody>
+          <a:bodyPr wrap="square" lIns="0" tIns="0" rIns="0" bIns="0" rtlCol="0" anchor="ctr"/>
+          <a:lstStyle/>
+          <a:p>
+            <a:pPr indent="0" marL="0">
+              <a:buNone/>
+            </a:pPr>
+            <a:r>
+              <a:rPr lang="en-US" sz="1000" dirty="0">
+                <a:solidFill>
+                  <a:srgbClr val="6B7280"/>
+                </a:solidFill>
+                <a:latin typeface="맑은 고딕" pitchFamily="34" charset="0"/>
+                <a:ea typeface="맑은 고딕" pitchFamily="34" charset="-122"/>
+                <a:cs typeface="맑은 고딕" pitchFamily="34" charset="-120"/>
+              </a:rPr>
+              <a:t>Bracelet  ·  재고 5개</a:t>
+            </a:r>
+            <a:pPr indent="0" marL="0">
+              <a:buNone/>
+            </a:pPr>
+            <a:r>
+              <a:rPr lang="en-US" sz="1000" b="1" dirty="0">
+                <a:solidFill>
+                  <a:srgbClr val="D72638"/>
+                </a:solidFill>
+                <a:latin typeface="맑은 고딕" pitchFamily="34" charset="0"/>
+                <a:ea typeface="맑은 고딕" pitchFamily="34" charset="-122"/>
+                <a:cs typeface="맑은 고딕" pitchFamily="34" charset="-120"/>
+              </a:rPr>
+              <a:t/>
+            </a:r>
+            <a:endParaRPr lang="en-US" sz="1000" dirty="0"/>
+          </a:p>
+        </p:txBody>
+      </p:sp>
+      <p:sp>
+        <p:nvSpPr>
+          <p:cNvPr id="27" name="Shape 24"/>
+          <p:cNvSpPr/>
+          <p:nvPr/>
+        </p:nvSpPr>
+        <p:spPr>
+          <a:xfrm>
+            <a:off x="7406640" y="4096512"/>
+            <a:ext cx="4206240" cy="640080"/>
+          </a:xfrm>
+          <a:prstGeom prst="rect">
+            <a:avLst/>
+          </a:prstGeom>
+          <a:solidFill>
+            <a:srgbClr val="FFF5F5"/>
+          </a:solidFill>
+          <a:ln w="6350">
+            <a:solidFill>
+              <a:srgbClr val="E5E7EB"/>
+            </a:solidFill>
+            <a:prstDash val="solid"/>
+          </a:ln>
+        </p:spPr>
+      </p:sp>
+      <p:sp>
+        <p:nvSpPr>
+          <p:cNvPr id="28" name="Shape 25"/>
+          <p:cNvSpPr/>
+          <p:nvPr/>
+        </p:nvSpPr>
+        <p:spPr>
+          <a:xfrm>
+            <a:off x="7406640" y="4096512"/>
+            <a:ext cx="109728" cy="640080"/>
+          </a:xfrm>
+          <a:prstGeom prst="rect">
+            <a:avLst/>
+          </a:prstGeom>
+          <a:solidFill>
+            <a:srgbClr val="D72638"/>
+          </a:solidFill>
+          <a:ln w="12700">
+            <a:solidFill>
+              <a:srgbClr val="D72638"/>
+            </a:solidFill>
+            <a:prstDash val="solid"/>
+          </a:ln>
+        </p:spPr>
+      </p:sp>
+      <p:sp>
+        <p:nvSpPr>
+          <p:cNvPr id="29" name="Shape 26"/>
+          <p:cNvSpPr/>
+          <p:nvPr/>
+        </p:nvSpPr>
+        <p:spPr>
+          <a:xfrm>
+            <a:off x="7571232" y="4187952"/>
+            <a:ext cx="548640" cy="256032"/>
+          </a:xfrm>
+          <a:prstGeom prst="rect">
+            <a:avLst/>
+          </a:prstGeom>
+          <a:solidFill>
+            <a:srgbClr val="D72638"/>
+          </a:solidFill>
+          <a:ln w="12700">
+            <a:solidFill>
+              <a:srgbClr val="D72638"/>
+            </a:solidFill>
+            <a:prstDash val="solid"/>
+          </a:ln>
+        </p:spPr>
+      </p:sp>
+      <p:sp>
+        <p:nvSpPr>
+          <p:cNvPr id="30" name="Text 27"/>
+          <p:cNvSpPr/>
+          <p:nvPr/>
+        </p:nvSpPr>
+        <p:spPr>
+          <a:xfrm>
+            <a:off x="7571232" y="4187952"/>
+            <a:ext cx="548640" cy="256032"/>
+          </a:xfrm>
+          <a:prstGeom prst="rect">
+            <a:avLst/>
+          </a:prstGeom>
+          <a:noFill/>
+          <a:ln/>
+        </p:spPr>
+        <p:txBody>
+          <a:bodyPr wrap="square" lIns="0" tIns="0" rIns="0" bIns="0" rtlCol="0" anchor="ctr"/>
+          <a:lstStyle/>
+          <a:p>
+            <a:pPr algn="ctr" indent="0" marL="0">
+              <a:buNone/>
+            </a:pPr>
+            <a:r>
+              <a:rPr lang="en-US" sz="900" b="1" dirty="0">
+                <a:solidFill>
+                  <a:srgbClr val="FFFFFF"/>
+                </a:solidFill>
+                <a:latin typeface="맑은 고딕" pitchFamily="34" charset="0"/>
+                <a:ea typeface="맑은 고딕" pitchFamily="34" charset="-122"/>
+                <a:cs typeface="맑은 고딕" pitchFamily="34" charset="-120"/>
+              </a:rPr>
+              <a:t>긴급</a:t>
+            </a:r>
+            <a:endParaRPr lang="en-US" sz="900" dirty="0"/>
+          </a:p>
+        </p:txBody>
+      </p:sp>
+      <p:sp>
+        <p:nvSpPr>
+          <p:cNvPr id="31" name="Text 28"/>
+          <p:cNvSpPr/>
+          <p:nvPr/>
+        </p:nvSpPr>
+        <p:spPr>
+          <a:xfrm>
+            <a:off x="8211312" y="4151376"/>
+            <a:ext cx="3291840" cy="274320"/>
+          </a:xfrm>
+          <a:prstGeom prst="rect">
+            <a:avLst/>
+          </a:prstGeom>
+          <a:noFill/>
+          <a:ln/>
+        </p:spPr>
+        <p:txBody>
+          <a:bodyPr wrap="square" lIns="0" tIns="0" rIns="0" bIns="0" rtlCol="0" anchor="ctr"/>
+          <a:lstStyle/>
+          <a:p>
+            <a:pPr indent="0" marL="0">
+              <a:buNone/>
+            </a:pPr>
+            <a:r>
+              <a:rPr lang="en-US" sz="1100" b="1" dirty="0">
+                <a:solidFill>
+                  <a:srgbClr val="0B1220"/>
+                </a:solidFill>
+                <a:latin typeface="맑은 고딕" pitchFamily="34" charset="0"/>
+                <a:ea typeface="맑은 고딕" pitchFamily="34" charset="-122"/>
+                <a:cs typeface="맑은 고딕" pitchFamily="34" charset="-120"/>
+              </a:rPr>
+              <a:t>[SILVER925] Crimson Open Ring</a:t>
+            </a:r>
+            <a:endParaRPr lang="en-US" sz="1100" dirty="0"/>
+          </a:p>
+        </p:txBody>
+      </p:sp>
+      <p:sp>
+        <p:nvSpPr>
+          <p:cNvPr id="32" name="Text 29"/>
+          <p:cNvSpPr/>
+          <p:nvPr/>
+        </p:nvSpPr>
+        <p:spPr>
+          <a:xfrm>
+            <a:off x="8211312" y="4425696"/>
+            <a:ext cx="3291840" cy="256032"/>
+          </a:xfrm>
+          <a:prstGeom prst="rect">
+            <a:avLst/>
+          </a:prstGeom>
+          <a:noFill/>
+          <a:ln/>
+        </p:spPr>
+        <p:txBody>
+          <a:bodyPr wrap="square" lIns="0" tIns="0" rIns="0" bIns="0" rtlCol="0" anchor="ctr"/>
+          <a:lstStyle/>
+          <a:p>
+            <a:pPr indent="0" marL="0">
+              <a:buNone/>
+            </a:pPr>
+            <a:r>
+              <a:rPr lang="en-US" sz="1000" dirty="0">
+                <a:solidFill>
+                  <a:srgbClr val="6B7280"/>
+                </a:solidFill>
+                <a:latin typeface="맑은 고딕" pitchFamily="34" charset="0"/>
+                <a:ea typeface="맑은 고딕" pitchFamily="34" charset="-122"/>
+                <a:cs typeface="맑은 고딕" pitchFamily="34" charset="-120"/>
+              </a:rPr>
+              <a:t>Ring  ·  재고 4개</a:t>
+            </a:r>
+            <a:pPr indent="0" marL="0">
+              <a:buNone/>
+            </a:pPr>
+            <a:r>
+              <a:rPr lang="en-US" sz="1000" b="1" dirty="0">
+                <a:solidFill>
+                  <a:srgbClr val="D72638"/>
+                </a:solidFill>
+                <a:latin typeface="맑은 고딕" pitchFamily="34" charset="0"/>
+                <a:ea typeface="맑은 고딕" pitchFamily="34" charset="-122"/>
+                <a:cs typeface="맑은 고딕" pitchFamily="34" charset="-120"/>
+              </a:rPr>
+              <a:t/>
+            </a:r>
+            <a:endParaRPr lang="en-US" sz="1000" dirty="0"/>
+          </a:p>
+        </p:txBody>
+      </p:sp>
+      <p:sp>
+        <p:nvSpPr>
+          <p:cNvPr id="33" name="Shape 30"/>
+          <p:cNvSpPr/>
+          <p:nvPr/>
+        </p:nvSpPr>
+        <p:spPr>
+          <a:xfrm>
+            <a:off x="7406640" y="4809744"/>
+            <a:ext cx="4206240" cy="640080"/>
+          </a:xfrm>
+          <a:prstGeom prst="rect">
+            <a:avLst/>
+          </a:prstGeom>
+          <a:solidFill>
+            <a:srgbClr val="FFF5F5"/>
+          </a:solidFill>
+          <a:ln w="6350">
+            <a:solidFill>
+              <a:srgbClr val="E5E7EB"/>
+            </a:solidFill>
+            <a:prstDash val="solid"/>
+          </a:ln>
+        </p:spPr>
+      </p:sp>
+      <p:sp>
+        <p:nvSpPr>
+          <p:cNvPr id="34" name="Shape 31"/>
+          <p:cNvSpPr/>
+          <p:nvPr/>
+        </p:nvSpPr>
+        <p:spPr>
+          <a:xfrm>
+            <a:off x="7406640" y="4809744"/>
+            <a:ext cx="109728" cy="640080"/>
+          </a:xfrm>
+          <a:prstGeom prst="rect">
+            <a:avLst/>
+          </a:prstGeom>
+          <a:solidFill>
+            <a:srgbClr val="D72638"/>
+          </a:solidFill>
+          <a:ln w="12700">
+            <a:solidFill>
+              <a:srgbClr val="D72638"/>
+            </a:solidFill>
+            <a:prstDash val="solid"/>
+          </a:ln>
+        </p:spPr>
+      </p:sp>
+      <p:sp>
+        <p:nvSpPr>
+          <p:cNvPr id="35" name="Shape 32"/>
+          <p:cNvSpPr/>
+          <p:nvPr/>
+        </p:nvSpPr>
+        <p:spPr>
+          <a:xfrm>
+            <a:off x="7571232" y="4901184"/>
+            <a:ext cx="548640" cy="256032"/>
+          </a:xfrm>
+          <a:prstGeom prst="rect">
+            <a:avLst/>
+          </a:prstGeom>
+          <a:solidFill>
+            <a:srgbClr val="D72638"/>
+          </a:solidFill>
+          <a:ln w="12700">
+            <a:solidFill>
+              <a:srgbClr val="D72638"/>
+            </a:solidFill>
+            <a:prstDash val="solid"/>
+          </a:ln>
+        </p:spPr>
+      </p:sp>
+      <p:sp>
+        <p:nvSpPr>
+          <p:cNvPr id="36" name="Text 33"/>
+          <p:cNvSpPr/>
+          <p:nvPr/>
+        </p:nvSpPr>
+        <p:spPr>
+          <a:xfrm>
+            <a:off x="7571232" y="4901184"/>
+            <a:ext cx="548640" cy="256032"/>
+          </a:xfrm>
+          <a:prstGeom prst="rect">
+            <a:avLst/>
+          </a:prstGeom>
+          <a:noFill/>
+          <a:ln/>
+        </p:spPr>
+        <p:txBody>
+          <a:bodyPr wrap="square" lIns="0" tIns="0" rIns="0" bIns="0" rtlCol="0" anchor="ctr"/>
+          <a:lstStyle/>
+          <a:p>
+            <a:pPr algn="ctr" indent="0" marL="0">
+              <a:buNone/>
+            </a:pPr>
+            <a:r>
+              <a:rPr lang="en-US" sz="900" b="1" dirty="0">
+                <a:solidFill>
+                  <a:srgbClr val="FFFFFF"/>
+                </a:solidFill>
+                <a:latin typeface="맑은 고딕" pitchFamily="34" charset="0"/>
+                <a:ea typeface="맑은 고딕" pitchFamily="34" charset="-122"/>
+                <a:cs typeface="맑은 고딕" pitchFamily="34" charset="-120"/>
+              </a:rPr>
+              <a:t>긴급</a:t>
+            </a:r>
+            <a:endParaRPr lang="en-US" sz="900" dirty="0"/>
+          </a:p>
+        </p:txBody>
+      </p:sp>
+      <p:sp>
+        <p:nvSpPr>
+          <p:cNvPr id="37" name="Text 34"/>
+          <p:cNvSpPr/>
+          <p:nvPr/>
+        </p:nvSpPr>
+        <p:spPr>
+          <a:xfrm>
+            <a:off x="8211312" y="4864608"/>
+            <a:ext cx="3291840" cy="274320"/>
+          </a:xfrm>
+          <a:prstGeom prst="rect">
+            <a:avLst/>
+          </a:prstGeom>
+          <a:noFill/>
+          <a:ln/>
+        </p:spPr>
+        <p:txBody>
+          <a:bodyPr wrap="square" lIns="0" tIns="0" rIns="0" bIns="0" rtlCol="0" anchor="ctr"/>
+          <a:lstStyle/>
+          <a:p>
+            <a:pPr indent="0" marL="0">
+              <a:buNone/>
+            </a:pPr>
+            <a:r>
+              <a:rPr lang="en-US" sz="1100" b="1" dirty="0">
+                <a:solidFill>
+                  <a:srgbClr val="0B1220"/>
+                </a:solidFill>
+                <a:latin typeface="맑은 고딕" pitchFamily="34" charset="0"/>
+                <a:ea typeface="맑은 고딕" pitchFamily="34" charset="-122"/>
+                <a:cs typeface="맑은 고딕" pitchFamily="34" charset="-120"/>
+              </a:rPr>
+              <a:t>Chainlink Necklace</a:t>
+            </a:r>
+            <a:endParaRPr lang="en-US" sz="1100" dirty="0"/>
+          </a:p>
+        </p:txBody>
+      </p:sp>
+      <p:sp>
+        <p:nvSpPr>
+          <p:cNvPr id="38" name="Text 35"/>
+          <p:cNvSpPr/>
+          <p:nvPr/>
+        </p:nvSpPr>
+        <p:spPr>
+          <a:xfrm>
+            <a:off x="8211312" y="5138928"/>
             <a:ext cx="3291840" cy="256032"/>
           </a:xfrm>
           <a:prstGeom prst="rect">
@@ -7618,13 +8030,13 @@
       </p:sp>
       <p:sp>
         <p:nvSpPr>
-          <p:cNvPr id="27" name="Shape 24"/>
-          <p:cNvSpPr/>
-          <p:nvPr/>
-        </p:nvSpPr>
-        <p:spPr>
-          <a:xfrm>
-            <a:off x="7406640" y="4096512"/>
+          <p:cNvPr id="39" name="Shape 36"/>
+          <p:cNvSpPr/>
+          <p:nvPr/>
+        </p:nvSpPr>
+        <p:spPr>
+          <a:xfrm>
+            <a:off x="7406640" y="5522976"/>
             <a:ext cx="4206240" cy="640080"/>
           </a:xfrm>
           <a:prstGeom prst="rect">
@@ -7643,13 +8055,13 @@
       </p:sp>
       <p:sp>
         <p:nvSpPr>
-          <p:cNvPr id="28" name="Shape 25"/>
-          <p:cNvSpPr/>
-          <p:nvPr/>
-        </p:nvSpPr>
-        <p:spPr>
-          <a:xfrm>
-            <a:off x="7406640" y="4096512"/>
+          <p:cNvPr id="40" name="Shape 37"/>
+          <p:cNvSpPr/>
+          <p:nvPr/>
+        </p:nvSpPr>
+        <p:spPr>
+          <a:xfrm>
+            <a:off x="7406640" y="5522976"/>
             <a:ext cx="109728" cy="640080"/>
           </a:xfrm>
           <a:prstGeom prst="rect">
@@ -7668,13 +8080,13 @@
       </p:sp>
       <p:sp>
         <p:nvSpPr>
-          <p:cNvPr id="29" name="Shape 26"/>
-          <p:cNvSpPr/>
-          <p:nvPr/>
-        </p:nvSpPr>
-        <p:spPr>
-          <a:xfrm>
-            <a:off x="7571232" y="4187952"/>
+          <p:cNvPr id="41" name="Shape 38"/>
+          <p:cNvSpPr/>
+          <p:nvPr/>
+        </p:nvSpPr>
+        <p:spPr>
+          <a:xfrm>
+            <a:off x="7571232" y="5614416"/>
             <a:ext cx="548640" cy="256032"/>
           </a:xfrm>
           <a:prstGeom prst="rect">
@@ -7693,13 +8105,13 @@
       </p:sp>
       <p:sp>
         <p:nvSpPr>
-          <p:cNvPr id="30" name="Text 27"/>
-          <p:cNvSpPr/>
-          <p:nvPr/>
-        </p:nvSpPr>
-        <p:spPr>
-          <a:xfrm>
-            <a:off x="7571232" y="4187952"/>
+          <p:cNvPr id="42" name="Text 39"/>
+          <p:cNvSpPr/>
+          <p:nvPr/>
+        </p:nvSpPr>
+        <p:spPr>
+          <a:xfrm>
+            <a:off x="7571232" y="5614416"/>
             <a:ext cx="548640" cy="256032"/>
           </a:xfrm>
           <a:prstGeom prst="rect">
@@ -7732,219 +8144,13 @@
       </p:sp>
       <p:sp>
         <p:nvSpPr>
-          <p:cNvPr id="31" name="Text 28"/>
-          <p:cNvSpPr/>
-          <p:nvPr/>
-        </p:nvSpPr>
-        <p:spPr>
-          <a:xfrm>
-            <a:off x="8211312" y="4151376"/>
-            <a:ext cx="3291840" cy="274320"/>
-          </a:xfrm>
-          <a:prstGeom prst="rect">
-            <a:avLst/>
-          </a:prstGeom>
-          <a:noFill/>
-          <a:ln/>
-        </p:spPr>
-        <p:txBody>
-          <a:bodyPr wrap="square" lIns="0" tIns="0" rIns="0" bIns="0" rtlCol="0" anchor="ctr"/>
-          <a:lstStyle/>
-          <a:p>
-            <a:pPr indent="0" marL="0">
-              <a:buNone/>
-            </a:pPr>
-            <a:r>
-              <a:rPr lang="en-US" sz="1100" b="1" dirty="0">
-                <a:solidFill>
-                  <a:srgbClr val="0B1220"/>
-                </a:solidFill>
-                <a:latin typeface="맑은 고딕" pitchFamily="34" charset="0"/>
-                <a:ea typeface="맑은 고딕" pitchFamily="34" charset="-122"/>
-                <a:cs typeface="맑은 고딕" pitchFamily="34" charset="-120"/>
-              </a:rPr>
-              <a:t>Chainlink Necklace</a:t>
-            </a:r>
-            <a:endParaRPr lang="en-US" sz="1100" dirty="0"/>
-          </a:p>
-        </p:txBody>
-      </p:sp>
-      <p:sp>
-        <p:nvSpPr>
-          <p:cNvPr id="32" name="Text 29"/>
-          <p:cNvSpPr/>
-          <p:nvPr/>
-        </p:nvSpPr>
-        <p:spPr>
-          <a:xfrm>
-            <a:off x="8211312" y="4425696"/>
-            <a:ext cx="3291840" cy="256032"/>
-          </a:xfrm>
-          <a:prstGeom prst="rect">
-            <a:avLst/>
-          </a:prstGeom>
-          <a:noFill/>
-          <a:ln/>
-        </p:spPr>
-        <p:txBody>
-          <a:bodyPr wrap="square" lIns="0" tIns="0" rIns="0" bIns="0" rtlCol="0" anchor="ctr"/>
-          <a:lstStyle/>
-          <a:p>
-            <a:pPr indent="0" marL="0">
-              <a:buNone/>
-            </a:pPr>
-            <a:r>
-              <a:rPr lang="en-US" sz="1000" dirty="0">
-                <a:solidFill>
-                  <a:srgbClr val="6B7280"/>
-                </a:solidFill>
-                <a:latin typeface="맑은 고딕" pitchFamily="34" charset="0"/>
-                <a:ea typeface="맑은 고딕" pitchFamily="34" charset="-122"/>
-                <a:cs typeface="맑은 고딕" pitchFamily="34" charset="-120"/>
-              </a:rPr>
-              <a:t>Necklace  ·  재고 1개</a:t>
-            </a:r>
-            <a:pPr indent="0" marL="0">
-              <a:buNone/>
-            </a:pPr>
-            <a:r>
-              <a:rPr lang="en-US" sz="1000" b="1" dirty="0">
-                <a:solidFill>
-                  <a:srgbClr val="D72638"/>
-                </a:solidFill>
-                <a:latin typeface="맑은 고딕" pitchFamily="34" charset="0"/>
-                <a:ea typeface="맑은 고딕" pitchFamily="34" charset="-122"/>
-                <a:cs typeface="맑은 고딕" pitchFamily="34" charset="-120"/>
-              </a:rPr>
-              <a:t/>
-            </a:r>
-            <a:endParaRPr lang="en-US" sz="1000" dirty="0"/>
-          </a:p>
-        </p:txBody>
-      </p:sp>
-      <p:sp>
-        <p:nvSpPr>
-          <p:cNvPr id="33" name="Shape 30"/>
-          <p:cNvSpPr/>
-          <p:nvPr/>
-        </p:nvSpPr>
-        <p:spPr>
-          <a:xfrm>
-            <a:off x="7406640" y="4809744"/>
-            <a:ext cx="4206240" cy="640080"/>
-          </a:xfrm>
-          <a:prstGeom prst="rect">
-            <a:avLst/>
-          </a:prstGeom>
-          <a:solidFill>
-            <a:srgbClr val="FFF5F5"/>
-          </a:solidFill>
-          <a:ln w="6350">
-            <a:solidFill>
-              <a:srgbClr val="E5E7EB"/>
-            </a:solidFill>
-            <a:prstDash val="solid"/>
-          </a:ln>
-        </p:spPr>
-      </p:sp>
-      <p:sp>
-        <p:nvSpPr>
-          <p:cNvPr id="34" name="Shape 31"/>
-          <p:cNvSpPr/>
-          <p:nvPr/>
-        </p:nvSpPr>
-        <p:spPr>
-          <a:xfrm>
-            <a:off x="7406640" y="4809744"/>
-            <a:ext cx="109728" cy="640080"/>
-          </a:xfrm>
-          <a:prstGeom prst="rect">
-            <a:avLst/>
-          </a:prstGeom>
-          <a:solidFill>
-            <a:srgbClr val="D72638"/>
-          </a:solidFill>
-          <a:ln w="12700">
-            <a:solidFill>
-              <a:srgbClr val="D72638"/>
-            </a:solidFill>
-            <a:prstDash val="solid"/>
-          </a:ln>
-        </p:spPr>
-      </p:sp>
-      <p:sp>
-        <p:nvSpPr>
-          <p:cNvPr id="35" name="Shape 32"/>
-          <p:cNvSpPr/>
-          <p:nvPr/>
-        </p:nvSpPr>
-        <p:spPr>
-          <a:xfrm>
-            <a:off x="7571232" y="4901184"/>
-            <a:ext cx="548640" cy="256032"/>
-          </a:xfrm>
-          <a:prstGeom prst="rect">
-            <a:avLst/>
-          </a:prstGeom>
-          <a:solidFill>
-            <a:srgbClr val="D72638"/>
-          </a:solidFill>
-          <a:ln w="12700">
-            <a:solidFill>
-              <a:srgbClr val="D72638"/>
-            </a:solidFill>
-            <a:prstDash val="solid"/>
-          </a:ln>
-        </p:spPr>
-      </p:sp>
-      <p:sp>
-        <p:nvSpPr>
-          <p:cNvPr id="36" name="Text 33"/>
-          <p:cNvSpPr/>
-          <p:nvPr/>
-        </p:nvSpPr>
-        <p:spPr>
-          <a:xfrm>
-            <a:off x="7571232" y="4901184"/>
-            <a:ext cx="548640" cy="256032"/>
-          </a:xfrm>
-          <a:prstGeom prst="rect">
-            <a:avLst/>
-          </a:prstGeom>
-          <a:noFill/>
-          <a:ln/>
-        </p:spPr>
-        <p:txBody>
-          <a:bodyPr wrap="square" lIns="0" tIns="0" rIns="0" bIns="0" rtlCol="0" anchor="ctr"/>
-          <a:lstStyle/>
-          <a:p>
-            <a:pPr algn="ctr" indent="0" marL="0">
-              <a:buNone/>
-            </a:pPr>
-            <a:r>
-              <a:rPr lang="en-US" sz="900" b="1" dirty="0">
-                <a:solidFill>
-                  <a:srgbClr val="FFFFFF"/>
-                </a:solidFill>
-                <a:latin typeface="맑은 고딕" pitchFamily="34" charset="0"/>
-                <a:ea typeface="맑은 고딕" pitchFamily="34" charset="-122"/>
-                <a:cs typeface="맑은 고딕" pitchFamily="34" charset="-120"/>
-              </a:rPr>
-              <a:t>긴급</a:t>
-            </a:r>
-            <a:endParaRPr lang="en-US" sz="900" dirty="0"/>
-          </a:p>
-        </p:txBody>
-      </p:sp>
-      <p:sp>
-        <p:nvSpPr>
-          <p:cNvPr id="37" name="Text 34"/>
-          <p:cNvSpPr/>
-          <p:nvPr/>
-        </p:nvSpPr>
-        <p:spPr>
-          <a:xfrm>
-            <a:off x="8211312" y="4864608"/>
+          <p:cNvPr id="43" name="Text 40"/>
+          <p:cNvSpPr/>
+          <p:nvPr/>
+        </p:nvSpPr>
+        <p:spPr>
+          <a:xfrm>
+            <a:off x="8211312" y="5577840"/>
             <a:ext cx="3291840" cy="274320"/>
           </a:xfrm>
           <a:prstGeom prst="rect">
@@ -7977,13 +8183,13 @@
       </p:sp>
       <p:sp>
         <p:nvSpPr>
-          <p:cNvPr id="38" name="Text 35"/>
-          <p:cNvSpPr/>
-          <p:nvPr/>
-        </p:nvSpPr>
-        <p:spPr>
-          <a:xfrm>
-            <a:off x="8211312" y="5138928"/>
+          <p:cNvPr id="44" name="Text 41"/>
+          <p:cNvSpPr/>
+          <p:nvPr/>
+        </p:nvSpPr>
+        <p:spPr>
+          <a:xfrm>
+            <a:off x="8211312" y="5852160"/>
             <a:ext cx="3291840" cy="256032"/>
           </a:xfrm>
           <a:prstGeom prst="rect">
@@ -8030,212 +8236,6 @@
       </p:sp>
       <p:sp>
         <p:nvSpPr>
-          <p:cNvPr id="39" name="Shape 36"/>
-          <p:cNvSpPr/>
-          <p:nvPr/>
-        </p:nvSpPr>
-        <p:spPr>
-          <a:xfrm>
-            <a:off x="7406640" y="5522976"/>
-            <a:ext cx="4206240" cy="640080"/>
-          </a:xfrm>
-          <a:prstGeom prst="rect">
-            <a:avLst/>
-          </a:prstGeom>
-          <a:solidFill>
-            <a:srgbClr val="FFF5F5"/>
-          </a:solidFill>
-          <a:ln w="6350">
-            <a:solidFill>
-              <a:srgbClr val="E5E7EB"/>
-            </a:solidFill>
-            <a:prstDash val="solid"/>
-          </a:ln>
-        </p:spPr>
-      </p:sp>
-      <p:sp>
-        <p:nvSpPr>
-          <p:cNvPr id="40" name="Shape 37"/>
-          <p:cNvSpPr/>
-          <p:nvPr/>
-        </p:nvSpPr>
-        <p:spPr>
-          <a:xfrm>
-            <a:off x="7406640" y="5522976"/>
-            <a:ext cx="109728" cy="640080"/>
-          </a:xfrm>
-          <a:prstGeom prst="rect">
-            <a:avLst/>
-          </a:prstGeom>
-          <a:solidFill>
-            <a:srgbClr val="D72638"/>
-          </a:solidFill>
-          <a:ln w="12700">
-            <a:solidFill>
-              <a:srgbClr val="D72638"/>
-            </a:solidFill>
-            <a:prstDash val="solid"/>
-          </a:ln>
-        </p:spPr>
-      </p:sp>
-      <p:sp>
-        <p:nvSpPr>
-          <p:cNvPr id="41" name="Shape 38"/>
-          <p:cNvSpPr/>
-          <p:nvPr/>
-        </p:nvSpPr>
-        <p:spPr>
-          <a:xfrm>
-            <a:off x="7571232" y="5614416"/>
-            <a:ext cx="548640" cy="256032"/>
-          </a:xfrm>
-          <a:prstGeom prst="rect">
-            <a:avLst/>
-          </a:prstGeom>
-          <a:solidFill>
-            <a:srgbClr val="D72638"/>
-          </a:solidFill>
-          <a:ln w="12700">
-            <a:solidFill>
-              <a:srgbClr val="D72638"/>
-            </a:solidFill>
-            <a:prstDash val="solid"/>
-          </a:ln>
-        </p:spPr>
-      </p:sp>
-      <p:sp>
-        <p:nvSpPr>
-          <p:cNvPr id="42" name="Text 39"/>
-          <p:cNvSpPr/>
-          <p:nvPr/>
-        </p:nvSpPr>
-        <p:spPr>
-          <a:xfrm>
-            <a:off x="7571232" y="5614416"/>
-            <a:ext cx="548640" cy="256032"/>
-          </a:xfrm>
-          <a:prstGeom prst="rect">
-            <a:avLst/>
-          </a:prstGeom>
-          <a:noFill/>
-          <a:ln/>
-        </p:spPr>
-        <p:txBody>
-          <a:bodyPr wrap="square" lIns="0" tIns="0" rIns="0" bIns="0" rtlCol="0" anchor="ctr"/>
-          <a:lstStyle/>
-          <a:p>
-            <a:pPr algn="ctr" indent="0" marL="0">
-              <a:buNone/>
-            </a:pPr>
-            <a:r>
-              <a:rPr lang="en-US" sz="900" b="1" dirty="0">
-                <a:solidFill>
-                  <a:srgbClr val="FFFFFF"/>
-                </a:solidFill>
-                <a:latin typeface="맑은 고딕" pitchFamily="34" charset="0"/>
-                <a:ea typeface="맑은 고딕" pitchFamily="34" charset="-122"/>
-                <a:cs typeface="맑은 고딕" pitchFamily="34" charset="-120"/>
-              </a:rPr>
-              <a:t>긴급</a:t>
-            </a:r>
-            <a:endParaRPr lang="en-US" sz="900" dirty="0"/>
-          </a:p>
-        </p:txBody>
-      </p:sp>
-      <p:sp>
-        <p:nvSpPr>
-          <p:cNvPr id="43" name="Text 40"/>
-          <p:cNvSpPr/>
-          <p:nvPr/>
-        </p:nvSpPr>
-        <p:spPr>
-          <a:xfrm>
-            <a:off x="8211312" y="5577840"/>
-            <a:ext cx="3291840" cy="274320"/>
-          </a:xfrm>
-          <a:prstGeom prst="rect">
-            <a:avLst/>
-          </a:prstGeom>
-          <a:noFill/>
-          <a:ln/>
-        </p:spPr>
-        <p:txBody>
-          <a:bodyPr wrap="square" lIns="0" tIns="0" rIns="0" bIns="0" rtlCol="0" anchor="ctr"/>
-          <a:lstStyle/>
-          <a:p>
-            <a:pPr indent="0" marL="0">
-              <a:buNone/>
-            </a:pPr>
-            <a:r>
-              <a:rPr lang="en-US" sz="1100" b="1" dirty="0">
-                <a:solidFill>
-                  <a:srgbClr val="0B1220"/>
-                </a:solidFill>
-                <a:latin typeface="맑은 고딕" pitchFamily="34" charset="0"/>
-                <a:ea typeface="맑은 고딕" pitchFamily="34" charset="-122"/>
-                <a:cs typeface="맑은 고딕" pitchFamily="34" charset="-120"/>
-              </a:rPr>
-              <a:t>Two-ball Bangle</a:t>
-            </a:r>
-            <a:endParaRPr lang="en-US" sz="1100" dirty="0"/>
-          </a:p>
-        </p:txBody>
-      </p:sp>
-      <p:sp>
-        <p:nvSpPr>
-          <p:cNvPr id="44" name="Text 41"/>
-          <p:cNvSpPr/>
-          <p:nvPr/>
-        </p:nvSpPr>
-        <p:spPr>
-          <a:xfrm>
-            <a:off x="8211312" y="5852160"/>
-            <a:ext cx="3291840" cy="256032"/>
-          </a:xfrm>
-          <a:prstGeom prst="rect">
-            <a:avLst/>
-          </a:prstGeom>
-          <a:noFill/>
-          <a:ln/>
-        </p:spPr>
-        <p:txBody>
-          <a:bodyPr wrap="square" lIns="0" tIns="0" rIns="0" bIns="0" rtlCol="0" anchor="ctr"/>
-          <a:lstStyle/>
-          <a:p>
-            <a:pPr indent="0" marL="0">
-              <a:buNone/>
-            </a:pPr>
-            <a:r>
-              <a:rPr lang="en-US" sz="1000" dirty="0">
-                <a:solidFill>
-                  <a:srgbClr val="6B7280"/>
-                </a:solidFill>
-                <a:latin typeface="맑은 고딕" pitchFamily="34" charset="0"/>
-                <a:ea typeface="맑은 고딕" pitchFamily="34" charset="-122"/>
-                <a:cs typeface="맑은 고딕" pitchFamily="34" charset="-120"/>
-              </a:rPr>
-              <a:t>Bracelet  ·  재고 0개</a:t>
-            </a:r>
-            <a:pPr indent="0" marL="0">
-              <a:buNone/>
-            </a:pPr>
-            <a:r>
-              <a:rPr lang="en-US" sz="1000" b="1" dirty="0">
-                <a:solidFill>
-                  <a:srgbClr val="D72638"/>
-                </a:solidFill>
-                <a:latin typeface="맑은 고딕" pitchFamily="34" charset="0"/>
-                <a:ea typeface="맑은 고딕" pitchFamily="34" charset="-122"/>
-                <a:cs typeface="맑은 고딕" pitchFamily="34" charset="-120"/>
-              </a:rPr>
-              <a:t/>
-            </a:r>
-            <a:endParaRPr lang="en-US" sz="1000" dirty="0"/>
-          </a:p>
-        </p:txBody>
-      </p:sp>
-      <p:sp>
-        <p:nvSpPr>
           <p:cNvPr id="45" name="Text 42"/>
           <p:cNvSpPr/>
           <p:nvPr/>
@@ -8267,7 +8267,7 @@
                 <a:ea typeface="맑은 고딕" pitchFamily="34" charset="-122"/>
                 <a:cs typeface="맑은 고딕" pitchFamily="34" charset="-120"/>
               </a:rPr>
-              <a:t>베스트 상품 리포트  ·  생성 2026-05-23 08:00</a:t>
+              <a:t>베스트 상품 리포트  ·  생성 2026-05-24 08:00</a:t>
             </a:r>
             <a:endParaRPr lang="en-US" sz="900" dirty="0"/>
           </a:p>
@@ -8480,7 +8480,7 @@
                 <a:ea typeface="맑은 고딕" pitchFamily="34" charset="-122"/>
                 <a:cs typeface="맑은 고딕" pitchFamily="34" charset="-120"/>
               </a:rPr>
-              <a:t>2026년 05월 23일 (토)</a:t>
+              <a:t>2026년 05월 24일 (일)</a:t>
             </a:r>
             <a:endParaRPr lang="en-US" sz="1200" dirty="0"/>
           </a:p>
@@ -8647,7 +8647,7 @@
                 <a:ea typeface="맑은 고딕" pitchFamily="34" charset="-122"/>
                 <a:cs typeface="맑은 고딕" pitchFamily="34" charset="-120"/>
               </a:rPr>
-              <a:t>79 개</a:t>
+              <a:t>194 개</a:t>
             </a:r>
             <a:endParaRPr lang="en-US" sz="3600" dirty="0"/>
           </a:p>
@@ -8853,7 +8853,7 @@
                 <a:ea typeface="맑은 고딕" pitchFamily="34" charset="-122"/>
                 <a:cs typeface="맑은 고딕" pitchFamily="34" charset="-120"/>
               </a:rPr>
-              <a:t>24</a:t>
+              <a:t>46</a:t>
             </a:r>
             <a:endParaRPr lang="en-US" sz="4400" dirty="0"/>
           </a:p>
@@ -9452,7 +9452,7 @@
                           <a:ea typeface="맑은 고딕" pitchFamily="34" charset="-122"/>
                           <a:cs typeface="맑은 고딕" pitchFamily="34" charset="-120"/>
                         </a:rPr>
-                        <a:t>24 개</a:t>
+                        <a:t>46 개</a:t>
                       </a:r>
                       <a:endParaRPr lang="en-US" sz="1400" dirty="0">
                         <a:latin typeface="맑은 고딕" charset="0"/>
@@ -9714,7 +9714,7 @@
                           <a:ea typeface="맑은 고딕" pitchFamily="34" charset="-122"/>
                           <a:cs typeface="맑은 고딕" pitchFamily="34" charset="-120"/>
                         </a:rPr>
-                        <a:t>23 개</a:t>
+                        <a:t>44 개</a:t>
                       </a:r>
                       <a:endParaRPr lang="en-US" sz="1200" dirty="0">
                         <a:latin typeface="맑은 고딕" charset="0"/>
@@ -9976,7 +9976,7 @@
                           <a:ea typeface="맑은 고딕" pitchFamily="34" charset="-122"/>
                           <a:cs typeface="맑은 고딕" pitchFamily="34" charset="-120"/>
                         </a:rPr>
-                        <a:t>10 개</a:t>
+                        <a:t>29 개</a:t>
                       </a:r>
                       <a:endParaRPr lang="en-US" sz="1200" dirty="0">
                         <a:latin typeface="맑은 고딕" charset="0"/>
@@ -10165,7 +10165,7 @@
                 <a:ea typeface="맑은 고딕" pitchFamily="34" charset="-122"/>
                 <a:cs typeface="맑은 고딕" pitchFamily="34" charset="-120"/>
               </a:rPr>
-              <a:t>베스트 상품 리포트  ·  생성 2026-05-23 08:00</a:t>
+              <a:t>베스트 상품 리포트  ·  생성 2026-05-24 08:00</a:t>
             </a:r>
             <a:endParaRPr lang="en-US" sz="900" dirty="0"/>
           </a:p>
@@ -10378,7 +10378,7 @@
                 <a:ea typeface="맑은 고딕" pitchFamily="34" charset="-122"/>
                 <a:cs typeface="맑은 고딕" pitchFamily="34" charset="-120"/>
               </a:rPr>
-              <a:t>2026년 05월 23일 (토)</a:t>
+              <a:t>2026년 05월 24일 (일)</a:t>
             </a:r>
             <a:endParaRPr lang="en-US" sz="1200" dirty="0"/>
           </a:p>
@@ -10929,7 +10929,7 @@
                 <a:ea typeface="맑은 고딕" pitchFamily="34" charset="-122"/>
                 <a:cs typeface="맑은 고딕" pitchFamily="34" charset="-120"/>
               </a:rPr>
-              <a:t>31,412</a:t>
+              <a:t>30,964</a:t>
             </a:r>
             <a:endParaRPr lang="en-US" sz="3000" dirty="0"/>
           </a:p>
@@ -11489,7 +11489,7 @@
                           <a:ea typeface="맑은 고딕" pitchFamily="34" charset="-122"/>
                           <a:cs typeface="맑은 고딕" pitchFamily="34" charset="-120"/>
                         </a:rPr>
-                        <a:t>2,093</a:t>
+                        <a:t>2,087</a:t>
                       </a:r>
                       <a:endParaRPr lang="en-US" sz="1000" dirty="0">
                         <a:latin typeface="맑은 고딕" charset="0"/>
@@ -11751,7 +11751,7 @@
                           <a:ea typeface="맑은 고딕" pitchFamily="34" charset="-122"/>
                           <a:cs typeface="맑은 고딕" pitchFamily="34" charset="-120"/>
                         </a:rPr>
-                        <a:t>1,620</a:t>
+                        <a:t>1,608</a:t>
                       </a:r>
                       <a:endParaRPr lang="en-US" sz="1000" dirty="0">
                         <a:latin typeface="맑은 고딕" charset="0"/>
@@ -12013,7 +12013,7 @@
                           <a:ea typeface="맑은 고딕" pitchFamily="34" charset="-122"/>
                           <a:cs typeface="맑은 고딕" pitchFamily="34" charset="-120"/>
                         </a:rPr>
-                        <a:t>1,436</a:t>
+                        <a:t>1,371</a:t>
                       </a:r>
                       <a:endParaRPr lang="en-US" sz="1000" dirty="0">
                         <a:latin typeface="맑은 고딕" charset="0"/>
@@ -12275,7 +12275,7 @@
                           <a:ea typeface="맑은 고딕" pitchFamily="34" charset="-122"/>
                           <a:cs typeface="맑은 고딕" pitchFamily="34" charset="-120"/>
                         </a:rPr>
-                        <a:t>1,324</a:t>
+                        <a:t>1,189</a:t>
                       </a:r>
                       <a:endParaRPr lang="en-US" sz="1000" dirty="0">
                         <a:latin typeface="맑은 고딕" charset="0"/>
@@ -12472,7 +12472,7 @@
                           <a:ea typeface="맑은 고딕" pitchFamily="34" charset="-122"/>
                           <a:cs typeface="맑은 고딕" pitchFamily="34" charset="-120"/>
                         </a:rPr>
-                        <a:t>컬러: 피치 / 기종 옵션: C type -&gt; C type</a:t>
+                        <a:t>컬러: 네온핑크 / 기종 옵션: USB -&gt; Apple 8pin</a:t>
                       </a:r>
                       <a:endParaRPr lang="en-US" sz="900" dirty="0">
                         <a:latin typeface="맑은 고딕" charset="0"/>
@@ -12537,7 +12537,7 @@
                           <a:ea typeface="맑은 고딕" pitchFamily="34" charset="-122"/>
                           <a:cs typeface="맑은 고딕" pitchFamily="34" charset="-120"/>
                         </a:rPr>
-                        <a:t>928</a:t>
+                        <a:t>918</a:t>
                       </a:r>
                       <a:endParaRPr lang="en-US" sz="1000" dirty="0">
                         <a:latin typeface="맑은 고딕" charset="0"/>
@@ -13556,7 +13556,7 @@
                 <a:ea typeface="맑은 고딕" pitchFamily="34" charset="-122"/>
                 <a:cs typeface="맑은 고딕" pitchFamily="34" charset="-120"/>
               </a:rPr>
-              <a:t>베스트 상품 리포트  ·  생성 2026-05-23 08:00</a:t>
+              <a:t>베스트 상품 리포트  ·  생성 2026-05-24 08:00</a:t>
             </a:r>
             <a:endParaRPr lang="en-US" sz="900" dirty="0"/>
           </a:p>
@@ -13769,7 +13769,7 @@
                 <a:ea typeface="맑은 고딕" pitchFamily="34" charset="-122"/>
                 <a:cs typeface="맑은 고딕" pitchFamily="34" charset="-120"/>
               </a:rPr>
-              <a:t>2026년 05월 23일 (토)</a:t>
+              <a:t>2026년 05월 24일 (일)</a:t>
             </a:r>
             <a:endParaRPr lang="en-US" sz="1200" dirty="0"/>
           </a:p>
@@ -13897,7 +13897,7 @@
                 <a:ea typeface="맑은 고딕" pitchFamily="34" charset="-122"/>
                 <a:cs typeface="맑은 고딕" pitchFamily="34" charset="-120"/>
               </a:rPr>
-              <a:t>🚨  긴급 리오더 67건    ·    주의 리오더 9건    ·    오늘 발주 검토 필수</a:t>
+              <a:t>🚨  긴급 리오더 70건    ·    주의 리오더 10건    ·    오늘 발주 검토 필수</a:t>
             </a:r>
             <a:pPr indent="0" marL="0">
               <a:buNone/>
@@ -14595,7 +14595,7 @@
                           <a:ea typeface="맑은 고딕" pitchFamily="34" charset="-122"/>
                           <a:cs typeface="맑은 고딕" pitchFamily="34" charset="-120"/>
                         </a:rPr>
-                        <a:t>ETC</a:t>
+                        <a:t>ELECTRONIC</a:t>
                       </a:r>
                       <a:endParaRPr lang="en-US" sz="1000" dirty="0">
                         <a:latin typeface="맑은 고딕" charset="0"/>
@@ -14663,7 +14663,7 @@
                           <a:ea typeface="맑은 고딕" pitchFamily="34" charset="-122"/>
                           <a:cs typeface="맑은 고딕" pitchFamily="34" charset="-120"/>
                         </a:rPr>
-                        <a:t>Cotton Lunch Mini Bag (5color) (색상: 레드)</a:t>
+                        <a:t>Jacquard Fast Charging Cable (7color) (컬러: 민트 / 기종옵션: C-Apple 8pin / 길이: 2m)</a:t>
                       </a:r>
                       <a:endParaRPr lang="en-US" sz="1100" dirty="0">
                         <a:latin typeface="맑은 고딕" charset="0"/>
@@ -14731,7 +14731,7 @@
                           <a:ea typeface="맑은 고딕" pitchFamily="34" charset="-122"/>
                           <a:cs typeface="맑은 고딕" pitchFamily="34" charset="-120"/>
                         </a:rPr>
-                        <a:t>0</a:t>
+                        <a:t>19</a:t>
                       </a:r>
                       <a:endParaRPr lang="en-US" sz="1100" dirty="0">
                         <a:latin typeface="맑은 고딕" charset="0"/>
@@ -14799,7 +14799,7 @@
                           <a:ea typeface="맑은 고딕" pitchFamily="34" charset="-122"/>
                           <a:cs typeface="맑은 고딕" pitchFamily="34" charset="-120"/>
                         </a:rPr>
-                        <a:t>8 개</a:t>
+                        <a:t>3 개</a:t>
                       </a:r>
                       <a:endParaRPr lang="en-US" sz="1100" dirty="0">
                         <a:latin typeface="맑은 고딕" charset="0"/>
@@ -14937,7 +14937,7 @@
                           <a:ea typeface="맑은 고딕" pitchFamily="34" charset="-122"/>
                           <a:cs typeface="맑은 고딕" pitchFamily="34" charset="-120"/>
                         </a:rPr>
-                        <a:t>CT</a:t>
+                        <a:t>PR</a:t>
                       </a:r>
                       <a:endParaRPr lang="en-US" sz="1100" dirty="0">
                         <a:latin typeface="맑은 고딕" charset="0"/>
@@ -15005,7 +15005,7 @@
                           <a:ea typeface="맑은 고딕" pitchFamily="34" charset="-122"/>
                           <a:cs typeface="맑은 고딕" pitchFamily="34" charset="-120"/>
                         </a:rPr>
-                        <a:t>Ring</a:t>
+                        <a:t>ETC</a:t>
                       </a:r>
                       <a:endParaRPr lang="en-US" sz="1000" dirty="0">
                         <a:latin typeface="맑은 고딕" charset="0"/>
@@ -15073,7 +15073,7 @@
                           <a:ea typeface="맑은 고딕" pitchFamily="34" charset="-122"/>
                           <a:cs typeface="맑은 고딕" pitchFamily="34" charset="-120"/>
                         </a:rPr>
-                        <a:t>"Linkrace" 925 Open Ring</a:t>
+                        <a:t>360° Rotating Phone Holder (컬러: 화이트)</a:t>
                       </a:r>
                       <a:endParaRPr lang="en-US" sz="1100" dirty="0">
                         <a:latin typeface="맑은 고딕" charset="0"/>
@@ -15141,7 +15141,7 @@
                           <a:ea typeface="맑은 고딕" pitchFamily="34" charset="-122"/>
                           <a:cs typeface="맑은 고딕" pitchFamily="34" charset="-120"/>
                         </a:rPr>
-                        <a:t>0</a:t>
+                        <a:t>11</a:t>
                       </a:r>
                       <a:endParaRPr lang="en-US" sz="1100" dirty="0">
                         <a:latin typeface="맑은 고딕" charset="0"/>
@@ -15209,7 +15209,7 @@
                           <a:ea typeface="맑은 고딕" pitchFamily="34" charset="-122"/>
                           <a:cs typeface="맑은 고딕" pitchFamily="34" charset="-120"/>
                         </a:rPr>
-                        <a:t>4 개</a:t>
+                        <a:t>3 개</a:t>
                       </a:r>
                       <a:endParaRPr lang="en-US" sz="1100" dirty="0">
                         <a:latin typeface="맑은 고딕" charset="0"/>
@@ -15415,7 +15415,7 @@
                           <a:ea typeface="맑은 고딕" pitchFamily="34" charset="-122"/>
                           <a:cs typeface="맑은 고딕" pitchFamily="34" charset="-120"/>
                         </a:rPr>
-                        <a:t>Necklace</a:t>
+                        <a:t>Bracelet</a:t>
                       </a:r>
                       <a:endParaRPr lang="en-US" sz="1000" dirty="0">
                         <a:latin typeface="맑은 고딕" charset="0"/>
@@ -15483,7 +15483,7 @@
                           <a:ea typeface="맑은 고딕" pitchFamily="34" charset="-122"/>
                           <a:cs typeface="맑은 고딕" pitchFamily="34" charset="-120"/>
                         </a:rPr>
-                        <a:t>B-Flower Necklace (Size: 2 Size)</a:t>
+                        <a:t>2PT Bracelet</a:t>
                       </a:r>
                       <a:endParaRPr lang="en-US" sz="1100" dirty="0">
                         <a:latin typeface="맑은 고딕" charset="0"/>
@@ -15551,7 +15551,7 @@
                           <a:ea typeface="맑은 고딕" pitchFamily="34" charset="-122"/>
                           <a:cs typeface="맑은 고딕" pitchFamily="34" charset="-120"/>
                         </a:rPr>
-                        <a:t>0</a:t>
+                        <a:t>5</a:t>
                       </a:r>
                       <a:endParaRPr lang="en-US" sz="1100" dirty="0">
                         <a:latin typeface="맑은 고딕" charset="0"/>
@@ -15757,7 +15757,7 @@
                           <a:ea typeface="맑은 고딕" pitchFamily="34" charset="-122"/>
                           <a:cs typeface="맑은 고딕" pitchFamily="34" charset="-120"/>
                         </a:rPr>
-                        <a:t>PR</a:t>
+                        <a:t>6A</a:t>
                       </a:r>
                       <a:endParaRPr lang="en-US" sz="1100" dirty="0">
                         <a:latin typeface="맑은 고딕" charset="0"/>
@@ -15825,7 +15825,7 @@
                           <a:ea typeface="맑은 고딕" pitchFamily="34" charset="-122"/>
                           <a:cs typeface="맑은 고딕" pitchFamily="34" charset="-120"/>
                         </a:rPr>
-                        <a:t>ELECTRONIC</a:t>
+                        <a:t>Ring</a:t>
                       </a:r>
                       <a:endParaRPr lang="en-US" sz="1000" dirty="0">
                         <a:latin typeface="맑은 고딕" charset="0"/>
@@ -15893,7 +15893,7 @@
                           <a:ea typeface="맑은 고딕" pitchFamily="34" charset="-122"/>
                           <a:cs typeface="맑은 고딕" pitchFamily="34" charset="-120"/>
                         </a:rPr>
-                        <a:t>Jacquard Fast Charging Cable (7color) (컬러: 블루 / 기종옵션: C-Apple 8pin / 길이: 2m)</a:t>
+                        <a:t>[SILVER925] Crimson Open Ring</a:t>
                       </a:r>
                       <a:endParaRPr lang="en-US" sz="1100" dirty="0">
                         <a:latin typeface="맑은 고딕" charset="0"/>
@@ -15961,7 +15961,7 @@
                           <a:ea typeface="맑은 고딕" pitchFamily="34" charset="-122"/>
                           <a:cs typeface="맑은 고딕" pitchFamily="34" charset="-120"/>
                         </a:rPr>
-                        <a:t>18</a:t>
+                        <a:t>4</a:t>
                       </a:r>
                       <a:endParaRPr lang="en-US" sz="1100" dirty="0">
                         <a:latin typeface="맑은 고딕" charset="0"/>
@@ -16167,7 +16167,7 @@
                           <a:ea typeface="맑은 고딕" pitchFamily="34" charset="-122"/>
                           <a:cs typeface="맑은 고딕" pitchFamily="34" charset="-120"/>
                         </a:rPr>
-                        <a:t>6A</a:t>
+                        <a:t>CT</a:t>
                       </a:r>
                       <a:endParaRPr lang="en-US" sz="1100" dirty="0">
                         <a:latin typeface="맑은 고딕" charset="0"/>
@@ -16235,7 +16235,7 @@
                           <a:ea typeface="맑은 고딕" pitchFamily="34" charset="-122"/>
                           <a:cs typeface="맑은 고딕" pitchFamily="34" charset="-120"/>
                         </a:rPr>
-                        <a:t>Necklace</a:t>
+                        <a:t>Ring</a:t>
                       </a:r>
                       <a:endParaRPr lang="en-US" sz="1000" dirty="0">
                         <a:latin typeface="맑은 고딕" charset="0"/>
@@ -16303,7 +16303,7 @@
                           <a:ea typeface="맑은 고딕" pitchFamily="34" charset="-122"/>
                           <a:cs typeface="맑은 고딕" pitchFamily="34" charset="-120"/>
                         </a:rPr>
-                        <a:t>Chainlink Necklace</a:t>
+                        <a:t>"Crackave" 925 Open Ring</a:t>
                       </a:r>
                       <a:endParaRPr lang="en-US" sz="1100" dirty="0">
                         <a:latin typeface="맑은 고딕" charset="0"/>
@@ -16371,7 +16371,7 @@
                           <a:ea typeface="맑은 고딕" pitchFamily="34" charset="-122"/>
                           <a:cs typeface="맑은 고딕" pitchFamily="34" charset="-120"/>
                         </a:rPr>
-                        <a:t>1</a:t>
+                        <a:t>2</a:t>
                       </a:r>
                       <a:endParaRPr lang="en-US" sz="1100" dirty="0">
                         <a:latin typeface="맑은 고딕" charset="0"/>
@@ -16439,7 +16439,7 @@
                           <a:ea typeface="맑은 고딕" pitchFamily="34" charset="-122"/>
                           <a:cs typeface="맑은 고딕" pitchFamily="34" charset="-120"/>
                         </a:rPr>
-                        <a:t>1 개</a:t>
+                        <a:t>2 개</a:t>
                       </a:r>
                       <a:endParaRPr lang="en-US" sz="1100" dirty="0">
                         <a:latin typeface="맑은 고딕" charset="0"/>
@@ -16577,7 +16577,7 @@
                           <a:ea typeface="맑은 고딕" pitchFamily="34" charset="-122"/>
                           <a:cs typeface="맑은 고딕" pitchFamily="34" charset="-120"/>
                         </a:rPr>
-                        <a:t>CT</a:t>
+                        <a:t>PR</a:t>
                       </a:r>
                       <a:endParaRPr lang="en-US" sz="1100" dirty="0">
                         <a:latin typeface="맑은 고딕" charset="0"/>
@@ -16645,7 +16645,7 @@
                           <a:ea typeface="맑은 고딕" pitchFamily="34" charset="-122"/>
                           <a:cs typeface="맑은 고딕" pitchFamily="34" charset="-120"/>
                         </a:rPr>
-                        <a:t>Ring</a:t>
+                        <a:t>ELECTRONIC</a:t>
                       </a:r>
                       <a:endParaRPr lang="en-US" sz="1000" dirty="0">
                         <a:latin typeface="맑은 고딕" charset="0"/>
@@ -16713,7 +16713,7 @@
                           <a:ea typeface="맑은 고딕" pitchFamily="34" charset="-122"/>
                           <a:cs typeface="맑은 고딕" pitchFamily="34" charset="-120"/>
                         </a:rPr>
-                        <a:t>"Crackave" 925 Open Ring</a:t>
+                        <a:t>Jacquard Fast Charging Cable (7color) (컬러: 퍼플 / 기종옵션: C-Apple 8pin / 길이: 2m)</a:t>
                       </a:r>
                       <a:endParaRPr lang="en-US" sz="1100" dirty="0">
                         <a:latin typeface="맑은 고딕" charset="0"/>
@@ -16781,7 +16781,7 @@
                           <a:ea typeface="맑은 고딕" pitchFamily="34" charset="-122"/>
                           <a:cs typeface="맑은 고딕" pitchFamily="34" charset="-120"/>
                         </a:rPr>
-                        <a:t>4</a:t>
+                        <a:t>8</a:t>
                       </a:r>
                       <a:endParaRPr lang="en-US" sz="1100" dirty="0">
                         <a:latin typeface="맑은 고딕" charset="0"/>
@@ -16849,7 +16849,7 @@
                           <a:ea typeface="맑은 고딕" pitchFamily="34" charset="-122"/>
                           <a:cs typeface="맑은 고딕" pitchFamily="34" charset="-120"/>
                         </a:rPr>
-                        <a:t>1 개</a:t>
+                        <a:t>2 개</a:t>
                       </a:r>
                       <a:endParaRPr lang="en-US" sz="1100" dirty="0">
                         <a:latin typeface="맑은 고딕" charset="0"/>
@@ -16987,7 +16987,7 @@
                           <a:ea typeface="맑은 고딕" pitchFamily="34" charset="-122"/>
                           <a:cs typeface="맑은 고딕" pitchFamily="34" charset="-120"/>
                         </a:rPr>
-                        <a:t>PR</a:t>
+                        <a:t>6A</a:t>
                       </a:r>
                       <a:endParaRPr lang="en-US" sz="1100" dirty="0">
                         <a:latin typeface="맑은 고딕" charset="0"/>
@@ -17055,7 +17055,7 @@
                           <a:ea typeface="맑은 고딕" pitchFamily="34" charset="-122"/>
                           <a:cs typeface="맑은 고딕" pitchFamily="34" charset="-120"/>
                         </a:rPr>
-                        <a:t>ELECTRONIC</a:t>
+                        <a:t>Necklace</a:t>
                       </a:r>
                       <a:endParaRPr lang="en-US" sz="1000" dirty="0">
                         <a:latin typeface="맑은 고딕" charset="0"/>
@@ -17123,7 +17123,7 @@
                           <a:ea typeface="맑은 고딕" pitchFamily="34" charset="-122"/>
                           <a:cs typeface="맑은 고딕" pitchFamily="34" charset="-120"/>
                         </a:rPr>
-                        <a:t>Jacquard Fast Charging Cable (7color) (컬러: 퍼플 / 기종옵션: C-Apple 8pin / 길이: 2m)</a:t>
+                        <a:t>Chainlink Necklace</a:t>
                       </a:r>
                       <a:endParaRPr lang="en-US" sz="1100" dirty="0">
                         <a:latin typeface="맑은 고딕" charset="0"/>
@@ -17191,7 +17191,7 @@
                           <a:ea typeface="맑은 고딕" pitchFamily="34" charset="-122"/>
                           <a:cs typeface="맑은 고딕" pitchFamily="34" charset="-120"/>
                         </a:rPr>
-                        <a:t>10</a:t>
+                        <a:t>0</a:t>
                       </a:r>
                       <a:endParaRPr lang="en-US" sz="1100" dirty="0">
                         <a:latin typeface="맑은 고딕" charset="0"/>
@@ -17397,7 +17397,7 @@
                           <a:ea typeface="맑은 고딕" pitchFamily="34" charset="-122"/>
                           <a:cs typeface="맑은 고딕" pitchFamily="34" charset="-120"/>
                         </a:rPr>
-                        <a:t>6A</a:t>
+                        <a:t>CT</a:t>
                       </a:r>
                       <a:endParaRPr lang="en-US" sz="1100" dirty="0">
                         <a:latin typeface="맑은 고딕" charset="0"/>
@@ -17465,7 +17465,7 @@
                           <a:ea typeface="맑은 고딕" pitchFamily="34" charset="-122"/>
                           <a:cs typeface="맑은 고딕" pitchFamily="34" charset="-120"/>
                         </a:rPr>
-                        <a:t>★Season off★</a:t>
+                        <a:t>Ring</a:t>
                       </a:r>
                       <a:endParaRPr lang="en-US" sz="1000" dirty="0">
                         <a:latin typeface="맑은 고딕" charset="0"/>
@@ -17533,7 +17533,7 @@
                           <a:ea typeface="맑은 고딕" pitchFamily="34" charset="-122"/>
                           <a:cs typeface="맑은 고딕" pitchFamily="34" charset="-120"/>
                         </a:rPr>
-                        <a:t>8-Ball Smart Tok</a:t>
+                        <a:t>"Mlayer" 925 Open Ring</a:t>
                       </a:r>
                       <a:endParaRPr lang="en-US" sz="1100" dirty="0">
                         <a:latin typeface="맑은 고딕" charset="0"/>
@@ -17601,7 +17601,7 @@
                           <a:ea typeface="맑은 고딕" pitchFamily="34" charset="-122"/>
                           <a:cs typeface="맑은 고딕" pitchFamily="34" charset="-120"/>
                         </a:rPr>
-                        <a:t>4</a:t>
+                        <a:t>3</a:t>
                       </a:r>
                       <a:endParaRPr lang="en-US" sz="1100" dirty="0">
                         <a:latin typeface="맑은 고딕" charset="0"/>
@@ -17669,7 +17669,7 @@
                           <a:ea typeface="맑은 고딕" pitchFamily="34" charset="-122"/>
                           <a:cs typeface="맑은 고딕" pitchFamily="34" charset="-120"/>
                         </a:rPr>
-                        <a:t>0 개</a:t>
+                        <a:t>1 개</a:t>
                       </a:r>
                       <a:endParaRPr lang="en-US" sz="1100" dirty="0">
                         <a:latin typeface="맑은 고딕" charset="0"/>
@@ -17807,7 +17807,7 @@
                           <a:ea typeface="맑은 고딕" pitchFamily="34" charset="-122"/>
                           <a:cs typeface="맑은 고딕" pitchFamily="34" charset="-120"/>
                         </a:rPr>
-                        <a:t>6A</a:t>
+                        <a:t>CT</a:t>
                       </a:r>
                       <a:endParaRPr lang="en-US" sz="1100" dirty="0">
                         <a:latin typeface="맑은 고딕" charset="0"/>
@@ -17875,7 +17875,7 @@
                           <a:ea typeface="맑은 고딕" pitchFamily="34" charset="-122"/>
                           <a:cs typeface="맑은 고딕" pitchFamily="34" charset="-120"/>
                         </a:rPr>
-                        <a:t>Bracelet</a:t>
+                        <a:t>Ring</a:t>
                       </a:r>
                       <a:endParaRPr lang="en-US" sz="1000" dirty="0">
                         <a:latin typeface="맑은 고딕" charset="0"/>
@@ -17943,7 +17943,7 @@
                           <a:ea typeface="맑은 고딕" pitchFamily="34" charset="-122"/>
                           <a:cs typeface="맑은 고딕" pitchFamily="34" charset="-120"/>
                         </a:rPr>
-                        <a:t>Two-ball Bangle</a:t>
+                        <a:t>"Bloometal" 925 Open Ring</a:t>
                       </a:r>
                       <a:endParaRPr lang="en-US" sz="1100" dirty="0">
                         <a:latin typeface="맑은 고딕" charset="0"/>
@@ -18011,7 +18011,7 @@
                           <a:ea typeface="맑은 고딕" pitchFamily="34" charset="-122"/>
                           <a:cs typeface="맑은 고딕" pitchFamily="34" charset="-120"/>
                         </a:rPr>
-                        <a:t>0</a:t>
+                        <a:t>2</a:t>
                       </a:r>
                       <a:endParaRPr lang="en-US" sz="1100" dirty="0">
                         <a:latin typeface="맑은 고딕" charset="0"/>
@@ -18079,7 +18079,7 @@
                           <a:ea typeface="맑은 고딕" pitchFamily="34" charset="-122"/>
                           <a:cs typeface="맑은 고딕" pitchFamily="34" charset="-120"/>
                         </a:rPr>
-                        <a:t>0 개</a:t>
+                        <a:t>1 개</a:t>
                       </a:r>
                       <a:endParaRPr lang="en-US" sz="1100" dirty="0">
                         <a:latin typeface="맑은 고딕" charset="0"/>
@@ -18168,7 +18168,7 @@
                 <a:ea typeface="맑은 고딕" pitchFamily="34" charset="-122"/>
                 <a:cs typeface="맑은 고딕" pitchFamily="34" charset="-120"/>
               </a:rPr>
-              <a:t>외 58건 더 있음 — 상세는 시트에서 확인</a:t>
+              <a:t>외 61건 더 있음 — 상세는 시트에서 확인</a:t>
             </a:r>
             <a:endParaRPr lang="en-US" sz="1000" dirty="0"/>
           </a:p>
@@ -18207,7 +18207,7 @@
                 <a:ea typeface="맑은 고딕" pitchFamily="34" charset="-122"/>
                 <a:cs typeface="맑은 고딕" pitchFamily="34" charset="-120"/>
               </a:rPr>
-              <a:t>베스트 상품 리포트  ·  생성 2026-05-23 08:00</a:t>
+              <a:t>베스트 상품 리포트  ·  생성 2026-05-24 08:00</a:t>
             </a:r>
             <a:endParaRPr lang="en-US" sz="900" dirty="0"/>
           </a:p>
@@ -18420,7 +18420,7 @@
                 <a:ea typeface="맑은 고딕" pitchFamily="34" charset="-122"/>
                 <a:cs typeface="맑은 고딕" pitchFamily="34" charset="-120"/>
               </a:rPr>
-              <a:t>2026년 05월 23일 (토)</a:t>
+              <a:t>2026년 05월 24일 (일)</a:t>
             </a:r>
             <a:endParaRPr lang="en-US" sz="1200" dirty="0"/>
           </a:p>
@@ -18587,7 +18587,7 @@
                 <a:ea typeface="맑은 고딕" pitchFamily="34" charset="-122"/>
                 <a:cs typeface="맑은 고딕" pitchFamily="34" charset="-120"/>
               </a:rPr>
-              <a:t>Google Sheet '브랜드 재고현황'  ·  최신화 2026-05-23 08:00</a:t>
+              <a:t>Google Sheet '브랜드 재고현황'  ·  최신화 2026-05-24 08:00</a:t>
             </a:r>
             <a:endParaRPr lang="en-US" sz="1100" dirty="0"/>
           </a:p>
@@ -19230,7 +19230,7 @@
                 <a:ea typeface="맑은 고딕" pitchFamily="34" charset="-122"/>
                 <a:cs typeface="맑은 고딕" pitchFamily="34" charset="-120"/>
               </a:rPr>
-              <a:t>✅ 3개 브랜드 모두 정상 추출  ·  24h 출고 기준 (2026-05-22 08:00 → 2026-05-23 08:00) · 신규 SKU 14건은 결제완료 기준</a:t>
+              <a:t>✅ 3개 브랜드 모두 정상 추출  ·  24h 출고 기준 (2026-05-23 08:00 → 2026-05-24 08:00) · 신규 SKU 11건은 결제완료 기준</a:t>
             </a:r>
             <a:endParaRPr lang="en-US" sz="1000" dirty="0"/>
           </a:p>
@@ -19269,7 +19269,7 @@
                 <a:ea typeface="맑은 고딕" pitchFamily="34" charset="-122"/>
                 <a:cs typeface="맑은 고딕" pitchFamily="34" charset="-120"/>
               </a:rPr>
-              <a:t>베스트 상품 리포트  ·  생성 2026-05-23 08:00</a:t>
+              <a:t>베스트 상품 리포트  ·  생성 2026-05-24 08:00</a:t>
             </a:r>
             <a:endParaRPr lang="en-US" sz="900" dirty="0"/>
           </a:p>

</xml_diff>

<commit_message>
chore: 매출 PPT 업로드 (best-sellers-2026-05-25.pptx) [auto]
</commit_message>
<xml_diff>
--- a/data/sales-report.pptx
+++ b/data/sales-report.pptx
@@ -1648,7 +1648,7 @@
                 <a:ea typeface="맑은 고딕" pitchFamily="34" charset="-122"/>
                 <a:cs typeface="맑은 고딕" pitchFamily="34" charset="-120"/>
               </a:rPr>
-              <a:t>2026년 05월 24일 (일)  ·  24h 출고 기준</a:t>
+              <a:t>2026년 05월 25일 (월)  ·  24h 출고 기준</a:t>
             </a:r>
             <a:endParaRPr lang="en-US" sz="2200" dirty="0"/>
           </a:p>
@@ -1726,7 +1726,7 @@
                 <a:ea typeface="맑은 고딕" pitchFamily="34" charset="-122"/>
                 <a:cs typeface="맑은 고딕" pitchFamily="34" charset="-120"/>
               </a:rPr>
-              <a:t>05.24</a:t>
+              <a:t>05.25</a:t>
             </a:r>
             <a:endParaRPr lang="en-US" sz="7200" dirty="0"/>
           </a:p>
@@ -1765,7 +1765,7 @@
                 <a:ea typeface="맑은 고딕" pitchFamily="34" charset="-122"/>
                 <a:cs typeface="맑은 고딕" pitchFamily="34" charset="-120"/>
               </a:rPr>
-              <a:t>일요일</a:t>
+              <a:t>월요일</a:t>
             </a:r>
             <a:endParaRPr lang="en-US" sz="1400" dirty="0"/>
           </a:p>
@@ -1804,7 +1804,7 @@
                 <a:ea typeface="맑은 고딕" pitchFamily="34" charset="-122"/>
                 <a:cs typeface="맑은 고딕" pitchFamily="34" charset="-120"/>
               </a:rPr>
-              <a:t>생성 2026-05-24 08:00  ·  Google Sheet 자동 동기</a:t>
+              <a:t>생성 2026-05-25 08:00  ·  Google Sheet 자동 동기</a:t>
             </a:r>
             <a:endParaRPr lang="en-US" sz="1000" dirty="0"/>
           </a:p>
@@ -1978,7 +1978,7 @@
                 <a:ea typeface="맑은 고딕" pitchFamily="34" charset="-122"/>
                 <a:cs typeface="맑은 고딕" pitchFamily="34" charset="-120"/>
               </a:rPr>
-              <a:t>2026년 05월 24일 (일)</a:t>
+              <a:t>2026년 05월 25일 (월)</a:t>
             </a:r>
             <a:endParaRPr lang="en-US" sz="1200" dirty="0"/>
           </a:p>
@@ -2145,7 +2145,7 @@
                 <a:ea typeface="맑은 고딕" pitchFamily="34" charset="-122"/>
                 <a:cs typeface="맑은 고딕" pitchFamily="34" charset="-120"/>
               </a:rPr>
-              <a:t>497 개</a:t>
+              <a:t>660 개</a:t>
             </a:r>
             <a:endParaRPr lang="en-US" sz="3600" dirty="0"/>
           </a:p>
@@ -2479,7 +2479,7 @@
                 <a:ea typeface="맑은 고딕" pitchFamily="34" charset="-122"/>
                 <a:cs typeface="맑은 고딕" pitchFamily="34" charset="-120"/>
               </a:rPr>
-              <a:t>10 건</a:t>
+              <a:t>9 건</a:t>
             </a:r>
             <a:endParaRPr lang="en-US" sz="3200" dirty="0"/>
           </a:p>
@@ -3677,7 +3677,7 @@
                           <a:ea typeface="맑은 고딕" pitchFamily="34" charset="-122"/>
                           <a:cs typeface="맑은 고딕" pitchFamily="34" charset="-120"/>
                         </a:rPr>
-                        <a:t>46 개</a:t>
+                        <a:t>99 개</a:t>
                       </a:r>
                       <a:endParaRPr lang="en-US" sz="1400" dirty="0">
                         <a:latin typeface="맑은 고딕" charset="0"/>
@@ -3809,7 +3809,7 @@
                           <a:ea typeface="맑은 고딕" pitchFamily="34" charset="-122"/>
                           <a:cs typeface="맑은 고딕" pitchFamily="34" charset="-120"/>
                         </a:rPr>
-                        <a:t>CT</a:t>
+                        <a:t>6A</a:t>
                       </a:r>
                       <a:endParaRPr lang="en-US" sz="1100" dirty="0">
                         <a:latin typeface="맑은 고딕" charset="0"/>
@@ -3874,7 +3874,7 @@
                           <a:ea typeface="맑은 고딕" pitchFamily="34" charset="-122"/>
                           <a:cs typeface="맑은 고딕" pitchFamily="34" charset="-120"/>
                         </a:rPr>
-                        <a:t>Necklace</a:t>
+                        <a:t>Ring</a:t>
                       </a:r>
                       <a:endParaRPr lang="en-US" sz="1000" dirty="0">
                         <a:latin typeface="맑은 고딕" charset="0"/>
@@ -3939,7 +3939,7 @@
                           <a:ea typeface="맑은 고딕" pitchFamily="34" charset="-122"/>
                           <a:cs typeface="맑은 고딕" pitchFamily="34" charset="-120"/>
                         </a:rPr>
-                        <a:t>CandyPOP Necklace (사이즈: 1size (37~43cm))</a:t>
+                        <a:t>[SILVER925] CH.alban Open Ring</a:t>
                       </a:r>
                       <a:endParaRPr lang="en-US" sz="1100" dirty="0">
                         <a:latin typeface="맑은 고딕" charset="0"/>
@@ -4004,7 +4004,7 @@
                           <a:ea typeface="맑은 고딕" pitchFamily="34" charset="-122"/>
                           <a:cs typeface="맑은 고딕" pitchFamily="34" charset="-120"/>
                         </a:rPr>
-                        <a:t>46 개</a:t>
+                        <a:t>59 개</a:t>
                       </a:r>
                       <a:endParaRPr lang="en-US" sz="1400" dirty="0">
                         <a:latin typeface="맑은 고딕" charset="0"/>
@@ -4136,7 +4136,7 @@
                           <a:ea typeface="맑은 고딕" pitchFamily="34" charset="-122"/>
                           <a:cs typeface="맑은 고딕" pitchFamily="34" charset="-120"/>
                         </a:rPr>
-                        <a:t>CT</a:t>
+                        <a:t>6A</a:t>
                       </a:r>
                       <a:endParaRPr lang="en-US" sz="1100" dirty="0">
                         <a:latin typeface="맑은 고딕" charset="0"/>
@@ -4201,7 +4201,7 @@
                           <a:ea typeface="맑은 고딕" pitchFamily="34" charset="-122"/>
                           <a:cs typeface="맑은 고딕" pitchFamily="34" charset="-120"/>
                         </a:rPr>
-                        <a:t>Necklace</a:t>
+                        <a:t>Ring</a:t>
                       </a:r>
                       <a:endParaRPr lang="en-US" sz="1000" dirty="0">
                         <a:latin typeface="맑은 고딕" charset="0"/>
@@ -4266,7 +4266,7 @@
                           <a:ea typeface="맑은 고딕" pitchFamily="34" charset="-122"/>
                           <a:cs typeface="맑은 고딕" pitchFamily="34" charset="-120"/>
                         </a:rPr>
-                        <a:t>CandyPOP Necklace (사이즈: 2size (47~52cm))</a:t>
+                        <a:t>[SILVER925] Starly Open Ring</a:t>
                       </a:r>
                       <a:endParaRPr lang="en-US" sz="1100" dirty="0">
                         <a:latin typeface="맑은 고딕" charset="0"/>
@@ -4331,7 +4331,7 @@
                           <a:ea typeface="맑은 고딕" pitchFamily="34" charset="-122"/>
                           <a:cs typeface="맑은 고딕" pitchFamily="34" charset="-120"/>
                         </a:rPr>
-                        <a:t>44 개</a:t>
+                        <a:t>45 개</a:t>
                       </a:r>
                       <a:endParaRPr lang="en-US" sz="1400" dirty="0">
                         <a:latin typeface="맑은 고딕" charset="0"/>
@@ -4528,7 +4528,7 @@
                           <a:ea typeface="맑은 고딕" pitchFamily="34" charset="-122"/>
                           <a:cs typeface="맑은 고딕" pitchFamily="34" charset="-120"/>
                         </a:rPr>
-                        <a:t>Ring</a:t>
+                        <a:t>Necklace</a:t>
                       </a:r>
                       <a:endParaRPr lang="en-US" sz="1000" dirty="0">
                         <a:latin typeface="맑은 고딕" charset="0"/>
@@ -4593,7 +4593,7 @@
                           <a:ea typeface="맑은 고딕" pitchFamily="34" charset="-122"/>
                           <a:cs typeface="맑은 고딕" pitchFamily="34" charset="-120"/>
                         </a:rPr>
-                        <a:t>[SILVER925] CH.alban Open Ring</a:t>
+                        <a:t>Tiny Cross Necklace</a:t>
                       </a:r>
                       <a:endParaRPr lang="en-US" sz="1100" dirty="0">
                         <a:latin typeface="맑은 고딕" charset="0"/>
@@ -4658,7 +4658,7 @@
                           <a:ea typeface="맑은 고딕" pitchFamily="34" charset="-122"/>
                           <a:cs typeface="맑은 고딕" pitchFamily="34" charset="-120"/>
                         </a:rPr>
-                        <a:t>42 개</a:t>
+                        <a:t>33 개</a:t>
                       </a:r>
                       <a:endParaRPr lang="en-US" sz="1200" dirty="0">
                         <a:latin typeface="맑은 고딕" charset="0"/>
@@ -4920,7 +4920,7 @@
                           <a:ea typeface="맑은 고딕" pitchFamily="34" charset="-122"/>
                           <a:cs typeface="맑은 고딕" pitchFamily="34" charset="-120"/>
                         </a:rPr>
-                        <a:t>ThreadDuo Necklace</a:t>
+                        <a:t>CandyPOP Necklace (사이즈: 1size (37~43cm))</a:t>
                       </a:r>
                       <a:endParaRPr lang="en-US" sz="1100" dirty="0">
                         <a:latin typeface="맑은 고딕" charset="0"/>
@@ -4985,7 +4985,7 @@
                           <a:ea typeface="맑은 고딕" pitchFamily="34" charset="-122"/>
                           <a:cs typeface="맑은 고딕" pitchFamily="34" charset="-120"/>
                         </a:rPr>
-                        <a:t>29 개</a:t>
+                        <a:t>32 개</a:t>
                       </a:r>
                       <a:endParaRPr lang="en-US" sz="1200" dirty="0">
                         <a:latin typeface="맑은 고딕" charset="0"/>
@@ -5071,7 +5071,7 @@
                 <a:ea typeface="맑은 고딕" pitchFamily="34" charset="-122"/>
                 <a:cs typeface="맑은 고딕" pitchFamily="34" charset="-120"/>
               </a:rPr>
-              <a:t>베스트 상품 리포트  ·  생성 2026-05-24 08:00</a:t>
+              <a:t>베스트 상품 리포트  ·  생성 2026-05-25 08:00</a:t>
             </a:r>
             <a:endParaRPr lang="en-US" sz="900" dirty="0"/>
           </a:p>
@@ -5284,7 +5284,7 @@
                 <a:ea typeface="맑은 고딕" pitchFamily="34" charset="-122"/>
                 <a:cs typeface="맑은 고딕" pitchFamily="34" charset="-120"/>
               </a:rPr>
-              <a:t>2026년 05월 24일 (일)</a:t>
+              <a:t>2026년 05월 25일 (월)</a:t>
             </a:r>
             <a:endParaRPr lang="en-US" sz="1200" dirty="0"/>
           </a:p>
@@ -5451,7 +5451,7 @@
                 <a:ea typeface="맑은 고딕" pitchFamily="34" charset="-122"/>
                 <a:cs typeface="맑은 고딕" pitchFamily="34" charset="-120"/>
               </a:rPr>
-              <a:t>303 개</a:t>
+              <a:t>521 개</a:t>
             </a:r>
             <a:endParaRPr lang="en-US" sz="3600" dirty="0"/>
           </a:p>
@@ -5657,7 +5657,7 @@
                 <a:ea typeface="맑은 고딕" pitchFamily="34" charset="-122"/>
                 <a:cs typeface="맑은 고딕" pitchFamily="34" charset="-120"/>
               </a:rPr>
-              <a:t>46</a:t>
+              <a:t>99</a:t>
             </a:r>
             <a:endParaRPr lang="en-US" sz="4400" dirty="0"/>
           </a:p>
@@ -6256,7 +6256,7 @@
                           <a:ea typeface="맑은 고딕" pitchFamily="34" charset="-122"/>
                           <a:cs typeface="맑은 고딕" pitchFamily="34" charset="-120"/>
                         </a:rPr>
-                        <a:t>46 개</a:t>
+                        <a:t>99 개</a:t>
                       </a:r>
                       <a:endParaRPr lang="en-US" sz="1400" dirty="0">
                         <a:latin typeface="맑은 고딕" charset="0"/>
@@ -6518,7 +6518,7 @@
                           <a:ea typeface="맑은 고딕" pitchFamily="34" charset="-122"/>
                           <a:cs typeface="맑은 고딕" pitchFamily="34" charset="-120"/>
                         </a:rPr>
-                        <a:t>42 개</a:t>
+                        <a:t>59 개</a:t>
                       </a:r>
                       <a:endParaRPr lang="en-US" sz="1200" dirty="0">
                         <a:latin typeface="맑은 고딕" charset="0"/>
@@ -6780,7 +6780,7 @@
                           <a:ea typeface="맑은 고딕" pitchFamily="34" charset="-122"/>
                           <a:cs typeface="맑은 고딕" pitchFamily="34" charset="-120"/>
                         </a:rPr>
-                        <a:t>19 개</a:t>
+                        <a:t>45 개</a:t>
                       </a:r>
                       <a:endParaRPr lang="en-US" sz="1200" dirty="0">
                         <a:latin typeface="맑은 고딕" charset="0"/>
@@ -7042,7 +7042,7 @@
                           <a:ea typeface="맑은 고딕" pitchFamily="34" charset="-122"/>
                           <a:cs typeface="맑은 고딕" pitchFamily="34" charset="-120"/>
                         </a:rPr>
-                        <a:t>17 개</a:t>
+                        <a:t>33 개</a:t>
                       </a:r>
                       <a:endParaRPr lang="en-US" sz="1200" dirty="0">
                         <a:latin typeface="맑은 고딕" charset="0"/>
@@ -7304,7 +7304,7 @@
                           <a:ea typeface="맑은 고딕" pitchFamily="34" charset="-122"/>
                           <a:cs typeface="맑은 고딕" pitchFamily="34" charset="-120"/>
                         </a:rPr>
-                        <a:t>17 개</a:t>
+                        <a:t>31 개</a:t>
                       </a:r>
                       <a:endParaRPr lang="en-US" sz="1200" dirty="0">
                         <a:latin typeface="맑은 고딕" charset="0"/>
@@ -7557,7 +7557,7 @@
                 <a:ea typeface="맑은 고딕" pitchFamily="34" charset="-122"/>
                 <a:cs typeface="맑은 고딕" pitchFamily="34" charset="-120"/>
               </a:rPr>
-              <a:t>2PT Bracelet</a:t>
+              <a:t>[SILVER925] Crimson Open Ring</a:t>
             </a:r>
             <a:endParaRPr lang="en-US" sz="1100" dirty="0"/>
           </a:p>
@@ -7596,7 +7596,7 @@
                 <a:ea typeface="맑은 고딕" pitchFamily="34" charset="-122"/>
                 <a:cs typeface="맑은 고딕" pitchFamily="34" charset="-120"/>
               </a:rPr>
-              <a:t>Bracelet  ·  재고 5개</a:t>
+              <a:t>Ring  ·  재고 1개</a:t>
             </a:r>
             <a:pPr indent="0" marL="0">
               <a:buNone/>
@@ -7763,7 +7763,7 @@
                 <a:ea typeface="맑은 고딕" pitchFamily="34" charset="-122"/>
                 <a:cs typeface="맑은 고딕" pitchFamily="34" charset="-120"/>
               </a:rPr>
-              <a:t>[SILVER925] Crimson Open Ring</a:t>
+              <a:t>2PT Bracelet</a:t>
             </a:r>
             <a:endParaRPr lang="en-US" sz="1100" dirty="0"/>
           </a:p>
@@ -7802,7 +7802,7 @@
                 <a:ea typeface="맑은 고딕" pitchFamily="34" charset="-122"/>
                 <a:cs typeface="맑은 고딕" pitchFamily="34" charset="-120"/>
               </a:rPr>
-              <a:t>Ring  ·  재고 4개</a:t>
+              <a:t>Bracelet  ·  재고 3개</a:t>
             </a:r>
             <a:pPr indent="0" marL="0">
               <a:buNone/>
@@ -7969,212 +7969,6 @@
                 <a:ea typeface="맑은 고딕" pitchFamily="34" charset="-122"/>
                 <a:cs typeface="맑은 고딕" pitchFamily="34" charset="-120"/>
               </a:rPr>
-              <a:t>Chainlink Necklace</a:t>
-            </a:r>
-            <a:endParaRPr lang="en-US" sz="1100" dirty="0"/>
-          </a:p>
-        </p:txBody>
-      </p:sp>
-      <p:sp>
-        <p:nvSpPr>
-          <p:cNvPr id="38" name="Text 35"/>
-          <p:cNvSpPr/>
-          <p:nvPr/>
-        </p:nvSpPr>
-        <p:spPr>
-          <a:xfrm>
-            <a:off x="8211312" y="5138928"/>
-            <a:ext cx="3291840" cy="256032"/>
-          </a:xfrm>
-          <a:prstGeom prst="rect">
-            <a:avLst/>
-          </a:prstGeom>
-          <a:noFill/>
-          <a:ln/>
-        </p:spPr>
-        <p:txBody>
-          <a:bodyPr wrap="square" lIns="0" tIns="0" rIns="0" bIns="0" rtlCol="0" anchor="ctr"/>
-          <a:lstStyle/>
-          <a:p>
-            <a:pPr indent="0" marL="0">
-              <a:buNone/>
-            </a:pPr>
-            <a:r>
-              <a:rPr lang="en-US" sz="1000" dirty="0">
-                <a:solidFill>
-                  <a:srgbClr val="6B7280"/>
-                </a:solidFill>
-                <a:latin typeface="맑은 고딕" pitchFamily="34" charset="0"/>
-                <a:ea typeface="맑은 고딕" pitchFamily="34" charset="-122"/>
-                <a:cs typeface="맑은 고딕" pitchFamily="34" charset="-120"/>
-              </a:rPr>
-              <a:t>Necklace  ·  재고 0개</a:t>
-            </a:r>
-            <a:pPr indent="0" marL="0">
-              <a:buNone/>
-            </a:pPr>
-            <a:r>
-              <a:rPr lang="en-US" sz="1000" b="1" dirty="0">
-                <a:solidFill>
-                  <a:srgbClr val="D72638"/>
-                </a:solidFill>
-                <a:latin typeface="맑은 고딕" pitchFamily="34" charset="0"/>
-                <a:ea typeface="맑은 고딕" pitchFamily="34" charset="-122"/>
-                <a:cs typeface="맑은 고딕" pitchFamily="34" charset="-120"/>
-              </a:rPr>
-              <a:t/>
-            </a:r>
-            <a:endParaRPr lang="en-US" sz="1000" dirty="0"/>
-          </a:p>
-        </p:txBody>
-      </p:sp>
-      <p:sp>
-        <p:nvSpPr>
-          <p:cNvPr id="39" name="Shape 36"/>
-          <p:cNvSpPr/>
-          <p:nvPr/>
-        </p:nvSpPr>
-        <p:spPr>
-          <a:xfrm>
-            <a:off x="7406640" y="5522976"/>
-            <a:ext cx="4206240" cy="640080"/>
-          </a:xfrm>
-          <a:prstGeom prst="rect">
-            <a:avLst/>
-          </a:prstGeom>
-          <a:solidFill>
-            <a:srgbClr val="FFF5F5"/>
-          </a:solidFill>
-          <a:ln w="6350">
-            <a:solidFill>
-              <a:srgbClr val="E5E7EB"/>
-            </a:solidFill>
-            <a:prstDash val="solid"/>
-          </a:ln>
-        </p:spPr>
-      </p:sp>
-      <p:sp>
-        <p:nvSpPr>
-          <p:cNvPr id="40" name="Shape 37"/>
-          <p:cNvSpPr/>
-          <p:nvPr/>
-        </p:nvSpPr>
-        <p:spPr>
-          <a:xfrm>
-            <a:off x="7406640" y="5522976"/>
-            <a:ext cx="109728" cy="640080"/>
-          </a:xfrm>
-          <a:prstGeom prst="rect">
-            <a:avLst/>
-          </a:prstGeom>
-          <a:solidFill>
-            <a:srgbClr val="D72638"/>
-          </a:solidFill>
-          <a:ln w="12700">
-            <a:solidFill>
-              <a:srgbClr val="D72638"/>
-            </a:solidFill>
-            <a:prstDash val="solid"/>
-          </a:ln>
-        </p:spPr>
-      </p:sp>
-      <p:sp>
-        <p:nvSpPr>
-          <p:cNvPr id="41" name="Shape 38"/>
-          <p:cNvSpPr/>
-          <p:nvPr/>
-        </p:nvSpPr>
-        <p:spPr>
-          <a:xfrm>
-            <a:off x="7571232" y="5614416"/>
-            <a:ext cx="548640" cy="256032"/>
-          </a:xfrm>
-          <a:prstGeom prst="rect">
-            <a:avLst/>
-          </a:prstGeom>
-          <a:solidFill>
-            <a:srgbClr val="D72638"/>
-          </a:solidFill>
-          <a:ln w="12700">
-            <a:solidFill>
-              <a:srgbClr val="D72638"/>
-            </a:solidFill>
-            <a:prstDash val="solid"/>
-          </a:ln>
-        </p:spPr>
-      </p:sp>
-      <p:sp>
-        <p:nvSpPr>
-          <p:cNvPr id="42" name="Text 39"/>
-          <p:cNvSpPr/>
-          <p:nvPr/>
-        </p:nvSpPr>
-        <p:spPr>
-          <a:xfrm>
-            <a:off x="7571232" y="5614416"/>
-            <a:ext cx="548640" cy="256032"/>
-          </a:xfrm>
-          <a:prstGeom prst="rect">
-            <a:avLst/>
-          </a:prstGeom>
-          <a:noFill/>
-          <a:ln/>
-        </p:spPr>
-        <p:txBody>
-          <a:bodyPr wrap="square" lIns="0" tIns="0" rIns="0" bIns="0" rtlCol="0" anchor="ctr"/>
-          <a:lstStyle/>
-          <a:p>
-            <a:pPr algn="ctr" indent="0" marL="0">
-              <a:buNone/>
-            </a:pPr>
-            <a:r>
-              <a:rPr lang="en-US" sz="900" b="1" dirty="0">
-                <a:solidFill>
-                  <a:srgbClr val="FFFFFF"/>
-                </a:solidFill>
-                <a:latin typeface="맑은 고딕" pitchFamily="34" charset="0"/>
-                <a:ea typeface="맑은 고딕" pitchFamily="34" charset="-122"/>
-                <a:cs typeface="맑은 고딕" pitchFamily="34" charset="-120"/>
-              </a:rPr>
-              <a:t>긴급</a:t>
-            </a:r>
-            <a:endParaRPr lang="en-US" sz="900" dirty="0"/>
-          </a:p>
-        </p:txBody>
-      </p:sp>
-      <p:sp>
-        <p:nvSpPr>
-          <p:cNvPr id="43" name="Text 40"/>
-          <p:cNvSpPr/>
-          <p:nvPr/>
-        </p:nvSpPr>
-        <p:spPr>
-          <a:xfrm>
-            <a:off x="8211312" y="5577840"/>
-            <a:ext cx="3291840" cy="274320"/>
-          </a:xfrm>
-          <a:prstGeom prst="rect">
-            <a:avLst/>
-          </a:prstGeom>
-          <a:noFill/>
-          <a:ln/>
-        </p:spPr>
-        <p:txBody>
-          <a:bodyPr wrap="square" lIns="0" tIns="0" rIns="0" bIns="0" rtlCol="0" anchor="ctr"/>
-          <a:lstStyle/>
-          <a:p>
-            <a:pPr indent="0" marL="0">
-              <a:buNone/>
-            </a:pPr>
-            <a:r>
-              <a:rPr lang="en-US" sz="1100" b="1" dirty="0">
-                <a:solidFill>
-                  <a:srgbClr val="0B1220"/>
-                </a:solidFill>
-                <a:latin typeface="맑은 고딕" pitchFamily="34" charset="0"/>
-                <a:ea typeface="맑은 고딕" pitchFamily="34" charset="-122"/>
-                <a:cs typeface="맑은 고딕" pitchFamily="34" charset="-120"/>
-              </a:rPr>
               <a:t>8-Ball Smart Tok</a:t>
             </a:r>
             <a:endParaRPr lang="en-US" sz="1100" dirty="0"/>
@@ -8183,13 +7977,13 @@
       </p:sp>
       <p:sp>
         <p:nvSpPr>
-          <p:cNvPr id="44" name="Text 41"/>
-          <p:cNvSpPr/>
-          <p:nvPr/>
-        </p:nvSpPr>
-        <p:spPr>
-          <a:xfrm>
-            <a:off x="8211312" y="5852160"/>
+          <p:cNvPr id="38" name="Text 35"/>
+          <p:cNvSpPr/>
+          <p:nvPr/>
+        </p:nvSpPr>
+        <p:spPr>
+          <a:xfrm>
+            <a:off x="8211312" y="5138928"/>
             <a:ext cx="3291840" cy="256032"/>
           </a:xfrm>
           <a:prstGeom prst="rect">
@@ -8236,6 +8030,212 @@
       </p:sp>
       <p:sp>
         <p:nvSpPr>
+          <p:cNvPr id="39" name="Shape 36"/>
+          <p:cNvSpPr/>
+          <p:nvPr/>
+        </p:nvSpPr>
+        <p:spPr>
+          <a:xfrm>
+            <a:off x="7406640" y="5522976"/>
+            <a:ext cx="4206240" cy="640080"/>
+          </a:xfrm>
+          <a:prstGeom prst="rect">
+            <a:avLst/>
+          </a:prstGeom>
+          <a:solidFill>
+            <a:srgbClr val="FFF5F5"/>
+          </a:solidFill>
+          <a:ln w="6350">
+            <a:solidFill>
+              <a:srgbClr val="E5E7EB"/>
+            </a:solidFill>
+            <a:prstDash val="solid"/>
+          </a:ln>
+        </p:spPr>
+      </p:sp>
+      <p:sp>
+        <p:nvSpPr>
+          <p:cNvPr id="40" name="Shape 37"/>
+          <p:cNvSpPr/>
+          <p:nvPr/>
+        </p:nvSpPr>
+        <p:spPr>
+          <a:xfrm>
+            <a:off x="7406640" y="5522976"/>
+            <a:ext cx="109728" cy="640080"/>
+          </a:xfrm>
+          <a:prstGeom prst="rect">
+            <a:avLst/>
+          </a:prstGeom>
+          <a:solidFill>
+            <a:srgbClr val="D72638"/>
+          </a:solidFill>
+          <a:ln w="12700">
+            <a:solidFill>
+              <a:srgbClr val="D72638"/>
+            </a:solidFill>
+            <a:prstDash val="solid"/>
+          </a:ln>
+        </p:spPr>
+      </p:sp>
+      <p:sp>
+        <p:nvSpPr>
+          <p:cNvPr id="41" name="Shape 38"/>
+          <p:cNvSpPr/>
+          <p:nvPr/>
+        </p:nvSpPr>
+        <p:spPr>
+          <a:xfrm>
+            <a:off x="7571232" y="5614416"/>
+            <a:ext cx="548640" cy="256032"/>
+          </a:xfrm>
+          <a:prstGeom prst="rect">
+            <a:avLst/>
+          </a:prstGeom>
+          <a:solidFill>
+            <a:srgbClr val="D72638"/>
+          </a:solidFill>
+          <a:ln w="12700">
+            <a:solidFill>
+              <a:srgbClr val="D72638"/>
+            </a:solidFill>
+            <a:prstDash val="solid"/>
+          </a:ln>
+        </p:spPr>
+      </p:sp>
+      <p:sp>
+        <p:nvSpPr>
+          <p:cNvPr id="42" name="Text 39"/>
+          <p:cNvSpPr/>
+          <p:nvPr/>
+        </p:nvSpPr>
+        <p:spPr>
+          <a:xfrm>
+            <a:off x="7571232" y="5614416"/>
+            <a:ext cx="548640" cy="256032"/>
+          </a:xfrm>
+          <a:prstGeom prst="rect">
+            <a:avLst/>
+          </a:prstGeom>
+          <a:noFill/>
+          <a:ln/>
+        </p:spPr>
+        <p:txBody>
+          <a:bodyPr wrap="square" lIns="0" tIns="0" rIns="0" bIns="0" rtlCol="0" anchor="ctr"/>
+          <a:lstStyle/>
+          <a:p>
+            <a:pPr algn="ctr" indent="0" marL="0">
+              <a:buNone/>
+            </a:pPr>
+            <a:r>
+              <a:rPr lang="en-US" sz="900" b="1" dirty="0">
+                <a:solidFill>
+                  <a:srgbClr val="FFFFFF"/>
+                </a:solidFill>
+                <a:latin typeface="맑은 고딕" pitchFamily="34" charset="0"/>
+                <a:ea typeface="맑은 고딕" pitchFamily="34" charset="-122"/>
+                <a:cs typeface="맑은 고딕" pitchFamily="34" charset="-120"/>
+              </a:rPr>
+              <a:t>긴급</a:t>
+            </a:r>
+            <a:endParaRPr lang="en-US" sz="900" dirty="0"/>
+          </a:p>
+        </p:txBody>
+      </p:sp>
+      <p:sp>
+        <p:nvSpPr>
+          <p:cNvPr id="43" name="Text 40"/>
+          <p:cNvSpPr/>
+          <p:nvPr/>
+        </p:nvSpPr>
+        <p:spPr>
+          <a:xfrm>
+            <a:off x="8211312" y="5577840"/>
+            <a:ext cx="3291840" cy="274320"/>
+          </a:xfrm>
+          <a:prstGeom prst="rect">
+            <a:avLst/>
+          </a:prstGeom>
+          <a:noFill/>
+          <a:ln/>
+        </p:spPr>
+        <p:txBody>
+          <a:bodyPr wrap="square" lIns="0" tIns="0" rIns="0" bIns="0" rtlCol="0" anchor="ctr"/>
+          <a:lstStyle/>
+          <a:p>
+            <a:pPr indent="0" marL="0">
+              <a:buNone/>
+            </a:pPr>
+            <a:r>
+              <a:rPr lang="en-US" sz="1100" b="1" dirty="0">
+                <a:solidFill>
+                  <a:srgbClr val="0B1220"/>
+                </a:solidFill>
+                <a:latin typeface="맑은 고딕" pitchFamily="34" charset="0"/>
+                <a:ea typeface="맑은 고딕" pitchFamily="34" charset="-122"/>
+                <a:cs typeface="맑은 고딕" pitchFamily="34" charset="-120"/>
+              </a:rPr>
+              <a:t>Two-ball Bangle</a:t>
+            </a:r>
+            <a:endParaRPr lang="en-US" sz="1100" dirty="0"/>
+          </a:p>
+        </p:txBody>
+      </p:sp>
+      <p:sp>
+        <p:nvSpPr>
+          <p:cNvPr id="44" name="Text 41"/>
+          <p:cNvSpPr/>
+          <p:nvPr/>
+        </p:nvSpPr>
+        <p:spPr>
+          <a:xfrm>
+            <a:off x="8211312" y="5852160"/>
+            <a:ext cx="3291840" cy="256032"/>
+          </a:xfrm>
+          <a:prstGeom prst="rect">
+            <a:avLst/>
+          </a:prstGeom>
+          <a:noFill/>
+          <a:ln/>
+        </p:spPr>
+        <p:txBody>
+          <a:bodyPr wrap="square" lIns="0" tIns="0" rIns="0" bIns="0" rtlCol="0" anchor="ctr"/>
+          <a:lstStyle/>
+          <a:p>
+            <a:pPr indent="0" marL="0">
+              <a:buNone/>
+            </a:pPr>
+            <a:r>
+              <a:rPr lang="en-US" sz="1000" dirty="0">
+                <a:solidFill>
+                  <a:srgbClr val="6B7280"/>
+                </a:solidFill>
+                <a:latin typeface="맑은 고딕" pitchFamily="34" charset="0"/>
+                <a:ea typeface="맑은 고딕" pitchFamily="34" charset="-122"/>
+                <a:cs typeface="맑은 고딕" pitchFamily="34" charset="-120"/>
+              </a:rPr>
+              <a:t>Bracelet  ·  재고 0개</a:t>
+            </a:r>
+            <a:pPr indent="0" marL="0">
+              <a:buNone/>
+            </a:pPr>
+            <a:r>
+              <a:rPr lang="en-US" sz="1000" b="1" dirty="0">
+                <a:solidFill>
+                  <a:srgbClr val="D72638"/>
+                </a:solidFill>
+                <a:latin typeface="맑은 고딕" pitchFamily="34" charset="0"/>
+                <a:ea typeface="맑은 고딕" pitchFamily="34" charset="-122"/>
+                <a:cs typeface="맑은 고딕" pitchFamily="34" charset="-120"/>
+              </a:rPr>
+              <a:t/>
+            </a:r>
+            <a:endParaRPr lang="en-US" sz="1000" dirty="0"/>
+          </a:p>
+        </p:txBody>
+      </p:sp>
+      <p:sp>
+        <p:nvSpPr>
           <p:cNvPr id="45" name="Text 42"/>
           <p:cNvSpPr/>
           <p:nvPr/>
@@ -8267,7 +8267,7 @@
                 <a:ea typeface="맑은 고딕" pitchFamily="34" charset="-122"/>
                 <a:cs typeface="맑은 고딕" pitchFamily="34" charset="-120"/>
               </a:rPr>
-              <a:t>베스트 상품 리포트  ·  생성 2026-05-24 08:00</a:t>
+              <a:t>베스트 상품 리포트  ·  생성 2026-05-25 08:00</a:t>
             </a:r>
             <a:endParaRPr lang="en-US" sz="900" dirty="0"/>
           </a:p>
@@ -8480,7 +8480,7 @@
                 <a:ea typeface="맑은 고딕" pitchFamily="34" charset="-122"/>
                 <a:cs typeface="맑은 고딕" pitchFamily="34" charset="-120"/>
               </a:rPr>
-              <a:t>2026년 05월 24일 (일)</a:t>
+              <a:t>2026년 05월 25일 (월)</a:t>
             </a:r>
             <a:endParaRPr lang="en-US" sz="1200" dirty="0"/>
           </a:p>
@@ -8647,7 +8647,7 @@
                 <a:ea typeface="맑은 고딕" pitchFamily="34" charset="-122"/>
                 <a:cs typeface="맑은 고딕" pitchFamily="34" charset="-120"/>
               </a:rPr>
-              <a:t>194 개</a:t>
+              <a:t>139 개</a:t>
             </a:r>
             <a:endParaRPr lang="en-US" sz="3600" dirty="0"/>
           </a:p>
@@ -8853,7 +8853,7 @@
                 <a:ea typeface="맑은 고딕" pitchFamily="34" charset="-122"/>
                 <a:cs typeface="맑은 고딕" pitchFamily="34" charset="-120"/>
               </a:rPr>
-              <a:t>46</a:t>
+              <a:t>32</a:t>
             </a:r>
             <a:endParaRPr lang="en-US" sz="4400" dirty="0"/>
           </a:p>
@@ -9452,7 +9452,7 @@
                           <a:ea typeface="맑은 고딕" pitchFamily="34" charset="-122"/>
                           <a:cs typeface="맑은 고딕" pitchFamily="34" charset="-120"/>
                         </a:rPr>
-                        <a:t>46 개</a:t>
+                        <a:t>32 개</a:t>
                       </a:r>
                       <a:endParaRPr lang="en-US" sz="1400" dirty="0">
                         <a:latin typeface="맑은 고딕" charset="0"/>
@@ -9714,7 +9714,7 @@
                           <a:ea typeface="맑은 고딕" pitchFamily="34" charset="-122"/>
                           <a:cs typeface="맑은 고딕" pitchFamily="34" charset="-120"/>
                         </a:rPr>
-                        <a:t>44 개</a:t>
+                        <a:t>22 개</a:t>
                       </a:r>
                       <a:endParaRPr lang="en-US" sz="1200" dirty="0">
                         <a:latin typeface="맑은 고딕" charset="0"/>
@@ -9976,7 +9976,7 @@
                           <a:ea typeface="맑은 고딕" pitchFamily="34" charset="-122"/>
                           <a:cs typeface="맑은 고딕" pitchFamily="34" charset="-120"/>
                         </a:rPr>
-                        <a:t>29 개</a:t>
+                        <a:t>18 개</a:t>
                       </a:r>
                       <a:endParaRPr lang="en-US" sz="1200" dirty="0">
                         <a:latin typeface="맑은 고딕" charset="0"/>
@@ -10165,7 +10165,7 @@
                 <a:ea typeface="맑은 고딕" pitchFamily="34" charset="-122"/>
                 <a:cs typeface="맑은 고딕" pitchFamily="34" charset="-120"/>
               </a:rPr>
-              <a:t>베스트 상품 리포트  ·  생성 2026-05-24 08:00</a:t>
+              <a:t>베스트 상품 리포트  ·  생성 2026-05-25 08:00</a:t>
             </a:r>
             <a:endParaRPr lang="en-US" sz="900" dirty="0"/>
           </a:p>
@@ -10378,7 +10378,7 @@
                 <a:ea typeface="맑은 고딕" pitchFamily="34" charset="-122"/>
                 <a:cs typeface="맑은 고딕" pitchFamily="34" charset="-120"/>
               </a:rPr>
-              <a:t>2026년 05월 24일 (일)</a:t>
+              <a:t>2026년 05월 25일 (월)</a:t>
             </a:r>
             <a:endParaRPr lang="en-US" sz="1200" dirty="0"/>
           </a:p>
@@ -10801,7 +10801,7 @@
                 <a:ea typeface="맑은 고딕" pitchFamily="34" charset="-122"/>
                 <a:cs typeface="맑은 고딕" pitchFamily="34" charset="-120"/>
               </a:rPr>
-              <a:t>7</a:t>
+              <a:t>8</a:t>
             </a:r>
             <a:endParaRPr lang="en-US" sz="3000" dirty="0"/>
           </a:p>
@@ -10929,7 +10929,7 @@
                 <a:ea typeface="맑은 고딕" pitchFamily="34" charset="-122"/>
                 <a:cs typeface="맑은 고딕" pitchFamily="34" charset="-120"/>
               </a:rPr>
-              <a:t>30,964</a:t>
+              <a:t>30,688</a:t>
             </a:r>
             <a:endParaRPr lang="en-US" sz="3000" dirty="0"/>
           </a:p>
@@ -11489,7 +11489,7 @@
                           <a:ea typeface="맑은 고딕" pitchFamily="34" charset="-122"/>
                           <a:cs typeface="맑은 고딕" pitchFamily="34" charset="-120"/>
                         </a:rPr>
-                        <a:t>2,087</a:t>
+                        <a:t>2,081</a:t>
                       </a:r>
                       <a:endParaRPr lang="en-US" sz="1000" dirty="0">
                         <a:latin typeface="맑은 고딕" charset="0"/>
@@ -11751,7 +11751,7 @@
                           <a:ea typeface="맑은 고딕" pitchFamily="34" charset="-122"/>
                           <a:cs typeface="맑은 고딕" pitchFamily="34" charset="-120"/>
                         </a:rPr>
-                        <a:t>1,608</a:t>
+                        <a:t>1,604</a:t>
                       </a:r>
                       <a:endParaRPr lang="en-US" sz="1000" dirty="0">
                         <a:latin typeface="맑은 고딕" charset="0"/>
@@ -12013,7 +12013,7 @@
                           <a:ea typeface="맑은 고딕" pitchFamily="34" charset="-122"/>
                           <a:cs typeface="맑은 고딕" pitchFamily="34" charset="-120"/>
                         </a:rPr>
-                        <a:t>1,371</a:t>
+                        <a:t>1,335</a:t>
                       </a:r>
                       <a:endParaRPr lang="en-US" sz="1000" dirty="0">
                         <a:latin typeface="맑은 고딕" charset="0"/>
@@ -12275,7 +12275,7 @@
                           <a:ea typeface="맑은 고딕" pitchFamily="34" charset="-122"/>
                           <a:cs typeface="맑은 고딕" pitchFamily="34" charset="-120"/>
                         </a:rPr>
-                        <a:t>1,189</a:t>
+                        <a:t>1,099</a:t>
                       </a:r>
                       <a:endParaRPr lang="en-US" sz="1000" dirty="0">
                         <a:latin typeface="맑은 고딕" charset="0"/>
@@ -12537,7 +12537,7 @@
                           <a:ea typeface="맑은 고딕" pitchFamily="34" charset="-122"/>
                           <a:cs typeface="맑은 고딕" pitchFamily="34" charset="-120"/>
                         </a:rPr>
-                        <a:t>918</a:t>
+                        <a:t>912</a:t>
                       </a:r>
                       <a:endParaRPr lang="en-US" sz="1000" dirty="0">
                         <a:latin typeface="맑은 고딕" charset="0"/>
@@ -13556,7 +13556,7 @@
                 <a:ea typeface="맑은 고딕" pitchFamily="34" charset="-122"/>
                 <a:cs typeface="맑은 고딕" pitchFamily="34" charset="-120"/>
               </a:rPr>
-              <a:t>베스트 상품 리포트  ·  생성 2026-05-24 08:00</a:t>
+              <a:t>베스트 상품 리포트  ·  생성 2026-05-25 08:00</a:t>
             </a:r>
             <a:endParaRPr lang="en-US" sz="900" dirty="0"/>
           </a:p>
@@ -13769,7 +13769,7 @@
                 <a:ea typeface="맑은 고딕" pitchFamily="34" charset="-122"/>
                 <a:cs typeface="맑은 고딕" pitchFamily="34" charset="-120"/>
               </a:rPr>
-              <a:t>2026년 05월 24일 (일)</a:t>
+              <a:t>2026년 05월 25일 (월)</a:t>
             </a:r>
             <a:endParaRPr lang="en-US" sz="1200" dirty="0"/>
           </a:p>
@@ -13897,7 +13897,7 @@
                 <a:ea typeface="맑은 고딕" pitchFamily="34" charset="-122"/>
                 <a:cs typeface="맑은 고딕" pitchFamily="34" charset="-120"/>
               </a:rPr>
-              <a:t>🚨  긴급 리오더 70건    ·    주의 리오더 10건    ·    오늘 발주 검토 필수</a:t>
+              <a:t>🚨  긴급 리오더 70건    ·    주의 리오더 9건    ·    오늘 발주 검토 필수</a:t>
             </a:r>
             <a:pPr indent="0" marL="0">
               <a:buNone/>
@@ -14527,7 +14527,7 @@
                           <a:ea typeface="맑은 고딕" pitchFamily="34" charset="-122"/>
                           <a:cs typeface="맑은 고딕" pitchFamily="34" charset="-120"/>
                         </a:rPr>
-                        <a:t>PR</a:t>
+                        <a:t>6A</a:t>
                       </a:r>
                       <a:endParaRPr lang="en-US" sz="1100" dirty="0">
                         <a:latin typeface="맑은 고딕" charset="0"/>
@@ -14595,7 +14595,7 @@
                           <a:ea typeface="맑은 고딕" pitchFamily="34" charset="-122"/>
                           <a:cs typeface="맑은 고딕" pitchFamily="34" charset="-120"/>
                         </a:rPr>
-                        <a:t>ELECTRONIC</a:t>
+                        <a:t>Ring</a:t>
                       </a:r>
                       <a:endParaRPr lang="en-US" sz="1000" dirty="0">
                         <a:latin typeface="맑은 고딕" charset="0"/>
@@ -14663,7 +14663,7 @@
                           <a:ea typeface="맑은 고딕" pitchFamily="34" charset="-122"/>
                           <a:cs typeface="맑은 고딕" pitchFamily="34" charset="-120"/>
                         </a:rPr>
-                        <a:t>Jacquard Fast Charging Cable (7color) (컬러: 민트 / 기종옵션: C-Apple 8pin / 길이: 2m)</a:t>
+                        <a:t>[SILVER925] Crimson Open Ring</a:t>
                       </a:r>
                       <a:endParaRPr lang="en-US" sz="1100" dirty="0">
                         <a:latin typeface="맑은 고딕" charset="0"/>
@@ -14731,7 +14731,7 @@
                           <a:ea typeface="맑은 고딕" pitchFamily="34" charset="-122"/>
                           <a:cs typeface="맑은 고딕" pitchFamily="34" charset="-120"/>
                         </a:rPr>
-                        <a:t>19</a:t>
+                        <a:t>1</a:t>
                       </a:r>
                       <a:endParaRPr lang="en-US" sz="1100" dirty="0">
                         <a:latin typeface="맑은 고딕" charset="0"/>
@@ -14937,7 +14937,7 @@
                           <a:ea typeface="맑은 고딕" pitchFamily="34" charset="-122"/>
                           <a:cs typeface="맑은 고딕" pitchFamily="34" charset="-120"/>
                         </a:rPr>
-                        <a:t>PR</a:t>
+                        <a:t>6A</a:t>
                       </a:r>
                       <a:endParaRPr lang="en-US" sz="1100" dirty="0">
                         <a:latin typeface="맑은 고딕" charset="0"/>
@@ -15005,7 +15005,7 @@
                           <a:ea typeface="맑은 고딕" pitchFamily="34" charset="-122"/>
                           <a:cs typeface="맑은 고딕" pitchFamily="34" charset="-120"/>
                         </a:rPr>
-                        <a:t>ETC</a:t>
+                        <a:t>Bracelet</a:t>
                       </a:r>
                       <a:endParaRPr lang="en-US" sz="1000" dirty="0">
                         <a:latin typeface="맑은 고딕" charset="0"/>
@@ -15073,7 +15073,7 @@
                           <a:ea typeface="맑은 고딕" pitchFamily="34" charset="-122"/>
                           <a:cs typeface="맑은 고딕" pitchFamily="34" charset="-120"/>
                         </a:rPr>
-                        <a:t>360° Rotating Phone Holder (컬러: 화이트)</a:t>
+                        <a:t>2PT Bracelet</a:t>
                       </a:r>
                       <a:endParaRPr lang="en-US" sz="1100" dirty="0">
                         <a:latin typeface="맑은 고딕" charset="0"/>
@@ -15141,7 +15141,7 @@
                           <a:ea typeface="맑은 고딕" pitchFamily="34" charset="-122"/>
                           <a:cs typeface="맑은 고딕" pitchFamily="34" charset="-120"/>
                         </a:rPr>
-                        <a:t>11</a:t>
+                        <a:t>3</a:t>
                       </a:r>
                       <a:endParaRPr lang="en-US" sz="1100" dirty="0">
                         <a:latin typeface="맑은 고딕" charset="0"/>
@@ -15209,7 +15209,7 @@
                           <a:ea typeface="맑은 고딕" pitchFamily="34" charset="-122"/>
                           <a:cs typeface="맑은 고딕" pitchFamily="34" charset="-120"/>
                         </a:rPr>
-                        <a:t>3 개</a:t>
+                        <a:t>2 개</a:t>
                       </a:r>
                       <a:endParaRPr lang="en-US" sz="1100" dirty="0">
                         <a:latin typeface="맑은 고딕" charset="0"/>
@@ -15347,7 +15347,7 @@
                           <a:ea typeface="맑은 고딕" pitchFamily="34" charset="-122"/>
                           <a:cs typeface="맑은 고딕" pitchFamily="34" charset="-120"/>
                         </a:rPr>
-                        <a:t>6A</a:t>
+                        <a:t>CT</a:t>
                       </a:r>
                       <a:endParaRPr lang="en-US" sz="1100" dirty="0">
                         <a:latin typeface="맑은 고딕" charset="0"/>
@@ -15415,7 +15415,7 @@
                           <a:ea typeface="맑은 고딕" pitchFamily="34" charset="-122"/>
                           <a:cs typeface="맑은 고딕" pitchFamily="34" charset="-120"/>
                         </a:rPr>
-                        <a:t>Bracelet</a:t>
+                        <a:t>Ring</a:t>
                       </a:r>
                       <a:endParaRPr lang="en-US" sz="1000" dirty="0">
                         <a:latin typeface="맑은 고딕" charset="0"/>
@@ -15483,7 +15483,7 @@
                           <a:ea typeface="맑은 고딕" pitchFamily="34" charset="-122"/>
                           <a:cs typeface="맑은 고딕" pitchFamily="34" charset="-120"/>
                         </a:rPr>
-                        <a:t>2PT Bracelet</a:t>
+                        <a:t>"Mlayer" 925 Open Ring</a:t>
                       </a:r>
                       <a:endParaRPr lang="en-US" sz="1100" dirty="0">
                         <a:latin typeface="맑은 고딕" charset="0"/>
@@ -15551,7 +15551,7 @@
                           <a:ea typeface="맑은 고딕" pitchFamily="34" charset="-122"/>
                           <a:cs typeface="맑은 고딕" pitchFamily="34" charset="-120"/>
                         </a:rPr>
-                        <a:t>5</a:t>
+                        <a:t>1</a:t>
                       </a:r>
                       <a:endParaRPr lang="en-US" sz="1100" dirty="0">
                         <a:latin typeface="맑은 고딕" charset="0"/>
@@ -15757,7 +15757,7 @@
                           <a:ea typeface="맑은 고딕" pitchFamily="34" charset="-122"/>
                           <a:cs typeface="맑은 고딕" pitchFamily="34" charset="-120"/>
                         </a:rPr>
-                        <a:t>6A</a:t>
+                        <a:t>CT</a:t>
                       </a:r>
                       <a:endParaRPr lang="en-US" sz="1100" dirty="0">
                         <a:latin typeface="맑은 고딕" charset="0"/>
@@ -15893,7 +15893,7 @@
                           <a:ea typeface="맑은 고딕" pitchFamily="34" charset="-122"/>
                           <a:cs typeface="맑은 고딕" pitchFamily="34" charset="-120"/>
                         </a:rPr>
-                        <a:t>[SILVER925] Crimson Open Ring</a:t>
+                        <a:t>"Bloometal" 925 Open Ring</a:t>
                       </a:r>
                       <a:endParaRPr lang="en-US" sz="1100" dirty="0">
                         <a:latin typeface="맑은 고딕" charset="0"/>
@@ -15961,7 +15961,7 @@
                           <a:ea typeface="맑은 고딕" pitchFamily="34" charset="-122"/>
                           <a:cs typeface="맑은 고딕" pitchFamily="34" charset="-120"/>
                         </a:rPr>
-                        <a:t>4</a:t>
+                        <a:t>0</a:t>
                       </a:r>
                       <a:endParaRPr lang="en-US" sz="1100" dirty="0">
                         <a:latin typeface="맑은 고딕" charset="0"/>
@@ -16371,7 +16371,7 @@
                           <a:ea typeface="맑은 고딕" pitchFamily="34" charset="-122"/>
                           <a:cs typeface="맑은 고딕" pitchFamily="34" charset="-120"/>
                         </a:rPr>
-                        <a:t>2</a:t>
+                        <a:t>1</a:t>
                       </a:r>
                       <a:endParaRPr lang="en-US" sz="1100" dirty="0">
                         <a:latin typeface="맑은 고딕" charset="0"/>
@@ -16439,7 +16439,7 @@
                           <a:ea typeface="맑은 고딕" pitchFamily="34" charset="-122"/>
                           <a:cs typeface="맑은 고딕" pitchFamily="34" charset="-120"/>
                         </a:rPr>
-                        <a:t>2 개</a:t>
+                        <a:t>1 개</a:t>
                       </a:r>
                       <a:endParaRPr lang="en-US" sz="1100" dirty="0">
                         <a:latin typeface="맑은 고딕" charset="0"/>
@@ -16713,7 +16713,7 @@
                           <a:ea typeface="맑은 고딕" pitchFamily="34" charset="-122"/>
                           <a:cs typeface="맑은 고딕" pitchFamily="34" charset="-120"/>
                         </a:rPr>
-                        <a:t>Jacquard Fast Charging Cable (7color) (컬러: 퍼플 / 기종옵션: C-Apple 8pin / 길이: 2m)</a:t>
+                        <a:t>Jacquard Fast Charging Cable (7color) (컬러: 민트 / 기종옵션: C-Apple 8pin / 길이: 2m)</a:t>
                       </a:r>
                       <a:endParaRPr lang="en-US" sz="1100" dirty="0">
                         <a:latin typeface="맑은 고딕" charset="0"/>
@@ -16781,7 +16781,7 @@
                           <a:ea typeface="맑은 고딕" pitchFamily="34" charset="-122"/>
                           <a:cs typeface="맑은 고딕" pitchFamily="34" charset="-120"/>
                         </a:rPr>
-                        <a:t>8</a:t>
+                        <a:t>18</a:t>
                       </a:r>
                       <a:endParaRPr lang="en-US" sz="1100" dirty="0">
                         <a:latin typeface="맑은 고딕" charset="0"/>
@@ -16849,7 +16849,7 @@
                           <a:ea typeface="맑은 고딕" pitchFamily="34" charset="-122"/>
                           <a:cs typeface="맑은 고딕" pitchFamily="34" charset="-120"/>
                         </a:rPr>
-                        <a:t>2 개</a:t>
+                        <a:t>1 개</a:t>
                       </a:r>
                       <a:endParaRPr lang="en-US" sz="1100" dirty="0">
                         <a:latin typeface="맑은 고딕" charset="0"/>
@@ -16987,7 +16987,7 @@
                           <a:ea typeface="맑은 고딕" pitchFamily="34" charset="-122"/>
                           <a:cs typeface="맑은 고딕" pitchFamily="34" charset="-120"/>
                         </a:rPr>
-                        <a:t>6A</a:t>
+                        <a:t>PR</a:t>
                       </a:r>
                       <a:endParaRPr lang="en-US" sz="1100" dirty="0">
                         <a:latin typeface="맑은 고딕" charset="0"/>
@@ -17055,7 +17055,7 @@
                           <a:ea typeface="맑은 고딕" pitchFamily="34" charset="-122"/>
                           <a:cs typeface="맑은 고딕" pitchFamily="34" charset="-120"/>
                         </a:rPr>
-                        <a:t>Necklace</a:t>
+                        <a:t>★ Last Sale ★</a:t>
                       </a:r>
                       <a:endParaRPr lang="en-US" sz="1000" dirty="0">
                         <a:latin typeface="맑은 고딕" charset="0"/>
@@ -17123,7 +17123,7 @@
                           <a:ea typeface="맑은 고딕" pitchFamily="34" charset="-122"/>
                           <a:cs typeface="맑은 고딕" pitchFamily="34" charset="-120"/>
                         </a:rPr>
-                        <a:t>Chainlink Necklace</a:t>
+                        <a:t>Cloud Grip Glass Mini Brush (3color) (컬러: 스카이블루)</a:t>
                       </a:r>
                       <a:endParaRPr lang="en-US" sz="1100" dirty="0">
                         <a:latin typeface="맑은 고딕" charset="0"/>
@@ -17191,7 +17191,7 @@
                           <a:ea typeface="맑은 고딕" pitchFamily="34" charset="-122"/>
                           <a:cs typeface="맑은 고딕" pitchFamily="34" charset="-120"/>
                         </a:rPr>
-                        <a:t>0</a:t>
+                        <a:t>14</a:t>
                       </a:r>
                       <a:endParaRPr lang="en-US" sz="1100" dirty="0">
                         <a:latin typeface="맑은 고딕" charset="0"/>
@@ -17397,7 +17397,7 @@
                           <a:ea typeface="맑은 고딕" pitchFamily="34" charset="-122"/>
                           <a:cs typeface="맑은 고딕" pitchFamily="34" charset="-120"/>
                         </a:rPr>
-                        <a:t>CT</a:t>
+                        <a:t>PR</a:t>
                       </a:r>
                       <a:endParaRPr lang="en-US" sz="1100" dirty="0">
                         <a:latin typeface="맑은 고딕" charset="0"/>
@@ -17465,7 +17465,7 @@
                           <a:ea typeface="맑은 고딕" pitchFamily="34" charset="-122"/>
                           <a:cs typeface="맑은 고딕" pitchFamily="34" charset="-120"/>
                         </a:rPr>
-                        <a:t>Ring</a:t>
+                        <a:t>ETC</a:t>
                       </a:r>
                       <a:endParaRPr lang="en-US" sz="1000" dirty="0">
                         <a:latin typeface="맑은 고딕" charset="0"/>
@@ -17533,7 +17533,7 @@
                           <a:ea typeface="맑은 고딕" pitchFamily="34" charset="-122"/>
                           <a:cs typeface="맑은 고딕" pitchFamily="34" charset="-120"/>
                         </a:rPr>
-                        <a:t>"Mlayer" 925 Open Ring</a:t>
+                        <a:t>360° Rotating Phone Holder (컬러: 화이트)</a:t>
                       </a:r>
                       <a:endParaRPr lang="en-US" sz="1100" dirty="0">
                         <a:latin typeface="맑은 고딕" charset="0"/>
@@ -17601,7 +17601,7 @@
                           <a:ea typeface="맑은 고딕" pitchFamily="34" charset="-122"/>
                           <a:cs typeface="맑은 고딕" pitchFamily="34" charset="-120"/>
                         </a:rPr>
-                        <a:t>3</a:t>
+                        <a:t>10</a:t>
                       </a:r>
                       <a:endParaRPr lang="en-US" sz="1100" dirty="0">
                         <a:latin typeface="맑은 고딕" charset="0"/>
@@ -17807,7 +17807,7 @@
                           <a:ea typeface="맑은 고딕" pitchFamily="34" charset="-122"/>
                           <a:cs typeface="맑은 고딕" pitchFamily="34" charset="-120"/>
                         </a:rPr>
-                        <a:t>CT</a:t>
+                        <a:t>6A</a:t>
                       </a:r>
                       <a:endParaRPr lang="en-US" sz="1100" dirty="0">
                         <a:latin typeface="맑은 고딕" charset="0"/>
@@ -17875,7 +17875,7 @@
                           <a:ea typeface="맑은 고딕" pitchFamily="34" charset="-122"/>
                           <a:cs typeface="맑은 고딕" pitchFamily="34" charset="-120"/>
                         </a:rPr>
-                        <a:t>Ring</a:t>
+                        <a:t>★Season off★</a:t>
                       </a:r>
                       <a:endParaRPr lang="en-US" sz="1000" dirty="0">
                         <a:latin typeface="맑은 고딕" charset="0"/>
@@ -17943,7 +17943,7 @@
                           <a:ea typeface="맑은 고딕" pitchFamily="34" charset="-122"/>
                           <a:cs typeface="맑은 고딕" pitchFamily="34" charset="-120"/>
                         </a:rPr>
-                        <a:t>"Bloometal" 925 Open Ring</a:t>
+                        <a:t>8-Ball Smart Tok</a:t>
                       </a:r>
                       <a:endParaRPr lang="en-US" sz="1100" dirty="0">
                         <a:latin typeface="맑은 고딕" charset="0"/>
@@ -18011,7 +18011,7 @@
                           <a:ea typeface="맑은 고딕" pitchFamily="34" charset="-122"/>
                           <a:cs typeface="맑은 고딕" pitchFamily="34" charset="-120"/>
                         </a:rPr>
-                        <a:t>2</a:t>
+                        <a:t>4</a:t>
                       </a:r>
                       <a:endParaRPr lang="en-US" sz="1100" dirty="0">
                         <a:latin typeface="맑은 고딕" charset="0"/>
@@ -18079,7 +18079,7 @@
                           <a:ea typeface="맑은 고딕" pitchFamily="34" charset="-122"/>
                           <a:cs typeface="맑은 고딕" pitchFamily="34" charset="-120"/>
                         </a:rPr>
-                        <a:t>1 개</a:t>
+                        <a:t>0 개</a:t>
                       </a:r>
                       <a:endParaRPr lang="en-US" sz="1100" dirty="0">
                         <a:latin typeface="맑은 고딕" charset="0"/>
@@ -18207,7 +18207,7 @@
                 <a:ea typeface="맑은 고딕" pitchFamily="34" charset="-122"/>
                 <a:cs typeface="맑은 고딕" pitchFamily="34" charset="-120"/>
               </a:rPr>
-              <a:t>베스트 상품 리포트  ·  생성 2026-05-24 08:00</a:t>
+              <a:t>베스트 상품 리포트  ·  생성 2026-05-25 08:00</a:t>
             </a:r>
             <a:endParaRPr lang="en-US" sz="900" dirty="0"/>
           </a:p>
@@ -18420,7 +18420,7 @@
                 <a:ea typeface="맑은 고딕" pitchFamily="34" charset="-122"/>
                 <a:cs typeface="맑은 고딕" pitchFamily="34" charset="-120"/>
               </a:rPr>
-              <a:t>2026년 05월 24일 (일)</a:t>
+              <a:t>2026년 05월 25일 (월)</a:t>
             </a:r>
             <a:endParaRPr lang="en-US" sz="1200" dirty="0"/>
           </a:p>
@@ -18587,7 +18587,7 @@
                 <a:ea typeface="맑은 고딕" pitchFamily="34" charset="-122"/>
                 <a:cs typeface="맑은 고딕" pitchFamily="34" charset="-120"/>
               </a:rPr>
-              <a:t>Google Sheet '브랜드 재고현황'  ·  최신화 2026-05-24 08:00</a:t>
+              <a:t>Google Sheet '브랜드 재고현황'  ·  최신화 2026-05-25 08:00</a:t>
             </a:r>
             <a:endParaRPr lang="en-US" sz="1100" dirty="0"/>
           </a:p>
@@ -19230,7 +19230,7 @@
                 <a:ea typeface="맑은 고딕" pitchFamily="34" charset="-122"/>
                 <a:cs typeface="맑은 고딕" pitchFamily="34" charset="-120"/>
               </a:rPr>
-              <a:t>✅ 3개 브랜드 모두 정상 추출  ·  24h 출고 기준 (2026-05-23 08:00 → 2026-05-24 08:00) · 신규 SKU 11건은 결제완료 기준</a:t>
+              <a:t>✅ 3개 브랜드 모두 정상 추출  ·  24h 출고 기준 (2026-05-24 08:00 → 2026-05-25 08:00) · 신규 SKU 11건은 결제완료 기준</a:t>
             </a:r>
             <a:endParaRPr lang="en-US" sz="1000" dirty="0"/>
           </a:p>
@@ -19269,7 +19269,7 @@
                 <a:ea typeface="맑은 고딕" pitchFamily="34" charset="-122"/>
                 <a:cs typeface="맑은 고딕" pitchFamily="34" charset="-120"/>
               </a:rPr>
-              <a:t>베스트 상품 리포트  ·  생성 2026-05-24 08:00</a:t>
+              <a:t>베스트 상품 리포트  ·  생성 2026-05-25 08:00</a:t>
             </a:r>
             <a:endParaRPr lang="en-US" sz="900" dirty="0"/>
           </a:p>

</xml_diff>

<commit_message>
chore: 매출 PPT 업로드 (best-sellers-2026-05-26.pptx) [auto]
</commit_message>
<xml_diff>
--- a/data/sales-report.pptx
+++ b/data/sales-report.pptx
@@ -1648,7 +1648,7 @@
                 <a:ea typeface="맑은 고딕" pitchFamily="34" charset="-122"/>
                 <a:cs typeface="맑은 고딕" pitchFamily="34" charset="-120"/>
               </a:rPr>
-              <a:t>2026년 05월 25일 (월)  ·  24h 출고 기준</a:t>
+              <a:t>2026년 05월 26일 (화)  ·  24h 출고 기준</a:t>
             </a:r>
             <a:endParaRPr lang="en-US" sz="2200" dirty="0"/>
           </a:p>
@@ -1726,7 +1726,7 @@
                 <a:ea typeface="맑은 고딕" pitchFamily="34" charset="-122"/>
                 <a:cs typeface="맑은 고딕" pitchFamily="34" charset="-120"/>
               </a:rPr>
-              <a:t>05.25</a:t>
+              <a:t>05.26</a:t>
             </a:r>
             <a:endParaRPr lang="en-US" sz="7200" dirty="0"/>
           </a:p>
@@ -1765,7 +1765,7 @@
                 <a:ea typeface="맑은 고딕" pitchFamily="34" charset="-122"/>
                 <a:cs typeface="맑은 고딕" pitchFamily="34" charset="-120"/>
               </a:rPr>
-              <a:t>월요일</a:t>
+              <a:t>화요일</a:t>
             </a:r>
             <a:endParaRPr lang="en-US" sz="1400" dirty="0"/>
           </a:p>
@@ -1804,7 +1804,7 @@
                 <a:ea typeface="맑은 고딕" pitchFamily="34" charset="-122"/>
                 <a:cs typeface="맑은 고딕" pitchFamily="34" charset="-120"/>
               </a:rPr>
-              <a:t>생성 2026-05-25 08:00  ·  Google Sheet 자동 동기</a:t>
+              <a:t>생성 2026-05-26 08:00  ·  Google Sheet 자동 동기</a:t>
             </a:r>
             <a:endParaRPr lang="en-US" sz="1000" dirty="0"/>
           </a:p>
@@ -1978,7 +1978,7 @@
                 <a:ea typeface="맑은 고딕" pitchFamily="34" charset="-122"/>
                 <a:cs typeface="맑은 고딕" pitchFamily="34" charset="-120"/>
               </a:rPr>
-              <a:t>2026년 05월 25일 (월)</a:t>
+              <a:t>2026년 05월 26일 (화)</a:t>
             </a:r>
             <a:endParaRPr lang="en-US" sz="1200" dirty="0"/>
           </a:p>
@@ -2145,7 +2145,7 @@
                 <a:ea typeface="맑은 고딕" pitchFamily="34" charset="-122"/>
                 <a:cs typeface="맑은 고딕" pitchFamily="34" charset="-120"/>
               </a:rPr>
-              <a:t>660 개</a:t>
+              <a:t>770 개</a:t>
             </a:r>
             <a:endParaRPr lang="en-US" sz="3600" dirty="0"/>
           </a:p>
@@ -2312,7 +2312,7 @@
                 <a:ea typeface="맑은 고딕" pitchFamily="34" charset="-122"/>
                 <a:cs typeface="맑은 고딕" pitchFamily="34" charset="-120"/>
               </a:rPr>
-              <a:t>70 건</a:t>
+              <a:t>73 건</a:t>
             </a:r>
             <a:endParaRPr lang="en-US" sz="3200" dirty="0"/>
           </a:p>
@@ -2479,7 +2479,7 @@
                 <a:ea typeface="맑은 고딕" pitchFamily="34" charset="-122"/>
                 <a:cs typeface="맑은 고딕" pitchFamily="34" charset="-120"/>
               </a:rPr>
-              <a:t>9 건</a:t>
+              <a:t>12 건</a:t>
             </a:r>
             <a:endParaRPr lang="en-US" sz="3200" dirty="0"/>
           </a:p>
@@ -3677,7 +3677,7 @@
                           <a:ea typeface="맑은 고딕" pitchFamily="34" charset="-122"/>
                           <a:cs typeface="맑은 고딕" pitchFamily="34" charset="-120"/>
                         </a:rPr>
-                        <a:t>99 개</a:t>
+                        <a:t>145 개</a:t>
                       </a:r>
                       <a:endParaRPr lang="en-US" sz="1400" dirty="0">
                         <a:latin typeface="맑은 고딕" charset="0"/>
@@ -3939,7 +3939,7 @@
                           <a:ea typeface="맑은 고딕" pitchFamily="34" charset="-122"/>
                           <a:cs typeface="맑은 고딕" pitchFamily="34" charset="-120"/>
                         </a:rPr>
-                        <a:t>[SILVER925] CH.alban Open Ring</a:t>
+                        <a:t>[SILVER925] Starly Open Ring</a:t>
                       </a:r>
                       <a:endParaRPr lang="en-US" sz="1100" dirty="0">
                         <a:latin typeface="맑은 고딕" charset="0"/>
@@ -4004,7 +4004,7 @@
                           <a:ea typeface="맑은 고딕" pitchFamily="34" charset="-122"/>
                           <a:cs typeface="맑은 고딕" pitchFamily="34" charset="-120"/>
                         </a:rPr>
-                        <a:t>59 개</a:t>
+                        <a:t>61 개</a:t>
                       </a:r>
                       <a:endParaRPr lang="en-US" sz="1400" dirty="0">
                         <a:latin typeface="맑은 고딕" charset="0"/>
@@ -4201,7 +4201,7 @@
                           <a:ea typeface="맑은 고딕" pitchFamily="34" charset="-122"/>
                           <a:cs typeface="맑은 고딕" pitchFamily="34" charset="-120"/>
                         </a:rPr>
-                        <a:t>Ring</a:t>
+                        <a:t>Necklace</a:t>
                       </a:r>
                       <a:endParaRPr lang="en-US" sz="1000" dirty="0">
                         <a:latin typeface="맑은 고딕" charset="0"/>
@@ -4266,7 +4266,7 @@
                           <a:ea typeface="맑은 고딕" pitchFamily="34" charset="-122"/>
                           <a:cs typeface="맑은 고딕" pitchFamily="34" charset="-120"/>
                         </a:rPr>
-                        <a:t>[SILVER925] Starly Open Ring</a:t>
+                        <a:t>Tiny Cross Necklace</a:t>
                       </a:r>
                       <a:endParaRPr lang="en-US" sz="1100" dirty="0">
                         <a:latin typeface="맑은 고딕" charset="0"/>
@@ -4331,7 +4331,7 @@
                           <a:ea typeface="맑은 고딕" pitchFamily="34" charset="-122"/>
                           <a:cs typeface="맑은 고딕" pitchFamily="34" charset="-120"/>
                         </a:rPr>
-                        <a:t>45 개</a:t>
+                        <a:t>47 개</a:t>
                       </a:r>
                       <a:endParaRPr lang="en-US" sz="1400" dirty="0">
                         <a:latin typeface="맑은 고딕" charset="0"/>
@@ -4528,7 +4528,7 @@
                           <a:ea typeface="맑은 고딕" pitchFamily="34" charset="-122"/>
                           <a:cs typeface="맑은 고딕" pitchFamily="34" charset="-120"/>
                         </a:rPr>
-                        <a:t>Necklace</a:t>
+                        <a:t>Ring</a:t>
                       </a:r>
                       <a:endParaRPr lang="en-US" sz="1000" dirty="0">
                         <a:latin typeface="맑은 고딕" charset="0"/>
@@ -4593,7 +4593,7 @@
                           <a:ea typeface="맑은 고딕" pitchFamily="34" charset="-122"/>
                           <a:cs typeface="맑은 고딕" pitchFamily="34" charset="-120"/>
                         </a:rPr>
-                        <a:t>Tiny Cross Necklace</a:t>
+                        <a:t>[SILVER925] Cstic Open Ring</a:t>
                       </a:r>
                       <a:endParaRPr lang="en-US" sz="1100" dirty="0">
                         <a:latin typeface="맑은 고딕" charset="0"/>
@@ -4658,7 +4658,7 @@
                           <a:ea typeface="맑은 고딕" pitchFamily="34" charset="-122"/>
                           <a:cs typeface="맑은 고딕" pitchFamily="34" charset="-120"/>
                         </a:rPr>
-                        <a:t>33 개</a:t>
+                        <a:t>43 개</a:t>
                       </a:r>
                       <a:endParaRPr lang="en-US" sz="1200" dirty="0">
                         <a:latin typeface="맑은 고딕" charset="0"/>
@@ -4790,7 +4790,7 @@
                           <a:ea typeface="맑은 고딕" pitchFamily="34" charset="-122"/>
                           <a:cs typeface="맑은 고딕" pitchFamily="34" charset="-120"/>
                         </a:rPr>
-                        <a:t>CT</a:t>
+                        <a:t>6A</a:t>
                       </a:r>
                       <a:endParaRPr lang="en-US" sz="1100" dirty="0">
                         <a:latin typeface="맑은 고딕" charset="0"/>
@@ -4855,7 +4855,7 @@
                           <a:ea typeface="맑은 고딕" pitchFamily="34" charset="-122"/>
                           <a:cs typeface="맑은 고딕" pitchFamily="34" charset="-120"/>
                         </a:rPr>
-                        <a:t>Necklace</a:t>
+                        <a:t>Ring</a:t>
                       </a:r>
                       <a:endParaRPr lang="en-US" sz="1000" dirty="0">
                         <a:latin typeface="맑은 고딕" charset="0"/>
@@ -4920,7 +4920,7 @@
                           <a:ea typeface="맑은 고딕" pitchFamily="34" charset="-122"/>
                           <a:cs typeface="맑은 고딕" pitchFamily="34" charset="-120"/>
                         </a:rPr>
-                        <a:t>CandyPOP Necklace (사이즈: 1size (37~43cm))</a:t>
+                        <a:t>[SILVER925] A Rua Open Ring</a:t>
                       </a:r>
                       <a:endParaRPr lang="en-US" sz="1100" dirty="0">
                         <a:latin typeface="맑은 고딕" charset="0"/>
@@ -4985,7 +4985,7 @@
                           <a:ea typeface="맑은 고딕" pitchFamily="34" charset="-122"/>
                           <a:cs typeface="맑은 고딕" pitchFamily="34" charset="-120"/>
                         </a:rPr>
-                        <a:t>32 개</a:t>
+                        <a:t>41 개</a:t>
                       </a:r>
                       <a:endParaRPr lang="en-US" sz="1200" dirty="0">
                         <a:latin typeface="맑은 고딕" charset="0"/>
@@ -5071,7 +5071,7 @@
                 <a:ea typeface="맑은 고딕" pitchFamily="34" charset="-122"/>
                 <a:cs typeface="맑은 고딕" pitchFamily="34" charset="-120"/>
               </a:rPr>
-              <a:t>베스트 상품 리포트  ·  생성 2026-05-25 08:00</a:t>
+              <a:t>베스트 상품 리포트  ·  생성 2026-05-26 08:00</a:t>
             </a:r>
             <a:endParaRPr lang="en-US" sz="900" dirty="0"/>
           </a:p>
@@ -5284,7 +5284,7 @@
                 <a:ea typeface="맑은 고딕" pitchFamily="34" charset="-122"/>
                 <a:cs typeface="맑은 고딕" pitchFamily="34" charset="-120"/>
               </a:rPr>
-              <a:t>2026년 05월 25일 (월)</a:t>
+              <a:t>2026년 05월 26일 (화)</a:t>
             </a:r>
             <a:endParaRPr lang="en-US" sz="1200" dirty="0"/>
           </a:p>
@@ -5451,7 +5451,7 @@
                 <a:ea typeface="맑은 고딕" pitchFamily="34" charset="-122"/>
                 <a:cs typeface="맑은 고딕" pitchFamily="34" charset="-120"/>
               </a:rPr>
-              <a:t>521 개</a:t>
+              <a:t>633 개</a:t>
             </a:r>
             <a:endParaRPr lang="en-US" sz="3600" dirty="0"/>
           </a:p>
@@ -5657,7 +5657,7 @@
                 <a:ea typeface="맑은 고딕" pitchFamily="34" charset="-122"/>
                 <a:cs typeface="맑은 고딕" pitchFamily="34" charset="-120"/>
               </a:rPr>
-              <a:t>99</a:t>
+              <a:t>145</a:t>
             </a:r>
             <a:endParaRPr lang="en-US" sz="4400" dirty="0"/>
           </a:p>
@@ -6256,7 +6256,7 @@
                           <a:ea typeface="맑은 고딕" pitchFamily="34" charset="-122"/>
                           <a:cs typeface="맑은 고딕" pitchFamily="34" charset="-120"/>
                         </a:rPr>
-                        <a:t>99 개</a:t>
+                        <a:t>145 개</a:t>
                       </a:r>
                       <a:endParaRPr lang="en-US" sz="1400" dirty="0">
                         <a:latin typeface="맑은 고딕" charset="0"/>
@@ -6453,7 +6453,7 @@
                           <a:ea typeface="맑은 고딕" pitchFamily="34" charset="-122"/>
                           <a:cs typeface="맑은 고딕" pitchFamily="34" charset="-120"/>
                         </a:rPr>
-                        <a:t>[SILVER925] CH.alban Open Ring</a:t>
+                        <a:t>[SILVER925] Starly Open Ring</a:t>
                       </a:r>
                       <a:endParaRPr lang="en-US" sz="1100" dirty="0">
                         <a:latin typeface="맑은 고딕" charset="0"/>
@@ -6518,7 +6518,7 @@
                           <a:ea typeface="맑은 고딕" pitchFamily="34" charset="-122"/>
                           <a:cs typeface="맑은 고딕" pitchFamily="34" charset="-120"/>
                         </a:rPr>
-                        <a:t>59 개</a:t>
+                        <a:t>61 개</a:t>
                       </a:r>
                       <a:endParaRPr lang="en-US" sz="1200" dirty="0">
                         <a:latin typeface="맑은 고딕" charset="0"/>
@@ -6650,7 +6650,7 @@
                           <a:ea typeface="맑은 고딕" pitchFamily="34" charset="-122"/>
                           <a:cs typeface="맑은 고딕" pitchFamily="34" charset="-120"/>
                         </a:rPr>
-                        <a:t>Ring</a:t>
+                        <a:t>Necklace</a:t>
                       </a:r>
                       <a:endParaRPr lang="en-US" sz="1000" dirty="0">
                         <a:latin typeface="맑은 고딕" charset="0"/>
@@ -6715,7 +6715,7 @@
                           <a:ea typeface="맑은 고딕" pitchFamily="34" charset="-122"/>
                           <a:cs typeface="맑은 고딕" pitchFamily="34" charset="-120"/>
                         </a:rPr>
-                        <a:t>[SILVER925] Starly Open Ring</a:t>
+                        <a:t>Tiny Cross Necklace</a:t>
                       </a:r>
                       <a:endParaRPr lang="en-US" sz="1100" dirty="0">
                         <a:latin typeface="맑은 고딕" charset="0"/>
@@ -6780,7 +6780,7 @@
                           <a:ea typeface="맑은 고딕" pitchFamily="34" charset="-122"/>
                           <a:cs typeface="맑은 고딕" pitchFamily="34" charset="-120"/>
                         </a:rPr>
-                        <a:t>45 개</a:t>
+                        <a:t>47 개</a:t>
                       </a:r>
                       <a:endParaRPr lang="en-US" sz="1200" dirty="0">
                         <a:latin typeface="맑은 고딕" charset="0"/>
@@ -6912,7 +6912,7 @@
                           <a:ea typeface="맑은 고딕" pitchFamily="34" charset="-122"/>
                           <a:cs typeface="맑은 고딕" pitchFamily="34" charset="-120"/>
                         </a:rPr>
-                        <a:t>Necklace</a:t>
+                        <a:t>Ring</a:t>
                       </a:r>
                       <a:endParaRPr lang="en-US" sz="1000" dirty="0">
                         <a:latin typeface="맑은 고딕" charset="0"/>
@@ -6977,7 +6977,7 @@
                           <a:ea typeface="맑은 고딕" pitchFamily="34" charset="-122"/>
                           <a:cs typeface="맑은 고딕" pitchFamily="34" charset="-120"/>
                         </a:rPr>
-                        <a:t>Tiny Cross Necklace</a:t>
+                        <a:t>[SILVER925] Cstic Open Ring</a:t>
                       </a:r>
                       <a:endParaRPr lang="en-US" sz="1100" dirty="0">
                         <a:latin typeface="맑은 고딕" charset="0"/>
@@ -7042,7 +7042,7 @@
                           <a:ea typeface="맑은 고딕" pitchFamily="34" charset="-122"/>
                           <a:cs typeface="맑은 고딕" pitchFamily="34" charset="-120"/>
                         </a:rPr>
-                        <a:t>33 개</a:t>
+                        <a:t>43 개</a:t>
                       </a:r>
                       <a:endParaRPr lang="en-US" sz="1200" dirty="0">
                         <a:latin typeface="맑은 고딕" charset="0"/>
@@ -7304,7 +7304,7 @@
                           <a:ea typeface="맑은 고딕" pitchFamily="34" charset="-122"/>
                           <a:cs typeface="맑은 고딕" pitchFamily="34" charset="-120"/>
                         </a:rPr>
-                        <a:t>31 개</a:t>
+                        <a:t>41 개</a:t>
                       </a:r>
                       <a:endParaRPr lang="en-US" sz="1200" dirty="0">
                         <a:latin typeface="맑은 고딕" charset="0"/>
@@ -7390,7 +7390,7 @@
                 <a:ea typeface="맑은 고딕" pitchFamily="34" charset="-122"/>
                 <a:cs typeface="맑은 고딕" pitchFamily="34" charset="-120"/>
               </a:rPr>
-              <a:t>리오더 필요  🔴 긴급 9건</a:t>
+              <a:t>리오더 필요  🔴 긴급 10건</a:t>
             </a:r>
             <a:pPr indent="0" marL="0">
               <a:buNone/>
@@ -7557,6 +7557,624 @@
                 <a:ea typeface="맑은 고딕" pitchFamily="34" charset="-122"/>
                 <a:cs typeface="맑은 고딕" pitchFamily="34" charset="-120"/>
               </a:rPr>
+              <a:t>[SILVER925] Flowy Open Ring</a:t>
+            </a:r>
+            <a:endParaRPr lang="en-US" sz="1100" dirty="0"/>
+          </a:p>
+        </p:txBody>
+      </p:sp>
+      <p:sp>
+        <p:nvSpPr>
+          <p:cNvPr id="26" name="Text 23"/>
+          <p:cNvSpPr/>
+          <p:nvPr/>
+        </p:nvSpPr>
+        <p:spPr>
+          <a:xfrm>
+            <a:off x="8211312" y="3712464"/>
+            <a:ext cx="3291840" cy="256032"/>
+          </a:xfrm>
+          <a:prstGeom prst="rect">
+            <a:avLst/>
+          </a:prstGeom>
+          <a:noFill/>
+          <a:ln/>
+        </p:spPr>
+        <p:txBody>
+          <a:bodyPr wrap="square" lIns="0" tIns="0" rIns="0" bIns="0" rtlCol="0" anchor="ctr"/>
+          <a:lstStyle/>
+          <a:p>
+            <a:pPr indent="0" marL="0">
+              <a:buNone/>
+            </a:pPr>
+            <a:r>
+              <a:rPr lang="en-US" sz="1000" dirty="0">
+                <a:solidFill>
+                  <a:srgbClr val="6B7280"/>
+                </a:solidFill>
+                <a:latin typeface="맑은 고딕" pitchFamily="34" charset="0"/>
+                <a:ea typeface="맑은 고딕" pitchFamily="34" charset="-122"/>
+                <a:cs typeface="맑은 고딕" pitchFamily="34" charset="-120"/>
+              </a:rPr>
+              <a:t>Ring  ·  재고 5개</a:t>
+            </a:r>
+            <a:pPr indent="0" marL="0">
+              <a:buNone/>
+            </a:pPr>
+            <a:r>
+              <a:rPr lang="en-US" sz="1000" b="1" dirty="0">
+                <a:solidFill>
+                  <a:srgbClr val="D72638"/>
+                </a:solidFill>
+                <a:latin typeface="맑은 고딕" pitchFamily="34" charset="0"/>
+                <a:ea typeface="맑은 고딕" pitchFamily="34" charset="-122"/>
+                <a:cs typeface="맑은 고딕" pitchFamily="34" charset="-120"/>
+              </a:rPr>
+              <a:t/>
+            </a:r>
+            <a:endParaRPr lang="en-US" sz="1000" dirty="0"/>
+          </a:p>
+        </p:txBody>
+      </p:sp>
+      <p:sp>
+        <p:nvSpPr>
+          <p:cNvPr id="27" name="Shape 24"/>
+          <p:cNvSpPr/>
+          <p:nvPr/>
+        </p:nvSpPr>
+        <p:spPr>
+          <a:xfrm>
+            <a:off x="7406640" y="4096512"/>
+            <a:ext cx="4206240" cy="640080"/>
+          </a:xfrm>
+          <a:prstGeom prst="rect">
+            <a:avLst/>
+          </a:prstGeom>
+          <a:solidFill>
+            <a:srgbClr val="FFF5F5"/>
+          </a:solidFill>
+          <a:ln w="6350">
+            <a:solidFill>
+              <a:srgbClr val="E5E7EB"/>
+            </a:solidFill>
+            <a:prstDash val="solid"/>
+          </a:ln>
+        </p:spPr>
+      </p:sp>
+      <p:sp>
+        <p:nvSpPr>
+          <p:cNvPr id="28" name="Shape 25"/>
+          <p:cNvSpPr/>
+          <p:nvPr/>
+        </p:nvSpPr>
+        <p:spPr>
+          <a:xfrm>
+            <a:off x="7406640" y="4096512"/>
+            <a:ext cx="109728" cy="640080"/>
+          </a:xfrm>
+          <a:prstGeom prst="rect">
+            <a:avLst/>
+          </a:prstGeom>
+          <a:solidFill>
+            <a:srgbClr val="D72638"/>
+          </a:solidFill>
+          <a:ln w="12700">
+            <a:solidFill>
+              <a:srgbClr val="D72638"/>
+            </a:solidFill>
+            <a:prstDash val="solid"/>
+          </a:ln>
+        </p:spPr>
+      </p:sp>
+      <p:sp>
+        <p:nvSpPr>
+          <p:cNvPr id="29" name="Shape 26"/>
+          <p:cNvSpPr/>
+          <p:nvPr/>
+        </p:nvSpPr>
+        <p:spPr>
+          <a:xfrm>
+            <a:off x="7571232" y="4187952"/>
+            <a:ext cx="548640" cy="256032"/>
+          </a:xfrm>
+          <a:prstGeom prst="rect">
+            <a:avLst/>
+          </a:prstGeom>
+          <a:solidFill>
+            <a:srgbClr val="D72638"/>
+          </a:solidFill>
+          <a:ln w="12700">
+            <a:solidFill>
+              <a:srgbClr val="D72638"/>
+            </a:solidFill>
+            <a:prstDash val="solid"/>
+          </a:ln>
+        </p:spPr>
+      </p:sp>
+      <p:sp>
+        <p:nvSpPr>
+          <p:cNvPr id="30" name="Text 27"/>
+          <p:cNvSpPr/>
+          <p:nvPr/>
+        </p:nvSpPr>
+        <p:spPr>
+          <a:xfrm>
+            <a:off x="7571232" y="4187952"/>
+            <a:ext cx="548640" cy="256032"/>
+          </a:xfrm>
+          <a:prstGeom prst="rect">
+            <a:avLst/>
+          </a:prstGeom>
+          <a:noFill/>
+          <a:ln/>
+        </p:spPr>
+        <p:txBody>
+          <a:bodyPr wrap="square" lIns="0" tIns="0" rIns="0" bIns="0" rtlCol="0" anchor="ctr"/>
+          <a:lstStyle/>
+          <a:p>
+            <a:pPr algn="ctr" indent="0" marL="0">
+              <a:buNone/>
+            </a:pPr>
+            <a:r>
+              <a:rPr lang="en-US" sz="900" b="1" dirty="0">
+                <a:solidFill>
+                  <a:srgbClr val="FFFFFF"/>
+                </a:solidFill>
+                <a:latin typeface="맑은 고딕" pitchFamily="34" charset="0"/>
+                <a:ea typeface="맑은 고딕" pitchFamily="34" charset="-122"/>
+                <a:cs typeface="맑은 고딕" pitchFamily="34" charset="-120"/>
+              </a:rPr>
+              <a:t>긴급</a:t>
+            </a:r>
+            <a:endParaRPr lang="en-US" sz="900" dirty="0"/>
+          </a:p>
+        </p:txBody>
+      </p:sp>
+      <p:sp>
+        <p:nvSpPr>
+          <p:cNvPr id="31" name="Text 28"/>
+          <p:cNvSpPr/>
+          <p:nvPr/>
+        </p:nvSpPr>
+        <p:spPr>
+          <a:xfrm>
+            <a:off x="8211312" y="4151376"/>
+            <a:ext cx="3291840" cy="274320"/>
+          </a:xfrm>
+          <a:prstGeom prst="rect">
+            <a:avLst/>
+          </a:prstGeom>
+          <a:noFill/>
+          <a:ln/>
+        </p:spPr>
+        <p:txBody>
+          <a:bodyPr wrap="square" lIns="0" tIns="0" rIns="0" bIns="0" rtlCol="0" anchor="ctr"/>
+          <a:lstStyle/>
+          <a:p>
+            <a:pPr indent="0" marL="0">
+              <a:buNone/>
+            </a:pPr>
+            <a:r>
+              <a:rPr lang="en-US" sz="1100" b="1" dirty="0">
+                <a:solidFill>
+                  <a:srgbClr val="0B1220"/>
+                </a:solidFill>
+                <a:latin typeface="맑은 고딕" pitchFamily="34" charset="0"/>
+                <a:ea typeface="맑은 고딕" pitchFamily="34" charset="-122"/>
+                <a:cs typeface="맑은 고딕" pitchFamily="34" charset="-120"/>
+              </a:rPr>
+              <a:t>2PT Bracelet</a:t>
+            </a:r>
+            <a:endParaRPr lang="en-US" sz="1100" dirty="0"/>
+          </a:p>
+        </p:txBody>
+      </p:sp>
+      <p:sp>
+        <p:nvSpPr>
+          <p:cNvPr id="32" name="Text 29"/>
+          <p:cNvSpPr/>
+          <p:nvPr/>
+        </p:nvSpPr>
+        <p:spPr>
+          <a:xfrm>
+            <a:off x="8211312" y="4425696"/>
+            <a:ext cx="3291840" cy="256032"/>
+          </a:xfrm>
+          <a:prstGeom prst="rect">
+            <a:avLst/>
+          </a:prstGeom>
+          <a:noFill/>
+          <a:ln/>
+        </p:spPr>
+        <p:txBody>
+          <a:bodyPr wrap="square" lIns="0" tIns="0" rIns="0" bIns="0" rtlCol="0" anchor="ctr"/>
+          <a:lstStyle/>
+          <a:p>
+            <a:pPr indent="0" marL="0">
+              <a:buNone/>
+            </a:pPr>
+            <a:r>
+              <a:rPr lang="en-US" sz="1000" dirty="0">
+                <a:solidFill>
+                  <a:srgbClr val="6B7280"/>
+                </a:solidFill>
+                <a:latin typeface="맑은 고딕" pitchFamily="34" charset="0"/>
+                <a:ea typeface="맑은 고딕" pitchFamily="34" charset="-122"/>
+                <a:cs typeface="맑은 고딕" pitchFamily="34" charset="-120"/>
+              </a:rPr>
+              <a:t>Bracelet  ·  재고 1개</a:t>
+            </a:r>
+            <a:pPr indent="0" marL="0">
+              <a:buNone/>
+            </a:pPr>
+            <a:r>
+              <a:rPr lang="en-US" sz="1000" b="1" dirty="0">
+                <a:solidFill>
+                  <a:srgbClr val="D72638"/>
+                </a:solidFill>
+                <a:latin typeface="맑은 고딕" pitchFamily="34" charset="0"/>
+                <a:ea typeface="맑은 고딕" pitchFamily="34" charset="-122"/>
+                <a:cs typeface="맑은 고딕" pitchFamily="34" charset="-120"/>
+              </a:rPr>
+              <a:t/>
+            </a:r>
+            <a:endParaRPr lang="en-US" sz="1000" dirty="0"/>
+          </a:p>
+        </p:txBody>
+      </p:sp>
+      <p:sp>
+        <p:nvSpPr>
+          <p:cNvPr id="33" name="Shape 30"/>
+          <p:cNvSpPr/>
+          <p:nvPr/>
+        </p:nvSpPr>
+        <p:spPr>
+          <a:xfrm>
+            <a:off x="7406640" y="4809744"/>
+            <a:ext cx="4206240" cy="640080"/>
+          </a:xfrm>
+          <a:prstGeom prst="rect">
+            <a:avLst/>
+          </a:prstGeom>
+          <a:solidFill>
+            <a:srgbClr val="FFF5F5"/>
+          </a:solidFill>
+          <a:ln w="6350">
+            <a:solidFill>
+              <a:srgbClr val="E5E7EB"/>
+            </a:solidFill>
+            <a:prstDash val="solid"/>
+          </a:ln>
+        </p:spPr>
+      </p:sp>
+      <p:sp>
+        <p:nvSpPr>
+          <p:cNvPr id="34" name="Shape 31"/>
+          <p:cNvSpPr/>
+          <p:nvPr/>
+        </p:nvSpPr>
+        <p:spPr>
+          <a:xfrm>
+            <a:off x="7406640" y="4809744"/>
+            <a:ext cx="109728" cy="640080"/>
+          </a:xfrm>
+          <a:prstGeom prst="rect">
+            <a:avLst/>
+          </a:prstGeom>
+          <a:solidFill>
+            <a:srgbClr val="D72638"/>
+          </a:solidFill>
+          <a:ln w="12700">
+            <a:solidFill>
+              <a:srgbClr val="D72638"/>
+            </a:solidFill>
+            <a:prstDash val="solid"/>
+          </a:ln>
+        </p:spPr>
+      </p:sp>
+      <p:sp>
+        <p:nvSpPr>
+          <p:cNvPr id="35" name="Shape 32"/>
+          <p:cNvSpPr/>
+          <p:nvPr/>
+        </p:nvSpPr>
+        <p:spPr>
+          <a:xfrm>
+            <a:off x="7571232" y="4901184"/>
+            <a:ext cx="548640" cy="256032"/>
+          </a:xfrm>
+          <a:prstGeom prst="rect">
+            <a:avLst/>
+          </a:prstGeom>
+          <a:solidFill>
+            <a:srgbClr val="D72638"/>
+          </a:solidFill>
+          <a:ln w="12700">
+            <a:solidFill>
+              <a:srgbClr val="D72638"/>
+            </a:solidFill>
+            <a:prstDash val="solid"/>
+          </a:ln>
+        </p:spPr>
+      </p:sp>
+      <p:sp>
+        <p:nvSpPr>
+          <p:cNvPr id="36" name="Text 33"/>
+          <p:cNvSpPr/>
+          <p:nvPr/>
+        </p:nvSpPr>
+        <p:spPr>
+          <a:xfrm>
+            <a:off x="7571232" y="4901184"/>
+            <a:ext cx="548640" cy="256032"/>
+          </a:xfrm>
+          <a:prstGeom prst="rect">
+            <a:avLst/>
+          </a:prstGeom>
+          <a:noFill/>
+          <a:ln/>
+        </p:spPr>
+        <p:txBody>
+          <a:bodyPr wrap="square" lIns="0" tIns="0" rIns="0" bIns="0" rtlCol="0" anchor="ctr"/>
+          <a:lstStyle/>
+          <a:p>
+            <a:pPr algn="ctr" indent="0" marL="0">
+              <a:buNone/>
+            </a:pPr>
+            <a:r>
+              <a:rPr lang="en-US" sz="900" b="1" dirty="0">
+                <a:solidFill>
+                  <a:srgbClr val="FFFFFF"/>
+                </a:solidFill>
+                <a:latin typeface="맑은 고딕" pitchFamily="34" charset="0"/>
+                <a:ea typeface="맑은 고딕" pitchFamily="34" charset="-122"/>
+                <a:cs typeface="맑은 고딕" pitchFamily="34" charset="-120"/>
+              </a:rPr>
+              <a:t>긴급</a:t>
+            </a:r>
+            <a:endParaRPr lang="en-US" sz="900" dirty="0"/>
+          </a:p>
+        </p:txBody>
+      </p:sp>
+      <p:sp>
+        <p:nvSpPr>
+          <p:cNvPr id="37" name="Text 34"/>
+          <p:cNvSpPr/>
+          <p:nvPr/>
+        </p:nvSpPr>
+        <p:spPr>
+          <a:xfrm>
+            <a:off x="8211312" y="4864608"/>
+            <a:ext cx="3291840" cy="274320"/>
+          </a:xfrm>
+          <a:prstGeom prst="rect">
+            <a:avLst/>
+          </a:prstGeom>
+          <a:noFill/>
+          <a:ln/>
+        </p:spPr>
+        <p:txBody>
+          <a:bodyPr wrap="square" lIns="0" tIns="0" rIns="0" bIns="0" rtlCol="0" anchor="ctr"/>
+          <a:lstStyle/>
+          <a:p>
+            <a:pPr indent="0" marL="0">
+              <a:buNone/>
+            </a:pPr>
+            <a:r>
+              <a:rPr lang="en-US" sz="1100" b="1" dirty="0">
+                <a:solidFill>
+                  <a:srgbClr val="0B1220"/>
+                </a:solidFill>
+                <a:latin typeface="맑은 고딕" pitchFamily="34" charset="0"/>
+                <a:ea typeface="맑은 고딕" pitchFamily="34" charset="-122"/>
+                <a:cs typeface="맑은 고딕" pitchFamily="34" charset="-120"/>
+              </a:rPr>
+              <a:t>8-Ball Smart Tok</a:t>
+            </a:r>
+            <a:endParaRPr lang="en-US" sz="1100" dirty="0"/>
+          </a:p>
+        </p:txBody>
+      </p:sp>
+      <p:sp>
+        <p:nvSpPr>
+          <p:cNvPr id="38" name="Text 35"/>
+          <p:cNvSpPr/>
+          <p:nvPr/>
+        </p:nvSpPr>
+        <p:spPr>
+          <a:xfrm>
+            <a:off x="8211312" y="5138928"/>
+            <a:ext cx="3291840" cy="256032"/>
+          </a:xfrm>
+          <a:prstGeom prst="rect">
+            <a:avLst/>
+          </a:prstGeom>
+          <a:noFill/>
+          <a:ln/>
+        </p:spPr>
+        <p:txBody>
+          <a:bodyPr wrap="square" lIns="0" tIns="0" rIns="0" bIns="0" rtlCol="0" anchor="ctr"/>
+          <a:lstStyle/>
+          <a:p>
+            <a:pPr indent="0" marL="0">
+              <a:buNone/>
+            </a:pPr>
+            <a:r>
+              <a:rPr lang="en-US" sz="1000" dirty="0">
+                <a:solidFill>
+                  <a:srgbClr val="6B7280"/>
+                </a:solidFill>
+                <a:latin typeface="맑은 고딕" pitchFamily="34" charset="0"/>
+                <a:ea typeface="맑은 고딕" pitchFamily="34" charset="-122"/>
+                <a:cs typeface="맑은 고딕" pitchFamily="34" charset="-120"/>
+              </a:rPr>
+              <a:t>★Season off★  ·  재고 4개</a:t>
+            </a:r>
+            <a:pPr indent="0" marL="0">
+              <a:buNone/>
+            </a:pPr>
+            <a:r>
+              <a:rPr lang="en-US" sz="1000" b="1" dirty="0">
+                <a:solidFill>
+                  <a:srgbClr val="D72638"/>
+                </a:solidFill>
+                <a:latin typeface="맑은 고딕" pitchFamily="34" charset="0"/>
+                <a:ea typeface="맑은 고딕" pitchFamily="34" charset="-122"/>
+                <a:cs typeface="맑은 고딕" pitchFamily="34" charset="-120"/>
+              </a:rPr>
+              <a:t/>
+            </a:r>
+            <a:endParaRPr lang="en-US" sz="1000" dirty="0"/>
+          </a:p>
+        </p:txBody>
+      </p:sp>
+      <p:sp>
+        <p:nvSpPr>
+          <p:cNvPr id="39" name="Shape 36"/>
+          <p:cNvSpPr/>
+          <p:nvPr/>
+        </p:nvSpPr>
+        <p:spPr>
+          <a:xfrm>
+            <a:off x="7406640" y="5522976"/>
+            <a:ext cx="4206240" cy="640080"/>
+          </a:xfrm>
+          <a:prstGeom prst="rect">
+            <a:avLst/>
+          </a:prstGeom>
+          <a:solidFill>
+            <a:srgbClr val="FFF5F5"/>
+          </a:solidFill>
+          <a:ln w="6350">
+            <a:solidFill>
+              <a:srgbClr val="E5E7EB"/>
+            </a:solidFill>
+            <a:prstDash val="solid"/>
+          </a:ln>
+        </p:spPr>
+      </p:sp>
+      <p:sp>
+        <p:nvSpPr>
+          <p:cNvPr id="40" name="Shape 37"/>
+          <p:cNvSpPr/>
+          <p:nvPr/>
+        </p:nvSpPr>
+        <p:spPr>
+          <a:xfrm>
+            <a:off x="7406640" y="5522976"/>
+            <a:ext cx="109728" cy="640080"/>
+          </a:xfrm>
+          <a:prstGeom prst="rect">
+            <a:avLst/>
+          </a:prstGeom>
+          <a:solidFill>
+            <a:srgbClr val="D72638"/>
+          </a:solidFill>
+          <a:ln w="12700">
+            <a:solidFill>
+              <a:srgbClr val="D72638"/>
+            </a:solidFill>
+            <a:prstDash val="solid"/>
+          </a:ln>
+        </p:spPr>
+      </p:sp>
+      <p:sp>
+        <p:nvSpPr>
+          <p:cNvPr id="41" name="Shape 38"/>
+          <p:cNvSpPr/>
+          <p:nvPr/>
+        </p:nvSpPr>
+        <p:spPr>
+          <a:xfrm>
+            <a:off x="7571232" y="5614416"/>
+            <a:ext cx="548640" cy="256032"/>
+          </a:xfrm>
+          <a:prstGeom prst="rect">
+            <a:avLst/>
+          </a:prstGeom>
+          <a:solidFill>
+            <a:srgbClr val="D72638"/>
+          </a:solidFill>
+          <a:ln w="12700">
+            <a:solidFill>
+              <a:srgbClr val="D72638"/>
+            </a:solidFill>
+            <a:prstDash val="solid"/>
+          </a:ln>
+        </p:spPr>
+      </p:sp>
+      <p:sp>
+        <p:nvSpPr>
+          <p:cNvPr id="42" name="Text 39"/>
+          <p:cNvSpPr/>
+          <p:nvPr/>
+        </p:nvSpPr>
+        <p:spPr>
+          <a:xfrm>
+            <a:off x="7571232" y="5614416"/>
+            <a:ext cx="548640" cy="256032"/>
+          </a:xfrm>
+          <a:prstGeom prst="rect">
+            <a:avLst/>
+          </a:prstGeom>
+          <a:noFill/>
+          <a:ln/>
+        </p:spPr>
+        <p:txBody>
+          <a:bodyPr wrap="square" lIns="0" tIns="0" rIns="0" bIns="0" rtlCol="0" anchor="ctr"/>
+          <a:lstStyle/>
+          <a:p>
+            <a:pPr algn="ctr" indent="0" marL="0">
+              <a:buNone/>
+            </a:pPr>
+            <a:r>
+              <a:rPr lang="en-US" sz="900" b="1" dirty="0">
+                <a:solidFill>
+                  <a:srgbClr val="FFFFFF"/>
+                </a:solidFill>
+                <a:latin typeface="맑은 고딕" pitchFamily="34" charset="0"/>
+                <a:ea typeface="맑은 고딕" pitchFamily="34" charset="-122"/>
+                <a:cs typeface="맑은 고딕" pitchFamily="34" charset="-120"/>
+              </a:rPr>
+              <a:t>긴급</a:t>
+            </a:r>
+            <a:endParaRPr lang="en-US" sz="900" dirty="0"/>
+          </a:p>
+        </p:txBody>
+      </p:sp>
+      <p:sp>
+        <p:nvSpPr>
+          <p:cNvPr id="43" name="Text 40"/>
+          <p:cNvSpPr/>
+          <p:nvPr/>
+        </p:nvSpPr>
+        <p:spPr>
+          <a:xfrm>
+            <a:off x="8211312" y="5577840"/>
+            <a:ext cx="3291840" cy="274320"/>
+          </a:xfrm>
+          <a:prstGeom prst="rect">
+            <a:avLst/>
+          </a:prstGeom>
+          <a:noFill/>
+          <a:ln/>
+        </p:spPr>
+        <p:txBody>
+          <a:bodyPr wrap="square" lIns="0" tIns="0" rIns="0" bIns="0" rtlCol="0" anchor="ctr"/>
+          <a:lstStyle/>
+          <a:p>
+            <a:pPr indent="0" marL="0">
+              <a:buNone/>
+            </a:pPr>
+            <a:r>
+              <a:rPr lang="en-US" sz="1100" b="1" dirty="0">
+                <a:solidFill>
+                  <a:srgbClr val="0B1220"/>
+                </a:solidFill>
+                <a:latin typeface="맑은 고딕" pitchFamily="34" charset="0"/>
+                <a:ea typeface="맑은 고딕" pitchFamily="34" charset="-122"/>
+                <a:cs typeface="맑은 고딕" pitchFamily="34" charset="-120"/>
+              </a:rPr>
               <a:t>[SILVER925] Crimson Open Ring</a:t>
             </a:r>
             <a:endParaRPr lang="en-US" sz="1100" dirty="0"/>
@@ -7565,13 +8183,13 @@
       </p:sp>
       <p:sp>
         <p:nvSpPr>
-          <p:cNvPr id="26" name="Text 23"/>
-          <p:cNvSpPr/>
-          <p:nvPr/>
-        </p:nvSpPr>
-        <p:spPr>
-          <a:xfrm>
-            <a:off x="8211312" y="3712464"/>
+          <p:cNvPr id="44" name="Text 41"/>
+          <p:cNvSpPr/>
+          <p:nvPr/>
+        </p:nvSpPr>
+        <p:spPr>
+          <a:xfrm>
+            <a:off x="8211312" y="5852160"/>
             <a:ext cx="3291840" cy="256032"/>
           </a:xfrm>
           <a:prstGeom prst="rect">
@@ -7618,624 +8236,6 @@
       </p:sp>
       <p:sp>
         <p:nvSpPr>
-          <p:cNvPr id="27" name="Shape 24"/>
-          <p:cNvSpPr/>
-          <p:nvPr/>
-        </p:nvSpPr>
-        <p:spPr>
-          <a:xfrm>
-            <a:off x="7406640" y="4096512"/>
-            <a:ext cx="4206240" cy="640080"/>
-          </a:xfrm>
-          <a:prstGeom prst="rect">
-            <a:avLst/>
-          </a:prstGeom>
-          <a:solidFill>
-            <a:srgbClr val="FFF5F5"/>
-          </a:solidFill>
-          <a:ln w="6350">
-            <a:solidFill>
-              <a:srgbClr val="E5E7EB"/>
-            </a:solidFill>
-            <a:prstDash val="solid"/>
-          </a:ln>
-        </p:spPr>
-      </p:sp>
-      <p:sp>
-        <p:nvSpPr>
-          <p:cNvPr id="28" name="Shape 25"/>
-          <p:cNvSpPr/>
-          <p:nvPr/>
-        </p:nvSpPr>
-        <p:spPr>
-          <a:xfrm>
-            <a:off x="7406640" y="4096512"/>
-            <a:ext cx="109728" cy="640080"/>
-          </a:xfrm>
-          <a:prstGeom prst="rect">
-            <a:avLst/>
-          </a:prstGeom>
-          <a:solidFill>
-            <a:srgbClr val="D72638"/>
-          </a:solidFill>
-          <a:ln w="12700">
-            <a:solidFill>
-              <a:srgbClr val="D72638"/>
-            </a:solidFill>
-            <a:prstDash val="solid"/>
-          </a:ln>
-        </p:spPr>
-      </p:sp>
-      <p:sp>
-        <p:nvSpPr>
-          <p:cNvPr id="29" name="Shape 26"/>
-          <p:cNvSpPr/>
-          <p:nvPr/>
-        </p:nvSpPr>
-        <p:spPr>
-          <a:xfrm>
-            <a:off x="7571232" y="4187952"/>
-            <a:ext cx="548640" cy="256032"/>
-          </a:xfrm>
-          <a:prstGeom prst="rect">
-            <a:avLst/>
-          </a:prstGeom>
-          <a:solidFill>
-            <a:srgbClr val="D72638"/>
-          </a:solidFill>
-          <a:ln w="12700">
-            <a:solidFill>
-              <a:srgbClr val="D72638"/>
-            </a:solidFill>
-            <a:prstDash val="solid"/>
-          </a:ln>
-        </p:spPr>
-      </p:sp>
-      <p:sp>
-        <p:nvSpPr>
-          <p:cNvPr id="30" name="Text 27"/>
-          <p:cNvSpPr/>
-          <p:nvPr/>
-        </p:nvSpPr>
-        <p:spPr>
-          <a:xfrm>
-            <a:off x="7571232" y="4187952"/>
-            <a:ext cx="548640" cy="256032"/>
-          </a:xfrm>
-          <a:prstGeom prst="rect">
-            <a:avLst/>
-          </a:prstGeom>
-          <a:noFill/>
-          <a:ln/>
-        </p:spPr>
-        <p:txBody>
-          <a:bodyPr wrap="square" lIns="0" tIns="0" rIns="0" bIns="0" rtlCol="0" anchor="ctr"/>
-          <a:lstStyle/>
-          <a:p>
-            <a:pPr algn="ctr" indent="0" marL="0">
-              <a:buNone/>
-            </a:pPr>
-            <a:r>
-              <a:rPr lang="en-US" sz="900" b="1" dirty="0">
-                <a:solidFill>
-                  <a:srgbClr val="FFFFFF"/>
-                </a:solidFill>
-                <a:latin typeface="맑은 고딕" pitchFamily="34" charset="0"/>
-                <a:ea typeface="맑은 고딕" pitchFamily="34" charset="-122"/>
-                <a:cs typeface="맑은 고딕" pitchFamily="34" charset="-120"/>
-              </a:rPr>
-              <a:t>긴급</a:t>
-            </a:r>
-            <a:endParaRPr lang="en-US" sz="900" dirty="0"/>
-          </a:p>
-        </p:txBody>
-      </p:sp>
-      <p:sp>
-        <p:nvSpPr>
-          <p:cNvPr id="31" name="Text 28"/>
-          <p:cNvSpPr/>
-          <p:nvPr/>
-        </p:nvSpPr>
-        <p:spPr>
-          <a:xfrm>
-            <a:off x="8211312" y="4151376"/>
-            <a:ext cx="3291840" cy="274320"/>
-          </a:xfrm>
-          <a:prstGeom prst="rect">
-            <a:avLst/>
-          </a:prstGeom>
-          <a:noFill/>
-          <a:ln/>
-        </p:spPr>
-        <p:txBody>
-          <a:bodyPr wrap="square" lIns="0" tIns="0" rIns="0" bIns="0" rtlCol="0" anchor="ctr"/>
-          <a:lstStyle/>
-          <a:p>
-            <a:pPr indent="0" marL="0">
-              <a:buNone/>
-            </a:pPr>
-            <a:r>
-              <a:rPr lang="en-US" sz="1100" b="1" dirty="0">
-                <a:solidFill>
-                  <a:srgbClr val="0B1220"/>
-                </a:solidFill>
-                <a:latin typeface="맑은 고딕" pitchFamily="34" charset="0"/>
-                <a:ea typeface="맑은 고딕" pitchFamily="34" charset="-122"/>
-                <a:cs typeface="맑은 고딕" pitchFamily="34" charset="-120"/>
-              </a:rPr>
-              <a:t>2PT Bracelet</a:t>
-            </a:r>
-            <a:endParaRPr lang="en-US" sz="1100" dirty="0"/>
-          </a:p>
-        </p:txBody>
-      </p:sp>
-      <p:sp>
-        <p:nvSpPr>
-          <p:cNvPr id="32" name="Text 29"/>
-          <p:cNvSpPr/>
-          <p:nvPr/>
-        </p:nvSpPr>
-        <p:spPr>
-          <a:xfrm>
-            <a:off x="8211312" y="4425696"/>
-            <a:ext cx="3291840" cy="256032"/>
-          </a:xfrm>
-          <a:prstGeom prst="rect">
-            <a:avLst/>
-          </a:prstGeom>
-          <a:noFill/>
-          <a:ln/>
-        </p:spPr>
-        <p:txBody>
-          <a:bodyPr wrap="square" lIns="0" tIns="0" rIns="0" bIns="0" rtlCol="0" anchor="ctr"/>
-          <a:lstStyle/>
-          <a:p>
-            <a:pPr indent="0" marL="0">
-              <a:buNone/>
-            </a:pPr>
-            <a:r>
-              <a:rPr lang="en-US" sz="1000" dirty="0">
-                <a:solidFill>
-                  <a:srgbClr val="6B7280"/>
-                </a:solidFill>
-                <a:latin typeface="맑은 고딕" pitchFamily="34" charset="0"/>
-                <a:ea typeface="맑은 고딕" pitchFamily="34" charset="-122"/>
-                <a:cs typeface="맑은 고딕" pitchFamily="34" charset="-120"/>
-              </a:rPr>
-              <a:t>Bracelet  ·  재고 3개</a:t>
-            </a:r>
-            <a:pPr indent="0" marL="0">
-              <a:buNone/>
-            </a:pPr>
-            <a:r>
-              <a:rPr lang="en-US" sz="1000" b="1" dirty="0">
-                <a:solidFill>
-                  <a:srgbClr val="D72638"/>
-                </a:solidFill>
-                <a:latin typeface="맑은 고딕" pitchFamily="34" charset="0"/>
-                <a:ea typeface="맑은 고딕" pitchFamily="34" charset="-122"/>
-                <a:cs typeface="맑은 고딕" pitchFamily="34" charset="-120"/>
-              </a:rPr>
-              <a:t/>
-            </a:r>
-            <a:endParaRPr lang="en-US" sz="1000" dirty="0"/>
-          </a:p>
-        </p:txBody>
-      </p:sp>
-      <p:sp>
-        <p:nvSpPr>
-          <p:cNvPr id="33" name="Shape 30"/>
-          <p:cNvSpPr/>
-          <p:nvPr/>
-        </p:nvSpPr>
-        <p:spPr>
-          <a:xfrm>
-            <a:off x="7406640" y="4809744"/>
-            <a:ext cx="4206240" cy="640080"/>
-          </a:xfrm>
-          <a:prstGeom prst="rect">
-            <a:avLst/>
-          </a:prstGeom>
-          <a:solidFill>
-            <a:srgbClr val="FFF5F5"/>
-          </a:solidFill>
-          <a:ln w="6350">
-            <a:solidFill>
-              <a:srgbClr val="E5E7EB"/>
-            </a:solidFill>
-            <a:prstDash val="solid"/>
-          </a:ln>
-        </p:spPr>
-      </p:sp>
-      <p:sp>
-        <p:nvSpPr>
-          <p:cNvPr id="34" name="Shape 31"/>
-          <p:cNvSpPr/>
-          <p:nvPr/>
-        </p:nvSpPr>
-        <p:spPr>
-          <a:xfrm>
-            <a:off x="7406640" y="4809744"/>
-            <a:ext cx="109728" cy="640080"/>
-          </a:xfrm>
-          <a:prstGeom prst="rect">
-            <a:avLst/>
-          </a:prstGeom>
-          <a:solidFill>
-            <a:srgbClr val="D72638"/>
-          </a:solidFill>
-          <a:ln w="12700">
-            <a:solidFill>
-              <a:srgbClr val="D72638"/>
-            </a:solidFill>
-            <a:prstDash val="solid"/>
-          </a:ln>
-        </p:spPr>
-      </p:sp>
-      <p:sp>
-        <p:nvSpPr>
-          <p:cNvPr id="35" name="Shape 32"/>
-          <p:cNvSpPr/>
-          <p:nvPr/>
-        </p:nvSpPr>
-        <p:spPr>
-          <a:xfrm>
-            <a:off x="7571232" y="4901184"/>
-            <a:ext cx="548640" cy="256032"/>
-          </a:xfrm>
-          <a:prstGeom prst="rect">
-            <a:avLst/>
-          </a:prstGeom>
-          <a:solidFill>
-            <a:srgbClr val="D72638"/>
-          </a:solidFill>
-          <a:ln w="12700">
-            <a:solidFill>
-              <a:srgbClr val="D72638"/>
-            </a:solidFill>
-            <a:prstDash val="solid"/>
-          </a:ln>
-        </p:spPr>
-      </p:sp>
-      <p:sp>
-        <p:nvSpPr>
-          <p:cNvPr id="36" name="Text 33"/>
-          <p:cNvSpPr/>
-          <p:nvPr/>
-        </p:nvSpPr>
-        <p:spPr>
-          <a:xfrm>
-            <a:off x="7571232" y="4901184"/>
-            <a:ext cx="548640" cy="256032"/>
-          </a:xfrm>
-          <a:prstGeom prst="rect">
-            <a:avLst/>
-          </a:prstGeom>
-          <a:noFill/>
-          <a:ln/>
-        </p:spPr>
-        <p:txBody>
-          <a:bodyPr wrap="square" lIns="0" tIns="0" rIns="0" bIns="0" rtlCol="0" anchor="ctr"/>
-          <a:lstStyle/>
-          <a:p>
-            <a:pPr algn="ctr" indent="0" marL="0">
-              <a:buNone/>
-            </a:pPr>
-            <a:r>
-              <a:rPr lang="en-US" sz="900" b="1" dirty="0">
-                <a:solidFill>
-                  <a:srgbClr val="FFFFFF"/>
-                </a:solidFill>
-                <a:latin typeface="맑은 고딕" pitchFamily="34" charset="0"/>
-                <a:ea typeface="맑은 고딕" pitchFamily="34" charset="-122"/>
-                <a:cs typeface="맑은 고딕" pitchFamily="34" charset="-120"/>
-              </a:rPr>
-              <a:t>긴급</a:t>
-            </a:r>
-            <a:endParaRPr lang="en-US" sz="900" dirty="0"/>
-          </a:p>
-        </p:txBody>
-      </p:sp>
-      <p:sp>
-        <p:nvSpPr>
-          <p:cNvPr id="37" name="Text 34"/>
-          <p:cNvSpPr/>
-          <p:nvPr/>
-        </p:nvSpPr>
-        <p:spPr>
-          <a:xfrm>
-            <a:off x="8211312" y="4864608"/>
-            <a:ext cx="3291840" cy="274320"/>
-          </a:xfrm>
-          <a:prstGeom prst="rect">
-            <a:avLst/>
-          </a:prstGeom>
-          <a:noFill/>
-          <a:ln/>
-        </p:spPr>
-        <p:txBody>
-          <a:bodyPr wrap="square" lIns="0" tIns="0" rIns="0" bIns="0" rtlCol="0" anchor="ctr"/>
-          <a:lstStyle/>
-          <a:p>
-            <a:pPr indent="0" marL="0">
-              <a:buNone/>
-            </a:pPr>
-            <a:r>
-              <a:rPr lang="en-US" sz="1100" b="1" dirty="0">
-                <a:solidFill>
-                  <a:srgbClr val="0B1220"/>
-                </a:solidFill>
-                <a:latin typeface="맑은 고딕" pitchFamily="34" charset="0"/>
-                <a:ea typeface="맑은 고딕" pitchFamily="34" charset="-122"/>
-                <a:cs typeface="맑은 고딕" pitchFamily="34" charset="-120"/>
-              </a:rPr>
-              <a:t>8-Ball Smart Tok</a:t>
-            </a:r>
-            <a:endParaRPr lang="en-US" sz="1100" dirty="0"/>
-          </a:p>
-        </p:txBody>
-      </p:sp>
-      <p:sp>
-        <p:nvSpPr>
-          <p:cNvPr id="38" name="Text 35"/>
-          <p:cNvSpPr/>
-          <p:nvPr/>
-        </p:nvSpPr>
-        <p:spPr>
-          <a:xfrm>
-            <a:off x="8211312" y="5138928"/>
-            <a:ext cx="3291840" cy="256032"/>
-          </a:xfrm>
-          <a:prstGeom prst="rect">
-            <a:avLst/>
-          </a:prstGeom>
-          <a:noFill/>
-          <a:ln/>
-        </p:spPr>
-        <p:txBody>
-          <a:bodyPr wrap="square" lIns="0" tIns="0" rIns="0" bIns="0" rtlCol="0" anchor="ctr"/>
-          <a:lstStyle/>
-          <a:p>
-            <a:pPr indent="0" marL="0">
-              <a:buNone/>
-            </a:pPr>
-            <a:r>
-              <a:rPr lang="en-US" sz="1000" dirty="0">
-                <a:solidFill>
-                  <a:srgbClr val="6B7280"/>
-                </a:solidFill>
-                <a:latin typeface="맑은 고딕" pitchFamily="34" charset="0"/>
-                <a:ea typeface="맑은 고딕" pitchFamily="34" charset="-122"/>
-                <a:cs typeface="맑은 고딕" pitchFamily="34" charset="-120"/>
-              </a:rPr>
-              <a:t>★Season off★  ·  재고 4개</a:t>
-            </a:r>
-            <a:pPr indent="0" marL="0">
-              <a:buNone/>
-            </a:pPr>
-            <a:r>
-              <a:rPr lang="en-US" sz="1000" b="1" dirty="0">
-                <a:solidFill>
-                  <a:srgbClr val="D72638"/>
-                </a:solidFill>
-                <a:latin typeface="맑은 고딕" pitchFamily="34" charset="0"/>
-                <a:ea typeface="맑은 고딕" pitchFamily="34" charset="-122"/>
-                <a:cs typeface="맑은 고딕" pitchFamily="34" charset="-120"/>
-              </a:rPr>
-              <a:t/>
-            </a:r>
-            <a:endParaRPr lang="en-US" sz="1000" dirty="0"/>
-          </a:p>
-        </p:txBody>
-      </p:sp>
-      <p:sp>
-        <p:nvSpPr>
-          <p:cNvPr id="39" name="Shape 36"/>
-          <p:cNvSpPr/>
-          <p:nvPr/>
-        </p:nvSpPr>
-        <p:spPr>
-          <a:xfrm>
-            <a:off x="7406640" y="5522976"/>
-            <a:ext cx="4206240" cy="640080"/>
-          </a:xfrm>
-          <a:prstGeom prst="rect">
-            <a:avLst/>
-          </a:prstGeom>
-          <a:solidFill>
-            <a:srgbClr val="FFF5F5"/>
-          </a:solidFill>
-          <a:ln w="6350">
-            <a:solidFill>
-              <a:srgbClr val="E5E7EB"/>
-            </a:solidFill>
-            <a:prstDash val="solid"/>
-          </a:ln>
-        </p:spPr>
-      </p:sp>
-      <p:sp>
-        <p:nvSpPr>
-          <p:cNvPr id="40" name="Shape 37"/>
-          <p:cNvSpPr/>
-          <p:nvPr/>
-        </p:nvSpPr>
-        <p:spPr>
-          <a:xfrm>
-            <a:off x="7406640" y="5522976"/>
-            <a:ext cx="109728" cy="640080"/>
-          </a:xfrm>
-          <a:prstGeom prst="rect">
-            <a:avLst/>
-          </a:prstGeom>
-          <a:solidFill>
-            <a:srgbClr val="D72638"/>
-          </a:solidFill>
-          <a:ln w="12700">
-            <a:solidFill>
-              <a:srgbClr val="D72638"/>
-            </a:solidFill>
-            <a:prstDash val="solid"/>
-          </a:ln>
-        </p:spPr>
-      </p:sp>
-      <p:sp>
-        <p:nvSpPr>
-          <p:cNvPr id="41" name="Shape 38"/>
-          <p:cNvSpPr/>
-          <p:nvPr/>
-        </p:nvSpPr>
-        <p:spPr>
-          <a:xfrm>
-            <a:off x="7571232" y="5614416"/>
-            <a:ext cx="548640" cy="256032"/>
-          </a:xfrm>
-          <a:prstGeom prst="rect">
-            <a:avLst/>
-          </a:prstGeom>
-          <a:solidFill>
-            <a:srgbClr val="D72638"/>
-          </a:solidFill>
-          <a:ln w="12700">
-            <a:solidFill>
-              <a:srgbClr val="D72638"/>
-            </a:solidFill>
-            <a:prstDash val="solid"/>
-          </a:ln>
-        </p:spPr>
-      </p:sp>
-      <p:sp>
-        <p:nvSpPr>
-          <p:cNvPr id="42" name="Text 39"/>
-          <p:cNvSpPr/>
-          <p:nvPr/>
-        </p:nvSpPr>
-        <p:spPr>
-          <a:xfrm>
-            <a:off x="7571232" y="5614416"/>
-            <a:ext cx="548640" cy="256032"/>
-          </a:xfrm>
-          <a:prstGeom prst="rect">
-            <a:avLst/>
-          </a:prstGeom>
-          <a:noFill/>
-          <a:ln/>
-        </p:spPr>
-        <p:txBody>
-          <a:bodyPr wrap="square" lIns="0" tIns="0" rIns="0" bIns="0" rtlCol="0" anchor="ctr"/>
-          <a:lstStyle/>
-          <a:p>
-            <a:pPr algn="ctr" indent="0" marL="0">
-              <a:buNone/>
-            </a:pPr>
-            <a:r>
-              <a:rPr lang="en-US" sz="900" b="1" dirty="0">
-                <a:solidFill>
-                  <a:srgbClr val="FFFFFF"/>
-                </a:solidFill>
-                <a:latin typeface="맑은 고딕" pitchFamily="34" charset="0"/>
-                <a:ea typeface="맑은 고딕" pitchFamily="34" charset="-122"/>
-                <a:cs typeface="맑은 고딕" pitchFamily="34" charset="-120"/>
-              </a:rPr>
-              <a:t>긴급</a:t>
-            </a:r>
-            <a:endParaRPr lang="en-US" sz="900" dirty="0"/>
-          </a:p>
-        </p:txBody>
-      </p:sp>
-      <p:sp>
-        <p:nvSpPr>
-          <p:cNvPr id="43" name="Text 40"/>
-          <p:cNvSpPr/>
-          <p:nvPr/>
-        </p:nvSpPr>
-        <p:spPr>
-          <a:xfrm>
-            <a:off x="8211312" y="5577840"/>
-            <a:ext cx="3291840" cy="274320"/>
-          </a:xfrm>
-          <a:prstGeom prst="rect">
-            <a:avLst/>
-          </a:prstGeom>
-          <a:noFill/>
-          <a:ln/>
-        </p:spPr>
-        <p:txBody>
-          <a:bodyPr wrap="square" lIns="0" tIns="0" rIns="0" bIns="0" rtlCol="0" anchor="ctr"/>
-          <a:lstStyle/>
-          <a:p>
-            <a:pPr indent="0" marL="0">
-              <a:buNone/>
-            </a:pPr>
-            <a:r>
-              <a:rPr lang="en-US" sz="1100" b="1" dirty="0">
-                <a:solidFill>
-                  <a:srgbClr val="0B1220"/>
-                </a:solidFill>
-                <a:latin typeface="맑은 고딕" pitchFamily="34" charset="0"/>
-                <a:ea typeface="맑은 고딕" pitchFamily="34" charset="-122"/>
-                <a:cs typeface="맑은 고딕" pitchFamily="34" charset="-120"/>
-              </a:rPr>
-              <a:t>Two-ball Bangle</a:t>
-            </a:r>
-            <a:endParaRPr lang="en-US" sz="1100" dirty="0"/>
-          </a:p>
-        </p:txBody>
-      </p:sp>
-      <p:sp>
-        <p:nvSpPr>
-          <p:cNvPr id="44" name="Text 41"/>
-          <p:cNvSpPr/>
-          <p:nvPr/>
-        </p:nvSpPr>
-        <p:spPr>
-          <a:xfrm>
-            <a:off x="8211312" y="5852160"/>
-            <a:ext cx="3291840" cy="256032"/>
-          </a:xfrm>
-          <a:prstGeom prst="rect">
-            <a:avLst/>
-          </a:prstGeom>
-          <a:noFill/>
-          <a:ln/>
-        </p:spPr>
-        <p:txBody>
-          <a:bodyPr wrap="square" lIns="0" tIns="0" rIns="0" bIns="0" rtlCol="0" anchor="ctr"/>
-          <a:lstStyle/>
-          <a:p>
-            <a:pPr indent="0" marL="0">
-              <a:buNone/>
-            </a:pPr>
-            <a:r>
-              <a:rPr lang="en-US" sz="1000" dirty="0">
-                <a:solidFill>
-                  <a:srgbClr val="6B7280"/>
-                </a:solidFill>
-                <a:latin typeface="맑은 고딕" pitchFamily="34" charset="0"/>
-                <a:ea typeface="맑은 고딕" pitchFamily="34" charset="-122"/>
-                <a:cs typeface="맑은 고딕" pitchFamily="34" charset="-120"/>
-              </a:rPr>
-              <a:t>Bracelet  ·  재고 0개</a:t>
-            </a:r>
-            <a:pPr indent="0" marL="0">
-              <a:buNone/>
-            </a:pPr>
-            <a:r>
-              <a:rPr lang="en-US" sz="1000" b="1" dirty="0">
-                <a:solidFill>
-                  <a:srgbClr val="D72638"/>
-                </a:solidFill>
-                <a:latin typeface="맑은 고딕" pitchFamily="34" charset="0"/>
-                <a:ea typeface="맑은 고딕" pitchFamily="34" charset="-122"/>
-                <a:cs typeface="맑은 고딕" pitchFamily="34" charset="-120"/>
-              </a:rPr>
-              <a:t/>
-            </a:r>
-            <a:endParaRPr lang="en-US" sz="1000" dirty="0"/>
-          </a:p>
-        </p:txBody>
-      </p:sp>
-      <p:sp>
-        <p:nvSpPr>
           <p:cNvPr id="45" name="Text 42"/>
           <p:cNvSpPr/>
           <p:nvPr/>
@@ -8267,7 +8267,7 @@
                 <a:ea typeface="맑은 고딕" pitchFamily="34" charset="-122"/>
                 <a:cs typeface="맑은 고딕" pitchFamily="34" charset="-120"/>
               </a:rPr>
-              <a:t>베스트 상품 리포트  ·  생성 2026-05-25 08:00</a:t>
+              <a:t>베스트 상품 리포트  ·  생성 2026-05-26 08:00</a:t>
             </a:r>
             <a:endParaRPr lang="en-US" sz="900" dirty="0"/>
           </a:p>
@@ -8480,7 +8480,7 @@
                 <a:ea typeface="맑은 고딕" pitchFamily="34" charset="-122"/>
                 <a:cs typeface="맑은 고딕" pitchFamily="34" charset="-120"/>
               </a:rPr>
-              <a:t>2026년 05월 25일 (월)</a:t>
+              <a:t>2026년 05월 26일 (화)</a:t>
             </a:r>
             <a:endParaRPr lang="en-US" sz="1200" dirty="0"/>
           </a:p>
@@ -8647,7 +8647,7 @@
                 <a:ea typeface="맑은 고딕" pitchFamily="34" charset="-122"/>
                 <a:cs typeface="맑은 고딕" pitchFamily="34" charset="-120"/>
               </a:rPr>
-              <a:t>139 개</a:t>
+              <a:t>137 개</a:t>
             </a:r>
             <a:endParaRPr lang="en-US" sz="3600" dirty="0"/>
           </a:p>
@@ -8775,7 +8775,7 @@
                 <a:ea typeface="맑은 고딕" pitchFamily="34" charset="-122"/>
                 <a:cs typeface="맑은 고딕" pitchFamily="34" charset="-120"/>
               </a:rPr>
-              <a:t>CandyPOP Necklace (사이즈: 1size (37~43cm))</a:t>
+              <a:t>CandyPOP Necklace (사이즈: 2size (47~52cm))</a:t>
             </a:r>
             <a:endParaRPr lang="en-US" sz="1800" dirty="0"/>
           </a:p>
@@ -8853,7 +8853,7 @@
                 <a:ea typeface="맑은 고딕" pitchFamily="34" charset="-122"/>
                 <a:cs typeface="맑은 고딕" pitchFamily="34" charset="-120"/>
               </a:rPr>
-              <a:t>32</a:t>
+              <a:t>33</a:t>
             </a:r>
             <a:endParaRPr lang="en-US" sz="4400" dirty="0"/>
           </a:p>
@@ -9387,7 +9387,7 @@
                           <a:ea typeface="맑은 고딕" pitchFamily="34" charset="-122"/>
                           <a:cs typeface="맑은 고딕" pitchFamily="34" charset="-120"/>
                         </a:rPr>
-                        <a:t>CandyPOP Necklace (사이즈: 1size (37~43cm))</a:t>
+                        <a:t>CandyPOP Necklace (사이즈: 2size (47~52cm))</a:t>
                       </a:r>
                       <a:endParaRPr lang="en-US" sz="1100" dirty="0">
                         <a:latin typeface="맑은 고딕" charset="0"/>
@@ -9452,7 +9452,7 @@
                           <a:ea typeface="맑은 고딕" pitchFamily="34" charset="-122"/>
                           <a:cs typeface="맑은 고딕" pitchFamily="34" charset="-120"/>
                         </a:rPr>
-                        <a:t>32 개</a:t>
+                        <a:t>33 개</a:t>
                       </a:r>
                       <a:endParaRPr lang="en-US" sz="1400" dirty="0">
                         <a:latin typeface="맑은 고딕" charset="0"/>
@@ -9649,7 +9649,7 @@
                           <a:ea typeface="맑은 고딕" pitchFamily="34" charset="-122"/>
                           <a:cs typeface="맑은 고딕" pitchFamily="34" charset="-120"/>
                         </a:rPr>
-                        <a:t>CandyPOP Necklace (사이즈: 2size (47~52cm))</a:t>
+                        <a:t>CandyPOP Necklace (사이즈: 1size (37~43cm))</a:t>
                       </a:r>
                       <a:endParaRPr lang="en-US" sz="1100" dirty="0">
                         <a:latin typeface="맑은 고딕" charset="0"/>
@@ -9714,7 +9714,7 @@
                           <a:ea typeface="맑은 고딕" pitchFamily="34" charset="-122"/>
                           <a:cs typeface="맑은 고딕" pitchFamily="34" charset="-120"/>
                         </a:rPr>
-                        <a:t>22 개</a:t>
+                        <a:t>32 개</a:t>
                       </a:r>
                       <a:endParaRPr lang="en-US" sz="1200" dirty="0">
                         <a:latin typeface="맑은 고딕" charset="0"/>
@@ -9846,7 +9846,7 @@
                           <a:ea typeface="맑은 고딕" pitchFamily="34" charset="-122"/>
                           <a:cs typeface="맑은 고딕" pitchFamily="34" charset="-120"/>
                         </a:rPr>
-                        <a:t>Necklace</a:t>
+                        <a:t>Ring</a:t>
                       </a:r>
                       <a:endParaRPr lang="en-US" sz="1000" dirty="0">
                         <a:latin typeface="맑은 고딕" charset="0"/>
@@ -9911,7 +9911,7 @@
                           <a:ea typeface="맑은 고딕" pitchFamily="34" charset="-122"/>
                           <a:cs typeface="맑은 고딕" pitchFamily="34" charset="-120"/>
                         </a:rPr>
-                        <a:t>ThreadDuo Necklace</a:t>
+                        <a:t>"4s" 925 Open Ring (사이즈: 남성)</a:t>
                       </a:r>
                       <a:endParaRPr lang="en-US" sz="1100" dirty="0">
                         <a:latin typeface="맑은 고딕" charset="0"/>
@@ -9976,7 +9976,7 @@
                           <a:ea typeface="맑은 고딕" pitchFamily="34" charset="-122"/>
                           <a:cs typeface="맑은 고딕" pitchFamily="34" charset="-120"/>
                         </a:rPr>
-                        <a:t>18 개</a:t>
+                        <a:t>23 개</a:t>
                       </a:r>
                       <a:endParaRPr lang="en-US" sz="1200" dirty="0">
                         <a:latin typeface="맑은 고딕" charset="0"/>
@@ -10062,7 +10062,7 @@
                 <a:ea typeface="맑은 고딕" pitchFamily="34" charset="-122"/>
                 <a:cs typeface="맑은 고딕" pitchFamily="34" charset="-120"/>
               </a:rPr>
-              <a:t>리오더 필요  🔴 긴급 19건</a:t>
+              <a:t>리오더 필요  🔴 긴급 21건</a:t>
             </a:r>
             <a:endParaRPr lang="en-US" sz="1500" dirty="0"/>
           </a:p>
@@ -10126,7 +10126,7 @@
                 <a:ea typeface="맑은 고딕" pitchFamily="34" charset="-122"/>
                 <a:cs typeface="맑은 고딕" pitchFamily="34" charset="-120"/>
               </a:rPr>
-              <a:t>🔴 긴급 19건  ·  상세는 시트 확인</a:t>
+              <a:t>🔴 긴급 21건  ·  상세는 시트 확인</a:t>
             </a:r>
             <a:endParaRPr lang="en-US" sz="1400" dirty="0"/>
           </a:p>
@@ -10165,7 +10165,7 @@
                 <a:ea typeface="맑은 고딕" pitchFamily="34" charset="-122"/>
                 <a:cs typeface="맑은 고딕" pitchFamily="34" charset="-120"/>
               </a:rPr>
-              <a:t>베스트 상품 리포트  ·  생성 2026-05-25 08:00</a:t>
+              <a:t>베스트 상품 리포트  ·  생성 2026-05-26 08:00</a:t>
             </a:r>
             <a:endParaRPr lang="en-US" sz="900" dirty="0"/>
           </a:p>
@@ -10378,7 +10378,7 @@
                 <a:ea typeface="맑은 고딕" pitchFamily="34" charset="-122"/>
                 <a:cs typeface="맑은 고딕" pitchFamily="34" charset="-120"/>
               </a:rPr>
-              <a:t>2026년 05월 25일 (월)</a:t>
+              <a:t>2026년 05월 26일 (화)</a:t>
             </a:r>
             <a:endParaRPr lang="en-US" sz="1200" dirty="0"/>
           </a:p>
@@ -10929,7 +10929,7 @@
                 <a:ea typeface="맑은 고딕" pitchFamily="34" charset="-122"/>
                 <a:cs typeface="맑은 고딕" pitchFamily="34" charset="-120"/>
               </a:rPr>
-              <a:t>30,688</a:t>
+              <a:t>30,201</a:t>
             </a:r>
             <a:endParaRPr lang="en-US" sz="3000" dirty="0"/>
           </a:p>
@@ -11489,7 +11489,7 @@
                           <a:ea typeface="맑은 고딕" pitchFamily="34" charset="-122"/>
                           <a:cs typeface="맑은 고딕" pitchFamily="34" charset="-120"/>
                         </a:rPr>
-                        <a:t>2,081</a:t>
+                        <a:t>2,073</a:t>
                       </a:r>
                       <a:endParaRPr lang="en-US" sz="1000" dirty="0">
                         <a:latin typeface="맑은 고딕" charset="0"/>
@@ -11751,7 +11751,7 @@
                           <a:ea typeface="맑은 고딕" pitchFamily="34" charset="-122"/>
                           <a:cs typeface="맑은 고딕" pitchFamily="34" charset="-120"/>
                         </a:rPr>
-                        <a:t>1,604</a:t>
+                        <a:t>1,594</a:t>
                       </a:r>
                       <a:endParaRPr lang="en-US" sz="1000" dirty="0">
                         <a:latin typeface="맑은 고딕" charset="0"/>
@@ -12013,7 +12013,7 @@
                           <a:ea typeface="맑은 고딕" pitchFamily="34" charset="-122"/>
                           <a:cs typeface="맑은 고딕" pitchFamily="34" charset="-120"/>
                         </a:rPr>
-                        <a:t>1,335</a:t>
+                        <a:t>1,275</a:t>
                       </a:r>
                       <a:endParaRPr lang="en-US" sz="1000" dirty="0">
                         <a:latin typeface="맑은 고딕" charset="0"/>
@@ -12275,7 +12275,7 @@
                           <a:ea typeface="맑은 고딕" pitchFamily="34" charset="-122"/>
                           <a:cs typeface="맑은 고딕" pitchFamily="34" charset="-120"/>
                         </a:rPr>
-                        <a:t>1,099</a:t>
+                        <a:t>964</a:t>
                       </a:r>
                       <a:endParaRPr lang="en-US" sz="1000" dirty="0">
                         <a:latin typeface="맑은 고딕" charset="0"/>
@@ -12537,7 +12537,7 @@
                           <a:ea typeface="맑은 고딕" pitchFamily="34" charset="-122"/>
                           <a:cs typeface="맑은 고딕" pitchFamily="34" charset="-120"/>
                         </a:rPr>
-                        <a:t>912</a:t>
+                        <a:t>898</a:t>
                       </a:r>
                       <a:endParaRPr lang="en-US" sz="1000" dirty="0">
                         <a:latin typeface="맑은 고딕" charset="0"/>
@@ -13556,7 +13556,7 @@
                 <a:ea typeface="맑은 고딕" pitchFamily="34" charset="-122"/>
                 <a:cs typeface="맑은 고딕" pitchFamily="34" charset="-120"/>
               </a:rPr>
-              <a:t>베스트 상품 리포트  ·  생성 2026-05-25 08:00</a:t>
+              <a:t>베스트 상품 리포트  ·  생성 2026-05-26 08:00</a:t>
             </a:r>
             <a:endParaRPr lang="en-US" sz="900" dirty="0"/>
           </a:p>
@@ -13769,7 +13769,7 @@
                 <a:ea typeface="맑은 고딕" pitchFamily="34" charset="-122"/>
                 <a:cs typeface="맑은 고딕" pitchFamily="34" charset="-120"/>
               </a:rPr>
-              <a:t>2026년 05월 25일 (월)</a:t>
+              <a:t>2026년 05월 26일 (화)</a:t>
             </a:r>
             <a:endParaRPr lang="en-US" sz="1200" dirty="0"/>
           </a:p>
@@ -13897,7 +13897,7 @@
                 <a:ea typeface="맑은 고딕" pitchFamily="34" charset="-122"/>
                 <a:cs typeface="맑은 고딕" pitchFamily="34" charset="-120"/>
               </a:rPr>
-              <a:t>🚨  긴급 리오더 70건    ·    주의 리오더 9건    ·    오늘 발주 검토 필수</a:t>
+              <a:t>🚨  긴급 리오더 73건    ·    주의 리오더 12건    ·    오늘 발주 검토 필수</a:t>
             </a:r>
             <a:pPr indent="0" marL="0">
               <a:buNone/>
@@ -14663,7 +14663,7 @@
                           <a:ea typeface="맑은 고딕" pitchFamily="34" charset="-122"/>
                           <a:cs typeface="맑은 고딕" pitchFamily="34" charset="-120"/>
                         </a:rPr>
-                        <a:t>[SILVER925] Crimson Open Ring</a:t>
+                        <a:t>[SILVER925] Flowy Open Ring</a:t>
                       </a:r>
                       <a:endParaRPr lang="en-US" sz="1100" dirty="0">
                         <a:latin typeface="맑은 고딕" charset="0"/>
@@ -14731,7 +14731,7 @@
                           <a:ea typeface="맑은 고딕" pitchFamily="34" charset="-122"/>
                           <a:cs typeface="맑은 고딕" pitchFamily="34" charset="-120"/>
                         </a:rPr>
-                        <a:t>1</a:t>
+                        <a:t>5</a:t>
                       </a:r>
                       <a:endParaRPr lang="en-US" sz="1100" dirty="0">
                         <a:latin typeface="맑은 고딕" charset="0"/>
@@ -15141,7 +15141,7 @@
                           <a:ea typeface="맑은 고딕" pitchFamily="34" charset="-122"/>
                           <a:cs typeface="맑은 고딕" pitchFamily="34" charset="-120"/>
                         </a:rPr>
-                        <a:t>3</a:t>
+                        <a:t>1</a:t>
                       </a:r>
                       <a:endParaRPr lang="en-US" sz="1100" dirty="0">
                         <a:latin typeface="맑은 고딕" charset="0"/>
@@ -15415,7 +15415,7 @@
                           <a:ea typeface="맑은 고딕" pitchFamily="34" charset="-122"/>
                           <a:cs typeface="맑은 고딕" pitchFamily="34" charset="-120"/>
                         </a:rPr>
-                        <a:t>Ring</a:t>
+                        <a:t>Necklace</a:t>
                       </a:r>
                       <a:endParaRPr lang="en-US" sz="1000" dirty="0">
                         <a:latin typeface="맑은 고딕" charset="0"/>
@@ -15483,7 +15483,7 @@
                           <a:ea typeface="맑은 고딕" pitchFamily="34" charset="-122"/>
                           <a:cs typeface="맑은 고딕" pitchFamily="34" charset="-120"/>
                         </a:rPr>
-                        <a:t>"Mlayer" 925 Open Ring</a:t>
+                        <a:t>DBLfix Necklace</a:t>
                       </a:r>
                       <a:endParaRPr lang="en-US" sz="1100" dirty="0">
                         <a:latin typeface="맑은 고딕" charset="0"/>
@@ -15551,7 +15551,7 @@
                           <a:ea typeface="맑은 고딕" pitchFamily="34" charset="-122"/>
                           <a:cs typeface="맑은 고딕" pitchFamily="34" charset="-120"/>
                         </a:rPr>
-                        <a:t>1</a:t>
+                        <a:t>5</a:t>
                       </a:r>
                       <a:endParaRPr lang="en-US" sz="1100" dirty="0">
                         <a:latin typeface="맑은 고딕" charset="0"/>
@@ -15619,7 +15619,7 @@
                           <a:ea typeface="맑은 고딕" pitchFamily="34" charset="-122"/>
                           <a:cs typeface="맑은 고딕" pitchFamily="34" charset="-120"/>
                         </a:rPr>
-                        <a:t>2 개</a:t>
+                        <a:t>1 개</a:t>
                       </a:r>
                       <a:endParaRPr lang="en-US" sz="1100" dirty="0">
                         <a:latin typeface="맑은 고딕" charset="0"/>
@@ -15893,7 +15893,7 @@
                           <a:ea typeface="맑은 고딕" pitchFamily="34" charset="-122"/>
                           <a:cs typeface="맑은 고딕" pitchFamily="34" charset="-120"/>
                         </a:rPr>
-                        <a:t>"Bloometal" 925 Open Ring</a:t>
+                        <a:t>"Ribbonwist" 925 Open Ring</a:t>
                       </a:r>
                       <a:endParaRPr lang="en-US" sz="1100" dirty="0">
                         <a:latin typeface="맑은 고딕" charset="0"/>
@@ -15961,7 +15961,7 @@
                           <a:ea typeface="맑은 고딕" pitchFamily="34" charset="-122"/>
                           <a:cs typeface="맑은 고딕" pitchFamily="34" charset="-120"/>
                         </a:rPr>
-                        <a:t>0</a:t>
+                        <a:t>5</a:t>
                       </a:r>
                       <a:endParaRPr lang="en-US" sz="1100" dirty="0">
                         <a:latin typeface="맑은 고딕" charset="0"/>
@@ -16029,7 +16029,7 @@
                           <a:ea typeface="맑은 고딕" pitchFamily="34" charset="-122"/>
                           <a:cs typeface="맑은 고딕" pitchFamily="34" charset="-120"/>
                         </a:rPr>
-                        <a:t>2 개</a:t>
+                        <a:t>1 개</a:t>
                       </a:r>
                       <a:endParaRPr lang="en-US" sz="1100" dirty="0">
                         <a:latin typeface="맑은 고딕" charset="0"/>
@@ -16167,7 +16167,7 @@
                           <a:ea typeface="맑은 고딕" pitchFamily="34" charset="-122"/>
                           <a:cs typeface="맑은 고딕" pitchFamily="34" charset="-120"/>
                         </a:rPr>
-                        <a:t>CT</a:t>
+                        <a:t>PR</a:t>
                       </a:r>
                       <a:endParaRPr lang="en-US" sz="1100" dirty="0">
                         <a:latin typeface="맑은 고딕" charset="0"/>
@@ -16235,7 +16235,7 @@
                           <a:ea typeface="맑은 고딕" pitchFamily="34" charset="-122"/>
                           <a:cs typeface="맑은 고딕" pitchFamily="34" charset="-120"/>
                         </a:rPr>
-                        <a:t>Ring</a:t>
+                        <a:t>ELECTRONIC</a:t>
                       </a:r>
                       <a:endParaRPr lang="en-US" sz="1000" dirty="0">
                         <a:latin typeface="맑은 고딕" charset="0"/>
@@ -16303,7 +16303,7 @@
                           <a:ea typeface="맑은 고딕" pitchFamily="34" charset="-122"/>
                           <a:cs typeface="맑은 고딕" pitchFamily="34" charset="-120"/>
                         </a:rPr>
-                        <a:t>"Crackave" 925 Open Ring</a:t>
+                        <a:t>Jacquard Fast Charging Cable (7color) (컬러: 민트 / 기종옵션: C-Apple 8pin / 길이: 2m)</a:t>
                       </a:r>
                       <a:endParaRPr lang="en-US" sz="1100" dirty="0">
                         <a:latin typeface="맑은 고딕" charset="0"/>
@@ -16371,7 +16371,7 @@
                           <a:ea typeface="맑은 고딕" pitchFamily="34" charset="-122"/>
                           <a:cs typeface="맑은 고딕" pitchFamily="34" charset="-120"/>
                         </a:rPr>
-                        <a:t>1</a:t>
+                        <a:t>17</a:t>
                       </a:r>
                       <a:endParaRPr lang="en-US" sz="1100" dirty="0">
                         <a:latin typeface="맑은 고딕" charset="0"/>
@@ -16577,7 +16577,7 @@
                           <a:ea typeface="맑은 고딕" pitchFamily="34" charset="-122"/>
                           <a:cs typeface="맑은 고딕" pitchFamily="34" charset="-120"/>
                         </a:rPr>
-                        <a:t>PR</a:t>
+                        <a:t>6A</a:t>
                       </a:r>
                       <a:endParaRPr lang="en-US" sz="1100" dirty="0">
                         <a:latin typeface="맑은 고딕" charset="0"/>
@@ -16645,7 +16645,7 @@
                           <a:ea typeface="맑은 고딕" pitchFamily="34" charset="-122"/>
                           <a:cs typeface="맑은 고딕" pitchFamily="34" charset="-120"/>
                         </a:rPr>
-                        <a:t>ELECTRONIC</a:t>
+                        <a:t>★Season off★</a:t>
                       </a:r>
                       <a:endParaRPr lang="en-US" sz="1000" dirty="0">
                         <a:latin typeface="맑은 고딕" charset="0"/>
@@ -16713,7 +16713,7 @@
                           <a:ea typeface="맑은 고딕" pitchFamily="34" charset="-122"/>
                           <a:cs typeface="맑은 고딕" pitchFamily="34" charset="-120"/>
                         </a:rPr>
-                        <a:t>Jacquard Fast Charging Cable (7color) (컬러: 민트 / 기종옵션: C-Apple 8pin / 길이: 2m)</a:t>
+                        <a:t>8-Ball Smart Tok</a:t>
                       </a:r>
                       <a:endParaRPr lang="en-US" sz="1100" dirty="0">
                         <a:latin typeface="맑은 고딕" charset="0"/>
@@ -16781,7 +16781,7 @@
                           <a:ea typeface="맑은 고딕" pitchFamily="34" charset="-122"/>
                           <a:cs typeface="맑은 고딕" pitchFamily="34" charset="-120"/>
                         </a:rPr>
-                        <a:t>18</a:t>
+                        <a:t>4</a:t>
                       </a:r>
                       <a:endParaRPr lang="en-US" sz="1100" dirty="0">
                         <a:latin typeface="맑은 고딕" charset="0"/>
@@ -16849,7 +16849,7 @@
                           <a:ea typeface="맑은 고딕" pitchFamily="34" charset="-122"/>
                           <a:cs typeface="맑은 고딕" pitchFamily="34" charset="-120"/>
                         </a:rPr>
-                        <a:t>1 개</a:t>
+                        <a:t>0 개</a:t>
                       </a:r>
                       <a:endParaRPr lang="en-US" sz="1100" dirty="0">
                         <a:latin typeface="맑은 고딕" charset="0"/>
@@ -16987,7 +16987,7 @@
                           <a:ea typeface="맑은 고딕" pitchFamily="34" charset="-122"/>
                           <a:cs typeface="맑은 고딕" pitchFamily="34" charset="-120"/>
                         </a:rPr>
-                        <a:t>PR</a:t>
+                        <a:t>6A</a:t>
                       </a:r>
                       <a:endParaRPr lang="en-US" sz="1100" dirty="0">
                         <a:latin typeface="맑은 고딕" charset="0"/>
@@ -17055,7 +17055,7 @@
                           <a:ea typeface="맑은 고딕" pitchFamily="34" charset="-122"/>
                           <a:cs typeface="맑은 고딕" pitchFamily="34" charset="-120"/>
                         </a:rPr>
-                        <a:t>★ Last Sale ★</a:t>
+                        <a:t>Ring</a:t>
                       </a:r>
                       <a:endParaRPr lang="en-US" sz="1000" dirty="0">
                         <a:latin typeface="맑은 고딕" charset="0"/>
@@ -17123,7 +17123,7 @@
                           <a:ea typeface="맑은 고딕" pitchFamily="34" charset="-122"/>
                           <a:cs typeface="맑은 고딕" pitchFamily="34" charset="-120"/>
                         </a:rPr>
-                        <a:t>Cloud Grip Glass Mini Brush (3color) (컬러: 스카이블루)</a:t>
+                        <a:t>[SILVER925] Crimson Open Ring</a:t>
                       </a:r>
                       <a:endParaRPr lang="en-US" sz="1100" dirty="0">
                         <a:latin typeface="맑은 고딕" charset="0"/>
@@ -17191,7 +17191,7 @@
                           <a:ea typeface="맑은 고딕" pitchFamily="34" charset="-122"/>
                           <a:cs typeface="맑은 고딕" pitchFamily="34" charset="-120"/>
                         </a:rPr>
-                        <a:t>14</a:t>
+                        <a:t>1</a:t>
                       </a:r>
                       <a:endParaRPr lang="en-US" sz="1100" dirty="0">
                         <a:latin typeface="맑은 고딕" charset="0"/>
@@ -17259,7 +17259,7 @@
                           <a:ea typeface="맑은 고딕" pitchFamily="34" charset="-122"/>
                           <a:cs typeface="맑은 고딕" pitchFamily="34" charset="-120"/>
                         </a:rPr>
-                        <a:t>1 개</a:t>
+                        <a:t>0 개</a:t>
                       </a:r>
                       <a:endParaRPr lang="en-US" sz="1100" dirty="0">
                         <a:latin typeface="맑은 고딕" charset="0"/>
@@ -17397,7 +17397,7 @@
                           <a:ea typeface="맑은 고딕" pitchFamily="34" charset="-122"/>
                           <a:cs typeface="맑은 고딕" pitchFamily="34" charset="-120"/>
                         </a:rPr>
-                        <a:t>PR</a:t>
+                        <a:t>6A</a:t>
                       </a:r>
                       <a:endParaRPr lang="en-US" sz="1100" dirty="0">
                         <a:latin typeface="맑은 고딕" charset="0"/>
@@ -17465,7 +17465,7 @@
                           <a:ea typeface="맑은 고딕" pitchFamily="34" charset="-122"/>
                           <a:cs typeface="맑은 고딕" pitchFamily="34" charset="-120"/>
                         </a:rPr>
-                        <a:t>ETC</a:t>
+                        <a:t>Bracelet</a:t>
                       </a:r>
                       <a:endParaRPr lang="en-US" sz="1000" dirty="0">
                         <a:latin typeface="맑은 고딕" charset="0"/>
@@ -17533,7 +17533,7 @@
                           <a:ea typeface="맑은 고딕" pitchFamily="34" charset="-122"/>
                           <a:cs typeface="맑은 고딕" pitchFamily="34" charset="-120"/>
                         </a:rPr>
-                        <a:t>360° Rotating Phone Holder (컬러: 화이트)</a:t>
+                        <a:t>Two-ball Bangle</a:t>
                       </a:r>
                       <a:endParaRPr lang="en-US" sz="1100" dirty="0">
                         <a:latin typeface="맑은 고딕" charset="0"/>
@@ -17601,7 +17601,7 @@
                           <a:ea typeface="맑은 고딕" pitchFamily="34" charset="-122"/>
                           <a:cs typeface="맑은 고딕" pitchFamily="34" charset="-120"/>
                         </a:rPr>
-                        <a:t>10</a:t>
+                        <a:t>0</a:t>
                       </a:r>
                       <a:endParaRPr lang="en-US" sz="1100" dirty="0">
                         <a:latin typeface="맑은 고딕" charset="0"/>
@@ -17669,7 +17669,7 @@
                           <a:ea typeface="맑은 고딕" pitchFamily="34" charset="-122"/>
                           <a:cs typeface="맑은 고딕" pitchFamily="34" charset="-120"/>
                         </a:rPr>
-                        <a:t>1 개</a:t>
+                        <a:t>0 개</a:t>
                       </a:r>
                       <a:endParaRPr lang="en-US" sz="1100" dirty="0">
                         <a:latin typeface="맑은 고딕" charset="0"/>
@@ -17875,7 +17875,7 @@
                           <a:ea typeface="맑은 고딕" pitchFamily="34" charset="-122"/>
                           <a:cs typeface="맑은 고딕" pitchFamily="34" charset="-120"/>
                         </a:rPr>
-                        <a:t>★Season off★</a:t>
+                        <a:t>★Best★</a:t>
                       </a:r>
                       <a:endParaRPr lang="en-US" sz="1000" dirty="0">
                         <a:latin typeface="맑은 고딕" charset="0"/>
@@ -17943,7 +17943,7 @@
                           <a:ea typeface="맑은 고딕" pitchFamily="34" charset="-122"/>
                           <a:cs typeface="맑은 고딕" pitchFamily="34" charset="-120"/>
                         </a:rPr>
-                        <a:t>8-Ball Smart Tok</a:t>
+                        <a:t>Marquise Necklace</a:t>
                       </a:r>
                       <a:endParaRPr lang="en-US" sz="1100" dirty="0">
                         <a:latin typeface="맑은 고딕" charset="0"/>
@@ -18011,7 +18011,7 @@
                           <a:ea typeface="맑은 고딕" pitchFamily="34" charset="-122"/>
                           <a:cs typeface="맑은 고딕" pitchFamily="34" charset="-120"/>
                         </a:rPr>
-                        <a:t>4</a:t>
+                        <a:t>0</a:t>
                       </a:r>
                       <a:endParaRPr lang="en-US" sz="1100" dirty="0">
                         <a:latin typeface="맑은 고딕" charset="0"/>
@@ -18168,7 +18168,7 @@
                 <a:ea typeface="맑은 고딕" pitchFamily="34" charset="-122"/>
                 <a:cs typeface="맑은 고딕" pitchFamily="34" charset="-120"/>
               </a:rPr>
-              <a:t>외 61건 더 있음 — 상세는 시트에서 확인</a:t>
+              <a:t>외 64건 더 있음 — 상세는 시트에서 확인</a:t>
             </a:r>
             <a:endParaRPr lang="en-US" sz="1000" dirty="0"/>
           </a:p>
@@ -18207,7 +18207,7 @@
                 <a:ea typeface="맑은 고딕" pitchFamily="34" charset="-122"/>
                 <a:cs typeface="맑은 고딕" pitchFamily="34" charset="-120"/>
               </a:rPr>
-              <a:t>베스트 상품 리포트  ·  생성 2026-05-25 08:00</a:t>
+              <a:t>베스트 상품 리포트  ·  생성 2026-05-26 08:00</a:t>
             </a:r>
             <a:endParaRPr lang="en-US" sz="900" dirty="0"/>
           </a:p>
@@ -18420,7 +18420,7 @@
                 <a:ea typeface="맑은 고딕" pitchFamily="34" charset="-122"/>
                 <a:cs typeface="맑은 고딕" pitchFamily="34" charset="-120"/>
               </a:rPr>
-              <a:t>2026년 05월 25일 (월)</a:t>
+              <a:t>2026년 05월 26일 (화)</a:t>
             </a:r>
             <a:endParaRPr lang="en-US" sz="1200" dirty="0"/>
           </a:p>
@@ -18587,7 +18587,7 @@
                 <a:ea typeface="맑은 고딕" pitchFamily="34" charset="-122"/>
                 <a:cs typeface="맑은 고딕" pitchFamily="34" charset="-120"/>
               </a:rPr>
-              <a:t>Google Sheet '브랜드 재고현황'  ·  최신화 2026-05-25 08:00</a:t>
+              <a:t>Google Sheet '브랜드 재고현황'  ·  최신화 2026-05-26 08:00</a:t>
             </a:r>
             <a:endParaRPr lang="en-US" sz="1100" dirty="0"/>
           </a:p>
@@ -19230,7 +19230,7 @@
                 <a:ea typeface="맑은 고딕" pitchFamily="34" charset="-122"/>
                 <a:cs typeface="맑은 고딕" pitchFamily="34" charset="-120"/>
               </a:rPr>
-              <a:t>✅ 3개 브랜드 모두 정상 추출  ·  24h 출고 기준 (2026-05-24 08:00 → 2026-05-25 08:00) · 신규 SKU 11건은 결제완료 기준</a:t>
+              <a:t>✅ 3개 브랜드 모두 정상 추출  ·  24h 출고 기준 (2026-05-25 08:00 → 2026-05-26 08:00) · 신규 SKU 11건은 결제완료 기준</a:t>
             </a:r>
             <a:endParaRPr lang="en-US" sz="1000" dirty="0"/>
           </a:p>
@@ -19269,7 +19269,7 @@
                 <a:ea typeface="맑은 고딕" pitchFamily="34" charset="-122"/>
                 <a:cs typeface="맑은 고딕" pitchFamily="34" charset="-120"/>
               </a:rPr>
-              <a:t>베스트 상품 리포트  ·  생성 2026-05-25 08:00</a:t>
+              <a:t>베스트 상품 리포트  ·  생성 2026-05-26 08:00</a:t>
             </a:r>
             <a:endParaRPr lang="en-US" sz="900" dirty="0"/>
           </a:p>

</xml_diff>

<commit_message>
chore: 매출 PPT 업로드 (best-sellers-2026-05-27.pptx) [auto]
</commit_message>
<xml_diff>
--- a/data/sales-report.pptx
+++ b/data/sales-report.pptx
@@ -1648,7 +1648,7 @@
                 <a:ea typeface="맑은 고딕" pitchFamily="34" charset="-122"/>
                 <a:cs typeface="맑은 고딕" pitchFamily="34" charset="-120"/>
               </a:rPr>
-              <a:t>2026년 05월 26일 (화)  ·  24h 출고 기준</a:t>
+              <a:t>2026년 05월 27일 (수)  ·  24h 출고 기준</a:t>
             </a:r>
             <a:endParaRPr lang="en-US" sz="2200" dirty="0"/>
           </a:p>
@@ -1726,7 +1726,7 @@
                 <a:ea typeface="맑은 고딕" pitchFamily="34" charset="-122"/>
                 <a:cs typeface="맑은 고딕" pitchFamily="34" charset="-120"/>
               </a:rPr>
-              <a:t>05.26</a:t>
+              <a:t>05.27</a:t>
             </a:r>
             <a:endParaRPr lang="en-US" sz="7200" dirty="0"/>
           </a:p>
@@ -1765,7 +1765,7 @@
                 <a:ea typeface="맑은 고딕" pitchFamily="34" charset="-122"/>
                 <a:cs typeface="맑은 고딕" pitchFamily="34" charset="-120"/>
               </a:rPr>
-              <a:t>화요일</a:t>
+              <a:t>수요일</a:t>
             </a:r>
             <a:endParaRPr lang="en-US" sz="1400" dirty="0"/>
           </a:p>
@@ -1804,7 +1804,7 @@
                 <a:ea typeface="맑은 고딕" pitchFamily="34" charset="-122"/>
                 <a:cs typeface="맑은 고딕" pitchFamily="34" charset="-120"/>
               </a:rPr>
-              <a:t>생성 2026-05-26 08:00  ·  Google Sheet 자동 동기</a:t>
+              <a:t>생성 2026-05-27 08:00  ·  Google Sheet 자동 동기</a:t>
             </a:r>
             <a:endParaRPr lang="en-US" sz="1000" dirty="0"/>
           </a:p>
@@ -1978,7 +1978,7 @@
                 <a:ea typeface="맑은 고딕" pitchFamily="34" charset="-122"/>
                 <a:cs typeface="맑은 고딕" pitchFamily="34" charset="-120"/>
               </a:rPr>
-              <a:t>2026년 05월 26일 (화)</a:t>
+              <a:t>2026년 05월 27일 (수)</a:t>
             </a:r>
             <a:endParaRPr lang="en-US" sz="1200" dirty="0"/>
           </a:p>
@@ -2145,7 +2145,7 @@
                 <a:ea typeface="맑은 고딕" pitchFamily="34" charset="-122"/>
                 <a:cs typeface="맑은 고딕" pitchFamily="34" charset="-120"/>
               </a:rPr>
-              <a:t>770 개</a:t>
+              <a:t>1914 개</a:t>
             </a:r>
             <a:endParaRPr lang="en-US" sz="3600" dirty="0"/>
           </a:p>
@@ -2312,7 +2312,7 @@
                 <a:ea typeface="맑은 고딕" pitchFamily="34" charset="-122"/>
                 <a:cs typeface="맑은 고딕" pitchFamily="34" charset="-120"/>
               </a:rPr>
-              <a:t>73 건</a:t>
+              <a:t>71 건</a:t>
             </a:r>
             <a:endParaRPr lang="en-US" sz="3200" dirty="0"/>
           </a:p>
@@ -2685,7 +2685,7 @@
                 <a:ea typeface="맑은 고딕" pitchFamily="34" charset="-122"/>
                 <a:cs typeface="맑은 고딕" pitchFamily="34" charset="-120"/>
               </a:rPr>
-              <a:t>86 SKU  ·  판매 OK</a:t>
+              <a:t>85 SKU  ·  판매 OK</a:t>
             </a:r>
             <a:pPr indent="0" marL="0">
               <a:buNone/>
@@ -2969,7 +2969,7 @@
                 <a:ea typeface="맑은 고딕" pitchFamily="34" charset="-122"/>
                 <a:cs typeface="맑은 고딕" pitchFamily="34" charset="-120"/>
               </a:rPr>
-              <a:t>192 SKU  ·  판매 데이터 있음</a:t>
+              <a:t>198 SKU  ·  판매 데이터 있음</a:t>
             </a:r>
             <a:pPr indent="0" marL="0">
               <a:buNone/>
@@ -3482,7 +3482,7 @@
                           <a:ea typeface="맑은 고딕" pitchFamily="34" charset="-122"/>
                           <a:cs typeface="맑은 고딕" pitchFamily="34" charset="-120"/>
                         </a:rPr>
-                        <a:t>6A</a:t>
+                        <a:t>CT</a:t>
                       </a:r>
                       <a:endParaRPr lang="en-US" sz="1100" dirty="0">
                         <a:latin typeface="맑은 고딕" charset="0"/>
@@ -3547,7 +3547,7 @@
                           <a:ea typeface="맑은 고딕" pitchFamily="34" charset="-122"/>
                           <a:cs typeface="맑은 고딕" pitchFamily="34" charset="-120"/>
                         </a:rPr>
-                        <a:t>Ring</a:t>
+                        <a:t>Necklace</a:t>
                       </a:r>
                       <a:endParaRPr lang="en-US" sz="1000" dirty="0">
                         <a:latin typeface="맑은 고딕" charset="0"/>
@@ -3612,7 +3612,7 @@
                           <a:ea typeface="맑은 고딕" pitchFamily="34" charset="-122"/>
                           <a:cs typeface="맑은 고딕" pitchFamily="34" charset="-120"/>
                         </a:rPr>
-                        <a:t>[SILVER925] Guyeong Open Ring v3.0 (silver)</a:t>
+                        <a:t>CandyPOP Necklace (사이즈: 2size (47~52cm))</a:t>
                       </a:r>
                       <a:endParaRPr lang="en-US" sz="1100" dirty="0">
                         <a:latin typeface="맑은 고딕" charset="0"/>
@@ -3677,7 +3677,7 @@
                           <a:ea typeface="맑은 고딕" pitchFamily="34" charset="-122"/>
                           <a:cs typeface="맑은 고딕" pitchFamily="34" charset="-120"/>
                         </a:rPr>
-                        <a:t>145 개</a:t>
+                        <a:t>1565 개</a:t>
                       </a:r>
                       <a:endParaRPr lang="en-US" sz="1400" dirty="0">
                         <a:latin typeface="맑은 고딕" charset="0"/>
@@ -3939,7 +3939,7 @@
                           <a:ea typeface="맑은 고딕" pitchFamily="34" charset="-122"/>
                           <a:cs typeface="맑은 고딕" pitchFamily="34" charset="-120"/>
                         </a:rPr>
-                        <a:t>[SILVER925] Starly Open Ring</a:t>
+                        <a:t>[SILVER925] Guyeong Open Ring v3.0 (silver)</a:t>
                       </a:r>
                       <a:endParaRPr lang="en-US" sz="1100" dirty="0">
                         <a:latin typeface="맑은 고딕" charset="0"/>
@@ -4004,7 +4004,7 @@
                           <a:ea typeface="맑은 고딕" pitchFamily="34" charset="-122"/>
                           <a:cs typeface="맑은 고딕" pitchFamily="34" charset="-120"/>
                         </a:rPr>
-                        <a:t>61 개</a:t>
+                        <a:t>46 개</a:t>
                       </a:r>
                       <a:endParaRPr lang="en-US" sz="1400" dirty="0">
                         <a:latin typeface="맑은 고딕" charset="0"/>
@@ -4201,7 +4201,7 @@
                           <a:ea typeface="맑은 고딕" pitchFamily="34" charset="-122"/>
                           <a:cs typeface="맑은 고딕" pitchFamily="34" charset="-120"/>
                         </a:rPr>
-                        <a:t>Necklace</a:t>
+                        <a:t>Ring</a:t>
                       </a:r>
                       <a:endParaRPr lang="en-US" sz="1000" dirty="0">
                         <a:latin typeface="맑은 고딕" charset="0"/>
@@ -4266,7 +4266,7 @@
                           <a:ea typeface="맑은 고딕" pitchFamily="34" charset="-122"/>
                           <a:cs typeface="맑은 고딕" pitchFamily="34" charset="-120"/>
                         </a:rPr>
-                        <a:t>Tiny Cross Necklace</a:t>
+                        <a:t>[SILVER925] CH.alban Open Ring</a:t>
                       </a:r>
                       <a:endParaRPr lang="en-US" sz="1100" dirty="0">
                         <a:latin typeface="맑은 고딕" charset="0"/>
@@ -4331,7 +4331,7 @@
                           <a:ea typeface="맑은 고딕" pitchFamily="34" charset="-122"/>
                           <a:cs typeface="맑은 고딕" pitchFamily="34" charset="-120"/>
                         </a:rPr>
-                        <a:t>47 개</a:t>
+                        <a:t>41 개</a:t>
                       </a:r>
                       <a:endParaRPr lang="en-US" sz="1400" dirty="0">
                         <a:latin typeface="맑은 고딕" charset="0"/>
@@ -4463,7 +4463,7 @@
                           <a:ea typeface="맑은 고딕" pitchFamily="34" charset="-122"/>
                           <a:cs typeface="맑은 고딕" pitchFamily="34" charset="-120"/>
                         </a:rPr>
-                        <a:t>6A</a:t>
+                        <a:t>CT</a:t>
                       </a:r>
                       <a:endParaRPr lang="en-US" sz="1100" dirty="0">
                         <a:latin typeface="맑은 고딕" charset="0"/>
@@ -4528,7 +4528,7 @@
                           <a:ea typeface="맑은 고딕" pitchFamily="34" charset="-122"/>
                           <a:cs typeface="맑은 고딕" pitchFamily="34" charset="-120"/>
                         </a:rPr>
-                        <a:t>Ring</a:t>
+                        <a:t>Necklace</a:t>
                       </a:r>
                       <a:endParaRPr lang="en-US" sz="1000" dirty="0">
                         <a:latin typeface="맑은 고딕" charset="0"/>
@@ -4593,7 +4593,7 @@
                           <a:ea typeface="맑은 고딕" pitchFamily="34" charset="-122"/>
                           <a:cs typeface="맑은 고딕" pitchFamily="34" charset="-120"/>
                         </a:rPr>
-                        <a:t>[SILVER925] Cstic Open Ring</a:t>
+                        <a:t>CandyPOP Necklace (사이즈: 1size (37~43cm))</a:t>
                       </a:r>
                       <a:endParaRPr lang="en-US" sz="1100" dirty="0">
                         <a:latin typeface="맑은 고딕" charset="0"/>
@@ -4658,7 +4658,7 @@
                           <a:ea typeface="맑은 고딕" pitchFamily="34" charset="-122"/>
                           <a:cs typeface="맑은 고딕" pitchFamily="34" charset="-120"/>
                         </a:rPr>
-                        <a:t>43 개</a:t>
+                        <a:t>29 개</a:t>
                       </a:r>
                       <a:endParaRPr lang="en-US" sz="1200" dirty="0">
                         <a:latin typeface="맑은 고딕" charset="0"/>
@@ -4790,7 +4790,7 @@
                           <a:ea typeface="맑은 고딕" pitchFamily="34" charset="-122"/>
                           <a:cs typeface="맑은 고딕" pitchFamily="34" charset="-120"/>
                         </a:rPr>
-                        <a:t>6A</a:t>
+                        <a:t>CT</a:t>
                       </a:r>
                       <a:endParaRPr lang="en-US" sz="1100" dirty="0">
                         <a:latin typeface="맑은 고딕" charset="0"/>
@@ -4855,7 +4855,7 @@
                           <a:ea typeface="맑은 고딕" pitchFamily="34" charset="-122"/>
                           <a:cs typeface="맑은 고딕" pitchFamily="34" charset="-120"/>
                         </a:rPr>
-                        <a:t>Ring</a:t>
+                        <a:t>Necklace</a:t>
                       </a:r>
                       <a:endParaRPr lang="en-US" sz="1000" dirty="0">
                         <a:latin typeface="맑은 고딕" charset="0"/>
@@ -4920,7 +4920,7 @@
                           <a:ea typeface="맑은 고딕" pitchFamily="34" charset="-122"/>
                           <a:cs typeface="맑은 고딕" pitchFamily="34" charset="-120"/>
                         </a:rPr>
-                        <a:t>[SILVER925] A Rua Open Ring</a:t>
+                        <a:t>ThreadDuo Necklace</a:t>
                       </a:r>
                       <a:endParaRPr lang="en-US" sz="1100" dirty="0">
                         <a:latin typeface="맑은 고딕" charset="0"/>
@@ -4985,7 +4985,7 @@
                           <a:ea typeface="맑은 고딕" pitchFamily="34" charset="-122"/>
                           <a:cs typeface="맑은 고딕" pitchFamily="34" charset="-120"/>
                         </a:rPr>
-                        <a:t>41 개</a:t>
+                        <a:t>19 개</a:t>
                       </a:r>
                       <a:endParaRPr lang="en-US" sz="1200" dirty="0">
                         <a:latin typeface="맑은 고딕" charset="0"/>
@@ -5071,7 +5071,7 @@
                 <a:ea typeface="맑은 고딕" pitchFamily="34" charset="-122"/>
                 <a:cs typeface="맑은 고딕" pitchFamily="34" charset="-120"/>
               </a:rPr>
-              <a:t>베스트 상품 리포트  ·  생성 2026-05-26 08:00</a:t>
+              <a:t>베스트 상품 리포트  ·  생성 2026-05-27 08:00</a:t>
             </a:r>
             <a:endParaRPr lang="en-US" sz="900" dirty="0"/>
           </a:p>
@@ -5284,7 +5284,7 @@
                 <a:ea typeface="맑은 고딕" pitchFamily="34" charset="-122"/>
                 <a:cs typeface="맑은 고딕" pitchFamily="34" charset="-120"/>
               </a:rPr>
-              <a:t>2026년 05월 26일 (화)</a:t>
+              <a:t>2026년 05월 27일 (수)</a:t>
             </a:r>
             <a:endParaRPr lang="en-US" sz="1200" dirty="0"/>
           </a:p>
@@ -5451,7 +5451,7 @@
                 <a:ea typeface="맑은 고딕" pitchFamily="34" charset="-122"/>
                 <a:cs typeface="맑은 고딕" pitchFamily="34" charset="-120"/>
               </a:rPr>
-              <a:t>633 개</a:t>
+              <a:t>256 개</a:t>
             </a:r>
             <a:endParaRPr lang="en-US" sz="3600" dirty="0"/>
           </a:p>
@@ -5657,7 +5657,7 @@
                 <a:ea typeface="맑은 고딕" pitchFamily="34" charset="-122"/>
                 <a:cs typeface="맑은 고딕" pitchFamily="34" charset="-120"/>
               </a:rPr>
-              <a:t>145</a:t>
+              <a:t>46</a:t>
             </a:r>
             <a:endParaRPr lang="en-US" sz="4400" dirty="0"/>
           </a:p>
@@ -6256,7 +6256,7 @@
                           <a:ea typeface="맑은 고딕" pitchFamily="34" charset="-122"/>
                           <a:cs typeface="맑은 고딕" pitchFamily="34" charset="-120"/>
                         </a:rPr>
-                        <a:t>145 개</a:t>
+                        <a:t>46 개</a:t>
                       </a:r>
                       <a:endParaRPr lang="en-US" sz="1400" dirty="0">
                         <a:latin typeface="맑은 고딕" charset="0"/>
@@ -6453,7 +6453,7 @@
                           <a:ea typeface="맑은 고딕" pitchFamily="34" charset="-122"/>
                           <a:cs typeface="맑은 고딕" pitchFamily="34" charset="-120"/>
                         </a:rPr>
-                        <a:t>[SILVER925] Starly Open Ring</a:t>
+                        <a:t>[SILVER925] CH.alban Open Ring</a:t>
                       </a:r>
                       <a:endParaRPr lang="en-US" sz="1100" dirty="0">
                         <a:latin typeface="맑은 고딕" charset="0"/>
@@ -6518,7 +6518,7 @@
                           <a:ea typeface="맑은 고딕" pitchFamily="34" charset="-122"/>
                           <a:cs typeface="맑은 고딕" pitchFamily="34" charset="-120"/>
                         </a:rPr>
-                        <a:t>61 개</a:t>
+                        <a:t>41 개</a:t>
                       </a:r>
                       <a:endParaRPr lang="en-US" sz="1200" dirty="0">
                         <a:latin typeface="맑은 고딕" charset="0"/>
@@ -6715,7 +6715,7 @@
                           <a:ea typeface="맑은 고딕" pitchFamily="34" charset="-122"/>
                           <a:cs typeface="맑은 고딕" pitchFamily="34" charset="-120"/>
                         </a:rPr>
-                        <a:t>Tiny Cross Necklace</a:t>
+                        <a:t>YOKNIS 9921 Necklace</a:t>
                       </a:r>
                       <a:endParaRPr lang="en-US" sz="1100" dirty="0">
                         <a:latin typeface="맑은 고딕" charset="0"/>
@@ -6780,7 +6780,7 @@
                           <a:ea typeface="맑은 고딕" pitchFamily="34" charset="-122"/>
                           <a:cs typeface="맑은 고딕" pitchFamily="34" charset="-120"/>
                         </a:rPr>
-                        <a:t>47 개</a:t>
+                        <a:t>14 개</a:t>
                       </a:r>
                       <a:endParaRPr lang="en-US" sz="1200" dirty="0">
                         <a:latin typeface="맑은 고딕" charset="0"/>
@@ -7042,7 +7042,7 @@
                           <a:ea typeface="맑은 고딕" pitchFamily="34" charset="-122"/>
                           <a:cs typeface="맑은 고딕" pitchFamily="34" charset="-120"/>
                         </a:rPr>
-                        <a:t>43 개</a:t>
+                        <a:t>11 개</a:t>
                       </a:r>
                       <a:endParaRPr lang="en-US" sz="1200" dirty="0">
                         <a:latin typeface="맑은 고딕" charset="0"/>
@@ -7239,7 +7239,7 @@
                           <a:ea typeface="맑은 고딕" pitchFamily="34" charset="-122"/>
                           <a:cs typeface="맑은 고딕" pitchFamily="34" charset="-120"/>
                         </a:rPr>
-                        <a:t>[SILVER925] A Rua Open Ring</a:t>
+                        <a:t>[SILVER925] Starly Open Ring</a:t>
                       </a:r>
                       <a:endParaRPr lang="en-US" sz="1100" dirty="0">
                         <a:latin typeface="맑은 고딕" charset="0"/>
@@ -7304,7 +7304,7 @@
                           <a:ea typeface="맑은 고딕" pitchFamily="34" charset="-122"/>
                           <a:cs typeface="맑은 고딕" pitchFamily="34" charset="-120"/>
                         </a:rPr>
-                        <a:t>41 개</a:t>
+                        <a:t>11 개</a:t>
                       </a:r>
                       <a:endParaRPr lang="en-US" sz="1200" dirty="0">
                         <a:latin typeface="맑은 고딕" charset="0"/>
@@ -7390,7 +7390,7 @@
                 <a:ea typeface="맑은 고딕" pitchFamily="34" charset="-122"/>
                 <a:cs typeface="맑은 고딕" pitchFamily="34" charset="-120"/>
               </a:rPr>
-              <a:t>리오더 필요  🔴 긴급 10건</a:t>
+              <a:t>리오더 필요  🔴 긴급 8건</a:t>
             </a:r>
             <a:pPr indent="0" marL="0">
               <a:buNone/>
@@ -7557,7 +7557,7 @@
                 <a:ea typeface="맑은 고딕" pitchFamily="34" charset="-122"/>
                 <a:cs typeface="맑은 고딕" pitchFamily="34" charset="-120"/>
               </a:rPr>
-              <a:t>[SILVER925] Flowy Open Ring</a:t>
+              <a:t>[SILVER925] Vearl Open Ring</a:t>
             </a:r>
             <a:endParaRPr lang="en-US" sz="1100" dirty="0"/>
           </a:p>
@@ -7763,7 +7763,7 @@
                 <a:ea typeface="맑은 고딕" pitchFamily="34" charset="-122"/>
                 <a:cs typeface="맑은 고딕" pitchFamily="34" charset="-120"/>
               </a:rPr>
-              <a:t>2PT Bracelet</a:t>
+              <a:t>[SILVER925] Flowy Open Ring</a:t>
             </a:r>
             <a:endParaRPr lang="en-US" sz="1100" dirty="0"/>
           </a:p>
@@ -7802,7 +7802,7 @@
                 <a:ea typeface="맑은 고딕" pitchFamily="34" charset="-122"/>
                 <a:cs typeface="맑은 고딕" pitchFamily="34" charset="-120"/>
               </a:rPr>
-              <a:t>Bracelet  ·  재고 1개</a:t>
+              <a:t>Ring  ·  재고 4개</a:t>
             </a:r>
             <a:pPr indent="0" marL="0">
               <a:buNone/>
@@ -8214,7 +8214,7 @@
                 <a:ea typeface="맑은 고딕" pitchFamily="34" charset="-122"/>
                 <a:cs typeface="맑은 고딕" pitchFamily="34" charset="-120"/>
               </a:rPr>
-              <a:t>Ring  ·  재고 1개</a:t>
+              <a:t>Ring  ·  재고 3개</a:t>
             </a:r>
             <a:pPr indent="0" marL="0">
               <a:buNone/>
@@ -8267,7 +8267,7 @@
                 <a:ea typeface="맑은 고딕" pitchFamily="34" charset="-122"/>
                 <a:cs typeface="맑은 고딕" pitchFamily="34" charset="-120"/>
               </a:rPr>
-              <a:t>베스트 상품 리포트  ·  생성 2026-05-26 08:00</a:t>
+              <a:t>베스트 상품 리포트  ·  생성 2026-05-27 08:00</a:t>
             </a:r>
             <a:endParaRPr lang="en-US" sz="900" dirty="0"/>
           </a:p>
@@ -8480,7 +8480,7 @@
                 <a:ea typeface="맑은 고딕" pitchFamily="34" charset="-122"/>
                 <a:cs typeface="맑은 고딕" pitchFamily="34" charset="-120"/>
               </a:rPr>
-              <a:t>2026년 05월 26일 (화)</a:t>
+              <a:t>2026년 05월 27일 (수)</a:t>
             </a:r>
             <a:endParaRPr lang="en-US" sz="1200" dirty="0"/>
           </a:p>
@@ -8647,7 +8647,7 @@
                 <a:ea typeface="맑은 고딕" pitchFamily="34" charset="-122"/>
                 <a:cs typeface="맑은 고딕" pitchFamily="34" charset="-120"/>
               </a:rPr>
-              <a:t>137 개</a:t>
+              <a:t>1658 개</a:t>
             </a:r>
             <a:endParaRPr lang="en-US" sz="3600" dirty="0"/>
           </a:p>
@@ -8853,7 +8853,7 @@
                 <a:ea typeface="맑은 고딕" pitchFamily="34" charset="-122"/>
                 <a:cs typeface="맑은 고딕" pitchFamily="34" charset="-120"/>
               </a:rPr>
-              <a:t>33</a:t>
+              <a:t>1565</a:t>
             </a:r>
             <a:endParaRPr lang="en-US" sz="4400" dirty="0"/>
           </a:p>
@@ -9452,7 +9452,7 @@
                           <a:ea typeface="맑은 고딕" pitchFamily="34" charset="-122"/>
                           <a:cs typeface="맑은 고딕" pitchFamily="34" charset="-120"/>
                         </a:rPr>
-                        <a:t>33 개</a:t>
+                        <a:t>1565 개</a:t>
                       </a:r>
                       <a:endParaRPr lang="en-US" sz="1400" dirty="0">
                         <a:latin typeface="맑은 고딕" charset="0"/>
@@ -9714,7 +9714,7 @@
                           <a:ea typeface="맑은 고딕" pitchFamily="34" charset="-122"/>
                           <a:cs typeface="맑은 고딕" pitchFamily="34" charset="-120"/>
                         </a:rPr>
-                        <a:t>32 개</a:t>
+                        <a:t>29 개</a:t>
                       </a:r>
                       <a:endParaRPr lang="en-US" sz="1200" dirty="0">
                         <a:latin typeface="맑은 고딕" charset="0"/>
@@ -9846,7 +9846,7 @@
                           <a:ea typeface="맑은 고딕" pitchFamily="34" charset="-122"/>
                           <a:cs typeface="맑은 고딕" pitchFamily="34" charset="-120"/>
                         </a:rPr>
-                        <a:t>Ring</a:t>
+                        <a:t>Necklace</a:t>
                       </a:r>
                       <a:endParaRPr lang="en-US" sz="1000" dirty="0">
                         <a:latin typeface="맑은 고딕" charset="0"/>
@@ -9911,7 +9911,7 @@
                           <a:ea typeface="맑은 고딕" pitchFamily="34" charset="-122"/>
                           <a:cs typeface="맑은 고딕" pitchFamily="34" charset="-120"/>
                         </a:rPr>
-                        <a:t>"4s" 925 Open Ring (사이즈: 남성)</a:t>
+                        <a:t>ThreadDuo Necklace</a:t>
                       </a:r>
                       <a:endParaRPr lang="en-US" sz="1100" dirty="0">
                         <a:latin typeface="맑은 고딕" charset="0"/>
@@ -9976,7 +9976,7 @@
                           <a:ea typeface="맑은 고딕" pitchFamily="34" charset="-122"/>
                           <a:cs typeface="맑은 고딕" pitchFamily="34" charset="-120"/>
                         </a:rPr>
-                        <a:t>23 개</a:t>
+                        <a:t>19 개</a:t>
                       </a:r>
                       <a:endParaRPr lang="en-US" sz="1200" dirty="0">
                         <a:latin typeface="맑은 고딕" charset="0"/>
@@ -10062,7 +10062,7 @@
                 <a:ea typeface="맑은 고딕" pitchFamily="34" charset="-122"/>
                 <a:cs typeface="맑은 고딕" pitchFamily="34" charset="-120"/>
               </a:rPr>
-              <a:t>리오더 필요  🔴 긴급 21건</a:t>
+              <a:t>리오더 필요  🔴 긴급 22건</a:t>
             </a:r>
             <a:endParaRPr lang="en-US" sz="1500" dirty="0"/>
           </a:p>
@@ -10126,7 +10126,7 @@
                 <a:ea typeface="맑은 고딕" pitchFamily="34" charset="-122"/>
                 <a:cs typeface="맑은 고딕" pitchFamily="34" charset="-120"/>
               </a:rPr>
-              <a:t>🔴 긴급 21건  ·  상세는 시트 확인</a:t>
+              <a:t>🔴 긴급 22건  ·  상세는 시트 확인</a:t>
             </a:r>
             <a:endParaRPr lang="en-US" sz="1400" dirty="0"/>
           </a:p>
@@ -10165,7 +10165,7 @@
                 <a:ea typeface="맑은 고딕" pitchFamily="34" charset="-122"/>
                 <a:cs typeface="맑은 고딕" pitchFamily="34" charset="-120"/>
               </a:rPr>
-              <a:t>베스트 상품 리포트  ·  생성 2026-05-26 08:00</a:t>
+              <a:t>베스트 상품 리포트  ·  생성 2026-05-27 08:00</a:t>
             </a:r>
             <a:endParaRPr lang="en-US" sz="900" dirty="0"/>
           </a:p>
@@ -10378,7 +10378,7 @@
                 <a:ea typeface="맑은 고딕" pitchFamily="34" charset="-122"/>
                 <a:cs typeface="맑은 고딕" pitchFamily="34" charset="-120"/>
               </a:rPr>
-              <a:t>2026년 05월 26일 (화)</a:t>
+              <a:t>2026년 05월 27일 (수)</a:t>
             </a:r>
             <a:endParaRPr lang="en-US" sz="1200" dirty="0"/>
           </a:p>
@@ -10545,7 +10545,7 @@
                 <a:ea typeface="맑은 고딕" pitchFamily="34" charset="-122"/>
                 <a:cs typeface="맑은 고딕" pitchFamily="34" charset="-120"/>
               </a:rPr>
-              <a:t>192</a:t>
+              <a:t>198</a:t>
             </a:r>
             <a:endParaRPr lang="en-US" sz="3000" dirty="0"/>
           </a:p>
@@ -10673,7 +10673,7 @@
                 <a:ea typeface="맑은 고딕" pitchFamily="34" charset="-122"/>
                 <a:cs typeface="맑은 고딕" pitchFamily="34" charset="-120"/>
               </a:rPr>
-              <a:t>28</a:t>
+              <a:t>27</a:t>
             </a:r>
             <a:endParaRPr lang="en-US" sz="3000" dirty="0"/>
           </a:p>
@@ -10929,7 +10929,7 @@
                 <a:ea typeface="맑은 고딕" pitchFamily="34" charset="-122"/>
                 <a:cs typeface="맑은 고딕" pitchFamily="34" charset="-120"/>
               </a:rPr>
-              <a:t>30,201</a:t>
+              <a:t>30,872</a:t>
             </a:r>
             <a:endParaRPr lang="en-US" sz="3000" dirty="0"/>
           </a:p>
@@ -11489,7 +11489,7 @@
                           <a:ea typeface="맑은 고딕" pitchFamily="34" charset="-122"/>
                           <a:cs typeface="맑은 고딕" pitchFamily="34" charset="-120"/>
                         </a:rPr>
-                        <a:t>2,073</a:t>
+                        <a:t>2,062</a:t>
                       </a:r>
                       <a:endParaRPr lang="en-US" sz="1000" dirty="0">
                         <a:latin typeface="맑은 고딕" charset="0"/>
@@ -11751,7 +11751,7 @@
                           <a:ea typeface="맑은 고딕" pitchFamily="34" charset="-122"/>
                           <a:cs typeface="맑은 고딕" pitchFamily="34" charset="-120"/>
                         </a:rPr>
-                        <a:t>1,594</a:t>
+                        <a:t>1,586</a:t>
                       </a:r>
                       <a:endParaRPr lang="en-US" sz="1000" dirty="0">
                         <a:latin typeface="맑은 고딕" charset="0"/>
@@ -12013,7 +12013,7 @@
                           <a:ea typeface="맑은 고딕" pitchFamily="34" charset="-122"/>
                           <a:cs typeface="맑은 고딕" pitchFamily="34" charset="-120"/>
                         </a:rPr>
-                        <a:t>1,275</a:t>
+                        <a:t>1,202</a:t>
                       </a:r>
                       <a:endParaRPr lang="en-US" sz="1000" dirty="0">
                         <a:latin typeface="맑은 고딕" charset="0"/>
@@ -12210,7 +12210,7 @@
                           <a:ea typeface="맑은 고딕" pitchFamily="34" charset="-122"/>
                           <a:cs typeface="맑은 고딕" pitchFamily="34" charset="-120"/>
                         </a:rPr>
-                        <a:t>컬러: 퍼플 / 기종 옵션: C type -&gt; C type</a:t>
+                        <a:t>컬러: 네온핑크 / 기종 옵션: USB -&gt; Apple 8pin</a:t>
                       </a:r>
                       <a:endParaRPr lang="en-US" sz="900" dirty="0">
                         <a:latin typeface="맑은 고딕" charset="0"/>
@@ -12275,7 +12275,7 @@
                           <a:ea typeface="맑은 고딕" pitchFamily="34" charset="-122"/>
                           <a:cs typeface="맑은 고딕" pitchFamily="34" charset="-120"/>
                         </a:rPr>
-                        <a:t>964</a:t>
+                        <a:t>887</a:t>
                       </a:r>
                       <a:endParaRPr lang="en-US" sz="1000" dirty="0">
                         <a:latin typeface="맑은 고딕" charset="0"/>
@@ -12472,7 +12472,7 @@
                           <a:ea typeface="맑은 고딕" pitchFamily="34" charset="-122"/>
                           <a:cs typeface="맑은 고딕" pitchFamily="34" charset="-120"/>
                         </a:rPr>
-                        <a:t>컬러: 네온핑크 / 기종 옵션: USB -&gt; Apple 8pin</a:t>
+                        <a:t>컬러: 퍼플 / 기종 옵션: C type -&gt; C type</a:t>
                       </a:r>
                       <a:endParaRPr lang="en-US" sz="900" dirty="0">
                         <a:latin typeface="맑은 고딕" charset="0"/>
@@ -12537,7 +12537,7 @@
                           <a:ea typeface="맑은 고딕" pitchFamily="34" charset="-122"/>
                           <a:cs typeface="맑은 고딕" pitchFamily="34" charset="-120"/>
                         </a:rPr>
-                        <a:t>898</a:t>
+                        <a:t>819</a:t>
                       </a:r>
                       <a:endParaRPr lang="en-US" sz="1000" dirty="0">
                         <a:latin typeface="맑은 고딕" charset="0"/>
@@ -12623,7 +12623,7 @@
                 <a:ea typeface="맑은 고딕" pitchFamily="34" charset="-122"/>
                 <a:cs typeface="맑은 고딕" pitchFamily="34" charset="-120"/>
               </a:rPr>
-              <a:t>재고 점검  🔴 품절 28건</a:t>
+              <a:t>재고 점검  🔴 품절 27건</a:t>
             </a:r>
             <a:pPr indent="0" marL="0">
               <a:buNone/>
@@ -13556,7 +13556,7 @@
                 <a:ea typeface="맑은 고딕" pitchFamily="34" charset="-122"/>
                 <a:cs typeface="맑은 고딕" pitchFamily="34" charset="-120"/>
               </a:rPr>
-              <a:t>베스트 상품 리포트  ·  생성 2026-05-26 08:00</a:t>
+              <a:t>베스트 상품 리포트  ·  생성 2026-05-27 08:00</a:t>
             </a:r>
             <a:endParaRPr lang="en-US" sz="900" dirty="0"/>
           </a:p>
@@ -13769,7 +13769,7 @@
                 <a:ea typeface="맑은 고딕" pitchFamily="34" charset="-122"/>
                 <a:cs typeface="맑은 고딕" pitchFamily="34" charset="-120"/>
               </a:rPr>
-              <a:t>2026년 05월 26일 (화)</a:t>
+              <a:t>2026년 05월 27일 (수)</a:t>
             </a:r>
             <a:endParaRPr lang="en-US" sz="1200" dirty="0"/>
           </a:p>
@@ -13897,7 +13897,7 @@
                 <a:ea typeface="맑은 고딕" pitchFamily="34" charset="-122"/>
                 <a:cs typeface="맑은 고딕" pitchFamily="34" charset="-120"/>
               </a:rPr>
-              <a:t>🚨  긴급 리오더 73건    ·    주의 리오더 12건    ·    오늘 발주 검토 필수</a:t>
+              <a:t>🚨  긴급 리오더 71건    ·    주의 리오더 12건    ·    오늘 발주 검토 필수</a:t>
             </a:r>
             <a:pPr indent="0" marL="0">
               <a:buNone/>
@@ -14527,7 +14527,7 @@
                           <a:ea typeface="맑은 고딕" pitchFamily="34" charset="-122"/>
                           <a:cs typeface="맑은 고딕" pitchFamily="34" charset="-120"/>
                         </a:rPr>
-                        <a:t>6A</a:t>
+                        <a:t>CT</a:t>
                       </a:r>
                       <a:endParaRPr lang="en-US" sz="1100" dirty="0">
                         <a:latin typeface="맑은 고딕" charset="0"/>
@@ -14595,7 +14595,7 @@
                           <a:ea typeface="맑은 고딕" pitchFamily="34" charset="-122"/>
                           <a:cs typeface="맑은 고딕" pitchFamily="34" charset="-120"/>
                         </a:rPr>
-                        <a:t>Ring</a:t>
+                        <a:t>Necklace</a:t>
                       </a:r>
                       <a:endParaRPr lang="en-US" sz="1000" dirty="0">
                         <a:latin typeface="맑은 고딕" charset="0"/>
@@ -14663,7 +14663,7 @@
                           <a:ea typeface="맑은 고딕" pitchFamily="34" charset="-122"/>
                           <a:cs typeface="맑은 고딕" pitchFamily="34" charset="-120"/>
                         </a:rPr>
-                        <a:t>[SILVER925] Flowy Open Ring</a:t>
+                        <a:t>CandyPOP Necklace (사이즈: 2size (47~52cm))</a:t>
                       </a:r>
                       <a:endParaRPr lang="en-US" sz="1100" dirty="0">
                         <a:latin typeface="맑은 고딕" charset="0"/>
@@ -14731,7 +14731,7 @@
                           <a:ea typeface="맑은 고딕" pitchFamily="34" charset="-122"/>
                           <a:cs typeface="맑은 고딕" pitchFamily="34" charset="-120"/>
                         </a:rPr>
-                        <a:t>5</a:t>
+                        <a:t>0</a:t>
                       </a:r>
                       <a:endParaRPr lang="en-US" sz="1100" dirty="0">
                         <a:latin typeface="맑은 고딕" charset="0"/>
@@ -14799,7 +14799,7 @@
                           <a:ea typeface="맑은 고딕" pitchFamily="34" charset="-122"/>
                           <a:cs typeface="맑은 고딕" pitchFamily="34" charset="-120"/>
                         </a:rPr>
-                        <a:t>3 개</a:t>
+                        <a:t>1565 개</a:t>
                       </a:r>
                       <a:endParaRPr lang="en-US" sz="1100" dirty="0">
                         <a:latin typeface="맑은 고딕" charset="0"/>
@@ -15005,7 +15005,7 @@
                           <a:ea typeface="맑은 고딕" pitchFamily="34" charset="-122"/>
                           <a:cs typeface="맑은 고딕" pitchFamily="34" charset="-120"/>
                         </a:rPr>
-                        <a:t>Bracelet</a:t>
+                        <a:t>Ring</a:t>
                       </a:r>
                       <a:endParaRPr lang="en-US" sz="1000" dirty="0">
                         <a:latin typeface="맑은 고딕" charset="0"/>
@@ -15073,7 +15073,7 @@
                           <a:ea typeface="맑은 고딕" pitchFamily="34" charset="-122"/>
                           <a:cs typeface="맑은 고딕" pitchFamily="34" charset="-120"/>
                         </a:rPr>
-                        <a:t>2PT Bracelet</a:t>
+                        <a:t>[SILVER925] Vearl Open Ring</a:t>
                       </a:r>
                       <a:endParaRPr lang="en-US" sz="1100" dirty="0">
                         <a:latin typeface="맑은 고딕" charset="0"/>
@@ -15141,7 +15141,7 @@
                           <a:ea typeface="맑은 고딕" pitchFamily="34" charset="-122"/>
                           <a:cs typeface="맑은 고딕" pitchFamily="34" charset="-120"/>
                         </a:rPr>
-                        <a:t>1</a:t>
+                        <a:t>5</a:t>
                       </a:r>
                       <a:endParaRPr lang="en-US" sz="1100" dirty="0">
                         <a:latin typeface="맑은 고딕" charset="0"/>
@@ -15209,7 +15209,7 @@
                           <a:ea typeface="맑은 고딕" pitchFamily="34" charset="-122"/>
                           <a:cs typeface="맑은 고딕" pitchFamily="34" charset="-120"/>
                         </a:rPr>
-                        <a:t>2 개</a:t>
+                        <a:t>5 개</a:t>
                       </a:r>
                       <a:endParaRPr lang="en-US" sz="1100" dirty="0">
                         <a:latin typeface="맑은 고딕" charset="0"/>
@@ -15347,7 +15347,7 @@
                           <a:ea typeface="맑은 고딕" pitchFamily="34" charset="-122"/>
                           <a:cs typeface="맑은 고딕" pitchFamily="34" charset="-120"/>
                         </a:rPr>
-                        <a:t>CT</a:t>
+                        <a:t>PR</a:t>
                       </a:r>
                       <a:endParaRPr lang="en-US" sz="1100" dirty="0">
                         <a:latin typeface="맑은 고딕" charset="0"/>
@@ -15415,7 +15415,7 @@
                           <a:ea typeface="맑은 고딕" pitchFamily="34" charset="-122"/>
                           <a:cs typeface="맑은 고딕" pitchFamily="34" charset="-120"/>
                         </a:rPr>
-                        <a:t>Necklace</a:t>
+                        <a:t>ELECTRONIC</a:t>
                       </a:r>
                       <a:endParaRPr lang="en-US" sz="1000" dirty="0">
                         <a:latin typeface="맑은 고딕" charset="0"/>
@@ -15483,7 +15483,7 @@
                           <a:ea typeface="맑은 고딕" pitchFamily="34" charset="-122"/>
                           <a:cs typeface="맑은 고딕" pitchFamily="34" charset="-120"/>
                         </a:rPr>
-                        <a:t>DBLfix Necklace</a:t>
+                        <a:t>Jacquard Fast Charging Cable (7color) (컬러: 민트 / 기종옵션: C-Apple 8pin / 길이: 2m)</a:t>
                       </a:r>
                       <a:endParaRPr lang="en-US" sz="1100" dirty="0">
                         <a:latin typeface="맑은 고딕" charset="0"/>
@@ -15551,7 +15551,7 @@
                           <a:ea typeface="맑은 고딕" pitchFamily="34" charset="-122"/>
                           <a:cs typeface="맑은 고딕" pitchFamily="34" charset="-120"/>
                         </a:rPr>
-                        <a:t>5</a:t>
+                        <a:t>15</a:t>
                       </a:r>
                       <a:endParaRPr lang="en-US" sz="1100" dirty="0">
                         <a:latin typeface="맑은 고딕" charset="0"/>
@@ -15619,7 +15619,7 @@
                           <a:ea typeface="맑은 고딕" pitchFamily="34" charset="-122"/>
                           <a:cs typeface="맑은 고딕" pitchFamily="34" charset="-120"/>
                         </a:rPr>
-                        <a:t>1 개</a:t>
+                        <a:t>2 개</a:t>
                       </a:r>
                       <a:endParaRPr lang="en-US" sz="1100" dirty="0">
                         <a:latin typeface="맑은 고딕" charset="0"/>
@@ -15757,7 +15757,7 @@
                           <a:ea typeface="맑은 고딕" pitchFamily="34" charset="-122"/>
                           <a:cs typeface="맑은 고딕" pitchFamily="34" charset="-120"/>
                         </a:rPr>
-                        <a:t>CT</a:t>
+                        <a:t>6A</a:t>
                       </a:r>
                       <a:endParaRPr lang="en-US" sz="1100" dirty="0">
                         <a:latin typeface="맑은 고딕" charset="0"/>
@@ -15893,7 +15893,7 @@
                           <a:ea typeface="맑은 고딕" pitchFamily="34" charset="-122"/>
                           <a:cs typeface="맑은 고딕" pitchFamily="34" charset="-120"/>
                         </a:rPr>
-                        <a:t>"Ribbonwist" 925 Open Ring</a:t>
+                        <a:t>[SILVER925] Flowy Open Ring</a:t>
                       </a:r>
                       <a:endParaRPr lang="en-US" sz="1100" dirty="0">
                         <a:latin typeface="맑은 고딕" charset="0"/>
@@ -15961,7 +15961,7 @@
                           <a:ea typeface="맑은 고딕" pitchFamily="34" charset="-122"/>
                           <a:cs typeface="맑은 고딕" pitchFamily="34" charset="-120"/>
                         </a:rPr>
-                        <a:t>5</a:t>
+                        <a:t>4</a:t>
                       </a:r>
                       <a:endParaRPr lang="en-US" sz="1100" dirty="0">
                         <a:latin typeface="맑은 고딕" charset="0"/>
@@ -16167,7 +16167,7 @@
                           <a:ea typeface="맑은 고딕" pitchFamily="34" charset="-122"/>
                           <a:cs typeface="맑은 고딕" pitchFamily="34" charset="-120"/>
                         </a:rPr>
-                        <a:t>PR</a:t>
+                        <a:t>CT</a:t>
                       </a:r>
                       <a:endParaRPr lang="en-US" sz="1100" dirty="0">
                         <a:latin typeface="맑은 고딕" charset="0"/>
@@ -16235,7 +16235,7 @@
                           <a:ea typeface="맑은 고딕" pitchFamily="34" charset="-122"/>
                           <a:cs typeface="맑은 고딕" pitchFamily="34" charset="-120"/>
                         </a:rPr>
-                        <a:t>ELECTRONIC</a:t>
+                        <a:t>Necklace</a:t>
                       </a:r>
                       <a:endParaRPr lang="en-US" sz="1000" dirty="0">
                         <a:latin typeface="맑은 고딕" charset="0"/>
@@ -16303,7 +16303,7 @@
                           <a:ea typeface="맑은 고딕" pitchFamily="34" charset="-122"/>
                           <a:cs typeface="맑은 고딕" pitchFamily="34" charset="-120"/>
                         </a:rPr>
-                        <a:t>Jacquard Fast Charging Cable (7color) (컬러: 민트 / 기종옵션: C-Apple 8pin / 길이: 2m)</a:t>
+                        <a:t>DBLfix Necklace</a:t>
                       </a:r>
                       <a:endParaRPr lang="en-US" sz="1100" dirty="0">
                         <a:latin typeface="맑은 고딕" charset="0"/>
@@ -16371,7 +16371,7 @@
                           <a:ea typeface="맑은 고딕" pitchFamily="34" charset="-122"/>
                           <a:cs typeface="맑은 고딕" pitchFamily="34" charset="-120"/>
                         </a:rPr>
-                        <a:t>17</a:t>
+                        <a:t>4</a:t>
                       </a:r>
                       <a:endParaRPr lang="en-US" sz="1100" dirty="0">
                         <a:latin typeface="맑은 고딕" charset="0"/>
@@ -16577,7 +16577,7 @@
                           <a:ea typeface="맑은 고딕" pitchFamily="34" charset="-122"/>
                           <a:cs typeface="맑은 고딕" pitchFamily="34" charset="-120"/>
                         </a:rPr>
-                        <a:t>6A</a:t>
+                        <a:t>PR</a:t>
                       </a:r>
                       <a:endParaRPr lang="en-US" sz="1100" dirty="0">
                         <a:latin typeface="맑은 고딕" charset="0"/>
@@ -16645,7 +16645,7 @@
                           <a:ea typeface="맑은 고딕" pitchFamily="34" charset="-122"/>
                           <a:cs typeface="맑은 고딕" pitchFamily="34" charset="-120"/>
                         </a:rPr>
-                        <a:t>★Season off★</a:t>
+                        <a:t>ETC</a:t>
                       </a:r>
                       <a:endParaRPr lang="en-US" sz="1000" dirty="0">
                         <a:latin typeface="맑은 고딕" charset="0"/>
@@ -16713,7 +16713,7 @@
                           <a:ea typeface="맑은 고딕" pitchFamily="34" charset="-122"/>
                           <a:cs typeface="맑은 고딕" pitchFamily="34" charset="-120"/>
                         </a:rPr>
-                        <a:t>8-Ball Smart Tok</a:t>
+                        <a:t>360° Rotating Phone Holder (컬러: 블랙)</a:t>
                       </a:r>
                       <a:endParaRPr lang="en-US" sz="1100" dirty="0">
                         <a:latin typeface="맑은 고딕" charset="0"/>
@@ -16781,7 +16781,7 @@
                           <a:ea typeface="맑은 고딕" pitchFamily="34" charset="-122"/>
                           <a:cs typeface="맑은 고딕" pitchFamily="34" charset="-120"/>
                         </a:rPr>
-                        <a:t>4</a:t>
+                        <a:t>16</a:t>
                       </a:r>
                       <a:endParaRPr lang="en-US" sz="1100" dirty="0">
                         <a:latin typeface="맑은 고딕" charset="0"/>
@@ -16849,7 +16849,7 @@
                           <a:ea typeface="맑은 고딕" pitchFamily="34" charset="-122"/>
                           <a:cs typeface="맑은 고딕" pitchFamily="34" charset="-120"/>
                         </a:rPr>
-                        <a:t>0 개</a:t>
+                        <a:t>1 개</a:t>
                       </a:r>
                       <a:endParaRPr lang="en-US" sz="1100" dirty="0">
                         <a:latin typeface="맑은 고딕" charset="0"/>
@@ -16987,7 +16987,7 @@
                           <a:ea typeface="맑은 고딕" pitchFamily="34" charset="-122"/>
                           <a:cs typeface="맑은 고딕" pitchFamily="34" charset="-120"/>
                         </a:rPr>
-                        <a:t>6A</a:t>
+                        <a:t>PR</a:t>
                       </a:r>
                       <a:endParaRPr lang="en-US" sz="1100" dirty="0">
                         <a:latin typeface="맑은 고딕" charset="0"/>
@@ -17055,7 +17055,7 @@
                           <a:ea typeface="맑은 고딕" pitchFamily="34" charset="-122"/>
                           <a:cs typeface="맑은 고딕" pitchFamily="34" charset="-120"/>
                         </a:rPr>
-                        <a:t>Ring</a:t>
+                        <a:t>ETC</a:t>
                       </a:r>
                       <a:endParaRPr lang="en-US" sz="1000" dirty="0">
                         <a:latin typeface="맑은 고딕" charset="0"/>
@@ -17123,7 +17123,7 @@
                           <a:ea typeface="맑은 고딕" pitchFamily="34" charset="-122"/>
                           <a:cs typeface="맑은 고딕" pitchFamily="34" charset="-120"/>
                         </a:rPr>
-                        <a:t>[SILVER925] Crimson Open Ring</a:t>
+                        <a:t>Cotton Lunch Mini Bag (5color) (색상: 아이보리)</a:t>
                       </a:r>
                       <a:endParaRPr lang="en-US" sz="1100" dirty="0">
                         <a:latin typeface="맑은 고딕" charset="0"/>
@@ -17191,7 +17191,7 @@
                           <a:ea typeface="맑은 고딕" pitchFamily="34" charset="-122"/>
                           <a:cs typeface="맑은 고딕" pitchFamily="34" charset="-120"/>
                         </a:rPr>
-                        <a:t>1</a:t>
+                        <a:t>18</a:t>
                       </a:r>
                       <a:endParaRPr lang="en-US" sz="1100" dirty="0">
                         <a:latin typeface="맑은 고딕" charset="0"/>
@@ -17259,7 +17259,7 @@
                           <a:ea typeface="맑은 고딕" pitchFamily="34" charset="-122"/>
                           <a:cs typeface="맑은 고딕" pitchFamily="34" charset="-120"/>
                         </a:rPr>
-                        <a:t>0 개</a:t>
+                        <a:t>1 개</a:t>
                       </a:r>
                       <a:endParaRPr lang="en-US" sz="1100" dirty="0">
                         <a:latin typeface="맑은 고딕" charset="0"/>
@@ -17397,7 +17397,7 @@
                           <a:ea typeface="맑은 고딕" pitchFamily="34" charset="-122"/>
                           <a:cs typeface="맑은 고딕" pitchFamily="34" charset="-120"/>
                         </a:rPr>
-                        <a:t>6A</a:t>
+                        <a:t>PR</a:t>
                       </a:r>
                       <a:endParaRPr lang="en-US" sz="1100" dirty="0">
                         <a:latin typeface="맑은 고딕" charset="0"/>
@@ -17465,7 +17465,7 @@
                           <a:ea typeface="맑은 고딕" pitchFamily="34" charset="-122"/>
                           <a:cs typeface="맑은 고딕" pitchFamily="34" charset="-120"/>
                         </a:rPr>
-                        <a:t>Bracelet</a:t>
+                        <a:t>ETC</a:t>
                       </a:r>
                       <a:endParaRPr lang="en-US" sz="1000" dirty="0">
                         <a:latin typeface="맑은 고딕" charset="0"/>
@@ -17533,7 +17533,7 @@
                           <a:ea typeface="맑은 고딕" pitchFamily="34" charset="-122"/>
                           <a:cs typeface="맑은 고딕" pitchFamily="34" charset="-120"/>
                         </a:rPr>
-                        <a:t>Two-ball Bangle</a:t>
+                        <a:t>360° Rotating Phone Holder (컬러: 화이트)</a:t>
                       </a:r>
                       <a:endParaRPr lang="en-US" sz="1100" dirty="0">
                         <a:latin typeface="맑은 고딕" charset="0"/>
@@ -17601,7 +17601,7 @@
                           <a:ea typeface="맑은 고딕" pitchFamily="34" charset="-122"/>
                           <a:cs typeface="맑은 고딕" pitchFamily="34" charset="-120"/>
                         </a:rPr>
-                        <a:t>0</a:t>
+                        <a:t>9</a:t>
                       </a:r>
                       <a:endParaRPr lang="en-US" sz="1100" dirty="0">
                         <a:latin typeface="맑은 고딕" charset="0"/>
@@ -17669,7 +17669,7 @@
                           <a:ea typeface="맑은 고딕" pitchFamily="34" charset="-122"/>
                           <a:cs typeface="맑은 고딕" pitchFamily="34" charset="-120"/>
                         </a:rPr>
-                        <a:t>0 개</a:t>
+                        <a:t>1 개</a:t>
                       </a:r>
                       <a:endParaRPr lang="en-US" sz="1100" dirty="0">
                         <a:latin typeface="맑은 고딕" charset="0"/>
@@ -17807,7 +17807,7 @@
                           <a:ea typeface="맑은 고딕" pitchFamily="34" charset="-122"/>
                           <a:cs typeface="맑은 고딕" pitchFamily="34" charset="-120"/>
                         </a:rPr>
-                        <a:t>6A</a:t>
+                        <a:t>PR</a:t>
                       </a:r>
                       <a:endParaRPr lang="en-US" sz="1100" dirty="0">
                         <a:latin typeface="맑은 고딕" charset="0"/>
@@ -17875,7 +17875,7 @@
                           <a:ea typeface="맑은 고딕" pitchFamily="34" charset="-122"/>
                           <a:cs typeface="맑은 고딕" pitchFamily="34" charset="-120"/>
                         </a:rPr>
-                        <a:t>★Best★</a:t>
+                        <a:t>ELECTRONIC</a:t>
                       </a:r>
                       <a:endParaRPr lang="en-US" sz="1000" dirty="0">
                         <a:latin typeface="맑은 고딕" charset="0"/>
@@ -17943,7 +17943,7 @@
                           <a:ea typeface="맑은 고딕" pitchFamily="34" charset="-122"/>
                           <a:cs typeface="맑은 고딕" pitchFamily="34" charset="-120"/>
                         </a:rPr>
-                        <a:t>Marquise Necklace</a:t>
+                        <a:t>Jacquard Fast Charging Cable (7color) (컬러: 퍼플 / 기종옵션: C-Apple 8pin / 길이: 2m)</a:t>
                       </a:r>
                       <a:endParaRPr lang="en-US" sz="1100" dirty="0">
                         <a:latin typeface="맑은 고딕" charset="0"/>
@@ -18011,7 +18011,7 @@
                           <a:ea typeface="맑은 고딕" pitchFamily="34" charset="-122"/>
                           <a:cs typeface="맑은 고딕" pitchFamily="34" charset="-120"/>
                         </a:rPr>
-                        <a:t>0</a:t>
+                        <a:t>7</a:t>
                       </a:r>
                       <a:endParaRPr lang="en-US" sz="1100" dirty="0">
                         <a:latin typeface="맑은 고딕" charset="0"/>
@@ -18079,7 +18079,7 @@
                           <a:ea typeface="맑은 고딕" pitchFamily="34" charset="-122"/>
                           <a:cs typeface="맑은 고딕" pitchFamily="34" charset="-120"/>
                         </a:rPr>
-                        <a:t>0 개</a:t>
+                        <a:t>1 개</a:t>
                       </a:r>
                       <a:endParaRPr lang="en-US" sz="1100" dirty="0">
                         <a:latin typeface="맑은 고딕" charset="0"/>
@@ -18168,7 +18168,7 @@
                 <a:ea typeface="맑은 고딕" pitchFamily="34" charset="-122"/>
                 <a:cs typeface="맑은 고딕" pitchFamily="34" charset="-120"/>
               </a:rPr>
-              <a:t>외 64건 더 있음 — 상세는 시트에서 확인</a:t>
+              <a:t>외 62건 더 있음 — 상세는 시트에서 확인</a:t>
             </a:r>
             <a:endParaRPr lang="en-US" sz="1000" dirty="0"/>
           </a:p>
@@ -18207,7 +18207,7 @@
                 <a:ea typeface="맑은 고딕" pitchFamily="34" charset="-122"/>
                 <a:cs typeface="맑은 고딕" pitchFamily="34" charset="-120"/>
               </a:rPr>
-              <a:t>베스트 상품 리포트  ·  생성 2026-05-26 08:00</a:t>
+              <a:t>베스트 상품 리포트  ·  생성 2026-05-27 08:00</a:t>
             </a:r>
             <a:endParaRPr lang="en-US" sz="900" dirty="0"/>
           </a:p>
@@ -18420,7 +18420,7 @@
                 <a:ea typeface="맑은 고딕" pitchFamily="34" charset="-122"/>
                 <a:cs typeface="맑은 고딕" pitchFamily="34" charset="-120"/>
               </a:rPr>
-              <a:t>2026년 05월 26일 (화)</a:t>
+              <a:t>2026년 05월 27일 (수)</a:t>
             </a:r>
             <a:endParaRPr lang="en-US" sz="1200" dirty="0"/>
           </a:p>
@@ -18587,7 +18587,7 @@
                 <a:ea typeface="맑은 고딕" pitchFamily="34" charset="-122"/>
                 <a:cs typeface="맑은 고딕" pitchFamily="34" charset="-120"/>
               </a:rPr>
-              <a:t>Google Sheet '브랜드 재고현황'  ·  최신화 2026-05-26 08:00</a:t>
+              <a:t>Google Sheet '브랜드 재고현황'  ·  최신화 2026-05-27 08:00</a:t>
             </a:r>
             <a:endParaRPr lang="en-US" sz="1100" dirty="0"/>
           </a:p>
@@ -19099,7 +19099,7 @@
                 <a:ea typeface="맑은 고딕" pitchFamily="34" charset="-122"/>
                 <a:cs typeface="맑은 고딕" pitchFamily="34" charset="-120"/>
               </a:rPr>
-              <a:t>✅ 6A 86 SKU  /  ✅ Cleartype 59 SKU  /  ✅ Produktepr 192 SKU (판매 수집됨)</a:t>
+              <a:t>✅ 6A 85 SKU  /  ✅ Cleartype 59 SKU  /  ✅ Produktepr 198 SKU (판매 수집됨)</a:t>
             </a:r>
             <a:endParaRPr lang="en-US" sz="1100" dirty="0"/>
           </a:p>
@@ -19230,7 +19230,7 @@
                 <a:ea typeface="맑은 고딕" pitchFamily="34" charset="-122"/>
                 <a:cs typeface="맑은 고딕" pitchFamily="34" charset="-120"/>
               </a:rPr>
-              <a:t>✅ 3개 브랜드 모두 정상 추출  ·  24h 출고 기준 (2026-05-25 08:00 → 2026-05-26 08:00) · 신규 SKU 11건은 결제완료 기준</a:t>
+              <a:t>✅ 3개 브랜드 모두 정상 추출  ·  24h 출고 기준 (2026-05-26 08:00 → 2026-05-27 08:00) · 신규 SKU 18건은 결제완료 기준</a:t>
             </a:r>
             <a:endParaRPr lang="en-US" sz="1000" dirty="0"/>
           </a:p>
@@ -19269,7 +19269,7 @@
                 <a:ea typeface="맑은 고딕" pitchFamily="34" charset="-122"/>
                 <a:cs typeface="맑은 고딕" pitchFamily="34" charset="-120"/>
               </a:rPr>
-              <a:t>베스트 상품 리포트  ·  생성 2026-05-26 08:00</a:t>
+              <a:t>베스트 상품 리포트  ·  생성 2026-05-27 08:00</a:t>
             </a:r>
             <a:endParaRPr lang="en-US" sz="900" dirty="0"/>
           </a:p>

</xml_diff>

<commit_message>
chore: 매출 PPT 업로드 (best-sellers-2026-05-28.pptx) [auto]
</commit_message>
<xml_diff>
--- a/data/sales-report.pptx
+++ b/data/sales-report.pptx
@@ -1648,7 +1648,7 @@
                 <a:ea typeface="맑은 고딕" pitchFamily="34" charset="-122"/>
                 <a:cs typeface="맑은 고딕" pitchFamily="34" charset="-120"/>
               </a:rPr>
-              <a:t>2026년 05월 27일 (수)  ·  24h 출고 기준</a:t>
+              <a:t>2026년 05월 28일 (목)  ·  24h 출고 기준</a:t>
             </a:r>
             <a:endParaRPr lang="en-US" sz="2200" dirty="0"/>
           </a:p>
@@ -1726,7 +1726,7 @@
                 <a:ea typeface="맑은 고딕" pitchFamily="34" charset="-122"/>
                 <a:cs typeface="맑은 고딕" pitchFamily="34" charset="-120"/>
               </a:rPr>
-              <a:t>05.27</a:t>
+              <a:t>05.28</a:t>
             </a:r>
             <a:endParaRPr lang="en-US" sz="7200" dirty="0"/>
           </a:p>
@@ -1765,7 +1765,7 @@
                 <a:ea typeface="맑은 고딕" pitchFamily="34" charset="-122"/>
                 <a:cs typeface="맑은 고딕" pitchFamily="34" charset="-120"/>
               </a:rPr>
-              <a:t>수요일</a:t>
+              <a:t>목요일</a:t>
             </a:r>
             <a:endParaRPr lang="en-US" sz="1400" dirty="0"/>
           </a:p>
@@ -1804,7 +1804,7 @@
                 <a:ea typeface="맑은 고딕" pitchFamily="34" charset="-122"/>
                 <a:cs typeface="맑은 고딕" pitchFamily="34" charset="-120"/>
               </a:rPr>
-              <a:t>생성 2026-05-27 08:00  ·  Google Sheet 자동 동기</a:t>
+              <a:t>생성 2026-05-28 08:00  ·  Google Sheet 자동 동기</a:t>
             </a:r>
             <a:endParaRPr lang="en-US" sz="1000" dirty="0"/>
           </a:p>
@@ -1978,7 +1978,7 @@
                 <a:ea typeface="맑은 고딕" pitchFamily="34" charset="-122"/>
                 <a:cs typeface="맑은 고딕" pitchFamily="34" charset="-120"/>
               </a:rPr>
-              <a:t>2026년 05월 27일 (수)</a:t>
+              <a:t>2026년 05월 28일 (목)</a:t>
             </a:r>
             <a:endParaRPr lang="en-US" sz="1200" dirty="0"/>
           </a:p>
@@ -2145,7 +2145,7 @@
                 <a:ea typeface="맑은 고딕" pitchFamily="34" charset="-122"/>
                 <a:cs typeface="맑은 고딕" pitchFamily="34" charset="-120"/>
               </a:rPr>
-              <a:t>1914 개</a:t>
+              <a:t>327 개</a:t>
             </a:r>
             <a:endParaRPr lang="en-US" sz="3600" dirty="0"/>
           </a:p>
@@ -2312,7 +2312,7 @@
                 <a:ea typeface="맑은 고딕" pitchFamily="34" charset="-122"/>
                 <a:cs typeface="맑은 고딕" pitchFamily="34" charset="-120"/>
               </a:rPr>
-              <a:t>71 건</a:t>
+              <a:t>75 건</a:t>
             </a:r>
             <a:endParaRPr lang="en-US" sz="3200" dirty="0"/>
           </a:p>
@@ -2685,7 +2685,7 @@
                 <a:ea typeface="맑은 고딕" pitchFamily="34" charset="-122"/>
                 <a:cs typeface="맑은 고딕" pitchFamily="34" charset="-120"/>
               </a:rPr>
-              <a:t>85 SKU  ·  판매 OK</a:t>
+              <a:t>86 SKU  ·  판매 OK</a:t>
             </a:r>
             <a:pPr indent="0" marL="0">
               <a:buNone/>
@@ -2969,7 +2969,7 @@
                 <a:ea typeface="맑은 고딕" pitchFamily="34" charset="-122"/>
                 <a:cs typeface="맑은 고딕" pitchFamily="34" charset="-120"/>
               </a:rPr>
-              <a:t>198 SKU  ·  판매 데이터 있음</a:t>
+              <a:t>200 SKU  ·  판매 데이터 있음</a:t>
             </a:r>
             <a:pPr indent="0" marL="0">
               <a:buNone/>
@@ -3482,7 +3482,7 @@
                           <a:ea typeface="맑은 고딕" pitchFamily="34" charset="-122"/>
                           <a:cs typeface="맑은 고딕" pitchFamily="34" charset="-120"/>
                         </a:rPr>
-                        <a:t>CT</a:t>
+                        <a:t>6A</a:t>
                       </a:r>
                       <a:endParaRPr lang="en-US" sz="1100" dirty="0">
                         <a:latin typeface="맑은 고딕" charset="0"/>
@@ -3547,7 +3547,7 @@
                           <a:ea typeface="맑은 고딕" pitchFamily="34" charset="-122"/>
                           <a:cs typeface="맑은 고딕" pitchFamily="34" charset="-120"/>
                         </a:rPr>
-                        <a:t>Necklace</a:t>
+                        <a:t>Ring</a:t>
                       </a:r>
                       <a:endParaRPr lang="en-US" sz="1000" dirty="0">
                         <a:latin typeface="맑은 고딕" charset="0"/>
@@ -3612,7 +3612,7 @@
                           <a:ea typeface="맑은 고딕" pitchFamily="34" charset="-122"/>
                           <a:cs typeface="맑은 고딕" pitchFamily="34" charset="-120"/>
                         </a:rPr>
-                        <a:t>CandyPOP Necklace (사이즈: 2size (47~52cm))</a:t>
+                        <a:t>[SILVER925] CH.alban Open Ring</a:t>
                       </a:r>
                       <a:endParaRPr lang="en-US" sz="1100" dirty="0">
                         <a:latin typeface="맑은 고딕" charset="0"/>
@@ -3677,7 +3677,7 @@
                           <a:ea typeface="맑은 고딕" pitchFamily="34" charset="-122"/>
                           <a:cs typeface="맑은 고딕" pitchFamily="34" charset="-120"/>
                         </a:rPr>
-                        <a:t>1565 개</a:t>
+                        <a:t>44 개</a:t>
                       </a:r>
                       <a:endParaRPr lang="en-US" sz="1400" dirty="0">
                         <a:latin typeface="맑은 고딕" charset="0"/>
@@ -4004,7 +4004,7 @@
                           <a:ea typeface="맑은 고딕" pitchFamily="34" charset="-122"/>
                           <a:cs typeface="맑은 고딕" pitchFamily="34" charset="-120"/>
                         </a:rPr>
-                        <a:t>46 개</a:t>
+                        <a:t>39 개</a:t>
                       </a:r>
                       <a:endParaRPr lang="en-US" sz="1400" dirty="0">
                         <a:latin typeface="맑은 고딕" charset="0"/>
@@ -4266,7 +4266,7 @@
                           <a:ea typeface="맑은 고딕" pitchFamily="34" charset="-122"/>
                           <a:cs typeface="맑은 고딕" pitchFamily="34" charset="-120"/>
                         </a:rPr>
-                        <a:t>[SILVER925] CH.alban Open Ring</a:t>
+                        <a:t>[SILVER925] Eramam Open Ring</a:t>
                       </a:r>
                       <a:endParaRPr lang="en-US" sz="1100" dirty="0">
                         <a:latin typeface="맑은 고딕" charset="0"/>
@@ -4331,7 +4331,7 @@
                           <a:ea typeface="맑은 고딕" pitchFamily="34" charset="-122"/>
                           <a:cs typeface="맑은 고딕" pitchFamily="34" charset="-120"/>
                         </a:rPr>
-                        <a:t>41 개</a:t>
+                        <a:t>23 개</a:t>
                       </a:r>
                       <a:endParaRPr lang="en-US" sz="1400" dirty="0">
                         <a:latin typeface="맑은 고딕" charset="0"/>
@@ -4593,7 +4593,7 @@
                           <a:ea typeface="맑은 고딕" pitchFamily="34" charset="-122"/>
                           <a:cs typeface="맑은 고딕" pitchFamily="34" charset="-120"/>
                         </a:rPr>
-                        <a:t>CandyPOP Necklace (사이즈: 1size (37~43cm))</a:t>
+                        <a:t>ThreadDuo Necklace</a:t>
                       </a:r>
                       <a:endParaRPr lang="en-US" sz="1100" dirty="0">
                         <a:latin typeface="맑은 고딕" charset="0"/>
@@ -4658,7 +4658,7 @@
                           <a:ea typeface="맑은 고딕" pitchFamily="34" charset="-122"/>
                           <a:cs typeface="맑은 고딕" pitchFamily="34" charset="-120"/>
                         </a:rPr>
-                        <a:t>29 개</a:t>
+                        <a:t>18 개</a:t>
                       </a:r>
                       <a:endParaRPr lang="en-US" sz="1200" dirty="0">
                         <a:latin typeface="맑은 고딕" charset="0"/>
@@ -4790,7 +4790,7 @@
                           <a:ea typeface="맑은 고딕" pitchFamily="34" charset="-122"/>
                           <a:cs typeface="맑은 고딕" pitchFamily="34" charset="-120"/>
                         </a:rPr>
-                        <a:t>CT</a:t>
+                        <a:t>6A</a:t>
                       </a:r>
                       <a:endParaRPr lang="en-US" sz="1100" dirty="0">
                         <a:latin typeface="맑은 고딕" charset="0"/>
@@ -4855,7 +4855,7 @@
                           <a:ea typeface="맑은 고딕" pitchFamily="34" charset="-122"/>
                           <a:cs typeface="맑은 고딕" pitchFamily="34" charset="-120"/>
                         </a:rPr>
-                        <a:t>Necklace</a:t>
+                        <a:t>Ring</a:t>
                       </a:r>
                       <a:endParaRPr lang="en-US" sz="1000" dirty="0">
                         <a:latin typeface="맑은 고딕" charset="0"/>
@@ -4920,7 +4920,7 @@
                           <a:ea typeface="맑은 고딕" pitchFamily="34" charset="-122"/>
                           <a:cs typeface="맑은 고딕" pitchFamily="34" charset="-120"/>
                         </a:rPr>
-                        <a:t>ThreadDuo Necklace</a:t>
+                        <a:t>[SILVER925] Cstic Open Ring</a:t>
                       </a:r>
                       <a:endParaRPr lang="en-US" sz="1100" dirty="0">
                         <a:latin typeface="맑은 고딕" charset="0"/>
@@ -4985,7 +4985,7 @@
                           <a:ea typeface="맑은 고딕" pitchFamily="34" charset="-122"/>
                           <a:cs typeface="맑은 고딕" pitchFamily="34" charset="-120"/>
                         </a:rPr>
-                        <a:t>19 개</a:t>
+                        <a:t>14 개</a:t>
                       </a:r>
                       <a:endParaRPr lang="en-US" sz="1200" dirty="0">
                         <a:latin typeface="맑은 고딕" charset="0"/>
@@ -5071,7 +5071,7 @@
                 <a:ea typeface="맑은 고딕" pitchFamily="34" charset="-122"/>
                 <a:cs typeface="맑은 고딕" pitchFamily="34" charset="-120"/>
               </a:rPr>
-              <a:t>베스트 상품 리포트  ·  생성 2026-05-27 08:00</a:t>
+              <a:t>베스트 상품 리포트  ·  생성 2026-05-28 08:00</a:t>
             </a:r>
             <a:endParaRPr lang="en-US" sz="900" dirty="0"/>
           </a:p>
@@ -5284,7 +5284,7 @@
                 <a:ea typeface="맑은 고딕" pitchFamily="34" charset="-122"/>
                 <a:cs typeface="맑은 고딕" pitchFamily="34" charset="-120"/>
               </a:rPr>
-              <a:t>2026년 05월 27일 (수)</a:t>
+              <a:t>2026년 05월 28일 (목)</a:t>
             </a:r>
             <a:endParaRPr lang="en-US" sz="1200" dirty="0"/>
           </a:p>
@@ -5451,7 +5451,7 @@
                 <a:ea typeface="맑은 고딕" pitchFamily="34" charset="-122"/>
                 <a:cs typeface="맑은 고딕" pitchFamily="34" charset="-120"/>
               </a:rPr>
-              <a:t>256 개</a:t>
+              <a:t>267 개</a:t>
             </a:r>
             <a:endParaRPr lang="en-US" sz="3600" dirty="0"/>
           </a:p>
@@ -5579,7 +5579,7 @@
                 <a:ea typeface="맑은 고딕" pitchFamily="34" charset="-122"/>
                 <a:cs typeface="맑은 고딕" pitchFamily="34" charset="-120"/>
               </a:rPr>
-              <a:t>[SILVER925] Guyeong Open Ring v3.0 (silver)</a:t>
+              <a:t>[SILVER925] CH.alban Open Ring</a:t>
             </a:r>
             <a:endParaRPr lang="en-US" sz="1800" dirty="0"/>
           </a:p>
@@ -5657,7 +5657,7 @@
                 <a:ea typeface="맑은 고딕" pitchFamily="34" charset="-122"/>
                 <a:cs typeface="맑은 고딕" pitchFamily="34" charset="-120"/>
               </a:rPr>
-              <a:t>46</a:t>
+              <a:t>44</a:t>
             </a:r>
             <a:endParaRPr lang="en-US" sz="4400" dirty="0"/>
           </a:p>
@@ -6191,7 +6191,7 @@
                           <a:ea typeface="맑은 고딕" pitchFamily="34" charset="-122"/>
                           <a:cs typeface="맑은 고딕" pitchFamily="34" charset="-120"/>
                         </a:rPr>
-                        <a:t>[SILVER925] Guyeong Open Ring v3.0 (silver)</a:t>
+                        <a:t>[SILVER925] CH.alban Open Ring</a:t>
                       </a:r>
                       <a:endParaRPr lang="en-US" sz="1100" dirty="0">
                         <a:latin typeface="맑은 고딕" charset="0"/>
@@ -6256,7 +6256,7 @@
                           <a:ea typeface="맑은 고딕" pitchFamily="34" charset="-122"/>
                           <a:cs typeface="맑은 고딕" pitchFamily="34" charset="-120"/>
                         </a:rPr>
-                        <a:t>46 개</a:t>
+                        <a:t>44 개</a:t>
                       </a:r>
                       <a:endParaRPr lang="en-US" sz="1400" dirty="0">
                         <a:latin typeface="맑은 고딕" charset="0"/>
@@ -6453,7 +6453,7 @@
                           <a:ea typeface="맑은 고딕" pitchFamily="34" charset="-122"/>
                           <a:cs typeface="맑은 고딕" pitchFamily="34" charset="-120"/>
                         </a:rPr>
-                        <a:t>[SILVER925] CH.alban Open Ring</a:t>
+                        <a:t>[SILVER925] Guyeong Open Ring v3.0 (silver)</a:t>
                       </a:r>
                       <a:endParaRPr lang="en-US" sz="1100" dirty="0">
                         <a:latin typeface="맑은 고딕" charset="0"/>
@@ -6518,7 +6518,7 @@
                           <a:ea typeface="맑은 고딕" pitchFamily="34" charset="-122"/>
                           <a:cs typeface="맑은 고딕" pitchFamily="34" charset="-120"/>
                         </a:rPr>
-                        <a:t>41 개</a:t>
+                        <a:t>39 개</a:t>
                       </a:r>
                       <a:endParaRPr lang="en-US" sz="1200" dirty="0">
                         <a:latin typeface="맑은 고딕" charset="0"/>
@@ -6650,7 +6650,7 @@
                           <a:ea typeface="맑은 고딕" pitchFamily="34" charset="-122"/>
                           <a:cs typeface="맑은 고딕" pitchFamily="34" charset="-120"/>
                         </a:rPr>
-                        <a:t>Necklace</a:t>
+                        <a:t>Ring</a:t>
                       </a:r>
                       <a:endParaRPr lang="en-US" sz="1000" dirty="0">
                         <a:latin typeface="맑은 고딕" charset="0"/>
@@ -6715,7 +6715,7 @@
                           <a:ea typeface="맑은 고딕" pitchFamily="34" charset="-122"/>
                           <a:cs typeface="맑은 고딕" pitchFamily="34" charset="-120"/>
                         </a:rPr>
-                        <a:t>YOKNIS 9921 Necklace</a:t>
+                        <a:t>[SILVER925] Eramam Open Ring</a:t>
                       </a:r>
                       <a:endParaRPr lang="en-US" sz="1100" dirty="0">
                         <a:latin typeface="맑은 고딕" charset="0"/>
@@ -6780,7 +6780,7 @@
                           <a:ea typeface="맑은 고딕" pitchFamily="34" charset="-122"/>
                           <a:cs typeface="맑은 고딕" pitchFamily="34" charset="-120"/>
                         </a:rPr>
-                        <a:t>14 개</a:t>
+                        <a:t>23 개</a:t>
                       </a:r>
                       <a:endParaRPr lang="en-US" sz="1200" dirty="0">
                         <a:latin typeface="맑은 고딕" charset="0"/>
@@ -7042,7 +7042,7 @@
                           <a:ea typeface="맑은 고딕" pitchFamily="34" charset="-122"/>
                           <a:cs typeface="맑은 고딕" pitchFamily="34" charset="-120"/>
                         </a:rPr>
-                        <a:t>11 개</a:t>
+                        <a:t>14 개</a:t>
                       </a:r>
                       <a:endParaRPr lang="en-US" sz="1200" dirty="0">
                         <a:latin typeface="맑은 고딕" charset="0"/>
@@ -7390,7 +7390,7 @@
                 <a:ea typeface="맑은 고딕" pitchFamily="34" charset="-122"/>
                 <a:cs typeface="맑은 고딕" pitchFamily="34" charset="-120"/>
               </a:rPr>
-              <a:t>리오더 필요  🔴 긴급 8건</a:t>
+              <a:t>리오더 필요  🔴 긴급 7건</a:t>
             </a:r>
             <a:pPr indent="0" marL="0">
               <a:buNone/>
@@ -7557,7 +7557,7 @@
                 <a:ea typeface="맑은 고딕" pitchFamily="34" charset="-122"/>
                 <a:cs typeface="맑은 고딕" pitchFamily="34" charset="-120"/>
               </a:rPr>
-              <a:t>[SILVER925] Vearl Open Ring</a:t>
+              <a:t>[SILVER925] Flowy Open Ring</a:t>
             </a:r>
             <a:endParaRPr lang="en-US" sz="1100" dirty="0"/>
           </a:p>
@@ -7596,7 +7596,7 @@
                 <a:ea typeface="맑은 고딕" pitchFamily="34" charset="-122"/>
                 <a:cs typeface="맑은 고딕" pitchFamily="34" charset="-120"/>
               </a:rPr>
-              <a:t>Ring  ·  재고 5개</a:t>
+              <a:t>Ring  ·  재고 3개</a:t>
             </a:r>
             <a:pPr indent="0" marL="0">
               <a:buNone/>
@@ -7763,212 +7763,6 @@
                 <a:ea typeface="맑은 고딕" pitchFamily="34" charset="-122"/>
                 <a:cs typeface="맑은 고딕" pitchFamily="34" charset="-120"/>
               </a:rPr>
-              <a:t>[SILVER925] Flowy Open Ring</a:t>
-            </a:r>
-            <a:endParaRPr lang="en-US" sz="1100" dirty="0"/>
-          </a:p>
-        </p:txBody>
-      </p:sp>
-      <p:sp>
-        <p:nvSpPr>
-          <p:cNvPr id="32" name="Text 29"/>
-          <p:cNvSpPr/>
-          <p:nvPr/>
-        </p:nvSpPr>
-        <p:spPr>
-          <a:xfrm>
-            <a:off x="8211312" y="4425696"/>
-            <a:ext cx="3291840" cy="256032"/>
-          </a:xfrm>
-          <a:prstGeom prst="rect">
-            <a:avLst/>
-          </a:prstGeom>
-          <a:noFill/>
-          <a:ln/>
-        </p:spPr>
-        <p:txBody>
-          <a:bodyPr wrap="square" lIns="0" tIns="0" rIns="0" bIns="0" rtlCol="0" anchor="ctr"/>
-          <a:lstStyle/>
-          <a:p>
-            <a:pPr indent="0" marL="0">
-              <a:buNone/>
-            </a:pPr>
-            <a:r>
-              <a:rPr lang="en-US" sz="1000" dirty="0">
-                <a:solidFill>
-                  <a:srgbClr val="6B7280"/>
-                </a:solidFill>
-                <a:latin typeface="맑은 고딕" pitchFamily="34" charset="0"/>
-                <a:ea typeface="맑은 고딕" pitchFamily="34" charset="-122"/>
-                <a:cs typeface="맑은 고딕" pitchFamily="34" charset="-120"/>
-              </a:rPr>
-              <a:t>Ring  ·  재고 4개</a:t>
-            </a:r>
-            <a:pPr indent="0" marL="0">
-              <a:buNone/>
-            </a:pPr>
-            <a:r>
-              <a:rPr lang="en-US" sz="1000" b="1" dirty="0">
-                <a:solidFill>
-                  <a:srgbClr val="D72638"/>
-                </a:solidFill>
-                <a:latin typeface="맑은 고딕" pitchFamily="34" charset="0"/>
-                <a:ea typeface="맑은 고딕" pitchFamily="34" charset="-122"/>
-                <a:cs typeface="맑은 고딕" pitchFamily="34" charset="-120"/>
-              </a:rPr>
-              <a:t/>
-            </a:r>
-            <a:endParaRPr lang="en-US" sz="1000" dirty="0"/>
-          </a:p>
-        </p:txBody>
-      </p:sp>
-      <p:sp>
-        <p:nvSpPr>
-          <p:cNvPr id="33" name="Shape 30"/>
-          <p:cNvSpPr/>
-          <p:nvPr/>
-        </p:nvSpPr>
-        <p:spPr>
-          <a:xfrm>
-            <a:off x="7406640" y="4809744"/>
-            <a:ext cx="4206240" cy="640080"/>
-          </a:xfrm>
-          <a:prstGeom prst="rect">
-            <a:avLst/>
-          </a:prstGeom>
-          <a:solidFill>
-            <a:srgbClr val="FFF5F5"/>
-          </a:solidFill>
-          <a:ln w="6350">
-            <a:solidFill>
-              <a:srgbClr val="E5E7EB"/>
-            </a:solidFill>
-            <a:prstDash val="solid"/>
-          </a:ln>
-        </p:spPr>
-      </p:sp>
-      <p:sp>
-        <p:nvSpPr>
-          <p:cNvPr id="34" name="Shape 31"/>
-          <p:cNvSpPr/>
-          <p:nvPr/>
-        </p:nvSpPr>
-        <p:spPr>
-          <a:xfrm>
-            <a:off x="7406640" y="4809744"/>
-            <a:ext cx="109728" cy="640080"/>
-          </a:xfrm>
-          <a:prstGeom prst="rect">
-            <a:avLst/>
-          </a:prstGeom>
-          <a:solidFill>
-            <a:srgbClr val="D72638"/>
-          </a:solidFill>
-          <a:ln w="12700">
-            <a:solidFill>
-              <a:srgbClr val="D72638"/>
-            </a:solidFill>
-            <a:prstDash val="solid"/>
-          </a:ln>
-        </p:spPr>
-      </p:sp>
-      <p:sp>
-        <p:nvSpPr>
-          <p:cNvPr id="35" name="Shape 32"/>
-          <p:cNvSpPr/>
-          <p:nvPr/>
-        </p:nvSpPr>
-        <p:spPr>
-          <a:xfrm>
-            <a:off x="7571232" y="4901184"/>
-            <a:ext cx="548640" cy="256032"/>
-          </a:xfrm>
-          <a:prstGeom prst="rect">
-            <a:avLst/>
-          </a:prstGeom>
-          <a:solidFill>
-            <a:srgbClr val="D72638"/>
-          </a:solidFill>
-          <a:ln w="12700">
-            <a:solidFill>
-              <a:srgbClr val="D72638"/>
-            </a:solidFill>
-            <a:prstDash val="solid"/>
-          </a:ln>
-        </p:spPr>
-      </p:sp>
-      <p:sp>
-        <p:nvSpPr>
-          <p:cNvPr id="36" name="Text 33"/>
-          <p:cNvSpPr/>
-          <p:nvPr/>
-        </p:nvSpPr>
-        <p:spPr>
-          <a:xfrm>
-            <a:off x="7571232" y="4901184"/>
-            <a:ext cx="548640" cy="256032"/>
-          </a:xfrm>
-          <a:prstGeom prst="rect">
-            <a:avLst/>
-          </a:prstGeom>
-          <a:noFill/>
-          <a:ln/>
-        </p:spPr>
-        <p:txBody>
-          <a:bodyPr wrap="square" lIns="0" tIns="0" rIns="0" bIns="0" rtlCol="0" anchor="ctr"/>
-          <a:lstStyle/>
-          <a:p>
-            <a:pPr algn="ctr" indent="0" marL="0">
-              <a:buNone/>
-            </a:pPr>
-            <a:r>
-              <a:rPr lang="en-US" sz="900" b="1" dirty="0">
-                <a:solidFill>
-                  <a:srgbClr val="FFFFFF"/>
-                </a:solidFill>
-                <a:latin typeface="맑은 고딕" pitchFamily="34" charset="0"/>
-                <a:ea typeface="맑은 고딕" pitchFamily="34" charset="-122"/>
-                <a:cs typeface="맑은 고딕" pitchFamily="34" charset="-120"/>
-              </a:rPr>
-              <a:t>긴급</a:t>
-            </a:r>
-            <a:endParaRPr lang="en-US" sz="900" dirty="0"/>
-          </a:p>
-        </p:txBody>
-      </p:sp>
-      <p:sp>
-        <p:nvSpPr>
-          <p:cNvPr id="37" name="Text 34"/>
-          <p:cNvSpPr/>
-          <p:nvPr/>
-        </p:nvSpPr>
-        <p:spPr>
-          <a:xfrm>
-            <a:off x="8211312" y="4864608"/>
-            <a:ext cx="3291840" cy="274320"/>
-          </a:xfrm>
-          <a:prstGeom prst="rect">
-            <a:avLst/>
-          </a:prstGeom>
-          <a:noFill/>
-          <a:ln/>
-        </p:spPr>
-        <p:txBody>
-          <a:bodyPr wrap="square" lIns="0" tIns="0" rIns="0" bIns="0" rtlCol="0" anchor="ctr"/>
-          <a:lstStyle/>
-          <a:p>
-            <a:pPr indent="0" marL="0">
-              <a:buNone/>
-            </a:pPr>
-            <a:r>
-              <a:rPr lang="en-US" sz="1100" b="1" dirty="0">
-                <a:solidFill>
-                  <a:srgbClr val="0B1220"/>
-                </a:solidFill>
-                <a:latin typeface="맑은 고딕" pitchFamily="34" charset="0"/>
-                <a:ea typeface="맑은 고딕" pitchFamily="34" charset="-122"/>
-                <a:cs typeface="맑은 고딕" pitchFamily="34" charset="-120"/>
-              </a:rPr>
               <a:t>8-Ball Smart Tok</a:t>
             </a:r>
             <a:endParaRPr lang="en-US" sz="1100" dirty="0"/>
@@ -7977,13 +7771,13 @@
       </p:sp>
       <p:sp>
         <p:nvSpPr>
-          <p:cNvPr id="38" name="Text 35"/>
-          <p:cNvSpPr/>
-          <p:nvPr/>
-        </p:nvSpPr>
-        <p:spPr>
-          <a:xfrm>
-            <a:off x="8211312" y="5138928"/>
+          <p:cNvPr id="32" name="Text 29"/>
+          <p:cNvSpPr/>
+          <p:nvPr/>
+        </p:nvSpPr>
+        <p:spPr>
+          <a:xfrm>
+            <a:off x="8211312" y="4425696"/>
             <a:ext cx="3291840" cy="256032"/>
           </a:xfrm>
           <a:prstGeom prst="rect">
@@ -8030,13 +7824,13 @@
       </p:sp>
       <p:sp>
         <p:nvSpPr>
-          <p:cNvPr id="39" name="Shape 36"/>
-          <p:cNvSpPr/>
-          <p:nvPr/>
-        </p:nvSpPr>
-        <p:spPr>
-          <a:xfrm>
-            <a:off x="7406640" y="5522976"/>
+          <p:cNvPr id="33" name="Shape 30"/>
+          <p:cNvSpPr/>
+          <p:nvPr/>
+        </p:nvSpPr>
+        <p:spPr>
+          <a:xfrm>
+            <a:off x="7406640" y="4809744"/>
             <a:ext cx="4206240" cy="640080"/>
           </a:xfrm>
           <a:prstGeom prst="rect">
@@ -8055,13 +7849,13 @@
       </p:sp>
       <p:sp>
         <p:nvSpPr>
-          <p:cNvPr id="40" name="Shape 37"/>
-          <p:cNvSpPr/>
-          <p:nvPr/>
-        </p:nvSpPr>
-        <p:spPr>
-          <a:xfrm>
-            <a:off x="7406640" y="5522976"/>
+          <p:cNvPr id="34" name="Shape 31"/>
+          <p:cNvSpPr/>
+          <p:nvPr/>
+        </p:nvSpPr>
+        <p:spPr>
+          <a:xfrm>
+            <a:off x="7406640" y="4809744"/>
             <a:ext cx="109728" cy="640080"/>
           </a:xfrm>
           <a:prstGeom prst="rect">
@@ -8080,13 +7874,13 @@
       </p:sp>
       <p:sp>
         <p:nvSpPr>
-          <p:cNvPr id="41" name="Shape 38"/>
-          <p:cNvSpPr/>
-          <p:nvPr/>
-        </p:nvSpPr>
-        <p:spPr>
-          <a:xfrm>
-            <a:off x="7571232" y="5614416"/>
+          <p:cNvPr id="35" name="Shape 32"/>
+          <p:cNvSpPr/>
+          <p:nvPr/>
+        </p:nvSpPr>
+        <p:spPr>
+          <a:xfrm>
+            <a:off x="7571232" y="4901184"/>
             <a:ext cx="548640" cy="256032"/>
           </a:xfrm>
           <a:prstGeom prst="rect">
@@ -8105,13 +7899,13 @@
       </p:sp>
       <p:sp>
         <p:nvSpPr>
-          <p:cNvPr id="42" name="Text 39"/>
-          <p:cNvSpPr/>
-          <p:nvPr/>
-        </p:nvSpPr>
-        <p:spPr>
-          <a:xfrm>
-            <a:off x="7571232" y="5614416"/>
+          <p:cNvPr id="36" name="Text 33"/>
+          <p:cNvSpPr/>
+          <p:nvPr/>
+        </p:nvSpPr>
+        <p:spPr>
+          <a:xfrm>
+            <a:off x="7571232" y="4901184"/>
             <a:ext cx="548640" cy="256032"/>
           </a:xfrm>
           <a:prstGeom prst="rect">
@@ -8144,13 +7938,13 @@
       </p:sp>
       <p:sp>
         <p:nvSpPr>
-          <p:cNvPr id="43" name="Text 40"/>
-          <p:cNvSpPr/>
-          <p:nvPr/>
-        </p:nvSpPr>
-        <p:spPr>
-          <a:xfrm>
-            <a:off x="8211312" y="5577840"/>
+          <p:cNvPr id="37" name="Text 34"/>
+          <p:cNvSpPr/>
+          <p:nvPr/>
+        </p:nvSpPr>
+        <p:spPr>
+          <a:xfrm>
+            <a:off x="8211312" y="4864608"/>
             <a:ext cx="3291840" cy="274320"/>
           </a:xfrm>
           <a:prstGeom prst="rect">
@@ -8183,13 +7977,13 @@
       </p:sp>
       <p:sp>
         <p:nvSpPr>
-          <p:cNvPr id="44" name="Text 41"/>
-          <p:cNvSpPr/>
-          <p:nvPr/>
-        </p:nvSpPr>
-        <p:spPr>
-          <a:xfrm>
-            <a:off x="8211312" y="5852160"/>
+          <p:cNvPr id="38" name="Text 35"/>
+          <p:cNvSpPr/>
+          <p:nvPr/>
+        </p:nvSpPr>
+        <p:spPr>
+          <a:xfrm>
+            <a:off x="8211312" y="5138928"/>
             <a:ext cx="3291840" cy="256032"/>
           </a:xfrm>
           <a:prstGeom prst="rect">
@@ -8236,6 +8030,212 @@
       </p:sp>
       <p:sp>
         <p:nvSpPr>
+          <p:cNvPr id="39" name="Shape 36"/>
+          <p:cNvSpPr/>
+          <p:nvPr/>
+        </p:nvSpPr>
+        <p:spPr>
+          <a:xfrm>
+            <a:off x="7406640" y="5522976"/>
+            <a:ext cx="4206240" cy="640080"/>
+          </a:xfrm>
+          <a:prstGeom prst="rect">
+            <a:avLst/>
+          </a:prstGeom>
+          <a:solidFill>
+            <a:srgbClr val="FFF5F5"/>
+          </a:solidFill>
+          <a:ln w="6350">
+            <a:solidFill>
+              <a:srgbClr val="E5E7EB"/>
+            </a:solidFill>
+            <a:prstDash val="solid"/>
+          </a:ln>
+        </p:spPr>
+      </p:sp>
+      <p:sp>
+        <p:nvSpPr>
+          <p:cNvPr id="40" name="Shape 37"/>
+          <p:cNvSpPr/>
+          <p:nvPr/>
+        </p:nvSpPr>
+        <p:spPr>
+          <a:xfrm>
+            <a:off x="7406640" y="5522976"/>
+            <a:ext cx="109728" cy="640080"/>
+          </a:xfrm>
+          <a:prstGeom prst="rect">
+            <a:avLst/>
+          </a:prstGeom>
+          <a:solidFill>
+            <a:srgbClr val="D72638"/>
+          </a:solidFill>
+          <a:ln w="12700">
+            <a:solidFill>
+              <a:srgbClr val="D72638"/>
+            </a:solidFill>
+            <a:prstDash val="solid"/>
+          </a:ln>
+        </p:spPr>
+      </p:sp>
+      <p:sp>
+        <p:nvSpPr>
+          <p:cNvPr id="41" name="Shape 38"/>
+          <p:cNvSpPr/>
+          <p:nvPr/>
+        </p:nvSpPr>
+        <p:spPr>
+          <a:xfrm>
+            <a:off x="7571232" y="5614416"/>
+            <a:ext cx="548640" cy="256032"/>
+          </a:xfrm>
+          <a:prstGeom prst="rect">
+            <a:avLst/>
+          </a:prstGeom>
+          <a:solidFill>
+            <a:srgbClr val="D72638"/>
+          </a:solidFill>
+          <a:ln w="12700">
+            <a:solidFill>
+              <a:srgbClr val="D72638"/>
+            </a:solidFill>
+            <a:prstDash val="solid"/>
+          </a:ln>
+        </p:spPr>
+      </p:sp>
+      <p:sp>
+        <p:nvSpPr>
+          <p:cNvPr id="42" name="Text 39"/>
+          <p:cNvSpPr/>
+          <p:nvPr/>
+        </p:nvSpPr>
+        <p:spPr>
+          <a:xfrm>
+            <a:off x="7571232" y="5614416"/>
+            <a:ext cx="548640" cy="256032"/>
+          </a:xfrm>
+          <a:prstGeom prst="rect">
+            <a:avLst/>
+          </a:prstGeom>
+          <a:noFill/>
+          <a:ln/>
+        </p:spPr>
+        <p:txBody>
+          <a:bodyPr wrap="square" lIns="0" tIns="0" rIns="0" bIns="0" rtlCol="0" anchor="ctr"/>
+          <a:lstStyle/>
+          <a:p>
+            <a:pPr algn="ctr" indent="0" marL="0">
+              <a:buNone/>
+            </a:pPr>
+            <a:r>
+              <a:rPr lang="en-US" sz="900" b="1" dirty="0">
+                <a:solidFill>
+                  <a:srgbClr val="FFFFFF"/>
+                </a:solidFill>
+                <a:latin typeface="맑은 고딕" pitchFamily="34" charset="0"/>
+                <a:ea typeface="맑은 고딕" pitchFamily="34" charset="-122"/>
+                <a:cs typeface="맑은 고딕" pitchFamily="34" charset="-120"/>
+              </a:rPr>
+              <a:t>긴급</a:t>
+            </a:r>
+            <a:endParaRPr lang="en-US" sz="900" dirty="0"/>
+          </a:p>
+        </p:txBody>
+      </p:sp>
+      <p:sp>
+        <p:nvSpPr>
+          <p:cNvPr id="43" name="Text 40"/>
+          <p:cNvSpPr/>
+          <p:nvPr/>
+        </p:nvSpPr>
+        <p:spPr>
+          <a:xfrm>
+            <a:off x="8211312" y="5577840"/>
+            <a:ext cx="3291840" cy="274320"/>
+          </a:xfrm>
+          <a:prstGeom prst="rect">
+            <a:avLst/>
+          </a:prstGeom>
+          <a:noFill/>
+          <a:ln/>
+        </p:spPr>
+        <p:txBody>
+          <a:bodyPr wrap="square" lIns="0" tIns="0" rIns="0" bIns="0" rtlCol="0" anchor="ctr"/>
+          <a:lstStyle/>
+          <a:p>
+            <a:pPr indent="0" marL="0">
+              <a:buNone/>
+            </a:pPr>
+            <a:r>
+              <a:rPr lang="en-US" sz="1100" b="1" dirty="0">
+                <a:solidFill>
+                  <a:srgbClr val="0B1220"/>
+                </a:solidFill>
+                <a:latin typeface="맑은 고딕" pitchFamily="34" charset="0"/>
+                <a:ea typeface="맑은 고딕" pitchFamily="34" charset="-122"/>
+                <a:cs typeface="맑은 고딕" pitchFamily="34" charset="-120"/>
+              </a:rPr>
+              <a:t>Two-ball Bangle</a:t>
+            </a:r>
+            <a:endParaRPr lang="en-US" sz="1100" dirty="0"/>
+          </a:p>
+        </p:txBody>
+      </p:sp>
+      <p:sp>
+        <p:nvSpPr>
+          <p:cNvPr id="44" name="Text 41"/>
+          <p:cNvSpPr/>
+          <p:nvPr/>
+        </p:nvSpPr>
+        <p:spPr>
+          <a:xfrm>
+            <a:off x="8211312" y="5852160"/>
+            <a:ext cx="3291840" cy="256032"/>
+          </a:xfrm>
+          <a:prstGeom prst="rect">
+            <a:avLst/>
+          </a:prstGeom>
+          <a:noFill/>
+          <a:ln/>
+        </p:spPr>
+        <p:txBody>
+          <a:bodyPr wrap="square" lIns="0" tIns="0" rIns="0" bIns="0" rtlCol="0" anchor="ctr"/>
+          <a:lstStyle/>
+          <a:p>
+            <a:pPr indent="0" marL="0">
+              <a:buNone/>
+            </a:pPr>
+            <a:r>
+              <a:rPr lang="en-US" sz="1000" dirty="0">
+                <a:solidFill>
+                  <a:srgbClr val="6B7280"/>
+                </a:solidFill>
+                <a:latin typeface="맑은 고딕" pitchFamily="34" charset="0"/>
+                <a:ea typeface="맑은 고딕" pitchFamily="34" charset="-122"/>
+                <a:cs typeface="맑은 고딕" pitchFamily="34" charset="-120"/>
+              </a:rPr>
+              <a:t>Bracelet  ·  재고 0개</a:t>
+            </a:r>
+            <a:pPr indent="0" marL="0">
+              <a:buNone/>
+            </a:pPr>
+            <a:r>
+              <a:rPr lang="en-US" sz="1000" b="1" dirty="0">
+                <a:solidFill>
+                  <a:srgbClr val="D72638"/>
+                </a:solidFill>
+                <a:latin typeface="맑은 고딕" pitchFamily="34" charset="0"/>
+                <a:ea typeface="맑은 고딕" pitchFamily="34" charset="-122"/>
+                <a:cs typeface="맑은 고딕" pitchFamily="34" charset="-120"/>
+              </a:rPr>
+              <a:t/>
+            </a:r>
+            <a:endParaRPr lang="en-US" sz="1000" dirty="0"/>
+          </a:p>
+        </p:txBody>
+      </p:sp>
+      <p:sp>
+        <p:nvSpPr>
           <p:cNvPr id="45" name="Text 42"/>
           <p:cNvSpPr/>
           <p:nvPr/>
@@ -8267,7 +8267,7 @@
                 <a:ea typeface="맑은 고딕" pitchFamily="34" charset="-122"/>
                 <a:cs typeface="맑은 고딕" pitchFamily="34" charset="-120"/>
               </a:rPr>
-              <a:t>베스트 상품 리포트  ·  생성 2026-05-27 08:00</a:t>
+              <a:t>베스트 상품 리포트  ·  생성 2026-05-28 08:00</a:t>
             </a:r>
             <a:endParaRPr lang="en-US" sz="900" dirty="0"/>
           </a:p>
@@ -8480,7 +8480,7 @@
                 <a:ea typeface="맑은 고딕" pitchFamily="34" charset="-122"/>
                 <a:cs typeface="맑은 고딕" pitchFamily="34" charset="-120"/>
               </a:rPr>
-              <a:t>2026년 05월 27일 (수)</a:t>
+              <a:t>2026년 05월 28일 (목)</a:t>
             </a:r>
             <a:endParaRPr lang="en-US" sz="1200" dirty="0"/>
           </a:p>
@@ -8647,7 +8647,7 @@
                 <a:ea typeface="맑은 고딕" pitchFamily="34" charset="-122"/>
                 <a:cs typeface="맑은 고딕" pitchFamily="34" charset="-120"/>
               </a:rPr>
-              <a:t>1658 개</a:t>
+              <a:t>60 개</a:t>
             </a:r>
             <a:endParaRPr lang="en-US" sz="3600" dirty="0"/>
           </a:p>
@@ -8775,7 +8775,7 @@
                 <a:ea typeface="맑은 고딕" pitchFamily="34" charset="-122"/>
                 <a:cs typeface="맑은 고딕" pitchFamily="34" charset="-120"/>
               </a:rPr>
-              <a:t>CandyPOP Necklace (사이즈: 2size (47~52cm))</a:t>
+              <a:t>ThreadDuo Necklace</a:t>
             </a:r>
             <a:endParaRPr lang="en-US" sz="1800" dirty="0"/>
           </a:p>
@@ -8853,7 +8853,7 @@
                 <a:ea typeface="맑은 고딕" pitchFamily="34" charset="-122"/>
                 <a:cs typeface="맑은 고딕" pitchFamily="34" charset="-120"/>
               </a:rPr>
-              <a:t>1565</a:t>
+              <a:t>18</a:t>
             </a:r>
             <a:endParaRPr lang="en-US" sz="4400" dirty="0"/>
           </a:p>
@@ -9387,7 +9387,7 @@
                           <a:ea typeface="맑은 고딕" pitchFamily="34" charset="-122"/>
                           <a:cs typeface="맑은 고딕" pitchFamily="34" charset="-120"/>
                         </a:rPr>
-                        <a:t>CandyPOP Necklace (사이즈: 2size (47~52cm))</a:t>
+                        <a:t>ThreadDuo Necklace</a:t>
                       </a:r>
                       <a:endParaRPr lang="en-US" sz="1100" dirty="0">
                         <a:latin typeface="맑은 고딕" charset="0"/>
@@ -9452,7 +9452,7 @@
                           <a:ea typeface="맑은 고딕" pitchFamily="34" charset="-122"/>
                           <a:cs typeface="맑은 고딕" pitchFamily="34" charset="-120"/>
                         </a:rPr>
-                        <a:t>1565 개</a:t>
+                        <a:t>18 개</a:t>
                       </a:r>
                       <a:endParaRPr lang="en-US" sz="1400" dirty="0">
                         <a:latin typeface="맑은 고딕" charset="0"/>
@@ -9714,7 +9714,7 @@
                           <a:ea typeface="맑은 고딕" pitchFamily="34" charset="-122"/>
                           <a:cs typeface="맑은 고딕" pitchFamily="34" charset="-120"/>
                         </a:rPr>
-                        <a:t>29 개</a:t>
+                        <a:t>11 개</a:t>
                       </a:r>
                       <a:endParaRPr lang="en-US" sz="1200" dirty="0">
                         <a:latin typeface="맑은 고딕" charset="0"/>
@@ -9846,7 +9846,7 @@
                           <a:ea typeface="맑은 고딕" pitchFamily="34" charset="-122"/>
                           <a:cs typeface="맑은 고딕" pitchFamily="34" charset="-120"/>
                         </a:rPr>
-                        <a:t>Necklace</a:t>
+                        <a:t>Ring</a:t>
                       </a:r>
                       <a:endParaRPr lang="en-US" sz="1000" dirty="0">
                         <a:latin typeface="맑은 고딕" charset="0"/>
@@ -9911,7 +9911,7 @@
                           <a:ea typeface="맑은 고딕" pitchFamily="34" charset="-122"/>
                           <a:cs typeface="맑은 고딕" pitchFamily="34" charset="-120"/>
                         </a:rPr>
-                        <a:t>ThreadDuo Necklace</a:t>
+                        <a:t>"Fenghuang" 925 Open Ring</a:t>
                       </a:r>
                       <a:endParaRPr lang="en-US" sz="1100" dirty="0">
                         <a:latin typeface="맑은 고딕" charset="0"/>
@@ -9976,7 +9976,7 @@
                           <a:ea typeface="맑은 고딕" pitchFamily="34" charset="-122"/>
                           <a:cs typeface="맑은 고딕" pitchFamily="34" charset="-120"/>
                         </a:rPr>
-                        <a:t>19 개</a:t>
+                        <a:t>8 개</a:t>
                       </a:r>
                       <a:endParaRPr lang="en-US" sz="1200" dirty="0">
                         <a:latin typeface="맑은 고딕" charset="0"/>
@@ -10062,7 +10062,7 @@
                 <a:ea typeface="맑은 고딕" pitchFamily="34" charset="-122"/>
                 <a:cs typeface="맑은 고딕" pitchFamily="34" charset="-120"/>
               </a:rPr>
-              <a:t>리오더 필요  🔴 긴급 22건</a:t>
+              <a:t>리오더 필요  🔴 긴급 21건</a:t>
             </a:r>
             <a:endParaRPr lang="en-US" sz="1500" dirty="0"/>
           </a:p>
@@ -10126,7 +10126,7 @@
                 <a:ea typeface="맑은 고딕" pitchFamily="34" charset="-122"/>
                 <a:cs typeface="맑은 고딕" pitchFamily="34" charset="-120"/>
               </a:rPr>
-              <a:t>🔴 긴급 22건  ·  상세는 시트 확인</a:t>
+              <a:t>🔴 긴급 21건  ·  상세는 시트 확인</a:t>
             </a:r>
             <a:endParaRPr lang="en-US" sz="1400" dirty="0"/>
           </a:p>
@@ -10165,7 +10165,7 @@
                 <a:ea typeface="맑은 고딕" pitchFamily="34" charset="-122"/>
                 <a:cs typeface="맑은 고딕" pitchFamily="34" charset="-120"/>
               </a:rPr>
-              <a:t>베스트 상품 리포트  ·  생성 2026-05-27 08:00</a:t>
+              <a:t>베스트 상품 리포트  ·  생성 2026-05-28 08:00</a:t>
             </a:r>
             <a:endParaRPr lang="en-US" sz="900" dirty="0"/>
           </a:p>
@@ -10378,7 +10378,7 @@
                 <a:ea typeface="맑은 고딕" pitchFamily="34" charset="-122"/>
                 <a:cs typeface="맑은 고딕" pitchFamily="34" charset="-120"/>
               </a:rPr>
-              <a:t>2026년 05월 27일 (수)</a:t>
+              <a:t>2026년 05월 28일 (목)</a:t>
             </a:r>
             <a:endParaRPr lang="en-US" sz="1200" dirty="0"/>
           </a:p>
@@ -10545,7 +10545,7 @@
                 <a:ea typeface="맑은 고딕" pitchFamily="34" charset="-122"/>
                 <a:cs typeface="맑은 고딕" pitchFamily="34" charset="-120"/>
               </a:rPr>
-              <a:t>198</a:t>
+              <a:t>200</a:t>
             </a:r>
             <a:endParaRPr lang="en-US" sz="3000" dirty="0"/>
           </a:p>
@@ -10673,7 +10673,7 @@
                 <a:ea typeface="맑은 고딕" pitchFamily="34" charset="-122"/>
                 <a:cs typeface="맑은 고딕" pitchFamily="34" charset="-120"/>
               </a:rPr>
-              <a:t>27</a:t>
+              <a:t>31</a:t>
             </a:r>
             <a:endParaRPr lang="en-US" sz="3000" dirty="0"/>
           </a:p>
@@ -10929,7 +10929,7 @@
                 <a:ea typeface="맑은 고딕" pitchFamily="34" charset="-122"/>
                 <a:cs typeface="맑은 고딕" pitchFamily="34" charset="-120"/>
               </a:rPr>
-              <a:t>30,872</a:t>
+              <a:t>30,125</a:t>
             </a:r>
             <a:endParaRPr lang="en-US" sz="3000" dirty="0"/>
           </a:p>
@@ -11489,7 +11489,7 @@
                           <a:ea typeface="맑은 고딕" pitchFamily="34" charset="-122"/>
                           <a:cs typeface="맑은 고딕" pitchFamily="34" charset="-120"/>
                         </a:rPr>
-                        <a:t>2,062</a:t>
+                        <a:t>2,056</a:t>
                       </a:r>
                       <a:endParaRPr lang="en-US" sz="1000" dirty="0">
                         <a:latin typeface="맑은 고딕" charset="0"/>
@@ -11751,7 +11751,7 @@
                           <a:ea typeface="맑은 고딕" pitchFamily="34" charset="-122"/>
                           <a:cs typeface="맑은 고딕" pitchFamily="34" charset="-120"/>
                         </a:rPr>
-                        <a:t>1,586</a:t>
+                        <a:t>1,576</a:t>
                       </a:r>
                       <a:endParaRPr lang="en-US" sz="1000" dirty="0">
                         <a:latin typeface="맑은 고딕" charset="0"/>
@@ -12013,7 +12013,7 @@
                           <a:ea typeface="맑은 고딕" pitchFamily="34" charset="-122"/>
                           <a:cs typeface="맑은 고딕" pitchFamily="34" charset="-120"/>
                         </a:rPr>
-                        <a:t>1,202</a:t>
+                        <a:t>1,140</a:t>
                       </a:r>
                       <a:endParaRPr lang="en-US" sz="1000" dirty="0">
                         <a:latin typeface="맑은 고딕" charset="0"/>
@@ -12275,7 +12275,7 @@
                           <a:ea typeface="맑은 고딕" pitchFamily="34" charset="-122"/>
                           <a:cs typeface="맑은 고딕" pitchFamily="34" charset="-120"/>
                         </a:rPr>
-                        <a:t>887</a:t>
+                        <a:t>880</a:t>
                       </a:r>
                       <a:endParaRPr lang="en-US" sz="1000" dirty="0">
                         <a:latin typeface="맑은 고딕" charset="0"/>
@@ -12407,7 +12407,7 @@
                           <a:ea typeface="맑은 고딕" pitchFamily="34" charset="-122"/>
                           <a:cs typeface="맑은 고딕" pitchFamily="34" charset="-120"/>
                         </a:rPr>
-                        <a:t>180° Fast Charging Cable (8color)</a:t>
+                        <a:t>Metallic Hair Pin</a:t>
                       </a:r>
                       <a:endParaRPr lang="en-US" sz="1000" dirty="0">
                         <a:latin typeface="맑은 고딕" charset="0"/>
@@ -12472,7 +12472,7 @@
                           <a:ea typeface="맑은 고딕" pitchFamily="34" charset="-122"/>
                           <a:cs typeface="맑은 고딕" pitchFamily="34" charset="-120"/>
                         </a:rPr>
-                        <a:t>컬러: 퍼플 / 기종 옵션: C type -&gt; C type</a:t>
+                        <a:t>옵션: 하트</a:t>
                       </a:r>
                       <a:endParaRPr lang="en-US" sz="900" dirty="0">
                         <a:latin typeface="맑은 고딕" charset="0"/>
@@ -12537,7 +12537,7 @@
                           <a:ea typeface="맑은 고딕" pitchFamily="34" charset="-122"/>
                           <a:cs typeface="맑은 고딕" pitchFamily="34" charset="-120"/>
                         </a:rPr>
-                        <a:t>819</a:t>
+                        <a:t>744</a:t>
                       </a:r>
                       <a:endParaRPr lang="en-US" sz="1000" dirty="0">
                         <a:latin typeface="맑은 고딕" charset="0"/>
@@ -12623,7 +12623,7 @@
                 <a:ea typeface="맑은 고딕" pitchFamily="34" charset="-122"/>
                 <a:cs typeface="맑은 고딕" pitchFamily="34" charset="-120"/>
               </a:rPr>
-              <a:t>재고 점검  🔴 품절 27건</a:t>
+              <a:t>재고 점검  🔴 품절 31건</a:t>
             </a:r>
             <a:pPr indent="0" marL="0">
               <a:buNone/>
@@ -12790,6 +12790,666 @@
                 <a:ea typeface="맑은 고딕" pitchFamily="34" charset="-122"/>
                 <a:cs typeface="맑은 고딕" pitchFamily="34" charset="-120"/>
               </a:rPr>
+              <a:t>Flower Keychain (6color)</a:t>
+            </a:r>
+            <a:endParaRPr lang="en-US" sz="1000" dirty="0"/>
+          </a:p>
+        </p:txBody>
+      </p:sp>
+      <p:sp>
+        <p:nvSpPr>
+          <p:cNvPr id="31" name="Text 28"/>
+          <p:cNvSpPr/>
+          <p:nvPr/>
+        </p:nvSpPr>
+        <p:spPr>
+          <a:xfrm>
+            <a:off x="8211312" y="3712464"/>
+            <a:ext cx="3291840" cy="256032"/>
+          </a:xfrm>
+          <a:prstGeom prst="rect">
+            <a:avLst/>
+          </a:prstGeom>
+          <a:noFill/>
+          <a:ln/>
+        </p:spPr>
+        <p:txBody>
+          <a:bodyPr wrap="square" lIns="0" tIns="0" rIns="0" bIns="0" rtlCol="0" anchor="ctr"/>
+          <a:lstStyle/>
+          <a:p>
+            <a:pPr indent="0" marL="0">
+              <a:buNone/>
+            </a:pPr>
+            <a:r>
+              <a:rPr lang="en-US" sz="900" dirty="0">
+                <a:solidFill>
+                  <a:srgbClr val="6B7280"/>
+                </a:solidFill>
+                <a:latin typeface="맑은 고딕" pitchFamily="34" charset="0"/>
+                <a:ea typeface="맑은 고딕" pitchFamily="34" charset="-122"/>
+                <a:cs typeface="맑은 고딕" pitchFamily="34" charset="-120"/>
+              </a:rPr>
+              <a:t>컬러: 피치  ·  재고 0개</a:t>
+            </a:r>
+            <a:pPr indent="0" marL="0">
+              <a:buNone/>
+            </a:pPr>
+            <a:r>
+              <a:rPr lang="en-US" sz="1000" dirty="0">
+                <a:solidFill>
+                  <a:srgbClr val="6B7280"/>
+                </a:solidFill>
+                <a:latin typeface="맑은 고딕" pitchFamily="34" charset="0"/>
+                <a:ea typeface="맑은 고딕" pitchFamily="34" charset="-122"/>
+                <a:cs typeface="맑은 고딕" pitchFamily="34" charset="-120"/>
+              </a:rPr>
+              <a:t/>
+            </a:r>
+            <a:pPr indent="0" marL="0">
+              <a:buNone/>
+            </a:pPr>
+            <a:r>
+              <a:rPr lang="en-US" sz="1000" b="1" dirty="0">
+                <a:solidFill>
+                  <a:srgbClr val="D72638"/>
+                </a:solidFill>
+                <a:latin typeface="맑은 고딕" pitchFamily="34" charset="0"/>
+                <a:ea typeface="맑은 고딕" pitchFamily="34" charset="-122"/>
+                <a:cs typeface="맑은 고딕" pitchFamily="34" charset="-120"/>
+              </a:rPr>
+              <a:t/>
+            </a:r>
+            <a:endParaRPr lang="en-US" sz="900" dirty="0"/>
+          </a:p>
+        </p:txBody>
+      </p:sp>
+      <p:sp>
+        <p:nvSpPr>
+          <p:cNvPr id="32" name="Shape 29"/>
+          <p:cNvSpPr/>
+          <p:nvPr/>
+        </p:nvSpPr>
+        <p:spPr>
+          <a:xfrm>
+            <a:off x="7406640" y="4096512"/>
+            <a:ext cx="4206240" cy="640080"/>
+          </a:xfrm>
+          <a:prstGeom prst="rect">
+            <a:avLst/>
+          </a:prstGeom>
+          <a:solidFill>
+            <a:srgbClr val="FFF5F5"/>
+          </a:solidFill>
+          <a:ln w="6350">
+            <a:solidFill>
+              <a:srgbClr val="E5E7EB"/>
+            </a:solidFill>
+            <a:prstDash val="solid"/>
+          </a:ln>
+        </p:spPr>
+      </p:sp>
+      <p:sp>
+        <p:nvSpPr>
+          <p:cNvPr id="33" name="Shape 30"/>
+          <p:cNvSpPr/>
+          <p:nvPr/>
+        </p:nvSpPr>
+        <p:spPr>
+          <a:xfrm>
+            <a:off x="7406640" y="4096512"/>
+            <a:ext cx="109728" cy="640080"/>
+          </a:xfrm>
+          <a:prstGeom prst="rect">
+            <a:avLst/>
+          </a:prstGeom>
+          <a:solidFill>
+            <a:srgbClr val="D72638"/>
+          </a:solidFill>
+          <a:ln w="12700">
+            <a:solidFill>
+              <a:srgbClr val="D72638"/>
+            </a:solidFill>
+            <a:prstDash val="solid"/>
+          </a:ln>
+        </p:spPr>
+      </p:sp>
+      <p:sp>
+        <p:nvSpPr>
+          <p:cNvPr id="34" name="Shape 31"/>
+          <p:cNvSpPr/>
+          <p:nvPr/>
+        </p:nvSpPr>
+        <p:spPr>
+          <a:xfrm>
+            <a:off x="7571232" y="4187952"/>
+            <a:ext cx="548640" cy="256032"/>
+          </a:xfrm>
+          <a:prstGeom prst="rect">
+            <a:avLst/>
+          </a:prstGeom>
+          <a:solidFill>
+            <a:srgbClr val="D72638"/>
+          </a:solidFill>
+          <a:ln w="12700">
+            <a:solidFill>
+              <a:srgbClr val="D72638"/>
+            </a:solidFill>
+            <a:prstDash val="solid"/>
+          </a:ln>
+        </p:spPr>
+      </p:sp>
+      <p:sp>
+        <p:nvSpPr>
+          <p:cNvPr id="35" name="Text 32"/>
+          <p:cNvSpPr/>
+          <p:nvPr/>
+        </p:nvSpPr>
+        <p:spPr>
+          <a:xfrm>
+            <a:off x="7571232" y="4187952"/>
+            <a:ext cx="548640" cy="256032"/>
+          </a:xfrm>
+          <a:prstGeom prst="rect">
+            <a:avLst/>
+          </a:prstGeom>
+          <a:noFill/>
+          <a:ln/>
+        </p:spPr>
+        <p:txBody>
+          <a:bodyPr wrap="square" lIns="0" tIns="0" rIns="0" bIns="0" rtlCol="0" anchor="ctr"/>
+          <a:lstStyle/>
+          <a:p>
+            <a:pPr algn="ctr" indent="0" marL="0">
+              <a:buNone/>
+            </a:pPr>
+            <a:r>
+              <a:rPr lang="en-US" sz="900" b="1" dirty="0">
+                <a:solidFill>
+                  <a:srgbClr val="FFFFFF"/>
+                </a:solidFill>
+                <a:latin typeface="맑은 고딕" pitchFamily="34" charset="0"/>
+                <a:ea typeface="맑은 고딕" pitchFamily="34" charset="-122"/>
+                <a:cs typeface="맑은 고딕" pitchFamily="34" charset="-120"/>
+              </a:rPr>
+              <a:t>긴급</a:t>
+            </a:r>
+            <a:endParaRPr lang="en-US" sz="900" dirty="0"/>
+          </a:p>
+        </p:txBody>
+      </p:sp>
+      <p:sp>
+        <p:nvSpPr>
+          <p:cNvPr id="36" name="Text 33"/>
+          <p:cNvSpPr/>
+          <p:nvPr/>
+        </p:nvSpPr>
+        <p:spPr>
+          <a:xfrm>
+            <a:off x="8211312" y="4151376"/>
+            <a:ext cx="3291840" cy="274320"/>
+          </a:xfrm>
+          <a:prstGeom prst="rect">
+            <a:avLst/>
+          </a:prstGeom>
+          <a:noFill/>
+          <a:ln/>
+        </p:spPr>
+        <p:txBody>
+          <a:bodyPr wrap="square" lIns="0" tIns="0" rIns="0" bIns="0" rtlCol="0" anchor="ctr"/>
+          <a:lstStyle/>
+          <a:p>
+            <a:pPr indent="0" marL="0">
+              <a:buNone/>
+            </a:pPr>
+            <a:r>
+              <a:rPr lang="en-US" sz="1000" b="1" dirty="0">
+                <a:solidFill>
+                  <a:srgbClr val="0B1220"/>
+                </a:solidFill>
+                <a:latin typeface="맑은 고딕" pitchFamily="34" charset="0"/>
+                <a:ea typeface="맑은 고딕" pitchFamily="34" charset="-122"/>
+                <a:cs typeface="맑은 고딕" pitchFamily="34" charset="-120"/>
+              </a:rPr>
+              <a:t>Basic Toliet Slippers (6color)</a:t>
+            </a:r>
+            <a:endParaRPr lang="en-US" sz="1000" dirty="0"/>
+          </a:p>
+        </p:txBody>
+      </p:sp>
+      <p:sp>
+        <p:nvSpPr>
+          <p:cNvPr id="37" name="Text 34"/>
+          <p:cNvSpPr/>
+          <p:nvPr/>
+        </p:nvSpPr>
+        <p:spPr>
+          <a:xfrm>
+            <a:off x="8211312" y="4425696"/>
+            <a:ext cx="3291840" cy="256032"/>
+          </a:xfrm>
+          <a:prstGeom prst="rect">
+            <a:avLst/>
+          </a:prstGeom>
+          <a:noFill/>
+          <a:ln/>
+        </p:spPr>
+        <p:txBody>
+          <a:bodyPr wrap="square" lIns="0" tIns="0" rIns="0" bIns="0" rtlCol="0" anchor="ctr"/>
+          <a:lstStyle/>
+          <a:p>
+            <a:pPr indent="0" marL="0">
+              <a:buNone/>
+            </a:pPr>
+            <a:r>
+              <a:rPr lang="en-US" sz="900" dirty="0">
+                <a:solidFill>
+                  <a:srgbClr val="6B7280"/>
+                </a:solidFill>
+                <a:latin typeface="맑은 고딕" pitchFamily="34" charset="0"/>
+                <a:ea typeface="맑은 고딕" pitchFamily="34" charset="-122"/>
+                <a:cs typeface="맑은 고딕" pitchFamily="34" charset="-120"/>
+              </a:rPr>
+              <a:t>컬러: 민트 / 사이즈: Free Size 230~270  ·  재고 0개</a:t>
+            </a:r>
+            <a:pPr indent="0" marL="0">
+              <a:buNone/>
+            </a:pPr>
+            <a:r>
+              <a:rPr lang="en-US" sz="1000" dirty="0">
+                <a:solidFill>
+                  <a:srgbClr val="6B7280"/>
+                </a:solidFill>
+                <a:latin typeface="맑은 고딕" pitchFamily="34" charset="0"/>
+                <a:ea typeface="맑은 고딕" pitchFamily="34" charset="-122"/>
+                <a:cs typeface="맑은 고딕" pitchFamily="34" charset="-120"/>
+              </a:rPr>
+              <a:t/>
+            </a:r>
+            <a:pPr indent="0" marL="0">
+              <a:buNone/>
+            </a:pPr>
+            <a:r>
+              <a:rPr lang="en-US" sz="1000" b="1" dirty="0">
+                <a:solidFill>
+                  <a:srgbClr val="D72638"/>
+                </a:solidFill>
+                <a:latin typeface="맑은 고딕" pitchFamily="34" charset="0"/>
+                <a:ea typeface="맑은 고딕" pitchFamily="34" charset="-122"/>
+                <a:cs typeface="맑은 고딕" pitchFamily="34" charset="-120"/>
+              </a:rPr>
+              <a:t/>
+            </a:r>
+            <a:endParaRPr lang="en-US" sz="900" dirty="0"/>
+          </a:p>
+        </p:txBody>
+      </p:sp>
+      <p:sp>
+        <p:nvSpPr>
+          <p:cNvPr id="38" name="Shape 35"/>
+          <p:cNvSpPr/>
+          <p:nvPr/>
+        </p:nvSpPr>
+        <p:spPr>
+          <a:xfrm>
+            <a:off x="7406640" y="4809744"/>
+            <a:ext cx="4206240" cy="640080"/>
+          </a:xfrm>
+          <a:prstGeom prst="rect">
+            <a:avLst/>
+          </a:prstGeom>
+          <a:solidFill>
+            <a:srgbClr val="FFF5F5"/>
+          </a:solidFill>
+          <a:ln w="6350">
+            <a:solidFill>
+              <a:srgbClr val="E5E7EB"/>
+            </a:solidFill>
+            <a:prstDash val="solid"/>
+          </a:ln>
+        </p:spPr>
+      </p:sp>
+      <p:sp>
+        <p:nvSpPr>
+          <p:cNvPr id="39" name="Shape 36"/>
+          <p:cNvSpPr/>
+          <p:nvPr/>
+        </p:nvSpPr>
+        <p:spPr>
+          <a:xfrm>
+            <a:off x="7406640" y="4809744"/>
+            <a:ext cx="109728" cy="640080"/>
+          </a:xfrm>
+          <a:prstGeom prst="rect">
+            <a:avLst/>
+          </a:prstGeom>
+          <a:solidFill>
+            <a:srgbClr val="D72638"/>
+          </a:solidFill>
+          <a:ln w="12700">
+            <a:solidFill>
+              <a:srgbClr val="D72638"/>
+            </a:solidFill>
+            <a:prstDash val="solid"/>
+          </a:ln>
+        </p:spPr>
+      </p:sp>
+      <p:sp>
+        <p:nvSpPr>
+          <p:cNvPr id="40" name="Shape 37"/>
+          <p:cNvSpPr/>
+          <p:nvPr/>
+        </p:nvSpPr>
+        <p:spPr>
+          <a:xfrm>
+            <a:off x="7571232" y="4901184"/>
+            <a:ext cx="548640" cy="256032"/>
+          </a:xfrm>
+          <a:prstGeom prst="rect">
+            <a:avLst/>
+          </a:prstGeom>
+          <a:solidFill>
+            <a:srgbClr val="D72638"/>
+          </a:solidFill>
+          <a:ln w="12700">
+            <a:solidFill>
+              <a:srgbClr val="D72638"/>
+            </a:solidFill>
+            <a:prstDash val="solid"/>
+          </a:ln>
+        </p:spPr>
+      </p:sp>
+      <p:sp>
+        <p:nvSpPr>
+          <p:cNvPr id="41" name="Text 38"/>
+          <p:cNvSpPr/>
+          <p:nvPr/>
+        </p:nvSpPr>
+        <p:spPr>
+          <a:xfrm>
+            <a:off x="7571232" y="4901184"/>
+            <a:ext cx="548640" cy="256032"/>
+          </a:xfrm>
+          <a:prstGeom prst="rect">
+            <a:avLst/>
+          </a:prstGeom>
+          <a:noFill/>
+          <a:ln/>
+        </p:spPr>
+        <p:txBody>
+          <a:bodyPr wrap="square" lIns="0" tIns="0" rIns="0" bIns="0" rtlCol="0" anchor="ctr"/>
+          <a:lstStyle/>
+          <a:p>
+            <a:pPr algn="ctr" indent="0" marL="0">
+              <a:buNone/>
+            </a:pPr>
+            <a:r>
+              <a:rPr lang="en-US" sz="900" b="1" dirty="0">
+                <a:solidFill>
+                  <a:srgbClr val="FFFFFF"/>
+                </a:solidFill>
+                <a:latin typeface="맑은 고딕" pitchFamily="34" charset="0"/>
+                <a:ea typeface="맑은 고딕" pitchFamily="34" charset="-122"/>
+                <a:cs typeface="맑은 고딕" pitchFamily="34" charset="-120"/>
+              </a:rPr>
+              <a:t>긴급</a:t>
+            </a:r>
+            <a:endParaRPr lang="en-US" sz="900" dirty="0"/>
+          </a:p>
+        </p:txBody>
+      </p:sp>
+      <p:sp>
+        <p:nvSpPr>
+          <p:cNvPr id="42" name="Text 39"/>
+          <p:cNvSpPr/>
+          <p:nvPr/>
+        </p:nvSpPr>
+        <p:spPr>
+          <a:xfrm>
+            <a:off x="8211312" y="4864608"/>
+            <a:ext cx="3291840" cy="274320"/>
+          </a:xfrm>
+          <a:prstGeom prst="rect">
+            <a:avLst/>
+          </a:prstGeom>
+          <a:noFill/>
+          <a:ln/>
+        </p:spPr>
+        <p:txBody>
+          <a:bodyPr wrap="square" lIns="0" tIns="0" rIns="0" bIns="0" rtlCol="0" anchor="ctr"/>
+          <a:lstStyle/>
+          <a:p>
+            <a:pPr indent="0" marL="0">
+              <a:buNone/>
+            </a:pPr>
+            <a:r>
+              <a:rPr lang="en-US" sz="1000" b="1" dirty="0">
+                <a:solidFill>
+                  <a:srgbClr val="0B1220"/>
+                </a:solidFill>
+                <a:latin typeface="맑은 고딕" pitchFamily="34" charset="0"/>
+                <a:ea typeface="맑은 고딕" pitchFamily="34" charset="-122"/>
+                <a:cs typeface="맑은 고딕" pitchFamily="34" charset="-120"/>
+              </a:rPr>
+              <a:t>Fuzzy Stripe Slippers (3color)</a:t>
+            </a:r>
+            <a:endParaRPr lang="en-US" sz="1000" dirty="0"/>
+          </a:p>
+        </p:txBody>
+      </p:sp>
+      <p:sp>
+        <p:nvSpPr>
+          <p:cNvPr id="43" name="Text 40"/>
+          <p:cNvSpPr/>
+          <p:nvPr/>
+        </p:nvSpPr>
+        <p:spPr>
+          <a:xfrm>
+            <a:off x="8211312" y="5138928"/>
+            <a:ext cx="3291840" cy="256032"/>
+          </a:xfrm>
+          <a:prstGeom prst="rect">
+            <a:avLst/>
+          </a:prstGeom>
+          <a:noFill/>
+          <a:ln/>
+        </p:spPr>
+        <p:txBody>
+          <a:bodyPr wrap="square" lIns="0" tIns="0" rIns="0" bIns="0" rtlCol="0" anchor="ctr"/>
+          <a:lstStyle/>
+          <a:p>
+            <a:pPr indent="0" marL="0">
+              <a:buNone/>
+            </a:pPr>
+            <a:r>
+              <a:rPr lang="en-US" sz="900" dirty="0">
+                <a:solidFill>
+                  <a:srgbClr val="6B7280"/>
+                </a:solidFill>
+                <a:latin typeface="맑은 고딕" pitchFamily="34" charset="0"/>
+                <a:ea typeface="맑은 고딕" pitchFamily="34" charset="-122"/>
+                <a:cs typeface="맑은 고딕" pitchFamily="34" charset="-120"/>
+              </a:rPr>
+              <a:t>컬러: 그린 / 사이즈: 240~250(여성)  ·  재고 0개</a:t>
+            </a:r>
+            <a:pPr indent="0" marL="0">
+              <a:buNone/>
+            </a:pPr>
+            <a:r>
+              <a:rPr lang="en-US" sz="1000" dirty="0">
+                <a:solidFill>
+                  <a:srgbClr val="6B7280"/>
+                </a:solidFill>
+                <a:latin typeface="맑은 고딕" pitchFamily="34" charset="0"/>
+                <a:ea typeface="맑은 고딕" pitchFamily="34" charset="-122"/>
+                <a:cs typeface="맑은 고딕" pitchFamily="34" charset="-120"/>
+              </a:rPr>
+              <a:t/>
+            </a:r>
+            <a:pPr indent="0" marL="0">
+              <a:buNone/>
+            </a:pPr>
+            <a:r>
+              <a:rPr lang="en-US" sz="1000" b="1" dirty="0">
+                <a:solidFill>
+                  <a:srgbClr val="D72638"/>
+                </a:solidFill>
+                <a:latin typeface="맑은 고딕" pitchFamily="34" charset="0"/>
+                <a:ea typeface="맑은 고딕" pitchFamily="34" charset="-122"/>
+                <a:cs typeface="맑은 고딕" pitchFamily="34" charset="-120"/>
+              </a:rPr>
+              <a:t/>
+            </a:r>
+            <a:endParaRPr lang="en-US" sz="900" dirty="0"/>
+          </a:p>
+        </p:txBody>
+      </p:sp>
+      <p:sp>
+        <p:nvSpPr>
+          <p:cNvPr id="44" name="Shape 41"/>
+          <p:cNvSpPr/>
+          <p:nvPr/>
+        </p:nvSpPr>
+        <p:spPr>
+          <a:xfrm>
+            <a:off x="7406640" y="5522976"/>
+            <a:ext cx="4206240" cy="640080"/>
+          </a:xfrm>
+          <a:prstGeom prst="rect">
+            <a:avLst/>
+          </a:prstGeom>
+          <a:solidFill>
+            <a:srgbClr val="FFF5F5"/>
+          </a:solidFill>
+          <a:ln w="6350">
+            <a:solidFill>
+              <a:srgbClr val="E5E7EB"/>
+            </a:solidFill>
+            <a:prstDash val="solid"/>
+          </a:ln>
+        </p:spPr>
+      </p:sp>
+      <p:sp>
+        <p:nvSpPr>
+          <p:cNvPr id="45" name="Shape 42"/>
+          <p:cNvSpPr/>
+          <p:nvPr/>
+        </p:nvSpPr>
+        <p:spPr>
+          <a:xfrm>
+            <a:off x="7406640" y="5522976"/>
+            <a:ext cx="109728" cy="640080"/>
+          </a:xfrm>
+          <a:prstGeom prst="rect">
+            <a:avLst/>
+          </a:prstGeom>
+          <a:solidFill>
+            <a:srgbClr val="D72638"/>
+          </a:solidFill>
+          <a:ln w="12700">
+            <a:solidFill>
+              <a:srgbClr val="D72638"/>
+            </a:solidFill>
+            <a:prstDash val="solid"/>
+          </a:ln>
+        </p:spPr>
+      </p:sp>
+      <p:sp>
+        <p:nvSpPr>
+          <p:cNvPr id="46" name="Shape 43"/>
+          <p:cNvSpPr/>
+          <p:nvPr/>
+        </p:nvSpPr>
+        <p:spPr>
+          <a:xfrm>
+            <a:off x="7571232" y="5614416"/>
+            <a:ext cx="548640" cy="256032"/>
+          </a:xfrm>
+          <a:prstGeom prst="rect">
+            <a:avLst/>
+          </a:prstGeom>
+          <a:solidFill>
+            <a:srgbClr val="D72638"/>
+          </a:solidFill>
+          <a:ln w="12700">
+            <a:solidFill>
+              <a:srgbClr val="D72638"/>
+            </a:solidFill>
+            <a:prstDash val="solid"/>
+          </a:ln>
+        </p:spPr>
+      </p:sp>
+      <p:sp>
+        <p:nvSpPr>
+          <p:cNvPr id="47" name="Text 44"/>
+          <p:cNvSpPr/>
+          <p:nvPr/>
+        </p:nvSpPr>
+        <p:spPr>
+          <a:xfrm>
+            <a:off x="7571232" y="5614416"/>
+            <a:ext cx="548640" cy="256032"/>
+          </a:xfrm>
+          <a:prstGeom prst="rect">
+            <a:avLst/>
+          </a:prstGeom>
+          <a:noFill/>
+          <a:ln/>
+        </p:spPr>
+        <p:txBody>
+          <a:bodyPr wrap="square" lIns="0" tIns="0" rIns="0" bIns="0" rtlCol="0" anchor="ctr"/>
+          <a:lstStyle/>
+          <a:p>
+            <a:pPr algn="ctr" indent="0" marL="0">
+              <a:buNone/>
+            </a:pPr>
+            <a:r>
+              <a:rPr lang="en-US" sz="900" b="1" dirty="0">
+                <a:solidFill>
+                  <a:srgbClr val="FFFFFF"/>
+                </a:solidFill>
+                <a:latin typeface="맑은 고딕" pitchFamily="34" charset="0"/>
+                <a:ea typeface="맑은 고딕" pitchFamily="34" charset="-122"/>
+                <a:cs typeface="맑은 고딕" pitchFamily="34" charset="-120"/>
+              </a:rPr>
+              <a:t>긴급</a:t>
+            </a:r>
+            <a:endParaRPr lang="en-US" sz="900" dirty="0"/>
+          </a:p>
+        </p:txBody>
+      </p:sp>
+      <p:sp>
+        <p:nvSpPr>
+          <p:cNvPr id="48" name="Text 45"/>
+          <p:cNvSpPr/>
+          <p:nvPr/>
+        </p:nvSpPr>
+        <p:spPr>
+          <a:xfrm>
+            <a:off x="8211312" y="5577840"/>
+            <a:ext cx="3291840" cy="274320"/>
+          </a:xfrm>
+          <a:prstGeom prst="rect">
+            <a:avLst/>
+          </a:prstGeom>
+          <a:noFill/>
+          <a:ln/>
+        </p:spPr>
+        <p:txBody>
+          <a:bodyPr wrap="square" lIns="0" tIns="0" rIns="0" bIns="0" rtlCol="0" anchor="ctr"/>
+          <a:lstStyle/>
+          <a:p>
+            <a:pPr indent="0" marL="0">
+              <a:buNone/>
+            </a:pPr>
+            <a:r>
+              <a:rPr lang="en-US" sz="1000" b="1" dirty="0">
+                <a:solidFill>
+                  <a:srgbClr val="0B1220"/>
+                </a:solidFill>
+                <a:latin typeface="맑은 고딕" pitchFamily="34" charset="0"/>
+                <a:ea typeface="맑은 고딕" pitchFamily="34" charset="-122"/>
+                <a:cs typeface="맑은 고딕" pitchFamily="34" charset="-120"/>
+              </a:rPr>
               <a:t>Cotton Lunch Mini Bag (5color)</a:t>
             </a:r>
             <a:endParaRPr lang="en-US" sz="1000" dirty="0"/>
@@ -12798,13 +13458,13 @@
       </p:sp>
       <p:sp>
         <p:nvSpPr>
-          <p:cNvPr id="31" name="Text 28"/>
-          <p:cNvSpPr/>
-          <p:nvPr/>
-        </p:nvSpPr>
-        <p:spPr>
-          <a:xfrm>
-            <a:off x="8211312" y="3712464"/>
+          <p:cNvPr id="49" name="Text 46"/>
+          <p:cNvSpPr/>
+          <p:nvPr/>
+        </p:nvSpPr>
+        <p:spPr>
+          <a:xfrm>
+            <a:off x="8211312" y="5852160"/>
             <a:ext cx="3291840" cy="256032"/>
           </a:xfrm>
           <a:prstGeom prst="rect">
@@ -12865,167 +13525,14 @@
       </p:sp>
       <p:sp>
         <p:nvSpPr>
-          <p:cNvPr id="32" name="Shape 29"/>
-          <p:cNvSpPr/>
-          <p:nvPr/>
-        </p:nvSpPr>
-        <p:spPr>
-          <a:xfrm>
-            <a:off x="7406640" y="4096512"/>
-            <a:ext cx="4206240" cy="640080"/>
-          </a:xfrm>
-          <a:prstGeom prst="rect">
-            <a:avLst/>
-          </a:prstGeom>
-          <a:solidFill>
-            <a:srgbClr val="FFF5F5"/>
-          </a:solidFill>
-          <a:ln w="6350">
-            <a:solidFill>
-              <a:srgbClr val="E5E7EB"/>
-            </a:solidFill>
-            <a:prstDash val="solid"/>
-          </a:ln>
-        </p:spPr>
-      </p:sp>
-      <p:sp>
-        <p:nvSpPr>
-          <p:cNvPr id="33" name="Shape 30"/>
-          <p:cNvSpPr/>
-          <p:nvPr/>
-        </p:nvSpPr>
-        <p:spPr>
-          <a:xfrm>
-            <a:off x="7406640" y="4096512"/>
-            <a:ext cx="109728" cy="640080"/>
-          </a:xfrm>
-          <a:prstGeom prst="rect">
-            <a:avLst/>
-          </a:prstGeom>
-          <a:solidFill>
-            <a:srgbClr val="D72638"/>
-          </a:solidFill>
-          <a:ln w="12700">
-            <a:solidFill>
-              <a:srgbClr val="D72638"/>
-            </a:solidFill>
-            <a:prstDash val="solid"/>
-          </a:ln>
-        </p:spPr>
-      </p:sp>
-      <p:sp>
-        <p:nvSpPr>
-          <p:cNvPr id="34" name="Shape 31"/>
-          <p:cNvSpPr/>
-          <p:nvPr/>
-        </p:nvSpPr>
-        <p:spPr>
-          <a:xfrm>
-            <a:off x="7571232" y="4187952"/>
-            <a:ext cx="548640" cy="256032"/>
-          </a:xfrm>
-          <a:prstGeom prst="rect">
-            <a:avLst/>
-          </a:prstGeom>
-          <a:solidFill>
-            <a:srgbClr val="D72638"/>
-          </a:solidFill>
-          <a:ln w="12700">
-            <a:solidFill>
-              <a:srgbClr val="D72638"/>
-            </a:solidFill>
-            <a:prstDash val="solid"/>
-          </a:ln>
-        </p:spPr>
-      </p:sp>
-      <p:sp>
-        <p:nvSpPr>
-          <p:cNvPr id="35" name="Text 32"/>
-          <p:cNvSpPr/>
-          <p:nvPr/>
-        </p:nvSpPr>
-        <p:spPr>
-          <a:xfrm>
-            <a:off x="7571232" y="4187952"/>
-            <a:ext cx="548640" cy="256032"/>
-          </a:xfrm>
-          <a:prstGeom prst="rect">
-            <a:avLst/>
-          </a:prstGeom>
-          <a:noFill/>
-          <a:ln/>
-        </p:spPr>
-        <p:txBody>
-          <a:bodyPr wrap="square" lIns="0" tIns="0" rIns="0" bIns="0" rtlCol="0" anchor="ctr"/>
-          <a:lstStyle/>
-          <a:p>
-            <a:pPr algn="ctr" indent="0" marL="0">
-              <a:buNone/>
-            </a:pPr>
-            <a:r>
-              <a:rPr lang="en-US" sz="900" b="1" dirty="0">
-                <a:solidFill>
-                  <a:srgbClr val="FFFFFF"/>
-                </a:solidFill>
-                <a:latin typeface="맑은 고딕" pitchFamily="34" charset="0"/>
-                <a:ea typeface="맑은 고딕" pitchFamily="34" charset="-122"/>
-                <a:cs typeface="맑은 고딕" pitchFamily="34" charset="-120"/>
-              </a:rPr>
-              <a:t>긴급</a:t>
-            </a:r>
-            <a:endParaRPr lang="en-US" sz="900" dirty="0"/>
-          </a:p>
-        </p:txBody>
-      </p:sp>
-      <p:sp>
-        <p:nvSpPr>
-          <p:cNvPr id="36" name="Text 33"/>
-          <p:cNvSpPr/>
-          <p:nvPr/>
-        </p:nvSpPr>
-        <p:spPr>
-          <a:xfrm>
-            <a:off x="8211312" y="4151376"/>
-            <a:ext cx="3291840" cy="274320"/>
-          </a:xfrm>
-          <a:prstGeom prst="rect">
-            <a:avLst/>
-          </a:prstGeom>
-          <a:noFill/>
-          <a:ln/>
-        </p:spPr>
-        <p:txBody>
-          <a:bodyPr wrap="square" lIns="0" tIns="0" rIns="0" bIns="0" rtlCol="0" anchor="ctr"/>
-          <a:lstStyle/>
-          <a:p>
-            <a:pPr indent="0" marL="0">
-              <a:buNone/>
-            </a:pPr>
-            <a:r>
-              <a:rPr lang="en-US" sz="1000" b="1" dirty="0">
-                <a:solidFill>
-                  <a:srgbClr val="0B1220"/>
-                </a:solidFill>
-                <a:latin typeface="맑은 고딕" pitchFamily="34" charset="0"/>
-                <a:ea typeface="맑은 고딕" pitchFamily="34" charset="-122"/>
-                <a:cs typeface="맑은 고딕" pitchFamily="34" charset="-120"/>
-              </a:rPr>
-              <a:t>Cotton Lunch Mini Bag (5color)</a:t>
-            </a:r>
-            <a:endParaRPr lang="en-US" sz="1000" dirty="0"/>
-          </a:p>
-        </p:txBody>
-      </p:sp>
-      <p:sp>
-        <p:nvSpPr>
-          <p:cNvPr id="37" name="Text 34"/>
-          <p:cNvSpPr/>
-          <p:nvPr/>
-        </p:nvSpPr>
-        <p:spPr>
-          <a:xfrm>
-            <a:off x="8211312" y="4425696"/>
-            <a:ext cx="3291840" cy="256032"/>
+          <p:cNvPr id="50" name="Text 47"/>
+          <p:cNvSpPr/>
+          <p:nvPr/>
+        </p:nvSpPr>
+        <p:spPr>
+          <a:xfrm>
+            <a:off x="548640" y="6492240"/>
+            <a:ext cx="7315200" cy="274320"/>
           </a:xfrm>
           <a:prstGeom prst="rect">
             <a:avLst/>
@@ -13049,514 +13556,7 @@
                 <a:ea typeface="맑은 고딕" pitchFamily="34" charset="-122"/>
                 <a:cs typeface="맑은 고딕" pitchFamily="34" charset="-120"/>
               </a:rPr>
-              <a:t>색상: 블랙  ·  재고 0개</a:t>
-            </a:r>
-            <a:pPr indent="0" marL="0">
-              <a:buNone/>
-            </a:pPr>
-            <a:r>
-              <a:rPr lang="en-US" sz="1000" dirty="0">
-                <a:solidFill>
-                  <a:srgbClr val="6B7280"/>
-                </a:solidFill>
-                <a:latin typeface="맑은 고딕" pitchFamily="34" charset="0"/>
-                <a:ea typeface="맑은 고딕" pitchFamily="34" charset="-122"/>
-                <a:cs typeface="맑은 고딕" pitchFamily="34" charset="-120"/>
-              </a:rPr>
-              <a:t/>
-            </a:r>
-            <a:pPr indent="0" marL="0">
-              <a:buNone/>
-            </a:pPr>
-            <a:r>
-              <a:rPr lang="en-US" sz="1000" b="1" dirty="0">
-                <a:solidFill>
-                  <a:srgbClr val="D72638"/>
-                </a:solidFill>
-                <a:latin typeface="맑은 고딕" pitchFamily="34" charset="0"/>
-                <a:ea typeface="맑은 고딕" pitchFamily="34" charset="-122"/>
-                <a:cs typeface="맑은 고딕" pitchFamily="34" charset="-120"/>
-              </a:rPr>
-              <a:t/>
-            </a:r>
-            <a:endParaRPr lang="en-US" sz="900" dirty="0"/>
-          </a:p>
-        </p:txBody>
-      </p:sp>
-      <p:sp>
-        <p:nvSpPr>
-          <p:cNvPr id="38" name="Shape 35"/>
-          <p:cNvSpPr/>
-          <p:nvPr/>
-        </p:nvSpPr>
-        <p:spPr>
-          <a:xfrm>
-            <a:off x="7406640" y="4809744"/>
-            <a:ext cx="4206240" cy="640080"/>
-          </a:xfrm>
-          <a:prstGeom prst="rect">
-            <a:avLst/>
-          </a:prstGeom>
-          <a:solidFill>
-            <a:srgbClr val="FFF5F5"/>
-          </a:solidFill>
-          <a:ln w="6350">
-            <a:solidFill>
-              <a:srgbClr val="E5E7EB"/>
-            </a:solidFill>
-            <a:prstDash val="solid"/>
-          </a:ln>
-        </p:spPr>
-      </p:sp>
-      <p:sp>
-        <p:nvSpPr>
-          <p:cNvPr id="39" name="Shape 36"/>
-          <p:cNvSpPr/>
-          <p:nvPr/>
-        </p:nvSpPr>
-        <p:spPr>
-          <a:xfrm>
-            <a:off x="7406640" y="4809744"/>
-            <a:ext cx="109728" cy="640080"/>
-          </a:xfrm>
-          <a:prstGeom prst="rect">
-            <a:avLst/>
-          </a:prstGeom>
-          <a:solidFill>
-            <a:srgbClr val="D72638"/>
-          </a:solidFill>
-          <a:ln w="12700">
-            <a:solidFill>
-              <a:srgbClr val="D72638"/>
-            </a:solidFill>
-            <a:prstDash val="solid"/>
-          </a:ln>
-        </p:spPr>
-      </p:sp>
-      <p:sp>
-        <p:nvSpPr>
-          <p:cNvPr id="40" name="Shape 37"/>
-          <p:cNvSpPr/>
-          <p:nvPr/>
-        </p:nvSpPr>
-        <p:spPr>
-          <a:xfrm>
-            <a:off x="7571232" y="4901184"/>
-            <a:ext cx="548640" cy="256032"/>
-          </a:xfrm>
-          <a:prstGeom prst="rect">
-            <a:avLst/>
-          </a:prstGeom>
-          <a:solidFill>
-            <a:srgbClr val="D72638"/>
-          </a:solidFill>
-          <a:ln w="12700">
-            <a:solidFill>
-              <a:srgbClr val="D72638"/>
-            </a:solidFill>
-            <a:prstDash val="solid"/>
-          </a:ln>
-        </p:spPr>
-      </p:sp>
-      <p:sp>
-        <p:nvSpPr>
-          <p:cNvPr id="41" name="Text 38"/>
-          <p:cNvSpPr/>
-          <p:nvPr/>
-        </p:nvSpPr>
-        <p:spPr>
-          <a:xfrm>
-            <a:off x="7571232" y="4901184"/>
-            <a:ext cx="548640" cy="256032"/>
-          </a:xfrm>
-          <a:prstGeom prst="rect">
-            <a:avLst/>
-          </a:prstGeom>
-          <a:noFill/>
-          <a:ln/>
-        </p:spPr>
-        <p:txBody>
-          <a:bodyPr wrap="square" lIns="0" tIns="0" rIns="0" bIns="0" rtlCol="0" anchor="ctr"/>
-          <a:lstStyle/>
-          <a:p>
-            <a:pPr algn="ctr" indent="0" marL="0">
-              <a:buNone/>
-            </a:pPr>
-            <a:r>
-              <a:rPr lang="en-US" sz="900" b="1" dirty="0">
-                <a:solidFill>
-                  <a:srgbClr val="FFFFFF"/>
-                </a:solidFill>
-                <a:latin typeface="맑은 고딕" pitchFamily="34" charset="0"/>
-                <a:ea typeface="맑은 고딕" pitchFamily="34" charset="-122"/>
-                <a:cs typeface="맑은 고딕" pitchFamily="34" charset="-120"/>
-              </a:rPr>
-              <a:t>긴급</a:t>
-            </a:r>
-            <a:endParaRPr lang="en-US" sz="900" dirty="0"/>
-          </a:p>
-        </p:txBody>
-      </p:sp>
-      <p:sp>
-        <p:nvSpPr>
-          <p:cNvPr id="42" name="Text 39"/>
-          <p:cNvSpPr/>
-          <p:nvPr/>
-        </p:nvSpPr>
-        <p:spPr>
-          <a:xfrm>
-            <a:off x="8211312" y="4864608"/>
-            <a:ext cx="3291840" cy="274320"/>
-          </a:xfrm>
-          <a:prstGeom prst="rect">
-            <a:avLst/>
-          </a:prstGeom>
-          <a:noFill/>
-          <a:ln/>
-        </p:spPr>
-        <p:txBody>
-          <a:bodyPr wrap="square" lIns="0" tIns="0" rIns="0" bIns="0" rtlCol="0" anchor="ctr"/>
-          <a:lstStyle/>
-          <a:p>
-            <a:pPr indent="0" marL="0">
-              <a:buNone/>
-            </a:pPr>
-            <a:r>
-              <a:rPr lang="en-US" sz="1000" b="1" dirty="0">
-                <a:solidFill>
-                  <a:srgbClr val="0B1220"/>
-                </a:solidFill>
-                <a:latin typeface="맑은 고딕" pitchFamily="34" charset="0"/>
-                <a:ea typeface="맑은 고딕" pitchFamily="34" charset="-122"/>
-                <a:cs typeface="맑은 고딕" pitchFamily="34" charset="-120"/>
-              </a:rPr>
-              <a:t>Food Bottle Opener</a:t>
-            </a:r>
-            <a:endParaRPr lang="en-US" sz="1000" dirty="0"/>
-          </a:p>
-        </p:txBody>
-      </p:sp>
-      <p:sp>
-        <p:nvSpPr>
-          <p:cNvPr id="43" name="Text 40"/>
-          <p:cNvSpPr/>
-          <p:nvPr/>
-        </p:nvSpPr>
-        <p:spPr>
-          <a:xfrm>
-            <a:off x="8211312" y="5138928"/>
-            <a:ext cx="3291840" cy="256032"/>
-          </a:xfrm>
-          <a:prstGeom prst="rect">
-            <a:avLst/>
-          </a:prstGeom>
-          <a:noFill/>
-          <a:ln/>
-        </p:spPr>
-        <p:txBody>
-          <a:bodyPr wrap="square" lIns="0" tIns="0" rIns="0" bIns="0" rtlCol="0" anchor="ctr"/>
-          <a:lstStyle/>
-          <a:p>
-            <a:pPr indent="0" marL="0">
-              <a:buNone/>
-            </a:pPr>
-            <a:r>
-              <a:rPr lang="en-US" sz="900" dirty="0">
-                <a:solidFill>
-                  <a:srgbClr val="6B7280"/>
-                </a:solidFill>
-                <a:latin typeface="맑은 고딕" pitchFamily="34" charset="0"/>
-                <a:ea typeface="맑은 고딕" pitchFamily="34" charset="-122"/>
-                <a:cs typeface="맑은 고딕" pitchFamily="34" charset="-120"/>
-              </a:rPr>
-              <a:t>종류: 당근  ·  재고 0개</a:t>
-            </a:r>
-            <a:pPr indent="0" marL="0">
-              <a:buNone/>
-            </a:pPr>
-            <a:r>
-              <a:rPr lang="en-US" sz="1000" dirty="0">
-                <a:solidFill>
-                  <a:srgbClr val="6B7280"/>
-                </a:solidFill>
-                <a:latin typeface="맑은 고딕" pitchFamily="34" charset="0"/>
-                <a:ea typeface="맑은 고딕" pitchFamily="34" charset="-122"/>
-                <a:cs typeface="맑은 고딕" pitchFamily="34" charset="-120"/>
-              </a:rPr>
-              <a:t/>
-            </a:r>
-            <a:pPr indent="0" marL="0">
-              <a:buNone/>
-            </a:pPr>
-            <a:r>
-              <a:rPr lang="en-US" sz="1000" b="1" dirty="0">
-                <a:solidFill>
-                  <a:srgbClr val="D72638"/>
-                </a:solidFill>
-                <a:latin typeface="맑은 고딕" pitchFamily="34" charset="0"/>
-                <a:ea typeface="맑은 고딕" pitchFamily="34" charset="-122"/>
-                <a:cs typeface="맑은 고딕" pitchFamily="34" charset="-120"/>
-              </a:rPr>
-              <a:t/>
-            </a:r>
-            <a:endParaRPr lang="en-US" sz="900" dirty="0"/>
-          </a:p>
-        </p:txBody>
-      </p:sp>
-      <p:sp>
-        <p:nvSpPr>
-          <p:cNvPr id="44" name="Shape 41"/>
-          <p:cNvSpPr/>
-          <p:nvPr/>
-        </p:nvSpPr>
-        <p:spPr>
-          <a:xfrm>
-            <a:off x="7406640" y="5522976"/>
-            <a:ext cx="4206240" cy="640080"/>
-          </a:xfrm>
-          <a:prstGeom prst="rect">
-            <a:avLst/>
-          </a:prstGeom>
-          <a:solidFill>
-            <a:srgbClr val="FFF5F5"/>
-          </a:solidFill>
-          <a:ln w="6350">
-            <a:solidFill>
-              <a:srgbClr val="E5E7EB"/>
-            </a:solidFill>
-            <a:prstDash val="solid"/>
-          </a:ln>
-        </p:spPr>
-      </p:sp>
-      <p:sp>
-        <p:nvSpPr>
-          <p:cNvPr id="45" name="Shape 42"/>
-          <p:cNvSpPr/>
-          <p:nvPr/>
-        </p:nvSpPr>
-        <p:spPr>
-          <a:xfrm>
-            <a:off x="7406640" y="5522976"/>
-            <a:ext cx="109728" cy="640080"/>
-          </a:xfrm>
-          <a:prstGeom prst="rect">
-            <a:avLst/>
-          </a:prstGeom>
-          <a:solidFill>
-            <a:srgbClr val="D72638"/>
-          </a:solidFill>
-          <a:ln w="12700">
-            <a:solidFill>
-              <a:srgbClr val="D72638"/>
-            </a:solidFill>
-            <a:prstDash val="solid"/>
-          </a:ln>
-        </p:spPr>
-      </p:sp>
-      <p:sp>
-        <p:nvSpPr>
-          <p:cNvPr id="46" name="Shape 43"/>
-          <p:cNvSpPr/>
-          <p:nvPr/>
-        </p:nvSpPr>
-        <p:spPr>
-          <a:xfrm>
-            <a:off x="7571232" y="5614416"/>
-            <a:ext cx="548640" cy="256032"/>
-          </a:xfrm>
-          <a:prstGeom prst="rect">
-            <a:avLst/>
-          </a:prstGeom>
-          <a:solidFill>
-            <a:srgbClr val="D72638"/>
-          </a:solidFill>
-          <a:ln w="12700">
-            <a:solidFill>
-              <a:srgbClr val="D72638"/>
-            </a:solidFill>
-            <a:prstDash val="solid"/>
-          </a:ln>
-        </p:spPr>
-      </p:sp>
-      <p:sp>
-        <p:nvSpPr>
-          <p:cNvPr id="47" name="Text 44"/>
-          <p:cNvSpPr/>
-          <p:nvPr/>
-        </p:nvSpPr>
-        <p:spPr>
-          <a:xfrm>
-            <a:off x="7571232" y="5614416"/>
-            <a:ext cx="548640" cy="256032"/>
-          </a:xfrm>
-          <a:prstGeom prst="rect">
-            <a:avLst/>
-          </a:prstGeom>
-          <a:noFill/>
-          <a:ln/>
-        </p:spPr>
-        <p:txBody>
-          <a:bodyPr wrap="square" lIns="0" tIns="0" rIns="0" bIns="0" rtlCol="0" anchor="ctr"/>
-          <a:lstStyle/>
-          <a:p>
-            <a:pPr algn="ctr" indent="0" marL="0">
-              <a:buNone/>
-            </a:pPr>
-            <a:r>
-              <a:rPr lang="en-US" sz="900" b="1" dirty="0">
-                <a:solidFill>
-                  <a:srgbClr val="FFFFFF"/>
-                </a:solidFill>
-                <a:latin typeface="맑은 고딕" pitchFamily="34" charset="0"/>
-                <a:ea typeface="맑은 고딕" pitchFamily="34" charset="-122"/>
-                <a:cs typeface="맑은 고딕" pitchFamily="34" charset="-120"/>
-              </a:rPr>
-              <a:t>긴급</a:t>
-            </a:r>
-            <a:endParaRPr lang="en-US" sz="900" dirty="0"/>
-          </a:p>
-        </p:txBody>
-      </p:sp>
-      <p:sp>
-        <p:nvSpPr>
-          <p:cNvPr id="48" name="Text 45"/>
-          <p:cNvSpPr/>
-          <p:nvPr/>
-        </p:nvSpPr>
-        <p:spPr>
-          <a:xfrm>
-            <a:off x="8211312" y="5577840"/>
-            <a:ext cx="3291840" cy="274320"/>
-          </a:xfrm>
-          <a:prstGeom prst="rect">
-            <a:avLst/>
-          </a:prstGeom>
-          <a:noFill/>
-          <a:ln/>
-        </p:spPr>
-        <p:txBody>
-          <a:bodyPr wrap="square" lIns="0" tIns="0" rIns="0" bIns="0" rtlCol="0" anchor="ctr"/>
-          <a:lstStyle/>
-          <a:p>
-            <a:pPr indent="0" marL="0">
-              <a:buNone/>
-            </a:pPr>
-            <a:r>
-              <a:rPr lang="en-US" sz="1000" b="1" dirty="0">
-                <a:solidFill>
-                  <a:srgbClr val="0B1220"/>
-                </a:solidFill>
-                <a:latin typeface="맑은 고딕" pitchFamily="34" charset="0"/>
-                <a:ea typeface="맑은 고딕" pitchFamily="34" charset="-122"/>
-                <a:cs typeface="맑은 고딕" pitchFamily="34" charset="-120"/>
-              </a:rPr>
-              <a:t>Food Bottle Opener</a:t>
-            </a:r>
-            <a:endParaRPr lang="en-US" sz="1000" dirty="0"/>
-          </a:p>
-        </p:txBody>
-      </p:sp>
-      <p:sp>
-        <p:nvSpPr>
-          <p:cNvPr id="49" name="Text 46"/>
-          <p:cNvSpPr/>
-          <p:nvPr/>
-        </p:nvSpPr>
-        <p:spPr>
-          <a:xfrm>
-            <a:off x="8211312" y="5852160"/>
-            <a:ext cx="3291840" cy="256032"/>
-          </a:xfrm>
-          <a:prstGeom prst="rect">
-            <a:avLst/>
-          </a:prstGeom>
-          <a:noFill/>
-          <a:ln/>
-        </p:spPr>
-        <p:txBody>
-          <a:bodyPr wrap="square" lIns="0" tIns="0" rIns="0" bIns="0" rtlCol="0" anchor="ctr"/>
-          <a:lstStyle/>
-          <a:p>
-            <a:pPr indent="0" marL="0">
-              <a:buNone/>
-            </a:pPr>
-            <a:r>
-              <a:rPr lang="en-US" sz="900" dirty="0">
-                <a:solidFill>
-                  <a:srgbClr val="6B7280"/>
-                </a:solidFill>
-                <a:latin typeface="맑은 고딕" pitchFamily="34" charset="0"/>
-                <a:ea typeface="맑은 고딕" pitchFamily="34" charset="-122"/>
-                <a:cs typeface="맑은 고딕" pitchFamily="34" charset="-120"/>
-              </a:rPr>
-              <a:t>종류: 치즈  ·  재고 0개</a:t>
-            </a:r>
-            <a:pPr indent="0" marL="0">
-              <a:buNone/>
-            </a:pPr>
-            <a:r>
-              <a:rPr lang="en-US" sz="1000" dirty="0">
-                <a:solidFill>
-                  <a:srgbClr val="6B7280"/>
-                </a:solidFill>
-                <a:latin typeface="맑은 고딕" pitchFamily="34" charset="0"/>
-                <a:ea typeface="맑은 고딕" pitchFamily="34" charset="-122"/>
-                <a:cs typeface="맑은 고딕" pitchFamily="34" charset="-120"/>
-              </a:rPr>
-              <a:t/>
-            </a:r>
-            <a:pPr indent="0" marL="0">
-              <a:buNone/>
-            </a:pPr>
-            <a:r>
-              <a:rPr lang="en-US" sz="1000" b="1" dirty="0">
-                <a:solidFill>
-                  <a:srgbClr val="D72638"/>
-                </a:solidFill>
-                <a:latin typeface="맑은 고딕" pitchFamily="34" charset="0"/>
-                <a:ea typeface="맑은 고딕" pitchFamily="34" charset="-122"/>
-                <a:cs typeface="맑은 고딕" pitchFamily="34" charset="-120"/>
-              </a:rPr>
-              <a:t/>
-            </a:r>
-            <a:endParaRPr lang="en-US" sz="900" dirty="0"/>
-          </a:p>
-        </p:txBody>
-      </p:sp>
-      <p:sp>
-        <p:nvSpPr>
-          <p:cNvPr id="50" name="Text 47"/>
-          <p:cNvSpPr/>
-          <p:nvPr/>
-        </p:nvSpPr>
-        <p:spPr>
-          <a:xfrm>
-            <a:off x="548640" y="6492240"/>
-            <a:ext cx="7315200" cy="274320"/>
-          </a:xfrm>
-          <a:prstGeom prst="rect">
-            <a:avLst/>
-          </a:prstGeom>
-          <a:noFill/>
-          <a:ln/>
-        </p:spPr>
-        <p:txBody>
-          <a:bodyPr wrap="square" lIns="0" tIns="0" rIns="0" bIns="0" rtlCol="0" anchor="ctr"/>
-          <a:lstStyle/>
-          <a:p>
-            <a:pPr indent="0" marL="0">
-              <a:buNone/>
-            </a:pPr>
-            <a:r>
-              <a:rPr lang="en-US" sz="900" dirty="0">
-                <a:solidFill>
-                  <a:srgbClr val="6B7280"/>
-                </a:solidFill>
-                <a:latin typeface="맑은 고딕" pitchFamily="34" charset="0"/>
-                <a:ea typeface="맑은 고딕" pitchFamily="34" charset="-122"/>
-                <a:cs typeface="맑은 고딕" pitchFamily="34" charset="-120"/>
-              </a:rPr>
-              <a:t>베스트 상품 리포트  ·  생성 2026-05-27 08:00</a:t>
+              <a:t>베스트 상품 리포트  ·  생성 2026-05-28 08:00</a:t>
             </a:r>
             <a:endParaRPr lang="en-US" sz="900" dirty="0"/>
           </a:p>
@@ -13769,7 +13769,7 @@
                 <a:ea typeface="맑은 고딕" pitchFamily="34" charset="-122"/>
                 <a:cs typeface="맑은 고딕" pitchFamily="34" charset="-120"/>
               </a:rPr>
-              <a:t>2026년 05월 27일 (수)</a:t>
+              <a:t>2026년 05월 28일 (목)</a:t>
             </a:r>
             <a:endParaRPr lang="en-US" sz="1200" dirty="0"/>
           </a:p>
@@ -13897,7 +13897,7 @@
                 <a:ea typeface="맑은 고딕" pitchFamily="34" charset="-122"/>
                 <a:cs typeface="맑은 고딕" pitchFamily="34" charset="-120"/>
               </a:rPr>
-              <a:t>🚨  긴급 리오더 71건    ·    주의 리오더 12건    ·    오늘 발주 검토 필수</a:t>
+              <a:t>🚨  긴급 리오더 75건    ·    주의 리오더 12건    ·    오늘 발주 검토 필수</a:t>
             </a:r>
             <a:pPr indent="0" marL="0">
               <a:buNone/>
@@ -14527,7 +14527,7 @@
                           <a:ea typeface="맑은 고딕" pitchFamily="34" charset="-122"/>
                           <a:cs typeface="맑은 고딕" pitchFamily="34" charset="-120"/>
                         </a:rPr>
-                        <a:t>CT</a:t>
+                        <a:t>PR</a:t>
                       </a:r>
                       <a:endParaRPr lang="en-US" sz="1100" dirty="0">
                         <a:latin typeface="맑은 고딕" charset="0"/>
@@ -14595,7 +14595,7 @@
                           <a:ea typeface="맑은 고딕" pitchFamily="34" charset="-122"/>
                           <a:cs typeface="맑은 고딕" pitchFamily="34" charset="-120"/>
                         </a:rPr>
-                        <a:t>Necklace</a:t>
+                        <a:t>ETC</a:t>
                       </a:r>
                       <a:endParaRPr lang="en-US" sz="1000" dirty="0">
                         <a:latin typeface="맑은 고딕" charset="0"/>
@@ -14663,7 +14663,7 @@
                           <a:ea typeface="맑은 고딕" pitchFamily="34" charset="-122"/>
                           <a:cs typeface="맑은 고딕" pitchFamily="34" charset="-120"/>
                         </a:rPr>
-                        <a:t>CandyPOP Necklace (사이즈: 2size (47~52cm))</a:t>
+                        <a:t>Flower Keychain (6color) (컬러: 피치)</a:t>
                       </a:r>
                       <a:endParaRPr lang="en-US" sz="1100" dirty="0">
                         <a:latin typeface="맑은 고딕" charset="0"/>
@@ -14799,7 +14799,7 @@
                           <a:ea typeface="맑은 고딕" pitchFamily="34" charset="-122"/>
                           <a:cs typeface="맑은 고딕" pitchFamily="34" charset="-120"/>
                         </a:rPr>
-                        <a:t>1565 개</a:t>
+                        <a:t>100 개</a:t>
                       </a:r>
                       <a:endParaRPr lang="en-US" sz="1100" dirty="0">
                         <a:latin typeface="맑은 고딕" charset="0"/>
@@ -14937,7 +14937,7 @@
                           <a:ea typeface="맑은 고딕" pitchFamily="34" charset="-122"/>
                           <a:cs typeface="맑은 고딕" pitchFamily="34" charset="-120"/>
                         </a:rPr>
-                        <a:t>6A</a:t>
+                        <a:t>PR</a:t>
                       </a:r>
                       <a:endParaRPr lang="en-US" sz="1100" dirty="0">
                         <a:latin typeface="맑은 고딕" charset="0"/>
@@ -15005,7 +15005,7 @@
                           <a:ea typeface="맑은 고딕" pitchFamily="34" charset="-122"/>
                           <a:cs typeface="맑은 고딕" pitchFamily="34" charset="-120"/>
                         </a:rPr>
-                        <a:t>Ring</a:t>
+                        <a:t>ETC</a:t>
                       </a:r>
                       <a:endParaRPr lang="en-US" sz="1000" dirty="0">
                         <a:latin typeface="맑은 고딕" charset="0"/>
@@ -15073,7 +15073,7 @@
                           <a:ea typeface="맑은 고딕" pitchFamily="34" charset="-122"/>
                           <a:cs typeface="맑은 고딕" pitchFamily="34" charset="-120"/>
                         </a:rPr>
-                        <a:t>[SILVER925] Vearl Open Ring</a:t>
+                        <a:t>1+1 Silk Scrunch (9color) (A 컬러: 레드 / B 컬러: 그린)</a:t>
                       </a:r>
                       <a:endParaRPr lang="en-US" sz="1100" dirty="0">
                         <a:latin typeface="맑은 고딕" charset="0"/>
@@ -15141,7 +15141,7 @@
                           <a:ea typeface="맑은 고딕" pitchFamily="34" charset="-122"/>
                           <a:cs typeface="맑은 고딕" pitchFamily="34" charset="-120"/>
                         </a:rPr>
-                        <a:t>5</a:t>
+                        <a:t>19</a:t>
                       </a:r>
                       <a:endParaRPr lang="en-US" sz="1100" dirty="0">
                         <a:latin typeface="맑은 고딕" charset="0"/>
@@ -15209,7 +15209,7 @@
                           <a:ea typeface="맑은 고딕" pitchFamily="34" charset="-122"/>
                           <a:cs typeface="맑은 고딕" pitchFamily="34" charset="-120"/>
                         </a:rPr>
-                        <a:t>5 개</a:t>
+                        <a:t>51 개</a:t>
                       </a:r>
                       <a:endParaRPr lang="en-US" sz="1100" dirty="0">
                         <a:latin typeface="맑은 고딕" charset="0"/>
@@ -15415,7 +15415,7 @@
                           <a:ea typeface="맑은 고딕" pitchFamily="34" charset="-122"/>
                           <a:cs typeface="맑은 고딕" pitchFamily="34" charset="-120"/>
                         </a:rPr>
-                        <a:t>ELECTRONIC</a:t>
+                        <a:t>ETC</a:t>
                       </a:r>
                       <a:endParaRPr lang="en-US" sz="1000" dirty="0">
                         <a:latin typeface="맑은 고딕" charset="0"/>
@@ -15483,7 +15483,7 @@
                           <a:ea typeface="맑은 고딕" pitchFamily="34" charset="-122"/>
                           <a:cs typeface="맑은 고딕" pitchFamily="34" charset="-120"/>
                         </a:rPr>
-                        <a:t>Jacquard Fast Charging Cable (7color) (컬러: 민트 / 기종옵션: C-Apple 8pin / 길이: 2m)</a:t>
+                        <a:t>1+1 Silk Scrunch (9color) (A 컬러: 그린 / B 컬러: 레드)</a:t>
                       </a:r>
                       <a:endParaRPr lang="en-US" sz="1100" dirty="0">
                         <a:latin typeface="맑은 고딕" charset="0"/>
@@ -15551,7 +15551,7 @@
                           <a:ea typeface="맑은 고딕" pitchFamily="34" charset="-122"/>
                           <a:cs typeface="맑은 고딕" pitchFamily="34" charset="-120"/>
                         </a:rPr>
-                        <a:t>15</a:t>
+                        <a:t>19</a:t>
                       </a:r>
                       <a:endParaRPr lang="en-US" sz="1100" dirty="0">
                         <a:latin typeface="맑은 고딕" charset="0"/>
@@ -15619,7 +15619,7 @@
                           <a:ea typeface="맑은 고딕" pitchFamily="34" charset="-122"/>
                           <a:cs typeface="맑은 고딕" pitchFamily="34" charset="-120"/>
                         </a:rPr>
-                        <a:t>2 개</a:t>
+                        <a:t>45 개</a:t>
                       </a:r>
                       <a:endParaRPr lang="en-US" sz="1100" dirty="0">
                         <a:latin typeface="맑은 고딕" charset="0"/>
@@ -15757,7 +15757,7 @@
                           <a:ea typeface="맑은 고딕" pitchFamily="34" charset="-122"/>
                           <a:cs typeface="맑은 고딕" pitchFamily="34" charset="-120"/>
                         </a:rPr>
-                        <a:t>6A</a:t>
+                        <a:t>PR</a:t>
                       </a:r>
                       <a:endParaRPr lang="en-US" sz="1100" dirty="0">
                         <a:latin typeface="맑은 고딕" charset="0"/>
@@ -15825,7 +15825,7 @@
                           <a:ea typeface="맑은 고딕" pitchFamily="34" charset="-122"/>
                           <a:cs typeface="맑은 고딕" pitchFamily="34" charset="-120"/>
                         </a:rPr>
-                        <a:t>Ring</a:t>
+                        <a:t>ETC</a:t>
                       </a:r>
                       <a:endParaRPr lang="en-US" sz="1000" dirty="0">
                         <a:latin typeface="맑은 고딕" charset="0"/>
@@ -15893,7 +15893,7 @@
                           <a:ea typeface="맑은 고딕" pitchFamily="34" charset="-122"/>
                           <a:cs typeface="맑은 고딕" pitchFamily="34" charset="-120"/>
                         </a:rPr>
-                        <a:t>[SILVER925] Flowy Open Ring</a:t>
+                        <a:t>Basic Toliet Slippers (6color) (컬러: 민트 / 사이즈: Free Size 230~270)</a:t>
                       </a:r>
                       <a:endParaRPr lang="en-US" sz="1100" dirty="0">
                         <a:latin typeface="맑은 고딕" charset="0"/>
@@ -15961,7 +15961,7 @@
                           <a:ea typeface="맑은 고딕" pitchFamily="34" charset="-122"/>
                           <a:cs typeface="맑은 고딕" pitchFamily="34" charset="-120"/>
                         </a:rPr>
-                        <a:t>4</a:t>
+                        <a:t>0</a:t>
                       </a:r>
                       <a:endParaRPr lang="en-US" sz="1100" dirty="0">
                         <a:latin typeface="맑은 고딕" charset="0"/>
@@ -16029,7 +16029,7 @@
                           <a:ea typeface="맑은 고딕" pitchFamily="34" charset="-122"/>
                           <a:cs typeface="맑은 고딕" pitchFamily="34" charset="-120"/>
                         </a:rPr>
-                        <a:t>1 개</a:t>
+                        <a:t>21 개</a:t>
                       </a:r>
                       <a:endParaRPr lang="en-US" sz="1100" dirty="0">
                         <a:latin typeface="맑은 고딕" charset="0"/>
@@ -16167,7 +16167,7 @@
                           <a:ea typeface="맑은 고딕" pitchFamily="34" charset="-122"/>
                           <a:cs typeface="맑은 고딕" pitchFamily="34" charset="-120"/>
                         </a:rPr>
-                        <a:t>CT</a:t>
+                        <a:t>PR</a:t>
                       </a:r>
                       <a:endParaRPr lang="en-US" sz="1100" dirty="0">
                         <a:latin typeface="맑은 고딕" charset="0"/>
@@ -16235,7 +16235,7 @@
                           <a:ea typeface="맑은 고딕" pitchFamily="34" charset="-122"/>
                           <a:cs typeface="맑은 고딕" pitchFamily="34" charset="-120"/>
                         </a:rPr>
-                        <a:t>Necklace</a:t>
+                        <a:t>ETC</a:t>
                       </a:r>
                       <a:endParaRPr lang="en-US" sz="1000" dirty="0">
                         <a:latin typeface="맑은 고딕" charset="0"/>
@@ -16303,7 +16303,7 @@
                           <a:ea typeface="맑은 고딕" pitchFamily="34" charset="-122"/>
                           <a:cs typeface="맑은 고딕" pitchFamily="34" charset="-120"/>
                         </a:rPr>
-                        <a:t>DBLfix Necklace</a:t>
+                        <a:t>1+1 Silk Scrunch (9color) (A 컬러: 레드 / B 컬러: 레드)</a:t>
                       </a:r>
                       <a:endParaRPr lang="en-US" sz="1100" dirty="0">
                         <a:latin typeface="맑은 고딕" charset="0"/>
@@ -16371,7 +16371,7 @@
                           <a:ea typeface="맑은 고딕" pitchFamily="34" charset="-122"/>
                           <a:cs typeface="맑은 고딕" pitchFamily="34" charset="-120"/>
                         </a:rPr>
-                        <a:t>4</a:t>
+                        <a:t>19</a:t>
                       </a:r>
                       <a:endParaRPr lang="en-US" sz="1100" dirty="0">
                         <a:latin typeface="맑은 고딕" charset="0"/>
@@ -16439,7 +16439,7 @@
                           <a:ea typeface="맑은 고딕" pitchFamily="34" charset="-122"/>
                           <a:cs typeface="맑은 고딕" pitchFamily="34" charset="-120"/>
                         </a:rPr>
-                        <a:t>1 개</a:t>
+                        <a:t>8 개</a:t>
                       </a:r>
                       <a:endParaRPr lang="en-US" sz="1100" dirty="0">
                         <a:latin typeface="맑은 고딕" charset="0"/>
@@ -16645,7 +16645,7 @@
                           <a:ea typeface="맑은 고딕" pitchFamily="34" charset="-122"/>
                           <a:cs typeface="맑은 고딕" pitchFamily="34" charset="-120"/>
                         </a:rPr>
-                        <a:t>ETC</a:t>
+                        <a:t>ELECTRONIC</a:t>
                       </a:r>
                       <a:endParaRPr lang="en-US" sz="1000" dirty="0">
                         <a:latin typeface="맑은 고딕" charset="0"/>
@@ -16713,7 +16713,7 @@
                           <a:ea typeface="맑은 고딕" pitchFamily="34" charset="-122"/>
                           <a:cs typeface="맑은 고딕" pitchFamily="34" charset="-120"/>
                         </a:rPr>
-                        <a:t>360° Rotating Phone Holder (컬러: 블랙)</a:t>
+                        <a:t>Jacquard Fast Charging Cable (7color) (컬러: 민트 / 기종옵션: C-Apple 8pin / 길이: 2m)</a:t>
                       </a:r>
                       <a:endParaRPr lang="en-US" sz="1100" dirty="0">
                         <a:latin typeface="맑은 고딕" charset="0"/>
@@ -16781,7 +16781,7 @@
                           <a:ea typeface="맑은 고딕" pitchFamily="34" charset="-122"/>
                           <a:cs typeface="맑은 고딕" pitchFamily="34" charset="-120"/>
                         </a:rPr>
-                        <a:t>16</a:t>
+                        <a:t>8</a:t>
                       </a:r>
                       <a:endParaRPr lang="en-US" sz="1100" dirty="0">
                         <a:latin typeface="맑은 고딕" charset="0"/>
@@ -16849,7 +16849,7 @@
                           <a:ea typeface="맑은 고딕" pitchFamily="34" charset="-122"/>
                           <a:cs typeface="맑은 고딕" pitchFamily="34" charset="-120"/>
                         </a:rPr>
-                        <a:t>1 개</a:t>
+                        <a:t>7 개</a:t>
                       </a:r>
                       <a:endParaRPr lang="en-US" sz="1100" dirty="0">
                         <a:latin typeface="맑은 고딕" charset="0"/>
@@ -17123,7 +17123,7 @@
                           <a:ea typeface="맑은 고딕" pitchFamily="34" charset="-122"/>
                           <a:cs typeface="맑은 고딕" pitchFamily="34" charset="-120"/>
                         </a:rPr>
-                        <a:t>Cotton Lunch Mini Bag (5color) (색상: 아이보리)</a:t>
+                        <a:t>Fuzzy Stripe Slippers (3color) (컬러: 그린 / 사이즈: 240~250(여성))</a:t>
                       </a:r>
                       <a:endParaRPr lang="en-US" sz="1100" dirty="0">
                         <a:latin typeface="맑은 고딕" charset="0"/>
@@ -17191,7 +17191,7 @@
                           <a:ea typeface="맑은 고딕" pitchFamily="34" charset="-122"/>
                           <a:cs typeface="맑은 고딕" pitchFamily="34" charset="-120"/>
                         </a:rPr>
-                        <a:t>18</a:t>
+                        <a:t>0</a:t>
                       </a:r>
                       <a:endParaRPr lang="en-US" sz="1100" dirty="0">
                         <a:latin typeface="맑은 고딕" charset="0"/>
@@ -17259,7 +17259,7 @@
                           <a:ea typeface="맑은 고딕" pitchFamily="34" charset="-122"/>
                           <a:cs typeface="맑은 고딕" pitchFamily="34" charset="-120"/>
                         </a:rPr>
-                        <a:t>1 개</a:t>
+                        <a:t>4 개</a:t>
                       </a:r>
                       <a:endParaRPr lang="en-US" sz="1100" dirty="0">
                         <a:latin typeface="맑은 고딕" charset="0"/>
@@ -17397,7 +17397,7 @@
                           <a:ea typeface="맑은 고딕" pitchFamily="34" charset="-122"/>
                           <a:cs typeface="맑은 고딕" pitchFamily="34" charset="-120"/>
                         </a:rPr>
-                        <a:t>PR</a:t>
+                        <a:t>6A</a:t>
                       </a:r>
                       <a:endParaRPr lang="en-US" sz="1100" dirty="0">
                         <a:latin typeface="맑은 고딕" charset="0"/>
@@ -17465,7 +17465,7 @@
                           <a:ea typeface="맑은 고딕" pitchFamily="34" charset="-122"/>
                           <a:cs typeface="맑은 고딕" pitchFamily="34" charset="-120"/>
                         </a:rPr>
-                        <a:t>ETC</a:t>
+                        <a:t>Ring</a:t>
                       </a:r>
                       <a:endParaRPr lang="en-US" sz="1000" dirty="0">
                         <a:latin typeface="맑은 고딕" charset="0"/>
@@ -17533,7 +17533,7 @@
                           <a:ea typeface="맑은 고딕" pitchFamily="34" charset="-122"/>
                           <a:cs typeface="맑은 고딕" pitchFamily="34" charset="-120"/>
                         </a:rPr>
-                        <a:t>360° Rotating Phone Holder (컬러: 화이트)</a:t>
+                        <a:t>[SILVER925] Flowy Open Ring</a:t>
                       </a:r>
                       <a:endParaRPr lang="en-US" sz="1100" dirty="0">
                         <a:latin typeface="맑은 고딕" charset="0"/>
@@ -17601,7 +17601,7 @@
                           <a:ea typeface="맑은 고딕" pitchFamily="34" charset="-122"/>
                           <a:cs typeface="맑은 고딕" pitchFamily="34" charset="-120"/>
                         </a:rPr>
-                        <a:t>9</a:t>
+                        <a:t>3</a:t>
                       </a:r>
                       <a:endParaRPr lang="en-US" sz="1100" dirty="0">
                         <a:latin typeface="맑은 고딕" charset="0"/>
@@ -17807,7 +17807,7 @@
                           <a:ea typeface="맑은 고딕" pitchFamily="34" charset="-122"/>
                           <a:cs typeface="맑은 고딕" pitchFamily="34" charset="-120"/>
                         </a:rPr>
-                        <a:t>PR</a:t>
+                        <a:t>CT</a:t>
                       </a:r>
                       <a:endParaRPr lang="en-US" sz="1100" dirty="0">
                         <a:latin typeface="맑은 고딕" charset="0"/>
@@ -17875,7 +17875,7 @@
                           <a:ea typeface="맑은 고딕" pitchFamily="34" charset="-122"/>
                           <a:cs typeface="맑은 고딕" pitchFamily="34" charset="-120"/>
                         </a:rPr>
-                        <a:t>ELECTRONIC</a:t>
+                        <a:t>Ring</a:t>
                       </a:r>
                       <a:endParaRPr lang="en-US" sz="1000" dirty="0">
                         <a:latin typeface="맑은 고딕" charset="0"/>
@@ -17943,7 +17943,7 @@
                           <a:ea typeface="맑은 고딕" pitchFamily="34" charset="-122"/>
                           <a:cs typeface="맑은 고딕" pitchFamily="34" charset="-120"/>
                         </a:rPr>
-                        <a:t>Jacquard Fast Charging Cable (7color) (컬러: 퍼플 / 기종옵션: C-Apple 8pin / 길이: 2m)</a:t>
+                        <a:t>"ATOR" 925 Open Ring</a:t>
                       </a:r>
                       <a:endParaRPr lang="en-US" sz="1100" dirty="0">
                         <a:latin typeface="맑은 고딕" charset="0"/>
@@ -18011,7 +18011,7 @@
                           <a:ea typeface="맑은 고딕" pitchFamily="34" charset="-122"/>
                           <a:cs typeface="맑은 고딕" pitchFamily="34" charset="-120"/>
                         </a:rPr>
-                        <a:t>7</a:t>
+                        <a:t>5</a:t>
                       </a:r>
                       <a:endParaRPr lang="en-US" sz="1100" dirty="0">
                         <a:latin typeface="맑은 고딕" charset="0"/>
@@ -18168,7 +18168,7 @@
                 <a:ea typeface="맑은 고딕" pitchFamily="34" charset="-122"/>
                 <a:cs typeface="맑은 고딕" pitchFamily="34" charset="-120"/>
               </a:rPr>
-              <a:t>외 62건 더 있음 — 상세는 시트에서 확인</a:t>
+              <a:t>외 66건 더 있음 — 상세는 시트에서 확인</a:t>
             </a:r>
             <a:endParaRPr lang="en-US" sz="1000" dirty="0"/>
           </a:p>
@@ -18207,7 +18207,7 @@
                 <a:ea typeface="맑은 고딕" pitchFamily="34" charset="-122"/>
                 <a:cs typeface="맑은 고딕" pitchFamily="34" charset="-120"/>
               </a:rPr>
-              <a:t>베스트 상품 리포트  ·  생성 2026-05-27 08:00</a:t>
+              <a:t>베스트 상품 리포트  ·  생성 2026-05-28 08:00</a:t>
             </a:r>
             <a:endParaRPr lang="en-US" sz="900" dirty="0"/>
           </a:p>
@@ -18420,7 +18420,7 @@
                 <a:ea typeface="맑은 고딕" pitchFamily="34" charset="-122"/>
                 <a:cs typeface="맑은 고딕" pitchFamily="34" charset="-120"/>
               </a:rPr>
-              <a:t>2026년 05월 27일 (수)</a:t>
+              <a:t>2026년 05월 28일 (목)</a:t>
             </a:r>
             <a:endParaRPr lang="en-US" sz="1200" dirty="0"/>
           </a:p>
@@ -18587,7 +18587,7 @@
                 <a:ea typeface="맑은 고딕" pitchFamily="34" charset="-122"/>
                 <a:cs typeface="맑은 고딕" pitchFamily="34" charset="-120"/>
               </a:rPr>
-              <a:t>Google Sheet '브랜드 재고현황'  ·  최신화 2026-05-27 08:00</a:t>
+              <a:t>Google Sheet '브랜드 재고현황'  ·  최신화 2026-05-28 08:00</a:t>
             </a:r>
             <a:endParaRPr lang="en-US" sz="1100" dirty="0"/>
           </a:p>
@@ -19099,7 +19099,7 @@
                 <a:ea typeface="맑은 고딕" pitchFamily="34" charset="-122"/>
                 <a:cs typeface="맑은 고딕" pitchFamily="34" charset="-120"/>
               </a:rPr>
-              <a:t>✅ 6A 85 SKU  /  ✅ Cleartype 59 SKU  /  ✅ Produktepr 198 SKU (판매 수집됨)</a:t>
+              <a:t>✅ 6A 86 SKU  /  ✅ Cleartype 59 SKU  /  ✅ Produktepr 200 SKU (판매 수집됨)</a:t>
             </a:r>
             <a:endParaRPr lang="en-US" sz="1100" dirty="0"/>
           </a:p>
@@ -19230,7 +19230,7 @@
                 <a:ea typeface="맑은 고딕" pitchFamily="34" charset="-122"/>
                 <a:cs typeface="맑은 고딕" pitchFamily="34" charset="-120"/>
               </a:rPr>
-              <a:t>✅ 3개 브랜드 모두 정상 추출  ·  24h 출고 기준 (2026-05-26 08:00 → 2026-05-27 08:00) · 신규 SKU 18건은 결제완료 기준</a:t>
+              <a:t>✅ 3개 브랜드 모두 정상 추출  ·  24h 출고 기준 (2026-05-27 08:00 → 2026-05-28 08:00) · 신규 SKU 16건은 결제완료 기준</a:t>
             </a:r>
             <a:endParaRPr lang="en-US" sz="1000" dirty="0"/>
           </a:p>
@@ -19269,7 +19269,7 @@
                 <a:ea typeface="맑은 고딕" pitchFamily="34" charset="-122"/>
                 <a:cs typeface="맑은 고딕" pitchFamily="34" charset="-120"/>
               </a:rPr>
-              <a:t>베스트 상품 리포트  ·  생성 2026-05-27 08:00</a:t>
+              <a:t>베스트 상품 리포트  ·  생성 2026-05-28 08:00</a:t>
             </a:r>
             <a:endParaRPr lang="en-US" sz="900" dirty="0"/>
           </a:p>

</xml_diff>

<commit_message>
chore: 매출 PPT 업로드 (best-sellers-2026-05-29.pptx) [auto]
</commit_message>
<xml_diff>
--- a/data/sales-report.pptx
+++ b/data/sales-report.pptx
@@ -1648,7 +1648,7 @@
                 <a:ea typeface="맑은 고딕" pitchFamily="34" charset="-122"/>
                 <a:cs typeface="맑은 고딕" pitchFamily="34" charset="-120"/>
               </a:rPr>
-              <a:t>2026년 05월 28일 (목)  ·  24h 출고 기준</a:t>
+              <a:t>2026년 05월 29일 (금)  ·  24h 출고 기준</a:t>
             </a:r>
             <a:endParaRPr lang="en-US" sz="2200" dirty="0"/>
           </a:p>
@@ -1726,7 +1726,7 @@
                 <a:ea typeface="맑은 고딕" pitchFamily="34" charset="-122"/>
                 <a:cs typeface="맑은 고딕" pitchFamily="34" charset="-120"/>
               </a:rPr>
-              <a:t>05.28</a:t>
+              <a:t>05.29</a:t>
             </a:r>
             <a:endParaRPr lang="en-US" sz="7200" dirty="0"/>
           </a:p>
@@ -1765,7 +1765,7 @@
                 <a:ea typeface="맑은 고딕" pitchFamily="34" charset="-122"/>
                 <a:cs typeface="맑은 고딕" pitchFamily="34" charset="-120"/>
               </a:rPr>
-              <a:t>목요일</a:t>
+              <a:t>금요일</a:t>
             </a:r>
             <a:endParaRPr lang="en-US" sz="1400" dirty="0"/>
           </a:p>
@@ -1804,7 +1804,7 @@
                 <a:ea typeface="맑은 고딕" pitchFamily="34" charset="-122"/>
                 <a:cs typeface="맑은 고딕" pitchFamily="34" charset="-120"/>
               </a:rPr>
-              <a:t>생성 2026-05-28 08:00  ·  Google Sheet 자동 동기</a:t>
+              <a:t>생성 2026-05-29 08:00  ·  Google Sheet 자동 동기</a:t>
             </a:r>
             <a:endParaRPr lang="en-US" sz="1000" dirty="0"/>
           </a:p>
@@ -1978,7 +1978,7 @@
                 <a:ea typeface="맑은 고딕" pitchFamily="34" charset="-122"/>
                 <a:cs typeface="맑은 고딕" pitchFamily="34" charset="-120"/>
               </a:rPr>
-              <a:t>2026년 05월 28일 (목)</a:t>
+              <a:t>2026년 05월 29일 (금)</a:t>
             </a:r>
             <a:endParaRPr lang="en-US" sz="1200" dirty="0"/>
           </a:p>
@@ -2145,7 +2145,7 @@
                 <a:ea typeface="맑은 고딕" pitchFamily="34" charset="-122"/>
                 <a:cs typeface="맑은 고딕" pitchFamily="34" charset="-120"/>
               </a:rPr>
-              <a:t>327 개</a:t>
+              <a:t>376 개</a:t>
             </a:r>
             <a:endParaRPr lang="en-US" sz="3600" dirty="0"/>
           </a:p>
@@ -2312,7 +2312,7 @@
                 <a:ea typeface="맑은 고딕" pitchFamily="34" charset="-122"/>
                 <a:cs typeface="맑은 고딕" pitchFamily="34" charset="-120"/>
               </a:rPr>
-              <a:t>75 건</a:t>
+              <a:t>67 건</a:t>
             </a:r>
             <a:endParaRPr lang="en-US" sz="3200" dirty="0"/>
           </a:p>
@@ -2685,7 +2685,7 @@
                 <a:ea typeface="맑은 고딕" pitchFamily="34" charset="-122"/>
                 <a:cs typeface="맑은 고딕" pitchFamily="34" charset="-120"/>
               </a:rPr>
-              <a:t>86 SKU  ·  판매 OK</a:t>
+              <a:t>88 SKU  ·  판매 OK</a:t>
             </a:r>
             <a:pPr indent="0" marL="0">
               <a:buNone/>
@@ -3677,7 +3677,7 @@
                           <a:ea typeface="맑은 고딕" pitchFamily="34" charset="-122"/>
                           <a:cs typeface="맑은 고딕" pitchFamily="34" charset="-120"/>
                         </a:rPr>
-                        <a:t>44 개</a:t>
+                        <a:t>60 개</a:t>
                       </a:r>
                       <a:endParaRPr lang="en-US" sz="1400" dirty="0">
                         <a:latin typeface="맑은 고딕" charset="0"/>
@@ -4004,7 +4004,7 @@
                           <a:ea typeface="맑은 고딕" pitchFamily="34" charset="-122"/>
                           <a:cs typeface="맑은 고딕" pitchFamily="34" charset="-120"/>
                         </a:rPr>
-                        <a:t>39 개</a:t>
+                        <a:t>35 개</a:t>
                       </a:r>
                       <a:endParaRPr lang="en-US" sz="1400" dirty="0">
                         <a:latin typeface="맑은 고딕" charset="0"/>
@@ -4136,7 +4136,7 @@
                           <a:ea typeface="맑은 고딕" pitchFamily="34" charset="-122"/>
                           <a:cs typeface="맑은 고딕" pitchFamily="34" charset="-120"/>
                         </a:rPr>
-                        <a:t>6A</a:t>
+                        <a:t>CT</a:t>
                       </a:r>
                       <a:endParaRPr lang="en-US" sz="1100" dirty="0">
                         <a:latin typeface="맑은 고딕" charset="0"/>
@@ -4201,7 +4201,7 @@
                           <a:ea typeface="맑은 고딕" pitchFamily="34" charset="-122"/>
                           <a:cs typeface="맑은 고딕" pitchFamily="34" charset="-120"/>
                         </a:rPr>
-                        <a:t>Ring</a:t>
+                        <a:t>Necklace</a:t>
                       </a:r>
                       <a:endParaRPr lang="en-US" sz="1000" dirty="0">
                         <a:latin typeface="맑은 고딕" charset="0"/>
@@ -4266,7 +4266,7 @@
                           <a:ea typeface="맑은 고딕" pitchFamily="34" charset="-122"/>
                           <a:cs typeface="맑은 고딕" pitchFamily="34" charset="-120"/>
                         </a:rPr>
-                        <a:t>[SILVER925] Eramam Open Ring</a:t>
+                        <a:t>ThreadDuo Necklace</a:t>
                       </a:r>
                       <a:endParaRPr lang="en-US" sz="1100" dirty="0">
                         <a:latin typeface="맑은 고딕" charset="0"/>
@@ -4331,7 +4331,7 @@
                           <a:ea typeface="맑은 고딕" pitchFamily="34" charset="-122"/>
                           <a:cs typeface="맑은 고딕" pitchFamily="34" charset="-120"/>
                         </a:rPr>
-                        <a:t>23 개</a:t>
+                        <a:t>15 개</a:t>
                       </a:r>
                       <a:endParaRPr lang="en-US" sz="1400" dirty="0">
                         <a:latin typeface="맑은 고딕" charset="0"/>
@@ -4463,7 +4463,7 @@
                           <a:ea typeface="맑은 고딕" pitchFamily="34" charset="-122"/>
                           <a:cs typeface="맑은 고딕" pitchFamily="34" charset="-120"/>
                         </a:rPr>
-                        <a:t>CT</a:t>
+                        <a:t>6A</a:t>
                       </a:r>
                       <a:endParaRPr lang="en-US" sz="1100" dirty="0">
                         <a:latin typeface="맑은 고딕" charset="0"/>
@@ -4528,7 +4528,7 @@
                           <a:ea typeface="맑은 고딕" pitchFamily="34" charset="-122"/>
                           <a:cs typeface="맑은 고딕" pitchFamily="34" charset="-120"/>
                         </a:rPr>
-                        <a:t>Necklace</a:t>
+                        <a:t>Ring</a:t>
                       </a:r>
                       <a:endParaRPr lang="en-US" sz="1000" dirty="0">
                         <a:latin typeface="맑은 고딕" charset="0"/>
@@ -4593,7 +4593,7 @@
                           <a:ea typeface="맑은 고딕" pitchFamily="34" charset="-122"/>
                           <a:cs typeface="맑은 고딕" pitchFamily="34" charset="-120"/>
                         </a:rPr>
-                        <a:t>ThreadDuo Necklace</a:t>
+                        <a:t>[SILVER925] Starly Open Ring</a:t>
                       </a:r>
                       <a:endParaRPr lang="en-US" sz="1100" dirty="0">
                         <a:latin typeface="맑은 고딕" charset="0"/>
@@ -4658,7 +4658,7 @@
                           <a:ea typeface="맑은 고딕" pitchFamily="34" charset="-122"/>
                           <a:cs typeface="맑은 고딕" pitchFamily="34" charset="-120"/>
                         </a:rPr>
-                        <a:t>18 개</a:t>
+                        <a:t>13 개</a:t>
                       </a:r>
                       <a:endParaRPr lang="en-US" sz="1200" dirty="0">
                         <a:latin typeface="맑은 고딕" charset="0"/>
@@ -4790,7 +4790,7 @@
                           <a:ea typeface="맑은 고딕" pitchFamily="34" charset="-122"/>
                           <a:cs typeface="맑은 고딕" pitchFamily="34" charset="-120"/>
                         </a:rPr>
-                        <a:t>6A</a:t>
+                        <a:t>CT</a:t>
                       </a:r>
                       <a:endParaRPr lang="en-US" sz="1100" dirty="0">
                         <a:latin typeface="맑은 고딕" charset="0"/>
@@ -4920,7 +4920,7 @@
                           <a:ea typeface="맑은 고딕" pitchFamily="34" charset="-122"/>
                           <a:cs typeface="맑은 고딕" pitchFamily="34" charset="-120"/>
                         </a:rPr>
-                        <a:t>[SILVER925] Cstic Open Ring</a:t>
+                        <a:t>"4s" 925 Open Ring (사이즈: 남성)</a:t>
                       </a:r>
                       <a:endParaRPr lang="en-US" sz="1100" dirty="0">
                         <a:latin typeface="맑은 고딕" charset="0"/>
@@ -4985,7 +4985,7 @@
                           <a:ea typeface="맑은 고딕" pitchFamily="34" charset="-122"/>
                           <a:cs typeface="맑은 고딕" pitchFamily="34" charset="-120"/>
                         </a:rPr>
-                        <a:t>14 개</a:t>
+                        <a:t>13 개</a:t>
                       </a:r>
                       <a:endParaRPr lang="en-US" sz="1200" dirty="0">
                         <a:latin typeface="맑은 고딕" charset="0"/>
@@ -5071,7 +5071,7 @@
                 <a:ea typeface="맑은 고딕" pitchFamily="34" charset="-122"/>
                 <a:cs typeface="맑은 고딕" pitchFamily="34" charset="-120"/>
               </a:rPr>
-              <a:t>베스트 상품 리포트  ·  생성 2026-05-28 08:00</a:t>
+              <a:t>베스트 상품 리포트  ·  생성 2026-05-29 08:00</a:t>
             </a:r>
             <a:endParaRPr lang="en-US" sz="900" dirty="0"/>
           </a:p>
@@ -5284,7 +5284,7 @@
                 <a:ea typeface="맑은 고딕" pitchFamily="34" charset="-122"/>
                 <a:cs typeface="맑은 고딕" pitchFamily="34" charset="-120"/>
               </a:rPr>
-              <a:t>2026년 05월 28일 (목)</a:t>
+              <a:t>2026년 05월 29일 (금)</a:t>
             </a:r>
             <a:endParaRPr lang="en-US" sz="1200" dirty="0"/>
           </a:p>
@@ -5451,7 +5451,7 @@
                 <a:ea typeface="맑은 고딕" pitchFamily="34" charset="-122"/>
                 <a:cs typeface="맑은 고딕" pitchFamily="34" charset="-120"/>
               </a:rPr>
-              <a:t>267 개</a:t>
+              <a:t>317 개</a:t>
             </a:r>
             <a:endParaRPr lang="en-US" sz="3600" dirty="0"/>
           </a:p>
@@ -5657,7 +5657,7 @@
                 <a:ea typeface="맑은 고딕" pitchFamily="34" charset="-122"/>
                 <a:cs typeface="맑은 고딕" pitchFamily="34" charset="-120"/>
               </a:rPr>
-              <a:t>44</a:t>
+              <a:t>60</a:t>
             </a:r>
             <a:endParaRPr lang="en-US" sz="4400" dirty="0"/>
           </a:p>
@@ -6256,7 +6256,7 @@
                           <a:ea typeface="맑은 고딕" pitchFamily="34" charset="-122"/>
                           <a:cs typeface="맑은 고딕" pitchFamily="34" charset="-120"/>
                         </a:rPr>
-                        <a:t>44 개</a:t>
+                        <a:t>60 개</a:t>
                       </a:r>
                       <a:endParaRPr lang="en-US" sz="1400" dirty="0">
                         <a:latin typeface="맑은 고딕" charset="0"/>
@@ -6518,7 +6518,7 @@
                           <a:ea typeface="맑은 고딕" pitchFamily="34" charset="-122"/>
                           <a:cs typeface="맑은 고딕" pitchFamily="34" charset="-120"/>
                         </a:rPr>
-                        <a:t>39 개</a:t>
+                        <a:t>35 개</a:t>
                       </a:r>
                       <a:endParaRPr lang="en-US" sz="1200" dirty="0">
                         <a:latin typeface="맑은 고딕" charset="0"/>
@@ -6715,7 +6715,7 @@
                           <a:ea typeface="맑은 고딕" pitchFamily="34" charset="-122"/>
                           <a:cs typeface="맑은 고딕" pitchFamily="34" charset="-120"/>
                         </a:rPr>
-                        <a:t>[SILVER925] Eramam Open Ring</a:t>
+                        <a:t>[SILVER925] Starly Open Ring</a:t>
                       </a:r>
                       <a:endParaRPr lang="en-US" sz="1100" dirty="0">
                         <a:latin typeface="맑은 고딕" charset="0"/>
@@ -6780,7 +6780,7 @@
                           <a:ea typeface="맑은 고딕" pitchFamily="34" charset="-122"/>
                           <a:cs typeface="맑은 고딕" pitchFamily="34" charset="-120"/>
                         </a:rPr>
-                        <a:t>23 개</a:t>
+                        <a:t>13 개</a:t>
                       </a:r>
                       <a:endParaRPr lang="en-US" sz="1200" dirty="0">
                         <a:latin typeface="맑은 고딕" charset="0"/>
@@ -7042,7 +7042,7 @@
                           <a:ea typeface="맑은 고딕" pitchFamily="34" charset="-122"/>
                           <a:cs typeface="맑은 고딕" pitchFamily="34" charset="-120"/>
                         </a:rPr>
-                        <a:t>14 개</a:t>
+                        <a:t>12 개</a:t>
                       </a:r>
                       <a:endParaRPr lang="en-US" sz="1200" dirty="0">
                         <a:latin typeface="맑은 고딕" charset="0"/>
@@ -7239,7 +7239,7 @@
                           <a:ea typeface="맑은 고딕" pitchFamily="34" charset="-122"/>
                           <a:cs typeface="맑은 고딕" pitchFamily="34" charset="-120"/>
                         </a:rPr>
-                        <a:t>[SILVER925] Starly Open Ring</a:t>
+                        <a:t>[SILVER925] A Rua Open Ring</a:t>
                       </a:r>
                       <a:endParaRPr lang="en-US" sz="1100" dirty="0">
                         <a:latin typeface="맑은 고딕" charset="0"/>
@@ -7304,7 +7304,7 @@
                           <a:ea typeface="맑은 고딕" pitchFamily="34" charset="-122"/>
                           <a:cs typeface="맑은 고딕" pitchFamily="34" charset="-120"/>
                         </a:rPr>
-                        <a:t>11 개</a:t>
+                        <a:t>12 개</a:t>
                       </a:r>
                       <a:endParaRPr lang="en-US" sz="1200" dirty="0">
                         <a:latin typeface="맑은 고딕" charset="0"/>
@@ -7390,7 +7390,7 @@
                 <a:ea typeface="맑은 고딕" pitchFamily="34" charset="-122"/>
                 <a:cs typeface="맑은 고딕" pitchFamily="34" charset="-120"/>
               </a:rPr>
-              <a:t>리오더 필요  🔴 긴급 7건</a:t>
+              <a:t>리오더 필요  🔴 긴급 6건</a:t>
             </a:r>
             <a:pPr indent="0" marL="0">
               <a:buNone/>
@@ -7557,7 +7557,7 @@
                 <a:ea typeface="맑은 고딕" pitchFamily="34" charset="-122"/>
                 <a:cs typeface="맑은 고딕" pitchFamily="34" charset="-120"/>
               </a:rPr>
-              <a:t>[SILVER925] Flowy Open Ring</a:t>
+              <a:t>[SILVER925] Crimson Open Ring</a:t>
             </a:r>
             <a:endParaRPr lang="en-US" sz="1100" dirty="0"/>
           </a:p>
@@ -7596,7 +7596,7 @@
                 <a:ea typeface="맑은 고딕" pitchFamily="34" charset="-122"/>
                 <a:cs typeface="맑은 고딕" pitchFamily="34" charset="-120"/>
               </a:rPr>
-              <a:t>Ring  ·  재고 3개</a:t>
+              <a:t>Ring  ·  재고 1개</a:t>
             </a:r>
             <a:pPr indent="0" marL="0">
               <a:buNone/>
@@ -7763,6 +7763,212 @@
                 <a:ea typeface="맑은 고딕" pitchFamily="34" charset="-122"/>
                 <a:cs typeface="맑은 고딕" pitchFamily="34" charset="-120"/>
               </a:rPr>
+              <a:t>[SILVER925] Flowy Open Ring</a:t>
+            </a:r>
+            <a:endParaRPr lang="en-US" sz="1100" dirty="0"/>
+          </a:p>
+        </p:txBody>
+      </p:sp>
+      <p:sp>
+        <p:nvSpPr>
+          <p:cNvPr id="32" name="Text 29"/>
+          <p:cNvSpPr/>
+          <p:nvPr/>
+        </p:nvSpPr>
+        <p:spPr>
+          <a:xfrm>
+            <a:off x="8211312" y="4425696"/>
+            <a:ext cx="3291840" cy="256032"/>
+          </a:xfrm>
+          <a:prstGeom prst="rect">
+            <a:avLst/>
+          </a:prstGeom>
+          <a:noFill/>
+          <a:ln/>
+        </p:spPr>
+        <p:txBody>
+          <a:bodyPr wrap="square" lIns="0" tIns="0" rIns="0" bIns="0" rtlCol="0" anchor="ctr"/>
+          <a:lstStyle/>
+          <a:p>
+            <a:pPr indent="0" marL="0">
+              <a:buNone/>
+            </a:pPr>
+            <a:r>
+              <a:rPr lang="en-US" sz="1000" dirty="0">
+                <a:solidFill>
+                  <a:srgbClr val="6B7280"/>
+                </a:solidFill>
+                <a:latin typeface="맑은 고딕" pitchFamily="34" charset="0"/>
+                <a:ea typeface="맑은 고딕" pitchFamily="34" charset="-122"/>
+                <a:cs typeface="맑은 고딕" pitchFamily="34" charset="-120"/>
+              </a:rPr>
+              <a:t>Ring  ·  재고 2개</a:t>
+            </a:r>
+            <a:pPr indent="0" marL="0">
+              <a:buNone/>
+            </a:pPr>
+            <a:r>
+              <a:rPr lang="en-US" sz="1000" b="1" dirty="0">
+                <a:solidFill>
+                  <a:srgbClr val="D72638"/>
+                </a:solidFill>
+                <a:latin typeface="맑은 고딕" pitchFamily="34" charset="0"/>
+                <a:ea typeface="맑은 고딕" pitchFamily="34" charset="-122"/>
+                <a:cs typeface="맑은 고딕" pitchFamily="34" charset="-120"/>
+              </a:rPr>
+              <a:t/>
+            </a:r>
+            <a:endParaRPr lang="en-US" sz="1000" dirty="0"/>
+          </a:p>
+        </p:txBody>
+      </p:sp>
+      <p:sp>
+        <p:nvSpPr>
+          <p:cNvPr id="33" name="Shape 30"/>
+          <p:cNvSpPr/>
+          <p:nvPr/>
+        </p:nvSpPr>
+        <p:spPr>
+          <a:xfrm>
+            <a:off x="7406640" y="4809744"/>
+            <a:ext cx="4206240" cy="640080"/>
+          </a:xfrm>
+          <a:prstGeom prst="rect">
+            <a:avLst/>
+          </a:prstGeom>
+          <a:solidFill>
+            <a:srgbClr val="FFF5F5"/>
+          </a:solidFill>
+          <a:ln w="6350">
+            <a:solidFill>
+              <a:srgbClr val="E5E7EB"/>
+            </a:solidFill>
+            <a:prstDash val="solid"/>
+          </a:ln>
+        </p:spPr>
+      </p:sp>
+      <p:sp>
+        <p:nvSpPr>
+          <p:cNvPr id="34" name="Shape 31"/>
+          <p:cNvSpPr/>
+          <p:nvPr/>
+        </p:nvSpPr>
+        <p:spPr>
+          <a:xfrm>
+            <a:off x="7406640" y="4809744"/>
+            <a:ext cx="109728" cy="640080"/>
+          </a:xfrm>
+          <a:prstGeom prst="rect">
+            <a:avLst/>
+          </a:prstGeom>
+          <a:solidFill>
+            <a:srgbClr val="D72638"/>
+          </a:solidFill>
+          <a:ln w="12700">
+            <a:solidFill>
+              <a:srgbClr val="D72638"/>
+            </a:solidFill>
+            <a:prstDash val="solid"/>
+          </a:ln>
+        </p:spPr>
+      </p:sp>
+      <p:sp>
+        <p:nvSpPr>
+          <p:cNvPr id="35" name="Shape 32"/>
+          <p:cNvSpPr/>
+          <p:nvPr/>
+        </p:nvSpPr>
+        <p:spPr>
+          <a:xfrm>
+            <a:off x="7571232" y="4901184"/>
+            <a:ext cx="548640" cy="256032"/>
+          </a:xfrm>
+          <a:prstGeom prst="rect">
+            <a:avLst/>
+          </a:prstGeom>
+          <a:solidFill>
+            <a:srgbClr val="D72638"/>
+          </a:solidFill>
+          <a:ln w="12700">
+            <a:solidFill>
+              <a:srgbClr val="D72638"/>
+            </a:solidFill>
+            <a:prstDash val="solid"/>
+          </a:ln>
+        </p:spPr>
+      </p:sp>
+      <p:sp>
+        <p:nvSpPr>
+          <p:cNvPr id="36" name="Text 33"/>
+          <p:cNvSpPr/>
+          <p:nvPr/>
+        </p:nvSpPr>
+        <p:spPr>
+          <a:xfrm>
+            <a:off x="7571232" y="4901184"/>
+            <a:ext cx="548640" cy="256032"/>
+          </a:xfrm>
+          <a:prstGeom prst="rect">
+            <a:avLst/>
+          </a:prstGeom>
+          <a:noFill/>
+          <a:ln/>
+        </p:spPr>
+        <p:txBody>
+          <a:bodyPr wrap="square" lIns="0" tIns="0" rIns="0" bIns="0" rtlCol="0" anchor="ctr"/>
+          <a:lstStyle/>
+          <a:p>
+            <a:pPr algn="ctr" indent="0" marL="0">
+              <a:buNone/>
+            </a:pPr>
+            <a:r>
+              <a:rPr lang="en-US" sz="900" b="1" dirty="0">
+                <a:solidFill>
+                  <a:srgbClr val="FFFFFF"/>
+                </a:solidFill>
+                <a:latin typeface="맑은 고딕" pitchFamily="34" charset="0"/>
+                <a:ea typeface="맑은 고딕" pitchFamily="34" charset="-122"/>
+                <a:cs typeface="맑은 고딕" pitchFamily="34" charset="-120"/>
+              </a:rPr>
+              <a:t>긴급</a:t>
+            </a:r>
+            <a:endParaRPr lang="en-US" sz="900" dirty="0"/>
+          </a:p>
+        </p:txBody>
+      </p:sp>
+      <p:sp>
+        <p:nvSpPr>
+          <p:cNvPr id="37" name="Text 34"/>
+          <p:cNvSpPr/>
+          <p:nvPr/>
+        </p:nvSpPr>
+        <p:spPr>
+          <a:xfrm>
+            <a:off x="8211312" y="4864608"/>
+            <a:ext cx="3291840" cy="274320"/>
+          </a:xfrm>
+          <a:prstGeom prst="rect">
+            <a:avLst/>
+          </a:prstGeom>
+          <a:noFill/>
+          <a:ln/>
+        </p:spPr>
+        <p:txBody>
+          <a:bodyPr wrap="square" lIns="0" tIns="0" rIns="0" bIns="0" rtlCol="0" anchor="ctr"/>
+          <a:lstStyle/>
+          <a:p>
+            <a:pPr indent="0" marL="0">
+              <a:buNone/>
+            </a:pPr>
+            <a:r>
+              <a:rPr lang="en-US" sz="1100" b="1" dirty="0">
+                <a:solidFill>
+                  <a:srgbClr val="0B1220"/>
+                </a:solidFill>
+                <a:latin typeface="맑은 고딕" pitchFamily="34" charset="0"/>
+                <a:ea typeface="맑은 고딕" pitchFamily="34" charset="-122"/>
+                <a:cs typeface="맑은 고딕" pitchFamily="34" charset="-120"/>
+              </a:rPr>
               <a:t>8-Ball Smart Tok</a:t>
             </a:r>
             <a:endParaRPr lang="en-US" sz="1100" dirty="0"/>
@@ -7771,13 +7977,13 @@
       </p:sp>
       <p:sp>
         <p:nvSpPr>
-          <p:cNvPr id="32" name="Text 29"/>
-          <p:cNvSpPr/>
-          <p:nvPr/>
-        </p:nvSpPr>
-        <p:spPr>
-          <a:xfrm>
-            <a:off x="8211312" y="4425696"/>
+          <p:cNvPr id="38" name="Text 35"/>
+          <p:cNvSpPr/>
+          <p:nvPr/>
+        </p:nvSpPr>
+        <p:spPr>
+          <a:xfrm>
+            <a:off x="8211312" y="5138928"/>
             <a:ext cx="3291840" cy="256032"/>
           </a:xfrm>
           <a:prstGeom prst="rect">
@@ -7824,212 +8030,6 @@
       </p:sp>
       <p:sp>
         <p:nvSpPr>
-          <p:cNvPr id="33" name="Shape 30"/>
-          <p:cNvSpPr/>
-          <p:nvPr/>
-        </p:nvSpPr>
-        <p:spPr>
-          <a:xfrm>
-            <a:off x="7406640" y="4809744"/>
-            <a:ext cx="4206240" cy="640080"/>
-          </a:xfrm>
-          <a:prstGeom prst="rect">
-            <a:avLst/>
-          </a:prstGeom>
-          <a:solidFill>
-            <a:srgbClr val="FFF5F5"/>
-          </a:solidFill>
-          <a:ln w="6350">
-            <a:solidFill>
-              <a:srgbClr val="E5E7EB"/>
-            </a:solidFill>
-            <a:prstDash val="solid"/>
-          </a:ln>
-        </p:spPr>
-      </p:sp>
-      <p:sp>
-        <p:nvSpPr>
-          <p:cNvPr id="34" name="Shape 31"/>
-          <p:cNvSpPr/>
-          <p:nvPr/>
-        </p:nvSpPr>
-        <p:spPr>
-          <a:xfrm>
-            <a:off x="7406640" y="4809744"/>
-            <a:ext cx="109728" cy="640080"/>
-          </a:xfrm>
-          <a:prstGeom prst="rect">
-            <a:avLst/>
-          </a:prstGeom>
-          <a:solidFill>
-            <a:srgbClr val="D72638"/>
-          </a:solidFill>
-          <a:ln w="12700">
-            <a:solidFill>
-              <a:srgbClr val="D72638"/>
-            </a:solidFill>
-            <a:prstDash val="solid"/>
-          </a:ln>
-        </p:spPr>
-      </p:sp>
-      <p:sp>
-        <p:nvSpPr>
-          <p:cNvPr id="35" name="Shape 32"/>
-          <p:cNvSpPr/>
-          <p:nvPr/>
-        </p:nvSpPr>
-        <p:spPr>
-          <a:xfrm>
-            <a:off x="7571232" y="4901184"/>
-            <a:ext cx="548640" cy="256032"/>
-          </a:xfrm>
-          <a:prstGeom prst="rect">
-            <a:avLst/>
-          </a:prstGeom>
-          <a:solidFill>
-            <a:srgbClr val="D72638"/>
-          </a:solidFill>
-          <a:ln w="12700">
-            <a:solidFill>
-              <a:srgbClr val="D72638"/>
-            </a:solidFill>
-            <a:prstDash val="solid"/>
-          </a:ln>
-        </p:spPr>
-      </p:sp>
-      <p:sp>
-        <p:nvSpPr>
-          <p:cNvPr id="36" name="Text 33"/>
-          <p:cNvSpPr/>
-          <p:nvPr/>
-        </p:nvSpPr>
-        <p:spPr>
-          <a:xfrm>
-            <a:off x="7571232" y="4901184"/>
-            <a:ext cx="548640" cy="256032"/>
-          </a:xfrm>
-          <a:prstGeom prst="rect">
-            <a:avLst/>
-          </a:prstGeom>
-          <a:noFill/>
-          <a:ln/>
-        </p:spPr>
-        <p:txBody>
-          <a:bodyPr wrap="square" lIns="0" tIns="0" rIns="0" bIns="0" rtlCol="0" anchor="ctr"/>
-          <a:lstStyle/>
-          <a:p>
-            <a:pPr algn="ctr" indent="0" marL="0">
-              <a:buNone/>
-            </a:pPr>
-            <a:r>
-              <a:rPr lang="en-US" sz="900" b="1" dirty="0">
-                <a:solidFill>
-                  <a:srgbClr val="FFFFFF"/>
-                </a:solidFill>
-                <a:latin typeface="맑은 고딕" pitchFamily="34" charset="0"/>
-                <a:ea typeface="맑은 고딕" pitchFamily="34" charset="-122"/>
-                <a:cs typeface="맑은 고딕" pitchFamily="34" charset="-120"/>
-              </a:rPr>
-              <a:t>긴급</a:t>
-            </a:r>
-            <a:endParaRPr lang="en-US" sz="900" dirty="0"/>
-          </a:p>
-        </p:txBody>
-      </p:sp>
-      <p:sp>
-        <p:nvSpPr>
-          <p:cNvPr id="37" name="Text 34"/>
-          <p:cNvSpPr/>
-          <p:nvPr/>
-        </p:nvSpPr>
-        <p:spPr>
-          <a:xfrm>
-            <a:off x="8211312" y="4864608"/>
-            <a:ext cx="3291840" cy="274320"/>
-          </a:xfrm>
-          <a:prstGeom prst="rect">
-            <a:avLst/>
-          </a:prstGeom>
-          <a:noFill/>
-          <a:ln/>
-        </p:spPr>
-        <p:txBody>
-          <a:bodyPr wrap="square" lIns="0" tIns="0" rIns="0" bIns="0" rtlCol="0" anchor="ctr"/>
-          <a:lstStyle/>
-          <a:p>
-            <a:pPr indent="0" marL="0">
-              <a:buNone/>
-            </a:pPr>
-            <a:r>
-              <a:rPr lang="en-US" sz="1100" b="1" dirty="0">
-                <a:solidFill>
-                  <a:srgbClr val="0B1220"/>
-                </a:solidFill>
-                <a:latin typeface="맑은 고딕" pitchFamily="34" charset="0"/>
-                <a:ea typeface="맑은 고딕" pitchFamily="34" charset="-122"/>
-                <a:cs typeface="맑은 고딕" pitchFamily="34" charset="-120"/>
-              </a:rPr>
-              <a:t>[SILVER925] Crimson Open Ring</a:t>
-            </a:r>
-            <a:endParaRPr lang="en-US" sz="1100" dirty="0"/>
-          </a:p>
-        </p:txBody>
-      </p:sp>
-      <p:sp>
-        <p:nvSpPr>
-          <p:cNvPr id="38" name="Text 35"/>
-          <p:cNvSpPr/>
-          <p:nvPr/>
-        </p:nvSpPr>
-        <p:spPr>
-          <a:xfrm>
-            <a:off x="8211312" y="5138928"/>
-            <a:ext cx="3291840" cy="256032"/>
-          </a:xfrm>
-          <a:prstGeom prst="rect">
-            <a:avLst/>
-          </a:prstGeom>
-          <a:noFill/>
-          <a:ln/>
-        </p:spPr>
-        <p:txBody>
-          <a:bodyPr wrap="square" lIns="0" tIns="0" rIns="0" bIns="0" rtlCol="0" anchor="ctr"/>
-          <a:lstStyle/>
-          <a:p>
-            <a:pPr indent="0" marL="0">
-              <a:buNone/>
-            </a:pPr>
-            <a:r>
-              <a:rPr lang="en-US" sz="1000" dirty="0">
-                <a:solidFill>
-                  <a:srgbClr val="6B7280"/>
-                </a:solidFill>
-                <a:latin typeface="맑은 고딕" pitchFamily="34" charset="0"/>
-                <a:ea typeface="맑은 고딕" pitchFamily="34" charset="-122"/>
-                <a:cs typeface="맑은 고딕" pitchFamily="34" charset="-120"/>
-              </a:rPr>
-              <a:t>Ring  ·  재고 3개</a:t>
-            </a:r>
-            <a:pPr indent="0" marL="0">
-              <a:buNone/>
-            </a:pPr>
-            <a:r>
-              <a:rPr lang="en-US" sz="1000" b="1" dirty="0">
-                <a:solidFill>
-                  <a:srgbClr val="D72638"/>
-                </a:solidFill>
-                <a:latin typeface="맑은 고딕" pitchFamily="34" charset="0"/>
-                <a:ea typeface="맑은 고딕" pitchFamily="34" charset="-122"/>
-                <a:cs typeface="맑은 고딕" pitchFamily="34" charset="-120"/>
-              </a:rPr>
-              <a:t/>
-            </a:r>
-            <a:endParaRPr lang="en-US" sz="1000" dirty="0"/>
-          </a:p>
-        </p:txBody>
-      </p:sp>
-      <p:sp>
-        <p:nvSpPr>
           <p:cNvPr id="39" name="Shape 36"/>
           <p:cNvSpPr/>
           <p:nvPr/>
@@ -8267,7 +8267,7 @@
                 <a:ea typeface="맑은 고딕" pitchFamily="34" charset="-122"/>
                 <a:cs typeface="맑은 고딕" pitchFamily="34" charset="-120"/>
               </a:rPr>
-              <a:t>베스트 상품 리포트  ·  생성 2026-05-28 08:00</a:t>
+              <a:t>베스트 상품 리포트  ·  생성 2026-05-29 08:00</a:t>
             </a:r>
             <a:endParaRPr lang="en-US" sz="900" dirty="0"/>
           </a:p>
@@ -8480,7 +8480,7 @@
                 <a:ea typeface="맑은 고딕" pitchFamily="34" charset="-122"/>
                 <a:cs typeface="맑은 고딕" pitchFamily="34" charset="-120"/>
               </a:rPr>
-              <a:t>2026년 05월 28일 (목)</a:t>
+              <a:t>2026년 05월 29일 (금)</a:t>
             </a:r>
             <a:endParaRPr lang="en-US" sz="1200" dirty="0"/>
           </a:p>
@@ -8647,7 +8647,7 @@
                 <a:ea typeface="맑은 고딕" pitchFamily="34" charset="-122"/>
                 <a:cs typeface="맑은 고딕" pitchFamily="34" charset="-120"/>
               </a:rPr>
-              <a:t>60 개</a:t>
+              <a:t>59 개</a:t>
             </a:r>
             <a:endParaRPr lang="en-US" sz="3600" dirty="0"/>
           </a:p>
@@ -8853,7 +8853,7 @@
                 <a:ea typeface="맑은 고딕" pitchFamily="34" charset="-122"/>
                 <a:cs typeface="맑은 고딕" pitchFamily="34" charset="-120"/>
               </a:rPr>
-              <a:t>18</a:t>
+              <a:t>15</a:t>
             </a:r>
             <a:endParaRPr lang="en-US" sz="4400" dirty="0"/>
           </a:p>
@@ -9452,7 +9452,7 @@
                           <a:ea typeface="맑은 고딕" pitchFamily="34" charset="-122"/>
                           <a:cs typeface="맑은 고딕" pitchFamily="34" charset="-120"/>
                         </a:rPr>
-                        <a:t>18 개</a:t>
+                        <a:t>15 개</a:t>
                       </a:r>
                       <a:endParaRPr lang="en-US" sz="1400" dirty="0">
                         <a:latin typeface="맑은 고딕" charset="0"/>
@@ -9584,7 +9584,7 @@
                           <a:ea typeface="맑은 고딕" pitchFamily="34" charset="-122"/>
                           <a:cs typeface="맑은 고딕" pitchFamily="34" charset="-120"/>
                         </a:rPr>
-                        <a:t>Necklace</a:t>
+                        <a:t>Ring</a:t>
                       </a:r>
                       <a:endParaRPr lang="en-US" sz="1000" dirty="0">
                         <a:latin typeface="맑은 고딕" charset="0"/>
@@ -9649,7 +9649,7 @@
                           <a:ea typeface="맑은 고딕" pitchFamily="34" charset="-122"/>
                           <a:cs typeface="맑은 고딕" pitchFamily="34" charset="-120"/>
                         </a:rPr>
-                        <a:t>CandyPOP Necklace (사이즈: 1size (37~43cm))</a:t>
+                        <a:t>"4s" 925 Open Ring (사이즈: 남성)</a:t>
                       </a:r>
                       <a:endParaRPr lang="en-US" sz="1100" dirty="0">
                         <a:latin typeface="맑은 고딕" charset="0"/>
@@ -9714,7 +9714,7 @@
                           <a:ea typeface="맑은 고딕" pitchFamily="34" charset="-122"/>
                           <a:cs typeface="맑은 고딕" pitchFamily="34" charset="-120"/>
                         </a:rPr>
-                        <a:t>11 개</a:t>
+                        <a:t>13 개</a:t>
                       </a:r>
                       <a:endParaRPr lang="en-US" sz="1200" dirty="0">
                         <a:latin typeface="맑은 고딕" charset="0"/>
@@ -9846,7 +9846,7 @@
                           <a:ea typeface="맑은 고딕" pitchFamily="34" charset="-122"/>
                           <a:cs typeface="맑은 고딕" pitchFamily="34" charset="-120"/>
                         </a:rPr>
-                        <a:t>Ring</a:t>
+                        <a:t>Necklace</a:t>
                       </a:r>
                       <a:endParaRPr lang="en-US" sz="1000" dirty="0">
                         <a:latin typeface="맑은 고딕" charset="0"/>
@@ -9911,7 +9911,7 @@
                           <a:ea typeface="맑은 고딕" pitchFamily="34" charset="-122"/>
                           <a:cs typeface="맑은 고딕" pitchFamily="34" charset="-120"/>
                         </a:rPr>
-                        <a:t>"Fenghuang" 925 Open Ring</a:t>
+                        <a:t>CandyPOP Necklace (사이즈: 1size (37~43cm))</a:t>
                       </a:r>
                       <a:endParaRPr lang="en-US" sz="1100" dirty="0">
                         <a:latin typeface="맑은 고딕" charset="0"/>
@@ -9976,7 +9976,7 @@
                           <a:ea typeface="맑은 고딕" pitchFamily="34" charset="-122"/>
                           <a:cs typeface="맑은 고딕" pitchFamily="34" charset="-120"/>
                         </a:rPr>
-                        <a:t>8 개</a:t>
+                        <a:t>7 개</a:t>
                       </a:r>
                       <a:endParaRPr lang="en-US" sz="1200" dirty="0">
                         <a:latin typeface="맑은 고딕" charset="0"/>
@@ -10062,7 +10062,7 @@
                 <a:ea typeface="맑은 고딕" pitchFamily="34" charset="-122"/>
                 <a:cs typeface="맑은 고딕" pitchFamily="34" charset="-120"/>
               </a:rPr>
-              <a:t>리오더 필요  🔴 긴급 21건</a:t>
+              <a:t>리오더 필요  🔴 긴급 20건</a:t>
             </a:r>
             <a:endParaRPr lang="en-US" sz="1500" dirty="0"/>
           </a:p>
@@ -10126,7 +10126,7 @@
                 <a:ea typeface="맑은 고딕" pitchFamily="34" charset="-122"/>
                 <a:cs typeface="맑은 고딕" pitchFamily="34" charset="-120"/>
               </a:rPr>
-              <a:t>🔴 긴급 21건  ·  상세는 시트 확인</a:t>
+              <a:t>🔴 긴급 20건  ·  상세는 시트 확인</a:t>
             </a:r>
             <a:endParaRPr lang="en-US" sz="1400" dirty="0"/>
           </a:p>
@@ -10165,7 +10165,7 @@
                 <a:ea typeface="맑은 고딕" pitchFamily="34" charset="-122"/>
                 <a:cs typeface="맑은 고딕" pitchFamily="34" charset="-120"/>
               </a:rPr>
-              <a:t>베스트 상품 리포트  ·  생성 2026-05-28 08:00</a:t>
+              <a:t>베스트 상품 리포트  ·  생성 2026-05-29 08:00</a:t>
             </a:r>
             <a:endParaRPr lang="en-US" sz="900" dirty="0"/>
           </a:p>
@@ -10378,7 +10378,7 @@
                 <a:ea typeface="맑은 고딕" pitchFamily="34" charset="-122"/>
                 <a:cs typeface="맑은 고딕" pitchFamily="34" charset="-120"/>
               </a:rPr>
-              <a:t>2026년 05월 28일 (목)</a:t>
+              <a:t>2026년 05월 29일 (금)</a:t>
             </a:r>
             <a:endParaRPr lang="en-US" sz="1200" dirty="0"/>
           </a:p>
@@ -10673,7 +10673,7 @@
                 <a:ea typeface="맑은 고딕" pitchFamily="34" charset="-122"/>
                 <a:cs typeface="맑은 고딕" pitchFamily="34" charset="-120"/>
               </a:rPr>
-              <a:t>31</a:t>
+              <a:t>24</a:t>
             </a:r>
             <a:endParaRPr lang="en-US" sz="3000" dirty="0"/>
           </a:p>
@@ -10801,7 +10801,7 @@
                 <a:ea typeface="맑은 고딕" pitchFamily="34" charset="-122"/>
                 <a:cs typeface="맑은 고딕" pitchFamily="34" charset="-120"/>
               </a:rPr>
-              <a:t>8</a:t>
+              <a:t>9</a:t>
             </a:r>
             <a:endParaRPr lang="en-US" sz="3000" dirty="0"/>
           </a:p>
@@ -10929,7 +10929,7 @@
                 <a:ea typeface="맑은 고딕" pitchFamily="34" charset="-122"/>
                 <a:cs typeface="맑은 고딕" pitchFamily="34" charset="-120"/>
               </a:rPr>
-              <a:t>30,125</a:t>
+              <a:t>32,113</a:t>
             </a:r>
             <a:endParaRPr lang="en-US" sz="3000" dirty="0"/>
           </a:p>
@@ -11489,7 +11489,7 @@
                           <a:ea typeface="맑은 고딕" pitchFamily="34" charset="-122"/>
                           <a:cs typeface="맑은 고딕" pitchFamily="34" charset="-120"/>
                         </a:rPr>
-                        <a:t>2,056</a:t>
+                        <a:t>2,049</a:t>
                       </a:r>
                       <a:endParaRPr lang="en-US" sz="1000" dirty="0">
                         <a:latin typeface="맑은 고딕" charset="0"/>
@@ -11751,7 +11751,7 @@
                           <a:ea typeface="맑은 고딕" pitchFamily="34" charset="-122"/>
                           <a:cs typeface="맑은 고딕" pitchFamily="34" charset="-120"/>
                         </a:rPr>
-                        <a:t>1,576</a:t>
+                        <a:t>1,570</a:t>
                       </a:r>
                       <a:endParaRPr lang="en-US" sz="1000" dirty="0">
                         <a:latin typeface="맑은 고딕" charset="0"/>
@@ -12013,7 +12013,7 @@
                           <a:ea typeface="맑은 고딕" pitchFamily="34" charset="-122"/>
                           <a:cs typeface="맑은 고딕" pitchFamily="34" charset="-120"/>
                         </a:rPr>
-                        <a:t>1,140</a:t>
+                        <a:t>1,081</a:t>
                       </a:r>
                       <a:endParaRPr lang="en-US" sz="1000" dirty="0">
                         <a:latin typeface="맑은 고딕" charset="0"/>
@@ -12275,7 +12275,7 @@
                           <a:ea typeface="맑은 고딕" pitchFamily="34" charset="-122"/>
                           <a:cs typeface="맑은 고딕" pitchFamily="34" charset="-120"/>
                         </a:rPr>
-                        <a:t>880</a:t>
+                        <a:t>869</a:t>
                       </a:r>
                       <a:endParaRPr lang="en-US" sz="1000" dirty="0">
                         <a:latin typeface="맑은 고딕" charset="0"/>
@@ -12623,7 +12623,7 @@
                 <a:ea typeface="맑은 고딕" pitchFamily="34" charset="-122"/>
                 <a:cs typeface="맑은 고딕" pitchFamily="34" charset="-120"/>
               </a:rPr>
-              <a:t>재고 점검  🔴 품절 31건</a:t>
+              <a:t>재고 점검  🔴 품절 24건</a:t>
             </a:r>
             <a:pPr indent="0" marL="0">
               <a:buNone/>
@@ -13010,226 +13010,6 @@
                 <a:ea typeface="맑은 고딕" pitchFamily="34" charset="-122"/>
                 <a:cs typeface="맑은 고딕" pitchFamily="34" charset="-120"/>
               </a:rPr>
-              <a:t>Basic Toliet Slippers (6color)</a:t>
-            </a:r>
-            <a:endParaRPr lang="en-US" sz="1000" dirty="0"/>
-          </a:p>
-        </p:txBody>
-      </p:sp>
-      <p:sp>
-        <p:nvSpPr>
-          <p:cNvPr id="37" name="Text 34"/>
-          <p:cNvSpPr/>
-          <p:nvPr/>
-        </p:nvSpPr>
-        <p:spPr>
-          <a:xfrm>
-            <a:off x="8211312" y="4425696"/>
-            <a:ext cx="3291840" cy="256032"/>
-          </a:xfrm>
-          <a:prstGeom prst="rect">
-            <a:avLst/>
-          </a:prstGeom>
-          <a:noFill/>
-          <a:ln/>
-        </p:spPr>
-        <p:txBody>
-          <a:bodyPr wrap="square" lIns="0" tIns="0" rIns="0" bIns="0" rtlCol="0" anchor="ctr"/>
-          <a:lstStyle/>
-          <a:p>
-            <a:pPr indent="0" marL="0">
-              <a:buNone/>
-            </a:pPr>
-            <a:r>
-              <a:rPr lang="en-US" sz="900" dirty="0">
-                <a:solidFill>
-                  <a:srgbClr val="6B7280"/>
-                </a:solidFill>
-                <a:latin typeface="맑은 고딕" pitchFamily="34" charset="0"/>
-                <a:ea typeface="맑은 고딕" pitchFamily="34" charset="-122"/>
-                <a:cs typeface="맑은 고딕" pitchFamily="34" charset="-120"/>
-              </a:rPr>
-              <a:t>컬러: 민트 / 사이즈: Free Size 230~270  ·  재고 0개</a:t>
-            </a:r>
-            <a:pPr indent="0" marL="0">
-              <a:buNone/>
-            </a:pPr>
-            <a:r>
-              <a:rPr lang="en-US" sz="1000" dirty="0">
-                <a:solidFill>
-                  <a:srgbClr val="6B7280"/>
-                </a:solidFill>
-                <a:latin typeface="맑은 고딕" pitchFamily="34" charset="0"/>
-                <a:ea typeface="맑은 고딕" pitchFamily="34" charset="-122"/>
-                <a:cs typeface="맑은 고딕" pitchFamily="34" charset="-120"/>
-              </a:rPr>
-              <a:t/>
-            </a:r>
-            <a:pPr indent="0" marL="0">
-              <a:buNone/>
-            </a:pPr>
-            <a:r>
-              <a:rPr lang="en-US" sz="1000" b="1" dirty="0">
-                <a:solidFill>
-                  <a:srgbClr val="D72638"/>
-                </a:solidFill>
-                <a:latin typeface="맑은 고딕" pitchFamily="34" charset="0"/>
-                <a:ea typeface="맑은 고딕" pitchFamily="34" charset="-122"/>
-                <a:cs typeface="맑은 고딕" pitchFamily="34" charset="-120"/>
-              </a:rPr>
-              <a:t/>
-            </a:r>
-            <a:endParaRPr lang="en-US" sz="900" dirty="0"/>
-          </a:p>
-        </p:txBody>
-      </p:sp>
-      <p:sp>
-        <p:nvSpPr>
-          <p:cNvPr id="38" name="Shape 35"/>
-          <p:cNvSpPr/>
-          <p:nvPr/>
-        </p:nvSpPr>
-        <p:spPr>
-          <a:xfrm>
-            <a:off x="7406640" y="4809744"/>
-            <a:ext cx="4206240" cy="640080"/>
-          </a:xfrm>
-          <a:prstGeom prst="rect">
-            <a:avLst/>
-          </a:prstGeom>
-          <a:solidFill>
-            <a:srgbClr val="FFF5F5"/>
-          </a:solidFill>
-          <a:ln w="6350">
-            <a:solidFill>
-              <a:srgbClr val="E5E7EB"/>
-            </a:solidFill>
-            <a:prstDash val="solid"/>
-          </a:ln>
-        </p:spPr>
-      </p:sp>
-      <p:sp>
-        <p:nvSpPr>
-          <p:cNvPr id="39" name="Shape 36"/>
-          <p:cNvSpPr/>
-          <p:nvPr/>
-        </p:nvSpPr>
-        <p:spPr>
-          <a:xfrm>
-            <a:off x="7406640" y="4809744"/>
-            <a:ext cx="109728" cy="640080"/>
-          </a:xfrm>
-          <a:prstGeom prst="rect">
-            <a:avLst/>
-          </a:prstGeom>
-          <a:solidFill>
-            <a:srgbClr val="D72638"/>
-          </a:solidFill>
-          <a:ln w="12700">
-            <a:solidFill>
-              <a:srgbClr val="D72638"/>
-            </a:solidFill>
-            <a:prstDash val="solid"/>
-          </a:ln>
-        </p:spPr>
-      </p:sp>
-      <p:sp>
-        <p:nvSpPr>
-          <p:cNvPr id="40" name="Shape 37"/>
-          <p:cNvSpPr/>
-          <p:nvPr/>
-        </p:nvSpPr>
-        <p:spPr>
-          <a:xfrm>
-            <a:off x="7571232" y="4901184"/>
-            <a:ext cx="548640" cy="256032"/>
-          </a:xfrm>
-          <a:prstGeom prst="rect">
-            <a:avLst/>
-          </a:prstGeom>
-          <a:solidFill>
-            <a:srgbClr val="D72638"/>
-          </a:solidFill>
-          <a:ln w="12700">
-            <a:solidFill>
-              <a:srgbClr val="D72638"/>
-            </a:solidFill>
-            <a:prstDash val="solid"/>
-          </a:ln>
-        </p:spPr>
-      </p:sp>
-      <p:sp>
-        <p:nvSpPr>
-          <p:cNvPr id="41" name="Text 38"/>
-          <p:cNvSpPr/>
-          <p:nvPr/>
-        </p:nvSpPr>
-        <p:spPr>
-          <a:xfrm>
-            <a:off x="7571232" y="4901184"/>
-            <a:ext cx="548640" cy="256032"/>
-          </a:xfrm>
-          <a:prstGeom prst="rect">
-            <a:avLst/>
-          </a:prstGeom>
-          <a:noFill/>
-          <a:ln/>
-        </p:spPr>
-        <p:txBody>
-          <a:bodyPr wrap="square" lIns="0" tIns="0" rIns="0" bIns="0" rtlCol="0" anchor="ctr"/>
-          <a:lstStyle/>
-          <a:p>
-            <a:pPr algn="ctr" indent="0" marL="0">
-              <a:buNone/>
-            </a:pPr>
-            <a:r>
-              <a:rPr lang="en-US" sz="900" b="1" dirty="0">
-                <a:solidFill>
-                  <a:srgbClr val="FFFFFF"/>
-                </a:solidFill>
-                <a:latin typeface="맑은 고딕" pitchFamily="34" charset="0"/>
-                <a:ea typeface="맑은 고딕" pitchFamily="34" charset="-122"/>
-                <a:cs typeface="맑은 고딕" pitchFamily="34" charset="-120"/>
-              </a:rPr>
-              <a:t>긴급</a:t>
-            </a:r>
-            <a:endParaRPr lang="en-US" sz="900" dirty="0"/>
-          </a:p>
-        </p:txBody>
-      </p:sp>
-      <p:sp>
-        <p:nvSpPr>
-          <p:cNvPr id="42" name="Text 39"/>
-          <p:cNvSpPr/>
-          <p:nvPr/>
-        </p:nvSpPr>
-        <p:spPr>
-          <a:xfrm>
-            <a:off x="8211312" y="4864608"/>
-            <a:ext cx="3291840" cy="274320"/>
-          </a:xfrm>
-          <a:prstGeom prst="rect">
-            <a:avLst/>
-          </a:prstGeom>
-          <a:noFill/>
-          <a:ln/>
-        </p:spPr>
-        <p:txBody>
-          <a:bodyPr wrap="square" lIns="0" tIns="0" rIns="0" bIns="0" rtlCol="0" anchor="ctr"/>
-          <a:lstStyle/>
-          <a:p>
-            <a:pPr indent="0" marL="0">
-              <a:buNone/>
-            </a:pPr>
-            <a:r>
-              <a:rPr lang="en-US" sz="1000" b="1" dirty="0">
-                <a:solidFill>
-                  <a:srgbClr val="0B1220"/>
-                </a:solidFill>
-                <a:latin typeface="맑은 고딕" pitchFamily="34" charset="0"/>
-                <a:ea typeface="맑은 고딕" pitchFamily="34" charset="-122"/>
-                <a:cs typeface="맑은 고딕" pitchFamily="34" charset="-120"/>
-              </a:rPr>
               <a:t>Fuzzy Stripe Slippers (3color)</a:t>
             </a:r>
             <a:endParaRPr lang="en-US" sz="1000" dirty="0"/>
@@ -13238,13 +13018,13 @@
       </p:sp>
       <p:sp>
         <p:nvSpPr>
-          <p:cNvPr id="43" name="Text 40"/>
-          <p:cNvSpPr/>
-          <p:nvPr/>
-        </p:nvSpPr>
-        <p:spPr>
-          <a:xfrm>
-            <a:off x="8211312" y="5138928"/>
+          <p:cNvPr id="37" name="Text 34"/>
+          <p:cNvSpPr/>
+          <p:nvPr/>
+        </p:nvSpPr>
+        <p:spPr>
+          <a:xfrm>
+            <a:off x="8211312" y="4425696"/>
             <a:ext cx="3291840" cy="256032"/>
           </a:xfrm>
           <a:prstGeom prst="rect">
@@ -13305,13 +13085,13 @@
       </p:sp>
       <p:sp>
         <p:nvSpPr>
-          <p:cNvPr id="44" name="Shape 41"/>
-          <p:cNvSpPr/>
-          <p:nvPr/>
-        </p:nvSpPr>
-        <p:spPr>
-          <a:xfrm>
-            <a:off x="7406640" y="5522976"/>
+          <p:cNvPr id="38" name="Shape 35"/>
+          <p:cNvSpPr/>
+          <p:nvPr/>
+        </p:nvSpPr>
+        <p:spPr>
+          <a:xfrm>
+            <a:off x="7406640" y="4809744"/>
             <a:ext cx="4206240" cy="640080"/>
           </a:xfrm>
           <a:prstGeom prst="rect">
@@ -13330,13 +13110,13 @@
       </p:sp>
       <p:sp>
         <p:nvSpPr>
-          <p:cNvPr id="45" name="Shape 42"/>
-          <p:cNvSpPr/>
-          <p:nvPr/>
-        </p:nvSpPr>
-        <p:spPr>
-          <a:xfrm>
-            <a:off x="7406640" y="5522976"/>
+          <p:cNvPr id="39" name="Shape 36"/>
+          <p:cNvSpPr/>
+          <p:nvPr/>
+        </p:nvSpPr>
+        <p:spPr>
+          <a:xfrm>
+            <a:off x="7406640" y="4809744"/>
             <a:ext cx="109728" cy="640080"/>
           </a:xfrm>
           <a:prstGeom prst="rect">
@@ -13355,13 +13135,13 @@
       </p:sp>
       <p:sp>
         <p:nvSpPr>
-          <p:cNvPr id="46" name="Shape 43"/>
-          <p:cNvSpPr/>
-          <p:nvPr/>
-        </p:nvSpPr>
-        <p:spPr>
-          <a:xfrm>
-            <a:off x="7571232" y="5614416"/>
+          <p:cNvPr id="40" name="Shape 37"/>
+          <p:cNvSpPr/>
+          <p:nvPr/>
+        </p:nvSpPr>
+        <p:spPr>
+          <a:xfrm>
+            <a:off x="7571232" y="4901184"/>
             <a:ext cx="548640" cy="256032"/>
           </a:xfrm>
           <a:prstGeom prst="rect">
@@ -13380,13 +13160,13 @@
       </p:sp>
       <p:sp>
         <p:nvSpPr>
-          <p:cNvPr id="47" name="Text 44"/>
-          <p:cNvSpPr/>
-          <p:nvPr/>
-        </p:nvSpPr>
-        <p:spPr>
-          <a:xfrm>
-            <a:off x="7571232" y="5614416"/>
+          <p:cNvPr id="41" name="Text 38"/>
+          <p:cNvSpPr/>
+          <p:nvPr/>
+        </p:nvSpPr>
+        <p:spPr>
+          <a:xfrm>
+            <a:off x="7571232" y="4901184"/>
             <a:ext cx="548640" cy="256032"/>
           </a:xfrm>
           <a:prstGeom prst="rect">
@@ -13419,13 +13199,13 @@
       </p:sp>
       <p:sp>
         <p:nvSpPr>
-          <p:cNvPr id="48" name="Text 45"/>
-          <p:cNvSpPr/>
-          <p:nvPr/>
-        </p:nvSpPr>
-        <p:spPr>
-          <a:xfrm>
-            <a:off x="8211312" y="5577840"/>
+          <p:cNvPr id="42" name="Text 39"/>
+          <p:cNvSpPr/>
+          <p:nvPr/>
+        </p:nvSpPr>
+        <p:spPr>
+          <a:xfrm>
+            <a:off x="8211312" y="4864608"/>
             <a:ext cx="3291840" cy="274320"/>
           </a:xfrm>
           <a:prstGeom prst="rect">
@@ -13458,13 +13238,13 @@
       </p:sp>
       <p:sp>
         <p:nvSpPr>
-          <p:cNvPr id="49" name="Text 46"/>
-          <p:cNvSpPr/>
-          <p:nvPr/>
-        </p:nvSpPr>
-        <p:spPr>
-          <a:xfrm>
-            <a:off x="8211312" y="5852160"/>
+          <p:cNvPr id="43" name="Text 40"/>
+          <p:cNvSpPr/>
+          <p:nvPr/>
+        </p:nvSpPr>
+        <p:spPr>
+          <a:xfrm>
+            <a:off x="8211312" y="5138928"/>
             <a:ext cx="3291840" cy="256032"/>
           </a:xfrm>
           <a:prstGeom prst="rect">
@@ -13525,14 +13305,167 @@
       </p:sp>
       <p:sp>
         <p:nvSpPr>
-          <p:cNvPr id="50" name="Text 47"/>
-          <p:cNvSpPr/>
-          <p:nvPr/>
-        </p:nvSpPr>
-        <p:spPr>
-          <a:xfrm>
-            <a:off x="548640" y="6492240"/>
-            <a:ext cx="7315200" cy="274320"/>
+          <p:cNvPr id="44" name="Shape 41"/>
+          <p:cNvSpPr/>
+          <p:nvPr/>
+        </p:nvSpPr>
+        <p:spPr>
+          <a:xfrm>
+            <a:off x="7406640" y="5522976"/>
+            <a:ext cx="4206240" cy="640080"/>
+          </a:xfrm>
+          <a:prstGeom prst="rect">
+            <a:avLst/>
+          </a:prstGeom>
+          <a:solidFill>
+            <a:srgbClr val="FFF5F5"/>
+          </a:solidFill>
+          <a:ln w="6350">
+            <a:solidFill>
+              <a:srgbClr val="E5E7EB"/>
+            </a:solidFill>
+            <a:prstDash val="solid"/>
+          </a:ln>
+        </p:spPr>
+      </p:sp>
+      <p:sp>
+        <p:nvSpPr>
+          <p:cNvPr id="45" name="Shape 42"/>
+          <p:cNvSpPr/>
+          <p:nvPr/>
+        </p:nvSpPr>
+        <p:spPr>
+          <a:xfrm>
+            <a:off x="7406640" y="5522976"/>
+            <a:ext cx="109728" cy="640080"/>
+          </a:xfrm>
+          <a:prstGeom prst="rect">
+            <a:avLst/>
+          </a:prstGeom>
+          <a:solidFill>
+            <a:srgbClr val="D72638"/>
+          </a:solidFill>
+          <a:ln w="12700">
+            <a:solidFill>
+              <a:srgbClr val="D72638"/>
+            </a:solidFill>
+            <a:prstDash val="solid"/>
+          </a:ln>
+        </p:spPr>
+      </p:sp>
+      <p:sp>
+        <p:nvSpPr>
+          <p:cNvPr id="46" name="Shape 43"/>
+          <p:cNvSpPr/>
+          <p:nvPr/>
+        </p:nvSpPr>
+        <p:spPr>
+          <a:xfrm>
+            <a:off x="7571232" y="5614416"/>
+            <a:ext cx="548640" cy="256032"/>
+          </a:xfrm>
+          <a:prstGeom prst="rect">
+            <a:avLst/>
+          </a:prstGeom>
+          <a:solidFill>
+            <a:srgbClr val="D72638"/>
+          </a:solidFill>
+          <a:ln w="12700">
+            <a:solidFill>
+              <a:srgbClr val="D72638"/>
+            </a:solidFill>
+            <a:prstDash val="solid"/>
+          </a:ln>
+        </p:spPr>
+      </p:sp>
+      <p:sp>
+        <p:nvSpPr>
+          <p:cNvPr id="47" name="Text 44"/>
+          <p:cNvSpPr/>
+          <p:nvPr/>
+        </p:nvSpPr>
+        <p:spPr>
+          <a:xfrm>
+            <a:off x="7571232" y="5614416"/>
+            <a:ext cx="548640" cy="256032"/>
+          </a:xfrm>
+          <a:prstGeom prst="rect">
+            <a:avLst/>
+          </a:prstGeom>
+          <a:noFill/>
+          <a:ln/>
+        </p:spPr>
+        <p:txBody>
+          <a:bodyPr wrap="square" lIns="0" tIns="0" rIns="0" bIns="0" rtlCol="0" anchor="ctr"/>
+          <a:lstStyle/>
+          <a:p>
+            <a:pPr algn="ctr" indent="0" marL="0">
+              <a:buNone/>
+            </a:pPr>
+            <a:r>
+              <a:rPr lang="en-US" sz="900" b="1" dirty="0">
+                <a:solidFill>
+                  <a:srgbClr val="FFFFFF"/>
+                </a:solidFill>
+                <a:latin typeface="맑은 고딕" pitchFamily="34" charset="0"/>
+                <a:ea typeface="맑은 고딕" pitchFamily="34" charset="-122"/>
+                <a:cs typeface="맑은 고딕" pitchFamily="34" charset="-120"/>
+              </a:rPr>
+              <a:t>긴급</a:t>
+            </a:r>
+            <a:endParaRPr lang="en-US" sz="900" dirty="0"/>
+          </a:p>
+        </p:txBody>
+      </p:sp>
+      <p:sp>
+        <p:nvSpPr>
+          <p:cNvPr id="48" name="Text 45"/>
+          <p:cNvSpPr/>
+          <p:nvPr/>
+        </p:nvSpPr>
+        <p:spPr>
+          <a:xfrm>
+            <a:off x="8211312" y="5577840"/>
+            <a:ext cx="3291840" cy="274320"/>
+          </a:xfrm>
+          <a:prstGeom prst="rect">
+            <a:avLst/>
+          </a:prstGeom>
+          <a:noFill/>
+          <a:ln/>
+        </p:spPr>
+        <p:txBody>
+          <a:bodyPr wrap="square" lIns="0" tIns="0" rIns="0" bIns="0" rtlCol="0" anchor="ctr"/>
+          <a:lstStyle/>
+          <a:p>
+            <a:pPr indent="0" marL="0">
+              <a:buNone/>
+            </a:pPr>
+            <a:r>
+              <a:rPr lang="en-US" sz="1000" b="1" dirty="0">
+                <a:solidFill>
+                  <a:srgbClr val="0B1220"/>
+                </a:solidFill>
+                <a:latin typeface="맑은 고딕" pitchFamily="34" charset="0"/>
+                <a:ea typeface="맑은 고딕" pitchFamily="34" charset="-122"/>
+                <a:cs typeface="맑은 고딕" pitchFamily="34" charset="-120"/>
+              </a:rPr>
+              <a:t>Cotton Lunch Mini Bag (5color)</a:t>
+            </a:r>
+            <a:endParaRPr lang="en-US" sz="1000" dirty="0"/>
+          </a:p>
+        </p:txBody>
+      </p:sp>
+      <p:sp>
+        <p:nvSpPr>
+          <p:cNvPr id="49" name="Text 46"/>
+          <p:cNvSpPr/>
+          <p:nvPr/>
+        </p:nvSpPr>
+        <p:spPr>
+          <a:xfrm>
+            <a:off x="8211312" y="5852160"/>
+            <a:ext cx="3291840" cy="256032"/>
           </a:xfrm>
           <a:prstGeom prst="rect">
             <a:avLst/>
@@ -13556,7 +13489,74 @@
                 <a:ea typeface="맑은 고딕" pitchFamily="34" charset="-122"/>
                 <a:cs typeface="맑은 고딕" pitchFamily="34" charset="-120"/>
               </a:rPr>
-              <a:t>베스트 상품 리포트  ·  생성 2026-05-28 08:00</a:t>
+              <a:t>색상: 블랙  ·  재고 0개</a:t>
+            </a:r>
+            <a:pPr indent="0" marL="0">
+              <a:buNone/>
+            </a:pPr>
+            <a:r>
+              <a:rPr lang="en-US" sz="1000" dirty="0">
+                <a:solidFill>
+                  <a:srgbClr val="6B7280"/>
+                </a:solidFill>
+                <a:latin typeface="맑은 고딕" pitchFamily="34" charset="0"/>
+                <a:ea typeface="맑은 고딕" pitchFamily="34" charset="-122"/>
+                <a:cs typeface="맑은 고딕" pitchFamily="34" charset="-120"/>
+              </a:rPr>
+              <a:t/>
+            </a:r>
+            <a:pPr indent="0" marL="0">
+              <a:buNone/>
+            </a:pPr>
+            <a:r>
+              <a:rPr lang="en-US" sz="1000" b="1" dirty="0">
+                <a:solidFill>
+                  <a:srgbClr val="D72638"/>
+                </a:solidFill>
+                <a:latin typeface="맑은 고딕" pitchFamily="34" charset="0"/>
+                <a:ea typeface="맑은 고딕" pitchFamily="34" charset="-122"/>
+                <a:cs typeface="맑은 고딕" pitchFamily="34" charset="-120"/>
+              </a:rPr>
+              <a:t/>
+            </a:r>
+            <a:endParaRPr lang="en-US" sz="900" dirty="0"/>
+          </a:p>
+        </p:txBody>
+      </p:sp>
+      <p:sp>
+        <p:nvSpPr>
+          <p:cNvPr id="50" name="Text 47"/>
+          <p:cNvSpPr/>
+          <p:nvPr/>
+        </p:nvSpPr>
+        <p:spPr>
+          <a:xfrm>
+            <a:off x="548640" y="6492240"/>
+            <a:ext cx="7315200" cy="274320"/>
+          </a:xfrm>
+          <a:prstGeom prst="rect">
+            <a:avLst/>
+          </a:prstGeom>
+          <a:noFill/>
+          <a:ln/>
+        </p:spPr>
+        <p:txBody>
+          <a:bodyPr wrap="square" lIns="0" tIns="0" rIns="0" bIns="0" rtlCol="0" anchor="ctr"/>
+          <a:lstStyle/>
+          <a:p>
+            <a:pPr indent="0" marL="0">
+              <a:buNone/>
+            </a:pPr>
+            <a:r>
+              <a:rPr lang="en-US" sz="900" dirty="0">
+                <a:solidFill>
+                  <a:srgbClr val="6B7280"/>
+                </a:solidFill>
+                <a:latin typeface="맑은 고딕" pitchFamily="34" charset="0"/>
+                <a:ea typeface="맑은 고딕" pitchFamily="34" charset="-122"/>
+                <a:cs typeface="맑은 고딕" pitchFamily="34" charset="-120"/>
+              </a:rPr>
+              <a:t>베스트 상품 리포트  ·  생성 2026-05-29 08:00</a:t>
             </a:r>
             <a:endParaRPr lang="en-US" sz="900" dirty="0"/>
           </a:p>
@@ -13769,7 +13769,7 @@
                 <a:ea typeface="맑은 고딕" pitchFamily="34" charset="-122"/>
                 <a:cs typeface="맑은 고딕" pitchFamily="34" charset="-120"/>
               </a:rPr>
-              <a:t>2026년 05월 28일 (목)</a:t>
+              <a:t>2026년 05월 29일 (금)</a:t>
             </a:r>
             <a:endParaRPr lang="en-US" sz="1200" dirty="0"/>
           </a:p>
@@ -13897,7 +13897,7 @@
                 <a:ea typeface="맑은 고딕" pitchFamily="34" charset="-122"/>
                 <a:cs typeface="맑은 고딕" pitchFamily="34" charset="-120"/>
               </a:rPr>
-              <a:t>🚨  긴급 리오더 75건    ·    주의 리오더 12건    ·    오늘 발주 검토 필수</a:t>
+              <a:t>🚨  긴급 리오더 67건    ·    주의 리오더 12건    ·    오늘 발주 검토 필수</a:t>
             </a:r>
             <a:pPr indent="0" marL="0">
               <a:buNone/>
@@ -14595,7 +14595,7 @@
                           <a:ea typeface="맑은 고딕" pitchFamily="34" charset="-122"/>
                           <a:cs typeface="맑은 고딕" pitchFamily="34" charset="-120"/>
                         </a:rPr>
-                        <a:t>ETC</a:t>
+                        <a:t>ELECTRONIC</a:t>
                       </a:r>
                       <a:endParaRPr lang="en-US" sz="1000" dirty="0">
                         <a:latin typeface="맑은 고딕" charset="0"/>
@@ -14663,7 +14663,7 @@
                           <a:ea typeface="맑은 고딕" pitchFamily="34" charset="-122"/>
                           <a:cs typeface="맑은 고딕" pitchFamily="34" charset="-120"/>
                         </a:rPr>
-                        <a:t>Flower Keychain (6color) (컬러: 피치)</a:t>
+                        <a:t>Jacquard Fast Charging Cable (7color) (컬러: 블루 / 기종옵션: C-Apple 8pin / 길이: 2m)</a:t>
                       </a:r>
                       <a:endParaRPr lang="en-US" sz="1100" dirty="0">
                         <a:latin typeface="맑은 고딕" charset="0"/>
@@ -14731,7 +14731,7 @@
                           <a:ea typeface="맑은 고딕" pitchFamily="34" charset="-122"/>
                           <a:cs typeface="맑은 고딕" pitchFamily="34" charset="-120"/>
                         </a:rPr>
-                        <a:t>0</a:t>
+                        <a:t>12</a:t>
                       </a:r>
                       <a:endParaRPr lang="en-US" sz="1100" dirty="0">
                         <a:latin typeface="맑은 고딕" charset="0"/>
@@ -14799,7 +14799,7 @@
                           <a:ea typeface="맑은 고딕" pitchFamily="34" charset="-122"/>
                           <a:cs typeface="맑은 고딕" pitchFamily="34" charset="-120"/>
                         </a:rPr>
-                        <a:t>100 개</a:t>
+                        <a:t>4 개</a:t>
                       </a:r>
                       <a:endParaRPr lang="en-US" sz="1100" dirty="0">
                         <a:latin typeface="맑은 고딕" charset="0"/>
@@ -14937,7 +14937,7 @@
                           <a:ea typeface="맑은 고딕" pitchFamily="34" charset="-122"/>
                           <a:cs typeface="맑은 고딕" pitchFamily="34" charset="-120"/>
                         </a:rPr>
-                        <a:t>PR</a:t>
+                        <a:t>CT</a:t>
                       </a:r>
                       <a:endParaRPr lang="en-US" sz="1100" dirty="0">
                         <a:latin typeface="맑은 고딕" charset="0"/>
@@ -15005,7 +15005,7 @@
                           <a:ea typeface="맑은 고딕" pitchFamily="34" charset="-122"/>
                           <a:cs typeface="맑은 고딕" pitchFamily="34" charset="-120"/>
                         </a:rPr>
-                        <a:t>ETC</a:t>
+                        <a:t>Ring</a:t>
                       </a:r>
                       <a:endParaRPr lang="en-US" sz="1000" dirty="0">
                         <a:latin typeface="맑은 고딕" charset="0"/>
@@ -15073,7 +15073,7 @@
                           <a:ea typeface="맑은 고딕" pitchFamily="34" charset="-122"/>
                           <a:cs typeface="맑은 고딕" pitchFamily="34" charset="-120"/>
                         </a:rPr>
-                        <a:t>1+1 Silk Scrunch (9color) (A 컬러: 레드 / B 컬러: 그린)</a:t>
+                        <a:t>"Giethoorn" 925 Open Ring</a:t>
                       </a:r>
                       <a:endParaRPr lang="en-US" sz="1100" dirty="0">
                         <a:latin typeface="맑은 고딕" charset="0"/>
@@ -15141,7 +15141,7 @@
                           <a:ea typeface="맑은 고딕" pitchFamily="34" charset="-122"/>
                           <a:cs typeface="맑은 고딕" pitchFamily="34" charset="-120"/>
                         </a:rPr>
-                        <a:t>19</a:t>
+                        <a:t>2</a:t>
                       </a:r>
                       <a:endParaRPr lang="en-US" sz="1100" dirty="0">
                         <a:latin typeface="맑은 고딕" charset="0"/>
@@ -15209,7 +15209,7 @@
                           <a:ea typeface="맑은 고딕" pitchFamily="34" charset="-122"/>
                           <a:cs typeface="맑은 고딕" pitchFamily="34" charset="-120"/>
                         </a:rPr>
-                        <a:t>51 개</a:t>
+                        <a:t>3 개</a:t>
                       </a:r>
                       <a:endParaRPr lang="en-US" sz="1100" dirty="0">
                         <a:latin typeface="맑은 고딕" charset="0"/>
@@ -15347,7 +15347,7 @@
                           <a:ea typeface="맑은 고딕" pitchFamily="34" charset="-122"/>
                           <a:cs typeface="맑은 고딕" pitchFamily="34" charset="-120"/>
                         </a:rPr>
-                        <a:t>PR</a:t>
+                        <a:t>6A</a:t>
                       </a:r>
                       <a:endParaRPr lang="en-US" sz="1100" dirty="0">
                         <a:latin typeface="맑은 고딕" charset="0"/>
@@ -15415,7 +15415,7 @@
                           <a:ea typeface="맑은 고딕" pitchFamily="34" charset="-122"/>
                           <a:cs typeface="맑은 고딕" pitchFamily="34" charset="-120"/>
                         </a:rPr>
-                        <a:t>ETC</a:t>
+                        <a:t>Ring</a:t>
                       </a:r>
                       <a:endParaRPr lang="en-US" sz="1000" dirty="0">
                         <a:latin typeface="맑은 고딕" charset="0"/>
@@ -15483,7 +15483,7 @@
                           <a:ea typeface="맑은 고딕" pitchFamily="34" charset="-122"/>
                           <a:cs typeface="맑은 고딕" pitchFamily="34" charset="-120"/>
                         </a:rPr>
-                        <a:t>1+1 Silk Scrunch (9color) (A 컬러: 그린 / B 컬러: 레드)</a:t>
+                        <a:t>[SILVER925] Crimson Open Ring</a:t>
                       </a:r>
                       <a:endParaRPr lang="en-US" sz="1100" dirty="0">
                         <a:latin typeface="맑은 고딕" charset="0"/>
@@ -15551,7 +15551,7 @@
                           <a:ea typeface="맑은 고딕" pitchFamily="34" charset="-122"/>
                           <a:cs typeface="맑은 고딕" pitchFamily="34" charset="-120"/>
                         </a:rPr>
-                        <a:t>19</a:t>
+                        <a:t>1</a:t>
                       </a:r>
                       <a:endParaRPr lang="en-US" sz="1100" dirty="0">
                         <a:latin typeface="맑은 고딕" charset="0"/>
@@ -15619,7 +15619,7 @@
                           <a:ea typeface="맑은 고딕" pitchFamily="34" charset="-122"/>
                           <a:cs typeface="맑은 고딕" pitchFamily="34" charset="-120"/>
                         </a:rPr>
-                        <a:t>45 개</a:t>
+                        <a:t>2 개</a:t>
                       </a:r>
                       <a:endParaRPr lang="en-US" sz="1100" dirty="0">
                         <a:latin typeface="맑은 고딕" charset="0"/>
@@ -15757,7 +15757,7 @@
                           <a:ea typeface="맑은 고딕" pitchFamily="34" charset="-122"/>
                           <a:cs typeface="맑은 고딕" pitchFamily="34" charset="-120"/>
                         </a:rPr>
-                        <a:t>PR</a:t>
+                        <a:t>6A</a:t>
                       </a:r>
                       <a:endParaRPr lang="en-US" sz="1100" dirty="0">
                         <a:latin typeface="맑은 고딕" charset="0"/>
@@ -15825,7 +15825,7 @@
                           <a:ea typeface="맑은 고딕" pitchFamily="34" charset="-122"/>
                           <a:cs typeface="맑은 고딕" pitchFamily="34" charset="-120"/>
                         </a:rPr>
-                        <a:t>ETC</a:t>
+                        <a:t>Ring</a:t>
                       </a:r>
                       <a:endParaRPr lang="en-US" sz="1000" dirty="0">
                         <a:latin typeface="맑은 고딕" charset="0"/>
@@ -15893,7 +15893,7 @@
                           <a:ea typeface="맑은 고딕" pitchFamily="34" charset="-122"/>
                           <a:cs typeface="맑은 고딕" pitchFamily="34" charset="-120"/>
                         </a:rPr>
-                        <a:t>Basic Toliet Slippers (6color) (컬러: 민트 / 사이즈: Free Size 230~270)</a:t>
+                        <a:t>[SILVER925] Flowy Open Ring</a:t>
                       </a:r>
                       <a:endParaRPr lang="en-US" sz="1100" dirty="0">
                         <a:latin typeface="맑은 고딕" charset="0"/>
@@ -15961,7 +15961,7 @@
                           <a:ea typeface="맑은 고딕" pitchFamily="34" charset="-122"/>
                           <a:cs typeface="맑은 고딕" pitchFamily="34" charset="-120"/>
                         </a:rPr>
-                        <a:t>0</a:t>
+                        <a:t>2</a:t>
                       </a:r>
                       <a:endParaRPr lang="en-US" sz="1100" dirty="0">
                         <a:latin typeface="맑은 고딕" charset="0"/>
@@ -16029,7 +16029,7 @@
                           <a:ea typeface="맑은 고딕" pitchFamily="34" charset="-122"/>
                           <a:cs typeface="맑은 고딕" pitchFamily="34" charset="-120"/>
                         </a:rPr>
-                        <a:t>21 개</a:t>
+                        <a:t>1 개</a:t>
                       </a:r>
                       <a:endParaRPr lang="en-US" sz="1100" dirty="0">
                         <a:latin typeface="맑은 고딕" charset="0"/>
@@ -16167,7 +16167,7 @@
                           <a:ea typeface="맑은 고딕" pitchFamily="34" charset="-122"/>
                           <a:cs typeface="맑은 고딕" pitchFamily="34" charset="-120"/>
                         </a:rPr>
-                        <a:t>PR</a:t>
+                        <a:t>CT</a:t>
                       </a:r>
                       <a:endParaRPr lang="en-US" sz="1100" dirty="0">
                         <a:latin typeface="맑은 고딕" charset="0"/>
@@ -16235,7 +16235,7 @@
                           <a:ea typeface="맑은 고딕" pitchFamily="34" charset="-122"/>
                           <a:cs typeface="맑은 고딕" pitchFamily="34" charset="-120"/>
                         </a:rPr>
-                        <a:t>ETC</a:t>
+                        <a:t>Ring</a:t>
                       </a:r>
                       <a:endParaRPr lang="en-US" sz="1000" dirty="0">
                         <a:latin typeface="맑은 고딕" charset="0"/>
@@ -16303,7 +16303,7 @@
                           <a:ea typeface="맑은 고딕" pitchFamily="34" charset="-122"/>
                           <a:cs typeface="맑은 고딕" pitchFamily="34" charset="-120"/>
                         </a:rPr>
-                        <a:t>1+1 Silk Scrunch (9color) (A 컬러: 레드 / B 컬러: 레드)</a:t>
+                        <a:t>"Crackave" 925 Open Ring</a:t>
                       </a:r>
                       <a:endParaRPr lang="en-US" sz="1100" dirty="0">
                         <a:latin typeface="맑은 고딕" charset="0"/>
@@ -16371,7 +16371,7 @@
                           <a:ea typeface="맑은 고딕" pitchFamily="34" charset="-122"/>
                           <a:cs typeface="맑은 고딕" pitchFamily="34" charset="-120"/>
                         </a:rPr>
-                        <a:t>19</a:t>
+                        <a:t>3</a:t>
                       </a:r>
                       <a:endParaRPr lang="en-US" sz="1100" dirty="0">
                         <a:latin typeface="맑은 고딕" charset="0"/>
@@ -16439,7 +16439,7 @@
                           <a:ea typeface="맑은 고딕" pitchFamily="34" charset="-122"/>
                           <a:cs typeface="맑은 고딕" pitchFamily="34" charset="-120"/>
                         </a:rPr>
-                        <a:t>8 개</a:t>
+                        <a:t>1 개</a:t>
                       </a:r>
                       <a:endParaRPr lang="en-US" sz="1100" dirty="0">
                         <a:latin typeface="맑은 고딕" charset="0"/>
@@ -16645,7 +16645,7 @@
                           <a:ea typeface="맑은 고딕" pitchFamily="34" charset="-122"/>
                           <a:cs typeface="맑은 고딕" pitchFamily="34" charset="-120"/>
                         </a:rPr>
-                        <a:t>ELECTRONIC</a:t>
+                        <a:t>ETC</a:t>
                       </a:r>
                       <a:endParaRPr lang="en-US" sz="1000" dirty="0">
                         <a:latin typeface="맑은 고딕" charset="0"/>
@@ -16713,7 +16713,7 @@
                           <a:ea typeface="맑은 고딕" pitchFamily="34" charset="-122"/>
                           <a:cs typeface="맑은 고딕" pitchFamily="34" charset="-120"/>
                         </a:rPr>
-                        <a:t>Jacquard Fast Charging Cable (7color) (컬러: 민트 / 기종옵션: C-Apple 8pin / 길이: 2m)</a:t>
+                        <a:t>360° Rotating Phone Holder (컬러: 블랙)</a:t>
                       </a:r>
                       <a:endParaRPr lang="en-US" sz="1100" dirty="0">
                         <a:latin typeface="맑은 고딕" charset="0"/>
@@ -16781,7 +16781,7 @@
                           <a:ea typeface="맑은 고딕" pitchFamily="34" charset="-122"/>
                           <a:cs typeface="맑은 고딕" pitchFamily="34" charset="-120"/>
                         </a:rPr>
-                        <a:t>8</a:t>
+                        <a:t>14</a:t>
                       </a:r>
                       <a:endParaRPr lang="en-US" sz="1100" dirty="0">
                         <a:latin typeface="맑은 고딕" charset="0"/>
@@ -16849,7 +16849,7 @@
                           <a:ea typeface="맑은 고딕" pitchFamily="34" charset="-122"/>
                           <a:cs typeface="맑은 고딕" pitchFamily="34" charset="-120"/>
                         </a:rPr>
-                        <a:t>7 개</a:t>
+                        <a:t>1 개</a:t>
                       </a:r>
                       <a:endParaRPr lang="en-US" sz="1100" dirty="0">
                         <a:latin typeface="맑은 고딕" charset="0"/>
@@ -17055,7 +17055,7 @@
                           <a:ea typeface="맑은 고딕" pitchFamily="34" charset="-122"/>
                           <a:cs typeface="맑은 고딕" pitchFamily="34" charset="-120"/>
                         </a:rPr>
-                        <a:t>ETC</a:t>
+                        <a:t>★ Last Sale ★</a:t>
                       </a:r>
                       <a:endParaRPr lang="en-US" sz="1000" dirty="0">
                         <a:latin typeface="맑은 고딕" charset="0"/>
@@ -17123,7 +17123,7 @@
                           <a:ea typeface="맑은 고딕" pitchFamily="34" charset="-122"/>
                           <a:cs typeface="맑은 고딕" pitchFamily="34" charset="-120"/>
                         </a:rPr>
-                        <a:t>Fuzzy Stripe Slippers (3color) (컬러: 그린 / 사이즈: 240~250(여성))</a:t>
+                        <a:t>Cloud Grip Glass Mini Brush (3color) (컬러: 스카이블루)</a:t>
                       </a:r>
                       <a:endParaRPr lang="en-US" sz="1100" dirty="0">
                         <a:latin typeface="맑은 고딕" charset="0"/>
@@ -17191,7 +17191,7 @@
                           <a:ea typeface="맑은 고딕" pitchFamily="34" charset="-122"/>
                           <a:cs typeface="맑은 고딕" pitchFamily="34" charset="-120"/>
                         </a:rPr>
-                        <a:t>0</a:t>
+                        <a:t>12</a:t>
                       </a:r>
                       <a:endParaRPr lang="en-US" sz="1100" dirty="0">
                         <a:latin typeface="맑은 고딕" charset="0"/>
@@ -17259,7 +17259,7 @@
                           <a:ea typeface="맑은 고딕" pitchFamily="34" charset="-122"/>
                           <a:cs typeface="맑은 고딕" pitchFamily="34" charset="-120"/>
                         </a:rPr>
-                        <a:t>4 개</a:t>
+                        <a:t>1 개</a:t>
                       </a:r>
                       <a:endParaRPr lang="en-US" sz="1100" dirty="0">
                         <a:latin typeface="맑은 고딕" charset="0"/>
@@ -17397,7 +17397,7 @@
                           <a:ea typeface="맑은 고딕" pitchFamily="34" charset="-122"/>
                           <a:cs typeface="맑은 고딕" pitchFamily="34" charset="-120"/>
                         </a:rPr>
-                        <a:t>6A</a:t>
+                        <a:t>PR</a:t>
                       </a:r>
                       <a:endParaRPr lang="en-US" sz="1100" dirty="0">
                         <a:latin typeface="맑은 고딕" charset="0"/>
@@ -17465,7 +17465,7 @@
                           <a:ea typeface="맑은 고딕" pitchFamily="34" charset="-122"/>
                           <a:cs typeface="맑은 고딕" pitchFamily="34" charset="-120"/>
                         </a:rPr>
-                        <a:t>Ring</a:t>
+                        <a:t>ETC</a:t>
                       </a:r>
                       <a:endParaRPr lang="en-US" sz="1000" dirty="0">
                         <a:latin typeface="맑은 고딕" charset="0"/>
@@ -17533,7 +17533,7 @@
                           <a:ea typeface="맑은 고딕" pitchFamily="34" charset="-122"/>
                           <a:cs typeface="맑은 고딕" pitchFamily="34" charset="-120"/>
                         </a:rPr>
-                        <a:t>[SILVER925] Flowy Open Ring</a:t>
+                        <a:t>360° Rotating Phone Holder (컬러: 화이트)</a:t>
                       </a:r>
                       <a:endParaRPr lang="en-US" sz="1100" dirty="0">
                         <a:latin typeface="맑은 고딕" charset="0"/>
@@ -17601,7 +17601,7 @@
                           <a:ea typeface="맑은 고딕" pitchFamily="34" charset="-122"/>
                           <a:cs typeface="맑은 고딕" pitchFamily="34" charset="-120"/>
                         </a:rPr>
-                        <a:t>3</a:t>
+                        <a:t>7</a:t>
                       </a:r>
                       <a:endParaRPr lang="en-US" sz="1100" dirty="0">
                         <a:latin typeface="맑은 고딕" charset="0"/>
@@ -17807,7 +17807,7 @@
                           <a:ea typeface="맑은 고딕" pitchFamily="34" charset="-122"/>
                           <a:cs typeface="맑은 고딕" pitchFamily="34" charset="-120"/>
                         </a:rPr>
-                        <a:t>CT</a:t>
+                        <a:t>PR</a:t>
                       </a:r>
                       <a:endParaRPr lang="en-US" sz="1100" dirty="0">
                         <a:latin typeface="맑은 고딕" charset="0"/>
@@ -17875,7 +17875,7 @@
                           <a:ea typeface="맑은 고딕" pitchFamily="34" charset="-122"/>
                           <a:cs typeface="맑은 고딕" pitchFamily="34" charset="-120"/>
                         </a:rPr>
-                        <a:t>Ring</a:t>
+                        <a:t>ELECTRONIC</a:t>
                       </a:r>
                       <a:endParaRPr lang="en-US" sz="1000" dirty="0">
                         <a:latin typeface="맑은 고딕" charset="0"/>
@@ -17943,7 +17943,7 @@
                           <a:ea typeface="맑은 고딕" pitchFamily="34" charset="-122"/>
                           <a:cs typeface="맑은 고딕" pitchFamily="34" charset="-120"/>
                         </a:rPr>
-                        <a:t>"ATOR" 925 Open Ring</a:t>
+                        <a:t>Jacquard Fast Charging Cable (7color) (컬러: 민트 / 기종옵션: C-Apple 8pin / 길이: 2m)</a:t>
                       </a:r>
                       <a:endParaRPr lang="en-US" sz="1100" dirty="0">
                         <a:latin typeface="맑은 고딕" charset="0"/>
@@ -18011,7 +18011,7 @@
                           <a:ea typeface="맑은 고딕" pitchFamily="34" charset="-122"/>
                           <a:cs typeface="맑은 고딕" pitchFamily="34" charset="-120"/>
                         </a:rPr>
-                        <a:t>5</a:t>
+                        <a:t>7</a:t>
                       </a:r>
                       <a:endParaRPr lang="en-US" sz="1100" dirty="0">
                         <a:latin typeface="맑은 고딕" charset="0"/>
@@ -18168,7 +18168,7 @@
                 <a:ea typeface="맑은 고딕" pitchFamily="34" charset="-122"/>
                 <a:cs typeface="맑은 고딕" pitchFamily="34" charset="-120"/>
               </a:rPr>
-              <a:t>외 66건 더 있음 — 상세는 시트에서 확인</a:t>
+              <a:t>외 58건 더 있음 — 상세는 시트에서 확인</a:t>
             </a:r>
             <a:endParaRPr lang="en-US" sz="1000" dirty="0"/>
           </a:p>
@@ -18207,7 +18207,7 @@
                 <a:ea typeface="맑은 고딕" pitchFamily="34" charset="-122"/>
                 <a:cs typeface="맑은 고딕" pitchFamily="34" charset="-120"/>
               </a:rPr>
-              <a:t>베스트 상품 리포트  ·  생성 2026-05-28 08:00</a:t>
+              <a:t>베스트 상품 리포트  ·  생성 2026-05-29 08:00</a:t>
             </a:r>
             <a:endParaRPr lang="en-US" sz="900" dirty="0"/>
           </a:p>
@@ -18420,7 +18420,7 @@
                 <a:ea typeface="맑은 고딕" pitchFamily="34" charset="-122"/>
                 <a:cs typeface="맑은 고딕" pitchFamily="34" charset="-120"/>
               </a:rPr>
-              <a:t>2026년 05월 28일 (목)</a:t>
+              <a:t>2026년 05월 29일 (금)</a:t>
             </a:r>
             <a:endParaRPr lang="en-US" sz="1200" dirty="0"/>
           </a:p>
@@ -18587,7 +18587,7 @@
                 <a:ea typeface="맑은 고딕" pitchFamily="34" charset="-122"/>
                 <a:cs typeface="맑은 고딕" pitchFamily="34" charset="-120"/>
               </a:rPr>
-              <a:t>Google Sheet '브랜드 재고현황'  ·  최신화 2026-05-28 08:00</a:t>
+              <a:t>Google Sheet '브랜드 재고현황'  ·  최신화 2026-05-29 08:00</a:t>
             </a:r>
             <a:endParaRPr lang="en-US" sz="1100" dirty="0"/>
           </a:p>
@@ -19099,7 +19099,7 @@
                 <a:ea typeface="맑은 고딕" pitchFamily="34" charset="-122"/>
                 <a:cs typeface="맑은 고딕" pitchFamily="34" charset="-120"/>
               </a:rPr>
-              <a:t>✅ 6A 86 SKU  /  ✅ Cleartype 59 SKU  /  ✅ Produktepr 200 SKU (판매 수집됨)</a:t>
+              <a:t>✅ 6A 88 SKU  /  ✅ Cleartype 59 SKU  /  ✅ Produktepr 200 SKU (판매 수집됨)</a:t>
             </a:r>
             <a:endParaRPr lang="en-US" sz="1100" dirty="0"/>
           </a:p>
@@ -19230,7 +19230,7 @@
                 <a:ea typeface="맑은 고딕" pitchFamily="34" charset="-122"/>
                 <a:cs typeface="맑은 고딕" pitchFamily="34" charset="-120"/>
               </a:rPr>
-              <a:t>✅ 3개 브랜드 모두 정상 추출  ·  24h 출고 기준 (2026-05-27 08:00 → 2026-05-28 08:00) · 신규 SKU 16건은 결제완료 기준</a:t>
+              <a:t>✅ 3개 브랜드 모두 정상 추출  ·  24h 출고 기준 (2026-05-28 08:00 → 2026-05-29 08:00) · 신규 SKU 16건은 결제완료 기준</a:t>
             </a:r>
             <a:endParaRPr lang="en-US" sz="1000" dirty="0"/>
           </a:p>
@@ -19269,7 +19269,7 @@
                 <a:ea typeface="맑은 고딕" pitchFamily="34" charset="-122"/>
                 <a:cs typeface="맑은 고딕" pitchFamily="34" charset="-120"/>
               </a:rPr>
-              <a:t>베스트 상품 리포트  ·  생성 2026-05-28 08:00</a:t>
+              <a:t>베스트 상품 리포트  ·  생성 2026-05-29 08:00</a:t>
             </a:r>
             <a:endParaRPr lang="en-US" sz="900" dirty="0"/>
           </a:p>

</xml_diff>

<commit_message>
chore: 매출 PPT 업로드 (best-sellers-2026-05-30.pptx) [auto]
</commit_message>
<xml_diff>
--- a/data/sales-report.pptx
+++ b/data/sales-report.pptx
@@ -1648,7 +1648,7 @@
                 <a:ea typeface="맑은 고딕" pitchFamily="34" charset="-122"/>
                 <a:cs typeface="맑은 고딕" pitchFamily="34" charset="-120"/>
               </a:rPr>
-              <a:t>2026년 05월 29일 (금)  ·  24h 출고 기준</a:t>
+              <a:t>2026년 05월 30일 (토)  ·  24h 출고 기준</a:t>
             </a:r>
             <a:endParaRPr lang="en-US" sz="2200" dirty="0"/>
           </a:p>
@@ -1726,7 +1726,7 @@
                 <a:ea typeface="맑은 고딕" pitchFamily="34" charset="-122"/>
                 <a:cs typeface="맑은 고딕" pitchFamily="34" charset="-120"/>
               </a:rPr>
-              <a:t>05.29</a:t>
+              <a:t>05.30</a:t>
             </a:r>
             <a:endParaRPr lang="en-US" sz="7200" dirty="0"/>
           </a:p>
@@ -1765,7 +1765,7 @@
                 <a:ea typeface="맑은 고딕" pitchFamily="34" charset="-122"/>
                 <a:cs typeface="맑은 고딕" pitchFamily="34" charset="-120"/>
               </a:rPr>
-              <a:t>금요일</a:t>
+              <a:t>토요일</a:t>
             </a:r>
             <a:endParaRPr lang="en-US" sz="1400" dirty="0"/>
           </a:p>
@@ -1804,7 +1804,7 @@
                 <a:ea typeface="맑은 고딕" pitchFamily="34" charset="-122"/>
                 <a:cs typeface="맑은 고딕" pitchFamily="34" charset="-120"/>
               </a:rPr>
-              <a:t>생성 2026-05-29 08:00  ·  Google Sheet 자동 동기</a:t>
+              <a:t>생성 2026-05-30 08:00  ·  Google Sheet 자동 동기</a:t>
             </a:r>
             <a:endParaRPr lang="en-US" sz="1000" dirty="0"/>
           </a:p>
@@ -1978,7 +1978,7 @@
                 <a:ea typeface="맑은 고딕" pitchFamily="34" charset="-122"/>
                 <a:cs typeface="맑은 고딕" pitchFamily="34" charset="-120"/>
               </a:rPr>
-              <a:t>2026년 05월 29일 (금)</a:t>
+              <a:t>2026년 05월 30일 (토)</a:t>
             </a:r>
             <a:endParaRPr lang="en-US" sz="1200" dirty="0"/>
           </a:p>
@@ -2145,7 +2145,7 @@
                 <a:ea typeface="맑은 고딕" pitchFamily="34" charset="-122"/>
                 <a:cs typeface="맑은 고딕" pitchFamily="34" charset="-120"/>
               </a:rPr>
-              <a:t>376 개</a:t>
+              <a:t>383 개</a:t>
             </a:r>
             <a:endParaRPr lang="en-US" sz="3600" dirty="0"/>
           </a:p>
@@ -2312,7 +2312,7 @@
                 <a:ea typeface="맑은 고딕" pitchFamily="34" charset="-122"/>
                 <a:cs typeface="맑은 고딕" pitchFamily="34" charset="-120"/>
               </a:rPr>
-              <a:t>67 건</a:t>
+              <a:t>66 건</a:t>
             </a:r>
             <a:endParaRPr lang="en-US" sz="3200" dirty="0"/>
           </a:p>
@@ -2479,7 +2479,7 @@
                 <a:ea typeface="맑은 고딕" pitchFamily="34" charset="-122"/>
                 <a:cs typeface="맑은 고딕" pitchFamily="34" charset="-120"/>
               </a:rPr>
-              <a:t>12 건</a:t>
+              <a:t>10 건</a:t>
             </a:r>
             <a:endParaRPr lang="en-US" sz="3200" dirty="0"/>
           </a:p>
@@ -2685,7 +2685,7 @@
                 <a:ea typeface="맑은 고딕" pitchFamily="34" charset="-122"/>
                 <a:cs typeface="맑은 고딕" pitchFamily="34" charset="-120"/>
               </a:rPr>
-              <a:t>88 SKU  ·  판매 OK</a:t>
+              <a:t>100 SKU  ·  판매 OK</a:t>
             </a:r>
             <a:pPr indent="0" marL="0">
               <a:buNone/>
@@ -3677,7 +3677,7 @@
                           <a:ea typeface="맑은 고딕" pitchFamily="34" charset="-122"/>
                           <a:cs typeface="맑은 고딕" pitchFamily="34" charset="-120"/>
                         </a:rPr>
-                        <a:t>60 개</a:t>
+                        <a:t>39 개</a:t>
                       </a:r>
                       <a:endParaRPr lang="en-US" sz="1400" dirty="0">
                         <a:latin typeface="맑은 고딕" charset="0"/>
@@ -3874,7 +3874,7 @@
                           <a:ea typeface="맑은 고딕" pitchFamily="34" charset="-122"/>
                           <a:cs typeface="맑은 고딕" pitchFamily="34" charset="-120"/>
                         </a:rPr>
-                        <a:t>Ring</a:t>
+                        <a:t>Necklace</a:t>
                       </a:r>
                       <a:endParaRPr lang="en-US" sz="1000" dirty="0">
                         <a:latin typeface="맑은 고딕" charset="0"/>
@@ -3939,7 +3939,7 @@
                           <a:ea typeface="맑은 고딕" pitchFamily="34" charset="-122"/>
                           <a:cs typeface="맑은 고딕" pitchFamily="34" charset="-120"/>
                         </a:rPr>
-                        <a:t>[SILVER925] Guyeong Open Ring v3.0 (silver)</a:t>
+                        <a:t>Marquise Necklace</a:t>
                       </a:r>
                       <a:endParaRPr lang="en-US" sz="1100" dirty="0">
                         <a:latin typeface="맑은 고딕" charset="0"/>
@@ -4004,7 +4004,7 @@
                           <a:ea typeface="맑은 고딕" pitchFamily="34" charset="-122"/>
                           <a:cs typeface="맑은 고딕" pitchFamily="34" charset="-120"/>
                         </a:rPr>
-                        <a:t>35 개</a:t>
+                        <a:t>29 개</a:t>
                       </a:r>
                       <a:endParaRPr lang="en-US" sz="1400" dirty="0">
                         <a:latin typeface="맑은 고딕" charset="0"/>
@@ -4136,7 +4136,7 @@
                           <a:ea typeface="맑은 고딕" pitchFamily="34" charset="-122"/>
                           <a:cs typeface="맑은 고딕" pitchFamily="34" charset="-120"/>
                         </a:rPr>
-                        <a:t>CT</a:t>
+                        <a:t>6A</a:t>
                       </a:r>
                       <a:endParaRPr lang="en-US" sz="1100" dirty="0">
                         <a:latin typeface="맑은 고딕" charset="0"/>
@@ -4201,7 +4201,7 @@
                           <a:ea typeface="맑은 고딕" pitchFamily="34" charset="-122"/>
                           <a:cs typeface="맑은 고딕" pitchFamily="34" charset="-120"/>
                         </a:rPr>
-                        <a:t>Necklace</a:t>
+                        <a:t>Ring</a:t>
                       </a:r>
                       <a:endParaRPr lang="en-US" sz="1000" dirty="0">
                         <a:latin typeface="맑은 고딕" charset="0"/>
@@ -4266,7 +4266,7 @@
                           <a:ea typeface="맑은 고딕" pitchFamily="34" charset="-122"/>
                           <a:cs typeface="맑은 고딕" pitchFamily="34" charset="-120"/>
                         </a:rPr>
-                        <a:t>ThreadDuo Necklace</a:t>
+                        <a:t>[SILVER925] Guyeong Open Ring v3.0 (silver)</a:t>
                       </a:r>
                       <a:endParaRPr lang="en-US" sz="1100" dirty="0">
                         <a:latin typeface="맑은 고딕" charset="0"/>
@@ -4331,7 +4331,7 @@
                           <a:ea typeface="맑은 고딕" pitchFamily="34" charset="-122"/>
                           <a:cs typeface="맑은 고딕" pitchFamily="34" charset="-120"/>
                         </a:rPr>
-                        <a:t>15 개</a:t>
+                        <a:t>28 개</a:t>
                       </a:r>
                       <a:endParaRPr lang="en-US" sz="1400" dirty="0">
                         <a:latin typeface="맑은 고딕" charset="0"/>
@@ -4463,7 +4463,7 @@
                           <a:ea typeface="맑은 고딕" pitchFamily="34" charset="-122"/>
                           <a:cs typeface="맑은 고딕" pitchFamily="34" charset="-120"/>
                         </a:rPr>
-                        <a:t>6A</a:t>
+                        <a:t>CT</a:t>
                       </a:r>
                       <a:endParaRPr lang="en-US" sz="1100" dirty="0">
                         <a:latin typeface="맑은 고딕" charset="0"/>
@@ -4528,7 +4528,7 @@
                           <a:ea typeface="맑은 고딕" pitchFamily="34" charset="-122"/>
                           <a:cs typeface="맑은 고딕" pitchFamily="34" charset="-120"/>
                         </a:rPr>
-                        <a:t>Ring</a:t>
+                        <a:t>Necklace</a:t>
                       </a:r>
                       <a:endParaRPr lang="en-US" sz="1000" dirty="0">
                         <a:latin typeface="맑은 고딕" charset="0"/>
@@ -4593,7 +4593,7 @@
                           <a:ea typeface="맑은 고딕" pitchFamily="34" charset="-122"/>
                           <a:cs typeface="맑은 고딕" pitchFamily="34" charset="-120"/>
                         </a:rPr>
-                        <a:t>[SILVER925] Starly Open Ring</a:t>
+                        <a:t>CandyPOP Necklace (사이즈: 1size (37~43cm))</a:t>
                       </a:r>
                       <a:endParaRPr lang="en-US" sz="1100" dirty="0">
                         <a:latin typeface="맑은 고딕" charset="0"/>
@@ -4658,7 +4658,7 @@
                           <a:ea typeface="맑은 고딕" pitchFamily="34" charset="-122"/>
                           <a:cs typeface="맑은 고딕" pitchFamily="34" charset="-120"/>
                         </a:rPr>
-                        <a:t>13 개</a:t>
+                        <a:t>24 개</a:t>
                       </a:r>
                       <a:endParaRPr lang="en-US" sz="1200" dirty="0">
                         <a:latin typeface="맑은 고딕" charset="0"/>
@@ -4790,7 +4790,7 @@
                           <a:ea typeface="맑은 고딕" pitchFamily="34" charset="-122"/>
                           <a:cs typeface="맑은 고딕" pitchFamily="34" charset="-120"/>
                         </a:rPr>
-                        <a:t>CT</a:t>
+                        <a:t>6A</a:t>
                       </a:r>
                       <a:endParaRPr lang="en-US" sz="1100" dirty="0">
                         <a:latin typeface="맑은 고딕" charset="0"/>
@@ -4920,7 +4920,7 @@
                           <a:ea typeface="맑은 고딕" pitchFamily="34" charset="-122"/>
                           <a:cs typeface="맑은 고딕" pitchFamily="34" charset="-120"/>
                         </a:rPr>
-                        <a:t>"4s" 925 Open Ring (사이즈: 남성)</a:t>
+                        <a:t>[SILVER925] Eramam Open Ring</a:t>
                       </a:r>
                       <a:endParaRPr lang="en-US" sz="1100" dirty="0">
                         <a:latin typeface="맑은 고딕" charset="0"/>
@@ -4985,7 +4985,7 @@
                           <a:ea typeface="맑은 고딕" pitchFamily="34" charset="-122"/>
                           <a:cs typeface="맑은 고딕" pitchFamily="34" charset="-120"/>
                         </a:rPr>
-                        <a:t>13 개</a:t>
+                        <a:t>21 개</a:t>
                       </a:r>
                       <a:endParaRPr lang="en-US" sz="1200" dirty="0">
                         <a:latin typeface="맑은 고딕" charset="0"/>
@@ -5071,7 +5071,7 @@
                 <a:ea typeface="맑은 고딕" pitchFamily="34" charset="-122"/>
                 <a:cs typeface="맑은 고딕" pitchFamily="34" charset="-120"/>
               </a:rPr>
-              <a:t>베스트 상품 리포트  ·  생성 2026-05-29 08:00</a:t>
+              <a:t>베스트 상품 리포트  ·  생성 2026-05-30 08:00</a:t>
             </a:r>
             <a:endParaRPr lang="en-US" sz="900" dirty="0"/>
           </a:p>
@@ -5284,7 +5284,7 @@
                 <a:ea typeface="맑은 고딕" pitchFamily="34" charset="-122"/>
                 <a:cs typeface="맑은 고딕" pitchFamily="34" charset="-120"/>
               </a:rPr>
-              <a:t>2026년 05월 29일 (금)</a:t>
+              <a:t>2026년 05월 30일 (토)</a:t>
             </a:r>
             <a:endParaRPr lang="en-US" sz="1200" dirty="0"/>
           </a:p>
@@ -5451,7 +5451,7 @@
                 <a:ea typeface="맑은 고딕" pitchFamily="34" charset="-122"/>
                 <a:cs typeface="맑은 고딕" pitchFamily="34" charset="-120"/>
               </a:rPr>
-              <a:t>317 개</a:t>
+              <a:t>304 개</a:t>
             </a:r>
             <a:endParaRPr lang="en-US" sz="3600" dirty="0"/>
           </a:p>
@@ -5657,7 +5657,7 @@
                 <a:ea typeface="맑은 고딕" pitchFamily="34" charset="-122"/>
                 <a:cs typeface="맑은 고딕" pitchFamily="34" charset="-120"/>
               </a:rPr>
-              <a:t>60</a:t>
+              <a:t>39</a:t>
             </a:r>
             <a:endParaRPr lang="en-US" sz="4400" dirty="0"/>
           </a:p>
@@ -6256,7 +6256,7 @@
                           <a:ea typeface="맑은 고딕" pitchFamily="34" charset="-122"/>
                           <a:cs typeface="맑은 고딕" pitchFamily="34" charset="-120"/>
                         </a:rPr>
-                        <a:t>60 개</a:t>
+                        <a:t>39 개</a:t>
                       </a:r>
                       <a:endParaRPr lang="en-US" sz="1400" dirty="0">
                         <a:latin typeface="맑은 고딕" charset="0"/>
@@ -6388,7 +6388,7 @@
                           <a:ea typeface="맑은 고딕" pitchFamily="34" charset="-122"/>
                           <a:cs typeface="맑은 고딕" pitchFamily="34" charset="-120"/>
                         </a:rPr>
-                        <a:t>Ring</a:t>
+                        <a:t>Necklace</a:t>
                       </a:r>
                       <a:endParaRPr lang="en-US" sz="1000" dirty="0">
                         <a:latin typeface="맑은 고딕" charset="0"/>
@@ -6453,7 +6453,7 @@
                           <a:ea typeface="맑은 고딕" pitchFamily="34" charset="-122"/>
                           <a:cs typeface="맑은 고딕" pitchFamily="34" charset="-120"/>
                         </a:rPr>
-                        <a:t>[SILVER925] Guyeong Open Ring v3.0 (silver)</a:t>
+                        <a:t>Marquise Necklace</a:t>
                       </a:r>
                       <a:endParaRPr lang="en-US" sz="1100" dirty="0">
                         <a:latin typeface="맑은 고딕" charset="0"/>
@@ -6518,7 +6518,7 @@
                           <a:ea typeface="맑은 고딕" pitchFamily="34" charset="-122"/>
                           <a:cs typeface="맑은 고딕" pitchFamily="34" charset="-120"/>
                         </a:rPr>
-                        <a:t>35 개</a:t>
+                        <a:t>29 개</a:t>
                       </a:r>
                       <a:endParaRPr lang="en-US" sz="1200" dirty="0">
                         <a:latin typeface="맑은 고딕" charset="0"/>
@@ -6715,7 +6715,7 @@
                           <a:ea typeface="맑은 고딕" pitchFamily="34" charset="-122"/>
                           <a:cs typeface="맑은 고딕" pitchFamily="34" charset="-120"/>
                         </a:rPr>
-                        <a:t>[SILVER925] Starly Open Ring</a:t>
+                        <a:t>[SILVER925] Guyeong Open Ring v3.0 (silver)</a:t>
                       </a:r>
                       <a:endParaRPr lang="en-US" sz="1100" dirty="0">
                         <a:latin typeface="맑은 고딕" charset="0"/>
@@ -6780,7 +6780,7 @@
                           <a:ea typeface="맑은 고딕" pitchFamily="34" charset="-122"/>
                           <a:cs typeface="맑은 고딕" pitchFamily="34" charset="-120"/>
                         </a:rPr>
-                        <a:t>13 개</a:t>
+                        <a:t>28 개</a:t>
                       </a:r>
                       <a:endParaRPr lang="en-US" sz="1200" dirty="0">
                         <a:latin typeface="맑은 고딕" charset="0"/>
@@ -6977,7 +6977,7 @@
                           <a:ea typeface="맑은 고딕" pitchFamily="34" charset="-122"/>
                           <a:cs typeface="맑은 고딕" pitchFamily="34" charset="-120"/>
                         </a:rPr>
-                        <a:t>[SILVER925] Cstic Open Ring</a:t>
+                        <a:t>[SILVER925] Eramam Open Ring</a:t>
                       </a:r>
                       <a:endParaRPr lang="en-US" sz="1100" dirty="0">
                         <a:latin typeface="맑은 고딕" charset="0"/>
@@ -7042,7 +7042,7 @@
                           <a:ea typeface="맑은 고딕" pitchFamily="34" charset="-122"/>
                           <a:cs typeface="맑은 고딕" pitchFamily="34" charset="-120"/>
                         </a:rPr>
-                        <a:t>12 개</a:t>
+                        <a:t>21 개</a:t>
                       </a:r>
                       <a:endParaRPr lang="en-US" sz="1200" dirty="0">
                         <a:latin typeface="맑은 고딕" charset="0"/>
@@ -7174,7 +7174,7 @@
                           <a:ea typeface="맑은 고딕" pitchFamily="34" charset="-122"/>
                           <a:cs typeface="맑은 고딕" pitchFamily="34" charset="-120"/>
                         </a:rPr>
-                        <a:t>Ring</a:t>
+                        <a:t>Necklace</a:t>
                       </a:r>
                       <a:endParaRPr lang="en-US" sz="1000" dirty="0">
                         <a:latin typeface="맑은 고딕" charset="0"/>
@@ -7239,7 +7239,7 @@
                           <a:ea typeface="맑은 고딕" pitchFamily="34" charset="-122"/>
                           <a:cs typeface="맑은 고딕" pitchFamily="34" charset="-120"/>
                         </a:rPr>
-                        <a:t>[SILVER925] A Rua Open Ring</a:t>
+                        <a:t>Tiny Cross Necklace</a:t>
                       </a:r>
                       <a:endParaRPr lang="en-US" sz="1100" dirty="0">
                         <a:latin typeface="맑은 고딕" charset="0"/>
@@ -7390,7 +7390,7 @@
                 <a:ea typeface="맑은 고딕" pitchFamily="34" charset="-122"/>
                 <a:cs typeface="맑은 고딕" pitchFamily="34" charset="-120"/>
               </a:rPr>
-              <a:t>리오더 필요  🔴 긴급 6건</a:t>
+              <a:t>리오더 필요  🔴 긴급 5건</a:t>
             </a:r>
             <a:pPr indent="0" marL="0">
               <a:buNone/>
@@ -7596,7 +7596,7 @@
                 <a:ea typeface="맑은 고딕" pitchFamily="34" charset="-122"/>
                 <a:cs typeface="맑은 고딕" pitchFamily="34" charset="-120"/>
               </a:rPr>
-              <a:t>Ring  ·  재고 1개</a:t>
+              <a:t>Ring  ·  재고 0개</a:t>
             </a:r>
             <a:pPr indent="0" marL="0">
               <a:buNone/>
@@ -7763,212 +7763,6 @@
                 <a:ea typeface="맑은 고딕" pitchFamily="34" charset="-122"/>
                 <a:cs typeface="맑은 고딕" pitchFamily="34" charset="-120"/>
               </a:rPr>
-              <a:t>[SILVER925] Flowy Open Ring</a:t>
-            </a:r>
-            <a:endParaRPr lang="en-US" sz="1100" dirty="0"/>
-          </a:p>
-        </p:txBody>
-      </p:sp>
-      <p:sp>
-        <p:nvSpPr>
-          <p:cNvPr id="32" name="Text 29"/>
-          <p:cNvSpPr/>
-          <p:nvPr/>
-        </p:nvSpPr>
-        <p:spPr>
-          <a:xfrm>
-            <a:off x="8211312" y="4425696"/>
-            <a:ext cx="3291840" cy="256032"/>
-          </a:xfrm>
-          <a:prstGeom prst="rect">
-            <a:avLst/>
-          </a:prstGeom>
-          <a:noFill/>
-          <a:ln/>
-        </p:spPr>
-        <p:txBody>
-          <a:bodyPr wrap="square" lIns="0" tIns="0" rIns="0" bIns="0" rtlCol="0" anchor="ctr"/>
-          <a:lstStyle/>
-          <a:p>
-            <a:pPr indent="0" marL="0">
-              <a:buNone/>
-            </a:pPr>
-            <a:r>
-              <a:rPr lang="en-US" sz="1000" dirty="0">
-                <a:solidFill>
-                  <a:srgbClr val="6B7280"/>
-                </a:solidFill>
-                <a:latin typeface="맑은 고딕" pitchFamily="34" charset="0"/>
-                <a:ea typeface="맑은 고딕" pitchFamily="34" charset="-122"/>
-                <a:cs typeface="맑은 고딕" pitchFamily="34" charset="-120"/>
-              </a:rPr>
-              <a:t>Ring  ·  재고 2개</a:t>
-            </a:r>
-            <a:pPr indent="0" marL="0">
-              <a:buNone/>
-            </a:pPr>
-            <a:r>
-              <a:rPr lang="en-US" sz="1000" b="1" dirty="0">
-                <a:solidFill>
-                  <a:srgbClr val="D72638"/>
-                </a:solidFill>
-                <a:latin typeface="맑은 고딕" pitchFamily="34" charset="0"/>
-                <a:ea typeface="맑은 고딕" pitchFamily="34" charset="-122"/>
-                <a:cs typeface="맑은 고딕" pitchFamily="34" charset="-120"/>
-              </a:rPr>
-              <a:t/>
-            </a:r>
-            <a:endParaRPr lang="en-US" sz="1000" dirty="0"/>
-          </a:p>
-        </p:txBody>
-      </p:sp>
-      <p:sp>
-        <p:nvSpPr>
-          <p:cNvPr id="33" name="Shape 30"/>
-          <p:cNvSpPr/>
-          <p:nvPr/>
-        </p:nvSpPr>
-        <p:spPr>
-          <a:xfrm>
-            <a:off x="7406640" y="4809744"/>
-            <a:ext cx="4206240" cy="640080"/>
-          </a:xfrm>
-          <a:prstGeom prst="rect">
-            <a:avLst/>
-          </a:prstGeom>
-          <a:solidFill>
-            <a:srgbClr val="FFF5F5"/>
-          </a:solidFill>
-          <a:ln w="6350">
-            <a:solidFill>
-              <a:srgbClr val="E5E7EB"/>
-            </a:solidFill>
-            <a:prstDash val="solid"/>
-          </a:ln>
-        </p:spPr>
-      </p:sp>
-      <p:sp>
-        <p:nvSpPr>
-          <p:cNvPr id="34" name="Shape 31"/>
-          <p:cNvSpPr/>
-          <p:nvPr/>
-        </p:nvSpPr>
-        <p:spPr>
-          <a:xfrm>
-            <a:off x="7406640" y="4809744"/>
-            <a:ext cx="109728" cy="640080"/>
-          </a:xfrm>
-          <a:prstGeom prst="rect">
-            <a:avLst/>
-          </a:prstGeom>
-          <a:solidFill>
-            <a:srgbClr val="D72638"/>
-          </a:solidFill>
-          <a:ln w="12700">
-            <a:solidFill>
-              <a:srgbClr val="D72638"/>
-            </a:solidFill>
-            <a:prstDash val="solid"/>
-          </a:ln>
-        </p:spPr>
-      </p:sp>
-      <p:sp>
-        <p:nvSpPr>
-          <p:cNvPr id="35" name="Shape 32"/>
-          <p:cNvSpPr/>
-          <p:nvPr/>
-        </p:nvSpPr>
-        <p:spPr>
-          <a:xfrm>
-            <a:off x="7571232" y="4901184"/>
-            <a:ext cx="548640" cy="256032"/>
-          </a:xfrm>
-          <a:prstGeom prst="rect">
-            <a:avLst/>
-          </a:prstGeom>
-          <a:solidFill>
-            <a:srgbClr val="D72638"/>
-          </a:solidFill>
-          <a:ln w="12700">
-            <a:solidFill>
-              <a:srgbClr val="D72638"/>
-            </a:solidFill>
-            <a:prstDash val="solid"/>
-          </a:ln>
-        </p:spPr>
-      </p:sp>
-      <p:sp>
-        <p:nvSpPr>
-          <p:cNvPr id="36" name="Text 33"/>
-          <p:cNvSpPr/>
-          <p:nvPr/>
-        </p:nvSpPr>
-        <p:spPr>
-          <a:xfrm>
-            <a:off x="7571232" y="4901184"/>
-            <a:ext cx="548640" cy="256032"/>
-          </a:xfrm>
-          <a:prstGeom prst="rect">
-            <a:avLst/>
-          </a:prstGeom>
-          <a:noFill/>
-          <a:ln/>
-        </p:spPr>
-        <p:txBody>
-          <a:bodyPr wrap="square" lIns="0" tIns="0" rIns="0" bIns="0" rtlCol="0" anchor="ctr"/>
-          <a:lstStyle/>
-          <a:p>
-            <a:pPr algn="ctr" indent="0" marL="0">
-              <a:buNone/>
-            </a:pPr>
-            <a:r>
-              <a:rPr lang="en-US" sz="900" b="1" dirty="0">
-                <a:solidFill>
-                  <a:srgbClr val="FFFFFF"/>
-                </a:solidFill>
-                <a:latin typeface="맑은 고딕" pitchFamily="34" charset="0"/>
-                <a:ea typeface="맑은 고딕" pitchFamily="34" charset="-122"/>
-                <a:cs typeface="맑은 고딕" pitchFamily="34" charset="-120"/>
-              </a:rPr>
-              <a:t>긴급</a:t>
-            </a:r>
-            <a:endParaRPr lang="en-US" sz="900" dirty="0"/>
-          </a:p>
-        </p:txBody>
-      </p:sp>
-      <p:sp>
-        <p:nvSpPr>
-          <p:cNvPr id="37" name="Text 34"/>
-          <p:cNvSpPr/>
-          <p:nvPr/>
-        </p:nvSpPr>
-        <p:spPr>
-          <a:xfrm>
-            <a:off x="8211312" y="4864608"/>
-            <a:ext cx="3291840" cy="274320"/>
-          </a:xfrm>
-          <a:prstGeom prst="rect">
-            <a:avLst/>
-          </a:prstGeom>
-          <a:noFill/>
-          <a:ln/>
-        </p:spPr>
-        <p:txBody>
-          <a:bodyPr wrap="square" lIns="0" tIns="0" rIns="0" bIns="0" rtlCol="0" anchor="ctr"/>
-          <a:lstStyle/>
-          <a:p>
-            <a:pPr indent="0" marL="0">
-              <a:buNone/>
-            </a:pPr>
-            <a:r>
-              <a:rPr lang="en-US" sz="1100" b="1" dirty="0">
-                <a:solidFill>
-                  <a:srgbClr val="0B1220"/>
-                </a:solidFill>
-                <a:latin typeface="맑은 고딕" pitchFamily="34" charset="0"/>
-                <a:ea typeface="맑은 고딕" pitchFamily="34" charset="-122"/>
-                <a:cs typeface="맑은 고딕" pitchFamily="34" charset="-120"/>
-              </a:rPr>
               <a:t>8-Ball Smart Tok</a:t>
             </a:r>
             <a:endParaRPr lang="en-US" sz="1100" dirty="0"/>
@@ -7977,13 +7771,13 @@
       </p:sp>
       <p:sp>
         <p:nvSpPr>
-          <p:cNvPr id="38" name="Text 35"/>
-          <p:cNvSpPr/>
-          <p:nvPr/>
-        </p:nvSpPr>
-        <p:spPr>
-          <a:xfrm>
-            <a:off x="8211312" y="5138928"/>
+          <p:cNvPr id="32" name="Text 29"/>
+          <p:cNvSpPr/>
+          <p:nvPr/>
+        </p:nvSpPr>
+        <p:spPr>
+          <a:xfrm>
+            <a:off x="8211312" y="4425696"/>
             <a:ext cx="3291840" cy="256032"/>
           </a:xfrm>
           <a:prstGeom prst="rect">
@@ -8030,13 +7824,13 @@
       </p:sp>
       <p:sp>
         <p:nvSpPr>
-          <p:cNvPr id="39" name="Shape 36"/>
-          <p:cNvSpPr/>
-          <p:nvPr/>
-        </p:nvSpPr>
-        <p:spPr>
-          <a:xfrm>
-            <a:off x="7406640" y="5522976"/>
+          <p:cNvPr id="33" name="Shape 30"/>
+          <p:cNvSpPr/>
+          <p:nvPr/>
+        </p:nvSpPr>
+        <p:spPr>
+          <a:xfrm>
+            <a:off x="7406640" y="4809744"/>
             <a:ext cx="4206240" cy="640080"/>
           </a:xfrm>
           <a:prstGeom prst="rect">
@@ -8055,13 +7849,13 @@
       </p:sp>
       <p:sp>
         <p:nvSpPr>
-          <p:cNvPr id="40" name="Shape 37"/>
-          <p:cNvSpPr/>
-          <p:nvPr/>
-        </p:nvSpPr>
-        <p:spPr>
-          <a:xfrm>
-            <a:off x="7406640" y="5522976"/>
+          <p:cNvPr id="34" name="Shape 31"/>
+          <p:cNvSpPr/>
+          <p:nvPr/>
+        </p:nvSpPr>
+        <p:spPr>
+          <a:xfrm>
+            <a:off x="7406640" y="4809744"/>
             <a:ext cx="109728" cy="640080"/>
           </a:xfrm>
           <a:prstGeom prst="rect">
@@ -8080,13 +7874,13 @@
       </p:sp>
       <p:sp>
         <p:nvSpPr>
-          <p:cNvPr id="41" name="Shape 38"/>
-          <p:cNvSpPr/>
-          <p:nvPr/>
-        </p:nvSpPr>
-        <p:spPr>
-          <a:xfrm>
-            <a:off x="7571232" y="5614416"/>
+          <p:cNvPr id="35" name="Shape 32"/>
+          <p:cNvSpPr/>
+          <p:nvPr/>
+        </p:nvSpPr>
+        <p:spPr>
+          <a:xfrm>
+            <a:off x="7571232" y="4901184"/>
             <a:ext cx="548640" cy="256032"/>
           </a:xfrm>
           <a:prstGeom prst="rect">
@@ -8105,13 +7899,13 @@
       </p:sp>
       <p:sp>
         <p:nvSpPr>
-          <p:cNvPr id="42" name="Text 39"/>
-          <p:cNvSpPr/>
-          <p:nvPr/>
-        </p:nvSpPr>
-        <p:spPr>
-          <a:xfrm>
-            <a:off x="7571232" y="5614416"/>
+          <p:cNvPr id="36" name="Text 33"/>
+          <p:cNvSpPr/>
+          <p:nvPr/>
+        </p:nvSpPr>
+        <p:spPr>
+          <a:xfrm>
+            <a:off x="7571232" y="4901184"/>
             <a:ext cx="548640" cy="256032"/>
           </a:xfrm>
           <a:prstGeom prst="rect">
@@ -8144,13 +7938,13 @@
       </p:sp>
       <p:sp>
         <p:nvSpPr>
-          <p:cNvPr id="43" name="Text 40"/>
-          <p:cNvSpPr/>
-          <p:nvPr/>
-        </p:nvSpPr>
-        <p:spPr>
-          <a:xfrm>
-            <a:off x="8211312" y="5577840"/>
+          <p:cNvPr id="37" name="Text 34"/>
+          <p:cNvSpPr/>
+          <p:nvPr/>
+        </p:nvSpPr>
+        <p:spPr>
+          <a:xfrm>
+            <a:off x="8211312" y="4864608"/>
             <a:ext cx="3291840" cy="274320"/>
           </a:xfrm>
           <a:prstGeom prst="rect">
@@ -8183,13 +7977,13 @@
       </p:sp>
       <p:sp>
         <p:nvSpPr>
-          <p:cNvPr id="44" name="Text 41"/>
-          <p:cNvSpPr/>
-          <p:nvPr/>
-        </p:nvSpPr>
-        <p:spPr>
-          <a:xfrm>
-            <a:off x="8211312" y="5852160"/>
+          <p:cNvPr id="38" name="Text 35"/>
+          <p:cNvSpPr/>
+          <p:nvPr/>
+        </p:nvSpPr>
+        <p:spPr>
+          <a:xfrm>
+            <a:off x="8211312" y="5138928"/>
             <a:ext cx="3291840" cy="256032"/>
           </a:xfrm>
           <a:prstGeom prst="rect">
@@ -8236,6 +8030,212 @@
       </p:sp>
       <p:sp>
         <p:nvSpPr>
+          <p:cNvPr id="39" name="Shape 36"/>
+          <p:cNvSpPr/>
+          <p:nvPr/>
+        </p:nvSpPr>
+        <p:spPr>
+          <a:xfrm>
+            <a:off x="7406640" y="5522976"/>
+            <a:ext cx="4206240" cy="640080"/>
+          </a:xfrm>
+          <a:prstGeom prst="rect">
+            <a:avLst/>
+          </a:prstGeom>
+          <a:solidFill>
+            <a:srgbClr val="FFF5F5"/>
+          </a:solidFill>
+          <a:ln w="6350">
+            <a:solidFill>
+              <a:srgbClr val="E5E7EB"/>
+            </a:solidFill>
+            <a:prstDash val="solid"/>
+          </a:ln>
+        </p:spPr>
+      </p:sp>
+      <p:sp>
+        <p:nvSpPr>
+          <p:cNvPr id="40" name="Shape 37"/>
+          <p:cNvSpPr/>
+          <p:nvPr/>
+        </p:nvSpPr>
+        <p:spPr>
+          <a:xfrm>
+            <a:off x="7406640" y="5522976"/>
+            <a:ext cx="109728" cy="640080"/>
+          </a:xfrm>
+          <a:prstGeom prst="rect">
+            <a:avLst/>
+          </a:prstGeom>
+          <a:solidFill>
+            <a:srgbClr val="D72638"/>
+          </a:solidFill>
+          <a:ln w="12700">
+            <a:solidFill>
+              <a:srgbClr val="D72638"/>
+            </a:solidFill>
+            <a:prstDash val="solid"/>
+          </a:ln>
+        </p:spPr>
+      </p:sp>
+      <p:sp>
+        <p:nvSpPr>
+          <p:cNvPr id="41" name="Shape 38"/>
+          <p:cNvSpPr/>
+          <p:nvPr/>
+        </p:nvSpPr>
+        <p:spPr>
+          <a:xfrm>
+            <a:off x="7571232" y="5614416"/>
+            <a:ext cx="548640" cy="256032"/>
+          </a:xfrm>
+          <a:prstGeom prst="rect">
+            <a:avLst/>
+          </a:prstGeom>
+          <a:solidFill>
+            <a:srgbClr val="D72638"/>
+          </a:solidFill>
+          <a:ln w="12700">
+            <a:solidFill>
+              <a:srgbClr val="D72638"/>
+            </a:solidFill>
+            <a:prstDash val="solid"/>
+          </a:ln>
+        </p:spPr>
+      </p:sp>
+      <p:sp>
+        <p:nvSpPr>
+          <p:cNvPr id="42" name="Text 39"/>
+          <p:cNvSpPr/>
+          <p:nvPr/>
+        </p:nvSpPr>
+        <p:spPr>
+          <a:xfrm>
+            <a:off x="7571232" y="5614416"/>
+            <a:ext cx="548640" cy="256032"/>
+          </a:xfrm>
+          <a:prstGeom prst="rect">
+            <a:avLst/>
+          </a:prstGeom>
+          <a:noFill/>
+          <a:ln/>
+        </p:spPr>
+        <p:txBody>
+          <a:bodyPr wrap="square" lIns="0" tIns="0" rIns="0" bIns="0" rtlCol="0" anchor="ctr"/>
+          <a:lstStyle/>
+          <a:p>
+            <a:pPr algn="ctr" indent="0" marL="0">
+              <a:buNone/>
+            </a:pPr>
+            <a:r>
+              <a:rPr lang="en-US" sz="900" b="1" dirty="0">
+                <a:solidFill>
+                  <a:srgbClr val="FFFFFF"/>
+                </a:solidFill>
+                <a:latin typeface="맑은 고딕" pitchFamily="34" charset="0"/>
+                <a:ea typeface="맑은 고딕" pitchFamily="34" charset="-122"/>
+                <a:cs typeface="맑은 고딕" pitchFamily="34" charset="-120"/>
+              </a:rPr>
+              <a:t>긴급</a:t>
+            </a:r>
+            <a:endParaRPr lang="en-US" sz="900" dirty="0"/>
+          </a:p>
+        </p:txBody>
+      </p:sp>
+      <p:sp>
+        <p:nvSpPr>
+          <p:cNvPr id="43" name="Text 40"/>
+          <p:cNvSpPr/>
+          <p:nvPr/>
+        </p:nvSpPr>
+        <p:spPr>
+          <a:xfrm>
+            <a:off x="8211312" y="5577840"/>
+            <a:ext cx="3291840" cy="274320"/>
+          </a:xfrm>
+          <a:prstGeom prst="rect">
+            <a:avLst/>
+          </a:prstGeom>
+          <a:noFill/>
+          <a:ln/>
+        </p:spPr>
+        <p:txBody>
+          <a:bodyPr wrap="square" lIns="0" tIns="0" rIns="0" bIns="0" rtlCol="0" anchor="ctr"/>
+          <a:lstStyle/>
+          <a:p>
+            <a:pPr indent="0" marL="0">
+              <a:buNone/>
+            </a:pPr>
+            <a:r>
+              <a:rPr lang="en-US" sz="1100" b="1" dirty="0">
+                <a:solidFill>
+                  <a:srgbClr val="0B1220"/>
+                </a:solidFill>
+                <a:latin typeface="맑은 고딕" pitchFamily="34" charset="0"/>
+                <a:ea typeface="맑은 고딕" pitchFamily="34" charset="-122"/>
+                <a:cs typeface="맑은 고딕" pitchFamily="34" charset="-120"/>
+              </a:rPr>
+              <a:t>B-Flower Necklace (Size: 1 Size)</a:t>
+            </a:r>
+            <a:endParaRPr lang="en-US" sz="1100" dirty="0"/>
+          </a:p>
+        </p:txBody>
+      </p:sp>
+      <p:sp>
+        <p:nvSpPr>
+          <p:cNvPr id="44" name="Text 41"/>
+          <p:cNvSpPr/>
+          <p:nvPr/>
+        </p:nvSpPr>
+        <p:spPr>
+          <a:xfrm>
+            <a:off x="8211312" y="5852160"/>
+            <a:ext cx="3291840" cy="256032"/>
+          </a:xfrm>
+          <a:prstGeom prst="rect">
+            <a:avLst/>
+          </a:prstGeom>
+          <a:noFill/>
+          <a:ln/>
+        </p:spPr>
+        <p:txBody>
+          <a:bodyPr wrap="square" lIns="0" tIns="0" rIns="0" bIns="0" rtlCol="0" anchor="ctr"/>
+          <a:lstStyle/>
+          <a:p>
+            <a:pPr indent="0" marL="0">
+              <a:buNone/>
+            </a:pPr>
+            <a:r>
+              <a:rPr lang="en-US" sz="1000" dirty="0">
+                <a:solidFill>
+                  <a:srgbClr val="6B7280"/>
+                </a:solidFill>
+                <a:latin typeface="맑은 고딕" pitchFamily="34" charset="0"/>
+                <a:ea typeface="맑은 고딕" pitchFamily="34" charset="-122"/>
+                <a:cs typeface="맑은 고딕" pitchFamily="34" charset="-120"/>
+              </a:rPr>
+              <a:t>Necklace  ·  재고 0개</a:t>
+            </a:r>
+            <a:pPr indent="0" marL="0">
+              <a:buNone/>
+            </a:pPr>
+            <a:r>
+              <a:rPr lang="en-US" sz="1000" b="1" dirty="0">
+                <a:solidFill>
+                  <a:srgbClr val="D72638"/>
+                </a:solidFill>
+                <a:latin typeface="맑은 고딕" pitchFamily="34" charset="0"/>
+                <a:ea typeface="맑은 고딕" pitchFamily="34" charset="-122"/>
+                <a:cs typeface="맑은 고딕" pitchFamily="34" charset="-120"/>
+              </a:rPr>
+              <a:t/>
+            </a:r>
+            <a:endParaRPr lang="en-US" sz="1000" dirty="0"/>
+          </a:p>
+        </p:txBody>
+      </p:sp>
+      <p:sp>
+        <p:nvSpPr>
           <p:cNvPr id="45" name="Text 42"/>
           <p:cNvSpPr/>
           <p:nvPr/>
@@ -8267,7 +8267,7 @@
                 <a:ea typeface="맑은 고딕" pitchFamily="34" charset="-122"/>
                 <a:cs typeface="맑은 고딕" pitchFamily="34" charset="-120"/>
               </a:rPr>
-              <a:t>베스트 상품 리포트  ·  생성 2026-05-29 08:00</a:t>
+              <a:t>베스트 상품 리포트  ·  생성 2026-05-30 08:00</a:t>
             </a:r>
             <a:endParaRPr lang="en-US" sz="900" dirty="0"/>
           </a:p>
@@ -8480,7 +8480,7 @@
                 <a:ea typeface="맑은 고딕" pitchFamily="34" charset="-122"/>
                 <a:cs typeface="맑은 고딕" pitchFamily="34" charset="-120"/>
               </a:rPr>
-              <a:t>2026년 05월 29일 (금)</a:t>
+              <a:t>2026년 05월 30일 (토)</a:t>
             </a:r>
             <a:endParaRPr lang="en-US" sz="1200" dirty="0"/>
           </a:p>
@@ -8647,7 +8647,7 @@
                 <a:ea typeface="맑은 고딕" pitchFamily="34" charset="-122"/>
                 <a:cs typeface="맑은 고딕" pitchFamily="34" charset="-120"/>
               </a:rPr>
-              <a:t>59 개</a:t>
+              <a:t>79 개</a:t>
             </a:r>
             <a:endParaRPr lang="en-US" sz="3600" dirty="0"/>
           </a:p>
@@ -8775,7 +8775,7 @@
                 <a:ea typeface="맑은 고딕" pitchFamily="34" charset="-122"/>
                 <a:cs typeface="맑은 고딕" pitchFamily="34" charset="-120"/>
               </a:rPr>
-              <a:t>ThreadDuo Necklace</a:t>
+              <a:t>CandyPOP Necklace (사이즈: 1size (37~43cm))</a:t>
             </a:r>
             <a:endParaRPr lang="en-US" sz="1800" dirty="0"/>
           </a:p>
@@ -8853,7 +8853,7 @@
                 <a:ea typeface="맑은 고딕" pitchFamily="34" charset="-122"/>
                 <a:cs typeface="맑은 고딕" pitchFamily="34" charset="-120"/>
               </a:rPr>
-              <a:t>15</a:t>
+              <a:t>24</a:t>
             </a:r>
             <a:endParaRPr lang="en-US" sz="4400" dirty="0"/>
           </a:p>
@@ -9387,7 +9387,7 @@
                           <a:ea typeface="맑은 고딕" pitchFamily="34" charset="-122"/>
                           <a:cs typeface="맑은 고딕" pitchFamily="34" charset="-120"/>
                         </a:rPr>
-                        <a:t>ThreadDuo Necklace</a:t>
+                        <a:t>CandyPOP Necklace (사이즈: 1size (37~43cm))</a:t>
                       </a:r>
                       <a:endParaRPr lang="en-US" sz="1100" dirty="0">
                         <a:latin typeface="맑은 고딕" charset="0"/>
@@ -9452,7 +9452,7 @@
                           <a:ea typeface="맑은 고딕" pitchFamily="34" charset="-122"/>
                           <a:cs typeface="맑은 고딕" pitchFamily="34" charset="-120"/>
                         </a:rPr>
-                        <a:t>15 개</a:t>
+                        <a:t>24 개</a:t>
                       </a:r>
                       <a:endParaRPr lang="en-US" sz="1400" dirty="0">
                         <a:latin typeface="맑은 고딕" charset="0"/>
@@ -9584,7 +9584,7 @@
                           <a:ea typeface="맑은 고딕" pitchFamily="34" charset="-122"/>
                           <a:cs typeface="맑은 고딕" pitchFamily="34" charset="-120"/>
                         </a:rPr>
-                        <a:t>Ring</a:t>
+                        <a:t>Necklace</a:t>
                       </a:r>
                       <a:endParaRPr lang="en-US" sz="1000" dirty="0">
                         <a:latin typeface="맑은 고딕" charset="0"/>
@@ -9649,7 +9649,7 @@
                           <a:ea typeface="맑은 고딕" pitchFamily="34" charset="-122"/>
                           <a:cs typeface="맑은 고딕" pitchFamily="34" charset="-120"/>
                         </a:rPr>
-                        <a:t>"4s" 925 Open Ring (사이즈: 남성)</a:t>
+                        <a:t>ThreadDuo Necklace</a:t>
                       </a:r>
                       <a:endParaRPr lang="en-US" sz="1100" dirty="0">
                         <a:latin typeface="맑은 고딕" charset="0"/>
@@ -9714,7 +9714,7 @@
                           <a:ea typeface="맑은 고딕" pitchFamily="34" charset="-122"/>
                           <a:cs typeface="맑은 고딕" pitchFamily="34" charset="-120"/>
                         </a:rPr>
-                        <a:t>13 개</a:t>
+                        <a:t>18 개</a:t>
                       </a:r>
                       <a:endParaRPr lang="en-US" sz="1200" dirty="0">
                         <a:latin typeface="맑은 고딕" charset="0"/>
@@ -9846,7 +9846,7 @@
                           <a:ea typeface="맑은 고딕" pitchFamily="34" charset="-122"/>
                           <a:cs typeface="맑은 고딕" pitchFamily="34" charset="-120"/>
                         </a:rPr>
-                        <a:t>Necklace</a:t>
+                        <a:t>Ring</a:t>
                       </a:r>
                       <a:endParaRPr lang="en-US" sz="1000" dirty="0">
                         <a:latin typeface="맑은 고딕" charset="0"/>
@@ -9911,7 +9911,7 @@
                           <a:ea typeface="맑은 고딕" pitchFamily="34" charset="-122"/>
                           <a:cs typeface="맑은 고딕" pitchFamily="34" charset="-120"/>
                         </a:rPr>
-                        <a:t>CandyPOP Necklace (사이즈: 1size (37~43cm))</a:t>
+                        <a:t>"4s" 925 Open Ring (사이즈: 남성)</a:t>
                       </a:r>
                       <a:endParaRPr lang="en-US" sz="1100" dirty="0">
                         <a:latin typeface="맑은 고딕" charset="0"/>
@@ -9976,7 +9976,7 @@
                           <a:ea typeface="맑은 고딕" pitchFamily="34" charset="-122"/>
                           <a:cs typeface="맑은 고딕" pitchFamily="34" charset="-120"/>
                         </a:rPr>
-                        <a:t>7 개</a:t>
+                        <a:t>11 개</a:t>
                       </a:r>
                       <a:endParaRPr lang="en-US" sz="1200" dirty="0">
                         <a:latin typeface="맑은 고딕" charset="0"/>
@@ -10165,7 +10165,7 @@
                 <a:ea typeface="맑은 고딕" pitchFamily="34" charset="-122"/>
                 <a:cs typeface="맑은 고딕" pitchFamily="34" charset="-120"/>
               </a:rPr>
-              <a:t>베스트 상품 리포트  ·  생성 2026-05-29 08:00</a:t>
+              <a:t>베스트 상품 리포트  ·  생성 2026-05-30 08:00</a:t>
             </a:r>
             <a:endParaRPr lang="en-US" sz="900" dirty="0"/>
           </a:p>
@@ -10378,7 +10378,7 @@
                 <a:ea typeface="맑은 고딕" pitchFamily="34" charset="-122"/>
                 <a:cs typeface="맑은 고딕" pitchFamily="34" charset="-120"/>
               </a:rPr>
-              <a:t>2026년 05월 29일 (금)</a:t>
+              <a:t>2026년 05월 30일 (토)</a:t>
             </a:r>
             <a:endParaRPr lang="en-US" sz="1200" dirty="0"/>
           </a:p>
@@ -10929,7 +10929,7 @@
                 <a:ea typeface="맑은 고딕" pitchFamily="34" charset="-122"/>
                 <a:cs typeface="맑은 고딕" pitchFamily="34" charset="-120"/>
               </a:rPr>
-              <a:t>32,113</a:t>
+              <a:t>31,518</a:t>
             </a:r>
             <a:endParaRPr lang="en-US" sz="3000" dirty="0"/>
           </a:p>
@@ -11489,7 +11489,7 @@
                           <a:ea typeface="맑은 고딕" pitchFamily="34" charset="-122"/>
                           <a:cs typeface="맑은 고딕" pitchFamily="34" charset="-120"/>
                         </a:rPr>
-                        <a:t>2,049</a:t>
+                        <a:t>2,043</a:t>
                       </a:r>
                       <a:endParaRPr lang="en-US" sz="1000" dirty="0">
                         <a:latin typeface="맑은 고딕" charset="0"/>
@@ -11751,7 +11751,7 @@
                           <a:ea typeface="맑은 고딕" pitchFamily="34" charset="-122"/>
                           <a:cs typeface="맑은 고딕" pitchFamily="34" charset="-120"/>
                         </a:rPr>
-                        <a:t>1,570</a:t>
+                        <a:t>1,565</a:t>
                       </a:r>
                       <a:endParaRPr lang="en-US" sz="1000" dirty="0">
                         <a:latin typeface="맑은 고딕" charset="0"/>
@@ -12013,7 +12013,7 @@
                           <a:ea typeface="맑은 고딕" pitchFamily="34" charset="-122"/>
                           <a:cs typeface="맑은 고딕" pitchFamily="34" charset="-120"/>
                         </a:rPr>
-                        <a:t>1,081</a:t>
+                        <a:t>1,047</a:t>
                       </a:r>
                       <a:endParaRPr lang="en-US" sz="1000" dirty="0">
                         <a:latin typeface="맑은 고딕" charset="0"/>
@@ -12275,7 +12275,7 @@
                           <a:ea typeface="맑은 고딕" pitchFamily="34" charset="-122"/>
                           <a:cs typeface="맑은 고딕" pitchFamily="34" charset="-120"/>
                         </a:rPr>
-                        <a:t>869</a:t>
+                        <a:t>849</a:t>
                       </a:r>
                       <a:endParaRPr lang="en-US" sz="1000" dirty="0">
                         <a:latin typeface="맑은 고딕" charset="0"/>
@@ -12537,7 +12537,7 @@
                           <a:ea typeface="맑은 고딕" pitchFamily="34" charset="-122"/>
                           <a:cs typeface="맑은 고딕" pitchFamily="34" charset="-120"/>
                         </a:rPr>
-                        <a:t>744</a:t>
+                        <a:t>743</a:t>
                       </a:r>
                       <a:endParaRPr lang="en-US" sz="1000" dirty="0">
                         <a:latin typeface="맑은 고딕" charset="0"/>
@@ -13556,7 +13556,7 @@
                 <a:ea typeface="맑은 고딕" pitchFamily="34" charset="-122"/>
                 <a:cs typeface="맑은 고딕" pitchFamily="34" charset="-120"/>
               </a:rPr>
-              <a:t>베스트 상품 리포트  ·  생성 2026-05-29 08:00</a:t>
+              <a:t>베스트 상품 리포트  ·  생성 2026-05-30 08:00</a:t>
             </a:r>
             <a:endParaRPr lang="en-US" sz="900" dirty="0"/>
           </a:p>
@@ -13769,7 +13769,7 @@
                 <a:ea typeface="맑은 고딕" pitchFamily="34" charset="-122"/>
                 <a:cs typeface="맑은 고딕" pitchFamily="34" charset="-120"/>
               </a:rPr>
-              <a:t>2026년 05월 29일 (금)</a:t>
+              <a:t>2026년 05월 30일 (토)</a:t>
             </a:r>
             <a:endParaRPr lang="en-US" sz="1200" dirty="0"/>
           </a:p>
@@ -13897,7 +13897,7 @@
                 <a:ea typeface="맑은 고딕" pitchFamily="34" charset="-122"/>
                 <a:cs typeface="맑은 고딕" pitchFamily="34" charset="-120"/>
               </a:rPr>
-              <a:t>🚨  긴급 리오더 67건    ·    주의 리오더 12건    ·    오늘 발주 검토 필수</a:t>
+              <a:t>🚨  긴급 리오더 66건    ·    주의 리오더 10건    ·    오늘 발주 검토 필수</a:t>
             </a:r>
             <a:pPr indent="0" marL="0">
               <a:buNone/>
@@ -14595,7 +14595,7 @@
                           <a:ea typeface="맑은 고딕" pitchFamily="34" charset="-122"/>
                           <a:cs typeface="맑은 고딕" pitchFamily="34" charset="-120"/>
                         </a:rPr>
-                        <a:t>ELECTRONIC</a:t>
+                        <a:t>ETC</a:t>
                       </a:r>
                       <a:endParaRPr lang="en-US" sz="1000" dirty="0">
                         <a:latin typeface="맑은 고딕" charset="0"/>
@@ -14663,7 +14663,7 @@
                           <a:ea typeface="맑은 고딕" pitchFamily="34" charset="-122"/>
                           <a:cs typeface="맑은 고딕" pitchFamily="34" charset="-120"/>
                         </a:rPr>
-                        <a:t>Jacquard Fast Charging Cable (7color) (컬러: 블루 / 기종옵션: C-Apple 8pin / 길이: 2m)</a:t>
+                        <a:t>360° Rotating Phone Holder (컬러: 화이트)</a:t>
                       </a:r>
                       <a:endParaRPr lang="en-US" sz="1100" dirty="0">
                         <a:latin typeface="맑은 고딕" charset="0"/>
@@ -14731,7 +14731,7 @@
                           <a:ea typeface="맑은 고딕" pitchFamily="34" charset="-122"/>
                           <a:cs typeface="맑은 고딕" pitchFamily="34" charset="-120"/>
                         </a:rPr>
-                        <a:t>12</a:t>
+                        <a:t>3</a:t>
                       </a:r>
                       <a:endParaRPr lang="en-US" sz="1100" dirty="0">
                         <a:latin typeface="맑은 고딕" charset="0"/>
@@ -14937,7 +14937,7 @@
                           <a:ea typeface="맑은 고딕" pitchFamily="34" charset="-122"/>
                           <a:cs typeface="맑은 고딕" pitchFamily="34" charset="-120"/>
                         </a:rPr>
-                        <a:t>CT</a:t>
+                        <a:t>6A</a:t>
                       </a:r>
                       <a:endParaRPr lang="en-US" sz="1100" dirty="0">
                         <a:latin typeface="맑은 고딕" charset="0"/>
@@ -15073,7 +15073,7 @@
                           <a:ea typeface="맑은 고딕" pitchFamily="34" charset="-122"/>
                           <a:cs typeface="맑은 고딕" pitchFamily="34" charset="-120"/>
                         </a:rPr>
-                        <a:t>"Giethoorn" 925 Open Ring</a:t>
+                        <a:t>[SILVER925] Crimson Open Ring</a:t>
                       </a:r>
                       <a:endParaRPr lang="en-US" sz="1100" dirty="0">
                         <a:latin typeface="맑은 고딕" charset="0"/>
@@ -15141,7 +15141,7 @@
                           <a:ea typeface="맑은 고딕" pitchFamily="34" charset="-122"/>
                           <a:cs typeface="맑은 고딕" pitchFamily="34" charset="-120"/>
                         </a:rPr>
-                        <a:t>2</a:t>
+                        <a:t>0</a:t>
                       </a:r>
                       <a:endParaRPr lang="en-US" sz="1100" dirty="0">
                         <a:latin typeface="맑은 고딕" charset="0"/>
@@ -15209,7 +15209,7 @@
                           <a:ea typeface="맑은 고딕" pitchFamily="34" charset="-122"/>
                           <a:cs typeface="맑은 고딕" pitchFamily="34" charset="-120"/>
                         </a:rPr>
-                        <a:t>3 개</a:t>
+                        <a:t>1 개</a:t>
                       </a:r>
                       <a:endParaRPr lang="en-US" sz="1100" dirty="0">
                         <a:latin typeface="맑은 고딕" charset="0"/>
@@ -15347,7 +15347,7 @@
                           <a:ea typeface="맑은 고딕" pitchFamily="34" charset="-122"/>
                           <a:cs typeface="맑은 고딕" pitchFamily="34" charset="-120"/>
                         </a:rPr>
-                        <a:t>6A</a:t>
+                        <a:t>CT</a:t>
                       </a:r>
                       <a:endParaRPr lang="en-US" sz="1100" dirty="0">
                         <a:latin typeface="맑은 고딕" charset="0"/>
@@ -15483,7 +15483,7 @@
                           <a:ea typeface="맑은 고딕" pitchFamily="34" charset="-122"/>
                           <a:cs typeface="맑은 고딕" pitchFamily="34" charset="-120"/>
                         </a:rPr>
-                        <a:t>[SILVER925] Crimson Open Ring</a:t>
+                        <a:t>"Ribbonwist" 925 Open Ring</a:t>
                       </a:r>
                       <a:endParaRPr lang="en-US" sz="1100" dirty="0">
                         <a:latin typeface="맑은 고딕" charset="0"/>
@@ -15551,7 +15551,7 @@
                           <a:ea typeface="맑은 고딕" pitchFamily="34" charset="-122"/>
                           <a:cs typeface="맑은 고딕" pitchFamily="34" charset="-120"/>
                         </a:rPr>
-                        <a:t>1</a:t>
+                        <a:t>5</a:t>
                       </a:r>
                       <a:endParaRPr lang="en-US" sz="1100" dirty="0">
                         <a:latin typeface="맑은 고딕" charset="0"/>
@@ -15619,7 +15619,7 @@
                           <a:ea typeface="맑은 고딕" pitchFamily="34" charset="-122"/>
                           <a:cs typeface="맑은 고딕" pitchFamily="34" charset="-120"/>
                         </a:rPr>
-                        <a:t>2 개</a:t>
+                        <a:t>1 개</a:t>
                       </a:r>
                       <a:endParaRPr lang="en-US" sz="1100" dirty="0">
                         <a:latin typeface="맑은 고딕" charset="0"/>
@@ -15757,7 +15757,7 @@
                           <a:ea typeface="맑은 고딕" pitchFamily="34" charset="-122"/>
                           <a:cs typeface="맑은 고딕" pitchFamily="34" charset="-120"/>
                         </a:rPr>
-                        <a:t>6A</a:t>
+                        <a:t>CT</a:t>
                       </a:r>
                       <a:endParaRPr lang="en-US" sz="1100" dirty="0">
                         <a:latin typeface="맑은 고딕" charset="0"/>
@@ -15893,7 +15893,7 @@
                           <a:ea typeface="맑은 고딕" pitchFamily="34" charset="-122"/>
                           <a:cs typeface="맑은 고딕" pitchFamily="34" charset="-120"/>
                         </a:rPr>
-                        <a:t>[SILVER925] Flowy Open Ring</a:t>
+                        <a:t>"Mlayer" 925 Open Ring</a:t>
                       </a:r>
                       <a:endParaRPr lang="en-US" sz="1100" dirty="0">
                         <a:latin typeface="맑은 고딕" charset="0"/>
@@ -16371,7 +16371,7 @@
                           <a:ea typeface="맑은 고딕" pitchFamily="34" charset="-122"/>
                           <a:cs typeface="맑은 고딕" pitchFamily="34" charset="-120"/>
                         </a:rPr>
-                        <a:t>3</a:t>
+                        <a:t>2</a:t>
                       </a:r>
                       <a:endParaRPr lang="en-US" sz="1100" dirty="0">
                         <a:latin typeface="맑은 고딕" charset="0"/>
@@ -16577,7 +16577,7 @@
                           <a:ea typeface="맑은 고딕" pitchFamily="34" charset="-122"/>
                           <a:cs typeface="맑은 고딕" pitchFamily="34" charset="-120"/>
                         </a:rPr>
-                        <a:t>PR</a:t>
+                        <a:t>CT</a:t>
                       </a:r>
                       <a:endParaRPr lang="en-US" sz="1100" dirty="0">
                         <a:latin typeface="맑은 고딕" charset="0"/>
@@ -16645,7 +16645,7 @@
                           <a:ea typeface="맑은 고딕" pitchFamily="34" charset="-122"/>
                           <a:cs typeface="맑은 고딕" pitchFamily="34" charset="-120"/>
                         </a:rPr>
-                        <a:t>ETC</a:t>
+                        <a:t>Ring</a:t>
                       </a:r>
                       <a:endParaRPr lang="en-US" sz="1000" dirty="0">
                         <a:latin typeface="맑은 고딕" charset="0"/>
@@ -16713,7 +16713,7 @@
                           <a:ea typeface="맑은 고딕" pitchFamily="34" charset="-122"/>
                           <a:cs typeface="맑은 고딕" pitchFamily="34" charset="-120"/>
                         </a:rPr>
-                        <a:t>360° Rotating Phone Holder (컬러: 블랙)</a:t>
+                        <a:t>"Bloometal" 925 Open Ring</a:t>
                       </a:r>
                       <a:endParaRPr lang="en-US" sz="1100" dirty="0">
                         <a:latin typeface="맑은 고딕" charset="0"/>
@@ -16781,7 +16781,7 @@
                           <a:ea typeface="맑은 고딕" pitchFamily="34" charset="-122"/>
                           <a:cs typeface="맑은 고딕" pitchFamily="34" charset="-120"/>
                         </a:rPr>
-                        <a:t>14</a:t>
+                        <a:t>0</a:t>
                       </a:r>
                       <a:endParaRPr lang="en-US" sz="1100" dirty="0">
                         <a:latin typeface="맑은 고딕" charset="0"/>
@@ -17055,7 +17055,7 @@
                           <a:ea typeface="맑은 고딕" pitchFamily="34" charset="-122"/>
                           <a:cs typeface="맑은 고딕" pitchFamily="34" charset="-120"/>
                         </a:rPr>
-                        <a:t>★ Last Sale ★</a:t>
+                        <a:t>ELECTRONIC</a:t>
                       </a:r>
                       <a:endParaRPr lang="en-US" sz="1000" dirty="0">
                         <a:latin typeface="맑은 고딕" charset="0"/>
@@ -17123,7 +17123,7 @@
                           <a:ea typeface="맑은 고딕" pitchFamily="34" charset="-122"/>
                           <a:cs typeface="맑은 고딕" pitchFamily="34" charset="-120"/>
                         </a:rPr>
-                        <a:t>Cloud Grip Glass Mini Brush (3color) (컬러: 스카이블루)</a:t>
+                        <a:t>Jacquard Fast Charging Cable (7color) (컬러: 블루 / 기종옵션: C-Apple 8pin / 길이: 2m)</a:t>
                       </a:r>
                       <a:endParaRPr lang="en-US" sz="1100" dirty="0">
                         <a:latin typeface="맑은 고딕" charset="0"/>
@@ -17191,7 +17191,7 @@
                           <a:ea typeface="맑은 고딕" pitchFamily="34" charset="-122"/>
                           <a:cs typeface="맑은 고딕" pitchFamily="34" charset="-120"/>
                         </a:rPr>
-                        <a:t>12</a:t>
+                        <a:t>11</a:t>
                       </a:r>
                       <a:endParaRPr lang="en-US" sz="1100" dirty="0">
                         <a:latin typeface="맑은 고딕" charset="0"/>
@@ -17465,7 +17465,7 @@
                           <a:ea typeface="맑은 고딕" pitchFamily="34" charset="-122"/>
                           <a:cs typeface="맑은 고딕" pitchFamily="34" charset="-120"/>
                         </a:rPr>
-                        <a:t>ETC</a:t>
+                        <a:t>ELECTRONIC</a:t>
                       </a:r>
                       <a:endParaRPr lang="en-US" sz="1000" dirty="0">
                         <a:latin typeface="맑은 고딕" charset="0"/>
@@ -17533,7 +17533,7 @@
                           <a:ea typeface="맑은 고딕" pitchFamily="34" charset="-122"/>
                           <a:cs typeface="맑은 고딕" pitchFamily="34" charset="-120"/>
                         </a:rPr>
-                        <a:t>360° Rotating Phone Holder (컬러: 화이트)</a:t>
+                        <a:t>Jacquard Fast Charging Cable (7color) (컬러: 퍼플 / 기종옵션: C-Apple 8pin / 길이: 2m)</a:t>
                       </a:r>
                       <a:endParaRPr lang="en-US" sz="1100" dirty="0">
                         <a:latin typeface="맑은 고딕" charset="0"/>
@@ -17601,7 +17601,7 @@
                           <a:ea typeface="맑은 고딕" pitchFamily="34" charset="-122"/>
                           <a:cs typeface="맑은 고딕" pitchFamily="34" charset="-120"/>
                         </a:rPr>
-                        <a:t>7</a:t>
+                        <a:t>4</a:t>
                       </a:r>
                       <a:endParaRPr lang="en-US" sz="1100" dirty="0">
                         <a:latin typeface="맑은 고딕" charset="0"/>
@@ -17807,7 +17807,7 @@
                           <a:ea typeface="맑은 고딕" pitchFamily="34" charset="-122"/>
                           <a:cs typeface="맑은 고딕" pitchFamily="34" charset="-120"/>
                         </a:rPr>
-                        <a:t>PR</a:t>
+                        <a:t>6A</a:t>
                       </a:r>
                       <a:endParaRPr lang="en-US" sz="1100" dirty="0">
                         <a:latin typeface="맑은 고딕" charset="0"/>
@@ -17875,7 +17875,7 @@
                           <a:ea typeface="맑은 고딕" pitchFamily="34" charset="-122"/>
                           <a:cs typeface="맑은 고딕" pitchFamily="34" charset="-120"/>
                         </a:rPr>
-                        <a:t>ELECTRONIC</a:t>
+                        <a:t>★Season off★</a:t>
                       </a:r>
                       <a:endParaRPr lang="en-US" sz="1000" dirty="0">
                         <a:latin typeface="맑은 고딕" charset="0"/>
@@ -17943,7 +17943,7 @@
                           <a:ea typeface="맑은 고딕" pitchFamily="34" charset="-122"/>
                           <a:cs typeface="맑은 고딕" pitchFamily="34" charset="-120"/>
                         </a:rPr>
-                        <a:t>Jacquard Fast Charging Cable (7color) (컬러: 민트 / 기종옵션: C-Apple 8pin / 길이: 2m)</a:t>
+                        <a:t>8-Ball Smart Tok</a:t>
                       </a:r>
                       <a:endParaRPr lang="en-US" sz="1100" dirty="0">
                         <a:latin typeface="맑은 고딕" charset="0"/>
@@ -18011,7 +18011,7 @@
                           <a:ea typeface="맑은 고딕" pitchFamily="34" charset="-122"/>
                           <a:cs typeface="맑은 고딕" pitchFamily="34" charset="-120"/>
                         </a:rPr>
-                        <a:t>7</a:t>
+                        <a:t>4</a:t>
                       </a:r>
                       <a:endParaRPr lang="en-US" sz="1100" dirty="0">
                         <a:latin typeface="맑은 고딕" charset="0"/>
@@ -18079,7 +18079,7 @@
                           <a:ea typeface="맑은 고딕" pitchFamily="34" charset="-122"/>
                           <a:cs typeface="맑은 고딕" pitchFamily="34" charset="-120"/>
                         </a:rPr>
-                        <a:t>1 개</a:t>
+                        <a:t>0 개</a:t>
                       </a:r>
                       <a:endParaRPr lang="en-US" sz="1100" dirty="0">
                         <a:latin typeface="맑은 고딕" charset="0"/>
@@ -18168,7 +18168,7 @@
                 <a:ea typeface="맑은 고딕" pitchFamily="34" charset="-122"/>
                 <a:cs typeface="맑은 고딕" pitchFamily="34" charset="-120"/>
               </a:rPr>
-              <a:t>외 58건 더 있음 — 상세는 시트에서 확인</a:t>
+              <a:t>외 57건 더 있음 — 상세는 시트에서 확인</a:t>
             </a:r>
             <a:endParaRPr lang="en-US" sz="1000" dirty="0"/>
           </a:p>
@@ -18207,7 +18207,7 @@
                 <a:ea typeface="맑은 고딕" pitchFamily="34" charset="-122"/>
                 <a:cs typeface="맑은 고딕" pitchFamily="34" charset="-120"/>
               </a:rPr>
-              <a:t>베스트 상품 리포트  ·  생성 2026-05-29 08:00</a:t>
+              <a:t>베스트 상품 리포트  ·  생성 2026-05-30 08:00</a:t>
             </a:r>
             <a:endParaRPr lang="en-US" sz="900" dirty="0"/>
           </a:p>
@@ -18420,7 +18420,7 @@
                 <a:ea typeface="맑은 고딕" pitchFamily="34" charset="-122"/>
                 <a:cs typeface="맑은 고딕" pitchFamily="34" charset="-120"/>
               </a:rPr>
-              <a:t>2026년 05월 29일 (금)</a:t>
+              <a:t>2026년 05월 30일 (토)</a:t>
             </a:r>
             <a:endParaRPr lang="en-US" sz="1200" dirty="0"/>
           </a:p>
@@ -18587,7 +18587,7 @@
                 <a:ea typeface="맑은 고딕" pitchFamily="34" charset="-122"/>
                 <a:cs typeface="맑은 고딕" pitchFamily="34" charset="-120"/>
               </a:rPr>
-              <a:t>Google Sheet '브랜드 재고현황'  ·  최신화 2026-05-29 08:00</a:t>
+              <a:t>Google Sheet '브랜드 재고현황'  ·  최신화 2026-05-30 08:00</a:t>
             </a:r>
             <a:endParaRPr lang="en-US" sz="1100" dirty="0"/>
           </a:p>
@@ -19099,7 +19099,7 @@
                 <a:ea typeface="맑은 고딕" pitchFamily="34" charset="-122"/>
                 <a:cs typeface="맑은 고딕" pitchFamily="34" charset="-120"/>
               </a:rPr>
-              <a:t>✅ 6A 88 SKU  /  ✅ Cleartype 59 SKU  /  ✅ Produktepr 200 SKU (판매 수집됨)</a:t>
+              <a:t>✅ 6A 100 SKU  /  ✅ Cleartype 59 SKU  /  ✅ Produktepr 200 SKU (판매 수집됨)</a:t>
             </a:r>
             <a:endParaRPr lang="en-US" sz="1100" dirty="0"/>
           </a:p>
@@ -19230,7 +19230,7 @@
                 <a:ea typeface="맑은 고딕" pitchFamily="34" charset="-122"/>
                 <a:cs typeface="맑은 고딕" pitchFamily="34" charset="-120"/>
               </a:rPr>
-              <a:t>✅ 3개 브랜드 모두 정상 추출  ·  24h 출고 기준 (2026-05-28 08:00 → 2026-05-29 08:00) · 신규 SKU 16건은 결제완료 기준</a:t>
+              <a:t>✅ 3개 브랜드 모두 정상 추출  ·  24h 출고 기준 (2026-05-29 08:00 → 2026-05-30 08:00) · 신규 SKU 27건은 결제완료 기준</a:t>
             </a:r>
             <a:endParaRPr lang="en-US" sz="1000" dirty="0"/>
           </a:p>
@@ -19269,7 +19269,7 @@
                 <a:ea typeface="맑은 고딕" pitchFamily="34" charset="-122"/>
                 <a:cs typeface="맑은 고딕" pitchFamily="34" charset="-120"/>
               </a:rPr>
-              <a:t>베스트 상품 리포트  ·  생성 2026-05-29 08:00</a:t>
+              <a:t>베스트 상품 리포트  ·  생성 2026-05-30 08:00</a:t>
             </a:r>
             <a:endParaRPr lang="en-US" sz="900" dirty="0"/>
           </a:p>

</xml_diff>

<commit_message>
chore: 매출 PPT 업로드 (best-sellers-2026-05-31.pptx) [auto]
</commit_message>
<xml_diff>
--- a/data/sales-report.pptx
+++ b/data/sales-report.pptx
@@ -1648,7 +1648,7 @@
                 <a:ea typeface="맑은 고딕" pitchFamily="34" charset="-122"/>
                 <a:cs typeface="맑은 고딕" pitchFamily="34" charset="-120"/>
               </a:rPr>
-              <a:t>2026년 05월 30일 (토)  ·  24h 출고 기준</a:t>
+              <a:t>2026년 05월 31일 (일)  ·  24h 출고 기준</a:t>
             </a:r>
             <a:endParaRPr lang="en-US" sz="2200" dirty="0"/>
           </a:p>
@@ -1726,7 +1726,7 @@
                 <a:ea typeface="맑은 고딕" pitchFamily="34" charset="-122"/>
                 <a:cs typeface="맑은 고딕" pitchFamily="34" charset="-120"/>
               </a:rPr>
-              <a:t>05.30</a:t>
+              <a:t>05.31</a:t>
             </a:r>
             <a:endParaRPr lang="en-US" sz="7200" dirty="0"/>
           </a:p>
@@ -1765,7 +1765,7 @@
                 <a:ea typeface="맑은 고딕" pitchFamily="34" charset="-122"/>
                 <a:cs typeface="맑은 고딕" pitchFamily="34" charset="-120"/>
               </a:rPr>
-              <a:t>토요일</a:t>
+              <a:t>일요일</a:t>
             </a:r>
             <a:endParaRPr lang="en-US" sz="1400" dirty="0"/>
           </a:p>
@@ -1804,7 +1804,7 @@
                 <a:ea typeface="맑은 고딕" pitchFamily="34" charset="-122"/>
                 <a:cs typeface="맑은 고딕" pitchFamily="34" charset="-120"/>
               </a:rPr>
-              <a:t>생성 2026-05-30 08:00  ·  Google Sheet 자동 동기</a:t>
+              <a:t>생성 2026-05-31 08:00  ·  Google Sheet 자동 동기</a:t>
             </a:r>
             <a:endParaRPr lang="en-US" sz="1000" dirty="0"/>
           </a:p>
@@ -1978,7 +1978,7 @@
                 <a:ea typeface="맑은 고딕" pitchFamily="34" charset="-122"/>
                 <a:cs typeface="맑은 고딕" pitchFamily="34" charset="-120"/>
               </a:rPr>
-              <a:t>2026년 05월 30일 (토)</a:t>
+              <a:t>2026년 05월 31일 (일)</a:t>
             </a:r>
             <a:endParaRPr lang="en-US" sz="1200" dirty="0"/>
           </a:p>
@@ -2145,7 +2145,7 @@
                 <a:ea typeface="맑은 고딕" pitchFamily="34" charset="-122"/>
                 <a:cs typeface="맑은 고딕" pitchFamily="34" charset="-120"/>
               </a:rPr>
-              <a:t>383 개</a:t>
+              <a:t>636 개</a:t>
             </a:r>
             <a:endParaRPr lang="en-US" sz="3600" dirty="0"/>
           </a:p>
@@ -2312,7 +2312,7 @@
                 <a:ea typeface="맑은 고딕" pitchFamily="34" charset="-122"/>
                 <a:cs typeface="맑은 고딕" pitchFamily="34" charset="-120"/>
               </a:rPr>
-              <a:t>66 건</a:t>
+              <a:t>68 건</a:t>
             </a:r>
             <a:endParaRPr lang="en-US" sz="3200" dirty="0"/>
           </a:p>
@@ -3612,7 +3612,7 @@
                           <a:ea typeface="맑은 고딕" pitchFamily="34" charset="-122"/>
                           <a:cs typeface="맑은 고딕" pitchFamily="34" charset="-120"/>
                         </a:rPr>
-                        <a:t>[SILVER925] CH.alban Open Ring</a:t>
+                        <a:t>[SILVER925] Guyeong Open Ring v3.0 (silver)</a:t>
                       </a:r>
                       <a:endParaRPr lang="en-US" sz="1100" dirty="0">
                         <a:latin typeface="맑은 고딕" charset="0"/>
@@ -3677,7 +3677,7 @@
                           <a:ea typeface="맑은 고딕" pitchFamily="34" charset="-122"/>
                           <a:cs typeface="맑은 고딕" pitchFamily="34" charset="-120"/>
                         </a:rPr>
-                        <a:t>39 개</a:t>
+                        <a:t>86 개</a:t>
                       </a:r>
                       <a:endParaRPr lang="en-US" sz="1400" dirty="0">
                         <a:latin typeface="맑은 고딕" charset="0"/>
@@ -4004,7 +4004,7 @@
                           <a:ea typeface="맑은 고딕" pitchFamily="34" charset="-122"/>
                           <a:cs typeface="맑은 고딕" pitchFamily="34" charset="-120"/>
                         </a:rPr>
-                        <a:t>29 개</a:t>
+                        <a:t>53 개</a:t>
                       </a:r>
                       <a:endParaRPr lang="en-US" sz="1400" dirty="0">
                         <a:latin typeface="맑은 고딕" charset="0"/>
@@ -4266,7 +4266,7 @@
                           <a:ea typeface="맑은 고딕" pitchFamily="34" charset="-122"/>
                           <a:cs typeface="맑은 고딕" pitchFamily="34" charset="-120"/>
                         </a:rPr>
-                        <a:t>[SILVER925] Guyeong Open Ring v3.0 (silver)</a:t>
+                        <a:t>[SILVER925] Eramam Open Ring</a:t>
                       </a:r>
                       <a:endParaRPr lang="en-US" sz="1100" dirty="0">
                         <a:latin typeface="맑은 고딕" charset="0"/>
@@ -4331,7 +4331,7 @@
                           <a:ea typeface="맑은 고딕" pitchFamily="34" charset="-122"/>
                           <a:cs typeface="맑은 고딕" pitchFamily="34" charset="-120"/>
                         </a:rPr>
-                        <a:t>28 개</a:t>
+                        <a:t>46 개</a:t>
                       </a:r>
                       <a:endParaRPr lang="en-US" sz="1400" dirty="0">
                         <a:latin typeface="맑은 고딕" charset="0"/>
@@ -4463,7 +4463,7 @@
                           <a:ea typeface="맑은 고딕" pitchFamily="34" charset="-122"/>
                           <a:cs typeface="맑은 고딕" pitchFamily="34" charset="-120"/>
                         </a:rPr>
-                        <a:t>CT</a:t>
+                        <a:t>6A</a:t>
                       </a:r>
                       <a:endParaRPr lang="en-US" sz="1100" dirty="0">
                         <a:latin typeface="맑은 고딕" charset="0"/>
@@ -4528,7 +4528,7 @@
                           <a:ea typeface="맑은 고딕" pitchFamily="34" charset="-122"/>
                           <a:cs typeface="맑은 고딕" pitchFamily="34" charset="-120"/>
                         </a:rPr>
-                        <a:t>Necklace</a:t>
+                        <a:t>Ring</a:t>
                       </a:r>
                       <a:endParaRPr lang="en-US" sz="1000" dirty="0">
                         <a:latin typeface="맑은 고딕" charset="0"/>
@@ -4593,7 +4593,7 @@
                           <a:ea typeface="맑은 고딕" pitchFamily="34" charset="-122"/>
                           <a:cs typeface="맑은 고딕" pitchFamily="34" charset="-120"/>
                         </a:rPr>
-                        <a:t>CandyPOP Necklace (사이즈: 1size (37~43cm))</a:t>
+                        <a:t>[SILVER925] CH.alban Open Ring</a:t>
                       </a:r>
                       <a:endParaRPr lang="en-US" sz="1100" dirty="0">
                         <a:latin typeface="맑은 고딕" charset="0"/>
@@ -4658,7 +4658,7 @@
                           <a:ea typeface="맑은 고딕" pitchFamily="34" charset="-122"/>
                           <a:cs typeface="맑은 고딕" pitchFamily="34" charset="-120"/>
                         </a:rPr>
-                        <a:t>24 개</a:t>
+                        <a:t>46 개</a:t>
                       </a:r>
                       <a:endParaRPr lang="en-US" sz="1200" dirty="0">
                         <a:latin typeface="맑은 고딕" charset="0"/>
@@ -4790,7 +4790,7 @@
                           <a:ea typeface="맑은 고딕" pitchFamily="34" charset="-122"/>
                           <a:cs typeface="맑은 고딕" pitchFamily="34" charset="-120"/>
                         </a:rPr>
-                        <a:t>6A</a:t>
+                        <a:t>CT</a:t>
                       </a:r>
                       <a:endParaRPr lang="en-US" sz="1100" dirty="0">
                         <a:latin typeface="맑은 고딕" charset="0"/>
@@ -4855,7 +4855,7 @@
                           <a:ea typeface="맑은 고딕" pitchFamily="34" charset="-122"/>
                           <a:cs typeface="맑은 고딕" pitchFamily="34" charset="-120"/>
                         </a:rPr>
-                        <a:t>Ring</a:t>
+                        <a:t>Necklace</a:t>
                       </a:r>
                       <a:endParaRPr lang="en-US" sz="1000" dirty="0">
                         <a:latin typeface="맑은 고딕" charset="0"/>
@@ -4920,7 +4920,7 @@
                           <a:ea typeface="맑은 고딕" pitchFamily="34" charset="-122"/>
                           <a:cs typeface="맑은 고딕" pitchFamily="34" charset="-120"/>
                         </a:rPr>
-                        <a:t>[SILVER925] Eramam Open Ring</a:t>
+                        <a:t>CandyPOP Necklace (사이즈: 1size (37~43cm))</a:t>
                       </a:r>
                       <a:endParaRPr lang="en-US" sz="1100" dirty="0">
                         <a:latin typeface="맑은 고딕" charset="0"/>
@@ -4985,7 +4985,7 @@
                           <a:ea typeface="맑은 고딕" pitchFamily="34" charset="-122"/>
                           <a:cs typeface="맑은 고딕" pitchFamily="34" charset="-120"/>
                         </a:rPr>
-                        <a:t>21 개</a:t>
+                        <a:t>41 개</a:t>
                       </a:r>
                       <a:endParaRPr lang="en-US" sz="1200" dirty="0">
                         <a:latin typeface="맑은 고딕" charset="0"/>
@@ -5071,7 +5071,7 @@
                 <a:ea typeface="맑은 고딕" pitchFamily="34" charset="-122"/>
                 <a:cs typeface="맑은 고딕" pitchFamily="34" charset="-120"/>
               </a:rPr>
-              <a:t>베스트 상품 리포트  ·  생성 2026-05-30 08:00</a:t>
+              <a:t>베스트 상품 리포트  ·  생성 2026-05-31 08:00</a:t>
             </a:r>
             <a:endParaRPr lang="en-US" sz="900" dirty="0"/>
           </a:p>
@@ -5284,7 +5284,7 @@
                 <a:ea typeface="맑은 고딕" pitchFamily="34" charset="-122"/>
                 <a:cs typeface="맑은 고딕" pitchFamily="34" charset="-120"/>
               </a:rPr>
-              <a:t>2026년 05월 30일 (토)</a:t>
+              <a:t>2026년 05월 31일 (일)</a:t>
             </a:r>
             <a:endParaRPr lang="en-US" sz="1200" dirty="0"/>
           </a:p>
@@ -5451,7 +5451,7 @@
                 <a:ea typeface="맑은 고딕" pitchFamily="34" charset="-122"/>
                 <a:cs typeface="맑은 고딕" pitchFamily="34" charset="-120"/>
               </a:rPr>
-              <a:t>304 개</a:t>
+              <a:t>487 개</a:t>
             </a:r>
             <a:endParaRPr lang="en-US" sz="3600" dirty="0"/>
           </a:p>
@@ -5579,7 +5579,7 @@
                 <a:ea typeface="맑은 고딕" pitchFamily="34" charset="-122"/>
                 <a:cs typeface="맑은 고딕" pitchFamily="34" charset="-120"/>
               </a:rPr>
-              <a:t>[SILVER925] CH.alban Open Ring</a:t>
+              <a:t>[SILVER925] Guyeong Open Ring v3.0 (silver)</a:t>
             </a:r>
             <a:endParaRPr lang="en-US" sz="1800" dirty="0"/>
           </a:p>
@@ -5657,7 +5657,7 @@
                 <a:ea typeface="맑은 고딕" pitchFamily="34" charset="-122"/>
                 <a:cs typeface="맑은 고딕" pitchFamily="34" charset="-120"/>
               </a:rPr>
-              <a:t>39</a:t>
+              <a:t>86</a:t>
             </a:r>
             <a:endParaRPr lang="en-US" sz="4400" dirty="0"/>
           </a:p>
@@ -6191,7 +6191,7 @@
                           <a:ea typeface="맑은 고딕" pitchFamily="34" charset="-122"/>
                           <a:cs typeface="맑은 고딕" pitchFamily="34" charset="-120"/>
                         </a:rPr>
-                        <a:t>[SILVER925] CH.alban Open Ring</a:t>
+                        <a:t>[SILVER925] Guyeong Open Ring v3.0 (silver)</a:t>
                       </a:r>
                       <a:endParaRPr lang="en-US" sz="1100" dirty="0">
                         <a:latin typeface="맑은 고딕" charset="0"/>
@@ -6256,7 +6256,7 @@
                           <a:ea typeface="맑은 고딕" pitchFamily="34" charset="-122"/>
                           <a:cs typeface="맑은 고딕" pitchFamily="34" charset="-120"/>
                         </a:rPr>
-                        <a:t>39 개</a:t>
+                        <a:t>86 개</a:t>
                       </a:r>
                       <a:endParaRPr lang="en-US" sz="1400" dirty="0">
                         <a:latin typeface="맑은 고딕" charset="0"/>
@@ -6518,7 +6518,7 @@
                           <a:ea typeface="맑은 고딕" pitchFamily="34" charset="-122"/>
                           <a:cs typeface="맑은 고딕" pitchFamily="34" charset="-120"/>
                         </a:rPr>
-                        <a:t>29 개</a:t>
+                        <a:t>53 개</a:t>
                       </a:r>
                       <a:endParaRPr lang="en-US" sz="1200" dirty="0">
                         <a:latin typeface="맑은 고딕" charset="0"/>
@@ -6715,7 +6715,7 @@
                           <a:ea typeface="맑은 고딕" pitchFamily="34" charset="-122"/>
                           <a:cs typeface="맑은 고딕" pitchFamily="34" charset="-120"/>
                         </a:rPr>
-                        <a:t>[SILVER925] Guyeong Open Ring v3.0 (silver)</a:t>
+                        <a:t>[SILVER925] Eramam Open Ring</a:t>
                       </a:r>
                       <a:endParaRPr lang="en-US" sz="1100" dirty="0">
                         <a:latin typeface="맑은 고딕" charset="0"/>
@@ -6780,7 +6780,7 @@
                           <a:ea typeface="맑은 고딕" pitchFamily="34" charset="-122"/>
                           <a:cs typeface="맑은 고딕" pitchFamily="34" charset="-120"/>
                         </a:rPr>
-                        <a:t>28 개</a:t>
+                        <a:t>46 개</a:t>
                       </a:r>
                       <a:endParaRPr lang="en-US" sz="1200" dirty="0">
                         <a:latin typeface="맑은 고딕" charset="0"/>
@@ -6977,7 +6977,7 @@
                           <a:ea typeface="맑은 고딕" pitchFamily="34" charset="-122"/>
                           <a:cs typeface="맑은 고딕" pitchFamily="34" charset="-120"/>
                         </a:rPr>
-                        <a:t>[SILVER925] Eramam Open Ring</a:t>
+                        <a:t>[SILVER925] CH.alban Open Ring</a:t>
                       </a:r>
                       <a:endParaRPr lang="en-US" sz="1100" dirty="0">
                         <a:latin typeface="맑은 고딕" charset="0"/>
@@ -7042,7 +7042,7 @@
                           <a:ea typeface="맑은 고딕" pitchFamily="34" charset="-122"/>
                           <a:cs typeface="맑은 고딕" pitchFamily="34" charset="-120"/>
                         </a:rPr>
-                        <a:t>21 개</a:t>
+                        <a:t>46 개</a:t>
                       </a:r>
                       <a:endParaRPr lang="en-US" sz="1200" dirty="0">
                         <a:latin typeface="맑은 고딕" charset="0"/>
@@ -7174,7 +7174,7 @@
                           <a:ea typeface="맑은 고딕" pitchFamily="34" charset="-122"/>
                           <a:cs typeface="맑은 고딕" pitchFamily="34" charset="-120"/>
                         </a:rPr>
-                        <a:t>Necklace</a:t>
+                        <a:t>Ring</a:t>
                       </a:r>
                       <a:endParaRPr lang="en-US" sz="1000" dirty="0">
                         <a:latin typeface="맑은 고딕" charset="0"/>
@@ -7239,7 +7239,7 @@
                           <a:ea typeface="맑은 고딕" pitchFamily="34" charset="-122"/>
                           <a:cs typeface="맑은 고딕" pitchFamily="34" charset="-120"/>
                         </a:rPr>
-                        <a:t>Tiny Cross Necklace</a:t>
+                        <a:t>[SILVER925] Starly Open Ring</a:t>
                       </a:r>
                       <a:endParaRPr lang="en-US" sz="1100" dirty="0">
                         <a:latin typeface="맑은 고딕" charset="0"/>
@@ -7304,7 +7304,7 @@
                           <a:ea typeface="맑은 고딕" pitchFamily="34" charset="-122"/>
                           <a:cs typeface="맑은 고딕" pitchFamily="34" charset="-120"/>
                         </a:rPr>
-                        <a:t>12 개</a:t>
+                        <a:t>28 개</a:t>
                       </a:r>
                       <a:endParaRPr lang="en-US" sz="1200" dirty="0">
                         <a:latin typeface="맑은 고딕" charset="0"/>
@@ -7557,6 +7557,418 @@
                 <a:ea typeface="맑은 고딕" pitchFamily="34" charset="-122"/>
                 <a:cs typeface="맑은 고딕" pitchFamily="34" charset="-120"/>
               </a:rPr>
+              <a:t>8-Ball Smart Tok</a:t>
+            </a:r>
+            <a:endParaRPr lang="en-US" sz="1100" dirty="0"/>
+          </a:p>
+        </p:txBody>
+      </p:sp>
+      <p:sp>
+        <p:nvSpPr>
+          <p:cNvPr id="26" name="Text 23"/>
+          <p:cNvSpPr/>
+          <p:nvPr/>
+        </p:nvSpPr>
+        <p:spPr>
+          <a:xfrm>
+            <a:off x="8211312" y="3712464"/>
+            <a:ext cx="3291840" cy="256032"/>
+          </a:xfrm>
+          <a:prstGeom prst="rect">
+            <a:avLst/>
+          </a:prstGeom>
+          <a:noFill/>
+          <a:ln/>
+        </p:spPr>
+        <p:txBody>
+          <a:bodyPr wrap="square" lIns="0" tIns="0" rIns="0" bIns="0" rtlCol="0" anchor="ctr"/>
+          <a:lstStyle/>
+          <a:p>
+            <a:pPr indent="0" marL="0">
+              <a:buNone/>
+            </a:pPr>
+            <a:r>
+              <a:rPr lang="en-US" sz="1000" dirty="0">
+                <a:solidFill>
+                  <a:srgbClr val="6B7280"/>
+                </a:solidFill>
+                <a:latin typeface="맑은 고딕" pitchFamily="34" charset="0"/>
+                <a:ea typeface="맑은 고딕" pitchFamily="34" charset="-122"/>
+                <a:cs typeface="맑은 고딕" pitchFamily="34" charset="-120"/>
+              </a:rPr>
+              <a:t>★Season off★  ·  재고 4개</a:t>
+            </a:r>
+            <a:pPr indent="0" marL="0">
+              <a:buNone/>
+            </a:pPr>
+            <a:r>
+              <a:rPr lang="en-US" sz="1000" b="1" dirty="0">
+                <a:solidFill>
+                  <a:srgbClr val="D72638"/>
+                </a:solidFill>
+                <a:latin typeface="맑은 고딕" pitchFamily="34" charset="0"/>
+                <a:ea typeface="맑은 고딕" pitchFamily="34" charset="-122"/>
+                <a:cs typeface="맑은 고딕" pitchFamily="34" charset="-120"/>
+              </a:rPr>
+              <a:t/>
+            </a:r>
+            <a:endParaRPr lang="en-US" sz="1000" dirty="0"/>
+          </a:p>
+        </p:txBody>
+      </p:sp>
+      <p:sp>
+        <p:nvSpPr>
+          <p:cNvPr id="27" name="Shape 24"/>
+          <p:cNvSpPr/>
+          <p:nvPr/>
+        </p:nvSpPr>
+        <p:spPr>
+          <a:xfrm>
+            <a:off x="7406640" y="4096512"/>
+            <a:ext cx="4206240" cy="640080"/>
+          </a:xfrm>
+          <a:prstGeom prst="rect">
+            <a:avLst/>
+          </a:prstGeom>
+          <a:solidFill>
+            <a:srgbClr val="FFF5F5"/>
+          </a:solidFill>
+          <a:ln w="6350">
+            <a:solidFill>
+              <a:srgbClr val="E5E7EB"/>
+            </a:solidFill>
+            <a:prstDash val="solid"/>
+          </a:ln>
+        </p:spPr>
+      </p:sp>
+      <p:sp>
+        <p:nvSpPr>
+          <p:cNvPr id="28" name="Shape 25"/>
+          <p:cNvSpPr/>
+          <p:nvPr/>
+        </p:nvSpPr>
+        <p:spPr>
+          <a:xfrm>
+            <a:off x="7406640" y="4096512"/>
+            <a:ext cx="109728" cy="640080"/>
+          </a:xfrm>
+          <a:prstGeom prst="rect">
+            <a:avLst/>
+          </a:prstGeom>
+          <a:solidFill>
+            <a:srgbClr val="D72638"/>
+          </a:solidFill>
+          <a:ln w="12700">
+            <a:solidFill>
+              <a:srgbClr val="D72638"/>
+            </a:solidFill>
+            <a:prstDash val="solid"/>
+          </a:ln>
+        </p:spPr>
+      </p:sp>
+      <p:sp>
+        <p:nvSpPr>
+          <p:cNvPr id="29" name="Shape 26"/>
+          <p:cNvSpPr/>
+          <p:nvPr/>
+        </p:nvSpPr>
+        <p:spPr>
+          <a:xfrm>
+            <a:off x="7571232" y="4187952"/>
+            <a:ext cx="548640" cy="256032"/>
+          </a:xfrm>
+          <a:prstGeom prst="rect">
+            <a:avLst/>
+          </a:prstGeom>
+          <a:solidFill>
+            <a:srgbClr val="D72638"/>
+          </a:solidFill>
+          <a:ln w="12700">
+            <a:solidFill>
+              <a:srgbClr val="D72638"/>
+            </a:solidFill>
+            <a:prstDash val="solid"/>
+          </a:ln>
+        </p:spPr>
+      </p:sp>
+      <p:sp>
+        <p:nvSpPr>
+          <p:cNvPr id="30" name="Text 27"/>
+          <p:cNvSpPr/>
+          <p:nvPr/>
+        </p:nvSpPr>
+        <p:spPr>
+          <a:xfrm>
+            <a:off x="7571232" y="4187952"/>
+            <a:ext cx="548640" cy="256032"/>
+          </a:xfrm>
+          <a:prstGeom prst="rect">
+            <a:avLst/>
+          </a:prstGeom>
+          <a:noFill/>
+          <a:ln/>
+        </p:spPr>
+        <p:txBody>
+          <a:bodyPr wrap="square" lIns="0" tIns="0" rIns="0" bIns="0" rtlCol="0" anchor="ctr"/>
+          <a:lstStyle/>
+          <a:p>
+            <a:pPr algn="ctr" indent="0" marL="0">
+              <a:buNone/>
+            </a:pPr>
+            <a:r>
+              <a:rPr lang="en-US" sz="900" b="1" dirty="0">
+                <a:solidFill>
+                  <a:srgbClr val="FFFFFF"/>
+                </a:solidFill>
+                <a:latin typeface="맑은 고딕" pitchFamily="34" charset="0"/>
+                <a:ea typeface="맑은 고딕" pitchFamily="34" charset="-122"/>
+                <a:cs typeface="맑은 고딕" pitchFamily="34" charset="-120"/>
+              </a:rPr>
+              <a:t>긴급</a:t>
+            </a:r>
+            <a:endParaRPr lang="en-US" sz="900" dirty="0"/>
+          </a:p>
+        </p:txBody>
+      </p:sp>
+      <p:sp>
+        <p:nvSpPr>
+          <p:cNvPr id="31" name="Text 28"/>
+          <p:cNvSpPr/>
+          <p:nvPr/>
+        </p:nvSpPr>
+        <p:spPr>
+          <a:xfrm>
+            <a:off x="8211312" y="4151376"/>
+            <a:ext cx="3291840" cy="274320"/>
+          </a:xfrm>
+          <a:prstGeom prst="rect">
+            <a:avLst/>
+          </a:prstGeom>
+          <a:noFill/>
+          <a:ln/>
+        </p:spPr>
+        <p:txBody>
+          <a:bodyPr wrap="square" lIns="0" tIns="0" rIns="0" bIns="0" rtlCol="0" anchor="ctr"/>
+          <a:lstStyle/>
+          <a:p>
+            <a:pPr indent="0" marL="0">
+              <a:buNone/>
+            </a:pPr>
+            <a:r>
+              <a:rPr lang="en-US" sz="1100" b="1" dirty="0">
+                <a:solidFill>
+                  <a:srgbClr val="0B1220"/>
+                </a:solidFill>
+                <a:latin typeface="맑은 고딕" pitchFamily="34" charset="0"/>
+                <a:ea typeface="맑은 고딕" pitchFamily="34" charset="-122"/>
+                <a:cs typeface="맑은 고딕" pitchFamily="34" charset="-120"/>
+              </a:rPr>
+              <a:t>Two-ball Bangle</a:t>
+            </a:r>
+            <a:endParaRPr lang="en-US" sz="1100" dirty="0"/>
+          </a:p>
+        </p:txBody>
+      </p:sp>
+      <p:sp>
+        <p:nvSpPr>
+          <p:cNvPr id="32" name="Text 29"/>
+          <p:cNvSpPr/>
+          <p:nvPr/>
+        </p:nvSpPr>
+        <p:spPr>
+          <a:xfrm>
+            <a:off x="8211312" y="4425696"/>
+            <a:ext cx="3291840" cy="256032"/>
+          </a:xfrm>
+          <a:prstGeom prst="rect">
+            <a:avLst/>
+          </a:prstGeom>
+          <a:noFill/>
+          <a:ln/>
+        </p:spPr>
+        <p:txBody>
+          <a:bodyPr wrap="square" lIns="0" tIns="0" rIns="0" bIns="0" rtlCol="0" anchor="ctr"/>
+          <a:lstStyle/>
+          <a:p>
+            <a:pPr indent="0" marL="0">
+              <a:buNone/>
+            </a:pPr>
+            <a:r>
+              <a:rPr lang="en-US" sz="1000" dirty="0">
+                <a:solidFill>
+                  <a:srgbClr val="6B7280"/>
+                </a:solidFill>
+                <a:latin typeface="맑은 고딕" pitchFamily="34" charset="0"/>
+                <a:ea typeface="맑은 고딕" pitchFamily="34" charset="-122"/>
+                <a:cs typeface="맑은 고딕" pitchFamily="34" charset="-120"/>
+              </a:rPr>
+              <a:t>Bracelet  ·  재고 0개</a:t>
+            </a:r>
+            <a:pPr indent="0" marL="0">
+              <a:buNone/>
+            </a:pPr>
+            <a:r>
+              <a:rPr lang="en-US" sz="1000" b="1" dirty="0">
+                <a:solidFill>
+                  <a:srgbClr val="D72638"/>
+                </a:solidFill>
+                <a:latin typeface="맑은 고딕" pitchFamily="34" charset="0"/>
+                <a:ea typeface="맑은 고딕" pitchFamily="34" charset="-122"/>
+                <a:cs typeface="맑은 고딕" pitchFamily="34" charset="-120"/>
+              </a:rPr>
+              <a:t/>
+            </a:r>
+            <a:endParaRPr lang="en-US" sz="1000" dirty="0"/>
+          </a:p>
+        </p:txBody>
+      </p:sp>
+      <p:sp>
+        <p:nvSpPr>
+          <p:cNvPr id="33" name="Shape 30"/>
+          <p:cNvSpPr/>
+          <p:nvPr/>
+        </p:nvSpPr>
+        <p:spPr>
+          <a:xfrm>
+            <a:off x="7406640" y="4809744"/>
+            <a:ext cx="4206240" cy="640080"/>
+          </a:xfrm>
+          <a:prstGeom prst="rect">
+            <a:avLst/>
+          </a:prstGeom>
+          <a:solidFill>
+            <a:srgbClr val="FFF5F5"/>
+          </a:solidFill>
+          <a:ln w="6350">
+            <a:solidFill>
+              <a:srgbClr val="E5E7EB"/>
+            </a:solidFill>
+            <a:prstDash val="solid"/>
+          </a:ln>
+        </p:spPr>
+      </p:sp>
+      <p:sp>
+        <p:nvSpPr>
+          <p:cNvPr id="34" name="Shape 31"/>
+          <p:cNvSpPr/>
+          <p:nvPr/>
+        </p:nvSpPr>
+        <p:spPr>
+          <a:xfrm>
+            <a:off x="7406640" y="4809744"/>
+            <a:ext cx="109728" cy="640080"/>
+          </a:xfrm>
+          <a:prstGeom prst="rect">
+            <a:avLst/>
+          </a:prstGeom>
+          <a:solidFill>
+            <a:srgbClr val="D72638"/>
+          </a:solidFill>
+          <a:ln w="12700">
+            <a:solidFill>
+              <a:srgbClr val="D72638"/>
+            </a:solidFill>
+            <a:prstDash val="solid"/>
+          </a:ln>
+        </p:spPr>
+      </p:sp>
+      <p:sp>
+        <p:nvSpPr>
+          <p:cNvPr id="35" name="Shape 32"/>
+          <p:cNvSpPr/>
+          <p:nvPr/>
+        </p:nvSpPr>
+        <p:spPr>
+          <a:xfrm>
+            <a:off x="7571232" y="4901184"/>
+            <a:ext cx="548640" cy="256032"/>
+          </a:xfrm>
+          <a:prstGeom prst="rect">
+            <a:avLst/>
+          </a:prstGeom>
+          <a:solidFill>
+            <a:srgbClr val="D72638"/>
+          </a:solidFill>
+          <a:ln w="12700">
+            <a:solidFill>
+              <a:srgbClr val="D72638"/>
+            </a:solidFill>
+            <a:prstDash val="solid"/>
+          </a:ln>
+        </p:spPr>
+      </p:sp>
+      <p:sp>
+        <p:nvSpPr>
+          <p:cNvPr id="36" name="Text 33"/>
+          <p:cNvSpPr/>
+          <p:nvPr/>
+        </p:nvSpPr>
+        <p:spPr>
+          <a:xfrm>
+            <a:off x="7571232" y="4901184"/>
+            <a:ext cx="548640" cy="256032"/>
+          </a:xfrm>
+          <a:prstGeom prst="rect">
+            <a:avLst/>
+          </a:prstGeom>
+          <a:noFill/>
+          <a:ln/>
+        </p:spPr>
+        <p:txBody>
+          <a:bodyPr wrap="square" lIns="0" tIns="0" rIns="0" bIns="0" rtlCol="0" anchor="ctr"/>
+          <a:lstStyle/>
+          <a:p>
+            <a:pPr algn="ctr" indent="0" marL="0">
+              <a:buNone/>
+            </a:pPr>
+            <a:r>
+              <a:rPr lang="en-US" sz="900" b="1" dirty="0">
+                <a:solidFill>
+                  <a:srgbClr val="FFFFFF"/>
+                </a:solidFill>
+                <a:latin typeface="맑은 고딕" pitchFamily="34" charset="0"/>
+                <a:ea typeface="맑은 고딕" pitchFamily="34" charset="-122"/>
+                <a:cs typeface="맑은 고딕" pitchFamily="34" charset="-120"/>
+              </a:rPr>
+              <a:t>긴급</a:t>
+            </a:r>
+            <a:endParaRPr lang="en-US" sz="900" dirty="0"/>
+          </a:p>
+        </p:txBody>
+      </p:sp>
+      <p:sp>
+        <p:nvSpPr>
+          <p:cNvPr id="37" name="Text 34"/>
+          <p:cNvSpPr/>
+          <p:nvPr/>
+        </p:nvSpPr>
+        <p:spPr>
+          <a:xfrm>
+            <a:off x="8211312" y="4864608"/>
+            <a:ext cx="3291840" cy="274320"/>
+          </a:xfrm>
+          <a:prstGeom prst="rect">
+            <a:avLst/>
+          </a:prstGeom>
+          <a:noFill/>
+          <a:ln/>
+        </p:spPr>
+        <p:txBody>
+          <a:bodyPr wrap="square" lIns="0" tIns="0" rIns="0" bIns="0" rtlCol="0" anchor="ctr"/>
+          <a:lstStyle/>
+          <a:p>
+            <a:pPr indent="0" marL="0">
+              <a:buNone/>
+            </a:pPr>
+            <a:r>
+              <a:rPr lang="en-US" sz="1100" b="1" dirty="0">
+                <a:solidFill>
+                  <a:srgbClr val="0B1220"/>
+                </a:solidFill>
+                <a:latin typeface="맑은 고딕" pitchFamily="34" charset="0"/>
+                <a:ea typeface="맑은 고딕" pitchFamily="34" charset="-122"/>
+                <a:cs typeface="맑은 고딕" pitchFamily="34" charset="-120"/>
+              </a:rPr>
               <a:t>[SILVER925] Crimson Open Ring</a:t>
             </a:r>
             <a:endParaRPr lang="en-US" sz="1100" dirty="0"/>
@@ -7565,13 +7977,13 @@
       </p:sp>
       <p:sp>
         <p:nvSpPr>
-          <p:cNvPr id="26" name="Text 23"/>
-          <p:cNvSpPr/>
-          <p:nvPr/>
-        </p:nvSpPr>
-        <p:spPr>
-          <a:xfrm>
-            <a:off x="8211312" y="3712464"/>
+          <p:cNvPr id="38" name="Text 35"/>
+          <p:cNvSpPr/>
+          <p:nvPr/>
+        </p:nvSpPr>
+        <p:spPr>
+          <a:xfrm>
+            <a:off x="8211312" y="5138928"/>
             <a:ext cx="3291840" cy="256032"/>
           </a:xfrm>
           <a:prstGeom prst="rect">
@@ -7618,418 +8030,6 @@
       </p:sp>
       <p:sp>
         <p:nvSpPr>
-          <p:cNvPr id="27" name="Shape 24"/>
-          <p:cNvSpPr/>
-          <p:nvPr/>
-        </p:nvSpPr>
-        <p:spPr>
-          <a:xfrm>
-            <a:off x="7406640" y="4096512"/>
-            <a:ext cx="4206240" cy="640080"/>
-          </a:xfrm>
-          <a:prstGeom prst="rect">
-            <a:avLst/>
-          </a:prstGeom>
-          <a:solidFill>
-            <a:srgbClr val="FFF5F5"/>
-          </a:solidFill>
-          <a:ln w="6350">
-            <a:solidFill>
-              <a:srgbClr val="E5E7EB"/>
-            </a:solidFill>
-            <a:prstDash val="solid"/>
-          </a:ln>
-        </p:spPr>
-      </p:sp>
-      <p:sp>
-        <p:nvSpPr>
-          <p:cNvPr id="28" name="Shape 25"/>
-          <p:cNvSpPr/>
-          <p:nvPr/>
-        </p:nvSpPr>
-        <p:spPr>
-          <a:xfrm>
-            <a:off x="7406640" y="4096512"/>
-            <a:ext cx="109728" cy="640080"/>
-          </a:xfrm>
-          <a:prstGeom prst="rect">
-            <a:avLst/>
-          </a:prstGeom>
-          <a:solidFill>
-            <a:srgbClr val="D72638"/>
-          </a:solidFill>
-          <a:ln w="12700">
-            <a:solidFill>
-              <a:srgbClr val="D72638"/>
-            </a:solidFill>
-            <a:prstDash val="solid"/>
-          </a:ln>
-        </p:spPr>
-      </p:sp>
-      <p:sp>
-        <p:nvSpPr>
-          <p:cNvPr id="29" name="Shape 26"/>
-          <p:cNvSpPr/>
-          <p:nvPr/>
-        </p:nvSpPr>
-        <p:spPr>
-          <a:xfrm>
-            <a:off x="7571232" y="4187952"/>
-            <a:ext cx="548640" cy="256032"/>
-          </a:xfrm>
-          <a:prstGeom prst="rect">
-            <a:avLst/>
-          </a:prstGeom>
-          <a:solidFill>
-            <a:srgbClr val="D72638"/>
-          </a:solidFill>
-          <a:ln w="12700">
-            <a:solidFill>
-              <a:srgbClr val="D72638"/>
-            </a:solidFill>
-            <a:prstDash val="solid"/>
-          </a:ln>
-        </p:spPr>
-      </p:sp>
-      <p:sp>
-        <p:nvSpPr>
-          <p:cNvPr id="30" name="Text 27"/>
-          <p:cNvSpPr/>
-          <p:nvPr/>
-        </p:nvSpPr>
-        <p:spPr>
-          <a:xfrm>
-            <a:off x="7571232" y="4187952"/>
-            <a:ext cx="548640" cy="256032"/>
-          </a:xfrm>
-          <a:prstGeom prst="rect">
-            <a:avLst/>
-          </a:prstGeom>
-          <a:noFill/>
-          <a:ln/>
-        </p:spPr>
-        <p:txBody>
-          <a:bodyPr wrap="square" lIns="0" tIns="0" rIns="0" bIns="0" rtlCol="0" anchor="ctr"/>
-          <a:lstStyle/>
-          <a:p>
-            <a:pPr algn="ctr" indent="0" marL="0">
-              <a:buNone/>
-            </a:pPr>
-            <a:r>
-              <a:rPr lang="en-US" sz="900" b="1" dirty="0">
-                <a:solidFill>
-                  <a:srgbClr val="FFFFFF"/>
-                </a:solidFill>
-                <a:latin typeface="맑은 고딕" pitchFamily="34" charset="0"/>
-                <a:ea typeface="맑은 고딕" pitchFamily="34" charset="-122"/>
-                <a:cs typeface="맑은 고딕" pitchFamily="34" charset="-120"/>
-              </a:rPr>
-              <a:t>긴급</a:t>
-            </a:r>
-            <a:endParaRPr lang="en-US" sz="900" dirty="0"/>
-          </a:p>
-        </p:txBody>
-      </p:sp>
-      <p:sp>
-        <p:nvSpPr>
-          <p:cNvPr id="31" name="Text 28"/>
-          <p:cNvSpPr/>
-          <p:nvPr/>
-        </p:nvSpPr>
-        <p:spPr>
-          <a:xfrm>
-            <a:off x="8211312" y="4151376"/>
-            <a:ext cx="3291840" cy="274320"/>
-          </a:xfrm>
-          <a:prstGeom prst="rect">
-            <a:avLst/>
-          </a:prstGeom>
-          <a:noFill/>
-          <a:ln/>
-        </p:spPr>
-        <p:txBody>
-          <a:bodyPr wrap="square" lIns="0" tIns="0" rIns="0" bIns="0" rtlCol="0" anchor="ctr"/>
-          <a:lstStyle/>
-          <a:p>
-            <a:pPr indent="0" marL="0">
-              <a:buNone/>
-            </a:pPr>
-            <a:r>
-              <a:rPr lang="en-US" sz="1100" b="1" dirty="0">
-                <a:solidFill>
-                  <a:srgbClr val="0B1220"/>
-                </a:solidFill>
-                <a:latin typeface="맑은 고딕" pitchFamily="34" charset="0"/>
-                <a:ea typeface="맑은 고딕" pitchFamily="34" charset="-122"/>
-                <a:cs typeface="맑은 고딕" pitchFamily="34" charset="-120"/>
-              </a:rPr>
-              <a:t>8-Ball Smart Tok</a:t>
-            </a:r>
-            <a:endParaRPr lang="en-US" sz="1100" dirty="0"/>
-          </a:p>
-        </p:txBody>
-      </p:sp>
-      <p:sp>
-        <p:nvSpPr>
-          <p:cNvPr id="32" name="Text 29"/>
-          <p:cNvSpPr/>
-          <p:nvPr/>
-        </p:nvSpPr>
-        <p:spPr>
-          <a:xfrm>
-            <a:off x="8211312" y="4425696"/>
-            <a:ext cx="3291840" cy="256032"/>
-          </a:xfrm>
-          <a:prstGeom prst="rect">
-            <a:avLst/>
-          </a:prstGeom>
-          <a:noFill/>
-          <a:ln/>
-        </p:spPr>
-        <p:txBody>
-          <a:bodyPr wrap="square" lIns="0" tIns="0" rIns="0" bIns="0" rtlCol="0" anchor="ctr"/>
-          <a:lstStyle/>
-          <a:p>
-            <a:pPr indent="0" marL="0">
-              <a:buNone/>
-            </a:pPr>
-            <a:r>
-              <a:rPr lang="en-US" sz="1000" dirty="0">
-                <a:solidFill>
-                  <a:srgbClr val="6B7280"/>
-                </a:solidFill>
-                <a:latin typeface="맑은 고딕" pitchFamily="34" charset="0"/>
-                <a:ea typeface="맑은 고딕" pitchFamily="34" charset="-122"/>
-                <a:cs typeface="맑은 고딕" pitchFamily="34" charset="-120"/>
-              </a:rPr>
-              <a:t>★Season off★  ·  재고 4개</a:t>
-            </a:r>
-            <a:pPr indent="0" marL="0">
-              <a:buNone/>
-            </a:pPr>
-            <a:r>
-              <a:rPr lang="en-US" sz="1000" b="1" dirty="0">
-                <a:solidFill>
-                  <a:srgbClr val="D72638"/>
-                </a:solidFill>
-                <a:latin typeface="맑은 고딕" pitchFamily="34" charset="0"/>
-                <a:ea typeface="맑은 고딕" pitchFamily="34" charset="-122"/>
-                <a:cs typeface="맑은 고딕" pitchFamily="34" charset="-120"/>
-              </a:rPr>
-              <a:t/>
-            </a:r>
-            <a:endParaRPr lang="en-US" sz="1000" dirty="0"/>
-          </a:p>
-        </p:txBody>
-      </p:sp>
-      <p:sp>
-        <p:nvSpPr>
-          <p:cNvPr id="33" name="Shape 30"/>
-          <p:cNvSpPr/>
-          <p:nvPr/>
-        </p:nvSpPr>
-        <p:spPr>
-          <a:xfrm>
-            <a:off x="7406640" y="4809744"/>
-            <a:ext cx="4206240" cy="640080"/>
-          </a:xfrm>
-          <a:prstGeom prst="rect">
-            <a:avLst/>
-          </a:prstGeom>
-          <a:solidFill>
-            <a:srgbClr val="FFF5F5"/>
-          </a:solidFill>
-          <a:ln w="6350">
-            <a:solidFill>
-              <a:srgbClr val="E5E7EB"/>
-            </a:solidFill>
-            <a:prstDash val="solid"/>
-          </a:ln>
-        </p:spPr>
-      </p:sp>
-      <p:sp>
-        <p:nvSpPr>
-          <p:cNvPr id="34" name="Shape 31"/>
-          <p:cNvSpPr/>
-          <p:nvPr/>
-        </p:nvSpPr>
-        <p:spPr>
-          <a:xfrm>
-            <a:off x="7406640" y="4809744"/>
-            <a:ext cx="109728" cy="640080"/>
-          </a:xfrm>
-          <a:prstGeom prst="rect">
-            <a:avLst/>
-          </a:prstGeom>
-          <a:solidFill>
-            <a:srgbClr val="D72638"/>
-          </a:solidFill>
-          <a:ln w="12700">
-            <a:solidFill>
-              <a:srgbClr val="D72638"/>
-            </a:solidFill>
-            <a:prstDash val="solid"/>
-          </a:ln>
-        </p:spPr>
-      </p:sp>
-      <p:sp>
-        <p:nvSpPr>
-          <p:cNvPr id="35" name="Shape 32"/>
-          <p:cNvSpPr/>
-          <p:nvPr/>
-        </p:nvSpPr>
-        <p:spPr>
-          <a:xfrm>
-            <a:off x="7571232" y="4901184"/>
-            <a:ext cx="548640" cy="256032"/>
-          </a:xfrm>
-          <a:prstGeom prst="rect">
-            <a:avLst/>
-          </a:prstGeom>
-          <a:solidFill>
-            <a:srgbClr val="D72638"/>
-          </a:solidFill>
-          <a:ln w="12700">
-            <a:solidFill>
-              <a:srgbClr val="D72638"/>
-            </a:solidFill>
-            <a:prstDash val="solid"/>
-          </a:ln>
-        </p:spPr>
-      </p:sp>
-      <p:sp>
-        <p:nvSpPr>
-          <p:cNvPr id="36" name="Text 33"/>
-          <p:cNvSpPr/>
-          <p:nvPr/>
-        </p:nvSpPr>
-        <p:spPr>
-          <a:xfrm>
-            <a:off x="7571232" y="4901184"/>
-            <a:ext cx="548640" cy="256032"/>
-          </a:xfrm>
-          <a:prstGeom prst="rect">
-            <a:avLst/>
-          </a:prstGeom>
-          <a:noFill/>
-          <a:ln/>
-        </p:spPr>
-        <p:txBody>
-          <a:bodyPr wrap="square" lIns="0" tIns="0" rIns="0" bIns="0" rtlCol="0" anchor="ctr"/>
-          <a:lstStyle/>
-          <a:p>
-            <a:pPr algn="ctr" indent="0" marL="0">
-              <a:buNone/>
-            </a:pPr>
-            <a:r>
-              <a:rPr lang="en-US" sz="900" b="1" dirty="0">
-                <a:solidFill>
-                  <a:srgbClr val="FFFFFF"/>
-                </a:solidFill>
-                <a:latin typeface="맑은 고딕" pitchFamily="34" charset="0"/>
-                <a:ea typeface="맑은 고딕" pitchFamily="34" charset="-122"/>
-                <a:cs typeface="맑은 고딕" pitchFamily="34" charset="-120"/>
-              </a:rPr>
-              <a:t>긴급</a:t>
-            </a:r>
-            <a:endParaRPr lang="en-US" sz="900" dirty="0"/>
-          </a:p>
-        </p:txBody>
-      </p:sp>
-      <p:sp>
-        <p:nvSpPr>
-          <p:cNvPr id="37" name="Text 34"/>
-          <p:cNvSpPr/>
-          <p:nvPr/>
-        </p:nvSpPr>
-        <p:spPr>
-          <a:xfrm>
-            <a:off x="8211312" y="4864608"/>
-            <a:ext cx="3291840" cy="274320"/>
-          </a:xfrm>
-          <a:prstGeom prst="rect">
-            <a:avLst/>
-          </a:prstGeom>
-          <a:noFill/>
-          <a:ln/>
-        </p:spPr>
-        <p:txBody>
-          <a:bodyPr wrap="square" lIns="0" tIns="0" rIns="0" bIns="0" rtlCol="0" anchor="ctr"/>
-          <a:lstStyle/>
-          <a:p>
-            <a:pPr indent="0" marL="0">
-              <a:buNone/>
-            </a:pPr>
-            <a:r>
-              <a:rPr lang="en-US" sz="1100" b="1" dirty="0">
-                <a:solidFill>
-                  <a:srgbClr val="0B1220"/>
-                </a:solidFill>
-                <a:latin typeface="맑은 고딕" pitchFamily="34" charset="0"/>
-                <a:ea typeface="맑은 고딕" pitchFamily="34" charset="-122"/>
-                <a:cs typeface="맑은 고딕" pitchFamily="34" charset="-120"/>
-              </a:rPr>
-              <a:t>Two-ball Bangle</a:t>
-            </a:r>
-            <a:endParaRPr lang="en-US" sz="1100" dirty="0"/>
-          </a:p>
-        </p:txBody>
-      </p:sp>
-      <p:sp>
-        <p:nvSpPr>
-          <p:cNvPr id="38" name="Text 35"/>
-          <p:cNvSpPr/>
-          <p:nvPr/>
-        </p:nvSpPr>
-        <p:spPr>
-          <a:xfrm>
-            <a:off x="8211312" y="5138928"/>
-            <a:ext cx="3291840" cy="256032"/>
-          </a:xfrm>
-          <a:prstGeom prst="rect">
-            <a:avLst/>
-          </a:prstGeom>
-          <a:noFill/>
-          <a:ln/>
-        </p:spPr>
-        <p:txBody>
-          <a:bodyPr wrap="square" lIns="0" tIns="0" rIns="0" bIns="0" rtlCol="0" anchor="ctr"/>
-          <a:lstStyle/>
-          <a:p>
-            <a:pPr indent="0" marL="0">
-              <a:buNone/>
-            </a:pPr>
-            <a:r>
-              <a:rPr lang="en-US" sz="1000" dirty="0">
-                <a:solidFill>
-                  <a:srgbClr val="6B7280"/>
-                </a:solidFill>
-                <a:latin typeface="맑은 고딕" pitchFamily="34" charset="0"/>
-                <a:ea typeface="맑은 고딕" pitchFamily="34" charset="-122"/>
-                <a:cs typeface="맑은 고딕" pitchFamily="34" charset="-120"/>
-              </a:rPr>
-              <a:t>Bracelet  ·  재고 0개</a:t>
-            </a:r>
-            <a:pPr indent="0" marL="0">
-              <a:buNone/>
-            </a:pPr>
-            <a:r>
-              <a:rPr lang="en-US" sz="1000" b="1" dirty="0">
-                <a:solidFill>
-                  <a:srgbClr val="D72638"/>
-                </a:solidFill>
-                <a:latin typeface="맑은 고딕" pitchFamily="34" charset="0"/>
-                <a:ea typeface="맑은 고딕" pitchFamily="34" charset="-122"/>
-                <a:cs typeface="맑은 고딕" pitchFamily="34" charset="-120"/>
-              </a:rPr>
-              <a:t/>
-            </a:r>
-            <a:endParaRPr lang="en-US" sz="1000" dirty="0"/>
-          </a:p>
-        </p:txBody>
-      </p:sp>
-      <p:sp>
-        <p:nvSpPr>
           <p:cNvPr id="39" name="Shape 36"/>
           <p:cNvSpPr/>
           <p:nvPr/>
@@ -8267,7 +8267,7 @@
                 <a:ea typeface="맑은 고딕" pitchFamily="34" charset="-122"/>
                 <a:cs typeface="맑은 고딕" pitchFamily="34" charset="-120"/>
               </a:rPr>
-              <a:t>베스트 상품 리포트  ·  생성 2026-05-30 08:00</a:t>
+              <a:t>베스트 상품 리포트  ·  생성 2026-05-31 08:00</a:t>
             </a:r>
             <a:endParaRPr lang="en-US" sz="900" dirty="0"/>
           </a:p>
@@ -8480,7 +8480,7 @@
                 <a:ea typeface="맑은 고딕" pitchFamily="34" charset="-122"/>
                 <a:cs typeface="맑은 고딕" pitchFamily="34" charset="-120"/>
               </a:rPr>
-              <a:t>2026년 05월 30일 (토)</a:t>
+              <a:t>2026년 05월 31일 (일)</a:t>
             </a:r>
             <a:endParaRPr lang="en-US" sz="1200" dirty="0"/>
           </a:p>
@@ -8647,7 +8647,7 @@
                 <a:ea typeface="맑은 고딕" pitchFamily="34" charset="-122"/>
                 <a:cs typeface="맑은 고딕" pitchFamily="34" charset="-120"/>
               </a:rPr>
-              <a:t>79 개</a:t>
+              <a:t>149 개</a:t>
             </a:r>
             <a:endParaRPr lang="en-US" sz="3600" dirty="0"/>
           </a:p>
@@ -8853,7 +8853,7 @@
                 <a:ea typeface="맑은 고딕" pitchFamily="34" charset="-122"/>
                 <a:cs typeface="맑은 고딕" pitchFamily="34" charset="-120"/>
               </a:rPr>
-              <a:t>24</a:t>
+              <a:t>41</a:t>
             </a:r>
             <a:endParaRPr lang="en-US" sz="4400" dirty="0"/>
           </a:p>
@@ -9452,7 +9452,7 @@
                           <a:ea typeface="맑은 고딕" pitchFamily="34" charset="-122"/>
                           <a:cs typeface="맑은 고딕" pitchFamily="34" charset="-120"/>
                         </a:rPr>
-                        <a:t>24 개</a:t>
+                        <a:t>41 개</a:t>
                       </a:r>
                       <a:endParaRPr lang="en-US" sz="1400" dirty="0">
                         <a:latin typeface="맑은 고딕" charset="0"/>
@@ -9649,7 +9649,7 @@
                           <a:ea typeface="맑은 고딕" pitchFamily="34" charset="-122"/>
                           <a:cs typeface="맑은 고딕" pitchFamily="34" charset="-120"/>
                         </a:rPr>
-                        <a:t>ThreadDuo Necklace</a:t>
+                        <a:t>CandyPOP Necklace (사이즈: 2size (47~52cm))</a:t>
                       </a:r>
                       <a:endParaRPr lang="en-US" sz="1100" dirty="0">
                         <a:latin typeface="맑은 고딕" charset="0"/>
@@ -9714,7 +9714,7 @@
                           <a:ea typeface="맑은 고딕" pitchFamily="34" charset="-122"/>
                           <a:cs typeface="맑은 고딕" pitchFamily="34" charset="-120"/>
                         </a:rPr>
-                        <a:t>18 개</a:t>
+                        <a:t>34 개</a:t>
                       </a:r>
                       <a:endParaRPr lang="en-US" sz="1200" dirty="0">
                         <a:latin typeface="맑은 고딕" charset="0"/>
@@ -9846,7 +9846,7 @@
                           <a:ea typeface="맑은 고딕" pitchFamily="34" charset="-122"/>
                           <a:cs typeface="맑은 고딕" pitchFamily="34" charset="-120"/>
                         </a:rPr>
-                        <a:t>Ring</a:t>
+                        <a:t>Necklace</a:t>
                       </a:r>
                       <a:endParaRPr lang="en-US" sz="1000" dirty="0">
                         <a:latin typeface="맑은 고딕" charset="0"/>
@@ -9911,7 +9911,7 @@
                           <a:ea typeface="맑은 고딕" pitchFamily="34" charset="-122"/>
                           <a:cs typeface="맑은 고딕" pitchFamily="34" charset="-120"/>
                         </a:rPr>
-                        <a:t>"4s" 925 Open Ring (사이즈: 남성)</a:t>
+                        <a:t>ThreadDuo Necklace</a:t>
                       </a:r>
                       <a:endParaRPr lang="en-US" sz="1100" dirty="0">
                         <a:latin typeface="맑은 고딕" charset="0"/>
@@ -9976,7 +9976,7 @@
                           <a:ea typeface="맑은 고딕" pitchFamily="34" charset="-122"/>
                           <a:cs typeface="맑은 고딕" pitchFamily="34" charset="-120"/>
                         </a:rPr>
-                        <a:t>11 개</a:t>
+                        <a:t>18 개</a:t>
                       </a:r>
                       <a:endParaRPr lang="en-US" sz="1200" dirty="0">
                         <a:latin typeface="맑은 고딕" charset="0"/>
@@ -10062,7 +10062,7 @@
                 <a:ea typeface="맑은 고딕" pitchFamily="34" charset="-122"/>
                 <a:cs typeface="맑은 고딕" pitchFamily="34" charset="-120"/>
               </a:rPr>
-              <a:t>리오더 필요  🔴 긴급 20건</a:t>
+              <a:t>리오더 필요  🔴 긴급 21건</a:t>
             </a:r>
             <a:endParaRPr lang="en-US" sz="1500" dirty="0"/>
           </a:p>
@@ -10126,7 +10126,7 @@
                 <a:ea typeface="맑은 고딕" pitchFamily="34" charset="-122"/>
                 <a:cs typeface="맑은 고딕" pitchFamily="34" charset="-120"/>
               </a:rPr>
-              <a:t>🔴 긴급 20건  ·  상세는 시트 확인</a:t>
+              <a:t>🔴 긴급 21건  ·  상세는 시트 확인</a:t>
             </a:r>
             <a:endParaRPr lang="en-US" sz="1400" dirty="0"/>
           </a:p>
@@ -10165,7 +10165,7 @@
                 <a:ea typeface="맑은 고딕" pitchFamily="34" charset="-122"/>
                 <a:cs typeface="맑은 고딕" pitchFamily="34" charset="-120"/>
               </a:rPr>
-              <a:t>베스트 상품 리포트  ·  생성 2026-05-30 08:00</a:t>
+              <a:t>베스트 상품 리포트  ·  생성 2026-05-31 08:00</a:t>
             </a:r>
             <a:endParaRPr lang="en-US" sz="900" dirty="0"/>
           </a:p>
@@ -10378,7 +10378,7 @@
                 <a:ea typeface="맑은 고딕" pitchFamily="34" charset="-122"/>
                 <a:cs typeface="맑은 고딕" pitchFamily="34" charset="-120"/>
               </a:rPr>
-              <a:t>2026년 05월 30일 (토)</a:t>
+              <a:t>2026년 05월 31일 (일)</a:t>
             </a:r>
             <a:endParaRPr lang="en-US" sz="1200" dirty="0"/>
           </a:p>
@@ -10801,7 +10801,7 @@
                 <a:ea typeface="맑은 고딕" pitchFamily="34" charset="-122"/>
                 <a:cs typeface="맑은 고딕" pitchFamily="34" charset="-120"/>
               </a:rPr>
-              <a:t>9</a:t>
+              <a:t>10</a:t>
             </a:r>
             <a:endParaRPr lang="en-US" sz="3000" dirty="0"/>
           </a:p>
@@ -10929,7 +10929,7 @@
                 <a:ea typeface="맑은 고딕" pitchFamily="34" charset="-122"/>
                 <a:cs typeface="맑은 고딕" pitchFamily="34" charset="-120"/>
               </a:rPr>
-              <a:t>31,518</a:t>
+              <a:t>30,888</a:t>
             </a:r>
             <a:endParaRPr lang="en-US" sz="3000" dirty="0"/>
           </a:p>
@@ -11489,7 +11489,7 @@
                           <a:ea typeface="맑은 고딕" pitchFamily="34" charset="-122"/>
                           <a:cs typeface="맑은 고딕" pitchFamily="34" charset="-120"/>
                         </a:rPr>
-                        <a:t>2,043</a:t>
+                        <a:t>2,039</a:t>
                       </a:r>
                       <a:endParaRPr lang="en-US" sz="1000" dirty="0">
                         <a:latin typeface="맑은 고딕" charset="0"/>
@@ -11751,7 +11751,7 @@
                           <a:ea typeface="맑은 고딕" pitchFamily="34" charset="-122"/>
                           <a:cs typeface="맑은 고딕" pitchFamily="34" charset="-120"/>
                         </a:rPr>
-                        <a:t>1,565</a:t>
+                        <a:t>1,554</a:t>
                       </a:r>
                       <a:endParaRPr lang="en-US" sz="1000" dirty="0">
                         <a:latin typeface="맑은 고딕" charset="0"/>
@@ -12013,7 +12013,7 @@
                           <a:ea typeface="맑은 고딕" pitchFamily="34" charset="-122"/>
                           <a:cs typeface="맑은 고딕" pitchFamily="34" charset="-120"/>
                         </a:rPr>
-                        <a:t>1,047</a:t>
+                        <a:t>1,008</a:t>
                       </a:r>
                       <a:endParaRPr lang="en-US" sz="1000" dirty="0">
                         <a:latin typeface="맑은 고딕" charset="0"/>
@@ -12275,7 +12275,7 @@
                           <a:ea typeface="맑은 고딕" pitchFamily="34" charset="-122"/>
                           <a:cs typeface="맑은 고딕" pitchFamily="34" charset="-120"/>
                         </a:rPr>
-                        <a:t>849</a:t>
+                        <a:t>839</a:t>
                       </a:r>
                       <a:endParaRPr lang="en-US" sz="1000" dirty="0">
                         <a:latin typeface="맑은 고딕" charset="0"/>
@@ -13556,7 +13556,7 @@
                 <a:ea typeface="맑은 고딕" pitchFamily="34" charset="-122"/>
                 <a:cs typeface="맑은 고딕" pitchFamily="34" charset="-120"/>
               </a:rPr>
-              <a:t>베스트 상품 리포트  ·  생성 2026-05-30 08:00</a:t>
+              <a:t>베스트 상품 리포트  ·  생성 2026-05-31 08:00</a:t>
             </a:r>
             <a:endParaRPr lang="en-US" sz="900" dirty="0"/>
           </a:p>
@@ -13769,7 +13769,7 @@
                 <a:ea typeface="맑은 고딕" pitchFamily="34" charset="-122"/>
                 <a:cs typeface="맑은 고딕" pitchFamily="34" charset="-120"/>
               </a:rPr>
-              <a:t>2026년 05월 30일 (토)</a:t>
+              <a:t>2026년 05월 31일 (일)</a:t>
             </a:r>
             <a:endParaRPr lang="en-US" sz="1200" dirty="0"/>
           </a:p>
@@ -13897,7 +13897,7 @@
                 <a:ea typeface="맑은 고딕" pitchFamily="34" charset="-122"/>
                 <a:cs typeface="맑은 고딕" pitchFamily="34" charset="-120"/>
               </a:rPr>
-              <a:t>🚨  긴급 리오더 66건    ·    주의 리오더 10건    ·    오늘 발주 검토 필수</a:t>
+              <a:t>🚨  긴급 리오더 68건    ·    주의 리오더 10건    ·    오늘 발주 검토 필수</a:t>
             </a:r>
             <a:pPr indent="0" marL="0">
               <a:buNone/>
@@ -14527,7 +14527,7 @@
                           <a:ea typeface="맑은 고딕" pitchFamily="34" charset="-122"/>
                           <a:cs typeface="맑은 고딕" pitchFamily="34" charset="-120"/>
                         </a:rPr>
-                        <a:t>PR</a:t>
+                        <a:t>CT</a:t>
                       </a:r>
                       <a:endParaRPr lang="en-US" sz="1100" dirty="0">
                         <a:latin typeface="맑은 고딕" charset="0"/>
@@ -14595,7 +14595,7 @@
                           <a:ea typeface="맑은 고딕" pitchFamily="34" charset="-122"/>
                           <a:cs typeface="맑은 고딕" pitchFamily="34" charset="-120"/>
                         </a:rPr>
-                        <a:t>ETC</a:t>
+                        <a:t>Ring</a:t>
                       </a:r>
                       <a:endParaRPr lang="en-US" sz="1000" dirty="0">
                         <a:latin typeface="맑은 고딕" charset="0"/>
@@ -14663,7 +14663,7 @@
                           <a:ea typeface="맑은 고딕" pitchFamily="34" charset="-122"/>
                           <a:cs typeface="맑은 고딕" pitchFamily="34" charset="-120"/>
                         </a:rPr>
-                        <a:t>360° Rotating Phone Holder (컬러: 화이트)</a:t>
+                        <a:t>"Fenghuang" 925 Open Ring</a:t>
                       </a:r>
                       <a:endParaRPr lang="en-US" sz="1100" dirty="0">
                         <a:latin typeface="맑은 고딕" charset="0"/>
@@ -14731,7 +14731,7 @@
                           <a:ea typeface="맑은 고딕" pitchFamily="34" charset="-122"/>
                           <a:cs typeface="맑은 고딕" pitchFamily="34" charset="-120"/>
                         </a:rPr>
-                        <a:t>3</a:t>
+                        <a:t>0</a:t>
                       </a:r>
                       <a:endParaRPr lang="en-US" sz="1100" dirty="0">
                         <a:latin typeface="맑은 고딕" charset="0"/>
@@ -14799,7 +14799,7 @@
                           <a:ea typeface="맑은 고딕" pitchFamily="34" charset="-122"/>
                           <a:cs typeface="맑은 고딕" pitchFamily="34" charset="-120"/>
                         </a:rPr>
-                        <a:t>4 개</a:t>
+                        <a:t>12 개</a:t>
                       </a:r>
                       <a:endParaRPr lang="en-US" sz="1100" dirty="0">
                         <a:latin typeface="맑은 고딕" charset="0"/>
@@ -14937,7 +14937,7 @@
                           <a:ea typeface="맑은 고딕" pitchFamily="34" charset="-122"/>
                           <a:cs typeface="맑은 고딕" pitchFamily="34" charset="-120"/>
                         </a:rPr>
-                        <a:t>6A</a:t>
+                        <a:t>PR</a:t>
                       </a:r>
                       <a:endParaRPr lang="en-US" sz="1100" dirty="0">
                         <a:latin typeface="맑은 고딕" charset="0"/>
@@ -15005,7 +15005,7 @@
                           <a:ea typeface="맑은 고딕" pitchFamily="34" charset="-122"/>
                           <a:cs typeface="맑은 고딕" pitchFamily="34" charset="-120"/>
                         </a:rPr>
-                        <a:t>Ring</a:t>
+                        <a:t>ELECTRONIC</a:t>
                       </a:r>
                       <a:endParaRPr lang="en-US" sz="1000" dirty="0">
                         <a:latin typeface="맑은 고딕" charset="0"/>
@@ -15073,7 +15073,7 @@
                           <a:ea typeface="맑은 고딕" pitchFamily="34" charset="-122"/>
                           <a:cs typeface="맑은 고딕" pitchFamily="34" charset="-120"/>
                         </a:rPr>
-                        <a:t>[SILVER925] Crimson Open Ring</a:t>
+                        <a:t>Jacquard Fast Charging Cable (7color) (컬러: 민트 / 기종옵션: C-Apple 8pin / 길이: 2m)</a:t>
                       </a:r>
                       <a:endParaRPr lang="en-US" sz="1100" dirty="0">
                         <a:latin typeface="맑은 고딕" charset="0"/>
@@ -15141,7 +15141,7 @@
                           <a:ea typeface="맑은 고딕" pitchFamily="34" charset="-122"/>
                           <a:cs typeface="맑은 고딕" pitchFamily="34" charset="-120"/>
                         </a:rPr>
-                        <a:t>0</a:t>
+                        <a:t>3</a:t>
                       </a:r>
                       <a:endParaRPr lang="en-US" sz="1100" dirty="0">
                         <a:latin typeface="맑은 고딕" charset="0"/>
@@ -15209,7 +15209,7 @@
                           <a:ea typeface="맑은 고딕" pitchFamily="34" charset="-122"/>
                           <a:cs typeface="맑은 고딕" pitchFamily="34" charset="-120"/>
                         </a:rPr>
-                        <a:t>1 개</a:t>
+                        <a:t>4 개</a:t>
                       </a:r>
                       <a:endParaRPr lang="en-US" sz="1100" dirty="0">
                         <a:latin typeface="맑은 고딕" charset="0"/>
@@ -15483,7 +15483,7 @@
                           <a:ea typeface="맑은 고딕" pitchFamily="34" charset="-122"/>
                           <a:cs typeface="맑은 고딕" pitchFamily="34" charset="-120"/>
                         </a:rPr>
-                        <a:t>"Ribbonwist" 925 Open Ring</a:t>
+                        <a:t>"Giethoorn" 925 Open Ring</a:t>
                       </a:r>
                       <a:endParaRPr lang="en-US" sz="1100" dirty="0">
                         <a:latin typeface="맑은 고딕" charset="0"/>
@@ -15551,7 +15551,7 @@
                           <a:ea typeface="맑은 고딕" pitchFamily="34" charset="-122"/>
                           <a:cs typeface="맑은 고딕" pitchFamily="34" charset="-120"/>
                         </a:rPr>
-                        <a:t>5</a:t>
+                        <a:t>1</a:t>
                       </a:r>
                       <a:endParaRPr lang="en-US" sz="1100" dirty="0">
                         <a:latin typeface="맑은 고딕" charset="0"/>
@@ -15619,7 +15619,7 @@
                           <a:ea typeface="맑은 고딕" pitchFamily="34" charset="-122"/>
                           <a:cs typeface="맑은 고딕" pitchFamily="34" charset="-120"/>
                         </a:rPr>
-                        <a:t>1 개</a:t>
+                        <a:t>2 개</a:t>
                       </a:r>
                       <a:endParaRPr lang="en-US" sz="1100" dirty="0">
                         <a:latin typeface="맑은 고딕" charset="0"/>
@@ -15757,7 +15757,7 @@
                           <a:ea typeface="맑은 고딕" pitchFamily="34" charset="-122"/>
                           <a:cs typeface="맑은 고딕" pitchFamily="34" charset="-120"/>
                         </a:rPr>
-                        <a:t>CT</a:t>
+                        <a:t>PR</a:t>
                       </a:r>
                       <a:endParaRPr lang="en-US" sz="1100" dirty="0">
                         <a:latin typeface="맑은 고딕" charset="0"/>
@@ -15825,7 +15825,7 @@
                           <a:ea typeface="맑은 고딕" pitchFamily="34" charset="-122"/>
                           <a:cs typeface="맑은 고딕" pitchFamily="34" charset="-120"/>
                         </a:rPr>
-                        <a:t>Ring</a:t>
+                        <a:t>ELECTRONIC</a:t>
                       </a:r>
                       <a:endParaRPr lang="en-US" sz="1000" dirty="0">
                         <a:latin typeface="맑은 고딕" charset="0"/>
@@ -15893,7 +15893,7 @@
                           <a:ea typeface="맑은 고딕" pitchFamily="34" charset="-122"/>
                           <a:cs typeface="맑은 고딕" pitchFamily="34" charset="-120"/>
                         </a:rPr>
-                        <a:t>"Mlayer" 925 Open Ring</a:t>
+                        <a:t>Jacquard Fast Charging Cable (7color) (컬러: 그레이 / 기종옵션: C-Apple 8pin / 길이: 1m)</a:t>
                       </a:r>
                       <a:endParaRPr lang="en-US" sz="1100" dirty="0">
                         <a:latin typeface="맑은 고딕" charset="0"/>
@@ -15961,7 +15961,7 @@
                           <a:ea typeface="맑은 고딕" pitchFamily="34" charset="-122"/>
                           <a:cs typeface="맑은 고딕" pitchFamily="34" charset="-120"/>
                         </a:rPr>
-                        <a:t>2</a:t>
+                        <a:t>19</a:t>
                       </a:r>
                       <a:endParaRPr lang="en-US" sz="1100" dirty="0">
                         <a:latin typeface="맑은 고딕" charset="0"/>
@@ -16029,7 +16029,7 @@
                           <a:ea typeface="맑은 고딕" pitchFamily="34" charset="-122"/>
                           <a:cs typeface="맑은 고딕" pitchFamily="34" charset="-120"/>
                         </a:rPr>
-                        <a:t>1 개</a:t>
+                        <a:t>2 개</a:t>
                       </a:r>
                       <a:endParaRPr lang="en-US" sz="1100" dirty="0">
                         <a:latin typeface="맑은 고딕" charset="0"/>
@@ -16167,7 +16167,7 @@
                           <a:ea typeface="맑은 고딕" pitchFamily="34" charset="-122"/>
                           <a:cs typeface="맑은 고딕" pitchFamily="34" charset="-120"/>
                         </a:rPr>
-                        <a:t>CT</a:t>
+                        <a:t>PR</a:t>
                       </a:r>
                       <a:endParaRPr lang="en-US" sz="1100" dirty="0">
                         <a:latin typeface="맑은 고딕" charset="0"/>
@@ -16235,7 +16235,7 @@
                           <a:ea typeface="맑은 고딕" pitchFamily="34" charset="-122"/>
                           <a:cs typeface="맑은 고딕" pitchFamily="34" charset="-120"/>
                         </a:rPr>
-                        <a:t>Ring</a:t>
+                        <a:t>ETC</a:t>
                       </a:r>
                       <a:endParaRPr lang="en-US" sz="1000" dirty="0">
                         <a:latin typeface="맑은 고딕" charset="0"/>
@@ -16303,7 +16303,7 @@
                           <a:ea typeface="맑은 고딕" pitchFamily="34" charset="-122"/>
                           <a:cs typeface="맑은 고딕" pitchFamily="34" charset="-120"/>
                         </a:rPr>
-                        <a:t>"Crackave" 925 Open Ring</a:t>
+                        <a:t>360° Rotating Phone Holder (컬러: 블랙)</a:t>
                       </a:r>
                       <a:endParaRPr lang="en-US" sz="1100" dirty="0">
                         <a:latin typeface="맑은 고딕" charset="0"/>
@@ -16371,7 +16371,7 @@
                           <a:ea typeface="맑은 고딕" pitchFamily="34" charset="-122"/>
                           <a:cs typeface="맑은 고딕" pitchFamily="34" charset="-120"/>
                         </a:rPr>
-                        <a:t>2</a:t>
+                        <a:t>12</a:t>
                       </a:r>
                       <a:endParaRPr lang="en-US" sz="1100" dirty="0">
                         <a:latin typeface="맑은 고딕" charset="0"/>
@@ -16439,7 +16439,7 @@
                           <a:ea typeface="맑은 고딕" pitchFamily="34" charset="-122"/>
                           <a:cs typeface="맑은 고딕" pitchFamily="34" charset="-120"/>
                         </a:rPr>
-                        <a:t>1 개</a:t>
+                        <a:t>2 개</a:t>
                       </a:r>
                       <a:endParaRPr lang="en-US" sz="1100" dirty="0">
                         <a:latin typeface="맑은 고딕" charset="0"/>
@@ -16577,7 +16577,7 @@
                           <a:ea typeface="맑은 고딕" pitchFamily="34" charset="-122"/>
                           <a:cs typeface="맑은 고딕" pitchFamily="34" charset="-120"/>
                         </a:rPr>
-                        <a:t>CT</a:t>
+                        <a:t>PR</a:t>
                       </a:r>
                       <a:endParaRPr lang="en-US" sz="1100" dirty="0">
                         <a:latin typeface="맑은 고딕" charset="0"/>
@@ -16645,7 +16645,7 @@
                           <a:ea typeface="맑은 고딕" pitchFamily="34" charset="-122"/>
                           <a:cs typeface="맑은 고딕" pitchFamily="34" charset="-120"/>
                         </a:rPr>
-                        <a:t>Ring</a:t>
+                        <a:t>ELECTRONIC</a:t>
                       </a:r>
                       <a:endParaRPr lang="en-US" sz="1000" dirty="0">
                         <a:latin typeface="맑은 고딕" charset="0"/>
@@ -16713,7 +16713,7 @@
                           <a:ea typeface="맑은 고딕" pitchFamily="34" charset="-122"/>
                           <a:cs typeface="맑은 고딕" pitchFamily="34" charset="-120"/>
                         </a:rPr>
-                        <a:t>"Bloometal" 925 Open Ring</a:t>
+                        <a:t>Jacquard Fast Charging Cable (7color) (컬러: 블루 / 기종옵션: C-Apple 8pin / 길이: 2m)</a:t>
                       </a:r>
                       <a:endParaRPr lang="en-US" sz="1100" dirty="0">
                         <a:latin typeface="맑은 고딕" charset="0"/>
@@ -16781,7 +16781,7 @@
                           <a:ea typeface="맑은 고딕" pitchFamily="34" charset="-122"/>
                           <a:cs typeface="맑은 고딕" pitchFamily="34" charset="-120"/>
                         </a:rPr>
-                        <a:t>0</a:t>
+                        <a:t>9</a:t>
                       </a:r>
                       <a:endParaRPr lang="en-US" sz="1100" dirty="0">
                         <a:latin typeface="맑은 고딕" charset="0"/>
@@ -16849,7 +16849,7 @@
                           <a:ea typeface="맑은 고딕" pitchFamily="34" charset="-122"/>
                           <a:cs typeface="맑은 고딕" pitchFamily="34" charset="-120"/>
                         </a:rPr>
-                        <a:t>1 개</a:t>
+                        <a:t>2 개</a:t>
                       </a:r>
                       <a:endParaRPr lang="en-US" sz="1100" dirty="0">
                         <a:latin typeface="맑은 고딕" charset="0"/>
@@ -16987,7 +16987,7 @@
                           <a:ea typeface="맑은 고딕" pitchFamily="34" charset="-122"/>
                           <a:cs typeface="맑은 고딕" pitchFamily="34" charset="-120"/>
                         </a:rPr>
-                        <a:t>PR</a:t>
+                        <a:t>CT</a:t>
                       </a:r>
                       <a:endParaRPr lang="en-US" sz="1100" dirty="0">
                         <a:latin typeface="맑은 고딕" charset="0"/>
@@ -17055,7 +17055,7 @@
                           <a:ea typeface="맑은 고딕" pitchFamily="34" charset="-122"/>
                           <a:cs typeface="맑은 고딕" pitchFamily="34" charset="-120"/>
                         </a:rPr>
-                        <a:t>ELECTRONIC</a:t>
+                        <a:t>Ring</a:t>
                       </a:r>
                       <a:endParaRPr lang="en-US" sz="1000" dirty="0">
                         <a:latin typeface="맑은 고딕" charset="0"/>
@@ -17123,7 +17123,7 @@
                           <a:ea typeface="맑은 고딕" pitchFamily="34" charset="-122"/>
                           <a:cs typeface="맑은 고딕" pitchFamily="34" charset="-120"/>
                         </a:rPr>
-                        <a:t>Jacquard Fast Charging Cable (7color) (컬러: 블루 / 기종옵션: C-Apple 8pin / 길이: 2m)</a:t>
+                        <a:t>"ATOR" 925 Open Ring</a:t>
                       </a:r>
                       <a:endParaRPr lang="en-US" sz="1100" dirty="0">
                         <a:latin typeface="맑은 고딕" charset="0"/>
@@ -17191,7 +17191,7 @@
                           <a:ea typeface="맑은 고딕" pitchFamily="34" charset="-122"/>
                           <a:cs typeface="맑은 고딕" pitchFamily="34" charset="-120"/>
                         </a:rPr>
-                        <a:t>11</a:t>
+                        <a:t>4</a:t>
                       </a:r>
                       <a:endParaRPr lang="en-US" sz="1100" dirty="0">
                         <a:latin typeface="맑은 고딕" charset="0"/>
@@ -17397,7 +17397,7 @@
                           <a:ea typeface="맑은 고딕" pitchFamily="34" charset="-122"/>
                           <a:cs typeface="맑은 고딕" pitchFamily="34" charset="-120"/>
                         </a:rPr>
-                        <a:t>PR</a:t>
+                        <a:t>CT</a:t>
                       </a:r>
                       <a:endParaRPr lang="en-US" sz="1100" dirty="0">
                         <a:latin typeface="맑은 고딕" charset="0"/>
@@ -17465,7 +17465,7 @@
                           <a:ea typeface="맑은 고딕" pitchFamily="34" charset="-122"/>
                           <a:cs typeface="맑은 고딕" pitchFamily="34" charset="-120"/>
                         </a:rPr>
-                        <a:t>ELECTRONIC</a:t>
+                        <a:t>Ring</a:t>
                       </a:r>
                       <a:endParaRPr lang="en-US" sz="1000" dirty="0">
                         <a:latin typeface="맑은 고딕" charset="0"/>
@@ -17533,7 +17533,7 @@
                           <a:ea typeface="맑은 고딕" pitchFamily="34" charset="-122"/>
                           <a:cs typeface="맑은 고딕" pitchFamily="34" charset="-120"/>
                         </a:rPr>
-                        <a:t>Jacquard Fast Charging Cable (7color) (컬러: 퍼플 / 기종옵션: C-Apple 8pin / 길이: 2m)</a:t>
+                        <a:t>"Crackave" 925 Open Ring</a:t>
                       </a:r>
                       <a:endParaRPr lang="en-US" sz="1100" dirty="0">
                         <a:latin typeface="맑은 고딕" charset="0"/>
@@ -17601,7 +17601,7 @@
                           <a:ea typeface="맑은 고딕" pitchFamily="34" charset="-122"/>
                           <a:cs typeface="맑은 고딕" pitchFamily="34" charset="-120"/>
                         </a:rPr>
-                        <a:t>4</a:t>
+                        <a:t>1</a:t>
                       </a:r>
                       <a:endParaRPr lang="en-US" sz="1100" dirty="0">
                         <a:latin typeface="맑은 고딕" charset="0"/>
@@ -17807,7 +17807,7 @@
                           <a:ea typeface="맑은 고딕" pitchFamily="34" charset="-122"/>
                           <a:cs typeface="맑은 고딕" pitchFamily="34" charset="-120"/>
                         </a:rPr>
-                        <a:t>6A</a:t>
+                        <a:t>PR</a:t>
                       </a:r>
                       <a:endParaRPr lang="en-US" sz="1100" dirty="0">
                         <a:latin typeface="맑은 고딕" charset="0"/>
@@ -17875,7 +17875,7 @@
                           <a:ea typeface="맑은 고딕" pitchFamily="34" charset="-122"/>
                           <a:cs typeface="맑은 고딕" pitchFamily="34" charset="-120"/>
                         </a:rPr>
-                        <a:t>★Season off★</a:t>
+                        <a:t>ELECTRONIC</a:t>
                       </a:r>
                       <a:endParaRPr lang="en-US" sz="1000" dirty="0">
                         <a:latin typeface="맑은 고딕" charset="0"/>
@@ -17943,7 +17943,7 @@
                           <a:ea typeface="맑은 고딕" pitchFamily="34" charset="-122"/>
                           <a:cs typeface="맑은 고딕" pitchFamily="34" charset="-120"/>
                         </a:rPr>
-                        <a:t>8-Ball Smart Tok</a:t>
+                        <a:t>Jacquard Fast Charging Cable (7color) (컬러: 퍼플 / 기종옵션: C-Apple 8pin / 길이: 2m)</a:t>
                       </a:r>
                       <a:endParaRPr lang="en-US" sz="1100" dirty="0">
                         <a:latin typeface="맑은 고딕" charset="0"/>
@@ -18011,7 +18011,7 @@
                           <a:ea typeface="맑은 고딕" pitchFamily="34" charset="-122"/>
                           <a:cs typeface="맑은 고딕" pitchFamily="34" charset="-120"/>
                         </a:rPr>
-                        <a:t>4</a:t>
+                        <a:t>3</a:t>
                       </a:r>
                       <a:endParaRPr lang="en-US" sz="1100" dirty="0">
                         <a:latin typeface="맑은 고딕" charset="0"/>
@@ -18079,7 +18079,7 @@
                           <a:ea typeface="맑은 고딕" pitchFamily="34" charset="-122"/>
                           <a:cs typeface="맑은 고딕" pitchFamily="34" charset="-120"/>
                         </a:rPr>
-                        <a:t>0 개</a:t>
+                        <a:t>1 개</a:t>
                       </a:r>
                       <a:endParaRPr lang="en-US" sz="1100" dirty="0">
                         <a:latin typeface="맑은 고딕" charset="0"/>
@@ -18168,7 +18168,7 @@
                 <a:ea typeface="맑은 고딕" pitchFamily="34" charset="-122"/>
                 <a:cs typeface="맑은 고딕" pitchFamily="34" charset="-120"/>
               </a:rPr>
-              <a:t>외 57건 더 있음 — 상세는 시트에서 확인</a:t>
+              <a:t>외 59건 더 있음 — 상세는 시트에서 확인</a:t>
             </a:r>
             <a:endParaRPr lang="en-US" sz="1000" dirty="0"/>
           </a:p>
@@ -18207,7 +18207,7 @@
                 <a:ea typeface="맑은 고딕" pitchFamily="34" charset="-122"/>
                 <a:cs typeface="맑은 고딕" pitchFamily="34" charset="-120"/>
               </a:rPr>
-              <a:t>베스트 상품 리포트  ·  생성 2026-05-30 08:00</a:t>
+              <a:t>베스트 상품 리포트  ·  생성 2026-05-31 08:00</a:t>
             </a:r>
             <a:endParaRPr lang="en-US" sz="900" dirty="0"/>
           </a:p>
@@ -18420,7 +18420,7 @@
                 <a:ea typeface="맑은 고딕" pitchFamily="34" charset="-122"/>
                 <a:cs typeface="맑은 고딕" pitchFamily="34" charset="-120"/>
               </a:rPr>
-              <a:t>2026년 05월 30일 (토)</a:t>
+              <a:t>2026년 05월 31일 (일)</a:t>
             </a:r>
             <a:endParaRPr lang="en-US" sz="1200" dirty="0"/>
           </a:p>
@@ -18587,7 +18587,7 @@
                 <a:ea typeface="맑은 고딕" pitchFamily="34" charset="-122"/>
                 <a:cs typeface="맑은 고딕" pitchFamily="34" charset="-120"/>
               </a:rPr>
-              <a:t>Google Sheet '브랜드 재고현황'  ·  최신화 2026-05-30 08:00</a:t>
+              <a:t>Google Sheet '브랜드 재고현황'  ·  최신화 2026-05-31 08:00</a:t>
             </a:r>
             <a:endParaRPr lang="en-US" sz="1100" dirty="0"/>
           </a:p>
@@ -19230,7 +19230,7 @@
                 <a:ea typeface="맑은 고딕" pitchFamily="34" charset="-122"/>
                 <a:cs typeface="맑은 고딕" pitchFamily="34" charset="-120"/>
               </a:rPr>
-              <a:t>✅ 3개 브랜드 모두 정상 추출  ·  24h 출고 기준 (2026-05-29 08:00 → 2026-05-30 08:00) · 신규 SKU 27건은 결제완료 기준</a:t>
+              <a:t>✅ 3개 브랜드 모두 정상 추출  ·  24h 출고 기준 (2026-05-30 08:00 → 2026-05-31 08:00) · 신규 SKU 14건은 결제완료 기준</a:t>
             </a:r>
             <a:endParaRPr lang="en-US" sz="1000" dirty="0"/>
           </a:p>
@@ -19269,7 +19269,7 @@
                 <a:ea typeface="맑은 고딕" pitchFamily="34" charset="-122"/>
                 <a:cs typeface="맑은 고딕" pitchFamily="34" charset="-120"/>
               </a:rPr>
-              <a:t>베스트 상품 리포트  ·  생성 2026-05-30 08:00</a:t>
+              <a:t>베스트 상품 리포트  ·  생성 2026-05-31 08:00</a:t>
             </a:r>
             <a:endParaRPr lang="en-US" sz="900" dirty="0"/>
           </a:p>

</xml_diff>

<commit_message>
chore: 매출 PPT 업로드 (best-sellers-2026-06-01.pptx) [auto]
</commit_message>
<xml_diff>
--- a/data/sales-report.pptx
+++ b/data/sales-report.pptx
@@ -1648,7 +1648,7 @@
                 <a:ea typeface="맑은 고딕" pitchFamily="34" charset="-122"/>
                 <a:cs typeface="맑은 고딕" pitchFamily="34" charset="-120"/>
               </a:rPr>
-              <a:t>2026년 05월 31일 (일)  ·  24h 출고 기준</a:t>
+              <a:t>2026년 06월 01일 (월)  ·  24h 출고 기준</a:t>
             </a:r>
             <a:endParaRPr lang="en-US" sz="2200" dirty="0"/>
           </a:p>
@@ -1726,7 +1726,7 @@
                 <a:ea typeface="맑은 고딕" pitchFamily="34" charset="-122"/>
                 <a:cs typeface="맑은 고딕" pitchFamily="34" charset="-120"/>
               </a:rPr>
-              <a:t>05.31</a:t>
+              <a:t>06.01</a:t>
             </a:r>
             <a:endParaRPr lang="en-US" sz="7200" dirty="0"/>
           </a:p>
@@ -1765,7 +1765,7 @@
                 <a:ea typeface="맑은 고딕" pitchFamily="34" charset="-122"/>
                 <a:cs typeface="맑은 고딕" pitchFamily="34" charset="-120"/>
               </a:rPr>
-              <a:t>일요일</a:t>
+              <a:t>월요일</a:t>
             </a:r>
             <a:endParaRPr lang="en-US" sz="1400" dirty="0"/>
           </a:p>
@@ -1804,7 +1804,7 @@
                 <a:ea typeface="맑은 고딕" pitchFamily="34" charset="-122"/>
                 <a:cs typeface="맑은 고딕" pitchFamily="34" charset="-120"/>
               </a:rPr>
-              <a:t>생성 2026-05-31 08:00  ·  Google Sheet 자동 동기</a:t>
+              <a:t>생성 2026-06-01 08:00  ·  Google Sheet 자동 동기</a:t>
             </a:r>
             <a:endParaRPr lang="en-US" sz="1000" dirty="0"/>
           </a:p>
@@ -1978,7 +1978,7 @@
                 <a:ea typeface="맑은 고딕" pitchFamily="34" charset="-122"/>
                 <a:cs typeface="맑은 고딕" pitchFamily="34" charset="-120"/>
               </a:rPr>
-              <a:t>2026년 05월 31일 (일)</a:t>
+              <a:t>2026년 06월 01일 (월)</a:t>
             </a:r>
             <a:endParaRPr lang="en-US" sz="1200" dirty="0"/>
           </a:p>
@@ -2145,7 +2145,7 @@
                 <a:ea typeface="맑은 고딕" pitchFamily="34" charset="-122"/>
                 <a:cs typeface="맑은 고딕" pitchFamily="34" charset="-120"/>
               </a:rPr>
-              <a:t>636 개</a:t>
+              <a:t>839 개</a:t>
             </a:r>
             <a:endParaRPr lang="en-US" sz="3600" dirty="0"/>
           </a:p>
@@ -2479,7 +2479,7 @@
                 <a:ea typeface="맑은 고딕" pitchFamily="34" charset="-122"/>
                 <a:cs typeface="맑은 고딕" pitchFamily="34" charset="-120"/>
               </a:rPr>
-              <a:t>10 건</a:t>
+              <a:t>9 건</a:t>
             </a:r>
             <a:endParaRPr lang="en-US" sz="3200" dirty="0"/>
           </a:p>
@@ -3677,7 +3677,7 @@
                           <a:ea typeface="맑은 고딕" pitchFamily="34" charset="-122"/>
                           <a:cs typeface="맑은 고딕" pitchFamily="34" charset="-120"/>
                         </a:rPr>
-                        <a:t>86 개</a:t>
+                        <a:t>136 개</a:t>
                       </a:r>
                       <a:endParaRPr lang="en-US" sz="1400" dirty="0">
                         <a:latin typeface="맑은 고딕" charset="0"/>
@@ -3874,7 +3874,7 @@
                           <a:ea typeface="맑은 고딕" pitchFamily="34" charset="-122"/>
                           <a:cs typeface="맑은 고딕" pitchFamily="34" charset="-120"/>
                         </a:rPr>
-                        <a:t>Necklace</a:t>
+                        <a:t>Ring</a:t>
                       </a:r>
                       <a:endParaRPr lang="en-US" sz="1000" dirty="0">
                         <a:latin typeface="맑은 고딕" charset="0"/>
@@ -3939,7 +3939,7 @@
                           <a:ea typeface="맑은 고딕" pitchFamily="34" charset="-122"/>
                           <a:cs typeface="맑은 고딕" pitchFamily="34" charset="-120"/>
                         </a:rPr>
-                        <a:t>Marquise Necklace</a:t>
+                        <a:t>[SILVER925] Eramam Open Ring</a:t>
                       </a:r>
                       <a:endParaRPr lang="en-US" sz="1100" dirty="0">
                         <a:latin typeface="맑은 고딕" charset="0"/>
@@ -4004,7 +4004,7 @@
                           <a:ea typeface="맑은 고딕" pitchFamily="34" charset="-122"/>
                           <a:cs typeface="맑은 고딕" pitchFamily="34" charset="-120"/>
                         </a:rPr>
-                        <a:t>53 개</a:t>
+                        <a:t>68 개</a:t>
                       </a:r>
                       <a:endParaRPr lang="en-US" sz="1400" dirty="0">
                         <a:latin typeface="맑은 고딕" charset="0"/>
@@ -4201,7 +4201,7 @@
                           <a:ea typeface="맑은 고딕" pitchFamily="34" charset="-122"/>
                           <a:cs typeface="맑은 고딕" pitchFamily="34" charset="-120"/>
                         </a:rPr>
-                        <a:t>Ring</a:t>
+                        <a:t>Necklace</a:t>
                       </a:r>
                       <a:endParaRPr lang="en-US" sz="1000" dirty="0">
                         <a:latin typeface="맑은 고딕" charset="0"/>
@@ -4266,7 +4266,7 @@
                           <a:ea typeface="맑은 고딕" pitchFamily="34" charset="-122"/>
                           <a:cs typeface="맑은 고딕" pitchFamily="34" charset="-120"/>
                         </a:rPr>
-                        <a:t>[SILVER925] Eramam Open Ring</a:t>
+                        <a:t>Marquise Necklace</a:t>
                       </a:r>
                       <a:endParaRPr lang="en-US" sz="1100" dirty="0">
                         <a:latin typeface="맑은 고딕" charset="0"/>
@@ -4331,7 +4331,7 @@
                           <a:ea typeface="맑은 고딕" pitchFamily="34" charset="-122"/>
                           <a:cs typeface="맑은 고딕" pitchFamily="34" charset="-120"/>
                         </a:rPr>
-                        <a:t>46 개</a:t>
+                        <a:t>64 개</a:t>
                       </a:r>
                       <a:endParaRPr lang="en-US" sz="1400" dirty="0">
                         <a:latin typeface="맑은 고딕" charset="0"/>
@@ -4658,7 +4658,7 @@
                           <a:ea typeface="맑은 고딕" pitchFamily="34" charset="-122"/>
                           <a:cs typeface="맑은 고딕" pitchFamily="34" charset="-120"/>
                         </a:rPr>
-                        <a:t>46 개</a:t>
+                        <a:t>52 개</a:t>
                       </a:r>
                       <a:endParaRPr lang="en-US" sz="1200" dirty="0">
                         <a:latin typeface="맑은 고딕" charset="0"/>
@@ -4790,7 +4790,7 @@
                           <a:ea typeface="맑은 고딕" pitchFamily="34" charset="-122"/>
                           <a:cs typeface="맑은 고딕" pitchFamily="34" charset="-120"/>
                         </a:rPr>
-                        <a:t>CT</a:t>
+                        <a:t>6A</a:t>
                       </a:r>
                       <a:endParaRPr lang="en-US" sz="1100" dirty="0">
                         <a:latin typeface="맑은 고딕" charset="0"/>
@@ -4855,7 +4855,7 @@
                           <a:ea typeface="맑은 고딕" pitchFamily="34" charset="-122"/>
                           <a:cs typeface="맑은 고딕" pitchFamily="34" charset="-120"/>
                         </a:rPr>
-                        <a:t>Necklace</a:t>
+                        <a:t>Ring</a:t>
                       </a:r>
                       <a:endParaRPr lang="en-US" sz="1000" dirty="0">
                         <a:latin typeface="맑은 고딕" charset="0"/>
@@ -4920,7 +4920,7 @@
                           <a:ea typeface="맑은 고딕" pitchFamily="34" charset="-122"/>
                           <a:cs typeface="맑은 고딕" pitchFamily="34" charset="-120"/>
                         </a:rPr>
-                        <a:t>CandyPOP Necklace (사이즈: 1size (37~43cm))</a:t>
+                        <a:t>[SILVER925] Starly Open Ring</a:t>
                       </a:r>
                       <a:endParaRPr lang="en-US" sz="1100" dirty="0">
                         <a:latin typeface="맑은 고딕" charset="0"/>
@@ -4985,7 +4985,7 @@
                           <a:ea typeface="맑은 고딕" pitchFamily="34" charset="-122"/>
                           <a:cs typeface="맑은 고딕" pitchFamily="34" charset="-120"/>
                         </a:rPr>
-                        <a:t>41 개</a:t>
+                        <a:t>42 개</a:t>
                       </a:r>
                       <a:endParaRPr lang="en-US" sz="1200" dirty="0">
                         <a:latin typeface="맑은 고딕" charset="0"/>
@@ -5071,7 +5071,7 @@
                 <a:ea typeface="맑은 고딕" pitchFamily="34" charset="-122"/>
                 <a:cs typeface="맑은 고딕" pitchFamily="34" charset="-120"/>
               </a:rPr>
-              <a:t>베스트 상품 리포트  ·  생성 2026-05-31 08:00</a:t>
+              <a:t>베스트 상품 리포트  ·  생성 2026-06-01 08:00</a:t>
             </a:r>
             <a:endParaRPr lang="en-US" sz="900" dirty="0"/>
           </a:p>
@@ -5284,7 +5284,7 @@
                 <a:ea typeface="맑은 고딕" pitchFamily="34" charset="-122"/>
                 <a:cs typeface="맑은 고딕" pitchFamily="34" charset="-120"/>
               </a:rPr>
-              <a:t>2026년 05월 31일 (일)</a:t>
+              <a:t>2026년 06월 01일 (월)</a:t>
             </a:r>
             <a:endParaRPr lang="en-US" sz="1200" dirty="0"/>
           </a:p>
@@ -5451,7 +5451,7 @@
                 <a:ea typeface="맑은 고딕" pitchFamily="34" charset="-122"/>
                 <a:cs typeface="맑은 고딕" pitchFamily="34" charset="-120"/>
               </a:rPr>
-              <a:t>487 개</a:t>
+              <a:t>722 개</a:t>
             </a:r>
             <a:endParaRPr lang="en-US" sz="3600" dirty="0"/>
           </a:p>
@@ -5657,7 +5657,7 @@
                 <a:ea typeface="맑은 고딕" pitchFamily="34" charset="-122"/>
                 <a:cs typeface="맑은 고딕" pitchFamily="34" charset="-120"/>
               </a:rPr>
-              <a:t>86</a:t>
+              <a:t>136</a:t>
             </a:r>
             <a:endParaRPr lang="en-US" sz="4400" dirty="0"/>
           </a:p>
@@ -6256,7 +6256,7 @@
                           <a:ea typeface="맑은 고딕" pitchFamily="34" charset="-122"/>
                           <a:cs typeface="맑은 고딕" pitchFamily="34" charset="-120"/>
                         </a:rPr>
-                        <a:t>86 개</a:t>
+                        <a:t>136 개</a:t>
                       </a:r>
                       <a:endParaRPr lang="en-US" sz="1400" dirty="0">
                         <a:latin typeface="맑은 고딕" charset="0"/>
@@ -6388,7 +6388,7 @@
                           <a:ea typeface="맑은 고딕" pitchFamily="34" charset="-122"/>
                           <a:cs typeface="맑은 고딕" pitchFamily="34" charset="-120"/>
                         </a:rPr>
-                        <a:t>Necklace</a:t>
+                        <a:t>Ring</a:t>
                       </a:r>
                       <a:endParaRPr lang="en-US" sz="1000" dirty="0">
                         <a:latin typeface="맑은 고딕" charset="0"/>
@@ -6453,7 +6453,7 @@
                           <a:ea typeface="맑은 고딕" pitchFamily="34" charset="-122"/>
                           <a:cs typeface="맑은 고딕" pitchFamily="34" charset="-120"/>
                         </a:rPr>
-                        <a:t>Marquise Necklace</a:t>
+                        <a:t>[SILVER925] Eramam Open Ring</a:t>
                       </a:r>
                       <a:endParaRPr lang="en-US" sz="1100" dirty="0">
                         <a:latin typeface="맑은 고딕" charset="0"/>
@@ -6518,7 +6518,7 @@
                           <a:ea typeface="맑은 고딕" pitchFamily="34" charset="-122"/>
                           <a:cs typeface="맑은 고딕" pitchFamily="34" charset="-120"/>
                         </a:rPr>
-                        <a:t>53 개</a:t>
+                        <a:t>68 개</a:t>
                       </a:r>
                       <a:endParaRPr lang="en-US" sz="1200" dirty="0">
                         <a:latin typeface="맑은 고딕" charset="0"/>
@@ -6650,7 +6650,7 @@
                           <a:ea typeface="맑은 고딕" pitchFamily="34" charset="-122"/>
                           <a:cs typeface="맑은 고딕" pitchFamily="34" charset="-120"/>
                         </a:rPr>
-                        <a:t>Ring</a:t>
+                        <a:t>Necklace</a:t>
                       </a:r>
                       <a:endParaRPr lang="en-US" sz="1000" dirty="0">
                         <a:latin typeface="맑은 고딕" charset="0"/>
@@ -6715,7 +6715,7 @@
                           <a:ea typeface="맑은 고딕" pitchFamily="34" charset="-122"/>
                           <a:cs typeface="맑은 고딕" pitchFamily="34" charset="-120"/>
                         </a:rPr>
-                        <a:t>[SILVER925] Eramam Open Ring</a:t>
+                        <a:t>Marquise Necklace</a:t>
                       </a:r>
                       <a:endParaRPr lang="en-US" sz="1100" dirty="0">
                         <a:latin typeface="맑은 고딕" charset="0"/>
@@ -6780,7 +6780,7 @@
                           <a:ea typeface="맑은 고딕" pitchFamily="34" charset="-122"/>
                           <a:cs typeface="맑은 고딕" pitchFamily="34" charset="-120"/>
                         </a:rPr>
-                        <a:t>46 개</a:t>
+                        <a:t>64 개</a:t>
                       </a:r>
                       <a:endParaRPr lang="en-US" sz="1200" dirty="0">
                         <a:latin typeface="맑은 고딕" charset="0"/>
@@ -7042,7 +7042,7 @@
                           <a:ea typeface="맑은 고딕" pitchFamily="34" charset="-122"/>
                           <a:cs typeface="맑은 고딕" pitchFamily="34" charset="-120"/>
                         </a:rPr>
-                        <a:t>46 개</a:t>
+                        <a:t>52 개</a:t>
                       </a:r>
                       <a:endParaRPr lang="en-US" sz="1200" dirty="0">
                         <a:latin typeface="맑은 고딕" charset="0"/>
@@ -7304,7 +7304,7 @@
                           <a:ea typeface="맑은 고딕" pitchFamily="34" charset="-122"/>
                           <a:cs typeface="맑은 고딕" pitchFamily="34" charset="-120"/>
                         </a:rPr>
-                        <a:t>28 개</a:t>
+                        <a:t>42 개</a:t>
                       </a:r>
                       <a:endParaRPr lang="en-US" sz="1200" dirty="0">
                         <a:latin typeface="맑은 고딕" charset="0"/>
@@ -8267,7 +8267,7 @@
                 <a:ea typeface="맑은 고딕" pitchFamily="34" charset="-122"/>
                 <a:cs typeface="맑은 고딕" pitchFamily="34" charset="-120"/>
               </a:rPr>
-              <a:t>베스트 상품 리포트  ·  생성 2026-05-31 08:00</a:t>
+              <a:t>베스트 상품 리포트  ·  생성 2026-06-01 08:00</a:t>
             </a:r>
             <a:endParaRPr lang="en-US" sz="900" dirty="0"/>
           </a:p>
@@ -8480,7 +8480,7 @@
                 <a:ea typeface="맑은 고딕" pitchFamily="34" charset="-122"/>
                 <a:cs typeface="맑은 고딕" pitchFamily="34" charset="-120"/>
               </a:rPr>
-              <a:t>2026년 05월 31일 (일)</a:t>
+              <a:t>2026년 06월 01일 (월)</a:t>
             </a:r>
             <a:endParaRPr lang="en-US" sz="1200" dirty="0"/>
           </a:p>
@@ -8647,7 +8647,7 @@
                 <a:ea typeface="맑은 고딕" pitchFamily="34" charset="-122"/>
                 <a:cs typeface="맑은 고딕" pitchFamily="34" charset="-120"/>
               </a:rPr>
-              <a:t>149 개</a:t>
+              <a:t>117 개</a:t>
             </a:r>
             <a:endParaRPr lang="en-US" sz="3600" dirty="0"/>
           </a:p>
@@ -8775,7 +8775,7 @@
                 <a:ea typeface="맑은 고딕" pitchFamily="34" charset="-122"/>
                 <a:cs typeface="맑은 고딕" pitchFamily="34" charset="-120"/>
               </a:rPr>
-              <a:t>CandyPOP Necklace (사이즈: 1size (37~43cm))</a:t>
+              <a:t>ThreadDuo Necklace</a:t>
             </a:r>
             <a:endParaRPr lang="en-US" sz="1800" dirty="0"/>
           </a:p>
@@ -8853,7 +8853,7 @@
                 <a:ea typeface="맑은 고딕" pitchFamily="34" charset="-122"/>
                 <a:cs typeface="맑은 고딕" pitchFamily="34" charset="-120"/>
               </a:rPr>
-              <a:t>41</a:t>
+              <a:t>27</a:t>
             </a:r>
             <a:endParaRPr lang="en-US" sz="4400" dirty="0"/>
           </a:p>
@@ -9387,7 +9387,7 @@
                           <a:ea typeface="맑은 고딕" pitchFamily="34" charset="-122"/>
                           <a:cs typeface="맑은 고딕" pitchFamily="34" charset="-120"/>
                         </a:rPr>
-                        <a:t>CandyPOP Necklace (사이즈: 1size (37~43cm))</a:t>
+                        <a:t>ThreadDuo Necklace</a:t>
                       </a:r>
                       <a:endParaRPr lang="en-US" sz="1100" dirty="0">
                         <a:latin typeface="맑은 고딕" charset="0"/>
@@ -9452,7 +9452,7 @@
                           <a:ea typeface="맑은 고딕" pitchFamily="34" charset="-122"/>
                           <a:cs typeface="맑은 고딕" pitchFamily="34" charset="-120"/>
                         </a:rPr>
-                        <a:t>41 개</a:t>
+                        <a:t>27 개</a:t>
                       </a:r>
                       <a:endParaRPr lang="en-US" sz="1400" dirty="0">
                         <a:latin typeface="맑은 고딕" charset="0"/>
@@ -9649,7 +9649,7 @@
                           <a:ea typeface="맑은 고딕" pitchFamily="34" charset="-122"/>
                           <a:cs typeface="맑은 고딕" pitchFamily="34" charset="-120"/>
                         </a:rPr>
-                        <a:t>CandyPOP Necklace (사이즈: 2size (47~52cm))</a:t>
+                        <a:t>CandyPOP Necklace (사이즈: 1size (37~43cm))</a:t>
                       </a:r>
                       <a:endParaRPr lang="en-US" sz="1100" dirty="0">
                         <a:latin typeface="맑은 고딕" charset="0"/>
@@ -9714,7 +9714,7 @@
                           <a:ea typeface="맑은 고딕" pitchFamily="34" charset="-122"/>
                           <a:cs typeface="맑은 고딕" pitchFamily="34" charset="-120"/>
                         </a:rPr>
-                        <a:t>34 개</a:t>
+                        <a:t>26 개</a:t>
                       </a:r>
                       <a:endParaRPr lang="en-US" sz="1200" dirty="0">
                         <a:latin typeface="맑은 고딕" charset="0"/>
@@ -9911,7 +9911,7 @@
                           <a:ea typeface="맑은 고딕" pitchFamily="34" charset="-122"/>
                           <a:cs typeface="맑은 고딕" pitchFamily="34" charset="-120"/>
                         </a:rPr>
-                        <a:t>ThreadDuo Necklace</a:t>
+                        <a:t>CandyPOP Necklace (사이즈: 2size (47~52cm))</a:t>
                       </a:r>
                       <a:endParaRPr lang="en-US" sz="1100" dirty="0">
                         <a:latin typeface="맑은 고딕" charset="0"/>
@@ -9976,7 +9976,7 @@
                           <a:ea typeface="맑은 고딕" pitchFamily="34" charset="-122"/>
                           <a:cs typeface="맑은 고딕" pitchFamily="34" charset="-120"/>
                         </a:rPr>
-                        <a:t>18 개</a:t>
+                        <a:t>22 개</a:t>
                       </a:r>
                       <a:endParaRPr lang="en-US" sz="1200" dirty="0">
                         <a:latin typeface="맑은 고딕" charset="0"/>
@@ -10165,7 +10165,7 @@
                 <a:ea typeface="맑은 고딕" pitchFamily="34" charset="-122"/>
                 <a:cs typeface="맑은 고딕" pitchFamily="34" charset="-120"/>
               </a:rPr>
-              <a:t>베스트 상품 리포트  ·  생성 2026-05-31 08:00</a:t>
+              <a:t>베스트 상품 리포트  ·  생성 2026-06-01 08:00</a:t>
             </a:r>
             <a:endParaRPr lang="en-US" sz="900" dirty="0"/>
           </a:p>
@@ -10378,7 +10378,7 @@
                 <a:ea typeface="맑은 고딕" pitchFamily="34" charset="-122"/>
                 <a:cs typeface="맑은 고딕" pitchFamily="34" charset="-120"/>
               </a:rPr>
-              <a:t>2026년 05월 31일 (일)</a:t>
+              <a:t>2026년 06월 01일 (월)</a:t>
             </a:r>
             <a:endParaRPr lang="en-US" sz="1200" dirty="0"/>
           </a:p>
@@ -10673,7 +10673,7 @@
                 <a:ea typeface="맑은 고딕" pitchFamily="34" charset="-122"/>
                 <a:cs typeface="맑은 고딕" pitchFamily="34" charset="-120"/>
               </a:rPr>
-              <a:t>24</a:t>
+              <a:t>26</a:t>
             </a:r>
             <a:endParaRPr lang="en-US" sz="3000" dirty="0"/>
           </a:p>
@@ -10801,7 +10801,7 @@
                 <a:ea typeface="맑은 고딕" pitchFamily="34" charset="-122"/>
                 <a:cs typeface="맑은 고딕" pitchFamily="34" charset="-120"/>
               </a:rPr>
-              <a:t>10</a:t>
+              <a:t>8</a:t>
             </a:r>
             <a:endParaRPr lang="en-US" sz="3000" dirty="0"/>
           </a:p>
@@ -10929,7 +10929,7 @@
                 <a:ea typeface="맑은 고딕" pitchFamily="34" charset="-122"/>
                 <a:cs typeface="맑은 고딕" pitchFamily="34" charset="-120"/>
               </a:rPr>
-              <a:t>30,888</a:t>
+              <a:t>30,352</a:t>
             </a:r>
             <a:endParaRPr lang="en-US" sz="3000" dirty="0"/>
           </a:p>
@@ -11489,7 +11489,7 @@
                           <a:ea typeface="맑은 고딕" pitchFamily="34" charset="-122"/>
                           <a:cs typeface="맑은 고딕" pitchFamily="34" charset="-120"/>
                         </a:rPr>
-                        <a:t>2,039</a:t>
+                        <a:t>2,028</a:t>
                       </a:r>
                       <a:endParaRPr lang="en-US" sz="1000" dirty="0">
                         <a:latin typeface="맑은 고딕" charset="0"/>
@@ -11751,7 +11751,7 @@
                           <a:ea typeface="맑은 고딕" pitchFamily="34" charset="-122"/>
                           <a:cs typeface="맑은 고딕" pitchFamily="34" charset="-120"/>
                         </a:rPr>
-                        <a:t>1,554</a:t>
+                        <a:t>1,545</a:t>
                       </a:r>
                       <a:endParaRPr lang="en-US" sz="1000" dirty="0">
                         <a:latin typeface="맑은 고딕" charset="0"/>
@@ -12013,7 +12013,7 @@
                           <a:ea typeface="맑은 고딕" pitchFamily="34" charset="-122"/>
                           <a:cs typeface="맑은 고딕" pitchFamily="34" charset="-120"/>
                         </a:rPr>
-                        <a:t>1,008</a:t>
+                        <a:t>968</a:t>
                       </a:r>
                       <a:endParaRPr lang="en-US" sz="1000" dirty="0">
                         <a:latin typeface="맑은 고딕" charset="0"/>
@@ -12275,7 +12275,7 @@
                           <a:ea typeface="맑은 고딕" pitchFamily="34" charset="-122"/>
                           <a:cs typeface="맑은 고딕" pitchFamily="34" charset="-120"/>
                         </a:rPr>
-                        <a:t>839</a:t>
+                        <a:t>830</a:t>
                       </a:r>
                       <a:endParaRPr lang="en-US" sz="1000" dirty="0">
                         <a:latin typeface="맑은 고딕" charset="0"/>
@@ -12623,7 +12623,7 @@
                 <a:ea typeface="맑은 고딕" pitchFamily="34" charset="-122"/>
                 <a:cs typeface="맑은 고딕" pitchFamily="34" charset="-120"/>
               </a:rPr>
-              <a:t>재고 점검  🔴 품절 24건</a:t>
+              <a:t>재고 점검  🔴 품절 26건</a:t>
             </a:r>
             <a:pPr indent="0" marL="0">
               <a:buNone/>
@@ -13556,7 +13556,7 @@
                 <a:ea typeface="맑은 고딕" pitchFamily="34" charset="-122"/>
                 <a:cs typeface="맑은 고딕" pitchFamily="34" charset="-120"/>
               </a:rPr>
-              <a:t>베스트 상품 리포트  ·  생성 2026-05-31 08:00</a:t>
+              <a:t>베스트 상품 리포트  ·  생성 2026-06-01 08:00</a:t>
             </a:r>
             <a:endParaRPr lang="en-US" sz="900" dirty="0"/>
           </a:p>
@@ -13769,7 +13769,7 @@
                 <a:ea typeface="맑은 고딕" pitchFamily="34" charset="-122"/>
                 <a:cs typeface="맑은 고딕" pitchFamily="34" charset="-120"/>
               </a:rPr>
-              <a:t>2026년 05월 31일 (일)</a:t>
+              <a:t>2026년 06월 01일 (월)</a:t>
             </a:r>
             <a:endParaRPr lang="en-US" sz="1200" dirty="0"/>
           </a:p>
@@ -13897,7 +13897,7 @@
                 <a:ea typeface="맑은 고딕" pitchFamily="34" charset="-122"/>
                 <a:cs typeface="맑은 고딕" pitchFamily="34" charset="-120"/>
               </a:rPr>
-              <a:t>🚨  긴급 리오더 68건    ·    주의 리오더 10건    ·    오늘 발주 검토 필수</a:t>
+              <a:t>🚨  긴급 리오더 68건    ·    주의 리오더 9건    ·    오늘 발주 검토 필수</a:t>
             </a:r>
             <a:pPr indent="0" marL="0">
               <a:buNone/>
@@ -14527,7 +14527,7 @@
                           <a:ea typeface="맑은 고딕" pitchFamily="34" charset="-122"/>
                           <a:cs typeface="맑은 고딕" pitchFamily="34" charset="-120"/>
                         </a:rPr>
-                        <a:t>CT</a:t>
+                        <a:t>PR</a:t>
                       </a:r>
                       <a:endParaRPr lang="en-US" sz="1100" dirty="0">
                         <a:latin typeface="맑은 고딕" charset="0"/>
@@ -14595,7 +14595,7 @@
                           <a:ea typeface="맑은 고딕" pitchFamily="34" charset="-122"/>
                           <a:cs typeface="맑은 고딕" pitchFamily="34" charset="-120"/>
                         </a:rPr>
-                        <a:t>Ring</a:t>
+                        <a:t>ELECTRONIC</a:t>
                       </a:r>
                       <a:endParaRPr lang="en-US" sz="1000" dirty="0">
                         <a:latin typeface="맑은 고딕" charset="0"/>
@@ -14663,7 +14663,7 @@
                           <a:ea typeface="맑은 고딕" pitchFamily="34" charset="-122"/>
                           <a:cs typeface="맑은 고딕" pitchFamily="34" charset="-120"/>
                         </a:rPr>
-                        <a:t>"Fenghuang" 925 Open Ring</a:t>
+                        <a:t>Jacquard Fast Charging Cable (7color) (컬러: 블루 / 기종옵션: C-Apple 8pin / 길이: 2m)</a:t>
                       </a:r>
                       <a:endParaRPr lang="en-US" sz="1100" dirty="0">
                         <a:latin typeface="맑은 고딕" charset="0"/>
@@ -14731,7 +14731,7 @@
                           <a:ea typeface="맑은 고딕" pitchFamily="34" charset="-122"/>
                           <a:cs typeface="맑은 고딕" pitchFamily="34" charset="-120"/>
                         </a:rPr>
-                        <a:t>0</a:t>
+                        <a:t>3</a:t>
                       </a:r>
                       <a:endParaRPr lang="en-US" sz="1100" dirty="0">
                         <a:latin typeface="맑은 고딕" charset="0"/>
@@ -14799,7 +14799,7 @@
                           <a:ea typeface="맑은 고딕" pitchFamily="34" charset="-122"/>
                           <a:cs typeface="맑은 고딕" pitchFamily="34" charset="-120"/>
                         </a:rPr>
-                        <a:t>12 개</a:t>
+                        <a:t>6 개</a:t>
                       </a:r>
                       <a:endParaRPr lang="en-US" sz="1100" dirty="0">
                         <a:latin typeface="맑은 고딕" charset="0"/>
@@ -15141,7 +15141,7 @@
                           <a:ea typeface="맑은 고딕" pitchFamily="34" charset="-122"/>
                           <a:cs typeface="맑은 고딕" pitchFamily="34" charset="-120"/>
                         </a:rPr>
-                        <a:t>3</a:t>
+                        <a:t>0</a:t>
                       </a:r>
                       <a:endParaRPr lang="en-US" sz="1100" dirty="0">
                         <a:latin typeface="맑은 고딕" charset="0"/>
@@ -15209,7 +15209,7 @@
                           <a:ea typeface="맑은 고딕" pitchFamily="34" charset="-122"/>
                           <a:cs typeface="맑은 고딕" pitchFamily="34" charset="-120"/>
                         </a:rPr>
-                        <a:t>4 개</a:t>
+                        <a:t>3 개</a:t>
                       </a:r>
                       <a:endParaRPr lang="en-US" sz="1100" dirty="0">
                         <a:latin typeface="맑은 고딕" charset="0"/>
@@ -15347,7 +15347,7 @@
                           <a:ea typeface="맑은 고딕" pitchFamily="34" charset="-122"/>
                           <a:cs typeface="맑은 고딕" pitchFamily="34" charset="-120"/>
                         </a:rPr>
-                        <a:t>CT</a:t>
+                        <a:t>PR</a:t>
                       </a:r>
                       <a:endParaRPr lang="en-US" sz="1100" dirty="0">
                         <a:latin typeface="맑은 고딕" charset="0"/>
@@ -15415,7 +15415,7 @@
                           <a:ea typeface="맑은 고딕" pitchFamily="34" charset="-122"/>
                           <a:cs typeface="맑은 고딕" pitchFamily="34" charset="-120"/>
                         </a:rPr>
-                        <a:t>Ring</a:t>
+                        <a:t>ELECTRONIC</a:t>
                       </a:r>
                       <a:endParaRPr lang="en-US" sz="1000" dirty="0">
                         <a:latin typeface="맑은 고딕" charset="0"/>
@@ -15483,7 +15483,7 @@
                           <a:ea typeface="맑은 고딕" pitchFamily="34" charset="-122"/>
                           <a:cs typeface="맑은 고딕" pitchFamily="34" charset="-120"/>
                         </a:rPr>
-                        <a:t>"Giethoorn" 925 Open Ring</a:t>
+                        <a:t>Jacquard Fast Charging Cable (7color) (컬러: 퍼플 / 기종옵션: C-Apple 8pin / 길이: 2m)</a:t>
                       </a:r>
                       <a:endParaRPr lang="en-US" sz="1100" dirty="0">
                         <a:latin typeface="맑은 고딕" charset="0"/>
@@ -15551,7 +15551,7 @@
                           <a:ea typeface="맑은 고딕" pitchFamily="34" charset="-122"/>
                           <a:cs typeface="맑은 고딕" pitchFamily="34" charset="-120"/>
                         </a:rPr>
-                        <a:t>1</a:t>
+                        <a:t>0</a:t>
                       </a:r>
                       <a:endParaRPr lang="en-US" sz="1100" dirty="0">
                         <a:latin typeface="맑은 고딕" charset="0"/>
@@ -15619,7 +15619,7 @@
                           <a:ea typeface="맑은 고딕" pitchFamily="34" charset="-122"/>
                           <a:cs typeface="맑은 고딕" pitchFamily="34" charset="-120"/>
                         </a:rPr>
-                        <a:t>2 개</a:t>
+                        <a:t>3 개</a:t>
                       </a:r>
                       <a:endParaRPr lang="en-US" sz="1100" dirty="0">
                         <a:latin typeface="맑은 고딕" charset="0"/>
@@ -15757,7 +15757,7 @@
                           <a:ea typeface="맑은 고딕" pitchFamily="34" charset="-122"/>
                           <a:cs typeface="맑은 고딕" pitchFamily="34" charset="-120"/>
                         </a:rPr>
-                        <a:t>PR</a:t>
+                        <a:t>CT</a:t>
                       </a:r>
                       <a:endParaRPr lang="en-US" sz="1100" dirty="0">
                         <a:latin typeface="맑은 고딕" charset="0"/>
@@ -15825,7 +15825,7 @@
                           <a:ea typeface="맑은 고딕" pitchFamily="34" charset="-122"/>
                           <a:cs typeface="맑은 고딕" pitchFamily="34" charset="-120"/>
                         </a:rPr>
-                        <a:t>ELECTRONIC</a:t>
+                        <a:t>Ring</a:t>
                       </a:r>
                       <a:endParaRPr lang="en-US" sz="1000" dirty="0">
                         <a:latin typeface="맑은 고딕" charset="0"/>
@@ -15893,7 +15893,7 @@
                           <a:ea typeface="맑은 고딕" pitchFamily="34" charset="-122"/>
                           <a:cs typeface="맑은 고딕" pitchFamily="34" charset="-120"/>
                         </a:rPr>
-                        <a:t>Jacquard Fast Charging Cable (7color) (컬러: 그레이 / 기종옵션: C-Apple 8pin / 길이: 1m)</a:t>
+                        <a:t>"ATOR" 925 Open Ring</a:t>
                       </a:r>
                       <a:endParaRPr lang="en-US" sz="1100" dirty="0">
                         <a:latin typeface="맑은 고딕" charset="0"/>
@@ -15961,7 +15961,7 @@
                           <a:ea typeface="맑은 고딕" pitchFamily="34" charset="-122"/>
                           <a:cs typeface="맑은 고딕" pitchFamily="34" charset="-120"/>
                         </a:rPr>
-                        <a:t>19</a:t>
+                        <a:t>3</a:t>
                       </a:r>
                       <a:endParaRPr lang="en-US" sz="1100" dirty="0">
                         <a:latin typeface="맑은 고딕" charset="0"/>
@@ -16029,7 +16029,7 @@
                           <a:ea typeface="맑은 고딕" pitchFamily="34" charset="-122"/>
                           <a:cs typeface="맑은 고딕" pitchFamily="34" charset="-120"/>
                         </a:rPr>
-                        <a:t>2 개</a:t>
+                        <a:t>1 개</a:t>
                       </a:r>
                       <a:endParaRPr lang="en-US" sz="1100" dirty="0">
                         <a:latin typeface="맑은 고딕" charset="0"/>
@@ -16167,7 +16167,7 @@
                           <a:ea typeface="맑은 고딕" pitchFamily="34" charset="-122"/>
                           <a:cs typeface="맑은 고딕" pitchFamily="34" charset="-120"/>
                         </a:rPr>
-                        <a:t>PR</a:t>
+                        <a:t>CT</a:t>
                       </a:r>
                       <a:endParaRPr lang="en-US" sz="1100" dirty="0">
                         <a:latin typeface="맑은 고딕" charset="0"/>
@@ -16235,7 +16235,7 @@
                           <a:ea typeface="맑은 고딕" pitchFamily="34" charset="-122"/>
                           <a:cs typeface="맑은 고딕" pitchFamily="34" charset="-120"/>
                         </a:rPr>
-                        <a:t>ETC</a:t>
+                        <a:t>Ring</a:t>
                       </a:r>
                       <a:endParaRPr lang="en-US" sz="1000" dirty="0">
                         <a:latin typeface="맑은 고딕" charset="0"/>
@@ -16303,7 +16303,7 @@
                           <a:ea typeface="맑은 고딕" pitchFamily="34" charset="-122"/>
                           <a:cs typeface="맑은 고딕" pitchFamily="34" charset="-120"/>
                         </a:rPr>
-                        <a:t>360° Rotating Phone Holder (컬러: 블랙)</a:t>
+                        <a:t>"Giethoorn" 925 Open Ring</a:t>
                       </a:r>
                       <a:endParaRPr lang="en-US" sz="1100" dirty="0">
                         <a:latin typeface="맑은 고딕" charset="0"/>
@@ -16371,7 +16371,7 @@
                           <a:ea typeface="맑은 고딕" pitchFamily="34" charset="-122"/>
                           <a:cs typeface="맑은 고딕" pitchFamily="34" charset="-120"/>
                         </a:rPr>
-                        <a:t>12</a:t>
+                        <a:t>0</a:t>
                       </a:r>
                       <a:endParaRPr lang="en-US" sz="1100" dirty="0">
                         <a:latin typeface="맑은 고딕" charset="0"/>
@@ -16439,7 +16439,7 @@
                           <a:ea typeface="맑은 고딕" pitchFamily="34" charset="-122"/>
                           <a:cs typeface="맑은 고딕" pitchFamily="34" charset="-120"/>
                         </a:rPr>
-                        <a:t>2 개</a:t>
+                        <a:t>1 개</a:t>
                       </a:r>
                       <a:endParaRPr lang="en-US" sz="1100" dirty="0">
                         <a:latin typeface="맑은 고딕" charset="0"/>
@@ -16645,7 +16645,7 @@
                           <a:ea typeface="맑은 고딕" pitchFamily="34" charset="-122"/>
                           <a:cs typeface="맑은 고딕" pitchFamily="34" charset="-120"/>
                         </a:rPr>
-                        <a:t>ELECTRONIC</a:t>
+                        <a:t>★ Last Sale ★</a:t>
                       </a:r>
                       <a:endParaRPr lang="en-US" sz="1000" dirty="0">
                         <a:latin typeface="맑은 고딕" charset="0"/>
@@ -16713,7 +16713,7 @@
                           <a:ea typeface="맑은 고딕" pitchFamily="34" charset="-122"/>
                           <a:cs typeface="맑은 고딕" pitchFamily="34" charset="-120"/>
                         </a:rPr>
-                        <a:t>Jacquard Fast Charging Cable (7color) (컬러: 블루 / 기종옵션: C-Apple 8pin / 길이: 2m)</a:t>
+                        <a:t>Cloud Grip Glass Mini Brush (3color) (컬러: 스카이블루)</a:t>
                       </a:r>
                       <a:endParaRPr lang="en-US" sz="1100" dirty="0">
                         <a:latin typeface="맑은 고딕" charset="0"/>
@@ -16781,7 +16781,7 @@
                           <a:ea typeface="맑은 고딕" pitchFamily="34" charset="-122"/>
                           <a:cs typeface="맑은 고딕" pitchFamily="34" charset="-120"/>
                         </a:rPr>
-                        <a:t>9</a:t>
+                        <a:t>11</a:t>
                       </a:r>
                       <a:endParaRPr lang="en-US" sz="1100" dirty="0">
                         <a:latin typeface="맑은 고딕" charset="0"/>
@@ -16849,7 +16849,7 @@
                           <a:ea typeface="맑은 고딕" pitchFamily="34" charset="-122"/>
                           <a:cs typeface="맑은 고딕" pitchFamily="34" charset="-120"/>
                         </a:rPr>
-                        <a:t>2 개</a:t>
+                        <a:t>1 개</a:t>
                       </a:r>
                       <a:endParaRPr lang="en-US" sz="1100" dirty="0">
                         <a:latin typeface="맑은 고딕" charset="0"/>
@@ -16987,7 +16987,7 @@
                           <a:ea typeface="맑은 고딕" pitchFamily="34" charset="-122"/>
                           <a:cs typeface="맑은 고딕" pitchFamily="34" charset="-120"/>
                         </a:rPr>
-                        <a:t>CT</a:t>
+                        <a:t>6A</a:t>
                       </a:r>
                       <a:endParaRPr lang="en-US" sz="1100" dirty="0">
                         <a:latin typeface="맑은 고딕" charset="0"/>
@@ -17055,7 +17055,7 @@
                           <a:ea typeface="맑은 고딕" pitchFamily="34" charset="-122"/>
                           <a:cs typeface="맑은 고딕" pitchFamily="34" charset="-120"/>
                         </a:rPr>
-                        <a:t>Ring</a:t>
+                        <a:t>★Season off★</a:t>
                       </a:r>
                       <a:endParaRPr lang="en-US" sz="1000" dirty="0">
                         <a:latin typeface="맑은 고딕" charset="0"/>
@@ -17123,7 +17123,7 @@
                           <a:ea typeface="맑은 고딕" pitchFamily="34" charset="-122"/>
                           <a:cs typeface="맑은 고딕" pitchFamily="34" charset="-120"/>
                         </a:rPr>
-                        <a:t>"ATOR" 925 Open Ring</a:t>
+                        <a:t>8-Ball Smart Tok</a:t>
                       </a:r>
                       <a:endParaRPr lang="en-US" sz="1100" dirty="0">
                         <a:latin typeface="맑은 고딕" charset="0"/>
@@ -17259,7 +17259,7 @@
                           <a:ea typeface="맑은 고딕" pitchFamily="34" charset="-122"/>
                           <a:cs typeface="맑은 고딕" pitchFamily="34" charset="-120"/>
                         </a:rPr>
-                        <a:t>1 개</a:t>
+                        <a:t>0 개</a:t>
                       </a:r>
                       <a:endParaRPr lang="en-US" sz="1100" dirty="0">
                         <a:latin typeface="맑은 고딕" charset="0"/>
@@ -17397,7 +17397,7 @@
                           <a:ea typeface="맑은 고딕" pitchFamily="34" charset="-122"/>
                           <a:cs typeface="맑은 고딕" pitchFamily="34" charset="-120"/>
                         </a:rPr>
-                        <a:t>CT</a:t>
+                        <a:t>6A</a:t>
                       </a:r>
                       <a:endParaRPr lang="en-US" sz="1100" dirty="0">
                         <a:latin typeface="맑은 고딕" charset="0"/>
@@ -17465,7 +17465,7 @@
                           <a:ea typeface="맑은 고딕" pitchFamily="34" charset="-122"/>
                           <a:cs typeface="맑은 고딕" pitchFamily="34" charset="-120"/>
                         </a:rPr>
-                        <a:t>Ring</a:t>
+                        <a:t>Bracelet</a:t>
                       </a:r>
                       <a:endParaRPr lang="en-US" sz="1000" dirty="0">
                         <a:latin typeface="맑은 고딕" charset="0"/>
@@ -17533,7 +17533,7 @@
                           <a:ea typeface="맑은 고딕" pitchFamily="34" charset="-122"/>
                           <a:cs typeface="맑은 고딕" pitchFamily="34" charset="-120"/>
                         </a:rPr>
-                        <a:t>"Crackave" 925 Open Ring</a:t>
+                        <a:t>Two-ball Bangle</a:t>
                       </a:r>
                       <a:endParaRPr lang="en-US" sz="1100" dirty="0">
                         <a:latin typeface="맑은 고딕" charset="0"/>
@@ -17601,7 +17601,7 @@
                           <a:ea typeface="맑은 고딕" pitchFamily="34" charset="-122"/>
                           <a:cs typeface="맑은 고딕" pitchFamily="34" charset="-120"/>
                         </a:rPr>
-                        <a:t>1</a:t>
+                        <a:t>0</a:t>
                       </a:r>
                       <a:endParaRPr lang="en-US" sz="1100" dirty="0">
                         <a:latin typeface="맑은 고딕" charset="0"/>
@@ -17669,7 +17669,7 @@
                           <a:ea typeface="맑은 고딕" pitchFamily="34" charset="-122"/>
                           <a:cs typeface="맑은 고딕" pitchFamily="34" charset="-120"/>
                         </a:rPr>
-                        <a:t>1 개</a:t>
+                        <a:t>0 개</a:t>
                       </a:r>
                       <a:endParaRPr lang="en-US" sz="1100" dirty="0">
                         <a:latin typeface="맑은 고딕" charset="0"/>
@@ -17807,7 +17807,7 @@
                           <a:ea typeface="맑은 고딕" pitchFamily="34" charset="-122"/>
                           <a:cs typeface="맑은 고딕" pitchFamily="34" charset="-120"/>
                         </a:rPr>
-                        <a:t>PR</a:t>
+                        <a:t>6A</a:t>
                       </a:r>
                       <a:endParaRPr lang="en-US" sz="1100" dirty="0">
                         <a:latin typeface="맑은 고딕" charset="0"/>
@@ -17875,7 +17875,7 @@
                           <a:ea typeface="맑은 고딕" pitchFamily="34" charset="-122"/>
                           <a:cs typeface="맑은 고딕" pitchFamily="34" charset="-120"/>
                         </a:rPr>
-                        <a:t>ELECTRONIC</a:t>
+                        <a:t>Ring</a:t>
                       </a:r>
                       <a:endParaRPr lang="en-US" sz="1000" dirty="0">
                         <a:latin typeface="맑은 고딕" charset="0"/>
@@ -17943,7 +17943,7 @@
                           <a:ea typeface="맑은 고딕" pitchFamily="34" charset="-122"/>
                           <a:cs typeface="맑은 고딕" pitchFamily="34" charset="-120"/>
                         </a:rPr>
-                        <a:t>Jacquard Fast Charging Cable (7color) (컬러: 퍼플 / 기종옵션: C-Apple 8pin / 길이: 2m)</a:t>
+                        <a:t>[SILVER925] Crimson Open Ring</a:t>
                       </a:r>
                       <a:endParaRPr lang="en-US" sz="1100" dirty="0">
                         <a:latin typeface="맑은 고딕" charset="0"/>
@@ -18011,7 +18011,7 @@
                           <a:ea typeface="맑은 고딕" pitchFamily="34" charset="-122"/>
                           <a:cs typeface="맑은 고딕" pitchFamily="34" charset="-120"/>
                         </a:rPr>
-                        <a:t>3</a:t>
+                        <a:t>0</a:t>
                       </a:r>
                       <a:endParaRPr lang="en-US" sz="1100" dirty="0">
                         <a:latin typeface="맑은 고딕" charset="0"/>
@@ -18079,7 +18079,7 @@
                           <a:ea typeface="맑은 고딕" pitchFamily="34" charset="-122"/>
                           <a:cs typeface="맑은 고딕" pitchFamily="34" charset="-120"/>
                         </a:rPr>
-                        <a:t>1 개</a:t>
+                        <a:t>0 개</a:t>
                       </a:r>
                       <a:endParaRPr lang="en-US" sz="1100" dirty="0">
                         <a:latin typeface="맑은 고딕" charset="0"/>
@@ -18207,7 +18207,7 @@
                 <a:ea typeface="맑은 고딕" pitchFamily="34" charset="-122"/>
                 <a:cs typeface="맑은 고딕" pitchFamily="34" charset="-120"/>
               </a:rPr>
-              <a:t>베스트 상품 리포트  ·  생성 2026-05-31 08:00</a:t>
+              <a:t>베스트 상품 리포트  ·  생성 2026-06-01 08:00</a:t>
             </a:r>
             <a:endParaRPr lang="en-US" sz="900" dirty="0"/>
           </a:p>
@@ -18420,7 +18420,7 @@
                 <a:ea typeface="맑은 고딕" pitchFamily="34" charset="-122"/>
                 <a:cs typeface="맑은 고딕" pitchFamily="34" charset="-120"/>
               </a:rPr>
-              <a:t>2026년 05월 31일 (일)</a:t>
+              <a:t>2026년 06월 01일 (월)</a:t>
             </a:r>
             <a:endParaRPr lang="en-US" sz="1200" dirty="0"/>
           </a:p>
@@ -18587,7 +18587,7 @@
                 <a:ea typeface="맑은 고딕" pitchFamily="34" charset="-122"/>
                 <a:cs typeface="맑은 고딕" pitchFamily="34" charset="-120"/>
               </a:rPr>
-              <a:t>Google Sheet '브랜드 재고현황'  ·  최신화 2026-05-31 08:00</a:t>
+              <a:t>Google Sheet '브랜드 재고현황'  ·  최신화 2026-06-01 08:00</a:t>
             </a:r>
             <a:endParaRPr lang="en-US" sz="1100" dirty="0"/>
           </a:p>
@@ -19230,7 +19230,7 @@
                 <a:ea typeface="맑은 고딕" pitchFamily="34" charset="-122"/>
                 <a:cs typeface="맑은 고딕" pitchFamily="34" charset="-120"/>
               </a:rPr>
-              <a:t>✅ 3개 브랜드 모두 정상 추출  ·  24h 출고 기준 (2026-05-30 08:00 → 2026-05-31 08:00) · 신규 SKU 14건은 결제완료 기준</a:t>
+              <a:t>✅ 3개 브랜드 모두 정상 추출  ·  24h 출고 기준 (2026-05-31 08:00 → 2026-06-01 08:00) · 신규 SKU 14건은 결제완료 기준</a:t>
             </a:r>
             <a:endParaRPr lang="en-US" sz="1000" dirty="0"/>
           </a:p>
@@ -19269,7 +19269,7 @@
                 <a:ea typeface="맑은 고딕" pitchFamily="34" charset="-122"/>
                 <a:cs typeface="맑은 고딕" pitchFamily="34" charset="-120"/>
               </a:rPr>
-              <a:t>베스트 상품 리포트  ·  생성 2026-05-31 08:00</a:t>
+              <a:t>베스트 상품 리포트  ·  생성 2026-06-01 08:00</a:t>
             </a:r>
             <a:endParaRPr lang="en-US" sz="900" dirty="0"/>
           </a:p>

</xml_diff>

<commit_message>
chore: 매출 PPT 업로드 (best-sellers-2026-06-02.pptx) [auto]
</commit_message>
<xml_diff>
--- a/data/sales-report.pptx
+++ b/data/sales-report.pptx
@@ -1648,7 +1648,7 @@
                 <a:ea typeface="맑은 고딕" pitchFamily="34" charset="-122"/>
                 <a:cs typeface="맑은 고딕" pitchFamily="34" charset="-120"/>
               </a:rPr>
-              <a:t>2026년 06월 01일 (월)  ·  24h 출고 기준</a:t>
+              <a:t>2026년 06월 02일 (화)  ·  24h 출고 기준</a:t>
             </a:r>
             <a:endParaRPr lang="en-US" sz="2200" dirty="0"/>
           </a:p>
@@ -1726,7 +1726,7 @@
                 <a:ea typeface="맑은 고딕" pitchFamily="34" charset="-122"/>
                 <a:cs typeface="맑은 고딕" pitchFamily="34" charset="-120"/>
               </a:rPr>
-              <a:t>06.01</a:t>
+              <a:t>06.02</a:t>
             </a:r>
             <a:endParaRPr lang="en-US" sz="7200" dirty="0"/>
           </a:p>
@@ -1765,7 +1765,7 @@
                 <a:ea typeface="맑은 고딕" pitchFamily="34" charset="-122"/>
                 <a:cs typeface="맑은 고딕" pitchFamily="34" charset="-120"/>
               </a:rPr>
-              <a:t>월요일</a:t>
+              <a:t>화요일</a:t>
             </a:r>
             <a:endParaRPr lang="en-US" sz="1400" dirty="0"/>
           </a:p>
@@ -1804,7 +1804,7 @@
                 <a:ea typeface="맑은 고딕" pitchFamily="34" charset="-122"/>
                 <a:cs typeface="맑은 고딕" pitchFamily="34" charset="-120"/>
               </a:rPr>
-              <a:t>생성 2026-06-01 08:00  ·  Google Sheet 자동 동기</a:t>
+              <a:t>생성 2026-06-02 08:00  ·  Google Sheet 자동 동기</a:t>
             </a:r>
             <a:endParaRPr lang="en-US" sz="1000" dirty="0"/>
           </a:p>
@@ -1978,7 +1978,7 @@
                 <a:ea typeface="맑은 고딕" pitchFamily="34" charset="-122"/>
                 <a:cs typeface="맑은 고딕" pitchFamily="34" charset="-120"/>
               </a:rPr>
-              <a:t>2026년 06월 01일 (월)</a:t>
+              <a:t>2026년 06월 02일 (화)</a:t>
             </a:r>
             <a:endParaRPr lang="en-US" sz="1200" dirty="0"/>
           </a:p>
@@ -2145,7 +2145,7 @@
                 <a:ea typeface="맑은 고딕" pitchFamily="34" charset="-122"/>
                 <a:cs typeface="맑은 고딕" pitchFamily="34" charset="-120"/>
               </a:rPr>
-              <a:t>839 개</a:t>
+              <a:t>693 개</a:t>
             </a:r>
             <a:endParaRPr lang="en-US" sz="3600" dirty="0"/>
           </a:p>
@@ -2312,7 +2312,7 @@
                 <a:ea typeface="맑은 고딕" pitchFamily="34" charset="-122"/>
                 <a:cs typeface="맑은 고딕" pitchFamily="34" charset="-120"/>
               </a:rPr>
-              <a:t>68 건</a:t>
+              <a:t>71 건</a:t>
             </a:r>
             <a:endParaRPr lang="en-US" sz="3200" dirty="0"/>
           </a:p>
@@ -2479,7 +2479,7 @@
                 <a:ea typeface="맑은 고딕" pitchFamily="34" charset="-122"/>
                 <a:cs typeface="맑은 고딕" pitchFamily="34" charset="-120"/>
               </a:rPr>
-              <a:t>9 건</a:t>
+              <a:t>7 건</a:t>
             </a:r>
             <a:endParaRPr lang="en-US" sz="3200" dirty="0"/>
           </a:p>
@@ -2969,7 +2969,7 @@
                 <a:ea typeface="맑은 고딕" pitchFamily="34" charset="-122"/>
                 <a:cs typeface="맑은 고딕" pitchFamily="34" charset="-120"/>
               </a:rPr>
-              <a:t>200 SKU  ·  판매 데이터 있음</a:t>
+              <a:t>201 SKU  ·  판매 데이터 있음</a:t>
             </a:r>
             <a:pPr indent="0" marL="0">
               <a:buNone/>
@@ -3612,7 +3612,7 @@
                           <a:ea typeface="맑은 고딕" pitchFamily="34" charset="-122"/>
                           <a:cs typeface="맑은 고딕" pitchFamily="34" charset="-120"/>
                         </a:rPr>
-                        <a:t>[SILVER925] Guyeong Open Ring v3.0 (silver)</a:t>
+                        <a:t>[SILVER925] Mustafakemalpaşa Ring (사이즈: 22호)</a:t>
                       </a:r>
                       <a:endParaRPr lang="en-US" sz="1100" dirty="0">
                         <a:latin typeface="맑은 고딕" charset="0"/>
@@ -3677,7 +3677,7 @@
                           <a:ea typeface="맑은 고딕" pitchFamily="34" charset="-122"/>
                           <a:cs typeface="맑은 고딕" pitchFamily="34" charset="-120"/>
                         </a:rPr>
-                        <a:t>136 개</a:t>
+                        <a:t>265 개</a:t>
                       </a:r>
                       <a:endParaRPr lang="en-US" sz="1400" dirty="0">
                         <a:latin typeface="맑은 고딕" charset="0"/>
@@ -3939,7 +3939,7 @@
                           <a:ea typeface="맑은 고딕" pitchFamily="34" charset="-122"/>
                           <a:cs typeface="맑은 고딕" pitchFamily="34" charset="-120"/>
                         </a:rPr>
-                        <a:t>[SILVER925] Eramam Open Ring</a:t>
+                        <a:t>[SILVER925] CH.alban Open Ring</a:t>
                       </a:r>
                       <a:endParaRPr lang="en-US" sz="1100" dirty="0">
                         <a:latin typeface="맑은 고딕" charset="0"/>
@@ -4004,7 +4004,7 @@
                           <a:ea typeface="맑은 고딕" pitchFamily="34" charset="-122"/>
                           <a:cs typeface="맑은 고딕" pitchFamily="34" charset="-120"/>
                         </a:rPr>
-                        <a:t>68 개</a:t>
+                        <a:t>44 개</a:t>
                       </a:r>
                       <a:endParaRPr lang="en-US" sz="1400" dirty="0">
                         <a:latin typeface="맑은 고딕" charset="0"/>
@@ -4201,7 +4201,7 @@
                           <a:ea typeface="맑은 고딕" pitchFamily="34" charset="-122"/>
                           <a:cs typeface="맑은 고딕" pitchFamily="34" charset="-120"/>
                         </a:rPr>
-                        <a:t>Necklace</a:t>
+                        <a:t>Ring</a:t>
                       </a:r>
                       <a:endParaRPr lang="en-US" sz="1000" dirty="0">
                         <a:latin typeface="맑은 고딕" charset="0"/>
@@ -4266,7 +4266,7 @@
                           <a:ea typeface="맑은 고딕" pitchFamily="34" charset="-122"/>
                           <a:cs typeface="맑은 고딕" pitchFamily="34" charset="-120"/>
                         </a:rPr>
-                        <a:t>Marquise Necklace</a:t>
+                        <a:t>[SILVER925] Guyeong Open Ring v3.0 (silver)</a:t>
                       </a:r>
                       <a:endParaRPr lang="en-US" sz="1100" dirty="0">
                         <a:latin typeface="맑은 고딕" charset="0"/>
@@ -4331,7 +4331,7 @@
                           <a:ea typeface="맑은 고딕" pitchFamily="34" charset="-122"/>
                           <a:cs typeface="맑은 고딕" pitchFamily="34" charset="-120"/>
                         </a:rPr>
-                        <a:t>64 개</a:t>
+                        <a:t>31 개</a:t>
                       </a:r>
                       <a:endParaRPr lang="en-US" sz="1400" dirty="0">
                         <a:latin typeface="맑은 고딕" charset="0"/>
@@ -4463,7 +4463,7 @@
                           <a:ea typeface="맑은 고딕" pitchFamily="34" charset="-122"/>
                           <a:cs typeface="맑은 고딕" pitchFamily="34" charset="-120"/>
                         </a:rPr>
-                        <a:t>6A</a:t>
+                        <a:t>CT</a:t>
                       </a:r>
                       <a:endParaRPr lang="en-US" sz="1100" dirty="0">
                         <a:latin typeface="맑은 고딕" charset="0"/>
@@ -4528,7 +4528,7 @@
                           <a:ea typeface="맑은 고딕" pitchFamily="34" charset="-122"/>
                           <a:cs typeface="맑은 고딕" pitchFamily="34" charset="-120"/>
                         </a:rPr>
-                        <a:t>Ring</a:t>
+                        <a:t>Necklace</a:t>
                       </a:r>
                       <a:endParaRPr lang="en-US" sz="1000" dirty="0">
                         <a:latin typeface="맑은 고딕" charset="0"/>
@@ -4593,7 +4593,7 @@
                           <a:ea typeface="맑은 고딕" pitchFamily="34" charset="-122"/>
                           <a:cs typeface="맑은 고딕" pitchFamily="34" charset="-120"/>
                         </a:rPr>
-                        <a:t>[SILVER925] CH.alban Open Ring</a:t>
+                        <a:t>CandyPOP Necklace (사이즈: 2size (47~52cm))</a:t>
                       </a:r>
                       <a:endParaRPr lang="en-US" sz="1100" dirty="0">
                         <a:latin typeface="맑은 고딕" charset="0"/>
@@ -4658,7 +4658,7 @@
                           <a:ea typeface="맑은 고딕" pitchFamily="34" charset="-122"/>
                           <a:cs typeface="맑은 고딕" pitchFamily="34" charset="-120"/>
                         </a:rPr>
-                        <a:t>52 개</a:t>
+                        <a:t>31 개</a:t>
                       </a:r>
                       <a:endParaRPr lang="en-US" sz="1200" dirty="0">
                         <a:latin typeface="맑은 고딕" charset="0"/>
@@ -4790,7 +4790,7 @@
                           <a:ea typeface="맑은 고딕" pitchFamily="34" charset="-122"/>
                           <a:cs typeface="맑은 고딕" pitchFamily="34" charset="-120"/>
                         </a:rPr>
-                        <a:t>6A</a:t>
+                        <a:t>CT</a:t>
                       </a:r>
                       <a:endParaRPr lang="en-US" sz="1100" dirty="0">
                         <a:latin typeface="맑은 고딕" charset="0"/>
@@ -4855,7 +4855,7 @@
                           <a:ea typeface="맑은 고딕" pitchFamily="34" charset="-122"/>
                           <a:cs typeface="맑은 고딕" pitchFamily="34" charset="-120"/>
                         </a:rPr>
-                        <a:t>Ring</a:t>
+                        <a:t>Necklace</a:t>
                       </a:r>
                       <a:endParaRPr lang="en-US" sz="1000" dirty="0">
                         <a:latin typeface="맑은 고딕" charset="0"/>
@@ -4920,7 +4920,7 @@
                           <a:ea typeface="맑은 고딕" pitchFamily="34" charset="-122"/>
                           <a:cs typeface="맑은 고딕" pitchFamily="34" charset="-120"/>
                         </a:rPr>
-                        <a:t>[SILVER925] Starly Open Ring</a:t>
+                        <a:t>CandyPOP Necklace (사이즈: 1size (37~43cm))</a:t>
                       </a:r>
                       <a:endParaRPr lang="en-US" sz="1100" dirty="0">
                         <a:latin typeface="맑은 고딕" charset="0"/>
@@ -4985,7 +4985,7 @@
                           <a:ea typeface="맑은 고딕" pitchFamily="34" charset="-122"/>
                           <a:cs typeface="맑은 고딕" pitchFamily="34" charset="-120"/>
                         </a:rPr>
-                        <a:t>42 개</a:t>
+                        <a:t>28 개</a:t>
                       </a:r>
                       <a:endParaRPr lang="en-US" sz="1200" dirty="0">
                         <a:latin typeface="맑은 고딕" charset="0"/>
@@ -5071,7 +5071,7 @@
                 <a:ea typeface="맑은 고딕" pitchFamily="34" charset="-122"/>
                 <a:cs typeface="맑은 고딕" pitchFamily="34" charset="-120"/>
               </a:rPr>
-              <a:t>베스트 상품 리포트  ·  생성 2026-06-01 08:00</a:t>
+              <a:t>베스트 상품 리포트  ·  생성 2026-06-02 08:00</a:t>
             </a:r>
             <a:endParaRPr lang="en-US" sz="900" dirty="0"/>
           </a:p>
@@ -5284,7 +5284,7 @@
                 <a:ea typeface="맑은 고딕" pitchFamily="34" charset="-122"/>
                 <a:cs typeface="맑은 고딕" pitchFamily="34" charset="-120"/>
               </a:rPr>
-              <a:t>2026년 06월 01일 (월)</a:t>
+              <a:t>2026년 06월 02일 (화)</a:t>
             </a:r>
             <a:endParaRPr lang="en-US" sz="1200" dirty="0"/>
           </a:p>
@@ -5451,7 +5451,7 @@
                 <a:ea typeface="맑은 고딕" pitchFamily="34" charset="-122"/>
                 <a:cs typeface="맑은 고딕" pitchFamily="34" charset="-120"/>
               </a:rPr>
-              <a:t>722 개</a:t>
+              <a:t>563 개</a:t>
             </a:r>
             <a:endParaRPr lang="en-US" sz="3600" dirty="0"/>
           </a:p>
@@ -5579,7 +5579,7 @@
                 <a:ea typeface="맑은 고딕" pitchFamily="34" charset="-122"/>
                 <a:cs typeface="맑은 고딕" pitchFamily="34" charset="-120"/>
               </a:rPr>
-              <a:t>[SILVER925] Guyeong Open Ring v3.0 (silver)</a:t>
+              <a:t>[SILVER925] Mustafakemalpaşa Ring (사이즈: 22호)</a:t>
             </a:r>
             <a:endParaRPr lang="en-US" sz="1800" dirty="0"/>
           </a:p>
@@ -5657,7 +5657,7 @@
                 <a:ea typeface="맑은 고딕" pitchFamily="34" charset="-122"/>
                 <a:cs typeface="맑은 고딕" pitchFamily="34" charset="-120"/>
               </a:rPr>
-              <a:t>136</a:t>
+              <a:t>265</a:t>
             </a:r>
             <a:endParaRPr lang="en-US" sz="4400" dirty="0"/>
           </a:p>
@@ -6191,7 +6191,7 @@
                           <a:ea typeface="맑은 고딕" pitchFamily="34" charset="-122"/>
                           <a:cs typeface="맑은 고딕" pitchFamily="34" charset="-120"/>
                         </a:rPr>
-                        <a:t>[SILVER925] Guyeong Open Ring v3.0 (silver)</a:t>
+                        <a:t>[SILVER925] Mustafakemalpaşa Ring (사이즈: 22호)</a:t>
                       </a:r>
                       <a:endParaRPr lang="en-US" sz="1100" dirty="0">
                         <a:latin typeface="맑은 고딕" charset="0"/>
@@ -6256,7 +6256,7 @@
                           <a:ea typeface="맑은 고딕" pitchFamily="34" charset="-122"/>
                           <a:cs typeface="맑은 고딕" pitchFamily="34" charset="-120"/>
                         </a:rPr>
-                        <a:t>136 개</a:t>
+                        <a:t>265 개</a:t>
                       </a:r>
                       <a:endParaRPr lang="en-US" sz="1400" dirty="0">
                         <a:latin typeface="맑은 고딕" charset="0"/>
@@ -6453,7 +6453,7 @@
                           <a:ea typeface="맑은 고딕" pitchFamily="34" charset="-122"/>
                           <a:cs typeface="맑은 고딕" pitchFamily="34" charset="-120"/>
                         </a:rPr>
-                        <a:t>[SILVER925] Eramam Open Ring</a:t>
+                        <a:t>[SILVER925] CH.alban Open Ring</a:t>
                       </a:r>
                       <a:endParaRPr lang="en-US" sz="1100" dirty="0">
                         <a:latin typeface="맑은 고딕" charset="0"/>
@@ -6518,7 +6518,7 @@
                           <a:ea typeface="맑은 고딕" pitchFamily="34" charset="-122"/>
                           <a:cs typeface="맑은 고딕" pitchFamily="34" charset="-120"/>
                         </a:rPr>
-                        <a:t>68 개</a:t>
+                        <a:t>44 개</a:t>
                       </a:r>
                       <a:endParaRPr lang="en-US" sz="1200" dirty="0">
                         <a:latin typeface="맑은 고딕" charset="0"/>
@@ -6650,7 +6650,7 @@
                           <a:ea typeface="맑은 고딕" pitchFamily="34" charset="-122"/>
                           <a:cs typeface="맑은 고딕" pitchFamily="34" charset="-120"/>
                         </a:rPr>
-                        <a:t>Necklace</a:t>
+                        <a:t>Ring</a:t>
                       </a:r>
                       <a:endParaRPr lang="en-US" sz="1000" dirty="0">
                         <a:latin typeface="맑은 고딕" charset="0"/>
@@ -6715,7 +6715,7 @@
                           <a:ea typeface="맑은 고딕" pitchFamily="34" charset="-122"/>
                           <a:cs typeface="맑은 고딕" pitchFamily="34" charset="-120"/>
                         </a:rPr>
-                        <a:t>Marquise Necklace</a:t>
+                        <a:t>[SILVER925] Guyeong Open Ring v3.0 (silver)</a:t>
                       </a:r>
                       <a:endParaRPr lang="en-US" sz="1100" dirty="0">
                         <a:latin typeface="맑은 고딕" charset="0"/>
@@ -6780,7 +6780,7 @@
                           <a:ea typeface="맑은 고딕" pitchFamily="34" charset="-122"/>
                           <a:cs typeface="맑은 고딕" pitchFamily="34" charset="-120"/>
                         </a:rPr>
-                        <a:t>64 개</a:t>
+                        <a:t>31 개</a:t>
                       </a:r>
                       <a:endParaRPr lang="en-US" sz="1200" dirty="0">
                         <a:latin typeface="맑은 고딕" charset="0"/>
@@ -6977,7 +6977,7 @@
                           <a:ea typeface="맑은 고딕" pitchFamily="34" charset="-122"/>
                           <a:cs typeface="맑은 고딕" pitchFamily="34" charset="-120"/>
                         </a:rPr>
-                        <a:t>[SILVER925] CH.alban Open Ring</a:t>
+                        <a:t>[SILVER925] Mustafakemalpaşa Ring (사이즈: 12호)</a:t>
                       </a:r>
                       <a:endParaRPr lang="en-US" sz="1100" dirty="0">
                         <a:latin typeface="맑은 고딕" charset="0"/>
@@ -7042,7 +7042,7 @@
                           <a:ea typeface="맑은 고딕" pitchFamily="34" charset="-122"/>
                           <a:cs typeface="맑은 고딕" pitchFamily="34" charset="-120"/>
                         </a:rPr>
-                        <a:t>52 개</a:t>
+                        <a:t>20 개</a:t>
                       </a:r>
                       <a:endParaRPr lang="en-US" sz="1200" dirty="0">
                         <a:latin typeface="맑은 고딕" charset="0"/>
@@ -7174,7 +7174,7 @@
                           <a:ea typeface="맑은 고딕" pitchFamily="34" charset="-122"/>
                           <a:cs typeface="맑은 고딕" pitchFamily="34" charset="-120"/>
                         </a:rPr>
-                        <a:t>Ring</a:t>
+                        <a:t>Necklace</a:t>
                       </a:r>
                       <a:endParaRPr lang="en-US" sz="1000" dirty="0">
                         <a:latin typeface="맑은 고딕" charset="0"/>
@@ -7239,7 +7239,7 @@
                           <a:ea typeface="맑은 고딕" pitchFamily="34" charset="-122"/>
                           <a:cs typeface="맑은 고딕" pitchFamily="34" charset="-120"/>
                         </a:rPr>
-                        <a:t>[SILVER925] Starly Open Ring</a:t>
+                        <a:t>YOKNIS 9921 Necklace</a:t>
                       </a:r>
                       <a:endParaRPr lang="en-US" sz="1100" dirty="0">
                         <a:latin typeface="맑은 고딕" charset="0"/>
@@ -7304,7 +7304,7 @@
                           <a:ea typeface="맑은 고딕" pitchFamily="34" charset="-122"/>
                           <a:cs typeface="맑은 고딕" pitchFamily="34" charset="-120"/>
                         </a:rPr>
-                        <a:t>42 개</a:t>
+                        <a:t>17 개</a:t>
                       </a:r>
                       <a:endParaRPr lang="en-US" sz="1200" dirty="0">
                         <a:latin typeface="맑은 고딕" charset="0"/>
@@ -7390,7 +7390,7 @@
                 <a:ea typeface="맑은 고딕" pitchFamily="34" charset="-122"/>
                 <a:cs typeface="맑은 고딕" pitchFamily="34" charset="-120"/>
               </a:rPr>
-              <a:t>리오더 필요  🔴 긴급 5건</a:t>
+              <a:t>리오더 필요  🔴 긴급 7건</a:t>
             </a:r>
             <a:pPr indent="0" marL="0">
               <a:buNone/>
@@ -7557,6 +7557,418 @@
                 <a:ea typeface="맑은 고딕" pitchFamily="34" charset="-122"/>
                 <a:cs typeface="맑은 고딕" pitchFamily="34" charset="-120"/>
               </a:rPr>
+              <a:t>[SILVER925] Mustafakemalpaşa Ring (사이즈: 12호)</a:t>
+            </a:r>
+            <a:endParaRPr lang="en-US" sz="1100" dirty="0"/>
+          </a:p>
+        </p:txBody>
+      </p:sp>
+      <p:sp>
+        <p:nvSpPr>
+          <p:cNvPr id="26" name="Text 23"/>
+          <p:cNvSpPr/>
+          <p:nvPr/>
+        </p:nvSpPr>
+        <p:spPr>
+          <a:xfrm>
+            <a:off x="8211312" y="3712464"/>
+            <a:ext cx="3291840" cy="256032"/>
+          </a:xfrm>
+          <a:prstGeom prst="rect">
+            <a:avLst/>
+          </a:prstGeom>
+          <a:noFill/>
+          <a:ln/>
+        </p:spPr>
+        <p:txBody>
+          <a:bodyPr wrap="square" lIns="0" tIns="0" rIns="0" bIns="0" rtlCol="0" anchor="ctr"/>
+          <a:lstStyle/>
+          <a:p>
+            <a:pPr indent="0" marL="0">
+              <a:buNone/>
+            </a:pPr>
+            <a:r>
+              <a:rPr lang="en-US" sz="1000" dirty="0">
+                <a:solidFill>
+                  <a:srgbClr val="6B7280"/>
+                </a:solidFill>
+                <a:latin typeface="맑은 고딕" pitchFamily="34" charset="0"/>
+                <a:ea typeface="맑은 고딕" pitchFamily="34" charset="-122"/>
+                <a:cs typeface="맑은 고딕" pitchFamily="34" charset="-120"/>
+              </a:rPr>
+              <a:t>Ring  ·  재고 0개</a:t>
+            </a:r>
+            <a:pPr indent="0" marL="0">
+              <a:buNone/>
+            </a:pPr>
+            <a:r>
+              <a:rPr lang="en-US" sz="1000" b="1" dirty="0">
+                <a:solidFill>
+                  <a:srgbClr val="D72638"/>
+                </a:solidFill>
+                <a:latin typeface="맑은 고딕" pitchFamily="34" charset="0"/>
+                <a:ea typeface="맑은 고딕" pitchFamily="34" charset="-122"/>
+                <a:cs typeface="맑은 고딕" pitchFamily="34" charset="-120"/>
+              </a:rPr>
+              <a:t/>
+            </a:r>
+            <a:endParaRPr lang="en-US" sz="1000" dirty="0"/>
+          </a:p>
+        </p:txBody>
+      </p:sp>
+      <p:sp>
+        <p:nvSpPr>
+          <p:cNvPr id="27" name="Shape 24"/>
+          <p:cNvSpPr/>
+          <p:nvPr/>
+        </p:nvSpPr>
+        <p:spPr>
+          <a:xfrm>
+            <a:off x="7406640" y="4096512"/>
+            <a:ext cx="4206240" cy="640080"/>
+          </a:xfrm>
+          <a:prstGeom prst="rect">
+            <a:avLst/>
+          </a:prstGeom>
+          <a:solidFill>
+            <a:srgbClr val="FFF5F5"/>
+          </a:solidFill>
+          <a:ln w="6350">
+            <a:solidFill>
+              <a:srgbClr val="E5E7EB"/>
+            </a:solidFill>
+            <a:prstDash val="solid"/>
+          </a:ln>
+        </p:spPr>
+      </p:sp>
+      <p:sp>
+        <p:nvSpPr>
+          <p:cNvPr id="28" name="Shape 25"/>
+          <p:cNvSpPr/>
+          <p:nvPr/>
+        </p:nvSpPr>
+        <p:spPr>
+          <a:xfrm>
+            <a:off x="7406640" y="4096512"/>
+            <a:ext cx="109728" cy="640080"/>
+          </a:xfrm>
+          <a:prstGeom prst="rect">
+            <a:avLst/>
+          </a:prstGeom>
+          <a:solidFill>
+            <a:srgbClr val="D72638"/>
+          </a:solidFill>
+          <a:ln w="12700">
+            <a:solidFill>
+              <a:srgbClr val="D72638"/>
+            </a:solidFill>
+            <a:prstDash val="solid"/>
+          </a:ln>
+        </p:spPr>
+      </p:sp>
+      <p:sp>
+        <p:nvSpPr>
+          <p:cNvPr id="29" name="Shape 26"/>
+          <p:cNvSpPr/>
+          <p:nvPr/>
+        </p:nvSpPr>
+        <p:spPr>
+          <a:xfrm>
+            <a:off x="7571232" y="4187952"/>
+            <a:ext cx="548640" cy="256032"/>
+          </a:xfrm>
+          <a:prstGeom prst="rect">
+            <a:avLst/>
+          </a:prstGeom>
+          <a:solidFill>
+            <a:srgbClr val="D72638"/>
+          </a:solidFill>
+          <a:ln w="12700">
+            <a:solidFill>
+              <a:srgbClr val="D72638"/>
+            </a:solidFill>
+            <a:prstDash val="solid"/>
+          </a:ln>
+        </p:spPr>
+      </p:sp>
+      <p:sp>
+        <p:nvSpPr>
+          <p:cNvPr id="30" name="Text 27"/>
+          <p:cNvSpPr/>
+          <p:nvPr/>
+        </p:nvSpPr>
+        <p:spPr>
+          <a:xfrm>
+            <a:off x="7571232" y="4187952"/>
+            <a:ext cx="548640" cy="256032"/>
+          </a:xfrm>
+          <a:prstGeom prst="rect">
+            <a:avLst/>
+          </a:prstGeom>
+          <a:noFill/>
+          <a:ln/>
+        </p:spPr>
+        <p:txBody>
+          <a:bodyPr wrap="square" lIns="0" tIns="0" rIns="0" bIns="0" rtlCol="0" anchor="ctr"/>
+          <a:lstStyle/>
+          <a:p>
+            <a:pPr algn="ctr" indent="0" marL="0">
+              <a:buNone/>
+            </a:pPr>
+            <a:r>
+              <a:rPr lang="en-US" sz="900" b="1" dirty="0">
+                <a:solidFill>
+                  <a:srgbClr val="FFFFFF"/>
+                </a:solidFill>
+                <a:latin typeface="맑은 고딕" pitchFamily="34" charset="0"/>
+                <a:ea typeface="맑은 고딕" pitchFamily="34" charset="-122"/>
+                <a:cs typeface="맑은 고딕" pitchFamily="34" charset="-120"/>
+              </a:rPr>
+              <a:t>긴급</a:t>
+            </a:r>
+            <a:endParaRPr lang="en-US" sz="900" dirty="0"/>
+          </a:p>
+        </p:txBody>
+      </p:sp>
+      <p:sp>
+        <p:nvSpPr>
+          <p:cNvPr id="31" name="Text 28"/>
+          <p:cNvSpPr/>
+          <p:nvPr/>
+        </p:nvSpPr>
+        <p:spPr>
+          <a:xfrm>
+            <a:off x="8211312" y="4151376"/>
+            <a:ext cx="3291840" cy="274320"/>
+          </a:xfrm>
+          <a:prstGeom prst="rect">
+            <a:avLst/>
+          </a:prstGeom>
+          <a:noFill/>
+          <a:ln/>
+        </p:spPr>
+        <p:txBody>
+          <a:bodyPr wrap="square" lIns="0" tIns="0" rIns="0" bIns="0" rtlCol="0" anchor="ctr"/>
+          <a:lstStyle/>
+          <a:p>
+            <a:pPr indent="0" marL="0">
+              <a:buNone/>
+            </a:pPr>
+            <a:r>
+              <a:rPr lang="en-US" sz="1100" b="1" dirty="0">
+                <a:solidFill>
+                  <a:srgbClr val="0B1220"/>
+                </a:solidFill>
+                <a:latin typeface="맑은 고딕" pitchFamily="34" charset="0"/>
+                <a:ea typeface="맑은 고딕" pitchFamily="34" charset="-122"/>
+                <a:cs typeface="맑은 고딕" pitchFamily="34" charset="-120"/>
+              </a:rPr>
+              <a:t>Phorn Bracelet</a:t>
+            </a:r>
+            <a:endParaRPr lang="en-US" sz="1100" dirty="0"/>
+          </a:p>
+        </p:txBody>
+      </p:sp>
+      <p:sp>
+        <p:nvSpPr>
+          <p:cNvPr id="32" name="Text 29"/>
+          <p:cNvSpPr/>
+          <p:nvPr/>
+        </p:nvSpPr>
+        <p:spPr>
+          <a:xfrm>
+            <a:off x="8211312" y="4425696"/>
+            <a:ext cx="3291840" cy="256032"/>
+          </a:xfrm>
+          <a:prstGeom prst="rect">
+            <a:avLst/>
+          </a:prstGeom>
+          <a:noFill/>
+          <a:ln/>
+        </p:spPr>
+        <p:txBody>
+          <a:bodyPr wrap="square" lIns="0" tIns="0" rIns="0" bIns="0" rtlCol="0" anchor="ctr"/>
+          <a:lstStyle/>
+          <a:p>
+            <a:pPr indent="0" marL="0">
+              <a:buNone/>
+            </a:pPr>
+            <a:r>
+              <a:rPr lang="en-US" sz="1000" dirty="0">
+                <a:solidFill>
+                  <a:srgbClr val="6B7280"/>
+                </a:solidFill>
+                <a:latin typeface="맑은 고딕" pitchFamily="34" charset="0"/>
+                <a:ea typeface="맑은 고딕" pitchFamily="34" charset="-122"/>
+                <a:cs typeface="맑은 고딕" pitchFamily="34" charset="-120"/>
+              </a:rPr>
+              <a:t>Bracelet  ·  재고 5개</a:t>
+            </a:r>
+            <a:pPr indent="0" marL="0">
+              <a:buNone/>
+            </a:pPr>
+            <a:r>
+              <a:rPr lang="en-US" sz="1000" b="1" dirty="0">
+                <a:solidFill>
+                  <a:srgbClr val="D72638"/>
+                </a:solidFill>
+                <a:latin typeface="맑은 고딕" pitchFamily="34" charset="0"/>
+                <a:ea typeface="맑은 고딕" pitchFamily="34" charset="-122"/>
+                <a:cs typeface="맑은 고딕" pitchFamily="34" charset="-120"/>
+              </a:rPr>
+              <a:t/>
+            </a:r>
+            <a:endParaRPr lang="en-US" sz="1000" dirty="0"/>
+          </a:p>
+        </p:txBody>
+      </p:sp>
+      <p:sp>
+        <p:nvSpPr>
+          <p:cNvPr id="33" name="Shape 30"/>
+          <p:cNvSpPr/>
+          <p:nvPr/>
+        </p:nvSpPr>
+        <p:spPr>
+          <a:xfrm>
+            <a:off x="7406640" y="4809744"/>
+            <a:ext cx="4206240" cy="640080"/>
+          </a:xfrm>
+          <a:prstGeom prst="rect">
+            <a:avLst/>
+          </a:prstGeom>
+          <a:solidFill>
+            <a:srgbClr val="FFF5F5"/>
+          </a:solidFill>
+          <a:ln w="6350">
+            <a:solidFill>
+              <a:srgbClr val="E5E7EB"/>
+            </a:solidFill>
+            <a:prstDash val="solid"/>
+          </a:ln>
+        </p:spPr>
+      </p:sp>
+      <p:sp>
+        <p:nvSpPr>
+          <p:cNvPr id="34" name="Shape 31"/>
+          <p:cNvSpPr/>
+          <p:nvPr/>
+        </p:nvSpPr>
+        <p:spPr>
+          <a:xfrm>
+            <a:off x="7406640" y="4809744"/>
+            <a:ext cx="109728" cy="640080"/>
+          </a:xfrm>
+          <a:prstGeom prst="rect">
+            <a:avLst/>
+          </a:prstGeom>
+          <a:solidFill>
+            <a:srgbClr val="D72638"/>
+          </a:solidFill>
+          <a:ln w="12700">
+            <a:solidFill>
+              <a:srgbClr val="D72638"/>
+            </a:solidFill>
+            <a:prstDash val="solid"/>
+          </a:ln>
+        </p:spPr>
+      </p:sp>
+      <p:sp>
+        <p:nvSpPr>
+          <p:cNvPr id="35" name="Shape 32"/>
+          <p:cNvSpPr/>
+          <p:nvPr/>
+        </p:nvSpPr>
+        <p:spPr>
+          <a:xfrm>
+            <a:off x="7571232" y="4901184"/>
+            <a:ext cx="548640" cy="256032"/>
+          </a:xfrm>
+          <a:prstGeom prst="rect">
+            <a:avLst/>
+          </a:prstGeom>
+          <a:solidFill>
+            <a:srgbClr val="D72638"/>
+          </a:solidFill>
+          <a:ln w="12700">
+            <a:solidFill>
+              <a:srgbClr val="D72638"/>
+            </a:solidFill>
+            <a:prstDash val="solid"/>
+          </a:ln>
+        </p:spPr>
+      </p:sp>
+      <p:sp>
+        <p:nvSpPr>
+          <p:cNvPr id="36" name="Text 33"/>
+          <p:cNvSpPr/>
+          <p:nvPr/>
+        </p:nvSpPr>
+        <p:spPr>
+          <a:xfrm>
+            <a:off x="7571232" y="4901184"/>
+            <a:ext cx="548640" cy="256032"/>
+          </a:xfrm>
+          <a:prstGeom prst="rect">
+            <a:avLst/>
+          </a:prstGeom>
+          <a:noFill/>
+          <a:ln/>
+        </p:spPr>
+        <p:txBody>
+          <a:bodyPr wrap="square" lIns="0" tIns="0" rIns="0" bIns="0" rtlCol="0" anchor="ctr"/>
+          <a:lstStyle/>
+          <a:p>
+            <a:pPr algn="ctr" indent="0" marL="0">
+              <a:buNone/>
+            </a:pPr>
+            <a:r>
+              <a:rPr lang="en-US" sz="900" b="1" dirty="0">
+                <a:solidFill>
+                  <a:srgbClr val="FFFFFF"/>
+                </a:solidFill>
+                <a:latin typeface="맑은 고딕" pitchFamily="34" charset="0"/>
+                <a:ea typeface="맑은 고딕" pitchFamily="34" charset="-122"/>
+                <a:cs typeface="맑은 고딕" pitchFamily="34" charset="-120"/>
+              </a:rPr>
+              <a:t>긴급</a:t>
+            </a:r>
+            <a:endParaRPr lang="en-US" sz="900" dirty="0"/>
+          </a:p>
+        </p:txBody>
+      </p:sp>
+      <p:sp>
+        <p:nvSpPr>
+          <p:cNvPr id="37" name="Text 34"/>
+          <p:cNvSpPr/>
+          <p:nvPr/>
+        </p:nvSpPr>
+        <p:spPr>
+          <a:xfrm>
+            <a:off x="8211312" y="4864608"/>
+            <a:ext cx="3291840" cy="274320"/>
+          </a:xfrm>
+          <a:prstGeom prst="rect">
+            <a:avLst/>
+          </a:prstGeom>
+          <a:noFill/>
+          <a:ln/>
+        </p:spPr>
+        <p:txBody>
+          <a:bodyPr wrap="square" lIns="0" tIns="0" rIns="0" bIns="0" rtlCol="0" anchor="ctr"/>
+          <a:lstStyle/>
+          <a:p>
+            <a:pPr indent="0" marL="0">
+              <a:buNone/>
+            </a:pPr>
+            <a:r>
+              <a:rPr lang="en-US" sz="1100" b="1" dirty="0">
+                <a:solidFill>
+                  <a:srgbClr val="0B1220"/>
+                </a:solidFill>
+                <a:latin typeface="맑은 고딕" pitchFamily="34" charset="0"/>
+                <a:ea typeface="맑은 고딕" pitchFamily="34" charset="-122"/>
+                <a:cs typeface="맑은 고딕" pitchFamily="34" charset="-120"/>
+              </a:rPr>
               <a:t>8-Ball Smart Tok</a:t>
             </a:r>
             <a:endParaRPr lang="en-US" sz="1100" dirty="0"/>
@@ -7565,13 +7977,13 @@
       </p:sp>
       <p:sp>
         <p:nvSpPr>
-          <p:cNvPr id="26" name="Text 23"/>
-          <p:cNvSpPr/>
-          <p:nvPr/>
-        </p:nvSpPr>
-        <p:spPr>
-          <a:xfrm>
-            <a:off x="8211312" y="3712464"/>
+          <p:cNvPr id="38" name="Text 35"/>
+          <p:cNvSpPr/>
+          <p:nvPr/>
+        </p:nvSpPr>
+        <p:spPr>
+          <a:xfrm>
+            <a:off x="8211312" y="5138928"/>
             <a:ext cx="3291840" cy="256032"/>
           </a:xfrm>
           <a:prstGeom prst="rect">
@@ -7618,13 +8030,13 @@
       </p:sp>
       <p:sp>
         <p:nvSpPr>
-          <p:cNvPr id="27" name="Shape 24"/>
-          <p:cNvSpPr/>
-          <p:nvPr/>
-        </p:nvSpPr>
-        <p:spPr>
-          <a:xfrm>
-            <a:off x="7406640" y="4096512"/>
+          <p:cNvPr id="39" name="Shape 36"/>
+          <p:cNvSpPr/>
+          <p:nvPr/>
+        </p:nvSpPr>
+        <p:spPr>
+          <a:xfrm>
+            <a:off x="7406640" y="5522976"/>
             <a:ext cx="4206240" cy="640080"/>
           </a:xfrm>
           <a:prstGeom prst="rect">
@@ -7643,13 +8055,13 @@
       </p:sp>
       <p:sp>
         <p:nvSpPr>
-          <p:cNvPr id="28" name="Shape 25"/>
-          <p:cNvSpPr/>
-          <p:nvPr/>
-        </p:nvSpPr>
-        <p:spPr>
-          <a:xfrm>
-            <a:off x="7406640" y="4096512"/>
+          <p:cNvPr id="40" name="Shape 37"/>
+          <p:cNvSpPr/>
+          <p:nvPr/>
+        </p:nvSpPr>
+        <p:spPr>
+          <a:xfrm>
+            <a:off x="7406640" y="5522976"/>
             <a:ext cx="109728" cy="640080"/>
           </a:xfrm>
           <a:prstGeom prst="rect">
@@ -7668,13 +8080,13 @@
       </p:sp>
       <p:sp>
         <p:nvSpPr>
-          <p:cNvPr id="29" name="Shape 26"/>
-          <p:cNvSpPr/>
-          <p:nvPr/>
-        </p:nvSpPr>
-        <p:spPr>
-          <a:xfrm>
-            <a:off x="7571232" y="4187952"/>
+          <p:cNvPr id="41" name="Shape 38"/>
+          <p:cNvSpPr/>
+          <p:nvPr/>
+        </p:nvSpPr>
+        <p:spPr>
+          <a:xfrm>
+            <a:off x="7571232" y="5614416"/>
             <a:ext cx="548640" cy="256032"/>
           </a:xfrm>
           <a:prstGeom prst="rect">
@@ -7693,13 +8105,13 @@
       </p:sp>
       <p:sp>
         <p:nvSpPr>
-          <p:cNvPr id="30" name="Text 27"/>
-          <p:cNvSpPr/>
-          <p:nvPr/>
-        </p:nvSpPr>
-        <p:spPr>
-          <a:xfrm>
-            <a:off x="7571232" y="4187952"/>
+          <p:cNvPr id="42" name="Text 39"/>
+          <p:cNvSpPr/>
+          <p:nvPr/>
+        </p:nvSpPr>
+        <p:spPr>
+          <a:xfrm>
+            <a:off x="7571232" y="5614416"/>
             <a:ext cx="548640" cy="256032"/>
           </a:xfrm>
           <a:prstGeom prst="rect">
@@ -7732,13 +8144,13 @@
       </p:sp>
       <p:sp>
         <p:nvSpPr>
-          <p:cNvPr id="31" name="Text 28"/>
-          <p:cNvSpPr/>
-          <p:nvPr/>
-        </p:nvSpPr>
-        <p:spPr>
-          <a:xfrm>
-            <a:off x="8211312" y="4151376"/>
+          <p:cNvPr id="43" name="Text 40"/>
+          <p:cNvSpPr/>
+          <p:nvPr/>
+        </p:nvSpPr>
+        <p:spPr>
+          <a:xfrm>
+            <a:off x="8211312" y="5577840"/>
             <a:ext cx="3291840" cy="274320"/>
           </a:xfrm>
           <a:prstGeom prst="rect">
@@ -7771,13 +8183,13 @@
       </p:sp>
       <p:sp>
         <p:nvSpPr>
-          <p:cNvPr id="32" name="Text 29"/>
-          <p:cNvSpPr/>
-          <p:nvPr/>
-        </p:nvSpPr>
-        <p:spPr>
-          <a:xfrm>
-            <a:off x="8211312" y="4425696"/>
+          <p:cNvPr id="44" name="Text 41"/>
+          <p:cNvSpPr/>
+          <p:nvPr/>
+        </p:nvSpPr>
+        <p:spPr>
+          <a:xfrm>
+            <a:off x="8211312" y="5852160"/>
             <a:ext cx="3291840" cy="256032"/>
           </a:xfrm>
           <a:prstGeom prst="rect">
@@ -7824,418 +8236,6 @@
       </p:sp>
       <p:sp>
         <p:nvSpPr>
-          <p:cNvPr id="33" name="Shape 30"/>
-          <p:cNvSpPr/>
-          <p:nvPr/>
-        </p:nvSpPr>
-        <p:spPr>
-          <a:xfrm>
-            <a:off x="7406640" y="4809744"/>
-            <a:ext cx="4206240" cy="640080"/>
-          </a:xfrm>
-          <a:prstGeom prst="rect">
-            <a:avLst/>
-          </a:prstGeom>
-          <a:solidFill>
-            <a:srgbClr val="FFF5F5"/>
-          </a:solidFill>
-          <a:ln w="6350">
-            <a:solidFill>
-              <a:srgbClr val="E5E7EB"/>
-            </a:solidFill>
-            <a:prstDash val="solid"/>
-          </a:ln>
-        </p:spPr>
-      </p:sp>
-      <p:sp>
-        <p:nvSpPr>
-          <p:cNvPr id="34" name="Shape 31"/>
-          <p:cNvSpPr/>
-          <p:nvPr/>
-        </p:nvSpPr>
-        <p:spPr>
-          <a:xfrm>
-            <a:off x="7406640" y="4809744"/>
-            <a:ext cx="109728" cy="640080"/>
-          </a:xfrm>
-          <a:prstGeom prst="rect">
-            <a:avLst/>
-          </a:prstGeom>
-          <a:solidFill>
-            <a:srgbClr val="D72638"/>
-          </a:solidFill>
-          <a:ln w="12700">
-            <a:solidFill>
-              <a:srgbClr val="D72638"/>
-            </a:solidFill>
-            <a:prstDash val="solid"/>
-          </a:ln>
-        </p:spPr>
-      </p:sp>
-      <p:sp>
-        <p:nvSpPr>
-          <p:cNvPr id="35" name="Shape 32"/>
-          <p:cNvSpPr/>
-          <p:nvPr/>
-        </p:nvSpPr>
-        <p:spPr>
-          <a:xfrm>
-            <a:off x="7571232" y="4901184"/>
-            <a:ext cx="548640" cy="256032"/>
-          </a:xfrm>
-          <a:prstGeom prst="rect">
-            <a:avLst/>
-          </a:prstGeom>
-          <a:solidFill>
-            <a:srgbClr val="D72638"/>
-          </a:solidFill>
-          <a:ln w="12700">
-            <a:solidFill>
-              <a:srgbClr val="D72638"/>
-            </a:solidFill>
-            <a:prstDash val="solid"/>
-          </a:ln>
-        </p:spPr>
-      </p:sp>
-      <p:sp>
-        <p:nvSpPr>
-          <p:cNvPr id="36" name="Text 33"/>
-          <p:cNvSpPr/>
-          <p:nvPr/>
-        </p:nvSpPr>
-        <p:spPr>
-          <a:xfrm>
-            <a:off x="7571232" y="4901184"/>
-            <a:ext cx="548640" cy="256032"/>
-          </a:xfrm>
-          <a:prstGeom prst="rect">
-            <a:avLst/>
-          </a:prstGeom>
-          <a:noFill/>
-          <a:ln/>
-        </p:spPr>
-        <p:txBody>
-          <a:bodyPr wrap="square" lIns="0" tIns="0" rIns="0" bIns="0" rtlCol="0" anchor="ctr"/>
-          <a:lstStyle/>
-          <a:p>
-            <a:pPr algn="ctr" indent="0" marL="0">
-              <a:buNone/>
-            </a:pPr>
-            <a:r>
-              <a:rPr lang="en-US" sz="900" b="1" dirty="0">
-                <a:solidFill>
-                  <a:srgbClr val="FFFFFF"/>
-                </a:solidFill>
-                <a:latin typeface="맑은 고딕" pitchFamily="34" charset="0"/>
-                <a:ea typeface="맑은 고딕" pitchFamily="34" charset="-122"/>
-                <a:cs typeface="맑은 고딕" pitchFamily="34" charset="-120"/>
-              </a:rPr>
-              <a:t>긴급</a:t>
-            </a:r>
-            <a:endParaRPr lang="en-US" sz="900" dirty="0"/>
-          </a:p>
-        </p:txBody>
-      </p:sp>
-      <p:sp>
-        <p:nvSpPr>
-          <p:cNvPr id="37" name="Text 34"/>
-          <p:cNvSpPr/>
-          <p:nvPr/>
-        </p:nvSpPr>
-        <p:spPr>
-          <a:xfrm>
-            <a:off x="8211312" y="4864608"/>
-            <a:ext cx="3291840" cy="274320"/>
-          </a:xfrm>
-          <a:prstGeom prst="rect">
-            <a:avLst/>
-          </a:prstGeom>
-          <a:noFill/>
-          <a:ln/>
-        </p:spPr>
-        <p:txBody>
-          <a:bodyPr wrap="square" lIns="0" tIns="0" rIns="0" bIns="0" rtlCol="0" anchor="ctr"/>
-          <a:lstStyle/>
-          <a:p>
-            <a:pPr indent="0" marL="0">
-              <a:buNone/>
-            </a:pPr>
-            <a:r>
-              <a:rPr lang="en-US" sz="1100" b="1" dirty="0">
-                <a:solidFill>
-                  <a:srgbClr val="0B1220"/>
-                </a:solidFill>
-                <a:latin typeface="맑은 고딕" pitchFamily="34" charset="0"/>
-                <a:ea typeface="맑은 고딕" pitchFamily="34" charset="-122"/>
-                <a:cs typeface="맑은 고딕" pitchFamily="34" charset="-120"/>
-              </a:rPr>
-              <a:t>[SILVER925] Crimson Open Ring</a:t>
-            </a:r>
-            <a:endParaRPr lang="en-US" sz="1100" dirty="0"/>
-          </a:p>
-        </p:txBody>
-      </p:sp>
-      <p:sp>
-        <p:nvSpPr>
-          <p:cNvPr id="38" name="Text 35"/>
-          <p:cNvSpPr/>
-          <p:nvPr/>
-        </p:nvSpPr>
-        <p:spPr>
-          <a:xfrm>
-            <a:off x="8211312" y="5138928"/>
-            <a:ext cx="3291840" cy="256032"/>
-          </a:xfrm>
-          <a:prstGeom prst="rect">
-            <a:avLst/>
-          </a:prstGeom>
-          <a:noFill/>
-          <a:ln/>
-        </p:spPr>
-        <p:txBody>
-          <a:bodyPr wrap="square" lIns="0" tIns="0" rIns="0" bIns="0" rtlCol="0" anchor="ctr"/>
-          <a:lstStyle/>
-          <a:p>
-            <a:pPr indent="0" marL="0">
-              <a:buNone/>
-            </a:pPr>
-            <a:r>
-              <a:rPr lang="en-US" sz="1000" dirty="0">
-                <a:solidFill>
-                  <a:srgbClr val="6B7280"/>
-                </a:solidFill>
-                <a:latin typeface="맑은 고딕" pitchFamily="34" charset="0"/>
-                <a:ea typeface="맑은 고딕" pitchFamily="34" charset="-122"/>
-                <a:cs typeface="맑은 고딕" pitchFamily="34" charset="-120"/>
-              </a:rPr>
-              <a:t>Ring  ·  재고 0개</a:t>
-            </a:r>
-            <a:pPr indent="0" marL="0">
-              <a:buNone/>
-            </a:pPr>
-            <a:r>
-              <a:rPr lang="en-US" sz="1000" b="1" dirty="0">
-                <a:solidFill>
-                  <a:srgbClr val="D72638"/>
-                </a:solidFill>
-                <a:latin typeface="맑은 고딕" pitchFamily="34" charset="0"/>
-                <a:ea typeface="맑은 고딕" pitchFamily="34" charset="-122"/>
-                <a:cs typeface="맑은 고딕" pitchFamily="34" charset="-120"/>
-              </a:rPr>
-              <a:t/>
-            </a:r>
-            <a:endParaRPr lang="en-US" sz="1000" dirty="0"/>
-          </a:p>
-        </p:txBody>
-      </p:sp>
-      <p:sp>
-        <p:nvSpPr>
-          <p:cNvPr id="39" name="Shape 36"/>
-          <p:cNvSpPr/>
-          <p:nvPr/>
-        </p:nvSpPr>
-        <p:spPr>
-          <a:xfrm>
-            <a:off x="7406640" y="5522976"/>
-            <a:ext cx="4206240" cy="640080"/>
-          </a:xfrm>
-          <a:prstGeom prst="rect">
-            <a:avLst/>
-          </a:prstGeom>
-          <a:solidFill>
-            <a:srgbClr val="FFF5F5"/>
-          </a:solidFill>
-          <a:ln w="6350">
-            <a:solidFill>
-              <a:srgbClr val="E5E7EB"/>
-            </a:solidFill>
-            <a:prstDash val="solid"/>
-          </a:ln>
-        </p:spPr>
-      </p:sp>
-      <p:sp>
-        <p:nvSpPr>
-          <p:cNvPr id="40" name="Shape 37"/>
-          <p:cNvSpPr/>
-          <p:nvPr/>
-        </p:nvSpPr>
-        <p:spPr>
-          <a:xfrm>
-            <a:off x="7406640" y="5522976"/>
-            <a:ext cx="109728" cy="640080"/>
-          </a:xfrm>
-          <a:prstGeom prst="rect">
-            <a:avLst/>
-          </a:prstGeom>
-          <a:solidFill>
-            <a:srgbClr val="D72638"/>
-          </a:solidFill>
-          <a:ln w="12700">
-            <a:solidFill>
-              <a:srgbClr val="D72638"/>
-            </a:solidFill>
-            <a:prstDash val="solid"/>
-          </a:ln>
-        </p:spPr>
-      </p:sp>
-      <p:sp>
-        <p:nvSpPr>
-          <p:cNvPr id="41" name="Shape 38"/>
-          <p:cNvSpPr/>
-          <p:nvPr/>
-        </p:nvSpPr>
-        <p:spPr>
-          <a:xfrm>
-            <a:off x="7571232" y="5614416"/>
-            <a:ext cx="548640" cy="256032"/>
-          </a:xfrm>
-          <a:prstGeom prst="rect">
-            <a:avLst/>
-          </a:prstGeom>
-          <a:solidFill>
-            <a:srgbClr val="D72638"/>
-          </a:solidFill>
-          <a:ln w="12700">
-            <a:solidFill>
-              <a:srgbClr val="D72638"/>
-            </a:solidFill>
-            <a:prstDash val="solid"/>
-          </a:ln>
-        </p:spPr>
-      </p:sp>
-      <p:sp>
-        <p:nvSpPr>
-          <p:cNvPr id="42" name="Text 39"/>
-          <p:cNvSpPr/>
-          <p:nvPr/>
-        </p:nvSpPr>
-        <p:spPr>
-          <a:xfrm>
-            <a:off x="7571232" y="5614416"/>
-            <a:ext cx="548640" cy="256032"/>
-          </a:xfrm>
-          <a:prstGeom prst="rect">
-            <a:avLst/>
-          </a:prstGeom>
-          <a:noFill/>
-          <a:ln/>
-        </p:spPr>
-        <p:txBody>
-          <a:bodyPr wrap="square" lIns="0" tIns="0" rIns="0" bIns="0" rtlCol="0" anchor="ctr"/>
-          <a:lstStyle/>
-          <a:p>
-            <a:pPr algn="ctr" indent="0" marL="0">
-              <a:buNone/>
-            </a:pPr>
-            <a:r>
-              <a:rPr lang="en-US" sz="900" b="1" dirty="0">
-                <a:solidFill>
-                  <a:srgbClr val="FFFFFF"/>
-                </a:solidFill>
-                <a:latin typeface="맑은 고딕" pitchFamily="34" charset="0"/>
-                <a:ea typeface="맑은 고딕" pitchFamily="34" charset="-122"/>
-                <a:cs typeface="맑은 고딕" pitchFamily="34" charset="-120"/>
-              </a:rPr>
-              <a:t>긴급</a:t>
-            </a:r>
-            <a:endParaRPr lang="en-US" sz="900" dirty="0"/>
-          </a:p>
-        </p:txBody>
-      </p:sp>
-      <p:sp>
-        <p:nvSpPr>
-          <p:cNvPr id="43" name="Text 40"/>
-          <p:cNvSpPr/>
-          <p:nvPr/>
-        </p:nvSpPr>
-        <p:spPr>
-          <a:xfrm>
-            <a:off x="8211312" y="5577840"/>
-            <a:ext cx="3291840" cy="274320"/>
-          </a:xfrm>
-          <a:prstGeom prst="rect">
-            <a:avLst/>
-          </a:prstGeom>
-          <a:noFill/>
-          <a:ln/>
-        </p:spPr>
-        <p:txBody>
-          <a:bodyPr wrap="square" lIns="0" tIns="0" rIns="0" bIns="0" rtlCol="0" anchor="ctr"/>
-          <a:lstStyle/>
-          <a:p>
-            <a:pPr indent="0" marL="0">
-              <a:buNone/>
-            </a:pPr>
-            <a:r>
-              <a:rPr lang="en-US" sz="1100" b="1" dirty="0">
-                <a:solidFill>
-                  <a:srgbClr val="0B1220"/>
-                </a:solidFill>
-                <a:latin typeface="맑은 고딕" pitchFamily="34" charset="0"/>
-                <a:ea typeface="맑은 고딕" pitchFamily="34" charset="-122"/>
-                <a:cs typeface="맑은 고딕" pitchFamily="34" charset="-120"/>
-              </a:rPr>
-              <a:t>B-Flower Necklace (Size: 1 Size)</a:t>
-            </a:r>
-            <a:endParaRPr lang="en-US" sz="1100" dirty="0"/>
-          </a:p>
-        </p:txBody>
-      </p:sp>
-      <p:sp>
-        <p:nvSpPr>
-          <p:cNvPr id="44" name="Text 41"/>
-          <p:cNvSpPr/>
-          <p:nvPr/>
-        </p:nvSpPr>
-        <p:spPr>
-          <a:xfrm>
-            <a:off x="8211312" y="5852160"/>
-            <a:ext cx="3291840" cy="256032"/>
-          </a:xfrm>
-          <a:prstGeom prst="rect">
-            <a:avLst/>
-          </a:prstGeom>
-          <a:noFill/>
-          <a:ln/>
-        </p:spPr>
-        <p:txBody>
-          <a:bodyPr wrap="square" lIns="0" tIns="0" rIns="0" bIns="0" rtlCol="0" anchor="ctr"/>
-          <a:lstStyle/>
-          <a:p>
-            <a:pPr indent="0" marL="0">
-              <a:buNone/>
-            </a:pPr>
-            <a:r>
-              <a:rPr lang="en-US" sz="1000" dirty="0">
-                <a:solidFill>
-                  <a:srgbClr val="6B7280"/>
-                </a:solidFill>
-                <a:latin typeface="맑은 고딕" pitchFamily="34" charset="0"/>
-                <a:ea typeface="맑은 고딕" pitchFamily="34" charset="-122"/>
-                <a:cs typeface="맑은 고딕" pitchFamily="34" charset="-120"/>
-              </a:rPr>
-              <a:t>Necklace  ·  재고 0개</a:t>
-            </a:r>
-            <a:pPr indent="0" marL="0">
-              <a:buNone/>
-            </a:pPr>
-            <a:r>
-              <a:rPr lang="en-US" sz="1000" b="1" dirty="0">
-                <a:solidFill>
-                  <a:srgbClr val="D72638"/>
-                </a:solidFill>
-                <a:latin typeface="맑은 고딕" pitchFamily="34" charset="0"/>
-                <a:ea typeface="맑은 고딕" pitchFamily="34" charset="-122"/>
-                <a:cs typeface="맑은 고딕" pitchFamily="34" charset="-120"/>
-              </a:rPr>
-              <a:t/>
-            </a:r>
-            <a:endParaRPr lang="en-US" sz="1000" dirty="0"/>
-          </a:p>
-        </p:txBody>
-      </p:sp>
-      <p:sp>
-        <p:nvSpPr>
           <p:cNvPr id="45" name="Text 42"/>
           <p:cNvSpPr/>
           <p:nvPr/>
@@ -8267,7 +8267,7 @@
                 <a:ea typeface="맑은 고딕" pitchFamily="34" charset="-122"/>
                 <a:cs typeface="맑은 고딕" pitchFamily="34" charset="-120"/>
               </a:rPr>
-              <a:t>베스트 상품 리포트  ·  생성 2026-06-01 08:00</a:t>
+              <a:t>베스트 상품 리포트  ·  생성 2026-06-02 08:00</a:t>
             </a:r>
             <a:endParaRPr lang="en-US" sz="900" dirty="0"/>
           </a:p>
@@ -8480,7 +8480,7 @@
                 <a:ea typeface="맑은 고딕" pitchFamily="34" charset="-122"/>
                 <a:cs typeface="맑은 고딕" pitchFamily="34" charset="-120"/>
               </a:rPr>
-              <a:t>2026년 06월 01일 (월)</a:t>
+              <a:t>2026년 06월 02일 (화)</a:t>
             </a:r>
             <a:endParaRPr lang="en-US" sz="1200" dirty="0"/>
           </a:p>
@@ -8647,7 +8647,7 @@
                 <a:ea typeface="맑은 고딕" pitchFamily="34" charset="-122"/>
                 <a:cs typeface="맑은 고딕" pitchFamily="34" charset="-120"/>
               </a:rPr>
-              <a:t>117 개</a:t>
+              <a:t>130 개</a:t>
             </a:r>
             <a:endParaRPr lang="en-US" sz="3600" dirty="0"/>
           </a:p>
@@ -8775,7 +8775,7 @@
                 <a:ea typeface="맑은 고딕" pitchFamily="34" charset="-122"/>
                 <a:cs typeface="맑은 고딕" pitchFamily="34" charset="-120"/>
               </a:rPr>
-              <a:t>ThreadDuo Necklace</a:t>
+              <a:t>CandyPOP Necklace (사이즈: 2size (47~52cm))</a:t>
             </a:r>
             <a:endParaRPr lang="en-US" sz="1800" dirty="0"/>
           </a:p>
@@ -8853,7 +8853,7 @@
                 <a:ea typeface="맑은 고딕" pitchFamily="34" charset="-122"/>
                 <a:cs typeface="맑은 고딕" pitchFamily="34" charset="-120"/>
               </a:rPr>
-              <a:t>27</a:t>
+              <a:t>31</a:t>
             </a:r>
             <a:endParaRPr lang="en-US" sz="4400" dirty="0"/>
           </a:p>
@@ -9387,7 +9387,7 @@
                           <a:ea typeface="맑은 고딕" pitchFamily="34" charset="-122"/>
                           <a:cs typeface="맑은 고딕" pitchFamily="34" charset="-120"/>
                         </a:rPr>
-                        <a:t>ThreadDuo Necklace</a:t>
+                        <a:t>CandyPOP Necklace (사이즈: 2size (47~52cm))</a:t>
                       </a:r>
                       <a:endParaRPr lang="en-US" sz="1100" dirty="0">
                         <a:latin typeface="맑은 고딕" charset="0"/>
@@ -9452,7 +9452,7 @@
                           <a:ea typeface="맑은 고딕" pitchFamily="34" charset="-122"/>
                           <a:cs typeface="맑은 고딕" pitchFamily="34" charset="-120"/>
                         </a:rPr>
-                        <a:t>27 개</a:t>
+                        <a:t>31 개</a:t>
                       </a:r>
                       <a:endParaRPr lang="en-US" sz="1400" dirty="0">
                         <a:latin typeface="맑은 고딕" charset="0"/>
@@ -9714,7 +9714,7 @@
                           <a:ea typeface="맑은 고딕" pitchFamily="34" charset="-122"/>
                           <a:cs typeface="맑은 고딕" pitchFamily="34" charset="-120"/>
                         </a:rPr>
-                        <a:t>26 개</a:t>
+                        <a:t>28 개</a:t>
                       </a:r>
                       <a:endParaRPr lang="en-US" sz="1200" dirty="0">
                         <a:latin typeface="맑은 고딕" charset="0"/>
@@ -9911,7 +9911,7 @@
                           <a:ea typeface="맑은 고딕" pitchFamily="34" charset="-122"/>
                           <a:cs typeface="맑은 고딕" pitchFamily="34" charset="-120"/>
                         </a:rPr>
-                        <a:t>CandyPOP Necklace (사이즈: 2size (47~52cm))</a:t>
+                        <a:t>ThreadDuo Necklace</a:t>
                       </a:r>
                       <a:endParaRPr lang="en-US" sz="1100" dirty="0">
                         <a:latin typeface="맑은 고딕" charset="0"/>
@@ -9976,7 +9976,7 @@
                           <a:ea typeface="맑은 고딕" pitchFamily="34" charset="-122"/>
                           <a:cs typeface="맑은 고딕" pitchFamily="34" charset="-120"/>
                         </a:rPr>
-                        <a:t>22 개</a:t>
+                        <a:t>21 개</a:t>
                       </a:r>
                       <a:endParaRPr lang="en-US" sz="1200" dirty="0">
                         <a:latin typeface="맑은 고딕" charset="0"/>
@@ -10062,7 +10062,7 @@
                 <a:ea typeface="맑은 고딕" pitchFamily="34" charset="-122"/>
                 <a:cs typeface="맑은 고딕" pitchFamily="34" charset="-120"/>
               </a:rPr>
-              <a:t>리오더 필요  🔴 긴급 21건</a:t>
+              <a:t>리오더 필요  🔴 긴급 22건</a:t>
             </a:r>
             <a:endParaRPr lang="en-US" sz="1500" dirty="0"/>
           </a:p>
@@ -10126,7 +10126,7 @@
                 <a:ea typeface="맑은 고딕" pitchFamily="34" charset="-122"/>
                 <a:cs typeface="맑은 고딕" pitchFamily="34" charset="-120"/>
               </a:rPr>
-              <a:t>🔴 긴급 21건  ·  상세는 시트 확인</a:t>
+              <a:t>🔴 긴급 22건  ·  상세는 시트 확인</a:t>
             </a:r>
             <a:endParaRPr lang="en-US" sz="1400" dirty="0"/>
           </a:p>
@@ -10165,7 +10165,7 @@
                 <a:ea typeface="맑은 고딕" pitchFamily="34" charset="-122"/>
                 <a:cs typeface="맑은 고딕" pitchFamily="34" charset="-120"/>
               </a:rPr>
-              <a:t>베스트 상품 리포트  ·  생성 2026-06-01 08:00</a:t>
+              <a:t>베스트 상품 리포트  ·  생성 2026-06-02 08:00</a:t>
             </a:r>
             <a:endParaRPr lang="en-US" sz="900" dirty="0"/>
           </a:p>
@@ -10378,7 +10378,7 @@
                 <a:ea typeface="맑은 고딕" pitchFamily="34" charset="-122"/>
                 <a:cs typeface="맑은 고딕" pitchFamily="34" charset="-120"/>
               </a:rPr>
-              <a:t>2026년 06월 01일 (월)</a:t>
+              <a:t>2026년 06월 02일 (화)</a:t>
             </a:r>
             <a:endParaRPr lang="en-US" sz="1200" dirty="0"/>
           </a:p>
@@ -10545,7 +10545,7 @@
                 <a:ea typeface="맑은 고딕" pitchFamily="34" charset="-122"/>
                 <a:cs typeface="맑은 고딕" pitchFamily="34" charset="-120"/>
               </a:rPr>
-              <a:t>200</a:t>
+              <a:t>201</a:t>
             </a:r>
             <a:endParaRPr lang="en-US" sz="3000" dirty="0"/>
           </a:p>
@@ -10673,7 +10673,7 @@
                 <a:ea typeface="맑은 고딕" pitchFamily="34" charset="-122"/>
                 <a:cs typeface="맑은 고딕" pitchFamily="34" charset="-120"/>
               </a:rPr>
-              <a:t>26</a:t>
+              <a:t>27</a:t>
             </a:r>
             <a:endParaRPr lang="en-US" sz="3000" dirty="0"/>
           </a:p>
@@ -10929,7 +10929,7 @@
                 <a:ea typeface="맑은 고딕" pitchFamily="34" charset="-122"/>
                 <a:cs typeface="맑은 고딕" pitchFamily="34" charset="-120"/>
               </a:rPr>
-              <a:t>30,352</a:t>
+              <a:t>30,147</a:t>
             </a:r>
             <a:endParaRPr lang="en-US" sz="3000" dirty="0"/>
           </a:p>
@@ -11489,7 +11489,7 @@
                           <a:ea typeface="맑은 고딕" pitchFamily="34" charset="-122"/>
                           <a:cs typeface="맑은 고딕" pitchFamily="34" charset="-120"/>
                         </a:rPr>
-                        <a:t>2,028</a:t>
+                        <a:t>2,023</a:t>
                       </a:r>
                       <a:endParaRPr lang="en-US" sz="1000" dirty="0">
                         <a:latin typeface="맑은 고딕" charset="0"/>
@@ -11751,7 +11751,7 @@
                           <a:ea typeface="맑은 고딕" pitchFamily="34" charset="-122"/>
                           <a:cs typeface="맑은 고딕" pitchFamily="34" charset="-120"/>
                         </a:rPr>
-                        <a:t>1,545</a:t>
+                        <a:t>1,542</a:t>
                       </a:r>
                       <a:endParaRPr lang="en-US" sz="1000" dirty="0">
                         <a:latin typeface="맑은 고딕" charset="0"/>
@@ -12013,7 +12013,7 @@
                           <a:ea typeface="맑은 고딕" pitchFamily="34" charset="-122"/>
                           <a:cs typeface="맑은 고딕" pitchFamily="34" charset="-120"/>
                         </a:rPr>
-                        <a:t>968</a:t>
+                        <a:t>923</a:t>
                       </a:r>
                       <a:endParaRPr lang="en-US" sz="1000" dirty="0">
                         <a:latin typeface="맑은 고딕" charset="0"/>
@@ -12275,7 +12275,7 @@
                           <a:ea typeface="맑은 고딕" pitchFamily="34" charset="-122"/>
                           <a:cs typeface="맑은 고딕" pitchFamily="34" charset="-120"/>
                         </a:rPr>
-                        <a:t>830</a:t>
+                        <a:t>818</a:t>
                       </a:r>
                       <a:endParaRPr lang="en-US" sz="1000" dirty="0">
                         <a:latin typeface="맑은 고딕" charset="0"/>
@@ -12623,7 +12623,7 @@
                 <a:ea typeface="맑은 고딕" pitchFamily="34" charset="-122"/>
                 <a:cs typeface="맑은 고딕" pitchFamily="34" charset="-120"/>
               </a:rPr>
-              <a:t>재고 점검  🔴 품절 26건</a:t>
+              <a:t>재고 점검  🔴 품절 27건</a:t>
             </a:r>
             <a:pPr indent="0" marL="0">
               <a:buNone/>
@@ -13010,6 +13010,226 @@
                 <a:ea typeface="맑은 고딕" pitchFamily="34" charset="-122"/>
                 <a:cs typeface="맑은 고딕" pitchFamily="34" charset="-120"/>
               </a:rPr>
+              <a:t>Basic Toliet Slippers (6color)</a:t>
+            </a:r>
+            <a:endParaRPr lang="en-US" sz="1000" dirty="0"/>
+          </a:p>
+        </p:txBody>
+      </p:sp>
+      <p:sp>
+        <p:nvSpPr>
+          <p:cNvPr id="37" name="Text 34"/>
+          <p:cNvSpPr/>
+          <p:nvPr/>
+        </p:nvSpPr>
+        <p:spPr>
+          <a:xfrm>
+            <a:off x="8211312" y="4425696"/>
+            <a:ext cx="3291840" cy="256032"/>
+          </a:xfrm>
+          <a:prstGeom prst="rect">
+            <a:avLst/>
+          </a:prstGeom>
+          <a:noFill/>
+          <a:ln/>
+        </p:spPr>
+        <p:txBody>
+          <a:bodyPr wrap="square" lIns="0" tIns="0" rIns="0" bIns="0" rtlCol="0" anchor="ctr"/>
+          <a:lstStyle/>
+          <a:p>
+            <a:pPr indent="0" marL="0">
+              <a:buNone/>
+            </a:pPr>
+            <a:r>
+              <a:rPr lang="en-US" sz="900" dirty="0">
+                <a:solidFill>
+                  <a:srgbClr val="6B7280"/>
+                </a:solidFill>
+                <a:latin typeface="맑은 고딕" pitchFamily="34" charset="0"/>
+                <a:ea typeface="맑은 고딕" pitchFamily="34" charset="-122"/>
+                <a:cs typeface="맑은 고딕" pitchFamily="34" charset="-120"/>
+              </a:rPr>
+              <a:t>컬러: 민트 / 사이즈: Free Size 230~270  ·  재고 0개</a:t>
+            </a:r>
+            <a:pPr indent="0" marL="0">
+              <a:buNone/>
+            </a:pPr>
+            <a:r>
+              <a:rPr lang="en-US" sz="1000" dirty="0">
+                <a:solidFill>
+                  <a:srgbClr val="6B7280"/>
+                </a:solidFill>
+                <a:latin typeface="맑은 고딕" pitchFamily="34" charset="0"/>
+                <a:ea typeface="맑은 고딕" pitchFamily="34" charset="-122"/>
+                <a:cs typeface="맑은 고딕" pitchFamily="34" charset="-120"/>
+              </a:rPr>
+              <a:t/>
+            </a:r>
+            <a:pPr indent="0" marL="0">
+              <a:buNone/>
+            </a:pPr>
+            <a:r>
+              <a:rPr lang="en-US" sz="1000" b="1" dirty="0">
+                <a:solidFill>
+                  <a:srgbClr val="D72638"/>
+                </a:solidFill>
+                <a:latin typeface="맑은 고딕" pitchFamily="34" charset="0"/>
+                <a:ea typeface="맑은 고딕" pitchFamily="34" charset="-122"/>
+                <a:cs typeface="맑은 고딕" pitchFamily="34" charset="-120"/>
+              </a:rPr>
+              <a:t/>
+            </a:r>
+            <a:endParaRPr lang="en-US" sz="900" dirty="0"/>
+          </a:p>
+        </p:txBody>
+      </p:sp>
+      <p:sp>
+        <p:nvSpPr>
+          <p:cNvPr id="38" name="Shape 35"/>
+          <p:cNvSpPr/>
+          <p:nvPr/>
+        </p:nvSpPr>
+        <p:spPr>
+          <a:xfrm>
+            <a:off x="7406640" y="4809744"/>
+            <a:ext cx="4206240" cy="640080"/>
+          </a:xfrm>
+          <a:prstGeom prst="rect">
+            <a:avLst/>
+          </a:prstGeom>
+          <a:solidFill>
+            <a:srgbClr val="FFF5F5"/>
+          </a:solidFill>
+          <a:ln w="6350">
+            <a:solidFill>
+              <a:srgbClr val="E5E7EB"/>
+            </a:solidFill>
+            <a:prstDash val="solid"/>
+          </a:ln>
+        </p:spPr>
+      </p:sp>
+      <p:sp>
+        <p:nvSpPr>
+          <p:cNvPr id="39" name="Shape 36"/>
+          <p:cNvSpPr/>
+          <p:nvPr/>
+        </p:nvSpPr>
+        <p:spPr>
+          <a:xfrm>
+            <a:off x="7406640" y="4809744"/>
+            <a:ext cx="109728" cy="640080"/>
+          </a:xfrm>
+          <a:prstGeom prst="rect">
+            <a:avLst/>
+          </a:prstGeom>
+          <a:solidFill>
+            <a:srgbClr val="D72638"/>
+          </a:solidFill>
+          <a:ln w="12700">
+            <a:solidFill>
+              <a:srgbClr val="D72638"/>
+            </a:solidFill>
+            <a:prstDash val="solid"/>
+          </a:ln>
+        </p:spPr>
+      </p:sp>
+      <p:sp>
+        <p:nvSpPr>
+          <p:cNvPr id="40" name="Shape 37"/>
+          <p:cNvSpPr/>
+          <p:nvPr/>
+        </p:nvSpPr>
+        <p:spPr>
+          <a:xfrm>
+            <a:off x="7571232" y="4901184"/>
+            <a:ext cx="548640" cy="256032"/>
+          </a:xfrm>
+          <a:prstGeom prst="rect">
+            <a:avLst/>
+          </a:prstGeom>
+          <a:solidFill>
+            <a:srgbClr val="D72638"/>
+          </a:solidFill>
+          <a:ln w="12700">
+            <a:solidFill>
+              <a:srgbClr val="D72638"/>
+            </a:solidFill>
+            <a:prstDash val="solid"/>
+          </a:ln>
+        </p:spPr>
+      </p:sp>
+      <p:sp>
+        <p:nvSpPr>
+          <p:cNvPr id="41" name="Text 38"/>
+          <p:cNvSpPr/>
+          <p:nvPr/>
+        </p:nvSpPr>
+        <p:spPr>
+          <a:xfrm>
+            <a:off x="7571232" y="4901184"/>
+            <a:ext cx="548640" cy="256032"/>
+          </a:xfrm>
+          <a:prstGeom prst="rect">
+            <a:avLst/>
+          </a:prstGeom>
+          <a:noFill/>
+          <a:ln/>
+        </p:spPr>
+        <p:txBody>
+          <a:bodyPr wrap="square" lIns="0" tIns="0" rIns="0" bIns="0" rtlCol="0" anchor="ctr"/>
+          <a:lstStyle/>
+          <a:p>
+            <a:pPr algn="ctr" indent="0" marL="0">
+              <a:buNone/>
+            </a:pPr>
+            <a:r>
+              <a:rPr lang="en-US" sz="900" b="1" dirty="0">
+                <a:solidFill>
+                  <a:srgbClr val="FFFFFF"/>
+                </a:solidFill>
+                <a:latin typeface="맑은 고딕" pitchFamily="34" charset="0"/>
+                <a:ea typeface="맑은 고딕" pitchFamily="34" charset="-122"/>
+                <a:cs typeface="맑은 고딕" pitchFamily="34" charset="-120"/>
+              </a:rPr>
+              <a:t>긴급</a:t>
+            </a:r>
+            <a:endParaRPr lang="en-US" sz="900" dirty="0"/>
+          </a:p>
+        </p:txBody>
+      </p:sp>
+      <p:sp>
+        <p:nvSpPr>
+          <p:cNvPr id="42" name="Text 39"/>
+          <p:cNvSpPr/>
+          <p:nvPr/>
+        </p:nvSpPr>
+        <p:spPr>
+          <a:xfrm>
+            <a:off x="8211312" y="4864608"/>
+            <a:ext cx="3291840" cy="274320"/>
+          </a:xfrm>
+          <a:prstGeom prst="rect">
+            <a:avLst/>
+          </a:prstGeom>
+          <a:noFill/>
+          <a:ln/>
+        </p:spPr>
+        <p:txBody>
+          <a:bodyPr wrap="square" lIns="0" tIns="0" rIns="0" bIns="0" rtlCol="0" anchor="ctr"/>
+          <a:lstStyle/>
+          <a:p>
+            <a:pPr indent="0" marL="0">
+              <a:buNone/>
+            </a:pPr>
+            <a:r>
+              <a:rPr lang="en-US" sz="1000" b="1" dirty="0">
+                <a:solidFill>
+                  <a:srgbClr val="0B1220"/>
+                </a:solidFill>
+                <a:latin typeface="맑은 고딕" pitchFamily="34" charset="0"/>
+                <a:ea typeface="맑은 고딕" pitchFamily="34" charset="-122"/>
+                <a:cs typeface="맑은 고딕" pitchFamily="34" charset="-120"/>
+              </a:rPr>
               <a:t>Fuzzy Stripe Slippers (3color)</a:t>
             </a:r>
             <a:endParaRPr lang="en-US" sz="1000" dirty="0"/>
@@ -13018,13 +13238,13 @@
       </p:sp>
       <p:sp>
         <p:nvSpPr>
-          <p:cNvPr id="37" name="Text 34"/>
-          <p:cNvSpPr/>
-          <p:nvPr/>
-        </p:nvSpPr>
-        <p:spPr>
-          <a:xfrm>
-            <a:off x="8211312" y="4425696"/>
+          <p:cNvPr id="43" name="Text 40"/>
+          <p:cNvSpPr/>
+          <p:nvPr/>
+        </p:nvSpPr>
+        <p:spPr>
+          <a:xfrm>
+            <a:off x="8211312" y="5138928"/>
             <a:ext cx="3291840" cy="256032"/>
           </a:xfrm>
           <a:prstGeom prst="rect">
@@ -13085,13 +13305,13 @@
       </p:sp>
       <p:sp>
         <p:nvSpPr>
-          <p:cNvPr id="38" name="Shape 35"/>
-          <p:cNvSpPr/>
-          <p:nvPr/>
-        </p:nvSpPr>
-        <p:spPr>
-          <a:xfrm>
-            <a:off x="7406640" y="4809744"/>
+          <p:cNvPr id="44" name="Shape 41"/>
+          <p:cNvSpPr/>
+          <p:nvPr/>
+        </p:nvSpPr>
+        <p:spPr>
+          <a:xfrm>
+            <a:off x="7406640" y="5522976"/>
             <a:ext cx="4206240" cy="640080"/>
           </a:xfrm>
           <a:prstGeom prst="rect">
@@ -13110,13 +13330,13 @@
       </p:sp>
       <p:sp>
         <p:nvSpPr>
-          <p:cNvPr id="39" name="Shape 36"/>
-          <p:cNvSpPr/>
-          <p:nvPr/>
-        </p:nvSpPr>
-        <p:spPr>
-          <a:xfrm>
-            <a:off x="7406640" y="4809744"/>
+          <p:cNvPr id="45" name="Shape 42"/>
+          <p:cNvSpPr/>
+          <p:nvPr/>
+        </p:nvSpPr>
+        <p:spPr>
+          <a:xfrm>
+            <a:off x="7406640" y="5522976"/>
             <a:ext cx="109728" cy="640080"/>
           </a:xfrm>
           <a:prstGeom prst="rect">
@@ -13135,13 +13355,13 @@
       </p:sp>
       <p:sp>
         <p:nvSpPr>
-          <p:cNvPr id="40" name="Shape 37"/>
-          <p:cNvSpPr/>
-          <p:nvPr/>
-        </p:nvSpPr>
-        <p:spPr>
-          <a:xfrm>
-            <a:off x="7571232" y="4901184"/>
+          <p:cNvPr id="46" name="Shape 43"/>
+          <p:cNvSpPr/>
+          <p:nvPr/>
+        </p:nvSpPr>
+        <p:spPr>
+          <a:xfrm>
+            <a:off x="7571232" y="5614416"/>
             <a:ext cx="548640" cy="256032"/>
           </a:xfrm>
           <a:prstGeom prst="rect">
@@ -13160,13 +13380,13 @@
       </p:sp>
       <p:sp>
         <p:nvSpPr>
-          <p:cNvPr id="41" name="Text 38"/>
-          <p:cNvSpPr/>
-          <p:nvPr/>
-        </p:nvSpPr>
-        <p:spPr>
-          <a:xfrm>
-            <a:off x="7571232" y="4901184"/>
+          <p:cNvPr id="47" name="Text 44"/>
+          <p:cNvSpPr/>
+          <p:nvPr/>
+        </p:nvSpPr>
+        <p:spPr>
+          <a:xfrm>
+            <a:off x="7571232" y="5614416"/>
             <a:ext cx="548640" cy="256032"/>
           </a:xfrm>
           <a:prstGeom prst="rect">
@@ -13199,13 +13419,13 @@
       </p:sp>
       <p:sp>
         <p:nvSpPr>
-          <p:cNvPr id="42" name="Text 39"/>
-          <p:cNvSpPr/>
-          <p:nvPr/>
-        </p:nvSpPr>
-        <p:spPr>
-          <a:xfrm>
-            <a:off x="8211312" y="4864608"/>
+          <p:cNvPr id="48" name="Text 45"/>
+          <p:cNvSpPr/>
+          <p:nvPr/>
+        </p:nvSpPr>
+        <p:spPr>
+          <a:xfrm>
+            <a:off x="8211312" y="5577840"/>
             <a:ext cx="3291840" cy="274320"/>
           </a:xfrm>
           <a:prstGeom prst="rect">
@@ -13238,13 +13458,13 @@
       </p:sp>
       <p:sp>
         <p:nvSpPr>
-          <p:cNvPr id="43" name="Text 40"/>
-          <p:cNvSpPr/>
-          <p:nvPr/>
-        </p:nvSpPr>
-        <p:spPr>
-          <a:xfrm>
-            <a:off x="8211312" y="5138928"/>
+          <p:cNvPr id="49" name="Text 46"/>
+          <p:cNvSpPr/>
+          <p:nvPr/>
+        </p:nvSpPr>
+        <p:spPr>
+          <a:xfrm>
+            <a:off x="8211312" y="5852160"/>
             <a:ext cx="3291840" cy="256032"/>
           </a:xfrm>
           <a:prstGeom prst="rect">
@@ -13305,167 +13525,14 @@
       </p:sp>
       <p:sp>
         <p:nvSpPr>
-          <p:cNvPr id="44" name="Shape 41"/>
-          <p:cNvSpPr/>
-          <p:nvPr/>
-        </p:nvSpPr>
-        <p:spPr>
-          <a:xfrm>
-            <a:off x="7406640" y="5522976"/>
-            <a:ext cx="4206240" cy="640080"/>
-          </a:xfrm>
-          <a:prstGeom prst="rect">
-            <a:avLst/>
-          </a:prstGeom>
-          <a:solidFill>
-            <a:srgbClr val="FFF5F5"/>
-          </a:solidFill>
-          <a:ln w="6350">
-            <a:solidFill>
-              <a:srgbClr val="E5E7EB"/>
-            </a:solidFill>
-            <a:prstDash val="solid"/>
-          </a:ln>
-        </p:spPr>
-      </p:sp>
-      <p:sp>
-        <p:nvSpPr>
-          <p:cNvPr id="45" name="Shape 42"/>
-          <p:cNvSpPr/>
-          <p:nvPr/>
-        </p:nvSpPr>
-        <p:spPr>
-          <a:xfrm>
-            <a:off x="7406640" y="5522976"/>
-            <a:ext cx="109728" cy="640080"/>
-          </a:xfrm>
-          <a:prstGeom prst="rect">
-            <a:avLst/>
-          </a:prstGeom>
-          <a:solidFill>
-            <a:srgbClr val="D72638"/>
-          </a:solidFill>
-          <a:ln w="12700">
-            <a:solidFill>
-              <a:srgbClr val="D72638"/>
-            </a:solidFill>
-            <a:prstDash val="solid"/>
-          </a:ln>
-        </p:spPr>
-      </p:sp>
-      <p:sp>
-        <p:nvSpPr>
-          <p:cNvPr id="46" name="Shape 43"/>
-          <p:cNvSpPr/>
-          <p:nvPr/>
-        </p:nvSpPr>
-        <p:spPr>
-          <a:xfrm>
-            <a:off x="7571232" y="5614416"/>
-            <a:ext cx="548640" cy="256032"/>
-          </a:xfrm>
-          <a:prstGeom prst="rect">
-            <a:avLst/>
-          </a:prstGeom>
-          <a:solidFill>
-            <a:srgbClr val="D72638"/>
-          </a:solidFill>
-          <a:ln w="12700">
-            <a:solidFill>
-              <a:srgbClr val="D72638"/>
-            </a:solidFill>
-            <a:prstDash val="solid"/>
-          </a:ln>
-        </p:spPr>
-      </p:sp>
-      <p:sp>
-        <p:nvSpPr>
-          <p:cNvPr id="47" name="Text 44"/>
-          <p:cNvSpPr/>
-          <p:nvPr/>
-        </p:nvSpPr>
-        <p:spPr>
-          <a:xfrm>
-            <a:off x="7571232" y="5614416"/>
-            <a:ext cx="548640" cy="256032"/>
-          </a:xfrm>
-          <a:prstGeom prst="rect">
-            <a:avLst/>
-          </a:prstGeom>
-          <a:noFill/>
-          <a:ln/>
-        </p:spPr>
-        <p:txBody>
-          <a:bodyPr wrap="square" lIns="0" tIns="0" rIns="0" bIns="0" rtlCol="0" anchor="ctr"/>
-          <a:lstStyle/>
-          <a:p>
-            <a:pPr algn="ctr" indent="0" marL="0">
-              <a:buNone/>
-            </a:pPr>
-            <a:r>
-              <a:rPr lang="en-US" sz="900" b="1" dirty="0">
-                <a:solidFill>
-                  <a:srgbClr val="FFFFFF"/>
-                </a:solidFill>
-                <a:latin typeface="맑은 고딕" pitchFamily="34" charset="0"/>
-                <a:ea typeface="맑은 고딕" pitchFamily="34" charset="-122"/>
-                <a:cs typeface="맑은 고딕" pitchFamily="34" charset="-120"/>
-              </a:rPr>
-              <a:t>긴급</a:t>
-            </a:r>
-            <a:endParaRPr lang="en-US" sz="900" dirty="0"/>
-          </a:p>
-        </p:txBody>
-      </p:sp>
-      <p:sp>
-        <p:nvSpPr>
-          <p:cNvPr id="48" name="Text 45"/>
-          <p:cNvSpPr/>
-          <p:nvPr/>
-        </p:nvSpPr>
-        <p:spPr>
-          <a:xfrm>
-            <a:off x="8211312" y="5577840"/>
-            <a:ext cx="3291840" cy="274320"/>
-          </a:xfrm>
-          <a:prstGeom prst="rect">
-            <a:avLst/>
-          </a:prstGeom>
-          <a:noFill/>
-          <a:ln/>
-        </p:spPr>
-        <p:txBody>
-          <a:bodyPr wrap="square" lIns="0" tIns="0" rIns="0" bIns="0" rtlCol="0" anchor="ctr"/>
-          <a:lstStyle/>
-          <a:p>
-            <a:pPr indent="0" marL="0">
-              <a:buNone/>
-            </a:pPr>
-            <a:r>
-              <a:rPr lang="en-US" sz="1000" b="1" dirty="0">
-                <a:solidFill>
-                  <a:srgbClr val="0B1220"/>
-                </a:solidFill>
-                <a:latin typeface="맑은 고딕" pitchFamily="34" charset="0"/>
-                <a:ea typeface="맑은 고딕" pitchFamily="34" charset="-122"/>
-                <a:cs typeface="맑은 고딕" pitchFamily="34" charset="-120"/>
-              </a:rPr>
-              <a:t>Cotton Lunch Mini Bag (5color)</a:t>
-            </a:r>
-            <a:endParaRPr lang="en-US" sz="1000" dirty="0"/>
-          </a:p>
-        </p:txBody>
-      </p:sp>
-      <p:sp>
-        <p:nvSpPr>
-          <p:cNvPr id="49" name="Text 46"/>
-          <p:cNvSpPr/>
-          <p:nvPr/>
-        </p:nvSpPr>
-        <p:spPr>
-          <a:xfrm>
-            <a:off x="8211312" y="5852160"/>
-            <a:ext cx="3291840" cy="256032"/>
+          <p:cNvPr id="50" name="Text 47"/>
+          <p:cNvSpPr/>
+          <p:nvPr/>
+        </p:nvSpPr>
+        <p:spPr>
+          <a:xfrm>
+            <a:off x="548640" y="6492240"/>
+            <a:ext cx="7315200" cy="274320"/>
           </a:xfrm>
           <a:prstGeom prst="rect">
             <a:avLst/>
@@ -13489,74 +13556,7 @@
                 <a:ea typeface="맑은 고딕" pitchFamily="34" charset="-122"/>
                 <a:cs typeface="맑은 고딕" pitchFamily="34" charset="-120"/>
               </a:rPr>
-              <a:t>색상: 블랙  ·  재고 0개</a:t>
-            </a:r>
-            <a:pPr indent="0" marL="0">
-              <a:buNone/>
-            </a:pPr>
-            <a:r>
-              <a:rPr lang="en-US" sz="1000" dirty="0">
-                <a:solidFill>
-                  <a:srgbClr val="6B7280"/>
-                </a:solidFill>
-                <a:latin typeface="맑은 고딕" pitchFamily="34" charset="0"/>
-                <a:ea typeface="맑은 고딕" pitchFamily="34" charset="-122"/>
-                <a:cs typeface="맑은 고딕" pitchFamily="34" charset="-120"/>
-              </a:rPr>
-              <a:t/>
-            </a:r>
-            <a:pPr indent="0" marL="0">
-              <a:buNone/>
-            </a:pPr>
-            <a:r>
-              <a:rPr lang="en-US" sz="1000" b="1" dirty="0">
-                <a:solidFill>
-                  <a:srgbClr val="D72638"/>
-                </a:solidFill>
-                <a:latin typeface="맑은 고딕" pitchFamily="34" charset="0"/>
-                <a:ea typeface="맑은 고딕" pitchFamily="34" charset="-122"/>
-                <a:cs typeface="맑은 고딕" pitchFamily="34" charset="-120"/>
-              </a:rPr>
-              <a:t/>
-            </a:r>
-            <a:endParaRPr lang="en-US" sz="900" dirty="0"/>
-          </a:p>
-        </p:txBody>
-      </p:sp>
-      <p:sp>
-        <p:nvSpPr>
-          <p:cNvPr id="50" name="Text 47"/>
-          <p:cNvSpPr/>
-          <p:nvPr/>
-        </p:nvSpPr>
-        <p:spPr>
-          <a:xfrm>
-            <a:off x="548640" y="6492240"/>
-            <a:ext cx="7315200" cy="274320"/>
-          </a:xfrm>
-          <a:prstGeom prst="rect">
-            <a:avLst/>
-          </a:prstGeom>
-          <a:noFill/>
-          <a:ln/>
-        </p:spPr>
-        <p:txBody>
-          <a:bodyPr wrap="square" lIns="0" tIns="0" rIns="0" bIns="0" rtlCol="0" anchor="ctr"/>
-          <a:lstStyle/>
-          <a:p>
-            <a:pPr indent="0" marL="0">
-              <a:buNone/>
-            </a:pPr>
-            <a:r>
-              <a:rPr lang="en-US" sz="900" dirty="0">
-                <a:solidFill>
-                  <a:srgbClr val="6B7280"/>
-                </a:solidFill>
-                <a:latin typeface="맑은 고딕" pitchFamily="34" charset="0"/>
-                <a:ea typeface="맑은 고딕" pitchFamily="34" charset="-122"/>
-                <a:cs typeface="맑은 고딕" pitchFamily="34" charset="-120"/>
-              </a:rPr>
-              <a:t>베스트 상품 리포트  ·  생성 2026-06-01 08:00</a:t>
+              <a:t>베스트 상품 리포트  ·  생성 2026-06-02 08:00</a:t>
             </a:r>
             <a:endParaRPr lang="en-US" sz="900" dirty="0"/>
           </a:p>
@@ -13769,7 +13769,7 @@
                 <a:ea typeface="맑은 고딕" pitchFamily="34" charset="-122"/>
                 <a:cs typeface="맑은 고딕" pitchFamily="34" charset="-120"/>
               </a:rPr>
-              <a:t>2026년 06월 01일 (월)</a:t>
+              <a:t>2026년 06월 02일 (화)</a:t>
             </a:r>
             <a:endParaRPr lang="en-US" sz="1200" dirty="0"/>
           </a:p>
@@ -13897,7 +13897,7 @@
                 <a:ea typeface="맑은 고딕" pitchFamily="34" charset="-122"/>
                 <a:cs typeface="맑은 고딕" pitchFamily="34" charset="-120"/>
               </a:rPr>
-              <a:t>🚨  긴급 리오더 68건    ·    주의 리오더 9건    ·    오늘 발주 검토 필수</a:t>
+              <a:t>🚨  긴급 리오더 71건    ·    주의 리오더 7건    ·    오늘 발주 검토 필수</a:t>
             </a:r>
             <a:pPr indent="0" marL="0">
               <a:buNone/>
@@ -14527,7 +14527,7 @@
                           <a:ea typeface="맑은 고딕" pitchFamily="34" charset="-122"/>
                           <a:cs typeface="맑은 고딕" pitchFamily="34" charset="-120"/>
                         </a:rPr>
-                        <a:t>PR</a:t>
+                        <a:t>6A</a:t>
                       </a:r>
                       <a:endParaRPr lang="en-US" sz="1100" dirty="0">
                         <a:latin typeface="맑은 고딕" charset="0"/>
@@ -14595,7 +14595,7 @@
                           <a:ea typeface="맑은 고딕" pitchFamily="34" charset="-122"/>
                           <a:cs typeface="맑은 고딕" pitchFamily="34" charset="-120"/>
                         </a:rPr>
-                        <a:t>ELECTRONIC</a:t>
+                        <a:t>Ring</a:t>
                       </a:r>
                       <a:endParaRPr lang="en-US" sz="1000" dirty="0">
                         <a:latin typeface="맑은 고딕" charset="0"/>
@@ -14663,7 +14663,7 @@
                           <a:ea typeface="맑은 고딕" pitchFamily="34" charset="-122"/>
                           <a:cs typeface="맑은 고딕" pitchFamily="34" charset="-120"/>
                         </a:rPr>
-                        <a:t>Jacquard Fast Charging Cable (7color) (컬러: 블루 / 기종옵션: C-Apple 8pin / 길이: 2m)</a:t>
+                        <a:t>[SILVER925] Mustafakemalpaşa Ring (사이즈: 12호)</a:t>
                       </a:r>
                       <a:endParaRPr lang="en-US" sz="1100" dirty="0">
                         <a:latin typeface="맑은 고딕" charset="0"/>
@@ -14731,7 +14731,7 @@
                           <a:ea typeface="맑은 고딕" pitchFamily="34" charset="-122"/>
                           <a:cs typeface="맑은 고딕" pitchFamily="34" charset="-120"/>
                         </a:rPr>
-                        <a:t>3</a:t>
+                        <a:t>0</a:t>
                       </a:r>
                       <a:endParaRPr lang="en-US" sz="1100" dirty="0">
                         <a:latin typeface="맑은 고딕" charset="0"/>
@@ -14799,7 +14799,7 @@
                           <a:ea typeface="맑은 고딕" pitchFamily="34" charset="-122"/>
                           <a:cs typeface="맑은 고딕" pitchFamily="34" charset="-120"/>
                         </a:rPr>
-                        <a:t>6 개</a:t>
+                        <a:t>20 개</a:t>
                       </a:r>
                       <a:endParaRPr lang="en-US" sz="1100" dirty="0">
                         <a:latin typeface="맑은 고딕" charset="0"/>
@@ -14937,7 +14937,7 @@
                           <a:ea typeface="맑은 고딕" pitchFamily="34" charset="-122"/>
                           <a:cs typeface="맑은 고딕" pitchFamily="34" charset="-120"/>
                         </a:rPr>
-                        <a:t>PR</a:t>
+                        <a:t>CT</a:t>
                       </a:r>
                       <a:endParaRPr lang="en-US" sz="1100" dirty="0">
                         <a:latin typeface="맑은 고딕" charset="0"/>
@@ -15005,7 +15005,7 @@
                           <a:ea typeface="맑은 고딕" pitchFamily="34" charset="-122"/>
                           <a:cs typeface="맑은 고딕" pitchFamily="34" charset="-120"/>
                         </a:rPr>
-                        <a:t>ELECTRONIC</a:t>
+                        <a:t>Ring</a:t>
                       </a:r>
                       <a:endParaRPr lang="en-US" sz="1000" dirty="0">
                         <a:latin typeface="맑은 고딕" charset="0"/>
@@ -15073,7 +15073,7 @@
                           <a:ea typeface="맑은 고딕" pitchFamily="34" charset="-122"/>
                           <a:cs typeface="맑은 고딕" pitchFamily="34" charset="-120"/>
                         </a:rPr>
-                        <a:t>Jacquard Fast Charging Cable (7color) (컬러: 민트 / 기종옵션: C-Apple 8pin / 길이: 2m)</a:t>
+                        <a:t>"Ribbonwist" 925 Open Ring</a:t>
                       </a:r>
                       <a:endParaRPr lang="en-US" sz="1100" dirty="0">
                         <a:latin typeface="맑은 고딕" charset="0"/>
@@ -15209,7 +15209,7 @@
                           <a:ea typeface="맑은 고딕" pitchFamily="34" charset="-122"/>
                           <a:cs typeface="맑은 고딕" pitchFamily="34" charset="-120"/>
                         </a:rPr>
-                        <a:t>3 개</a:t>
+                        <a:t>5 개</a:t>
                       </a:r>
                       <a:endParaRPr lang="en-US" sz="1100" dirty="0">
                         <a:latin typeface="맑은 고딕" charset="0"/>
@@ -15347,7 +15347,7 @@
                           <a:ea typeface="맑은 고딕" pitchFamily="34" charset="-122"/>
                           <a:cs typeface="맑은 고딕" pitchFamily="34" charset="-120"/>
                         </a:rPr>
-                        <a:t>PR</a:t>
+                        <a:t>CT</a:t>
                       </a:r>
                       <a:endParaRPr lang="en-US" sz="1100" dirty="0">
                         <a:latin typeface="맑은 고딕" charset="0"/>
@@ -15415,7 +15415,7 @@
                           <a:ea typeface="맑은 고딕" pitchFamily="34" charset="-122"/>
                           <a:cs typeface="맑은 고딕" pitchFamily="34" charset="-120"/>
                         </a:rPr>
-                        <a:t>ELECTRONIC</a:t>
+                        <a:t>Ring</a:t>
                       </a:r>
                       <a:endParaRPr lang="en-US" sz="1000" dirty="0">
                         <a:latin typeface="맑은 고딕" charset="0"/>
@@ -15483,7 +15483,7 @@
                           <a:ea typeface="맑은 고딕" pitchFamily="34" charset="-122"/>
                           <a:cs typeface="맑은 고딕" pitchFamily="34" charset="-120"/>
                         </a:rPr>
-                        <a:t>Jacquard Fast Charging Cable (7color) (컬러: 퍼플 / 기종옵션: C-Apple 8pin / 길이: 2m)</a:t>
+                        <a:t>"Qrone" 925 Open Ring</a:t>
                       </a:r>
                       <a:endParaRPr lang="en-US" sz="1100" dirty="0">
                         <a:latin typeface="맑은 고딕" charset="0"/>
@@ -15551,7 +15551,7 @@
                           <a:ea typeface="맑은 고딕" pitchFamily="34" charset="-122"/>
                           <a:cs typeface="맑은 고딕" pitchFamily="34" charset="-120"/>
                         </a:rPr>
-                        <a:t>0</a:t>
+                        <a:t>5</a:t>
                       </a:r>
                       <a:endParaRPr lang="en-US" sz="1100" dirty="0">
                         <a:latin typeface="맑은 고딕" charset="0"/>
@@ -15961,7 +15961,7 @@
                           <a:ea typeface="맑은 고딕" pitchFamily="34" charset="-122"/>
                           <a:cs typeface="맑은 고딕" pitchFamily="34" charset="-120"/>
                         </a:rPr>
-                        <a:t>3</a:t>
+                        <a:t>0</a:t>
                       </a:r>
                       <a:endParaRPr lang="en-US" sz="1100" dirty="0">
                         <a:latin typeface="맑은 고딕" charset="0"/>
@@ -16029,7 +16029,7 @@
                           <a:ea typeface="맑은 고딕" pitchFamily="34" charset="-122"/>
                           <a:cs typeface="맑은 고딕" pitchFamily="34" charset="-120"/>
                         </a:rPr>
-                        <a:t>1 개</a:t>
+                        <a:t>3 개</a:t>
                       </a:r>
                       <a:endParaRPr lang="en-US" sz="1100" dirty="0">
                         <a:latin typeface="맑은 고딕" charset="0"/>
@@ -16167,7 +16167,7 @@
                           <a:ea typeface="맑은 고딕" pitchFamily="34" charset="-122"/>
                           <a:cs typeface="맑은 고딕" pitchFamily="34" charset="-120"/>
                         </a:rPr>
-                        <a:t>CT</a:t>
+                        <a:t>6A</a:t>
                       </a:r>
                       <a:endParaRPr lang="en-US" sz="1100" dirty="0">
                         <a:latin typeface="맑은 고딕" charset="0"/>
@@ -16235,7 +16235,7 @@
                           <a:ea typeface="맑은 고딕" pitchFamily="34" charset="-122"/>
                           <a:cs typeface="맑은 고딕" pitchFamily="34" charset="-120"/>
                         </a:rPr>
-                        <a:t>Ring</a:t>
+                        <a:t>Bracelet</a:t>
                       </a:r>
                       <a:endParaRPr lang="en-US" sz="1000" dirty="0">
                         <a:latin typeface="맑은 고딕" charset="0"/>
@@ -16303,7 +16303,7 @@
                           <a:ea typeface="맑은 고딕" pitchFamily="34" charset="-122"/>
                           <a:cs typeface="맑은 고딕" pitchFamily="34" charset="-120"/>
                         </a:rPr>
-                        <a:t>"Giethoorn" 925 Open Ring</a:t>
+                        <a:t>Phorn Bracelet</a:t>
                       </a:r>
                       <a:endParaRPr lang="en-US" sz="1100" dirty="0">
                         <a:latin typeface="맑은 고딕" charset="0"/>
@@ -16371,7 +16371,7 @@
                           <a:ea typeface="맑은 고딕" pitchFamily="34" charset="-122"/>
                           <a:cs typeface="맑은 고딕" pitchFamily="34" charset="-120"/>
                         </a:rPr>
-                        <a:t>0</a:t>
+                        <a:t>5</a:t>
                       </a:r>
                       <a:endParaRPr lang="en-US" sz="1100" dirty="0">
                         <a:latin typeface="맑은 고딕" charset="0"/>
@@ -16439,7 +16439,7 @@
                           <a:ea typeface="맑은 고딕" pitchFamily="34" charset="-122"/>
                           <a:cs typeface="맑은 고딕" pitchFamily="34" charset="-120"/>
                         </a:rPr>
-                        <a:t>1 개</a:t>
+                        <a:t>2 개</a:t>
                       </a:r>
                       <a:endParaRPr lang="en-US" sz="1100" dirty="0">
                         <a:latin typeface="맑은 고딕" charset="0"/>
@@ -16577,7 +16577,7 @@
                           <a:ea typeface="맑은 고딕" pitchFamily="34" charset="-122"/>
                           <a:cs typeface="맑은 고딕" pitchFamily="34" charset="-120"/>
                         </a:rPr>
-                        <a:t>PR</a:t>
+                        <a:t>CT</a:t>
                       </a:r>
                       <a:endParaRPr lang="en-US" sz="1100" dirty="0">
                         <a:latin typeface="맑은 고딕" charset="0"/>
@@ -16645,7 +16645,7 @@
                           <a:ea typeface="맑은 고딕" pitchFamily="34" charset="-122"/>
                           <a:cs typeface="맑은 고딕" pitchFamily="34" charset="-120"/>
                         </a:rPr>
-                        <a:t>★ Last Sale ★</a:t>
+                        <a:t>Ring</a:t>
                       </a:r>
                       <a:endParaRPr lang="en-US" sz="1000" dirty="0">
                         <a:latin typeface="맑은 고딕" charset="0"/>
@@ -16713,7 +16713,7 @@
                           <a:ea typeface="맑은 고딕" pitchFamily="34" charset="-122"/>
                           <a:cs typeface="맑은 고딕" pitchFamily="34" charset="-120"/>
                         </a:rPr>
-                        <a:t>Cloud Grip Glass Mini Brush (3color) (컬러: 스카이블루)</a:t>
+                        <a:t>"Mlayer" 925 Open Ring</a:t>
                       </a:r>
                       <a:endParaRPr lang="en-US" sz="1100" dirty="0">
                         <a:latin typeface="맑은 고딕" charset="0"/>
@@ -16781,7 +16781,7 @@
                           <a:ea typeface="맑은 고딕" pitchFamily="34" charset="-122"/>
                           <a:cs typeface="맑은 고딕" pitchFamily="34" charset="-120"/>
                         </a:rPr>
-                        <a:t>11</a:t>
+                        <a:t>0</a:t>
                       </a:r>
                       <a:endParaRPr lang="en-US" sz="1100" dirty="0">
                         <a:latin typeface="맑은 고딕" charset="0"/>
@@ -16849,7 +16849,7 @@
                           <a:ea typeface="맑은 고딕" pitchFamily="34" charset="-122"/>
                           <a:cs typeface="맑은 고딕" pitchFamily="34" charset="-120"/>
                         </a:rPr>
-                        <a:t>1 개</a:t>
+                        <a:t>2 개</a:t>
                       </a:r>
                       <a:endParaRPr lang="en-US" sz="1100" dirty="0">
                         <a:latin typeface="맑은 고딕" charset="0"/>
@@ -16987,7 +16987,7 @@
                           <a:ea typeface="맑은 고딕" pitchFamily="34" charset="-122"/>
                           <a:cs typeface="맑은 고딕" pitchFamily="34" charset="-120"/>
                         </a:rPr>
-                        <a:t>6A</a:t>
+                        <a:t>PR</a:t>
                       </a:r>
                       <a:endParaRPr lang="en-US" sz="1100" dirty="0">
                         <a:latin typeface="맑은 고딕" charset="0"/>
@@ -17055,7 +17055,7 @@
                           <a:ea typeface="맑은 고딕" pitchFamily="34" charset="-122"/>
                           <a:cs typeface="맑은 고딕" pitchFamily="34" charset="-120"/>
                         </a:rPr>
-                        <a:t>★Season off★</a:t>
+                        <a:t>ETC</a:t>
                       </a:r>
                       <a:endParaRPr lang="en-US" sz="1000" dirty="0">
                         <a:latin typeface="맑은 고딕" charset="0"/>
@@ -17123,7 +17123,7 @@
                           <a:ea typeface="맑은 고딕" pitchFamily="34" charset="-122"/>
                           <a:cs typeface="맑은 고딕" pitchFamily="34" charset="-120"/>
                         </a:rPr>
-                        <a:t>8-Ball Smart Tok</a:t>
+                        <a:t>360° Rotating Phone Holder (컬러: 블랙)</a:t>
                       </a:r>
                       <a:endParaRPr lang="en-US" sz="1100" dirty="0">
                         <a:latin typeface="맑은 고딕" charset="0"/>
@@ -17191,7 +17191,7 @@
                           <a:ea typeface="맑은 고딕" pitchFamily="34" charset="-122"/>
                           <a:cs typeface="맑은 고딕" pitchFamily="34" charset="-120"/>
                         </a:rPr>
-                        <a:t>4</a:t>
+                        <a:t>10</a:t>
                       </a:r>
                       <a:endParaRPr lang="en-US" sz="1100" dirty="0">
                         <a:latin typeface="맑은 고딕" charset="0"/>
@@ -17259,7 +17259,7 @@
                           <a:ea typeface="맑은 고딕" pitchFamily="34" charset="-122"/>
                           <a:cs typeface="맑은 고딕" pitchFamily="34" charset="-120"/>
                         </a:rPr>
-                        <a:t>0 개</a:t>
+                        <a:t>2 개</a:t>
                       </a:r>
                       <a:endParaRPr lang="en-US" sz="1100" dirty="0">
                         <a:latin typeface="맑은 고딕" charset="0"/>
@@ -17397,7 +17397,7 @@
                           <a:ea typeface="맑은 고딕" pitchFamily="34" charset="-122"/>
                           <a:cs typeface="맑은 고딕" pitchFamily="34" charset="-120"/>
                         </a:rPr>
-                        <a:t>6A</a:t>
+                        <a:t>PR</a:t>
                       </a:r>
                       <a:endParaRPr lang="en-US" sz="1100" dirty="0">
                         <a:latin typeface="맑은 고딕" charset="0"/>
@@ -17465,7 +17465,7 @@
                           <a:ea typeface="맑은 고딕" pitchFamily="34" charset="-122"/>
                           <a:cs typeface="맑은 고딕" pitchFamily="34" charset="-120"/>
                         </a:rPr>
-                        <a:t>Bracelet</a:t>
+                        <a:t>ETC</a:t>
                       </a:r>
                       <a:endParaRPr lang="en-US" sz="1000" dirty="0">
                         <a:latin typeface="맑은 고딕" charset="0"/>
@@ -17533,7 +17533,7 @@
                           <a:ea typeface="맑은 고딕" pitchFamily="34" charset="-122"/>
                           <a:cs typeface="맑은 고딕" pitchFamily="34" charset="-120"/>
                         </a:rPr>
-                        <a:t>Two-ball Bangle</a:t>
+                        <a:t>360° Rotating Phone Holder (컬러: 화이트)</a:t>
                       </a:r>
                       <a:endParaRPr lang="en-US" sz="1100" dirty="0">
                         <a:latin typeface="맑은 고딕" charset="0"/>
@@ -17601,7 +17601,7 @@
                           <a:ea typeface="맑은 고딕" pitchFamily="34" charset="-122"/>
                           <a:cs typeface="맑은 고딕" pitchFamily="34" charset="-120"/>
                         </a:rPr>
-                        <a:t>0</a:t>
+                        <a:t>1</a:t>
                       </a:r>
                       <a:endParaRPr lang="en-US" sz="1100" dirty="0">
                         <a:latin typeface="맑은 고딕" charset="0"/>
@@ -17669,7 +17669,7 @@
                           <a:ea typeface="맑은 고딕" pitchFamily="34" charset="-122"/>
                           <a:cs typeface="맑은 고딕" pitchFamily="34" charset="-120"/>
                         </a:rPr>
-                        <a:t>0 개</a:t>
+                        <a:t>2 개</a:t>
                       </a:r>
                       <a:endParaRPr lang="en-US" sz="1100" dirty="0">
                         <a:latin typeface="맑은 고딕" charset="0"/>
@@ -17807,7 +17807,7 @@
                           <a:ea typeface="맑은 고딕" pitchFamily="34" charset="-122"/>
                           <a:cs typeface="맑은 고딕" pitchFamily="34" charset="-120"/>
                         </a:rPr>
-                        <a:t>6A</a:t>
+                        <a:t>CT</a:t>
                       </a:r>
                       <a:endParaRPr lang="en-US" sz="1100" dirty="0">
                         <a:latin typeface="맑은 고딕" charset="0"/>
@@ -17943,7 +17943,7 @@
                           <a:ea typeface="맑은 고딕" pitchFamily="34" charset="-122"/>
                           <a:cs typeface="맑은 고딕" pitchFamily="34" charset="-120"/>
                         </a:rPr>
-                        <a:t>[SILVER925] Crimson Open Ring</a:t>
+                        <a:t>"Crackave" 925 Open Ring</a:t>
                       </a:r>
                       <a:endParaRPr lang="en-US" sz="1100" dirty="0">
                         <a:latin typeface="맑은 고딕" charset="0"/>
@@ -18079,7 +18079,7 @@
                           <a:ea typeface="맑은 고딕" pitchFamily="34" charset="-122"/>
                           <a:cs typeface="맑은 고딕" pitchFamily="34" charset="-120"/>
                         </a:rPr>
-                        <a:t>0 개</a:t>
+                        <a:t>1 개</a:t>
                       </a:r>
                       <a:endParaRPr lang="en-US" sz="1100" dirty="0">
                         <a:latin typeface="맑은 고딕" charset="0"/>
@@ -18168,7 +18168,7 @@
                 <a:ea typeface="맑은 고딕" pitchFamily="34" charset="-122"/>
                 <a:cs typeface="맑은 고딕" pitchFamily="34" charset="-120"/>
               </a:rPr>
-              <a:t>외 59건 더 있음 — 상세는 시트에서 확인</a:t>
+              <a:t>외 62건 더 있음 — 상세는 시트에서 확인</a:t>
             </a:r>
             <a:endParaRPr lang="en-US" sz="1000" dirty="0"/>
           </a:p>
@@ -18207,7 +18207,7 @@
                 <a:ea typeface="맑은 고딕" pitchFamily="34" charset="-122"/>
                 <a:cs typeface="맑은 고딕" pitchFamily="34" charset="-120"/>
               </a:rPr>
-              <a:t>베스트 상품 리포트  ·  생성 2026-06-01 08:00</a:t>
+              <a:t>베스트 상품 리포트  ·  생성 2026-06-02 08:00</a:t>
             </a:r>
             <a:endParaRPr lang="en-US" sz="900" dirty="0"/>
           </a:p>
@@ -18420,7 +18420,7 @@
                 <a:ea typeface="맑은 고딕" pitchFamily="34" charset="-122"/>
                 <a:cs typeface="맑은 고딕" pitchFamily="34" charset="-120"/>
               </a:rPr>
-              <a:t>2026년 06월 01일 (월)</a:t>
+              <a:t>2026년 06월 02일 (화)</a:t>
             </a:r>
             <a:endParaRPr lang="en-US" sz="1200" dirty="0"/>
           </a:p>
@@ -18587,7 +18587,7 @@
                 <a:ea typeface="맑은 고딕" pitchFamily="34" charset="-122"/>
                 <a:cs typeface="맑은 고딕" pitchFamily="34" charset="-120"/>
               </a:rPr>
-              <a:t>Google Sheet '브랜드 재고현황'  ·  최신화 2026-06-01 08:00</a:t>
+              <a:t>Google Sheet '브랜드 재고현황'  ·  최신화 2026-06-02 08:00</a:t>
             </a:r>
             <a:endParaRPr lang="en-US" sz="1100" dirty="0"/>
           </a:p>
@@ -19099,7 +19099,7 @@
                 <a:ea typeface="맑은 고딕" pitchFamily="34" charset="-122"/>
                 <a:cs typeface="맑은 고딕" pitchFamily="34" charset="-120"/>
               </a:rPr>
-              <a:t>✅ 6A 100 SKU  /  ✅ Cleartype 59 SKU  /  ✅ Produktepr 200 SKU (판매 수집됨)</a:t>
+              <a:t>✅ 6A 100 SKU  /  ✅ Cleartype 59 SKU  /  ✅ Produktepr 201 SKU (판매 수집됨)</a:t>
             </a:r>
             <a:endParaRPr lang="en-US" sz="1100" dirty="0"/>
           </a:p>
@@ -19230,7 +19230,7 @@
                 <a:ea typeface="맑은 고딕" pitchFamily="34" charset="-122"/>
                 <a:cs typeface="맑은 고딕" pitchFamily="34" charset="-120"/>
               </a:rPr>
-              <a:t>✅ 3개 브랜드 모두 정상 추출  ·  24h 출고 기준 (2026-05-31 08:00 → 2026-06-01 08:00) · 신규 SKU 14건은 결제완료 기준</a:t>
+              <a:t>✅ 3개 브랜드 모두 정상 추출  ·  24h 출고 기준 (2026-06-01 08:00 → 2026-06-02 08:00) · 신규 SKU 15건은 결제완료 기준</a:t>
             </a:r>
             <a:endParaRPr lang="en-US" sz="1000" dirty="0"/>
           </a:p>
@@ -19269,7 +19269,7 @@
                 <a:ea typeface="맑은 고딕" pitchFamily="34" charset="-122"/>
                 <a:cs typeface="맑은 고딕" pitchFamily="34" charset="-120"/>
               </a:rPr>
-              <a:t>베스트 상품 리포트  ·  생성 2026-06-01 08:00</a:t>
+              <a:t>베스트 상품 리포트  ·  생성 2026-06-02 08:00</a:t>
             </a:r>
             <a:endParaRPr lang="en-US" sz="900" dirty="0"/>
           </a:p>

</xml_diff>

<commit_message>
chore: 매출 PPT 업로드 (best-sellers-2026-06-03.pptx) [auto]
</commit_message>
<xml_diff>
--- a/data/sales-report.pptx
+++ b/data/sales-report.pptx
@@ -1648,7 +1648,7 @@
                 <a:ea typeface="맑은 고딕" pitchFamily="34" charset="-122"/>
                 <a:cs typeface="맑은 고딕" pitchFamily="34" charset="-120"/>
               </a:rPr>
-              <a:t>2026년 06월 02일 (화)  ·  24h 출고 기준</a:t>
+              <a:t>2026년 06월 03일 (수)  ·  24h 출고 기준</a:t>
             </a:r>
             <a:endParaRPr lang="en-US" sz="2200" dirty="0"/>
           </a:p>
@@ -1726,7 +1726,7 @@
                 <a:ea typeface="맑은 고딕" pitchFamily="34" charset="-122"/>
                 <a:cs typeface="맑은 고딕" pitchFamily="34" charset="-120"/>
               </a:rPr>
-              <a:t>06.02</a:t>
+              <a:t>06.03</a:t>
             </a:r>
             <a:endParaRPr lang="en-US" sz="7200" dirty="0"/>
           </a:p>
@@ -1765,7 +1765,7 @@
                 <a:ea typeface="맑은 고딕" pitchFamily="34" charset="-122"/>
                 <a:cs typeface="맑은 고딕" pitchFamily="34" charset="-120"/>
               </a:rPr>
-              <a:t>화요일</a:t>
+              <a:t>수요일</a:t>
             </a:r>
             <a:endParaRPr lang="en-US" sz="1400" dirty="0"/>
           </a:p>
@@ -1804,7 +1804,7 @@
                 <a:ea typeface="맑은 고딕" pitchFamily="34" charset="-122"/>
                 <a:cs typeface="맑은 고딕" pitchFamily="34" charset="-120"/>
               </a:rPr>
-              <a:t>생성 2026-06-02 08:00  ·  Google Sheet 자동 동기</a:t>
+              <a:t>생성 2026-06-03 08:00  ·  Google Sheet 자동 동기</a:t>
             </a:r>
             <a:endParaRPr lang="en-US" sz="1000" dirty="0"/>
           </a:p>
@@ -1978,7 +1978,7 @@
                 <a:ea typeface="맑은 고딕" pitchFamily="34" charset="-122"/>
                 <a:cs typeface="맑은 고딕" pitchFamily="34" charset="-120"/>
               </a:rPr>
-              <a:t>2026년 06월 02일 (화)</a:t>
+              <a:t>2026년 06월 03일 (수)</a:t>
             </a:r>
             <a:endParaRPr lang="en-US" sz="1200" dirty="0"/>
           </a:p>
@@ -2145,7 +2145,7 @@
                 <a:ea typeface="맑은 고딕" pitchFamily="34" charset="-122"/>
                 <a:cs typeface="맑은 고딕" pitchFamily="34" charset="-120"/>
               </a:rPr>
-              <a:t>693 개</a:t>
+              <a:t>482 개</a:t>
             </a:r>
             <a:endParaRPr lang="en-US" sz="3600" dirty="0"/>
           </a:p>
@@ -2312,7 +2312,7 @@
                 <a:ea typeface="맑은 고딕" pitchFamily="34" charset="-122"/>
                 <a:cs typeface="맑은 고딕" pitchFamily="34" charset="-120"/>
               </a:rPr>
-              <a:t>71 건</a:t>
+              <a:t>68 건</a:t>
             </a:r>
             <a:endParaRPr lang="en-US" sz="3200" dirty="0"/>
           </a:p>
@@ -2479,7 +2479,7 @@
                 <a:ea typeface="맑은 고딕" pitchFamily="34" charset="-122"/>
                 <a:cs typeface="맑은 고딕" pitchFamily="34" charset="-120"/>
               </a:rPr>
-              <a:t>7 건</a:t>
+              <a:t>6 건</a:t>
             </a:r>
             <a:endParaRPr lang="en-US" sz="3200" dirty="0"/>
           </a:p>
@@ -2685,7 +2685,7 @@
                 <a:ea typeface="맑은 고딕" pitchFamily="34" charset="-122"/>
                 <a:cs typeface="맑은 고딕" pitchFamily="34" charset="-120"/>
               </a:rPr>
-              <a:t>100 SKU  ·  판매 OK</a:t>
+              <a:t>99 SKU  ·  판매 OK</a:t>
             </a:r>
             <a:pPr indent="0" marL="0">
               <a:buNone/>
@@ -2827,7 +2827,7 @@
                 <a:ea typeface="맑은 고딕" pitchFamily="34" charset="-122"/>
                 <a:cs typeface="맑은 고딕" pitchFamily="34" charset="-120"/>
               </a:rPr>
-              <a:t>59 SKU  ·  판매 OK</a:t>
+              <a:t>60 SKU  ·  판매 OK</a:t>
             </a:r>
             <a:pPr indent="0" marL="0">
               <a:buNone/>
@@ -3612,7 +3612,7 @@
                           <a:ea typeface="맑은 고딕" pitchFamily="34" charset="-122"/>
                           <a:cs typeface="맑은 고딕" pitchFamily="34" charset="-120"/>
                         </a:rPr>
-                        <a:t>[SILVER925] Mustafakemalpaşa Ring (사이즈: 22호)</a:t>
+                        <a:t>[SILVER925] CH.alban Open Ring</a:t>
                       </a:r>
                       <a:endParaRPr lang="en-US" sz="1100" dirty="0">
                         <a:latin typeface="맑은 고딕" charset="0"/>
@@ -3677,7 +3677,7 @@
                           <a:ea typeface="맑은 고딕" pitchFamily="34" charset="-122"/>
                           <a:cs typeface="맑은 고딕" pitchFamily="34" charset="-120"/>
                         </a:rPr>
-                        <a:t>265 개</a:t>
+                        <a:t>58 개</a:t>
                       </a:r>
                       <a:endParaRPr lang="en-US" sz="1400" dirty="0">
                         <a:latin typeface="맑은 고딕" charset="0"/>
@@ -3939,7 +3939,7 @@
                           <a:ea typeface="맑은 고딕" pitchFamily="34" charset="-122"/>
                           <a:cs typeface="맑은 고딕" pitchFamily="34" charset="-120"/>
                         </a:rPr>
-                        <a:t>[SILVER925] CH.alban Open Ring</a:t>
+                        <a:t>[SILVER925] Guyeong Open Ring v3.0 (silver)</a:t>
                       </a:r>
                       <a:endParaRPr lang="en-US" sz="1100" dirty="0">
                         <a:latin typeface="맑은 고딕" charset="0"/>
@@ -4004,7 +4004,7 @@
                           <a:ea typeface="맑은 고딕" pitchFamily="34" charset="-122"/>
                           <a:cs typeface="맑은 고딕" pitchFamily="34" charset="-120"/>
                         </a:rPr>
-                        <a:t>44 개</a:t>
+                        <a:t>51 개</a:t>
                       </a:r>
                       <a:endParaRPr lang="en-US" sz="1400" dirty="0">
                         <a:latin typeface="맑은 고딕" charset="0"/>
@@ -4266,7 +4266,7 @@
                           <a:ea typeface="맑은 고딕" pitchFamily="34" charset="-122"/>
                           <a:cs typeface="맑은 고딕" pitchFamily="34" charset="-120"/>
                         </a:rPr>
-                        <a:t>[SILVER925] Guyeong Open Ring v3.0 (silver)</a:t>
+                        <a:t>[SILVER925] Eramam Open Ring</a:t>
                       </a:r>
                       <a:endParaRPr lang="en-US" sz="1100" dirty="0">
                         <a:latin typeface="맑은 고딕" charset="0"/>
@@ -4331,7 +4331,7 @@
                           <a:ea typeface="맑은 고딕" pitchFamily="34" charset="-122"/>
                           <a:cs typeface="맑은 고딕" pitchFamily="34" charset="-120"/>
                         </a:rPr>
-                        <a:t>31 개</a:t>
+                        <a:t>21 개</a:t>
                       </a:r>
                       <a:endParaRPr lang="en-US" sz="1400" dirty="0">
                         <a:latin typeface="맑은 고딕" charset="0"/>
@@ -4593,7 +4593,7 @@
                           <a:ea typeface="맑은 고딕" pitchFamily="34" charset="-122"/>
                           <a:cs typeface="맑은 고딕" pitchFamily="34" charset="-120"/>
                         </a:rPr>
-                        <a:t>CandyPOP Necklace (사이즈: 2size (47~52cm))</a:t>
+                        <a:t>CandyPOP Necklace (사이즈: 1size (37~43cm))</a:t>
                       </a:r>
                       <a:endParaRPr lang="en-US" sz="1100" dirty="0">
                         <a:latin typeface="맑은 고딕" charset="0"/>
@@ -4658,7 +4658,7 @@
                           <a:ea typeface="맑은 고딕" pitchFamily="34" charset="-122"/>
                           <a:cs typeface="맑은 고딕" pitchFamily="34" charset="-120"/>
                         </a:rPr>
-                        <a:t>31 개</a:t>
+                        <a:t>21 개</a:t>
                       </a:r>
                       <a:endParaRPr lang="en-US" sz="1200" dirty="0">
                         <a:latin typeface="맑은 고딕" charset="0"/>
@@ -4790,7 +4790,7 @@
                           <a:ea typeface="맑은 고딕" pitchFamily="34" charset="-122"/>
                           <a:cs typeface="맑은 고딕" pitchFamily="34" charset="-120"/>
                         </a:rPr>
-                        <a:t>CT</a:t>
+                        <a:t>6A</a:t>
                       </a:r>
                       <a:endParaRPr lang="en-US" sz="1100" dirty="0">
                         <a:latin typeface="맑은 고딕" charset="0"/>
@@ -4920,7 +4920,7 @@
                           <a:ea typeface="맑은 고딕" pitchFamily="34" charset="-122"/>
                           <a:cs typeface="맑은 고딕" pitchFamily="34" charset="-120"/>
                         </a:rPr>
-                        <a:t>CandyPOP Necklace (사이즈: 1size (37~43cm))</a:t>
+                        <a:t>Marquise Necklace</a:t>
                       </a:r>
                       <a:endParaRPr lang="en-US" sz="1100" dirty="0">
                         <a:latin typeface="맑은 고딕" charset="0"/>
@@ -4985,7 +4985,7 @@
                           <a:ea typeface="맑은 고딕" pitchFamily="34" charset="-122"/>
                           <a:cs typeface="맑은 고딕" pitchFamily="34" charset="-120"/>
                         </a:rPr>
-                        <a:t>28 개</a:t>
+                        <a:t>19 개</a:t>
                       </a:r>
                       <a:endParaRPr lang="en-US" sz="1200" dirty="0">
                         <a:latin typeface="맑은 고딕" charset="0"/>
@@ -5071,7 +5071,7 @@
                 <a:ea typeface="맑은 고딕" pitchFamily="34" charset="-122"/>
                 <a:cs typeface="맑은 고딕" pitchFamily="34" charset="-120"/>
               </a:rPr>
-              <a:t>베스트 상품 리포트  ·  생성 2026-06-02 08:00</a:t>
+              <a:t>베스트 상품 리포트  ·  생성 2026-06-03 08:00</a:t>
             </a:r>
             <a:endParaRPr lang="en-US" sz="900" dirty="0"/>
           </a:p>
@@ -5284,7 +5284,7 @@
                 <a:ea typeface="맑은 고딕" pitchFamily="34" charset="-122"/>
                 <a:cs typeface="맑은 고딕" pitchFamily="34" charset="-120"/>
               </a:rPr>
-              <a:t>2026년 06월 02일 (화)</a:t>
+              <a:t>2026년 06월 03일 (수)</a:t>
             </a:r>
             <a:endParaRPr lang="en-US" sz="1200" dirty="0"/>
           </a:p>
@@ -5451,7 +5451,7 @@
                 <a:ea typeface="맑은 고딕" pitchFamily="34" charset="-122"/>
                 <a:cs typeface="맑은 고딕" pitchFamily="34" charset="-120"/>
               </a:rPr>
-              <a:t>563 개</a:t>
+              <a:t>397 개</a:t>
             </a:r>
             <a:endParaRPr lang="en-US" sz="3600" dirty="0"/>
           </a:p>
@@ -5579,7 +5579,7 @@
                 <a:ea typeface="맑은 고딕" pitchFamily="34" charset="-122"/>
                 <a:cs typeface="맑은 고딕" pitchFamily="34" charset="-120"/>
               </a:rPr>
-              <a:t>[SILVER925] Mustafakemalpaşa Ring (사이즈: 22호)</a:t>
+              <a:t>[SILVER925] CH.alban Open Ring</a:t>
             </a:r>
             <a:endParaRPr lang="en-US" sz="1800" dirty="0"/>
           </a:p>
@@ -5657,7 +5657,7 @@
                 <a:ea typeface="맑은 고딕" pitchFamily="34" charset="-122"/>
                 <a:cs typeface="맑은 고딕" pitchFamily="34" charset="-120"/>
               </a:rPr>
-              <a:t>265</a:t>
+              <a:t>58</a:t>
             </a:r>
             <a:endParaRPr lang="en-US" sz="4400" dirty="0"/>
           </a:p>
@@ -6191,7 +6191,7 @@
                           <a:ea typeface="맑은 고딕" pitchFamily="34" charset="-122"/>
                           <a:cs typeface="맑은 고딕" pitchFamily="34" charset="-120"/>
                         </a:rPr>
-                        <a:t>[SILVER925] Mustafakemalpaşa Ring (사이즈: 22호)</a:t>
+                        <a:t>[SILVER925] CH.alban Open Ring</a:t>
                       </a:r>
                       <a:endParaRPr lang="en-US" sz="1100" dirty="0">
                         <a:latin typeface="맑은 고딕" charset="0"/>
@@ -6256,7 +6256,7 @@
                           <a:ea typeface="맑은 고딕" pitchFamily="34" charset="-122"/>
                           <a:cs typeface="맑은 고딕" pitchFamily="34" charset="-120"/>
                         </a:rPr>
-                        <a:t>265 개</a:t>
+                        <a:t>58 개</a:t>
                       </a:r>
                       <a:endParaRPr lang="en-US" sz="1400" dirty="0">
                         <a:latin typeface="맑은 고딕" charset="0"/>
@@ -6453,7 +6453,7 @@
                           <a:ea typeface="맑은 고딕" pitchFamily="34" charset="-122"/>
                           <a:cs typeface="맑은 고딕" pitchFamily="34" charset="-120"/>
                         </a:rPr>
-                        <a:t>[SILVER925] CH.alban Open Ring</a:t>
+                        <a:t>[SILVER925] Guyeong Open Ring v3.0 (silver)</a:t>
                       </a:r>
                       <a:endParaRPr lang="en-US" sz="1100" dirty="0">
                         <a:latin typeface="맑은 고딕" charset="0"/>
@@ -6518,7 +6518,7 @@
                           <a:ea typeface="맑은 고딕" pitchFamily="34" charset="-122"/>
                           <a:cs typeface="맑은 고딕" pitchFamily="34" charset="-120"/>
                         </a:rPr>
-                        <a:t>44 개</a:t>
+                        <a:t>51 개</a:t>
                       </a:r>
                       <a:endParaRPr lang="en-US" sz="1200" dirty="0">
                         <a:latin typeface="맑은 고딕" charset="0"/>
@@ -6715,7 +6715,7 @@
                           <a:ea typeface="맑은 고딕" pitchFamily="34" charset="-122"/>
                           <a:cs typeface="맑은 고딕" pitchFamily="34" charset="-120"/>
                         </a:rPr>
-                        <a:t>[SILVER925] Guyeong Open Ring v3.0 (silver)</a:t>
+                        <a:t>[SILVER925] Eramam Open Ring</a:t>
                       </a:r>
                       <a:endParaRPr lang="en-US" sz="1100" dirty="0">
                         <a:latin typeface="맑은 고딕" charset="0"/>
@@ -6780,7 +6780,7 @@
                           <a:ea typeface="맑은 고딕" pitchFamily="34" charset="-122"/>
                           <a:cs typeface="맑은 고딕" pitchFamily="34" charset="-120"/>
                         </a:rPr>
-                        <a:t>31 개</a:t>
+                        <a:t>21 개</a:t>
                       </a:r>
                       <a:endParaRPr lang="en-US" sz="1200" dirty="0">
                         <a:latin typeface="맑은 고딕" charset="0"/>
@@ -6912,7 +6912,7 @@
                           <a:ea typeface="맑은 고딕" pitchFamily="34" charset="-122"/>
                           <a:cs typeface="맑은 고딕" pitchFamily="34" charset="-120"/>
                         </a:rPr>
-                        <a:t>Ring</a:t>
+                        <a:t>Necklace</a:t>
                       </a:r>
                       <a:endParaRPr lang="en-US" sz="1000" dirty="0">
                         <a:latin typeface="맑은 고딕" charset="0"/>
@@ -6977,7 +6977,7 @@
                           <a:ea typeface="맑은 고딕" pitchFamily="34" charset="-122"/>
                           <a:cs typeface="맑은 고딕" pitchFamily="34" charset="-120"/>
                         </a:rPr>
-                        <a:t>[SILVER925] Mustafakemalpaşa Ring (사이즈: 12호)</a:t>
+                        <a:t>Marquise Necklace</a:t>
                       </a:r>
                       <a:endParaRPr lang="en-US" sz="1100" dirty="0">
                         <a:latin typeface="맑은 고딕" charset="0"/>
@@ -7042,7 +7042,7 @@
                           <a:ea typeface="맑은 고딕" pitchFamily="34" charset="-122"/>
                           <a:cs typeface="맑은 고딕" pitchFamily="34" charset="-120"/>
                         </a:rPr>
-                        <a:t>20 개</a:t>
+                        <a:t>19 개</a:t>
                       </a:r>
                       <a:endParaRPr lang="en-US" sz="1200" dirty="0">
                         <a:latin typeface="맑은 고딕" charset="0"/>
@@ -7174,7 +7174,7 @@
                           <a:ea typeface="맑은 고딕" pitchFamily="34" charset="-122"/>
                           <a:cs typeface="맑은 고딕" pitchFamily="34" charset="-120"/>
                         </a:rPr>
-                        <a:t>Necklace</a:t>
+                        <a:t>Ring</a:t>
                       </a:r>
                       <a:endParaRPr lang="en-US" sz="1000" dirty="0">
                         <a:latin typeface="맑은 고딕" charset="0"/>
@@ -7239,7 +7239,7 @@
                           <a:ea typeface="맑은 고딕" pitchFamily="34" charset="-122"/>
                           <a:cs typeface="맑은 고딕" pitchFamily="34" charset="-120"/>
                         </a:rPr>
-                        <a:t>YOKNIS 9921 Necklace</a:t>
+                        <a:t>[SILVER925] Cstic Open Ring</a:t>
                       </a:r>
                       <a:endParaRPr lang="en-US" sz="1100" dirty="0">
                         <a:latin typeface="맑은 고딕" charset="0"/>
@@ -7304,7 +7304,7 @@
                           <a:ea typeface="맑은 고딕" pitchFamily="34" charset="-122"/>
                           <a:cs typeface="맑은 고딕" pitchFamily="34" charset="-120"/>
                         </a:rPr>
-                        <a:t>17 개</a:t>
+                        <a:t>16 개</a:t>
                       </a:r>
                       <a:endParaRPr lang="en-US" sz="1200" dirty="0">
                         <a:latin typeface="맑은 고딕" charset="0"/>
@@ -7557,7 +7557,7 @@
                 <a:ea typeface="맑은 고딕" pitchFamily="34" charset="-122"/>
                 <a:cs typeface="맑은 고딕" pitchFamily="34" charset="-120"/>
               </a:rPr>
-              <a:t>[SILVER925] Mustafakemalpaşa Ring (사이즈: 12호)</a:t>
+              <a:t>[SILVER925] Width Open Ring</a:t>
             </a:r>
             <a:endParaRPr lang="en-US" sz="1100" dirty="0"/>
           </a:p>
@@ -7572,6 +7572,418 @@
         <p:spPr>
           <a:xfrm>
             <a:off x="8211312" y="3712464"/>
+            <a:ext cx="3291840" cy="256032"/>
+          </a:xfrm>
+          <a:prstGeom prst="rect">
+            <a:avLst/>
+          </a:prstGeom>
+          <a:noFill/>
+          <a:ln/>
+        </p:spPr>
+        <p:txBody>
+          <a:bodyPr wrap="square" lIns="0" tIns="0" rIns="0" bIns="0" rtlCol="0" anchor="ctr"/>
+          <a:lstStyle/>
+          <a:p>
+            <a:pPr indent="0" marL="0">
+              <a:buNone/>
+            </a:pPr>
+            <a:r>
+              <a:rPr lang="en-US" sz="1000" dirty="0">
+                <a:solidFill>
+                  <a:srgbClr val="6B7280"/>
+                </a:solidFill>
+                <a:latin typeface="맑은 고딕" pitchFamily="34" charset="0"/>
+                <a:ea typeface="맑은 고딕" pitchFamily="34" charset="-122"/>
+                <a:cs typeface="맑은 고딕" pitchFamily="34" charset="-120"/>
+              </a:rPr>
+              <a:t>Ring  ·  재고 5개</a:t>
+            </a:r>
+            <a:pPr indent="0" marL="0">
+              <a:buNone/>
+            </a:pPr>
+            <a:r>
+              <a:rPr lang="en-US" sz="1000" b="1" dirty="0">
+                <a:solidFill>
+                  <a:srgbClr val="D72638"/>
+                </a:solidFill>
+                <a:latin typeface="맑은 고딕" pitchFamily="34" charset="0"/>
+                <a:ea typeface="맑은 고딕" pitchFamily="34" charset="-122"/>
+                <a:cs typeface="맑은 고딕" pitchFamily="34" charset="-120"/>
+              </a:rPr>
+              <a:t/>
+            </a:r>
+            <a:endParaRPr lang="en-US" sz="1000" dirty="0"/>
+          </a:p>
+        </p:txBody>
+      </p:sp>
+      <p:sp>
+        <p:nvSpPr>
+          <p:cNvPr id="27" name="Shape 24"/>
+          <p:cNvSpPr/>
+          <p:nvPr/>
+        </p:nvSpPr>
+        <p:spPr>
+          <a:xfrm>
+            <a:off x="7406640" y="4096512"/>
+            <a:ext cx="4206240" cy="640080"/>
+          </a:xfrm>
+          <a:prstGeom prst="rect">
+            <a:avLst/>
+          </a:prstGeom>
+          <a:solidFill>
+            <a:srgbClr val="FFF5F5"/>
+          </a:solidFill>
+          <a:ln w="6350">
+            <a:solidFill>
+              <a:srgbClr val="E5E7EB"/>
+            </a:solidFill>
+            <a:prstDash val="solid"/>
+          </a:ln>
+        </p:spPr>
+      </p:sp>
+      <p:sp>
+        <p:nvSpPr>
+          <p:cNvPr id="28" name="Shape 25"/>
+          <p:cNvSpPr/>
+          <p:nvPr/>
+        </p:nvSpPr>
+        <p:spPr>
+          <a:xfrm>
+            <a:off x="7406640" y="4096512"/>
+            <a:ext cx="109728" cy="640080"/>
+          </a:xfrm>
+          <a:prstGeom prst="rect">
+            <a:avLst/>
+          </a:prstGeom>
+          <a:solidFill>
+            <a:srgbClr val="D72638"/>
+          </a:solidFill>
+          <a:ln w="12700">
+            <a:solidFill>
+              <a:srgbClr val="D72638"/>
+            </a:solidFill>
+            <a:prstDash val="solid"/>
+          </a:ln>
+        </p:spPr>
+      </p:sp>
+      <p:sp>
+        <p:nvSpPr>
+          <p:cNvPr id="29" name="Shape 26"/>
+          <p:cNvSpPr/>
+          <p:nvPr/>
+        </p:nvSpPr>
+        <p:spPr>
+          <a:xfrm>
+            <a:off x="7571232" y="4187952"/>
+            <a:ext cx="548640" cy="256032"/>
+          </a:xfrm>
+          <a:prstGeom prst="rect">
+            <a:avLst/>
+          </a:prstGeom>
+          <a:solidFill>
+            <a:srgbClr val="D72638"/>
+          </a:solidFill>
+          <a:ln w="12700">
+            <a:solidFill>
+              <a:srgbClr val="D72638"/>
+            </a:solidFill>
+            <a:prstDash val="solid"/>
+          </a:ln>
+        </p:spPr>
+      </p:sp>
+      <p:sp>
+        <p:nvSpPr>
+          <p:cNvPr id="30" name="Text 27"/>
+          <p:cNvSpPr/>
+          <p:nvPr/>
+        </p:nvSpPr>
+        <p:spPr>
+          <a:xfrm>
+            <a:off x="7571232" y="4187952"/>
+            <a:ext cx="548640" cy="256032"/>
+          </a:xfrm>
+          <a:prstGeom prst="rect">
+            <a:avLst/>
+          </a:prstGeom>
+          <a:noFill/>
+          <a:ln/>
+        </p:spPr>
+        <p:txBody>
+          <a:bodyPr wrap="square" lIns="0" tIns="0" rIns="0" bIns="0" rtlCol="0" anchor="ctr"/>
+          <a:lstStyle/>
+          <a:p>
+            <a:pPr algn="ctr" indent="0" marL="0">
+              <a:buNone/>
+            </a:pPr>
+            <a:r>
+              <a:rPr lang="en-US" sz="900" b="1" dirty="0">
+                <a:solidFill>
+                  <a:srgbClr val="FFFFFF"/>
+                </a:solidFill>
+                <a:latin typeface="맑은 고딕" pitchFamily="34" charset="0"/>
+                <a:ea typeface="맑은 고딕" pitchFamily="34" charset="-122"/>
+                <a:cs typeface="맑은 고딕" pitchFamily="34" charset="-120"/>
+              </a:rPr>
+              <a:t>긴급</a:t>
+            </a:r>
+            <a:endParaRPr lang="en-US" sz="900" dirty="0"/>
+          </a:p>
+        </p:txBody>
+      </p:sp>
+      <p:sp>
+        <p:nvSpPr>
+          <p:cNvPr id="31" name="Text 28"/>
+          <p:cNvSpPr/>
+          <p:nvPr/>
+        </p:nvSpPr>
+        <p:spPr>
+          <a:xfrm>
+            <a:off x="8211312" y="4151376"/>
+            <a:ext cx="3291840" cy="274320"/>
+          </a:xfrm>
+          <a:prstGeom prst="rect">
+            <a:avLst/>
+          </a:prstGeom>
+          <a:noFill/>
+          <a:ln/>
+        </p:spPr>
+        <p:txBody>
+          <a:bodyPr wrap="square" lIns="0" tIns="0" rIns="0" bIns="0" rtlCol="0" anchor="ctr"/>
+          <a:lstStyle/>
+          <a:p>
+            <a:pPr indent="0" marL="0">
+              <a:buNone/>
+            </a:pPr>
+            <a:r>
+              <a:rPr lang="en-US" sz="1100" b="1" dirty="0">
+                <a:solidFill>
+                  <a:srgbClr val="0B1220"/>
+                </a:solidFill>
+                <a:latin typeface="맑은 고딕" pitchFamily="34" charset="0"/>
+                <a:ea typeface="맑은 고딕" pitchFamily="34" charset="-122"/>
+                <a:cs typeface="맑은 고딕" pitchFamily="34" charset="-120"/>
+              </a:rPr>
+              <a:t>8-Ball Smart Tok</a:t>
+            </a:r>
+            <a:endParaRPr lang="en-US" sz="1100" dirty="0"/>
+          </a:p>
+        </p:txBody>
+      </p:sp>
+      <p:sp>
+        <p:nvSpPr>
+          <p:cNvPr id="32" name="Text 29"/>
+          <p:cNvSpPr/>
+          <p:nvPr/>
+        </p:nvSpPr>
+        <p:spPr>
+          <a:xfrm>
+            <a:off x="8211312" y="4425696"/>
+            <a:ext cx="3291840" cy="256032"/>
+          </a:xfrm>
+          <a:prstGeom prst="rect">
+            <a:avLst/>
+          </a:prstGeom>
+          <a:noFill/>
+          <a:ln/>
+        </p:spPr>
+        <p:txBody>
+          <a:bodyPr wrap="square" lIns="0" tIns="0" rIns="0" bIns="0" rtlCol="0" anchor="ctr"/>
+          <a:lstStyle/>
+          <a:p>
+            <a:pPr indent="0" marL="0">
+              <a:buNone/>
+            </a:pPr>
+            <a:r>
+              <a:rPr lang="en-US" sz="1000" dirty="0">
+                <a:solidFill>
+                  <a:srgbClr val="6B7280"/>
+                </a:solidFill>
+                <a:latin typeface="맑은 고딕" pitchFamily="34" charset="0"/>
+                <a:ea typeface="맑은 고딕" pitchFamily="34" charset="-122"/>
+                <a:cs typeface="맑은 고딕" pitchFamily="34" charset="-120"/>
+              </a:rPr>
+              <a:t>★Season off★  ·  재고 4개</a:t>
+            </a:r>
+            <a:pPr indent="0" marL="0">
+              <a:buNone/>
+            </a:pPr>
+            <a:r>
+              <a:rPr lang="en-US" sz="1000" b="1" dirty="0">
+                <a:solidFill>
+                  <a:srgbClr val="D72638"/>
+                </a:solidFill>
+                <a:latin typeface="맑은 고딕" pitchFamily="34" charset="0"/>
+                <a:ea typeface="맑은 고딕" pitchFamily="34" charset="-122"/>
+                <a:cs typeface="맑은 고딕" pitchFamily="34" charset="-120"/>
+              </a:rPr>
+              <a:t/>
+            </a:r>
+            <a:endParaRPr lang="en-US" sz="1000" dirty="0"/>
+          </a:p>
+        </p:txBody>
+      </p:sp>
+      <p:sp>
+        <p:nvSpPr>
+          <p:cNvPr id="33" name="Shape 30"/>
+          <p:cNvSpPr/>
+          <p:nvPr/>
+        </p:nvSpPr>
+        <p:spPr>
+          <a:xfrm>
+            <a:off x="7406640" y="4809744"/>
+            <a:ext cx="4206240" cy="640080"/>
+          </a:xfrm>
+          <a:prstGeom prst="rect">
+            <a:avLst/>
+          </a:prstGeom>
+          <a:solidFill>
+            <a:srgbClr val="FFF5F5"/>
+          </a:solidFill>
+          <a:ln w="6350">
+            <a:solidFill>
+              <a:srgbClr val="E5E7EB"/>
+            </a:solidFill>
+            <a:prstDash val="solid"/>
+          </a:ln>
+        </p:spPr>
+      </p:sp>
+      <p:sp>
+        <p:nvSpPr>
+          <p:cNvPr id="34" name="Shape 31"/>
+          <p:cNvSpPr/>
+          <p:nvPr/>
+        </p:nvSpPr>
+        <p:spPr>
+          <a:xfrm>
+            <a:off x="7406640" y="4809744"/>
+            <a:ext cx="109728" cy="640080"/>
+          </a:xfrm>
+          <a:prstGeom prst="rect">
+            <a:avLst/>
+          </a:prstGeom>
+          <a:solidFill>
+            <a:srgbClr val="D72638"/>
+          </a:solidFill>
+          <a:ln w="12700">
+            <a:solidFill>
+              <a:srgbClr val="D72638"/>
+            </a:solidFill>
+            <a:prstDash val="solid"/>
+          </a:ln>
+        </p:spPr>
+      </p:sp>
+      <p:sp>
+        <p:nvSpPr>
+          <p:cNvPr id="35" name="Shape 32"/>
+          <p:cNvSpPr/>
+          <p:nvPr/>
+        </p:nvSpPr>
+        <p:spPr>
+          <a:xfrm>
+            <a:off x="7571232" y="4901184"/>
+            <a:ext cx="548640" cy="256032"/>
+          </a:xfrm>
+          <a:prstGeom prst="rect">
+            <a:avLst/>
+          </a:prstGeom>
+          <a:solidFill>
+            <a:srgbClr val="D72638"/>
+          </a:solidFill>
+          <a:ln w="12700">
+            <a:solidFill>
+              <a:srgbClr val="D72638"/>
+            </a:solidFill>
+            <a:prstDash val="solid"/>
+          </a:ln>
+        </p:spPr>
+      </p:sp>
+      <p:sp>
+        <p:nvSpPr>
+          <p:cNvPr id="36" name="Text 33"/>
+          <p:cNvSpPr/>
+          <p:nvPr/>
+        </p:nvSpPr>
+        <p:spPr>
+          <a:xfrm>
+            <a:off x="7571232" y="4901184"/>
+            <a:ext cx="548640" cy="256032"/>
+          </a:xfrm>
+          <a:prstGeom prst="rect">
+            <a:avLst/>
+          </a:prstGeom>
+          <a:noFill/>
+          <a:ln/>
+        </p:spPr>
+        <p:txBody>
+          <a:bodyPr wrap="square" lIns="0" tIns="0" rIns="0" bIns="0" rtlCol="0" anchor="ctr"/>
+          <a:lstStyle/>
+          <a:p>
+            <a:pPr algn="ctr" indent="0" marL="0">
+              <a:buNone/>
+            </a:pPr>
+            <a:r>
+              <a:rPr lang="en-US" sz="900" b="1" dirty="0">
+                <a:solidFill>
+                  <a:srgbClr val="FFFFFF"/>
+                </a:solidFill>
+                <a:latin typeface="맑은 고딕" pitchFamily="34" charset="0"/>
+                <a:ea typeface="맑은 고딕" pitchFamily="34" charset="-122"/>
+                <a:cs typeface="맑은 고딕" pitchFamily="34" charset="-120"/>
+              </a:rPr>
+              <a:t>긴급</a:t>
+            </a:r>
+            <a:endParaRPr lang="en-US" sz="900" dirty="0"/>
+          </a:p>
+        </p:txBody>
+      </p:sp>
+      <p:sp>
+        <p:nvSpPr>
+          <p:cNvPr id="37" name="Text 34"/>
+          <p:cNvSpPr/>
+          <p:nvPr/>
+        </p:nvSpPr>
+        <p:spPr>
+          <a:xfrm>
+            <a:off x="8211312" y="4864608"/>
+            <a:ext cx="3291840" cy="274320"/>
+          </a:xfrm>
+          <a:prstGeom prst="rect">
+            <a:avLst/>
+          </a:prstGeom>
+          <a:noFill/>
+          <a:ln/>
+        </p:spPr>
+        <p:txBody>
+          <a:bodyPr wrap="square" lIns="0" tIns="0" rIns="0" bIns="0" rtlCol="0" anchor="ctr"/>
+          <a:lstStyle/>
+          <a:p>
+            <a:pPr indent="0" marL="0">
+              <a:buNone/>
+            </a:pPr>
+            <a:r>
+              <a:rPr lang="en-US" sz="1100" b="1" dirty="0">
+                <a:solidFill>
+                  <a:srgbClr val="0B1220"/>
+                </a:solidFill>
+                <a:latin typeface="맑은 고딕" pitchFamily="34" charset="0"/>
+                <a:ea typeface="맑은 고딕" pitchFamily="34" charset="-122"/>
+                <a:cs typeface="맑은 고딕" pitchFamily="34" charset="-120"/>
+              </a:rPr>
+              <a:t>[SILVER925] Crimson Open Ring</a:t>
+            </a:r>
+            <a:endParaRPr lang="en-US" sz="1100" dirty="0"/>
+          </a:p>
+        </p:txBody>
+      </p:sp>
+      <p:sp>
+        <p:nvSpPr>
+          <p:cNvPr id="38" name="Text 35"/>
+          <p:cNvSpPr/>
+          <p:nvPr/>
+        </p:nvSpPr>
+        <p:spPr>
+          <a:xfrm>
+            <a:off x="8211312" y="5138928"/>
             <a:ext cx="3291840" cy="256032"/>
           </a:xfrm>
           <a:prstGeom prst="rect">
@@ -7618,13 +8030,13 @@
       </p:sp>
       <p:sp>
         <p:nvSpPr>
-          <p:cNvPr id="27" name="Shape 24"/>
-          <p:cNvSpPr/>
-          <p:nvPr/>
-        </p:nvSpPr>
-        <p:spPr>
-          <a:xfrm>
-            <a:off x="7406640" y="4096512"/>
+          <p:cNvPr id="39" name="Shape 36"/>
+          <p:cNvSpPr/>
+          <p:nvPr/>
+        </p:nvSpPr>
+        <p:spPr>
+          <a:xfrm>
+            <a:off x="7406640" y="5522976"/>
             <a:ext cx="4206240" cy="640080"/>
           </a:xfrm>
           <a:prstGeom prst="rect">
@@ -7643,13 +8055,13 @@
       </p:sp>
       <p:sp>
         <p:nvSpPr>
-          <p:cNvPr id="28" name="Shape 25"/>
-          <p:cNvSpPr/>
-          <p:nvPr/>
-        </p:nvSpPr>
-        <p:spPr>
-          <a:xfrm>
-            <a:off x="7406640" y="4096512"/>
+          <p:cNvPr id="40" name="Shape 37"/>
+          <p:cNvSpPr/>
+          <p:nvPr/>
+        </p:nvSpPr>
+        <p:spPr>
+          <a:xfrm>
+            <a:off x="7406640" y="5522976"/>
             <a:ext cx="109728" cy="640080"/>
           </a:xfrm>
           <a:prstGeom prst="rect">
@@ -7668,13 +8080,13 @@
       </p:sp>
       <p:sp>
         <p:nvSpPr>
-          <p:cNvPr id="29" name="Shape 26"/>
-          <p:cNvSpPr/>
-          <p:nvPr/>
-        </p:nvSpPr>
-        <p:spPr>
-          <a:xfrm>
-            <a:off x="7571232" y="4187952"/>
+          <p:cNvPr id="41" name="Shape 38"/>
+          <p:cNvSpPr/>
+          <p:nvPr/>
+        </p:nvSpPr>
+        <p:spPr>
+          <a:xfrm>
+            <a:off x="7571232" y="5614416"/>
             <a:ext cx="548640" cy="256032"/>
           </a:xfrm>
           <a:prstGeom prst="rect">
@@ -7693,13 +8105,13 @@
       </p:sp>
       <p:sp>
         <p:nvSpPr>
-          <p:cNvPr id="30" name="Text 27"/>
-          <p:cNvSpPr/>
-          <p:nvPr/>
-        </p:nvSpPr>
-        <p:spPr>
-          <a:xfrm>
-            <a:off x="7571232" y="4187952"/>
+          <p:cNvPr id="42" name="Text 39"/>
+          <p:cNvSpPr/>
+          <p:nvPr/>
+        </p:nvSpPr>
+        <p:spPr>
+          <a:xfrm>
+            <a:off x="7571232" y="5614416"/>
             <a:ext cx="548640" cy="256032"/>
           </a:xfrm>
           <a:prstGeom prst="rect">
@@ -7732,13 +8144,13 @@
       </p:sp>
       <p:sp>
         <p:nvSpPr>
-          <p:cNvPr id="31" name="Text 28"/>
-          <p:cNvSpPr/>
-          <p:nvPr/>
-        </p:nvSpPr>
-        <p:spPr>
-          <a:xfrm>
-            <a:off x="8211312" y="4151376"/>
+          <p:cNvPr id="43" name="Text 40"/>
+          <p:cNvSpPr/>
+          <p:nvPr/>
+        </p:nvSpPr>
+        <p:spPr>
+          <a:xfrm>
+            <a:off x="8211312" y="5577840"/>
             <a:ext cx="3291840" cy="274320"/>
           </a:xfrm>
           <a:prstGeom prst="rect">
@@ -7763,7 +8175,7 @@
                 <a:ea typeface="맑은 고딕" pitchFamily="34" charset="-122"/>
                 <a:cs typeface="맑은 고딕" pitchFamily="34" charset="-120"/>
               </a:rPr>
-              <a:t>Phorn Bracelet</a:t>
+              <a:t>B-Flower Necklace (Size: 1 Size)</a:t>
             </a:r>
             <a:endParaRPr lang="en-US" sz="1100" dirty="0"/>
           </a:p>
@@ -7771,13 +8183,13 @@
       </p:sp>
       <p:sp>
         <p:nvSpPr>
-          <p:cNvPr id="32" name="Text 29"/>
-          <p:cNvSpPr/>
-          <p:nvPr/>
-        </p:nvSpPr>
-        <p:spPr>
-          <a:xfrm>
-            <a:off x="8211312" y="4425696"/>
+          <p:cNvPr id="44" name="Text 41"/>
+          <p:cNvSpPr/>
+          <p:nvPr/>
+        </p:nvSpPr>
+        <p:spPr>
+          <a:xfrm>
+            <a:off x="8211312" y="5852160"/>
             <a:ext cx="3291840" cy="256032"/>
           </a:xfrm>
           <a:prstGeom prst="rect">
@@ -7802,7 +8214,7 @@
                 <a:ea typeface="맑은 고딕" pitchFamily="34" charset="-122"/>
                 <a:cs typeface="맑은 고딕" pitchFamily="34" charset="-120"/>
               </a:rPr>
-              <a:t>Bracelet  ·  재고 5개</a:t>
+              <a:t>Necklace  ·  재고 0개</a:t>
             </a:r>
             <a:pPr indent="0" marL="0">
               <a:buNone/>
@@ -7824,418 +8236,6 @@
       </p:sp>
       <p:sp>
         <p:nvSpPr>
-          <p:cNvPr id="33" name="Shape 30"/>
-          <p:cNvSpPr/>
-          <p:nvPr/>
-        </p:nvSpPr>
-        <p:spPr>
-          <a:xfrm>
-            <a:off x="7406640" y="4809744"/>
-            <a:ext cx="4206240" cy="640080"/>
-          </a:xfrm>
-          <a:prstGeom prst="rect">
-            <a:avLst/>
-          </a:prstGeom>
-          <a:solidFill>
-            <a:srgbClr val="FFF5F5"/>
-          </a:solidFill>
-          <a:ln w="6350">
-            <a:solidFill>
-              <a:srgbClr val="E5E7EB"/>
-            </a:solidFill>
-            <a:prstDash val="solid"/>
-          </a:ln>
-        </p:spPr>
-      </p:sp>
-      <p:sp>
-        <p:nvSpPr>
-          <p:cNvPr id="34" name="Shape 31"/>
-          <p:cNvSpPr/>
-          <p:nvPr/>
-        </p:nvSpPr>
-        <p:spPr>
-          <a:xfrm>
-            <a:off x="7406640" y="4809744"/>
-            <a:ext cx="109728" cy="640080"/>
-          </a:xfrm>
-          <a:prstGeom prst="rect">
-            <a:avLst/>
-          </a:prstGeom>
-          <a:solidFill>
-            <a:srgbClr val="D72638"/>
-          </a:solidFill>
-          <a:ln w="12700">
-            <a:solidFill>
-              <a:srgbClr val="D72638"/>
-            </a:solidFill>
-            <a:prstDash val="solid"/>
-          </a:ln>
-        </p:spPr>
-      </p:sp>
-      <p:sp>
-        <p:nvSpPr>
-          <p:cNvPr id="35" name="Shape 32"/>
-          <p:cNvSpPr/>
-          <p:nvPr/>
-        </p:nvSpPr>
-        <p:spPr>
-          <a:xfrm>
-            <a:off x="7571232" y="4901184"/>
-            <a:ext cx="548640" cy="256032"/>
-          </a:xfrm>
-          <a:prstGeom prst="rect">
-            <a:avLst/>
-          </a:prstGeom>
-          <a:solidFill>
-            <a:srgbClr val="D72638"/>
-          </a:solidFill>
-          <a:ln w="12700">
-            <a:solidFill>
-              <a:srgbClr val="D72638"/>
-            </a:solidFill>
-            <a:prstDash val="solid"/>
-          </a:ln>
-        </p:spPr>
-      </p:sp>
-      <p:sp>
-        <p:nvSpPr>
-          <p:cNvPr id="36" name="Text 33"/>
-          <p:cNvSpPr/>
-          <p:nvPr/>
-        </p:nvSpPr>
-        <p:spPr>
-          <a:xfrm>
-            <a:off x="7571232" y="4901184"/>
-            <a:ext cx="548640" cy="256032"/>
-          </a:xfrm>
-          <a:prstGeom prst="rect">
-            <a:avLst/>
-          </a:prstGeom>
-          <a:noFill/>
-          <a:ln/>
-        </p:spPr>
-        <p:txBody>
-          <a:bodyPr wrap="square" lIns="0" tIns="0" rIns="0" bIns="0" rtlCol="0" anchor="ctr"/>
-          <a:lstStyle/>
-          <a:p>
-            <a:pPr algn="ctr" indent="0" marL="0">
-              <a:buNone/>
-            </a:pPr>
-            <a:r>
-              <a:rPr lang="en-US" sz="900" b="1" dirty="0">
-                <a:solidFill>
-                  <a:srgbClr val="FFFFFF"/>
-                </a:solidFill>
-                <a:latin typeface="맑은 고딕" pitchFamily="34" charset="0"/>
-                <a:ea typeface="맑은 고딕" pitchFamily="34" charset="-122"/>
-                <a:cs typeface="맑은 고딕" pitchFamily="34" charset="-120"/>
-              </a:rPr>
-              <a:t>긴급</a:t>
-            </a:r>
-            <a:endParaRPr lang="en-US" sz="900" dirty="0"/>
-          </a:p>
-        </p:txBody>
-      </p:sp>
-      <p:sp>
-        <p:nvSpPr>
-          <p:cNvPr id="37" name="Text 34"/>
-          <p:cNvSpPr/>
-          <p:nvPr/>
-        </p:nvSpPr>
-        <p:spPr>
-          <a:xfrm>
-            <a:off x="8211312" y="4864608"/>
-            <a:ext cx="3291840" cy="274320"/>
-          </a:xfrm>
-          <a:prstGeom prst="rect">
-            <a:avLst/>
-          </a:prstGeom>
-          <a:noFill/>
-          <a:ln/>
-        </p:spPr>
-        <p:txBody>
-          <a:bodyPr wrap="square" lIns="0" tIns="0" rIns="0" bIns="0" rtlCol="0" anchor="ctr"/>
-          <a:lstStyle/>
-          <a:p>
-            <a:pPr indent="0" marL="0">
-              <a:buNone/>
-            </a:pPr>
-            <a:r>
-              <a:rPr lang="en-US" sz="1100" b="1" dirty="0">
-                <a:solidFill>
-                  <a:srgbClr val="0B1220"/>
-                </a:solidFill>
-                <a:latin typeface="맑은 고딕" pitchFamily="34" charset="0"/>
-                <a:ea typeface="맑은 고딕" pitchFamily="34" charset="-122"/>
-                <a:cs typeface="맑은 고딕" pitchFamily="34" charset="-120"/>
-              </a:rPr>
-              <a:t>8-Ball Smart Tok</a:t>
-            </a:r>
-            <a:endParaRPr lang="en-US" sz="1100" dirty="0"/>
-          </a:p>
-        </p:txBody>
-      </p:sp>
-      <p:sp>
-        <p:nvSpPr>
-          <p:cNvPr id="38" name="Text 35"/>
-          <p:cNvSpPr/>
-          <p:nvPr/>
-        </p:nvSpPr>
-        <p:spPr>
-          <a:xfrm>
-            <a:off x="8211312" y="5138928"/>
-            <a:ext cx="3291840" cy="256032"/>
-          </a:xfrm>
-          <a:prstGeom prst="rect">
-            <a:avLst/>
-          </a:prstGeom>
-          <a:noFill/>
-          <a:ln/>
-        </p:spPr>
-        <p:txBody>
-          <a:bodyPr wrap="square" lIns="0" tIns="0" rIns="0" bIns="0" rtlCol="0" anchor="ctr"/>
-          <a:lstStyle/>
-          <a:p>
-            <a:pPr indent="0" marL="0">
-              <a:buNone/>
-            </a:pPr>
-            <a:r>
-              <a:rPr lang="en-US" sz="1000" dirty="0">
-                <a:solidFill>
-                  <a:srgbClr val="6B7280"/>
-                </a:solidFill>
-                <a:latin typeface="맑은 고딕" pitchFamily="34" charset="0"/>
-                <a:ea typeface="맑은 고딕" pitchFamily="34" charset="-122"/>
-                <a:cs typeface="맑은 고딕" pitchFamily="34" charset="-120"/>
-              </a:rPr>
-              <a:t>★Season off★  ·  재고 4개</a:t>
-            </a:r>
-            <a:pPr indent="0" marL="0">
-              <a:buNone/>
-            </a:pPr>
-            <a:r>
-              <a:rPr lang="en-US" sz="1000" b="1" dirty="0">
-                <a:solidFill>
-                  <a:srgbClr val="D72638"/>
-                </a:solidFill>
-                <a:latin typeface="맑은 고딕" pitchFamily="34" charset="0"/>
-                <a:ea typeface="맑은 고딕" pitchFamily="34" charset="-122"/>
-                <a:cs typeface="맑은 고딕" pitchFamily="34" charset="-120"/>
-              </a:rPr>
-              <a:t/>
-            </a:r>
-            <a:endParaRPr lang="en-US" sz="1000" dirty="0"/>
-          </a:p>
-        </p:txBody>
-      </p:sp>
-      <p:sp>
-        <p:nvSpPr>
-          <p:cNvPr id="39" name="Shape 36"/>
-          <p:cNvSpPr/>
-          <p:nvPr/>
-        </p:nvSpPr>
-        <p:spPr>
-          <a:xfrm>
-            <a:off x="7406640" y="5522976"/>
-            <a:ext cx="4206240" cy="640080"/>
-          </a:xfrm>
-          <a:prstGeom prst="rect">
-            <a:avLst/>
-          </a:prstGeom>
-          <a:solidFill>
-            <a:srgbClr val="FFF5F5"/>
-          </a:solidFill>
-          <a:ln w="6350">
-            <a:solidFill>
-              <a:srgbClr val="E5E7EB"/>
-            </a:solidFill>
-            <a:prstDash val="solid"/>
-          </a:ln>
-        </p:spPr>
-      </p:sp>
-      <p:sp>
-        <p:nvSpPr>
-          <p:cNvPr id="40" name="Shape 37"/>
-          <p:cNvSpPr/>
-          <p:nvPr/>
-        </p:nvSpPr>
-        <p:spPr>
-          <a:xfrm>
-            <a:off x="7406640" y="5522976"/>
-            <a:ext cx="109728" cy="640080"/>
-          </a:xfrm>
-          <a:prstGeom prst="rect">
-            <a:avLst/>
-          </a:prstGeom>
-          <a:solidFill>
-            <a:srgbClr val="D72638"/>
-          </a:solidFill>
-          <a:ln w="12700">
-            <a:solidFill>
-              <a:srgbClr val="D72638"/>
-            </a:solidFill>
-            <a:prstDash val="solid"/>
-          </a:ln>
-        </p:spPr>
-      </p:sp>
-      <p:sp>
-        <p:nvSpPr>
-          <p:cNvPr id="41" name="Shape 38"/>
-          <p:cNvSpPr/>
-          <p:nvPr/>
-        </p:nvSpPr>
-        <p:spPr>
-          <a:xfrm>
-            <a:off x="7571232" y="5614416"/>
-            <a:ext cx="548640" cy="256032"/>
-          </a:xfrm>
-          <a:prstGeom prst="rect">
-            <a:avLst/>
-          </a:prstGeom>
-          <a:solidFill>
-            <a:srgbClr val="D72638"/>
-          </a:solidFill>
-          <a:ln w="12700">
-            <a:solidFill>
-              <a:srgbClr val="D72638"/>
-            </a:solidFill>
-            <a:prstDash val="solid"/>
-          </a:ln>
-        </p:spPr>
-      </p:sp>
-      <p:sp>
-        <p:nvSpPr>
-          <p:cNvPr id="42" name="Text 39"/>
-          <p:cNvSpPr/>
-          <p:nvPr/>
-        </p:nvSpPr>
-        <p:spPr>
-          <a:xfrm>
-            <a:off x="7571232" y="5614416"/>
-            <a:ext cx="548640" cy="256032"/>
-          </a:xfrm>
-          <a:prstGeom prst="rect">
-            <a:avLst/>
-          </a:prstGeom>
-          <a:noFill/>
-          <a:ln/>
-        </p:spPr>
-        <p:txBody>
-          <a:bodyPr wrap="square" lIns="0" tIns="0" rIns="0" bIns="0" rtlCol="0" anchor="ctr"/>
-          <a:lstStyle/>
-          <a:p>
-            <a:pPr algn="ctr" indent="0" marL="0">
-              <a:buNone/>
-            </a:pPr>
-            <a:r>
-              <a:rPr lang="en-US" sz="900" b="1" dirty="0">
-                <a:solidFill>
-                  <a:srgbClr val="FFFFFF"/>
-                </a:solidFill>
-                <a:latin typeface="맑은 고딕" pitchFamily="34" charset="0"/>
-                <a:ea typeface="맑은 고딕" pitchFamily="34" charset="-122"/>
-                <a:cs typeface="맑은 고딕" pitchFamily="34" charset="-120"/>
-              </a:rPr>
-              <a:t>긴급</a:t>
-            </a:r>
-            <a:endParaRPr lang="en-US" sz="900" dirty="0"/>
-          </a:p>
-        </p:txBody>
-      </p:sp>
-      <p:sp>
-        <p:nvSpPr>
-          <p:cNvPr id="43" name="Text 40"/>
-          <p:cNvSpPr/>
-          <p:nvPr/>
-        </p:nvSpPr>
-        <p:spPr>
-          <a:xfrm>
-            <a:off x="8211312" y="5577840"/>
-            <a:ext cx="3291840" cy="274320"/>
-          </a:xfrm>
-          <a:prstGeom prst="rect">
-            <a:avLst/>
-          </a:prstGeom>
-          <a:noFill/>
-          <a:ln/>
-        </p:spPr>
-        <p:txBody>
-          <a:bodyPr wrap="square" lIns="0" tIns="0" rIns="0" bIns="0" rtlCol="0" anchor="ctr"/>
-          <a:lstStyle/>
-          <a:p>
-            <a:pPr indent="0" marL="0">
-              <a:buNone/>
-            </a:pPr>
-            <a:r>
-              <a:rPr lang="en-US" sz="1100" b="1" dirty="0">
-                <a:solidFill>
-                  <a:srgbClr val="0B1220"/>
-                </a:solidFill>
-                <a:latin typeface="맑은 고딕" pitchFamily="34" charset="0"/>
-                <a:ea typeface="맑은 고딕" pitchFamily="34" charset="-122"/>
-                <a:cs typeface="맑은 고딕" pitchFamily="34" charset="-120"/>
-              </a:rPr>
-              <a:t>Two-ball Bangle</a:t>
-            </a:r>
-            <a:endParaRPr lang="en-US" sz="1100" dirty="0"/>
-          </a:p>
-        </p:txBody>
-      </p:sp>
-      <p:sp>
-        <p:nvSpPr>
-          <p:cNvPr id="44" name="Text 41"/>
-          <p:cNvSpPr/>
-          <p:nvPr/>
-        </p:nvSpPr>
-        <p:spPr>
-          <a:xfrm>
-            <a:off x="8211312" y="5852160"/>
-            <a:ext cx="3291840" cy="256032"/>
-          </a:xfrm>
-          <a:prstGeom prst="rect">
-            <a:avLst/>
-          </a:prstGeom>
-          <a:noFill/>
-          <a:ln/>
-        </p:spPr>
-        <p:txBody>
-          <a:bodyPr wrap="square" lIns="0" tIns="0" rIns="0" bIns="0" rtlCol="0" anchor="ctr"/>
-          <a:lstStyle/>
-          <a:p>
-            <a:pPr indent="0" marL="0">
-              <a:buNone/>
-            </a:pPr>
-            <a:r>
-              <a:rPr lang="en-US" sz="1000" dirty="0">
-                <a:solidFill>
-                  <a:srgbClr val="6B7280"/>
-                </a:solidFill>
-                <a:latin typeface="맑은 고딕" pitchFamily="34" charset="0"/>
-                <a:ea typeface="맑은 고딕" pitchFamily="34" charset="-122"/>
-                <a:cs typeface="맑은 고딕" pitchFamily="34" charset="-120"/>
-              </a:rPr>
-              <a:t>Bracelet  ·  재고 0개</a:t>
-            </a:r>
-            <a:pPr indent="0" marL="0">
-              <a:buNone/>
-            </a:pPr>
-            <a:r>
-              <a:rPr lang="en-US" sz="1000" b="1" dirty="0">
-                <a:solidFill>
-                  <a:srgbClr val="D72638"/>
-                </a:solidFill>
-                <a:latin typeface="맑은 고딕" pitchFamily="34" charset="0"/>
-                <a:ea typeface="맑은 고딕" pitchFamily="34" charset="-122"/>
-                <a:cs typeface="맑은 고딕" pitchFamily="34" charset="-120"/>
-              </a:rPr>
-              <a:t/>
-            </a:r>
-            <a:endParaRPr lang="en-US" sz="1000" dirty="0"/>
-          </a:p>
-        </p:txBody>
-      </p:sp>
-      <p:sp>
-        <p:nvSpPr>
           <p:cNvPr id="45" name="Text 42"/>
           <p:cNvSpPr/>
           <p:nvPr/>
@@ -8267,7 +8267,7 @@
                 <a:ea typeface="맑은 고딕" pitchFamily="34" charset="-122"/>
                 <a:cs typeface="맑은 고딕" pitchFamily="34" charset="-120"/>
               </a:rPr>
-              <a:t>베스트 상품 리포트  ·  생성 2026-06-02 08:00</a:t>
+              <a:t>베스트 상품 리포트  ·  생성 2026-06-03 08:00</a:t>
             </a:r>
             <a:endParaRPr lang="en-US" sz="900" dirty="0"/>
           </a:p>
@@ -8480,7 +8480,7 @@
                 <a:ea typeface="맑은 고딕" pitchFamily="34" charset="-122"/>
                 <a:cs typeface="맑은 고딕" pitchFamily="34" charset="-120"/>
               </a:rPr>
-              <a:t>2026년 06월 02일 (화)</a:t>
+              <a:t>2026년 06월 03일 (수)</a:t>
             </a:r>
             <a:endParaRPr lang="en-US" sz="1200" dirty="0"/>
           </a:p>
@@ -8647,7 +8647,7 @@
                 <a:ea typeface="맑은 고딕" pitchFamily="34" charset="-122"/>
                 <a:cs typeface="맑은 고딕" pitchFamily="34" charset="-120"/>
               </a:rPr>
-              <a:t>130 개</a:t>
+              <a:t>85 개</a:t>
             </a:r>
             <a:endParaRPr lang="en-US" sz="3600" dirty="0"/>
           </a:p>
@@ -8775,7 +8775,7 @@
                 <a:ea typeface="맑은 고딕" pitchFamily="34" charset="-122"/>
                 <a:cs typeface="맑은 고딕" pitchFamily="34" charset="-120"/>
               </a:rPr>
-              <a:t>CandyPOP Necklace (사이즈: 2size (47~52cm))</a:t>
+              <a:t>CandyPOP Necklace (사이즈: 1size (37~43cm))</a:t>
             </a:r>
             <a:endParaRPr lang="en-US" sz="1800" dirty="0"/>
           </a:p>
@@ -8853,7 +8853,7 @@
                 <a:ea typeface="맑은 고딕" pitchFamily="34" charset="-122"/>
                 <a:cs typeface="맑은 고딕" pitchFamily="34" charset="-120"/>
               </a:rPr>
-              <a:t>31</a:t>
+              <a:t>21</a:t>
             </a:r>
             <a:endParaRPr lang="en-US" sz="4400" dirty="0"/>
           </a:p>
@@ -9387,7 +9387,7 @@
                           <a:ea typeface="맑은 고딕" pitchFamily="34" charset="-122"/>
                           <a:cs typeface="맑은 고딕" pitchFamily="34" charset="-120"/>
                         </a:rPr>
-                        <a:t>CandyPOP Necklace (사이즈: 2size (47~52cm))</a:t>
+                        <a:t>CandyPOP Necklace (사이즈: 1size (37~43cm))</a:t>
                       </a:r>
                       <a:endParaRPr lang="en-US" sz="1100" dirty="0">
                         <a:latin typeface="맑은 고딕" charset="0"/>
@@ -9452,7 +9452,7 @@
                           <a:ea typeface="맑은 고딕" pitchFamily="34" charset="-122"/>
                           <a:cs typeface="맑은 고딕" pitchFamily="34" charset="-120"/>
                         </a:rPr>
-                        <a:t>31 개</a:t>
+                        <a:t>21 개</a:t>
                       </a:r>
                       <a:endParaRPr lang="en-US" sz="1400" dirty="0">
                         <a:latin typeface="맑은 고딕" charset="0"/>
@@ -9649,7 +9649,7 @@
                           <a:ea typeface="맑은 고딕" pitchFamily="34" charset="-122"/>
                           <a:cs typeface="맑은 고딕" pitchFamily="34" charset="-120"/>
                         </a:rPr>
-                        <a:t>CandyPOP Necklace (사이즈: 1size (37~43cm))</a:t>
+                        <a:t>ThreadDuo Necklace</a:t>
                       </a:r>
                       <a:endParaRPr lang="en-US" sz="1100" dirty="0">
                         <a:latin typeface="맑은 고딕" charset="0"/>
@@ -9714,7 +9714,7 @@
                           <a:ea typeface="맑은 고딕" pitchFamily="34" charset="-122"/>
                           <a:cs typeface="맑은 고딕" pitchFamily="34" charset="-120"/>
                         </a:rPr>
-                        <a:t>28 개</a:t>
+                        <a:t>18 개</a:t>
                       </a:r>
                       <a:endParaRPr lang="en-US" sz="1200" dirty="0">
                         <a:latin typeface="맑은 고딕" charset="0"/>
@@ -9911,7 +9911,7 @@
                           <a:ea typeface="맑은 고딕" pitchFamily="34" charset="-122"/>
                           <a:cs typeface="맑은 고딕" pitchFamily="34" charset="-120"/>
                         </a:rPr>
-                        <a:t>ThreadDuo Necklace</a:t>
+                        <a:t>CandyPOP Necklace (사이즈: 2size (47~52cm))</a:t>
                       </a:r>
                       <a:endParaRPr lang="en-US" sz="1100" dirty="0">
                         <a:latin typeface="맑은 고딕" charset="0"/>
@@ -9976,7 +9976,7 @@
                           <a:ea typeface="맑은 고딕" pitchFamily="34" charset="-122"/>
                           <a:cs typeface="맑은 고딕" pitchFamily="34" charset="-120"/>
                         </a:rPr>
-                        <a:t>21 개</a:t>
+                        <a:t>15 개</a:t>
                       </a:r>
                       <a:endParaRPr lang="en-US" sz="1200" dirty="0">
                         <a:latin typeface="맑은 고딕" charset="0"/>
@@ -10062,7 +10062,7 @@
                 <a:ea typeface="맑은 고딕" pitchFamily="34" charset="-122"/>
                 <a:cs typeface="맑은 고딕" pitchFamily="34" charset="-120"/>
               </a:rPr>
-              <a:t>리오더 필요  🔴 긴급 22건</a:t>
+              <a:t>리오더 필요  🔴 긴급 16건</a:t>
             </a:r>
             <a:endParaRPr lang="en-US" sz="1500" dirty="0"/>
           </a:p>
@@ -10126,7 +10126,7 @@
                 <a:ea typeface="맑은 고딕" pitchFamily="34" charset="-122"/>
                 <a:cs typeface="맑은 고딕" pitchFamily="34" charset="-120"/>
               </a:rPr>
-              <a:t>🔴 긴급 22건  ·  상세는 시트 확인</a:t>
+              <a:t>🔴 긴급 16건  ·  상세는 시트 확인</a:t>
             </a:r>
             <a:endParaRPr lang="en-US" sz="1400" dirty="0"/>
           </a:p>
@@ -10165,7 +10165,7 @@
                 <a:ea typeface="맑은 고딕" pitchFamily="34" charset="-122"/>
                 <a:cs typeface="맑은 고딕" pitchFamily="34" charset="-120"/>
               </a:rPr>
-              <a:t>베스트 상품 리포트  ·  생성 2026-06-02 08:00</a:t>
+              <a:t>베스트 상품 리포트  ·  생성 2026-06-03 08:00</a:t>
             </a:r>
             <a:endParaRPr lang="en-US" sz="900" dirty="0"/>
           </a:p>
@@ -10378,7 +10378,7 @@
                 <a:ea typeface="맑은 고딕" pitchFamily="34" charset="-122"/>
                 <a:cs typeface="맑은 고딕" pitchFamily="34" charset="-120"/>
               </a:rPr>
-              <a:t>2026년 06월 02일 (화)</a:t>
+              <a:t>2026년 06월 03일 (수)</a:t>
             </a:r>
             <a:endParaRPr lang="en-US" sz="1200" dirty="0"/>
           </a:p>
@@ -10673,7 +10673,7 @@
                 <a:ea typeface="맑은 고딕" pitchFamily="34" charset="-122"/>
                 <a:cs typeface="맑은 고딕" pitchFamily="34" charset="-120"/>
               </a:rPr>
-              <a:t>27</a:t>
+              <a:t>31</a:t>
             </a:r>
             <a:endParaRPr lang="en-US" sz="3000" dirty="0"/>
           </a:p>
@@ -10801,7 +10801,7 @@
                 <a:ea typeface="맑은 고딕" pitchFamily="34" charset="-122"/>
                 <a:cs typeface="맑은 고딕" pitchFamily="34" charset="-120"/>
               </a:rPr>
-              <a:t>8</a:t>
+              <a:t>7</a:t>
             </a:r>
             <a:endParaRPr lang="en-US" sz="3000" dirty="0"/>
           </a:p>
@@ -10929,7 +10929,7 @@
                 <a:ea typeface="맑은 고딕" pitchFamily="34" charset="-122"/>
                 <a:cs typeface="맑은 고딕" pitchFamily="34" charset="-120"/>
               </a:rPr>
-              <a:t>30,147</a:t>
+              <a:t>28,870</a:t>
             </a:r>
             <a:endParaRPr lang="en-US" sz="3000" dirty="0"/>
           </a:p>
@@ -11489,7 +11489,7 @@
                           <a:ea typeface="맑은 고딕" pitchFamily="34" charset="-122"/>
                           <a:cs typeface="맑은 고딕" pitchFamily="34" charset="-120"/>
                         </a:rPr>
-                        <a:t>2,023</a:t>
+                        <a:t>2,019</a:t>
                       </a:r>
                       <a:endParaRPr lang="en-US" sz="1000" dirty="0">
                         <a:latin typeface="맑은 고딕" charset="0"/>
@@ -11751,7 +11751,7 @@
                           <a:ea typeface="맑은 고딕" pitchFamily="34" charset="-122"/>
                           <a:cs typeface="맑은 고딕" pitchFamily="34" charset="-120"/>
                         </a:rPr>
-                        <a:t>1,542</a:t>
+                        <a:t>1,539</a:t>
                       </a:r>
                       <a:endParaRPr lang="en-US" sz="1000" dirty="0">
                         <a:latin typeface="맑은 고딕" charset="0"/>
@@ -12013,7 +12013,7 @@
                           <a:ea typeface="맑은 고딕" pitchFamily="34" charset="-122"/>
                           <a:cs typeface="맑은 고딕" pitchFamily="34" charset="-120"/>
                         </a:rPr>
-                        <a:t>923</a:t>
+                        <a:t>890</a:t>
                       </a:r>
                       <a:endParaRPr lang="en-US" sz="1000" dirty="0">
                         <a:latin typeface="맑은 고딕" charset="0"/>
@@ -12275,7 +12275,7 @@
                           <a:ea typeface="맑은 고딕" pitchFamily="34" charset="-122"/>
                           <a:cs typeface="맑은 고딕" pitchFamily="34" charset="-120"/>
                         </a:rPr>
-                        <a:t>818</a:t>
+                        <a:t>811</a:t>
                       </a:r>
                       <a:endParaRPr lang="en-US" sz="1000" dirty="0">
                         <a:latin typeface="맑은 고딕" charset="0"/>
@@ -12623,7 +12623,7 @@
                 <a:ea typeface="맑은 고딕" pitchFamily="34" charset="-122"/>
                 <a:cs typeface="맑은 고딕" pitchFamily="34" charset="-120"/>
               </a:rPr>
-              <a:t>재고 점검  🔴 품절 27건</a:t>
+              <a:t>재고 점검  🔴 품절 31건</a:t>
             </a:r>
             <a:pPr indent="0" marL="0">
               <a:buNone/>
@@ -13230,6 +13230,226 @@
                 <a:ea typeface="맑은 고딕" pitchFamily="34" charset="-122"/>
                 <a:cs typeface="맑은 고딕" pitchFamily="34" charset="-120"/>
               </a:rPr>
+              <a:t>360° Rotating Phone Holder</a:t>
+            </a:r>
+            <a:endParaRPr lang="en-US" sz="1000" dirty="0"/>
+          </a:p>
+        </p:txBody>
+      </p:sp>
+      <p:sp>
+        <p:nvSpPr>
+          <p:cNvPr id="43" name="Text 40"/>
+          <p:cNvSpPr/>
+          <p:nvPr/>
+        </p:nvSpPr>
+        <p:spPr>
+          <a:xfrm>
+            <a:off x="8211312" y="5138928"/>
+            <a:ext cx="3291840" cy="256032"/>
+          </a:xfrm>
+          <a:prstGeom prst="rect">
+            <a:avLst/>
+          </a:prstGeom>
+          <a:noFill/>
+          <a:ln/>
+        </p:spPr>
+        <p:txBody>
+          <a:bodyPr wrap="square" lIns="0" tIns="0" rIns="0" bIns="0" rtlCol="0" anchor="ctr"/>
+          <a:lstStyle/>
+          <a:p>
+            <a:pPr indent="0" marL="0">
+              <a:buNone/>
+            </a:pPr>
+            <a:r>
+              <a:rPr lang="en-US" sz="900" dirty="0">
+                <a:solidFill>
+                  <a:srgbClr val="6B7280"/>
+                </a:solidFill>
+                <a:latin typeface="맑은 고딕" pitchFamily="34" charset="0"/>
+                <a:ea typeface="맑은 고딕" pitchFamily="34" charset="-122"/>
+                <a:cs typeface="맑은 고딕" pitchFamily="34" charset="-120"/>
+              </a:rPr>
+              <a:t>컬러: 화이트  ·  재고 0개</a:t>
+            </a:r>
+            <a:pPr indent="0" marL="0">
+              <a:buNone/>
+            </a:pPr>
+            <a:r>
+              <a:rPr lang="en-US" sz="1000" dirty="0">
+                <a:solidFill>
+                  <a:srgbClr val="6B7280"/>
+                </a:solidFill>
+                <a:latin typeface="맑은 고딕" pitchFamily="34" charset="0"/>
+                <a:ea typeface="맑은 고딕" pitchFamily="34" charset="-122"/>
+                <a:cs typeface="맑은 고딕" pitchFamily="34" charset="-120"/>
+              </a:rPr>
+              <a:t/>
+            </a:r>
+            <a:pPr indent="0" marL="0">
+              <a:buNone/>
+            </a:pPr>
+            <a:r>
+              <a:rPr lang="en-US" sz="1000" b="1" dirty="0">
+                <a:solidFill>
+                  <a:srgbClr val="D72638"/>
+                </a:solidFill>
+                <a:latin typeface="맑은 고딕" pitchFamily="34" charset="0"/>
+                <a:ea typeface="맑은 고딕" pitchFamily="34" charset="-122"/>
+                <a:cs typeface="맑은 고딕" pitchFamily="34" charset="-120"/>
+              </a:rPr>
+              <a:t/>
+            </a:r>
+            <a:endParaRPr lang="en-US" sz="900" dirty="0"/>
+          </a:p>
+        </p:txBody>
+      </p:sp>
+      <p:sp>
+        <p:nvSpPr>
+          <p:cNvPr id="44" name="Shape 41"/>
+          <p:cNvSpPr/>
+          <p:nvPr/>
+        </p:nvSpPr>
+        <p:spPr>
+          <a:xfrm>
+            <a:off x="7406640" y="5522976"/>
+            <a:ext cx="4206240" cy="640080"/>
+          </a:xfrm>
+          <a:prstGeom prst="rect">
+            <a:avLst/>
+          </a:prstGeom>
+          <a:solidFill>
+            <a:srgbClr val="FFF5F5"/>
+          </a:solidFill>
+          <a:ln w="6350">
+            <a:solidFill>
+              <a:srgbClr val="E5E7EB"/>
+            </a:solidFill>
+            <a:prstDash val="solid"/>
+          </a:ln>
+        </p:spPr>
+      </p:sp>
+      <p:sp>
+        <p:nvSpPr>
+          <p:cNvPr id="45" name="Shape 42"/>
+          <p:cNvSpPr/>
+          <p:nvPr/>
+        </p:nvSpPr>
+        <p:spPr>
+          <a:xfrm>
+            <a:off x="7406640" y="5522976"/>
+            <a:ext cx="109728" cy="640080"/>
+          </a:xfrm>
+          <a:prstGeom prst="rect">
+            <a:avLst/>
+          </a:prstGeom>
+          <a:solidFill>
+            <a:srgbClr val="D72638"/>
+          </a:solidFill>
+          <a:ln w="12700">
+            <a:solidFill>
+              <a:srgbClr val="D72638"/>
+            </a:solidFill>
+            <a:prstDash val="solid"/>
+          </a:ln>
+        </p:spPr>
+      </p:sp>
+      <p:sp>
+        <p:nvSpPr>
+          <p:cNvPr id="46" name="Shape 43"/>
+          <p:cNvSpPr/>
+          <p:nvPr/>
+        </p:nvSpPr>
+        <p:spPr>
+          <a:xfrm>
+            <a:off x="7571232" y="5614416"/>
+            <a:ext cx="548640" cy="256032"/>
+          </a:xfrm>
+          <a:prstGeom prst="rect">
+            <a:avLst/>
+          </a:prstGeom>
+          <a:solidFill>
+            <a:srgbClr val="D72638"/>
+          </a:solidFill>
+          <a:ln w="12700">
+            <a:solidFill>
+              <a:srgbClr val="D72638"/>
+            </a:solidFill>
+            <a:prstDash val="solid"/>
+          </a:ln>
+        </p:spPr>
+      </p:sp>
+      <p:sp>
+        <p:nvSpPr>
+          <p:cNvPr id="47" name="Text 44"/>
+          <p:cNvSpPr/>
+          <p:nvPr/>
+        </p:nvSpPr>
+        <p:spPr>
+          <a:xfrm>
+            <a:off x="7571232" y="5614416"/>
+            <a:ext cx="548640" cy="256032"/>
+          </a:xfrm>
+          <a:prstGeom prst="rect">
+            <a:avLst/>
+          </a:prstGeom>
+          <a:noFill/>
+          <a:ln/>
+        </p:spPr>
+        <p:txBody>
+          <a:bodyPr wrap="square" lIns="0" tIns="0" rIns="0" bIns="0" rtlCol="0" anchor="ctr"/>
+          <a:lstStyle/>
+          <a:p>
+            <a:pPr algn="ctr" indent="0" marL="0">
+              <a:buNone/>
+            </a:pPr>
+            <a:r>
+              <a:rPr lang="en-US" sz="900" b="1" dirty="0">
+                <a:solidFill>
+                  <a:srgbClr val="FFFFFF"/>
+                </a:solidFill>
+                <a:latin typeface="맑은 고딕" pitchFamily="34" charset="0"/>
+                <a:ea typeface="맑은 고딕" pitchFamily="34" charset="-122"/>
+                <a:cs typeface="맑은 고딕" pitchFamily="34" charset="-120"/>
+              </a:rPr>
+              <a:t>긴급</a:t>
+            </a:r>
+            <a:endParaRPr lang="en-US" sz="900" dirty="0"/>
+          </a:p>
+        </p:txBody>
+      </p:sp>
+      <p:sp>
+        <p:nvSpPr>
+          <p:cNvPr id="48" name="Text 45"/>
+          <p:cNvSpPr/>
+          <p:nvPr/>
+        </p:nvSpPr>
+        <p:spPr>
+          <a:xfrm>
+            <a:off x="8211312" y="5577840"/>
+            <a:ext cx="3291840" cy="274320"/>
+          </a:xfrm>
+          <a:prstGeom prst="rect">
+            <a:avLst/>
+          </a:prstGeom>
+          <a:noFill/>
+          <a:ln/>
+        </p:spPr>
+        <p:txBody>
+          <a:bodyPr wrap="square" lIns="0" tIns="0" rIns="0" bIns="0" rtlCol="0" anchor="ctr"/>
+          <a:lstStyle/>
+          <a:p>
+            <a:pPr indent="0" marL="0">
+              <a:buNone/>
+            </a:pPr>
+            <a:r>
+              <a:rPr lang="en-US" sz="1000" b="1" dirty="0">
+                <a:solidFill>
+                  <a:srgbClr val="0B1220"/>
+                </a:solidFill>
+                <a:latin typeface="맑은 고딕" pitchFamily="34" charset="0"/>
+                <a:ea typeface="맑은 고딕" pitchFamily="34" charset="-122"/>
+                <a:cs typeface="맑은 고딕" pitchFamily="34" charset="-120"/>
+              </a:rPr>
               <a:t>Fuzzy Stripe Slippers (3color)</a:t>
             </a:r>
             <a:endParaRPr lang="en-US" sz="1000" dirty="0"/>
@@ -13238,13 +13458,13 @@
       </p:sp>
       <p:sp>
         <p:nvSpPr>
-          <p:cNvPr id="43" name="Text 40"/>
-          <p:cNvSpPr/>
-          <p:nvPr/>
-        </p:nvSpPr>
-        <p:spPr>
-          <a:xfrm>
-            <a:off x="8211312" y="5138928"/>
+          <p:cNvPr id="49" name="Text 46"/>
+          <p:cNvSpPr/>
+          <p:nvPr/>
+        </p:nvSpPr>
+        <p:spPr>
+          <a:xfrm>
+            <a:off x="8211312" y="5852160"/>
             <a:ext cx="3291840" cy="256032"/>
           </a:xfrm>
           <a:prstGeom prst="rect">
@@ -13305,167 +13525,14 @@
       </p:sp>
       <p:sp>
         <p:nvSpPr>
-          <p:cNvPr id="44" name="Shape 41"/>
-          <p:cNvSpPr/>
-          <p:nvPr/>
-        </p:nvSpPr>
-        <p:spPr>
-          <a:xfrm>
-            <a:off x="7406640" y="5522976"/>
-            <a:ext cx="4206240" cy="640080"/>
-          </a:xfrm>
-          <a:prstGeom prst="rect">
-            <a:avLst/>
-          </a:prstGeom>
-          <a:solidFill>
-            <a:srgbClr val="FFF5F5"/>
-          </a:solidFill>
-          <a:ln w="6350">
-            <a:solidFill>
-              <a:srgbClr val="E5E7EB"/>
-            </a:solidFill>
-            <a:prstDash val="solid"/>
-          </a:ln>
-        </p:spPr>
-      </p:sp>
-      <p:sp>
-        <p:nvSpPr>
-          <p:cNvPr id="45" name="Shape 42"/>
-          <p:cNvSpPr/>
-          <p:nvPr/>
-        </p:nvSpPr>
-        <p:spPr>
-          <a:xfrm>
-            <a:off x="7406640" y="5522976"/>
-            <a:ext cx="109728" cy="640080"/>
-          </a:xfrm>
-          <a:prstGeom prst="rect">
-            <a:avLst/>
-          </a:prstGeom>
-          <a:solidFill>
-            <a:srgbClr val="D72638"/>
-          </a:solidFill>
-          <a:ln w="12700">
-            <a:solidFill>
-              <a:srgbClr val="D72638"/>
-            </a:solidFill>
-            <a:prstDash val="solid"/>
-          </a:ln>
-        </p:spPr>
-      </p:sp>
-      <p:sp>
-        <p:nvSpPr>
-          <p:cNvPr id="46" name="Shape 43"/>
-          <p:cNvSpPr/>
-          <p:nvPr/>
-        </p:nvSpPr>
-        <p:spPr>
-          <a:xfrm>
-            <a:off x="7571232" y="5614416"/>
-            <a:ext cx="548640" cy="256032"/>
-          </a:xfrm>
-          <a:prstGeom prst="rect">
-            <a:avLst/>
-          </a:prstGeom>
-          <a:solidFill>
-            <a:srgbClr val="D72638"/>
-          </a:solidFill>
-          <a:ln w="12700">
-            <a:solidFill>
-              <a:srgbClr val="D72638"/>
-            </a:solidFill>
-            <a:prstDash val="solid"/>
-          </a:ln>
-        </p:spPr>
-      </p:sp>
-      <p:sp>
-        <p:nvSpPr>
-          <p:cNvPr id="47" name="Text 44"/>
-          <p:cNvSpPr/>
-          <p:nvPr/>
-        </p:nvSpPr>
-        <p:spPr>
-          <a:xfrm>
-            <a:off x="7571232" y="5614416"/>
-            <a:ext cx="548640" cy="256032"/>
-          </a:xfrm>
-          <a:prstGeom prst="rect">
-            <a:avLst/>
-          </a:prstGeom>
-          <a:noFill/>
-          <a:ln/>
-        </p:spPr>
-        <p:txBody>
-          <a:bodyPr wrap="square" lIns="0" tIns="0" rIns="0" bIns="0" rtlCol="0" anchor="ctr"/>
-          <a:lstStyle/>
-          <a:p>
-            <a:pPr algn="ctr" indent="0" marL="0">
-              <a:buNone/>
-            </a:pPr>
-            <a:r>
-              <a:rPr lang="en-US" sz="900" b="1" dirty="0">
-                <a:solidFill>
-                  <a:srgbClr val="FFFFFF"/>
-                </a:solidFill>
-                <a:latin typeface="맑은 고딕" pitchFamily="34" charset="0"/>
-                <a:ea typeface="맑은 고딕" pitchFamily="34" charset="-122"/>
-                <a:cs typeface="맑은 고딕" pitchFamily="34" charset="-120"/>
-              </a:rPr>
-              <a:t>긴급</a:t>
-            </a:r>
-            <a:endParaRPr lang="en-US" sz="900" dirty="0"/>
-          </a:p>
-        </p:txBody>
-      </p:sp>
-      <p:sp>
-        <p:nvSpPr>
-          <p:cNvPr id="48" name="Text 45"/>
-          <p:cNvSpPr/>
-          <p:nvPr/>
-        </p:nvSpPr>
-        <p:spPr>
-          <a:xfrm>
-            <a:off x="8211312" y="5577840"/>
-            <a:ext cx="3291840" cy="274320"/>
-          </a:xfrm>
-          <a:prstGeom prst="rect">
-            <a:avLst/>
-          </a:prstGeom>
-          <a:noFill/>
-          <a:ln/>
-        </p:spPr>
-        <p:txBody>
-          <a:bodyPr wrap="square" lIns="0" tIns="0" rIns="0" bIns="0" rtlCol="0" anchor="ctr"/>
-          <a:lstStyle/>
-          <a:p>
-            <a:pPr indent="0" marL="0">
-              <a:buNone/>
-            </a:pPr>
-            <a:r>
-              <a:rPr lang="en-US" sz="1000" b="1" dirty="0">
-                <a:solidFill>
-                  <a:srgbClr val="0B1220"/>
-                </a:solidFill>
-                <a:latin typeface="맑은 고딕" pitchFamily="34" charset="0"/>
-                <a:ea typeface="맑은 고딕" pitchFamily="34" charset="-122"/>
-                <a:cs typeface="맑은 고딕" pitchFamily="34" charset="-120"/>
-              </a:rPr>
-              <a:t>Cotton Lunch Mini Bag (5color)</a:t>
-            </a:r>
-            <a:endParaRPr lang="en-US" sz="1000" dirty="0"/>
-          </a:p>
-        </p:txBody>
-      </p:sp>
-      <p:sp>
-        <p:nvSpPr>
-          <p:cNvPr id="49" name="Text 46"/>
-          <p:cNvSpPr/>
-          <p:nvPr/>
-        </p:nvSpPr>
-        <p:spPr>
-          <a:xfrm>
-            <a:off x="8211312" y="5852160"/>
-            <a:ext cx="3291840" cy="256032"/>
+          <p:cNvPr id="50" name="Text 47"/>
+          <p:cNvSpPr/>
+          <p:nvPr/>
+        </p:nvSpPr>
+        <p:spPr>
+          <a:xfrm>
+            <a:off x="548640" y="6492240"/>
+            <a:ext cx="7315200" cy="274320"/>
           </a:xfrm>
           <a:prstGeom prst="rect">
             <a:avLst/>
@@ -13489,74 +13556,7 @@
                 <a:ea typeface="맑은 고딕" pitchFamily="34" charset="-122"/>
                 <a:cs typeface="맑은 고딕" pitchFamily="34" charset="-120"/>
               </a:rPr>
-              <a:t>색상: 레드  ·  재고 0개</a:t>
-            </a:r>
-            <a:pPr indent="0" marL="0">
-              <a:buNone/>
-            </a:pPr>
-            <a:r>
-              <a:rPr lang="en-US" sz="1000" dirty="0">
-                <a:solidFill>
-                  <a:srgbClr val="6B7280"/>
-                </a:solidFill>
-                <a:latin typeface="맑은 고딕" pitchFamily="34" charset="0"/>
-                <a:ea typeface="맑은 고딕" pitchFamily="34" charset="-122"/>
-                <a:cs typeface="맑은 고딕" pitchFamily="34" charset="-120"/>
-              </a:rPr>
-              <a:t/>
-            </a:r>
-            <a:pPr indent="0" marL="0">
-              <a:buNone/>
-            </a:pPr>
-            <a:r>
-              <a:rPr lang="en-US" sz="1000" b="1" dirty="0">
-                <a:solidFill>
-                  <a:srgbClr val="D72638"/>
-                </a:solidFill>
-                <a:latin typeface="맑은 고딕" pitchFamily="34" charset="0"/>
-                <a:ea typeface="맑은 고딕" pitchFamily="34" charset="-122"/>
-                <a:cs typeface="맑은 고딕" pitchFamily="34" charset="-120"/>
-              </a:rPr>
-              <a:t/>
-            </a:r>
-            <a:endParaRPr lang="en-US" sz="900" dirty="0"/>
-          </a:p>
-        </p:txBody>
-      </p:sp>
-      <p:sp>
-        <p:nvSpPr>
-          <p:cNvPr id="50" name="Text 47"/>
-          <p:cNvSpPr/>
-          <p:nvPr/>
-        </p:nvSpPr>
-        <p:spPr>
-          <a:xfrm>
-            <a:off x="548640" y="6492240"/>
-            <a:ext cx="7315200" cy="274320"/>
-          </a:xfrm>
-          <a:prstGeom prst="rect">
-            <a:avLst/>
-          </a:prstGeom>
-          <a:noFill/>
-          <a:ln/>
-        </p:spPr>
-        <p:txBody>
-          <a:bodyPr wrap="square" lIns="0" tIns="0" rIns="0" bIns="0" rtlCol="0" anchor="ctr"/>
-          <a:lstStyle/>
-          <a:p>
-            <a:pPr indent="0" marL="0">
-              <a:buNone/>
-            </a:pPr>
-            <a:r>
-              <a:rPr lang="en-US" sz="900" dirty="0">
-                <a:solidFill>
-                  <a:srgbClr val="6B7280"/>
-                </a:solidFill>
-                <a:latin typeface="맑은 고딕" pitchFamily="34" charset="0"/>
-                <a:ea typeface="맑은 고딕" pitchFamily="34" charset="-122"/>
-                <a:cs typeface="맑은 고딕" pitchFamily="34" charset="-120"/>
-              </a:rPr>
-              <a:t>베스트 상품 리포트  ·  생성 2026-06-02 08:00</a:t>
+              <a:t>베스트 상품 리포트  ·  생성 2026-06-03 08:00</a:t>
             </a:r>
             <a:endParaRPr lang="en-US" sz="900" dirty="0"/>
           </a:p>
@@ -13769,7 +13769,7 @@
                 <a:ea typeface="맑은 고딕" pitchFamily="34" charset="-122"/>
                 <a:cs typeface="맑은 고딕" pitchFamily="34" charset="-120"/>
               </a:rPr>
-              <a:t>2026년 06월 02일 (화)</a:t>
+              <a:t>2026년 06월 03일 (수)</a:t>
             </a:r>
             <a:endParaRPr lang="en-US" sz="1200" dirty="0"/>
           </a:p>
@@ -13897,7 +13897,7 @@
                 <a:ea typeface="맑은 고딕" pitchFamily="34" charset="-122"/>
                 <a:cs typeface="맑은 고딕" pitchFamily="34" charset="-120"/>
               </a:rPr>
-              <a:t>🚨  긴급 리오더 71건    ·    주의 리오더 7건    ·    오늘 발주 검토 필수</a:t>
+              <a:t>🚨  긴급 리오더 68건    ·    주의 리오더 6건    ·    오늘 발주 검토 필수</a:t>
             </a:r>
             <a:pPr indent="0" marL="0">
               <a:buNone/>
@@ -14527,7 +14527,7 @@
                           <a:ea typeface="맑은 고딕" pitchFamily="34" charset="-122"/>
                           <a:cs typeface="맑은 고딕" pitchFamily="34" charset="-120"/>
                         </a:rPr>
-                        <a:t>6A</a:t>
+                        <a:t>PR</a:t>
                       </a:r>
                       <a:endParaRPr lang="en-US" sz="1100" dirty="0">
                         <a:latin typeface="맑은 고딕" charset="0"/>
@@ -14595,7 +14595,7 @@
                           <a:ea typeface="맑은 고딕" pitchFamily="34" charset="-122"/>
                           <a:cs typeface="맑은 고딕" pitchFamily="34" charset="-120"/>
                         </a:rPr>
-                        <a:t>Ring</a:t>
+                        <a:t>ELECTRONIC</a:t>
                       </a:r>
                       <a:endParaRPr lang="en-US" sz="1000" dirty="0">
                         <a:latin typeface="맑은 고딕" charset="0"/>
@@ -14663,7 +14663,7 @@
                           <a:ea typeface="맑은 고딕" pitchFamily="34" charset="-122"/>
                           <a:cs typeface="맑은 고딕" pitchFamily="34" charset="-120"/>
                         </a:rPr>
-                        <a:t>[SILVER925] Mustafakemalpaşa Ring (사이즈: 12호)</a:t>
+                        <a:t>180° Fast Charging Cable (8color) (컬러: 퍼플 / 기종 옵션: C type -&gt; C type)</a:t>
                       </a:r>
                       <a:endParaRPr lang="en-US" sz="1100" dirty="0">
                         <a:latin typeface="맑은 고딕" charset="0"/>
@@ -14799,7 +14799,7 @@
                           <a:ea typeface="맑은 고딕" pitchFamily="34" charset="-122"/>
                           <a:cs typeface="맑은 고딕" pitchFamily="34" charset="-120"/>
                         </a:rPr>
-                        <a:t>20 개</a:t>
+                        <a:t>370 개</a:t>
                       </a:r>
                       <a:endParaRPr lang="en-US" sz="1100" dirty="0">
                         <a:latin typeface="맑은 고딕" charset="0"/>
@@ -14937,7 +14937,7 @@
                           <a:ea typeface="맑은 고딕" pitchFamily="34" charset="-122"/>
                           <a:cs typeface="맑은 고딕" pitchFamily="34" charset="-120"/>
                         </a:rPr>
-                        <a:t>CT</a:t>
+                        <a:t>PR</a:t>
                       </a:r>
                       <a:endParaRPr lang="en-US" sz="1100" dirty="0">
                         <a:latin typeface="맑은 고딕" charset="0"/>
@@ -15005,7 +15005,7 @@
                           <a:ea typeface="맑은 고딕" pitchFamily="34" charset="-122"/>
                           <a:cs typeface="맑은 고딕" pitchFamily="34" charset="-120"/>
                         </a:rPr>
-                        <a:t>Ring</a:t>
+                        <a:t>ELECTRONIC</a:t>
                       </a:r>
                       <a:endParaRPr lang="en-US" sz="1000" dirty="0">
                         <a:latin typeface="맑은 고딕" charset="0"/>
@@ -15073,7 +15073,7 @@
                           <a:ea typeface="맑은 고딕" pitchFamily="34" charset="-122"/>
                           <a:cs typeface="맑은 고딕" pitchFamily="34" charset="-120"/>
                         </a:rPr>
-                        <a:t>"Ribbonwist" 925 Open Ring</a:t>
+                        <a:t>180° Fast Charging Cable (8color) (컬러: 네온그린 / 기종 옵션: USB -&gt; C type)</a:t>
                       </a:r>
                       <a:endParaRPr lang="en-US" sz="1100" dirty="0">
                         <a:latin typeface="맑은 고딕" charset="0"/>
@@ -15209,7 +15209,7 @@
                           <a:ea typeface="맑은 고딕" pitchFamily="34" charset="-122"/>
                           <a:cs typeface="맑은 고딕" pitchFamily="34" charset="-120"/>
                         </a:rPr>
-                        <a:t>5 개</a:t>
+                        <a:t>139 개</a:t>
                       </a:r>
                       <a:endParaRPr lang="en-US" sz="1100" dirty="0">
                         <a:latin typeface="맑은 고딕" charset="0"/>
@@ -15347,7 +15347,7 @@
                           <a:ea typeface="맑은 고딕" pitchFamily="34" charset="-122"/>
                           <a:cs typeface="맑은 고딕" pitchFamily="34" charset="-120"/>
                         </a:rPr>
-                        <a:t>CT</a:t>
+                        <a:t>PR</a:t>
                       </a:r>
                       <a:endParaRPr lang="en-US" sz="1100" dirty="0">
                         <a:latin typeface="맑은 고딕" charset="0"/>
@@ -15415,7 +15415,7 @@
                           <a:ea typeface="맑은 고딕" pitchFamily="34" charset="-122"/>
                           <a:cs typeface="맑은 고딕" pitchFamily="34" charset="-120"/>
                         </a:rPr>
-                        <a:t>Ring</a:t>
+                        <a:t>ETC</a:t>
                       </a:r>
                       <a:endParaRPr lang="en-US" sz="1000" dirty="0">
                         <a:latin typeface="맑은 고딕" charset="0"/>
@@ -15483,7 +15483,7 @@
                           <a:ea typeface="맑은 고딕" pitchFamily="34" charset="-122"/>
                           <a:cs typeface="맑은 고딕" pitchFamily="34" charset="-120"/>
                         </a:rPr>
-                        <a:t>"Qrone" 925 Open Ring</a:t>
+                        <a:t>Pixel Mini Handle Pouch (4color) (컬러: 민트)</a:t>
                       </a:r>
                       <a:endParaRPr lang="en-US" sz="1100" dirty="0">
                         <a:latin typeface="맑은 고딕" charset="0"/>
@@ -15551,7 +15551,7 @@
                           <a:ea typeface="맑은 고딕" pitchFamily="34" charset="-122"/>
                           <a:cs typeface="맑은 고딕" pitchFamily="34" charset="-120"/>
                         </a:rPr>
-                        <a:t>5</a:t>
+                        <a:t>2</a:t>
                       </a:r>
                       <a:endParaRPr lang="en-US" sz="1100" dirty="0">
                         <a:latin typeface="맑은 고딕" charset="0"/>
@@ -15619,7 +15619,7 @@
                           <a:ea typeface="맑은 고딕" pitchFamily="34" charset="-122"/>
                           <a:cs typeface="맑은 고딕" pitchFamily="34" charset="-120"/>
                         </a:rPr>
-                        <a:t>3 개</a:t>
+                        <a:t>21 개</a:t>
                       </a:r>
                       <a:endParaRPr lang="en-US" sz="1100" dirty="0">
                         <a:latin typeface="맑은 고딕" charset="0"/>
@@ -15757,7 +15757,7 @@
                           <a:ea typeface="맑은 고딕" pitchFamily="34" charset="-122"/>
                           <a:cs typeface="맑은 고딕" pitchFamily="34" charset="-120"/>
                         </a:rPr>
-                        <a:t>CT</a:t>
+                        <a:t>6A</a:t>
                       </a:r>
                       <a:endParaRPr lang="en-US" sz="1100" dirty="0">
                         <a:latin typeface="맑은 고딕" charset="0"/>
@@ -15893,7 +15893,7 @@
                           <a:ea typeface="맑은 고딕" pitchFamily="34" charset="-122"/>
                           <a:cs typeface="맑은 고딕" pitchFamily="34" charset="-120"/>
                         </a:rPr>
-                        <a:t>"ATOR" 925 Open Ring</a:t>
+                        <a:t>[SILVER925] Width Open Ring</a:t>
                       </a:r>
                       <a:endParaRPr lang="en-US" sz="1100" dirty="0">
                         <a:latin typeface="맑은 고딕" charset="0"/>
@@ -15961,7 +15961,7 @@
                           <a:ea typeface="맑은 고딕" pitchFamily="34" charset="-122"/>
                           <a:cs typeface="맑은 고딕" pitchFamily="34" charset="-120"/>
                         </a:rPr>
-                        <a:t>0</a:t>
+                        <a:t>5</a:t>
                       </a:r>
                       <a:endParaRPr lang="en-US" sz="1100" dirty="0">
                         <a:latin typeface="맑은 고딕" charset="0"/>
@@ -16029,7 +16029,7 @@
                           <a:ea typeface="맑은 고딕" pitchFamily="34" charset="-122"/>
                           <a:cs typeface="맑은 고딕" pitchFamily="34" charset="-120"/>
                         </a:rPr>
-                        <a:t>3 개</a:t>
+                        <a:t>7 개</a:t>
                       </a:r>
                       <a:endParaRPr lang="en-US" sz="1100" dirty="0">
                         <a:latin typeface="맑은 고딕" charset="0"/>
@@ -16167,7 +16167,7 @@
                           <a:ea typeface="맑은 고딕" pitchFamily="34" charset="-122"/>
                           <a:cs typeface="맑은 고딕" pitchFamily="34" charset="-120"/>
                         </a:rPr>
-                        <a:t>6A</a:t>
+                        <a:t>CT</a:t>
                       </a:r>
                       <a:endParaRPr lang="en-US" sz="1100" dirty="0">
                         <a:latin typeface="맑은 고딕" charset="0"/>
@@ -16235,7 +16235,7 @@
                           <a:ea typeface="맑은 고딕" pitchFamily="34" charset="-122"/>
                           <a:cs typeface="맑은 고딕" pitchFamily="34" charset="-120"/>
                         </a:rPr>
-                        <a:t>Bracelet</a:t>
+                        <a:t>Ring</a:t>
                       </a:r>
                       <a:endParaRPr lang="en-US" sz="1000" dirty="0">
                         <a:latin typeface="맑은 고딕" charset="0"/>
@@ -16303,7 +16303,7 @@
                           <a:ea typeface="맑은 고딕" pitchFamily="34" charset="-122"/>
                           <a:cs typeface="맑은 고딕" pitchFamily="34" charset="-120"/>
                         </a:rPr>
-                        <a:t>Phorn Bracelet</a:t>
+                        <a:t>"Qrone" 925 Open Ring</a:t>
                       </a:r>
                       <a:endParaRPr lang="en-US" sz="1100" dirty="0">
                         <a:latin typeface="맑은 고딕" charset="0"/>
@@ -16371,7 +16371,7 @@
                           <a:ea typeface="맑은 고딕" pitchFamily="34" charset="-122"/>
                           <a:cs typeface="맑은 고딕" pitchFamily="34" charset="-120"/>
                         </a:rPr>
-                        <a:t>5</a:t>
+                        <a:t>3</a:t>
                       </a:r>
                       <a:endParaRPr lang="en-US" sz="1100" dirty="0">
                         <a:latin typeface="맑은 고딕" charset="0"/>
@@ -16577,7 +16577,7 @@
                           <a:ea typeface="맑은 고딕" pitchFamily="34" charset="-122"/>
                           <a:cs typeface="맑은 고딕" pitchFamily="34" charset="-120"/>
                         </a:rPr>
-                        <a:t>CT</a:t>
+                        <a:t>PR</a:t>
                       </a:r>
                       <a:endParaRPr lang="en-US" sz="1100" dirty="0">
                         <a:latin typeface="맑은 고딕" charset="0"/>
@@ -16645,7 +16645,7 @@
                           <a:ea typeface="맑은 고딕" pitchFamily="34" charset="-122"/>
                           <a:cs typeface="맑은 고딕" pitchFamily="34" charset="-120"/>
                         </a:rPr>
-                        <a:t>Ring</a:t>
+                        <a:t>ELECTRONIC</a:t>
                       </a:r>
                       <a:endParaRPr lang="en-US" sz="1000" dirty="0">
                         <a:latin typeface="맑은 고딕" charset="0"/>
@@ -16713,7 +16713,7 @@
                           <a:ea typeface="맑은 고딕" pitchFamily="34" charset="-122"/>
                           <a:cs typeface="맑은 고딕" pitchFamily="34" charset="-120"/>
                         </a:rPr>
-                        <a:t>"Mlayer" 925 Open Ring</a:t>
+                        <a:t>Jacquard Fast Charging Cable (7color) (컬러: 블루 / 기종옵션: C-Apple 8pin / 길이: 2m)</a:t>
                       </a:r>
                       <a:endParaRPr lang="en-US" sz="1100" dirty="0">
                         <a:latin typeface="맑은 고딕" charset="0"/>
@@ -16987,7 +16987,7 @@
                           <a:ea typeface="맑은 고딕" pitchFamily="34" charset="-122"/>
                           <a:cs typeface="맑은 고딕" pitchFamily="34" charset="-120"/>
                         </a:rPr>
-                        <a:t>PR</a:t>
+                        <a:t>CT</a:t>
                       </a:r>
                       <a:endParaRPr lang="en-US" sz="1100" dirty="0">
                         <a:latin typeface="맑은 고딕" charset="0"/>
@@ -17055,7 +17055,7 @@
                           <a:ea typeface="맑은 고딕" pitchFamily="34" charset="-122"/>
                           <a:cs typeface="맑은 고딕" pitchFamily="34" charset="-120"/>
                         </a:rPr>
-                        <a:t>ETC</a:t>
+                        <a:t>Necklace</a:t>
                       </a:r>
                       <a:endParaRPr lang="en-US" sz="1000" dirty="0">
                         <a:latin typeface="맑은 고딕" charset="0"/>
@@ -17123,7 +17123,7 @@
                           <a:ea typeface="맑은 고딕" pitchFamily="34" charset="-122"/>
                           <a:cs typeface="맑은 고딕" pitchFamily="34" charset="-120"/>
                         </a:rPr>
-                        <a:t>360° Rotating Phone Holder (컬러: 블랙)</a:t>
+                        <a:t>DBLfix Necklace</a:t>
                       </a:r>
                       <a:endParaRPr lang="en-US" sz="1100" dirty="0">
                         <a:latin typeface="맑은 고딕" charset="0"/>
@@ -17191,7 +17191,7 @@
                           <a:ea typeface="맑은 고딕" pitchFamily="34" charset="-122"/>
                           <a:cs typeface="맑은 고딕" pitchFamily="34" charset="-120"/>
                         </a:rPr>
-                        <a:t>10</a:t>
+                        <a:t>5</a:t>
                       </a:r>
                       <a:endParaRPr lang="en-US" sz="1100" dirty="0">
                         <a:latin typeface="맑은 고딕" charset="0"/>
@@ -17259,7 +17259,7 @@
                           <a:ea typeface="맑은 고딕" pitchFamily="34" charset="-122"/>
                           <a:cs typeface="맑은 고딕" pitchFamily="34" charset="-120"/>
                         </a:rPr>
-                        <a:t>2 개</a:t>
+                        <a:t>1 개</a:t>
                       </a:r>
                       <a:endParaRPr lang="en-US" sz="1100" dirty="0">
                         <a:latin typeface="맑은 고딕" charset="0"/>
@@ -17465,7 +17465,7 @@
                           <a:ea typeface="맑은 고딕" pitchFamily="34" charset="-122"/>
                           <a:cs typeface="맑은 고딕" pitchFamily="34" charset="-120"/>
                         </a:rPr>
-                        <a:t>ETC</a:t>
+                        <a:t>ELECTRONIC</a:t>
                       </a:r>
                       <a:endParaRPr lang="en-US" sz="1000" dirty="0">
                         <a:latin typeface="맑은 고딕" charset="0"/>
@@ -17533,7 +17533,7 @@
                           <a:ea typeface="맑은 고딕" pitchFamily="34" charset="-122"/>
                           <a:cs typeface="맑은 고딕" pitchFamily="34" charset="-120"/>
                         </a:rPr>
-                        <a:t>360° Rotating Phone Holder (컬러: 화이트)</a:t>
+                        <a:t>Jacquard Fast Charging Cable (7color) (컬러: 그레이 / 기종옵션: C-Apple 8pin / 길이: 1m)</a:t>
                       </a:r>
                       <a:endParaRPr lang="en-US" sz="1100" dirty="0">
                         <a:latin typeface="맑은 고딕" charset="0"/>
@@ -17601,7 +17601,7 @@
                           <a:ea typeface="맑은 고딕" pitchFamily="34" charset="-122"/>
                           <a:cs typeface="맑은 고딕" pitchFamily="34" charset="-120"/>
                         </a:rPr>
-                        <a:t>1</a:t>
+                        <a:t>17</a:t>
                       </a:r>
                       <a:endParaRPr lang="en-US" sz="1100" dirty="0">
                         <a:latin typeface="맑은 고딕" charset="0"/>
@@ -17669,7 +17669,7 @@
                           <a:ea typeface="맑은 고딕" pitchFamily="34" charset="-122"/>
                           <a:cs typeface="맑은 고딕" pitchFamily="34" charset="-120"/>
                         </a:rPr>
-                        <a:t>2 개</a:t>
+                        <a:t>1 개</a:t>
                       </a:r>
                       <a:endParaRPr lang="en-US" sz="1100" dirty="0">
                         <a:latin typeface="맑은 고딕" charset="0"/>
@@ -17807,7 +17807,7 @@
                           <a:ea typeface="맑은 고딕" pitchFamily="34" charset="-122"/>
                           <a:cs typeface="맑은 고딕" pitchFamily="34" charset="-120"/>
                         </a:rPr>
-                        <a:t>CT</a:t>
+                        <a:t>PR</a:t>
                       </a:r>
                       <a:endParaRPr lang="en-US" sz="1100" dirty="0">
                         <a:latin typeface="맑은 고딕" charset="0"/>
@@ -17875,7 +17875,7 @@
                           <a:ea typeface="맑은 고딕" pitchFamily="34" charset="-122"/>
                           <a:cs typeface="맑은 고딕" pitchFamily="34" charset="-120"/>
                         </a:rPr>
-                        <a:t>Ring</a:t>
+                        <a:t>ETC</a:t>
                       </a:r>
                       <a:endParaRPr lang="en-US" sz="1000" dirty="0">
                         <a:latin typeface="맑은 고딕" charset="0"/>
@@ -17943,7 +17943,7 @@
                           <a:ea typeface="맑은 고딕" pitchFamily="34" charset="-122"/>
                           <a:cs typeface="맑은 고딕" pitchFamily="34" charset="-120"/>
                         </a:rPr>
-                        <a:t>"Crackave" 925 Open Ring</a:t>
+                        <a:t>360° Rotating Phone Holder (컬러: 블랙)</a:t>
                       </a:r>
                       <a:endParaRPr lang="en-US" sz="1100" dirty="0">
                         <a:latin typeface="맑은 고딕" charset="0"/>
@@ -18011,7 +18011,7 @@
                           <a:ea typeface="맑은 고딕" pitchFamily="34" charset="-122"/>
                           <a:cs typeface="맑은 고딕" pitchFamily="34" charset="-120"/>
                         </a:rPr>
-                        <a:t>0</a:t>
+                        <a:t>9</a:t>
                       </a:r>
                       <a:endParaRPr lang="en-US" sz="1100" dirty="0">
                         <a:latin typeface="맑은 고딕" charset="0"/>
@@ -18168,7 +18168,7 @@
                 <a:ea typeface="맑은 고딕" pitchFamily="34" charset="-122"/>
                 <a:cs typeface="맑은 고딕" pitchFamily="34" charset="-120"/>
               </a:rPr>
-              <a:t>외 62건 더 있음 — 상세는 시트에서 확인</a:t>
+              <a:t>외 59건 더 있음 — 상세는 시트에서 확인</a:t>
             </a:r>
             <a:endParaRPr lang="en-US" sz="1000" dirty="0"/>
           </a:p>
@@ -18207,7 +18207,7 @@
                 <a:ea typeface="맑은 고딕" pitchFamily="34" charset="-122"/>
                 <a:cs typeface="맑은 고딕" pitchFamily="34" charset="-120"/>
               </a:rPr>
-              <a:t>베스트 상품 리포트  ·  생성 2026-06-02 08:00</a:t>
+              <a:t>베스트 상품 리포트  ·  생성 2026-06-03 08:00</a:t>
             </a:r>
             <a:endParaRPr lang="en-US" sz="900" dirty="0"/>
           </a:p>
@@ -18420,7 +18420,7 @@
                 <a:ea typeface="맑은 고딕" pitchFamily="34" charset="-122"/>
                 <a:cs typeface="맑은 고딕" pitchFamily="34" charset="-120"/>
               </a:rPr>
-              <a:t>2026년 06월 02일 (화)</a:t>
+              <a:t>2026년 06월 03일 (수)</a:t>
             </a:r>
             <a:endParaRPr lang="en-US" sz="1200" dirty="0"/>
           </a:p>
@@ -18587,7 +18587,7 @@
                 <a:ea typeface="맑은 고딕" pitchFamily="34" charset="-122"/>
                 <a:cs typeface="맑은 고딕" pitchFamily="34" charset="-120"/>
               </a:rPr>
-              <a:t>Google Sheet '브랜드 재고현황'  ·  최신화 2026-06-02 08:00</a:t>
+              <a:t>Google Sheet '브랜드 재고현황'  ·  최신화 2026-06-03 08:00</a:t>
             </a:r>
             <a:endParaRPr lang="en-US" sz="1100" dirty="0"/>
           </a:p>
@@ -19099,7 +19099,7 @@
                 <a:ea typeface="맑은 고딕" pitchFamily="34" charset="-122"/>
                 <a:cs typeface="맑은 고딕" pitchFamily="34" charset="-120"/>
               </a:rPr>
-              <a:t>✅ 6A 100 SKU  /  ✅ Cleartype 59 SKU  /  ✅ Produktepr 201 SKU (판매 수집됨)</a:t>
+              <a:t>✅ 6A 99 SKU  /  ✅ Cleartype 60 SKU  /  ✅ Produktepr 201 SKU (판매 수집됨)</a:t>
             </a:r>
             <a:endParaRPr lang="en-US" sz="1100" dirty="0"/>
           </a:p>
@@ -19230,7 +19230,7 @@
                 <a:ea typeface="맑은 고딕" pitchFamily="34" charset="-122"/>
                 <a:cs typeface="맑은 고딕" pitchFamily="34" charset="-120"/>
               </a:rPr>
-              <a:t>✅ 3개 브랜드 모두 정상 추출  ·  24h 출고 기준 (2026-06-01 08:00 → 2026-06-02 08:00) · 신규 SKU 15건은 결제완료 기준</a:t>
+              <a:t>✅ 3개 브랜드 모두 정상 추출  ·  24h 출고 기준 (2026-06-02 08:00 → 2026-06-03 08:00) · 신규 SKU 16건은 결제완료 기준</a:t>
             </a:r>
             <a:endParaRPr lang="en-US" sz="1000" dirty="0"/>
           </a:p>
@@ -19269,7 +19269,7 @@
                 <a:ea typeface="맑은 고딕" pitchFamily="34" charset="-122"/>
                 <a:cs typeface="맑은 고딕" pitchFamily="34" charset="-120"/>
               </a:rPr>
-              <a:t>베스트 상품 리포트  ·  생성 2026-06-02 08:00</a:t>
+              <a:t>베스트 상품 리포트  ·  생성 2026-06-03 08:00</a:t>
             </a:r>
             <a:endParaRPr lang="en-US" sz="900" dirty="0"/>
           </a:p>

</xml_diff>

<commit_message>
chore: 매출 PPT 업로드 (best-sellers-2026-06-04.pptx) [auto]
</commit_message>
<xml_diff>
--- a/data/sales-report.pptx
+++ b/data/sales-report.pptx
@@ -1648,7 +1648,7 @@
                 <a:ea typeface="맑은 고딕" pitchFamily="34" charset="-122"/>
                 <a:cs typeface="맑은 고딕" pitchFamily="34" charset="-120"/>
               </a:rPr>
-              <a:t>2026년 06월 03일 (수)  ·  24h 출고 기준</a:t>
+              <a:t>2026년 06월 04일 (목)  ·  24h 출고 기준</a:t>
             </a:r>
             <a:endParaRPr lang="en-US" sz="2200" dirty="0"/>
           </a:p>
@@ -1726,7 +1726,7 @@
                 <a:ea typeface="맑은 고딕" pitchFamily="34" charset="-122"/>
                 <a:cs typeface="맑은 고딕" pitchFamily="34" charset="-120"/>
               </a:rPr>
-              <a:t>06.03</a:t>
+              <a:t>06.04</a:t>
             </a:r>
             <a:endParaRPr lang="en-US" sz="7200" dirty="0"/>
           </a:p>
@@ -1765,7 +1765,7 @@
                 <a:ea typeface="맑은 고딕" pitchFamily="34" charset="-122"/>
                 <a:cs typeface="맑은 고딕" pitchFamily="34" charset="-120"/>
               </a:rPr>
-              <a:t>수요일</a:t>
+              <a:t>목요일</a:t>
             </a:r>
             <a:endParaRPr lang="en-US" sz="1400" dirty="0"/>
           </a:p>
@@ -1804,7 +1804,7 @@
                 <a:ea typeface="맑은 고딕" pitchFamily="34" charset="-122"/>
                 <a:cs typeface="맑은 고딕" pitchFamily="34" charset="-120"/>
               </a:rPr>
-              <a:t>생성 2026-06-03 08:00  ·  Google Sheet 자동 동기</a:t>
+              <a:t>생성 2026-06-04 08:00  ·  Google Sheet 자동 동기</a:t>
             </a:r>
             <a:endParaRPr lang="en-US" sz="1000" dirty="0"/>
           </a:p>
@@ -1978,7 +1978,7 @@
                 <a:ea typeface="맑은 고딕" pitchFamily="34" charset="-122"/>
                 <a:cs typeface="맑은 고딕" pitchFamily="34" charset="-120"/>
               </a:rPr>
-              <a:t>2026년 06월 03일 (수)</a:t>
+              <a:t>2026년 06월 04일 (목)</a:t>
             </a:r>
             <a:endParaRPr lang="en-US" sz="1200" dirty="0"/>
           </a:p>
@@ -2145,7 +2145,7 @@
                 <a:ea typeface="맑은 고딕" pitchFamily="34" charset="-122"/>
                 <a:cs typeface="맑은 고딕" pitchFamily="34" charset="-120"/>
               </a:rPr>
-              <a:t>482 개</a:t>
+              <a:t>351 개</a:t>
             </a:r>
             <a:endParaRPr lang="en-US" sz="3600" dirty="0"/>
           </a:p>
@@ -2312,7 +2312,7 @@
                 <a:ea typeface="맑은 고딕" pitchFamily="34" charset="-122"/>
                 <a:cs typeface="맑은 고딕" pitchFamily="34" charset="-120"/>
               </a:rPr>
-              <a:t>68 건</a:t>
+              <a:t>63 건</a:t>
             </a:r>
             <a:endParaRPr lang="en-US" sz="3200" dirty="0"/>
           </a:p>
@@ -3612,7 +3612,7 @@
                           <a:ea typeface="맑은 고딕" pitchFamily="34" charset="-122"/>
                           <a:cs typeface="맑은 고딕" pitchFamily="34" charset="-120"/>
                         </a:rPr>
-                        <a:t>[SILVER925] CH.alban Open Ring</a:t>
+                        <a:t>[SILVER925] Guyeong Open Ring v3.0 (silver)</a:t>
                       </a:r>
                       <a:endParaRPr lang="en-US" sz="1100" dirty="0">
                         <a:latin typeface="맑은 고딕" charset="0"/>
@@ -3677,7 +3677,7 @@
                           <a:ea typeface="맑은 고딕" pitchFamily="34" charset="-122"/>
                           <a:cs typeface="맑은 고딕" pitchFamily="34" charset="-120"/>
                         </a:rPr>
-                        <a:t>58 개</a:t>
+                        <a:t>56 개</a:t>
                       </a:r>
                       <a:endParaRPr lang="en-US" sz="1400" dirty="0">
                         <a:latin typeface="맑은 고딕" charset="0"/>
@@ -3809,7 +3809,7 @@
                           <a:ea typeface="맑은 고딕" pitchFamily="34" charset="-122"/>
                           <a:cs typeface="맑은 고딕" pitchFamily="34" charset="-120"/>
                         </a:rPr>
-                        <a:t>6A</a:t>
+                        <a:t>CT</a:t>
                       </a:r>
                       <a:endParaRPr lang="en-US" sz="1100" dirty="0">
                         <a:latin typeface="맑은 고딕" charset="0"/>
@@ -3874,7 +3874,7 @@
                           <a:ea typeface="맑은 고딕" pitchFamily="34" charset="-122"/>
                           <a:cs typeface="맑은 고딕" pitchFamily="34" charset="-120"/>
                         </a:rPr>
-                        <a:t>Ring</a:t>
+                        <a:t>Necklace</a:t>
                       </a:r>
                       <a:endParaRPr lang="en-US" sz="1000" dirty="0">
                         <a:latin typeface="맑은 고딕" charset="0"/>
@@ -3939,7 +3939,7 @@
                           <a:ea typeface="맑은 고딕" pitchFamily="34" charset="-122"/>
                           <a:cs typeface="맑은 고딕" pitchFamily="34" charset="-120"/>
                         </a:rPr>
-                        <a:t>[SILVER925] Guyeong Open Ring v3.0 (silver)</a:t>
+                        <a:t>CandyPOP Necklace (사이즈: 1size (37~43cm))</a:t>
                       </a:r>
                       <a:endParaRPr lang="en-US" sz="1100" dirty="0">
                         <a:latin typeface="맑은 고딕" charset="0"/>
@@ -4004,7 +4004,7 @@
                           <a:ea typeface="맑은 고딕" pitchFamily="34" charset="-122"/>
                           <a:cs typeface="맑은 고딕" pitchFamily="34" charset="-120"/>
                         </a:rPr>
-                        <a:t>51 개</a:t>
+                        <a:t>27 개</a:t>
                       </a:r>
                       <a:endParaRPr lang="en-US" sz="1400" dirty="0">
                         <a:latin typeface="맑은 고딕" charset="0"/>
@@ -4136,7 +4136,7 @@
                           <a:ea typeface="맑은 고딕" pitchFamily="34" charset="-122"/>
                           <a:cs typeface="맑은 고딕" pitchFamily="34" charset="-120"/>
                         </a:rPr>
-                        <a:t>6A</a:t>
+                        <a:t>CT</a:t>
                       </a:r>
                       <a:endParaRPr lang="en-US" sz="1100" dirty="0">
                         <a:latin typeface="맑은 고딕" charset="0"/>
@@ -4201,7 +4201,7 @@
                           <a:ea typeface="맑은 고딕" pitchFamily="34" charset="-122"/>
                           <a:cs typeface="맑은 고딕" pitchFamily="34" charset="-120"/>
                         </a:rPr>
-                        <a:t>Ring</a:t>
+                        <a:t>Necklace</a:t>
                       </a:r>
                       <a:endParaRPr lang="en-US" sz="1000" dirty="0">
                         <a:latin typeface="맑은 고딕" charset="0"/>
@@ -4266,7 +4266,7 @@
                           <a:ea typeface="맑은 고딕" pitchFamily="34" charset="-122"/>
                           <a:cs typeface="맑은 고딕" pitchFamily="34" charset="-120"/>
                         </a:rPr>
-                        <a:t>[SILVER925] Eramam Open Ring</a:t>
+                        <a:t>CandyPOP Necklace (사이즈: 2size (47~52cm))</a:t>
                       </a:r>
                       <a:endParaRPr lang="en-US" sz="1100" dirty="0">
                         <a:latin typeface="맑은 고딕" charset="0"/>
@@ -4331,7 +4331,7 @@
                           <a:ea typeface="맑은 고딕" pitchFamily="34" charset="-122"/>
                           <a:cs typeface="맑은 고딕" pitchFamily="34" charset="-120"/>
                         </a:rPr>
-                        <a:t>21 개</a:t>
+                        <a:t>25 개</a:t>
                       </a:r>
                       <a:endParaRPr lang="en-US" sz="1400" dirty="0">
                         <a:latin typeface="맑은 고딕" charset="0"/>
@@ -4463,7 +4463,7 @@
                           <a:ea typeface="맑은 고딕" pitchFamily="34" charset="-122"/>
                           <a:cs typeface="맑은 고딕" pitchFamily="34" charset="-120"/>
                         </a:rPr>
-                        <a:t>CT</a:t>
+                        <a:t>6A</a:t>
                       </a:r>
                       <a:endParaRPr lang="en-US" sz="1100" dirty="0">
                         <a:latin typeface="맑은 고딕" charset="0"/>
@@ -4528,7 +4528,7 @@
                           <a:ea typeface="맑은 고딕" pitchFamily="34" charset="-122"/>
                           <a:cs typeface="맑은 고딕" pitchFamily="34" charset="-120"/>
                         </a:rPr>
-                        <a:t>Necklace</a:t>
+                        <a:t>Ring</a:t>
                       </a:r>
                       <a:endParaRPr lang="en-US" sz="1000" dirty="0">
                         <a:latin typeface="맑은 고딕" charset="0"/>
@@ -4593,7 +4593,7 @@
                           <a:ea typeface="맑은 고딕" pitchFamily="34" charset="-122"/>
                           <a:cs typeface="맑은 고딕" pitchFamily="34" charset="-120"/>
                         </a:rPr>
-                        <a:t>CandyPOP Necklace (사이즈: 1size (37~43cm))</a:t>
+                        <a:t>[SILVER925] Eramam Open Ring</a:t>
                       </a:r>
                       <a:endParaRPr lang="en-US" sz="1100" dirty="0">
                         <a:latin typeface="맑은 고딕" charset="0"/>
@@ -4658,7 +4658,7 @@
                           <a:ea typeface="맑은 고딕" pitchFamily="34" charset="-122"/>
                           <a:cs typeface="맑은 고딕" pitchFamily="34" charset="-120"/>
                         </a:rPr>
-                        <a:t>21 개</a:t>
+                        <a:t>24 개</a:t>
                       </a:r>
                       <a:endParaRPr lang="en-US" sz="1200" dirty="0">
                         <a:latin typeface="맑은 고딕" charset="0"/>
@@ -4985,7 +4985,7 @@
                           <a:ea typeface="맑은 고딕" pitchFamily="34" charset="-122"/>
                           <a:cs typeface="맑은 고딕" pitchFamily="34" charset="-120"/>
                         </a:rPr>
-                        <a:t>19 개</a:t>
+                        <a:t>22 개</a:t>
                       </a:r>
                       <a:endParaRPr lang="en-US" sz="1200" dirty="0">
                         <a:latin typeface="맑은 고딕" charset="0"/>
@@ -5071,7 +5071,7 @@
                 <a:ea typeface="맑은 고딕" pitchFamily="34" charset="-122"/>
                 <a:cs typeface="맑은 고딕" pitchFamily="34" charset="-120"/>
               </a:rPr>
-              <a:t>베스트 상품 리포트  ·  생성 2026-06-03 08:00</a:t>
+              <a:t>베스트 상품 리포트  ·  생성 2026-06-04 08:00</a:t>
             </a:r>
             <a:endParaRPr lang="en-US" sz="900" dirty="0"/>
           </a:p>
@@ -5284,7 +5284,7 @@
                 <a:ea typeface="맑은 고딕" pitchFamily="34" charset="-122"/>
                 <a:cs typeface="맑은 고딕" pitchFamily="34" charset="-120"/>
               </a:rPr>
-              <a:t>2026년 06월 03일 (수)</a:t>
+              <a:t>2026년 06월 04일 (목)</a:t>
             </a:r>
             <a:endParaRPr lang="en-US" sz="1200" dirty="0"/>
           </a:p>
@@ -5451,7 +5451,7 @@
                 <a:ea typeface="맑은 고딕" pitchFamily="34" charset="-122"/>
                 <a:cs typeface="맑은 고딕" pitchFamily="34" charset="-120"/>
               </a:rPr>
-              <a:t>397 개</a:t>
+              <a:t>245 개</a:t>
             </a:r>
             <a:endParaRPr lang="en-US" sz="3600" dirty="0"/>
           </a:p>
@@ -5579,7 +5579,7 @@
                 <a:ea typeface="맑은 고딕" pitchFamily="34" charset="-122"/>
                 <a:cs typeface="맑은 고딕" pitchFamily="34" charset="-120"/>
               </a:rPr>
-              <a:t>[SILVER925] CH.alban Open Ring</a:t>
+              <a:t>[SILVER925] Guyeong Open Ring v3.0 (silver)</a:t>
             </a:r>
             <a:endParaRPr lang="en-US" sz="1800" dirty="0"/>
           </a:p>
@@ -5657,7 +5657,7 @@
                 <a:ea typeface="맑은 고딕" pitchFamily="34" charset="-122"/>
                 <a:cs typeface="맑은 고딕" pitchFamily="34" charset="-120"/>
               </a:rPr>
-              <a:t>58</a:t>
+              <a:t>56</a:t>
             </a:r>
             <a:endParaRPr lang="en-US" sz="4400" dirty="0"/>
           </a:p>
@@ -6191,7 +6191,7 @@
                           <a:ea typeface="맑은 고딕" pitchFamily="34" charset="-122"/>
                           <a:cs typeface="맑은 고딕" pitchFamily="34" charset="-120"/>
                         </a:rPr>
-                        <a:t>[SILVER925] CH.alban Open Ring</a:t>
+                        <a:t>[SILVER925] Guyeong Open Ring v3.0 (silver)</a:t>
                       </a:r>
                       <a:endParaRPr lang="en-US" sz="1100" dirty="0">
                         <a:latin typeface="맑은 고딕" charset="0"/>
@@ -6256,7 +6256,7 @@
                           <a:ea typeface="맑은 고딕" pitchFamily="34" charset="-122"/>
                           <a:cs typeface="맑은 고딕" pitchFamily="34" charset="-120"/>
                         </a:rPr>
-                        <a:t>58 개</a:t>
+                        <a:t>56 개</a:t>
                       </a:r>
                       <a:endParaRPr lang="en-US" sz="1400" dirty="0">
                         <a:latin typeface="맑은 고딕" charset="0"/>
@@ -6453,7 +6453,7 @@
                           <a:ea typeface="맑은 고딕" pitchFamily="34" charset="-122"/>
                           <a:cs typeface="맑은 고딕" pitchFamily="34" charset="-120"/>
                         </a:rPr>
-                        <a:t>[SILVER925] Guyeong Open Ring v3.0 (silver)</a:t>
+                        <a:t>[SILVER925] Eramam Open Ring</a:t>
                       </a:r>
                       <a:endParaRPr lang="en-US" sz="1100" dirty="0">
                         <a:latin typeface="맑은 고딕" charset="0"/>
@@ -6518,7 +6518,7 @@
                           <a:ea typeface="맑은 고딕" pitchFamily="34" charset="-122"/>
                           <a:cs typeface="맑은 고딕" pitchFamily="34" charset="-120"/>
                         </a:rPr>
-                        <a:t>51 개</a:t>
+                        <a:t>24 개</a:t>
                       </a:r>
                       <a:endParaRPr lang="en-US" sz="1200" dirty="0">
                         <a:latin typeface="맑은 고딕" charset="0"/>
@@ -6650,7 +6650,7 @@
                           <a:ea typeface="맑은 고딕" pitchFamily="34" charset="-122"/>
                           <a:cs typeface="맑은 고딕" pitchFamily="34" charset="-120"/>
                         </a:rPr>
-                        <a:t>Ring</a:t>
+                        <a:t>Necklace</a:t>
                       </a:r>
                       <a:endParaRPr lang="en-US" sz="1000" dirty="0">
                         <a:latin typeface="맑은 고딕" charset="0"/>
@@ -6715,7 +6715,7 @@
                           <a:ea typeface="맑은 고딕" pitchFamily="34" charset="-122"/>
                           <a:cs typeface="맑은 고딕" pitchFamily="34" charset="-120"/>
                         </a:rPr>
-                        <a:t>[SILVER925] Eramam Open Ring</a:t>
+                        <a:t>Marquise Necklace</a:t>
                       </a:r>
                       <a:endParaRPr lang="en-US" sz="1100" dirty="0">
                         <a:latin typeface="맑은 고딕" charset="0"/>
@@ -6780,7 +6780,7 @@
                           <a:ea typeface="맑은 고딕" pitchFamily="34" charset="-122"/>
                           <a:cs typeface="맑은 고딕" pitchFamily="34" charset="-120"/>
                         </a:rPr>
-                        <a:t>21 개</a:t>
+                        <a:t>22 개</a:t>
                       </a:r>
                       <a:endParaRPr lang="en-US" sz="1200" dirty="0">
                         <a:latin typeface="맑은 고딕" charset="0"/>
@@ -6912,7 +6912,7 @@
                           <a:ea typeface="맑은 고딕" pitchFamily="34" charset="-122"/>
                           <a:cs typeface="맑은 고딕" pitchFamily="34" charset="-120"/>
                         </a:rPr>
-                        <a:t>Necklace</a:t>
+                        <a:t>Ring</a:t>
                       </a:r>
                       <a:endParaRPr lang="en-US" sz="1000" dirty="0">
                         <a:latin typeface="맑은 고딕" charset="0"/>
@@ -6977,7 +6977,7 @@
                           <a:ea typeface="맑은 고딕" pitchFamily="34" charset="-122"/>
                           <a:cs typeface="맑은 고딕" pitchFamily="34" charset="-120"/>
                         </a:rPr>
-                        <a:t>Marquise Necklace</a:t>
+                        <a:t>[SILVER925] A Rua Open Ring</a:t>
                       </a:r>
                       <a:endParaRPr lang="en-US" sz="1100" dirty="0">
                         <a:latin typeface="맑은 고딕" charset="0"/>
@@ -7042,7 +7042,7 @@
                           <a:ea typeface="맑은 고딕" pitchFamily="34" charset="-122"/>
                           <a:cs typeface="맑은 고딕" pitchFamily="34" charset="-120"/>
                         </a:rPr>
-                        <a:t>19 개</a:t>
+                        <a:t>18 개</a:t>
                       </a:r>
                       <a:endParaRPr lang="en-US" sz="1200" dirty="0">
                         <a:latin typeface="맑은 고딕" charset="0"/>
@@ -7596,7 +7596,7 @@
                 <a:ea typeface="맑은 고딕" pitchFamily="34" charset="-122"/>
                 <a:cs typeface="맑은 고딕" pitchFamily="34" charset="-120"/>
               </a:rPr>
-              <a:t>Ring  ·  재고 5개</a:t>
+              <a:t>Ring  ·  재고 4개</a:t>
             </a:r>
             <a:pPr indent="0" marL="0">
               <a:buNone/>
@@ -8267,7 +8267,7 @@
                 <a:ea typeface="맑은 고딕" pitchFamily="34" charset="-122"/>
                 <a:cs typeface="맑은 고딕" pitchFamily="34" charset="-120"/>
               </a:rPr>
-              <a:t>베스트 상품 리포트  ·  생성 2026-06-03 08:00</a:t>
+              <a:t>베스트 상품 리포트  ·  생성 2026-06-04 08:00</a:t>
             </a:r>
             <a:endParaRPr lang="en-US" sz="900" dirty="0"/>
           </a:p>
@@ -8480,7 +8480,7 @@
                 <a:ea typeface="맑은 고딕" pitchFamily="34" charset="-122"/>
                 <a:cs typeface="맑은 고딕" pitchFamily="34" charset="-120"/>
               </a:rPr>
-              <a:t>2026년 06월 03일 (수)</a:t>
+              <a:t>2026년 06월 04일 (목)</a:t>
             </a:r>
             <a:endParaRPr lang="en-US" sz="1200" dirty="0"/>
           </a:p>
@@ -8647,7 +8647,7 @@
                 <a:ea typeface="맑은 고딕" pitchFamily="34" charset="-122"/>
                 <a:cs typeface="맑은 고딕" pitchFamily="34" charset="-120"/>
               </a:rPr>
-              <a:t>85 개</a:t>
+              <a:t>106 개</a:t>
             </a:r>
             <a:endParaRPr lang="en-US" sz="3600" dirty="0"/>
           </a:p>
@@ -8853,7 +8853,7 @@
                 <a:ea typeface="맑은 고딕" pitchFamily="34" charset="-122"/>
                 <a:cs typeface="맑은 고딕" pitchFamily="34" charset="-120"/>
               </a:rPr>
-              <a:t>21</a:t>
+              <a:t>27</a:t>
             </a:r>
             <a:endParaRPr lang="en-US" sz="4400" dirty="0"/>
           </a:p>
@@ -9452,7 +9452,7 @@
                           <a:ea typeface="맑은 고딕" pitchFamily="34" charset="-122"/>
                           <a:cs typeface="맑은 고딕" pitchFamily="34" charset="-120"/>
                         </a:rPr>
-                        <a:t>21 개</a:t>
+                        <a:t>27 개</a:t>
                       </a:r>
                       <a:endParaRPr lang="en-US" sz="1400" dirty="0">
                         <a:latin typeface="맑은 고딕" charset="0"/>
@@ -9649,7 +9649,7 @@
                           <a:ea typeface="맑은 고딕" pitchFamily="34" charset="-122"/>
                           <a:cs typeface="맑은 고딕" pitchFamily="34" charset="-120"/>
                         </a:rPr>
-                        <a:t>ThreadDuo Necklace</a:t>
+                        <a:t>CandyPOP Necklace (사이즈: 2size (47~52cm))</a:t>
                       </a:r>
                       <a:endParaRPr lang="en-US" sz="1100" dirty="0">
                         <a:latin typeface="맑은 고딕" charset="0"/>
@@ -9714,7 +9714,7 @@
                           <a:ea typeface="맑은 고딕" pitchFamily="34" charset="-122"/>
                           <a:cs typeface="맑은 고딕" pitchFamily="34" charset="-120"/>
                         </a:rPr>
-                        <a:t>18 개</a:t>
+                        <a:t>25 개</a:t>
                       </a:r>
                       <a:endParaRPr lang="en-US" sz="1200" dirty="0">
                         <a:latin typeface="맑은 고딕" charset="0"/>
@@ -9911,7 +9911,7 @@
                           <a:ea typeface="맑은 고딕" pitchFamily="34" charset="-122"/>
                           <a:cs typeface="맑은 고딕" pitchFamily="34" charset="-120"/>
                         </a:rPr>
-                        <a:t>CandyPOP Necklace (사이즈: 2size (47~52cm))</a:t>
+                        <a:t>ThreadDuo Necklace</a:t>
                       </a:r>
                       <a:endParaRPr lang="en-US" sz="1100" dirty="0">
                         <a:latin typeface="맑은 고딕" charset="0"/>
@@ -10165,7 +10165,7 @@
                 <a:ea typeface="맑은 고딕" pitchFamily="34" charset="-122"/>
                 <a:cs typeface="맑은 고딕" pitchFamily="34" charset="-120"/>
               </a:rPr>
-              <a:t>베스트 상품 리포트  ·  생성 2026-06-03 08:00</a:t>
+              <a:t>베스트 상품 리포트  ·  생성 2026-06-04 08:00</a:t>
             </a:r>
             <a:endParaRPr lang="en-US" sz="900" dirty="0"/>
           </a:p>
@@ -10378,7 +10378,7 @@
                 <a:ea typeface="맑은 고딕" pitchFamily="34" charset="-122"/>
                 <a:cs typeface="맑은 고딕" pitchFamily="34" charset="-120"/>
               </a:rPr>
-              <a:t>2026년 06월 03일 (수)</a:t>
+              <a:t>2026년 06월 04일 (목)</a:t>
             </a:r>
             <a:endParaRPr lang="en-US" sz="1200" dirty="0"/>
           </a:p>
@@ -10673,7 +10673,7 @@
                 <a:ea typeface="맑은 고딕" pitchFamily="34" charset="-122"/>
                 <a:cs typeface="맑은 고딕" pitchFamily="34" charset="-120"/>
               </a:rPr>
-              <a:t>31</a:t>
+              <a:t>25</a:t>
             </a:r>
             <a:endParaRPr lang="en-US" sz="3000" dirty="0"/>
           </a:p>
@@ -10801,7 +10801,7 @@
                 <a:ea typeface="맑은 고딕" pitchFamily="34" charset="-122"/>
                 <a:cs typeface="맑은 고딕" pitchFamily="34" charset="-120"/>
               </a:rPr>
-              <a:t>7</a:t>
+              <a:t>8</a:t>
             </a:r>
             <a:endParaRPr lang="en-US" sz="3000" dirty="0"/>
           </a:p>
@@ -10929,7 +10929,7 @@
                 <a:ea typeface="맑은 고딕" pitchFamily="34" charset="-122"/>
                 <a:cs typeface="맑은 고딕" pitchFamily="34" charset="-120"/>
               </a:rPr>
-              <a:t>28,870</a:t>
+              <a:t>35,672</a:t>
             </a:r>
             <a:endParaRPr lang="en-US" sz="3000" dirty="0"/>
           </a:p>
@@ -11489,7 +11489,7 @@
                           <a:ea typeface="맑은 고딕" pitchFamily="34" charset="-122"/>
                           <a:cs typeface="맑은 고딕" pitchFamily="34" charset="-120"/>
                         </a:rPr>
-                        <a:t>2,019</a:t>
+                        <a:t>3,226</a:t>
                       </a:r>
                       <a:endParaRPr lang="en-US" sz="1000" dirty="0">
                         <a:latin typeface="맑은 고딕" charset="0"/>
@@ -11751,7 +11751,7 @@
                           <a:ea typeface="맑은 고딕" pitchFamily="34" charset="-122"/>
                           <a:cs typeface="맑은 고딕" pitchFamily="34" charset="-120"/>
                         </a:rPr>
-                        <a:t>1,539</a:t>
+                        <a:t>1,938</a:t>
                       </a:r>
                       <a:endParaRPr lang="en-US" sz="1000" dirty="0">
                         <a:latin typeface="맑은 고딕" charset="0"/>
@@ -12013,7 +12013,7 @@
                           <a:ea typeface="맑은 고딕" pitchFamily="34" charset="-122"/>
                           <a:cs typeface="맑은 고딕" pitchFamily="34" charset="-120"/>
                         </a:rPr>
-                        <a:t>890</a:t>
+                        <a:t>1,806</a:t>
                       </a:r>
                       <a:endParaRPr lang="en-US" sz="1000" dirty="0">
                         <a:latin typeface="맑은 고딕" charset="0"/>
@@ -12210,7 +12210,7 @@
                           <a:ea typeface="맑은 고딕" pitchFamily="34" charset="-122"/>
                           <a:cs typeface="맑은 고딕" pitchFamily="34" charset="-120"/>
                         </a:rPr>
-                        <a:t>컬러: 네온핑크 / 기종 옵션: USB -&gt; Apple 8pin</a:t>
+                        <a:t>컬러: 퍼플 / 기종 옵션: C type -&gt; C type</a:t>
                       </a:r>
                       <a:endParaRPr lang="en-US" sz="900" dirty="0">
                         <a:latin typeface="맑은 고딕" charset="0"/>
@@ -12275,7 +12275,7 @@
                           <a:ea typeface="맑은 고딕" pitchFamily="34" charset="-122"/>
                           <a:cs typeface="맑은 고딕" pitchFamily="34" charset="-120"/>
                         </a:rPr>
-                        <a:t>811</a:t>
+                        <a:t>1,407</a:t>
                       </a:r>
                       <a:endParaRPr lang="en-US" sz="1000" dirty="0">
                         <a:latin typeface="맑은 고딕" charset="0"/>
@@ -12407,7 +12407,7 @@
                           <a:ea typeface="맑은 고딕" pitchFamily="34" charset="-122"/>
                           <a:cs typeface="맑은 고딕" pitchFamily="34" charset="-120"/>
                         </a:rPr>
-                        <a:t>Metallic Hair Pin</a:t>
+                        <a:t>180° Fast Charging Cable (8color)</a:t>
                       </a:r>
                       <a:endParaRPr lang="en-US" sz="1000" dirty="0">
                         <a:latin typeface="맑은 고딕" charset="0"/>
@@ -12472,7 +12472,7 @@
                           <a:ea typeface="맑은 고딕" pitchFamily="34" charset="-122"/>
                           <a:cs typeface="맑은 고딕" pitchFamily="34" charset="-120"/>
                         </a:rPr>
-                        <a:t>옵션: 하트</a:t>
+                        <a:t>컬러: 피치 / 기종 옵션: C type -&gt; C type</a:t>
                       </a:r>
                       <a:endParaRPr lang="en-US" sz="900" dirty="0">
                         <a:latin typeface="맑은 고딕" charset="0"/>
@@ -12537,7 +12537,7 @@
                           <a:ea typeface="맑은 고딕" pitchFamily="34" charset="-122"/>
                           <a:cs typeface="맑은 고딕" pitchFamily="34" charset="-120"/>
                         </a:rPr>
-                        <a:t>743</a:t>
+                        <a:t>1,021</a:t>
                       </a:r>
                       <a:endParaRPr lang="en-US" sz="1000" dirty="0">
                         <a:latin typeface="맑은 고딕" charset="0"/>
@@ -12623,7 +12623,7 @@
                 <a:ea typeface="맑은 고딕" pitchFamily="34" charset="-122"/>
                 <a:cs typeface="맑은 고딕" pitchFamily="34" charset="-120"/>
               </a:rPr>
-              <a:t>재고 점검  🔴 품절 31건</a:t>
+              <a:t>재고 점검  🔴 품절 25건</a:t>
             </a:r>
             <a:pPr indent="0" marL="0">
               <a:buNone/>
@@ -13556,7 +13556,7 @@
                 <a:ea typeface="맑은 고딕" pitchFamily="34" charset="-122"/>
                 <a:cs typeface="맑은 고딕" pitchFamily="34" charset="-120"/>
               </a:rPr>
-              <a:t>베스트 상품 리포트  ·  생성 2026-06-03 08:00</a:t>
+              <a:t>베스트 상품 리포트  ·  생성 2026-06-04 08:00</a:t>
             </a:r>
             